<commit_message>
deck 2-3-Alignment: six section-break slides, in 2-2-2's established style
Inserted one break per section of the revised architecture (SECTION 0-5),
at positions 2, 5, 10, 17, 23, 27 (deck now 33 slides). Geometry, palette,
and type transcribed from 2-2-2's break slides (eyebrow "SECTION N" 20pt
bold gold 8E6F3E; title 40pt centered on the Section layout; question line
24pt 5C4826; centered gold rule), hand-placed on the deck's existing
Section layout -- no layout imported. All six rendered single-line; no
title shortened. Footer-band crowding measured across all content slides:
minimum gap 0.38in, above the 0.2in threshold; nothing to fix.
</commit_message>
<xml_diff>
--- a/course/lectures/act-2-delegation-and-control/03-alignment/2-3-Alignment.pptx
+++ b/course/lectures/act-2-delegation-and-control/03-alignment/2-3-Alignment.pptx
@@ -9,26 +9,32 @@
   </p:notesMasterIdLst>
   <p:sldIdLst>
     <p:sldId id="256" r:id="rId7"/>
+    <p:sldId id="283" r:id="rId48"/>
     <p:sldId id="257" r:id="rId8"/>
     <p:sldId id="258" r:id="rId9"/>
+    <p:sldId id="284" r:id="rId49"/>
     <p:sldId id="259" r:id="rId10"/>
     <p:sldId id="260" r:id="rId11"/>
     <p:sldId id="261" r:id="rId12"/>
     <p:sldId id="262" r:id="rId13"/>
+    <p:sldId id="285" r:id="rId50"/>
     <p:sldId id="263" r:id="rId14"/>
     <p:sldId id="264" r:id="rId15"/>
     <p:sldId id="265" r:id="rId16"/>
     <p:sldId id="266" r:id="rId17"/>
     <p:sldId id="267" r:id="rId18"/>
     <p:sldId id="268" r:id="rId19"/>
+    <p:sldId id="286" r:id="rId51"/>
     <p:sldId id="269" r:id="rId20"/>
     <p:sldId id="270" r:id="rId21"/>
     <p:sldId id="271" r:id="rId22"/>
     <p:sldId id="272" r:id="rId23"/>
     <p:sldId id="273" r:id="rId24"/>
+    <p:sldId id="287" r:id="rId52"/>
     <p:sldId id="274" r:id="rId25"/>
     <p:sldId id="275" r:id="rId26"/>
     <p:sldId id="276" r:id="rId27"/>
+    <p:sldId id="288" r:id="rId53"/>
     <p:sldId id="277" r:id="rId28"/>
     <p:sldId id="278" r:id="rId29"/>
     <p:sldId id="279" r:id="rId30"/>
@@ -17342,6 +17348,662 @@
 </p:sld>
 </file>
 
+<file path=ppt/slides/slide28.xml><?xml version="1.0" encoding="utf-8"?>
+<p:sld xmlns:a="http://schemas.openxmlformats.org/drawingml/2006/main" xmlns:r="http://schemas.openxmlformats.org/officeDocument/2006/relationships" xmlns:p="http://schemas.openxmlformats.org/presentationml/2006/main">
+  <p:cSld>
+    <p:spTree>
+      <p:nvGrpSpPr>
+        <p:cNvPr id="1" name=""/>
+        <p:cNvGrpSpPr/>
+        <p:nvPr/>
+      </p:nvGrpSpPr>
+      <p:grpSpPr>
+        <a:xfrm>
+          <a:off x="0" y="0"/>
+          <a:ext cx="0" cy="0"/>
+          <a:chOff x="0" y="0"/>
+          <a:chExt cx="0" cy="0"/>
+        </a:xfrm>
+      </p:grpSpPr>
+      <p:sp>
+        <p:nvSpPr>
+          <p:cNvPr id="100" name="SectionLabel"/>
+          <p:cNvSpPr txBox="1"/>
+          <p:nvPr/>
+        </p:nvSpPr>
+        <p:spPr>
+          <a:xfrm>
+            <a:off x="685800" y="1243584"/>
+            <a:ext cx="7772400" cy="365760"/>
+          </a:xfrm>
+          <a:prstGeom prst="rect">
+            <a:avLst/>
+          </a:prstGeom>
+          <a:noFill/>
+          <a:ln>
+            <a:noFill/>
+          </a:ln>
+        </p:spPr>
+        <p:txBody>
+          <a:bodyPr wrap="square" lIns="0" tIns="0" rIns="0" bIns="0" anchor="t"/>
+          <a:lstStyle/>
+          <a:p>
+            <a:pPr marL="0" marR="0" lvl="0" indent="0" algn="ctr" defTabSz="457200" rtl="0" eaLnBrk="1" fontAlgn="auto" latinLnBrk="0" hangingPunct="1">
+              <a:lnSpc>
+                <a:spcPct val="100000"/>
+              </a:lnSpc>
+              <a:spcBef>
+                <a:spcPts val="0"/>
+              </a:spcBef>
+              <a:spcAft>
+                <a:spcPts val="0"/>
+              </a:spcAft>
+              <a:buClrTx/>
+              <a:buSzTx/>
+              <a:buFontTx/>
+              <a:buNone/>
+              <a:tabLst/>
+              <a:defRPr/>
+            </a:pPr>
+            <a:r>
+              <a:rPr kumimoji="0" lang="en-US" sz="2000" b="1" i="0" u="none" strike="noStrike" kern="1200" cap="none" spc="0" normalizeH="0" baseline="0" noProof="0" dirty="0">
+                <a:ln>
+                  <a:noFill/>
+                </a:ln>
+                <a:solidFill>
+                  <a:srgbClr val="8E6F3E"/>
+                </a:solidFill>
+                <a:effectLst/>
+                <a:uLnTx/>
+                <a:uFillTx/>
+                <a:latin typeface="Calibri" panose="020F0502020204030204"/>
+                <a:ea typeface="+mn-ea"/>
+                <a:cs typeface="+mn-cs"/>
+              </a:rPr>
+              <a:t>SECTION 0</a:t>
+            </a:r>
+          </a:p>
+        </p:txBody>
+      </p:sp>
+      <p:sp>
+        <p:nvSpPr>
+          <p:cNvPr id="2" name="Title 1"/>
+          <p:cNvSpPr>
+            <a:spLocks noGrp="1"/>
+          </p:cNvSpPr>
+          <p:nvPr>
+            <p:ph type="title"/>
+          </p:nvPr>
+        </p:nvSpPr>
+        <p:spPr>
+          <a:xfrm>
+            <a:off x="685800" y="1700784"/>
+            <a:ext cx="7772400" cy="1005840"/>
+          </a:xfrm>
+        </p:spPr>
+        <p:txBody>
+          <a:bodyPr>
+            <a:normAutofit/>
+          </a:bodyPr>
+          <a:lstStyle/>
+          <a:p>
+            <a:pPr algn="ctr">
+              <a:buNone/>
+              <a:defRPr b="0"/>
+            </a:pPr>
+            <a:r>
+              <a:rPr lang="en-US" sz="4000" b="0" i="0" dirty="0">
+                <a:solidFill>
+                  <a:srgbClr val="000000"/>
+                </a:solidFill>
+              </a:rPr>
+              <a:t>Validation meets Delegation</a:t>
+            </a:r>
+          </a:p>
+        </p:txBody>
+      </p:sp>
+      <p:sp>
+        <p:nvSpPr>
+          <p:cNvPr id="3" name="Slide Number Placeholder 3"/>
+          <p:cNvSpPr>
+            <a:spLocks noGrp="1"/>
+          </p:cNvSpPr>
+          <p:nvPr>
+            <p:ph type="sldNum" sz="quarter" idx="4"/>
+          </p:nvPr>
+        </p:nvSpPr>
+        <p:spPr/>
+        <p:txBody>
+          <a:bodyPr/>
+          <a:lstStyle/>
+          <a:p>
+            <a:pPr marL="0" marR="0" lvl="0" indent="0" algn="r" defTabSz="457200" rtl="0" eaLnBrk="1" fontAlgn="auto" latinLnBrk="0" hangingPunct="1">
+              <a:lnSpc>
+                <a:spcPct val="100000"/>
+              </a:lnSpc>
+              <a:spcBef>
+                <a:spcPts val="0"/>
+              </a:spcBef>
+              <a:spcAft>
+                <a:spcPts val="0"/>
+              </a:spcAft>
+              <a:buClrTx/>
+              <a:buSzTx/>
+              <a:buFontTx/>
+              <a:buNone/>
+              <a:tabLst/>
+              <a:defRPr/>
+            </a:pPr>
+            <a:fld id="{B7EB45DA-9A0D-DC49-8E02-F30A5DDC21C3}" type="slidenum">
+              <a:rPr kumimoji="0" lang="en-US" sz="1200" b="0" i="0" u="none" strike="noStrike" kern="1200" cap="none" spc="0" normalizeH="0" baseline="0" noProof="0" smtClean="0">
+                <a:ln>
+                  <a:noFill/>
+                </a:ln>
+                <a:solidFill>
+                  <a:srgbClr val="000000">
+                    <a:tint val="75000"/>
+                  </a:srgbClr>
+                </a:solidFill>
+                <a:effectLst/>
+                <a:uLnTx/>
+                <a:uFillTx/>
+                <a:latin typeface="Calibri" panose="020F0502020204030204"/>
+                <a:ea typeface="+mn-ea"/>
+                <a:cs typeface="+mn-cs"/>
+              </a:rPr>
+              <a:pPr marL="0" marR="0" lvl="0" indent="0" algn="r" defTabSz="457200" rtl="0" eaLnBrk="1" fontAlgn="auto" latinLnBrk="0" hangingPunct="1">
+                <a:lnSpc>
+                  <a:spcPct val="100000"/>
+                </a:lnSpc>
+                <a:spcBef>
+                  <a:spcPts val="0"/>
+                </a:spcBef>
+                <a:spcAft>
+                  <a:spcPts val="0"/>
+                </a:spcAft>
+                <a:buClrTx/>
+                <a:buSzTx/>
+                <a:buFontTx/>
+                <a:buNone/>
+                <a:tabLst/>
+                <a:defRPr/>
+              </a:pPr>
+              <a:t>2</a:t>
+            </a:fld>
+            <a:endParaRPr kumimoji="0" lang="en-US" sz="1200" b="0" i="0" u="none" strike="noStrike" kern="1200" cap="none" spc="0" normalizeH="0" baseline="0" noProof="0">
+              <a:ln>
+                <a:noFill/>
+              </a:ln>
+              <a:solidFill>
+                <a:srgbClr val="000000">
+                  <a:tint val="75000"/>
+                </a:srgbClr>
+              </a:solidFill>
+              <a:effectLst/>
+              <a:uLnTx/>
+              <a:uFillTx/>
+              <a:latin typeface="Calibri" panose="020F0502020204030204"/>
+              <a:ea typeface="+mn-ea"/>
+              <a:cs typeface="+mn-cs"/>
+            </a:endParaRPr>
+          </a:p>
+        </p:txBody>
+      </p:sp>
+      <p:sp>
+        <p:nvSpPr>
+          <p:cNvPr id="101" name="Question"/>
+          <p:cNvSpPr txBox="1"/>
+          <p:nvPr/>
+        </p:nvSpPr>
+        <p:spPr>
+          <a:xfrm>
+            <a:off x="685800" y="2798064"/>
+            <a:ext cx="7772400" cy="475488"/>
+          </a:xfrm>
+          <a:prstGeom prst="rect">
+            <a:avLst/>
+          </a:prstGeom>
+          <a:noFill/>
+          <a:ln>
+            <a:noFill/>
+          </a:ln>
+        </p:spPr>
+        <p:txBody>
+          <a:bodyPr wrap="square" lIns="0" tIns="0" rIns="0" bIns="0" anchor="t"/>
+          <a:lstStyle/>
+          <a:p>
+            <a:pPr marL="0" marR="0" lvl="0" indent="0" algn="ctr" defTabSz="457200" rtl="0" eaLnBrk="1" fontAlgn="auto" latinLnBrk="0" hangingPunct="1">
+              <a:lnSpc>
+                <a:spcPct val="100000"/>
+              </a:lnSpc>
+              <a:spcBef>
+                <a:spcPts val="0"/>
+              </a:spcBef>
+              <a:spcAft>
+                <a:spcPts val="0"/>
+              </a:spcAft>
+              <a:buClrTx/>
+              <a:buSzTx/>
+              <a:buFontTx/>
+              <a:buNone/>
+              <a:tabLst/>
+              <a:defRPr/>
+            </a:pPr>
+            <a:r>
+              <a:rPr kumimoji="0" lang="en-US" sz="2400" b="0" i="0" u="none" strike="noStrike" kern="1200" cap="none" spc="0" normalizeH="0" baseline="0" noProof="0" dirty="0">
+                <a:ln>
+                  <a:noFill/>
+                </a:ln>
+                <a:solidFill>
+                  <a:srgbClr val="5C4826"/>
+                </a:solidFill>
+                <a:effectLst/>
+                <a:uLnTx/>
+                <a:uFillTx/>
+                <a:latin typeface="Calibri" panose="020F0502020204030204"/>
+                <a:ea typeface="+mn-ea"/>
+                <a:cs typeface="+mn-cs"/>
+              </a:rPr>
+              <a:t>When should engineering knowledge govern delegated work?</a:t>
+            </a:r>
+          </a:p>
+        </p:txBody>
+      </p:sp>
+      <p:sp>
+        <p:nvSpPr>
+          <p:cNvPr id="103" name="Rule"/>
+          <p:cNvSpPr/>
+          <p:nvPr/>
+        </p:nvSpPr>
+        <p:spPr>
+          <a:xfrm>
+            <a:off x="3429000" y="3584448"/>
+            <a:ext cx="2286000" cy="51206"/>
+          </a:xfrm>
+          <a:prstGeom prst="rect">
+            <a:avLst/>
+          </a:prstGeom>
+          <a:solidFill>
+            <a:srgbClr val="8E6F3E"/>
+          </a:solidFill>
+          <a:ln>
+            <a:noFill/>
+          </a:ln>
+        </p:spPr>
+        <p:txBody>
+          <a:bodyPr wrap="square" lIns="27432" tIns="22860" rIns="27432" bIns="22860" anchor="ctr"/>
+          <a:lstStyle/>
+          <a:p>
+            <a:pPr marL="0" marR="0" lvl="0" indent="0" algn="l" defTabSz="457200" rtl="0" eaLnBrk="1" fontAlgn="auto" latinLnBrk="0" hangingPunct="1">
+              <a:lnSpc>
+                <a:spcPct val="100000"/>
+              </a:lnSpc>
+              <a:spcBef>
+                <a:spcPts val="0"/>
+              </a:spcBef>
+              <a:spcAft>
+                <a:spcPts val="0"/>
+              </a:spcAft>
+              <a:buClrTx/>
+              <a:buSzTx/>
+              <a:buFontTx/>
+              <a:buNone/>
+              <a:tabLst/>
+              <a:defRPr/>
+            </a:pPr>
+            <a:endParaRPr kumimoji="0" lang="en-US" sz="1800" b="0" i="0" u="none" strike="noStrike" kern="1200" cap="none" spc="0" normalizeH="0" baseline="0" noProof="0">
+              <a:ln>
+                <a:noFill/>
+              </a:ln>
+              <a:solidFill>
+                <a:srgbClr val="000000"/>
+              </a:solidFill>
+              <a:effectLst/>
+              <a:uLnTx/>
+              <a:uFillTx/>
+              <a:latin typeface="Calibri" panose="020F0502020204030204"/>
+              <a:ea typeface="+mn-ea"/>
+              <a:cs typeface="+mn-cs"/>
+            </a:endParaRPr>
+          </a:p>
+        </p:txBody>
+      </p:sp>
+    </p:spTree>
+  </p:cSld>
+  <p:clrMapOvr>
+    <a:masterClrMapping/>
+  </p:clrMapOvr>
+</p:sld>
+</file>
+
+<file path=ppt/slides/slide29.xml><?xml version="1.0" encoding="utf-8"?>
+<p:sld xmlns:a="http://schemas.openxmlformats.org/drawingml/2006/main" xmlns:r="http://schemas.openxmlformats.org/officeDocument/2006/relationships" xmlns:p="http://schemas.openxmlformats.org/presentationml/2006/main">
+  <p:cSld>
+    <p:spTree>
+      <p:nvGrpSpPr>
+        <p:cNvPr id="1" name=""/>
+        <p:cNvGrpSpPr/>
+        <p:nvPr/>
+      </p:nvGrpSpPr>
+      <p:grpSpPr>
+        <a:xfrm>
+          <a:off x="0" y="0"/>
+          <a:ext cx="0" cy="0"/>
+          <a:chOff x="0" y="0"/>
+          <a:chExt cx="0" cy="0"/>
+        </a:xfrm>
+      </p:grpSpPr>
+      <p:sp>
+        <p:nvSpPr>
+          <p:cNvPr id="100" name="SectionLabel"/>
+          <p:cNvSpPr txBox="1"/>
+          <p:nvPr/>
+        </p:nvSpPr>
+        <p:spPr>
+          <a:xfrm>
+            <a:off x="685800" y="1243584"/>
+            <a:ext cx="7772400" cy="365760"/>
+          </a:xfrm>
+          <a:prstGeom prst="rect">
+            <a:avLst/>
+          </a:prstGeom>
+          <a:noFill/>
+          <a:ln>
+            <a:noFill/>
+          </a:ln>
+        </p:spPr>
+        <p:txBody>
+          <a:bodyPr wrap="square" lIns="0" tIns="0" rIns="0" bIns="0" anchor="t"/>
+          <a:lstStyle/>
+          <a:p>
+            <a:pPr marL="0" marR="0" lvl="0" indent="0" algn="ctr" defTabSz="457200" rtl="0" eaLnBrk="1" fontAlgn="auto" latinLnBrk="0" hangingPunct="1">
+              <a:lnSpc>
+                <a:spcPct val="100000"/>
+              </a:lnSpc>
+              <a:spcBef>
+                <a:spcPts val="0"/>
+              </a:spcBef>
+              <a:spcAft>
+                <a:spcPts val="0"/>
+              </a:spcAft>
+              <a:buClrTx/>
+              <a:buSzTx/>
+              <a:buFontTx/>
+              <a:buNone/>
+              <a:tabLst/>
+              <a:defRPr/>
+            </a:pPr>
+            <a:r>
+              <a:rPr kumimoji="0" lang="en-US" sz="2000" b="1" i="0" u="none" strike="noStrike" kern="1200" cap="none" spc="0" normalizeH="0" baseline="0" noProof="0" dirty="0">
+                <a:ln>
+                  <a:noFill/>
+                </a:ln>
+                <a:solidFill>
+                  <a:srgbClr val="8E6F3E"/>
+                </a:solidFill>
+                <a:effectLst/>
+                <a:uLnTx/>
+                <a:uFillTx/>
+                <a:latin typeface="Calibri" panose="020F0502020204030204"/>
+                <a:ea typeface="+mn-ea"/>
+                <a:cs typeface="+mn-cs"/>
+              </a:rPr>
+              <a:t>SECTION 1</a:t>
+            </a:r>
+          </a:p>
+        </p:txBody>
+      </p:sp>
+      <p:sp>
+        <p:nvSpPr>
+          <p:cNvPr id="2" name="Title 1"/>
+          <p:cNvSpPr>
+            <a:spLocks noGrp="1"/>
+          </p:cNvSpPr>
+          <p:nvPr>
+            <p:ph type="title"/>
+          </p:nvPr>
+        </p:nvSpPr>
+        <p:spPr>
+          <a:xfrm>
+            <a:off x="685800" y="1700784"/>
+            <a:ext cx="7772400" cy="1005840"/>
+          </a:xfrm>
+        </p:spPr>
+        <p:txBody>
+          <a:bodyPr>
+            <a:normAutofit/>
+          </a:bodyPr>
+          <a:lstStyle/>
+          <a:p>
+            <a:pPr algn="ctr">
+              <a:buNone/>
+              <a:defRPr b="0"/>
+            </a:pPr>
+            <a:r>
+              <a:rPr lang="en-US" sz="4000" b="0" i="0" dirty="0">
+                <a:solidFill>
+                  <a:srgbClr val="000000"/>
+                </a:solidFill>
+              </a:rPr>
+              <a:t>How do you know?</a:t>
+            </a:r>
+          </a:p>
+        </p:txBody>
+      </p:sp>
+      <p:sp>
+        <p:nvSpPr>
+          <p:cNvPr id="3" name="Slide Number Placeholder 3"/>
+          <p:cNvSpPr>
+            <a:spLocks noGrp="1"/>
+          </p:cNvSpPr>
+          <p:nvPr>
+            <p:ph type="sldNum" sz="quarter" idx="4"/>
+          </p:nvPr>
+        </p:nvSpPr>
+        <p:spPr/>
+        <p:txBody>
+          <a:bodyPr/>
+          <a:lstStyle/>
+          <a:p>
+            <a:pPr marL="0" marR="0" lvl="0" indent="0" algn="r" defTabSz="457200" rtl="0" eaLnBrk="1" fontAlgn="auto" latinLnBrk="0" hangingPunct="1">
+              <a:lnSpc>
+                <a:spcPct val="100000"/>
+              </a:lnSpc>
+              <a:spcBef>
+                <a:spcPts val="0"/>
+              </a:spcBef>
+              <a:spcAft>
+                <a:spcPts val="0"/>
+              </a:spcAft>
+              <a:buClrTx/>
+              <a:buSzTx/>
+              <a:buFontTx/>
+              <a:buNone/>
+              <a:tabLst/>
+              <a:defRPr/>
+            </a:pPr>
+            <a:fld id="{B7EB45DA-9A0D-DC49-8E02-F30A5DDC21C3}" type="slidenum">
+              <a:rPr kumimoji="0" lang="en-US" sz="1200" b="0" i="0" u="none" strike="noStrike" kern="1200" cap="none" spc="0" normalizeH="0" baseline="0" noProof="0" smtClean="0">
+                <a:ln>
+                  <a:noFill/>
+                </a:ln>
+                <a:solidFill>
+                  <a:srgbClr val="000000">
+                    <a:tint val="75000"/>
+                  </a:srgbClr>
+                </a:solidFill>
+                <a:effectLst/>
+                <a:uLnTx/>
+                <a:uFillTx/>
+                <a:latin typeface="Calibri" panose="020F0502020204030204"/>
+                <a:ea typeface="+mn-ea"/>
+                <a:cs typeface="+mn-cs"/>
+              </a:rPr>
+              <a:pPr marL="0" marR="0" lvl="0" indent="0" algn="r" defTabSz="457200" rtl="0" eaLnBrk="1" fontAlgn="auto" latinLnBrk="0" hangingPunct="1">
+                <a:lnSpc>
+                  <a:spcPct val="100000"/>
+                </a:lnSpc>
+                <a:spcBef>
+                  <a:spcPts val="0"/>
+                </a:spcBef>
+                <a:spcAft>
+                  <a:spcPts val="0"/>
+                </a:spcAft>
+                <a:buClrTx/>
+                <a:buSzTx/>
+                <a:buFontTx/>
+                <a:buNone/>
+                <a:tabLst/>
+                <a:defRPr/>
+              </a:pPr>
+              <a:t>5</a:t>
+            </a:fld>
+            <a:endParaRPr kumimoji="0" lang="en-US" sz="1200" b="0" i="0" u="none" strike="noStrike" kern="1200" cap="none" spc="0" normalizeH="0" baseline="0" noProof="0">
+              <a:ln>
+                <a:noFill/>
+              </a:ln>
+              <a:solidFill>
+                <a:srgbClr val="000000">
+                  <a:tint val="75000"/>
+                </a:srgbClr>
+              </a:solidFill>
+              <a:effectLst/>
+              <a:uLnTx/>
+              <a:uFillTx/>
+              <a:latin typeface="Calibri" panose="020F0502020204030204"/>
+              <a:ea typeface="+mn-ea"/>
+              <a:cs typeface="+mn-cs"/>
+            </a:endParaRPr>
+          </a:p>
+        </p:txBody>
+      </p:sp>
+      <p:sp>
+        <p:nvSpPr>
+          <p:cNvPr id="101" name="Question"/>
+          <p:cNvSpPr txBox="1"/>
+          <p:nvPr/>
+        </p:nvSpPr>
+        <p:spPr>
+          <a:xfrm>
+            <a:off x="685800" y="2798064"/>
+            <a:ext cx="7772400" cy="475488"/>
+          </a:xfrm>
+          <a:prstGeom prst="rect">
+            <a:avLst/>
+          </a:prstGeom>
+          <a:noFill/>
+          <a:ln>
+            <a:noFill/>
+          </a:ln>
+        </p:spPr>
+        <p:txBody>
+          <a:bodyPr wrap="square" lIns="0" tIns="0" rIns="0" bIns="0" anchor="t"/>
+          <a:lstStyle/>
+          <a:p>
+            <a:pPr marL="0" marR="0" lvl="0" indent="0" algn="ctr" defTabSz="457200" rtl="0" eaLnBrk="1" fontAlgn="auto" latinLnBrk="0" hangingPunct="1">
+              <a:lnSpc>
+                <a:spcPct val="100000"/>
+              </a:lnSpc>
+              <a:spcBef>
+                <a:spcPts val="0"/>
+              </a:spcBef>
+              <a:spcAft>
+                <a:spcPts val="0"/>
+              </a:spcAft>
+              <a:buClrTx/>
+              <a:buSzTx/>
+              <a:buFontTx/>
+              <a:buNone/>
+              <a:tabLst/>
+              <a:defRPr/>
+            </a:pPr>
+            <a:r>
+              <a:rPr kumimoji="0" lang="en-US" sz="2400" b="0" i="0" u="none" strike="noStrike" kern="1200" cap="none" spc="0" normalizeH="0" baseline="0" noProof="0" dirty="0">
+                <a:ln>
+                  <a:noFill/>
+                </a:ln>
+                <a:solidFill>
+                  <a:srgbClr val="5C4826"/>
+                </a:solidFill>
+                <a:effectLst/>
+                <a:uLnTx/>
+                <a:uFillTx/>
+                <a:latin typeface="Calibri" panose="020F0502020204030204"/>
+                <a:ea typeface="+mn-ea"/>
+                <a:cs typeface="+mn-cs"/>
+              </a:rPr>
+              <a:t>How do you decide whether it did what you wanted?</a:t>
+            </a:r>
+          </a:p>
+        </p:txBody>
+      </p:sp>
+      <p:sp>
+        <p:nvSpPr>
+          <p:cNvPr id="103" name="Rule"/>
+          <p:cNvSpPr/>
+          <p:nvPr/>
+        </p:nvSpPr>
+        <p:spPr>
+          <a:xfrm>
+            <a:off x="3429000" y="3584448"/>
+            <a:ext cx="2286000" cy="51206"/>
+          </a:xfrm>
+          <a:prstGeom prst="rect">
+            <a:avLst/>
+          </a:prstGeom>
+          <a:solidFill>
+            <a:srgbClr val="8E6F3E"/>
+          </a:solidFill>
+          <a:ln>
+            <a:noFill/>
+          </a:ln>
+        </p:spPr>
+        <p:txBody>
+          <a:bodyPr wrap="square" lIns="27432" tIns="22860" rIns="27432" bIns="22860" anchor="ctr"/>
+          <a:lstStyle/>
+          <a:p>
+            <a:pPr marL="0" marR="0" lvl="0" indent="0" algn="l" defTabSz="457200" rtl="0" eaLnBrk="1" fontAlgn="auto" latinLnBrk="0" hangingPunct="1">
+              <a:lnSpc>
+                <a:spcPct val="100000"/>
+              </a:lnSpc>
+              <a:spcBef>
+                <a:spcPts val="0"/>
+              </a:spcBef>
+              <a:spcAft>
+                <a:spcPts val="0"/>
+              </a:spcAft>
+              <a:buClrTx/>
+              <a:buSzTx/>
+              <a:buFontTx/>
+              <a:buNone/>
+              <a:tabLst/>
+              <a:defRPr/>
+            </a:pPr>
+            <a:endParaRPr kumimoji="0" lang="en-US" sz="1800" b="0" i="0" u="none" strike="noStrike" kern="1200" cap="none" spc="0" normalizeH="0" baseline="0" noProof="0">
+              <a:ln>
+                <a:noFill/>
+              </a:ln>
+              <a:solidFill>
+                <a:srgbClr val="000000"/>
+              </a:solidFill>
+              <a:effectLst/>
+              <a:uLnTx/>
+              <a:uFillTx/>
+              <a:latin typeface="Calibri" panose="020F0502020204030204"/>
+              <a:ea typeface="+mn-ea"/>
+              <a:cs typeface="+mn-cs"/>
+            </a:endParaRPr>
+          </a:p>
+        </p:txBody>
+      </p:sp>
+    </p:spTree>
+  </p:cSld>
+  <p:clrMapOvr>
+    <a:masterClrMapping/>
+  </p:clrMapOvr>
+</p:sld>
+</file>
+
 <file path=ppt/slides/slide3.xml><?xml version="1.0" encoding="utf-8"?>
 <p:sld xmlns:a="http://schemas.openxmlformats.org/drawingml/2006/main" xmlns:p="http://schemas.openxmlformats.org/presentationml/2006/main" xmlns:r="http://schemas.openxmlformats.org/officeDocument/2006/relationships">
   <p:cSld>
@@ -17757,6 +18419,1318 @@
               </a:rPr>
               <a:t>to the control problem of Delegation.</a:t>
             </a:r>
+          </a:p>
+        </p:txBody>
+      </p:sp>
+    </p:spTree>
+  </p:cSld>
+  <p:clrMapOvr>
+    <a:masterClrMapping/>
+  </p:clrMapOvr>
+</p:sld>
+</file>
+
+<file path=ppt/slides/slide30.xml><?xml version="1.0" encoding="utf-8"?>
+<p:sld xmlns:a="http://schemas.openxmlformats.org/drawingml/2006/main" xmlns:r="http://schemas.openxmlformats.org/officeDocument/2006/relationships" xmlns:p="http://schemas.openxmlformats.org/presentationml/2006/main">
+  <p:cSld>
+    <p:spTree>
+      <p:nvGrpSpPr>
+        <p:cNvPr id="1" name=""/>
+        <p:cNvGrpSpPr/>
+        <p:nvPr/>
+      </p:nvGrpSpPr>
+      <p:grpSpPr>
+        <a:xfrm>
+          <a:off x="0" y="0"/>
+          <a:ext cx="0" cy="0"/>
+          <a:chOff x="0" y="0"/>
+          <a:chExt cx="0" cy="0"/>
+        </a:xfrm>
+      </p:grpSpPr>
+      <p:sp>
+        <p:nvSpPr>
+          <p:cNvPr id="100" name="SectionLabel"/>
+          <p:cNvSpPr txBox="1"/>
+          <p:nvPr/>
+        </p:nvSpPr>
+        <p:spPr>
+          <a:xfrm>
+            <a:off x="685800" y="1243584"/>
+            <a:ext cx="7772400" cy="365760"/>
+          </a:xfrm>
+          <a:prstGeom prst="rect">
+            <a:avLst/>
+          </a:prstGeom>
+          <a:noFill/>
+          <a:ln>
+            <a:noFill/>
+          </a:ln>
+        </p:spPr>
+        <p:txBody>
+          <a:bodyPr wrap="square" lIns="0" tIns="0" rIns="0" bIns="0" anchor="t"/>
+          <a:lstStyle/>
+          <a:p>
+            <a:pPr marL="0" marR="0" lvl="0" indent="0" algn="ctr" defTabSz="457200" rtl="0" eaLnBrk="1" fontAlgn="auto" latinLnBrk="0" hangingPunct="1">
+              <a:lnSpc>
+                <a:spcPct val="100000"/>
+              </a:lnSpc>
+              <a:spcBef>
+                <a:spcPts val="0"/>
+              </a:spcBef>
+              <a:spcAft>
+                <a:spcPts val="0"/>
+              </a:spcAft>
+              <a:buClrTx/>
+              <a:buSzTx/>
+              <a:buFontTx/>
+              <a:buNone/>
+              <a:tabLst/>
+              <a:defRPr/>
+            </a:pPr>
+            <a:r>
+              <a:rPr kumimoji="0" lang="en-US" sz="2000" b="1" i="0" u="none" strike="noStrike" kern="1200" cap="none" spc="0" normalizeH="0" baseline="0" noProof="0" dirty="0">
+                <a:ln>
+                  <a:noFill/>
+                </a:ln>
+                <a:solidFill>
+                  <a:srgbClr val="8E6F3E"/>
+                </a:solidFill>
+                <a:effectLst/>
+                <a:uLnTx/>
+                <a:uFillTx/>
+                <a:latin typeface="Calibri" panose="020F0502020204030204"/>
+                <a:ea typeface="+mn-ea"/>
+                <a:cs typeface="+mn-cs"/>
+              </a:rPr>
+              <a:t>SECTION 2</a:t>
+            </a:r>
+          </a:p>
+        </p:txBody>
+      </p:sp>
+      <p:sp>
+        <p:nvSpPr>
+          <p:cNvPr id="2" name="Title 1"/>
+          <p:cNvSpPr>
+            <a:spLocks noGrp="1"/>
+          </p:cNvSpPr>
+          <p:nvPr>
+            <p:ph type="title"/>
+          </p:nvPr>
+        </p:nvSpPr>
+        <p:spPr>
+          <a:xfrm>
+            <a:off x="685800" y="1700784"/>
+            <a:ext cx="7772400" cy="1005840"/>
+          </a:xfrm>
+        </p:spPr>
+        <p:txBody>
+          <a:bodyPr>
+            <a:normAutofit/>
+          </a:bodyPr>
+          <a:lstStyle/>
+          <a:p>
+            <a:pPr algn="ctr">
+              <a:buNone/>
+              <a:defRPr b="0"/>
+            </a:pPr>
+            <a:r>
+              <a:rPr lang="en-US" sz="4000" b="0" i="0" dirty="0">
+                <a:solidFill>
+                  <a:srgbClr val="000000"/>
+                </a:solidFill>
+              </a:rPr>
+              <a:t>From evidence to authority</a:t>
+            </a:r>
+          </a:p>
+        </p:txBody>
+      </p:sp>
+      <p:sp>
+        <p:nvSpPr>
+          <p:cNvPr id="3" name="Slide Number Placeholder 3"/>
+          <p:cNvSpPr>
+            <a:spLocks noGrp="1"/>
+          </p:cNvSpPr>
+          <p:nvPr>
+            <p:ph type="sldNum" sz="quarter" idx="4"/>
+          </p:nvPr>
+        </p:nvSpPr>
+        <p:spPr/>
+        <p:txBody>
+          <a:bodyPr/>
+          <a:lstStyle/>
+          <a:p>
+            <a:pPr marL="0" marR="0" lvl="0" indent="0" algn="r" defTabSz="457200" rtl="0" eaLnBrk="1" fontAlgn="auto" latinLnBrk="0" hangingPunct="1">
+              <a:lnSpc>
+                <a:spcPct val="100000"/>
+              </a:lnSpc>
+              <a:spcBef>
+                <a:spcPts val="0"/>
+              </a:spcBef>
+              <a:spcAft>
+                <a:spcPts val="0"/>
+              </a:spcAft>
+              <a:buClrTx/>
+              <a:buSzTx/>
+              <a:buFontTx/>
+              <a:buNone/>
+              <a:tabLst/>
+              <a:defRPr/>
+            </a:pPr>
+            <a:fld id="{B7EB45DA-9A0D-DC49-8E02-F30A5DDC21C3}" type="slidenum">
+              <a:rPr kumimoji="0" lang="en-US" sz="1200" b="0" i="0" u="none" strike="noStrike" kern="1200" cap="none" spc="0" normalizeH="0" baseline="0" noProof="0" smtClean="0">
+                <a:ln>
+                  <a:noFill/>
+                </a:ln>
+                <a:solidFill>
+                  <a:srgbClr val="000000">
+                    <a:tint val="75000"/>
+                  </a:srgbClr>
+                </a:solidFill>
+                <a:effectLst/>
+                <a:uLnTx/>
+                <a:uFillTx/>
+                <a:latin typeface="Calibri" panose="020F0502020204030204"/>
+                <a:ea typeface="+mn-ea"/>
+                <a:cs typeface="+mn-cs"/>
+              </a:rPr>
+              <a:pPr marL="0" marR="0" lvl="0" indent="0" algn="r" defTabSz="457200" rtl="0" eaLnBrk="1" fontAlgn="auto" latinLnBrk="0" hangingPunct="1">
+                <a:lnSpc>
+                  <a:spcPct val="100000"/>
+                </a:lnSpc>
+                <a:spcBef>
+                  <a:spcPts val="0"/>
+                </a:spcBef>
+                <a:spcAft>
+                  <a:spcPts val="0"/>
+                </a:spcAft>
+                <a:buClrTx/>
+                <a:buSzTx/>
+                <a:buFontTx/>
+                <a:buNone/>
+                <a:tabLst/>
+                <a:defRPr/>
+              </a:pPr>
+              <a:t>10</a:t>
+            </a:fld>
+            <a:endParaRPr kumimoji="0" lang="en-US" sz="1200" b="0" i="0" u="none" strike="noStrike" kern="1200" cap="none" spc="0" normalizeH="0" baseline="0" noProof="0">
+              <a:ln>
+                <a:noFill/>
+              </a:ln>
+              <a:solidFill>
+                <a:srgbClr val="000000">
+                  <a:tint val="75000"/>
+                </a:srgbClr>
+              </a:solidFill>
+              <a:effectLst/>
+              <a:uLnTx/>
+              <a:uFillTx/>
+              <a:latin typeface="Calibri" panose="020F0502020204030204"/>
+              <a:ea typeface="+mn-ea"/>
+              <a:cs typeface="+mn-cs"/>
+            </a:endParaRPr>
+          </a:p>
+        </p:txBody>
+      </p:sp>
+      <p:sp>
+        <p:nvSpPr>
+          <p:cNvPr id="101" name="Question"/>
+          <p:cNvSpPr txBox="1"/>
+          <p:nvPr/>
+        </p:nvSpPr>
+        <p:spPr>
+          <a:xfrm>
+            <a:off x="685800" y="2798064"/>
+            <a:ext cx="7772400" cy="475488"/>
+          </a:xfrm>
+          <a:prstGeom prst="rect">
+            <a:avLst/>
+          </a:prstGeom>
+          <a:noFill/>
+          <a:ln>
+            <a:noFill/>
+          </a:ln>
+        </p:spPr>
+        <p:txBody>
+          <a:bodyPr wrap="square" lIns="0" tIns="0" rIns="0" bIns="0" anchor="t"/>
+          <a:lstStyle/>
+          <a:p>
+            <a:pPr marL="0" marR="0" lvl="0" indent="0" algn="ctr" defTabSz="457200" rtl="0" eaLnBrk="1" fontAlgn="auto" latinLnBrk="0" hangingPunct="1">
+              <a:lnSpc>
+                <a:spcPct val="100000"/>
+              </a:lnSpc>
+              <a:spcBef>
+                <a:spcPts val="0"/>
+              </a:spcBef>
+              <a:spcAft>
+                <a:spcPts val="0"/>
+              </a:spcAft>
+              <a:buClrTx/>
+              <a:buSzTx/>
+              <a:buFontTx/>
+              <a:buNone/>
+              <a:tabLst/>
+              <a:defRPr/>
+            </a:pPr>
+            <a:r>
+              <a:rPr kumimoji="0" lang="en-US" sz="2400" b="0" i="0" u="none" strike="noStrike" kern="1200" cap="none" spc="0" normalizeH="0" baseline="0" noProof="0" dirty="0">
+                <a:ln>
+                  <a:noFill/>
+                </a:ln>
+                <a:solidFill>
+                  <a:srgbClr val="5C4826"/>
+                </a:solidFill>
+                <a:effectLst/>
+                <a:uLnTx/>
+                <a:uFillTx/>
+                <a:latin typeface="Calibri" panose="020F0502020204030204"/>
+                <a:ea typeface="+mn-ea"/>
+                <a:cs typeface="+mn-cs"/>
+              </a:rPr>
+              <a:t>When should a failed check have consequences?</a:t>
+            </a:r>
+          </a:p>
+        </p:txBody>
+      </p:sp>
+      <p:sp>
+        <p:nvSpPr>
+          <p:cNvPr id="103" name="Rule"/>
+          <p:cNvSpPr/>
+          <p:nvPr/>
+        </p:nvSpPr>
+        <p:spPr>
+          <a:xfrm>
+            <a:off x="3429000" y="3584448"/>
+            <a:ext cx="2286000" cy="51206"/>
+          </a:xfrm>
+          <a:prstGeom prst="rect">
+            <a:avLst/>
+          </a:prstGeom>
+          <a:solidFill>
+            <a:srgbClr val="8E6F3E"/>
+          </a:solidFill>
+          <a:ln>
+            <a:noFill/>
+          </a:ln>
+        </p:spPr>
+        <p:txBody>
+          <a:bodyPr wrap="square" lIns="27432" tIns="22860" rIns="27432" bIns="22860" anchor="ctr"/>
+          <a:lstStyle/>
+          <a:p>
+            <a:pPr marL="0" marR="0" lvl="0" indent="0" algn="l" defTabSz="457200" rtl="0" eaLnBrk="1" fontAlgn="auto" latinLnBrk="0" hangingPunct="1">
+              <a:lnSpc>
+                <a:spcPct val="100000"/>
+              </a:lnSpc>
+              <a:spcBef>
+                <a:spcPts val="0"/>
+              </a:spcBef>
+              <a:spcAft>
+                <a:spcPts val="0"/>
+              </a:spcAft>
+              <a:buClrTx/>
+              <a:buSzTx/>
+              <a:buFontTx/>
+              <a:buNone/>
+              <a:tabLst/>
+              <a:defRPr/>
+            </a:pPr>
+            <a:endParaRPr kumimoji="0" lang="en-US" sz="1800" b="0" i="0" u="none" strike="noStrike" kern="1200" cap="none" spc="0" normalizeH="0" baseline="0" noProof="0">
+              <a:ln>
+                <a:noFill/>
+              </a:ln>
+              <a:solidFill>
+                <a:srgbClr val="000000"/>
+              </a:solidFill>
+              <a:effectLst/>
+              <a:uLnTx/>
+              <a:uFillTx/>
+              <a:latin typeface="Calibri" panose="020F0502020204030204"/>
+              <a:ea typeface="+mn-ea"/>
+              <a:cs typeface="+mn-cs"/>
+            </a:endParaRPr>
+          </a:p>
+        </p:txBody>
+      </p:sp>
+    </p:spTree>
+  </p:cSld>
+  <p:clrMapOvr>
+    <a:masterClrMapping/>
+  </p:clrMapOvr>
+</p:sld>
+</file>
+
+<file path=ppt/slides/slide31.xml><?xml version="1.0" encoding="utf-8"?>
+<p:sld xmlns:a="http://schemas.openxmlformats.org/drawingml/2006/main" xmlns:r="http://schemas.openxmlformats.org/officeDocument/2006/relationships" xmlns:p="http://schemas.openxmlformats.org/presentationml/2006/main">
+  <p:cSld>
+    <p:spTree>
+      <p:nvGrpSpPr>
+        <p:cNvPr id="1" name=""/>
+        <p:cNvGrpSpPr/>
+        <p:nvPr/>
+      </p:nvGrpSpPr>
+      <p:grpSpPr>
+        <a:xfrm>
+          <a:off x="0" y="0"/>
+          <a:ext cx="0" cy="0"/>
+          <a:chOff x="0" y="0"/>
+          <a:chExt cx="0" cy="0"/>
+        </a:xfrm>
+      </p:grpSpPr>
+      <p:sp>
+        <p:nvSpPr>
+          <p:cNvPr id="100" name="SectionLabel"/>
+          <p:cNvSpPr txBox="1"/>
+          <p:nvPr/>
+        </p:nvSpPr>
+        <p:spPr>
+          <a:xfrm>
+            <a:off x="685800" y="1243584"/>
+            <a:ext cx="7772400" cy="365760"/>
+          </a:xfrm>
+          <a:prstGeom prst="rect">
+            <a:avLst/>
+          </a:prstGeom>
+          <a:noFill/>
+          <a:ln>
+            <a:noFill/>
+          </a:ln>
+        </p:spPr>
+        <p:txBody>
+          <a:bodyPr wrap="square" lIns="0" tIns="0" rIns="0" bIns="0" anchor="t"/>
+          <a:lstStyle/>
+          <a:p>
+            <a:pPr marL="0" marR="0" lvl="0" indent="0" algn="ctr" defTabSz="457200" rtl="0" eaLnBrk="1" fontAlgn="auto" latinLnBrk="0" hangingPunct="1">
+              <a:lnSpc>
+                <a:spcPct val="100000"/>
+              </a:lnSpc>
+              <a:spcBef>
+                <a:spcPts val="0"/>
+              </a:spcBef>
+              <a:spcAft>
+                <a:spcPts val="0"/>
+              </a:spcAft>
+              <a:buClrTx/>
+              <a:buSzTx/>
+              <a:buFontTx/>
+              <a:buNone/>
+              <a:tabLst/>
+              <a:defRPr/>
+            </a:pPr>
+            <a:r>
+              <a:rPr kumimoji="0" lang="en-US" sz="2000" b="1" i="0" u="none" strike="noStrike" kern="1200" cap="none" spc="0" normalizeH="0" baseline="0" noProof="0" dirty="0">
+                <a:ln>
+                  <a:noFill/>
+                </a:ln>
+                <a:solidFill>
+                  <a:srgbClr val="8E6F3E"/>
+                </a:solidFill>
+                <a:effectLst/>
+                <a:uLnTx/>
+                <a:uFillTx/>
+                <a:latin typeface="Calibri" panose="020F0502020204030204"/>
+                <a:ea typeface="+mn-ea"/>
+                <a:cs typeface="+mn-cs"/>
+              </a:rPr>
+              <a:t>SECTION 3</a:t>
+            </a:r>
+          </a:p>
+        </p:txBody>
+      </p:sp>
+      <p:sp>
+        <p:nvSpPr>
+          <p:cNvPr id="2" name="Title 1"/>
+          <p:cNvSpPr>
+            <a:spLocks noGrp="1"/>
+          </p:cNvSpPr>
+          <p:nvPr>
+            <p:ph type="title"/>
+          </p:nvPr>
+        </p:nvSpPr>
+        <p:spPr>
+          <a:xfrm>
+            <a:off x="685800" y="1700784"/>
+            <a:ext cx="7772400" cy="1005840"/>
+          </a:xfrm>
+        </p:spPr>
+        <p:txBody>
+          <a:bodyPr>
+            <a:normAutofit/>
+          </a:bodyPr>
+          <a:lstStyle/>
+          <a:p>
+            <a:pPr algn="ctr">
+              <a:buNone/>
+              <a:defRPr b="0"/>
+            </a:pPr>
+            <a:r>
+              <a:rPr lang="en-US" sz="4000" b="0" i="0" dirty="0">
+                <a:solidFill>
+                  <a:srgbClr val="000000"/>
+                </a:solidFill>
+              </a:rPr>
+              <a:t>Check it where you can know</a:t>
+            </a:r>
+          </a:p>
+        </p:txBody>
+      </p:sp>
+      <p:sp>
+        <p:nvSpPr>
+          <p:cNvPr id="3" name="Slide Number Placeholder 3"/>
+          <p:cNvSpPr>
+            <a:spLocks noGrp="1"/>
+          </p:cNvSpPr>
+          <p:nvPr>
+            <p:ph type="sldNum" sz="quarter" idx="4"/>
+          </p:nvPr>
+        </p:nvSpPr>
+        <p:spPr/>
+        <p:txBody>
+          <a:bodyPr/>
+          <a:lstStyle/>
+          <a:p>
+            <a:pPr marL="0" marR="0" lvl="0" indent="0" algn="r" defTabSz="457200" rtl="0" eaLnBrk="1" fontAlgn="auto" latinLnBrk="0" hangingPunct="1">
+              <a:lnSpc>
+                <a:spcPct val="100000"/>
+              </a:lnSpc>
+              <a:spcBef>
+                <a:spcPts val="0"/>
+              </a:spcBef>
+              <a:spcAft>
+                <a:spcPts val="0"/>
+              </a:spcAft>
+              <a:buClrTx/>
+              <a:buSzTx/>
+              <a:buFontTx/>
+              <a:buNone/>
+              <a:tabLst/>
+              <a:defRPr/>
+            </a:pPr>
+            <a:fld id="{B7EB45DA-9A0D-DC49-8E02-F30A5DDC21C3}" type="slidenum">
+              <a:rPr kumimoji="0" lang="en-US" sz="1200" b="0" i="0" u="none" strike="noStrike" kern="1200" cap="none" spc="0" normalizeH="0" baseline="0" noProof="0" smtClean="0">
+                <a:ln>
+                  <a:noFill/>
+                </a:ln>
+                <a:solidFill>
+                  <a:srgbClr val="000000">
+                    <a:tint val="75000"/>
+                  </a:srgbClr>
+                </a:solidFill>
+                <a:effectLst/>
+                <a:uLnTx/>
+                <a:uFillTx/>
+                <a:latin typeface="Calibri" panose="020F0502020204030204"/>
+                <a:ea typeface="+mn-ea"/>
+                <a:cs typeface="+mn-cs"/>
+              </a:rPr>
+              <a:pPr marL="0" marR="0" lvl="0" indent="0" algn="r" defTabSz="457200" rtl="0" eaLnBrk="1" fontAlgn="auto" latinLnBrk="0" hangingPunct="1">
+                <a:lnSpc>
+                  <a:spcPct val="100000"/>
+                </a:lnSpc>
+                <a:spcBef>
+                  <a:spcPts val="0"/>
+                </a:spcBef>
+                <a:spcAft>
+                  <a:spcPts val="0"/>
+                </a:spcAft>
+                <a:buClrTx/>
+                <a:buSzTx/>
+                <a:buFontTx/>
+                <a:buNone/>
+                <a:tabLst/>
+                <a:defRPr/>
+              </a:pPr>
+              <a:t>17</a:t>
+            </a:fld>
+            <a:endParaRPr kumimoji="0" lang="en-US" sz="1200" b="0" i="0" u="none" strike="noStrike" kern="1200" cap="none" spc="0" normalizeH="0" baseline="0" noProof="0">
+              <a:ln>
+                <a:noFill/>
+              </a:ln>
+              <a:solidFill>
+                <a:srgbClr val="000000">
+                  <a:tint val="75000"/>
+                </a:srgbClr>
+              </a:solidFill>
+              <a:effectLst/>
+              <a:uLnTx/>
+              <a:uFillTx/>
+              <a:latin typeface="Calibri" panose="020F0502020204030204"/>
+              <a:ea typeface="+mn-ea"/>
+              <a:cs typeface="+mn-cs"/>
+            </a:endParaRPr>
+          </a:p>
+        </p:txBody>
+      </p:sp>
+      <p:sp>
+        <p:nvSpPr>
+          <p:cNvPr id="101" name="Question"/>
+          <p:cNvSpPr txBox="1"/>
+          <p:nvPr/>
+        </p:nvSpPr>
+        <p:spPr>
+          <a:xfrm>
+            <a:off x="685800" y="2798064"/>
+            <a:ext cx="7772400" cy="475488"/>
+          </a:xfrm>
+          <a:prstGeom prst="rect">
+            <a:avLst/>
+          </a:prstGeom>
+          <a:noFill/>
+          <a:ln>
+            <a:noFill/>
+          </a:ln>
+        </p:spPr>
+        <p:txBody>
+          <a:bodyPr wrap="square" lIns="0" tIns="0" rIns="0" bIns="0" anchor="t"/>
+          <a:lstStyle/>
+          <a:p>
+            <a:pPr marL="0" marR="0" lvl="0" indent="0" algn="ctr" defTabSz="457200" rtl="0" eaLnBrk="1" fontAlgn="auto" latinLnBrk="0" hangingPunct="1">
+              <a:lnSpc>
+                <a:spcPct val="100000"/>
+              </a:lnSpc>
+              <a:spcBef>
+                <a:spcPts val="0"/>
+              </a:spcBef>
+              <a:spcAft>
+                <a:spcPts val="0"/>
+              </a:spcAft>
+              <a:buClrTx/>
+              <a:buSzTx/>
+              <a:buFontTx/>
+              <a:buNone/>
+              <a:tabLst/>
+              <a:defRPr/>
+            </a:pPr>
+            <a:r>
+              <a:rPr kumimoji="0" lang="en-US" sz="2400" b="0" i="0" u="none" strike="noStrike" kern="1200" cap="none" spc="0" normalizeH="0" baseline="0" noProof="0" dirty="0">
+                <a:ln>
+                  <a:noFill/>
+                </a:ln>
+                <a:solidFill>
+                  <a:srgbClr val="5C4826"/>
+                </a:solidFill>
+                <a:effectLst/>
+                <a:uLnTx/>
+                <a:uFillTx/>
+                <a:latin typeface="Calibri" panose="020F0502020204030204"/>
+                <a:ea typeface="+mn-ea"/>
+                <a:cs typeface="+mn-cs"/>
+              </a:rPr>
+              <a:t>Where can each obligation actually be decided?</a:t>
+            </a:r>
+          </a:p>
+        </p:txBody>
+      </p:sp>
+      <p:sp>
+        <p:nvSpPr>
+          <p:cNvPr id="103" name="Rule"/>
+          <p:cNvSpPr/>
+          <p:nvPr/>
+        </p:nvSpPr>
+        <p:spPr>
+          <a:xfrm>
+            <a:off x="3429000" y="3584448"/>
+            <a:ext cx="2286000" cy="51206"/>
+          </a:xfrm>
+          <a:prstGeom prst="rect">
+            <a:avLst/>
+          </a:prstGeom>
+          <a:solidFill>
+            <a:srgbClr val="8E6F3E"/>
+          </a:solidFill>
+          <a:ln>
+            <a:noFill/>
+          </a:ln>
+        </p:spPr>
+        <p:txBody>
+          <a:bodyPr wrap="square" lIns="27432" tIns="22860" rIns="27432" bIns="22860" anchor="ctr"/>
+          <a:lstStyle/>
+          <a:p>
+            <a:pPr marL="0" marR="0" lvl="0" indent="0" algn="l" defTabSz="457200" rtl="0" eaLnBrk="1" fontAlgn="auto" latinLnBrk="0" hangingPunct="1">
+              <a:lnSpc>
+                <a:spcPct val="100000"/>
+              </a:lnSpc>
+              <a:spcBef>
+                <a:spcPts val="0"/>
+              </a:spcBef>
+              <a:spcAft>
+                <a:spcPts val="0"/>
+              </a:spcAft>
+              <a:buClrTx/>
+              <a:buSzTx/>
+              <a:buFontTx/>
+              <a:buNone/>
+              <a:tabLst/>
+              <a:defRPr/>
+            </a:pPr>
+            <a:endParaRPr kumimoji="0" lang="en-US" sz="1800" b="0" i="0" u="none" strike="noStrike" kern="1200" cap="none" spc="0" normalizeH="0" baseline="0" noProof="0">
+              <a:ln>
+                <a:noFill/>
+              </a:ln>
+              <a:solidFill>
+                <a:srgbClr val="000000"/>
+              </a:solidFill>
+              <a:effectLst/>
+              <a:uLnTx/>
+              <a:uFillTx/>
+              <a:latin typeface="Calibri" panose="020F0502020204030204"/>
+              <a:ea typeface="+mn-ea"/>
+              <a:cs typeface="+mn-cs"/>
+            </a:endParaRPr>
+          </a:p>
+        </p:txBody>
+      </p:sp>
+    </p:spTree>
+  </p:cSld>
+  <p:clrMapOvr>
+    <a:masterClrMapping/>
+  </p:clrMapOvr>
+</p:sld>
+</file>
+
+<file path=ppt/slides/slide32.xml><?xml version="1.0" encoding="utf-8"?>
+<p:sld xmlns:a="http://schemas.openxmlformats.org/drawingml/2006/main" xmlns:r="http://schemas.openxmlformats.org/officeDocument/2006/relationships" xmlns:p="http://schemas.openxmlformats.org/presentationml/2006/main">
+  <p:cSld>
+    <p:spTree>
+      <p:nvGrpSpPr>
+        <p:cNvPr id="1" name=""/>
+        <p:cNvGrpSpPr/>
+        <p:nvPr/>
+      </p:nvGrpSpPr>
+      <p:grpSpPr>
+        <a:xfrm>
+          <a:off x="0" y="0"/>
+          <a:ext cx="0" cy="0"/>
+          <a:chOff x="0" y="0"/>
+          <a:chExt cx="0" cy="0"/>
+        </a:xfrm>
+      </p:grpSpPr>
+      <p:sp>
+        <p:nvSpPr>
+          <p:cNvPr id="100" name="SectionLabel"/>
+          <p:cNvSpPr txBox="1"/>
+          <p:nvPr/>
+        </p:nvSpPr>
+        <p:spPr>
+          <a:xfrm>
+            <a:off x="685800" y="1243584"/>
+            <a:ext cx="7772400" cy="365760"/>
+          </a:xfrm>
+          <a:prstGeom prst="rect">
+            <a:avLst/>
+          </a:prstGeom>
+          <a:noFill/>
+          <a:ln>
+            <a:noFill/>
+          </a:ln>
+        </p:spPr>
+        <p:txBody>
+          <a:bodyPr wrap="square" lIns="0" tIns="0" rIns="0" bIns="0" anchor="t"/>
+          <a:lstStyle/>
+          <a:p>
+            <a:pPr marL="0" marR="0" lvl="0" indent="0" algn="ctr" defTabSz="457200" rtl="0" eaLnBrk="1" fontAlgn="auto" latinLnBrk="0" hangingPunct="1">
+              <a:lnSpc>
+                <a:spcPct val="100000"/>
+              </a:lnSpc>
+              <a:spcBef>
+                <a:spcPts val="0"/>
+              </a:spcBef>
+              <a:spcAft>
+                <a:spcPts val="0"/>
+              </a:spcAft>
+              <a:buClrTx/>
+              <a:buSzTx/>
+              <a:buFontTx/>
+              <a:buNone/>
+              <a:tabLst/>
+              <a:defRPr/>
+            </a:pPr>
+            <a:r>
+              <a:rPr kumimoji="0" lang="en-US" sz="2000" b="1" i="0" u="none" strike="noStrike" kern="1200" cap="none" spc="0" normalizeH="0" baseline="0" noProof="0" dirty="0">
+                <a:ln>
+                  <a:noFill/>
+                </a:ln>
+                <a:solidFill>
+                  <a:srgbClr val="8E6F3E"/>
+                </a:solidFill>
+                <a:effectLst/>
+                <a:uLnTx/>
+                <a:uFillTx/>
+                <a:latin typeface="Calibri" panose="020F0502020204030204"/>
+                <a:ea typeface="+mn-ea"/>
+                <a:cs typeface="+mn-cs"/>
+              </a:rPr>
+              <a:t>SECTION 4</a:t>
+            </a:r>
+          </a:p>
+        </p:txBody>
+      </p:sp>
+      <p:sp>
+        <p:nvSpPr>
+          <p:cNvPr id="2" name="Title 1"/>
+          <p:cNvSpPr>
+            <a:spLocks noGrp="1"/>
+          </p:cNvSpPr>
+          <p:nvPr>
+            <p:ph type="title"/>
+          </p:nvPr>
+        </p:nvSpPr>
+        <p:spPr>
+          <a:xfrm>
+            <a:off x="685800" y="1700784"/>
+            <a:ext cx="7772400" cy="1005840"/>
+          </a:xfrm>
+        </p:spPr>
+        <p:txBody>
+          <a:bodyPr>
+            <a:normAutofit/>
+          </a:bodyPr>
+          <a:lstStyle/>
+          <a:p>
+            <a:pPr algn="ctr">
+              <a:buNone/>
+              <a:defRPr b="0"/>
+            </a:pPr>
+            <a:r>
+              <a:rPr lang="en-US" sz="4000" b="0" i="0" dirty="0">
+                <a:solidFill>
+                  <a:srgbClr val="000000"/>
+                </a:solidFill>
+              </a:rPr>
+              <a:t>Design the Alignment</a:t>
+            </a:r>
+          </a:p>
+        </p:txBody>
+      </p:sp>
+      <p:sp>
+        <p:nvSpPr>
+          <p:cNvPr id="3" name="Slide Number Placeholder 3"/>
+          <p:cNvSpPr>
+            <a:spLocks noGrp="1"/>
+          </p:cNvSpPr>
+          <p:nvPr>
+            <p:ph type="sldNum" sz="quarter" idx="4"/>
+          </p:nvPr>
+        </p:nvSpPr>
+        <p:spPr/>
+        <p:txBody>
+          <a:bodyPr/>
+          <a:lstStyle/>
+          <a:p>
+            <a:pPr marL="0" marR="0" lvl="0" indent="0" algn="r" defTabSz="457200" rtl="0" eaLnBrk="1" fontAlgn="auto" latinLnBrk="0" hangingPunct="1">
+              <a:lnSpc>
+                <a:spcPct val="100000"/>
+              </a:lnSpc>
+              <a:spcBef>
+                <a:spcPts val="0"/>
+              </a:spcBef>
+              <a:spcAft>
+                <a:spcPts val="0"/>
+              </a:spcAft>
+              <a:buClrTx/>
+              <a:buSzTx/>
+              <a:buFontTx/>
+              <a:buNone/>
+              <a:tabLst/>
+              <a:defRPr/>
+            </a:pPr>
+            <a:fld id="{B7EB45DA-9A0D-DC49-8E02-F30A5DDC21C3}" type="slidenum">
+              <a:rPr kumimoji="0" lang="en-US" sz="1200" b="0" i="0" u="none" strike="noStrike" kern="1200" cap="none" spc="0" normalizeH="0" baseline="0" noProof="0" smtClean="0">
+                <a:ln>
+                  <a:noFill/>
+                </a:ln>
+                <a:solidFill>
+                  <a:srgbClr val="000000">
+                    <a:tint val="75000"/>
+                  </a:srgbClr>
+                </a:solidFill>
+                <a:effectLst/>
+                <a:uLnTx/>
+                <a:uFillTx/>
+                <a:latin typeface="Calibri" panose="020F0502020204030204"/>
+                <a:ea typeface="+mn-ea"/>
+                <a:cs typeface="+mn-cs"/>
+              </a:rPr>
+              <a:pPr marL="0" marR="0" lvl="0" indent="0" algn="r" defTabSz="457200" rtl="0" eaLnBrk="1" fontAlgn="auto" latinLnBrk="0" hangingPunct="1">
+                <a:lnSpc>
+                  <a:spcPct val="100000"/>
+                </a:lnSpc>
+                <a:spcBef>
+                  <a:spcPts val="0"/>
+                </a:spcBef>
+                <a:spcAft>
+                  <a:spcPts val="0"/>
+                </a:spcAft>
+                <a:buClrTx/>
+                <a:buSzTx/>
+                <a:buFontTx/>
+                <a:buNone/>
+                <a:tabLst/>
+                <a:defRPr/>
+              </a:pPr>
+              <a:t>23</a:t>
+            </a:fld>
+            <a:endParaRPr kumimoji="0" lang="en-US" sz="1200" b="0" i="0" u="none" strike="noStrike" kern="1200" cap="none" spc="0" normalizeH="0" baseline="0" noProof="0">
+              <a:ln>
+                <a:noFill/>
+              </a:ln>
+              <a:solidFill>
+                <a:srgbClr val="000000">
+                  <a:tint val="75000"/>
+                </a:srgbClr>
+              </a:solidFill>
+              <a:effectLst/>
+              <a:uLnTx/>
+              <a:uFillTx/>
+              <a:latin typeface="Calibri" panose="020F0502020204030204"/>
+              <a:ea typeface="+mn-ea"/>
+              <a:cs typeface="+mn-cs"/>
+            </a:endParaRPr>
+          </a:p>
+        </p:txBody>
+      </p:sp>
+      <p:sp>
+        <p:nvSpPr>
+          <p:cNvPr id="101" name="Question"/>
+          <p:cNvSpPr txBox="1"/>
+          <p:nvPr/>
+        </p:nvSpPr>
+        <p:spPr>
+          <a:xfrm>
+            <a:off x="685800" y="2798064"/>
+            <a:ext cx="7772400" cy="475488"/>
+          </a:xfrm>
+          <a:prstGeom prst="rect">
+            <a:avLst/>
+          </a:prstGeom>
+          <a:noFill/>
+          <a:ln>
+            <a:noFill/>
+          </a:ln>
+        </p:spPr>
+        <p:txBody>
+          <a:bodyPr wrap="square" lIns="0" tIns="0" rIns="0" bIns="0" anchor="t"/>
+          <a:lstStyle/>
+          <a:p>
+            <a:pPr marL="0" marR="0" lvl="0" indent="0" algn="ctr" defTabSz="457200" rtl="0" eaLnBrk="1" fontAlgn="auto" latinLnBrk="0" hangingPunct="1">
+              <a:lnSpc>
+                <a:spcPct val="100000"/>
+              </a:lnSpc>
+              <a:spcBef>
+                <a:spcPts val="0"/>
+              </a:spcBef>
+              <a:spcAft>
+                <a:spcPts val="0"/>
+              </a:spcAft>
+              <a:buClrTx/>
+              <a:buSzTx/>
+              <a:buFontTx/>
+              <a:buNone/>
+              <a:tabLst/>
+              <a:defRPr/>
+            </a:pPr>
+            <a:r>
+              <a:rPr kumimoji="0" lang="en-US" sz="2400" b="0" i="0" u="none" strike="noStrike" kern="1200" cap="none" spc="0" normalizeH="0" baseline="0" noProof="0" dirty="0">
+                <a:ln>
+                  <a:noFill/>
+                </a:ln>
+                <a:solidFill>
+                  <a:srgbClr val="5C4826"/>
+                </a:solidFill>
+                <a:effectLst/>
+                <a:uLnTx/>
+                <a:uFillTx/>
+                <a:latin typeface="Calibri" panose="020F0502020204030204"/>
+                <a:ea typeface="+mn-ea"/>
+                <a:cs typeface="+mn-cs"/>
+              </a:rPr>
+              <a:t>What must be true, and what should hold it?</a:t>
+            </a:r>
+          </a:p>
+        </p:txBody>
+      </p:sp>
+      <p:sp>
+        <p:nvSpPr>
+          <p:cNvPr id="103" name="Rule"/>
+          <p:cNvSpPr/>
+          <p:nvPr/>
+        </p:nvSpPr>
+        <p:spPr>
+          <a:xfrm>
+            <a:off x="3429000" y="3584448"/>
+            <a:ext cx="2286000" cy="51206"/>
+          </a:xfrm>
+          <a:prstGeom prst="rect">
+            <a:avLst/>
+          </a:prstGeom>
+          <a:solidFill>
+            <a:srgbClr val="8E6F3E"/>
+          </a:solidFill>
+          <a:ln>
+            <a:noFill/>
+          </a:ln>
+        </p:spPr>
+        <p:txBody>
+          <a:bodyPr wrap="square" lIns="27432" tIns="22860" rIns="27432" bIns="22860" anchor="ctr"/>
+          <a:lstStyle/>
+          <a:p>
+            <a:pPr marL="0" marR="0" lvl="0" indent="0" algn="l" defTabSz="457200" rtl="0" eaLnBrk="1" fontAlgn="auto" latinLnBrk="0" hangingPunct="1">
+              <a:lnSpc>
+                <a:spcPct val="100000"/>
+              </a:lnSpc>
+              <a:spcBef>
+                <a:spcPts val="0"/>
+              </a:spcBef>
+              <a:spcAft>
+                <a:spcPts val="0"/>
+              </a:spcAft>
+              <a:buClrTx/>
+              <a:buSzTx/>
+              <a:buFontTx/>
+              <a:buNone/>
+              <a:tabLst/>
+              <a:defRPr/>
+            </a:pPr>
+            <a:endParaRPr kumimoji="0" lang="en-US" sz="1800" b="0" i="0" u="none" strike="noStrike" kern="1200" cap="none" spc="0" normalizeH="0" baseline="0" noProof="0">
+              <a:ln>
+                <a:noFill/>
+              </a:ln>
+              <a:solidFill>
+                <a:srgbClr val="000000"/>
+              </a:solidFill>
+              <a:effectLst/>
+              <a:uLnTx/>
+              <a:uFillTx/>
+              <a:latin typeface="Calibri" panose="020F0502020204030204"/>
+              <a:ea typeface="+mn-ea"/>
+              <a:cs typeface="+mn-cs"/>
+            </a:endParaRPr>
+          </a:p>
+        </p:txBody>
+      </p:sp>
+    </p:spTree>
+  </p:cSld>
+  <p:clrMapOvr>
+    <a:masterClrMapping/>
+  </p:clrMapOvr>
+</p:sld>
+</file>
+
+<file path=ppt/slides/slide33.xml><?xml version="1.0" encoding="utf-8"?>
+<p:sld xmlns:a="http://schemas.openxmlformats.org/drawingml/2006/main" xmlns:r="http://schemas.openxmlformats.org/officeDocument/2006/relationships" xmlns:p="http://schemas.openxmlformats.org/presentationml/2006/main">
+  <p:cSld>
+    <p:spTree>
+      <p:nvGrpSpPr>
+        <p:cNvPr id="1" name=""/>
+        <p:cNvGrpSpPr/>
+        <p:nvPr/>
+      </p:nvGrpSpPr>
+      <p:grpSpPr>
+        <a:xfrm>
+          <a:off x="0" y="0"/>
+          <a:ext cx="0" cy="0"/>
+          <a:chOff x="0" y="0"/>
+          <a:chExt cx="0" cy="0"/>
+        </a:xfrm>
+      </p:grpSpPr>
+      <p:sp>
+        <p:nvSpPr>
+          <p:cNvPr id="100" name="SectionLabel"/>
+          <p:cNvSpPr txBox="1"/>
+          <p:nvPr/>
+        </p:nvSpPr>
+        <p:spPr>
+          <a:xfrm>
+            <a:off x="685800" y="1243584"/>
+            <a:ext cx="7772400" cy="365760"/>
+          </a:xfrm>
+          <a:prstGeom prst="rect">
+            <a:avLst/>
+          </a:prstGeom>
+          <a:noFill/>
+          <a:ln>
+            <a:noFill/>
+          </a:ln>
+        </p:spPr>
+        <p:txBody>
+          <a:bodyPr wrap="square" lIns="0" tIns="0" rIns="0" bIns="0" anchor="t"/>
+          <a:lstStyle/>
+          <a:p>
+            <a:pPr marL="0" marR="0" lvl="0" indent="0" algn="ctr" defTabSz="457200" rtl="0" eaLnBrk="1" fontAlgn="auto" latinLnBrk="0" hangingPunct="1">
+              <a:lnSpc>
+                <a:spcPct val="100000"/>
+              </a:lnSpc>
+              <a:spcBef>
+                <a:spcPts val="0"/>
+              </a:spcBef>
+              <a:spcAft>
+                <a:spcPts val="0"/>
+              </a:spcAft>
+              <a:buClrTx/>
+              <a:buSzTx/>
+              <a:buFontTx/>
+              <a:buNone/>
+              <a:tabLst/>
+              <a:defRPr/>
+            </a:pPr>
+            <a:r>
+              <a:rPr kumimoji="0" lang="en-US" sz="2000" b="1" i="0" u="none" strike="noStrike" kern="1200" cap="none" spc="0" normalizeH="0" baseline="0" noProof="0" dirty="0">
+                <a:ln>
+                  <a:noFill/>
+                </a:ln>
+                <a:solidFill>
+                  <a:srgbClr val="8E6F3E"/>
+                </a:solidFill>
+                <a:effectLst/>
+                <a:uLnTx/>
+                <a:uFillTx/>
+                <a:latin typeface="Calibri" panose="020F0502020204030204"/>
+                <a:ea typeface="+mn-ea"/>
+                <a:cs typeface="+mn-cs"/>
+              </a:rPr>
+              <a:t>SECTION 5</a:t>
+            </a:r>
+          </a:p>
+        </p:txBody>
+      </p:sp>
+      <p:sp>
+        <p:nvSpPr>
+          <p:cNvPr id="2" name="Title 1"/>
+          <p:cNvSpPr>
+            <a:spLocks noGrp="1"/>
+          </p:cNvSpPr>
+          <p:nvPr>
+            <p:ph type="title"/>
+          </p:nvPr>
+        </p:nvSpPr>
+        <p:spPr>
+          <a:xfrm>
+            <a:off x="685800" y="1700784"/>
+            <a:ext cx="7772400" cy="1005840"/>
+          </a:xfrm>
+        </p:spPr>
+        <p:txBody>
+          <a:bodyPr>
+            <a:normAutofit/>
+          </a:bodyPr>
+          <a:lstStyle/>
+          <a:p>
+            <a:pPr algn="ctr">
+              <a:buNone/>
+              <a:defRPr b="0"/>
+            </a:pPr>
+            <a:r>
+              <a:rPr lang="en-US" sz="4000" b="0" i="0" dirty="0">
+                <a:solidFill>
+                  <a:srgbClr val="000000"/>
+                </a:solidFill>
+              </a:rPr>
+              <a:t>What do models buy us?</a:t>
+            </a:r>
+          </a:p>
+        </p:txBody>
+      </p:sp>
+      <p:sp>
+        <p:nvSpPr>
+          <p:cNvPr id="3" name="Slide Number Placeholder 3"/>
+          <p:cNvSpPr>
+            <a:spLocks noGrp="1"/>
+          </p:cNvSpPr>
+          <p:nvPr>
+            <p:ph type="sldNum" sz="quarter" idx="4"/>
+          </p:nvPr>
+        </p:nvSpPr>
+        <p:spPr/>
+        <p:txBody>
+          <a:bodyPr/>
+          <a:lstStyle/>
+          <a:p>
+            <a:pPr marL="0" marR="0" lvl="0" indent="0" algn="r" defTabSz="457200" rtl="0" eaLnBrk="1" fontAlgn="auto" latinLnBrk="0" hangingPunct="1">
+              <a:lnSpc>
+                <a:spcPct val="100000"/>
+              </a:lnSpc>
+              <a:spcBef>
+                <a:spcPts val="0"/>
+              </a:spcBef>
+              <a:spcAft>
+                <a:spcPts val="0"/>
+              </a:spcAft>
+              <a:buClrTx/>
+              <a:buSzTx/>
+              <a:buFontTx/>
+              <a:buNone/>
+              <a:tabLst/>
+              <a:defRPr/>
+            </a:pPr>
+            <a:fld id="{B7EB45DA-9A0D-DC49-8E02-F30A5DDC21C3}" type="slidenum">
+              <a:rPr kumimoji="0" lang="en-US" sz="1200" b="0" i="0" u="none" strike="noStrike" kern="1200" cap="none" spc="0" normalizeH="0" baseline="0" noProof="0" smtClean="0">
+                <a:ln>
+                  <a:noFill/>
+                </a:ln>
+                <a:solidFill>
+                  <a:srgbClr val="000000">
+                    <a:tint val="75000"/>
+                  </a:srgbClr>
+                </a:solidFill>
+                <a:effectLst/>
+                <a:uLnTx/>
+                <a:uFillTx/>
+                <a:latin typeface="Calibri" panose="020F0502020204030204"/>
+                <a:ea typeface="+mn-ea"/>
+                <a:cs typeface="+mn-cs"/>
+              </a:rPr>
+              <a:pPr marL="0" marR="0" lvl="0" indent="0" algn="r" defTabSz="457200" rtl="0" eaLnBrk="1" fontAlgn="auto" latinLnBrk="0" hangingPunct="1">
+                <a:lnSpc>
+                  <a:spcPct val="100000"/>
+                </a:lnSpc>
+                <a:spcBef>
+                  <a:spcPts val="0"/>
+                </a:spcBef>
+                <a:spcAft>
+                  <a:spcPts val="0"/>
+                </a:spcAft>
+                <a:buClrTx/>
+                <a:buSzTx/>
+                <a:buFontTx/>
+                <a:buNone/>
+                <a:tabLst/>
+                <a:defRPr/>
+              </a:pPr>
+              <a:t>27</a:t>
+            </a:fld>
+            <a:endParaRPr kumimoji="0" lang="en-US" sz="1200" b="0" i="0" u="none" strike="noStrike" kern="1200" cap="none" spc="0" normalizeH="0" baseline="0" noProof="0">
+              <a:ln>
+                <a:noFill/>
+              </a:ln>
+              <a:solidFill>
+                <a:srgbClr val="000000">
+                  <a:tint val="75000"/>
+                </a:srgbClr>
+              </a:solidFill>
+              <a:effectLst/>
+              <a:uLnTx/>
+              <a:uFillTx/>
+              <a:latin typeface="Calibri" panose="020F0502020204030204"/>
+              <a:ea typeface="+mn-ea"/>
+              <a:cs typeface="+mn-cs"/>
+            </a:endParaRPr>
+          </a:p>
+        </p:txBody>
+      </p:sp>
+      <p:sp>
+        <p:nvSpPr>
+          <p:cNvPr id="101" name="Question"/>
+          <p:cNvSpPr txBox="1"/>
+          <p:nvPr/>
+        </p:nvSpPr>
+        <p:spPr>
+          <a:xfrm>
+            <a:off x="685800" y="2798064"/>
+            <a:ext cx="7772400" cy="475488"/>
+          </a:xfrm>
+          <a:prstGeom prst="rect">
+            <a:avLst/>
+          </a:prstGeom>
+          <a:noFill/>
+          <a:ln>
+            <a:noFill/>
+          </a:ln>
+        </p:spPr>
+        <p:txBody>
+          <a:bodyPr wrap="square" lIns="0" tIns="0" rIns="0" bIns="0" anchor="t"/>
+          <a:lstStyle/>
+          <a:p>
+            <a:pPr marL="0" marR="0" lvl="0" indent="0" algn="ctr" defTabSz="457200" rtl="0" eaLnBrk="1" fontAlgn="auto" latinLnBrk="0" hangingPunct="1">
+              <a:lnSpc>
+                <a:spcPct val="100000"/>
+              </a:lnSpc>
+              <a:spcBef>
+                <a:spcPts val="0"/>
+              </a:spcBef>
+              <a:spcAft>
+                <a:spcPts val="0"/>
+              </a:spcAft>
+              <a:buClrTx/>
+              <a:buSzTx/>
+              <a:buFontTx/>
+              <a:buNone/>
+              <a:tabLst/>
+              <a:defRPr/>
+            </a:pPr>
+            <a:r>
+              <a:rPr kumimoji="0" lang="en-US" sz="2400" b="0" i="0" u="none" strike="noStrike" kern="1200" cap="none" spc="0" normalizeH="0" baseline="0" noProof="0" dirty="0">
+                <a:ln>
+                  <a:noFill/>
+                </a:ln>
+                <a:solidFill>
+                  <a:srgbClr val="5C4826"/>
+                </a:solidFill>
+                <a:effectLst/>
+                <a:uLnTx/>
+                <a:uFillTx/>
+                <a:latin typeface="Calibri" panose="020F0502020204030204"/>
+                <a:ea typeface="+mn-ea"/>
+                <a:cs typeface="+mn-cs"/>
+              </a:rPr>
+              <a:t>What does an explicit model add?</a:t>
+            </a:r>
+          </a:p>
+        </p:txBody>
+      </p:sp>
+      <p:sp>
+        <p:nvSpPr>
+          <p:cNvPr id="103" name="Rule"/>
+          <p:cNvSpPr/>
+          <p:nvPr/>
+        </p:nvSpPr>
+        <p:spPr>
+          <a:xfrm>
+            <a:off x="3429000" y="3584448"/>
+            <a:ext cx="2286000" cy="51206"/>
+          </a:xfrm>
+          <a:prstGeom prst="rect">
+            <a:avLst/>
+          </a:prstGeom>
+          <a:solidFill>
+            <a:srgbClr val="8E6F3E"/>
+          </a:solidFill>
+          <a:ln>
+            <a:noFill/>
+          </a:ln>
+        </p:spPr>
+        <p:txBody>
+          <a:bodyPr wrap="square" lIns="27432" tIns="22860" rIns="27432" bIns="22860" anchor="ctr"/>
+          <a:lstStyle/>
+          <a:p>
+            <a:pPr marL="0" marR="0" lvl="0" indent="0" algn="l" defTabSz="457200" rtl="0" eaLnBrk="1" fontAlgn="auto" latinLnBrk="0" hangingPunct="1">
+              <a:lnSpc>
+                <a:spcPct val="100000"/>
+              </a:lnSpc>
+              <a:spcBef>
+                <a:spcPts val="0"/>
+              </a:spcBef>
+              <a:spcAft>
+                <a:spcPts val="0"/>
+              </a:spcAft>
+              <a:buClrTx/>
+              <a:buSzTx/>
+              <a:buFontTx/>
+              <a:buNone/>
+              <a:tabLst/>
+              <a:defRPr/>
+            </a:pPr>
+            <a:endParaRPr kumimoji="0" lang="en-US" sz="1800" b="0" i="0" u="none" strike="noStrike" kern="1200" cap="none" spc="0" normalizeH="0" baseline="0" noProof="0">
+              <a:ln>
+                <a:noFill/>
+              </a:ln>
+              <a:solidFill>
+                <a:srgbClr val="000000"/>
+              </a:solidFill>
+              <a:effectLst/>
+              <a:uLnTx/>
+              <a:uFillTx/>
+              <a:latin typeface="Calibri" panose="020F0502020204030204"/>
+              <a:ea typeface="+mn-ea"/>
+              <a:cs typeface="+mn-cs"/>
+            </a:endParaRPr>
           </a:p>
         </p:txBody>
       </p:sp>

</xml_diff>

<commit_message>
deck 2-3 rebuild phase 3: Section-2 failure-model slides + models-drive-controls bridge
</commit_message>
<xml_diff>
--- a/course/lectures/act-2-delegation-and-control/03-alignment/2-3-Alignment.pptx
+++ b/course/lectures/act-2-delegation-and-control/03-alignment/2-3-Alignment.pptx
@@ -41,6 +41,12 @@
     <p:sldId id="293" r:id="rId37"/>
     <p:sldId id="294" r:id="rId38"/>
     <p:sldId id="295" r:id="rId39"/>
+    <p:sldId id="296" r:id="rId40"/>
+    <p:sldId id="297" r:id="rId41"/>
+    <p:sldId id="298" r:id="rId42"/>
+    <p:sldId id="299" r:id="rId14"/>
+    <p:sldId id="300" r:id="rId12"/>
+    <p:sldId id="301" r:id="rId11"/>
   </p:sldIdLst>
   <p:sldSz cx="9144000" cy="6858000" type="screen4x3"/>
   <p:notesSz cx="6858000" cy="9144000"/>
@@ -2223,6 +2229,426 @@
           <a:p>
             <a:r>
               <a:t>First explicit process-modeling slide. The distinction matters: we are modeling the engineering process, not pretending we have a faithful cognitive model of an LLM.</a:t>
+            </a:r>
+          </a:p>
+        </p:txBody>
+      </p:sp>
+      <p:sp>
+        <p:nvSpPr>
+          <p:cNvPr id="4" name="Slide Number Placeholder 3"/>
+          <p:cNvSpPr>
+            <a:spLocks noGrp="1"/>
+          </p:cNvSpPr>
+          <p:nvPr>
+            <p:ph type="sldNum" idx="5" sz="quarter"/>
+          </p:nvPr>
+        </p:nvSpPr>
+        <p:spPr/>
+      </p:sp>
+    </p:spTree>
+  </p:cSld>
+  <p:clrMapOvr>
+    <a:masterClrMapping/>
+  </p:clrMapOvr>
+</p:notes>
+</file>
+
+<file path=ppt/notesSlides/notesSlide32.xml><?xml version="1.0" encoding="utf-8"?>
+<p:notes xmlns:a="http://schemas.openxmlformats.org/drawingml/2006/main" xmlns:p="http://schemas.openxmlformats.org/presentationml/2006/main" xmlns:r="http://schemas.openxmlformats.org/officeDocument/2006/relationships">
+  <p:cSld>
+    <p:spTree>
+      <p:nvGrpSpPr>
+        <p:cNvPr id="1" name=""/>
+        <p:cNvGrpSpPr/>
+        <p:nvPr/>
+      </p:nvGrpSpPr>
+      <p:grpSpPr>
+        <a:xfrm>
+          <a:off x="0" y="0"/>
+          <a:ext cx="0" cy="0"/>
+          <a:chOff x="0" y="0"/>
+          <a:chExt cx="0" cy="0"/>
+        </a:xfrm>
+      </p:grpSpPr>
+      <p:sp>
+        <p:nvSpPr>
+          <p:cNvPr id="2" name="Slide Image Placeholder 1"/>
+          <p:cNvSpPr>
+            <a:spLocks noGrp="1"/>
+          </p:cNvSpPr>
+          <p:nvPr>
+            <p:ph type="sldImg" idx="2"/>
+          </p:nvPr>
+        </p:nvSpPr>
+        <p:spPr/>
+      </p:sp>
+      <p:sp>
+        <p:nvSpPr>
+          <p:cNvPr id="3" name="Notes Placeholder 2"/>
+          <p:cNvSpPr>
+            <a:spLocks noGrp="1"/>
+          </p:cNvSpPr>
+          <p:nvPr>
+            <p:ph type="body" idx="3" sz="quarter"/>
+          </p:nvPr>
+        </p:nvSpPr>
+        <p:spPr/>
+        <p:txBody>
+          <a:bodyPr/>
+          <a:lstStyle/>
+          <a:p>
+            <a:r>
+              <a:t>Reuse of the Section-1 process diagram, now with the endpoint highlighted: does the chain end in ACCEPTABLE work? The question shifts from "what should happen" to "what can go wrong."</a:t>
+            </a:r>
+          </a:p>
+        </p:txBody>
+      </p:sp>
+      <p:sp>
+        <p:nvSpPr>
+          <p:cNvPr id="4" name="Slide Number Placeholder 3"/>
+          <p:cNvSpPr>
+            <a:spLocks noGrp="1"/>
+          </p:cNvSpPr>
+          <p:nvPr>
+            <p:ph type="sldNum" idx="5" sz="quarter"/>
+          </p:nvPr>
+        </p:nvSpPr>
+        <p:spPr/>
+      </p:sp>
+    </p:spTree>
+  </p:cSld>
+  <p:clrMapOvr>
+    <a:masterClrMapping/>
+  </p:clrMapOvr>
+</p:notes>
+</file>
+
+<file path=ppt/notesSlides/notesSlide33.xml><?xml version="1.0" encoding="utf-8"?>
+<p:notes xmlns:a="http://schemas.openxmlformats.org/drawingml/2006/main" xmlns:p="http://schemas.openxmlformats.org/presentationml/2006/main" xmlns:r="http://schemas.openxmlformats.org/officeDocument/2006/relationships">
+  <p:cSld>
+    <p:spTree>
+      <p:nvGrpSpPr>
+        <p:cNvPr id="1" name=""/>
+        <p:cNvGrpSpPr/>
+        <p:nvPr/>
+      </p:nvGrpSpPr>
+      <p:grpSpPr>
+        <a:xfrm>
+          <a:off x="0" y="0"/>
+          <a:ext cx="0" cy="0"/>
+          <a:chOff x="0" y="0"/>
+          <a:chExt cx="0" cy="0"/>
+        </a:xfrm>
+      </p:grpSpPr>
+      <p:sp>
+        <p:nvSpPr>
+          <p:cNvPr id="2" name="Slide Image Placeholder 1"/>
+          <p:cNvSpPr>
+            <a:spLocks noGrp="1"/>
+          </p:cNvSpPr>
+          <p:nvPr>
+            <p:ph type="sldImg" idx="2"/>
+          </p:nvPr>
+        </p:nvSpPr>
+        <p:spPr/>
+      </p:sp>
+      <p:sp>
+        <p:nvSpPr>
+          <p:cNvPr id="3" name="Notes Placeholder 2"/>
+          <p:cNvSpPr>
+            <a:spLocks noGrp="1"/>
+          </p:cNvSpPr>
+          <p:nvPr>
+            <p:ph type="body" idx="3" sz="quarter"/>
+          </p:nvPr>
+        </p:nvSpPr>
+        <p:spPr/>
+        <p:txBody>
+          <a:bodyPr/>
+          <a:lstStyle/>
+          <a:p>
+            <a:r>
+              <a:t>First failure mode; take them one at a time. The artifact itself is wrong against an obligation.</a:t>
+            </a:r>
+          </a:p>
+        </p:txBody>
+      </p:sp>
+      <p:sp>
+        <p:nvSpPr>
+          <p:cNvPr id="4" name="Slide Number Placeholder 3"/>
+          <p:cNvSpPr>
+            <a:spLocks noGrp="1"/>
+          </p:cNvSpPr>
+          <p:nvPr>
+            <p:ph type="sldNum" idx="5" sz="quarter"/>
+          </p:nvPr>
+        </p:nvSpPr>
+        <p:spPr/>
+      </p:sp>
+    </p:spTree>
+  </p:cSld>
+  <p:clrMapOvr>
+    <a:masterClrMapping/>
+  </p:clrMapOvr>
+</p:notes>
+</file>
+
+<file path=ppt/notesSlides/notesSlide34.xml><?xml version="1.0" encoding="utf-8"?>
+<p:notes xmlns:a="http://schemas.openxmlformats.org/drawingml/2006/main" xmlns:p="http://schemas.openxmlformats.org/presentationml/2006/main" xmlns:r="http://schemas.openxmlformats.org/officeDocument/2006/relationships">
+  <p:cSld>
+    <p:spTree>
+      <p:nvGrpSpPr>
+        <p:cNvPr id="1" name=""/>
+        <p:cNvGrpSpPr/>
+        <p:nvPr/>
+      </p:nvGrpSpPr>
+      <p:grpSpPr>
+        <a:xfrm>
+          <a:off x="0" y="0"/>
+          <a:ext cx="0" cy="0"/>
+          <a:chOff x="0" y="0"/>
+          <a:chExt cx="0" cy="0"/>
+        </a:xfrm>
+      </p:grpSpPr>
+      <p:sp>
+        <p:nvSpPr>
+          <p:cNvPr id="2" name="Slide Image Placeholder 1"/>
+          <p:cNvSpPr>
+            <a:spLocks noGrp="1"/>
+          </p:cNvSpPr>
+          <p:nvPr>
+            <p:ph type="sldImg" idx="2"/>
+          </p:nvPr>
+        </p:nvSpPr>
+        <p:spPr/>
+      </p:sp>
+      <p:sp>
+        <p:nvSpPr>
+          <p:cNvPr id="3" name="Notes Placeholder 2"/>
+          <p:cNvSpPr>
+            <a:spLocks noGrp="1"/>
+          </p:cNvSpPr>
+          <p:nvPr>
+            <p:ph type="body" idx="3" sz="quarter"/>
+          </p:nvPr>
+        </p:nvSpPr>
+        <p:spPr/>
+        <p:txBody>
+          <a:bodyPr/>
+          <a:lstStyle/>
+          <a:p>
+            <a:r>
+              <a:t>Crucial: each example can leave a final state that LOOKS fine. The failure is in the path, not (only) the artifact — which is why final-state validation alone does not capture it.</a:t>
+            </a:r>
+          </a:p>
+        </p:txBody>
+      </p:sp>
+      <p:sp>
+        <p:nvSpPr>
+          <p:cNvPr id="4" name="Slide Number Placeholder 3"/>
+          <p:cNvSpPr>
+            <a:spLocks noGrp="1"/>
+          </p:cNvSpPr>
+          <p:nvPr>
+            <p:ph type="sldNum" idx="5" sz="quarter"/>
+          </p:nvPr>
+        </p:nvSpPr>
+        <p:spPr/>
+      </p:sp>
+    </p:spTree>
+  </p:cSld>
+  <p:clrMapOvr>
+    <a:masterClrMapping/>
+  </p:clrMapOvr>
+</p:notes>
+</file>
+
+<file path=ppt/notesSlides/notesSlide35.xml><?xml version="1.0" encoding="utf-8"?>
+<p:notes xmlns:a="http://schemas.openxmlformats.org/drawingml/2006/main" xmlns:p="http://schemas.openxmlformats.org/presentationml/2006/main" xmlns:r="http://schemas.openxmlformats.org/officeDocument/2006/relationships">
+  <p:cSld>
+    <p:spTree>
+      <p:nvGrpSpPr>
+        <p:cNvPr id="1" name=""/>
+        <p:cNvGrpSpPr/>
+        <p:nvPr/>
+      </p:nvGrpSpPr>
+      <p:grpSpPr>
+        <a:xfrm>
+          <a:off x="0" y="0"/>
+          <a:ext cx="0" cy="0"/>
+          <a:chOff x="0" y="0"/>
+          <a:chExt cx="0" cy="0"/>
+        </a:xfrm>
+      </p:grpSpPr>
+      <p:sp>
+        <p:nvSpPr>
+          <p:cNvPr id="2" name="Slide Image Placeholder 1"/>
+          <p:cNvSpPr>
+            <a:spLocks noGrp="1"/>
+          </p:cNvSpPr>
+          <p:nvPr>
+            <p:ph type="sldImg" idx="2"/>
+          </p:nvPr>
+        </p:nvSpPr>
+        <p:spPr/>
+      </p:sp>
+      <p:sp>
+        <p:nvSpPr>
+          <p:cNvPr id="3" name="Notes Placeholder 2"/>
+          <p:cNvSpPr>
+            <a:spLocks noGrp="1"/>
+          </p:cNvSpPr>
+          <p:nvPr>
+            <p:ph type="body" idx="3" sz="quarter"/>
+          </p:nvPr>
+        </p:nvSpPr>
+        <p:spPr/>
+        <p:txBody>
+          <a:bodyPr/>
+          <a:lstStyle/>
+          <a:p>
+            <a:r>
+              <a:t>Third failure mode. Explicit callback to the Agents lecture. This is what sets up gates later in the section.</a:t>
+            </a:r>
+          </a:p>
+        </p:txBody>
+      </p:sp>
+      <p:sp>
+        <p:nvSpPr>
+          <p:cNvPr id="4" name="Slide Number Placeholder 3"/>
+          <p:cNvSpPr>
+            <a:spLocks noGrp="1"/>
+          </p:cNvSpPr>
+          <p:nvPr>
+            <p:ph type="sldNum" idx="5" sz="quarter"/>
+          </p:nvPr>
+        </p:nvSpPr>
+        <p:spPr/>
+      </p:sp>
+    </p:spTree>
+  </p:cSld>
+  <p:clrMapOvr>
+    <a:masterClrMapping/>
+  </p:clrMapOvr>
+</p:notes>
+</file>
+
+<file path=ppt/notesSlides/notesSlide36.xml><?xml version="1.0" encoding="utf-8"?>
+<p:notes xmlns:a="http://schemas.openxmlformats.org/drawingml/2006/main" xmlns:p="http://schemas.openxmlformats.org/presentationml/2006/main" xmlns:r="http://schemas.openxmlformats.org/officeDocument/2006/relationships">
+  <p:cSld>
+    <p:spTree>
+      <p:nvGrpSpPr>
+        <p:cNvPr id="1" name=""/>
+        <p:cNvGrpSpPr/>
+        <p:nvPr/>
+      </p:nvGrpSpPr>
+      <p:grpSpPr>
+        <a:xfrm>
+          <a:off x="0" y="0"/>
+          <a:ext cx="0" cy="0"/>
+          <a:chOff x="0" y="0"/>
+          <a:chExt cx="0" cy="0"/>
+        </a:xfrm>
+      </p:grpSpPr>
+      <p:sp>
+        <p:nvSpPr>
+          <p:cNvPr id="2" name="Slide Image Placeholder 1"/>
+          <p:cNvSpPr>
+            <a:spLocks noGrp="1"/>
+          </p:cNvSpPr>
+          <p:nvPr>
+            <p:ph type="sldImg" idx="2"/>
+          </p:nvPr>
+        </p:nvSpPr>
+        <p:spPr/>
+      </p:sp>
+      <p:sp>
+        <p:nvSpPr>
+          <p:cNvPr id="3" name="Notes Placeholder 2"/>
+          <p:cNvSpPr>
+            <a:spLocks noGrp="1"/>
+          </p:cNvSpPr>
+          <p:nvPr>
+            <p:ph type="body" idx="3" sz="quarter"/>
+          </p:nvPr>
+        </p:nvSpPr>
+        <p:spPr/>
+        <p:txBody>
+          <a:bodyPr/>
+          <a:lstStyle/>
+          <a:p>
+            <a:r>
+              <a:t>This earns the control vocabulary: the failure model, not a framework, motivates the four roles on the next slide.</a:t>
+            </a:r>
+          </a:p>
+        </p:txBody>
+      </p:sp>
+      <p:sp>
+        <p:nvSpPr>
+          <p:cNvPr id="4" name="Slide Number Placeholder 3"/>
+          <p:cNvSpPr>
+            <a:spLocks noGrp="1"/>
+          </p:cNvSpPr>
+          <p:nvPr>
+            <p:ph type="sldNum" idx="5" sz="quarter"/>
+          </p:nvPr>
+        </p:nvSpPr>
+        <p:spPr/>
+      </p:sp>
+    </p:spTree>
+  </p:cSld>
+  <p:clrMapOvr>
+    <a:masterClrMapping/>
+  </p:clrMapOvr>
+</p:notes>
+</file>
+
+<file path=ppt/notesSlides/notesSlide37.xml><?xml version="1.0" encoding="utf-8"?>
+<p:notes xmlns:a="http://schemas.openxmlformats.org/drawingml/2006/main" xmlns:p="http://schemas.openxmlformats.org/presentationml/2006/main" xmlns:r="http://schemas.openxmlformats.org/officeDocument/2006/relationships">
+  <p:cSld>
+    <p:spTree>
+      <p:nvGrpSpPr>
+        <p:cNvPr id="1" name=""/>
+        <p:cNvGrpSpPr/>
+        <p:nvPr/>
+      </p:nvGrpSpPr>
+      <p:grpSpPr>
+        <a:xfrm>
+          <a:off x="0" y="0"/>
+          <a:ext cx="0" cy="0"/>
+          <a:chOff x="0" y="0"/>
+          <a:chExt cx="0" cy="0"/>
+        </a:xfrm>
+      </p:grpSpPr>
+      <p:sp>
+        <p:nvSpPr>
+          <p:cNvPr id="2" name="Slide Image Placeholder 1"/>
+          <p:cNvSpPr>
+            <a:spLocks noGrp="1"/>
+          </p:cNvSpPr>
+          <p:nvPr>
+            <p:ph type="sldImg" idx="2"/>
+          </p:nvPr>
+        </p:nvSpPr>
+        <p:spPr/>
+      </p:sp>
+      <p:sp>
+        <p:nvSpPr>
+          <p:cNvPr id="3" name="Notes Placeholder 2"/>
+          <p:cNvSpPr>
+            <a:spLocks noGrp="1"/>
+          </p:cNvSpPr>
+          <p:nvPr>
+            <p:ph type="body" idx="3" sz="quarter"/>
+          </p:nvPr>
+        </p:nvSpPr>
+        <p:spPr/>
+        <p:txBody>
+          <a:bodyPr/>
+          <a:lstStyle/>
+          <a:p>
+            <a:r>
+              <a:t>The missing bridge between Modeling and Alignment: one explicit model, several controls derived from it, their verdicts meeting at a gate.</a:t>
             </a:r>
           </a:p>
         </p:txBody>
@@ -17935,6 +18361,3563 @@
                 </a:solidFill>
               </a:rPr>
               <a:t>It need not prescribe the agent’s internal reasoning.</a:t>
+            </a:r>
+          </a:p>
+        </p:txBody>
+      </p:sp>
+    </p:spTree>
+  </p:cSld>
+  <p:clrMapOvr>
+    <a:masterClrMapping/>
+  </p:clrMapOvr>
+</p:sld>
+</file>
+
+<file path=ppt/slides/slide34.xml><?xml version="1.0" encoding="utf-8"?>
+<p:sld xmlns:a="http://schemas.openxmlformats.org/drawingml/2006/main" xmlns:p="http://schemas.openxmlformats.org/presentationml/2006/main" xmlns:r="http://schemas.openxmlformats.org/officeDocument/2006/relationships">
+  <p:cSld>
+    <p:spTree>
+      <p:nvGrpSpPr>
+        <p:cNvPr id="1" name=""/>
+        <p:cNvGrpSpPr/>
+        <p:nvPr/>
+      </p:nvGrpSpPr>
+      <p:grpSpPr/>
+      <p:sp>
+        <p:nvSpPr>
+          <p:cNvPr id="2" name="Content Placeholder 1"/>
+          <p:cNvSpPr>
+            <a:spLocks noGrp="1"/>
+          </p:cNvSpPr>
+          <p:nvPr>
+            <p:ph idx="1"/>
+          </p:nvPr>
+        </p:nvSpPr>
+        <p:spPr/>
+        <p:txBody>
+          <a:bodyPr/>
+          <a:lstStyle/>
+          <a:p/>
+        </p:txBody>
+      </p:sp>
+      <p:sp>
+        <p:nvSpPr>
+          <p:cNvPr id="3" name="Title 2"/>
+          <p:cNvSpPr>
+            <a:spLocks noGrp="1"/>
+          </p:cNvSpPr>
+          <p:nvPr>
+            <p:ph type="title"/>
+          </p:nvPr>
+        </p:nvSpPr>
+        <p:spPr/>
+        <p:txBody>
+          <a:bodyPr/>
+          <a:lstStyle/>
+          <a:p>
+            <a:r>
+              <a:rPr sz="2400"/>
+              <a:t>A process gives us something to reason about</a:t>
+            </a:r>
+          </a:p>
+        </p:txBody>
+      </p:sp>
+      <p:sp>
+        <p:nvSpPr>
+          <p:cNvPr id="4" name="PCWorkOrder"/>
+          <p:cNvSpPr/>
+          <p:nvPr/>
+        </p:nvSpPr>
+        <p:spPr>
+          <a:xfrm>
+            <a:off x="502920" y="1005840"/>
+            <a:ext cx="1737360" cy="548640"/>
+          </a:xfrm>
+          <a:prstGeom prst="rect">
+            <a:avLst/>
+          </a:prstGeom>
+          <a:solidFill>
+            <a:srgbClr val="8E6F3E"/>
+          </a:solidFill>
+          <a:ln>
+            <a:noFill/>
+          </a:ln>
+          <a:effectLst/>
+        </p:spPr>
+        <p:style>
+          <a:lnRef idx="1">
+            <a:schemeClr val="accent1"/>
+          </a:lnRef>
+          <a:fillRef idx="3">
+            <a:schemeClr val="accent1"/>
+          </a:fillRef>
+          <a:effectRef idx="2">
+            <a:schemeClr val="accent1"/>
+          </a:effectRef>
+          <a:fontRef idx="minor">
+            <a:schemeClr val="lt1"/>
+          </a:fontRef>
+        </p:style>
+        <p:txBody>
+          <a:bodyPr rtlCol="0" anchor="ctr" wrap="square" lIns="27432" rIns="27432" tIns="22860" bIns="22860"/>
+          <a:lstStyle/>
+          <a:p>
+            <a:pPr algn="ctr"/>
+            <a:r>
+              <a:rPr sz="1500" b="1" i="0">
+                <a:solidFill>
+                  <a:srgbClr val="FFFFFF"/>
+                </a:solidFill>
+              </a:rPr>
+              <a:t>WORK ORDER</a:t>
+            </a:r>
+          </a:p>
+        </p:txBody>
+      </p:sp>
+      <p:cxnSp>
+        <p:nvCxnSpPr>
+          <p:cNvPr id="5" name="Connector 4"/>
+          <p:cNvCxnSpPr/>
+          <p:nvPr/>
+        </p:nvCxnSpPr>
+        <p:spPr>
+          <a:xfrm>
+            <a:off x="1371600" y="1554480"/>
+            <a:ext cx="0" cy="365760"/>
+          </a:xfrm>
+          <a:prstGeom prst="line">
+            <a:avLst/>
+          </a:prstGeom>
+          <a:ln w="28575">
+            <a:solidFill>
+              <a:srgbClr val="8E6F3E"/>
+            </a:solidFill>
+            <a:tailEnd type="triangle" w="med" len="med"/>
+          </a:ln>
+          <a:effectLst/>
+        </p:spPr>
+        <p:style>
+          <a:lnRef idx="2">
+            <a:schemeClr val="accent1"/>
+          </a:lnRef>
+          <a:fillRef idx="0">
+            <a:schemeClr val="accent1"/>
+          </a:fillRef>
+          <a:effectRef idx="1">
+            <a:schemeClr val="accent1"/>
+          </a:effectRef>
+          <a:fontRef idx="minor">
+            <a:schemeClr val="tx1"/>
+          </a:fontRef>
+        </p:style>
+      </p:cxnSp>
+      <p:sp>
+        <p:nvSpPr>
+          <p:cNvPr id="6" name="PCINSPECT"/>
+          <p:cNvSpPr/>
+          <p:nvPr/>
+        </p:nvSpPr>
+        <p:spPr>
+          <a:xfrm>
+            <a:off x="502920" y="1920240"/>
+            <a:ext cx="1417320" cy="594360"/>
+          </a:xfrm>
+          <a:prstGeom prst="rect">
+            <a:avLst/>
+          </a:prstGeom>
+          <a:solidFill>
+            <a:srgbClr val="F5F1E8"/>
+          </a:solidFill>
+          <a:ln w="12700">
+            <a:solidFill>
+              <a:srgbClr val="C9B991"/>
+            </a:solidFill>
+          </a:ln>
+          <a:effectLst/>
+        </p:spPr>
+        <p:style>
+          <a:lnRef idx="1">
+            <a:schemeClr val="accent1"/>
+          </a:lnRef>
+          <a:fillRef idx="3">
+            <a:schemeClr val="accent1"/>
+          </a:fillRef>
+          <a:effectRef idx="2">
+            <a:schemeClr val="accent1"/>
+          </a:effectRef>
+          <a:fontRef idx="minor">
+            <a:schemeClr val="lt1"/>
+          </a:fontRef>
+        </p:style>
+        <p:txBody>
+          <a:bodyPr rtlCol="0" anchor="ctr" wrap="square" lIns="27432" rIns="27432" tIns="22860" bIns="22860"/>
+          <a:lstStyle/>
+          <a:p>
+            <a:pPr algn="ctr"/>
+            <a:r>
+              <a:rPr sz="1500" b="1" i="0">
+                <a:solidFill>
+                  <a:srgbClr val="5C4826"/>
+                </a:solidFill>
+              </a:rPr>
+              <a:t>INSPECT</a:t>
+            </a:r>
+          </a:p>
+        </p:txBody>
+      </p:sp>
+      <p:cxnSp>
+        <p:nvCxnSpPr>
+          <p:cNvPr id="7" name="Connector 6"/>
+          <p:cNvCxnSpPr/>
+          <p:nvPr/>
+        </p:nvCxnSpPr>
+        <p:spPr>
+          <a:xfrm>
+            <a:off x="1920240" y="2217420"/>
+            <a:ext cx="182880" cy="0"/>
+          </a:xfrm>
+          <a:prstGeom prst="line">
+            <a:avLst/>
+          </a:prstGeom>
+          <a:ln w="28575">
+            <a:solidFill>
+              <a:srgbClr val="8E6F3E"/>
+            </a:solidFill>
+            <a:tailEnd type="triangle" w="med" len="med"/>
+          </a:ln>
+          <a:effectLst/>
+        </p:spPr>
+        <p:style>
+          <a:lnRef idx="2">
+            <a:schemeClr val="accent1"/>
+          </a:lnRef>
+          <a:fillRef idx="0">
+            <a:schemeClr val="accent1"/>
+          </a:fillRef>
+          <a:effectRef idx="1">
+            <a:schemeClr val="accent1"/>
+          </a:effectRef>
+          <a:fontRef idx="minor">
+            <a:schemeClr val="tx1"/>
+          </a:fontRef>
+        </p:style>
+      </p:cxnSp>
+      <p:sp>
+        <p:nvSpPr>
+          <p:cNvPr id="8" name="PCMODIFY"/>
+          <p:cNvSpPr/>
+          <p:nvPr/>
+        </p:nvSpPr>
+        <p:spPr>
+          <a:xfrm>
+            <a:off x="2103120" y="1920240"/>
+            <a:ext cx="1417320" cy="594360"/>
+          </a:xfrm>
+          <a:prstGeom prst="rect">
+            <a:avLst/>
+          </a:prstGeom>
+          <a:solidFill>
+            <a:srgbClr val="F5F1E8"/>
+          </a:solidFill>
+          <a:ln w="12700">
+            <a:solidFill>
+              <a:srgbClr val="C9B991"/>
+            </a:solidFill>
+          </a:ln>
+          <a:effectLst/>
+        </p:spPr>
+        <p:style>
+          <a:lnRef idx="1">
+            <a:schemeClr val="accent1"/>
+          </a:lnRef>
+          <a:fillRef idx="3">
+            <a:schemeClr val="accent1"/>
+          </a:fillRef>
+          <a:effectRef idx="2">
+            <a:schemeClr val="accent1"/>
+          </a:effectRef>
+          <a:fontRef idx="minor">
+            <a:schemeClr val="lt1"/>
+          </a:fontRef>
+        </p:style>
+        <p:txBody>
+          <a:bodyPr rtlCol="0" anchor="ctr" wrap="square" lIns="27432" rIns="27432" tIns="22860" bIns="22860"/>
+          <a:lstStyle/>
+          <a:p>
+            <a:pPr algn="ctr"/>
+            <a:r>
+              <a:rPr sz="1500" b="1" i="0">
+                <a:solidFill>
+                  <a:srgbClr val="5C4826"/>
+                </a:solidFill>
+              </a:rPr>
+              <a:t>MODIFY</a:t>
+            </a:r>
+          </a:p>
+        </p:txBody>
+      </p:sp>
+      <p:cxnSp>
+        <p:nvCxnSpPr>
+          <p:cNvPr id="9" name="Connector 8"/>
+          <p:cNvCxnSpPr/>
+          <p:nvPr/>
+        </p:nvCxnSpPr>
+        <p:spPr>
+          <a:xfrm>
+            <a:off x="3520439" y="2217420"/>
+            <a:ext cx="182881" cy="0"/>
+          </a:xfrm>
+          <a:prstGeom prst="line">
+            <a:avLst/>
+          </a:prstGeom>
+          <a:ln w="28575">
+            <a:solidFill>
+              <a:srgbClr val="8E6F3E"/>
+            </a:solidFill>
+            <a:tailEnd type="triangle" w="med" len="med"/>
+          </a:ln>
+          <a:effectLst/>
+        </p:spPr>
+        <p:style>
+          <a:lnRef idx="2">
+            <a:schemeClr val="accent1"/>
+          </a:lnRef>
+          <a:fillRef idx="0">
+            <a:schemeClr val="accent1"/>
+          </a:fillRef>
+          <a:effectRef idx="1">
+            <a:schemeClr val="accent1"/>
+          </a:effectRef>
+          <a:fontRef idx="minor">
+            <a:schemeClr val="tx1"/>
+          </a:fontRef>
+        </p:style>
+      </p:cxnSp>
+      <p:sp>
+        <p:nvSpPr>
+          <p:cNvPr id="10" name="PCCHECK"/>
+          <p:cNvSpPr/>
+          <p:nvPr/>
+        </p:nvSpPr>
+        <p:spPr>
+          <a:xfrm>
+            <a:off x="3703320" y="1920240"/>
+            <a:ext cx="1417320" cy="594360"/>
+          </a:xfrm>
+          <a:prstGeom prst="rect">
+            <a:avLst/>
+          </a:prstGeom>
+          <a:solidFill>
+            <a:srgbClr val="F5F1E8"/>
+          </a:solidFill>
+          <a:ln w="12700">
+            <a:solidFill>
+              <a:srgbClr val="C9B991"/>
+            </a:solidFill>
+          </a:ln>
+          <a:effectLst/>
+        </p:spPr>
+        <p:style>
+          <a:lnRef idx="1">
+            <a:schemeClr val="accent1"/>
+          </a:lnRef>
+          <a:fillRef idx="3">
+            <a:schemeClr val="accent1"/>
+          </a:fillRef>
+          <a:effectRef idx="2">
+            <a:schemeClr val="accent1"/>
+          </a:effectRef>
+          <a:fontRef idx="minor">
+            <a:schemeClr val="lt1"/>
+          </a:fontRef>
+        </p:style>
+        <p:txBody>
+          <a:bodyPr rtlCol="0" anchor="ctr" wrap="square" lIns="27432" rIns="27432" tIns="22860" bIns="22860"/>
+          <a:lstStyle/>
+          <a:p>
+            <a:pPr algn="ctr"/>
+            <a:r>
+              <a:rPr sz="1500" b="1" i="0">
+                <a:solidFill>
+                  <a:srgbClr val="5C4826"/>
+                </a:solidFill>
+              </a:rPr>
+              <a:t>CHECK</a:t>
+            </a:r>
+          </a:p>
+        </p:txBody>
+      </p:sp>
+      <p:cxnSp>
+        <p:nvCxnSpPr>
+          <p:cNvPr id="11" name="Connector 10"/>
+          <p:cNvCxnSpPr/>
+          <p:nvPr/>
+        </p:nvCxnSpPr>
+        <p:spPr>
+          <a:xfrm>
+            <a:off x="5120640" y="2217420"/>
+            <a:ext cx="182880" cy="0"/>
+          </a:xfrm>
+          <a:prstGeom prst="line">
+            <a:avLst/>
+          </a:prstGeom>
+          <a:ln w="28575">
+            <a:solidFill>
+              <a:srgbClr val="8E6F3E"/>
+            </a:solidFill>
+            <a:tailEnd type="triangle" w="med" len="med"/>
+          </a:ln>
+          <a:effectLst/>
+        </p:spPr>
+        <p:style>
+          <a:lnRef idx="2">
+            <a:schemeClr val="accent1"/>
+          </a:lnRef>
+          <a:fillRef idx="0">
+            <a:schemeClr val="accent1"/>
+          </a:fillRef>
+          <a:effectRef idx="1">
+            <a:schemeClr val="accent1"/>
+          </a:effectRef>
+          <a:fontRef idx="minor">
+            <a:schemeClr val="tx1"/>
+          </a:fontRef>
+        </p:style>
+      </p:cxnSp>
+      <p:sp>
+        <p:nvSpPr>
+          <p:cNvPr id="12" name="PCCOMMIT"/>
+          <p:cNvSpPr/>
+          <p:nvPr/>
+        </p:nvSpPr>
+        <p:spPr>
+          <a:xfrm>
+            <a:off x="5303520" y="1920240"/>
+            <a:ext cx="1417320" cy="594360"/>
+          </a:xfrm>
+          <a:prstGeom prst="rect">
+            <a:avLst/>
+          </a:prstGeom>
+          <a:solidFill>
+            <a:srgbClr val="F5F1E8"/>
+          </a:solidFill>
+          <a:ln w="12700">
+            <a:solidFill>
+              <a:srgbClr val="C9B991"/>
+            </a:solidFill>
+          </a:ln>
+          <a:effectLst/>
+        </p:spPr>
+        <p:style>
+          <a:lnRef idx="1">
+            <a:schemeClr val="accent1"/>
+          </a:lnRef>
+          <a:fillRef idx="3">
+            <a:schemeClr val="accent1"/>
+          </a:fillRef>
+          <a:effectRef idx="2">
+            <a:schemeClr val="accent1"/>
+          </a:effectRef>
+          <a:fontRef idx="minor">
+            <a:schemeClr val="lt1"/>
+          </a:fontRef>
+        </p:style>
+        <p:txBody>
+          <a:bodyPr rtlCol="0" anchor="ctr" wrap="square" lIns="27432" rIns="27432" tIns="22860" bIns="22860"/>
+          <a:lstStyle/>
+          <a:p>
+            <a:pPr algn="ctr"/>
+            <a:r>
+              <a:rPr sz="1500" b="1" i="0">
+                <a:solidFill>
+                  <a:srgbClr val="5C4826"/>
+                </a:solidFill>
+              </a:rPr>
+              <a:t>COMMIT</a:t>
+            </a:r>
+          </a:p>
+        </p:txBody>
+      </p:sp>
+      <p:cxnSp>
+        <p:nvCxnSpPr>
+          <p:cNvPr id="13" name="Connector 12"/>
+          <p:cNvCxnSpPr/>
+          <p:nvPr/>
+        </p:nvCxnSpPr>
+        <p:spPr>
+          <a:xfrm>
+            <a:off x="6720840" y="2217420"/>
+            <a:ext cx="182880" cy="0"/>
+          </a:xfrm>
+          <a:prstGeom prst="line">
+            <a:avLst/>
+          </a:prstGeom>
+          <a:ln w="28575">
+            <a:solidFill>
+              <a:srgbClr val="8E6F3E"/>
+            </a:solidFill>
+            <a:tailEnd type="triangle" w="med" len="med"/>
+          </a:ln>
+          <a:effectLst/>
+        </p:spPr>
+        <p:style>
+          <a:lnRef idx="2">
+            <a:schemeClr val="accent1"/>
+          </a:lnRef>
+          <a:fillRef idx="0">
+            <a:schemeClr val="accent1"/>
+          </a:fillRef>
+          <a:effectRef idx="1">
+            <a:schemeClr val="accent1"/>
+          </a:effectRef>
+          <a:fontRef idx="minor">
+            <a:schemeClr val="tx1"/>
+          </a:fontRef>
+        </p:style>
+      </p:cxnSp>
+      <p:sp>
+        <p:nvSpPr>
+          <p:cNvPr id="14" name="PCPROPOSE"/>
+          <p:cNvSpPr/>
+          <p:nvPr/>
+        </p:nvSpPr>
+        <p:spPr>
+          <a:xfrm>
+            <a:off x="6903720" y="1920240"/>
+            <a:ext cx="1417320" cy="594360"/>
+          </a:xfrm>
+          <a:prstGeom prst="rect">
+            <a:avLst/>
+          </a:prstGeom>
+          <a:solidFill>
+            <a:srgbClr val="F5F1E8"/>
+          </a:solidFill>
+          <a:ln w="12700">
+            <a:solidFill>
+              <a:srgbClr val="C9B991"/>
+            </a:solidFill>
+          </a:ln>
+          <a:effectLst/>
+        </p:spPr>
+        <p:style>
+          <a:lnRef idx="1">
+            <a:schemeClr val="accent1"/>
+          </a:lnRef>
+          <a:fillRef idx="3">
+            <a:schemeClr val="accent1"/>
+          </a:fillRef>
+          <a:effectRef idx="2">
+            <a:schemeClr val="accent1"/>
+          </a:effectRef>
+          <a:fontRef idx="minor">
+            <a:schemeClr val="lt1"/>
+          </a:fontRef>
+        </p:style>
+        <p:txBody>
+          <a:bodyPr rtlCol="0" anchor="ctr" wrap="square" lIns="27432" rIns="27432" tIns="22860" bIns="22860"/>
+          <a:lstStyle/>
+          <a:p>
+            <a:pPr algn="ctr"/>
+            <a:r>
+              <a:rPr sz="1500" b="1" i="0">
+                <a:solidFill>
+                  <a:srgbClr val="5C4826"/>
+                </a:solidFill>
+              </a:rPr>
+              <a:t>PROPOSE</a:t>
+            </a:r>
+          </a:p>
+        </p:txBody>
+      </p:sp>
+      <p:cxnSp>
+        <p:nvCxnSpPr>
+          <p:cNvPr id="15" name="Connector 14"/>
+          <p:cNvCxnSpPr/>
+          <p:nvPr/>
+        </p:nvCxnSpPr>
+        <p:spPr>
+          <a:xfrm>
+            <a:off x="4411980" y="2514600"/>
+            <a:ext cx="0" cy="274320"/>
+          </a:xfrm>
+          <a:prstGeom prst="line">
+            <a:avLst/>
+          </a:prstGeom>
+          <a:ln w="19050">
+            <a:solidFill>
+              <a:srgbClr val="C9B991"/>
+            </a:solidFill>
+          </a:ln>
+          <a:effectLst/>
+        </p:spPr>
+        <p:style>
+          <a:lnRef idx="2">
+            <a:schemeClr val="accent1"/>
+          </a:lnRef>
+          <a:fillRef idx="0">
+            <a:schemeClr val="accent1"/>
+          </a:fillRef>
+          <a:effectRef idx="1">
+            <a:schemeClr val="accent1"/>
+          </a:effectRef>
+          <a:fontRef idx="minor">
+            <a:schemeClr val="tx1"/>
+          </a:fontRef>
+        </p:style>
+      </p:cxnSp>
+      <p:cxnSp>
+        <p:nvCxnSpPr>
+          <p:cNvPr id="16" name="Connector 15"/>
+          <p:cNvCxnSpPr/>
+          <p:nvPr/>
+        </p:nvCxnSpPr>
+        <p:spPr>
+          <a:xfrm flipH="1">
+            <a:off x="2811779" y="2788920"/>
+            <a:ext cx="1600201" cy="0"/>
+          </a:xfrm>
+          <a:prstGeom prst="line">
+            <a:avLst/>
+          </a:prstGeom>
+          <a:ln w="19050">
+            <a:solidFill>
+              <a:srgbClr val="C9B991"/>
+            </a:solidFill>
+          </a:ln>
+          <a:effectLst/>
+        </p:spPr>
+        <p:style>
+          <a:lnRef idx="2">
+            <a:schemeClr val="accent1"/>
+          </a:lnRef>
+          <a:fillRef idx="0">
+            <a:schemeClr val="accent1"/>
+          </a:fillRef>
+          <a:effectRef idx="1">
+            <a:schemeClr val="accent1"/>
+          </a:effectRef>
+          <a:fontRef idx="minor">
+            <a:schemeClr val="tx1"/>
+          </a:fontRef>
+        </p:style>
+      </p:cxnSp>
+      <p:cxnSp>
+        <p:nvCxnSpPr>
+          <p:cNvPr id="17" name="Connector 16"/>
+          <p:cNvCxnSpPr/>
+          <p:nvPr/>
+        </p:nvCxnSpPr>
+        <p:spPr>
+          <a:xfrm flipV="1">
+            <a:off x="2811779" y="2551176"/>
+            <a:ext cx="0" cy="237744"/>
+          </a:xfrm>
+          <a:prstGeom prst="line">
+            <a:avLst/>
+          </a:prstGeom>
+          <a:ln w="19050">
+            <a:solidFill>
+              <a:srgbClr val="C9B991"/>
+            </a:solidFill>
+            <a:tailEnd type="triangle" w="med" len="med"/>
+          </a:ln>
+          <a:effectLst/>
+        </p:spPr>
+        <p:style>
+          <a:lnRef idx="2">
+            <a:schemeClr val="accent1"/>
+          </a:lnRef>
+          <a:fillRef idx="0">
+            <a:schemeClr val="accent1"/>
+          </a:fillRef>
+          <a:effectRef idx="1">
+            <a:schemeClr val="accent1"/>
+          </a:effectRef>
+          <a:fontRef idx="minor">
+            <a:schemeClr val="tx1"/>
+          </a:fontRef>
+        </p:style>
+      </p:cxnSp>
+      <p:cxnSp>
+        <p:nvCxnSpPr>
+          <p:cNvPr id="18" name="Connector 17"/>
+          <p:cNvCxnSpPr/>
+          <p:nvPr/>
+        </p:nvCxnSpPr>
+        <p:spPr>
+          <a:xfrm>
+            <a:off x="7612379" y="2514600"/>
+            <a:ext cx="0" cy="521208"/>
+          </a:xfrm>
+          <a:prstGeom prst="line">
+            <a:avLst/>
+          </a:prstGeom>
+          <a:ln w="28575">
+            <a:solidFill>
+              <a:srgbClr val="8E6F3E"/>
+            </a:solidFill>
+            <a:tailEnd type="triangle" w="med" len="med"/>
+          </a:ln>
+          <a:effectLst/>
+        </p:spPr>
+        <p:style>
+          <a:lnRef idx="2">
+            <a:schemeClr val="accent1"/>
+          </a:lnRef>
+          <a:fillRef idx="0">
+            <a:schemeClr val="accent1"/>
+          </a:fillRef>
+          <a:effectRef idx="1">
+            <a:schemeClr val="accent1"/>
+          </a:effectRef>
+          <a:fontRef idx="minor">
+            <a:schemeClr val="tx1"/>
+          </a:fontRef>
+        </p:style>
+      </p:cxnSp>
+      <p:sp>
+        <p:nvSpPr>
+          <p:cNvPr id="19" name="PCOutcome"/>
+          <p:cNvSpPr/>
+          <p:nvPr/>
+        </p:nvSpPr>
+        <p:spPr>
+          <a:xfrm>
+            <a:off x="6903720" y="3054096"/>
+            <a:ext cx="1920240" cy="548640"/>
+          </a:xfrm>
+          <a:prstGeom prst="rect">
+            <a:avLst/>
+          </a:prstGeom>
+          <a:solidFill>
+            <a:srgbClr val="8E6F3E"/>
+          </a:solidFill>
+          <a:ln>
+            <a:noFill/>
+          </a:ln>
+          <a:effectLst/>
+        </p:spPr>
+        <p:style>
+          <a:lnRef idx="1">
+            <a:schemeClr val="accent1"/>
+          </a:lnRef>
+          <a:fillRef idx="3">
+            <a:schemeClr val="accent1"/>
+          </a:fillRef>
+          <a:effectRef idx="2">
+            <a:schemeClr val="accent1"/>
+          </a:effectRef>
+          <a:fontRef idx="minor">
+            <a:schemeClr val="lt1"/>
+          </a:fontRef>
+        </p:style>
+        <p:txBody>
+          <a:bodyPr rtlCol="0" anchor="ctr" wrap="square" lIns="27432" rIns="27432" tIns="22860" bIns="22860"/>
+          <a:lstStyle/>
+          <a:p>
+            <a:pPr algn="ctr"/>
+            <a:r>
+              <a:rPr sz="1500" b="1" i="0">
+                <a:solidFill>
+                  <a:srgbClr val="FFFFFF"/>
+                </a:solidFill>
+              </a:rPr>
+              <a:t>acceptable work?</a:t>
+            </a:r>
+          </a:p>
+        </p:txBody>
+      </p:sp>
+      <p:sp>
+        <p:nvSpPr>
+          <p:cNvPr id="20" name="FooterBand"/>
+          <p:cNvSpPr/>
+          <p:nvPr/>
+        </p:nvSpPr>
+        <p:spPr>
+          <a:xfrm>
+            <a:off x="274320" y="5852160"/>
+            <a:ext cx="8595360" cy="566928"/>
+          </a:xfrm>
+          <a:prstGeom prst="rect">
+            <a:avLst/>
+          </a:prstGeom>
+          <a:solidFill>
+            <a:srgbClr val="8E6F3E"/>
+          </a:solidFill>
+          <a:ln>
+            <a:noFill/>
+          </a:ln>
+          <a:effectLst/>
+        </p:spPr>
+        <p:style>
+          <a:lnRef idx="1">
+            <a:schemeClr val="accent1"/>
+          </a:lnRef>
+          <a:fillRef idx="3">
+            <a:schemeClr val="accent1"/>
+          </a:fillRef>
+          <a:effectRef idx="2">
+            <a:schemeClr val="accent1"/>
+          </a:effectRef>
+          <a:fontRef idx="minor">
+            <a:schemeClr val="lt1"/>
+          </a:fontRef>
+        </p:style>
+        <p:txBody>
+          <a:bodyPr rtlCol="0" anchor="ctr" wrap="square" lIns="27432" rIns="27432" tIns="22860" bIns="22860"/>
+          <a:lstStyle/>
+          <a:p>
+            <a:pPr algn="ctr"/>
+            <a:r>
+              <a:rPr sz="1600" b="1" i="0">
+                <a:solidFill>
+                  <a:srgbClr val="FFFFFF"/>
+                </a:solidFill>
+              </a:rPr>
+              <a:t>If we want to control delegated work,</a:t>
+            </a:r>
+          </a:p>
+          <a:p>
+            <a:pPr algn="ctr"/>
+            <a:r>
+              <a:rPr sz="1600" b="1" i="0">
+                <a:solidFill>
+                  <a:srgbClr val="FFFFFF"/>
+                </a:solidFill>
+              </a:rPr>
+              <a:t>we need a model of how it can fail.</a:t>
+            </a:r>
+          </a:p>
+        </p:txBody>
+      </p:sp>
+    </p:spTree>
+  </p:cSld>
+  <p:clrMapOvr>
+    <a:masterClrMapping/>
+  </p:clrMapOvr>
+</p:sld>
+</file>
+
+<file path=ppt/slides/slide35.xml><?xml version="1.0" encoding="utf-8"?>
+<p:sld xmlns:a="http://schemas.openxmlformats.org/drawingml/2006/main" xmlns:p="http://schemas.openxmlformats.org/presentationml/2006/main" xmlns:r="http://schemas.openxmlformats.org/officeDocument/2006/relationships">
+  <p:cSld>
+    <p:spTree>
+      <p:nvGrpSpPr>
+        <p:cNvPr id="1" name=""/>
+        <p:cNvGrpSpPr/>
+        <p:nvPr/>
+      </p:nvGrpSpPr>
+      <p:grpSpPr/>
+      <p:sp>
+        <p:nvSpPr>
+          <p:cNvPr id="2" name="Content Placeholder 1"/>
+          <p:cNvSpPr>
+            <a:spLocks noGrp="1"/>
+          </p:cNvSpPr>
+          <p:nvPr>
+            <p:ph idx="1"/>
+          </p:nvPr>
+        </p:nvSpPr>
+        <p:spPr/>
+        <p:txBody>
+          <a:bodyPr/>
+          <a:lstStyle/>
+          <a:p/>
+        </p:txBody>
+      </p:sp>
+      <p:sp>
+        <p:nvSpPr>
+          <p:cNvPr id="3" name="Title 2"/>
+          <p:cNvSpPr>
+            <a:spLocks noGrp="1"/>
+          </p:cNvSpPr>
+          <p:nvPr>
+            <p:ph type="title"/>
+          </p:nvPr>
+        </p:nvSpPr>
+        <p:spPr/>
+        <p:txBody>
+          <a:bodyPr/>
+          <a:lstStyle/>
+          <a:p>
+            <a:r>
+              <a:rPr sz="2400"/>
+              <a:t>The result can be wrong</a:t>
+            </a:r>
+          </a:p>
+        </p:txBody>
+      </p:sp>
+      <p:sp>
+        <p:nvSpPr>
+          <p:cNvPr id="4" name="Example"/>
+          <p:cNvSpPr txBox="1"/>
+          <p:nvPr/>
+        </p:nvSpPr>
+        <p:spPr>
+          <a:xfrm>
+            <a:off x="274320" y="932688"/>
+            <a:ext cx="8595360" cy="640080"/>
+          </a:xfrm>
+          <a:prstGeom prst="rect">
+            <a:avLst/>
+          </a:prstGeom>
+          <a:noFill/>
+        </p:spPr>
+        <p:txBody>
+          <a:bodyPr wrap="square" anchor="t">
+            <a:spAutoFit/>
+          </a:bodyPr>
+          <a:lstStyle/>
+          <a:p>
+            <a:pPr algn="l"/>
+            <a:r>
+              <a:rPr sz="1700" b="0" i="1">
+                <a:solidFill>
+                  <a:srgbClr val="555960"/>
+                </a:solidFill>
+              </a:rPr>
+              <a:t>Requirement: existing clients continue to behave identically.</a:t>
+            </a:r>
+          </a:p>
+          <a:p>
+            <a:pPr algn="l"/>
+            <a:r>
+              <a:rPr sz="1700" b="0" i="1">
+                <a:solidFill>
+                  <a:srgbClr val="555960"/>
+                </a:solidFill>
+              </a:rPr>
+              <a:t>The agent changes response semantics.</a:t>
+            </a:r>
+          </a:p>
+        </p:txBody>
+      </p:sp>
+      <p:sp>
+        <p:nvSpPr>
+          <p:cNvPr id="5" name="FRequest"/>
+          <p:cNvSpPr/>
+          <p:nvPr/>
+        </p:nvSpPr>
+        <p:spPr>
+          <a:xfrm>
+            <a:off x="1097280" y="1965960"/>
+            <a:ext cx="1737360" cy="566928"/>
+          </a:xfrm>
+          <a:prstGeom prst="rect">
+            <a:avLst/>
+          </a:prstGeom>
+          <a:solidFill>
+            <a:srgbClr val="F5F1E8"/>
+          </a:solidFill>
+          <a:ln w="12700">
+            <a:solidFill>
+              <a:srgbClr val="C9B991"/>
+            </a:solidFill>
+          </a:ln>
+          <a:effectLst/>
+        </p:spPr>
+        <p:style>
+          <a:lnRef idx="1">
+            <a:schemeClr val="accent1"/>
+          </a:lnRef>
+          <a:fillRef idx="3">
+            <a:schemeClr val="accent1"/>
+          </a:fillRef>
+          <a:effectRef idx="2">
+            <a:schemeClr val="accent1"/>
+          </a:effectRef>
+          <a:fontRef idx="minor">
+            <a:schemeClr val="lt1"/>
+          </a:fontRef>
+        </p:style>
+        <p:txBody>
+          <a:bodyPr rtlCol="0" anchor="ctr" wrap="square" lIns="27432" rIns="27432" tIns="22860" bIns="22860"/>
+          <a:lstStyle/>
+          <a:p>
+            <a:pPr algn="ctr"/>
+            <a:r>
+              <a:rPr sz="1500" b="1" i="0">
+                <a:solidFill>
+                  <a:srgbClr val="5C4826"/>
+                </a:solidFill>
+              </a:rPr>
+              <a:t>REQUEST</a:t>
+            </a:r>
+          </a:p>
+        </p:txBody>
+      </p:sp>
+      <p:cxnSp>
+        <p:nvCxnSpPr>
+          <p:cNvPr id="6" name="Connector 5"/>
+          <p:cNvCxnSpPr/>
+          <p:nvPr/>
+        </p:nvCxnSpPr>
+        <p:spPr>
+          <a:xfrm>
+            <a:off x="2834640" y="2249424"/>
+            <a:ext cx="411480" cy="0"/>
+          </a:xfrm>
+          <a:prstGeom prst="line">
+            <a:avLst/>
+          </a:prstGeom>
+          <a:ln w="28575">
+            <a:solidFill>
+              <a:srgbClr val="8E6F3E"/>
+            </a:solidFill>
+            <a:tailEnd type="triangle" w="med" len="med"/>
+          </a:ln>
+          <a:effectLst/>
+        </p:spPr>
+        <p:style>
+          <a:lnRef idx="2">
+            <a:schemeClr val="accent1"/>
+          </a:lnRef>
+          <a:fillRef idx="0">
+            <a:schemeClr val="accent1"/>
+          </a:fillRef>
+          <a:effectRef idx="1">
+            <a:schemeClr val="accent1"/>
+          </a:effectRef>
+          <a:fontRef idx="minor">
+            <a:schemeClr val="tx1"/>
+          </a:fontRef>
+        </p:style>
+      </p:cxnSp>
+      <p:sp>
+        <p:nvSpPr>
+          <p:cNvPr id="7" name="FImpl"/>
+          <p:cNvSpPr/>
+          <p:nvPr/>
+        </p:nvSpPr>
+        <p:spPr>
+          <a:xfrm>
+            <a:off x="3246120" y="1965960"/>
+            <a:ext cx="2194560" cy="566928"/>
+          </a:xfrm>
+          <a:prstGeom prst="rect">
+            <a:avLst/>
+          </a:prstGeom>
+          <a:solidFill>
+            <a:srgbClr val="F5F1E8"/>
+          </a:solidFill>
+          <a:ln w="12700">
+            <a:solidFill>
+              <a:srgbClr val="C9B991"/>
+            </a:solidFill>
+          </a:ln>
+          <a:effectLst/>
+        </p:spPr>
+        <p:style>
+          <a:lnRef idx="1">
+            <a:schemeClr val="accent1"/>
+          </a:lnRef>
+          <a:fillRef idx="3">
+            <a:schemeClr val="accent1"/>
+          </a:fillRef>
+          <a:effectRef idx="2">
+            <a:schemeClr val="accent1"/>
+          </a:effectRef>
+          <a:fontRef idx="minor">
+            <a:schemeClr val="lt1"/>
+          </a:fontRef>
+        </p:style>
+        <p:txBody>
+          <a:bodyPr rtlCol="0" anchor="ctr" wrap="square" lIns="27432" rIns="27432" tIns="22860" bIns="22860"/>
+          <a:lstStyle/>
+          <a:p>
+            <a:pPr algn="ctr"/>
+            <a:r>
+              <a:rPr sz="1400" b="1" i="0">
+                <a:solidFill>
+                  <a:srgbClr val="5C4826"/>
+                </a:solidFill>
+              </a:rPr>
+              <a:t>IMPLEMENTATION</a:t>
+            </a:r>
+          </a:p>
+        </p:txBody>
+      </p:sp>
+      <p:cxnSp>
+        <p:nvCxnSpPr>
+          <p:cNvPr id="8" name="Connector 7"/>
+          <p:cNvCxnSpPr/>
+          <p:nvPr/>
+        </p:nvCxnSpPr>
+        <p:spPr>
+          <a:xfrm>
+            <a:off x="4343400" y="2532888"/>
+            <a:ext cx="0" cy="484632"/>
+          </a:xfrm>
+          <a:prstGeom prst="line">
+            <a:avLst/>
+          </a:prstGeom>
+          <a:ln w="28575">
+            <a:solidFill>
+              <a:srgbClr val="8E6F3E"/>
+            </a:solidFill>
+          </a:ln>
+          <a:effectLst/>
+        </p:spPr>
+        <p:style>
+          <a:lnRef idx="2">
+            <a:schemeClr val="accent1"/>
+          </a:lnRef>
+          <a:fillRef idx="0">
+            <a:schemeClr val="accent1"/>
+          </a:fillRef>
+          <a:effectRef idx="1">
+            <a:schemeClr val="accent1"/>
+          </a:effectRef>
+          <a:fontRef idx="minor">
+            <a:schemeClr val="tx1"/>
+          </a:fontRef>
+        </p:style>
+      </p:cxnSp>
+      <p:sp>
+        <p:nvSpPr>
+          <p:cNvPr id="9" name="FX"/>
+          <p:cNvSpPr txBox="1"/>
+          <p:nvPr/>
+        </p:nvSpPr>
+        <p:spPr>
+          <a:xfrm>
+            <a:off x="4114800" y="2788920"/>
+            <a:ext cx="457200" cy="384048"/>
+          </a:xfrm>
+          <a:prstGeom prst="rect">
+            <a:avLst/>
+          </a:prstGeom>
+          <a:noFill/>
+        </p:spPr>
+        <p:txBody>
+          <a:bodyPr wrap="square" anchor="t">
+            <a:spAutoFit/>
+          </a:bodyPr>
+          <a:lstStyle/>
+          <a:p>
+            <a:pPr algn="ctr"/>
+            <a:r>
+              <a:rPr sz="2400" b="1" i="0">
+                <a:solidFill>
+                  <a:srgbClr val="5C4826"/>
+                </a:solidFill>
+              </a:rPr>
+              <a:t>✗</a:t>
+            </a:r>
+          </a:p>
+        </p:txBody>
+      </p:sp>
+      <p:sp>
+        <p:nvSpPr>
+          <p:cNvPr id="10" name="FReq"/>
+          <p:cNvSpPr txBox="1"/>
+          <p:nvPr/>
+        </p:nvSpPr>
+        <p:spPr>
+          <a:xfrm>
+            <a:off x="3291840" y="3246120"/>
+            <a:ext cx="2103120" cy="365760"/>
+          </a:xfrm>
+          <a:prstGeom prst="rect">
+            <a:avLst/>
+          </a:prstGeom>
+          <a:noFill/>
+        </p:spPr>
+        <p:txBody>
+          <a:bodyPr wrap="square" anchor="t">
+            <a:spAutoFit/>
+          </a:bodyPr>
+          <a:lstStyle/>
+          <a:p>
+            <a:pPr algn="ctr"/>
+            <a:r>
+              <a:rPr sz="1500" b="0" i="0">
+                <a:solidFill>
+                  <a:srgbClr val="555960"/>
+                </a:solidFill>
+              </a:rPr>
+              <a:t>required behavior</a:t>
+            </a:r>
+          </a:p>
+        </p:txBody>
+      </p:sp>
+      <p:sp>
+        <p:nvSpPr>
+          <p:cNvPr id="11" name="FailLabel"/>
+          <p:cNvSpPr/>
+          <p:nvPr/>
+        </p:nvSpPr>
+        <p:spPr>
+          <a:xfrm>
+            <a:off x="502920" y="4069080"/>
+            <a:ext cx="2560320" cy="594360"/>
+          </a:xfrm>
+          <a:prstGeom prst="rect">
+            <a:avLst/>
+          </a:prstGeom>
+          <a:solidFill>
+            <a:srgbClr val="8E6F3E"/>
+          </a:solidFill>
+          <a:ln>
+            <a:noFill/>
+          </a:ln>
+          <a:effectLst/>
+        </p:spPr>
+        <p:style>
+          <a:lnRef idx="1">
+            <a:schemeClr val="accent1"/>
+          </a:lnRef>
+          <a:fillRef idx="3">
+            <a:schemeClr val="accent1"/>
+          </a:fillRef>
+          <a:effectRef idx="2">
+            <a:schemeClr val="accent1"/>
+          </a:effectRef>
+          <a:fontRef idx="minor">
+            <a:schemeClr val="lt1"/>
+          </a:fontRef>
+        </p:style>
+        <p:txBody>
+          <a:bodyPr rtlCol="0" anchor="ctr" wrap="square" lIns="27432" rIns="27432" tIns="22860" bIns="22860"/>
+          <a:lstStyle/>
+          <a:p>
+            <a:pPr algn="ctr"/>
+            <a:r>
+              <a:rPr sz="1500" b="1" i="0">
+                <a:solidFill>
+                  <a:srgbClr val="FFFFFF"/>
+                </a:solidFill>
+              </a:rPr>
+              <a:t>ARTIFACT FAILURE</a:t>
+            </a:r>
+          </a:p>
+        </p:txBody>
+      </p:sp>
+      <p:sp>
+        <p:nvSpPr>
+          <p:cNvPr id="12" name="FailDef"/>
+          <p:cNvSpPr txBox="1"/>
+          <p:nvPr/>
+        </p:nvSpPr>
+        <p:spPr>
+          <a:xfrm>
+            <a:off x="3246120" y="4133087"/>
+            <a:ext cx="5394960" cy="502920"/>
+          </a:xfrm>
+          <a:prstGeom prst="rect">
+            <a:avLst/>
+          </a:prstGeom>
+          <a:noFill/>
+        </p:spPr>
+        <p:txBody>
+          <a:bodyPr wrap="square" anchor="t">
+            <a:spAutoFit/>
+          </a:bodyPr>
+          <a:lstStyle/>
+          <a:p>
+            <a:pPr algn="l"/>
+            <a:r>
+              <a:rPr sz="2000" b="0" i="0">
+                <a:solidFill>
+                  <a:srgbClr val="5C4826"/>
+                </a:solidFill>
+              </a:rPr>
+              <a:t>The resulting system violates an obligation.</a:t>
+            </a:r>
+          </a:p>
+        </p:txBody>
+      </p:sp>
+      <p:sp>
+        <p:nvSpPr>
+          <p:cNvPr id="13" name="FailKinds"/>
+          <p:cNvSpPr txBox="1"/>
+          <p:nvPr/>
+        </p:nvSpPr>
+        <p:spPr>
+          <a:xfrm>
+            <a:off x="274320" y="4983480"/>
+            <a:ext cx="8595360" cy="365760"/>
+          </a:xfrm>
+          <a:prstGeom prst="rect">
+            <a:avLst/>
+          </a:prstGeom>
+          <a:noFill/>
+        </p:spPr>
+        <p:txBody>
+          <a:bodyPr wrap="square" anchor="t">
+            <a:spAutoFit/>
+          </a:bodyPr>
+          <a:lstStyle/>
+          <a:p>
+            <a:pPr algn="ctr"/>
+            <a:r>
+              <a:rPr sz="1500" b="0" i="1">
+                <a:solidFill>
+                  <a:srgbClr val="555960"/>
+                </a:solidFill>
+              </a:rPr>
+              <a:t>wrong behavior · violated invariant · excessive memory · incompatible API</a:t>
+            </a:r>
+          </a:p>
+        </p:txBody>
+      </p:sp>
+    </p:spTree>
+  </p:cSld>
+  <p:clrMapOvr>
+    <a:masterClrMapping/>
+  </p:clrMapOvr>
+</p:sld>
+</file>
+
+<file path=ppt/slides/slide36.xml><?xml version="1.0" encoding="utf-8"?>
+<p:sld xmlns:a="http://schemas.openxmlformats.org/drawingml/2006/main" xmlns:p="http://schemas.openxmlformats.org/presentationml/2006/main" xmlns:r="http://schemas.openxmlformats.org/officeDocument/2006/relationships">
+  <p:cSld>
+    <p:spTree>
+      <p:nvGrpSpPr>
+        <p:cNvPr id="1" name=""/>
+        <p:cNvGrpSpPr/>
+        <p:nvPr/>
+      </p:nvGrpSpPr>
+      <p:grpSpPr/>
+      <p:sp>
+        <p:nvSpPr>
+          <p:cNvPr id="2" name="Content Placeholder 1"/>
+          <p:cNvSpPr>
+            <a:spLocks noGrp="1"/>
+          </p:cNvSpPr>
+          <p:nvPr>
+            <p:ph idx="1"/>
+          </p:nvPr>
+        </p:nvSpPr>
+        <p:spPr/>
+        <p:txBody>
+          <a:bodyPr/>
+          <a:lstStyle/>
+          <a:p/>
+        </p:txBody>
+      </p:sp>
+      <p:sp>
+        <p:nvSpPr>
+          <p:cNvPr id="3" name="Title 2"/>
+          <p:cNvSpPr>
+            <a:spLocks noGrp="1"/>
+          </p:cNvSpPr>
+          <p:nvPr>
+            <p:ph type="title"/>
+          </p:nvPr>
+        </p:nvSpPr>
+        <p:spPr/>
+        <p:txBody>
+          <a:bodyPr/>
+          <a:lstStyle/>
+          <a:p>
+            <a:r>
+              <a:rPr sz="2400"/>
+              <a:t>The agent can do the wrong work</a:t>
+            </a:r>
+          </a:p>
+        </p:txBody>
+      </p:sp>
+      <p:sp>
+        <p:nvSpPr>
+          <p:cNvPr id="4" name="WrongWork1"/>
+          <p:cNvSpPr/>
+          <p:nvPr/>
+        </p:nvSpPr>
+        <p:spPr>
+          <a:xfrm>
+            <a:off x="502920" y="1005840"/>
+            <a:ext cx="8138160" cy="566928"/>
+          </a:xfrm>
+          <a:prstGeom prst="rect">
+            <a:avLst/>
+          </a:prstGeom>
+          <a:solidFill>
+            <a:srgbClr val="F5F1E8"/>
+          </a:solidFill>
+          <a:ln w="12700">
+            <a:solidFill>
+              <a:srgbClr val="C9B991"/>
+            </a:solidFill>
+          </a:ln>
+          <a:effectLst/>
+        </p:spPr>
+        <p:style>
+          <a:lnRef idx="1">
+            <a:schemeClr val="accent1"/>
+          </a:lnRef>
+          <a:fillRef idx="3">
+            <a:schemeClr val="accent1"/>
+          </a:fillRef>
+          <a:effectRef idx="2">
+            <a:schemeClr val="accent1"/>
+          </a:effectRef>
+          <a:fontRef idx="minor">
+            <a:schemeClr val="lt1"/>
+          </a:fontRef>
+        </p:style>
+        <p:txBody>
+          <a:bodyPr rtlCol="0" anchor="ctr" wrap="square" lIns="27432" rIns="27432" tIns="22860" bIns="22860"/>
+          <a:lstStyle/>
+          <a:p>
+            <a:pPr algn="l"/>
+            <a:r>
+              <a:rPr sz="1700" b="0" i="0">
+                <a:solidFill>
+                  <a:srgbClr val="5C4826"/>
+                </a:solidFill>
+              </a:rPr>
+              <a:t>Modifies files outside the declared scope</a:t>
+            </a:r>
+          </a:p>
+        </p:txBody>
+      </p:sp>
+      <p:sp>
+        <p:nvSpPr>
+          <p:cNvPr id="5" name="WrongWork2"/>
+          <p:cNvSpPr/>
+          <p:nvPr/>
+        </p:nvSpPr>
+        <p:spPr>
+          <a:xfrm>
+            <a:off x="502920" y="1737360"/>
+            <a:ext cx="8138160" cy="566928"/>
+          </a:xfrm>
+          <a:prstGeom prst="rect">
+            <a:avLst/>
+          </a:prstGeom>
+          <a:solidFill>
+            <a:srgbClr val="F5F1E8"/>
+          </a:solidFill>
+          <a:ln w="12700">
+            <a:solidFill>
+              <a:srgbClr val="C9B991"/>
+            </a:solidFill>
+          </a:ln>
+          <a:effectLst/>
+        </p:spPr>
+        <p:style>
+          <a:lnRef idx="1">
+            <a:schemeClr val="accent1"/>
+          </a:lnRef>
+          <a:fillRef idx="3">
+            <a:schemeClr val="accent1"/>
+          </a:fillRef>
+          <a:effectRef idx="2">
+            <a:schemeClr val="accent1"/>
+          </a:effectRef>
+          <a:fontRef idx="minor">
+            <a:schemeClr val="lt1"/>
+          </a:fontRef>
+        </p:style>
+        <p:txBody>
+          <a:bodyPr rtlCol="0" anchor="ctr" wrap="square" lIns="27432" rIns="27432" tIns="22860" bIns="22860"/>
+          <a:lstStyle/>
+          <a:p>
+            <a:pPr algn="l"/>
+            <a:r>
+              <a:rPr sz="1700" b="0" i="0">
+                <a:solidFill>
+                  <a:srgbClr val="5C4826"/>
+                </a:solidFill>
+              </a:rPr>
+              <a:t>Replaces an approved dependency</a:t>
+            </a:r>
+          </a:p>
+        </p:txBody>
+      </p:sp>
+      <p:sp>
+        <p:nvSpPr>
+          <p:cNvPr id="6" name="WrongWork3"/>
+          <p:cNvSpPr/>
+          <p:nvPr/>
+        </p:nvSpPr>
+        <p:spPr>
+          <a:xfrm>
+            <a:off x="502920" y="2468880"/>
+            <a:ext cx="8138160" cy="566928"/>
+          </a:xfrm>
+          <a:prstGeom prst="rect">
+            <a:avLst/>
+          </a:prstGeom>
+          <a:solidFill>
+            <a:srgbClr val="F5F1E8"/>
+          </a:solidFill>
+          <a:ln w="12700">
+            <a:solidFill>
+              <a:srgbClr val="C9B991"/>
+            </a:solidFill>
+          </a:ln>
+          <a:effectLst/>
+        </p:spPr>
+        <p:style>
+          <a:lnRef idx="1">
+            <a:schemeClr val="accent1"/>
+          </a:lnRef>
+          <a:fillRef idx="3">
+            <a:schemeClr val="accent1"/>
+          </a:fillRef>
+          <a:effectRef idx="2">
+            <a:schemeClr val="accent1"/>
+          </a:effectRef>
+          <a:fontRef idx="minor">
+            <a:schemeClr val="lt1"/>
+          </a:fontRef>
+        </p:style>
+        <p:txBody>
+          <a:bodyPr rtlCol="0" anchor="ctr" wrap="square" lIns="27432" rIns="27432" tIns="22860" bIns="22860"/>
+          <a:lstStyle/>
+          <a:p>
+            <a:pPr algn="l"/>
+            <a:r>
+              <a:rPr sz="1700" b="0" i="0">
+                <a:solidFill>
+                  <a:srgbClr val="5C4826"/>
+                </a:solidFill>
+              </a:rPr>
+              <a:t>Changes the model instead of satisfying it</a:t>
+            </a:r>
+          </a:p>
+        </p:txBody>
+      </p:sp>
+      <p:sp>
+        <p:nvSpPr>
+          <p:cNvPr id="7" name="WrongWork4"/>
+          <p:cNvSpPr/>
+          <p:nvPr/>
+        </p:nvSpPr>
+        <p:spPr>
+          <a:xfrm>
+            <a:off x="502920" y="3200400"/>
+            <a:ext cx="8138160" cy="566928"/>
+          </a:xfrm>
+          <a:prstGeom prst="rect">
+            <a:avLst/>
+          </a:prstGeom>
+          <a:solidFill>
+            <a:srgbClr val="F5F1E8"/>
+          </a:solidFill>
+          <a:ln w="12700">
+            <a:solidFill>
+              <a:srgbClr val="C9B991"/>
+            </a:solidFill>
+          </a:ln>
+          <a:effectLst/>
+        </p:spPr>
+        <p:style>
+          <a:lnRef idx="1">
+            <a:schemeClr val="accent1"/>
+          </a:lnRef>
+          <a:fillRef idx="3">
+            <a:schemeClr val="accent1"/>
+          </a:fillRef>
+          <a:effectRef idx="2">
+            <a:schemeClr val="accent1"/>
+          </a:effectRef>
+          <a:fontRef idx="minor">
+            <a:schemeClr val="lt1"/>
+          </a:fontRef>
+        </p:style>
+        <p:txBody>
+          <a:bodyPr rtlCol="0" anchor="ctr" wrap="square" lIns="27432" rIns="27432" tIns="22860" bIns="22860"/>
+          <a:lstStyle/>
+          <a:p>
+            <a:pPr algn="l"/>
+            <a:r>
+              <a:rPr sz="1700" b="0" i="0">
+                <a:solidFill>
+                  <a:srgbClr val="5C4826"/>
+                </a:solidFill>
+              </a:rPr>
+              <a:t>“Fixes” a test to make the implementation pass</a:t>
+            </a:r>
+          </a:p>
+        </p:txBody>
+      </p:sp>
+      <p:sp>
+        <p:nvSpPr>
+          <p:cNvPr id="8" name="ScopeLabel"/>
+          <p:cNvSpPr/>
+          <p:nvPr/>
+        </p:nvSpPr>
+        <p:spPr>
+          <a:xfrm>
+            <a:off x="502920" y="4160520"/>
+            <a:ext cx="3108960" cy="594360"/>
+          </a:xfrm>
+          <a:prstGeom prst="rect">
+            <a:avLst/>
+          </a:prstGeom>
+          <a:solidFill>
+            <a:srgbClr val="8E6F3E"/>
+          </a:solidFill>
+          <a:ln>
+            <a:noFill/>
+          </a:ln>
+          <a:effectLst/>
+        </p:spPr>
+        <p:style>
+          <a:lnRef idx="1">
+            <a:schemeClr val="accent1"/>
+          </a:lnRef>
+          <a:fillRef idx="3">
+            <a:schemeClr val="accent1"/>
+          </a:fillRef>
+          <a:effectRef idx="2">
+            <a:schemeClr val="accent1"/>
+          </a:effectRef>
+          <a:fontRef idx="minor">
+            <a:schemeClr val="lt1"/>
+          </a:fontRef>
+        </p:style>
+        <p:txBody>
+          <a:bodyPr rtlCol="0" anchor="ctr" wrap="square" lIns="27432" rIns="27432" tIns="22860" bIns="22860"/>
+          <a:lstStyle/>
+          <a:p>
+            <a:pPr algn="ctr"/>
+            <a:r>
+              <a:rPr sz="1500" b="1" i="0">
+                <a:solidFill>
+                  <a:srgbClr val="FFFFFF"/>
+                </a:solidFill>
+              </a:rPr>
+              <a:t>SCOPE / PROCESS FAILURE</a:t>
+            </a:r>
+          </a:p>
+        </p:txBody>
+      </p:sp>
+      <p:sp>
+        <p:nvSpPr>
+          <p:cNvPr id="9" name="ScopeDef"/>
+          <p:cNvSpPr txBox="1"/>
+          <p:nvPr/>
+        </p:nvSpPr>
+        <p:spPr>
+          <a:xfrm>
+            <a:off x="3794760" y="4224528"/>
+            <a:ext cx="4846320" cy="502920"/>
+          </a:xfrm>
+          <a:prstGeom prst="rect">
+            <a:avLst/>
+          </a:prstGeom>
+          <a:noFill/>
+        </p:spPr>
+        <p:txBody>
+          <a:bodyPr wrap="square" anchor="t">
+            <a:spAutoFit/>
+          </a:bodyPr>
+          <a:lstStyle/>
+          <a:p>
+            <a:pPr algn="l"/>
+            <a:r>
+              <a:rPr sz="2000" b="0" i="0">
+                <a:solidFill>
+                  <a:srgbClr val="5C4826"/>
+                </a:solidFill>
+              </a:rPr>
+              <a:t>The path to the result violates the work order.</a:t>
+            </a:r>
+          </a:p>
+        </p:txBody>
+      </p:sp>
+      <p:sp>
+        <p:nvSpPr>
+          <p:cNvPr id="10" name="FooterBand"/>
+          <p:cNvSpPr/>
+          <p:nvPr/>
+        </p:nvSpPr>
+        <p:spPr>
+          <a:xfrm>
+            <a:off x="274320" y="5852160"/>
+            <a:ext cx="8595360" cy="566928"/>
+          </a:xfrm>
+          <a:prstGeom prst="rect">
+            <a:avLst/>
+          </a:prstGeom>
+          <a:solidFill>
+            <a:srgbClr val="8E6F3E"/>
+          </a:solidFill>
+          <a:ln>
+            <a:noFill/>
+          </a:ln>
+          <a:effectLst/>
+        </p:spPr>
+        <p:style>
+          <a:lnRef idx="1">
+            <a:schemeClr val="accent1"/>
+          </a:lnRef>
+          <a:fillRef idx="3">
+            <a:schemeClr val="accent1"/>
+          </a:fillRef>
+          <a:effectRef idx="2">
+            <a:schemeClr val="accent1"/>
+          </a:effectRef>
+          <a:fontRef idx="minor">
+            <a:schemeClr val="lt1"/>
+          </a:fontRef>
+        </p:style>
+        <p:txBody>
+          <a:bodyPr rtlCol="0" anchor="ctr" wrap="square" lIns="27432" rIns="27432" tIns="22860" bIns="22860"/>
+          <a:lstStyle/>
+          <a:p>
+            <a:pPr algn="ctr"/>
+            <a:r>
+              <a:rPr sz="2000" b="1" i="0">
+                <a:solidFill>
+                  <a:srgbClr val="FFFFFF"/>
+                </a:solidFill>
+              </a:rPr>
+              <a:t>Final-state validation alone does not capture it.</a:t>
+            </a:r>
+          </a:p>
+        </p:txBody>
+      </p:sp>
+    </p:spTree>
+  </p:cSld>
+  <p:clrMapOvr>
+    <a:masterClrMapping/>
+  </p:clrMapOvr>
+</p:sld>
+</file>
+
+<file path=ppt/slides/slide37.xml><?xml version="1.0" encoding="utf-8"?>
+<p:sld xmlns:a="http://schemas.openxmlformats.org/drawingml/2006/main" xmlns:p="http://schemas.openxmlformats.org/presentationml/2006/main" xmlns:r="http://schemas.openxmlformats.org/officeDocument/2006/relationships">
+  <p:cSld>
+    <p:spTree>
+      <p:nvGrpSpPr>
+        <p:cNvPr id="1" name=""/>
+        <p:cNvGrpSpPr/>
+        <p:nvPr/>
+      </p:nvGrpSpPr>
+      <p:grpSpPr/>
+      <p:sp>
+        <p:nvSpPr>
+          <p:cNvPr id="2" name="Content Placeholder 1"/>
+          <p:cNvSpPr>
+            <a:spLocks noGrp="1"/>
+          </p:cNvSpPr>
+          <p:nvPr>
+            <p:ph idx="1"/>
+          </p:nvPr>
+        </p:nvSpPr>
+        <p:spPr/>
+        <p:txBody>
+          <a:bodyPr/>
+          <a:lstStyle/>
+          <a:p/>
+        </p:txBody>
+      </p:sp>
+      <p:sp>
+        <p:nvSpPr>
+          <p:cNvPr id="3" name="Title 2"/>
+          <p:cNvSpPr>
+            <a:spLocks noGrp="1"/>
+          </p:cNvSpPr>
+          <p:nvPr>
+            <p:ph type="title"/>
+          </p:nvPr>
+        </p:nvSpPr>
+        <p:spPr/>
+        <p:txBody>
+          <a:bodyPr/>
+          <a:lstStyle/>
+          <a:p>
+            <a:r>
+              <a:rPr sz="2400"/>
+              <a:t>The agent can exceed its authority</a:t>
+            </a:r>
+          </a:p>
+        </p:txBody>
+      </p:sp>
+      <p:sp>
+        <p:nvSpPr>
+          <p:cNvPr id="4" name="AuthREAD"/>
+          <p:cNvSpPr/>
+          <p:nvPr/>
+        </p:nvSpPr>
+        <p:spPr>
+          <a:xfrm>
+            <a:off x="411480" y="1645920"/>
+            <a:ext cx="1188720" cy="566928"/>
+          </a:xfrm>
+          <a:prstGeom prst="rect">
+            <a:avLst/>
+          </a:prstGeom>
+          <a:solidFill>
+            <a:srgbClr val="F5F1E8"/>
+          </a:solidFill>
+          <a:ln w="12700">
+            <a:solidFill>
+              <a:srgbClr val="C9B991"/>
+            </a:solidFill>
+          </a:ln>
+          <a:effectLst/>
+        </p:spPr>
+        <p:style>
+          <a:lnRef idx="1">
+            <a:schemeClr val="accent1"/>
+          </a:lnRef>
+          <a:fillRef idx="3">
+            <a:schemeClr val="accent1"/>
+          </a:fillRef>
+          <a:effectRef idx="2">
+            <a:schemeClr val="accent1"/>
+          </a:effectRef>
+          <a:fontRef idx="minor">
+            <a:schemeClr val="lt1"/>
+          </a:fontRef>
+        </p:style>
+        <p:txBody>
+          <a:bodyPr rtlCol="0" anchor="ctr" wrap="square" lIns="27432" rIns="27432" tIns="22860" bIns="22860"/>
+          <a:lstStyle/>
+          <a:p>
+            <a:pPr algn="ctr"/>
+            <a:r>
+              <a:rPr sz="1400" b="1" i="0">
+                <a:solidFill>
+                  <a:srgbClr val="5C4826"/>
+                </a:solidFill>
+              </a:rPr>
+              <a:t>READ</a:t>
+            </a:r>
+          </a:p>
+        </p:txBody>
+      </p:sp>
+      <p:sp>
+        <p:nvSpPr>
+          <p:cNvPr id="5" name="AuthMarkREAD"/>
+          <p:cNvSpPr txBox="1"/>
+          <p:nvPr/>
+        </p:nvSpPr>
+        <p:spPr>
+          <a:xfrm>
+            <a:off x="411480" y="2331720"/>
+            <a:ext cx="1188720" cy="457200"/>
+          </a:xfrm>
+          <a:prstGeom prst="rect">
+            <a:avLst/>
+          </a:prstGeom>
+          <a:noFill/>
+        </p:spPr>
+        <p:txBody>
+          <a:bodyPr wrap="square" anchor="t">
+            <a:spAutoFit/>
+          </a:bodyPr>
+          <a:lstStyle/>
+          <a:p>
+            <a:pPr algn="ctr"/>
+            <a:r>
+              <a:rPr sz="2400" b="1" i="0">
+                <a:solidFill>
+                  <a:srgbClr val="5C4826"/>
+                </a:solidFill>
+              </a:rPr>
+              <a:t>✓</a:t>
+            </a:r>
+          </a:p>
+        </p:txBody>
+      </p:sp>
+      <p:cxnSp>
+        <p:nvCxnSpPr>
+          <p:cNvPr id="6" name="Connector 5"/>
+          <p:cNvCxnSpPr/>
+          <p:nvPr/>
+        </p:nvCxnSpPr>
+        <p:spPr>
+          <a:xfrm>
+            <a:off x="1600200" y="1929384"/>
+            <a:ext cx="237744" cy="0"/>
+          </a:xfrm>
+          <a:prstGeom prst="line">
+            <a:avLst/>
+          </a:prstGeom>
+          <a:ln w="28575">
+            <a:solidFill>
+              <a:srgbClr val="8E6F3E"/>
+            </a:solidFill>
+            <a:tailEnd type="triangle" w="med" len="med"/>
+          </a:ln>
+          <a:effectLst/>
+        </p:spPr>
+        <p:style>
+          <a:lnRef idx="2">
+            <a:schemeClr val="accent1"/>
+          </a:lnRef>
+          <a:fillRef idx="0">
+            <a:schemeClr val="accent1"/>
+          </a:fillRef>
+          <a:effectRef idx="1">
+            <a:schemeClr val="accent1"/>
+          </a:effectRef>
+          <a:fontRef idx="minor">
+            <a:schemeClr val="tx1"/>
+          </a:fontRef>
+        </p:style>
+      </p:cxnSp>
+      <p:sp>
+        <p:nvSpPr>
+          <p:cNvPr id="7" name="AuthMODIFY"/>
+          <p:cNvSpPr/>
+          <p:nvPr/>
+        </p:nvSpPr>
+        <p:spPr>
+          <a:xfrm>
+            <a:off x="1837944" y="1645920"/>
+            <a:ext cx="1188720" cy="566928"/>
+          </a:xfrm>
+          <a:prstGeom prst="rect">
+            <a:avLst/>
+          </a:prstGeom>
+          <a:solidFill>
+            <a:srgbClr val="F5F1E8"/>
+          </a:solidFill>
+          <a:ln w="12700">
+            <a:solidFill>
+              <a:srgbClr val="C9B991"/>
+            </a:solidFill>
+          </a:ln>
+          <a:effectLst/>
+        </p:spPr>
+        <p:style>
+          <a:lnRef idx="1">
+            <a:schemeClr val="accent1"/>
+          </a:lnRef>
+          <a:fillRef idx="3">
+            <a:schemeClr val="accent1"/>
+          </a:fillRef>
+          <a:effectRef idx="2">
+            <a:schemeClr val="accent1"/>
+          </a:effectRef>
+          <a:fontRef idx="minor">
+            <a:schemeClr val="lt1"/>
+          </a:fontRef>
+        </p:style>
+        <p:txBody>
+          <a:bodyPr rtlCol="0" anchor="ctr" wrap="square" lIns="27432" rIns="27432" tIns="22860" bIns="22860"/>
+          <a:lstStyle/>
+          <a:p>
+            <a:pPr algn="ctr"/>
+            <a:r>
+              <a:rPr sz="1400" b="1" i="0">
+                <a:solidFill>
+                  <a:srgbClr val="5C4826"/>
+                </a:solidFill>
+              </a:rPr>
+              <a:t>MODIFY</a:t>
+            </a:r>
+          </a:p>
+        </p:txBody>
+      </p:sp>
+      <p:sp>
+        <p:nvSpPr>
+          <p:cNvPr id="8" name="AuthMarkMODIFY"/>
+          <p:cNvSpPr txBox="1"/>
+          <p:nvPr/>
+        </p:nvSpPr>
+        <p:spPr>
+          <a:xfrm>
+            <a:off x="1837944" y="2331720"/>
+            <a:ext cx="1188720" cy="457200"/>
+          </a:xfrm>
+          <a:prstGeom prst="rect">
+            <a:avLst/>
+          </a:prstGeom>
+          <a:noFill/>
+        </p:spPr>
+        <p:txBody>
+          <a:bodyPr wrap="square" anchor="t">
+            <a:spAutoFit/>
+          </a:bodyPr>
+          <a:lstStyle/>
+          <a:p>
+            <a:pPr algn="ctr"/>
+            <a:r>
+              <a:rPr sz="2400" b="1" i="0">
+                <a:solidFill>
+                  <a:srgbClr val="5C4826"/>
+                </a:solidFill>
+              </a:rPr>
+              <a:t>✓</a:t>
+            </a:r>
+          </a:p>
+        </p:txBody>
+      </p:sp>
+      <p:cxnSp>
+        <p:nvCxnSpPr>
+          <p:cNvPr id="9" name="Connector 8"/>
+          <p:cNvCxnSpPr/>
+          <p:nvPr/>
+        </p:nvCxnSpPr>
+        <p:spPr>
+          <a:xfrm>
+            <a:off x="3026664" y="1929384"/>
+            <a:ext cx="237744" cy="0"/>
+          </a:xfrm>
+          <a:prstGeom prst="line">
+            <a:avLst/>
+          </a:prstGeom>
+          <a:ln w="28575">
+            <a:solidFill>
+              <a:srgbClr val="8E6F3E"/>
+            </a:solidFill>
+            <a:tailEnd type="triangle" w="med" len="med"/>
+          </a:ln>
+          <a:effectLst/>
+        </p:spPr>
+        <p:style>
+          <a:lnRef idx="2">
+            <a:schemeClr val="accent1"/>
+          </a:lnRef>
+          <a:fillRef idx="0">
+            <a:schemeClr val="accent1"/>
+          </a:fillRef>
+          <a:effectRef idx="1">
+            <a:schemeClr val="accent1"/>
+          </a:effectRef>
+          <a:fontRef idx="minor">
+            <a:schemeClr val="tx1"/>
+          </a:fontRef>
+        </p:style>
+      </p:cxnSp>
+      <p:sp>
+        <p:nvSpPr>
+          <p:cNvPr id="10" name="AuthCOMMIT"/>
+          <p:cNvSpPr/>
+          <p:nvPr/>
+        </p:nvSpPr>
+        <p:spPr>
+          <a:xfrm>
+            <a:off x="3264408" y="1645920"/>
+            <a:ext cx="1188720" cy="566928"/>
+          </a:xfrm>
+          <a:prstGeom prst="rect">
+            <a:avLst/>
+          </a:prstGeom>
+          <a:solidFill>
+            <a:srgbClr val="F5F1E8"/>
+          </a:solidFill>
+          <a:ln w="12700">
+            <a:solidFill>
+              <a:srgbClr val="C9B991"/>
+            </a:solidFill>
+          </a:ln>
+          <a:effectLst/>
+        </p:spPr>
+        <p:style>
+          <a:lnRef idx="1">
+            <a:schemeClr val="accent1"/>
+          </a:lnRef>
+          <a:fillRef idx="3">
+            <a:schemeClr val="accent1"/>
+          </a:fillRef>
+          <a:effectRef idx="2">
+            <a:schemeClr val="accent1"/>
+          </a:effectRef>
+          <a:fontRef idx="minor">
+            <a:schemeClr val="lt1"/>
+          </a:fontRef>
+        </p:style>
+        <p:txBody>
+          <a:bodyPr rtlCol="0" anchor="ctr" wrap="square" lIns="27432" rIns="27432" tIns="22860" bIns="22860"/>
+          <a:lstStyle/>
+          <a:p>
+            <a:pPr algn="ctr"/>
+            <a:r>
+              <a:rPr sz="1400" b="1" i="0">
+                <a:solidFill>
+                  <a:srgbClr val="5C4826"/>
+                </a:solidFill>
+              </a:rPr>
+              <a:t>COMMIT</a:t>
+            </a:r>
+          </a:p>
+        </p:txBody>
+      </p:sp>
+      <p:sp>
+        <p:nvSpPr>
+          <p:cNvPr id="11" name="AuthMarkCOMMIT"/>
+          <p:cNvSpPr txBox="1"/>
+          <p:nvPr/>
+        </p:nvSpPr>
+        <p:spPr>
+          <a:xfrm>
+            <a:off x="3264408" y="2331720"/>
+            <a:ext cx="1188720" cy="457200"/>
+          </a:xfrm>
+          <a:prstGeom prst="rect">
+            <a:avLst/>
+          </a:prstGeom>
+          <a:noFill/>
+        </p:spPr>
+        <p:txBody>
+          <a:bodyPr wrap="square" anchor="t">
+            <a:spAutoFit/>
+          </a:bodyPr>
+          <a:lstStyle/>
+          <a:p>
+            <a:pPr algn="ctr"/>
+            <a:r>
+              <a:rPr sz="2400" b="1" i="0">
+                <a:solidFill>
+                  <a:srgbClr val="5C4826"/>
+                </a:solidFill>
+              </a:rPr>
+              <a:t>✓</a:t>
+            </a:r>
+          </a:p>
+        </p:txBody>
+      </p:sp>
+      <p:cxnSp>
+        <p:nvCxnSpPr>
+          <p:cNvPr id="12" name="Connector 11"/>
+          <p:cNvCxnSpPr/>
+          <p:nvPr/>
+        </p:nvCxnSpPr>
+        <p:spPr>
+          <a:xfrm>
+            <a:off x="4453128" y="1929384"/>
+            <a:ext cx="237744" cy="0"/>
+          </a:xfrm>
+          <a:prstGeom prst="line">
+            <a:avLst/>
+          </a:prstGeom>
+          <a:ln w="28575">
+            <a:solidFill>
+              <a:srgbClr val="8E6F3E"/>
+            </a:solidFill>
+            <a:tailEnd type="triangle" w="med" len="med"/>
+          </a:ln>
+          <a:effectLst/>
+        </p:spPr>
+        <p:style>
+          <a:lnRef idx="2">
+            <a:schemeClr val="accent1"/>
+          </a:lnRef>
+          <a:fillRef idx="0">
+            <a:schemeClr val="accent1"/>
+          </a:fillRef>
+          <a:effectRef idx="1">
+            <a:schemeClr val="accent1"/>
+          </a:effectRef>
+          <a:fontRef idx="minor">
+            <a:schemeClr val="tx1"/>
+          </a:fontRef>
+        </p:style>
+      </p:cxnSp>
+      <p:sp>
+        <p:nvSpPr>
+          <p:cNvPr id="13" name="AuthPUSH"/>
+          <p:cNvSpPr/>
+          <p:nvPr/>
+        </p:nvSpPr>
+        <p:spPr>
+          <a:xfrm>
+            <a:off x="4690872" y="1645920"/>
+            <a:ext cx="1188720" cy="566928"/>
+          </a:xfrm>
+          <a:prstGeom prst="rect">
+            <a:avLst/>
+          </a:prstGeom>
+          <a:solidFill>
+            <a:srgbClr val="F5F1E8"/>
+          </a:solidFill>
+          <a:ln w="12700">
+            <a:solidFill>
+              <a:srgbClr val="C9B991"/>
+            </a:solidFill>
+          </a:ln>
+          <a:effectLst/>
+        </p:spPr>
+        <p:style>
+          <a:lnRef idx="1">
+            <a:schemeClr val="accent1"/>
+          </a:lnRef>
+          <a:fillRef idx="3">
+            <a:schemeClr val="accent1"/>
+          </a:fillRef>
+          <a:effectRef idx="2">
+            <a:schemeClr val="accent1"/>
+          </a:effectRef>
+          <a:fontRef idx="minor">
+            <a:schemeClr val="lt1"/>
+          </a:fontRef>
+        </p:style>
+        <p:txBody>
+          <a:bodyPr rtlCol="0" anchor="ctr" wrap="square" lIns="27432" rIns="27432" tIns="22860" bIns="22860"/>
+          <a:lstStyle/>
+          <a:p>
+            <a:pPr algn="ctr"/>
+            <a:r>
+              <a:rPr sz="1400" b="1" i="0">
+                <a:solidFill>
+                  <a:srgbClr val="5C4826"/>
+                </a:solidFill>
+              </a:rPr>
+              <a:t>PUSH</a:t>
+            </a:r>
+          </a:p>
+        </p:txBody>
+      </p:sp>
+      <p:sp>
+        <p:nvSpPr>
+          <p:cNvPr id="14" name="AuthMarkPUSH"/>
+          <p:cNvSpPr txBox="1"/>
+          <p:nvPr/>
+        </p:nvSpPr>
+        <p:spPr>
+          <a:xfrm>
+            <a:off x="4690872" y="2331720"/>
+            <a:ext cx="1188720" cy="457200"/>
+          </a:xfrm>
+          <a:prstGeom prst="rect">
+            <a:avLst/>
+          </a:prstGeom>
+          <a:noFill/>
+        </p:spPr>
+        <p:txBody>
+          <a:bodyPr wrap="square" anchor="t">
+            <a:spAutoFit/>
+          </a:bodyPr>
+          <a:lstStyle/>
+          <a:p>
+            <a:pPr algn="ctr"/>
+            <a:r>
+              <a:rPr sz="2400" b="1" i="0">
+                <a:solidFill>
+                  <a:srgbClr val="5C4826"/>
+                </a:solidFill>
+              </a:rPr>
+              <a:t>✓</a:t>
+            </a:r>
+          </a:p>
+        </p:txBody>
+      </p:sp>
+      <p:cxnSp>
+        <p:nvCxnSpPr>
+          <p:cNvPr id="15" name="Connector 14"/>
+          <p:cNvCxnSpPr/>
+          <p:nvPr/>
+        </p:nvCxnSpPr>
+        <p:spPr>
+          <a:xfrm>
+            <a:off x="5879592" y="1929384"/>
+            <a:ext cx="237744" cy="0"/>
+          </a:xfrm>
+          <a:prstGeom prst="line">
+            <a:avLst/>
+          </a:prstGeom>
+          <a:ln w="28575">
+            <a:solidFill>
+              <a:srgbClr val="8E6F3E"/>
+            </a:solidFill>
+            <a:tailEnd type="triangle" w="med" len="med"/>
+          </a:ln>
+          <a:effectLst/>
+        </p:spPr>
+        <p:style>
+          <a:lnRef idx="2">
+            <a:schemeClr val="accent1"/>
+          </a:lnRef>
+          <a:fillRef idx="0">
+            <a:schemeClr val="accent1"/>
+          </a:fillRef>
+          <a:effectRef idx="1">
+            <a:schemeClr val="accent1"/>
+          </a:effectRef>
+          <a:fontRef idx="minor">
+            <a:schemeClr val="tx1"/>
+          </a:fontRef>
+        </p:style>
+      </p:cxnSp>
+      <p:sp>
+        <p:nvSpPr>
+          <p:cNvPr id="16" name="AuthMERGE"/>
+          <p:cNvSpPr/>
+          <p:nvPr/>
+        </p:nvSpPr>
+        <p:spPr>
+          <a:xfrm>
+            <a:off x="6117336" y="1645920"/>
+            <a:ext cx="1188720" cy="566928"/>
+          </a:xfrm>
+          <a:prstGeom prst="rect">
+            <a:avLst/>
+          </a:prstGeom>
+          <a:solidFill>
+            <a:srgbClr val="F5F1E8"/>
+          </a:solidFill>
+          <a:ln w="12700">
+            <a:solidFill>
+              <a:srgbClr val="C9B991"/>
+            </a:solidFill>
+          </a:ln>
+          <a:effectLst/>
+        </p:spPr>
+        <p:style>
+          <a:lnRef idx="1">
+            <a:schemeClr val="accent1"/>
+          </a:lnRef>
+          <a:fillRef idx="3">
+            <a:schemeClr val="accent1"/>
+          </a:fillRef>
+          <a:effectRef idx="2">
+            <a:schemeClr val="accent1"/>
+          </a:effectRef>
+          <a:fontRef idx="minor">
+            <a:schemeClr val="lt1"/>
+          </a:fontRef>
+        </p:style>
+        <p:txBody>
+          <a:bodyPr rtlCol="0" anchor="ctr" wrap="square" lIns="27432" rIns="27432" tIns="22860" bIns="22860"/>
+          <a:lstStyle/>
+          <a:p>
+            <a:pPr algn="ctr"/>
+            <a:r>
+              <a:rPr sz="1400" b="1" i="0">
+                <a:solidFill>
+                  <a:srgbClr val="5C4826"/>
+                </a:solidFill>
+              </a:rPr>
+              <a:t>MERGE</a:t>
+            </a:r>
+          </a:p>
+        </p:txBody>
+      </p:sp>
+      <p:sp>
+        <p:nvSpPr>
+          <p:cNvPr id="17" name="AuthMarkMERGE"/>
+          <p:cNvSpPr txBox="1"/>
+          <p:nvPr/>
+        </p:nvSpPr>
+        <p:spPr>
+          <a:xfrm>
+            <a:off x="6117336" y="2331720"/>
+            <a:ext cx="1188720" cy="457200"/>
+          </a:xfrm>
+          <a:prstGeom prst="rect">
+            <a:avLst/>
+          </a:prstGeom>
+          <a:noFill/>
+        </p:spPr>
+        <p:txBody>
+          <a:bodyPr wrap="square" anchor="t">
+            <a:spAutoFit/>
+          </a:bodyPr>
+          <a:lstStyle/>
+          <a:p>
+            <a:pPr algn="ctr"/>
+            <a:r>
+              <a:rPr sz="2400" b="1" i="0">
+                <a:solidFill>
+                  <a:srgbClr val="555960"/>
+                </a:solidFill>
+              </a:rPr>
+              <a:t>✗</a:t>
+            </a:r>
+          </a:p>
+        </p:txBody>
+      </p:sp>
+      <p:cxnSp>
+        <p:nvCxnSpPr>
+          <p:cNvPr id="18" name="Connector 17"/>
+          <p:cNvCxnSpPr/>
+          <p:nvPr/>
+        </p:nvCxnSpPr>
+        <p:spPr>
+          <a:xfrm>
+            <a:off x="7306056" y="1929384"/>
+            <a:ext cx="237744" cy="0"/>
+          </a:xfrm>
+          <a:prstGeom prst="line">
+            <a:avLst/>
+          </a:prstGeom>
+          <a:ln w="28575">
+            <a:solidFill>
+              <a:srgbClr val="8E6F3E"/>
+            </a:solidFill>
+            <a:tailEnd type="triangle" w="med" len="med"/>
+          </a:ln>
+          <a:effectLst/>
+        </p:spPr>
+        <p:style>
+          <a:lnRef idx="2">
+            <a:schemeClr val="accent1"/>
+          </a:lnRef>
+          <a:fillRef idx="0">
+            <a:schemeClr val="accent1"/>
+          </a:fillRef>
+          <a:effectRef idx="1">
+            <a:schemeClr val="accent1"/>
+          </a:effectRef>
+          <a:fontRef idx="minor">
+            <a:schemeClr val="tx1"/>
+          </a:fontRef>
+        </p:style>
+      </p:cxnSp>
+      <p:sp>
+        <p:nvSpPr>
+          <p:cNvPr id="19" name="AuthDEPLOY"/>
+          <p:cNvSpPr/>
+          <p:nvPr/>
+        </p:nvSpPr>
+        <p:spPr>
+          <a:xfrm>
+            <a:off x="7543800" y="1645920"/>
+            <a:ext cx="1188720" cy="566928"/>
+          </a:xfrm>
+          <a:prstGeom prst="rect">
+            <a:avLst/>
+          </a:prstGeom>
+          <a:solidFill>
+            <a:srgbClr val="F5F1E8"/>
+          </a:solidFill>
+          <a:ln w="12700">
+            <a:solidFill>
+              <a:srgbClr val="C9B991"/>
+            </a:solidFill>
+          </a:ln>
+          <a:effectLst/>
+        </p:spPr>
+        <p:style>
+          <a:lnRef idx="1">
+            <a:schemeClr val="accent1"/>
+          </a:lnRef>
+          <a:fillRef idx="3">
+            <a:schemeClr val="accent1"/>
+          </a:fillRef>
+          <a:effectRef idx="2">
+            <a:schemeClr val="accent1"/>
+          </a:effectRef>
+          <a:fontRef idx="minor">
+            <a:schemeClr val="lt1"/>
+          </a:fontRef>
+        </p:style>
+        <p:txBody>
+          <a:bodyPr rtlCol="0" anchor="ctr" wrap="square" lIns="27432" rIns="27432" tIns="22860" bIns="22860"/>
+          <a:lstStyle/>
+          <a:p>
+            <a:pPr algn="ctr"/>
+            <a:r>
+              <a:rPr sz="1400" b="1" i="0">
+                <a:solidFill>
+                  <a:srgbClr val="5C4826"/>
+                </a:solidFill>
+              </a:rPr>
+              <a:t>DEPLOY</a:t>
+            </a:r>
+          </a:p>
+        </p:txBody>
+      </p:sp>
+      <p:sp>
+        <p:nvSpPr>
+          <p:cNvPr id="20" name="AuthMarkDEPLOY"/>
+          <p:cNvSpPr txBox="1"/>
+          <p:nvPr/>
+        </p:nvSpPr>
+        <p:spPr>
+          <a:xfrm>
+            <a:off x="7543800" y="2331720"/>
+            <a:ext cx="1188720" cy="457200"/>
+          </a:xfrm>
+          <a:prstGeom prst="rect">
+            <a:avLst/>
+          </a:prstGeom>
+          <a:noFill/>
+        </p:spPr>
+        <p:txBody>
+          <a:bodyPr wrap="square" anchor="t">
+            <a:spAutoFit/>
+          </a:bodyPr>
+          <a:lstStyle/>
+          <a:p>
+            <a:pPr algn="ctr"/>
+            <a:r>
+              <a:rPr sz="2400" b="1" i="0">
+                <a:solidFill>
+                  <a:srgbClr val="555960"/>
+                </a:solidFill>
+              </a:rPr>
+              <a:t>✗</a:t>
+            </a:r>
+          </a:p>
+        </p:txBody>
+      </p:sp>
+      <p:sp>
+        <p:nvSpPr>
+          <p:cNvPr id="21" name="AuthStmt"/>
+          <p:cNvSpPr txBox="1"/>
+          <p:nvPr/>
+        </p:nvSpPr>
+        <p:spPr>
+          <a:xfrm>
+            <a:off x="502920" y="3383280"/>
+            <a:ext cx="8138160" cy="548640"/>
+          </a:xfrm>
+          <a:prstGeom prst="rect">
+            <a:avLst/>
+          </a:prstGeom>
+          <a:noFill/>
+        </p:spPr>
+        <p:txBody>
+          <a:bodyPr wrap="square" anchor="t">
+            <a:spAutoFit/>
+          </a:bodyPr>
+          <a:lstStyle/>
+          <a:p>
+            <a:pPr algn="ctr"/>
+            <a:r>
+              <a:rPr sz="2000" b="0" i="0">
+                <a:solidFill>
+                  <a:srgbClr val="5C4826"/>
+                </a:solidFill>
+              </a:rPr>
+              <a:t>The agent may be capable of an action that it is not authorized to take.</a:t>
+            </a:r>
+          </a:p>
+        </p:txBody>
+      </p:sp>
+      <p:sp>
+        <p:nvSpPr>
+          <p:cNvPr id="22" name="AuthCallback"/>
+          <p:cNvSpPr txBox="1"/>
+          <p:nvPr/>
+        </p:nvSpPr>
+        <p:spPr>
+          <a:xfrm>
+            <a:off x="502920" y="4114800"/>
+            <a:ext cx="8138160" cy="457200"/>
+          </a:xfrm>
+          <a:prstGeom prst="rect">
+            <a:avLst/>
+          </a:prstGeom>
+          <a:noFill/>
+        </p:spPr>
+        <p:txBody>
+          <a:bodyPr wrap="square" anchor="t">
+            <a:spAutoFit/>
+          </a:bodyPr>
+          <a:lstStyle/>
+          <a:p>
+            <a:pPr algn="ctr"/>
+            <a:r>
+              <a:rPr sz="2000" b="1" i="0">
+                <a:solidFill>
+                  <a:srgbClr val="8E6F3E"/>
+                </a:solidFill>
+              </a:rPr>
+              <a:t>From Agents: capability is not authority.</a:t>
+            </a:r>
+          </a:p>
+        </p:txBody>
+      </p:sp>
+    </p:spTree>
+  </p:cSld>
+  <p:clrMapOvr>
+    <a:masterClrMapping/>
+  </p:clrMapOvr>
+</p:sld>
+</file>
+
+<file path=ppt/slides/slide38.xml><?xml version="1.0" encoding="utf-8"?>
+<p:sld xmlns:a="http://schemas.openxmlformats.org/drawingml/2006/main" xmlns:p="http://schemas.openxmlformats.org/presentationml/2006/main" xmlns:r="http://schemas.openxmlformats.org/officeDocument/2006/relationships">
+  <p:cSld>
+    <p:spTree>
+      <p:nvGrpSpPr>
+        <p:cNvPr id="1" name=""/>
+        <p:cNvGrpSpPr/>
+        <p:nvPr/>
+      </p:nvGrpSpPr>
+      <p:grpSpPr/>
+      <p:sp>
+        <p:nvSpPr>
+          <p:cNvPr id="2" name="Content Placeholder 1"/>
+          <p:cNvSpPr>
+            <a:spLocks noGrp="1"/>
+          </p:cNvSpPr>
+          <p:nvPr>
+            <p:ph idx="1"/>
+          </p:nvPr>
+        </p:nvSpPr>
+        <p:spPr/>
+        <p:txBody>
+          <a:bodyPr/>
+          <a:lstStyle/>
+          <a:p/>
+        </p:txBody>
+      </p:sp>
+      <p:sp>
+        <p:nvSpPr>
+          <p:cNvPr id="3" name="Title 2"/>
+          <p:cNvSpPr>
+            <a:spLocks noGrp="1"/>
+          </p:cNvSpPr>
+          <p:nvPr>
+            <p:ph type="title"/>
+          </p:nvPr>
+        </p:nvSpPr>
+        <p:spPr/>
+        <p:txBody>
+          <a:bodyPr/>
+          <a:lstStyle/>
+          <a:p>
+            <a:r>
+              <a:rPr sz="2400"/>
+              <a:t>A failure model suggests controls</a:t>
+            </a:r>
+          </a:p>
+        </p:txBody>
+      </p:sp>
+      <p:graphicFrame>
+        <p:nvGraphicFramePr>
+          <p:cNvPr id="4" name="FailureControlTable"/>
+          <p:cNvGraphicFramePr>
+            <a:graphicFrameLocks noGrp="1"/>
+          </p:cNvGraphicFramePr>
+          <p:nvPr/>
+        </p:nvGraphicFramePr>
+        <p:xfrm>
+          <a:off x="914400" y="1188720"/>
+          <a:ext cx="7315200" cy="3182112"/>
+        </p:xfrm>
+        <a:graphic>
+          <a:graphicData uri="http://schemas.openxmlformats.org/drawingml/2006/table">
+            <a:tbl>
+              <a:tblPr>
+                <a:tableStyleId>{5C22544A-7EE6-4342-B048-85BDC9FD1C3A}</a:tableStyleId>
+              </a:tblPr>
+              <a:tblGrid>
+                <a:gridCol w="2743200"/>
+                <a:gridCol w="4572000"/>
+              </a:tblGrid>
+              <a:tr h="548640">
+                <a:tc>
+                  <a:txBody>
+                    <a:bodyPr wrap="square" anchor="ctr"/>
+                    <a:lstStyle/>
+                    <a:p>
+                      <a:pPr algn="l"/>
+                      <a:r>
+                        <a:rPr sz="1800" b="1" i="0">
+                          <a:solidFill>
+                            <a:srgbClr val="FFFFFF"/>
+                          </a:solidFill>
+                        </a:rPr>
+                        <a:t>Failure</a:t>
+                      </a:r>
+                    </a:p>
+                  </a:txBody>
+                  <a:tcPr anchor="ctr" marL="68580" marR="45720" marT="27432" marB="27432">
+                    <a:solidFill>
+                      <a:srgbClr val="8E6F3E"/>
+                    </a:solidFill>
+                  </a:tcPr>
+                </a:tc>
+                <a:tc>
+                  <a:txBody>
+                    <a:bodyPr wrap="square" anchor="ctr"/>
+                    <a:lstStyle/>
+                    <a:p>
+                      <a:pPr algn="l"/>
+                      <a:r>
+                        <a:rPr sz="1800" b="1" i="0">
+                          <a:solidFill>
+                            <a:srgbClr val="FFFFFF"/>
+                          </a:solidFill>
+                        </a:rPr>
+                        <a:t>What we need</a:t>
+                      </a:r>
+                    </a:p>
+                  </a:txBody>
+                  <a:tcPr anchor="ctr" marL="68580" marR="45720" marT="27432" marB="27432">
+                    <a:solidFill>
+                      <a:srgbClr val="8E6F3E"/>
+                    </a:solidFill>
+                  </a:tcPr>
+                </a:tc>
+              </a:tr>
+              <a:tr h="658368">
+                <a:tc>
+                  <a:txBody>
+                    <a:bodyPr wrap="square" anchor="ctr"/>
+                    <a:lstStyle/>
+                    <a:p>
+                      <a:pPr algn="l"/>
+                      <a:r>
+                        <a:rPr sz="1700" b="1" i="0">
+                          <a:solidFill>
+                            <a:srgbClr val="5C4826"/>
+                          </a:solidFill>
+                        </a:rPr>
+                        <a:t>wrong result</a:t>
+                      </a:r>
+                    </a:p>
+                  </a:txBody>
+                  <a:tcPr anchor="ctr" marL="68580" marR="45720" marT="27432" marB="27432">
+                    <a:solidFill>
+                      <a:srgbClr val="F5F1E8"/>
+                    </a:solidFill>
+                  </a:tcPr>
+                </a:tc>
+                <a:tc>
+                  <a:txBody>
+                    <a:bodyPr wrap="square" anchor="ctr"/>
+                    <a:lstStyle/>
+                    <a:p>
+                      <a:pPr algn="l"/>
+                      <a:r>
+                        <a:rPr sz="1700" b="0" i="0">
+                          <a:solidFill>
+                            <a:srgbClr val="5C4826"/>
+                          </a:solidFill>
+                        </a:rPr>
+                        <a:t>establish properties of the artifact</a:t>
+                      </a:r>
+                    </a:p>
+                  </a:txBody>
+                  <a:tcPr anchor="ctr" marL="68580" marR="45720" marT="27432" marB="27432">
+                    <a:solidFill>
+                      <a:srgbClr val="FBF8F2"/>
+                    </a:solidFill>
+                  </a:tcPr>
+                </a:tc>
+              </a:tr>
+              <a:tr h="658368">
+                <a:tc>
+                  <a:txBody>
+                    <a:bodyPr wrap="square" anchor="ctr"/>
+                    <a:lstStyle/>
+                    <a:p>
+                      <a:pPr algn="l"/>
+                      <a:r>
+                        <a:rPr sz="1700" b="1" i="0">
+                          <a:solidFill>
+                            <a:srgbClr val="5C4826"/>
+                          </a:solidFill>
+                        </a:rPr>
+                        <a:t>wrong process</a:t>
+                      </a:r>
+                    </a:p>
+                  </a:txBody>
+                  <a:tcPr anchor="ctr" marL="68580" marR="45720" marT="27432" marB="27432">
+                    <a:solidFill>
+                      <a:srgbClr val="F5F1E8"/>
+                    </a:solidFill>
+                  </a:tcPr>
+                </a:tc>
+                <a:tc>
+                  <a:txBody>
+                    <a:bodyPr wrap="square" anchor="ctr"/>
+                    <a:lstStyle/>
+                    <a:p>
+                      <a:pPr algn="l"/>
+                      <a:r>
+                        <a:rPr sz="1700" b="0" i="0">
+                          <a:solidFill>
+                            <a:srgbClr val="5C4826"/>
+                          </a:solidFill>
+                        </a:rPr>
+                        <a:t>observe or constrain actions</a:t>
+                      </a:r>
+                    </a:p>
+                  </a:txBody>
+                  <a:tcPr anchor="ctr" marL="68580" marR="45720" marT="27432" marB="27432">
+                    <a:solidFill>
+                      <a:srgbClr val="FBF8F2"/>
+                    </a:solidFill>
+                  </a:tcPr>
+                </a:tc>
+              </a:tr>
+              <a:tr h="658368">
+                <a:tc>
+                  <a:txBody>
+                    <a:bodyPr wrap="square" anchor="ctr"/>
+                    <a:lstStyle/>
+                    <a:p>
+                      <a:pPr algn="l"/>
+                      <a:r>
+                        <a:rPr sz="1700" b="1" i="0">
+                          <a:solidFill>
+                            <a:srgbClr val="5C4826"/>
+                          </a:solidFill>
+                        </a:rPr>
+                        <a:t>excess authority</a:t>
+                      </a:r>
+                    </a:p>
+                  </a:txBody>
+                  <a:tcPr anchor="ctr" marL="68580" marR="45720" marT="27432" marB="27432">
+                    <a:solidFill>
+                      <a:srgbClr val="F5F1E8"/>
+                    </a:solidFill>
+                  </a:tcPr>
+                </a:tc>
+                <a:tc>
+                  <a:txBody>
+                    <a:bodyPr wrap="square" anchor="ctr"/>
+                    <a:lstStyle/>
+                    <a:p>
+                      <a:pPr algn="l"/>
+                      <a:r>
+                        <a:rPr sz="1700" b="0" i="0">
+                          <a:solidFill>
+                            <a:srgbClr val="5C4826"/>
+                          </a:solidFill>
+                        </a:rPr>
+                        <a:t>restrict consequential actions</a:t>
+                      </a:r>
+                    </a:p>
+                  </a:txBody>
+                  <a:tcPr anchor="ctr" marL="68580" marR="45720" marT="27432" marB="27432">
+                    <a:solidFill>
+                      <a:srgbClr val="FBF8F2"/>
+                    </a:solidFill>
+                  </a:tcPr>
+                </a:tc>
+              </a:tr>
+              <a:tr h="658368">
+                <a:tc>
+                  <a:txBody>
+                    <a:bodyPr wrap="square" anchor="ctr"/>
+                    <a:lstStyle/>
+                    <a:p>
+                      <a:pPr algn="l"/>
+                      <a:r>
+                        <a:rPr sz="1700" b="1" i="0">
+                          <a:solidFill>
+                            <a:srgbClr val="5C4826"/>
+                          </a:solidFill>
+                        </a:rPr>
+                        <a:t>insufficient evidence</a:t>
+                      </a:r>
+                    </a:p>
+                  </a:txBody>
+                  <a:tcPr anchor="ctr" marL="68580" marR="45720" marT="27432" marB="27432">
+                    <a:solidFill>
+                      <a:srgbClr val="F5F1E8"/>
+                    </a:solidFill>
+                  </a:tcPr>
+                </a:tc>
+                <a:tc>
+                  <a:txBody>
+                    <a:bodyPr wrap="square" anchor="ctr"/>
+                    <a:lstStyle/>
+                    <a:p>
+                      <a:pPr algn="l"/>
+                      <a:r>
+                        <a:rPr sz="1700" b="0" i="0">
+                          <a:solidFill>
+                            <a:srgbClr val="5C4826"/>
+                          </a:solidFill>
+                        </a:rPr>
+                        <a:t>require evidence before acceptance</a:t>
+                      </a:r>
+                    </a:p>
+                  </a:txBody>
+                  <a:tcPr anchor="ctr" marL="68580" marR="45720" marT="27432" marB="27432">
+                    <a:solidFill>
+                      <a:srgbClr val="FBF8F2"/>
+                    </a:solidFill>
+                  </a:tcPr>
+                </a:tc>
+              </a:tr>
+            </a:tbl>
+          </a:graphicData>
+        </a:graphic>
+      </p:graphicFrame>
+      <p:sp>
+        <p:nvSpPr>
+          <p:cNvPr id="5" name="FCTransition"/>
+          <p:cNvSpPr txBox="1"/>
+          <p:nvPr/>
+        </p:nvSpPr>
+        <p:spPr>
+          <a:xfrm>
+            <a:off x="502920" y="4800600"/>
+            <a:ext cx="8138160" cy="548640"/>
+          </a:xfrm>
+          <a:prstGeom prst="rect">
+            <a:avLst/>
+          </a:prstGeom>
+          <a:noFill/>
+        </p:spPr>
+        <p:txBody>
+          <a:bodyPr wrap="square" anchor="t">
+            <a:spAutoFit/>
+          </a:bodyPr>
+          <a:lstStyle/>
+          <a:p>
+            <a:pPr algn="ctr"/>
+            <a:r>
+              <a:rPr sz="1800" b="0" i="0">
+                <a:solidFill>
+                  <a:srgbClr val="5C4826"/>
+                </a:solidFill>
+              </a:rPr>
+              <a:t>We can now ask how to make each failure impossible, observable, detectable, or consequential.</a:t>
+            </a:r>
+          </a:p>
+        </p:txBody>
+      </p:sp>
+    </p:spTree>
+  </p:cSld>
+  <p:clrMapOvr>
+    <a:masterClrMapping/>
+  </p:clrMapOvr>
+</p:sld>
+</file>
+
+<file path=ppt/slides/slide39.xml><?xml version="1.0" encoding="utf-8"?>
+<p:sld xmlns:a="http://schemas.openxmlformats.org/drawingml/2006/main" xmlns:p="http://schemas.openxmlformats.org/presentationml/2006/main" xmlns:r="http://schemas.openxmlformats.org/officeDocument/2006/relationships">
+  <p:cSld>
+    <p:spTree>
+      <p:nvGrpSpPr>
+        <p:cNvPr id="1" name=""/>
+        <p:cNvGrpSpPr/>
+        <p:nvPr/>
+      </p:nvGrpSpPr>
+      <p:grpSpPr/>
+      <p:sp>
+        <p:nvSpPr>
+          <p:cNvPr id="2" name="Content Placeholder 1"/>
+          <p:cNvSpPr>
+            <a:spLocks noGrp="1"/>
+          </p:cNvSpPr>
+          <p:nvPr>
+            <p:ph idx="1"/>
+          </p:nvPr>
+        </p:nvSpPr>
+        <p:spPr/>
+        <p:txBody>
+          <a:bodyPr/>
+          <a:lstStyle/>
+          <a:p/>
+        </p:txBody>
+      </p:sp>
+      <p:sp>
+        <p:nvSpPr>
+          <p:cNvPr id="3" name="Title 2"/>
+          <p:cNvSpPr>
+            <a:spLocks noGrp="1"/>
+          </p:cNvSpPr>
+          <p:nvPr>
+            <p:ph type="title"/>
+          </p:nvPr>
+        </p:nvSpPr>
+        <p:spPr/>
+        <p:txBody>
+          <a:bodyPr/>
+          <a:lstStyle/>
+          <a:p>
+            <a:r>
+              <a:rPr sz="2400"/>
+              <a:t>Models can drive controls</a:t>
+            </a:r>
+          </a:p>
+        </p:txBody>
+      </p:sp>
+      <p:sp>
+        <p:nvSpPr>
+          <p:cNvPr id="4" name="ArchModel"/>
+          <p:cNvSpPr/>
+          <p:nvPr/>
+        </p:nvSpPr>
+        <p:spPr>
+          <a:xfrm>
+            <a:off x="3291840" y="1005840"/>
+            <a:ext cx="2560320" cy="594360"/>
+          </a:xfrm>
+          <a:prstGeom prst="rect">
+            <a:avLst/>
+          </a:prstGeom>
+          <a:solidFill>
+            <a:srgbClr val="8E6F3E"/>
+          </a:solidFill>
+          <a:ln>
+            <a:noFill/>
+          </a:ln>
+          <a:effectLst/>
+        </p:spPr>
+        <p:style>
+          <a:lnRef idx="1">
+            <a:schemeClr val="accent1"/>
+          </a:lnRef>
+          <a:fillRef idx="3">
+            <a:schemeClr val="accent1"/>
+          </a:fillRef>
+          <a:effectRef idx="2">
+            <a:schemeClr val="accent1"/>
+          </a:effectRef>
+          <a:fontRef idx="minor">
+            <a:schemeClr val="lt1"/>
+          </a:fontRef>
+        </p:style>
+        <p:txBody>
+          <a:bodyPr rtlCol="0" anchor="ctr" wrap="square" lIns="27432" rIns="27432" tIns="22860" bIns="22860"/>
+          <a:lstStyle/>
+          <a:p>
+            <a:pPr algn="ctr"/>
+            <a:r>
+              <a:rPr sz="1500" b="1" i="0">
+                <a:solidFill>
+                  <a:srgbClr val="FFFFFF"/>
+                </a:solidFill>
+              </a:rPr>
+              <a:t>ARCHITECTURE MODEL</a:t>
+            </a:r>
+          </a:p>
+        </p:txBody>
+      </p:sp>
+      <p:sp>
+        <p:nvSpPr>
+          <p:cNvPr id="5" name="MC-dependency check"/>
+          <p:cNvSpPr/>
+          <p:nvPr/>
+        </p:nvSpPr>
+        <p:spPr>
+          <a:xfrm>
+            <a:off x="1188720" y="2240280"/>
+            <a:ext cx="1828800" cy="640080"/>
+          </a:xfrm>
+          <a:prstGeom prst="rect">
+            <a:avLst/>
+          </a:prstGeom>
+          <a:solidFill>
+            <a:srgbClr val="F5F1E8"/>
+          </a:solidFill>
+          <a:ln w="12700">
+            <a:solidFill>
+              <a:srgbClr val="C9B991"/>
+            </a:solidFill>
+          </a:ln>
+          <a:effectLst/>
+        </p:spPr>
+        <p:style>
+          <a:lnRef idx="1">
+            <a:schemeClr val="accent1"/>
+          </a:lnRef>
+          <a:fillRef idx="3">
+            <a:schemeClr val="accent1"/>
+          </a:fillRef>
+          <a:effectRef idx="2">
+            <a:schemeClr val="accent1"/>
+          </a:effectRef>
+          <a:fontRef idx="minor">
+            <a:schemeClr val="lt1"/>
+          </a:fontRef>
+        </p:style>
+        <p:txBody>
+          <a:bodyPr rtlCol="0" anchor="ctr" wrap="square" lIns="27432" rIns="27432" tIns="22860" bIns="22860"/>
+          <a:lstStyle/>
+          <a:p>
+            <a:pPr algn="ctr"/>
+            <a:r>
+              <a:rPr sz="1500" b="0" i="0">
+                <a:solidFill>
+                  <a:srgbClr val="5C4826"/>
+                </a:solidFill>
+              </a:rPr>
+              <a:t>dependency check</a:t>
+            </a:r>
+          </a:p>
+        </p:txBody>
+      </p:sp>
+      <p:sp>
+        <p:nvSpPr>
+          <p:cNvPr id="6" name="MC-memory analysis"/>
+          <p:cNvSpPr/>
+          <p:nvPr/>
+        </p:nvSpPr>
+        <p:spPr>
+          <a:xfrm>
+            <a:off x="3657600" y="2240280"/>
+            <a:ext cx="1828800" cy="640080"/>
+          </a:xfrm>
+          <a:prstGeom prst="rect">
+            <a:avLst/>
+          </a:prstGeom>
+          <a:solidFill>
+            <a:srgbClr val="F5F1E8"/>
+          </a:solidFill>
+          <a:ln w="12700">
+            <a:solidFill>
+              <a:srgbClr val="C9B991"/>
+            </a:solidFill>
+          </a:ln>
+          <a:effectLst/>
+        </p:spPr>
+        <p:style>
+          <a:lnRef idx="1">
+            <a:schemeClr val="accent1"/>
+          </a:lnRef>
+          <a:fillRef idx="3">
+            <a:schemeClr val="accent1"/>
+          </a:fillRef>
+          <a:effectRef idx="2">
+            <a:schemeClr val="accent1"/>
+          </a:effectRef>
+          <a:fontRef idx="minor">
+            <a:schemeClr val="lt1"/>
+          </a:fontRef>
+        </p:style>
+        <p:txBody>
+          <a:bodyPr rtlCol="0" anchor="ctr" wrap="square" lIns="27432" rIns="27432" tIns="22860" bIns="22860"/>
+          <a:lstStyle/>
+          <a:p>
+            <a:pPr algn="ctr"/>
+            <a:r>
+              <a:rPr sz="1500" b="0" i="0">
+                <a:solidFill>
+                  <a:srgbClr val="5C4826"/>
+                </a:solidFill>
+              </a:rPr>
+              <a:t>memory analysis</a:t>
+            </a:r>
+          </a:p>
+        </p:txBody>
+      </p:sp>
+      <p:sp>
+        <p:nvSpPr>
+          <p:cNvPr id="7" name="MC-interface check"/>
+          <p:cNvSpPr/>
+          <p:nvPr/>
+        </p:nvSpPr>
+        <p:spPr>
+          <a:xfrm>
+            <a:off x="6126480" y="2240280"/>
+            <a:ext cx="1828800" cy="640080"/>
+          </a:xfrm>
+          <a:prstGeom prst="rect">
+            <a:avLst/>
+          </a:prstGeom>
+          <a:solidFill>
+            <a:srgbClr val="F5F1E8"/>
+          </a:solidFill>
+          <a:ln w="12700">
+            <a:solidFill>
+              <a:srgbClr val="C9B991"/>
+            </a:solidFill>
+          </a:ln>
+          <a:effectLst/>
+        </p:spPr>
+        <p:style>
+          <a:lnRef idx="1">
+            <a:schemeClr val="accent1"/>
+          </a:lnRef>
+          <a:fillRef idx="3">
+            <a:schemeClr val="accent1"/>
+          </a:fillRef>
+          <a:effectRef idx="2">
+            <a:schemeClr val="accent1"/>
+          </a:effectRef>
+          <a:fontRef idx="minor">
+            <a:schemeClr val="lt1"/>
+          </a:fontRef>
+        </p:style>
+        <p:txBody>
+          <a:bodyPr rtlCol="0" anchor="ctr" wrap="square" lIns="27432" rIns="27432" tIns="22860" bIns="22860"/>
+          <a:lstStyle/>
+          <a:p>
+            <a:pPr algn="ctr"/>
+            <a:r>
+              <a:rPr sz="1500" b="0" i="0">
+                <a:solidFill>
+                  <a:srgbClr val="5C4826"/>
+                </a:solidFill>
+              </a:rPr>
+              <a:t>interface check</a:t>
+            </a:r>
+          </a:p>
+        </p:txBody>
+      </p:sp>
+      <p:cxnSp>
+        <p:nvCxnSpPr>
+          <p:cNvPr id="8" name="Connector 7"/>
+          <p:cNvCxnSpPr/>
+          <p:nvPr/>
+        </p:nvCxnSpPr>
+        <p:spPr>
+          <a:xfrm flipH="1">
+            <a:off x="2103120" y="1600200"/>
+            <a:ext cx="2468880" cy="640080"/>
+          </a:xfrm>
+          <a:prstGeom prst="line">
+            <a:avLst/>
+          </a:prstGeom>
+          <a:ln w="28575">
+            <a:solidFill>
+              <a:srgbClr val="8E6F3E"/>
+            </a:solidFill>
+            <a:tailEnd type="triangle" w="med" len="med"/>
+          </a:ln>
+          <a:effectLst/>
+        </p:spPr>
+        <p:style>
+          <a:lnRef idx="2">
+            <a:schemeClr val="accent1"/>
+          </a:lnRef>
+          <a:fillRef idx="0">
+            <a:schemeClr val="accent1"/>
+          </a:fillRef>
+          <a:effectRef idx="1">
+            <a:schemeClr val="accent1"/>
+          </a:effectRef>
+          <a:fontRef idx="minor">
+            <a:schemeClr val="tx1"/>
+          </a:fontRef>
+        </p:style>
+      </p:cxnSp>
+      <p:cxnSp>
+        <p:nvCxnSpPr>
+          <p:cNvPr id="9" name="Connector 8"/>
+          <p:cNvCxnSpPr/>
+          <p:nvPr/>
+        </p:nvCxnSpPr>
+        <p:spPr>
+          <a:xfrm>
+            <a:off x="4572000" y="1600200"/>
+            <a:ext cx="0" cy="640080"/>
+          </a:xfrm>
+          <a:prstGeom prst="line">
+            <a:avLst/>
+          </a:prstGeom>
+          <a:ln w="28575">
+            <a:solidFill>
+              <a:srgbClr val="8E6F3E"/>
+            </a:solidFill>
+            <a:tailEnd type="triangle" w="med" len="med"/>
+          </a:ln>
+          <a:effectLst/>
+        </p:spPr>
+        <p:style>
+          <a:lnRef idx="2">
+            <a:schemeClr val="accent1"/>
+          </a:lnRef>
+          <a:fillRef idx="0">
+            <a:schemeClr val="accent1"/>
+          </a:fillRef>
+          <a:effectRef idx="1">
+            <a:schemeClr val="accent1"/>
+          </a:effectRef>
+          <a:fontRef idx="minor">
+            <a:schemeClr val="tx1"/>
+          </a:fontRef>
+        </p:style>
+      </p:cxnSp>
+      <p:cxnSp>
+        <p:nvCxnSpPr>
+          <p:cNvPr id="10" name="Connector 9"/>
+          <p:cNvCxnSpPr/>
+          <p:nvPr/>
+        </p:nvCxnSpPr>
+        <p:spPr>
+          <a:xfrm>
+            <a:off x="4572000" y="1600200"/>
+            <a:ext cx="2468880" cy="640080"/>
+          </a:xfrm>
+          <a:prstGeom prst="line">
+            <a:avLst/>
+          </a:prstGeom>
+          <a:ln w="28575">
+            <a:solidFill>
+              <a:srgbClr val="8E6F3E"/>
+            </a:solidFill>
+            <a:tailEnd type="triangle" w="med" len="med"/>
+          </a:ln>
+          <a:effectLst/>
+        </p:spPr>
+        <p:style>
+          <a:lnRef idx="2">
+            <a:schemeClr val="accent1"/>
+          </a:lnRef>
+          <a:fillRef idx="0">
+            <a:schemeClr val="accent1"/>
+          </a:fillRef>
+          <a:effectRef idx="1">
+            <a:schemeClr val="accent1"/>
+          </a:effectRef>
+          <a:fontRef idx="minor">
+            <a:schemeClr val="tx1"/>
+          </a:fontRef>
+        </p:style>
+      </p:cxnSp>
+      <p:cxnSp>
+        <p:nvCxnSpPr>
+          <p:cNvPr id="11" name="Connector 10"/>
+          <p:cNvCxnSpPr/>
+          <p:nvPr/>
+        </p:nvCxnSpPr>
+        <p:spPr>
+          <a:xfrm>
+            <a:off x="2103120" y="2880360"/>
+            <a:ext cx="2468880" cy="731520"/>
+          </a:xfrm>
+          <a:prstGeom prst="line">
+            <a:avLst/>
+          </a:prstGeom>
+          <a:ln w="28575">
+            <a:solidFill>
+              <a:srgbClr val="8E6F3E"/>
+            </a:solidFill>
+            <a:tailEnd type="triangle" w="med" len="med"/>
+          </a:ln>
+          <a:effectLst/>
+        </p:spPr>
+        <p:style>
+          <a:lnRef idx="2">
+            <a:schemeClr val="accent1"/>
+          </a:lnRef>
+          <a:fillRef idx="0">
+            <a:schemeClr val="accent1"/>
+          </a:fillRef>
+          <a:effectRef idx="1">
+            <a:schemeClr val="accent1"/>
+          </a:effectRef>
+          <a:fontRef idx="minor">
+            <a:schemeClr val="tx1"/>
+          </a:fontRef>
+        </p:style>
+      </p:cxnSp>
+      <p:cxnSp>
+        <p:nvCxnSpPr>
+          <p:cNvPr id="12" name="Connector 11"/>
+          <p:cNvCxnSpPr/>
+          <p:nvPr/>
+        </p:nvCxnSpPr>
+        <p:spPr>
+          <a:xfrm>
+            <a:off x="4572000" y="2880360"/>
+            <a:ext cx="0" cy="731520"/>
+          </a:xfrm>
+          <a:prstGeom prst="line">
+            <a:avLst/>
+          </a:prstGeom>
+          <a:ln w="28575">
+            <a:solidFill>
+              <a:srgbClr val="8E6F3E"/>
+            </a:solidFill>
+            <a:tailEnd type="triangle" w="med" len="med"/>
+          </a:ln>
+          <a:effectLst/>
+        </p:spPr>
+        <p:style>
+          <a:lnRef idx="2">
+            <a:schemeClr val="accent1"/>
+          </a:lnRef>
+          <a:fillRef idx="0">
+            <a:schemeClr val="accent1"/>
+          </a:fillRef>
+          <a:effectRef idx="1">
+            <a:schemeClr val="accent1"/>
+          </a:effectRef>
+          <a:fontRef idx="minor">
+            <a:schemeClr val="tx1"/>
+          </a:fontRef>
+        </p:style>
+      </p:cxnSp>
+      <p:cxnSp>
+        <p:nvCxnSpPr>
+          <p:cNvPr id="13" name="Connector 12"/>
+          <p:cNvCxnSpPr/>
+          <p:nvPr/>
+        </p:nvCxnSpPr>
+        <p:spPr>
+          <a:xfrm flipH="1">
+            <a:off x="4572000" y="2880360"/>
+            <a:ext cx="2468880" cy="731520"/>
+          </a:xfrm>
+          <a:prstGeom prst="line">
+            <a:avLst/>
+          </a:prstGeom>
+          <a:ln w="28575">
+            <a:solidFill>
+              <a:srgbClr val="8E6F3E"/>
+            </a:solidFill>
+            <a:tailEnd type="triangle" w="med" len="med"/>
+          </a:ln>
+          <a:effectLst/>
+        </p:spPr>
+        <p:style>
+          <a:lnRef idx="2">
+            <a:schemeClr val="accent1"/>
+          </a:lnRef>
+          <a:fillRef idx="0">
+            <a:schemeClr val="accent1"/>
+          </a:fillRef>
+          <a:effectRef idx="1">
+            <a:schemeClr val="accent1"/>
+          </a:effectRef>
+          <a:fontRef idx="minor">
+            <a:schemeClr val="tx1"/>
+          </a:fontRef>
+        </p:style>
+      </p:cxnSp>
+      <p:sp>
+        <p:nvSpPr>
+          <p:cNvPr id="14" name="MCVerdicts"/>
+          <p:cNvSpPr txBox="1"/>
+          <p:nvPr/>
+        </p:nvSpPr>
+        <p:spPr>
+          <a:xfrm>
+            <a:off x="5349240" y="3127248"/>
+            <a:ext cx="1188720" cy="320040"/>
+          </a:xfrm>
+          <a:prstGeom prst="rect">
+            <a:avLst/>
+          </a:prstGeom>
+          <a:noFill/>
+        </p:spPr>
+        <p:txBody>
+          <a:bodyPr wrap="square" anchor="t">
+            <a:spAutoFit/>
+          </a:bodyPr>
+          <a:lstStyle/>
+          <a:p>
+            <a:pPr algn="l"/>
+            <a:r>
+              <a:rPr sz="1400" b="0" i="0">
+                <a:solidFill>
+                  <a:srgbClr val="555960"/>
+                </a:solidFill>
+              </a:rPr>
+              <a:t>verdicts</a:t>
+            </a:r>
+          </a:p>
+        </p:txBody>
+      </p:sp>
+      <p:sp>
+        <p:nvSpPr>
+          <p:cNvPr id="15" name="MCGate"/>
+          <p:cNvSpPr/>
+          <p:nvPr/>
+        </p:nvSpPr>
+        <p:spPr>
+          <a:xfrm>
+            <a:off x="3749039" y="3630168"/>
+            <a:ext cx="1645920" cy="566928"/>
+          </a:xfrm>
+          <a:prstGeom prst="rect">
+            <a:avLst/>
+          </a:prstGeom>
+          <a:solidFill>
+            <a:srgbClr val="8E6F3E"/>
+          </a:solidFill>
+          <a:ln>
+            <a:noFill/>
+          </a:ln>
+          <a:effectLst/>
+        </p:spPr>
+        <p:style>
+          <a:lnRef idx="1">
+            <a:schemeClr val="accent1"/>
+          </a:lnRef>
+          <a:fillRef idx="3">
+            <a:schemeClr val="accent1"/>
+          </a:fillRef>
+          <a:effectRef idx="2">
+            <a:schemeClr val="accent1"/>
+          </a:effectRef>
+          <a:fontRef idx="minor">
+            <a:schemeClr val="lt1"/>
+          </a:fontRef>
+        </p:style>
+        <p:txBody>
+          <a:bodyPr rtlCol="0" anchor="ctr" wrap="square" lIns="27432" rIns="27432" tIns="22860" bIns="22860"/>
+          <a:lstStyle/>
+          <a:p>
+            <a:pPr algn="ctr"/>
+            <a:r>
+              <a:rPr sz="1600" b="1" i="0">
+                <a:solidFill>
+                  <a:srgbClr val="FFFFFF"/>
+                </a:solidFill>
+              </a:rPr>
+              <a:t>GATE</a:t>
+            </a:r>
+          </a:p>
+        </p:txBody>
+      </p:sp>
+      <p:sp>
+        <p:nvSpPr>
+          <p:cNvPr id="16" name="MCPoint"/>
+          <p:cNvSpPr txBox="1"/>
+          <p:nvPr/>
+        </p:nvSpPr>
+        <p:spPr>
+          <a:xfrm>
+            <a:off x="502920" y="4572000"/>
+            <a:ext cx="8138160" cy="548640"/>
+          </a:xfrm>
+          <a:prstGeom prst="rect">
+            <a:avLst/>
+          </a:prstGeom>
+          <a:noFill/>
+        </p:spPr>
+        <p:txBody>
+          <a:bodyPr wrap="square" anchor="t">
+            <a:spAutoFit/>
+          </a:bodyPr>
+          <a:lstStyle/>
+          <a:p>
+            <a:pPr algn="ctr"/>
+            <a:r>
+              <a:rPr sz="2000" b="0" i="0">
+                <a:solidFill>
+                  <a:srgbClr val="5C4826"/>
+                </a:solidFill>
+              </a:rPr>
+              <a:t>The same explicit engineering knowledge can support multiple validators and constraints.</a:t>
+            </a:r>
+          </a:p>
+        </p:txBody>
+      </p:sp>
+      <p:sp>
+        <p:nvSpPr>
+          <p:cNvPr id="17" name="FooterBand"/>
+          <p:cNvSpPr/>
+          <p:nvPr/>
+        </p:nvSpPr>
+        <p:spPr>
+          <a:xfrm>
+            <a:off x="274320" y="5852160"/>
+            <a:ext cx="8595360" cy="566928"/>
+          </a:xfrm>
+          <a:prstGeom prst="rect">
+            <a:avLst/>
+          </a:prstGeom>
+          <a:solidFill>
+            <a:srgbClr val="8E6F3E"/>
+          </a:solidFill>
+          <a:ln>
+            <a:noFill/>
+          </a:ln>
+          <a:effectLst/>
+        </p:spPr>
+        <p:style>
+          <a:lnRef idx="1">
+            <a:schemeClr val="accent1"/>
+          </a:lnRef>
+          <a:fillRef idx="3">
+            <a:schemeClr val="accent1"/>
+          </a:fillRef>
+          <a:effectRef idx="2">
+            <a:schemeClr val="accent1"/>
+          </a:effectRef>
+          <a:fontRef idx="minor">
+            <a:schemeClr val="lt1"/>
+          </a:fontRef>
+        </p:style>
+        <p:txBody>
+          <a:bodyPr rtlCol="0" anchor="ctr" wrap="square" lIns="27432" rIns="27432" tIns="22860" bIns="22860"/>
+          <a:lstStyle/>
+          <a:p>
+            <a:pPr algn="ctr"/>
+            <a:r>
+              <a:rPr sz="2000" b="1" i="0">
+                <a:solidFill>
+                  <a:srgbClr val="FFFFFF"/>
+                </a:solidFill>
+              </a:rPr>
+              <a:t>A model becomes operational when the engineered environment uses it.</a:t>
             </a:r>
           </a:p>
         </p:txBody>

</xml_diff>

<commit_message>
deck 2-3 rebuild phase 4: reorder into the five-section causal spine
</commit_message>
<xml_diff>
--- a/course/lectures/act-2-delegation-and-control/03-alignment/2-3-Alignment.pptx
+++ b/course/lectures/act-2-delegation-and-control/03-alignment/2-3-Alignment.pptx
@@ -9,13 +9,25 @@
   </p:notesMasterIdLst>
   <p:sldIdLst>
     <p:sldId id="256" r:id="rId7"/>
+    <p:sldId id="289" r:id="rId15"/>
+    <p:sldId id="290" r:id="rId34"/>
     <p:sldId id="258" r:id="rId9"/>
     <p:sldId id="284" r:id="rId49"/>
+    <p:sldId id="291" r:id="rId35"/>
+    <p:sldId id="292" r:id="rId36"/>
+    <p:sldId id="293" r:id="rId37"/>
+    <p:sldId id="294" r:id="rId38"/>
+    <p:sldId id="295" r:id="rId39"/>
+    <p:sldId id="285" r:id="rId50"/>
+    <p:sldId id="296" r:id="rId40"/>
+    <p:sldId id="297" r:id="rId41"/>
+    <p:sldId id="298" r:id="rId42"/>
+    <p:sldId id="299" r:id="rId14"/>
     <p:sldId id="262" r:id="rId13"/>
-    <p:sldId id="285" r:id="rId50"/>
-    <p:sldId id="265" r:id="rId16"/>
+    <p:sldId id="300" r:id="rId12"/>
     <p:sldId id="266" r:id="rId17"/>
     <p:sldId id="267" r:id="rId18"/>
+    <p:sldId id="265" r:id="rId16"/>
     <p:sldId id="268" r:id="rId19"/>
     <p:sldId id="286" r:id="rId51"/>
     <p:sldId id="269" r:id="rId20"/>
@@ -23,30 +35,18 @@
     <p:sldId id="271" r:id="rId22"/>
     <p:sldId id="272" r:id="rId23"/>
     <p:sldId id="273" r:id="rId24"/>
+    <p:sldId id="288" r:id="rId53"/>
+    <p:sldId id="277" r:id="rId28"/>
+    <p:sldId id="278" r:id="rId29"/>
+    <p:sldId id="279" r:id="rId30"/>
+    <p:sldId id="301" r:id="rId11"/>
+    <p:sldId id="280" r:id="rId31"/>
+    <p:sldId id="281" r:id="rId32"/>
     <p:sldId id="287" r:id="rId52"/>
     <p:sldId id="274" r:id="rId25"/>
     <p:sldId id="275" r:id="rId26"/>
     <p:sldId id="276" r:id="rId27"/>
-    <p:sldId id="288" r:id="rId53"/>
-    <p:sldId id="277" r:id="rId28"/>
-    <p:sldId id="278" r:id="rId29"/>
-    <p:sldId id="279" r:id="rId30"/>
-    <p:sldId id="280" r:id="rId31"/>
-    <p:sldId id="281" r:id="rId32"/>
     <p:sldId id="282" r:id="rId33"/>
-    <p:sldId id="289" r:id="rId15"/>
-    <p:sldId id="290" r:id="rId34"/>
-    <p:sldId id="291" r:id="rId35"/>
-    <p:sldId id="292" r:id="rId36"/>
-    <p:sldId id="293" r:id="rId37"/>
-    <p:sldId id="294" r:id="rId38"/>
-    <p:sldId id="295" r:id="rId39"/>
-    <p:sldId id="296" r:id="rId40"/>
-    <p:sldId id="297" r:id="rId41"/>
-    <p:sldId id="298" r:id="rId42"/>
-    <p:sldId id="299" r:id="rId14"/>
-    <p:sldId id="300" r:id="rId12"/>
-    <p:sldId id="301" r:id="rId11"/>
   </p:sldIdLst>
   <p:sldSz cx="9144000" cy="6858000" type="screen4x3"/>
   <p:notesSz cx="6858000" cy="9144000"/>

</xml_diff>

<commit_message>
deck 2-3 item 1: slide 18 four roles redrawn as two conceptual pairs, not a pipeline
Replaces the CONSTRAINT -> WORK/AGENT/ARTIFACT -> VALIDATOR -> GATE map with
the chapter's two-pair tree: constraint/sensor under WORK/STATE,
validator/gate under DECISION/ADMISSION, hanging off ENGINEERING OBLIGATION.
Definitions and the roles-not-components line retained; speaker note updated.

Co-Authored-By: Claude Opus 5 <noreply@anthropic.com>
</commit_message>
<xml_diff>
--- a/course/lectures/act-2-delegation-and-control/03-alignment/2-3-Alignment.pptx
+++ b/course/lectures/act-2-delegation-and-control/03-alignment/2-3-Alignment.pptx
@@ -688,7 +688,7 @@
           <a:lstStyle/>
           <a:p>
             <a:r>
-              <a:t>A CI test can sense, validate, and gate at once; a narrow interface constrains while producing evidence of use. Then map the roles onto the delegated process: constraint bounds the agent; sensor observes it; validator judges the artifact; the gate decides whether work crosses the next boundary.</a:t>
+              <a:t>The four roles are two conceptual pairs, not a pipeline: constraint and sensor concern the work and its state (what may happen; what did happen); validator and gate concern judgment and admission (is it OK; may it pass). One mechanism may bundle roles: a CI test senses, validates, and gates at once; a narrow interface constrains while producing evidence of use.</a:t>
             </a:r>
           </a:p>
         </p:txBody>
@@ -11664,14 +11664,66 @@
       </p:sp>
       <p:sp>
         <p:nvSpPr>
-          <p:cNvPr id="18" name="MapConstraint"/>
+          <p:cNvPr id="18" name="PairObligation"/>
           <p:cNvSpPr/>
           <p:nvPr/>
         </p:nvSpPr>
         <p:spPr>
           <a:xfrm>
-            <a:off x="1965960" y="4160520"/>
-            <a:ext cx="1554480" cy="475488"/>
+            <a:off x="3017520" y="4096512"/>
+            <a:ext cx="3108960" cy="438912"/>
+          </a:xfrm>
+          <a:prstGeom prst="rect">
+            <a:avLst/>
+          </a:prstGeom>
+          <a:solidFill>
+            <a:srgbClr val="8E6F3E"/>
+          </a:solidFill>
+          <a:ln>
+            <a:noFill/>
+          </a:ln>
+          <a:effectLst/>
+        </p:spPr>
+        <p:style>
+          <a:lnRef idx="1">
+            <a:schemeClr val="accent1"/>
+          </a:lnRef>
+          <a:fillRef idx="3">
+            <a:schemeClr val="accent1"/>
+          </a:fillRef>
+          <a:effectRef idx="2">
+            <a:schemeClr val="accent1"/>
+          </a:effectRef>
+          <a:fontRef idx="minor">
+            <a:schemeClr val="lt1"/>
+          </a:fontRef>
+        </p:style>
+        <p:txBody>
+          <a:bodyPr rtlCol="0" anchor="ctr" wrap="square" lIns="27432" rIns="27432" tIns="22860" bIns="22860"/>
+          <a:lstStyle/>
+          <a:p>
+            <a:pPr algn="ctr"/>
+            <a:r>
+              <a:rPr sz="1400" b="1" i="0">
+                <a:solidFill>
+                  <a:srgbClr val="FFFFFF"/>
+                </a:solidFill>
+              </a:rPr>
+              <a:t>ENGINEERING OBLIGATION</a:t>
+            </a:r>
+          </a:p>
+        </p:txBody>
+      </p:sp>
+      <p:sp>
+        <p:nvSpPr>
+          <p:cNvPr id="19" name="PairWorkState"/>
+          <p:cNvSpPr/>
+          <p:nvPr/>
+        </p:nvSpPr>
+        <p:spPr>
+          <a:xfrm>
+            <a:off x="1234440" y="4864608"/>
+            <a:ext cx="2286000" cy="411480"/>
           </a:xfrm>
           <a:prstGeom prst="rect">
             <a:avLst/>
@@ -11706,63 +11758,26 @@
           <a:p>
             <a:pPr algn="ctr"/>
             <a:r>
-              <a:rPr sz="1400" b="1" i="0">
+              <a:rPr sz="1300" b="1" i="0">
                 <a:solidFill>
                   <a:srgbClr val="5C4826"/>
                 </a:solidFill>
               </a:rPr>
-              <a:t>CONSTRAINT</a:t>
-            </a:r>
-          </a:p>
-        </p:txBody>
-      </p:sp>
-      <p:cxnSp>
-        <p:nvCxnSpPr>
-          <p:cNvPr id="19" name="Connector 18"/>
-          <p:cNvCxnSpPr/>
-          <p:nvPr/>
-        </p:nvCxnSpPr>
-        <p:spPr>
-          <a:xfrm>
-            <a:off x="2743200" y="4636008"/>
-            <a:ext cx="0" cy="256032"/>
-          </a:xfrm>
-          <a:prstGeom prst="line">
-            <a:avLst/>
-          </a:prstGeom>
-          <a:ln w="28575">
-            <a:solidFill>
-              <a:srgbClr val="8E6F3E"/>
-            </a:solidFill>
-            <a:tailEnd type="triangle" w="med" len="med"/>
-          </a:ln>
-          <a:effectLst/>
-        </p:spPr>
-        <p:style>
-          <a:lnRef idx="2">
-            <a:schemeClr val="accent1"/>
-          </a:lnRef>
-          <a:fillRef idx="0">
-            <a:schemeClr val="accent1"/>
-          </a:fillRef>
-          <a:effectRef idx="1">
-            <a:schemeClr val="accent1"/>
-          </a:effectRef>
-          <a:fontRef idx="minor">
-            <a:schemeClr val="tx1"/>
-          </a:fontRef>
-        </p:style>
-      </p:cxnSp>
-      <p:sp>
-        <p:nvSpPr>
-          <p:cNvPr id="20" name="MapWork"/>
+              <a:t>WORK / STATE</a:t>
+            </a:r>
+          </a:p>
+        </p:txBody>
+      </p:sp>
+      <p:sp>
+        <p:nvSpPr>
+          <p:cNvPr id="20" name="PairDecision"/>
           <p:cNvSpPr/>
           <p:nvPr/>
         </p:nvSpPr>
         <p:spPr>
           <a:xfrm>
-            <a:off x="502920" y="4892040"/>
-            <a:ext cx="1188720" cy="530352"/>
+            <a:off x="5623560" y="4864608"/>
+            <a:ext cx="2286000" cy="411480"/>
           </a:xfrm>
           <a:prstGeom prst="rect">
             <a:avLst/>
@@ -11797,152 +11812,26 @@
           <a:p>
             <a:pPr algn="ctr"/>
             <a:r>
-              <a:rPr sz="1400" b="1" i="0">
+              <a:rPr sz="1300" b="1" i="0">
                 <a:solidFill>
                   <a:srgbClr val="5C4826"/>
                 </a:solidFill>
               </a:rPr>
-              <a:t>WORK</a:t>
-            </a:r>
-          </a:p>
-        </p:txBody>
-      </p:sp>
-      <p:cxnSp>
-        <p:nvCxnSpPr>
-          <p:cNvPr id="21" name="Connector 20"/>
-          <p:cNvCxnSpPr/>
-          <p:nvPr/>
-        </p:nvCxnSpPr>
-        <p:spPr>
-          <a:xfrm>
-            <a:off x="1691640" y="5157216"/>
-            <a:ext cx="274320" cy="0"/>
-          </a:xfrm>
-          <a:prstGeom prst="line">
-            <a:avLst/>
-          </a:prstGeom>
-          <a:ln w="28575">
-            <a:solidFill>
-              <a:srgbClr val="8E6F3E"/>
-            </a:solidFill>
-            <a:tailEnd type="triangle" w="med" len="med"/>
-          </a:ln>
-          <a:effectLst/>
-        </p:spPr>
-        <p:style>
-          <a:lnRef idx="2">
-            <a:schemeClr val="accent1"/>
-          </a:lnRef>
-          <a:fillRef idx="0">
-            <a:schemeClr val="accent1"/>
-          </a:fillRef>
-          <a:effectRef idx="1">
-            <a:schemeClr val="accent1"/>
-          </a:effectRef>
-          <a:fontRef idx="minor">
-            <a:schemeClr val="tx1"/>
-          </a:fontRef>
-        </p:style>
-      </p:cxnSp>
-      <p:sp>
-        <p:nvSpPr>
-          <p:cNvPr id="22" name="MapAgent"/>
+              <a:t>DECISION / ADMISSION</a:t>
+            </a:r>
+          </a:p>
+        </p:txBody>
+      </p:sp>
+      <p:sp>
+        <p:nvSpPr>
+          <p:cNvPr id="21" name="PairLeafConstraint"/>
           <p:cNvSpPr/>
           <p:nvPr/>
         </p:nvSpPr>
         <p:spPr>
           <a:xfrm>
-            <a:off x="1965960" y="4892040"/>
-            <a:ext cx="1554480" cy="530352"/>
-          </a:xfrm>
-          <a:prstGeom prst="rect">
-            <a:avLst/>
-          </a:prstGeom>
-          <a:solidFill>
-            <a:srgbClr val="8E6F3E"/>
-          </a:solidFill>
-          <a:ln>
-            <a:noFill/>
-          </a:ln>
-          <a:effectLst/>
-        </p:spPr>
-        <p:style>
-          <a:lnRef idx="1">
-            <a:schemeClr val="accent1"/>
-          </a:lnRef>
-          <a:fillRef idx="3">
-            <a:schemeClr val="accent1"/>
-          </a:fillRef>
-          <a:effectRef idx="2">
-            <a:schemeClr val="accent1"/>
-          </a:effectRef>
-          <a:fontRef idx="minor">
-            <a:schemeClr val="lt1"/>
-          </a:fontRef>
-        </p:style>
-        <p:txBody>
-          <a:bodyPr rtlCol="0" anchor="ctr" wrap="square" lIns="27432" rIns="27432" tIns="22860" bIns="22860"/>
-          <a:lstStyle/>
-          <a:p>
-            <a:pPr algn="ctr"/>
-            <a:r>
-              <a:rPr sz="1400" b="1" i="0">
-                <a:solidFill>
-                  <a:srgbClr val="FFFFFF"/>
-                </a:solidFill>
-              </a:rPr>
-              <a:t>AGENT</a:t>
-            </a:r>
-          </a:p>
-        </p:txBody>
-      </p:sp>
-      <p:cxnSp>
-        <p:nvCxnSpPr>
-          <p:cNvPr id="23" name="Connector 22"/>
-          <p:cNvCxnSpPr/>
-          <p:nvPr/>
-        </p:nvCxnSpPr>
-        <p:spPr>
-          <a:xfrm>
-            <a:off x="3520440" y="5157216"/>
-            <a:ext cx="274320" cy="0"/>
-          </a:xfrm>
-          <a:prstGeom prst="line">
-            <a:avLst/>
-          </a:prstGeom>
-          <a:ln w="28575">
-            <a:solidFill>
-              <a:srgbClr val="8E6F3E"/>
-            </a:solidFill>
-            <a:tailEnd type="triangle" w="med" len="med"/>
-          </a:ln>
-          <a:effectLst/>
-        </p:spPr>
-        <p:style>
-          <a:lnRef idx="2">
-            <a:schemeClr val="accent1"/>
-          </a:lnRef>
-          <a:fillRef idx="0">
-            <a:schemeClr val="accent1"/>
-          </a:fillRef>
-          <a:effectRef idx="1">
-            <a:schemeClr val="accent1"/>
-          </a:effectRef>
-          <a:fontRef idx="minor">
-            <a:schemeClr val="tx1"/>
-          </a:fontRef>
-        </p:style>
-      </p:cxnSp>
-      <p:sp>
-        <p:nvSpPr>
-          <p:cNvPr id="24" name="MapArtifact"/>
-          <p:cNvSpPr/>
-          <p:nvPr/>
-        </p:nvSpPr>
-        <p:spPr>
-          <a:xfrm>
-            <a:off x="3794760" y="4892040"/>
-            <a:ext cx="1554480" cy="530352"/>
+            <a:off x="502920" y="5532120"/>
+            <a:ext cx="1783080" cy="731520"/>
           </a:xfrm>
           <a:prstGeom prst="rect">
             <a:avLst/>
@@ -11977,63 +11866,37 @@
           <a:p>
             <a:pPr algn="ctr"/>
             <a:r>
-              <a:rPr sz="1400" b="1" i="0">
+              <a:rPr sz="1300" b="1" i="0">
                 <a:solidFill>
                   <a:srgbClr val="5C4826"/>
                 </a:solidFill>
               </a:rPr>
-              <a:t>ARTIFACT</a:t>
-            </a:r>
-          </a:p>
-        </p:txBody>
-      </p:sp>
-      <p:cxnSp>
-        <p:nvCxnSpPr>
-          <p:cNvPr id="25" name="Connector 24"/>
-          <p:cNvCxnSpPr/>
-          <p:nvPr/>
-        </p:nvCxnSpPr>
-        <p:spPr>
-          <a:xfrm>
-            <a:off x="2743200" y="5422392"/>
-            <a:ext cx="0" cy="265176"/>
-          </a:xfrm>
-          <a:prstGeom prst="line">
-            <a:avLst/>
-          </a:prstGeom>
-          <a:ln w="28575">
-            <a:solidFill>
-              <a:srgbClr val="8E6F3E"/>
-            </a:solidFill>
-            <a:tailEnd type="triangle" w="med" len="med"/>
-          </a:ln>
-          <a:effectLst/>
-        </p:spPr>
-        <p:style>
-          <a:lnRef idx="2">
-            <a:schemeClr val="accent1"/>
-          </a:lnRef>
-          <a:fillRef idx="0">
-            <a:schemeClr val="accent1"/>
-          </a:fillRef>
-          <a:effectRef idx="1">
-            <a:schemeClr val="accent1"/>
-          </a:effectRef>
-          <a:fontRef idx="minor">
-            <a:schemeClr val="tx1"/>
-          </a:fontRef>
-        </p:style>
-      </p:cxnSp>
-      <p:sp>
-        <p:nvSpPr>
-          <p:cNvPr id="26" name="MapSensor"/>
+              <a:t>CONSTRAINT</a:t>
+            </a:r>
+          </a:p>
+          <a:p>
+            <a:pPr algn="ctr"/>
+            <a:r>
+              <a:rPr sz="1000" b="0" i="1">
+                <a:solidFill>
+                  <a:srgbClr val="555960"/>
+                </a:solidFill>
+              </a:rPr>
+              <a:t>what may happen</a:t>
+            </a:r>
+          </a:p>
+        </p:txBody>
+      </p:sp>
+      <p:sp>
+        <p:nvSpPr>
+          <p:cNvPr id="22" name="PairLeafSensor"/>
           <p:cNvSpPr/>
           <p:nvPr/>
         </p:nvSpPr>
         <p:spPr>
           <a:xfrm>
-            <a:off x="1965960" y="5687568"/>
-            <a:ext cx="1554480" cy="475488"/>
+            <a:off x="2468880" y="5532120"/>
+            <a:ext cx="1783080" cy="731520"/>
           </a:xfrm>
           <a:prstGeom prst="rect">
             <a:avLst/>
@@ -12068,7 +11931,7 @@
           <a:p>
             <a:pPr algn="ctr"/>
             <a:r>
-              <a:rPr sz="1400" b="1" i="0">
+              <a:rPr sz="1300" b="1" i="0">
                 <a:solidFill>
                   <a:srgbClr val="5C4826"/>
                 </a:solidFill>
@@ -12076,55 +11939,29 @@
               <a:t>SENSOR</a:t>
             </a:r>
           </a:p>
-        </p:txBody>
-      </p:sp>
-      <p:cxnSp>
-        <p:nvCxnSpPr>
-          <p:cNvPr id="27" name="Connector 26"/>
-          <p:cNvCxnSpPr/>
-          <p:nvPr/>
-        </p:nvCxnSpPr>
-        <p:spPr>
-          <a:xfrm>
-            <a:off x="4572000" y="5422392"/>
-            <a:ext cx="0" cy="265176"/>
-          </a:xfrm>
-          <a:prstGeom prst="line">
-            <a:avLst/>
-          </a:prstGeom>
-          <a:ln w="28575">
-            <a:solidFill>
-              <a:srgbClr val="8E6F3E"/>
-            </a:solidFill>
-            <a:tailEnd type="triangle" w="med" len="med"/>
-          </a:ln>
-          <a:effectLst/>
-        </p:spPr>
-        <p:style>
-          <a:lnRef idx="2">
-            <a:schemeClr val="accent1"/>
-          </a:lnRef>
-          <a:fillRef idx="0">
-            <a:schemeClr val="accent1"/>
-          </a:fillRef>
-          <a:effectRef idx="1">
-            <a:schemeClr val="accent1"/>
-          </a:effectRef>
-          <a:fontRef idx="minor">
-            <a:schemeClr val="tx1"/>
-          </a:fontRef>
-        </p:style>
-      </p:cxnSp>
-      <p:sp>
-        <p:nvSpPr>
-          <p:cNvPr id="28" name="MapValidator"/>
+          <a:p>
+            <a:pPr algn="ctr"/>
+            <a:r>
+              <a:rPr sz="1000" b="0" i="1">
+                <a:solidFill>
+                  <a:srgbClr val="555960"/>
+                </a:solidFill>
+              </a:rPr>
+              <a:t>what happened</a:t>
+            </a:r>
+          </a:p>
+        </p:txBody>
+      </p:sp>
+      <p:sp>
+        <p:nvSpPr>
+          <p:cNvPr id="23" name="PairLeafValidator"/>
           <p:cNvSpPr/>
           <p:nvPr/>
         </p:nvSpPr>
         <p:spPr>
           <a:xfrm>
-            <a:off x="3794760" y="5687568"/>
-            <a:ext cx="1554480" cy="475488"/>
+            <a:off x="4892040" y="5532120"/>
+            <a:ext cx="1783080" cy="731520"/>
           </a:xfrm>
           <a:prstGeom prst="rect">
             <a:avLst/>
@@ -12159,7 +11996,7 @@
           <a:p>
             <a:pPr algn="ctr"/>
             <a:r>
-              <a:rPr sz="1400" b="1" i="0">
+              <a:rPr sz="1300" b="1" i="0">
                 <a:solidFill>
                   <a:srgbClr val="5C4826"/>
                 </a:solidFill>
@@ -12167,141 +12004,29 @@
               <a:t>VALIDATOR</a:t>
             </a:r>
           </a:p>
-        </p:txBody>
-      </p:sp>
-      <p:sp>
-        <p:nvSpPr>
-          <p:cNvPr id="31" name="MapEvidence"/>
-          <p:cNvSpPr txBox="1"/>
-          <p:nvPr/>
-        </p:nvSpPr>
-        <p:spPr>
-          <a:xfrm>
-            <a:off x="3127248" y="6199632"/>
-            <a:ext cx="1097280" cy="274320"/>
-          </a:xfrm>
-          <a:prstGeom prst="rect">
-            <a:avLst/>
-          </a:prstGeom>
-          <a:noFill/>
-        </p:spPr>
-        <p:txBody>
-          <a:bodyPr wrap="square" anchor="ctr">
-            <a:spAutoFit/>
-          </a:bodyPr>
-          <a:lstStyle/>
           <a:p>
             <a:pPr algn="ctr"/>
             <a:r>
-              <a:rPr sz="1100" b="0" i="0">
+              <a:rPr sz="1000" b="0" i="1">
                 <a:solidFill>
                   <a:srgbClr val="555960"/>
                 </a:solidFill>
               </a:rPr>
-              <a:t>evidence</a:t>
-            </a:r>
-          </a:p>
-        </p:txBody>
-      </p:sp>
-      <p:sp>
-        <p:nvSpPr>
-          <p:cNvPr id="32" name="MapGate"/>
+              <a:t>is it OK?</a:t>
+            </a:r>
+          </a:p>
+        </p:txBody>
+      </p:sp>
+      <p:sp>
+        <p:nvSpPr>
+          <p:cNvPr id="24" name="PairLeafGate"/>
           <p:cNvSpPr/>
           <p:nvPr/>
         </p:nvSpPr>
         <p:spPr>
           <a:xfrm>
-            <a:off x="6035040" y="5687568"/>
-            <a:ext cx="1188720" cy="475488"/>
-          </a:xfrm>
-          <a:prstGeom prst="rect">
-            <a:avLst/>
-          </a:prstGeom>
-          <a:solidFill>
-            <a:srgbClr val="8E6F3E"/>
-          </a:solidFill>
-          <a:ln>
-            <a:noFill/>
-          </a:ln>
-          <a:effectLst/>
-        </p:spPr>
-        <p:style>
-          <a:lnRef idx="1">
-            <a:schemeClr val="accent1"/>
-          </a:lnRef>
-          <a:fillRef idx="3">
-            <a:schemeClr val="accent1"/>
-          </a:fillRef>
-          <a:effectRef idx="2">
-            <a:schemeClr val="accent1"/>
-          </a:effectRef>
-          <a:fontRef idx="minor">
-            <a:schemeClr val="lt1"/>
-          </a:fontRef>
-        </p:style>
-        <p:txBody>
-          <a:bodyPr rtlCol="0" anchor="ctr" wrap="square" lIns="27432" rIns="27432" tIns="22860" bIns="22860"/>
-          <a:lstStyle/>
-          <a:p>
-            <a:pPr algn="ctr"/>
-            <a:r>
-              <a:rPr sz="1400" b="1" i="0">
-                <a:solidFill>
-                  <a:srgbClr val="FFFFFF"/>
-                </a:solidFill>
-              </a:rPr>
-              <a:t>GATE</a:t>
-            </a:r>
-          </a:p>
-        </p:txBody>
-      </p:sp>
-      <p:cxnSp>
-        <p:nvCxnSpPr>
-          <p:cNvPr id="33" name="Connector 32"/>
-          <p:cNvCxnSpPr/>
-          <p:nvPr/>
-        </p:nvCxnSpPr>
-        <p:spPr>
-          <a:xfrm>
-            <a:off x="7223760" y="5925312"/>
-            <a:ext cx="274319" cy="0"/>
-          </a:xfrm>
-          <a:prstGeom prst="line">
-            <a:avLst/>
-          </a:prstGeom>
-          <a:ln w="28575">
-            <a:solidFill>
-              <a:srgbClr val="8E6F3E"/>
-            </a:solidFill>
-            <a:tailEnd type="triangle" w="med" len="med"/>
-          </a:ln>
-          <a:effectLst/>
-        </p:spPr>
-        <p:style>
-          <a:lnRef idx="2">
-            <a:schemeClr val="accent1"/>
-          </a:lnRef>
-          <a:fillRef idx="0">
-            <a:schemeClr val="accent1"/>
-          </a:fillRef>
-          <a:effectRef idx="1">
-            <a:schemeClr val="accent1"/>
-          </a:effectRef>
-          <a:fontRef idx="minor">
-            <a:schemeClr val="tx1"/>
-          </a:fontRef>
-        </p:style>
-      </p:cxnSp>
-      <p:sp>
-        <p:nvSpPr>
-          <p:cNvPr id="34" name="MapNext"/>
-          <p:cNvSpPr/>
-          <p:nvPr/>
-        </p:nvSpPr>
-        <p:spPr>
-          <a:xfrm>
-            <a:off x="7498079" y="5687568"/>
-            <a:ext cx="1417320" cy="475488"/>
+            <a:off x="6858000" y="5532120"/>
+            <a:ext cx="1783080" cy="731520"/>
           </a:xfrm>
           <a:prstGeom prst="rect">
             <a:avLst/>
@@ -12336,26 +12061,37 @@
           <a:p>
             <a:pPr algn="ctr"/>
             <a:r>
-              <a:rPr sz="1100" b="1" i="0">
+              <a:rPr sz="1300" b="1" i="0">
                 <a:solidFill>
                   <a:srgbClr val="5C4826"/>
                 </a:solidFill>
               </a:rPr>
-              <a:t>NEXT BOUNDARY</a:t>
+              <a:t>GATE</a:t>
+            </a:r>
+          </a:p>
+          <a:p>
+            <a:pPr algn="ctr"/>
+            <a:r>
+              <a:rPr sz="1000" b="0" i="1">
+                <a:solidFill>
+                  <a:srgbClr val="555960"/>
+                </a:solidFill>
+              </a:rPr>
+              <a:t>may it pass?</a:t>
             </a:r>
           </a:p>
         </p:txBody>
       </p:sp>
       <p:cxnSp>
         <p:nvCxnSpPr>
-          <p:cNvPr id="35" name="Connector 34"/>
+          <p:cNvPr id="25" name="PairConnL"/>
           <p:cNvCxnSpPr/>
           <p:nvPr/>
         </p:nvCxnSpPr>
         <p:spPr>
-          <a:xfrm>
-            <a:off x="3520440" y="5925312"/>
-            <a:ext cx="274320" cy="0"/>
+          <a:xfrm flipH="1">
+            <a:off x="2377440" y="4535424"/>
+            <a:ext cx="2194560" cy="329184"/>
           </a:xfrm>
           <a:prstGeom prst="line">
             <a:avLst/>
@@ -12366,7 +12102,6 @@
             </a:solidFill>
             <a:tailEnd type="triangle" w="med" len="med"/>
           </a:ln>
-          <a:effectLst/>
         </p:spPr>
         <p:style>
           <a:lnRef idx="2">
@@ -12385,14 +12120,14 @@
       </p:cxnSp>
       <p:cxnSp>
         <p:nvCxnSpPr>
-          <p:cNvPr id="36" name="Connector 35"/>
+          <p:cNvPr id="26" name="PairConnR"/>
           <p:cNvCxnSpPr/>
           <p:nvPr/>
         </p:nvCxnSpPr>
         <p:spPr>
           <a:xfrm>
-            <a:off x="5349240" y="5925312"/>
-            <a:ext cx="685800" cy="0"/>
+            <a:off x="4572000" y="4535424"/>
+            <a:ext cx="2194560" cy="329184"/>
           </a:xfrm>
           <a:prstGeom prst="line">
             <a:avLst/>
@@ -12403,7 +12138,6 @@
             </a:solidFill>
             <a:tailEnd type="triangle" w="med" len="med"/>
           </a:ln>
-          <a:effectLst/>
         </p:spPr>
         <p:style>
           <a:lnRef idx="2">
@@ -12420,40 +12154,150 @@
           </a:fontRef>
         </p:style>
       </p:cxnSp>
-      <p:sp>
-        <p:nvSpPr>
-          <p:cNvPr id="37" name="MapVerdict"/>
-          <p:cNvSpPr txBox="1"/>
-          <p:nvPr/>
-        </p:nvSpPr>
-        <p:spPr>
-          <a:xfrm>
-            <a:off x="5257800" y="6199632"/>
-            <a:ext cx="914400" cy="237744"/>
-          </a:xfrm>
-          <a:prstGeom prst="rect">
-            <a:avLst/>
-          </a:prstGeom>
-          <a:noFill/>
-        </p:spPr>
-        <p:txBody>
-          <a:bodyPr wrap="square" anchor="t">
-            <a:spAutoFit/>
-          </a:bodyPr>
-          <a:lstStyle/>
-          <a:p>
-            <a:pPr algn="ctr"/>
-            <a:r>
-              <a:rPr sz="1100" b="0" i="0">
-                <a:solidFill>
-                  <a:srgbClr val="555960"/>
-                </a:solidFill>
-              </a:rPr>
-              <a:t>verdict</a:t>
-            </a:r>
-          </a:p>
-        </p:txBody>
-      </p:sp>
+      <p:cxnSp>
+        <p:nvCxnSpPr>
+          <p:cNvPr id="27" name="PairConnL1"/>
+          <p:cNvCxnSpPr/>
+          <p:nvPr/>
+        </p:nvCxnSpPr>
+        <p:spPr>
+          <a:xfrm flipH="1">
+            <a:off x="1394460" y="5276088"/>
+            <a:ext cx="982980" cy="256032"/>
+          </a:xfrm>
+          <a:prstGeom prst="line">
+            <a:avLst/>
+          </a:prstGeom>
+          <a:ln w="28575">
+            <a:solidFill>
+              <a:srgbClr val="8E6F3E"/>
+            </a:solidFill>
+            <a:tailEnd type="triangle" w="med" len="med"/>
+          </a:ln>
+        </p:spPr>
+        <p:style>
+          <a:lnRef idx="2">
+            <a:schemeClr val="accent1"/>
+          </a:lnRef>
+          <a:fillRef idx="0">
+            <a:schemeClr val="accent1"/>
+          </a:fillRef>
+          <a:effectRef idx="1">
+            <a:schemeClr val="accent1"/>
+          </a:effectRef>
+          <a:fontRef idx="minor">
+            <a:schemeClr val="tx1"/>
+          </a:fontRef>
+        </p:style>
+      </p:cxnSp>
+      <p:cxnSp>
+        <p:nvCxnSpPr>
+          <p:cNvPr id="28" name="PairConnL2"/>
+          <p:cNvCxnSpPr/>
+          <p:nvPr/>
+        </p:nvCxnSpPr>
+        <p:spPr>
+          <a:xfrm>
+            <a:off x="2377440" y="5276088"/>
+            <a:ext cx="982980" cy="256032"/>
+          </a:xfrm>
+          <a:prstGeom prst="line">
+            <a:avLst/>
+          </a:prstGeom>
+          <a:ln w="28575">
+            <a:solidFill>
+              <a:srgbClr val="8E6F3E"/>
+            </a:solidFill>
+            <a:tailEnd type="triangle" w="med" len="med"/>
+          </a:ln>
+        </p:spPr>
+        <p:style>
+          <a:lnRef idx="2">
+            <a:schemeClr val="accent1"/>
+          </a:lnRef>
+          <a:fillRef idx="0">
+            <a:schemeClr val="accent1"/>
+          </a:fillRef>
+          <a:effectRef idx="1">
+            <a:schemeClr val="accent1"/>
+          </a:effectRef>
+          <a:fontRef idx="minor">
+            <a:schemeClr val="tx1"/>
+          </a:fontRef>
+        </p:style>
+      </p:cxnSp>
+      <p:cxnSp>
+        <p:nvCxnSpPr>
+          <p:cNvPr id="29" name="PairConnR1"/>
+          <p:cNvCxnSpPr/>
+          <p:nvPr/>
+        </p:nvCxnSpPr>
+        <p:spPr>
+          <a:xfrm flipH="1">
+            <a:off x="5783580" y="5276088"/>
+            <a:ext cx="982980" cy="256032"/>
+          </a:xfrm>
+          <a:prstGeom prst="line">
+            <a:avLst/>
+          </a:prstGeom>
+          <a:ln w="28575">
+            <a:solidFill>
+              <a:srgbClr val="8E6F3E"/>
+            </a:solidFill>
+            <a:tailEnd type="triangle" w="med" len="med"/>
+          </a:ln>
+        </p:spPr>
+        <p:style>
+          <a:lnRef idx="2">
+            <a:schemeClr val="accent1"/>
+          </a:lnRef>
+          <a:fillRef idx="0">
+            <a:schemeClr val="accent1"/>
+          </a:fillRef>
+          <a:effectRef idx="1">
+            <a:schemeClr val="accent1"/>
+          </a:effectRef>
+          <a:fontRef idx="minor">
+            <a:schemeClr val="tx1"/>
+          </a:fontRef>
+        </p:style>
+      </p:cxnSp>
+      <p:cxnSp>
+        <p:nvCxnSpPr>
+          <p:cNvPr id="30" name="PairConnR2"/>
+          <p:cNvCxnSpPr/>
+          <p:nvPr/>
+        </p:nvCxnSpPr>
+        <p:spPr>
+          <a:xfrm>
+            <a:off x="6766560" y="5276088"/>
+            <a:ext cx="982980" cy="256032"/>
+          </a:xfrm>
+          <a:prstGeom prst="line">
+            <a:avLst/>
+          </a:prstGeom>
+          <a:ln w="28575">
+            <a:solidFill>
+              <a:srgbClr val="8E6F3E"/>
+            </a:solidFill>
+            <a:tailEnd type="triangle" w="med" len="med"/>
+          </a:ln>
+        </p:spPr>
+        <p:style>
+          <a:lnRef idx="2">
+            <a:schemeClr val="accent1"/>
+          </a:lnRef>
+          <a:fillRef idx="0">
+            <a:schemeClr val="accent1"/>
+          </a:fillRef>
+          <a:effectRef idx="1">
+            <a:schemeClr val="accent1"/>
+          </a:effectRef>
+          <a:fontRef idx="minor">
+            <a:schemeClr val="tx1"/>
+          </a:fontRef>
+        </p:style>
+      </p:cxnSp>
     </p:spTree>
   </p:cSld>
   <p:clrMapOvr>

</xml_diff>

<commit_message>
deck 2-3 item 2: slide 19 adopts Fig 3.3-1 constraint-vs-sensor decision tree
Replaces the PREVENT/DETECT two-column prose with the chapter's decision-tree
asset (book/assets/constraint-vs-sensor.svg rendered at 3200px), so the deck
and chapter cannot drift. Footer retained verbatim; explanatory line kept
below the figure.

Co-Authored-By: Claude Opus 5 <noreply@anthropic.com>
</commit_message>
<xml_diff>
--- a/course/lectures/act-2-delegation-and-control/03-alignment/2-3-Alignment.pptx
+++ b/course/lectures/act-2-delegation-and-control/03-alignment/2-3-Alignment.pptx
@@ -758,7 +758,7 @@
           <a:lstStyle/>
           <a:p>
             <a:r>
-              <a:t>The first engineering preference is prevention — when cheap and reliable. Enum/permission/narrow-API versus test/trace examples.</a:t>
+              <a:t>Figure 3.3-1 (constraint vs sensor): the student performs the choice. Can the unwanted state be excluded cleanly and reliably? YES: constraint (typed enum, permission, narrow API). NO: sensor (metric, trace, call scan, log) — then validate the evidence, and gate on the verdict when appropriate. The first engineering preference is prevention, when cheap and reliable.</a:t>
             </a:r>
           </a:p>
         </p:txBody>
@@ -12367,203 +12367,13 @@
       </p:sp>
       <p:sp>
         <p:nvSpPr>
-          <p:cNvPr id="5" name="Rectangle 4"/>
-          <p:cNvSpPr/>
-          <p:nvPr/>
-        </p:nvSpPr>
-        <p:spPr>
-          <a:xfrm>
-            <a:off x="502920" y="1051560"/>
-            <a:ext cx="3977639" cy="2377440"/>
-          </a:xfrm>
-          <a:prstGeom prst="rect">
-            <a:avLst/>
-          </a:prstGeom>
-          <a:solidFill>
-            <a:srgbClr val="F5F1E8"/>
-          </a:solidFill>
-          <a:ln w="12700">
-            <a:solidFill>
-              <a:srgbClr val="C9B991"/>
-            </a:solidFill>
-          </a:ln>
-          <a:effectLst/>
-        </p:spPr>
-        <p:style>
-          <a:lnRef idx="1">
-            <a:schemeClr val="accent1"/>
-          </a:lnRef>
-          <a:fillRef idx="3">
-            <a:schemeClr val="accent1"/>
-          </a:fillRef>
-          <a:effectRef idx="2">
-            <a:schemeClr val="accent1"/>
-          </a:effectRef>
-          <a:fontRef idx="minor">
-            <a:schemeClr val="lt1"/>
-          </a:fontRef>
-        </p:style>
-        <p:txBody>
-          <a:bodyPr rtlCol="0" anchor="t" wrap="square" lIns="137160" rIns="27432" tIns="73152" bIns="22860"/>
-          <a:lstStyle/>
-          <a:p>
-            <a:pPr algn="l"/>
-            <a:r>
-              <a:rPr sz="2000" b="1" i="0">
-                <a:solidFill>
-                  <a:srgbClr val="8E6F3E"/>
-                </a:solidFill>
-              </a:rPr>
-              <a:t>PREVENT</a:t>
-            </a:r>
-          </a:p>
-          <a:p>
-            <a:pPr algn="l">
-              <a:spcBef>
-                <a:spcPts val="800"/>
-              </a:spcBef>
-            </a:pPr>
-            <a:r>
-              <a:rPr sz="1800" b="0" i="0">
-                <a:solidFill>
-                  <a:srgbClr val="5C4826"/>
-                </a:solidFill>
-              </a:rPr>
-              <a:t>If an invalid state can be excluded cheaply and reliably, constrain it.</a:t>
-            </a:r>
-          </a:p>
-          <a:p>
-            <a:pPr algn="l">
-              <a:spcBef>
-                <a:spcPts val="1000"/>
-              </a:spcBef>
-            </a:pPr>
-            <a:r>
-              <a:rPr sz="1800" b="0" i="1">
-                <a:solidFill>
-                  <a:srgbClr val="555960"/>
-                </a:solidFill>
-              </a:rPr>
-              <a:t>closed enumeration · permission</a:t>
-            </a:r>
-          </a:p>
-          <a:p>
-            <a:pPr algn="l"/>
-            <a:r>
-              <a:rPr sz="1800" b="0" i="1">
-                <a:solidFill>
-                  <a:srgbClr val="555960"/>
-                </a:solidFill>
-              </a:rPr>
-              <a:t>narrow API · typed representation</a:t>
-            </a:r>
-          </a:p>
-        </p:txBody>
-      </p:sp>
-      <p:sp>
-        <p:nvSpPr>
-          <p:cNvPr id="6" name="Rectangle 5"/>
-          <p:cNvSpPr/>
-          <p:nvPr/>
-        </p:nvSpPr>
-        <p:spPr>
-          <a:xfrm>
-            <a:off x="4663440" y="1051560"/>
-            <a:ext cx="3977639" cy="2377440"/>
-          </a:xfrm>
-          <a:prstGeom prst="rect">
-            <a:avLst/>
-          </a:prstGeom>
-          <a:solidFill>
-            <a:srgbClr val="FBF8F2"/>
-          </a:solidFill>
-          <a:ln w="12700">
-            <a:solidFill>
-              <a:srgbClr val="C9B991"/>
-            </a:solidFill>
-          </a:ln>
-          <a:effectLst/>
-        </p:spPr>
-        <p:style>
-          <a:lnRef idx="1">
-            <a:schemeClr val="accent1"/>
-          </a:lnRef>
-          <a:fillRef idx="3">
-            <a:schemeClr val="accent1"/>
-          </a:fillRef>
-          <a:effectRef idx="2">
-            <a:schemeClr val="accent1"/>
-          </a:effectRef>
-          <a:fontRef idx="minor">
-            <a:schemeClr val="lt1"/>
-          </a:fontRef>
-        </p:style>
-        <p:txBody>
-          <a:bodyPr rtlCol="0" anchor="t" wrap="square" lIns="137160" rIns="27432" tIns="73152" bIns="22860"/>
-          <a:lstStyle/>
-          <a:p>
-            <a:pPr algn="l"/>
-            <a:r>
-              <a:rPr sz="2000" b="1" i="0">
-                <a:solidFill>
-                  <a:srgbClr val="8E6F3E"/>
-                </a:solidFill>
-              </a:rPr>
-              <a:t>DETECT</a:t>
-            </a:r>
-          </a:p>
-          <a:p>
-            <a:pPr algn="l">
-              <a:spcBef>
-                <a:spcPts val="800"/>
-              </a:spcBef>
-            </a:pPr>
-            <a:r>
-              <a:rPr sz="1800" b="0" i="0">
-                <a:solidFill>
-                  <a:srgbClr val="5C4826"/>
-                </a:solidFill>
-              </a:rPr>
-              <a:t>Otherwise, observe the work and evaluate the evidence.</a:t>
-            </a:r>
-          </a:p>
-          <a:p>
-            <a:pPr algn="l">
-              <a:spcBef>
-                <a:spcPts val="1000"/>
-              </a:spcBef>
-            </a:pPr>
-            <a:r>
-              <a:rPr sz="1800" b="0" i="1">
-                <a:solidFill>
-                  <a:srgbClr val="555960"/>
-                </a:solidFill>
-              </a:rPr>
-              <a:t>test · trace · measurement · analysis</a:t>
-            </a:r>
-          </a:p>
-          <a:p>
-            <a:pPr algn="l"/>
-            <a:r>
-              <a:rPr sz="1800" b="0" i="1">
-                <a:solidFill>
-                  <a:srgbClr val="555960"/>
-                </a:solidFill>
-              </a:rPr>
-              <a:t>then validate it — and gate on the verdict when appropriate</a:t>
-            </a:r>
-          </a:p>
-        </p:txBody>
-      </p:sp>
-      <p:sp>
-        <p:nvSpPr>
           <p:cNvPr id="7" name="TextBox 6"/>
           <p:cNvSpPr txBox="1"/>
           <p:nvPr/>
         </p:nvSpPr>
         <p:spPr>
           <a:xfrm>
-            <a:off x="274320" y="4023360"/>
+            <a:off x="274320" y="4617720"/>
             <a:ext cx="8595360" cy="731520"/>
           </a:xfrm>
           <a:prstGeom prst="rect">
@@ -12652,6 +12462,30 @@
           </a:p>
         </p:txBody>
       </p:sp>
+      <p:pic>
+        <p:nvPicPr>
+          <p:cNvPr id="9" name="Fig-3-3-1-constraint-vs-sensor" descr="constraint-vs-sensor-deck.png"/>
+          <p:cNvPicPr>
+            <a:picLocks noChangeAspect="1"/>
+          </p:cNvPicPr>
+          <p:nvPr/>
+        </p:nvPicPr>
+        <p:blipFill>
+          <a:blip r:embed="rId3"/>
+          <a:stretch>
+            <a:fillRect/>
+          </a:stretch>
+        </p:blipFill>
+        <p:spPr>
+          <a:xfrm>
+            <a:off x="731520" y="1051560"/>
+            <a:ext cx="7680960" cy="3360420"/>
+          </a:xfrm>
+          <a:prstGeom prst="rect">
+            <a:avLst/>
+          </a:prstGeom>
+        </p:spPr>
+      </p:pic>
     </p:spTree>
   </p:cSld>
   <p:clrMapOvr>

</xml_diff>

<commit_message>
deck 2-3 item 3: slides 23-26 become example -> explanation -> rule -> counterexample
Slide 24 replaces the two-panel prose with Fig 3.2-3 (semantic-gap-levels
asset): a property spanning several commits/calls/turns cannot be decided
from any single event. Slide 25's takeaway now says legible and decidable,
plus one line tying to Modeling (wrong abstraction = property not
represented; wrong boundary = evidence unavailable). Slides 23 and 26
unchanged.

Co-Authored-By: Claude Opus 5 <noreply@anthropic.com>
</commit_message>
<xml_diff>
--- a/course/lectures/act-2-delegation-and-control/03-alignment/2-3-Alignment.pptx
+++ b/course/lectures/act-2-delegation-and-control/03-alignment/2-3-Alignment.pptx
@@ -968,7 +968,7 @@
           <a:lstStyle/>
           <a:p>
             <a:r>
-              <a:t>Ask the room why not everything at edit time before revealing the right panel.</a:t>
+              <a:t>Figure 3.2-3 (the semantic gap): this explains WHY the rule exists rather than merely stating it. The obligation is legible only at the boundary where the whole unit of work is assembled; below it, no single commit / call / turn carries enough to decide. Ask the room why not everything at edit time before revealing. "Shift left" is not an unconditional maxim — check earlier only when the required evidence exists earlier.</a:t>
             </a:r>
           </a:p>
         </p:txBody>
@@ -1038,7 +1038,7 @@
           <a:lstStyle/>
           <a:p>
             <a:r>
-              <a:t>The central callback of Section 3 — put the two statements side by side and let students recognize the principle.</a:t>
+              <a:t>The central callback of Section 3 — put the two statements side by side and let students recognize the principle. The takeaway uses the chapter vocabulary: the earliest boundary where the obligation is legible and decidable. The last line ties to the Modeling lecture: wrong abstraction means the property is not represented; wrong Alignment boundary means the evidence is unavailable.</a:t>
             </a:r>
           </a:p>
         </p:txBody>
@@ -15964,234 +15964,6 @@
       </p:sp>
       <p:sp>
         <p:nvSpPr>
-          <p:cNvPr id="5" name="Rectangle 4"/>
-          <p:cNvSpPr/>
-          <p:nvPr/>
-        </p:nvSpPr>
-        <p:spPr>
-          <a:xfrm>
-            <a:off x="502920" y="1051560"/>
-            <a:ext cx="3977639" cy="2788920"/>
-          </a:xfrm>
-          <a:prstGeom prst="rect">
-            <a:avLst/>
-          </a:prstGeom>
-          <a:solidFill>
-            <a:srgbClr val="F5F1E8"/>
-          </a:solidFill>
-          <a:ln w="12700">
-            <a:solidFill>
-              <a:srgbClr val="C9B991"/>
-            </a:solidFill>
-          </a:ln>
-          <a:effectLst/>
-        </p:spPr>
-        <p:style>
-          <a:lnRef idx="1">
-            <a:schemeClr val="accent1"/>
-          </a:lnRef>
-          <a:fillRef idx="3">
-            <a:schemeClr val="accent1"/>
-          </a:fillRef>
-          <a:effectRef idx="2">
-            <a:schemeClr val="accent1"/>
-          </a:effectRef>
-          <a:fontRef idx="minor">
-            <a:schemeClr val="lt1"/>
-          </a:fontRef>
-        </p:style>
-        <p:txBody>
-          <a:bodyPr rtlCol="0" anchor="t" wrap="square" lIns="137160" rIns="27432" tIns="73152" bIns="22860"/>
-          <a:lstStyle/>
-          <a:p>
-            <a:pPr algn="l"/>
-            <a:r>
-              <a:rPr sz="2000" b="1" i="0">
-                <a:solidFill>
-                  <a:srgbClr val="8E6F3E"/>
-                </a:solidFill>
-              </a:rPr>
-              <a:t>EARLIER IS CHEAPER</a:t>
-            </a:r>
-          </a:p>
-          <a:p>
-            <a:pPr algn="l">
-              <a:spcBef>
-                <a:spcPts val="800"/>
-              </a:spcBef>
-            </a:pPr>
-            <a:r>
-              <a:rPr sz="1800" b="0" i="0">
-                <a:solidFill>
-                  <a:srgbClr val="5C4826"/>
-                </a:solidFill>
-              </a:rPr>
-              <a:t>Early detection or prevention reduces wasted work and consequence.</a:t>
-            </a:r>
-          </a:p>
-          <a:p>
-            <a:pPr algn="l">
-              <a:spcBef>
-                <a:spcPts val="1000"/>
-              </a:spcBef>
-            </a:pPr>
-            <a:r>
-              <a:rPr sz="1800" b="0" i="1">
-                <a:solidFill>
-                  <a:srgbClr val="555960"/>
-                </a:solidFill>
-              </a:rPr>
-              <a:t>So why not put every check at edit time?</a:t>
-            </a:r>
-          </a:p>
-        </p:txBody>
-      </p:sp>
-      <p:sp>
-        <p:nvSpPr>
-          <p:cNvPr id="6" name="Rectangle 5"/>
-          <p:cNvSpPr/>
-          <p:nvPr/>
-        </p:nvSpPr>
-        <p:spPr>
-          <a:xfrm>
-            <a:off x="4663440" y="1051560"/>
-            <a:ext cx="3977639" cy="2788920"/>
-          </a:xfrm>
-          <a:prstGeom prst="rect">
-            <a:avLst/>
-          </a:prstGeom>
-          <a:solidFill>
-            <a:srgbClr val="FBF8F2"/>
-          </a:solidFill>
-          <a:ln w="12700">
-            <a:solidFill>
-              <a:srgbClr val="C9B991"/>
-            </a:solidFill>
-          </a:ln>
-          <a:effectLst/>
-        </p:spPr>
-        <p:style>
-          <a:lnRef idx="1">
-            <a:schemeClr val="accent1"/>
-          </a:lnRef>
-          <a:fillRef idx="3">
-            <a:schemeClr val="accent1"/>
-          </a:fillRef>
-          <a:effectRef idx="2">
-            <a:schemeClr val="accent1"/>
-          </a:effectRef>
-          <a:fontRef idx="minor">
-            <a:schemeClr val="lt1"/>
-          </a:fontRef>
-        </p:style>
-        <p:txBody>
-          <a:bodyPr rtlCol="0" anchor="t" wrap="square" lIns="137160" rIns="27432" tIns="73152" bIns="22860"/>
-          <a:lstStyle/>
-          <a:p>
-            <a:pPr algn="l"/>
-            <a:r>
-              <a:rPr sz="2000" b="1" i="0">
-                <a:solidFill>
-                  <a:srgbClr val="8E6F3E"/>
-                </a:solidFill>
-              </a:rPr>
-              <a:t>SOME PROPERTIES</a:t>
-            </a:r>
-          </a:p>
-          <a:p>
-            <a:pPr algn="l"/>
-            <a:r>
-              <a:rPr sz="2000" b="1" i="0">
-                <a:solidFill>
-                  <a:srgbClr val="8E6F3E"/>
-                </a:solidFill>
-              </a:rPr>
-              <a:t>CANNOT BE DECIDED YET</a:t>
-            </a:r>
-          </a:p>
-          <a:p>
-            <a:pPr algn="l">
-              <a:spcBef>
-                <a:spcPts val="800"/>
-              </a:spcBef>
-            </a:pPr>
-            <a:r>
-              <a:rPr sz="1800" b="0" i="0">
-                <a:solidFill>
-                  <a:srgbClr val="5C4826"/>
-                </a:solidFill>
-              </a:rPr>
-              <a:t>Integration behavior needs composition.</a:t>
-            </a:r>
-          </a:p>
-          <a:p>
-            <a:pPr algn="l">
-              <a:spcBef>
-                <a:spcPts val="400"/>
-              </a:spcBef>
-            </a:pPr>
-            <a:r>
-              <a:rPr sz="1800" b="0" i="0">
-                <a:solidFill>
-                  <a:srgbClr val="5C4826"/>
-                </a:solidFill>
-              </a:rPr>
-              <a:t>Production behavior needs deployed conditions.</a:t>
-            </a:r>
-          </a:p>
-          <a:p>
-            <a:pPr algn="l">
-              <a:spcBef>
-                <a:spcPts val="400"/>
-              </a:spcBef>
-            </a:pPr>
-            <a:r>
-              <a:rPr sz="1800" b="0" i="0">
-                <a:solidFill>
-                  <a:srgbClr val="5C4826"/>
-                </a:solidFill>
-              </a:rPr>
-              <a:t>Mid-task, work may legitimately disagree with an end-state obligation.</a:t>
-            </a:r>
-          </a:p>
-        </p:txBody>
-      </p:sp>
-      <p:sp>
-        <p:nvSpPr>
-          <p:cNvPr id="7" name="TextBox 6"/>
-          <p:cNvSpPr txBox="1"/>
-          <p:nvPr/>
-        </p:nvSpPr>
-        <p:spPr>
-          <a:xfrm>
-            <a:off x="274320" y="4114800"/>
-            <a:ext cx="8595360" cy="457200"/>
-          </a:xfrm>
-          <a:prstGeom prst="rect">
-            <a:avLst/>
-          </a:prstGeom>
-          <a:noFill/>
-        </p:spPr>
-        <p:txBody>
-          <a:bodyPr wrap="square" anchor="t">
-            <a:spAutoFit/>
-          </a:bodyPr>
-          <a:lstStyle/>
-          <a:p>
-            <a:pPr algn="ctr"/>
-            <a:r>
-              <a:rPr sz="2000" b="0" i="1">
-                <a:solidFill>
-                  <a:srgbClr val="555960"/>
-                </a:solidFill>
-              </a:rPr>
-              <a:t>“Shift left” is not an unconditional maxim.</a:t>
-            </a:r>
-          </a:p>
-        </p:txBody>
-      </p:sp>
-      <p:sp>
-        <p:nvSpPr>
           <p:cNvPr id="8" name="FooterBand"/>
           <p:cNvSpPr/>
           <p:nvPr/>
@@ -16238,6 +16010,75 @@
                 </a:solidFill>
               </a:rPr>
               <a:t>Check earlier when the required evidence exists earlier.</a:t>
+            </a:r>
+          </a:p>
+        </p:txBody>
+      </p:sp>
+      <p:pic>
+        <p:nvPicPr>
+          <p:cNvPr id="9" name="Fig-3-2-3-semantic-gap" descr="semantic-gap-levels-deck.png"/>
+          <p:cNvPicPr>
+            <a:picLocks noChangeAspect="1"/>
+          </p:cNvPicPr>
+          <p:nvPr/>
+        </p:nvPicPr>
+        <p:blipFill>
+          <a:blip r:embed="rId3"/>
+          <a:stretch>
+            <a:fillRect/>
+          </a:stretch>
+        </p:blipFill>
+        <p:spPr>
+          <a:xfrm>
+            <a:off x="548640" y="1188720"/>
+            <a:ext cx="8046720" cy="3017520"/>
+          </a:xfrm>
+          <a:prstGeom prst="rect">
+            <a:avLst/>
+          </a:prstGeom>
+        </p:spPr>
+      </p:pic>
+      <p:sp>
+        <p:nvSpPr>
+          <p:cNvPr id="10" name="SemanticGapTakeaway"/>
+          <p:cNvSpPr txBox="1"/>
+          <p:nvPr/>
+        </p:nvSpPr>
+        <p:spPr>
+          <a:xfrm>
+            <a:off x="274320" y="4389120"/>
+            <a:ext cx="8595360" cy="822960"/>
+          </a:xfrm>
+          <a:prstGeom prst="rect">
+            <a:avLst/>
+          </a:prstGeom>
+          <a:noFill/>
+        </p:spPr>
+        <p:txBody>
+          <a:bodyPr wrap="square" anchor="t" lIns="27432" rIns="27432" tIns="22860" bIns="22860">
+            <a:spAutoFit/>
+          </a:bodyPr>
+          <a:lstStyle/>
+          <a:p>
+            <a:pPr algn="ctr"/>
+            <a:r>
+              <a:rPr sz="1600" b="0" i="0">
+                <a:solidFill>
+                  <a:srgbClr val="5C4826"/>
+                </a:solidFill>
+              </a:rPr>
+              <a:t>A property that spans several commits, calls, or turns cannot be decided from any single event.</a:t>
+            </a:r>
+          </a:p>
+          <a:p>
+            <a:pPr algn="ctr"/>
+            <a:r>
+              <a:rPr sz="1600" b="1" i="0">
+                <a:solidFill>
+                  <a:srgbClr val="5C4826"/>
+                </a:solidFill>
+              </a:rPr>
+              <a:t>Lift the mechanism to the first boundary where the whole obligation becomes legible.</a:t>
             </a:r>
           </a:p>
         </p:txBody>
@@ -16560,7 +16401,7 @@
           <a:noFill/>
         </p:spPr>
         <p:txBody>
-          <a:bodyPr wrap="square" anchor="t">
+          <a:bodyPr wrap="square" anchor="ctr" lIns="27432" rIns="27432" tIns="22860" bIns="22860">
             <a:spAutoFit/>
           </a:bodyPr>
           <a:lstStyle/>
@@ -16574,6 +16415,14 @@
               </a:rPr>
               <a:t>Both rules place the check at the earliest point</a:t>
             </a:r>
+            <a:r>
+              <a:rPr sz="1800" b="1" i="0">
+                <a:solidFill>
+                  <a:srgbClr val="5C4826"/>
+                </a:solidFill>
+              </a:rPr>
+              <a:t>Both place the check at the earliest boundary</a:t>
+            </a:r>
           </a:p>
           <a:p>
             <a:pPr algn="ctr"/>
@@ -16584,6 +16433,51 @@
                 </a:solidFill>
               </a:rPr>
               <a:t>with enough information to decide the claim.</a:t>
+            </a:r>
+          </a:p>
+          <a:p>
+            <a:pPr algn="ctr"/>
+            <a:r>
+              <a:rPr sz="1800" b="1" i="0">
+                <a:solidFill>
+                  <a:srgbClr val="5C4826"/>
+                </a:solidFill>
+              </a:rPr>
+              <a:t>where the obligation is legible and decidable.</a:t>
+            </a:r>
+          </a:p>
+        </p:txBody>
+      </p:sp>
+      <p:sp>
+        <p:nvSpPr>
+          <p:cNvPr id="10" name="ModelingTie"/>
+          <p:cNvSpPr txBox="1"/>
+          <p:nvPr/>
+        </p:nvSpPr>
+        <p:spPr>
+          <a:xfrm>
+            <a:off x="274320" y="4709160"/>
+            <a:ext cx="8595360" cy="731520"/>
+          </a:xfrm>
+          <a:prstGeom prst="rect">
+            <a:avLst/>
+          </a:prstGeom>
+          <a:noFill/>
+        </p:spPr>
+        <p:txBody>
+          <a:bodyPr wrap="square" anchor="t" lIns="27432" rIns="27432" tIns="22860" bIns="22860">
+            <a:spAutoFit/>
+          </a:bodyPr>
+          <a:lstStyle/>
+          <a:p>
+            <a:pPr algn="ctr"/>
+            <a:r>
+              <a:rPr sz="1500" b="0" i="1">
+                <a:solidFill>
+                  <a:srgbClr val="555960"/>
+                </a:solidFill>
+              </a:rPr>
+              <a:t>Wrong abstraction: the property is not represented.  Wrong Alignment boundary: the evidence is unavailable.</a:t>
             </a:r>
           </a:p>
         </p:txBody>

</xml_diff>

<commit_message>
deck 2-3 item 4: slide 32 uses the real shipped model, not an abstract box
Replaces the generic ARCHITECTURE MODEL with the workbench
medium-document-processing example: one Document Processing Service model
(bounded-retry lifecycle + working-memory envelope) consumed three ways —
lifecycle check (Completed never re-processed), retry bound (at most 2),
memory analysis (2 x 384 MB within 1 GB) — verdicts meeting at the gate.
All figures are declarations in system.mage.yaml, asserted at edit time.

Co-Authored-By: Claude Opus 5 <noreply@anthropic.com>
</commit_message>
<xml_diff>
--- a/course/lectures/act-2-delegation-and-control/03-alignment/2-3-Alignment.pptx
+++ b/course/lectures/act-2-delegation-and-control/03-alignment/2-3-Alignment.pptx
@@ -2648,7 +2648,7 @@
           <a:lstStyle/>
           <a:p>
             <a:r>
-              <a:t>The missing bridge between Modeling and Alignment: one explicit model, several controls derived from it, their verdicts meeting at a gate.</a:t>
+              <a:t>The bridge between Modeling and Alignment, shown on a REAL shipped model (workbench example: medium-document-processing). One document service, declared once — entities, a bounded-retry lifecycle (submitted/queued/processing/completed/failed, retry_count at most 2), and a working-memory envelope (two 384 MB task slots against a 1 GB worker) — is consumed several ways: a lifecycle reachability check, a retry-bound check, and a memory analysis. Two kinds of question over one system; their verdicts meet at a gate. Nothing here was reconstructed from the code — every figure is a declaration in the model.</a:t>
             </a:r>
           </a:p>
         </p:txBody>
@@ -18964,14 +18964,48 @@
       </p:sp>
       <p:sp>
         <p:nvSpPr>
-          <p:cNvPr id="4" name="ArchModel"/>
+          <p:cNvPr id="14" name="MCVerdicts"/>
+          <p:cNvSpPr txBox="1"/>
+          <p:nvPr/>
+        </p:nvSpPr>
+        <p:spPr>
+          <a:xfrm>
+            <a:off x="5532120" y="3886200"/>
+            <a:ext cx="1097280" cy="320040"/>
+          </a:xfrm>
+          <a:prstGeom prst="rect">
+            <a:avLst/>
+          </a:prstGeom>
+          <a:noFill/>
+        </p:spPr>
+        <p:txBody>
+          <a:bodyPr wrap="square" anchor="t">
+            <a:spAutoFit/>
+          </a:bodyPr>
+          <a:lstStyle/>
+          <a:p>
+            <a:pPr algn="l"/>
+            <a:r>
+              <a:rPr sz="1400" b="0" i="0">
+                <a:solidFill>
+                  <a:srgbClr val="555960"/>
+                </a:solidFill>
+              </a:rPr>
+              <a:t>verdicts</a:t>
+            </a:r>
+          </a:p>
+        </p:txBody>
+      </p:sp>
+      <p:sp>
+        <p:nvSpPr>
+          <p:cNvPr id="15" name="MCGate"/>
           <p:cNvSpPr/>
           <p:nvPr/>
         </p:nvSpPr>
         <p:spPr>
           <a:xfrm>
-            <a:off x="3291840" y="1005840"/>
-            <a:ext cx="2560320" cy="594360"/>
+            <a:off x="3749039" y="3767328"/>
+            <a:ext cx="1645920" cy="566928"/>
           </a:xfrm>
           <a:prstGeom prst="rect">
             <a:avLst/>
@@ -19004,26 +19038,175 @@
           <a:p>
             <a:pPr algn="ctr"/>
             <a:r>
-              <a:rPr sz="1500" b="1" i="0">
+              <a:rPr sz="1600" b="1" i="0">
                 <a:solidFill>
                   <a:srgbClr val="FFFFFF"/>
                 </a:solidFill>
               </a:rPr>
-              <a:t>ARCHITECTURE MODEL</a:t>
-            </a:r>
-          </a:p>
-        </p:txBody>
-      </p:sp>
-      <p:sp>
-        <p:nvSpPr>
-          <p:cNvPr id="5" name="MC-dependency check"/>
+              <a:t>GATE</a:t>
+            </a:r>
+          </a:p>
+        </p:txBody>
+      </p:sp>
+      <p:sp>
+        <p:nvSpPr>
+          <p:cNvPr id="16" name="MCPoint"/>
+          <p:cNvSpPr txBox="1"/>
+          <p:nvPr/>
+        </p:nvSpPr>
+        <p:spPr>
+          <a:xfrm>
+            <a:off x="502920" y="4572000"/>
+            <a:ext cx="8138160" cy="548640"/>
+          </a:xfrm>
+          <a:prstGeom prst="rect">
+            <a:avLst/>
+          </a:prstGeom>
+          <a:noFill/>
+        </p:spPr>
+        <p:txBody>
+          <a:bodyPr wrap="square" anchor="t">
+            <a:spAutoFit/>
+          </a:bodyPr>
+          <a:lstStyle/>
+          <a:p>
+            <a:pPr algn="ctr"/>
+            <a:r>
+              <a:rPr sz="2000" b="0" i="0">
+                <a:solidFill>
+                  <a:srgbClr val="5C4826"/>
+                </a:solidFill>
+              </a:rPr>
+              <a:t>The same explicit engineering knowledge can support multiple validators and constraints.</a:t>
+            </a:r>
+          </a:p>
+        </p:txBody>
+      </p:sp>
+      <p:sp>
+        <p:nvSpPr>
+          <p:cNvPr id="17" name="FooterBand"/>
           <p:cNvSpPr/>
           <p:nvPr/>
         </p:nvSpPr>
         <p:spPr>
           <a:xfrm>
-            <a:off x="1188720" y="2240280"/>
-            <a:ext cx="1828800" cy="640080"/>
+            <a:off x="274320" y="5852160"/>
+            <a:ext cx="8595360" cy="566928"/>
+          </a:xfrm>
+          <a:prstGeom prst="rect">
+            <a:avLst/>
+          </a:prstGeom>
+          <a:solidFill>
+            <a:srgbClr val="8E6F3E"/>
+          </a:solidFill>
+          <a:ln>
+            <a:noFill/>
+          </a:ln>
+          <a:effectLst/>
+        </p:spPr>
+        <p:style>
+          <a:lnRef idx="1">
+            <a:schemeClr val="accent1"/>
+          </a:lnRef>
+          <a:fillRef idx="3">
+            <a:schemeClr val="accent1"/>
+          </a:fillRef>
+          <a:effectRef idx="2">
+            <a:schemeClr val="accent1"/>
+          </a:effectRef>
+          <a:fontRef idx="minor">
+            <a:schemeClr val="lt1"/>
+          </a:fontRef>
+        </p:style>
+        <p:txBody>
+          <a:bodyPr rtlCol="0" anchor="ctr" wrap="square" lIns="27432" rIns="27432" tIns="22860" bIns="22860"/>
+          <a:lstStyle/>
+          <a:p>
+            <a:pPr algn="ctr"/>
+            <a:r>
+              <a:rPr sz="2000" b="1" i="0">
+                <a:solidFill>
+                  <a:srgbClr val="FFFFFF"/>
+                </a:solidFill>
+              </a:rPr>
+              <a:t>A model becomes operational when the engineered environment uses it.</a:t>
+            </a:r>
+          </a:p>
+        </p:txBody>
+      </p:sp>
+      <p:sp>
+        <p:nvSpPr>
+          <p:cNvPr id="18" name="RealModel"/>
+          <p:cNvSpPr/>
+          <p:nvPr/>
+        </p:nvSpPr>
+        <p:spPr>
+          <a:xfrm>
+            <a:off x="2103120" y="914400"/>
+            <a:ext cx="4937760" cy="804672"/>
+          </a:xfrm>
+          <a:prstGeom prst="rect">
+            <a:avLst/>
+          </a:prstGeom>
+          <a:solidFill>
+            <a:srgbClr val="8E6F3E"/>
+          </a:solidFill>
+          <a:ln>
+            <a:noFill/>
+          </a:ln>
+          <a:effectLst/>
+        </p:spPr>
+        <p:style>
+          <a:lnRef idx="1">
+            <a:schemeClr val="accent1"/>
+          </a:lnRef>
+          <a:fillRef idx="3">
+            <a:schemeClr val="accent1"/>
+          </a:fillRef>
+          <a:effectRef idx="2">
+            <a:schemeClr val="accent1"/>
+          </a:effectRef>
+          <a:fontRef idx="minor">
+            <a:schemeClr val="lt1"/>
+          </a:fontRef>
+        </p:style>
+        <p:txBody>
+          <a:bodyPr rtlCol="0" anchor="ctr" wrap="square" lIns="27432" rIns="27432" tIns="22860" bIns="22860"/>
+          <a:lstStyle/>
+          <a:p>
+            <a:pPr algn="ctr"/>
+            <a:r>
+              <a:rPr sz="1400" b="1" i="0">
+                <a:solidFill>
+                  <a:srgbClr val="FFFFFF"/>
+                </a:solidFill>
+              </a:rPr>
+              <a:t>DOCUMENT PROCESSING SERVICE</a:t>
+            </a:r>
+          </a:p>
+          <a:p>
+            <a:pPr algn="ctr"/>
+            <a:r>
+              <a:rPr sz="1050" b="0" i="1">
+                <a:solidFill>
+                  <a:srgbClr val="FBF8F2"/>
+                </a:solidFill>
+              </a:rPr>
+              <a:t>one explicit model: lifecycle machine + resource graph</a:t>
+            </a:r>
+          </a:p>
+        </p:txBody>
+      </p:sp>
+      <p:sp>
+        <p:nvSpPr>
+          <p:cNvPr id="19" name="MC-lifecycle"/>
+          <p:cNvSpPr/>
+          <p:nvPr/>
+        </p:nvSpPr>
+        <p:spPr>
+          <a:xfrm>
+            <a:off x="411480" y="2240280"/>
+            <a:ext cx="2468880" cy="960120"/>
           </a:xfrm>
           <a:prstGeom prst="rect">
             <a:avLst/>
@@ -19058,26 +19241,37 @@
           <a:p>
             <a:pPr algn="ctr"/>
             <a:r>
-              <a:rPr sz="1500" b="0" i="0">
+              <a:rPr sz="1200" b="1" i="0">
                 <a:solidFill>
                   <a:srgbClr val="5C4826"/>
                 </a:solidFill>
               </a:rPr>
-              <a:t>dependency check</a:t>
-            </a:r>
-          </a:p>
-        </p:txBody>
-      </p:sp>
-      <p:sp>
-        <p:nvSpPr>
-          <p:cNvPr id="6" name="MC-memory analysis"/>
+              <a:t>LIFECYCLE CHECK</a:t>
+            </a:r>
+          </a:p>
+          <a:p>
+            <a:pPr algn="ctr"/>
+            <a:r>
+              <a:rPr sz="950" b="0" i="0">
+                <a:solidFill>
+                  <a:srgbClr val="555960"/>
+                </a:solidFill>
+              </a:rPr>
+              <a:t>can a Completed document ever be processed again?  no</a:t>
+            </a:r>
+          </a:p>
+        </p:txBody>
+      </p:sp>
+      <p:sp>
+        <p:nvSpPr>
+          <p:cNvPr id="20" name="MC-retry"/>
           <p:cNvSpPr/>
           <p:nvPr/>
         </p:nvSpPr>
         <p:spPr>
           <a:xfrm>
-            <a:off x="3657600" y="2240280"/>
-            <a:ext cx="1828800" cy="640080"/>
+            <a:off x="3337560" y="2240280"/>
+            <a:ext cx="2468880" cy="960120"/>
           </a:xfrm>
           <a:prstGeom prst="rect">
             <a:avLst/>
@@ -19112,26 +19306,37 @@
           <a:p>
             <a:pPr algn="ctr"/>
             <a:r>
-              <a:rPr sz="1500" b="0" i="0">
+              <a:rPr sz="1200" b="1" i="0">
                 <a:solidFill>
                   <a:srgbClr val="5C4826"/>
                 </a:solidFill>
               </a:rPr>
-              <a:t>memory analysis</a:t>
-            </a:r>
-          </a:p>
-        </p:txBody>
-      </p:sp>
-      <p:sp>
-        <p:nvSpPr>
-          <p:cNvPr id="7" name="MC-interface check"/>
+              <a:t>RETRY BOUND</a:t>
+            </a:r>
+          </a:p>
+          <a:p>
+            <a:pPr algn="ctr"/>
+            <a:r>
+              <a:rPr sz="950" b="0" i="0">
+                <a:solidFill>
+                  <a:srgbClr val="555960"/>
+                </a:solidFill>
+              </a:rPr>
+              <a:t>can the retry loop run forever?  no — at most 2 retries</a:t>
+            </a:r>
+          </a:p>
+        </p:txBody>
+      </p:sp>
+      <p:sp>
+        <p:nvSpPr>
+          <p:cNvPr id="21" name="MC-memory"/>
           <p:cNvSpPr/>
           <p:nvPr/>
         </p:nvSpPr>
         <p:spPr>
           <a:xfrm>
-            <a:off x="6126480" y="2240280"/>
-            <a:ext cx="1828800" cy="640080"/>
+            <a:off x="6263640" y="2240280"/>
+            <a:ext cx="2468880" cy="960120"/>
           </a:xfrm>
           <a:prstGeom prst="rect">
             <a:avLst/>
@@ -19166,26 +19371,37 @@
           <a:p>
             <a:pPr algn="ctr"/>
             <a:r>
-              <a:rPr sz="1500" b="0" i="0">
+              <a:rPr sz="1200" b="1" i="0">
                 <a:solidFill>
                   <a:srgbClr val="5C4826"/>
                 </a:solidFill>
               </a:rPr>
-              <a:t>interface check</a:t>
+              <a:t>MEMORY ANALYSIS</a:t>
+            </a:r>
+          </a:p>
+          <a:p>
+            <a:pPr algn="ctr"/>
+            <a:r>
+              <a:rPr sz="950" b="0" i="0">
+                <a:solidFill>
+                  <a:srgbClr val="555960"/>
+                </a:solidFill>
+              </a:rPr>
+              <a:t>peak demand 2 × 384 MB — within the 1 GB worker ceiling</a:t>
             </a:r>
           </a:p>
         </p:txBody>
       </p:sp>
       <p:cxnSp>
         <p:nvCxnSpPr>
-          <p:cNvPr id="8" name="Connector 7"/>
+          <p:cNvPr id="22" name="RM-Conn1"/>
           <p:cNvCxnSpPr/>
           <p:nvPr/>
         </p:nvCxnSpPr>
         <p:spPr>
           <a:xfrm flipH="1">
-            <a:off x="2103120" y="1600200"/>
-            <a:ext cx="2468880" cy="640080"/>
+            <a:off x="1645920" y="1719072"/>
+            <a:ext cx="2926080" cy="521208"/>
           </a:xfrm>
           <a:prstGeom prst="line">
             <a:avLst/>
@@ -19196,7 +19412,6 @@
             </a:solidFill>
             <a:tailEnd type="triangle" w="med" len="med"/>
           </a:ln>
-          <a:effectLst/>
         </p:spPr>
         <p:style>
           <a:lnRef idx="2">
@@ -19215,14 +19430,14 @@
       </p:cxnSp>
       <p:cxnSp>
         <p:nvCxnSpPr>
-          <p:cNvPr id="9" name="Connector 8"/>
+          <p:cNvPr id="23" name="RM-Conn2"/>
           <p:cNvCxnSpPr/>
           <p:nvPr/>
         </p:nvCxnSpPr>
         <p:spPr>
           <a:xfrm>
-            <a:off x="4572000" y="1600200"/>
-            <a:ext cx="0" cy="640080"/>
+            <a:off x="4572000" y="1719072"/>
+            <a:ext cx="0" cy="521208"/>
           </a:xfrm>
           <a:prstGeom prst="line">
             <a:avLst/>
@@ -19233,7 +19448,6 @@
             </a:solidFill>
             <a:tailEnd type="triangle" w="med" len="med"/>
           </a:ln>
-          <a:effectLst/>
         </p:spPr>
         <p:style>
           <a:lnRef idx="2">
@@ -19252,14 +19466,14 @@
       </p:cxnSp>
       <p:cxnSp>
         <p:nvCxnSpPr>
-          <p:cNvPr id="10" name="Connector 9"/>
+          <p:cNvPr id="24" name="RM-Conn3"/>
           <p:cNvCxnSpPr/>
           <p:nvPr/>
         </p:nvCxnSpPr>
         <p:spPr>
           <a:xfrm>
-            <a:off x="4572000" y="1600200"/>
-            <a:ext cx="2468880" cy="640080"/>
+            <a:off x="4572000" y="1719072"/>
+            <a:ext cx="2926079" cy="521208"/>
           </a:xfrm>
           <a:prstGeom prst="line">
             <a:avLst/>
@@ -19270,7 +19484,6 @@
             </a:solidFill>
             <a:tailEnd type="triangle" w="med" len="med"/>
           </a:ln>
-          <a:effectLst/>
         </p:spPr>
         <p:style>
           <a:lnRef idx="2">
@@ -19289,14 +19502,14 @@
       </p:cxnSp>
       <p:cxnSp>
         <p:nvCxnSpPr>
-          <p:cNvPr id="11" name="Connector 10"/>
+          <p:cNvPr id="25" name="RM-Conn4"/>
           <p:cNvCxnSpPr/>
           <p:nvPr/>
         </p:nvCxnSpPr>
         <p:spPr>
           <a:xfrm>
-            <a:off x="2103120" y="2880360"/>
-            <a:ext cx="2468880" cy="731520"/>
+            <a:off x="1645920" y="3200400"/>
+            <a:ext cx="2377440" cy="566928"/>
           </a:xfrm>
           <a:prstGeom prst="line">
             <a:avLst/>
@@ -19307,7 +19520,6 @@
             </a:solidFill>
             <a:tailEnd type="triangle" w="med" len="med"/>
           </a:ln>
-          <a:effectLst/>
         </p:spPr>
         <p:style>
           <a:lnRef idx="2">
@@ -19326,14 +19538,14 @@
       </p:cxnSp>
       <p:cxnSp>
         <p:nvCxnSpPr>
-          <p:cNvPr id="12" name="Connector 11"/>
+          <p:cNvPr id="26" name="RM-Conn5"/>
           <p:cNvCxnSpPr/>
           <p:nvPr/>
         </p:nvCxnSpPr>
         <p:spPr>
           <a:xfrm>
-            <a:off x="4572000" y="2880360"/>
-            <a:ext cx="0" cy="731520"/>
+            <a:off x="4572000" y="3200400"/>
+            <a:ext cx="0" cy="566928"/>
           </a:xfrm>
           <a:prstGeom prst="line">
             <a:avLst/>
@@ -19344,7 +19556,6 @@
             </a:solidFill>
             <a:tailEnd type="triangle" w="med" len="med"/>
           </a:ln>
-          <a:effectLst/>
         </p:spPr>
         <p:style>
           <a:lnRef idx="2">
@@ -19363,14 +19574,14 @@
       </p:cxnSp>
       <p:cxnSp>
         <p:nvCxnSpPr>
-          <p:cNvPr id="13" name="Connector 12"/>
+          <p:cNvPr id="27" name="RM-Conn6"/>
           <p:cNvCxnSpPr/>
           <p:nvPr/>
         </p:nvCxnSpPr>
         <p:spPr>
           <a:xfrm flipH="1">
-            <a:off x="4572000" y="2880360"/>
-            <a:ext cx="2468880" cy="731520"/>
+            <a:off x="5120640" y="3200400"/>
+            <a:ext cx="2377439" cy="566928"/>
           </a:xfrm>
           <a:prstGeom prst="line">
             <a:avLst/>
@@ -19381,7 +19592,6 @@
             </a:solidFill>
             <a:tailEnd type="triangle" w="med" len="med"/>
           </a:ln>
-          <a:effectLst/>
         </p:spPr>
         <p:style>
           <a:lnRef idx="2">
@@ -19398,178 +19608,6 @@
           </a:fontRef>
         </p:style>
       </p:cxnSp>
-      <p:sp>
-        <p:nvSpPr>
-          <p:cNvPr id="14" name="MCVerdicts"/>
-          <p:cNvSpPr txBox="1"/>
-          <p:nvPr/>
-        </p:nvSpPr>
-        <p:spPr>
-          <a:xfrm>
-            <a:off x="5532120" y="3749039"/>
-            <a:ext cx="1097280" cy="320040"/>
-          </a:xfrm>
-          <a:prstGeom prst="rect">
-            <a:avLst/>
-          </a:prstGeom>
-          <a:noFill/>
-        </p:spPr>
-        <p:txBody>
-          <a:bodyPr wrap="square" anchor="t">
-            <a:spAutoFit/>
-          </a:bodyPr>
-          <a:lstStyle/>
-          <a:p>
-            <a:pPr algn="l"/>
-            <a:r>
-              <a:rPr sz="1400" b="0" i="0">
-                <a:solidFill>
-                  <a:srgbClr val="555960"/>
-                </a:solidFill>
-              </a:rPr>
-              <a:t>verdicts</a:t>
-            </a:r>
-          </a:p>
-        </p:txBody>
-      </p:sp>
-      <p:sp>
-        <p:nvSpPr>
-          <p:cNvPr id="15" name="MCGate"/>
-          <p:cNvSpPr/>
-          <p:nvPr/>
-        </p:nvSpPr>
-        <p:spPr>
-          <a:xfrm>
-            <a:off x="3749039" y="3630168"/>
-            <a:ext cx="1645920" cy="566928"/>
-          </a:xfrm>
-          <a:prstGeom prst="rect">
-            <a:avLst/>
-          </a:prstGeom>
-          <a:solidFill>
-            <a:srgbClr val="8E6F3E"/>
-          </a:solidFill>
-          <a:ln>
-            <a:noFill/>
-          </a:ln>
-          <a:effectLst/>
-        </p:spPr>
-        <p:style>
-          <a:lnRef idx="1">
-            <a:schemeClr val="accent1"/>
-          </a:lnRef>
-          <a:fillRef idx="3">
-            <a:schemeClr val="accent1"/>
-          </a:fillRef>
-          <a:effectRef idx="2">
-            <a:schemeClr val="accent1"/>
-          </a:effectRef>
-          <a:fontRef idx="minor">
-            <a:schemeClr val="lt1"/>
-          </a:fontRef>
-        </p:style>
-        <p:txBody>
-          <a:bodyPr rtlCol="0" anchor="ctr" wrap="square" lIns="27432" rIns="27432" tIns="22860" bIns="22860"/>
-          <a:lstStyle/>
-          <a:p>
-            <a:pPr algn="ctr"/>
-            <a:r>
-              <a:rPr sz="1600" b="1" i="0">
-                <a:solidFill>
-                  <a:srgbClr val="FFFFFF"/>
-                </a:solidFill>
-              </a:rPr>
-              <a:t>GATE</a:t>
-            </a:r>
-          </a:p>
-        </p:txBody>
-      </p:sp>
-      <p:sp>
-        <p:nvSpPr>
-          <p:cNvPr id="16" name="MCPoint"/>
-          <p:cNvSpPr txBox="1"/>
-          <p:nvPr/>
-        </p:nvSpPr>
-        <p:spPr>
-          <a:xfrm>
-            <a:off x="502920" y="4572000"/>
-            <a:ext cx="8138160" cy="548640"/>
-          </a:xfrm>
-          <a:prstGeom prst="rect">
-            <a:avLst/>
-          </a:prstGeom>
-          <a:noFill/>
-        </p:spPr>
-        <p:txBody>
-          <a:bodyPr wrap="square" anchor="t">
-            <a:spAutoFit/>
-          </a:bodyPr>
-          <a:lstStyle/>
-          <a:p>
-            <a:pPr algn="ctr"/>
-            <a:r>
-              <a:rPr sz="2000" b="0" i="0">
-                <a:solidFill>
-                  <a:srgbClr val="5C4826"/>
-                </a:solidFill>
-              </a:rPr>
-              <a:t>The same explicit engineering knowledge can support multiple validators and constraints.</a:t>
-            </a:r>
-          </a:p>
-        </p:txBody>
-      </p:sp>
-      <p:sp>
-        <p:nvSpPr>
-          <p:cNvPr id="17" name="FooterBand"/>
-          <p:cNvSpPr/>
-          <p:nvPr/>
-        </p:nvSpPr>
-        <p:spPr>
-          <a:xfrm>
-            <a:off x="274320" y="5852160"/>
-            <a:ext cx="8595360" cy="566928"/>
-          </a:xfrm>
-          <a:prstGeom prst="rect">
-            <a:avLst/>
-          </a:prstGeom>
-          <a:solidFill>
-            <a:srgbClr val="8E6F3E"/>
-          </a:solidFill>
-          <a:ln>
-            <a:noFill/>
-          </a:ln>
-          <a:effectLst/>
-        </p:spPr>
-        <p:style>
-          <a:lnRef idx="1">
-            <a:schemeClr val="accent1"/>
-          </a:lnRef>
-          <a:fillRef idx="3">
-            <a:schemeClr val="accent1"/>
-          </a:fillRef>
-          <a:effectRef idx="2">
-            <a:schemeClr val="accent1"/>
-          </a:effectRef>
-          <a:fontRef idx="minor">
-            <a:schemeClr val="lt1"/>
-          </a:fontRef>
-        </p:style>
-        <p:txBody>
-          <a:bodyPr rtlCol="0" anchor="ctr" wrap="square" lIns="27432" rIns="27432" tIns="22860" bIns="22860"/>
-          <a:lstStyle/>
-          <a:p>
-            <a:pPr algn="ctr"/>
-            <a:r>
-              <a:rPr sz="2000" b="1" i="0">
-                <a:solidFill>
-                  <a:srgbClr val="FFFFFF"/>
-                </a:solidFill>
-              </a:rPr>
-              <a:t>A model becomes operational when the engineered environment uses it.</a:t>
-            </a:r>
-          </a:p>
-        </p:txBody>
-      </p:sp>
     </p:spTree>
   </p:cSld>
   <p:clrMapOvr>

</xml_diff>

<commit_message>
deck 2-3 item 5: slide 33 adopts Fig 3.2-1 three-relations; slide 34 keeps the triangle
Slide 33 takes the chapter's visual grammar — correspondence, conformance,
acceptance as three separate horizontal relations whose evidence is not
interchangeable (book/assets/three-relations.svg). Slide 34's
obligation/model/realization triangle is untouched, so the progression is:
three conflated relations, then agreement occupying only one edge. NOTE:
the spec's asset table named c3-bidirectional-correspondence.svg, but that
asset is the two-way MODEL/REALITY loop; the spec's own description of
Fig 3.2-1 matches three-relations.svg (chapter 3.2 line 108), adopted here.

Co-Authored-By: Claude Opus 5 <noreply@anthropic.com>
</commit_message>
<xml_diff>
--- a/course/lectures/act-2-delegation-and-control/03-alignment/2-3-Alignment.pptx
+++ b/course/lectures/act-2-delegation-and-control/03-alignment/2-3-Alignment.pptx
@@ -1738,7 +1738,7 @@
           <a:lstStyle/>
           <a:p>
             <a:r>
-              <a:t>Correspondence / conformance earns its appearance here, now that the students have designed real checks.</a:t>
+              <a:t>Figure 3.2-1: three distinct relations, drawn separately so they cannot be read as one. Correspondence — do two representations agree? Conformance — does the artifact satisfy an independent obligation? Acceptance — will the receiving environment admit it? Evidence for one does not establish the others: a model and realization can agree completely and still violate an external obligation, and a representation extracted from the implementation corresponds by construction — that is not independent evidence of correctness. Next slide: now look specifically at obligation / model / realization — agreement occupies only one edge.</a:t>
             </a:r>
           </a:p>
         </p:txBody>
@@ -19677,246 +19677,6 @@
       </p:sp>
       <p:sp>
         <p:nvSpPr>
-          <p:cNvPr id="5" name="Rectangle 4"/>
-          <p:cNvSpPr/>
-          <p:nvPr/>
-        </p:nvSpPr>
-        <p:spPr>
-          <a:xfrm>
-            <a:off x="502920" y="1097280"/>
-            <a:ext cx="3977639" cy="2103120"/>
-          </a:xfrm>
-          <a:prstGeom prst="rect">
-            <a:avLst/>
-          </a:prstGeom>
-          <a:solidFill>
-            <a:srgbClr val="F5F1E8"/>
-          </a:solidFill>
-          <a:ln w="12700">
-            <a:solidFill>
-              <a:srgbClr val="C9B991"/>
-            </a:solidFill>
-          </a:ln>
-          <a:effectLst/>
-        </p:spPr>
-        <p:style>
-          <a:lnRef idx="1">
-            <a:schemeClr val="accent1"/>
-          </a:lnRef>
-          <a:fillRef idx="3">
-            <a:schemeClr val="accent1"/>
-          </a:fillRef>
-          <a:effectRef idx="2">
-            <a:schemeClr val="accent1"/>
-          </a:effectRef>
-          <a:fontRef idx="minor">
-            <a:schemeClr val="lt1"/>
-          </a:fontRef>
-        </p:style>
-        <p:txBody>
-          <a:bodyPr rtlCol="0" anchor="t" wrap="square" lIns="137160" rIns="27432" tIns="73152" bIns="22860"/>
-          <a:lstStyle/>
-          <a:p>
-            <a:pPr algn="l"/>
-            <a:r>
-              <a:rPr sz="1800" b="1" i="0">
-                <a:solidFill>
-                  <a:srgbClr val="8E6F3E"/>
-                </a:solidFill>
-              </a:rPr>
-              <a:t>MODEL AND REALIZATION</a:t>
-            </a:r>
-          </a:p>
-          <a:p>
-            <a:pPr algn="l"/>
-            <a:r>
-              <a:rPr sz="1800" b="1" i="0">
-                <a:solidFill>
-                  <a:srgbClr val="8E6F3E"/>
-                </a:solidFill>
-              </a:rPr>
-              <a:t>AGREE</a:t>
-            </a:r>
-          </a:p>
-          <a:p>
-            <a:pPr algn="l">
-              <a:spcBef>
-                <a:spcPts val="800"/>
-              </a:spcBef>
-            </a:pPr>
-            <a:r>
-              <a:rPr sz="1800" b="0" i="0">
-                <a:solidFill>
-                  <a:srgbClr val="5C4826"/>
-                </a:solidFill>
-              </a:rPr>
-              <a:t>They can agree completely and still violate an external obligation.</a:t>
-            </a:r>
-          </a:p>
-        </p:txBody>
-      </p:sp>
-      <p:sp>
-        <p:nvSpPr>
-          <p:cNvPr id="6" name="Rectangle 5"/>
-          <p:cNvSpPr/>
-          <p:nvPr/>
-        </p:nvSpPr>
-        <p:spPr>
-          <a:xfrm>
-            <a:off x="4663440" y="1097280"/>
-            <a:ext cx="3977639" cy="2103120"/>
-          </a:xfrm>
-          <a:prstGeom prst="rect">
-            <a:avLst/>
-          </a:prstGeom>
-          <a:solidFill>
-            <a:srgbClr val="FBF8F2"/>
-          </a:solidFill>
-          <a:ln w="12700">
-            <a:solidFill>
-              <a:srgbClr val="C9B991"/>
-            </a:solidFill>
-          </a:ln>
-          <a:effectLst/>
-        </p:spPr>
-        <p:style>
-          <a:lnRef idx="1">
-            <a:schemeClr val="accent1"/>
-          </a:lnRef>
-          <a:fillRef idx="3">
-            <a:schemeClr val="accent1"/>
-          </a:fillRef>
-          <a:effectRef idx="2">
-            <a:schemeClr val="accent1"/>
-          </a:effectRef>
-          <a:fontRef idx="minor">
-            <a:schemeClr val="lt1"/>
-          </a:fontRef>
-        </p:style>
-        <p:txBody>
-          <a:bodyPr rtlCol="0" anchor="t" wrap="square" lIns="137160" rIns="27432" tIns="73152" bIns="22860"/>
-          <a:lstStyle/>
-          <a:p>
-            <a:pPr algn="l"/>
-            <a:r>
-              <a:rPr sz="1800" b="1" i="0">
-                <a:solidFill>
-                  <a:srgbClr val="8E6F3E"/>
-                </a:solidFill>
-              </a:rPr>
-              <a:t>DERIVED FROM</a:t>
-            </a:r>
-          </a:p>
-          <a:p>
-            <a:pPr algn="l"/>
-            <a:r>
-              <a:rPr sz="1800" b="1" i="0">
-                <a:solidFill>
-                  <a:srgbClr val="8E6F3E"/>
-                </a:solidFill>
-              </a:rPr>
-              <a:t>THE IMPLEMENTATION</a:t>
-            </a:r>
-          </a:p>
-          <a:p>
-            <a:pPr algn="l">
-              <a:spcBef>
-                <a:spcPts val="800"/>
-              </a:spcBef>
-            </a:pPr>
-            <a:r>
-              <a:rPr sz="1800" b="0" i="0">
-                <a:solidFill>
-                  <a:srgbClr val="5C4826"/>
-                </a:solidFill>
-              </a:rPr>
-              <a:t>A representation extracted from the implementation may correspond by construction. That does not provide independent evidence of correctness.</a:t>
-            </a:r>
-          </a:p>
-        </p:txBody>
-      </p:sp>
-      <p:sp>
-        <p:nvSpPr>
-          <p:cNvPr id="7" name="TextBox 6"/>
-          <p:cNvSpPr txBox="1"/>
-          <p:nvPr/>
-        </p:nvSpPr>
-        <p:spPr>
-          <a:xfrm>
-            <a:off x="685800" y="3429000"/>
-            <a:ext cx="7772400" cy="1234440"/>
-          </a:xfrm>
-          <a:prstGeom prst="rect">
-            <a:avLst/>
-          </a:prstGeom>
-          <a:noFill/>
-        </p:spPr>
-        <p:txBody>
-          <a:bodyPr wrap="square" anchor="t">
-            <a:spAutoFit/>
-          </a:bodyPr>
-          <a:lstStyle/>
-          <a:p>
-            <a:pPr algn="l"/>
-            <a:r>
-              <a:rPr sz="2000" b="1" i="0">
-                <a:solidFill>
-                  <a:srgbClr val="5C4826"/>
-                </a:solidFill>
-              </a:rPr>
-              <a:t>Correspondence</a:t>
-            </a:r>
-            <a:r>
-              <a:rPr sz="2000" b="0" i="0">
-                <a:solidFill>
-                  <a:srgbClr val="5C4826"/>
-                </a:solidFill>
-              </a:rPr>
-              <a:t> — do two representations agree?</a:t>
-            </a:r>
-          </a:p>
-          <a:p>
-            <a:pPr algn="l"/>
-            <a:r>
-              <a:rPr sz="2000" b="1" i="0">
-                <a:solidFill>
-                  <a:srgbClr val="5C4826"/>
-                </a:solidFill>
-              </a:rPr>
-              <a:t>Conformance</a:t>
-            </a:r>
-            <a:r>
-              <a:rPr sz="2000" b="0" i="0">
-                <a:solidFill>
-                  <a:srgbClr val="5C4826"/>
-                </a:solidFill>
-              </a:rPr>
-              <a:t> — does the artifact satisfy an independent obligation?</a:t>
-            </a:r>
-          </a:p>
-          <a:p>
-            <a:pPr algn="l"/>
-            <a:r>
-              <a:rPr sz="2000" b="1" i="0">
-                <a:solidFill>
-                  <a:srgbClr val="5C4826"/>
-                </a:solidFill>
-              </a:rPr>
-              <a:t>Acceptance</a:t>
-            </a:r>
-            <a:r>
-              <a:rPr sz="2000" b="0" i="0">
-                <a:solidFill>
-                  <a:srgbClr val="5C4826"/>
-                </a:solidFill>
-              </a:rPr>
-              <a:t> — will the environment admit it?</a:t>
-            </a:r>
-          </a:p>
-        </p:txBody>
-      </p:sp>
-      <p:sp>
-        <p:nvSpPr>
           <p:cNvPr id="9" name="FooterBand"/>
           <p:cNvSpPr/>
           <p:nvPr/>
@@ -19963,6 +19723,64 @@
                 </a:solidFill>
               </a:rPr>
               <a:t>Evidence for one does not establish the others.</a:t>
+            </a:r>
+          </a:p>
+        </p:txBody>
+      </p:sp>
+      <p:pic>
+        <p:nvPicPr>
+          <p:cNvPr id="10" name="Fig-3-2-1-three-relations" descr="three-relations-deck.png"/>
+          <p:cNvPicPr>
+            <a:picLocks noChangeAspect="1"/>
+          </p:cNvPicPr>
+          <p:nvPr/>
+        </p:nvPicPr>
+        <p:blipFill>
+          <a:blip r:embed="rId3"/>
+          <a:stretch>
+            <a:fillRect/>
+          </a:stretch>
+        </p:blipFill>
+        <p:spPr>
+          <a:xfrm>
+            <a:off x="1417320" y="1051560"/>
+            <a:ext cx="6309360" cy="3680460"/>
+          </a:xfrm>
+          <a:prstGeom prst="rect">
+            <a:avLst/>
+          </a:prstGeom>
+        </p:spPr>
+      </p:pic>
+      <p:sp>
+        <p:nvSpPr>
+          <p:cNvPr id="11" name="ThreeRelationsTakeaway"/>
+          <p:cNvSpPr txBox="1"/>
+          <p:nvPr/>
+        </p:nvSpPr>
+        <p:spPr>
+          <a:xfrm>
+            <a:off x="274320" y="4937760"/>
+            <a:ext cx="8595360" cy="502920"/>
+          </a:xfrm>
+          <a:prstGeom prst="rect">
+            <a:avLst/>
+          </a:prstGeom>
+          <a:noFill/>
+        </p:spPr>
+        <p:txBody>
+          <a:bodyPr wrap="square" anchor="t" lIns="27432" rIns="27432" tIns="22860" bIns="22860">
+            <a:spAutoFit/>
+          </a:bodyPr>
+          <a:lstStyle/>
+          <a:p>
+            <a:pPr algn="ctr"/>
+            <a:r>
+              <a:rPr sz="1600" b="0" i="0">
+                <a:solidFill>
+                  <a:srgbClr val="5C4826"/>
+                </a:solidFill>
+              </a:rPr>
+              <a:t>Three relations people casually conflate — and their evidence is not interchangeable.</a:t>
             </a:r>
           </a:p>
         </p:txBody>

</xml_diff>

<commit_message>
deck 2-3 item 6: slide 17 failure -> response correspondence made visual
The four-row table becomes four failure cards on the left mapped by arrows
to four engineering responses on the right — the bridge from diagnosis to
mechanism. Content unchanged; transition line kept below.

Co-Authored-By: Claude Opus 5 <noreply@anthropic.com>
</commit_message>
<xml_diff>
--- a/course/lectures/act-2-delegation-and-control/03-alignment/2-3-Alignment.pptx
+++ b/course/lectures/act-2-delegation-and-control/03-alignment/2-3-Alignment.pptx
@@ -2578,7 +2578,7 @@
           <a:lstStyle/>
           <a:p>
             <a:r>
-              <a:t>This earns the control vocabulary: the failure model, not a framework, motivates the four roles on the next slide.</a:t>
+              <a:t>The bridge from diagnosis to mechanism: each failure from the last four slides maps to a distinct engineering response. The four failures are genuinely different — wrong artifact, wrong process, excess authority, insufficient evidence — which is why the next slide needs four roles rather than one checker. This earns the control vocabulary: the failure model, not a framework, motivates the roles.</a:t>
             </a:r>
           </a:p>
         </p:txBody>
@@ -10923,262 +10923,6 @@
           </a:p>
         </p:txBody>
       </p:sp>
-      <p:graphicFrame>
-        <p:nvGraphicFramePr>
-          <p:cNvPr id="4" name="FailureControlTable"/>
-          <p:cNvGraphicFramePr>
-            <a:graphicFrameLocks noGrp="1"/>
-          </p:cNvGraphicFramePr>
-          <p:nvPr/>
-        </p:nvGraphicFramePr>
-        <p:xfrm>
-          <a:off x="914400" y="1188720"/>
-          <a:ext cx="7315200" cy="3182112"/>
-        </p:xfrm>
-        <a:graphic>
-          <a:graphicData uri="http://schemas.openxmlformats.org/drawingml/2006/table">
-            <a:tbl>
-              <a:tblPr>
-                <a:tableStyleId>{5C22544A-7EE6-4342-B048-85BDC9FD1C3A}</a:tableStyleId>
-              </a:tblPr>
-              <a:tblGrid>
-                <a:gridCol w="2743200"/>
-                <a:gridCol w="4572000"/>
-              </a:tblGrid>
-              <a:tr h="548640">
-                <a:tc>
-                  <a:txBody>
-                    <a:bodyPr wrap="square" anchor="ctr"/>
-                    <a:lstStyle/>
-                    <a:p>
-                      <a:pPr algn="l"/>
-                      <a:r>
-                        <a:rPr sz="1800" b="1" i="0">
-                          <a:solidFill>
-                            <a:srgbClr val="FFFFFF"/>
-                          </a:solidFill>
-                        </a:rPr>
-                        <a:t>Failure</a:t>
-                      </a:r>
-                    </a:p>
-                  </a:txBody>
-                  <a:tcPr anchor="ctr" marL="68580" marR="45720" marT="27432" marB="27432">
-                    <a:solidFill>
-                      <a:srgbClr val="8E6F3E"/>
-                    </a:solidFill>
-                  </a:tcPr>
-                </a:tc>
-                <a:tc>
-                  <a:txBody>
-                    <a:bodyPr wrap="square" anchor="ctr"/>
-                    <a:lstStyle/>
-                    <a:p>
-                      <a:pPr algn="l"/>
-                      <a:r>
-                        <a:rPr sz="1800" b="1" i="0">
-                          <a:solidFill>
-                            <a:srgbClr val="FFFFFF"/>
-                          </a:solidFill>
-                        </a:rPr>
-                        <a:t>What we need</a:t>
-                      </a:r>
-                    </a:p>
-                  </a:txBody>
-                  <a:tcPr anchor="ctr" marL="68580" marR="45720" marT="27432" marB="27432">
-                    <a:solidFill>
-                      <a:srgbClr val="8E6F3E"/>
-                    </a:solidFill>
-                  </a:tcPr>
-                </a:tc>
-              </a:tr>
-              <a:tr h="658368">
-                <a:tc>
-                  <a:txBody>
-                    <a:bodyPr wrap="square" anchor="ctr"/>
-                    <a:lstStyle/>
-                    <a:p>
-                      <a:pPr algn="l"/>
-                      <a:r>
-                        <a:rPr sz="1700" b="1" i="0">
-                          <a:solidFill>
-                            <a:srgbClr val="5C4826"/>
-                          </a:solidFill>
-                        </a:rPr>
-                        <a:t>wrong result</a:t>
-                      </a:r>
-                    </a:p>
-                  </a:txBody>
-                  <a:tcPr anchor="ctr" marL="68580" marR="45720" marT="27432" marB="27432">
-                    <a:solidFill>
-                      <a:srgbClr val="F5F1E8"/>
-                    </a:solidFill>
-                  </a:tcPr>
-                </a:tc>
-                <a:tc>
-                  <a:txBody>
-                    <a:bodyPr wrap="square" anchor="ctr"/>
-                    <a:lstStyle/>
-                    <a:p>
-                      <a:pPr algn="l"/>
-                      <a:r>
-                        <a:rPr sz="1700" b="0" i="0">
-                          <a:solidFill>
-                            <a:srgbClr val="5C4826"/>
-                          </a:solidFill>
-                        </a:rPr>
-                        <a:t>establish properties of the artifact</a:t>
-                      </a:r>
-                    </a:p>
-                  </a:txBody>
-                  <a:tcPr anchor="ctr" marL="68580" marR="45720" marT="27432" marB="27432">
-                    <a:solidFill>
-                      <a:srgbClr val="FBF8F2"/>
-                    </a:solidFill>
-                  </a:tcPr>
-                </a:tc>
-              </a:tr>
-              <a:tr h="658368">
-                <a:tc>
-                  <a:txBody>
-                    <a:bodyPr wrap="square" anchor="ctr"/>
-                    <a:lstStyle/>
-                    <a:p>
-                      <a:pPr algn="l"/>
-                      <a:r>
-                        <a:rPr sz="1700" b="1" i="0">
-                          <a:solidFill>
-                            <a:srgbClr val="5C4826"/>
-                          </a:solidFill>
-                        </a:rPr>
-                        <a:t>wrong process</a:t>
-                      </a:r>
-                    </a:p>
-                  </a:txBody>
-                  <a:tcPr anchor="ctr" marL="68580" marR="45720" marT="27432" marB="27432">
-                    <a:solidFill>
-                      <a:srgbClr val="F5F1E8"/>
-                    </a:solidFill>
-                  </a:tcPr>
-                </a:tc>
-                <a:tc>
-                  <a:txBody>
-                    <a:bodyPr wrap="square" anchor="ctr"/>
-                    <a:lstStyle/>
-                    <a:p>
-                      <a:pPr algn="l"/>
-                      <a:r>
-                        <a:rPr sz="1700" b="0" i="0">
-                          <a:solidFill>
-                            <a:srgbClr val="5C4826"/>
-                          </a:solidFill>
-                        </a:rPr>
-                        <a:t>observe or constrain actions</a:t>
-                      </a:r>
-                    </a:p>
-                  </a:txBody>
-                  <a:tcPr anchor="ctr" marL="68580" marR="45720" marT="27432" marB="27432">
-                    <a:solidFill>
-                      <a:srgbClr val="FBF8F2"/>
-                    </a:solidFill>
-                  </a:tcPr>
-                </a:tc>
-              </a:tr>
-              <a:tr h="658368">
-                <a:tc>
-                  <a:txBody>
-                    <a:bodyPr wrap="square" anchor="ctr"/>
-                    <a:lstStyle/>
-                    <a:p>
-                      <a:pPr algn="l"/>
-                      <a:r>
-                        <a:rPr sz="1700" b="1" i="0">
-                          <a:solidFill>
-                            <a:srgbClr val="5C4826"/>
-                          </a:solidFill>
-                        </a:rPr>
-                        <a:t>excess authority</a:t>
-                      </a:r>
-                    </a:p>
-                  </a:txBody>
-                  <a:tcPr anchor="ctr" marL="68580" marR="45720" marT="27432" marB="27432">
-                    <a:solidFill>
-                      <a:srgbClr val="F5F1E8"/>
-                    </a:solidFill>
-                  </a:tcPr>
-                </a:tc>
-                <a:tc>
-                  <a:txBody>
-                    <a:bodyPr wrap="square" anchor="ctr"/>
-                    <a:lstStyle/>
-                    <a:p>
-                      <a:pPr algn="l"/>
-                      <a:r>
-                        <a:rPr sz="1700" b="0" i="0">
-                          <a:solidFill>
-                            <a:srgbClr val="5C4826"/>
-                          </a:solidFill>
-                        </a:rPr>
-                        <a:t>restrict consequential actions</a:t>
-                      </a:r>
-                    </a:p>
-                  </a:txBody>
-                  <a:tcPr anchor="ctr" marL="68580" marR="45720" marT="27432" marB="27432">
-                    <a:solidFill>
-                      <a:srgbClr val="FBF8F2"/>
-                    </a:solidFill>
-                  </a:tcPr>
-                </a:tc>
-              </a:tr>
-              <a:tr h="658368">
-                <a:tc>
-                  <a:txBody>
-                    <a:bodyPr wrap="square" anchor="ctr"/>
-                    <a:lstStyle/>
-                    <a:p>
-                      <a:pPr algn="l"/>
-                      <a:r>
-                        <a:rPr sz="1700" b="1" i="0">
-                          <a:solidFill>
-                            <a:srgbClr val="5C4826"/>
-                          </a:solidFill>
-                        </a:rPr>
-                        <a:t>insufficient evidence</a:t>
-                      </a:r>
-                    </a:p>
-                  </a:txBody>
-                  <a:tcPr anchor="ctr" marL="68580" marR="45720" marT="27432" marB="27432">
-                    <a:solidFill>
-                      <a:srgbClr val="F5F1E8"/>
-                    </a:solidFill>
-                  </a:tcPr>
-                </a:tc>
-                <a:tc>
-                  <a:txBody>
-                    <a:bodyPr wrap="square" anchor="ctr"/>
-                    <a:lstStyle/>
-                    <a:p>
-                      <a:pPr algn="l"/>
-                      <a:r>
-                        <a:rPr sz="1700" b="0" i="0">
-                          <a:solidFill>
-                            <a:srgbClr val="5C4826"/>
-                          </a:solidFill>
-                        </a:rPr>
-                        <a:t>require evidence before acceptance</a:t>
-                      </a:r>
-                    </a:p>
-                  </a:txBody>
-                  <a:tcPr anchor="ctr" marL="68580" marR="45720" marT="27432" marB="27432">
-                    <a:solidFill>
-                      <a:srgbClr val="FBF8F2"/>
-                    </a:solidFill>
-                  </a:tcPr>
-                </a:tc>
-              </a:tr>
-            </a:tbl>
-          </a:graphicData>
-        </a:graphic>
-      </p:graphicFrame>
       <p:sp>
         <p:nvSpPr>
           <p:cNvPr id="5" name="FCTransition"/>
@@ -11187,7 +10931,7 @@
         </p:nvSpPr>
         <p:spPr>
           <a:xfrm>
-            <a:off x="502920" y="4800600"/>
+            <a:off x="502920" y="5303520"/>
             <a:ext cx="8138160" cy="548640"/>
           </a:xfrm>
           <a:prstGeom prst="rect">
@@ -11213,6 +10957,650 @@
           </a:p>
         </p:txBody>
       </p:sp>
+      <p:sp>
+        <p:nvSpPr>
+          <p:cNvPr id="6" name="FCHeadFailure"/>
+          <p:cNvSpPr txBox="1"/>
+          <p:nvPr/>
+        </p:nvSpPr>
+        <p:spPr>
+          <a:xfrm>
+            <a:off x="502920" y="932688"/>
+            <a:ext cx="3291840" cy="292608"/>
+          </a:xfrm>
+          <a:prstGeom prst="rect">
+            <a:avLst/>
+          </a:prstGeom>
+          <a:noFill/>
+        </p:spPr>
+        <p:txBody>
+          <a:bodyPr wrap="square" anchor="t" lIns="27432" rIns="27432" tIns="22860" bIns="22860">
+            <a:spAutoFit/>
+          </a:bodyPr>
+          <a:lstStyle/>
+          <a:p>
+            <a:pPr algn="ctr"/>
+            <a:r>
+              <a:rPr sz="1200" b="1" i="0">
+                <a:solidFill>
+                  <a:srgbClr val="8E6F3E"/>
+                </a:solidFill>
+              </a:rPr>
+              <a:t>FAILURE</a:t>
+            </a:r>
+          </a:p>
+        </p:txBody>
+      </p:sp>
+      <p:sp>
+        <p:nvSpPr>
+          <p:cNvPr id="7" name="FCHeadResponse"/>
+          <p:cNvSpPr txBox="1"/>
+          <p:nvPr/>
+        </p:nvSpPr>
+        <p:spPr>
+          <a:xfrm>
+            <a:off x="4800600" y="932688"/>
+            <a:ext cx="3840480" cy="292608"/>
+          </a:xfrm>
+          <a:prstGeom prst="rect">
+            <a:avLst/>
+          </a:prstGeom>
+          <a:noFill/>
+        </p:spPr>
+        <p:txBody>
+          <a:bodyPr wrap="square" anchor="t" lIns="27432" rIns="27432" tIns="22860" bIns="22860">
+            <a:spAutoFit/>
+          </a:bodyPr>
+          <a:lstStyle/>
+          <a:p>
+            <a:pPr algn="ctr"/>
+            <a:r>
+              <a:rPr sz="1200" b="1" i="0">
+                <a:solidFill>
+                  <a:srgbClr val="8E6F3E"/>
+                </a:solidFill>
+              </a:rPr>
+              <a:t>ENGINEERING RESPONSE</a:t>
+            </a:r>
+          </a:p>
+        </p:txBody>
+      </p:sp>
+      <p:sp>
+        <p:nvSpPr>
+          <p:cNvPr id="8" name="FCFail1"/>
+          <p:cNvSpPr/>
+          <p:nvPr/>
+        </p:nvSpPr>
+        <p:spPr>
+          <a:xfrm>
+            <a:off x="502920" y="1325880"/>
+            <a:ext cx="3291840" cy="841248"/>
+          </a:xfrm>
+          <a:prstGeom prst="rect">
+            <a:avLst/>
+          </a:prstGeom>
+          <a:solidFill>
+            <a:srgbClr val="F5F1E8"/>
+          </a:solidFill>
+          <a:ln w="12700">
+            <a:solidFill>
+              <a:srgbClr val="C9B991"/>
+            </a:solidFill>
+          </a:ln>
+          <a:effectLst/>
+        </p:spPr>
+        <p:style>
+          <a:lnRef idx="1">
+            <a:schemeClr val="accent1"/>
+          </a:lnRef>
+          <a:fillRef idx="3">
+            <a:schemeClr val="accent1"/>
+          </a:fillRef>
+          <a:effectRef idx="2">
+            <a:schemeClr val="accent1"/>
+          </a:effectRef>
+          <a:fontRef idx="minor">
+            <a:schemeClr val="lt1"/>
+          </a:fontRef>
+        </p:style>
+        <p:txBody>
+          <a:bodyPr rtlCol="0" anchor="ctr" wrap="square" lIns="27432" rIns="27432" tIns="22860" bIns="22860"/>
+          <a:lstStyle/>
+          <a:p>
+            <a:pPr algn="ctr"/>
+            <a:r>
+              <a:rPr sz="1400" b="1" i="0">
+                <a:solidFill>
+                  <a:srgbClr val="5C4826"/>
+                </a:solidFill>
+              </a:rPr>
+              <a:t>WRONG RESULT</a:t>
+            </a:r>
+          </a:p>
+        </p:txBody>
+      </p:sp>
+      <p:sp>
+        <p:nvSpPr>
+          <p:cNvPr id="9" name="FCResp1"/>
+          <p:cNvSpPr/>
+          <p:nvPr/>
+        </p:nvSpPr>
+        <p:spPr>
+          <a:xfrm>
+            <a:off x="4800600" y="1325880"/>
+            <a:ext cx="3840480" cy="841248"/>
+          </a:xfrm>
+          <a:prstGeom prst="rect">
+            <a:avLst/>
+          </a:prstGeom>
+          <a:solidFill>
+            <a:srgbClr val="F5F1E8"/>
+          </a:solidFill>
+          <a:ln w="12700">
+            <a:solidFill>
+              <a:srgbClr val="C9B991"/>
+            </a:solidFill>
+          </a:ln>
+          <a:effectLst/>
+        </p:spPr>
+        <p:style>
+          <a:lnRef idx="1">
+            <a:schemeClr val="accent1"/>
+          </a:lnRef>
+          <a:fillRef idx="3">
+            <a:schemeClr val="accent1"/>
+          </a:fillRef>
+          <a:effectRef idx="2">
+            <a:schemeClr val="accent1"/>
+          </a:effectRef>
+          <a:fontRef idx="minor">
+            <a:schemeClr val="lt1"/>
+          </a:fontRef>
+        </p:style>
+        <p:txBody>
+          <a:bodyPr rtlCol="0" anchor="ctr" wrap="square" lIns="27432" rIns="27432" tIns="22860" bIns="22860"/>
+          <a:lstStyle/>
+          <a:p>
+            <a:pPr algn="ctr"/>
+            <a:r>
+              <a:rPr sz="1300" b="0" i="0">
+                <a:solidFill>
+                  <a:srgbClr val="5C4826"/>
+                </a:solidFill>
+              </a:rPr>
+              <a:t>establish properties of the artifact</a:t>
+            </a:r>
+          </a:p>
+        </p:txBody>
+      </p:sp>
+      <p:cxnSp>
+        <p:nvCxnSpPr>
+          <p:cNvPr id="10" name="FCArrow1"/>
+          <p:cNvCxnSpPr/>
+          <p:nvPr/>
+        </p:nvCxnSpPr>
+        <p:spPr>
+          <a:xfrm>
+            <a:off x="3794760" y="1746504"/>
+            <a:ext cx="1005840" cy="0"/>
+          </a:xfrm>
+          <a:prstGeom prst="line">
+            <a:avLst/>
+          </a:prstGeom>
+          <a:ln w="28575">
+            <a:solidFill>
+              <a:srgbClr val="8E6F3E"/>
+            </a:solidFill>
+            <a:tailEnd type="triangle" w="med" len="med"/>
+          </a:ln>
+        </p:spPr>
+        <p:style>
+          <a:lnRef idx="2">
+            <a:schemeClr val="accent1"/>
+          </a:lnRef>
+          <a:fillRef idx="0">
+            <a:schemeClr val="accent1"/>
+          </a:fillRef>
+          <a:effectRef idx="1">
+            <a:schemeClr val="accent1"/>
+          </a:effectRef>
+          <a:fontRef idx="minor">
+            <a:schemeClr val="tx1"/>
+          </a:fontRef>
+        </p:style>
+      </p:cxnSp>
+      <p:sp>
+        <p:nvSpPr>
+          <p:cNvPr id="11" name="FCFail2"/>
+          <p:cNvSpPr/>
+          <p:nvPr/>
+        </p:nvSpPr>
+        <p:spPr>
+          <a:xfrm>
+            <a:off x="502920" y="2304288"/>
+            <a:ext cx="3291840" cy="841248"/>
+          </a:xfrm>
+          <a:prstGeom prst="rect">
+            <a:avLst/>
+          </a:prstGeom>
+          <a:solidFill>
+            <a:srgbClr val="F5F1E8"/>
+          </a:solidFill>
+          <a:ln w="12700">
+            <a:solidFill>
+              <a:srgbClr val="C9B991"/>
+            </a:solidFill>
+          </a:ln>
+          <a:effectLst/>
+        </p:spPr>
+        <p:style>
+          <a:lnRef idx="1">
+            <a:schemeClr val="accent1"/>
+          </a:lnRef>
+          <a:fillRef idx="3">
+            <a:schemeClr val="accent1"/>
+          </a:fillRef>
+          <a:effectRef idx="2">
+            <a:schemeClr val="accent1"/>
+          </a:effectRef>
+          <a:fontRef idx="minor">
+            <a:schemeClr val="lt1"/>
+          </a:fontRef>
+        </p:style>
+        <p:txBody>
+          <a:bodyPr rtlCol="0" anchor="ctr" wrap="square" lIns="27432" rIns="27432" tIns="22860" bIns="22860"/>
+          <a:lstStyle/>
+          <a:p>
+            <a:pPr algn="ctr"/>
+            <a:r>
+              <a:rPr sz="1400" b="1" i="0">
+                <a:solidFill>
+                  <a:srgbClr val="5C4826"/>
+                </a:solidFill>
+              </a:rPr>
+              <a:t>WRONG PROCESS</a:t>
+            </a:r>
+          </a:p>
+        </p:txBody>
+      </p:sp>
+      <p:sp>
+        <p:nvSpPr>
+          <p:cNvPr id="12" name="FCResp2"/>
+          <p:cNvSpPr/>
+          <p:nvPr/>
+        </p:nvSpPr>
+        <p:spPr>
+          <a:xfrm>
+            <a:off x="4800600" y="2304288"/>
+            <a:ext cx="3840480" cy="841248"/>
+          </a:xfrm>
+          <a:prstGeom prst="rect">
+            <a:avLst/>
+          </a:prstGeom>
+          <a:solidFill>
+            <a:srgbClr val="F5F1E8"/>
+          </a:solidFill>
+          <a:ln w="12700">
+            <a:solidFill>
+              <a:srgbClr val="C9B991"/>
+            </a:solidFill>
+          </a:ln>
+          <a:effectLst/>
+        </p:spPr>
+        <p:style>
+          <a:lnRef idx="1">
+            <a:schemeClr val="accent1"/>
+          </a:lnRef>
+          <a:fillRef idx="3">
+            <a:schemeClr val="accent1"/>
+          </a:fillRef>
+          <a:effectRef idx="2">
+            <a:schemeClr val="accent1"/>
+          </a:effectRef>
+          <a:fontRef idx="minor">
+            <a:schemeClr val="lt1"/>
+          </a:fontRef>
+        </p:style>
+        <p:txBody>
+          <a:bodyPr rtlCol="0" anchor="ctr" wrap="square" lIns="27432" rIns="27432" tIns="22860" bIns="22860"/>
+          <a:lstStyle/>
+          <a:p>
+            <a:pPr algn="ctr"/>
+            <a:r>
+              <a:rPr sz="1300" b="0" i="0">
+                <a:solidFill>
+                  <a:srgbClr val="5C4826"/>
+                </a:solidFill>
+              </a:rPr>
+              <a:t>observe or constrain actions</a:t>
+            </a:r>
+          </a:p>
+        </p:txBody>
+      </p:sp>
+      <p:cxnSp>
+        <p:nvCxnSpPr>
+          <p:cNvPr id="13" name="FCArrow2"/>
+          <p:cNvCxnSpPr/>
+          <p:nvPr/>
+        </p:nvCxnSpPr>
+        <p:spPr>
+          <a:xfrm>
+            <a:off x="3794760" y="2724912"/>
+            <a:ext cx="1005840" cy="0"/>
+          </a:xfrm>
+          <a:prstGeom prst="line">
+            <a:avLst/>
+          </a:prstGeom>
+          <a:ln w="28575">
+            <a:solidFill>
+              <a:srgbClr val="8E6F3E"/>
+            </a:solidFill>
+            <a:tailEnd type="triangle" w="med" len="med"/>
+          </a:ln>
+        </p:spPr>
+        <p:style>
+          <a:lnRef idx="2">
+            <a:schemeClr val="accent1"/>
+          </a:lnRef>
+          <a:fillRef idx="0">
+            <a:schemeClr val="accent1"/>
+          </a:fillRef>
+          <a:effectRef idx="1">
+            <a:schemeClr val="accent1"/>
+          </a:effectRef>
+          <a:fontRef idx="minor">
+            <a:schemeClr val="tx1"/>
+          </a:fontRef>
+        </p:style>
+      </p:cxnSp>
+      <p:sp>
+        <p:nvSpPr>
+          <p:cNvPr id="14" name="FCFail3"/>
+          <p:cNvSpPr/>
+          <p:nvPr/>
+        </p:nvSpPr>
+        <p:spPr>
+          <a:xfrm>
+            <a:off x="502920" y="3282696"/>
+            <a:ext cx="3291840" cy="841248"/>
+          </a:xfrm>
+          <a:prstGeom prst="rect">
+            <a:avLst/>
+          </a:prstGeom>
+          <a:solidFill>
+            <a:srgbClr val="F5F1E8"/>
+          </a:solidFill>
+          <a:ln w="12700">
+            <a:solidFill>
+              <a:srgbClr val="C9B991"/>
+            </a:solidFill>
+          </a:ln>
+          <a:effectLst/>
+        </p:spPr>
+        <p:style>
+          <a:lnRef idx="1">
+            <a:schemeClr val="accent1"/>
+          </a:lnRef>
+          <a:fillRef idx="3">
+            <a:schemeClr val="accent1"/>
+          </a:fillRef>
+          <a:effectRef idx="2">
+            <a:schemeClr val="accent1"/>
+          </a:effectRef>
+          <a:fontRef idx="minor">
+            <a:schemeClr val="lt1"/>
+          </a:fontRef>
+        </p:style>
+        <p:txBody>
+          <a:bodyPr rtlCol="0" anchor="ctr" wrap="square" lIns="27432" rIns="27432" tIns="22860" bIns="22860"/>
+          <a:lstStyle/>
+          <a:p>
+            <a:pPr algn="ctr"/>
+            <a:r>
+              <a:rPr sz="1400" b="1" i="0">
+                <a:solidFill>
+                  <a:srgbClr val="5C4826"/>
+                </a:solidFill>
+              </a:rPr>
+              <a:t>EXCESS AUTHORITY</a:t>
+            </a:r>
+          </a:p>
+        </p:txBody>
+      </p:sp>
+      <p:sp>
+        <p:nvSpPr>
+          <p:cNvPr id="15" name="FCResp3"/>
+          <p:cNvSpPr/>
+          <p:nvPr/>
+        </p:nvSpPr>
+        <p:spPr>
+          <a:xfrm>
+            <a:off x="4800600" y="3282696"/>
+            <a:ext cx="3840480" cy="841248"/>
+          </a:xfrm>
+          <a:prstGeom prst="rect">
+            <a:avLst/>
+          </a:prstGeom>
+          <a:solidFill>
+            <a:srgbClr val="F5F1E8"/>
+          </a:solidFill>
+          <a:ln w="12700">
+            <a:solidFill>
+              <a:srgbClr val="C9B991"/>
+            </a:solidFill>
+          </a:ln>
+          <a:effectLst/>
+        </p:spPr>
+        <p:style>
+          <a:lnRef idx="1">
+            <a:schemeClr val="accent1"/>
+          </a:lnRef>
+          <a:fillRef idx="3">
+            <a:schemeClr val="accent1"/>
+          </a:fillRef>
+          <a:effectRef idx="2">
+            <a:schemeClr val="accent1"/>
+          </a:effectRef>
+          <a:fontRef idx="minor">
+            <a:schemeClr val="lt1"/>
+          </a:fontRef>
+        </p:style>
+        <p:txBody>
+          <a:bodyPr rtlCol="0" anchor="ctr" wrap="square" lIns="27432" rIns="27432" tIns="22860" bIns="22860"/>
+          <a:lstStyle/>
+          <a:p>
+            <a:pPr algn="ctr"/>
+            <a:r>
+              <a:rPr sz="1300" b="0" i="0">
+                <a:solidFill>
+                  <a:srgbClr val="5C4826"/>
+                </a:solidFill>
+              </a:rPr>
+              <a:t>restrict consequential actions</a:t>
+            </a:r>
+          </a:p>
+        </p:txBody>
+      </p:sp>
+      <p:cxnSp>
+        <p:nvCxnSpPr>
+          <p:cNvPr id="16" name="FCArrow3"/>
+          <p:cNvCxnSpPr/>
+          <p:nvPr/>
+        </p:nvCxnSpPr>
+        <p:spPr>
+          <a:xfrm>
+            <a:off x="3794760" y="3703320"/>
+            <a:ext cx="1005840" cy="0"/>
+          </a:xfrm>
+          <a:prstGeom prst="line">
+            <a:avLst/>
+          </a:prstGeom>
+          <a:ln w="28575">
+            <a:solidFill>
+              <a:srgbClr val="8E6F3E"/>
+            </a:solidFill>
+            <a:tailEnd type="triangle" w="med" len="med"/>
+          </a:ln>
+        </p:spPr>
+        <p:style>
+          <a:lnRef idx="2">
+            <a:schemeClr val="accent1"/>
+          </a:lnRef>
+          <a:fillRef idx="0">
+            <a:schemeClr val="accent1"/>
+          </a:fillRef>
+          <a:effectRef idx="1">
+            <a:schemeClr val="accent1"/>
+          </a:effectRef>
+          <a:fontRef idx="minor">
+            <a:schemeClr val="tx1"/>
+          </a:fontRef>
+        </p:style>
+      </p:cxnSp>
+      <p:sp>
+        <p:nvSpPr>
+          <p:cNvPr id="17" name="FCFail4"/>
+          <p:cNvSpPr/>
+          <p:nvPr/>
+        </p:nvSpPr>
+        <p:spPr>
+          <a:xfrm>
+            <a:off x="502920" y="4261104"/>
+            <a:ext cx="3291840" cy="841248"/>
+          </a:xfrm>
+          <a:prstGeom prst="rect">
+            <a:avLst/>
+          </a:prstGeom>
+          <a:solidFill>
+            <a:srgbClr val="F5F1E8"/>
+          </a:solidFill>
+          <a:ln w="12700">
+            <a:solidFill>
+              <a:srgbClr val="C9B991"/>
+            </a:solidFill>
+          </a:ln>
+          <a:effectLst/>
+        </p:spPr>
+        <p:style>
+          <a:lnRef idx="1">
+            <a:schemeClr val="accent1"/>
+          </a:lnRef>
+          <a:fillRef idx="3">
+            <a:schemeClr val="accent1"/>
+          </a:fillRef>
+          <a:effectRef idx="2">
+            <a:schemeClr val="accent1"/>
+          </a:effectRef>
+          <a:fontRef idx="minor">
+            <a:schemeClr val="lt1"/>
+          </a:fontRef>
+        </p:style>
+        <p:txBody>
+          <a:bodyPr rtlCol="0" anchor="ctr" wrap="square" lIns="27432" rIns="27432" tIns="22860" bIns="22860"/>
+          <a:lstStyle/>
+          <a:p>
+            <a:pPr algn="ctr"/>
+            <a:r>
+              <a:rPr sz="1400" b="1" i="0">
+                <a:solidFill>
+                  <a:srgbClr val="5C4826"/>
+                </a:solidFill>
+              </a:rPr>
+              <a:t>INSUFFICIENT EVIDENCE</a:t>
+            </a:r>
+          </a:p>
+        </p:txBody>
+      </p:sp>
+      <p:sp>
+        <p:nvSpPr>
+          <p:cNvPr id="18" name="FCResp4"/>
+          <p:cNvSpPr/>
+          <p:nvPr/>
+        </p:nvSpPr>
+        <p:spPr>
+          <a:xfrm>
+            <a:off x="4800600" y="4261104"/>
+            <a:ext cx="3840480" cy="841248"/>
+          </a:xfrm>
+          <a:prstGeom prst="rect">
+            <a:avLst/>
+          </a:prstGeom>
+          <a:solidFill>
+            <a:srgbClr val="F5F1E8"/>
+          </a:solidFill>
+          <a:ln w="12700">
+            <a:solidFill>
+              <a:srgbClr val="C9B991"/>
+            </a:solidFill>
+          </a:ln>
+          <a:effectLst/>
+        </p:spPr>
+        <p:style>
+          <a:lnRef idx="1">
+            <a:schemeClr val="accent1"/>
+          </a:lnRef>
+          <a:fillRef idx="3">
+            <a:schemeClr val="accent1"/>
+          </a:fillRef>
+          <a:effectRef idx="2">
+            <a:schemeClr val="accent1"/>
+          </a:effectRef>
+          <a:fontRef idx="minor">
+            <a:schemeClr val="lt1"/>
+          </a:fontRef>
+        </p:style>
+        <p:txBody>
+          <a:bodyPr rtlCol="0" anchor="ctr" wrap="square" lIns="27432" rIns="27432" tIns="22860" bIns="22860"/>
+          <a:lstStyle/>
+          <a:p>
+            <a:pPr algn="ctr"/>
+            <a:r>
+              <a:rPr sz="1300" b="0" i="0">
+                <a:solidFill>
+                  <a:srgbClr val="5C4826"/>
+                </a:solidFill>
+              </a:rPr>
+              <a:t>require evidence before acceptance</a:t>
+            </a:r>
+          </a:p>
+        </p:txBody>
+      </p:sp>
+      <p:cxnSp>
+        <p:nvCxnSpPr>
+          <p:cNvPr id="19" name="FCArrow4"/>
+          <p:cNvCxnSpPr/>
+          <p:nvPr/>
+        </p:nvCxnSpPr>
+        <p:spPr>
+          <a:xfrm>
+            <a:off x="3794760" y="4681728"/>
+            <a:ext cx="1005840" cy="0"/>
+          </a:xfrm>
+          <a:prstGeom prst="line">
+            <a:avLst/>
+          </a:prstGeom>
+          <a:ln w="28575">
+            <a:solidFill>
+              <a:srgbClr val="8E6F3E"/>
+            </a:solidFill>
+            <a:tailEnd type="triangle" w="med" len="med"/>
+          </a:ln>
+        </p:spPr>
+        <p:style>
+          <a:lnRef idx="2">
+            <a:schemeClr val="accent1"/>
+          </a:lnRef>
+          <a:fillRef idx="0">
+            <a:schemeClr val="accent1"/>
+          </a:fillRef>
+          <a:effectRef idx="1">
+            <a:schemeClr val="accent1"/>
+          </a:effectRef>
+          <a:fontRef idx="minor">
+            <a:schemeClr val="tx1"/>
+          </a:fontRef>
+        </p:style>
+      </p:cxnSp>
     </p:spTree>
   </p:cSld>
   <p:clrMapOvr>

</xml_diff>

<commit_message>
deck 2-3 item 7: activity slide 36 gives students a tiny explicit model
The four obligations move to a left column (wording unchanged); the right
half carries the Controller model as an explicit declaration — API,
uses/forbidden relations, memory bound — plus the per-cycle interaction
line for obligation 4 (observable only in composition). Students design
controls against a given model instead of reconstructing one from prose.

Co-Authored-By: Claude Opus 5 <noreply@anthropic.com>
</commit_message>
<xml_diff>
--- a/course/lectures/act-2-delegation-and-control/03-alignment/2-3-Alignment.pptx
+++ b/course/lectures/act-2-delegation-and-control/03-alignment/2-3-Alignment.pptx
@@ -1248,7 +1248,7 @@
           <a:lstStyle/>
           <a:p>
             <a:r>
-              <a:t>Section 5 (18 min): ~10–12 min team work, ~6 min debrief. Same scenario for every team so the debrief can compare designs. The instruction is deliberately wider than "how will each obligation be checked?" — teams design the delegated process AND its controls. One obligation is structurally preventable, one measured, one static, one integration-only — keep that heterogeneity.</a:t>
+              <a:t>Section 5 (18 min): ~10–12 min team work, ~6 min debrief. Same scenario for every team so the debrief can compare designs. The instruction is deliberately wider than "how will each obligation be checked?" — teams design the delegated process AND its controls. One obligation is structurally preventable, one measured, one static, one integration-only — keep that heterogeneity. The model is GIVEN explicitly — students should not spend the exercise reconstructing it from prose immediately after being told why reconstruction is undesirable. The cycle line is the interaction behavior: obligation 4 is observable only in composition, so it forces a different boundary than the other three.</a:t>
             </a:r>
           </a:p>
         </p:txBody>
@@ -21302,8 +21302,8 @@
         </p:nvSpPr>
         <p:spPr>
           <a:xfrm>
-            <a:off x="274320" y="1965960"/>
-            <a:ext cx="4206240" cy="1005840"/>
+            <a:off x="274320" y="1920240"/>
+            <a:ext cx="4160520" cy="749808"/>
           </a:xfrm>
           <a:prstGeom prst="rect">
             <a:avLst/>
@@ -21338,7 +21338,7 @@
           <a:p>
             <a:pPr algn="l"/>
             <a:r>
-              <a:rPr sz="1800" b="1" i="0">
+              <a:rPr sz="1400" b="1" i="0">
                 <a:solidFill>
                   <a:srgbClr val="8E6F3E"/>
                 </a:solidFill>
@@ -21346,7 +21346,7 @@
               <a:t>1  ·  </a:t>
             </a:r>
             <a:r>
-              <a:rPr sz="1800" b="0" i="0">
+              <a:rPr sz="1400" b="0" i="0">
                 <a:solidFill>
                   <a:srgbClr val="5C4826"/>
                 </a:solidFill>
@@ -21364,8 +21364,8 @@
         </p:nvSpPr>
         <p:spPr>
           <a:xfrm>
-            <a:off x="4663440" y="1965960"/>
-            <a:ext cx="4206240" cy="1005840"/>
+            <a:off x="274320" y="2743200"/>
+            <a:ext cx="4160520" cy="749808"/>
           </a:xfrm>
           <a:prstGeom prst="rect">
             <a:avLst/>
@@ -21400,7 +21400,7 @@
           <a:p>
             <a:pPr algn="l"/>
             <a:r>
-              <a:rPr sz="1800" b="1" i="0">
+              <a:rPr sz="1400" b="1" i="0">
                 <a:solidFill>
                   <a:srgbClr val="8E6F3E"/>
                 </a:solidFill>
@@ -21408,7 +21408,7 @@
               <a:t>2  ·  </a:t>
             </a:r>
             <a:r>
-              <a:rPr sz="1800" b="0" i="0">
+              <a:rPr sz="1400" b="0" i="0">
                 <a:solidFill>
                   <a:srgbClr val="5C4826"/>
                 </a:solidFill>
@@ -21426,8 +21426,8 @@
         </p:nvSpPr>
         <p:spPr>
           <a:xfrm>
-            <a:off x="274320" y="3154680"/>
-            <a:ext cx="4206240" cy="1005840"/>
+            <a:off x="274320" y="3566160"/>
+            <a:ext cx="4160520" cy="749808"/>
           </a:xfrm>
           <a:prstGeom prst="rect">
             <a:avLst/>
@@ -21462,7 +21462,7 @@
           <a:p>
             <a:pPr algn="l"/>
             <a:r>
-              <a:rPr sz="1800" b="1" i="0">
+              <a:rPr sz="1400" b="1" i="0">
                 <a:solidFill>
                   <a:srgbClr val="8E6F3E"/>
                 </a:solidFill>
@@ -21470,7 +21470,7 @@
               <a:t>3  ·  </a:t>
             </a:r>
             <a:r>
-              <a:rPr sz="1800" b="0" i="0">
+              <a:rPr sz="1400" b="0" i="0">
                 <a:solidFill>
                   <a:srgbClr val="5C4826"/>
                 </a:solidFill>
@@ -21488,8 +21488,8 @@
         </p:nvSpPr>
         <p:spPr>
           <a:xfrm>
-            <a:off x="4663440" y="3154680"/>
-            <a:ext cx="4206240" cy="1005840"/>
+            <a:off x="274320" y="4389120"/>
+            <a:ext cx="4160520" cy="749808"/>
           </a:xfrm>
           <a:prstGeom prst="rect">
             <a:avLst/>
@@ -21524,7 +21524,7 @@
           <a:p>
             <a:pPr algn="l"/>
             <a:r>
-              <a:rPr sz="1800" b="1" i="0">
+              <a:rPr sz="1400" b="1" i="0">
                 <a:solidFill>
                   <a:srgbClr val="8E6F3E"/>
                 </a:solidFill>
@@ -21532,7 +21532,7 @@
               <a:t>4  ·  </a:t>
             </a:r>
             <a:r>
-              <a:rPr sz="1800" b="0" i="0">
+              <a:rPr sz="1400" b="0" i="0">
                 <a:solidFill>
                   <a:srgbClr val="5C4826"/>
                 </a:solidFill>
@@ -21550,7 +21550,7 @@
         </p:nvSpPr>
         <p:spPr>
           <a:xfrm>
-            <a:off x="274320" y="4572000"/>
+            <a:off x="274320" y="5230368"/>
             <a:ext cx="8595360" cy="457200"/>
           </a:xfrm>
           <a:prstGeom prst="rect">
@@ -21624,6 +21624,143 @@
                 </a:solidFill>
               </a:rPr>
               <a:t>Design the delegated process and its controls.</a:t>
+            </a:r>
+          </a:p>
+        </p:txBody>
+      </p:sp>
+      <p:sp>
+        <p:nvSpPr>
+          <p:cNvPr id="13" name="GivenModel"/>
+          <p:cNvSpPr/>
+          <p:nvPr/>
+        </p:nvSpPr>
+        <p:spPr>
+          <a:xfrm>
+            <a:off x="4617720" y="1920240"/>
+            <a:ext cx="4251960" cy="3218688"/>
+          </a:xfrm>
+          <a:prstGeom prst="rect">
+            <a:avLst/>
+          </a:prstGeom>
+          <a:solidFill>
+            <a:srgbClr val="F5F1E8"/>
+          </a:solidFill>
+          <a:ln w="12700">
+            <a:solidFill>
+              <a:srgbClr val="C9B991"/>
+            </a:solidFill>
+          </a:ln>
+          <a:effectLst/>
+        </p:spPr>
+        <p:style>
+          <a:lnRef idx="1">
+            <a:schemeClr val="accent1"/>
+          </a:lnRef>
+          <a:fillRef idx="3">
+            <a:schemeClr val="accent1"/>
+          </a:fillRef>
+          <a:effectRef idx="2">
+            <a:schemeClr val="accent1"/>
+          </a:effectRef>
+          <a:fontRef idx="minor">
+            <a:schemeClr val="lt1"/>
+          </a:fontRef>
+        </p:style>
+        <p:txBody>
+          <a:bodyPr rtlCol="0" anchor="t" wrap="square" lIns="27432" rIns="27432" tIns="22860" bIns="22860"/>
+          <a:lstStyle/>
+          <a:p>
+            <a:pPr algn="l"/>
+            <a:r>
+              <a:rPr sz="1150" b="1" i="0">
+                <a:solidFill>
+                  <a:srgbClr val="8E6F3E"/>
+                </a:solidFill>
+              </a:rPr>
+              <a:t>THE MODEL — GIVEN, NOT RECONSTRUCTED</a:t>
+            </a:r>
+          </a:p>
+          <a:p>
+            <a:pPr algn="l"/>
+            <a:r>
+              <a:rPr sz="1200" b="0" i="0">
+                <a:solidFill>
+                  <a:srgbClr val="5C4826"/>
+                </a:solidFill>
+                <a:latin typeface="Consolas"/>
+              </a:rPr>
+              <a:t>Controller</a:t>
+            </a:r>
+          </a:p>
+          <a:p>
+            <a:pPr algn="l"/>
+            <a:r>
+              <a:rPr sz="1200" b="0" i="0">
+                <a:solidFill>
+                  <a:srgbClr val="5C4826"/>
+                </a:solidFill>
+                <a:latin typeface="Consolas"/>
+              </a:rPr>
+              <a:t> ├─ API: IController</a:t>
+            </a:r>
+          </a:p>
+          <a:p>
+            <a:pPr algn="l"/>
+            <a:r>
+              <a:rPr sz="1200" b="0" i="0">
+                <a:solidFill>
+                  <a:srgbClr val="5C4826"/>
+                </a:solidFill>
+                <a:latin typeface="Consolas"/>
+              </a:rPr>
+              <a:t> ├─ uses → Sensor</a:t>
+            </a:r>
+          </a:p>
+          <a:p>
+            <a:pPr algn="l"/>
+            <a:r>
+              <a:rPr sz="1200" b="0" i="0">
+                <a:solidFill>
+                  <a:srgbClr val="5C4826"/>
+                </a:solidFill>
+                <a:latin typeface="Consolas"/>
+              </a:rPr>
+              <a:t> ├─ uses → Actuator</a:t>
+            </a:r>
+          </a:p>
+          <a:p>
+            <a:pPr algn="l"/>
+            <a:r>
+              <a:rPr sz="1200" b="0" i="0">
+                <a:solidFill>
+                  <a:srgbClr val="5C4826"/>
+                </a:solidFill>
+                <a:latin typeface="Consolas"/>
+              </a:rPr>
+              <a:t> ├─ forbidden → CloudSDK</a:t>
+            </a:r>
+          </a:p>
+          <a:p>
+            <a:pPr algn="l"/>
+            <a:r>
+              <a:rPr sz="1200" b="0" i="0">
+                <a:solidFill>
+                  <a:srgbClr val="5C4826"/>
+                </a:solidFill>
+                <a:latin typeface="Consolas"/>
+              </a:rPr>
+              <a:t> └─ memory ≤ 64 MB</a:t>
+            </a:r>
+          </a:p>
+          <a:p>
+            <a:pPr algn="l"/>
+            <a:r>
+              <a:rPr sz="1050" b="0" i="1">
+                <a:solidFill>
+                  <a:srgbClr val="555960"/>
+                </a:solidFill>
+              </a:rPr>
+              <a:t>each cycle: Sensor.read → decide → Actuator.act</a:t>
             </a:r>
           </a:p>
         </p:txBody>

</xml_diff>

<commit_message>
deck 2-3: visual-QA fixes on slides 18 and 25
Render-and-inspect found two defects introduced by the figure wave: slide
25's takeaway textbox carried BOTH the old and new takeaway runs (the
rewrite appended instead of replacing), and slide 18's roles line wrapped
into the new tree. The takeaway now reads exactly two lines (earliest
boundary / legible and decidable); the roles line sits at 13pt on one line.

Co-Authored-By: Claude Opus 5 <noreply@anthropic.com>
</commit_message>
<xml_diff>
--- a/course/lectures/act-2-delegation-and-control/03-alignment/2-3-Alignment.pptx
+++ b/course/lectures/act-2-delegation-and-control/03-alignment/2-3-Alignment.pptx
@@ -12040,7 +12040,7 @@
           <a:p>
             <a:pPr algn="ctr"/>
             <a:r>
-              <a:rPr sz="2000" b="0" i="1">
+              <a:rPr sz="1300" b="0" i="1">
                 <a:solidFill>
                   <a:srgbClr val="555960"/>
                 </a:solidFill>
@@ -16796,31 +16796,12 @@
           <a:p>
             <a:pPr algn="ctr"/>
             <a:r>
-              <a:rPr sz="2000" b="0" i="1">
-                <a:solidFill>
-                  <a:srgbClr val="555960"/>
-                </a:solidFill>
-              </a:rPr>
-              <a:t>Both rules place the check at the earliest point</a:t>
-            </a:r>
-            <a:r>
               <a:rPr sz="1800" b="1" i="0">
                 <a:solidFill>
                   <a:srgbClr val="5C4826"/>
                 </a:solidFill>
               </a:rPr>
               <a:t>Both place the check at the earliest boundary</a:t>
-            </a:r>
-          </a:p>
-          <a:p>
-            <a:pPr algn="ctr"/>
-            <a:r>
-              <a:rPr sz="2000" b="0" i="1">
-                <a:solidFill>
-                  <a:srgbClr val="555960"/>
-                </a:solidFill>
-              </a:rPr>
-              <a:t>with enough information to decide the claim.</a:t>
             </a:r>
           </a:p>
           <a:p>

</xml_diff>

<commit_message>
deck 2-3 prune A: drop the two opening-section commentary lines
'Not a third framework' (Validation meets Delegation) and the
'We do not merely give agents prompts' footer (work-environment slide):
the diagrams beside them already say it.
</commit_message>
<xml_diff>
--- a/course/lectures/act-2-delegation-and-control/03-alignment/2-3-Alignment.pptx
+++ b/course/lectures/act-2-delegation-and-control/03-alignment/2-3-Alignment.pptx
@@ -23312,40 +23312,6 @@
       </p:sp>
       <p:sp>
         <p:nvSpPr>
-          <p:cNvPr id="11" name="TextBox 10"/>
-          <p:cNvSpPr txBox="1"/>
-          <p:nvPr/>
-        </p:nvSpPr>
-        <p:spPr>
-          <a:xfrm>
-            <a:off x="274320" y="4736592"/>
-            <a:ext cx="8595360" cy="457200"/>
-          </a:xfrm>
-          <a:prstGeom prst="rect">
-            <a:avLst/>
-          </a:prstGeom>
-          <a:noFill/>
-        </p:spPr>
-        <p:txBody>
-          <a:bodyPr wrap="square" anchor="t">
-            <a:spAutoFit/>
-          </a:bodyPr>
-          <a:lstStyle/>
-          <a:p>
-            <a:pPr algn="ctr"/>
-            <a:r>
-              <a:rPr sz="2000" b="0" i="1">
-                <a:solidFill>
-                  <a:srgbClr val="555960"/>
-                </a:solidFill>
-              </a:rPr>
-              <a:t>Not a third framework — the point where the first two meet.</a:t>
-            </a:r>
-          </a:p>
-        </p:txBody>
-      </p:sp>
-      <p:sp>
-        <p:nvSpPr>
           <p:cNvPr id="12" name="FooterBand"/>
           <p:cNvSpPr/>
           <p:nvPr/>
@@ -24831,69 +24797,6 @@
                 </a:solidFill>
               </a:rPr>
               <a:t>Git worktree · branch · issue · repository instructions · tools · tests · CI · PR</a:t>
-            </a:r>
-          </a:p>
-        </p:txBody>
-      </p:sp>
-      <p:sp>
-        <p:nvSpPr>
-          <p:cNvPr id="20" name="FooterBand"/>
-          <p:cNvSpPr/>
-          <p:nvPr/>
-        </p:nvSpPr>
-        <p:spPr>
-          <a:xfrm>
-            <a:off x="274320" y="5852160"/>
-            <a:ext cx="8595360" cy="566928"/>
-          </a:xfrm>
-          <a:prstGeom prst="rect">
-            <a:avLst/>
-          </a:prstGeom>
-          <a:solidFill>
-            <a:srgbClr val="8E6F3E"/>
-          </a:solidFill>
-          <a:ln>
-            <a:noFill/>
-          </a:ln>
-          <a:effectLst/>
-        </p:spPr>
-        <p:style>
-          <a:lnRef idx="1">
-            <a:schemeClr val="accent1"/>
-          </a:lnRef>
-          <a:fillRef idx="3">
-            <a:schemeClr val="accent1"/>
-          </a:fillRef>
-          <a:effectRef idx="2">
-            <a:schemeClr val="accent1"/>
-          </a:effectRef>
-          <a:fontRef idx="minor">
-            <a:schemeClr val="lt1"/>
-          </a:fontRef>
-        </p:style>
-        <p:txBody>
-          <a:bodyPr rtlCol="0" anchor="ctr" wrap="square" lIns="27432" rIns="27432" tIns="22860" bIns="22860"/>
-          <a:lstStyle/>
-          <a:p>
-            <a:pPr algn="ctr"/>
-            <a:r>
-              <a:rPr sz="1600" b="1" i="0">
-                <a:solidFill>
-                  <a:srgbClr val="FFFFFF"/>
-                </a:solidFill>
-              </a:rPr>
-              <a:t>We do not merely give agents prompts.</a:t>
-            </a:r>
-          </a:p>
-          <a:p>
-            <a:pPr algn="ctr"/>
-            <a:r>
-              <a:rPr sz="1600" b="1" i="0">
-                <a:solidFill>
-                  <a:srgbClr val="FFFFFF"/>
-                </a:solidFill>
-              </a:rPr>
-              <a:t>We place them inside engineered processes.</a:t>
             </a:r>
           </a:p>
         </p:txBody>

</xml_diff>

<commit_message>
deck 2-3 prune B: cut the scaffolding slide and four restatements
Delete 'A process gives us something to reason about' (divider now goes
straight into the four failure modes). 'Evidence is evidence only
relative to an obligation' becomes 'Evidence bears on an obligation.'
Drop the over-caption on 'Prevent or detect?', the 'Some actions are
permitted...' line (gate footer says it), and the 'added step is
consequence' footer (the diagram says CONSEQUENCE).
</commit_message>
<xml_diff>
--- a/course/lectures/act-2-delegation-and-control/03-alignment/2-3-Alignment.pptx
+++ b/course/lectures/act-2-delegation-and-control/03-alignment/2-3-Alignment.pptx
@@ -19,7 +19,6 @@
     <p:sldId id="294" r:id="rId38"/>
     <p:sldId id="295" r:id="rId39"/>
     <p:sldId id="285" r:id="rId50"/>
-    <p:sldId id="296" r:id="rId40"/>
     <p:sldId id="297" r:id="rId41"/>
     <p:sldId id="298" r:id="rId42"/>
     <p:sldId id="299" r:id="rId14"/>
@@ -2229,76 +2228,6 @@
           <a:p>
             <a:r>
               <a:t>First explicit process-modeling slide. The distinction matters: we are modeling the engineering process, not pretending we have a faithful cognitive model of an LLM.</a:t>
-            </a:r>
-          </a:p>
-        </p:txBody>
-      </p:sp>
-      <p:sp>
-        <p:nvSpPr>
-          <p:cNvPr id="4" name="Slide Number Placeholder 3"/>
-          <p:cNvSpPr>
-            <a:spLocks noGrp="1"/>
-          </p:cNvSpPr>
-          <p:nvPr>
-            <p:ph type="sldNum" idx="5" sz="quarter"/>
-          </p:nvPr>
-        </p:nvSpPr>
-        <p:spPr/>
-      </p:sp>
-    </p:spTree>
-  </p:cSld>
-  <p:clrMapOvr>
-    <a:masterClrMapping/>
-  </p:clrMapOvr>
-</p:notes>
-</file>
-
-<file path=ppt/notesSlides/notesSlide32.xml><?xml version="1.0" encoding="utf-8"?>
-<p:notes xmlns:a="http://schemas.openxmlformats.org/drawingml/2006/main" xmlns:p="http://schemas.openxmlformats.org/presentationml/2006/main" xmlns:r="http://schemas.openxmlformats.org/officeDocument/2006/relationships">
-  <p:cSld>
-    <p:spTree>
-      <p:nvGrpSpPr>
-        <p:cNvPr id="1" name=""/>
-        <p:cNvGrpSpPr/>
-        <p:nvPr/>
-      </p:nvGrpSpPr>
-      <p:grpSpPr>
-        <a:xfrm>
-          <a:off x="0" y="0"/>
-          <a:ext cx="0" cy="0"/>
-          <a:chOff x="0" y="0"/>
-          <a:chExt cx="0" cy="0"/>
-        </a:xfrm>
-      </p:grpSpPr>
-      <p:sp>
-        <p:nvSpPr>
-          <p:cNvPr id="2" name="Slide Image Placeholder 1"/>
-          <p:cNvSpPr>
-            <a:spLocks noGrp="1"/>
-          </p:cNvSpPr>
-          <p:nvPr>
-            <p:ph type="sldImg" idx="2"/>
-          </p:nvPr>
-        </p:nvSpPr>
-        <p:spPr/>
-      </p:sp>
-      <p:sp>
-        <p:nvSpPr>
-          <p:cNvPr id="3" name="Notes Placeholder 2"/>
-          <p:cNvSpPr>
-            <a:spLocks noGrp="1"/>
-          </p:cNvSpPr>
-          <p:nvPr>
-            <p:ph type="body" idx="3" sz="quarter"/>
-          </p:nvPr>
-        </p:nvSpPr>
-        <p:spPr/>
-        <p:txBody>
-          <a:bodyPr/>
-          <a:lstStyle/>
-          <a:p>
-            <a:r>
-              <a:t>Reuse of the Section-1 process diagram, now with the endpoint highlighted: does the chain end in ACCEPTABLE work? The question shifts from "what should happen" to "what can go wrong."</a:t>
             </a:r>
           </a:p>
         </p:txBody>
@@ -7874,831 +7803,6 @@
 </p:sld>
 </file>
 
-<file path=ppt/slides/slide12.xml><?xml version="1.0" encoding="utf-8"?>
-<p:sld xmlns:a="http://schemas.openxmlformats.org/drawingml/2006/main" xmlns:p="http://schemas.openxmlformats.org/presentationml/2006/main" xmlns:r="http://schemas.openxmlformats.org/officeDocument/2006/relationships">
-  <p:cSld>
-    <p:spTree>
-      <p:nvGrpSpPr>
-        <p:cNvPr id="1" name=""/>
-        <p:cNvGrpSpPr/>
-        <p:nvPr/>
-      </p:nvGrpSpPr>
-      <p:grpSpPr/>
-      <p:sp>
-        <p:nvSpPr>
-          <p:cNvPr id="2" name="Content Placeholder 1"/>
-          <p:cNvSpPr>
-            <a:spLocks noGrp="1"/>
-          </p:cNvSpPr>
-          <p:nvPr>
-            <p:ph idx="1"/>
-          </p:nvPr>
-        </p:nvSpPr>
-        <p:spPr/>
-        <p:txBody>
-          <a:bodyPr/>
-          <a:lstStyle/>
-          <a:p/>
-        </p:txBody>
-      </p:sp>
-      <p:sp>
-        <p:nvSpPr>
-          <p:cNvPr id="3" name="Title 2"/>
-          <p:cNvSpPr>
-            <a:spLocks noGrp="1"/>
-          </p:cNvSpPr>
-          <p:nvPr>
-            <p:ph type="title"/>
-          </p:nvPr>
-        </p:nvSpPr>
-        <p:spPr/>
-        <p:txBody>
-          <a:bodyPr/>
-          <a:lstStyle/>
-          <a:p>
-            <a:r>
-              <a:rPr sz="2400"/>
-              <a:t>A process gives us something to reason about</a:t>
-            </a:r>
-          </a:p>
-        </p:txBody>
-      </p:sp>
-      <p:sp>
-        <p:nvSpPr>
-          <p:cNvPr id="4" name="PCWorkOrder"/>
-          <p:cNvSpPr/>
-          <p:nvPr/>
-        </p:nvSpPr>
-        <p:spPr>
-          <a:xfrm>
-            <a:off x="502920" y="1005840"/>
-            <a:ext cx="1737360" cy="548640"/>
-          </a:xfrm>
-          <a:prstGeom prst="rect">
-            <a:avLst/>
-          </a:prstGeom>
-          <a:solidFill>
-            <a:srgbClr val="8E6F3E"/>
-          </a:solidFill>
-          <a:ln>
-            <a:noFill/>
-          </a:ln>
-          <a:effectLst/>
-        </p:spPr>
-        <p:style>
-          <a:lnRef idx="1">
-            <a:schemeClr val="accent1"/>
-          </a:lnRef>
-          <a:fillRef idx="3">
-            <a:schemeClr val="accent1"/>
-          </a:fillRef>
-          <a:effectRef idx="2">
-            <a:schemeClr val="accent1"/>
-          </a:effectRef>
-          <a:fontRef idx="minor">
-            <a:schemeClr val="lt1"/>
-          </a:fontRef>
-        </p:style>
-        <p:txBody>
-          <a:bodyPr rtlCol="0" anchor="ctr" wrap="square" lIns="27432" rIns="27432" tIns="22860" bIns="22860"/>
-          <a:lstStyle/>
-          <a:p>
-            <a:pPr algn="ctr"/>
-            <a:r>
-              <a:rPr sz="1500" b="1" i="0">
-                <a:solidFill>
-                  <a:srgbClr val="FFFFFF"/>
-                </a:solidFill>
-              </a:rPr>
-              <a:t>WORK ORDER</a:t>
-            </a:r>
-          </a:p>
-        </p:txBody>
-      </p:sp>
-      <p:cxnSp>
-        <p:nvCxnSpPr>
-          <p:cNvPr id="5" name="Connector 4"/>
-          <p:cNvCxnSpPr/>
-          <p:nvPr/>
-        </p:nvCxnSpPr>
-        <p:spPr>
-          <a:xfrm>
-            <a:off x="1371600" y="1554480"/>
-            <a:ext cx="0" cy="365760"/>
-          </a:xfrm>
-          <a:prstGeom prst="line">
-            <a:avLst/>
-          </a:prstGeom>
-          <a:ln w="28575">
-            <a:solidFill>
-              <a:srgbClr val="8E6F3E"/>
-            </a:solidFill>
-            <a:tailEnd type="triangle" w="med" len="med"/>
-          </a:ln>
-          <a:effectLst/>
-        </p:spPr>
-        <p:style>
-          <a:lnRef idx="2">
-            <a:schemeClr val="accent1"/>
-          </a:lnRef>
-          <a:fillRef idx="0">
-            <a:schemeClr val="accent1"/>
-          </a:fillRef>
-          <a:effectRef idx="1">
-            <a:schemeClr val="accent1"/>
-          </a:effectRef>
-          <a:fontRef idx="minor">
-            <a:schemeClr val="tx1"/>
-          </a:fontRef>
-        </p:style>
-      </p:cxnSp>
-      <p:sp>
-        <p:nvSpPr>
-          <p:cNvPr id="6" name="PCINSPECT"/>
-          <p:cNvSpPr/>
-          <p:nvPr/>
-        </p:nvSpPr>
-        <p:spPr>
-          <a:xfrm>
-            <a:off x="502920" y="1920240"/>
-            <a:ext cx="1417320" cy="594360"/>
-          </a:xfrm>
-          <a:prstGeom prst="rect">
-            <a:avLst/>
-          </a:prstGeom>
-          <a:solidFill>
-            <a:srgbClr val="F5F1E8"/>
-          </a:solidFill>
-          <a:ln w="12700">
-            <a:solidFill>
-              <a:srgbClr val="C9B991"/>
-            </a:solidFill>
-          </a:ln>
-          <a:effectLst/>
-        </p:spPr>
-        <p:style>
-          <a:lnRef idx="1">
-            <a:schemeClr val="accent1"/>
-          </a:lnRef>
-          <a:fillRef idx="3">
-            <a:schemeClr val="accent1"/>
-          </a:fillRef>
-          <a:effectRef idx="2">
-            <a:schemeClr val="accent1"/>
-          </a:effectRef>
-          <a:fontRef idx="minor">
-            <a:schemeClr val="lt1"/>
-          </a:fontRef>
-        </p:style>
-        <p:txBody>
-          <a:bodyPr rtlCol="0" anchor="ctr" wrap="square" lIns="27432" rIns="27432" tIns="22860" bIns="22860"/>
-          <a:lstStyle/>
-          <a:p>
-            <a:pPr algn="ctr"/>
-            <a:r>
-              <a:rPr sz="1500" b="1" i="0">
-                <a:solidFill>
-                  <a:srgbClr val="5C4826"/>
-                </a:solidFill>
-              </a:rPr>
-              <a:t>INSPECT</a:t>
-            </a:r>
-          </a:p>
-        </p:txBody>
-      </p:sp>
-      <p:cxnSp>
-        <p:nvCxnSpPr>
-          <p:cNvPr id="7" name="Connector 6"/>
-          <p:cNvCxnSpPr/>
-          <p:nvPr/>
-        </p:nvCxnSpPr>
-        <p:spPr>
-          <a:xfrm>
-            <a:off x="1920240" y="2217420"/>
-            <a:ext cx="182880" cy="0"/>
-          </a:xfrm>
-          <a:prstGeom prst="line">
-            <a:avLst/>
-          </a:prstGeom>
-          <a:ln w="28575">
-            <a:solidFill>
-              <a:srgbClr val="8E6F3E"/>
-            </a:solidFill>
-            <a:tailEnd type="triangle" w="med" len="med"/>
-          </a:ln>
-          <a:effectLst/>
-        </p:spPr>
-        <p:style>
-          <a:lnRef idx="2">
-            <a:schemeClr val="accent1"/>
-          </a:lnRef>
-          <a:fillRef idx="0">
-            <a:schemeClr val="accent1"/>
-          </a:fillRef>
-          <a:effectRef idx="1">
-            <a:schemeClr val="accent1"/>
-          </a:effectRef>
-          <a:fontRef idx="minor">
-            <a:schemeClr val="tx1"/>
-          </a:fontRef>
-        </p:style>
-      </p:cxnSp>
-      <p:sp>
-        <p:nvSpPr>
-          <p:cNvPr id="8" name="PCMODIFY"/>
-          <p:cNvSpPr/>
-          <p:nvPr/>
-        </p:nvSpPr>
-        <p:spPr>
-          <a:xfrm>
-            <a:off x="2103120" y="1920240"/>
-            <a:ext cx="1417320" cy="594360"/>
-          </a:xfrm>
-          <a:prstGeom prst="rect">
-            <a:avLst/>
-          </a:prstGeom>
-          <a:solidFill>
-            <a:srgbClr val="F5F1E8"/>
-          </a:solidFill>
-          <a:ln w="12700">
-            <a:solidFill>
-              <a:srgbClr val="C9B991"/>
-            </a:solidFill>
-          </a:ln>
-          <a:effectLst/>
-        </p:spPr>
-        <p:style>
-          <a:lnRef idx="1">
-            <a:schemeClr val="accent1"/>
-          </a:lnRef>
-          <a:fillRef idx="3">
-            <a:schemeClr val="accent1"/>
-          </a:fillRef>
-          <a:effectRef idx="2">
-            <a:schemeClr val="accent1"/>
-          </a:effectRef>
-          <a:fontRef idx="minor">
-            <a:schemeClr val="lt1"/>
-          </a:fontRef>
-        </p:style>
-        <p:txBody>
-          <a:bodyPr rtlCol="0" anchor="ctr" wrap="square" lIns="27432" rIns="27432" tIns="22860" bIns="22860"/>
-          <a:lstStyle/>
-          <a:p>
-            <a:pPr algn="ctr"/>
-            <a:r>
-              <a:rPr sz="1500" b="1" i="0">
-                <a:solidFill>
-                  <a:srgbClr val="5C4826"/>
-                </a:solidFill>
-              </a:rPr>
-              <a:t>MODIFY</a:t>
-            </a:r>
-          </a:p>
-        </p:txBody>
-      </p:sp>
-      <p:cxnSp>
-        <p:nvCxnSpPr>
-          <p:cNvPr id="9" name="Connector 8"/>
-          <p:cNvCxnSpPr/>
-          <p:nvPr/>
-        </p:nvCxnSpPr>
-        <p:spPr>
-          <a:xfrm>
-            <a:off x="3520439" y="2217420"/>
-            <a:ext cx="182881" cy="0"/>
-          </a:xfrm>
-          <a:prstGeom prst="line">
-            <a:avLst/>
-          </a:prstGeom>
-          <a:ln w="28575">
-            <a:solidFill>
-              <a:srgbClr val="8E6F3E"/>
-            </a:solidFill>
-            <a:tailEnd type="triangle" w="med" len="med"/>
-          </a:ln>
-          <a:effectLst/>
-        </p:spPr>
-        <p:style>
-          <a:lnRef idx="2">
-            <a:schemeClr val="accent1"/>
-          </a:lnRef>
-          <a:fillRef idx="0">
-            <a:schemeClr val="accent1"/>
-          </a:fillRef>
-          <a:effectRef idx="1">
-            <a:schemeClr val="accent1"/>
-          </a:effectRef>
-          <a:fontRef idx="minor">
-            <a:schemeClr val="tx1"/>
-          </a:fontRef>
-        </p:style>
-      </p:cxnSp>
-      <p:sp>
-        <p:nvSpPr>
-          <p:cNvPr id="10" name="PCCHECK"/>
-          <p:cNvSpPr/>
-          <p:nvPr/>
-        </p:nvSpPr>
-        <p:spPr>
-          <a:xfrm>
-            <a:off x="3703320" y="1920240"/>
-            <a:ext cx="1417320" cy="594360"/>
-          </a:xfrm>
-          <a:prstGeom prst="rect">
-            <a:avLst/>
-          </a:prstGeom>
-          <a:solidFill>
-            <a:srgbClr val="F5F1E8"/>
-          </a:solidFill>
-          <a:ln w="12700">
-            <a:solidFill>
-              <a:srgbClr val="C9B991"/>
-            </a:solidFill>
-          </a:ln>
-          <a:effectLst/>
-        </p:spPr>
-        <p:style>
-          <a:lnRef idx="1">
-            <a:schemeClr val="accent1"/>
-          </a:lnRef>
-          <a:fillRef idx="3">
-            <a:schemeClr val="accent1"/>
-          </a:fillRef>
-          <a:effectRef idx="2">
-            <a:schemeClr val="accent1"/>
-          </a:effectRef>
-          <a:fontRef idx="minor">
-            <a:schemeClr val="lt1"/>
-          </a:fontRef>
-        </p:style>
-        <p:txBody>
-          <a:bodyPr rtlCol="0" anchor="ctr" wrap="square" lIns="27432" rIns="27432" tIns="22860" bIns="22860"/>
-          <a:lstStyle/>
-          <a:p>
-            <a:pPr algn="ctr"/>
-            <a:r>
-              <a:rPr sz="1500" b="1" i="0">
-                <a:solidFill>
-                  <a:srgbClr val="5C4826"/>
-                </a:solidFill>
-              </a:rPr>
-              <a:t>CHECK</a:t>
-            </a:r>
-          </a:p>
-        </p:txBody>
-      </p:sp>
-      <p:cxnSp>
-        <p:nvCxnSpPr>
-          <p:cNvPr id="11" name="Connector 10"/>
-          <p:cNvCxnSpPr/>
-          <p:nvPr/>
-        </p:nvCxnSpPr>
-        <p:spPr>
-          <a:xfrm>
-            <a:off x="5120640" y="2217420"/>
-            <a:ext cx="182880" cy="0"/>
-          </a:xfrm>
-          <a:prstGeom prst="line">
-            <a:avLst/>
-          </a:prstGeom>
-          <a:ln w="28575">
-            <a:solidFill>
-              <a:srgbClr val="8E6F3E"/>
-            </a:solidFill>
-            <a:tailEnd type="triangle" w="med" len="med"/>
-          </a:ln>
-          <a:effectLst/>
-        </p:spPr>
-        <p:style>
-          <a:lnRef idx="2">
-            <a:schemeClr val="accent1"/>
-          </a:lnRef>
-          <a:fillRef idx="0">
-            <a:schemeClr val="accent1"/>
-          </a:fillRef>
-          <a:effectRef idx="1">
-            <a:schemeClr val="accent1"/>
-          </a:effectRef>
-          <a:fontRef idx="minor">
-            <a:schemeClr val="tx1"/>
-          </a:fontRef>
-        </p:style>
-      </p:cxnSp>
-      <p:sp>
-        <p:nvSpPr>
-          <p:cNvPr id="12" name="PCCOMMIT"/>
-          <p:cNvSpPr/>
-          <p:nvPr/>
-        </p:nvSpPr>
-        <p:spPr>
-          <a:xfrm>
-            <a:off x="5303520" y="1920240"/>
-            <a:ext cx="1417320" cy="594360"/>
-          </a:xfrm>
-          <a:prstGeom prst="rect">
-            <a:avLst/>
-          </a:prstGeom>
-          <a:solidFill>
-            <a:srgbClr val="F5F1E8"/>
-          </a:solidFill>
-          <a:ln w="12700">
-            <a:solidFill>
-              <a:srgbClr val="C9B991"/>
-            </a:solidFill>
-          </a:ln>
-          <a:effectLst/>
-        </p:spPr>
-        <p:style>
-          <a:lnRef idx="1">
-            <a:schemeClr val="accent1"/>
-          </a:lnRef>
-          <a:fillRef idx="3">
-            <a:schemeClr val="accent1"/>
-          </a:fillRef>
-          <a:effectRef idx="2">
-            <a:schemeClr val="accent1"/>
-          </a:effectRef>
-          <a:fontRef idx="minor">
-            <a:schemeClr val="lt1"/>
-          </a:fontRef>
-        </p:style>
-        <p:txBody>
-          <a:bodyPr rtlCol="0" anchor="ctr" wrap="square" lIns="27432" rIns="27432" tIns="22860" bIns="22860"/>
-          <a:lstStyle/>
-          <a:p>
-            <a:pPr algn="ctr"/>
-            <a:r>
-              <a:rPr sz="1500" b="1" i="0">
-                <a:solidFill>
-                  <a:srgbClr val="5C4826"/>
-                </a:solidFill>
-              </a:rPr>
-              <a:t>COMMIT</a:t>
-            </a:r>
-          </a:p>
-        </p:txBody>
-      </p:sp>
-      <p:cxnSp>
-        <p:nvCxnSpPr>
-          <p:cNvPr id="13" name="Connector 12"/>
-          <p:cNvCxnSpPr/>
-          <p:nvPr/>
-        </p:nvCxnSpPr>
-        <p:spPr>
-          <a:xfrm>
-            <a:off x="6720840" y="2217420"/>
-            <a:ext cx="182880" cy="0"/>
-          </a:xfrm>
-          <a:prstGeom prst="line">
-            <a:avLst/>
-          </a:prstGeom>
-          <a:ln w="28575">
-            <a:solidFill>
-              <a:srgbClr val="8E6F3E"/>
-            </a:solidFill>
-            <a:tailEnd type="triangle" w="med" len="med"/>
-          </a:ln>
-          <a:effectLst/>
-        </p:spPr>
-        <p:style>
-          <a:lnRef idx="2">
-            <a:schemeClr val="accent1"/>
-          </a:lnRef>
-          <a:fillRef idx="0">
-            <a:schemeClr val="accent1"/>
-          </a:fillRef>
-          <a:effectRef idx="1">
-            <a:schemeClr val="accent1"/>
-          </a:effectRef>
-          <a:fontRef idx="minor">
-            <a:schemeClr val="tx1"/>
-          </a:fontRef>
-        </p:style>
-      </p:cxnSp>
-      <p:sp>
-        <p:nvSpPr>
-          <p:cNvPr id="14" name="PCPROPOSE"/>
-          <p:cNvSpPr/>
-          <p:nvPr/>
-        </p:nvSpPr>
-        <p:spPr>
-          <a:xfrm>
-            <a:off x="6903720" y="1920240"/>
-            <a:ext cx="1417320" cy="594360"/>
-          </a:xfrm>
-          <a:prstGeom prst="rect">
-            <a:avLst/>
-          </a:prstGeom>
-          <a:solidFill>
-            <a:srgbClr val="F5F1E8"/>
-          </a:solidFill>
-          <a:ln w="12700">
-            <a:solidFill>
-              <a:srgbClr val="C9B991"/>
-            </a:solidFill>
-          </a:ln>
-          <a:effectLst/>
-        </p:spPr>
-        <p:style>
-          <a:lnRef idx="1">
-            <a:schemeClr val="accent1"/>
-          </a:lnRef>
-          <a:fillRef idx="3">
-            <a:schemeClr val="accent1"/>
-          </a:fillRef>
-          <a:effectRef idx="2">
-            <a:schemeClr val="accent1"/>
-          </a:effectRef>
-          <a:fontRef idx="minor">
-            <a:schemeClr val="lt1"/>
-          </a:fontRef>
-        </p:style>
-        <p:txBody>
-          <a:bodyPr rtlCol="0" anchor="ctr" wrap="square" lIns="27432" rIns="27432" tIns="22860" bIns="22860"/>
-          <a:lstStyle/>
-          <a:p>
-            <a:pPr algn="ctr"/>
-            <a:r>
-              <a:rPr sz="1500" b="1" i="0">
-                <a:solidFill>
-                  <a:srgbClr val="5C4826"/>
-                </a:solidFill>
-              </a:rPr>
-              <a:t>PROPOSE</a:t>
-            </a:r>
-          </a:p>
-        </p:txBody>
-      </p:sp>
-      <p:cxnSp>
-        <p:nvCxnSpPr>
-          <p:cNvPr id="15" name="Connector 14"/>
-          <p:cNvCxnSpPr/>
-          <p:nvPr/>
-        </p:nvCxnSpPr>
-        <p:spPr>
-          <a:xfrm>
-            <a:off x="4411980" y="2514600"/>
-            <a:ext cx="0" cy="274320"/>
-          </a:xfrm>
-          <a:prstGeom prst="line">
-            <a:avLst/>
-          </a:prstGeom>
-          <a:ln w="19050">
-            <a:solidFill>
-              <a:srgbClr val="C9B991"/>
-            </a:solidFill>
-          </a:ln>
-          <a:effectLst/>
-        </p:spPr>
-        <p:style>
-          <a:lnRef idx="2">
-            <a:schemeClr val="accent1"/>
-          </a:lnRef>
-          <a:fillRef idx="0">
-            <a:schemeClr val="accent1"/>
-          </a:fillRef>
-          <a:effectRef idx="1">
-            <a:schemeClr val="accent1"/>
-          </a:effectRef>
-          <a:fontRef idx="minor">
-            <a:schemeClr val="tx1"/>
-          </a:fontRef>
-        </p:style>
-      </p:cxnSp>
-      <p:cxnSp>
-        <p:nvCxnSpPr>
-          <p:cNvPr id="16" name="Connector 15"/>
-          <p:cNvCxnSpPr/>
-          <p:nvPr/>
-        </p:nvCxnSpPr>
-        <p:spPr>
-          <a:xfrm flipH="1">
-            <a:off x="2811779" y="2788920"/>
-            <a:ext cx="1600201" cy="0"/>
-          </a:xfrm>
-          <a:prstGeom prst="line">
-            <a:avLst/>
-          </a:prstGeom>
-          <a:ln w="19050">
-            <a:solidFill>
-              <a:srgbClr val="C9B991"/>
-            </a:solidFill>
-          </a:ln>
-          <a:effectLst/>
-        </p:spPr>
-        <p:style>
-          <a:lnRef idx="2">
-            <a:schemeClr val="accent1"/>
-          </a:lnRef>
-          <a:fillRef idx="0">
-            <a:schemeClr val="accent1"/>
-          </a:fillRef>
-          <a:effectRef idx="1">
-            <a:schemeClr val="accent1"/>
-          </a:effectRef>
-          <a:fontRef idx="minor">
-            <a:schemeClr val="tx1"/>
-          </a:fontRef>
-        </p:style>
-      </p:cxnSp>
-      <p:cxnSp>
-        <p:nvCxnSpPr>
-          <p:cNvPr id="17" name="Connector 16"/>
-          <p:cNvCxnSpPr/>
-          <p:nvPr/>
-        </p:nvCxnSpPr>
-        <p:spPr>
-          <a:xfrm flipV="1">
-            <a:off x="2811779" y="2551176"/>
-            <a:ext cx="0" cy="237744"/>
-          </a:xfrm>
-          <a:prstGeom prst="line">
-            <a:avLst/>
-          </a:prstGeom>
-          <a:ln w="19050">
-            <a:solidFill>
-              <a:srgbClr val="C9B991"/>
-            </a:solidFill>
-            <a:tailEnd type="triangle" w="med" len="med"/>
-          </a:ln>
-          <a:effectLst/>
-        </p:spPr>
-        <p:style>
-          <a:lnRef idx="2">
-            <a:schemeClr val="accent1"/>
-          </a:lnRef>
-          <a:fillRef idx="0">
-            <a:schemeClr val="accent1"/>
-          </a:fillRef>
-          <a:effectRef idx="1">
-            <a:schemeClr val="accent1"/>
-          </a:effectRef>
-          <a:fontRef idx="minor">
-            <a:schemeClr val="tx1"/>
-          </a:fontRef>
-        </p:style>
-      </p:cxnSp>
-      <p:cxnSp>
-        <p:nvCxnSpPr>
-          <p:cNvPr id="18" name="Connector 17"/>
-          <p:cNvCxnSpPr/>
-          <p:nvPr/>
-        </p:nvCxnSpPr>
-        <p:spPr>
-          <a:xfrm>
-            <a:off x="7612379" y="2514600"/>
-            <a:ext cx="0" cy="521208"/>
-          </a:xfrm>
-          <a:prstGeom prst="line">
-            <a:avLst/>
-          </a:prstGeom>
-          <a:ln w="28575">
-            <a:solidFill>
-              <a:srgbClr val="8E6F3E"/>
-            </a:solidFill>
-            <a:tailEnd type="triangle" w="med" len="med"/>
-          </a:ln>
-          <a:effectLst/>
-        </p:spPr>
-        <p:style>
-          <a:lnRef idx="2">
-            <a:schemeClr val="accent1"/>
-          </a:lnRef>
-          <a:fillRef idx="0">
-            <a:schemeClr val="accent1"/>
-          </a:fillRef>
-          <a:effectRef idx="1">
-            <a:schemeClr val="accent1"/>
-          </a:effectRef>
-          <a:fontRef idx="minor">
-            <a:schemeClr val="tx1"/>
-          </a:fontRef>
-        </p:style>
-      </p:cxnSp>
-      <p:sp>
-        <p:nvSpPr>
-          <p:cNvPr id="19" name="PCOutcome"/>
-          <p:cNvSpPr/>
-          <p:nvPr/>
-        </p:nvSpPr>
-        <p:spPr>
-          <a:xfrm>
-            <a:off x="6903720" y="3054096"/>
-            <a:ext cx="1920240" cy="548640"/>
-          </a:xfrm>
-          <a:prstGeom prst="rect">
-            <a:avLst/>
-          </a:prstGeom>
-          <a:solidFill>
-            <a:srgbClr val="8E6F3E"/>
-          </a:solidFill>
-          <a:ln>
-            <a:noFill/>
-          </a:ln>
-          <a:effectLst/>
-        </p:spPr>
-        <p:style>
-          <a:lnRef idx="1">
-            <a:schemeClr val="accent1"/>
-          </a:lnRef>
-          <a:fillRef idx="3">
-            <a:schemeClr val="accent1"/>
-          </a:fillRef>
-          <a:effectRef idx="2">
-            <a:schemeClr val="accent1"/>
-          </a:effectRef>
-          <a:fontRef idx="minor">
-            <a:schemeClr val="lt1"/>
-          </a:fontRef>
-        </p:style>
-        <p:txBody>
-          <a:bodyPr rtlCol="0" anchor="ctr" wrap="square" lIns="27432" rIns="27432" tIns="22860" bIns="22860"/>
-          <a:lstStyle/>
-          <a:p>
-            <a:pPr algn="ctr"/>
-            <a:r>
-              <a:rPr sz="1500" b="1" i="0">
-                <a:solidFill>
-                  <a:srgbClr val="FFFFFF"/>
-                </a:solidFill>
-              </a:rPr>
-              <a:t>acceptable work?</a:t>
-            </a:r>
-          </a:p>
-        </p:txBody>
-      </p:sp>
-      <p:sp>
-        <p:nvSpPr>
-          <p:cNvPr id="20" name="FooterBand"/>
-          <p:cNvSpPr/>
-          <p:nvPr/>
-        </p:nvSpPr>
-        <p:spPr>
-          <a:xfrm>
-            <a:off x="274320" y="5852160"/>
-            <a:ext cx="8595360" cy="566928"/>
-          </a:xfrm>
-          <a:prstGeom prst="rect">
-            <a:avLst/>
-          </a:prstGeom>
-          <a:solidFill>
-            <a:srgbClr val="8E6F3E"/>
-          </a:solidFill>
-          <a:ln>
-            <a:noFill/>
-          </a:ln>
-          <a:effectLst/>
-        </p:spPr>
-        <p:style>
-          <a:lnRef idx="1">
-            <a:schemeClr val="accent1"/>
-          </a:lnRef>
-          <a:fillRef idx="3">
-            <a:schemeClr val="accent1"/>
-          </a:fillRef>
-          <a:effectRef idx="2">
-            <a:schemeClr val="accent1"/>
-          </a:effectRef>
-          <a:fontRef idx="minor">
-            <a:schemeClr val="lt1"/>
-          </a:fontRef>
-        </p:style>
-        <p:txBody>
-          <a:bodyPr rtlCol="0" anchor="ctr" wrap="square" lIns="27432" rIns="27432" tIns="22860" bIns="22860"/>
-          <a:lstStyle/>
-          <a:p>
-            <a:pPr algn="ctr"/>
-            <a:r>
-              <a:rPr sz="1600" b="1" i="0">
-                <a:solidFill>
-                  <a:srgbClr val="FFFFFF"/>
-                </a:solidFill>
-              </a:rPr>
-              <a:t>If we want to control delegated work,</a:t>
-            </a:r>
-          </a:p>
-          <a:p>
-            <a:pPr algn="ctr"/>
-            <a:r>
-              <a:rPr sz="1600" b="1" i="0">
-                <a:solidFill>
-                  <a:srgbClr val="FFFFFF"/>
-                </a:solidFill>
-              </a:rPr>
-              <a:t>we need a model of how it can fail.</a:t>
-            </a:r>
-          </a:p>
-        </p:txBody>
-      </p:sp>
-    </p:spTree>
-  </p:cSld>
-  <p:clrMapOvr>
-    <a:masterClrMapping/>
-  </p:clrMapOvr>
-</p:sld>
-</file>
-
 <file path=ppt/slides/slide13.xml><?xml version="1.0" encoding="utf-8"?>
 <p:sld xmlns:a="http://schemas.openxmlformats.org/drawingml/2006/main" xmlns:p="http://schemas.openxmlformats.org/presentationml/2006/main" xmlns:r="http://schemas.openxmlformats.org/officeDocument/2006/relationships">
   <p:cSld>
@@ -10861,7 +9965,7 @@
                   <a:srgbClr val="FFFFFF"/>
                 </a:solidFill>
               </a:rPr>
-              <a:t>Evidence is evidence only relative to an obligation.</a:t>
+              <a:t>Evidence bears on an obligation.</a:t>
             </a:r>
           </a:p>
         </p:txBody>
@@ -12755,51 +11859,6 @@
       </p:sp>
       <p:sp>
         <p:nvSpPr>
-          <p:cNvPr id="7" name="TextBox 6"/>
-          <p:cNvSpPr txBox="1"/>
-          <p:nvPr/>
-        </p:nvSpPr>
-        <p:spPr>
-          <a:xfrm>
-            <a:off x="274320" y="4617720"/>
-            <a:ext cx="8595360" cy="731520"/>
-          </a:xfrm>
-          <a:prstGeom prst="rect">
-            <a:avLst/>
-          </a:prstGeom>
-          <a:noFill/>
-        </p:spPr>
-        <p:txBody>
-          <a:bodyPr wrap="square" anchor="t">
-            <a:spAutoFit/>
-          </a:bodyPr>
-          <a:lstStyle/>
-          <a:p>
-            <a:pPr algn="ctr"/>
-            <a:r>
-              <a:rPr sz="2000" b="0" i="1">
-                <a:solidFill>
-                  <a:srgbClr val="555960"/>
-                </a:solidFill>
-              </a:rPr>
-              <a:t>Not every invalid state can be excluded in advance. Some properties appear</a:t>
-            </a:r>
-          </a:p>
-          <a:p>
-            <a:pPr algn="ctr"/>
-            <a:r>
-              <a:rPr sz="2000" b="0" i="1">
-                <a:solidFill>
-                  <a:srgbClr val="555960"/>
-                </a:solidFill>
-              </a:rPr>
-              <a:t>only across a sequence of actions, in the assembled system, or at runtime.</a:t>
-            </a:r>
-          </a:p>
-        </p:txBody>
-      </p:sp>
-      <p:sp>
-        <p:nvSpPr>
           <p:cNvPr id="8" name="FooterBand"/>
           <p:cNvSpPr/>
           <p:nvPr/>
@@ -13656,40 +12715,6 @@
       </p:sp>
       <p:sp>
         <p:nvSpPr>
-          <p:cNvPr id="28" name="TextBox 27"/>
-          <p:cNvSpPr txBox="1"/>
-          <p:nvPr/>
-        </p:nvSpPr>
-        <p:spPr>
-          <a:xfrm>
-            <a:off x="274320" y="3840480"/>
-            <a:ext cx="8595360" cy="411480"/>
-          </a:xfrm>
-          <a:prstGeom prst="rect">
-            <a:avLst/>
-          </a:prstGeom>
-          <a:noFill/>
-        </p:spPr>
-        <p:txBody>
-          <a:bodyPr wrap="square" anchor="t">
-            <a:spAutoFit/>
-          </a:bodyPr>
-          <a:lstStyle/>
-          <a:p>
-            <a:pPr algn="ctr"/>
-            <a:r>
-              <a:rPr sz="2000" b="1" i="0">
-                <a:solidFill>
-                  <a:srgbClr val="5C4826"/>
-                </a:solidFill>
-              </a:rPr>
-              <a:t>Some actions are permitted only after their obligations are satisfied.</a:t>
-            </a:r>
-          </a:p>
-        </p:txBody>
-      </p:sp>
-      <p:sp>
-        <p:nvSpPr>
           <p:cNvPr id="29" name="FooterBand"/>
           <p:cNvSpPr/>
           <p:nvPr/>
@@ -14716,58 +13741,6 @@
                 </a:solidFill>
               </a:rPr>
               <a:t>Alignment asks what the verdict should control.</a:t>
-            </a:r>
-          </a:p>
-        </p:txBody>
-      </p:sp>
-      <p:sp>
-        <p:nvSpPr>
-          <p:cNvPr id="26" name="FooterBand"/>
-          <p:cNvSpPr/>
-          <p:nvPr/>
-        </p:nvSpPr>
-        <p:spPr>
-          <a:xfrm>
-            <a:off x="274320" y="5852160"/>
-            <a:ext cx="8595360" cy="566928"/>
-          </a:xfrm>
-          <a:prstGeom prst="rect">
-            <a:avLst/>
-          </a:prstGeom>
-          <a:solidFill>
-            <a:srgbClr val="8E6F3E"/>
-          </a:solidFill>
-          <a:ln>
-            <a:noFill/>
-          </a:ln>
-          <a:effectLst/>
-        </p:spPr>
-        <p:style>
-          <a:lnRef idx="1">
-            <a:schemeClr val="accent1"/>
-          </a:lnRef>
-          <a:fillRef idx="3">
-            <a:schemeClr val="accent1"/>
-          </a:fillRef>
-          <a:effectRef idx="2">
-            <a:schemeClr val="accent1"/>
-          </a:effectRef>
-          <a:fontRef idx="minor">
-            <a:schemeClr val="lt1"/>
-          </a:fontRef>
-        </p:style>
-        <p:txBody>
-          <a:bodyPr rtlCol="0" anchor="ctr" wrap="square"/>
-          <a:lstStyle/>
-          <a:p>
-            <a:pPr algn="ctr"/>
-            <a:r>
-              <a:rPr sz="2000" b="1" i="0">
-                <a:solidFill>
-                  <a:srgbClr val="FFFFFF"/>
-                </a:solidFill>
-              </a:rPr>
-              <a:t>The added step is consequence: the verdict can control what happens next.</a:t>
             </a:r>
           </a:p>
         </p:txBody>

</xml_diff>

<commit_message>
deck 2-3 prune D: models section — de-collapse validator/gate, redraw three relations
'Models can drive controls' now reads MODEL -> ANALYSES -> VERDICTS ->
optional GATE (the analyses produce verdicts; a gate may consume them)
and loses the 'model becomes operational' line. 'Agreement is not
correctness' is redrawn at lecture scale: three enormous rows
(CORRESPONDENCE / CONFORMANCE / ACCEPTANCE), almost no prose, keeping
only the gold footer. The models slide loses its closing aphorism.
</commit_message>
<xml_diff>
--- a/course/lectures/act-2-delegation-and-control/03-alignment/2-3-Alignment.pptx
+++ b/course/lectures/act-2-delegation-and-control/03-alignment/2-3-Alignment.pptx
@@ -15716,6 +15716,904 @@
 </p:sld>
 </file>
 
+<file path=ppt/slides/slide24.xml><?xml version="1.0" encoding="utf-8"?>
+<p:sld xmlns:a="http://schemas.openxmlformats.org/drawingml/2006/main" xmlns:p="http://schemas.openxmlformats.org/presentationml/2006/main" xmlns:r="http://schemas.openxmlformats.org/officeDocument/2006/relationships">
+  <p:cSld>
+    <p:spTree>
+      <p:nvGrpSpPr>
+        <p:cNvPr id="1" name=""/>
+        <p:cNvGrpSpPr/>
+        <p:nvPr/>
+      </p:nvGrpSpPr>
+      <p:grpSpPr/>
+      <p:sp>
+        <p:nvSpPr>
+          <p:cNvPr id="3" name="Title 2"/>
+          <p:cNvSpPr>
+            <a:spLocks noGrp="1"/>
+          </p:cNvSpPr>
+          <p:nvPr>
+            <p:ph type="title"/>
+          </p:nvPr>
+        </p:nvSpPr>
+        <p:spPr/>
+        <p:txBody>
+          <a:bodyPr wrap="square"/>
+          <a:lstStyle/>
+          <a:p>
+            <a:r>
+              <a:rPr sz="2400" b="0">
+                <a:solidFill>
+                  <a:srgbClr val="000000"/>
+                </a:solidFill>
+              </a:rPr>
+              <a:t>Right obligation, wrong boundary</a:t>
+            </a:r>
+          </a:p>
+        </p:txBody>
+      </p:sp>
+      <p:sp>
+        <p:nvSpPr>
+          <p:cNvPr id="4" name="Slide Number Placeholder 5"/>
+          <p:cNvSpPr>
+            <a:spLocks noGrp="1"/>
+          </p:cNvSpPr>
+          <p:nvPr>
+            <p:ph type="sldNum" sz="quarter" idx="4"/>
+          </p:nvPr>
+        </p:nvSpPr>
+        <p:spPr/>
+        <p:txBody>
+          <a:bodyPr/>
+          <a:lstStyle/>
+          <a:p>
+            <a:fld id="{B7EB45DA-9A0D-DC49-8E02-F30A5DDC21C3}" type="slidenum">
+              <a:rPr lang="en-US" smtClean="0"/>
+              <a:t>1</a:t>
+            </a:fld>
+            <a:endParaRPr lang="en-US"/>
+          </a:p>
+        </p:txBody>
+      </p:sp>
+      <p:sp>
+        <p:nvSpPr>
+          <p:cNvPr id="5" name="Rectangle 4"/>
+          <p:cNvSpPr/>
+          <p:nvPr/>
+        </p:nvSpPr>
+        <p:spPr>
+          <a:xfrm>
+            <a:off x="274320" y="1005840"/>
+            <a:ext cx="8595360" cy="640080"/>
+          </a:xfrm>
+          <a:prstGeom prst="rect">
+            <a:avLst/>
+          </a:prstGeom>
+          <a:solidFill>
+            <a:srgbClr val="FBF8F2"/>
+          </a:solidFill>
+          <a:ln w="12700">
+            <a:solidFill>
+              <a:srgbClr val="C9B991"/>
+            </a:solidFill>
+          </a:ln>
+          <a:effectLst/>
+        </p:spPr>
+        <p:style>
+          <a:lnRef idx="1">
+            <a:schemeClr val="accent1"/>
+          </a:lnRef>
+          <a:fillRef idx="3">
+            <a:schemeClr val="accent1"/>
+          </a:fillRef>
+          <a:effectRef idx="2">
+            <a:schemeClr val="accent1"/>
+          </a:effectRef>
+          <a:fontRef idx="minor">
+            <a:schemeClr val="lt1"/>
+          </a:fontRef>
+        </p:style>
+        <p:txBody>
+          <a:bodyPr rtlCol="0" anchor="ctr" wrap="square" lIns="137160" rIns="27432" tIns="73152" bIns="22860"/>
+          <a:lstStyle/>
+          <a:p>
+            <a:pPr algn="l"/>
+            <a:r>
+              <a:rPr sz="1800" b="1" i="0">
+                <a:solidFill>
+                  <a:srgbClr val="8E6F3E"/>
+                </a:solidFill>
+              </a:rPr>
+              <a:t>OBLIGATION — </a:t>
+            </a:r>
+            <a:r>
+              <a:rPr sz="1800" b="0" i="0">
+                <a:solidFill>
+                  <a:srgbClr val="5C4826"/>
+                </a:solidFill>
+              </a:rPr>
+              <a:t>the code and its architectural model must agree when the task completes.</a:t>
+            </a:r>
+          </a:p>
+        </p:txBody>
+      </p:sp>
+      <p:sp>
+        <p:nvSpPr>
+          <p:cNvPr id="6" name="Rectangle 5"/>
+          <p:cNvSpPr/>
+          <p:nvPr/>
+        </p:nvSpPr>
+        <p:spPr>
+          <a:xfrm>
+            <a:off x="292608" y="1920240"/>
+            <a:ext cx="1188720" cy="566928"/>
+          </a:xfrm>
+          <a:prstGeom prst="rect">
+            <a:avLst/>
+          </a:prstGeom>
+          <a:solidFill>
+            <a:srgbClr val="F5F1E8"/>
+          </a:solidFill>
+          <a:ln w="12700">
+            <a:solidFill>
+              <a:srgbClr val="C9B991"/>
+            </a:solidFill>
+          </a:ln>
+          <a:effectLst/>
+        </p:spPr>
+        <p:style>
+          <a:lnRef idx="1">
+            <a:schemeClr val="accent1"/>
+          </a:lnRef>
+          <a:fillRef idx="3">
+            <a:schemeClr val="accent1"/>
+          </a:fillRef>
+          <a:effectRef idx="2">
+            <a:schemeClr val="accent1"/>
+          </a:effectRef>
+          <a:fontRef idx="minor">
+            <a:schemeClr val="lt1"/>
+          </a:fontRef>
+        </p:style>
+        <p:txBody>
+          <a:bodyPr rtlCol="0" anchor="ctr" wrap="square" lIns="27432" rIns="27432" tIns="22860" bIns="22860"/>
+          <a:lstStyle/>
+          <a:p>
+            <a:pPr algn="ctr"/>
+            <a:r>
+              <a:rPr sz="1800" b="1" i="0">
+                <a:solidFill>
+                  <a:srgbClr val="5C4826"/>
+                </a:solidFill>
+              </a:rPr>
+              <a:t>EDIT</a:t>
+            </a:r>
+          </a:p>
+        </p:txBody>
+      </p:sp>
+      <p:cxnSp>
+        <p:nvCxnSpPr>
+          <p:cNvPr id="7" name="Connector 6"/>
+          <p:cNvCxnSpPr/>
+          <p:nvPr/>
+        </p:nvCxnSpPr>
+        <p:spPr>
+          <a:xfrm>
+            <a:off x="1490472" y="2203704"/>
+            <a:ext cx="237744" cy="0"/>
+          </a:xfrm>
+          <a:prstGeom prst="line">
+            <a:avLst/>
+          </a:prstGeom>
+          <a:ln w="28575">
+            <a:solidFill>
+              <a:srgbClr val="8E6F3E"/>
+            </a:solidFill>
+            <a:tailEnd type="triangle" w="med" len="med"/>
+          </a:ln>
+          <a:effectLst/>
+        </p:spPr>
+        <p:style>
+          <a:lnRef idx="2">
+            <a:schemeClr val="accent1"/>
+          </a:lnRef>
+          <a:fillRef idx="0">
+            <a:schemeClr val="accent1"/>
+          </a:fillRef>
+          <a:effectRef idx="1">
+            <a:schemeClr val="accent1"/>
+          </a:effectRef>
+          <a:fontRef idx="minor">
+            <a:schemeClr val="tx1"/>
+          </a:fontRef>
+        </p:style>
+      </p:cxnSp>
+      <p:sp>
+        <p:nvSpPr>
+          <p:cNvPr id="8" name="Rectangle 7"/>
+          <p:cNvSpPr/>
+          <p:nvPr/>
+        </p:nvSpPr>
+        <p:spPr>
+          <a:xfrm>
+            <a:off x="1737360" y="1920240"/>
+            <a:ext cx="1188720" cy="566928"/>
+          </a:xfrm>
+          <a:prstGeom prst="rect">
+            <a:avLst/>
+          </a:prstGeom>
+          <a:solidFill>
+            <a:srgbClr val="F5F1E8"/>
+          </a:solidFill>
+          <a:ln w="12700">
+            <a:solidFill>
+              <a:srgbClr val="C9B991"/>
+            </a:solidFill>
+          </a:ln>
+          <a:effectLst/>
+        </p:spPr>
+        <p:style>
+          <a:lnRef idx="1">
+            <a:schemeClr val="accent1"/>
+          </a:lnRef>
+          <a:fillRef idx="3">
+            <a:schemeClr val="accent1"/>
+          </a:fillRef>
+          <a:effectRef idx="2">
+            <a:schemeClr val="accent1"/>
+          </a:effectRef>
+          <a:fontRef idx="minor">
+            <a:schemeClr val="lt1"/>
+          </a:fontRef>
+        </p:style>
+        <p:txBody>
+          <a:bodyPr rtlCol="0" anchor="ctr" wrap="square" lIns="27432" rIns="27432" tIns="22860" bIns="22860"/>
+          <a:lstStyle/>
+          <a:p>
+            <a:pPr algn="ctr"/>
+            <a:r>
+              <a:rPr sz="1800" b="1" i="0">
+                <a:solidFill>
+                  <a:srgbClr val="5C4826"/>
+                </a:solidFill>
+              </a:rPr>
+              <a:t>COMMIT</a:t>
+            </a:r>
+          </a:p>
+        </p:txBody>
+      </p:sp>
+      <p:cxnSp>
+        <p:nvCxnSpPr>
+          <p:cNvPr id="9" name="Connector 8"/>
+          <p:cNvCxnSpPr/>
+          <p:nvPr/>
+        </p:nvCxnSpPr>
+        <p:spPr>
+          <a:xfrm>
+            <a:off x="2935224" y="2203704"/>
+            <a:ext cx="237744" cy="0"/>
+          </a:xfrm>
+          <a:prstGeom prst="line">
+            <a:avLst/>
+          </a:prstGeom>
+          <a:ln w="28575">
+            <a:solidFill>
+              <a:srgbClr val="8E6F3E"/>
+            </a:solidFill>
+            <a:tailEnd type="triangle" w="med" len="med"/>
+          </a:ln>
+          <a:effectLst/>
+        </p:spPr>
+        <p:style>
+          <a:lnRef idx="2">
+            <a:schemeClr val="accent1"/>
+          </a:lnRef>
+          <a:fillRef idx="0">
+            <a:schemeClr val="accent1"/>
+          </a:fillRef>
+          <a:effectRef idx="1">
+            <a:schemeClr val="accent1"/>
+          </a:effectRef>
+          <a:fontRef idx="minor">
+            <a:schemeClr val="tx1"/>
+          </a:fontRef>
+        </p:style>
+      </p:cxnSp>
+      <p:sp>
+        <p:nvSpPr>
+          <p:cNvPr id="10" name="Rectangle 9"/>
+          <p:cNvSpPr/>
+          <p:nvPr/>
+        </p:nvSpPr>
+        <p:spPr>
+          <a:xfrm>
+            <a:off x="3182112" y="1920240"/>
+            <a:ext cx="1188720" cy="566928"/>
+          </a:xfrm>
+          <a:prstGeom prst="rect">
+            <a:avLst/>
+          </a:prstGeom>
+          <a:solidFill>
+            <a:srgbClr val="F5F1E8"/>
+          </a:solidFill>
+          <a:ln w="12700">
+            <a:solidFill>
+              <a:srgbClr val="C9B991"/>
+            </a:solidFill>
+          </a:ln>
+          <a:effectLst/>
+        </p:spPr>
+        <p:style>
+          <a:lnRef idx="1">
+            <a:schemeClr val="accent1"/>
+          </a:lnRef>
+          <a:fillRef idx="3">
+            <a:schemeClr val="accent1"/>
+          </a:fillRef>
+          <a:effectRef idx="2">
+            <a:schemeClr val="accent1"/>
+          </a:effectRef>
+          <a:fontRef idx="minor">
+            <a:schemeClr val="lt1"/>
+          </a:fontRef>
+        </p:style>
+        <p:txBody>
+          <a:bodyPr rtlCol="0" anchor="ctr" wrap="square" lIns="27432" rIns="27432" tIns="22860" bIns="22860"/>
+          <a:lstStyle/>
+          <a:p>
+            <a:pPr algn="ctr"/>
+            <a:r>
+              <a:rPr sz="1800" b="1" i="0">
+                <a:solidFill>
+                  <a:srgbClr val="5C4826"/>
+                </a:solidFill>
+              </a:rPr>
+              <a:t>PUSH</a:t>
+            </a:r>
+          </a:p>
+        </p:txBody>
+      </p:sp>
+      <p:cxnSp>
+        <p:nvCxnSpPr>
+          <p:cNvPr id="11" name="Connector 10"/>
+          <p:cNvCxnSpPr/>
+          <p:nvPr/>
+        </p:nvCxnSpPr>
+        <p:spPr>
+          <a:xfrm>
+            <a:off x="4379976" y="2203704"/>
+            <a:ext cx="237744" cy="0"/>
+          </a:xfrm>
+          <a:prstGeom prst="line">
+            <a:avLst/>
+          </a:prstGeom>
+          <a:ln w="28575">
+            <a:solidFill>
+              <a:srgbClr val="8E6F3E"/>
+            </a:solidFill>
+            <a:tailEnd type="triangle" w="med" len="med"/>
+          </a:ln>
+          <a:effectLst/>
+        </p:spPr>
+        <p:style>
+          <a:lnRef idx="2">
+            <a:schemeClr val="accent1"/>
+          </a:lnRef>
+          <a:fillRef idx="0">
+            <a:schemeClr val="accent1"/>
+          </a:fillRef>
+          <a:effectRef idx="1">
+            <a:schemeClr val="accent1"/>
+          </a:effectRef>
+          <a:fontRef idx="minor">
+            <a:schemeClr val="tx1"/>
+          </a:fontRef>
+        </p:style>
+      </p:cxnSp>
+      <p:sp>
+        <p:nvSpPr>
+          <p:cNvPr id="12" name="Rectangle 11"/>
+          <p:cNvSpPr/>
+          <p:nvPr/>
+        </p:nvSpPr>
+        <p:spPr>
+          <a:xfrm>
+            <a:off x="4626864" y="1920240"/>
+            <a:ext cx="1188720" cy="566928"/>
+          </a:xfrm>
+          <a:prstGeom prst="rect">
+            <a:avLst/>
+          </a:prstGeom>
+          <a:solidFill>
+            <a:srgbClr val="F5F1E8"/>
+          </a:solidFill>
+          <a:ln w="12700">
+            <a:solidFill>
+              <a:srgbClr val="C9B991"/>
+            </a:solidFill>
+          </a:ln>
+          <a:effectLst/>
+        </p:spPr>
+        <p:style>
+          <a:lnRef idx="1">
+            <a:schemeClr val="accent1"/>
+          </a:lnRef>
+          <a:fillRef idx="3">
+            <a:schemeClr val="accent1"/>
+          </a:fillRef>
+          <a:effectRef idx="2">
+            <a:schemeClr val="accent1"/>
+          </a:effectRef>
+          <a:fontRef idx="minor">
+            <a:schemeClr val="lt1"/>
+          </a:fontRef>
+        </p:style>
+        <p:txBody>
+          <a:bodyPr rtlCol="0" anchor="ctr" wrap="square" lIns="27432" rIns="27432" tIns="22860" bIns="22860"/>
+          <a:lstStyle/>
+          <a:p>
+            <a:pPr algn="ctr"/>
+            <a:r>
+              <a:rPr sz="1800" b="1" i="0">
+                <a:solidFill>
+                  <a:srgbClr val="5C4826"/>
+                </a:solidFill>
+              </a:rPr>
+              <a:t>MERGE</a:t>
+            </a:r>
+          </a:p>
+        </p:txBody>
+      </p:sp>
+      <p:cxnSp>
+        <p:nvCxnSpPr>
+          <p:cNvPr id="13" name="Connector 12"/>
+          <p:cNvCxnSpPr/>
+          <p:nvPr/>
+        </p:nvCxnSpPr>
+        <p:spPr>
+          <a:xfrm>
+            <a:off x="5824728" y="2203704"/>
+            <a:ext cx="237744" cy="0"/>
+          </a:xfrm>
+          <a:prstGeom prst="line">
+            <a:avLst/>
+          </a:prstGeom>
+          <a:ln w="28575">
+            <a:solidFill>
+              <a:srgbClr val="8E6F3E"/>
+            </a:solidFill>
+            <a:tailEnd type="triangle" w="med" len="med"/>
+          </a:ln>
+          <a:effectLst/>
+        </p:spPr>
+        <p:style>
+          <a:lnRef idx="2">
+            <a:schemeClr val="accent1"/>
+          </a:lnRef>
+          <a:fillRef idx="0">
+            <a:schemeClr val="accent1"/>
+          </a:fillRef>
+          <a:effectRef idx="1">
+            <a:schemeClr val="accent1"/>
+          </a:effectRef>
+          <a:fontRef idx="minor">
+            <a:schemeClr val="tx1"/>
+          </a:fontRef>
+        </p:style>
+      </p:cxnSp>
+      <p:sp>
+        <p:nvSpPr>
+          <p:cNvPr id="14" name="Rectangle 13"/>
+          <p:cNvSpPr/>
+          <p:nvPr/>
+        </p:nvSpPr>
+        <p:spPr>
+          <a:xfrm>
+            <a:off x="6071616" y="1920240"/>
+            <a:ext cx="1188720" cy="566928"/>
+          </a:xfrm>
+          <a:prstGeom prst="rect">
+            <a:avLst/>
+          </a:prstGeom>
+          <a:solidFill>
+            <a:srgbClr val="F5F1E8"/>
+          </a:solidFill>
+          <a:ln w="12700">
+            <a:solidFill>
+              <a:srgbClr val="C9B991"/>
+            </a:solidFill>
+          </a:ln>
+          <a:effectLst/>
+        </p:spPr>
+        <p:style>
+          <a:lnRef idx="1">
+            <a:schemeClr val="accent1"/>
+          </a:lnRef>
+          <a:fillRef idx="3">
+            <a:schemeClr val="accent1"/>
+          </a:fillRef>
+          <a:effectRef idx="2">
+            <a:schemeClr val="accent1"/>
+          </a:effectRef>
+          <a:fontRef idx="minor">
+            <a:schemeClr val="lt1"/>
+          </a:fontRef>
+        </p:style>
+        <p:txBody>
+          <a:bodyPr rtlCol="0" anchor="ctr" wrap="square" lIns="27432" rIns="27432" tIns="22860" bIns="22860"/>
+          <a:lstStyle/>
+          <a:p>
+            <a:pPr algn="ctr"/>
+            <a:r>
+              <a:rPr sz="1800" b="1" i="0">
+                <a:solidFill>
+                  <a:srgbClr val="5C4826"/>
+                </a:solidFill>
+              </a:rPr>
+              <a:t>DEPLOY</a:t>
+            </a:r>
+          </a:p>
+        </p:txBody>
+      </p:sp>
+      <p:cxnSp>
+        <p:nvCxnSpPr>
+          <p:cNvPr id="15" name="Connector 14"/>
+          <p:cNvCxnSpPr/>
+          <p:nvPr/>
+        </p:nvCxnSpPr>
+        <p:spPr>
+          <a:xfrm>
+            <a:off x="7269480" y="2203704"/>
+            <a:ext cx="237744" cy="0"/>
+          </a:xfrm>
+          <a:prstGeom prst="line">
+            <a:avLst/>
+          </a:prstGeom>
+          <a:ln w="28575">
+            <a:solidFill>
+              <a:srgbClr val="8E6F3E"/>
+            </a:solidFill>
+            <a:tailEnd type="triangle" w="med" len="med"/>
+          </a:ln>
+          <a:effectLst/>
+        </p:spPr>
+        <p:style>
+          <a:lnRef idx="2">
+            <a:schemeClr val="accent1"/>
+          </a:lnRef>
+          <a:fillRef idx="0">
+            <a:schemeClr val="accent1"/>
+          </a:fillRef>
+          <a:effectRef idx="1">
+            <a:schemeClr val="accent1"/>
+          </a:effectRef>
+          <a:fontRef idx="minor">
+            <a:schemeClr val="tx1"/>
+          </a:fontRef>
+        </p:style>
+      </p:cxnSp>
+      <p:sp>
+        <p:nvSpPr>
+          <p:cNvPr id="16" name="Rectangle 15"/>
+          <p:cNvSpPr/>
+          <p:nvPr/>
+        </p:nvSpPr>
+        <p:spPr>
+          <a:xfrm>
+            <a:off x="7516368" y="1920240"/>
+            <a:ext cx="1188720" cy="566928"/>
+          </a:xfrm>
+          <a:prstGeom prst="rect">
+            <a:avLst/>
+          </a:prstGeom>
+          <a:solidFill>
+            <a:srgbClr val="F5F1E8"/>
+          </a:solidFill>
+          <a:ln w="12700">
+            <a:solidFill>
+              <a:srgbClr val="C9B991"/>
+            </a:solidFill>
+          </a:ln>
+          <a:effectLst/>
+        </p:spPr>
+        <p:style>
+          <a:lnRef idx="1">
+            <a:schemeClr val="accent1"/>
+          </a:lnRef>
+          <a:fillRef idx="3">
+            <a:schemeClr val="accent1"/>
+          </a:fillRef>
+          <a:effectRef idx="2">
+            <a:schemeClr val="accent1"/>
+          </a:effectRef>
+          <a:fontRef idx="minor">
+            <a:schemeClr val="lt1"/>
+          </a:fontRef>
+        </p:style>
+        <p:txBody>
+          <a:bodyPr rtlCol="0" anchor="ctr" wrap="square" lIns="27432" rIns="27432" tIns="22860" bIns="22860"/>
+          <a:lstStyle/>
+          <a:p>
+            <a:pPr algn="ctr"/>
+            <a:r>
+              <a:rPr sz="1800" b="1" i="0">
+                <a:solidFill>
+                  <a:srgbClr val="5C4826"/>
+                </a:solidFill>
+              </a:rPr>
+              <a:t>RUNTIME</a:t>
+            </a:r>
+          </a:p>
+        </p:txBody>
+      </p:sp>
+      <p:cxnSp>
+        <p:nvCxnSpPr>
+          <p:cNvPr id="17" name="Connector 16"/>
+          <p:cNvCxnSpPr/>
+          <p:nvPr/>
+        </p:nvCxnSpPr>
+        <p:spPr>
+          <a:xfrm flipV="1">
+            <a:off x="2331720" y="2606040"/>
+            <a:ext cx="0" cy="640080"/>
+          </a:xfrm>
+          <a:prstGeom prst="line">
+            <a:avLst/>
+          </a:prstGeom>
+          <a:ln w="28575">
+            <a:solidFill>
+              <a:srgbClr val="8E6F3E"/>
+            </a:solidFill>
+            <a:tailEnd type="triangle" w="med" len="med"/>
+          </a:ln>
+          <a:effectLst/>
+        </p:spPr>
+        <p:style>
+          <a:lnRef idx="2">
+            <a:schemeClr val="accent1"/>
+          </a:lnRef>
+          <a:fillRef idx="0">
+            <a:schemeClr val="accent1"/>
+          </a:fillRef>
+          <a:effectRef idx="1">
+            <a:schemeClr val="accent1"/>
+          </a:effectRef>
+          <a:fontRef idx="minor">
+            <a:schemeClr val="tx1"/>
+          </a:fontRef>
+        </p:style>
+      </p:cxnSp>
+      <p:sp>
+        <p:nvSpPr>
+          <p:cNvPr id="18" name="Rectangle 17"/>
+          <p:cNvSpPr/>
+          <p:nvPr/>
+        </p:nvSpPr>
+        <p:spPr>
+          <a:xfrm>
+            <a:off x="1051560" y="3291840"/>
+            <a:ext cx="2560320" cy="1051560"/>
+          </a:xfrm>
+          <a:prstGeom prst="rect">
+            <a:avLst/>
+          </a:prstGeom>
+          <a:solidFill>
+            <a:srgbClr val="FBF8F2"/>
+          </a:solidFill>
+          <a:ln w="12700">
+            <a:solidFill>
+              <a:srgbClr val="C9B991"/>
+            </a:solidFill>
+          </a:ln>
+          <a:effectLst/>
+        </p:spPr>
+        <p:style>
+          <a:lnRef idx="1">
+            <a:schemeClr val="accent1"/>
+          </a:lnRef>
+          <a:fillRef idx="3">
+            <a:schemeClr val="accent1"/>
+          </a:fillRef>
+          <a:effectRef idx="2">
+            <a:schemeClr val="accent1"/>
+          </a:effectRef>
+          <a:fontRef idx="minor">
+            <a:schemeClr val="lt1"/>
+          </a:fontRef>
+        </p:style>
+        <p:txBody>
+          <a:bodyPr rtlCol="0" anchor="ctr" wrap="square" lIns="27432" rIns="27432" tIns="22860" bIns="22860"/>
+          <a:lstStyle/>
+          <a:p>
+            <a:pPr algn="ctr"/>
+            <a:r>
+              <a:rPr sz="1800" b="1" i="0">
+                <a:solidFill>
+                  <a:srgbClr val="5C4826"/>
+                </a:solidFill>
+              </a:rPr>
+              <a:t>✗  enforced per-commit</a:t>
+            </a:r>
+          </a:p>
+          <a:p>
+            <a:pPr algn="ctr"/>
+            <a:r>
+              <a:rPr sz="1800" b="0" i="1">
+                <a:solidFill>
+                  <a:srgbClr val="555960"/>
+                </a:solidFill>
+              </a:rPr>
+              <a:t>rejects legitimate</a:t>
+            </a:r>
+          </a:p>
+          <a:p>
+            <a:pPr algn="ctr"/>
+            <a:r>
+              <a:rPr sz="1800" b="0" i="1">
+                <a:solidFill>
+                  <a:srgbClr val="555960"/>
+                </a:solidFill>
+              </a:rPr>
+              <a:t>intermediate states</a:t>
+            </a:r>
+          </a:p>
+        </p:txBody>
+      </p:sp>
+      <p:cxnSp>
+        <p:nvCxnSpPr>
+          <p:cNvPr id="19" name="Connector 18"/>
+          <p:cNvCxnSpPr/>
+          <p:nvPr/>
+        </p:nvCxnSpPr>
+        <p:spPr>
+          <a:xfrm flipV="1">
+            <a:off x="5221224" y="2606040"/>
+            <a:ext cx="0" cy="640080"/>
+          </a:xfrm>
+          <a:prstGeom prst="line">
+            <a:avLst/>
+          </a:prstGeom>
+          <a:ln w="28575">
+            <a:solidFill>
+              <a:srgbClr val="8E6F3E"/>
+            </a:solidFill>
+            <a:tailEnd type="triangle" w="med" len="med"/>
+          </a:ln>
+          <a:effectLst/>
+        </p:spPr>
+        <p:style>
+          <a:lnRef idx="2">
+            <a:schemeClr val="accent1"/>
+          </a:lnRef>
+          <a:fillRef idx="0">
+            <a:schemeClr val="accent1"/>
+          </a:fillRef>
+          <a:effectRef idx="1">
+            <a:schemeClr val="accent1"/>
+          </a:effectRef>
+          <a:fontRef idx="minor">
+            <a:schemeClr val="tx1"/>
+          </a:fontRef>
+        </p:style>
+      </p:cxnSp>
+      <p:sp>
+        <p:nvSpPr>
+          <p:cNvPr id="20" name="Rectangle 19"/>
+          <p:cNvSpPr/>
+          <p:nvPr/>
+        </p:nvSpPr>
+        <p:spPr>
+          <a:xfrm>
+            <a:off x="3941064" y="3291840"/>
+            <a:ext cx="2560320" cy="1051560"/>
+          </a:xfrm>
+          <a:prstGeom prst="rect">
+            <a:avLst/>
+          </a:prstGeom>
+          <a:solidFill>
+            <a:srgbClr val="F5F1E8"/>
+          </a:solidFill>
+          <a:ln w="12700">
+            <a:solidFill>
+              <a:srgbClr val="C9B991"/>
+            </a:solidFill>
+          </a:ln>
+          <a:effectLst/>
+        </p:spPr>
+        <p:style>
+          <a:lnRef idx="1">
+            <a:schemeClr val="accent1"/>
+          </a:lnRef>
+          <a:fillRef idx="3">
+            <a:schemeClr val="accent1"/>
+          </a:fillRef>
+          <a:effectRef idx="2">
+            <a:schemeClr val="accent1"/>
+          </a:effectRef>
+          <a:fontRef idx="minor">
+            <a:schemeClr val="lt1"/>
+          </a:fontRef>
+        </p:style>
+        <p:txBody>
+          <a:bodyPr rtlCol="0" anchor="ctr" wrap="square" lIns="27432" rIns="27432" tIns="22860" bIns="22860"/>
+          <a:lstStyle/>
+          <a:p>
+            <a:pPr algn="ctr"/>
+            <a:r>
+              <a:rPr sz="1800" b="1" i="0">
+                <a:solidFill>
+                  <a:srgbClr val="5C4826"/>
+                </a:solidFill>
+              </a:rPr>
+              <a:t>✓  decided at merge</a:t>
+            </a:r>
+          </a:p>
+          <a:p>
+            <a:pPr algn="ctr"/>
+            <a:r>
+              <a:rPr sz="1800" b="0" i="1">
+                <a:solidFill>
+                  <a:srgbClr val="555960"/>
+                </a:solidFill>
+              </a:rPr>
+              <a:t>when the task’s work</a:t>
+            </a:r>
+          </a:p>
+          <a:p>
+            <a:pPr algn="ctr"/>
+            <a:r>
+              <a:rPr sz="1800" b="0" i="1">
+                <a:solidFill>
+                  <a:srgbClr val="555960"/>
+                </a:solidFill>
+              </a:rPr>
+              <a:t>is assembled</a:t>
+            </a:r>
+          </a:p>
+        </p:txBody>
+      </p:sp>
+      <p:sp>
+        <p:nvSpPr>
+          <p:cNvPr id="21" name="TextBox 20"/>
+          <p:cNvSpPr txBox="1"/>
+          <p:nvPr/>
+        </p:nvSpPr>
+        <p:spPr>
+          <a:xfrm>
+            <a:off x="274320" y="4572000"/>
+            <a:ext cx="8595360" cy="502920"/>
+          </a:xfrm>
+          <a:prstGeom prst="rect">
+            <a:avLst/>
+          </a:prstGeom>
+          <a:noFill/>
+        </p:spPr>
+        <p:txBody>
+          <a:bodyPr wrap="square" anchor="t">
+            <a:spAutoFit/>
+          </a:bodyPr>
+          <a:lstStyle/>
+          <a:p>
+            <a:pPr algn="ctr"/>
+            <a:r>
+              <a:rPr sz="2000" b="0" i="1">
+                <a:solidFill>
+                  <a:srgbClr val="555960"/>
+                </a:solidFill>
+              </a:rPr>
+              <a:t>The obligation is right. The early boundary simply cannot decide it yet.</a:t>
+            </a:r>
+          </a:p>
+        </p:txBody>
+      </p:sp>
+    </p:spTree>
+  </p:cSld>
+  <p:clrMapOvr>
+    <a:masterClrMapping/>
+  </p:clrMapOvr>
+</p:sld>
+</file>
+
 <file path=ppt/slides/slide25.xml><?xml version="1.0" encoding="utf-8"?>
 <p:sld xmlns:a="http://schemas.openxmlformats.org/drawingml/2006/main" xmlns:p="http://schemas.openxmlformats.org/presentationml/2006/main" xmlns:r="http://schemas.openxmlformats.org/officeDocument/2006/relationships">
   <p:cSld>
@@ -15728,7 +16626,7 @@
       <p:grpSpPr/>
       <p:sp>
         <p:nvSpPr>
-          <p:cNvPr id="3" name="Title 2"/>
+          <p:cNvPr id="2" name="Title 1"/>
           <p:cNvSpPr>
             <a:spLocks noGrp="1"/>
           </p:cNvSpPr>
@@ -15736,25 +16634,31 @@
             <p:ph type="title"/>
           </p:nvPr>
         </p:nvSpPr>
-        <p:spPr/>
+        <p:spPr>
+          <a:xfrm>
+            <a:off x="685800" y="2139696"/>
+            <a:ext cx="7772400" cy="1444752"/>
+          </a:xfrm>
+        </p:spPr>
         <p:txBody>
           <a:bodyPr wrap="square"/>
           <a:lstStyle/>
           <a:p>
-            <a:r>
-              <a:rPr sz="2400" b="0">
+            <a:pPr algn="ctr"/>
+            <a:r>
+              <a:rPr sz="3400">
                 <a:solidFill>
                   <a:srgbClr val="000000"/>
                 </a:solidFill>
               </a:rPr>
-              <a:t>Right obligation, wrong boundary</a:t>
-            </a:r>
-          </a:p>
-        </p:txBody>
-      </p:sp>
-      <p:sp>
-        <p:nvSpPr>
-          <p:cNvPr id="4" name="Slide Number Placeholder 5"/>
+              <a:t>Stretch break</a:t>
+            </a:r>
+          </a:p>
+        </p:txBody>
+      </p:sp>
+      <p:sp>
+        <p:nvSpPr>
+          <p:cNvPr id="3" name="Slide Number Placeholder 5"/>
           <p:cNvSpPr>
             <a:spLocks noGrp="1"/>
           </p:cNvSpPr>
@@ -15777,25 +16681,23 @@
       </p:sp>
       <p:sp>
         <p:nvSpPr>
-          <p:cNvPr id="5" name="Rectangle 4"/>
+          <p:cNvPr id="4" name="Rectangle 3"/>
           <p:cNvSpPr/>
           <p:nvPr/>
         </p:nvSpPr>
         <p:spPr>
           <a:xfrm>
-            <a:off x="274320" y="1005840"/>
-            <a:ext cx="8595360" cy="640080"/>
+            <a:off x="3429000" y="3383280"/>
+            <a:ext cx="2286000" cy="54864"/>
           </a:xfrm>
           <a:prstGeom prst="rect">
             <a:avLst/>
           </a:prstGeom>
           <a:solidFill>
-            <a:srgbClr val="FBF8F2"/>
+            <a:srgbClr val="8E6F3E"/>
           </a:solidFill>
-          <a:ln w="12700">
-            <a:solidFill>
-              <a:srgbClr val="C9B991"/>
-            </a:solidFill>
+          <a:ln>
+            <a:noFill/>
           </a:ln>
           <a:effectLst/>
         </p:spPr>
@@ -15814,795 +16716,10 @@
           </a:fontRef>
         </p:style>
         <p:txBody>
-          <a:bodyPr rtlCol="0" anchor="ctr" wrap="square" lIns="137160" rIns="27432" tIns="73152" bIns="22860"/>
-          <a:lstStyle/>
-          <a:p>
-            <a:pPr algn="l"/>
-            <a:r>
-              <a:rPr sz="1800" b="1" i="0">
-                <a:solidFill>
-                  <a:srgbClr val="8E6F3E"/>
-                </a:solidFill>
-              </a:rPr>
-              <a:t>OBLIGATION — </a:t>
-            </a:r>
-            <a:r>
-              <a:rPr sz="1800" b="0" i="0">
-                <a:solidFill>
-                  <a:srgbClr val="5C4826"/>
-                </a:solidFill>
-              </a:rPr>
-              <a:t>the code and its architectural model must agree when the task completes.</a:t>
-            </a:r>
-          </a:p>
-        </p:txBody>
-      </p:sp>
-      <p:sp>
-        <p:nvSpPr>
-          <p:cNvPr id="6" name="Rectangle 5"/>
-          <p:cNvSpPr/>
-          <p:nvPr/>
-        </p:nvSpPr>
-        <p:spPr>
-          <a:xfrm>
-            <a:off x="292608" y="1920240"/>
-            <a:ext cx="1188720" cy="566928"/>
-          </a:xfrm>
-          <a:prstGeom prst="rect">
-            <a:avLst/>
-          </a:prstGeom>
-          <a:solidFill>
-            <a:srgbClr val="F5F1E8"/>
-          </a:solidFill>
-          <a:ln w="12700">
-            <a:solidFill>
-              <a:srgbClr val="C9B991"/>
-            </a:solidFill>
-          </a:ln>
-          <a:effectLst/>
-        </p:spPr>
-        <p:style>
-          <a:lnRef idx="1">
-            <a:schemeClr val="accent1"/>
-          </a:lnRef>
-          <a:fillRef idx="3">
-            <a:schemeClr val="accent1"/>
-          </a:fillRef>
-          <a:effectRef idx="2">
-            <a:schemeClr val="accent1"/>
-          </a:effectRef>
-          <a:fontRef idx="minor">
-            <a:schemeClr val="lt1"/>
-          </a:fontRef>
-        </p:style>
-        <p:txBody>
-          <a:bodyPr rtlCol="0" anchor="ctr" wrap="square" lIns="27432" rIns="27432" tIns="22860" bIns="22860"/>
+          <a:bodyPr rtlCol="0" anchor="ctr"/>
           <a:lstStyle/>
           <a:p>
             <a:pPr algn="ctr"/>
-            <a:r>
-              <a:rPr sz="1800" b="1" i="0">
-                <a:solidFill>
-                  <a:srgbClr val="5C4826"/>
-                </a:solidFill>
-              </a:rPr>
-              <a:t>EDIT</a:t>
-            </a:r>
-          </a:p>
-        </p:txBody>
-      </p:sp>
-      <p:cxnSp>
-        <p:nvCxnSpPr>
-          <p:cNvPr id="7" name="Connector 6"/>
-          <p:cNvCxnSpPr/>
-          <p:nvPr/>
-        </p:nvCxnSpPr>
-        <p:spPr>
-          <a:xfrm>
-            <a:off x="1490472" y="2203704"/>
-            <a:ext cx="237744" cy="0"/>
-          </a:xfrm>
-          <a:prstGeom prst="line">
-            <a:avLst/>
-          </a:prstGeom>
-          <a:ln w="28575">
-            <a:solidFill>
-              <a:srgbClr val="8E6F3E"/>
-            </a:solidFill>
-            <a:tailEnd type="triangle" w="med" len="med"/>
-          </a:ln>
-          <a:effectLst/>
-        </p:spPr>
-        <p:style>
-          <a:lnRef idx="2">
-            <a:schemeClr val="accent1"/>
-          </a:lnRef>
-          <a:fillRef idx="0">
-            <a:schemeClr val="accent1"/>
-          </a:fillRef>
-          <a:effectRef idx="1">
-            <a:schemeClr val="accent1"/>
-          </a:effectRef>
-          <a:fontRef idx="minor">
-            <a:schemeClr val="tx1"/>
-          </a:fontRef>
-        </p:style>
-      </p:cxnSp>
-      <p:sp>
-        <p:nvSpPr>
-          <p:cNvPr id="8" name="Rectangle 7"/>
-          <p:cNvSpPr/>
-          <p:nvPr/>
-        </p:nvSpPr>
-        <p:spPr>
-          <a:xfrm>
-            <a:off x="1737360" y="1920240"/>
-            <a:ext cx="1188720" cy="566928"/>
-          </a:xfrm>
-          <a:prstGeom prst="rect">
-            <a:avLst/>
-          </a:prstGeom>
-          <a:solidFill>
-            <a:srgbClr val="F5F1E8"/>
-          </a:solidFill>
-          <a:ln w="12700">
-            <a:solidFill>
-              <a:srgbClr val="C9B991"/>
-            </a:solidFill>
-          </a:ln>
-          <a:effectLst/>
-        </p:spPr>
-        <p:style>
-          <a:lnRef idx="1">
-            <a:schemeClr val="accent1"/>
-          </a:lnRef>
-          <a:fillRef idx="3">
-            <a:schemeClr val="accent1"/>
-          </a:fillRef>
-          <a:effectRef idx="2">
-            <a:schemeClr val="accent1"/>
-          </a:effectRef>
-          <a:fontRef idx="minor">
-            <a:schemeClr val="lt1"/>
-          </a:fontRef>
-        </p:style>
-        <p:txBody>
-          <a:bodyPr rtlCol="0" anchor="ctr" wrap="square" lIns="27432" rIns="27432" tIns="22860" bIns="22860"/>
-          <a:lstStyle/>
-          <a:p>
-            <a:pPr algn="ctr"/>
-            <a:r>
-              <a:rPr sz="1800" b="1" i="0">
-                <a:solidFill>
-                  <a:srgbClr val="5C4826"/>
-                </a:solidFill>
-              </a:rPr>
-              <a:t>COMMIT</a:t>
-            </a:r>
-          </a:p>
-        </p:txBody>
-      </p:sp>
-      <p:cxnSp>
-        <p:nvCxnSpPr>
-          <p:cNvPr id="9" name="Connector 8"/>
-          <p:cNvCxnSpPr/>
-          <p:nvPr/>
-        </p:nvCxnSpPr>
-        <p:spPr>
-          <a:xfrm>
-            <a:off x="2935224" y="2203704"/>
-            <a:ext cx="237744" cy="0"/>
-          </a:xfrm>
-          <a:prstGeom prst="line">
-            <a:avLst/>
-          </a:prstGeom>
-          <a:ln w="28575">
-            <a:solidFill>
-              <a:srgbClr val="8E6F3E"/>
-            </a:solidFill>
-            <a:tailEnd type="triangle" w="med" len="med"/>
-          </a:ln>
-          <a:effectLst/>
-        </p:spPr>
-        <p:style>
-          <a:lnRef idx="2">
-            <a:schemeClr val="accent1"/>
-          </a:lnRef>
-          <a:fillRef idx="0">
-            <a:schemeClr val="accent1"/>
-          </a:fillRef>
-          <a:effectRef idx="1">
-            <a:schemeClr val="accent1"/>
-          </a:effectRef>
-          <a:fontRef idx="minor">
-            <a:schemeClr val="tx1"/>
-          </a:fontRef>
-        </p:style>
-      </p:cxnSp>
-      <p:sp>
-        <p:nvSpPr>
-          <p:cNvPr id="10" name="Rectangle 9"/>
-          <p:cNvSpPr/>
-          <p:nvPr/>
-        </p:nvSpPr>
-        <p:spPr>
-          <a:xfrm>
-            <a:off x="3182112" y="1920240"/>
-            <a:ext cx="1188720" cy="566928"/>
-          </a:xfrm>
-          <a:prstGeom prst="rect">
-            <a:avLst/>
-          </a:prstGeom>
-          <a:solidFill>
-            <a:srgbClr val="F5F1E8"/>
-          </a:solidFill>
-          <a:ln w="12700">
-            <a:solidFill>
-              <a:srgbClr val="C9B991"/>
-            </a:solidFill>
-          </a:ln>
-          <a:effectLst/>
-        </p:spPr>
-        <p:style>
-          <a:lnRef idx="1">
-            <a:schemeClr val="accent1"/>
-          </a:lnRef>
-          <a:fillRef idx="3">
-            <a:schemeClr val="accent1"/>
-          </a:fillRef>
-          <a:effectRef idx="2">
-            <a:schemeClr val="accent1"/>
-          </a:effectRef>
-          <a:fontRef idx="minor">
-            <a:schemeClr val="lt1"/>
-          </a:fontRef>
-        </p:style>
-        <p:txBody>
-          <a:bodyPr rtlCol="0" anchor="ctr" wrap="square" lIns="27432" rIns="27432" tIns="22860" bIns="22860"/>
-          <a:lstStyle/>
-          <a:p>
-            <a:pPr algn="ctr"/>
-            <a:r>
-              <a:rPr sz="1800" b="1" i="0">
-                <a:solidFill>
-                  <a:srgbClr val="5C4826"/>
-                </a:solidFill>
-              </a:rPr>
-              <a:t>PUSH</a:t>
-            </a:r>
-          </a:p>
-        </p:txBody>
-      </p:sp>
-      <p:cxnSp>
-        <p:nvCxnSpPr>
-          <p:cNvPr id="11" name="Connector 10"/>
-          <p:cNvCxnSpPr/>
-          <p:nvPr/>
-        </p:nvCxnSpPr>
-        <p:spPr>
-          <a:xfrm>
-            <a:off x="4379976" y="2203704"/>
-            <a:ext cx="237744" cy="0"/>
-          </a:xfrm>
-          <a:prstGeom prst="line">
-            <a:avLst/>
-          </a:prstGeom>
-          <a:ln w="28575">
-            <a:solidFill>
-              <a:srgbClr val="8E6F3E"/>
-            </a:solidFill>
-            <a:tailEnd type="triangle" w="med" len="med"/>
-          </a:ln>
-          <a:effectLst/>
-        </p:spPr>
-        <p:style>
-          <a:lnRef idx="2">
-            <a:schemeClr val="accent1"/>
-          </a:lnRef>
-          <a:fillRef idx="0">
-            <a:schemeClr val="accent1"/>
-          </a:fillRef>
-          <a:effectRef idx="1">
-            <a:schemeClr val="accent1"/>
-          </a:effectRef>
-          <a:fontRef idx="minor">
-            <a:schemeClr val="tx1"/>
-          </a:fontRef>
-        </p:style>
-      </p:cxnSp>
-      <p:sp>
-        <p:nvSpPr>
-          <p:cNvPr id="12" name="Rectangle 11"/>
-          <p:cNvSpPr/>
-          <p:nvPr/>
-        </p:nvSpPr>
-        <p:spPr>
-          <a:xfrm>
-            <a:off x="4626864" y="1920240"/>
-            <a:ext cx="1188720" cy="566928"/>
-          </a:xfrm>
-          <a:prstGeom prst="rect">
-            <a:avLst/>
-          </a:prstGeom>
-          <a:solidFill>
-            <a:srgbClr val="F5F1E8"/>
-          </a:solidFill>
-          <a:ln w="12700">
-            <a:solidFill>
-              <a:srgbClr val="C9B991"/>
-            </a:solidFill>
-          </a:ln>
-          <a:effectLst/>
-        </p:spPr>
-        <p:style>
-          <a:lnRef idx="1">
-            <a:schemeClr val="accent1"/>
-          </a:lnRef>
-          <a:fillRef idx="3">
-            <a:schemeClr val="accent1"/>
-          </a:fillRef>
-          <a:effectRef idx="2">
-            <a:schemeClr val="accent1"/>
-          </a:effectRef>
-          <a:fontRef idx="minor">
-            <a:schemeClr val="lt1"/>
-          </a:fontRef>
-        </p:style>
-        <p:txBody>
-          <a:bodyPr rtlCol="0" anchor="ctr" wrap="square" lIns="27432" rIns="27432" tIns="22860" bIns="22860"/>
-          <a:lstStyle/>
-          <a:p>
-            <a:pPr algn="ctr"/>
-            <a:r>
-              <a:rPr sz="1800" b="1" i="0">
-                <a:solidFill>
-                  <a:srgbClr val="5C4826"/>
-                </a:solidFill>
-              </a:rPr>
-              <a:t>MERGE</a:t>
-            </a:r>
-          </a:p>
-        </p:txBody>
-      </p:sp>
-      <p:cxnSp>
-        <p:nvCxnSpPr>
-          <p:cNvPr id="13" name="Connector 12"/>
-          <p:cNvCxnSpPr/>
-          <p:nvPr/>
-        </p:nvCxnSpPr>
-        <p:spPr>
-          <a:xfrm>
-            <a:off x="5824728" y="2203704"/>
-            <a:ext cx="237744" cy="0"/>
-          </a:xfrm>
-          <a:prstGeom prst="line">
-            <a:avLst/>
-          </a:prstGeom>
-          <a:ln w="28575">
-            <a:solidFill>
-              <a:srgbClr val="8E6F3E"/>
-            </a:solidFill>
-            <a:tailEnd type="triangle" w="med" len="med"/>
-          </a:ln>
-          <a:effectLst/>
-        </p:spPr>
-        <p:style>
-          <a:lnRef idx="2">
-            <a:schemeClr val="accent1"/>
-          </a:lnRef>
-          <a:fillRef idx="0">
-            <a:schemeClr val="accent1"/>
-          </a:fillRef>
-          <a:effectRef idx="1">
-            <a:schemeClr val="accent1"/>
-          </a:effectRef>
-          <a:fontRef idx="minor">
-            <a:schemeClr val="tx1"/>
-          </a:fontRef>
-        </p:style>
-      </p:cxnSp>
-      <p:sp>
-        <p:nvSpPr>
-          <p:cNvPr id="14" name="Rectangle 13"/>
-          <p:cNvSpPr/>
-          <p:nvPr/>
-        </p:nvSpPr>
-        <p:spPr>
-          <a:xfrm>
-            <a:off x="6071616" y="1920240"/>
-            <a:ext cx="1188720" cy="566928"/>
-          </a:xfrm>
-          <a:prstGeom prst="rect">
-            <a:avLst/>
-          </a:prstGeom>
-          <a:solidFill>
-            <a:srgbClr val="F5F1E8"/>
-          </a:solidFill>
-          <a:ln w="12700">
-            <a:solidFill>
-              <a:srgbClr val="C9B991"/>
-            </a:solidFill>
-          </a:ln>
-          <a:effectLst/>
-        </p:spPr>
-        <p:style>
-          <a:lnRef idx="1">
-            <a:schemeClr val="accent1"/>
-          </a:lnRef>
-          <a:fillRef idx="3">
-            <a:schemeClr val="accent1"/>
-          </a:fillRef>
-          <a:effectRef idx="2">
-            <a:schemeClr val="accent1"/>
-          </a:effectRef>
-          <a:fontRef idx="minor">
-            <a:schemeClr val="lt1"/>
-          </a:fontRef>
-        </p:style>
-        <p:txBody>
-          <a:bodyPr rtlCol="0" anchor="ctr" wrap="square" lIns="27432" rIns="27432" tIns="22860" bIns="22860"/>
-          <a:lstStyle/>
-          <a:p>
-            <a:pPr algn="ctr"/>
-            <a:r>
-              <a:rPr sz="1800" b="1" i="0">
-                <a:solidFill>
-                  <a:srgbClr val="5C4826"/>
-                </a:solidFill>
-              </a:rPr>
-              <a:t>DEPLOY</a:t>
-            </a:r>
-          </a:p>
-        </p:txBody>
-      </p:sp>
-      <p:cxnSp>
-        <p:nvCxnSpPr>
-          <p:cNvPr id="15" name="Connector 14"/>
-          <p:cNvCxnSpPr/>
-          <p:nvPr/>
-        </p:nvCxnSpPr>
-        <p:spPr>
-          <a:xfrm>
-            <a:off x="7269480" y="2203704"/>
-            <a:ext cx="237744" cy="0"/>
-          </a:xfrm>
-          <a:prstGeom prst="line">
-            <a:avLst/>
-          </a:prstGeom>
-          <a:ln w="28575">
-            <a:solidFill>
-              <a:srgbClr val="8E6F3E"/>
-            </a:solidFill>
-            <a:tailEnd type="triangle" w="med" len="med"/>
-          </a:ln>
-          <a:effectLst/>
-        </p:spPr>
-        <p:style>
-          <a:lnRef idx="2">
-            <a:schemeClr val="accent1"/>
-          </a:lnRef>
-          <a:fillRef idx="0">
-            <a:schemeClr val="accent1"/>
-          </a:fillRef>
-          <a:effectRef idx="1">
-            <a:schemeClr val="accent1"/>
-          </a:effectRef>
-          <a:fontRef idx="minor">
-            <a:schemeClr val="tx1"/>
-          </a:fontRef>
-        </p:style>
-      </p:cxnSp>
-      <p:sp>
-        <p:nvSpPr>
-          <p:cNvPr id="16" name="Rectangle 15"/>
-          <p:cNvSpPr/>
-          <p:nvPr/>
-        </p:nvSpPr>
-        <p:spPr>
-          <a:xfrm>
-            <a:off x="7516368" y="1920240"/>
-            <a:ext cx="1188720" cy="566928"/>
-          </a:xfrm>
-          <a:prstGeom prst="rect">
-            <a:avLst/>
-          </a:prstGeom>
-          <a:solidFill>
-            <a:srgbClr val="F5F1E8"/>
-          </a:solidFill>
-          <a:ln w="12700">
-            <a:solidFill>
-              <a:srgbClr val="C9B991"/>
-            </a:solidFill>
-          </a:ln>
-          <a:effectLst/>
-        </p:spPr>
-        <p:style>
-          <a:lnRef idx="1">
-            <a:schemeClr val="accent1"/>
-          </a:lnRef>
-          <a:fillRef idx="3">
-            <a:schemeClr val="accent1"/>
-          </a:fillRef>
-          <a:effectRef idx="2">
-            <a:schemeClr val="accent1"/>
-          </a:effectRef>
-          <a:fontRef idx="minor">
-            <a:schemeClr val="lt1"/>
-          </a:fontRef>
-        </p:style>
-        <p:txBody>
-          <a:bodyPr rtlCol="0" anchor="ctr" wrap="square" lIns="27432" rIns="27432" tIns="22860" bIns="22860"/>
-          <a:lstStyle/>
-          <a:p>
-            <a:pPr algn="ctr"/>
-            <a:r>
-              <a:rPr sz="1800" b="1" i="0">
-                <a:solidFill>
-                  <a:srgbClr val="5C4826"/>
-                </a:solidFill>
-              </a:rPr>
-              <a:t>RUNTIME</a:t>
-            </a:r>
-          </a:p>
-        </p:txBody>
-      </p:sp>
-      <p:cxnSp>
-        <p:nvCxnSpPr>
-          <p:cNvPr id="17" name="Connector 16"/>
-          <p:cNvCxnSpPr/>
-          <p:nvPr/>
-        </p:nvCxnSpPr>
-        <p:spPr>
-          <a:xfrm flipV="1">
-            <a:off x="2331720" y="2606040"/>
-            <a:ext cx="0" cy="640080"/>
-          </a:xfrm>
-          <a:prstGeom prst="line">
-            <a:avLst/>
-          </a:prstGeom>
-          <a:ln w="28575">
-            <a:solidFill>
-              <a:srgbClr val="8E6F3E"/>
-            </a:solidFill>
-            <a:tailEnd type="triangle" w="med" len="med"/>
-          </a:ln>
-          <a:effectLst/>
-        </p:spPr>
-        <p:style>
-          <a:lnRef idx="2">
-            <a:schemeClr val="accent1"/>
-          </a:lnRef>
-          <a:fillRef idx="0">
-            <a:schemeClr val="accent1"/>
-          </a:fillRef>
-          <a:effectRef idx="1">
-            <a:schemeClr val="accent1"/>
-          </a:effectRef>
-          <a:fontRef idx="minor">
-            <a:schemeClr val="tx1"/>
-          </a:fontRef>
-        </p:style>
-      </p:cxnSp>
-      <p:sp>
-        <p:nvSpPr>
-          <p:cNvPr id="18" name="Rectangle 17"/>
-          <p:cNvSpPr/>
-          <p:nvPr/>
-        </p:nvSpPr>
-        <p:spPr>
-          <a:xfrm>
-            <a:off x="1051560" y="3291840"/>
-            <a:ext cx="2560320" cy="1051560"/>
-          </a:xfrm>
-          <a:prstGeom prst="rect">
-            <a:avLst/>
-          </a:prstGeom>
-          <a:solidFill>
-            <a:srgbClr val="FBF8F2"/>
-          </a:solidFill>
-          <a:ln w="12700">
-            <a:solidFill>
-              <a:srgbClr val="C9B991"/>
-            </a:solidFill>
-          </a:ln>
-          <a:effectLst/>
-        </p:spPr>
-        <p:style>
-          <a:lnRef idx="1">
-            <a:schemeClr val="accent1"/>
-          </a:lnRef>
-          <a:fillRef idx="3">
-            <a:schemeClr val="accent1"/>
-          </a:fillRef>
-          <a:effectRef idx="2">
-            <a:schemeClr val="accent1"/>
-          </a:effectRef>
-          <a:fontRef idx="minor">
-            <a:schemeClr val="lt1"/>
-          </a:fontRef>
-        </p:style>
-        <p:txBody>
-          <a:bodyPr rtlCol="0" anchor="ctr" wrap="square" lIns="27432" rIns="27432" tIns="22860" bIns="22860"/>
-          <a:lstStyle/>
-          <a:p>
-            <a:pPr algn="ctr"/>
-            <a:r>
-              <a:rPr sz="1800" b="1" i="0">
-                <a:solidFill>
-                  <a:srgbClr val="5C4826"/>
-                </a:solidFill>
-              </a:rPr>
-              <a:t>✗  enforced per-commit</a:t>
-            </a:r>
-          </a:p>
-          <a:p>
-            <a:pPr algn="ctr"/>
-            <a:r>
-              <a:rPr sz="1800" b="0" i="1">
-                <a:solidFill>
-                  <a:srgbClr val="555960"/>
-                </a:solidFill>
-              </a:rPr>
-              <a:t>rejects legitimate</a:t>
-            </a:r>
-          </a:p>
-          <a:p>
-            <a:pPr algn="ctr"/>
-            <a:r>
-              <a:rPr sz="1800" b="0" i="1">
-                <a:solidFill>
-                  <a:srgbClr val="555960"/>
-                </a:solidFill>
-              </a:rPr>
-              <a:t>intermediate states</a:t>
-            </a:r>
-          </a:p>
-        </p:txBody>
-      </p:sp>
-      <p:cxnSp>
-        <p:nvCxnSpPr>
-          <p:cNvPr id="19" name="Connector 18"/>
-          <p:cNvCxnSpPr/>
-          <p:nvPr/>
-        </p:nvCxnSpPr>
-        <p:spPr>
-          <a:xfrm flipV="1">
-            <a:off x="5221224" y="2606040"/>
-            <a:ext cx="0" cy="640080"/>
-          </a:xfrm>
-          <a:prstGeom prst="line">
-            <a:avLst/>
-          </a:prstGeom>
-          <a:ln w="28575">
-            <a:solidFill>
-              <a:srgbClr val="8E6F3E"/>
-            </a:solidFill>
-            <a:tailEnd type="triangle" w="med" len="med"/>
-          </a:ln>
-          <a:effectLst/>
-        </p:spPr>
-        <p:style>
-          <a:lnRef idx="2">
-            <a:schemeClr val="accent1"/>
-          </a:lnRef>
-          <a:fillRef idx="0">
-            <a:schemeClr val="accent1"/>
-          </a:fillRef>
-          <a:effectRef idx="1">
-            <a:schemeClr val="accent1"/>
-          </a:effectRef>
-          <a:fontRef idx="minor">
-            <a:schemeClr val="tx1"/>
-          </a:fontRef>
-        </p:style>
-      </p:cxnSp>
-      <p:sp>
-        <p:nvSpPr>
-          <p:cNvPr id="20" name="Rectangle 19"/>
-          <p:cNvSpPr/>
-          <p:nvPr/>
-        </p:nvSpPr>
-        <p:spPr>
-          <a:xfrm>
-            <a:off x="3941064" y="3291840"/>
-            <a:ext cx="2560320" cy="1051560"/>
-          </a:xfrm>
-          <a:prstGeom prst="rect">
-            <a:avLst/>
-          </a:prstGeom>
-          <a:solidFill>
-            <a:srgbClr val="F5F1E8"/>
-          </a:solidFill>
-          <a:ln w="12700">
-            <a:solidFill>
-              <a:srgbClr val="C9B991"/>
-            </a:solidFill>
-          </a:ln>
-          <a:effectLst/>
-        </p:spPr>
-        <p:style>
-          <a:lnRef idx="1">
-            <a:schemeClr val="accent1"/>
-          </a:lnRef>
-          <a:fillRef idx="3">
-            <a:schemeClr val="accent1"/>
-          </a:fillRef>
-          <a:effectRef idx="2">
-            <a:schemeClr val="accent1"/>
-          </a:effectRef>
-          <a:fontRef idx="minor">
-            <a:schemeClr val="lt1"/>
-          </a:fontRef>
-        </p:style>
-        <p:txBody>
-          <a:bodyPr rtlCol="0" anchor="ctr" wrap="square" lIns="27432" rIns="27432" tIns="22860" bIns="22860"/>
-          <a:lstStyle/>
-          <a:p>
-            <a:pPr algn="ctr"/>
-            <a:r>
-              <a:rPr sz="1800" b="1" i="0">
-                <a:solidFill>
-                  <a:srgbClr val="5C4826"/>
-                </a:solidFill>
-              </a:rPr>
-              <a:t>✓  decided at merge</a:t>
-            </a:r>
-          </a:p>
-          <a:p>
-            <a:pPr algn="ctr"/>
-            <a:r>
-              <a:rPr sz="1800" b="0" i="1">
-                <a:solidFill>
-                  <a:srgbClr val="555960"/>
-                </a:solidFill>
-              </a:rPr>
-              <a:t>when the task’s work</a:t>
-            </a:r>
-          </a:p>
-          <a:p>
-            <a:pPr algn="ctr"/>
-            <a:r>
-              <a:rPr sz="1800" b="0" i="1">
-                <a:solidFill>
-                  <a:srgbClr val="555960"/>
-                </a:solidFill>
-              </a:rPr>
-              <a:t>is assembled</a:t>
-            </a:r>
-          </a:p>
-        </p:txBody>
-      </p:sp>
-      <p:sp>
-        <p:nvSpPr>
-          <p:cNvPr id="21" name="TextBox 20"/>
-          <p:cNvSpPr txBox="1"/>
-          <p:nvPr/>
-        </p:nvSpPr>
-        <p:spPr>
-          <a:xfrm>
-            <a:off x="274320" y="4572000"/>
-            <a:ext cx="8595360" cy="502920"/>
-          </a:xfrm>
-          <a:prstGeom prst="rect">
-            <a:avLst/>
-          </a:prstGeom>
-          <a:noFill/>
-        </p:spPr>
-        <p:txBody>
-          <a:bodyPr wrap="square" anchor="t">
-            <a:spAutoFit/>
-          </a:bodyPr>
-          <a:lstStyle/>
-          <a:p>
-            <a:pPr algn="ctr"/>
-            <a:r>
-              <a:rPr sz="2000" b="0" i="1">
-                <a:solidFill>
-                  <a:srgbClr val="555960"/>
-                </a:solidFill>
-              </a:rPr>
-              <a:t>The obligation is right. The early boundary simply cannot decide it yet.</a:t>
-            </a:r>
           </a:p>
         </p:txBody>
       </p:sp>
@@ -16615,123 +16732,6 @@
 </file>
 
 <file path=ppt/slides/slide26.xml><?xml version="1.0" encoding="utf-8"?>
-<p:sld xmlns:a="http://schemas.openxmlformats.org/drawingml/2006/main" xmlns:p="http://schemas.openxmlformats.org/presentationml/2006/main" xmlns:r="http://schemas.openxmlformats.org/officeDocument/2006/relationships">
-  <p:cSld>
-    <p:spTree>
-      <p:nvGrpSpPr>
-        <p:cNvPr id="1" name=""/>
-        <p:cNvGrpSpPr/>
-        <p:nvPr/>
-      </p:nvGrpSpPr>
-      <p:grpSpPr/>
-      <p:sp>
-        <p:nvSpPr>
-          <p:cNvPr id="2" name="Title 1"/>
-          <p:cNvSpPr>
-            <a:spLocks noGrp="1"/>
-          </p:cNvSpPr>
-          <p:nvPr>
-            <p:ph type="title"/>
-          </p:nvPr>
-        </p:nvSpPr>
-        <p:spPr>
-          <a:xfrm>
-            <a:off x="685800" y="2139696"/>
-            <a:ext cx="7772400" cy="1444752"/>
-          </a:xfrm>
-        </p:spPr>
-        <p:txBody>
-          <a:bodyPr wrap="square"/>
-          <a:lstStyle/>
-          <a:p>
-            <a:pPr algn="ctr"/>
-            <a:r>
-              <a:rPr sz="3400">
-                <a:solidFill>
-                  <a:srgbClr val="000000"/>
-                </a:solidFill>
-              </a:rPr>
-              <a:t>Stretch break</a:t>
-            </a:r>
-          </a:p>
-        </p:txBody>
-      </p:sp>
-      <p:sp>
-        <p:nvSpPr>
-          <p:cNvPr id="3" name="Slide Number Placeholder 5"/>
-          <p:cNvSpPr>
-            <a:spLocks noGrp="1"/>
-          </p:cNvSpPr>
-          <p:nvPr>
-            <p:ph type="sldNum" sz="quarter" idx="4"/>
-          </p:nvPr>
-        </p:nvSpPr>
-        <p:spPr/>
-        <p:txBody>
-          <a:bodyPr/>
-          <a:lstStyle/>
-          <a:p>
-            <a:fld id="{B7EB45DA-9A0D-DC49-8E02-F30A5DDC21C3}" type="slidenum">
-              <a:rPr lang="en-US" smtClean="0"/>
-              <a:t>1</a:t>
-            </a:fld>
-            <a:endParaRPr lang="en-US"/>
-          </a:p>
-        </p:txBody>
-      </p:sp>
-      <p:sp>
-        <p:nvSpPr>
-          <p:cNvPr id="4" name="Rectangle 3"/>
-          <p:cNvSpPr/>
-          <p:nvPr/>
-        </p:nvSpPr>
-        <p:spPr>
-          <a:xfrm>
-            <a:off x="3429000" y="3383280"/>
-            <a:ext cx="2286000" cy="54864"/>
-          </a:xfrm>
-          <a:prstGeom prst="rect">
-            <a:avLst/>
-          </a:prstGeom>
-          <a:solidFill>
-            <a:srgbClr val="8E6F3E"/>
-          </a:solidFill>
-          <a:ln>
-            <a:noFill/>
-          </a:ln>
-          <a:effectLst/>
-        </p:spPr>
-        <p:style>
-          <a:lnRef idx="1">
-            <a:schemeClr val="accent1"/>
-          </a:lnRef>
-          <a:fillRef idx="3">
-            <a:schemeClr val="accent1"/>
-          </a:fillRef>
-          <a:effectRef idx="2">
-            <a:schemeClr val="accent1"/>
-          </a:effectRef>
-          <a:fontRef idx="minor">
-            <a:schemeClr val="lt1"/>
-          </a:fontRef>
-        </p:style>
-        <p:txBody>
-          <a:bodyPr rtlCol="0" anchor="ctr"/>
-          <a:lstStyle/>
-          <a:p>
-            <a:pPr algn="ctr"/>
-          </a:p>
-        </p:txBody>
-      </p:sp>
-    </p:spTree>
-  </p:cSld>
-  <p:clrMapOvr>
-    <a:masterClrMapping/>
-  </p:clrMapOvr>
-</p:sld>
-</file>
-
-<file path=ppt/slides/slide27.xml><?xml version="1.0" encoding="utf-8"?>
 <p:sld xmlns:a="http://schemas.openxmlformats.org/drawingml/2006/main" xmlns:r="http://schemas.openxmlformats.org/officeDocument/2006/relationships" xmlns:p="http://schemas.openxmlformats.org/presentationml/2006/main">
   <p:cSld>
     <p:spTree>
@@ -17059,6 +17059,152 @@
 </p:sld>
 </file>
 
+<file path=ppt/slides/slide27.xml><?xml version="1.0" encoding="utf-8"?>
+<p:sld xmlns:a="http://schemas.openxmlformats.org/drawingml/2006/main" xmlns:p="http://schemas.openxmlformats.org/presentationml/2006/main" xmlns:r="http://schemas.openxmlformats.org/officeDocument/2006/relationships">
+  <p:cSld>
+    <p:spTree>
+      <p:nvGrpSpPr>
+        <p:cNvPr id="1" name=""/>
+        <p:cNvGrpSpPr/>
+        <p:nvPr/>
+      </p:nvGrpSpPr>
+      <p:grpSpPr/>
+      <p:sp>
+        <p:nvSpPr>
+          <p:cNvPr id="3" name="Title 2"/>
+          <p:cNvSpPr>
+            <a:spLocks noGrp="1"/>
+          </p:cNvSpPr>
+          <p:nvPr>
+            <p:ph type="title"/>
+          </p:nvPr>
+        </p:nvSpPr>
+        <p:spPr/>
+        <p:txBody>
+          <a:bodyPr wrap="square"/>
+          <a:lstStyle/>
+          <a:p>
+            <a:r>
+              <a:rPr sz="2400" b="0">
+                <a:solidFill>
+                  <a:srgbClr val="000000"/>
+                </a:solidFill>
+              </a:rPr>
+              <a:t>We just did Alignment without models</a:t>
+            </a:r>
+          </a:p>
+        </p:txBody>
+      </p:sp>
+      <p:sp>
+        <p:nvSpPr>
+          <p:cNvPr id="4" name="Slide Number Placeholder 5"/>
+          <p:cNvSpPr>
+            <a:spLocks noGrp="1"/>
+          </p:cNvSpPr>
+          <p:nvPr>
+            <p:ph type="sldNum" sz="quarter" idx="4"/>
+          </p:nvPr>
+        </p:nvSpPr>
+        <p:spPr/>
+        <p:txBody>
+          <a:bodyPr/>
+          <a:lstStyle/>
+          <a:p>
+            <a:fld id="{B7EB45DA-9A0D-DC49-8E02-F30A5DDC21C3}" type="slidenum">
+              <a:rPr lang="en-US" smtClean="0"/>
+              <a:t>1</a:t>
+            </a:fld>
+            <a:endParaRPr lang="en-US"/>
+          </a:p>
+        </p:txBody>
+      </p:sp>
+      <p:sp>
+        <p:nvSpPr>
+          <p:cNvPr id="5" name="TextBox 4"/>
+          <p:cNvSpPr txBox="1"/>
+          <p:nvPr/>
+        </p:nvSpPr>
+        <p:spPr>
+          <a:xfrm>
+            <a:off x="548640" y="1645920"/>
+            <a:ext cx="8046720" cy="1463040"/>
+          </a:xfrm>
+          <a:prstGeom prst="rect">
+            <a:avLst/>
+          </a:prstGeom>
+          <a:noFill/>
+        </p:spPr>
+        <p:txBody>
+          <a:bodyPr wrap="square" anchor="ctr">
+            <a:spAutoFit/>
+          </a:bodyPr>
+          <a:lstStyle/>
+          <a:p>
+            <a:pPr algn="ctr"/>
+            <a:r>
+              <a:rPr sz="2400" b="1" i="0">
+                <a:solidFill>
+                  <a:srgbClr val="000000"/>
+                </a:solidFill>
+              </a:rPr>
+              <a:t>We just reasoned about constraints, evidence, evaluation, and authority.</a:t>
+            </a:r>
+          </a:p>
+          <a:p>
+            <a:pPr algn="ctr"/>
+            <a:r>
+              <a:rPr sz="2400" b="1" i="0">
+                <a:solidFill>
+                  <a:srgbClr val="000000"/>
+                </a:solidFill>
+              </a:rPr>
+              <a:t>No explicit model was required.</a:t>
+            </a:r>
+          </a:p>
+        </p:txBody>
+      </p:sp>
+      <p:sp>
+        <p:nvSpPr>
+          <p:cNvPr id="6" name="TextBox 5"/>
+          <p:cNvSpPr txBox="1"/>
+          <p:nvPr/>
+        </p:nvSpPr>
+        <p:spPr>
+          <a:xfrm>
+            <a:off x="548640" y="3840480"/>
+            <a:ext cx="8046720" cy="548640"/>
+          </a:xfrm>
+          <a:prstGeom prst="rect">
+            <a:avLst/>
+          </a:prstGeom>
+          <a:noFill/>
+        </p:spPr>
+        <p:txBody>
+          <a:bodyPr wrap="square" anchor="t">
+            <a:spAutoFit/>
+          </a:bodyPr>
+          <a:lstStyle/>
+          <a:p>
+            <a:pPr algn="ctr"/>
+            <a:r>
+              <a:rPr sz="2300" b="0" i="1">
+                <a:solidFill>
+                  <a:srgbClr val="8E6F3E"/>
+                </a:solidFill>
+              </a:rPr>
+              <a:t>So why did we spend the previous lecture on Modeling?</a:t>
+            </a:r>
+          </a:p>
+        </p:txBody>
+      </p:sp>
+    </p:spTree>
+  </p:cSld>
+  <p:clrMapOvr>
+    <a:masterClrMapping/>
+  </p:clrMapOvr>
+</p:sld>
+</file>
+
 <file path=ppt/slides/slide28.xml><?xml version="1.0" encoding="utf-8"?>
 <p:sld xmlns:a="http://schemas.openxmlformats.org/drawingml/2006/main" xmlns:p="http://schemas.openxmlformats.org/presentationml/2006/main" xmlns:r="http://schemas.openxmlformats.org/officeDocument/2006/relationships">
   <p:cSld>
@@ -17071,7 +17217,7 @@
       <p:grpSpPr/>
       <p:sp>
         <p:nvSpPr>
-          <p:cNvPr id="3" name="Title 2"/>
+          <p:cNvPr id="2" name="Title 1"/>
           <p:cNvSpPr>
             <a:spLocks noGrp="1"/>
           </p:cNvSpPr>
@@ -17079,25 +17225,31 @@
             <p:ph type="title"/>
           </p:nvPr>
         </p:nvSpPr>
-        <p:spPr/>
+        <p:spPr>
+          <a:xfrm>
+            <a:off x="685800" y="1700784"/>
+            <a:ext cx="7772400" cy="1005840"/>
+          </a:xfrm>
+        </p:spPr>
         <p:txBody>
           <a:bodyPr wrap="square"/>
           <a:lstStyle/>
           <a:p>
-            <a:r>
-              <a:rPr sz="2400" b="0">
+            <a:pPr algn="ctr"/>
+            <a:r>
+              <a:rPr sz="4000">
                 <a:solidFill>
                   <a:srgbClr val="000000"/>
                 </a:solidFill>
               </a:rPr>
-              <a:t>We just did Alignment without models</a:t>
-            </a:r>
-          </a:p>
-        </p:txBody>
-      </p:sp>
-      <p:sp>
-        <p:nvSpPr>
-          <p:cNvPr id="4" name="Slide Number Placeholder 5"/>
+              <a:t>What do models buy us?</a:t>
+            </a:r>
+          </a:p>
+        </p:txBody>
+      </p:sp>
+      <p:sp>
+        <p:nvSpPr>
+          <p:cNvPr id="3" name="Slide Number Placeholder 5"/>
           <p:cNvSpPr>
             <a:spLocks noGrp="1"/>
           </p:cNvSpPr>
@@ -17120,59 +17272,14 @@
       </p:sp>
       <p:sp>
         <p:nvSpPr>
-          <p:cNvPr id="5" name="TextBox 4"/>
+          <p:cNvPr id="4" name="TextBox 3"/>
           <p:cNvSpPr txBox="1"/>
           <p:nvPr/>
         </p:nvSpPr>
         <p:spPr>
           <a:xfrm>
-            <a:off x="548640" y="1645920"/>
-            <a:ext cx="8046720" cy="1463040"/>
-          </a:xfrm>
-          <a:prstGeom prst="rect">
-            <a:avLst/>
-          </a:prstGeom>
-          <a:noFill/>
-        </p:spPr>
-        <p:txBody>
-          <a:bodyPr wrap="square" anchor="ctr">
-            <a:spAutoFit/>
-          </a:bodyPr>
-          <a:lstStyle/>
-          <a:p>
-            <a:pPr algn="ctr"/>
-            <a:r>
-              <a:rPr sz="2400" b="1" i="0">
-                <a:solidFill>
-                  <a:srgbClr val="000000"/>
-                </a:solidFill>
-              </a:rPr>
-              <a:t>We just reasoned about constraints, evidence, evaluation, and authority.</a:t>
-            </a:r>
-          </a:p>
-          <a:p>
-            <a:pPr algn="ctr"/>
-            <a:r>
-              <a:rPr sz="2400" b="1" i="0">
-                <a:solidFill>
-                  <a:srgbClr val="000000"/>
-                </a:solidFill>
-              </a:rPr>
-              <a:t>No explicit model was required.</a:t>
-            </a:r>
-          </a:p>
-        </p:txBody>
-      </p:sp>
-      <p:sp>
-        <p:nvSpPr>
-          <p:cNvPr id="6" name="TextBox 5"/>
-          <p:cNvSpPr txBox="1"/>
-          <p:nvPr/>
-        </p:nvSpPr>
-        <p:spPr>
-          <a:xfrm>
-            <a:off x="548640" y="3840480"/>
-            <a:ext cx="8046720" cy="548640"/>
+            <a:off x="685800" y="1243584"/>
+            <a:ext cx="7772400" cy="365760"/>
           </a:xfrm>
           <a:prstGeom prst="rect">
             <a:avLst/>
@@ -17187,13 +17294,57 @@
           <a:p>
             <a:pPr algn="ctr"/>
             <a:r>
-              <a:rPr sz="2300" b="0" i="1">
+              <a:rPr sz="2000" b="1" i="0">
                 <a:solidFill>
                   <a:srgbClr val="8E6F3E"/>
                 </a:solidFill>
               </a:rPr>
-              <a:t>So why did we spend the previous lecture on Modeling?</a:t>
-            </a:r>
+              <a:t>DISCUSSION</a:t>
+            </a:r>
+          </a:p>
+        </p:txBody>
+      </p:sp>
+      <p:sp>
+        <p:nvSpPr>
+          <p:cNvPr id="5" name="Rectangle 4"/>
+          <p:cNvSpPr/>
+          <p:nvPr/>
+        </p:nvSpPr>
+        <p:spPr>
+          <a:xfrm>
+            <a:off x="3429000" y="3017520"/>
+            <a:ext cx="2286000" cy="54864"/>
+          </a:xfrm>
+          <a:prstGeom prst="rect">
+            <a:avLst/>
+          </a:prstGeom>
+          <a:solidFill>
+            <a:srgbClr val="8E6F3E"/>
+          </a:solidFill>
+          <a:ln>
+            <a:noFill/>
+          </a:ln>
+          <a:effectLst/>
+        </p:spPr>
+        <p:style>
+          <a:lnRef idx="1">
+            <a:schemeClr val="accent1"/>
+          </a:lnRef>
+          <a:fillRef idx="3">
+            <a:schemeClr val="accent1"/>
+          </a:fillRef>
+          <a:effectRef idx="2">
+            <a:schemeClr val="accent1"/>
+          </a:effectRef>
+          <a:fontRef idx="minor">
+            <a:schemeClr val="lt1"/>
+          </a:fontRef>
+        </p:style>
+        <p:txBody>
+          <a:bodyPr rtlCol="0" anchor="ctr"/>
+          <a:lstStyle/>
+          <a:p>
+            <a:pPr algn="ctr"/>
           </a:p>
         </p:txBody>
       </p:sp>
@@ -17217,7 +17368,7 @@
       <p:grpSpPr/>
       <p:sp>
         <p:nvSpPr>
-          <p:cNvPr id="2" name="Title 1"/>
+          <p:cNvPr id="3" name="Title 2"/>
           <p:cNvSpPr>
             <a:spLocks noGrp="1"/>
           </p:cNvSpPr>
@@ -17225,31 +17376,25 @@
             <p:ph type="title"/>
           </p:nvPr>
         </p:nvSpPr>
-        <p:spPr>
-          <a:xfrm>
-            <a:off x="685800" y="1700784"/>
-            <a:ext cx="7772400" cy="1005840"/>
-          </a:xfrm>
-        </p:spPr>
+        <p:spPr/>
         <p:txBody>
           <a:bodyPr wrap="square"/>
           <a:lstStyle/>
           <a:p>
-            <a:pPr algn="ctr"/>
-            <a:r>
-              <a:rPr sz="4000">
+            <a:r>
+              <a:rPr sz="2400" b="0">
                 <a:solidFill>
                   <a:srgbClr val="000000"/>
                 </a:solidFill>
               </a:rPr>
-              <a:t>What do models buy us?</a:t>
-            </a:r>
-          </a:p>
-        </p:txBody>
-      </p:sp>
-      <p:sp>
-        <p:nvSpPr>
-          <p:cNvPr id="3" name="Slide Number Placeholder 5"/>
+              <a:t>Models make engineering knowledge explicit</a:t>
+            </a:r>
+          </a:p>
+        </p:txBody>
+      </p:sp>
+      <p:sp>
+        <p:nvSpPr>
+          <p:cNvPr id="4" name="Slide Number Placeholder 5"/>
           <p:cNvSpPr>
             <a:spLocks noGrp="1"/>
           </p:cNvSpPr>
@@ -17272,14 +17417,14 @@
       </p:sp>
       <p:sp>
         <p:nvSpPr>
-          <p:cNvPr id="4" name="TextBox 3"/>
+          <p:cNvPr id="5" name="TextBox 4"/>
           <p:cNvSpPr txBox="1"/>
           <p:nvPr/>
         </p:nvSpPr>
         <p:spPr>
           <a:xfrm>
-            <a:off x="685800" y="1243584"/>
-            <a:ext cx="7772400" cy="365760"/>
+            <a:off x="640080" y="914400"/>
+            <a:ext cx="8595360" cy="365760"/>
           </a:xfrm>
           <a:prstGeom prst="rect">
             <a:avLst/>
@@ -17292,37 +17437,39 @@
           </a:bodyPr>
           <a:lstStyle/>
           <a:p>
-            <a:pPr algn="ctr"/>
+            <a:pPr algn="l"/>
             <a:r>
               <a:rPr sz="2000" b="1" i="0">
                 <a:solidFill>
                   <a:srgbClr val="8E6F3E"/>
                 </a:solidFill>
               </a:rPr>
-              <a:t>DISCUSSION</a:t>
-            </a:r>
-          </a:p>
-        </p:txBody>
-      </p:sp>
-      <p:sp>
-        <p:nvSpPr>
-          <p:cNvPr id="5" name="Rectangle 4"/>
+              <a:t>A MODEL CAN …</a:t>
+            </a:r>
+          </a:p>
+        </p:txBody>
+      </p:sp>
+      <p:sp>
+        <p:nvSpPr>
+          <p:cNvPr id="6" name="Rectangle 5"/>
           <p:cNvSpPr/>
           <p:nvPr/>
         </p:nvSpPr>
         <p:spPr>
           <a:xfrm>
-            <a:off x="3429000" y="3017520"/>
-            <a:ext cx="2286000" cy="54864"/>
+            <a:off x="640080" y="1371600"/>
+            <a:ext cx="2560320" cy="731520"/>
           </a:xfrm>
           <a:prstGeom prst="rect">
             <a:avLst/>
           </a:prstGeom>
           <a:solidFill>
-            <a:srgbClr val="8E6F3E"/>
+            <a:srgbClr val="F5F1E8"/>
           </a:solidFill>
-          <a:ln>
-            <a:noFill/>
+          <a:ln w="12700">
+            <a:solidFill>
+              <a:srgbClr val="C9B991"/>
+            </a:solidFill>
           </a:ln>
           <a:effectLst/>
         </p:spPr>
@@ -17341,10 +17488,350 @@
           </a:fontRef>
         </p:style>
         <p:txBody>
-          <a:bodyPr rtlCol="0" anchor="ctr"/>
+          <a:bodyPr rtlCol="0" anchor="ctr" wrap="square" lIns="27432" rIns="27432" tIns="22860" bIns="22860"/>
           <a:lstStyle/>
           <a:p>
             <a:pPr algn="ctr"/>
+            <a:r>
+              <a:rPr sz="1800" b="1" i="0">
+                <a:solidFill>
+                  <a:srgbClr val="5C4826"/>
+                </a:solidFill>
+              </a:rPr>
+              <a:t>PRESERVE</a:t>
+            </a:r>
+          </a:p>
+        </p:txBody>
+      </p:sp>
+      <p:sp>
+        <p:nvSpPr>
+          <p:cNvPr id="7" name="TextBox 6"/>
+          <p:cNvSpPr txBox="1"/>
+          <p:nvPr/>
+        </p:nvSpPr>
+        <p:spPr>
+          <a:xfrm>
+            <a:off x="3383280" y="1499616"/>
+            <a:ext cx="5440680" cy="731520"/>
+          </a:xfrm>
+          <a:prstGeom prst="rect">
+            <a:avLst/>
+          </a:prstGeom>
+          <a:noFill/>
+        </p:spPr>
+        <p:txBody>
+          <a:bodyPr wrap="square" anchor="t">
+            <a:spAutoFit/>
+          </a:bodyPr>
+          <a:lstStyle/>
+          <a:p>
+            <a:pPr algn="l"/>
+            <a:r>
+              <a:rPr sz="2000" b="0" i="0">
+                <a:solidFill>
+                  <a:srgbClr val="5C4826"/>
+                </a:solidFill>
+              </a:rPr>
+              <a:t>distinctions that matter</a:t>
+            </a:r>
+          </a:p>
+        </p:txBody>
+      </p:sp>
+      <p:sp>
+        <p:nvSpPr>
+          <p:cNvPr id="8" name="Rectangle 7"/>
+          <p:cNvSpPr/>
+          <p:nvPr/>
+        </p:nvSpPr>
+        <p:spPr>
+          <a:xfrm>
+            <a:off x="640080" y="2304288"/>
+            <a:ext cx="2560320" cy="731520"/>
+          </a:xfrm>
+          <a:prstGeom prst="rect">
+            <a:avLst/>
+          </a:prstGeom>
+          <a:solidFill>
+            <a:srgbClr val="F5F1E8"/>
+          </a:solidFill>
+          <a:ln w="12700">
+            <a:solidFill>
+              <a:srgbClr val="C9B991"/>
+            </a:solidFill>
+          </a:ln>
+          <a:effectLst/>
+        </p:spPr>
+        <p:style>
+          <a:lnRef idx="1">
+            <a:schemeClr val="accent1"/>
+          </a:lnRef>
+          <a:fillRef idx="3">
+            <a:schemeClr val="accent1"/>
+          </a:fillRef>
+          <a:effectRef idx="2">
+            <a:schemeClr val="accent1"/>
+          </a:effectRef>
+          <a:fontRef idx="minor">
+            <a:schemeClr val="lt1"/>
+          </a:fontRef>
+        </p:style>
+        <p:txBody>
+          <a:bodyPr rtlCol="0" anchor="ctr" wrap="square" lIns="27432" rIns="27432" tIns="22860" bIns="22860"/>
+          <a:lstStyle/>
+          <a:p>
+            <a:pPr algn="ctr"/>
+            <a:r>
+              <a:rPr sz="1800" b="1" i="0">
+                <a:solidFill>
+                  <a:srgbClr val="5C4826"/>
+                </a:solidFill>
+              </a:rPr>
+              <a:t>EXPOSE</a:t>
+            </a:r>
+          </a:p>
+        </p:txBody>
+      </p:sp>
+      <p:sp>
+        <p:nvSpPr>
+          <p:cNvPr id="9" name="TextBox 8"/>
+          <p:cNvSpPr txBox="1"/>
+          <p:nvPr/>
+        </p:nvSpPr>
+        <p:spPr>
+          <a:xfrm>
+            <a:off x="3383280" y="2432304"/>
+            <a:ext cx="5440680" cy="731520"/>
+          </a:xfrm>
+          <a:prstGeom prst="rect">
+            <a:avLst/>
+          </a:prstGeom>
+          <a:noFill/>
+        </p:spPr>
+        <p:txBody>
+          <a:bodyPr wrap="square" anchor="t">
+            <a:spAutoFit/>
+          </a:bodyPr>
+          <a:lstStyle/>
+          <a:p>
+            <a:pPr algn="l"/>
+            <a:r>
+              <a:rPr sz="2000" b="0" i="0">
+                <a:solidFill>
+                  <a:srgbClr val="5C4826"/>
+                </a:solidFill>
+              </a:rPr>
+              <a:t>relationships that would otherwise be reconstructed</a:t>
+            </a:r>
+          </a:p>
+        </p:txBody>
+      </p:sp>
+      <p:sp>
+        <p:nvSpPr>
+          <p:cNvPr id="10" name="Rectangle 9"/>
+          <p:cNvSpPr/>
+          <p:nvPr/>
+        </p:nvSpPr>
+        <p:spPr>
+          <a:xfrm>
+            <a:off x="640080" y="3236976"/>
+            <a:ext cx="2560320" cy="731520"/>
+          </a:xfrm>
+          <a:prstGeom prst="rect">
+            <a:avLst/>
+          </a:prstGeom>
+          <a:solidFill>
+            <a:srgbClr val="F5F1E8"/>
+          </a:solidFill>
+          <a:ln w="12700">
+            <a:solidFill>
+              <a:srgbClr val="C9B991"/>
+            </a:solidFill>
+          </a:ln>
+          <a:effectLst/>
+        </p:spPr>
+        <p:style>
+          <a:lnRef idx="1">
+            <a:schemeClr val="accent1"/>
+          </a:lnRef>
+          <a:fillRef idx="3">
+            <a:schemeClr val="accent1"/>
+          </a:fillRef>
+          <a:effectRef idx="2">
+            <a:schemeClr val="accent1"/>
+          </a:effectRef>
+          <a:fontRef idx="minor">
+            <a:schemeClr val="lt1"/>
+          </a:fontRef>
+        </p:style>
+        <p:txBody>
+          <a:bodyPr rtlCol="0" anchor="ctr" wrap="square" lIns="27432" rIns="27432" tIns="22860" bIns="22860"/>
+          <a:lstStyle/>
+          <a:p>
+            <a:pPr algn="ctr"/>
+            <a:r>
+              <a:rPr sz="1800" b="1" i="0">
+                <a:solidFill>
+                  <a:srgbClr val="5C4826"/>
+                </a:solidFill>
+              </a:rPr>
+              <a:t>LEAVE OPEN</a:t>
+            </a:r>
+          </a:p>
+        </p:txBody>
+      </p:sp>
+      <p:sp>
+        <p:nvSpPr>
+          <p:cNvPr id="11" name="TextBox 10"/>
+          <p:cNvSpPr txBox="1"/>
+          <p:nvPr/>
+        </p:nvSpPr>
+        <p:spPr>
+          <a:xfrm>
+            <a:off x="3383280" y="3364992"/>
+            <a:ext cx="5440680" cy="731520"/>
+          </a:xfrm>
+          <a:prstGeom prst="rect">
+            <a:avLst/>
+          </a:prstGeom>
+          <a:noFill/>
+        </p:spPr>
+        <p:txBody>
+          <a:bodyPr wrap="square" anchor="t">
+            <a:spAutoFit/>
+          </a:bodyPr>
+          <a:lstStyle/>
+          <a:p>
+            <a:pPr algn="l"/>
+            <a:r>
+              <a:rPr sz="2000" b="0" i="0">
+                <a:solidFill>
+                  <a:srgbClr val="5C4826"/>
+                </a:solidFill>
+              </a:rPr>
+              <a:t>realization choices that do not matter</a:t>
+            </a:r>
+          </a:p>
+        </p:txBody>
+      </p:sp>
+      <p:sp>
+        <p:nvSpPr>
+          <p:cNvPr id="12" name="Rectangle 11"/>
+          <p:cNvSpPr/>
+          <p:nvPr/>
+        </p:nvSpPr>
+        <p:spPr>
+          <a:xfrm>
+            <a:off x="640080" y="4169664"/>
+            <a:ext cx="2560320" cy="731520"/>
+          </a:xfrm>
+          <a:prstGeom prst="rect">
+            <a:avLst/>
+          </a:prstGeom>
+          <a:solidFill>
+            <a:srgbClr val="F5F1E8"/>
+          </a:solidFill>
+          <a:ln w="12700">
+            <a:solidFill>
+              <a:srgbClr val="C9B991"/>
+            </a:solidFill>
+          </a:ln>
+          <a:effectLst/>
+        </p:spPr>
+        <p:style>
+          <a:lnRef idx="1">
+            <a:schemeClr val="accent1"/>
+          </a:lnRef>
+          <a:fillRef idx="3">
+            <a:schemeClr val="accent1"/>
+          </a:fillRef>
+          <a:effectRef idx="2">
+            <a:schemeClr val="accent1"/>
+          </a:effectRef>
+          <a:fontRef idx="minor">
+            <a:schemeClr val="lt1"/>
+          </a:fontRef>
+        </p:style>
+        <p:txBody>
+          <a:bodyPr rtlCol="0" anchor="ctr" wrap="square" lIns="27432" rIns="27432" tIns="22860" bIns="22860"/>
+          <a:lstStyle/>
+          <a:p>
+            <a:pPr algn="ctr"/>
+            <a:r>
+              <a:rPr sz="1800" b="1" i="0">
+                <a:solidFill>
+                  <a:srgbClr val="5C4826"/>
+                </a:solidFill>
+              </a:rPr>
+              <a:t>ENABLE</a:t>
+            </a:r>
+          </a:p>
+        </p:txBody>
+      </p:sp>
+      <p:sp>
+        <p:nvSpPr>
+          <p:cNvPr id="13" name="TextBox 12"/>
+          <p:cNvSpPr txBox="1"/>
+          <p:nvPr/>
+        </p:nvSpPr>
+        <p:spPr>
+          <a:xfrm>
+            <a:off x="3383280" y="4297680"/>
+            <a:ext cx="5440680" cy="731520"/>
+          </a:xfrm>
+          <a:prstGeom prst="rect">
+            <a:avLst/>
+          </a:prstGeom>
+          <a:noFill/>
+        </p:spPr>
+        <p:txBody>
+          <a:bodyPr wrap="square" anchor="t">
+            <a:spAutoFit/>
+          </a:bodyPr>
+          <a:lstStyle/>
+          <a:p>
+            <a:pPr algn="l"/>
+            <a:r>
+              <a:rPr sz="2000" b="0" i="0">
+                <a:solidFill>
+                  <a:srgbClr val="5C4826"/>
+                </a:solidFill>
+              </a:rPr>
+              <a:t>evaluations that otherwise require reconstruction</a:t>
+            </a:r>
+          </a:p>
+        </p:txBody>
+      </p:sp>
+      <p:sp>
+        <p:nvSpPr>
+          <p:cNvPr id="14" name="TextBox 13"/>
+          <p:cNvSpPr txBox="1"/>
+          <p:nvPr/>
+        </p:nvSpPr>
+        <p:spPr>
+          <a:xfrm>
+            <a:off x="274320" y="5010912"/>
+            <a:ext cx="8595360" cy="411480"/>
+          </a:xfrm>
+          <a:prstGeom prst="rect">
+            <a:avLst/>
+          </a:prstGeom>
+          <a:noFill/>
+        </p:spPr>
+        <p:txBody>
+          <a:bodyPr wrap="square" anchor="t">
+            <a:spAutoFit/>
+          </a:bodyPr>
+          <a:lstStyle/>
+          <a:p>
+            <a:pPr algn="ctr"/>
+            <a:r>
+              <a:rPr sz="2000" b="0" i="1">
+                <a:solidFill>
+                  <a:srgbClr val="555960"/>
+                </a:solidFill>
+              </a:rPr>
+              <a:t>Different analyses can then operate over the same engineering knowledge.</a:t>
+            </a:r>
           </a:p>
         </p:txBody>
       </p:sp>
@@ -17549,6 +18036,23 @@
       <p:grpSpPr/>
       <p:sp>
         <p:nvSpPr>
+          <p:cNvPr id="2" name="Content Placeholder 1"/>
+          <p:cNvSpPr>
+            <a:spLocks noGrp="1"/>
+          </p:cNvSpPr>
+          <p:nvPr>
+            <p:ph idx="1"/>
+          </p:nvPr>
+        </p:nvSpPr>
+        <p:spPr/>
+        <p:txBody>
+          <a:bodyPr/>
+          <a:lstStyle/>
+          <a:p/>
+        </p:txBody>
+      </p:sp>
+      <p:sp>
+        <p:nvSpPr>
           <p:cNvPr id="3" name="Title 2"/>
           <p:cNvSpPr>
             <a:spLocks noGrp="1"/>
@@ -17559,53 +18063,78 @@
         </p:nvSpPr>
         <p:spPr/>
         <p:txBody>
-          <a:bodyPr wrap="square"/>
-          <a:lstStyle/>
-          <a:p>
-            <a:r>
-              <a:rPr sz="2400" b="0">
-                <a:solidFill>
-                  <a:srgbClr val="000000"/>
-                </a:solidFill>
-              </a:rPr>
-              <a:t>Models make engineering knowledge explicit</a:t>
-            </a:r>
-          </a:p>
-        </p:txBody>
-      </p:sp>
-      <p:sp>
-        <p:nvSpPr>
-          <p:cNvPr id="4" name="Slide Number Placeholder 5"/>
-          <p:cNvSpPr>
-            <a:spLocks noGrp="1"/>
-          </p:cNvSpPr>
-          <p:nvPr>
-            <p:ph type="sldNum" sz="quarter" idx="4"/>
-          </p:nvPr>
-        </p:nvSpPr>
-        <p:spPr/>
-        <p:txBody>
           <a:bodyPr/>
           <a:lstStyle/>
           <a:p>
-            <a:fld id="{B7EB45DA-9A0D-DC49-8E02-F30A5DDC21C3}" type="slidenum">
-              <a:rPr lang="en-US" smtClean="0"/>
-              <a:t>1</a:t>
-            </a:fld>
-            <a:endParaRPr lang="en-US"/>
-          </a:p>
-        </p:txBody>
-      </p:sp>
-      <p:sp>
-        <p:nvSpPr>
-          <p:cNvPr id="5" name="TextBox 4"/>
+            <a:r>
+              <a:rPr sz="2400"/>
+              <a:t>Models can drive controls</a:t>
+            </a:r>
+          </a:p>
+        </p:txBody>
+      </p:sp>
+      <p:sp>
+        <p:nvSpPr>
+          <p:cNvPr id="15" name="MCGate"/>
+          <p:cNvSpPr/>
+          <p:nvPr/>
+        </p:nvSpPr>
+        <p:spPr>
+          <a:xfrm>
+            <a:off x="3749039" y="3767328"/>
+            <a:ext cx="1645920" cy="566928"/>
+          </a:xfrm>
+          <a:prstGeom prst="rect">
+            <a:avLst/>
+          </a:prstGeom>
+          <a:solidFill>
+            <a:srgbClr val="8E6F3E"/>
+          </a:solidFill>
+          <a:ln>
+            <a:noFill/>
+          </a:ln>
+          <a:effectLst/>
+        </p:spPr>
+        <p:style>
+          <a:lnRef idx="1">
+            <a:schemeClr val="accent1"/>
+          </a:lnRef>
+          <a:fillRef idx="3">
+            <a:schemeClr val="accent1"/>
+          </a:fillRef>
+          <a:effectRef idx="2">
+            <a:schemeClr val="accent1"/>
+          </a:effectRef>
+          <a:fontRef idx="minor">
+            <a:schemeClr val="lt1"/>
+          </a:fontRef>
+        </p:style>
+        <p:txBody>
+          <a:bodyPr rtlCol="0" anchor="ctr" wrap="square" lIns="27432" rIns="27432" tIns="22860" bIns="22860"/>
+          <a:lstStyle/>
+          <a:p>
+            <a:pPr algn="ctr"/>
+            <a:r>
+              <a:rPr sz="1600" b="1" i="0">
+                <a:solidFill>
+                  <a:srgbClr val="FFFFFF"/>
+                </a:solidFill>
+              </a:rPr>
+              <a:t>VERDICTS</a:t>
+            </a:r>
+          </a:p>
+        </p:txBody>
+      </p:sp>
+      <p:sp>
+        <p:nvSpPr>
+          <p:cNvPr id="16" name="MCPoint"/>
           <p:cNvSpPr txBox="1"/>
           <p:nvPr/>
         </p:nvSpPr>
         <p:spPr>
           <a:xfrm>
-            <a:off x="640080" y="914400"/>
-            <a:ext cx="8595360" cy="365760"/>
+            <a:off x="502920" y="4572000"/>
+            <a:ext cx="8138160" cy="548640"/>
           </a:xfrm>
           <a:prstGeom prst="rect">
             <a:avLst/>
@@ -17618,28 +18147,91 @@
           </a:bodyPr>
           <a:lstStyle/>
           <a:p>
-            <a:pPr algn="l"/>
-            <a:r>
-              <a:rPr sz="2000" b="1" i="0">
-                <a:solidFill>
-                  <a:srgbClr val="8E6F3E"/>
-                </a:solidFill>
-              </a:rPr>
-              <a:t>A MODEL CAN …</a:t>
-            </a:r>
-          </a:p>
-        </p:txBody>
-      </p:sp>
-      <p:sp>
-        <p:nvSpPr>
-          <p:cNvPr id="6" name="Rectangle 5"/>
+            <a:pPr algn="ctr"/>
+            <a:r>
+              <a:rPr sz="2000" b="0" i="0">
+                <a:solidFill>
+                  <a:srgbClr val="5C4826"/>
+                </a:solidFill>
+              </a:rPr>
+              <a:t>The same explicit engineering knowledge can support multiple validators and constraints.</a:t>
+            </a:r>
+          </a:p>
+        </p:txBody>
+      </p:sp>
+      <p:sp>
+        <p:nvSpPr>
+          <p:cNvPr id="18" name="RealModel"/>
           <p:cNvSpPr/>
           <p:nvPr/>
         </p:nvSpPr>
         <p:spPr>
           <a:xfrm>
-            <a:off x="640080" y="1371600"/>
-            <a:ext cx="2560320" cy="731520"/>
+            <a:off x="2103120" y="914400"/>
+            <a:ext cx="4937760" cy="804672"/>
+          </a:xfrm>
+          <a:prstGeom prst="rect">
+            <a:avLst/>
+          </a:prstGeom>
+          <a:solidFill>
+            <a:srgbClr val="8E6F3E"/>
+          </a:solidFill>
+          <a:ln>
+            <a:noFill/>
+          </a:ln>
+          <a:effectLst/>
+        </p:spPr>
+        <p:style>
+          <a:lnRef idx="1">
+            <a:schemeClr val="accent1"/>
+          </a:lnRef>
+          <a:fillRef idx="3">
+            <a:schemeClr val="accent1"/>
+          </a:fillRef>
+          <a:effectRef idx="2">
+            <a:schemeClr val="accent1"/>
+          </a:effectRef>
+          <a:fontRef idx="minor">
+            <a:schemeClr val="lt1"/>
+          </a:fontRef>
+        </p:style>
+        <p:txBody>
+          <a:bodyPr rtlCol="0" anchor="ctr" wrap="square" lIns="27432" rIns="27432" tIns="22860" bIns="22860"/>
+          <a:lstStyle/>
+          <a:p>
+            <a:pPr algn="ctr"/>
+            <a:r>
+              <a:rPr sz="1400" b="1" i="0">
+                <a:solidFill>
+                  <a:srgbClr val="FFFFFF"/>
+                </a:solidFill>
+              </a:rPr>
+              <a:t>DOCUMENT PROCESSING SERVICE</a:t>
+            </a:r>
+          </a:p>
+          <a:p>
+            <a:pPr algn="ctr"/>
+            <a:r>
+              <a:rPr sz="1050" b="0" i="1">
+                <a:solidFill>
+                  <a:srgbClr val="FBF8F2"/>
+                </a:solidFill>
+              </a:rPr>
+              <a:t>one explicit model: lifecycle machine + resource graph</a:t>
+            </a:r>
+          </a:p>
+        </p:txBody>
+      </p:sp>
+      <p:sp>
+        <p:nvSpPr>
+          <p:cNvPr id="19" name="MC-lifecycle"/>
+          <p:cNvSpPr/>
+          <p:nvPr/>
+        </p:nvSpPr>
+        <p:spPr>
+          <a:xfrm>
+            <a:off x="411480" y="2240280"/>
+            <a:ext cx="2468880" cy="960120"/>
           </a:xfrm>
           <a:prstGeom prst="rect">
             <a:avLst/>
@@ -17674,60 +18266,37 @@
           <a:p>
             <a:pPr algn="ctr"/>
             <a:r>
-              <a:rPr sz="1800" b="1" i="0">
+              <a:rPr sz="1200" b="1" i="0">
                 <a:solidFill>
                   <a:srgbClr val="5C4826"/>
                 </a:solidFill>
               </a:rPr>
-              <a:t>PRESERVE</a:t>
-            </a:r>
-          </a:p>
-        </p:txBody>
-      </p:sp>
-      <p:sp>
-        <p:nvSpPr>
-          <p:cNvPr id="7" name="TextBox 6"/>
-          <p:cNvSpPr txBox="1"/>
-          <p:nvPr/>
-        </p:nvSpPr>
-        <p:spPr>
-          <a:xfrm>
-            <a:off x="3383280" y="1499616"/>
-            <a:ext cx="5440680" cy="731520"/>
-          </a:xfrm>
-          <a:prstGeom prst="rect">
-            <a:avLst/>
-          </a:prstGeom>
-          <a:noFill/>
-        </p:spPr>
-        <p:txBody>
-          <a:bodyPr wrap="square" anchor="t">
-            <a:spAutoFit/>
-          </a:bodyPr>
-          <a:lstStyle/>
-          <a:p>
-            <a:pPr algn="l"/>
-            <a:r>
-              <a:rPr sz="2000" b="0" i="0">
-                <a:solidFill>
-                  <a:srgbClr val="5C4826"/>
-                </a:solidFill>
-              </a:rPr>
-              <a:t>distinctions that matter</a:t>
-            </a:r>
-          </a:p>
-        </p:txBody>
-      </p:sp>
-      <p:sp>
-        <p:nvSpPr>
-          <p:cNvPr id="8" name="Rectangle 7"/>
+              <a:t>LIFECYCLE CHECK</a:t>
+            </a:r>
+          </a:p>
+          <a:p>
+            <a:pPr algn="ctr"/>
+            <a:r>
+              <a:rPr sz="950" b="0" i="0">
+                <a:solidFill>
+                  <a:srgbClr val="555960"/>
+                </a:solidFill>
+              </a:rPr>
+              <a:t>can a Completed document ever be processed again?  no</a:t>
+            </a:r>
+          </a:p>
+        </p:txBody>
+      </p:sp>
+      <p:sp>
+        <p:nvSpPr>
+          <p:cNvPr id="20" name="MC-retry"/>
           <p:cNvSpPr/>
           <p:nvPr/>
         </p:nvSpPr>
         <p:spPr>
           <a:xfrm>
-            <a:off x="640080" y="2304288"/>
-            <a:ext cx="2560320" cy="731520"/>
+            <a:off x="3337560" y="2240280"/>
+            <a:ext cx="2468880" cy="960120"/>
           </a:xfrm>
           <a:prstGeom prst="rect">
             <a:avLst/>
@@ -17762,60 +18331,37 @@
           <a:p>
             <a:pPr algn="ctr"/>
             <a:r>
-              <a:rPr sz="1800" b="1" i="0">
+              <a:rPr sz="1200" b="1" i="0">
                 <a:solidFill>
                   <a:srgbClr val="5C4826"/>
                 </a:solidFill>
               </a:rPr>
-              <a:t>EXPOSE</a:t>
-            </a:r>
-          </a:p>
-        </p:txBody>
-      </p:sp>
-      <p:sp>
-        <p:nvSpPr>
-          <p:cNvPr id="9" name="TextBox 8"/>
-          <p:cNvSpPr txBox="1"/>
-          <p:nvPr/>
-        </p:nvSpPr>
-        <p:spPr>
-          <a:xfrm>
-            <a:off x="3383280" y="2432304"/>
-            <a:ext cx="5440680" cy="731520"/>
-          </a:xfrm>
-          <a:prstGeom prst="rect">
-            <a:avLst/>
-          </a:prstGeom>
-          <a:noFill/>
-        </p:spPr>
-        <p:txBody>
-          <a:bodyPr wrap="square" anchor="t">
-            <a:spAutoFit/>
-          </a:bodyPr>
-          <a:lstStyle/>
-          <a:p>
-            <a:pPr algn="l"/>
-            <a:r>
-              <a:rPr sz="2000" b="0" i="0">
-                <a:solidFill>
-                  <a:srgbClr val="5C4826"/>
-                </a:solidFill>
-              </a:rPr>
-              <a:t>relationships that would otherwise be reconstructed</a:t>
-            </a:r>
-          </a:p>
-        </p:txBody>
-      </p:sp>
-      <p:sp>
-        <p:nvSpPr>
-          <p:cNvPr id="10" name="Rectangle 9"/>
+              <a:t>RETRY BOUND</a:t>
+            </a:r>
+          </a:p>
+          <a:p>
+            <a:pPr algn="ctr"/>
+            <a:r>
+              <a:rPr sz="950" b="0" i="0">
+                <a:solidFill>
+                  <a:srgbClr val="555960"/>
+                </a:solidFill>
+              </a:rPr>
+              <a:t>can the retry loop run forever?  no — at most 2 retries</a:t>
+            </a:r>
+          </a:p>
+        </p:txBody>
+      </p:sp>
+      <p:sp>
+        <p:nvSpPr>
+          <p:cNvPr id="21" name="MC-memory"/>
           <p:cNvSpPr/>
           <p:nvPr/>
         </p:nvSpPr>
         <p:spPr>
           <a:xfrm>
-            <a:off x="640080" y="3236976"/>
-            <a:ext cx="2560320" cy="731520"/>
+            <a:off x="6263640" y="2240280"/>
+            <a:ext cx="2468880" cy="960120"/>
           </a:xfrm>
           <a:prstGeom prst="rect">
             <a:avLst/>
@@ -17850,26 +18396,253 @@
           <a:p>
             <a:pPr algn="ctr"/>
             <a:r>
-              <a:rPr sz="1800" b="1" i="0">
+              <a:rPr sz="1200" b="1" i="0">
                 <a:solidFill>
                   <a:srgbClr val="5C4826"/>
                 </a:solidFill>
               </a:rPr>
-              <a:t>LEAVE OPEN</a:t>
-            </a:r>
-          </a:p>
-        </p:txBody>
-      </p:sp>
-      <p:sp>
-        <p:nvSpPr>
-          <p:cNvPr id="11" name="TextBox 10"/>
+              <a:t>MEMORY ANALYSIS</a:t>
+            </a:r>
+          </a:p>
+          <a:p>
+            <a:pPr algn="ctr"/>
+            <a:r>
+              <a:rPr sz="950" b="0" i="0">
+                <a:solidFill>
+                  <a:srgbClr val="555960"/>
+                </a:solidFill>
+              </a:rPr>
+              <a:t>peak demand 2 × 384 MB — within the 1 GB worker ceiling</a:t>
+            </a:r>
+          </a:p>
+        </p:txBody>
+      </p:sp>
+      <p:cxnSp>
+        <p:nvCxnSpPr>
+          <p:cNvPr id="22" name="RM-Conn1"/>
+          <p:cNvCxnSpPr/>
+          <p:nvPr/>
+        </p:nvCxnSpPr>
+        <p:spPr>
+          <a:xfrm flipH="1">
+            <a:off x="1645920" y="1719072"/>
+            <a:ext cx="2926080" cy="521208"/>
+          </a:xfrm>
+          <a:prstGeom prst="line">
+            <a:avLst/>
+          </a:prstGeom>
+          <a:ln w="28575">
+            <a:solidFill>
+              <a:srgbClr val="8E6F3E"/>
+            </a:solidFill>
+            <a:tailEnd type="triangle" w="med" len="med"/>
+          </a:ln>
+        </p:spPr>
+        <p:style>
+          <a:lnRef idx="2">
+            <a:schemeClr val="accent1"/>
+          </a:lnRef>
+          <a:fillRef idx="0">
+            <a:schemeClr val="accent1"/>
+          </a:fillRef>
+          <a:effectRef idx="1">
+            <a:schemeClr val="accent1"/>
+          </a:effectRef>
+          <a:fontRef idx="minor">
+            <a:schemeClr val="tx1"/>
+          </a:fontRef>
+        </p:style>
+      </p:cxnSp>
+      <p:cxnSp>
+        <p:nvCxnSpPr>
+          <p:cNvPr id="23" name="RM-Conn2"/>
+          <p:cNvCxnSpPr/>
+          <p:nvPr/>
+        </p:nvCxnSpPr>
+        <p:spPr>
+          <a:xfrm>
+            <a:off x="4572000" y="1719072"/>
+            <a:ext cx="0" cy="521208"/>
+          </a:xfrm>
+          <a:prstGeom prst="line">
+            <a:avLst/>
+          </a:prstGeom>
+          <a:ln w="28575">
+            <a:solidFill>
+              <a:srgbClr val="8E6F3E"/>
+            </a:solidFill>
+            <a:tailEnd type="triangle" w="med" len="med"/>
+          </a:ln>
+        </p:spPr>
+        <p:style>
+          <a:lnRef idx="2">
+            <a:schemeClr val="accent1"/>
+          </a:lnRef>
+          <a:fillRef idx="0">
+            <a:schemeClr val="accent1"/>
+          </a:fillRef>
+          <a:effectRef idx="1">
+            <a:schemeClr val="accent1"/>
+          </a:effectRef>
+          <a:fontRef idx="minor">
+            <a:schemeClr val="tx1"/>
+          </a:fontRef>
+        </p:style>
+      </p:cxnSp>
+      <p:cxnSp>
+        <p:nvCxnSpPr>
+          <p:cNvPr id="24" name="RM-Conn3"/>
+          <p:cNvCxnSpPr/>
+          <p:nvPr/>
+        </p:nvCxnSpPr>
+        <p:spPr>
+          <a:xfrm>
+            <a:off x="4572000" y="1719072"/>
+            <a:ext cx="2926079" cy="521208"/>
+          </a:xfrm>
+          <a:prstGeom prst="line">
+            <a:avLst/>
+          </a:prstGeom>
+          <a:ln w="28575">
+            <a:solidFill>
+              <a:srgbClr val="8E6F3E"/>
+            </a:solidFill>
+            <a:tailEnd type="triangle" w="med" len="med"/>
+          </a:ln>
+        </p:spPr>
+        <p:style>
+          <a:lnRef idx="2">
+            <a:schemeClr val="accent1"/>
+          </a:lnRef>
+          <a:fillRef idx="0">
+            <a:schemeClr val="accent1"/>
+          </a:fillRef>
+          <a:effectRef idx="1">
+            <a:schemeClr val="accent1"/>
+          </a:effectRef>
+          <a:fontRef idx="minor">
+            <a:schemeClr val="tx1"/>
+          </a:fontRef>
+        </p:style>
+      </p:cxnSp>
+      <p:cxnSp>
+        <p:nvCxnSpPr>
+          <p:cNvPr id="25" name="RM-Conn4"/>
+          <p:cNvCxnSpPr/>
+          <p:nvPr/>
+        </p:nvCxnSpPr>
+        <p:spPr>
+          <a:xfrm>
+            <a:off x="1645920" y="3200400"/>
+            <a:ext cx="2377440" cy="566928"/>
+          </a:xfrm>
+          <a:prstGeom prst="line">
+            <a:avLst/>
+          </a:prstGeom>
+          <a:ln w="28575">
+            <a:solidFill>
+              <a:srgbClr val="8E6F3E"/>
+            </a:solidFill>
+            <a:tailEnd type="triangle" w="med" len="med"/>
+          </a:ln>
+        </p:spPr>
+        <p:style>
+          <a:lnRef idx="2">
+            <a:schemeClr val="accent1"/>
+          </a:lnRef>
+          <a:fillRef idx="0">
+            <a:schemeClr val="accent1"/>
+          </a:fillRef>
+          <a:effectRef idx="1">
+            <a:schemeClr val="accent1"/>
+          </a:effectRef>
+          <a:fontRef idx="minor">
+            <a:schemeClr val="tx1"/>
+          </a:fontRef>
+        </p:style>
+      </p:cxnSp>
+      <p:cxnSp>
+        <p:nvCxnSpPr>
+          <p:cNvPr id="26" name="RM-Conn5"/>
+          <p:cNvCxnSpPr/>
+          <p:nvPr/>
+        </p:nvCxnSpPr>
+        <p:spPr>
+          <a:xfrm>
+            <a:off x="4572000" y="3200400"/>
+            <a:ext cx="0" cy="566928"/>
+          </a:xfrm>
+          <a:prstGeom prst="line">
+            <a:avLst/>
+          </a:prstGeom>
+          <a:ln w="28575">
+            <a:solidFill>
+              <a:srgbClr val="8E6F3E"/>
+            </a:solidFill>
+            <a:tailEnd type="triangle" w="med" len="med"/>
+          </a:ln>
+        </p:spPr>
+        <p:style>
+          <a:lnRef idx="2">
+            <a:schemeClr val="accent1"/>
+          </a:lnRef>
+          <a:fillRef idx="0">
+            <a:schemeClr val="accent1"/>
+          </a:fillRef>
+          <a:effectRef idx="1">
+            <a:schemeClr val="accent1"/>
+          </a:effectRef>
+          <a:fontRef idx="minor">
+            <a:schemeClr val="tx1"/>
+          </a:fontRef>
+        </p:style>
+      </p:cxnSp>
+      <p:cxnSp>
+        <p:nvCxnSpPr>
+          <p:cNvPr id="27" name="RM-Conn6"/>
+          <p:cNvCxnSpPr/>
+          <p:nvPr/>
+        </p:nvCxnSpPr>
+        <p:spPr>
+          <a:xfrm flipH="1">
+            <a:off x="5120640" y="3200400"/>
+            <a:ext cx="2377439" cy="566928"/>
+          </a:xfrm>
+          <a:prstGeom prst="line">
+            <a:avLst/>
+          </a:prstGeom>
+          <a:ln w="28575">
+            <a:solidFill>
+              <a:srgbClr val="8E6F3E"/>
+            </a:solidFill>
+            <a:tailEnd type="triangle" w="med" len="med"/>
+          </a:ln>
+        </p:spPr>
+        <p:style>
+          <a:lnRef idx="2">
+            <a:schemeClr val="accent1"/>
+          </a:lnRef>
+          <a:fillRef idx="0">
+            <a:schemeClr val="accent1"/>
+          </a:fillRef>
+          <a:effectRef idx="1">
+            <a:schemeClr val="accent1"/>
+          </a:effectRef>
+          <a:fontRef idx="minor">
+            <a:schemeClr val="tx1"/>
+          </a:fontRef>
+        </p:style>
+      </p:cxnSp>
+      <p:sp>
+        <p:nvSpPr>
+          <p:cNvPr id="28" name="MC-Optional"/>
           <p:cNvSpPr txBox="1"/>
           <p:nvPr/>
         </p:nvSpPr>
         <p:spPr>
           <a:xfrm>
-            <a:off x="3383280" y="3364992"/>
-            <a:ext cx="5440680" cy="731520"/>
+            <a:off x="5989320" y="3438144"/>
+            <a:ext cx="1234440" cy="274320"/>
           </a:xfrm>
           <a:prstGeom prst="rect">
             <a:avLst/>
@@ -17882,39 +18655,37 @@
           </a:bodyPr>
           <a:lstStyle/>
           <a:p>
-            <a:pPr algn="l"/>
-            <a:r>
-              <a:rPr sz="2000" b="0" i="0">
-                <a:solidFill>
-                  <a:srgbClr val="5C4826"/>
-                </a:solidFill>
-              </a:rPr>
-              <a:t>realization choices that do not matter</a:t>
-            </a:r>
-          </a:p>
-        </p:txBody>
-      </p:sp>
-      <p:sp>
-        <p:nvSpPr>
-          <p:cNvPr id="12" name="Rectangle 11"/>
+            <a:pPr algn="ctr"/>
+            <a:r>
+              <a:rPr sz="1200" b="0" i="1">
+                <a:solidFill>
+                  <a:srgbClr val="555960"/>
+                </a:solidFill>
+              </a:rPr>
+              <a:t>optional</a:t>
+            </a:r>
+          </a:p>
+        </p:txBody>
+      </p:sp>
+      <p:sp>
+        <p:nvSpPr>
+          <p:cNvPr id="29" name="MC-GateOpt"/>
           <p:cNvSpPr/>
           <p:nvPr/>
         </p:nvSpPr>
         <p:spPr>
           <a:xfrm>
-            <a:off x="640080" y="4169664"/>
-            <a:ext cx="2560320" cy="731520"/>
+            <a:off x="5989320" y="3767328"/>
+            <a:ext cx="1234440" cy="566928"/>
           </a:xfrm>
           <a:prstGeom prst="rect">
             <a:avLst/>
           </a:prstGeom>
           <a:solidFill>
-            <a:srgbClr val="F5F1E8"/>
+            <a:srgbClr val="8E6F3E"/>
           </a:solidFill>
-          <a:ln w="12700">
-            <a:solidFill>
-              <a:srgbClr val="C9B991"/>
-            </a:solidFill>
+          <a:ln>
+            <a:noFill/>
           </a:ln>
           <a:effectLst/>
         </p:spPr>
@@ -17938,136 +18709,53 @@
           <a:p>
             <a:pPr algn="ctr"/>
             <a:r>
-              <a:rPr sz="1800" b="1" i="0">
-                <a:solidFill>
-                  <a:srgbClr val="5C4826"/>
-                </a:solidFill>
-              </a:rPr>
-              <a:t>ENABLE</a:t>
-            </a:r>
-          </a:p>
-        </p:txBody>
-      </p:sp>
-      <p:sp>
-        <p:nvSpPr>
-          <p:cNvPr id="13" name="TextBox 12"/>
-          <p:cNvSpPr txBox="1"/>
-          <p:nvPr/>
-        </p:nvSpPr>
-        <p:spPr>
-          <a:xfrm>
-            <a:off x="3383280" y="4297680"/>
-            <a:ext cx="5440680" cy="731520"/>
-          </a:xfrm>
-          <a:prstGeom prst="rect">
-            <a:avLst/>
-          </a:prstGeom>
-          <a:noFill/>
-        </p:spPr>
-        <p:txBody>
-          <a:bodyPr wrap="square" anchor="t">
-            <a:spAutoFit/>
-          </a:bodyPr>
-          <a:lstStyle/>
-          <a:p>
-            <a:pPr algn="l"/>
-            <a:r>
-              <a:rPr sz="2000" b="0" i="0">
-                <a:solidFill>
-                  <a:srgbClr val="5C4826"/>
-                </a:solidFill>
-              </a:rPr>
-              <a:t>evaluations that otherwise require reconstruction</a:t>
-            </a:r>
-          </a:p>
-        </p:txBody>
-      </p:sp>
-      <p:sp>
-        <p:nvSpPr>
-          <p:cNvPr id="14" name="TextBox 13"/>
-          <p:cNvSpPr txBox="1"/>
-          <p:nvPr/>
-        </p:nvSpPr>
-        <p:spPr>
-          <a:xfrm>
-            <a:off x="274320" y="5010912"/>
-            <a:ext cx="8595360" cy="411480"/>
-          </a:xfrm>
-          <a:prstGeom prst="rect">
-            <a:avLst/>
-          </a:prstGeom>
-          <a:noFill/>
-        </p:spPr>
-        <p:txBody>
-          <a:bodyPr wrap="square" anchor="t">
-            <a:spAutoFit/>
-          </a:bodyPr>
-          <a:lstStyle/>
-          <a:p>
-            <a:pPr algn="ctr"/>
-            <a:r>
-              <a:rPr sz="2000" b="0" i="1">
-                <a:solidFill>
-                  <a:srgbClr val="555960"/>
-                </a:solidFill>
-              </a:rPr>
-              <a:t>Different analyses can then operate over the same engineering knowledge.</a:t>
-            </a:r>
-          </a:p>
-        </p:txBody>
-      </p:sp>
-      <p:sp>
-        <p:nvSpPr>
-          <p:cNvPr id="15" name="FooterBand"/>
-          <p:cNvSpPr/>
-          <p:nvPr/>
-        </p:nvSpPr>
-        <p:spPr>
-          <a:xfrm>
-            <a:off x="274320" y="5852160"/>
-            <a:ext cx="8595360" cy="566928"/>
-          </a:xfrm>
-          <a:prstGeom prst="rect">
-            <a:avLst/>
-          </a:prstGeom>
-          <a:solidFill>
-            <a:srgbClr val="8E6F3E"/>
-          </a:solidFill>
-          <a:ln>
-            <a:noFill/>
+              <a:rPr sz="1600" b="1" i="0">
+                <a:solidFill>
+                  <a:srgbClr val="FFFFFF"/>
+                </a:solidFill>
+              </a:rPr>
+              <a:t>GATE</a:t>
+            </a:r>
+          </a:p>
+        </p:txBody>
+      </p:sp>
+      <p:cxnSp>
+        <p:nvCxnSpPr>
+          <p:cNvPr id="30" name="MC-VGArrow"/>
+          <p:cNvCxnSpPr/>
+          <p:nvPr/>
+        </p:nvCxnSpPr>
+        <p:spPr>
+          <a:xfrm>
+            <a:off x="5468112" y="4050791"/>
+            <a:ext cx="457200" cy="0"/>
+          </a:xfrm>
+          <a:prstGeom prst="line">
+            <a:avLst/>
+          </a:prstGeom>
+          <a:ln w="28575">
+            <a:solidFill>
+              <a:srgbClr val="8E6F3E"/>
+            </a:solidFill>
+            <a:tailEnd type="triangle" w="med" len="med"/>
           </a:ln>
           <a:effectLst/>
         </p:spPr>
         <p:style>
-          <a:lnRef idx="1">
+          <a:lnRef idx="2">
             <a:schemeClr val="accent1"/>
           </a:lnRef>
-          <a:fillRef idx="3">
+          <a:fillRef idx="0">
             <a:schemeClr val="accent1"/>
           </a:fillRef>
-          <a:effectRef idx="2">
+          <a:effectRef idx="1">
             <a:schemeClr val="accent1"/>
           </a:effectRef>
           <a:fontRef idx="minor">
-            <a:schemeClr val="lt1"/>
+            <a:schemeClr val="tx1"/>
           </a:fontRef>
         </p:style>
-        <p:txBody>
-          <a:bodyPr rtlCol="0" anchor="ctr" wrap="square"/>
-          <a:lstStyle/>
-          <a:p>
-            <a:pPr algn="ctr"/>
-            <a:r>
-              <a:rPr sz="2000" b="1" i="0">
-                <a:solidFill>
-                  <a:srgbClr val="FFFFFF"/>
-                </a:solidFill>
-              </a:rPr>
-              <a:t>Explicit structure can turn reconstruction into inspection.</a:t>
-            </a:r>
-          </a:p>
-        </p:txBody>
-      </p:sp>
+      </p:cxnSp>
     </p:spTree>
   </p:cSld>
   <p:clrMapOvr>
@@ -18088,23 +18776,6 @@
       <p:grpSpPr/>
       <p:sp>
         <p:nvSpPr>
-          <p:cNvPr id="2" name="Content Placeholder 1"/>
-          <p:cNvSpPr>
-            <a:spLocks noGrp="1"/>
-          </p:cNvSpPr>
-          <p:nvPr>
-            <p:ph idx="1"/>
-          </p:nvPr>
-        </p:nvSpPr>
-        <p:spPr/>
-        <p:txBody>
-          <a:bodyPr/>
-          <a:lstStyle/>
-          <a:p/>
-        </p:txBody>
-      </p:sp>
-      <p:sp>
-        <p:nvSpPr>
           <p:cNvPr id="3" name="Title 2"/>
           <p:cNvSpPr>
             <a:spLocks noGrp="1"/>
@@ -18115,60 +18786,53 @@
         </p:nvSpPr>
         <p:spPr/>
         <p:txBody>
+          <a:bodyPr wrap="square"/>
+          <a:lstStyle/>
+          <a:p>
+            <a:r>
+              <a:rPr sz="2400" b="0">
+                <a:solidFill>
+                  <a:srgbClr val="000000"/>
+                </a:solidFill>
+              </a:rPr>
+              <a:t>Agreement is not correctness</a:t>
+            </a:r>
+          </a:p>
+        </p:txBody>
+      </p:sp>
+      <p:sp>
+        <p:nvSpPr>
+          <p:cNvPr id="4" name="Slide Number Placeholder 5"/>
+          <p:cNvSpPr>
+            <a:spLocks noGrp="1"/>
+          </p:cNvSpPr>
+          <p:nvPr>
+            <p:ph type="sldNum" sz="quarter" idx="4"/>
+          </p:nvPr>
+        </p:nvSpPr>
+        <p:spPr/>
+        <p:txBody>
           <a:bodyPr/>
           <a:lstStyle/>
           <a:p>
-            <a:r>
-              <a:rPr sz="2400"/>
-              <a:t>Models can drive controls</a:t>
-            </a:r>
-          </a:p>
-        </p:txBody>
-      </p:sp>
-      <p:sp>
-        <p:nvSpPr>
-          <p:cNvPr id="14" name="MCVerdicts"/>
-          <p:cNvSpPr txBox="1"/>
-          <p:nvPr/>
-        </p:nvSpPr>
-        <p:spPr>
-          <a:xfrm>
-            <a:off x="5532120" y="3886200"/>
-            <a:ext cx="1097280" cy="320040"/>
-          </a:xfrm>
-          <a:prstGeom prst="rect">
-            <a:avLst/>
-          </a:prstGeom>
-          <a:noFill/>
-        </p:spPr>
-        <p:txBody>
-          <a:bodyPr wrap="square" anchor="t">
-            <a:spAutoFit/>
-          </a:bodyPr>
-          <a:lstStyle/>
-          <a:p>
-            <a:pPr algn="l"/>
-            <a:r>
-              <a:rPr sz="1400" b="0" i="0">
-                <a:solidFill>
-                  <a:srgbClr val="555960"/>
-                </a:solidFill>
-              </a:rPr>
-              <a:t>verdicts</a:t>
-            </a:r>
-          </a:p>
-        </p:txBody>
-      </p:sp>
-      <p:sp>
-        <p:nvSpPr>
-          <p:cNvPr id="15" name="MCGate"/>
+            <a:fld id="{B7EB45DA-9A0D-DC49-8E02-F30A5DDC21C3}" type="slidenum">
+              <a:rPr lang="en-US" smtClean="0"/>
+              <a:t>1</a:t>
+            </a:fld>
+            <a:endParaRPr lang="en-US"/>
+          </a:p>
+        </p:txBody>
+      </p:sp>
+      <p:sp>
+        <p:nvSpPr>
+          <p:cNvPr id="9" name="FooterBand"/>
           <p:cNvSpPr/>
           <p:nvPr/>
         </p:nvSpPr>
         <p:spPr>
           <a:xfrm>
-            <a:off x="3749039" y="3767328"/>
-            <a:ext cx="1645920" cy="566928"/>
+            <a:off x="274320" y="5852160"/>
+            <a:ext cx="8595360" cy="566928"/>
           </a:xfrm>
           <a:prstGeom prst="rect">
             <a:avLst/>
@@ -18196,31 +18860,31 @@
           </a:fontRef>
         </p:style>
         <p:txBody>
-          <a:bodyPr rtlCol="0" anchor="ctr" wrap="square" lIns="27432" rIns="27432" tIns="22860" bIns="22860"/>
+          <a:bodyPr rtlCol="0" anchor="ctr" wrap="square"/>
           <a:lstStyle/>
           <a:p>
             <a:pPr algn="ctr"/>
             <a:r>
-              <a:rPr sz="1600" b="1" i="0">
+              <a:rPr sz="2000" b="1" i="0">
                 <a:solidFill>
                   <a:srgbClr val="FFFFFF"/>
                 </a:solidFill>
               </a:rPr>
-              <a:t>GATE</a:t>
-            </a:r>
-          </a:p>
-        </p:txBody>
-      </p:sp>
-      <p:sp>
-        <p:nvSpPr>
-          <p:cNvPr id="16" name="MCPoint"/>
+              <a:t>Evidence for one does not establish the others.</a:t>
+            </a:r>
+          </a:p>
+        </p:txBody>
+      </p:sp>
+      <p:sp>
+        <p:nvSpPr>
+          <p:cNvPr id="15" name="TR-Label1"/>
           <p:cNvSpPr txBox="1"/>
           <p:nvPr/>
         </p:nvSpPr>
         <p:spPr>
           <a:xfrm>
-            <a:off x="502920" y="4572000"/>
-            <a:ext cx="8138160" cy="548640"/>
+            <a:off x="320040" y="1353312"/>
+            <a:ext cx="2697480" cy="457200"/>
           </a:xfrm>
           <a:prstGeom prst="rect">
             <a:avLst/>
@@ -18233,143 +18897,28 @@
           </a:bodyPr>
           <a:lstStyle/>
           <a:p>
-            <a:pPr algn="ctr"/>
-            <a:r>
-              <a:rPr sz="2000" b="0" i="0">
-                <a:solidFill>
-                  <a:srgbClr val="5C4826"/>
-                </a:solidFill>
-              </a:rPr>
-              <a:t>The same explicit engineering knowledge can support multiple validators and constraints.</a:t>
-            </a:r>
-          </a:p>
-        </p:txBody>
-      </p:sp>
-      <p:sp>
-        <p:nvSpPr>
-          <p:cNvPr id="17" name="FooterBand"/>
+            <a:pPr algn="l"/>
+            <a:r>
+              <a:rPr sz="2200" b="1" i="0">
+                <a:solidFill>
+                  <a:srgbClr val="8E6F3E"/>
+                </a:solidFill>
+              </a:rPr>
+              <a:t>CORRESPONDENCE</a:t>
+            </a:r>
+          </a:p>
+        </p:txBody>
+      </p:sp>
+      <p:sp>
+        <p:nvSpPr>
+          <p:cNvPr id="16" name="TR-Box1a"/>
           <p:cNvSpPr/>
           <p:nvPr/>
         </p:nvSpPr>
         <p:spPr>
           <a:xfrm>
-            <a:off x="274320" y="5852160"/>
-            <a:ext cx="8595360" cy="566928"/>
-          </a:xfrm>
-          <a:prstGeom prst="rect">
-            <a:avLst/>
-          </a:prstGeom>
-          <a:solidFill>
-            <a:srgbClr val="8E6F3E"/>
-          </a:solidFill>
-          <a:ln>
-            <a:noFill/>
-          </a:ln>
-          <a:effectLst/>
-        </p:spPr>
-        <p:style>
-          <a:lnRef idx="1">
-            <a:schemeClr val="accent1"/>
-          </a:lnRef>
-          <a:fillRef idx="3">
-            <a:schemeClr val="accent1"/>
-          </a:fillRef>
-          <a:effectRef idx="2">
-            <a:schemeClr val="accent1"/>
-          </a:effectRef>
-          <a:fontRef idx="minor">
-            <a:schemeClr val="lt1"/>
-          </a:fontRef>
-        </p:style>
-        <p:txBody>
-          <a:bodyPr rtlCol="0" anchor="ctr" wrap="square" lIns="27432" rIns="27432" tIns="22860" bIns="22860"/>
-          <a:lstStyle/>
-          <a:p>
-            <a:pPr algn="ctr"/>
-            <a:r>
-              <a:rPr sz="2000" b="1" i="0">
-                <a:solidFill>
-                  <a:srgbClr val="FFFFFF"/>
-                </a:solidFill>
-              </a:rPr>
-              <a:t>A model becomes operational when the engineered environment uses it.</a:t>
-            </a:r>
-          </a:p>
-        </p:txBody>
-      </p:sp>
-      <p:sp>
-        <p:nvSpPr>
-          <p:cNvPr id="18" name="RealModel"/>
-          <p:cNvSpPr/>
-          <p:nvPr/>
-        </p:nvSpPr>
-        <p:spPr>
-          <a:xfrm>
-            <a:off x="2103120" y="914400"/>
-            <a:ext cx="4937760" cy="804672"/>
-          </a:xfrm>
-          <a:prstGeom prst="rect">
-            <a:avLst/>
-          </a:prstGeom>
-          <a:solidFill>
-            <a:srgbClr val="8E6F3E"/>
-          </a:solidFill>
-          <a:ln>
-            <a:noFill/>
-          </a:ln>
-          <a:effectLst/>
-        </p:spPr>
-        <p:style>
-          <a:lnRef idx="1">
-            <a:schemeClr val="accent1"/>
-          </a:lnRef>
-          <a:fillRef idx="3">
-            <a:schemeClr val="accent1"/>
-          </a:fillRef>
-          <a:effectRef idx="2">
-            <a:schemeClr val="accent1"/>
-          </a:effectRef>
-          <a:fontRef idx="minor">
-            <a:schemeClr val="lt1"/>
-          </a:fontRef>
-        </p:style>
-        <p:txBody>
-          <a:bodyPr rtlCol="0" anchor="ctr" wrap="square" lIns="27432" rIns="27432" tIns="22860" bIns="22860"/>
-          <a:lstStyle/>
-          <a:p>
-            <a:pPr algn="ctr"/>
-            <a:r>
-              <a:rPr sz="1400" b="1" i="0">
-                <a:solidFill>
-                  <a:srgbClr val="FFFFFF"/>
-                </a:solidFill>
-              </a:rPr>
-              <a:t>DOCUMENT PROCESSING SERVICE</a:t>
-            </a:r>
-          </a:p>
-          <a:p>
-            <a:pPr algn="ctr"/>
-            <a:r>
-              <a:rPr sz="1050" b="0" i="1">
-                <a:solidFill>
-                  <a:srgbClr val="FBF8F2"/>
-                </a:solidFill>
-              </a:rPr>
-              <a:t>one explicit model: lifecycle machine + resource graph</a:t>
-            </a:r>
-          </a:p>
-        </p:txBody>
-      </p:sp>
-      <p:sp>
-        <p:nvSpPr>
-          <p:cNvPr id="19" name="MC-lifecycle"/>
-          <p:cNvSpPr/>
-          <p:nvPr/>
-        </p:nvSpPr>
-        <p:spPr>
-          <a:xfrm>
-            <a:off x="411480" y="2240280"/>
-            <a:ext cx="2468880" cy="960120"/>
+            <a:off x="3108960" y="1280160"/>
+            <a:ext cx="1965960" cy="731520"/>
           </a:xfrm>
           <a:prstGeom prst="rect">
             <a:avLst/>
@@ -18404,37 +18953,26 @@
           <a:p>
             <a:pPr algn="ctr"/>
             <a:r>
-              <a:rPr sz="1200" b="1" i="0">
+              <a:rPr sz="1500" b="0" i="0">
                 <a:solidFill>
                   <a:srgbClr val="5C4826"/>
                 </a:solidFill>
               </a:rPr>
-              <a:t>LIFECYCLE CHECK</a:t>
-            </a:r>
-          </a:p>
-          <a:p>
-            <a:pPr algn="ctr"/>
-            <a:r>
-              <a:rPr sz="950" b="0" i="0">
-                <a:solidFill>
-                  <a:srgbClr val="555960"/>
-                </a:solidFill>
-              </a:rPr>
-              <a:t>can a Completed document ever be processed again?  no</a:t>
-            </a:r>
-          </a:p>
-        </p:txBody>
-      </p:sp>
-      <p:sp>
-        <p:nvSpPr>
-          <p:cNvPr id="20" name="MC-retry"/>
+              <a:t>implementation</a:t>
+            </a:r>
+          </a:p>
+        </p:txBody>
+      </p:sp>
+      <p:sp>
+        <p:nvSpPr>
+          <p:cNvPr id="17" name="TR-Box1b"/>
           <p:cNvSpPr/>
           <p:nvPr/>
         </p:nvSpPr>
         <p:spPr>
           <a:xfrm>
-            <a:off x="3337560" y="2240280"/>
-            <a:ext cx="2468880" cy="960120"/>
+            <a:off x="5989320" y="1280160"/>
+            <a:ext cx="2834640" cy="731520"/>
           </a:xfrm>
           <a:prstGeom prst="rect">
             <a:avLst/>
@@ -18469,37 +19007,132 @@
           <a:p>
             <a:pPr algn="ctr"/>
             <a:r>
-              <a:rPr sz="1200" b="1" i="0">
+              <a:rPr sz="1500" b="0" i="0">
                 <a:solidFill>
                   <a:srgbClr val="5C4826"/>
                 </a:solidFill>
               </a:rPr>
-              <a:t>RETRY BOUND</a:t>
-            </a:r>
-          </a:p>
+              <a:t>representation</a:t>
+            </a:r>
+          </a:p>
+        </p:txBody>
+      </p:sp>
+      <p:cxnSp>
+        <p:nvCxnSpPr>
+          <p:cNvPr id="18" name="TR-Arrow1"/>
+          <p:cNvCxnSpPr/>
+          <p:nvPr/>
+        </p:nvCxnSpPr>
+        <p:spPr>
+          <a:xfrm>
+            <a:off x="5138928" y="1645920"/>
+            <a:ext cx="786384" cy="0"/>
+          </a:xfrm>
+          <a:prstGeom prst="line">
+            <a:avLst/>
+          </a:prstGeom>
+          <a:ln w="28575">
+            <a:solidFill>
+              <a:srgbClr val="8E6F3E"/>
+            </a:solidFill>
+            <a:headEnd type="triangle" w="med" len="med"/>
+            <a:tailEnd type="triangle" w="med" len="med"/>
+          </a:ln>
+          <a:effectLst/>
+        </p:spPr>
+        <p:style>
+          <a:lnRef idx="2">
+            <a:schemeClr val="accent1"/>
+          </a:lnRef>
+          <a:fillRef idx="0">
+            <a:schemeClr val="accent1"/>
+          </a:fillRef>
+          <a:effectRef idx="1">
+            <a:schemeClr val="accent1"/>
+          </a:effectRef>
+          <a:fontRef idx="minor">
+            <a:schemeClr val="tx1"/>
+          </a:fontRef>
+        </p:style>
+      </p:cxnSp>
+      <p:sp>
+        <p:nvSpPr>
+          <p:cNvPr id="19" name="TR-Q1"/>
+          <p:cNvSpPr txBox="1"/>
+          <p:nvPr/>
+        </p:nvSpPr>
+        <p:spPr>
+          <a:xfrm>
+            <a:off x="4617720" y="1097280"/>
+            <a:ext cx="1828800" cy="292608"/>
+          </a:xfrm>
+          <a:prstGeom prst="rect">
+            <a:avLst/>
+          </a:prstGeom>
+          <a:noFill/>
+        </p:spPr>
+        <p:txBody>
+          <a:bodyPr wrap="square" anchor="t">
+            <a:spAutoFit/>
+          </a:bodyPr>
+          <a:lstStyle/>
           <a:p>
             <a:pPr algn="ctr"/>
             <a:r>
-              <a:rPr sz="950" b="0" i="0">
+              <a:rPr sz="1200" b="0" i="1">
                 <a:solidFill>
                   <a:srgbClr val="555960"/>
                 </a:solidFill>
               </a:rPr>
-              <a:t>can the retry loop run forever?  no — at most 2 retries</a:t>
-            </a:r>
-          </a:p>
-        </p:txBody>
-      </p:sp>
-      <p:sp>
-        <p:nvSpPr>
-          <p:cNvPr id="21" name="MC-memory"/>
+              <a:t>do they agree?</a:t>
+            </a:r>
+          </a:p>
+        </p:txBody>
+      </p:sp>
+      <p:sp>
+        <p:nvSpPr>
+          <p:cNvPr id="20" name="TR-Label2"/>
+          <p:cNvSpPr txBox="1"/>
+          <p:nvPr/>
+        </p:nvSpPr>
+        <p:spPr>
+          <a:xfrm>
+            <a:off x="320040" y="2953512"/>
+            <a:ext cx="2697480" cy="457200"/>
+          </a:xfrm>
+          <a:prstGeom prst="rect">
+            <a:avLst/>
+          </a:prstGeom>
+          <a:noFill/>
+        </p:spPr>
+        <p:txBody>
+          <a:bodyPr wrap="square" anchor="t">
+            <a:spAutoFit/>
+          </a:bodyPr>
+          <a:lstStyle/>
+          <a:p>
+            <a:pPr algn="l"/>
+            <a:r>
+              <a:rPr sz="2200" b="1" i="0">
+                <a:solidFill>
+                  <a:srgbClr val="8E6F3E"/>
+                </a:solidFill>
+              </a:rPr>
+              <a:t>CONFORMANCE</a:t>
+            </a:r>
+          </a:p>
+        </p:txBody>
+      </p:sp>
+      <p:sp>
+        <p:nvSpPr>
+          <p:cNvPr id="21" name="TR-Box2a"/>
           <p:cNvSpPr/>
           <p:nvPr/>
         </p:nvSpPr>
         <p:spPr>
           <a:xfrm>
-            <a:off x="6263640" y="2240280"/>
-            <a:ext cx="2468880" cy="960120"/>
+            <a:off x="3108960" y="2880360"/>
+            <a:ext cx="1965960" cy="731520"/>
           </a:xfrm>
           <a:prstGeom prst="rect">
             <a:avLst/>
@@ -18534,37 +19167,80 @@
           <a:p>
             <a:pPr algn="ctr"/>
             <a:r>
-              <a:rPr sz="1200" b="1" i="0">
+              <a:rPr sz="1500" b="0" i="0">
                 <a:solidFill>
                   <a:srgbClr val="5C4826"/>
                 </a:solidFill>
               </a:rPr>
-              <a:t>MEMORY ANALYSIS</a:t>
-            </a:r>
-          </a:p>
+              <a:t>artifact</a:t>
+            </a:r>
+          </a:p>
+        </p:txBody>
+      </p:sp>
+      <p:sp>
+        <p:nvSpPr>
+          <p:cNvPr id="22" name="TR-Box2b"/>
+          <p:cNvSpPr/>
+          <p:nvPr/>
+        </p:nvSpPr>
+        <p:spPr>
+          <a:xfrm>
+            <a:off x="5989320" y="2880360"/>
+            <a:ext cx="2834640" cy="731520"/>
+          </a:xfrm>
+          <a:prstGeom prst="rect">
+            <a:avLst/>
+          </a:prstGeom>
+          <a:solidFill>
+            <a:srgbClr val="F5F1E8"/>
+          </a:solidFill>
+          <a:ln w="12700">
+            <a:solidFill>
+              <a:srgbClr val="C9B991"/>
+            </a:solidFill>
+          </a:ln>
+          <a:effectLst/>
+        </p:spPr>
+        <p:style>
+          <a:lnRef idx="1">
+            <a:schemeClr val="accent1"/>
+          </a:lnRef>
+          <a:fillRef idx="3">
+            <a:schemeClr val="accent1"/>
+          </a:fillRef>
+          <a:effectRef idx="2">
+            <a:schemeClr val="accent1"/>
+          </a:effectRef>
+          <a:fontRef idx="minor">
+            <a:schemeClr val="lt1"/>
+          </a:fontRef>
+        </p:style>
+        <p:txBody>
+          <a:bodyPr rtlCol="0" anchor="ctr" wrap="square" lIns="27432" rIns="27432" tIns="22860" bIns="22860"/>
+          <a:lstStyle/>
           <a:p>
             <a:pPr algn="ctr"/>
             <a:r>
-              <a:rPr sz="950" b="0" i="0">
-                <a:solidFill>
-                  <a:srgbClr val="555960"/>
-                </a:solidFill>
-              </a:rPr>
-              <a:t>peak demand 2 × 384 MB — within the 1 GB worker ceiling</a:t>
+              <a:rPr sz="1500" b="0" i="0">
+                <a:solidFill>
+                  <a:srgbClr val="5C4826"/>
+                </a:solidFill>
+              </a:rPr>
+              <a:t>independent obligation</a:t>
             </a:r>
           </a:p>
         </p:txBody>
       </p:sp>
       <p:cxnSp>
         <p:nvCxnSpPr>
-          <p:cNvPr id="22" name="RM-Conn1"/>
+          <p:cNvPr id="23" name="TR-Arrow2"/>
           <p:cNvCxnSpPr/>
           <p:nvPr/>
         </p:nvCxnSpPr>
         <p:spPr>
-          <a:xfrm flipH="1">
-            <a:off x="1645920" y="1719072"/>
-            <a:ext cx="2926080" cy="521208"/>
+          <a:xfrm>
+            <a:off x="5138928" y="3246120"/>
+            <a:ext cx="786384" cy="0"/>
           </a:xfrm>
           <a:prstGeom prst="line">
             <a:avLst/>
@@ -18575,6 +19251,7 @@
             </a:solidFill>
             <a:tailEnd type="triangle" w="med" len="med"/>
           </a:ln>
+          <a:effectLst/>
         </p:spPr>
         <p:style>
           <a:lnRef idx="2">
@@ -18591,16 +19268,192 @@
           </a:fontRef>
         </p:style>
       </p:cxnSp>
+      <p:sp>
+        <p:nvSpPr>
+          <p:cNvPr id="24" name="TR-Q2"/>
+          <p:cNvSpPr txBox="1"/>
+          <p:nvPr/>
+        </p:nvSpPr>
+        <p:spPr>
+          <a:xfrm>
+            <a:off x="4617720" y="2697480"/>
+            <a:ext cx="1828800" cy="292608"/>
+          </a:xfrm>
+          <a:prstGeom prst="rect">
+            <a:avLst/>
+          </a:prstGeom>
+          <a:noFill/>
+        </p:spPr>
+        <p:txBody>
+          <a:bodyPr wrap="square" anchor="t">
+            <a:spAutoFit/>
+          </a:bodyPr>
+          <a:lstStyle/>
+          <a:p>
+            <a:pPr algn="ctr"/>
+            <a:r>
+              <a:rPr sz="1200" b="0" i="1">
+                <a:solidFill>
+                  <a:srgbClr val="555960"/>
+                </a:solidFill>
+              </a:rPr>
+              <a:t>does it satisfy?</a:t>
+            </a:r>
+          </a:p>
+        </p:txBody>
+      </p:sp>
+      <p:sp>
+        <p:nvSpPr>
+          <p:cNvPr id="25" name="TR-Label3"/>
+          <p:cNvSpPr txBox="1"/>
+          <p:nvPr/>
+        </p:nvSpPr>
+        <p:spPr>
+          <a:xfrm>
+            <a:off x="320040" y="4553712"/>
+            <a:ext cx="2697480" cy="457200"/>
+          </a:xfrm>
+          <a:prstGeom prst="rect">
+            <a:avLst/>
+          </a:prstGeom>
+          <a:noFill/>
+        </p:spPr>
+        <p:txBody>
+          <a:bodyPr wrap="square" anchor="t">
+            <a:spAutoFit/>
+          </a:bodyPr>
+          <a:lstStyle/>
+          <a:p>
+            <a:pPr algn="l"/>
+            <a:r>
+              <a:rPr sz="2200" b="1" i="0">
+                <a:solidFill>
+                  <a:srgbClr val="8E6F3E"/>
+                </a:solidFill>
+              </a:rPr>
+              <a:t>ACCEPTANCE</a:t>
+            </a:r>
+          </a:p>
+        </p:txBody>
+      </p:sp>
+      <p:sp>
+        <p:nvSpPr>
+          <p:cNvPr id="26" name="TR-Box3a"/>
+          <p:cNvSpPr/>
+          <p:nvPr/>
+        </p:nvSpPr>
+        <p:spPr>
+          <a:xfrm>
+            <a:off x="3108960" y="4480559"/>
+            <a:ext cx="1965960" cy="731520"/>
+          </a:xfrm>
+          <a:prstGeom prst="rect">
+            <a:avLst/>
+          </a:prstGeom>
+          <a:solidFill>
+            <a:srgbClr val="F5F1E8"/>
+          </a:solidFill>
+          <a:ln w="12700">
+            <a:solidFill>
+              <a:srgbClr val="C9B991"/>
+            </a:solidFill>
+          </a:ln>
+          <a:effectLst/>
+        </p:spPr>
+        <p:style>
+          <a:lnRef idx="1">
+            <a:schemeClr val="accent1"/>
+          </a:lnRef>
+          <a:fillRef idx="3">
+            <a:schemeClr val="accent1"/>
+          </a:fillRef>
+          <a:effectRef idx="2">
+            <a:schemeClr val="accent1"/>
+          </a:effectRef>
+          <a:fontRef idx="minor">
+            <a:schemeClr val="lt1"/>
+          </a:fontRef>
+        </p:style>
+        <p:txBody>
+          <a:bodyPr rtlCol="0" anchor="ctr" wrap="square" lIns="27432" rIns="27432" tIns="22860" bIns="22860"/>
+          <a:lstStyle/>
+          <a:p>
+            <a:pPr algn="ctr"/>
+            <a:r>
+              <a:rPr sz="1500" b="0" i="0">
+                <a:solidFill>
+                  <a:srgbClr val="5C4826"/>
+                </a:solidFill>
+              </a:rPr>
+              <a:t>artifact</a:t>
+            </a:r>
+          </a:p>
+        </p:txBody>
+      </p:sp>
+      <p:sp>
+        <p:nvSpPr>
+          <p:cNvPr id="27" name="TR-Box3b"/>
+          <p:cNvSpPr/>
+          <p:nvPr/>
+        </p:nvSpPr>
+        <p:spPr>
+          <a:xfrm>
+            <a:off x="5989320" y="4480559"/>
+            <a:ext cx="2834640" cy="731520"/>
+          </a:xfrm>
+          <a:prstGeom prst="rect">
+            <a:avLst/>
+          </a:prstGeom>
+          <a:solidFill>
+            <a:srgbClr val="F5F1E8"/>
+          </a:solidFill>
+          <a:ln w="12700">
+            <a:solidFill>
+              <a:srgbClr val="C9B991"/>
+            </a:solidFill>
+          </a:ln>
+          <a:effectLst/>
+        </p:spPr>
+        <p:style>
+          <a:lnRef idx="1">
+            <a:schemeClr val="accent1"/>
+          </a:lnRef>
+          <a:fillRef idx="3">
+            <a:schemeClr val="accent1"/>
+          </a:fillRef>
+          <a:effectRef idx="2">
+            <a:schemeClr val="accent1"/>
+          </a:effectRef>
+          <a:fontRef idx="minor">
+            <a:schemeClr val="lt1"/>
+          </a:fontRef>
+        </p:style>
+        <p:txBody>
+          <a:bodyPr rtlCol="0" anchor="ctr" wrap="square" lIns="27432" rIns="27432" tIns="22860" bIns="22860"/>
+          <a:lstStyle/>
+          <a:p>
+            <a:pPr algn="ctr"/>
+            <a:r>
+              <a:rPr sz="1500" b="0" i="0">
+                <a:solidFill>
+                  <a:srgbClr val="5C4826"/>
+                </a:solidFill>
+              </a:rPr>
+              <a:t>receiving environment</a:t>
+            </a:r>
+          </a:p>
+        </p:txBody>
+      </p:sp>
       <p:cxnSp>
         <p:nvCxnSpPr>
-          <p:cNvPr id="23" name="RM-Conn2"/>
+          <p:cNvPr id="28" name="TR-Arrow3"/>
           <p:cNvCxnSpPr/>
           <p:nvPr/>
         </p:nvCxnSpPr>
         <p:spPr>
           <a:xfrm>
-            <a:off x="4572000" y="1719072"/>
-            <a:ext cx="0" cy="521208"/>
+            <a:off x="5138928" y="4846320"/>
+            <a:ext cx="786384" cy="0"/>
           </a:xfrm>
           <a:prstGeom prst="line">
             <a:avLst/>
@@ -18611,6 +19464,7 @@
             </a:solidFill>
             <a:tailEnd type="triangle" w="med" len="med"/>
           </a:ln>
+          <a:effectLst/>
         </p:spPr>
         <p:style>
           <a:lnRef idx="2">
@@ -18627,150 +19481,40 @@
           </a:fontRef>
         </p:style>
       </p:cxnSp>
-      <p:cxnSp>
-        <p:nvCxnSpPr>
-          <p:cNvPr id="24" name="RM-Conn3"/>
-          <p:cNvCxnSpPr/>
-          <p:nvPr/>
-        </p:nvCxnSpPr>
-        <p:spPr>
-          <a:xfrm>
-            <a:off x="4572000" y="1719072"/>
-            <a:ext cx="2926079" cy="521208"/>
-          </a:xfrm>
-          <a:prstGeom prst="line">
-            <a:avLst/>
-          </a:prstGeom>
-          <a:ln w="28575">
-            <a:solidFill>
-              <a:srgbClr val="8E6F3E"/>
-            </a:solidFill>
-            <a:tailEnd type="triangle" w="med" len="med"/>
-          </a:ln>
-        </p:spPr>
-        <p:style>
-          <a:lnRef idx="2">
-            <a:schemeClr val="accent1"/>
-          </a:lnRef>
-          <a:fillRef idx="0">
-            <a:schemeClr val="accent1"/>
-          </a:fillRef>
-          <a:effectRef idx="1">
-            <a:schemeClr val="accent1"/>
-          </a:effectRef>
-          <a:fontRef idx="minor">
-            <a:schemeClr val="tx1"/>
-          </a:fontRef>
-        </p:style>
-      </p:cxnSp>
-      <p:cxnSp>
-        <p:nvCxnSpPr>
-          <p:cNvPr id="25" name="RM-Conn4"/>
-          <p:cNvCxnSpPr/>
-          <p:nvPr/>
-        </p:nvCxnSpPr>
-        <p:spPr>
-          <a:xfrm>
-            <a:off x="1645920" y="3200400"/>
-            <a:ext cx="2377440" cy="566928"/>
-          </a:xfrm>
-          <a:prstGeom prst="line">
-            <a:avLst/>
-          </a:prstGeom>
-          <a:ln w="28575">
-            <a:solidFill>
-              <a:srgbClr val="8E6F3E"/>
-            </a:solidFill>
-            <a:tailEnd type="triangle" w="med" len="med"/>
-          </a:ln>
-        </p:spPr>
-        <p:style>
-          <a:lnRef idx="2">
-            <a:schemeClr val="accent1"/>
-          </a:lnRef>
-          <a:fillRef idx="0">
-            <a:schemeClr val="accent1"/>
-          </a:fillRef>
-          <a:effectRef idx="1">
-            <a:schemeClr val="accent1"/>
-          </a:effectRef>
-          <a:fontRef idx="minor">
-            <a:schemeClr val="tx1"/>
-          </a:fontRef>
-        </p:style>
-      </p:cxnSp>
-      <p:cxnSp>
-        <p:nvCxnSpPr>
-          <p:cNvPr id="26" name="RM-Conn5"/>
-          <p:cNvCxnSpPr/>
-          <p:nvPr/>
-        </p:nvCxnSpPr>
-        <p:spPr>
-          <a:xfrm>
-            <a:off x="4572000" y="3200400"/>
-            <a:ext cx="0" cy="566928"/>
-          </a:xfrm>
-          <a:prstGeom prst="line">
-            <a:avLst/>
-          </a:prstGeom>
-          <a:ln w="28575">
-            <a:solidFill>
-              <a:srgbClr val="8E6F3E"/>
-            </a:solidFill>
-            <a:tailEnd type="triangle" w="med" len="med"/>
-          </a:ln>
-        </p:spPr>
-        <p:style>
-          <a:lnRef idx="2">
-            <a:schemeClr val="accent1"/>
-          </a:lnRef>
-          <a:fillRef idx="0">
-            <a:schemeClr val="accent1"/>
-          </a:fillRef>
-          <a:effectRef idx="1">
-            <a:schemeClr val="accent1"/>
-          </a:effectRef>
-          <a:fontRef idx="minor">
-            <a:schemeClr val="tx1"/>
-          </a:fontRef>
-        </p:style>
-      </p:cxnSp>
-      <p:cxnSp>
-        <p:nvCxnSpPr>
-          <p:cNvPr id="27" name="RM-Conn6"/>
-          <p:cNvCxnSpPr/>
-          <p:nvPr/>
-        </p:nvCxnSpPr>
-        <p:spPr>
-          <a:xfrm flipH="1">
-            <a:off x="5120640" y="3200400"/>
-            <a:ext cx="2377439" cy="566928"/>
-          </a:xfrm>
-          <a:prstGeom prst="line">
-            <a:avLst/>
-          </a:prstGeom>
-          <a:ln w="28575">
-            <a:solidFill>
-              <a:srgbClr val="8E6F3E"/>
-            </a:solidFill>
-            <a:tailEnd type="triangle" w="med" len="med"/>
-          </a:ln>
-        </p:spPr>
-        <p:style>
-          <a:lnRef idx="2">
-            <a:schemeClr val="accent1"/>
-          </a:lnRef>
-          <a:fillRef idx="0">
-            <a:schemeClr val="accent1"/>
-          </a:fillRef>
-          <a:effectRef idx="1">
-            <a:schemeClr val="accent1"/>
-          </a:effectRef>
-          <a:fontRef idx="minor">
-            <a:schemeClr val="tx1"/>
-          </a:fontRef>
-        </p:style>
-      </p:cxnSp>
+      <p:sp>
+        <p:nvSpPr>
+          <p:cNvPr id="29" name="TR-Q3"/>
+          <p:cNvSpPr txBox="1"/>
+          <p:nvPr/>
+        </p:nvSpPr>
+        <p:spPr>
+          <a:xfrm>
+            <a:off x="4617720" y="4297679"/>
+            <a:ext cx="1828800" cy="292608"/>
+          </a:xfrm>
+          <a:prstGeom prst="rect">
+            <a:avLst/>
+          </a:prstGeom>
+          <a:noFill/>
+        </p:spPr>
+        <p:txBody>
+          <a:bodyPr wrap="square" anchor="t">
+            <a:spAutoFit/>
+          </a:bodyPr>
+          <a:lstStyle/>
+          <a:p>
+            <a:pPr algn="ctr"/>
+            <a:r>
+              <a:rPr sz="1200" b="0" i="1">
+                <a:solidFill>
+                  <a:srgbClr val="555960"/>
+                </a:solidFill>
+              </a:rPr>
+              <a:t>will it accept?</a:t>
+            </a:r>
+          </a:p>
+        </p:txBody>
+      </p:sp>
     </p:spTree>
   </p:cSld>
   <p:clrMapOvr>
@@ -18810,183 +19554,6 @@
                   <a:srgbClr val="000000"/>
                 </a:solidFill>
               </a:rPr>
-              <a:t>Agreement is not correctness</a:t>
-            </a:r>
-          </a:p>
-        </p:txBody>
-      </p:sp>
-      <p:sp>
-        <p:nvSpPr>
-          <p:cNvPr id="4" name="Slide Number Placeholder 5"/>
-          <p:cNvSpPr>
-            <a:spLocks noGrp="1"/>
-          </p:cNvSpPr>
-          <p:nvPr>
-            <p:ph type="sldNum" sz="quarter" idx="4"/>
-          </p:nvPr>
-        </p:nvSpPr>
-        <p:spPr/>
-        <p:txBody>
-          <a:bodyPr/>
-          <a:lstStyle/>
-          <a:p>
-            <a:fld id="{B7EB45DA-9A0D-DC49-8E02-F30A5DDC21C3}" type="slidenum">
-              <a:rPr lang="en-US" smtClean="0"/>
-              <a:t>1</a:t>
-            </a:fld>
-            <a:endParaRPr lang="en-US"/>
-          </a:p>
-        </p:txBody>
-      </p:sp>
-      <p:sp>
-        <p:nvSpPr>
-          <p:cNvPr id="9" name="FooterBand"/>
-          <p:cNvSpPr/>
-          <p:nvPr/>
-        </p:nvSpPr>
-        <p:spPr>
-          <a:xfrm>
-            <a:off x="274320" y="5852160"/>
-            <a:ext cx="8595360" cy="566928"/>
-          </a:xfrm>
-          <a:prstGeom prst="rect">
-            <a:avLst/>
-          </a:prstGeom>
-          <a:solidFill>
-            <a:srgbClr val="8E6F3E"/>
-          </a:solidFill>
-          <a:ln>
-            <a:noFill/>
-          </a:ln>
-          <a:effectLst/>
-        </p:spPr>
-        <p:style>
-          <a:lnRef idx="1">
-            <a:schemeClr val="accent1"/>
-          </a:lnRef>
-          <a:fillRef idx="3">
-            <a:schemeClr val="accent1"/>
-          </a:fillRef>
-          <a:effectRef idx="2">
-            <a:schemeClr val="accent1"/>
-          </a:effectRef>
-          <a:fontRef idx="minor">
-            <a:schemeClr val="lt1"/>
-          </a:fontRef>
-        </p:style>
-        <p:txBody>
-          <a:bodyPr rtlCol="0" anchor="ctr" wrap="square"/>
-          <a:lstStyle/>
-          <a:p>
-            <a:pPr algn="ctr"/>
-            <a:r>
-              <a:rPr sz="2000" b="1" i="0">
-                <a:solidFill>
-                  <a:srgbClr val="FFFFFF"/>
-                </a:solidFill>
-              </a:rPr>
-              <a:t>Evidence for one does not establish the others.</a:t>
-            </a:r>
-          </a:p>
-        </p:txBody>
-      </p:sp>
-      <p:pic>
-        <p:nvPicPr>
-          <p:cNvPr id="10" name="Fig-3-2-1-three-relations" descr="three-relations-deck.png"/>
-          <p:cNvPicPr>
-            <a:picLocks noChangeAspect="1"/>
-          </p:cNvPicPr>
-          <p:nvPr/>
-        </p:nvPicPr>
-        <p:blipFill>
-          <a:blip r:embed="rId3"/>
-          <a:stretch>
-            <a:fillRect/>
-          </a:stretch>
-        </p:blipFill>
-        <p:spPr>
-          <a:xfrm>
-            <a:off x="1417320" y="1051560"/>
-            <a:ext cx="6309360" cy="3680460"/>
-          </a:xfrm>
-          <a:prstGeom prst="rect">
-            <a:avLst/>
-          </a:prstGeom>
-        </p:spPr>
-      </p:pic>
-      <p:sp>
-        <p:nvSpPr>
-          <p:cNvPr id="11" name="ThreeRelationsTakeaway"/>
-          <p:cNvSpPr txBox="1"/>
-          <p:nvPr/>
-        </p:nvSpPr>
-        <p:spPr>
-          <a:xfrm>
-            <a:off x="274320" y="4937760"/>
-            <a:ext cx="8595360" cy="502920"/>
-          </a:xfrm>
-          <a:prstGeom prst="rect">
-            <a:avLst/>
-          </a:prstGeom>
-          <a:noFill/>
-        </p:spPr>
-        <p:txBody>
-          <a:bodyPr wrap="square" anchor="t" lIns="27432" rIns="27432" tIns="22860" bIns="22860">
-            <a:spAutoFit/>
-          </a:bodyPr>
-          <a:lstStyle/>
-          <a:p>
-            <a:pPr algn="ctr"/>
-            <a:r>
-              <a:rPr sz="1600" b="0" i="0">
-                <a:solidFill>
-                  <a:srgbClr val="5C4826"/>
-                </a:solidFill>
-              </a:rPr>
-              <a:t>Three relations people casually conflate — and their evidence is not interchangeable.</a:t>
-            </a:r>
-          </a:p>
-        </p:txBody>
-      </p:sp>
-    </p:spTree>
-  </p:cSld>
-  <p:clrMapOvr>
-    <a:masterClrMapping/>
-  </p:clrMapOvr>
-</p:sld>
-</file>
-
-<file path=ppt/slides/slide33.xml><?xml version="1.0" encoding="utf-8"?>
-<p:sld xmlns:a="http://schemas.openxmlformats.org/drawingml/2006/main" xmlns:p="http://schemas.openxmlformats.org/presentationml/2006/main" xmlns:r="http://schemas.openxmlformats.org/officeDocument/2006/relationships">
-  <p:cSld>
-    <p:spTree>
-      <p:nvGrpSpPr>
-        <p:cNvPr id="1" name=""/>
-        <p:cNvGrpSpPr/>
-        <p:nvPr/>
-      </p:nvGrpSpPr>
-      <p:grpSpPr/>
-      <p:sp>
-        <p:nvSpPr>
-          <p:cNvPr id="3" name="Title 2"/>
-          <p:cNvSpPr>
-            <a:spLocks noGrp="1"/>
-          </p:cNvSpPr>
-          <p:nvPr>
-            <p:ph type="title"/>
-          </p:nvPr>
-        </p:nvSpPr>
-        <p:spPr/>
-        <p:txBody>
-          <a:bodyPr wrap="square"/>
-          <a:lstStyle/>
-          <a:p>
-            <a:r>
-              <a:rPr sz="2400" b="0">
-                <a:solidFill>
-                  <a:srgbClr val="000000"/>
-                </a:solidFill>
-              </a:rPr>
               <a:t>Three things can disagree</a:t>
             </a:r>
           </a:p>
@@ -19573,7 +20140,7 @@
 </p:sld>
 </file>
 
-<file path=ppt/slides/slide34.xml><?xml version="1.0" encoding="utf-8"?>
+<file path=ppt/slides/slide33.xml><?xml version="1.0" encoding="utf-8"?>
 <p:sld xmlns:a="http://schemas.openxmlformats.org/drawingml/2006/main" xmlns:r="http://schemas.openxmlformats.org/officeDocument/2006/relationships" xmlns:p="http://schemas.openxmlformats.org/presentationml/2006/main">
   <p:cSld>
     <p:spTree>
@@ -19901,7 +20468,7 @@
 </p:sld>
 </file>
 
-<file path=ppt/slides/slide35.xml><?xml version="1.0" encoding="utf-8"?>
+<file path=ppt/slides/slide34.xml><?xml version="1.0" encoding="utf-8"?>
 <p:sld xmlns:a="http://schemas.openxmlformats.org/drawingml/2006/main" xmlns:p="http://schemas.openxmlformats.org/presentationml/2006/main" xmlns:r="http://schemas.openxmlformats.org/officeDocument/2006/relationships">
   <p:cSld>
     <p:spTree>
@@ -20548,7 +21115,7 @@
 </p:sld>
 </file>
 
-<file path=ppt/slides/slide36.xml><?xml version="1.0" encoding="utf-8"?>
+<file path=ppt/slides/slide35.xml><?xml version="1.0" encoding="utf-8"?>
 <p:sld xmlns:a="http://schemas.openxmlformats.org/drawingml/2006/main" xmlns:p="http://schemas.openxmlformats.org/presentationml/2006/main" xmlns:r="http://schemas.openxmlformats.org/officeDocument/2006/relationships">
   <p:cSld>
     <p:spTree>
@@ -21015,7 +21582,7 @@
 </p:sld>
 </file>
 
-<file path=ppt/slides/slide37.xml><?xml version="1.0" encoding="utf-8"?>
+<file path=ppt/slides/slide36.xml><?xml version="1.0" encoding="utf-8"?>
 <p:sld xmlns:a="http://schemas.openxmlformats.org/drawingml/2006/main" xmlns:p="http://schemas.openxmlformats.org/presentationml/2006/main" xmlns:r="http://schemas.openxmlformats.org/officeDocument/2006/relationships">
   <p:cSld>
     <p:spTree>
@@ -21416,7 +21983,7 @@
 </p:sld>
 </file>
 
-<file path=ppt/slides/slide38.xml><?xml version="1.0" encoding="utf-8"?>
+<file path=ppt/slides/slide37.xml><?xml version="1.0" encoding="utf-8"?>
 <p:sld xmlns:a="http://schemas.openxmlformats.org/drawingml/2006/main" xmlns:p="http://schemas.openxmlformats.org/presentationml/2006/main" xmlns:r="http://schemas.openxmlformats.org/officeDocument/2006/relationships">
   <p:cSld>
     <p:spTree>

</xml_diff>

<commit_message>
deck 2-3 prune E: activity gives the obligation, not its kind
Obligation 4 becomes 'Preserve the cycle ordering: Sensor.read ->
decide -> Actuator.act.' — students must discover that its evidence
requires interaction. Drop 'Four obligations of different kinds.'
(same reason) and the two setup lines on 'Compare your designs'
(title + four questions is enough).
</commit_message>
<xml_diff>
--- a/course/lectures/act-2-delegation-and-control/03-alignment/2-3-Alignment.pptx
+++ b/course/lectures/act-2-delegation-and-control/03-alignment/2-3-Alignment.pptx
@@ -20879,41 +20879,7 @@
                   <a:srgbClr val="5C4826"/>
                 </a:solidFill>
               </a:rPr>
-              <a:t>Retain a behavior observable only when components interact.</a:t>
-            </a:r>
-          </a:p>
-        </p:txBody>
-      </p:sp>
-      <p:sp>
-        <p:nvSpPr>
-          <p:cNvPr id="11" name="TextBox 10"/>
-          <p:cNvSpPr txBox="1"/>
-          <p:nvPr/>
-        </p:nvSpPr>
-        <p:spPr>
-          <a:xfrm>
-            <a:off x="274320" y="5230368"/>
-            <a:ext cx="8595360" cy="457200"/>
-          </a:xfrm>
-          <a:prstGeom prst="rect">
-            <a:avLst/>
-          </a:prstGeom>
-          <a:noFill/>
-        </p:spPr>
-        <p:txBody>
-          <a:bodyPr wrap="square" anchor="t">
-            <a:spAutoFit/>
-          </a:bodyPr>
-          <a:lstStyle/>
-          <a:p>
-            <a:pPr algn="ctr"/>
-            <a:r>
-              <a:rPr sz="2000" b="0" i="1">
-                <a:solidFill>
-                  <a:srgbClr val="555960"/>
-                </a:solidFill>
-              </a:rPr>
-              <a:t>Four obligations of different kinds.</a:t>
+              <a:t>Preserve the cycle ordering: Sensor.read → decide → Actuator.act.</a:t>
             </a:r>
           </a:p>
         </p:txBody>
@@ -21638,92 +21604,6 @@
               <a:t>1</a:t>
             </a:fld>
             <a:endParaRPr lang="en-US"/>
-          </a:p>
-        </p:txBody>
-      </p:sp>
-      <p:sp>
-        <p:nvSpPr>
-          <p:cNvPr id="8" name="TextBox 7"/>
-          <p:cNvSpPr txBox="1"/>
-          <p:nvPr/>
-        </p:nvSpPr>
-        <p:spPr>
-          <a:xfrm>
-            <a:off x="274320" y="4754880"/>
-            <a:ext cx="8595360" cy="457200"/>
-          </a:xfrm>
-          <a:prstGeom prst="rect">
-            <a:avLst/>
-          </a:prstGeom>
-          <a:noFill/>
-        </p:spPr>
-        <p:txBody>
-          <a:bodyPr wrap="square" anchor="t">
-            <a:spAutoFit/>
-          </a:bodyPr>
-          <a:lstStyle/>
-          <a:p>
-            <a:pPr algn="ctr"/>
-            <a:r>
-              <a:rPr sz="2000" b="0" i="1">
-                <a:solidFill>
-                  <a:srgbClr val="555960"/>
-                </a:solidFill>
-              </a:rPr>
-              <a:t>There may be more than one defensible control design.</a:t>
-            </a:r>
-          </a:p>
-        </p:txBody>
-      </p:sp>
-      <p:sp>
-        <p:nvSpPr>
-          <p:cNvPr id="9" name="FooterBand"/>
-          <p:cNvSpPr/>
-          <p:nvPr/>
-        </p:nvSpPr>
-        <p:spPr>
-          <a:xfrm>
-            <a:off x="274320" y="5852160"/>
-            <a:ext cx="8595360" cy="566928"/>
-          </a:xfrm>
-          <a:prstGeom prst="rect">
-            <a:avLst/>
-          </a:prstGeom>
-          <a:solidFill>
-            <a:srgbClr val="8E6F3E"/>
-          </a:solidFill>
-          <a:ln>
-            <a:noFill/>
-          </a:ln>
-          <a:effectLst/>
-        </p:spPr>
-        <p:style>
-          <a:lnRef idx="1">
-            <a:schemeClr val="accent1"/>
-          </a:lnRef>
-          <a:fillRef idx="3">
-            <a:schemeClr val="accent1"/>
-          </a:fillRef>
-          <a:effectRef idx="2">
-            <a:schemeClr val="accent1"/>
-          </a:effectRef>
-          <a:fontRef idx="minor">
-            <a:schemeClr val="lt1"/>
-          </a:fontRef>
-        </p:style>
-        <p:txBody>
-          <a:bodyPr rtlCol="0" anchor="ctr" wrap="square"/>
-          <a:lstStyle/>
-          <a:p>
-            <a:pPr algn="ctr"/>
-            <a:r>
-              <a:rPr sz="2000" b="1" i="0">
-                <a:solidFill>
-                  <a:srgbClr val="FFFFFF"/>
-                </a:solidFill>
-              </a:rPr>
-              <a:t>The obligation constrains the design. Engineering judgment remains.</a:t>
-            </a:r>
           </a:p>
         </p:txBody>
       </p:sp>

</xml_diff>

<commit_message>
deck 2-3: targeted copyedit pass (12 author-listed edits)
Slide 6 footer tightened; slide 10 'required evidence'; slide 16
transition line deleted (title + table only); slide 19 authority text
tightened; slide 23 retitled 'Earlier is not always possible'; slide 24
OBLIGATION em dash removed; slide 29 EXPOSE -> 'have to be inferred';
slide 30 ONE EXPLICIT MODEL label + em dashes -> comma, GATE confirmed
downstream of VERDICTS (no layout change needed); slide 33 divider
subtitle -> 'How should the environment control delegated work?';
slide 34 'GIVEN MODEL'; slide 36 prompts restructured two-line,
'Constraint vs. evidence'. Terminology sweep: both post-OBLIGATION
'property' occurrences (slides 16, 22) are what-an-analysis-establishes
usages; kept.

Co-Authored-By: Claude Opus 5 <noreply@anthropic.com>
</commit_message>
<xml_diff>
--- a/course/lectures/act-2-delegation-and-control/03-alignment/2-3-Alignment.pptx
+++ b/course/lectures/act-2-delegation-and-control/03-alignment/2-3-Alignment.pptx
@@ -7329,7 +7329,7 @@
                   <a:srgbClr val="555960"/>
                 </a:solidFill>
               </a:rPr>
-              <a:t>permitted actions · required transitions · stopping criteria · evidence produced</a:t>
+              <a:t>permitted actions · required transitions · stopping criteria · required evidence</a:t>
             </a:r>
           </a:p>
         </p:txBody>
@@ -9964,40 +9964,6 @@
       </p:sp>
       <p:sp>
         <p:nvSpPr>
-          <p:cNvPr id="5" name="FCTransition"/>
-          <p:cNvSpPr txBox="1"/>
-          <p:nvPr/>
-        </p:nvSpPr>
-        <p:spPr>
-          <a:xfrm>
-            <a:off x="502920" y="5303520"/>
-            <a:ext cx="8138160" cy="548640"/>
-          </a:xfrm>
-          <a:prstGeom prst="rect">
-            <a:avLst/>
-          </a:prstGeom>
-          <a:noFill/>
-        </p:spPr>
-        <p:txBody>
-          <a:bodyPr wrap="square" anchor="t">
-            <a:spAutoFit/>
-          </a:bodyPr>
-          <a:lstStyle/>
-          <a:p>
-            <a:pPr algn="ctr"/>
-            <a:r>
-              <a:rPr sz="1800" b="0" i="0">
-                <a:solidFill>
-                  <a:srgbClr val="5C4826"/>
-                </a:solidFill>
-              </a:rPr>
-              <a:t>We can now ask how to make each failure impossible, observable, detectable, or consequential.</a:t>
-            </a:r>
-          </a:p>
-        </p:txBody>
-      </p:sp>
-      <p:sp>
-        <p:nvSpPr>
           <p:cNvPr id="6" name="FCHeadFailure"/>
           <p:cNvSpPr txBox="1"/>
           <p:nvPr/>
@@ -12389,7 +12355,7 @@
                   <a:srgbClr val="555960"/>
                 </a:solidFill>
               </a:rPr>
-              <a:t>The agent may propose freely. It may modify its branch freely.</a:t>
+              <a:t>The agent may modify and propose freely.</a:t>
             </a:r>
           </a:p>
           <a:p>
@@ -12400,7 +12366,7 @@
                   <a:srgbClr val="555960"/>
                 </a:solidFill>
               </a:rPr>
-              <a:t>It may merge if the checks pass. It may deploy if the release satisfies admission obligations.</a:t>
+              <a:t>Merge and deployment are conditional on verdicts.</a:t>
             </a:r>
           </a:p>
         </p:txBody>
@@ -15185,7 +15151,7 @@
                   <a:srgbClr val="000000"/>
                 </a:solidFill>
               </a:rPr>
-              <a:t>Earlier is cheaper — but not always possible</a:t>
+              <a:t>Earlier is not always possible</a:t>
             </a:r>
           </a:p>
         </p:txBody>
@@ -15824,7 +15790,7 @@
                   <a:srgbClr val="8E6F3E"/>
                 </a:solidFill>
               </a:rPr>
-              <a:t>OBLIGATION — </a:t>
+              <a:t>OBLIGATION  </a:t>
             </a:r>
             <a:r>
               <a:rPr sz="1800" b="0" i="0">
@@ -15832,7 +15798,7 @@
                   <a:srgbClr val="5C4826"/>
                 </a:solidFill>
               </a:rPr>
-              <a:t>the code and its architectural model must agree when the task completes.</a:t>
+              <a:t>The code and its architectural model must agree when the task completes.</a:t>
             </a:r>
           </a:p>
         </p:txBody>
@@ -17620,7 +17586,7 @@
                   <a:srgbClr val="5C4826"/>
                 </a:solidFill>
               </a:rPr>
-              <a:t>relationships that would otherwise be reconstructed</a:t>
+              <a:t>relationships that would otherwise have to be inferred</a:t>
             </a:r>
           </a:p>
         </p:txBody>
@@ -18212,12 +18178,20 @@
           <a:p>
             <a:pPr algn="ctr"/>
             <a:r>
+              <a:rPr sz="1050" b="1" i="0">
+                <a:solidFill>
+                  <a:srgbClr val="FBF8F2"/>
+                </a:solidFill>
+              </a:rPr>
+              <a:t>ONE EXPLICIT MODEL  </a:t>
+            </a:r>
+            <a:r>
               <a:rPr sz="1050" b="0" i="1">
                 <a:solidFill>
                   <a:srgbClr val="FBF8F2"/>
                 </a:solidFill>
               </a:rPr>
-              <a:t>one explicit model: lifecycle machine + resource graph</a:t>
+              <a:t>lifecycle machine + resource graph</a:t>
             </a:r>
           </a:p>
         </p:txBody>
@@ -18347,7 +18321,7 @@
                   <a:srgbClr val="555960"/>
                 </a:solidFill>
               </a:rPr>
-              <a:t>can the retry loop run forever?  no — at most 2 retries</a:t>
+              <a:t>can the retry loop run forever?  no, at most 2 retries</a:t>
             </a:r>
           </a:p>
         </p:txBody>
@@ -18412,7 +18386,7 @@
                   <a:srgbClr val="555960"/>
                 </a:solidFill>
               </a:rPr>
-              <a:t>peak demand 2 × 384 MB — within the 1 GB worker ceiling</a:t>
+              <a:t>peak demand 2 × 384 MB, within the 1 GB worker ceiling</a:t>
             </a:r>
           </a:p>
         </p:txBody>
@@ -20396,7 +20370,7 @@
                 <a:ea typeface="+mn-ea"/>
                 <a:cs typeface="+mn-cs"/>
               </a:rPr>
-              <a:t>Given the failures, obligations, and boundaries, what should control the agent?</a:t>
+              <a:t>How should the environment control delegated work?</a:t>
             </a:r>
           </a:p>
         </p:txBody>
@@ -20985,7 +20959,7 @@
                   <a:srgbClr val="8E6F3E"/>
                 </a:solidFill>
               </a:rPr>
-              <a:t>THE MODEL — GIVEN, NOT RECONSTRUCTED</a:t>
+              <a:t>GIVEN MODEL</a:t>
             </a:r>
           </a:p>
           <a:p>
@@ -21656,8 +21630,11 @@
                   <a:srgbClr val="5C4826"/>
                 </a:solidFill>
               </a:rPr>
-              <a:t>Same obligation, different boundary — </a:t>
-            </a:r>
+              <a:t>Same obligation, different boundary</a:t>
+            </a:r>
+          </a:p>
+          <a:p>
+            <a:pPr algn="l"/>
             <a:r>
               <a:rPr sz="1700" b="0" i="0">
                 <a:solidFill>
@@ -21718,15 +21695,18 @@
                   <a:srgbClr val="5C4826"/>
                 </a:solidFill>
               </a:rPr>
-              <a:t>Constraint vs. validator — </a:t>
-            </a:r>
+              <a:t>Constraint vs. evidence</a:t>
+            </a:r>
+          </a:p>
+          <a:p>
+            <a:pPr algn="l"/>
             <a:r>
               <a:rPr sz="1700" b="0" i="0">
                 <a:solidFill>
                   <a:srgbClr val="5C4826"/>
                 </a:solidFill>
               </a:rPr>
-              <a:t>What failure does each prevent or detect?</a:t>
+              <a:t>Can the failure be prevented, or must it be observed and evaluated?</a:t>
             </a:r>
           </a:p>
         </p:txBody>
@@ -21740,7 +21720,7 @@
         <p:spPr>
           <a:xfrm>
             <a:off x="502920" y="2880360"/>
-            <a:ext cx="8138160" cy="749808"/>
+            <a:ext cx="8138160" cy="932688"/>
           </a:xfrm>
           <a:prstGeom prst="rect">
             <a:avLst/>
@@ -21780,8 +21760,11 @@
                   <a:srgbClr val="5C4826"/>
                 </a:solidFill>
               </a:rPr>
-              <a:t>Different authority — </a:t>
-            </a:r>
+              <a:t>Different authority</a:t>
+            </a:r>
+          </a:p>
+          <a:p>
+            <a:pPr algn="l"/>
             <a:r>
               <a:rPr sz="1700" b="0" i="0">
                 <a:solidFill>
@@ -21801,7 +21784,7 @@
         </p:nvSpPr>
         <p:spPr>
           <a:xfrm>
-            <a:off x="502920" y="3794760"/>
+            <a:off x="502920" y="3977639"/>
             <a:ext cx="8138160" cy="749808"/>
           </a:xfrm>
           <a:prstGeom prst="rect">
@@ -21842,8 +21825,11 @@
                   <a:srgbClr val="5C4826"/>
                 </a:solidFill>
               </a:rPr>
-              <a:t>Model vs. reconstruction — </a:t>
-            </a:r>
+              <a:t>Model vs. reconstruction</a:t>
+            </a:r>
+          </a:p>
+          <a:p>
+            <a:pPr algn="l"/>
             <a:r>
               <a:rPr sz="1700" b="0" i="0">
                 <a:solidFill>
@@ -23264,7 +23250,7 @@
                   <a:srgbClr val="FFFFFF"/>
                 </a:solidFill>
               </a:rPr>
-              <a:t>Delegation also requires a process for producing it.</a:t>
+              <a:t>Delegation also specifies a process.</a:t>
             </a:r>
           </a:p>
         </p:txBody>

</xml_diff>

<commit_message>
deck 2-3: place authored speaker notes on all 37 slides
Each slide's notes replaced verbatim with the lecturer's authored block
(TIMING + talking points + ANIMATION reveal order preserved as text),
matched by title; slides 21 and 33 gained notes slides. Verified at
reopen: all 37 notes byte-identical to the authored blocks; slide count
unchanged; copyedited strings intact.

Co-Authored-By: Claude Opus 5 <noreply@anthropic.com>
</commit_message>
<xml_diff>
--- a/course/lectures/act-2-delegation-and-control/03-alignment/2-3-Alignment.pptx
+++ b/course/lectures/act-2-delegation-and-control/03-alignment/2-3-Alignment.pptx
@@ -546,7 +546,27 @@
           <a:lstStyle/>
           <a:p>
             <a:r>
-              <a:t>Open with the question; do not answer it yet. Do not preview the model. Transition: "Rather than define Alignment, let's give an agent some work."</a:t>
+              <a:t>TIMING: 1 minute</a:t>
+            </a:r>
+          </a:p>
+          <a:p>
+            <a:r>
+              <a:t>- Last time we talked about Modeling: how to make consequential engineering knowledge explicit while leaving irrelevant degrees of freedom open.</a:t>
+            </a:r>
+          </a:p>
+          <a:p>
+            <a:r>
+              <a:t>- Today we ask the complementary question: once we know something about the work, what should that knowledge control?</a:t>
+            </a:r>
+          </a:p>
+          <a:p>
+            <a:r>
+              <a:t>- The title question is deliberately broad: "How do you know whether an agent is doing what you want?" We are going to unpack both know and want.</a:t>
+            </a:r>
+          </a:p>
+          <a:p>
+            <a:r>
+              <a:t>- Start with an agent and essentially no engineered control around it.</a:t>
             </a:r>
           </a:p>
         </p:txBody>
@@ -616,7 +636,72 @@
           <a:lstStyle/>
           <a:p>
             <a:r>
-              <a:t>The pivotal picture: verification governing admission to greater consequence. Demoted build (speaker): a verdict can carry increasing authority — WARN (note it) / RECOMMEND (ask the agent to reconsider) / REJECT (refuse the patch) / PREVENT (make the action impossible). Guidance shapes behavior; enforcement determines what the environment accepts.</a:t>
+              <a:t>TIMING: 2 minutes</a:t>
+            </a:r>
+          </a:p>
+          <a:p>
+            <a:r>
+              <a:t>- Evidence becomes useful when a validator turns it into a verdict.</a:t>
+            </a:r>
+          </a:p>
+          <a:p>
+            <a:r>
+              <a:t>- But a verdict alone does not control anything.</a:t>
+            </a:r>
+          </a:p>
+          <a:p>
+            <a:r>
+              <a:t>- A gate connects that verdict to authority.</a:t>
+            </a:r>
+          </a:p>
+          <a:p>
+            <a:r>
+              <a:t>- The agent can work locally and propose changes. Merge or deployment can require a satisfactory verdict.</a:t>
+            </a:r>
+          </a:p>
+          <a:p>
+            <a:r>
+              <a:t>- This is stronger than telling the agent "please don't merge broken code."</a:t>
+            </a:r>
+          </a:p>
+          <a:p>
+            <a:r>
+              <a:t>- The environment itself conditions authority on the engineering judgment.</a:t>
+            </a:r>
+          </a:p>
+          <a:p>
+            <a:r>
+              <a:t>- A gate therefore makes authority conditional on a verdict.</a:t>
+            </a:r>
+          </a:p>
+          <a:p>
+            <a:r>
+              <a:t>ANIMATION</a:t>
+            </a:r>
+          </a:p>
+          <a:p>
+            <a:r>
+              <a:t>- Reveal WORK, evidence, VALIDATOR.</a:t>
+            </a:r>
+          </a:p>
+          <a:p>
+            <a:r>
+              <a:t>- Reveal verdict.</a:t>
+            </a:r>
+          </a:p>
+          <a:p>
+            <a:r>
+              <a:t>- Reveal GATE.</a:t>
+            </a:r>
+          </a:p>
+          <a:p>
+            <a:r>
+              <a:t>- Reveal MERGE / DEPLOY only after explaining the verdict.</a:t>
+            </a:r>
+          </a:p>
+          <a:p>
+            <a:r>
+              <a:t>- Reveal the final definition last.</a:t>
             </a:r>
           </a:p>
         </p:txBody>
@@ -686,7 +771,77 @@
           <a:lstStyle/>
           <a:p>
             <a:r>
-              <a:t>The four roles are two conceptual pairs, not a pipeline: constraint and sensor concern the work and its state (what may happen; what did happen); validator and gate concern judgment and admission (is it OK; may it pass). One mechanism may bundle roles: a CI test senses, validates, and gates at once; a narrow interface constrains while producing evidence of use.</a:t>
+              <a:t>TIMING: 3 minutes</a:t>
+            </a:r>
+          </a:p>
+          <a:p>
+            <a:r>
+              <a:t>- We can now name four control roles.</a:t>
+            </a:r>
+          </a:p>
+          <a:p>
+            <a:r>
+              <a:t>- A constraint narrows what may happen.</a:t>
+            </a:r>
+          </a:p>
+          <a:p>
+            <a:r>
+              <a:t>- A sensor tells us what happened and produces evidence.</a:t>
+            </a:r>
+          </a:p>
+          <a:p>
+            <a:r>
+              <a:t>- A validator evaluates that evidence against an obligation.</a:t>
+            </a:r>
+          </a:p>
+          <a:p>
+            <a:r>
+              <a:t>- A gate controls whether work crosses a boundary.</a:t>
+            </a:r>
+          </a:p>
+          <a:p>
+            <a:r>
+              <a:t>- These are roles, not an architecture requiring four separate services.</a:t>
+            </a:r>
+          </a:p>
+          <a:p>
+            <a:r>
+              <a:t>- A single mechanism can perform several roles.</a:t>
+            </a:r>
+          </a:p>
+          <a:p>
+            <a:r>
+              <a:t>- Keep the two sides distinct: constraints and sensors concern work/state; validators and gates concern judgment/admission.</a:t>
+            </a:r>
+          </a:p>
+          <a:p>
+            <a:r>
+              <a:t>- This vocabulary gives us a way to design rather than simply say "add checks."</a:t>
+            </a:r>
+          </a:p>
+          <a:p>
+            <a:r>
+              <a:t>ANIMATION</a:t>
+            </a:r>
+          </a:p>
+          <a:p>
+            <a:r>
+              <a:t>- Reveal CONSTRAINT and SENSOR first under WORK / STATE.</a:t>
+            </a:r>
+          </a:p>
+          <a:p>
+            <a:r>
+              <a:t>- Reveal VALIDATOR and GATE under DECISION / ADMISSION.</a:t>
+            </a:r>
+          </a:p>
+          <a:p>
+            <a:r>
+              <a:t>- Reveal the role definitions with each.</a:t>
+            </a:r>
+          </a:p>
+          <a:p>
+            <a:r>
+              <a:t>- Reveal the "roles, not four required components" note last.</a:t>
             </a:r>
           </a:p>
         </p:txBody>
@@ -756,7 +911,77 @@
           <a:lstStyle/>
           <a:p>
             <a:r>
-              <a:t>Figure 3.3-1 (constraint vs sensor): the student performs the choice. Can the unwanted state be excluded cleanly and reliably? YES: constraint (typed enum, permission, narrow API). NO: sensor (metric, trace, call scan, log) — then validate the evidence, and gate on the verdict when appropriate. The first engineering preference is prevention, when cheap and reliable.</a:t>
+              <a:t>TIMING: 3 minutes</a:t>
+            </a:r>
+          </a:p>
+          <a:p>
+            <a:r>
+              <a:t>- Given an obligation, first ask whether the unwanted state can be excluded cleanly.</a:t>
+            </a:r>
+          </a:p>
+          <a:p>
+            <a:r>
+              <a:t>- If yes, prefer prevention. A narrow API, type, permission, or constrained representation can make the invalid state unavailable.</a:t>
+            </a:r>
+          </a:p>
+          <a:p>
+            <a:r>
+              <a:t>- If not, we need evidence about what happened.</a:t>
+            </a:r>
+          </a:p>
+          <a:p>
+            <a:r>
+              <a:t>- Why might prevention be impossible? The property may emerge only across several actions, after composition, or at runtime.</a:t>
+            </a:r>
+          </a:p>
+          <a:p>
+            <a:r>
+              <a:t>- For example, a type can prevent some malformed states locally. It cannot generally prove your end-to-end latency under production load.</a:t>
+            </a:r>
+          </a:p>
+          <a:p>
+            <a:r>
+              <a:t>- Do not force every obligation into a constraint.</a:t>
+            </a:r>
+          </a:p>
+          <a:p>
+            <a:r>
+              <a:t>- The rule is deliberately asymmetric: if the wrong state can cheaply and reliably be made impossible, do that. Otherwise, collect evidence and evaluate it.</a:t>
+            </a:r>
+          </a:p>
+          <a:p>
+            <a:r>
+              <a:t>ANIMATION</a:t>
+            </a:r>
+          </a:p>
+          <a:p>
+            <a:r>
+              <a:t>- Begin with ENGINEERING OBLIGATION.</a:t>
+            </a:r>
+          </a:p>
+          <a:p>
+            <a:r>
+              <a:t>- Reveal the decision question.</a:t>
+            </a:r>
+          </a:p>
+          <a:p>
+            <a:r>
+              <a:t>- Reveal YES to CONSTRAINT.</a:t>
+            </a:r>
+          </a:p>
+          <a:p>
+            <a:r>
+              <a:t>- Reveal NO to SENSOR.</a:t>
+            </a:r>
+          </a:p>
+          <a:p>
+            <a:r>
+              <a:t>- Reveal examples under each.</a:t>
+            </a:r>
+          </a:p>
+          <a:p>
+            <a:r>
+              <a:t>- Reveal the gold rule last.</a:t>
             </a:r>
           </a:p>
         </p:txBody>
@@ -826,7 +1051,62 @@
           <a:lstStyle/>
           <a:p>
             <a:r>
-              <a:t>Closes Section 2: Alignment as Validation with consequences, not a second framework. Validation asks whether evidence supports the claim; Alignment asks what the verdict should control. If this feels abstract, 60-second true story: a merge automation resolved conflicts by taking one side, silently dropping content on overlapping edits. A guard DETECTED when a conflict touched critical files, correctly judged the resolution unsafe — and logged it as a warning only. The operation proceeded, and the tree lost content. The system had evidence; the validator judged correctly; nothing acted on the verdict. The durable fix was not a louder warning — it removed the unsafe capability altogether.</a:t>
+              <a:t>TIMING: 2 minutes</a:t>
+            </a:r>
+          </a:p>
+          <a:p>
+            <a:r>
+              <a:t>- This is the central distinction for the lecture.</a:t>
+            </a:r>
+          </a:p>
+          <a:p>
+            <a:r>
+              <a:t>- Validation gets us from claim and evidence to judgment.</a:t>
+            </a:r>
+          </a:p>
+          <a:p>
+            <a:r>
+              <a:t>- Alignment asks what that judgment should control.</a:t>
+            </a:r>
+          </a:p>
+          <a:p>
+            <a:r>
+              <a:t>- A failed check might merely produce information. It might block a commit, a merge, a release, or a runtime action.</a:t>
+            </a:r>
+          </a:p>
+          <a:p>
+            <a:r>
+              <a:t>- Those are different engineering designs even if the validator is identical.</a:t>
+            </a:r>
+          </a:p>
+          <a:p>
+            <a:r>
+              <a:t>- So Alignment is not "more validation." It is the design of consequences attached to engineering judgments.</a:t>
+            </a:r>
+          </a:p>
+          <a:p>
+            <a:r>
+              <a:t>ANIMATION</a:t>
+            </a:r>
+          </a:p>
+          <a:p>
+            <a:r>
+              <a:t>- Reveal VALIDATION row first.</a:t>
+            </a:r>
+          </a:p>
+          <a:p>
+            <a:r>
+              <a:t>- Reveal ALIGNMENT row second.</a:t>
+            </a:r>
+          </a:p>
+          <a:p>
+            <a:r>
+              <a:t>- Highlight ACTION versus CONSEQUENCE.</a:t>
+            </a:r>
+          </a:p>
+          <a:p>
+            <a:r>
+              <a:t>- Reveal the two explanatory questions last.</a:t>
             </a:r>
           </a:p>
         </p:txBody>
@@ -896,7 +1176,67 @@
           <a:lstStyle/>
           <a:p>
             <a:r>
-              <a:t>Section 3 (12 min). The lifecycle pipeline is the visual anchor for the whole section. Build: place the candidate checks one at a time, asking the room where each belongs before revealing it.</a:t>
+              <a:t>TIMING: 2 minutes</a:t>
+            </a:r>
+          </a:p>
+          <a:p>
+            <a:r>
+              <a:t>- Think about the boundaries available in ordinary software work: edit, commit, push, merge, deploy, runtime.</a:t>
+            </a:r>
+          </a:p>
+          <a:p>
+            <a:r>
+              <a:t>- Different obligations become decidable at different points.</a:t>
+            </a:r>
+          </a:p>
+          <a:p>
+            <a:r>
+              <a:t>- A type property may be decidable during editing or compilation.</a:t>
+            </a:r>
+          </a:p>
+          <a:p>
+            <a:r>
+              <a:t>- A forbidden dependency may be decidable from a commit or repository state.</a:t>
+            </a:r>
+          </a:p>
+          <a:p>
+            <a:r>
+              <a:t>- Integration behavior may require assembled work.</a:t>
+            </a:r>
+          </a:p>
+          <a:p>
+            <a:r>
+              <a:t>- Latency under load may require deployment or runtime evidence.</a:t>
+            </a:r>
+          </a:p>
+          <a:p>
+            <a:r>
+              <a:t>- There is no universally correct "shift left" answer.</a:t>
+            </a:r>
+          </a:p>
+          <a:p>
+            <a:r>
+              <a:t>- Check at the earliest boundary where the obligation can actually be decided.</a:t>
+            </a:r>
+          </a:p>
+          <a:p>
+            <a:r>
+              <a:t>ANIMATION</a:t>
+            </a:r>
+          </a:p>
+          <a:p>
+            <a:r>
+              <a:t>- Reveal the boundary sequence first.</a:t>
+            </a:r>
+          </a:p>
+          <a:p>
+            <a:r>
+              <a:t>- Reveal each example property at its appropriate boundary.</a:t>
+            </a:r>
+          </a:p>
+          <a:p>
+            <a:r>
+              <a:t>- Reveal the rule last.</a:t>
             </a:r>
           </a:p>
         </p:txBody>
@@ -966,13 +1306,157 @@
           <a:lstStyle/>
           <a:p>
             <a:r>
-              <a:t>Figure 3.2-3 (the semantic gap): this explains WHY the rule exists rather than merely stating it. The obligation is legible only at the boundary where the whole unit of work is assembled; below it, no single commit / call / turn carries enough to decide. Ask the room why not everything at edit time before revealing. "Shift left" is not an unconditional maxim — check earlier only when the required evidence exists earlier.</a:t>
-            </a:r>
-          </a:p>
-          <a:p/>
-          <a:p>
-            <a:r>
-              <a:t>Generalization (cut slide "The boundary follows the property" — speak it, do not show it): Validation taught: check at the lowest scope that can establish it, but no lower. Alignment generalizes: check at the earliest boundary where the obligation can be decided, but no earlier. Both place the check at the earliest boundary where the obligation is legible and decidable. Modeling tie: wrong abstraction — the property is not represented; wrong Alignment boundary — the evidence is unavailable.</a:t>
+              <a:t>TIMING: 2 minutes</a:t>
+            </a:r>
+          </a:p>
+          <a:p>
+            <a:r>
+              <a:t>- Why can't we always check earlier?</a:t>
+            </a:r>
+          </a:p>
+          <a:p>
+            <a:r>
+              <a:t>- Some obligations span a unit of work.</a:t>
+            </a:r>
+          </a:p>
+          <a:p>
+            <a:r>
+              <a:t>- Imagine several individually valid commits. During intermediate commits, the architecture model and implementation may temporarily disagree because the change is incomplete.</a:t>
+            </a:r>
+          </a:p>
+          <a:p>
+            <a:r>
+              <a:t>- No individual commit contains enough information to decide the completed-work obligation.</a:t>
+            </a:r>
+          </a:p>
+          <a:p>
+            <a:r>
+              <a:t>- The correct response is not to weaken the obligation.</a:t>
+            </a:r>
+          </a:p>
+          <a:p>
+            <a:r>
+              <a:t>- Move the check to the first boundary at which the obligation becomes decidable.</a:t>
+            </a:r>
+          </a:p>
+          <a:p>
+            <a:r>
+              <a:t>- Earlier detection is usually cheaper, which is why we reach for it first; the constraint is what is decidable, not what is desirable.</a:t>
+            </a:r>
+          </a:p>
+          <a:p>
+            <a:r>
+              <a:t>ANIMATION</a:t>
+            </a:r>
+          </a:p>
+          <a:p>
+            <a:r>
+              <a:t>- Reveal individual commits.</a:t>
+            </a:r>
+          </a:p>
+          <a:p>
+            <a:r>
+              <a:t>- Reveal "obligation not decidable at any individual commit."</a:t>
+            </a:r>
+          </a:p>
+          <a:p>
+            <a:r>
+              <a:t>- Reveal COMPLETED UNIT OF WORK.</a:t>
+            </a:r>
+          </a:p>
+          <a:p>
+            <a:r>
+              <a:t>- Reveal "obligation decidable here."</a:t>
+            </a:r>
+          </a:p>
+          <a:p>
+            <a:r>
+              <a:t>- Reveal the upward movement of the check last.</a:t>
+            </a:r>
+          </a:p>
+        </p:txBody>
+      </p:sp>
+      <p:sp>
+        <p:nvSpPr>
+          <p:cNvPr id="4" name="Slide Number Placeholder 3"/>
+          <p:cNvSpPr>
+            <a:spLocks noGrp="1"/>
+          </p:cNvSpPr>
+          <p:nvPr>
+            <p:ph type="sldNum" idx="5" sz="quarter"/>
+          </p:nvPr>
+        </p:nvSpPr>
+        <p:spPr/>
+      </p:sp>
+    </p:spTree>
+  </p:cSld>
+  <p:clrMapOvr>
+    <a:masterClrMapping/>
+  </p:clrMapOvr>
+</p:notes>
+</file>
+
+<file path=ppt/notesSlides/notesSlide16.xml><?xml version="1.0" encoding="utf-8"?>
+<p:notes xmlns:a="http://schemas.openxmlformats.org/drawingml/2006/main" xmlns:p="http://schemas.openxmlformats.org/presentationml/2006/main" xmlns:r="http://schemas.openxmlformats.org/officeDocument/2006/relationships">
+  <p:cSld>
+    <p:spTree>
+      <p:nvGrpSpPr>
+        <p:cNvPr id="1" name=""/>
+        <p:cNvGrpSpPr/>
+        <p:nvPr/>
+      </p:nvGrpSpPr>
+      <p:grpSpPr>
+        <a:xfrm>
+          <a:off x="0" y="0"/>
+          <a:ext cx="0" cy="0"/>
+          <a:chOff x="0" y="0"/>
+          <a:chExt cx="0" cy="0"/>
+        </a:xfrm>
+      </p:grpSpPr>
+      <p:sp>
+        <p:nvSpPr>
+          <p:cNvPr id="2" name="Slide Image Placeholder 1"/>
+          <p:cNvSpPr>
+            <a:spLocks noGrp="1"/>
+          </p:cNvSpPr>
+          <p:nvPr>
+            <p:ph type="sldImg" idx="2"/>
+          </p:nvPr>
+        </p:nvSpPr>
+        <p:spPr/>
+      </p:sp>
+      <p:sp>
+        <p:nvSpPr>
+          <p:cNvPr id="3" name="Notes Placeholder 2"/>
+          <p:cNvSpPr>
+            <a:spLocks noGrp="1"/>
+          </p:cNvSpPr>
+          <p:nvPr>
+            <p:ph type="body" idx="3" sz="quarter"/>
+          </p:nvPr>
+        </p:nvSpPr>
+        <p:spPr/>
+        <p:txBody>
+          <a:bodyPr/>
+          <a:lstStyle/>
+          <a:p>
+            <a:r>
+              <a:t>TIMING: 30 seconds</a:t>
+            </a:r>
+          </a:p>
+          <a:p>
+            <a:r>
+              <a:t>- Enough vocabulary.</a:t>
+            </a:r>
+          </a:p>
+          <a:p>
+            <a:r>
+              <a:t>- Now use it.</a:t>
+            </a:r>
+          </a:p>
+          <a:p>
+            <a:r>
+              <a:t>- You are going to receive explicit obligations and a model, and design the delegated process around them.</a:t>
             </a:r>
           </a:p>
         </p:txBody>
@@ -1042,7 +1526,67 @@
           <a:lstStyle/>
           <a:p>
             <a:r>
-              <a:t>Worked example. Enforcing an end-state obligation per-commit produces a bad control: it enforces the right obligation at a boundary that cannot yet decide it.</a:t>
+              <a:t>TIMING: 2 minutes</a:t>
+            </a:r>
+          </a:p>
+          <a:p>
+            <a:r>
+              <a:t>- Here is the concrete failure mode.</a:t>
+            </a:r>
+          </a:p>
+          <a:p>
+            <a:r>
+              <a:t>- The obligation is legitimate: when the task is complete, code and architectural model must correspond.</a:t>
+            </a:r>
+          </a:p>
+          <a:p>
+            <a:r>
+              <a:t>- Enforcing that obligation after every intermediate edit or commit rejects legitimate transitional states.</a:t>
+            </a:r>
+          </a:p>
+          <a:p>
+            <a:r>
+              <a:t>- At merge, the task's work is assembled and the obligation can be evaluated.</a:t>
+            </a:r>
+          </a:p>
+          <a:p>
+            <a:r>
+              <a:t>- Notice the distinction: the obligation was not wrong; its placement was wrong.</a:t>
+            </a:r>
+          </a:p>
+          <a:p>
+            <a:r>
+              <a:t>- This is an Alignment design error, not a reason to abandon the property.</a:t>
+            </a:r>
+          </a:p>
+          <a:p>
+            <a:r>
+              <a:t>ANIMATION</a:t>
+            </a:r>
+          </a:p>
+          <a:p>
+            <a:r>
+              <a:t>- Reveal the obligation.</a:t>
+            </a:r>
+          </a:p>
+          <a:p>
+            <a:r>
+              <a:t>- Reveal per-commit enforcement and the red X.</a:t>
+            </a:r>
+          </a:p>
+          <a:p>
+            <a:r>
+              <a:t>- Reveal the consequence: legitimate intermediate states rejected.</a:t>
+            </a:r>
+          </a:p>
+          <a:p>
+            <a:r>
+              <a:t>- Reveal merge and green check.</a:t>
+            </a:r>
+          </a:p>
+          <a:p>
+            <a:r>
+              <a:t>- Reveal the final sentence last.</a:t>
             </a:r>
           </a:p>
         </p:txBody>
@@ -1112,7 +1656,22 @@
           <a:lstStyle/>
           <a:p>
             <a:r>
-              <a:t>Two minutes, then the team activity.</a:t>
+              <a:t>TIMING: 2-3 minutes</a:t>
+            </a:r>
+          </a:p>
+          <a:p>
+            <a:r>
+              <a:t>- Give them an actual short break.</a:t>
+            </a:r>
+          </a:p>
+          <a:p>
+            <a:r>
+              <a:t>- Resume by saying: so far, nothing we did required a SysML model, a state machine, or any other explicit engineering model.</a:t>
+            </a:r>
+          </a:p>
+          <a:p>
+            <a:r>
+              <a:t>- That sets up the next section.</a:t>
             </a:r>
           </a:p>
         </p:txBody>
@@ -1182,7 +1741,67 @@
           <a:lstStyle/>
           <a:p>
             <a:r>
-              <a:t>Section 5 (18 min): ~10–12 min team work, ~6 min debrief. Same scenario for every team so the debrief can compare designs. The instruction is deliberately wider than "how will each obligation be checked?" — teams design the delegated process AND its controls. One obligation is structurally preventable, one measured, one static, one integration-only — keep that heterogeneity. The model is GIVEN explicitly — students should not spend the exercise reconstructing it from prose immediately after being told why reconstruction is undesirable. The cycle line is the interaction behavior: obligation 4 is observable only in composition, so it forces a different boundary than the other three.</a:t>
+              <a:t>TIMING: 2 minutes setup + 8-10 minutes work</a:t>
+            </a:r>
+          </a:p>
+          <a:p>
+            <a:r>
+              <a:t>- Scenario: an agent modifies an embedded controller.</a:t>
+            </a:r>
+          </a:p>
+          <a:p>
+            <a:r>
+              <a:t>- You have four obligations: API preservation, a memory bound, forbidden dependency, and cycle ordering.</a:t>
+            </a:r>
+          </a:p>
+          <a:p>
+            <a:r>
+              <a:t>- The model is given. Do not spend the activity rediscovering it from implementation.</a:t>
+            </a:r>
+          </a:p>
+          <a:p>
+            <a:r>
+              <a:t>- Your job is to design the delegated process and its controls.</a:t>
+            </a:r>
+          </a:p>
+          <a:p>
+            <a:r>
+              <a:t>- Different obligations should lead you toward different evidence, mechanisms, and boundaries.</a:t>
+            </a:r>
+          </a:p>
+          <a:p>
+            <a:r>
+              <a:t>- Do not assume everything should block everything.</a:t>
+            </a:r>
+          </a:p>
+          <a:p>
+            <a:r>
+              <a:t>- You should be able to defend why each control sits where you put it.</a:t>
+            </a:r>
+          </a:p>
+          <a:p>
+            <a:r>
+              <a:t>ANIMATION</a:t>
+            </a:r>
+          </a:p>
+          <a:p>
+            <a:r>
+              <a:t>- Reveal scenario.</a:t>
+            </a:r>
+          </a:p>
+          <a:p>
+            <a:r>
+              <a:t>- Reveal obligations one at a time.</a:t>
+            </a:r>
+          </a:p>
+          <a:p>
+            <a:r>
+              <a:t>- Reveal the given model.</a:t>
+            </a:r>
+          </a:p>
+          <a:p>
+            <a:r>
+              <a:t>- Reveal "Design the delegated process and its controls" as the start signal.</a:t>
             </a:r>
           </a:p>
         </p:txBody>
@@ -1252,7 +1871,57 @@
           <a:lstStyle/>
           <a:p>
             <a:r>
-              <a:t>Explicit callback to Architecture/Design — the same degrees-of-freedom visual language. Speaker: "This is the same design problem we have seen before: decide which degrees of freedom matter." We are NOT teaching students to write giant prompts that micromanage agents.</a:t>
+              <a:t>TIMING: 2 minutes</a:t>
+            </a:r>
+          </a:p>
+          <a:p>
+            <a:r>
+              <a:t>- Recall degrees of freedom from Architecture and Design.</a:t>
+            </a:r>
+          </a:p>
+          <a:p>
+            <a:r>
+              <a:t>- Engineering is not about specifying everything.</a:t>
+            </a:r>
+          </a:p>
+          <a:p>
+            <a:r>
+              <a:t>- We bind choices whose consequences matter: worktree, scope, forbidden actions, evidence, delivery boundary.</a:t>
+            </a:r>
+          </a:p>
+          <a:p>
+            <a:r>
+              <a:t>- We deliberately leave other choices free: local decomposition, naming, implementation details, algorithms where no obligation constrains them.</a:t>
+            </a:r>
+          </a:p>
+          <a:p>
+            <a:r>
+              <a:t>- If we specify all of those too, we have defeated much of the purpose of delegation.</a:t>
+            </a:r>
+          </a:p>
+          <a:p>
+            <a:r>
+              <a:t>- Good delegation is therefore selective reduction of degrees of freedom.</a:t>
+            </a:r>
+          </a:p>
+          <a:p>
+            <a:r>
+              <a:t>ANIMATION</a:t>
+            </a:r>
+          </a:p>
+          <a:p>
+            <a:r>
+              <a:t>- Reveal BOUND first.</a:t>
+            </a:r>
+          </a:p>
+          <a:p>
+            <a:r>
+              <a:t>- Reveal LEAVE FREE second.</a:t>
+            </a:r>
+          </a:p>
+          <a:p>
+            <a:r>
+              <a:t>- Reveal the concluding sentence last.</a:t>
             </a:r>
           </a:p>
         </p:txBody>
@@ -1322,7 +1991,72 @@
           <a:lstStyle/>
           <a:p>
             <a:r>
-              <a:t>The entire lecture on one slide — the design sequence each team applies to each obligation. Give them 10–12 minutes.</a:t>
+              <a:t>TIMING: activity continues</a:t>
+            </a:r>
+          </a:p>
+          <a:p>
+            <a:r>
+              <a:t>- Leave this slide up while teams work.</a:t>
+            </a:r>
+          </a:p>
+          <a:p>
+            <a:r>
+              <a:t>- For each obligation, walk through the same questions.</a:t>
+            </a:r>
+          </a:p>
+          <a:p>
+            <a:r>
+              <a:t>- Failure: what specifically can go wrong?</a:t>
+            </a:r>
+          </a:p>
+          <a:p>
+            <a:r>
+              <a:t>- Obligation: what must actually remain true?</a:t>
+            </a:r>
+          </a:p>
+          <a:p>
+            <a:r>
+              <a:t>- Control: can the invalid state be prevented, or do you need evidence?</a:t>
+            </a:r>
+          </a:p>
+          <a:p>
+            <a:r>
+              <a:t>- Evidence: what observation bears on the obligation?</a:t>
+            </a:r>
+          </a:p>
+          <a:p>
+            <a:r>
+              <a:t>- Boundary: where does enough information exist to decide it?</a:t>
+            </a:r>
+          </a:p>
+          <a:p>
+            <a:r>
+              <a:t>- Mechanism: which roles are needed?</a:t>
+            </a:r>
+          </a:p>
+          <a:p>
+            <a:r>
+              <a:t>- Authority: what happens when the verdict is negative?</a:t>
+            </a:r>
+          </a:p>
+          <a:p>
+            <a:r>
+              <a:t>- Circulate and challenge teams especially on boundary and authority.</a:t>
+            </a:r>
+          </a:p>
+          <a:p>
+            <a:r>
+              <a:t>- If someone says "run a test," ask what obligation the test establishes.</a:t>
+            </a:r>
+          </a:p>
+          <a:p>
+            <a:r>
+              <a:t>- If someone says "block the commit," ask whether the obligation is decidable at commit.</a:t>
+            </a:r>
+          </a:p>
+          <a:p>
+            <a:r>
+              <a:t>- If someone says "tell the agent not to," ask whether the environment can enforce it instead.</a:t>
             </a:r>
           </a:p>
         </p:txBody>
@@ -1392,7 +2126,52 @@
           <a:lstStyle/>
           <a:p>
             <a:r>
-              <a:t>Select disagreements, not merely good answers — each comparison corresponds directly to a lecture choice. The outcome: students can perform Alignment and say what an explicit model bought them.</a:t>
+              <a:t>TIMING: 4-5 minutes</a:t>
+            </a:r>
+          </a:p>
+          <a:p>
+            <a:r>
+              <a:t>- Have two or three teams report a control they designed differently.</a:t>
+            </a:r>
+          </a:p>
+          <a:p>
+            <a:r>
+              <a:t>- Do not search immediately for the one correct design. Compare the engineering tradeoffs.</a:t>
+            </a:r>
+          </a:p>
+          <a:p>
+            <a:r>
+              <a:t>- If teams chose different boundaries for the same obligation, ask which boundary actually contains enough information.</a:t>
+            </a:r>
+          </a:p>
+          <a:p>
+            <a:r>
+              <a:t>- If one team chose a constraint and another chose detection, ask whether the invalid state can cleanly be excluded.</a:t>
+            </a:r>
+          </a:p>
+          <a:p>
+            <a:r>
+              <a:t>- If teams attach different consequences, ask whether this failure warrants blocking commit, PR, merge, deployment, or merely producing evidence.</a:t>
+            </a:r>
+          </a:p>
+          <a:p>
+            <a:r>
+              <a:t>- Finally ask what work the explicit model saved. What would have had to be reconstructed from implementation otherwise?</a:t>
+            </a:r>
+          </a:p>
+          <a:p>
+            <a:r>
+              <a:t>- The important thing is that the design is defensible against the failure model and obligation, not that everyone chose identical machinery.</a:t>
+            </a:r>
+          </a:p>
+          <a:p>
+            <a:r>
+              <a:t>ANIMATION</a:t>
+            </a:r>
+          </a:p>
+          <a:p>
+            <a:r>
+              <a:t>- Reveal comparison questions one at a time as they become relevant to student answers.</a:t>
             </a:r>
           </a:p>
         </p:txBody>
@@ -1462,7 +2241,32 @@
           <a:lstStyle/>
           <a:p>
             <a:r>
-              <a:t>Say it explicitly. Deliberate mode change: fewer slides, more discussion, from here out.</a:t>
+              <a:t>TIMING: 1 minute</a:t>
+            </a:r>
+          </a:p>
+          <a:p>
+            <a:r>
+              <a:t>- Everything so far could be done with tests, permissions, CI, repository state, and ordinary process controls.</a:t>
+            </a:r>
+          </a:p>
+          <a:p>
+            <a:r>
+              <a:t>- We reasoned about obligations, evidence, validators, constraints, gates, and authority.</a:t>
+            </a:r>
+          </a:p>
+          <a:p>
+            <a:r>
+              <a:t>- No explicit model was logically required.</a:t>
+            </a:r>
+          </a:p>
+          <a:p>
+            <a:r>
+              <a:t>- So explicit modeling has to earn its cost.</a:t>
+            </a:r>
+          </a:p>
+          <a:p>
+            <a:r>
+              <a:t>- What does it let us do better?</a:t>
             </a:r>
           </a:p>
         </p:txBody>
@@ -1532,7 +2336,27 @@
           <a:lstStyle/>
           <a:p>
             <a:r>
-              <a:t>Put only the question on screen and stop. ~5 minutes of whole-class discussion; let students recover ideas from Modeling before showing any answer list.</a:t>
+              <a:t>TIMING: 2 minutes</a:t>
+            </a:r>
+          </a:p>
+          <a:p>
+            <a:r>
+              <a:t>- Ask the room before answering.</a:t>
+            </a:r>
+          </a:p>
+          <a:p>
+            <a:r>
+              <a:t>- Look for answers about preserving knowledge, making relationships inspectable, enabling analysis, reducing repeated reconstruction, and separating what matters from what does not.</a:t>
+            </a:r>
+          </a:p>
+          <a:p>
+            <a:r>
+              <a:t>- Push beyond "documentation." If the model is only documentation, it is not yet clear why Alignment cares.</a:t>
+            </a:r>
+          </a:p>
+          <a:p>
+            <a:r>
+              <a:t>- Ask: what could a control do with a model that is difficult to do with prose or by repeatedly inspecting implementation?</a:t>
             </a:r>
           </a:p>
         </p:txBody>
@@ -1602,7 +2426,72 @@
           <a:lstStyle/>
           <a:p>
             <a:r>
-              <a:t>After the discussion, consolidate: what an explicit representation adds to the Alignment the students just performed.</a:t>
+              <a:t>TIMING: 2 minutes</a:t>
+            </a:r>
+          </a:p>
+          <a:p>
+            <a:r>
+              <a:t>- A model preserves distinctions we have decided matter.</a:t>
+            </a:r>
+          </a:p>
+          <a:p>
+            <a:r>
+              <a:t>- It exposes relationships that would otherwise need to be inferred.</a:t>
+            </a:r>
+          </a:p>
+          <a:p>
+            <a:r>
+              <a:t>- It can deliberately leave realization choices open.</a:t>
+            </a:r>
+          </a:p>
+          <a:p>
+            <a:r>
+              <a:t>- And because the information is explicit and structured, analyses can operate over it directly.</a:t>
+            </a:r>
+          </a:p>
+          <a:p>
+            <a:r>
+              <a:t>- The key point is not that models contain more information than implementation.</a:t>
+            </a:r>
+          </a:p>
+          <a:p>
+            <a:r>
+              <a:t>- The point is that they can contain the right engineering information in a form suited to the question.</a:t>
+            </a:r>
+          </a:p>
+          <a:p>
+            <a:r>
+              <a:t>- Multiple analyses can then operate over the same explicit knowledge.</a:t>
+            </a:r>
+          </a:p>
+          <a:p>
+            <a:r>
+              <a:t>ANIMATION</a:t>
+            </a:r>
+          </a:p>
+          <a:p>
+            <a:r>
+              <a:t>- Reveal PRESERVE.</a:t>
+            </a:r>
+          </a:p>
+          <a:p>
+            <a:r>
+              <a:t>- Reveal EXPOSE.</a:t>
+            </a:r>
+          </a:p>
+          <a:p>
+            <a:r>
+              <a:t>- Reveal LEAVE OPEN.</a:t>
+            </a:r>
+          </a:p>
+          <a:p>
+            <a:r>
+              <a:t>- Reveal ENABLE.</a:t>
+            </a:r>
+          </a:p>
+          <a:p>
+            <a:r>
+              <a:t>- Reveal the concluding sentence last.</a:t>
             </a:r>
           </a:p>
         </p:txBody>
@@ -1672,7 +2561,77 @@
           <a:lstStyle/>
           <a:p>
             <a:r>
-              <a:t>Figure 3.2-1: three distinct relations, drawn separately so they cannot be read as one. Correspondence — do two representations agree? Conformance — does the artifact satisfy an independent obligation? Acceptance — will the receiving environment admit it? Evidence for one does not establish the others: a model and realization can agree completely and still violate an external obligation, and a representation extracted from the implementation corresponds by construction — that is not independent evidence of correctness. Next slide: now look specifically at obligation / model / realization — agreement occupies only one edge.</a:t>
+              <a:t>TIMING: 2 minutes</a:t>
+            </a:r>
+          </a:p>
+          <a:p>
+            <a:r>
+              <a:t>- Once we have models, we need one more distinction.</a:t>
+            </a:r>
+          </a:p>
+          <a:p>
+            <a:r>
+              <a:t>- Correspondence: do two representations agree?</a:t>
+            </a:r>
+          </a:p>
+          <a:p>
+            <a:r>
+              <a:t>- Conformance: does an artifact satisfy an independent obligation?</a:t>
+            </a:r>
+          </a:p>
+          <a:p>
+            <a:r>
+              <a:t>- Acceptance: will the receiving environment accept the artifact?</a:t>
+            </a:r>
+          </a:p>
+          <a:p>
+            <a:r>
+              <a:t>- These are different claims.</a:t>
+            </a:r>
+          </a:p>
+          <a:p>
+            <a:r>
+              <a:t>- A model and implementation can correspond perfectly and both be wrong relative to the requirement.</a:t>
+            </a:r>
+          </a:p>
+          <a:p>
+            <a:r>
+              <a:t>- An artifact can satisfy its requirement but still be rejected by an incompatible receiving environment.</a:t>
+            </a:r>
+          </a:p>
+          <a:p>
+            <a:r>
+              <a:t>- Evidence for one relation does not establish the others.</a:t>
+            </a:r>
+          </a:p>
+          <a:p>
+            <a:r>
+              <a:t>- This is why "the implementation matches the model" is not by itself a correctness argument.</a:t>
+            </a:r>
+          </a:p>
+          <a:p>
+            <a:r>
+              <a:t>ANIMATION</a:t>
+            </a:r>
+          </a:p>
+          <a:p>
+            <a:r>
+              <a:t>- Reveal CORRESPONDENCE row.</a:t>
+            </a:r>
+          </a:p>
+          <a:p>
+            <a:r>
+              <a:t>- Reveal CONFORMANCE row.</a:t>
+            </a:r>
+          </a:p>
+          <a:p>
+            <a:r>
+              <a:t>- Reveal ACCEPTANCE row.</a:t>
+            </a:r>
+          </a:p>
+          <a:p>
+            <a:r>
+              <a:t>- Reveal "Evidence for one does not establish the others" last.</a:t>
             </a:r>
           </a:p>
         </p:txBody>
@@ -1742,7 +2701,87 @@
           <a:lstStyle/>
           <a:p>
             <a:r>
-              <a:t>Ask what each edge means before giving the labels. This makes correspondence / conformance concrete rather than vocabulary.</a:t>
+              <a:t>TIMING: 2-3 minutes</a:t>
+            </a:r>
+          </a:p>
+          <a:p>
+            <a:r>
+              <a:t>- Specialize that distinction to model-based engineering.</a:t>
+            </a:r>
+          </a:p>
+          <a:p>
+            <a:r>
+              <a:t>- Transition explicitly: those were three different kinds of engineering claim. Now specialize this to model-based engineering. We have three things that can disagree.</a:t>
+            </a:r>
+          </a:p>
+          <a:p>
+            <a:r>
+              <a:t>- We now have an obligation, a model, and a realization.</a:t>
+            </a:r>
+          </a:p>
+          <a:p>
+            <a:r>
+              <a:t>- Ask what claim each edge makes.</a:t>
+            </a:r>
+          </a:p>
+          <a:p>
+            <a:r>
+              <a:t>- Does the model actually capture the obligation?</a:t>
+            </a:r>
+          </a:p>
+          <a:p>
+            <a:r>
+              <a:t>- Does the realization satisfy the obligation?</a:t>
+            </a:r>
+          </a:p>
+          <a:p>
+            <a:r>
+              <a:t>- Do model and realization correspond?</a:t>
+            </a:r>
+          </a:p>
+          <a:p>
+            <a:r>
+              <a:t>- None of those edges establishes the other two.</a:t>
+            </a:r>
+          </a:p>
+          <a:p>
+            <a:r>
+              <a:t>- This matters because model-driven development can otherwise create a false sense of assurance: we can become very good at keeping implementation synchronized with a bad model.</a:t>
+            </a:r>
+          </a:p>
+          <a:p>
+            <a:r>
+              <a:t>- Correspondence is useful, but it is only one edge of the engineering argument.</a:t>
+            </a:r>
+          </a:p>
+          <a:p>
+            <a:r>
+              <a:t>ANIMATION</a:t>
+            </a:r>
+          </a:p>
+          <a:p>
+            <a:r>
+              <a:t>- Reveal OBLIGATION, MODEL, REALIZATION without edges if possible.</a:t>
+            </a:r>
+          </a:p>
+          <a:p>
+            <a:r>
+              <a:t>- Reveal obligation-model question.</a:t>
+            </a:r>
+          </a:p>
+          <a:p>
+            <a:r>
+              <a:t>- Reveal obligation-realization question.</a:t>
+            </a:r>
+          </a:p>
+          <a:p>
+            <a:r>
+              <a:t>- Reveal model-realization question.</a:t>
+            </a:r>
+          </a:p>
+          <a:p>
+            <a:r>
+              <a:t>- Ask "What evidence would establish each?" before revealing the closing sentence.</a:t>
             </a:r>
           </a:p>
         </p:txBody>
@@ -1812,7 +2851,97 @@
           <a:lstStyle/>
           <a:p>
             <a:r>
-              <a:t>Return to the opening. Build: the six questions appear one at a time — the first is the new one. Spoken close, returning to the opening activity: "You told an agent to vibe-code a todo list; later you told one to add bulk refunds. Both times the question was: does it work? We now have a better question: what must be true, what evidence can establish it, and what will the engineered environment permit when it isn’t?" Then the FA-SDLC handoff sentence only.</a:t>
+              <a:t>TIMING: 3 minutes</a:t>
+            </a:r>
+          </a:p>
+          <a:p>
+            <a:r>
+              <a:t>- Return to the question from slide 1.</a:t>
+            </a:r>
+          </a:p>
+          <a:p>
+            <a:r>
+              <a:t>- Modeling and Alignment solve different parts of the problem.</a:t>
+            </a:r>
+          </a:p>
+          <a:p>
+            <a:r>
+              <a:t>- Modeling makes consequential engineering knowledge explicit while leaving irrelevant choices free.</a:t>
+            </a:r>
+          </a:p>
+          <a:p>
+            <a:r>
+              <a:t>- Alignment decides which obligations have consequences in the engineered environment.</a:t>
+            </a:r>
+          </a:p>
+          <a:p>
+            <a:r>
+              <a:t>- Then walk the reusable questions in order.</a:t>
+            </a:r>
+          </a:p>
+          <a:p>
+            <a:r>
+              <a:t>- How can delegated work fail? Start with the failure model.</a:t>
+            </a:r>
+          </a:p>
+          <a:p>
+            <a:r>
+              <a:t>- What must be true? State the obligation.</a:t>
+            </a:r>
+          </a:p>
+          <a:p>
+            <a:r>
+              <a:t>- What evidence bears on it? Do not confuse activity with evidence.</a:t>
+            </a:r>
+          </a:p>
+          <a:p>
+            <a:r>
+              <a:t>- Where can it be decided? Put the mechanism at a boundary with sufficient information.</a:t>
+            </a:r>
+          </a:p>
+          <a:p>
+            <a:r>
+              <a:t>- How will it be evaluated? Identify the validator or equivalent judgment.</a:t>
+            </a:r>
+          </a:p>
+          <a:p>
+            <a:r>
+              <a:t>- Should failure control what happens next? Decide the authority of the verdict.</a:t>
+            </a:r>
+          </a:p>
+          <a:p>
+            <a:r>
+              <a:t>- That last question is what turns Validation into Alignment.</a:t>
+            </a:r>
+          </a:p>
+          <a:p>
+            <a:r>
+              <a:t>- End there. Do not add another summary or slogan.</a:t>
+            </a:r>
+          </a:p>
+          <a:p>
+            <a:r>
+              <a:t>ANIMATION</a:t>
+            </a:r>
+          </a:p>
+          <a:p>
+            <a:r>
+              <a:t>- Reveal MODELING.</a:t>
+            </a:r>
+          </a:p>
+          <a:p>
+            <a:r>
+              <a:t>- Reveal ALIGNMENT.</a:t>
+            </a:r>
+          </a:p>
+          <a:p>
+            <a:r>
+              <a:t>- Reveal the reusable questions one at a time.</a:t>
+            </a:r>
+          </a:p>
+          <a:p>
+            <a:r>
+              <a:t>- Leave the final question, "Should failure control what happens next?", as the last reveal and final image of the lecture.</a:t>
             </a:r>
           </a:p>
         </p:txBody>
@@ -1882,7 +3011,17 @@
           <a:lstStyle/>
           <a:p>
             <a:r>
-              <a:t>Section 1 (12 min). Transition from the todo app: "That was fine for a todo list. Now suppose the work matters. What else would we give the agent?"</a:t>
+              <a:t>TIMING: 30 seconds</a:t>
+            </a:r>
+          </a:p>
+          <a:p>
+            <a:r>
+              <a:t>- Before we can control delegated work, we need to be precise about what we delegated.</a:t>
+            </a:r>
+          </a:p>
+          <a:p>
+            <a:r>
+              <a:t>- A prompt that names an outcome is not yet a complete engineering process.</a:t>
             </a:r>
           </a:p>
         </p:txBody>
@@ -1952,7 +3091,17 @@
           <a:lstStyle/>
           <a:p>
             <a:r>
-              <a:t>Section 2 (15 min). Build the failure model one mode at a time before any control vocabulary appears.</a:t>
+              <a:t>TIMING: 30 seconds</a:t>
+            </a:r>
+          </a:p>
+          <a:p>
+            <a:r>
+              <a:t>- Now we have a process, ask the engineering question: how can it fail?</a:t>
+            </a:r>
+          </a:p>
+          <a:p>
+            <a:r>
+              <a:t>- Different failures will require different kinds of control.</a:t>
             </a:r>
           </a:p>
         </p:txBody>
@@ -2022,7 +3171,72 @@
           <a:lstStyle/>
           <a:p>
             <a:r>
-              <a:t>Lands after the todo-app discussion: name the two halves the students just experienced. The footer phrase is the unit framing (it also opens the lander). No Section 0, no recap — straight into Section 1.</a:t>
+              <a:t>TIMING: 3 minutes</a:t>
+            </a:r>
+          </a:p>
+          <a:p>
+            <a:r>
+              <a:t>- We already have two pieces of the problem.</a:t>
+            </a:r>
+          </a:p>
+          <a:p>
+            <a:r>
+              <a:t>- Validation asks when evidence justifies a judgment or action.</a:t>
+            </a:r>
+          </a:p>
+          <a:p>
+            <a:r>
+              <a:t>- Delegation asks what action another actor is permitted to take on our behalf.</a:t>
+            </a:r>
+          </a:p>
+          <a:p>
+            <a:r>
+              <a:t>- Alignment is where those meet.</a:t>
+            </a:r>
+          </a:p>
+          <a:p>
+            <a:r>
+              <a:t>- Suppose a test says the implementation is wrong. That is a validation result. What happens now?</a:t>
+            </a:r>
+          </a:p>
+          <a:p>
+            <a:r>
+              <a:t>- Does the agent merely receive advice? Is the commit rejected? Can the PR merge? Can the artifact deploy?</a:t>
+            </a:r>
+          </a:p>
+          <a:p>
+            <a:r>
+              <a:t>- Alignment connects the engineering judgment to what the engineered environment permits.</a:t>
+            </a:r>
+          </a:p>
+          <a:p>
+            <a:r>
+              <a:t>- "Agent or environment" matters. Often the strongest control is not telling the agent what not to do. It is designing the environment so the consequential action is unavailable.</a:t>
+            </a:r>
+          </a:p>
+          <a:p>
+            <a:r>
+              <a:t>ANIMATION</a:t>
+            </a:r>
+          </a:p>
+          <a:p>
+            <a:r>
+              <a:t>- Reveal VALIDATION first.</a:t>
+            </a:r>
+          </a:p>
+          <a:p>
+            <a:r>
+              <a:t>- Reveal DELEGATION second.</a:t>
+            </a:r>
+          </a:p>
+          <a:p>
+            <a:r>
+              <a:t>- Reveal ALIGNMENT and its question last.</a:t>
+            </a:r>
+          </a:p>
+          <a:p>
+            <a:r>
+              <a:t>- Finish with the bottom definition.</a:t>
             </a:r>
           </a:p>
         </p:txBody>
@@ -2092,7 +3306,17 @@
           <a:lstStyle/>
           <a:p>
             <a:r>
-              <a:t>Section 4 (12 min). Moved BEFORE the design activity: the Modeling payoff is a design resource the activity should get to use.</a:t>
+              <a:t>TIMING: 30 seconds</a:t>
+            </a:r>
+          </a:p>
+          <a:p>
+            <a:r>
+              <a:t>- We have just built a theory of Alignment without assuming explicit models.</a:t>
+            </a:r>
+          </a:p>
+          <a:p>
+            <a:r>
+              <a:t>- So the obvious challenge is: why did we spend the previous lecture on Modeling?</a:t>
             </a:r>
           </a:p>
         </p:txBody>
@@ -2162,7 +3386,147 @@
           <a:lstStyle/>
           <a:p>
             <a:r>
-              <a:t>First explicit process-modeling slide. The distinction matters: we are modeling the engineering process, not pretending we have a faithful cognitive model of an LLM.</a:t>
+              <a:t>TIMING: 2 minutes</a:t>
+            </a:r>
+          </a:p>
+          <a:p>
+            <a:r>
+              <a:t>- We can now recognize the same move we made in the Modeling lecture.</a:t>
+            </a:r>
+          </a:p>
+          <a:p>
+            <a:r>
+              <a:t>- The work order and environment define a model of the delegated process.</a:t>
+            </a:r>
+          </a:p>
+          <a:p>
+            <a:r>
+              <a:t>- It has permitted actions, transitions, stopping conditions, and expected evidence.</a:t>
+            </a:r>
+          </a:p>
+          <a:p>
+            <a:r>
+              <a:t>- Importantly, this is not a model of the agent's internal chain of thought.</a:t>
+            </a:r>
+          </a:p>
+          <a:p>
+            <a:r>
+              <a:t>- We generally do not need to prescribe how the agent reasons internally.</a:t>
+            </a:r>
+          </a:p>
+          <a:p>
+            <a:r>
+              <a:t>- We need enough external structure to reason about consequential behavior.</a:t>
+            </a:r>
+          </a:p>
+          <a:p>
+            <a:r>
+              <a:t>- That gives us something against which failure can be defined.</a:t>
+            </a:r>
+          </a:p>
+          <a:p>
+            <a:r>
+              <a:t>ANIMATION</a:t>
+            </a:r>
+          </a:p>
+          <a:p>
+            <a:r>
+              <a:t>- Reveal the process sequence.</a:t>
+            </a:r>
+          </a:p>
+          <a:p>
+            <a:r>
+              <a:t>- Reveal the four kinds of modeled information.</a:t>
+            </a:r>
+          </a:p>
+          <a:p>
+            <a:r>
+              <a:t>- Reveal the final sentence about internal reasoning last.</a:t>
+            </a:r>
+          </a:p>
+        </p:txBody>
+      </p:sp>
+      <p:sp>
+        <p:nvSpPr>
+          <p:cNvPr id="4" name="Slide Number Placeholder 3"/>
+          <p:cNvSpPr>
+            <a:spLocks noGrp="1"/>
+          </p:cNvSpPr>
+          <p:nvPr>
+            <p:ph type="sldNum" idx="5" sz="quarter"/>
+          </p:nvPr>
+        </p:nvSpPr>
+        <p:spPr/>
+      </p:sp>
+    </p:spTree>
+  </p:cSld>
+  <p:clrMapOvr>
+    <a:masterClrMapping/>
+  </p:clrMapOvr>
+</p:notes>
+</file>
+
+<file path=ppt/notesSlides/notesSlide32.xml><?xml version="1.0" encoding="utf-8"?>
+<p:notes xmlns:a="http://schemas.openxmlformats.org/drawingml/2006/main" xmlns:p="http://schemas.openxmlformats.org/presentationml/2006/main" xmlns:r="http://schemas.openxmlformats.org/officeDocument/2006/relationships">
+  <p:cSld>
+    <p:spTree>
+      <p:nvGrpSpPr>
+        <p:cNvPr id="1" name=""/>
+        <p:cNvGrpSpPr/>
+        <p:nvPr/>
+      </p:nvGrpSpPr>
+      <p:grpSpPr>
+        <a:xfrm>
+          <a:off x="0" y="0"/>
+          <a:ext cx="0" cy="0"/>
+          <a:chOff x="0" y="0"/>
+          <a:chExt cx="0" cy="0"/>
+        </a:xfrm>
+      </p:grpSpPr>
+      <p:sp>
+        <p:nvSpPr>
+          <p:cNvPr id="2" name="Slide Image Placeholder 1"/>
+          <p:cNvSpPr>
+            <a:spLocks noGrp="1"/>
+          </p:cNvSpPr>
+          <p:nvPr>
+            <p:ph type="sldImg" idx="2"/>
+          </p:nvPr>
+        </p:nvSpPr>
+        <p:spPr/>
+      </p:sp>
+      <p:sp>
+        <p:nvSpPr>
+          <p:cNvPr id="3" name="Notes Placeholder 2"/>
+          <p:cNvSpPr>
+            <a:spLocks noGrp="1"/>
+          </p:cNvSpPr>
+          <p:nvPr>
+            <p:ph type="body" idx="3" sz="quarter"/>
+          </p:nvPr>
+        </p:nvSpPr>
+        <p:spPr/>
+        <p:txBody>
+          <a:bodyPr/>
+          <a:lstStyle/>
+          <a:p>
+            <a:r>
+              <a:t>TIMING: 30 seconds</a:t>
+            </a:r>
+          </a:p>
+          <a:p>
+            <a:r>
+              <a:t>- We now know what kinds of controls exist.</a:t>
+            </a:r>
+          </a:p>
+          <a:p>
+            <a:r>
+              <a:t>- Next question: where should the control operate?</a:t>
+            </a:r>
+          </a:p>
+          <a:p>
+            <a:r>
+              <a:t>- The answer depends on where enough information exists to decide the obligation.</a:t>
             </a:r>
           </a:p>
         </p:txBody>
@@ -2232,7 +3596,52 @@
           <a:lstStyle/>
           <a:p>
             <a:r>
-              <a:t>First failure mode; take them one at a time. The artifact itself is wrong against an obligation.</a:t>
+              <a:t>TIMING: 90 seconds</a:t>
+            </a:r>
+          </a:p>
+          <a:p>
+            <a:r>
+              <a:t>- First and most familiar: the artifact itself can violate an obligation.</a:t>
+            </a:r>
+          </a:p>
+          <a:p>
+            <a:r>
+              <a:t>- We asked for bulk refunds while preserving existing client behavior. The new implementation changes response semantics.</a:t>
+            </a:r>
+          </a:p>
+          <a:p>
+            <a:r>
+              <a:t>- The agent may have followed the requested process perfectly and still produced the wrong system.</a:t>
+            </a:r>
+          </a:p>
+          <a:p>
+            <a:r>
+              <a:t>- This is ordinary artifact failure.</a:t>
+            </a:r>
+          </a:p>
+          <a:p>
+            <a:r>
+              <a:t>- Examples include functional behavior, invariants, resource bounds, and compatibility obligations.</a:t>
+            </a:r>
+          </a:p>
+          <a:p>
+            <a:r>
+              <a:t>ANIMATION</a:t>
+            </a:r>
+          </a:p>
+          <a:p>
+            <a:r>
+              <a:t>- Reveal requirement.</a:t>
+            </a:r>
+          </a:p>
+          <a:p>
+            <a:r>
+              <a:t>- Reveal the implementation change and X.</a:t>
+            </a:r>
+          </a:p>
+          <a:p>
+            <a:r>
+              <a:t>- Reveal ARTIFACT FAILURE definition last.</a:t>
             </a:r>
           </a:p>
         </p:txBody>
@@ -2302,7 +3711,52 @@
           <a:lstStyle/>
           <a:p>
             <a:r>
-              <a:t>Crucial: each example can leave a final state that LOOKS fine. The failure is in the path, not (only) the artifact — which is why final-state validation alone does not capture it.</a:t>
+              <a:t>TIMING: 90 seconds</a:t>
+            </a:r>
+          </a:p>
+          <a:p>
+            <a:r>
+              <a:t>- A correct final artifact is not the only thing we care about.</a:t>
+            </a:r>
+          </a:p>
+          <a:p>
+            <a:r>
+              <a:t>- The agent can modify files outside scope, replace an approved dependency, change the model instead of satisfying it, or weaken the test that exposes the defect.</a:t>
+            </a:r>
+          </a:p>
+          <a:p>
+            <a:r>
+              <a:t>- Some of these actions might even lead to a final artifact that appears to pass.</a:t>
+            </a:r>
+          </a:p>
+          <a:p>
+            <a:r>
+              <a:t>- That is why final-state validation is insufficient.</a:t>
+            </a:r>
+          </a:p>
+          <a:p>
+            <a:r>
+              <a:t>- The path to the result can itself violate the work order.</a:t>
+            </a:r>
+          </a:p>
+          <a:p>
+            <a:r>
+              <a:t>ANIMATION</a:t>
+            </a:r>
+          </a:p>
+          <a:p>
+            <a:r>
+              <a:t>- Reveal examples one at a time.</a:t>
+            </a:r>
+          </a:p>
+          <a:p>
+            <a:r>
+              <a:t>- Reveal SCOPE / PROCESS FAILURE after the examples.</a:t>
+            </a:r>
+          </a:p>
+          <a:p>
+            <a:r>
+              <a:t>- Finish on "Final-state validation alone does not capture it."</a:t>
             </a:r>
           </a:p>
         </p:txBody>
@@ -2372,7 +3826,62 @@
           <a:lstStyle/>
           <a:p>
             <a:r>
-              <a:t>Third failure mode. Explicit callback to the Agents lecture. This is what sets up gates later in the section.</a:t>
+              <a:t>TIMING: 90 seconds</a:t>
+            </a:r>
+          </a:p>
+          <a:p>
+            <a:r>
+              <a:t>- Third failure: capability and authority are different.</a:t>
+            </a:r>
+          </a:p>
+          <a:p>
+            <a:r>
+              <a:t>- We saw this distinction in Agents.</a:t>
+            </a:r>
+          </a:p>
+          <a:p>
+            <a:r>
+              <a:t>- The agent may be technically capable of pushing, merging, or deploying. That does not mean we delegated all of those actions.</a:t>
+            </a:r>
+          </a:p>
+          <a:p>
+            <a:r>
+              <a:t>- A useful agent often needs broad capability to perform local work.</a:t>
+            </a:r>
+          </a:p>
+          <a:p>
+            <a:r>
+              <a:t>- Consequential actions can still require separate authority.</a:t>
+            </a:r>
+          </a:p>
+          <a:p>
+            <a:r>
+              <a:t>- This distinction will become important when we introduce gates.</a:t>
+            </a:r>
+          </a:p>
+          <a:p>
+            <a:r>
+              <a:t>ANIMATION</a:t>
+            </a:r>
+          </a:p>
+          <a:p>
+            <a:r>
+              <a:t>- Reveal READ, MODIFY, COMMIT as permitted.</a:t>
+            </a:r>
+          </a:p>
+          <a:p>
+            <a:r>
+              <a:t>- Reveal PUSH if appropriate to the intended work order.</a:t>
+            </a:r>
+          </a:p>
+          <a:p>
+            <a:r>
+              <a:t>- Reveal MERGE and DEPLOY as prohibited.</a:t>
+            </a:r>
+          </a:p>
+          <a:p>
+            <a:r>
+              <a:t>- Reveal "capability is not authority" last.</a:t>
             </a:r>
           </a:p>
         </p:txBody>
@@ -2442,7 +3951,52 @@
           <a:lstStyle/>
           <a:p>
             <a:r>
-              <a:t>The bridge from diagnosis to mechanism: each failure from the last four slides maps to a distinct engineering response. The four failures are genuinely different — wrong artifact, wrong process, excess authority, insufficient evidence — which is why the next slide needs four roles rather than one checker. This earns the control vocabulary: the failure model, not a framework, motivates the roles.</a:t>
+              <a:t>TIMING: 2 minutes</a:t>
+            </a:r>
+          </a:p>
+          <a:p>
+            <a:r>
+              <a:t>- Put the four failures together.</a:t>
+            </a:r>
+          </a:p>
+          <a:p>
+            <a:r>
+              <a:t>- Wrong result means we need evidence about artifact properties.</a:t>
+            </a:r>
+          </a:p>
+          <a:p>
+            <a:r>
+              <a:t>- Wrong process means we need to observe or constrain actions, not merely inspect the final state.</a:t>
+            </a:r>
+          </a:p>
+          <a:p>
+            <a:r>
+              <a:t>- Excess authority means consequential actions must be restricted.</a:t>
+            </a:r>
+          </a:p>
+          <a:p>
+            <a:r>
+              <a:t>- Insufficient evidence means acceptance must depend on evidence appropriate to the obligation.</a:t>
+            </a:r>
+          </a:p>
+          <a:p>
+            <a:r>
+              <a:t>- This is why we built the failure model first. Controls should answer plausible failures rather than being accumulated as generic "best practices."</a:t>
+            </a:r>
+          </a:p>
+          <a:p>
+            <a:r>
+              <a:t>ANIMATION</a:t>
+            </a:r>
+          </a:p>
+          <a:p>
+            <a:r>
+              <a:t>- Reveal one failure/response row at a time.</a:t>
+            </a:r>
+          </a:p>
+          <a:p>
+            <a:r>
+              <a:t>- Ask students for the response before revealing it where practical.</a:t>
             </a:r>
           </a:p>
         </p:txBody>
@@ -2512,7 +4066,87 @@
           <a:lstStyle/>
           <a:p>
             <a:r>
-              <a:t>The bridge between Modeling and Alignment, shown on a REAL shipped model (workbench example: medium-document-processing). One document service, declared once — entities, a bounded-retry lifecycle (submitted/queued/processing/completed/failed, retry_count at most 2), and a working-memory envelope (two 384 MB task slots against a 1 GB worker) — is consumed several ways: a lifecycle reachability check, a retry-bound check, and a memory analysis. Two kinds of question over one system; their verdicts meet at a gate. Nothing here was reconstructed from the code — every figure is a declaration in the model.</a:t>
+              <a:t>TIMING: 3 minutes</a:t>
+            </a:r>
+          </a:p>
+          <a:p>
+            <a:r>
+              <a:t>- Make this concrete with one document-processing-service model.</a:t>
+            </a:r>
+          </a:p>
+          <a:p>
+            <a:r>
+              <a:t>- Suppose the model includes a lifecycle machine and resource graph.</a:t>
+            </a:r>
+          </a:p>
+          <a:p>
+            <a:r>
+              <a:t>- From the lifecycle model, ask whether a Completed document can re-enter processing.</a:t>
+            </a:r>
+          </a:p>
+          <a:p>
+            <a:r>
+              <a:t>- From retry structure, establish whether the retry loop is bounded.</a:t>
+            </a:r>
+          </a:p>
+          <a:p>
+            <a:r>
+              <a:t>- From the resource graph, calculate peak memory demand.</a:t>
+            </a:r>
+          </a:p>
+          <a:p>
+            <a:r>
+              <a:t>- These are different validators over shared engineering knowledge.</a:t>
+            </a:r>
+          </a:p>
+          <a:p>
+            <a:r>
+              <a:t>- Their verdicts may simply be reported, or some may feed a gate.</a:t>
+            </a:r>
+          </a:p>
+          <a:p>
+            <a:r>
+              <a:t>- The gate is optional because not every judgment should automatically block an action.</a:t>
+            </a:r>
+          </a:p>
+          <a:p>
+            <a:r>
+              <a:t>- This is what models buy Alignment: explicit engineering knowledge can be consumed by multiple controls without reconstructing the relevant structure separately each time.</a:t>
+            </a:r>
+          </a:p>
+          <a:p>
+            <a:r>
+              <a:t>ANIMATION</a:t>
+            </a:r>
+          </a:p>
+          <a:p>
+            <a:r>
+              <a:t>- Reveal the explicit model first.</a:t>
+            </a:r>
+          </a:p>
+          <a:p>
+            <a:r>
+              <a:t>- Reveal LIFECYCLE CHECK and verdict.</a:t>
+            </a:r>
+          </a:p>
+          <a:p>
+            <a:r>
+              <a:t>- Reveal RETRY BOUND and verdict.</a:t>
+            </a:r>
+          </a:p>
+          <a:p>
+            <a:r>
+              <a:t>- Reveal MEMORY ANALYSIS and verdict.</a:t>
+            </a:r>
+          </a:p>
+          <a:p>
+            <a:r>
+              <a:t>- Reveal VERDICTS.</a:t>
+            </a:r>
+          </a:p>
+          <a:p>
+            <a:r>
+              <a:t>- Reveal optional GATE last.</a:t>
             </a:r>
           </a:p>
         </p:txBody>
@@ -2582,7 +4216,67 @@
           <a:lstStyle/>
           <a:p>
             <a:r>
-              <a:t>A PLAUSIBLE work order, not a generic list. Walk the rows; the right-hand annotations name what each row is doing: outcome, scope, obligations, process, stopping condition, authority.</a:t>
+              <a:t>TIMING: 2 minutes</a:t>
+            </a:r>
+          </a:p>
+          <a:p>
+            <a:r>
+              <a:t>- Here is a much more useful delegation than "add bulk refunds."</a:t>
+            </a:r>
+          </a:p>
+          <a:p>
+            <a:r>
+              <a:t>- Goal says what we want.</a:t>
+            </a:r>
+          </a:p>
+          <a:p>
+            <a:r>
+              <a:t>- Scope says where the work belongs.</a:t>
+            </a:r>
+          </a:p>
+          <a:p>
+            <a:r>
+              <a:t>- Preserve and Do not encode obligations and exclusions.</a:t>
+            </a:r>
+          </a:p>
+          <a:p>
+            <a:r>
+              <a:t>- Check says what evidence we expect.</a:t>
+            </a:r>
+          </a:p>
+          <a:p>
+            <a:r>
+              <a:t>- Deliver says when this unit of work terminates.</a:t>
+            </a:r>
+          </a:p>
+          <a:p>
+            <a:r>
+              <a:t>- Authority says what consequential actions remain outside the delegation.</a:t>
+            </a:r>
+          </a:p>
+          <a:p>
+            <a:r>
+              <a:t>- Notice that none of this tells the agent exactly how to implement bulk refunds.</a:t>
+            </a:r>
+          </a:p>
+          <a:p>
+            <a:r>
+              <a:t>- That is deliberate.</a:t>
+            </a:r>
+          </a:p>
+          <a:p>
+            <a:r>
+              <a:t>ANIMATION</a:t>
+            </a:r>
+          </a:p>
+          <a:p>
+            <a:r>
+              <a:t>- Reveal the work order row by row.</a:t>
+            </a:r>
+          </a:p>
+          <a:p>
+            <a:r>
+              <a:t>- Reveal the right-side category labels after each corresponding row, or all together at the end.</a:t>
             </a:r>
           </a:p>
         </p:txBody>
@@ -2652,7 +4346,62 @@
           <a:lstStyle/>
           <a:p>
             <a:r>
-              <a:t>This is where "environment" finally becomes concrete. The agent is not a chat window: it is placed inside a repository, with tools and context, and its work leaves through a commit and a PR.</a:t>
+              <a:t>TIMING: 2 minutes</a:t>
+            </a:r>
+          </a:p>
+          <a:p>
+            <a:r>
+              <a:t>- In practice, the agent does not receive only natural-language instructions.</a:t>
+            </a:r>
+          </a:p>
+          <a:p>
+            <a:r>
+              <a:t>- It receives a repository, worktree, branch, tools, tests, CI configuration, issue context, and repository instructions.</a:t>
+            </a:r>
+          </a:p>
+          <a:p>
+            <a:r>
+              <a:t>- Those things collectively define part of the delegated environment.</a:t>
+            </a:r>
+          </a:p>
+          <a:p>
+            <a:r>
+              <a:t>- Some are information. Some are capabilities. Some are constraints.</a:t>
+            </a:r>
+          </a:p>
+          <a:p>
+            <a:r>
+              <a:t>- The output is also structured: not "some code somewhere," but typically a proposed change, commit, or PR.</a:t>
+            </a:r>
+          </a:p>
+          <a:p>
+            <a:r>
+              <a:t>- This environment is already doing engineering work before we add any sophisticated agent-specific machinery.</a:t>
+            </a:r>
+          </a:p>
+          <a:p>
+            <a:r>
+              <a:t>ANIMATION</a:t>
+            </a:r>
+          </a:p>
+          <a:p>
+            <a:r>
+              <a:t>- Reveal WORK ORDER and WORKTREE.</a:t>
+            </a:r>
+          </a:p>
+          <a:p>
+            <a:r>
+              <a:t>- Reveal AGENT.</a:t>
+            </a:r>
+          </a:p>
+          <a:p>
+            <a:r>
+              <a:t>- Reveal proposed change / commit / PR.</a:t>
+            </a:r>
+          </a:p>
+          <a:p>
+            <a:r>
+              <a:t>- Reveal the concrete environment elements last.</a:t>
             </a:r>
           </a:p>
         </p:txBody>
@@ -2722,7 +4471,57 @@
           <a:lstStyle/>
           <a:p>
             <a:r>
-              <a:t>Transition from the todo app: "That was fine for a todo list. Now suppose the work matters. What else would we give the agent?" Caution: do NOT claim every delegation requires all of these to be explicitly specified. The point is that some process will occur whether you model it or not.</a:t>
+              <a:t>TIMING: 2 minutes</a:t>
+            </a:r>
+          </a:p>
+          <a:p>
+            <a:r>
+              <a:t>- "Add bulk refunds" describes an outcome.</a:t>
+            </a:r>
+          </a:p>
+          <a:p>
+            <a:r>
+              <a:t>- Imagine handing that sentence to a human engineer on their first day. What else would they need to know?</a:t>
+            </a:r>
+          </a:p>
+          <a:p>
+            <a:r>
+              <a:t>- Where may they work? What existing behavior must survive? What may they not touch? What checks establish success? What are they supposed to hand back?</a:t>
+            </a:r>
+          </a:p>
+          <a:p>
+            <a:r>
+              <a:t>- Agentic engineering does not make those questions disappear.</a:t>
+            </a:r>
+          </a:p>
+          <a:p>
+            <a:r>
+              <a:t>- In fact, cheap implementation makes it easier to discover that we never answered them.</a:t>
+            </a:r>
+          </a:p>
+          <a:p>
+            <a:r>
+              <a:t>- Delegation therefore includes both the desired outcome and a process within which the outcome is produced.</a:t>
+            </a:r>
+          </a:p>
+          <a:p>
+            <a:r>
+              <a:t>ANIMATION</a:t>
+            </a:r>
+          </a:p>
+          <a:p>
+            <a:r>
+              <a:t>- Show TASK first.</a:t>
+            </a:r>
+          </a:p>
+          <a:p>
+            <a:r>
+              <a:t>- Ask "what else do you need?" before revealing PROCESS questions.</a:t>
+            </a:r>
+          </a:p>
+          <a:p>
+            <a:r>
+              <a:t>- Reveal process questions progressively.</a:t>
             </a:r>
           </a:p>
         </p:txBody>
@@ -2792,7 +4591,57 @@
           <a:lstStyle/>
           <a:p>
             <a:r>
-              <a:t>Fourth failure mode. "All tests pass" is a claim, not yet evidence of the right thing. Recover the Section-1 definition: an OBLIGATION is a condition against which the work can be wrong. Evidence is evidence only relative to an obligation — one of the strongest propositions in the deck; let it land here.</a:t>
+              <a:t>TIMING: 2 minutes</a:t>
+            </a:r>
+          </a:p>
+          <a:p>
+            <a:r>
+              <a:t>- Fourth failure: "all tests pass" sounds like evidence, but evidence of what?</a:t>
+            </a:r>
+          </a:p>
+          <a:p>
+            <a:r>
+              <a:t>- Which tests? What obligation does each test bear on? In what environment did they run? What remains untested?</a:t>
+            </a:r>
+          </a:p>
+          <a:p>
+            <a:r>
+              <a:t>- Introduce obligation carefully: a condition against which the work can be wrong.</a:t>
+            </a:r>
+          </a:p>
+          <a:p>
+            <a:r>
+              <a:t>- Evidence is not useful merely because some measurement or test exists. It must bear on an obligation we care about.</a:t>
+            </a:r>
+          </a:p>
+          <a:p>
+            <a:r>
+              <a:t>- This is why the opening exercise produced different answers to "does it work?" Students silently chose different obligations and collected different evidence.</a:t>
+            </a:r>
+          </a:p>
+          <a:p>
+            <a:r>
+              <a:t>ANIMATION</a:t>
+            </a:r>
+          </a:p>
+          <a:p>
+            <a:r>
+              <a:t>- Reveal the agent's claim first: "All tests pass."</a:t>
+            </a:r>
+          </a:p>
+          <a:p>
+            <a:r>
+              <a:t>- Reveal OBLIGATION definition.</a:t>
+            </a:r>
+          </a:p>
+          <a:p>
+            <a:r>
+              <a:t>- Reveal the diagnostic questions.</a:t>
+            </a:r>
+          </a:p>
+          <a:p>
+            <a:r>
+              <a:t>- Reveal "Evidence bears on an obligation" last.</a:t>
             </a:r>
           </a:p>
         </p:txBody>
@@ -2862,7 +4711,67 @@
           <a:lstStyle/>
           <a:p>
             <a:r>
-              <a:t>Almost empty on purpose — no list of suggested checks initially; let the room discover the ambiguity. The gold line and the check list are a BUILD revealed after discussion. Collect: adding, editing, deletion, persistence, appearance, console errors, refresh, multiple tabs. Only after they volunteer these, point out that they are implicitly inventing obligations and evidence. Do not resolve anything yet.</a:t>
+              <a:t>TIMING: 3 minutes</a:t>
+            </a:r>
+          </a:p>
+          <a:p>
+            <a:r>
+              <a:t>- Stop coding. Open what the agent produced.</a:t>
+            </a:r>
+          </a:p>
+          <a:p>
+            <a:r>
+              <a:t>- Show of hands: does yours work?</a:t>
+            </a:r>
+          </a:p>
+          <a:p>
+            <a:r>
+              <a:t>- Now the important question: what did you do before you were willing to say yes?</a:t>
+            </a:r>
+          </a:p>
+          <a:p>
+            <a:r>
+              <a:t>- Take answers from the room before revealing examples.</a:t>
+            </a:r>
+          </a:p>
+          <a:p>
+            <a:r>
+              <a:t>- Students will usually test adding, deleting, refresh, perhaps editing. Someone may inspect the console. Someone may notice something nobody else checked.</a:t>
+            </a:r>
+          </a:p>
+          <a:p>
+            <a:r>
+              <a:t>- The phrase "it works" concealed a collection of claims and a collection of evidence.</a:t>
+            </a:r>
+          </a:p>
+          <a:p>
+            <a:r>
+              <a:t>- Notice also what you probably did not establish. Did anyone test two tabs? malformed input? browser restart? storage exhaustion?</a:t>
+            </a:r>
+          </a:p>
+          <a:p>
+            <a:r>
+              <a:t>- This is our Validation problem again: a judgment depends on what claim we are making and what evidence bears on it.</a:t>
+            </a:r>
+          </a:p>
+          <a:p>
+            <a:r>
+              <a:t>ANIMATION</a:t>
+            </a:r>
+          </a:p>
+          <a:p>
+            <a:r>
+              <a:t>- Start with only "Does it work?"</a:t>
+            </a:r>
+          </a:p>
+          <a:p>
+            <a:r>
+              <a:t>- Reveal "What did you check before answering?" after collecting yes/no answers.</a:t>
+            </a:r>
+          </a:p>
+          <a:p>
+            <a:r>
+              <a:t>- Reveal the example checks only after students supply their own.</a:t>
             </a:r>
           </a:p>
         </p:txBody>
@@ -2932,7 +4841,52 @@
           <a:lstStyle/>
           <a:p>
             <a:r>
-              <a:t>Deliberately low-stakes and independent of the running engineering example. Students should experience "I asked an agent for something; it produced something that looks plausible; now what does WORKS mean?" before consequential delegated work appears. "Use whatever implementation approach you think is appropriate" deliberately creates degrees of freedom to return to later: different frameworks, storage mechanisms, UI choices, command sequences. The prompt paragraph is a single copyable block — students paste it into Claude Code.</a:t>
+              <a:t>TIMING: 6 minutes</a:t>
+            </a:r>
+          </a:p>
+          <a:p>
+            <a:r>
+              <a:t>- This is an experiment, not a programming exercise. Do exactly what the prompt says.</a:t>
+            </a:r>
+          </a:p>
+          <a:p>
+            <a:r>
+              <a:t>- Give the agent the work. Do not rescue it, redirect it, or improve its choices.</a:t>
+            </a:r>
+          </a:p>
+          <a:p>
+            <a:r>
+              <a:t>- Notice how much freedom the prompt leaves: language, framework, architecture, persistence mechanism, styling, testing strategy.</a:t>
+            </a:r>
+          </a:p>
+          <a:p>
+            <a:r>
+              <a:t>- If the agent asks you to choose something that the prompt leaves open, let it choose.</a:t>
+            </a:r>
+          </a:p>
+          <a:p>
+            <a:r>
+              <a:t>- The interesting part comes after it says it is finished.</a:t>
+            </a:r>
+          </a:p>
+          <a:p>
+            <a:r>
+              <a:t>ANIMATION</a:t>
+            </a:r>
+          </a:p>
+          <a:p>
+            <a:r>
+              <a:t>- Reveal the task first.</a:t>
+            </a:r>
+          </a:p>
+          <a:p>
+            <a:r>
+              <a:t>- Reveal "Do not help the agent" and "If it makes a choice…" only after students have started reading.</a:t>
+            </a:r>
+          </a:p>
+          <a:p>
+            <a:r>
+              <a:t>- Start the five-minute timer after instructions are clear.</a:t>
             </a:r>
           </a:p>
         </p:txBody>

</xml_diff>

<commit_message>
deck 2-3: open with the Master Equation before the vibe-code exercise (37 -> 38)
New slide 2 'The Master Equation', inserted between the title slide and
'Vibe code a todo list' (located by title adjacency). Visually rhymes with
2-2-1 slide 3 'The equation of production': identical equation box
(54pt italic 5C4826 at the same offsets), identical gloss line, identical
gold FooterBand geometry carrying the one gold-rule question 'What makes a
result acceptable?'. The four definitions are compressed to a single small
line (T task / M reasoning model / R representation / H harness/process)
per the author's revision. Author's speaker notes attached; the 37
pre-existing slides' notes verified byte-identical.

Co-Authored-By: Claude Opus 5 <noreply@anthropic.com>
</commit_message>
<xml_diff>
--- a/course/lectures/act-2-delegation-and-control/03-alignment/2-3-Alignment.pptx
+++ b/course/lectures/act-2-delegation-and-control/03-alignment/2-3-Alignment.pptx
@@ -9,6 +9,7 @@
   </p:notesMasterIdLst>
   <p:sldIdLst>
     <p:sldId id="256" r:id="rId7"/>
+    <p:sldId id="302" r:id="rId54"/>
     <p:sldId id="289" r:id="rId15"/>
     <p:sldId id="290" r:id="rId34"/>
     <p:sldId id="258" r:id="rId9"/>
@@ -4171,6 +4172,111 @@
 </p:notes>
 </file>
 
+<file path=ppt/notesSlides/notesSlide38.xml><?xml version="1.0" encoding="utf-8"?>
+<p:notes xmlns:a="http://schemas.openxmlformats.org/drawingml/2006/main" xmlns:p="http://schemas.openxmlformats.org/presentationml/2006/main" xmlns:r="http://schemas.openxmlformats.org/officeDocument/2006/relationships">
+  <p:cSld>
+    <p:spTree>
+      <p:nvGrpSpPr>
+        <p:cNvPr id="1" name=""/>
+        <p:cNvGrpSpPr/>
+        <p:nvPr/>
+      </p:nvGrpSpPr>
+      <p:grpSpPr>
+        <a:xfrm>
+          <a:off x="0" y="0"/>
+          <a:ext cx="0" cy="0"/>
+          <a:chOff x="0" y="0"/>
+          <a:chExt cx="0" cy="0"/>
+        </a:xfrm>
+      </p:grpSpPr>
+      <p:sp>
+        <p:nvSpPr>
+          <p:cNvPr id="2" name="Slide Image Placeholder 1"/>
+          <p:cNvSpPr>
+            <a:spLocks noGrp="1"/>
+          </p:cNvSpPr>
+          <p:nvPr>
+            <p:ph type="sldImg" idx="2"/>
+          </p:nvPr>
+        </p:nvSpPr>
+        <p:spPr/>
+      </p:sp>
+      <p:sp>
+        <p:nvSpPr>
+          <p:cNvPr id="3" name="Notes Placeholder 2"/>
+          <p:cNvSpPr>
+            <a:spLocks noGrp="1"/>
+          </p:cNvSpPr>
+          <p:nvPr>
+            <p:ph type="body" idx="3" sz="quarter"/>
+          </p:nvPr>
+        </p:nvSpPr>
+        <p:spPr/>
+        <p:txBody>
+          <a:bodyPr/>
+          <a:lstStyle/>
+          <a:p>
+            <a:r>
+              <a:t>TIMING: 1 minute</a:t>
+            </a:r>
+          </a:p>
+          <a:p>
+            <a:r>
+              <a:t>- You saw this equation in Modeling. It describes the production problem: given the task, reasoner, representation, and harness, how likely is delegation to produce an acceptable result?</a:t>
+            </a:r>
+          </a:p>
+          <a:p>
+            <a:r>
+              <a:t>- Last time we opened R. Modeling changes the representation available to the reasoner.</a:t>
+            </a:r>
+          </a:p>
+          <a:p>
+            <a:r>
+              <a:t>- Today, notice one word we have mostly taken for granted: acceptable. What does that mean?</a:t>
+            </a:r>
+          </a:p>
+          <a:p>
+            <a:r>
+              <a:t>- Then immediately: let's run the production system.</a:t>
+            </a:r>
+          </a:p>
+          <a:p>
+            <a:r>
+              <a:t>- Advance to the vibe-coding exercise. Do not explain Alignment first; the students are about to experience the ambiguity in "acceptable" for themselves.</a:t>
+            </a:r>
+          </a:p>
+          <a:p>
+            <a:r>
+              <a:t/>
+            </a:r>
+          </a:p>
+          <a:p>
+            <a:r>
+              <a:t>ANIMATION</a:t>
+            </a:r>
+          </a:p>
+          <a:p>
+            <a:r>
+              <a:t>- Reveal the equation exactly as remembered from Modeling.</a:t>
+            </a:r>
+          </a:p>
+          <a:p>
+            <a:r>
+              <a:t>- Reveal the four definitions.</a:t>
+            </a:r>
+          </a:p>
+          <a:p>
+            <a:r>
+              <a:t>- Reveal "What makes a result acceptable?" last, and leave it up as you advance.</a:t>
+            </a:r>
+          </a:p>
+        </p:txBody>
+      </p:sp>
+    </p:spTree>
+  </p:cSld>
+</p:notes>
+</file>
+
 <file path=ppt/notesSlides/notesSlide4.xml><?xml version="1.0" encoding="utf-8"?>
 <p:notes xmlns:a="http://schemas.openxmlformats.org/drawingml/2006/main" xmlns:p="http://schemas.openxmlformats.org/presentationml/2006/main" xmlns:r="http://schemas.openxmlformats.org/officeDocument/2006/relationships">
   <p:cSld>
@@ -7459,7 +7565,7 @@
             </a:r>
             <a:r>
               <a:rPr lang="en-US" b="1" u="none" dirty="0"/>
-              <a:t>		Details</a:t>
+              <a:t xml:space="preserve">		Details</a:t>
             </a:r>
           </a:p>
           <a:p>
@@ -7636,7 +7742,7 @@
             </a:r>
             <a:r>
               <a:rPr lang="en-US" b="1" u="none" dirty="0"/>
-              <a:t>		Details</a:t>
+              <a:t xml:space="preserve">		Details</a:t>
             </a:r>
           </a:p>
           <a:p>
@@ -17744,7 +17850,7 @@
                   <a:srgbClr val="8E6F3E"/>
                 </a:solidFill>
               </a:rPr>
-              <a:t>OBLIGATION  </a:t>
+              <a:t xml:space="preserve">OBLIGATION  </a:t>
             </a:r>
             <a:r>
               <a:rPr sz="1800" b="0" i="0">
@@ -20137,7 +20243,7 @@
                   <a:srgbClr val="FBF8F2"/>
                 </a:solidFill>
               </a:rPr>
-              <a:t>ONE EXPLICIT MODEL  </a:t>
+              <a:t xml:space="preserve">ONE EXPLICIT MODEL  </a:t>
             </a:r>
             <a:r>
               <a:rPr sz="1050" b="0" i="1">
@@ -22551,7 +22657,7 @@
                   <a:srgbClr val="8E6F3E"/>
                 </a:solidFill>
               </a:rPr>
-              <a:t>SCENARIO — </a:t>
+              <a:t xml:space="preserve">SCENARIO — </a:t>
             </a:r>
             <a:r>
               <a:rPr sz="2000" b="1" i="0">
@@ -22613,7 +22719,7 @@
                   <a:srgbClr val="8E6F3E"/>
                 </a:solidFill>
               </a:rPr>
-              <a:t>1  ·  </a:t>
+              <a:t xml:space="preserve">1  ·  </a:t>
             </a:r>
             <a:r>
               <a:rPr sz="1400" b="0" i="0">
@@ -22675,7 +22781,7 @@
                   <a:srgbClr val="8E6F3E"/>
                 </a:solidFill>
               </a:rPr>
-              <a:t>2  ·  </a:t>
+              <a:t xml:space="preserve">2  ·  </a:t>
             </a:r>
             <a:r>
               <a:rPr sz="1400" b="0" i="0">
@@ -22737,7 +22843,7 @@
                   <a:srgbClr val="8E6F3E"/>
                 </a:solidFill>
               </a:rPr>
-              <a:t>3  ·  </a:t>
+              <a:t xml:space="preserve">3  ·  </a:t>
             </a:r>
             <a:r>
               <a:rPr sz="1400" b="0" i="0">
@@ -22799,7 +22905,7 @@
                   <a:srgbClr val="8E6F3E"/>
                 </a:solidFill>
               </a:rPr>
-              <a:t>4  ·  </a:t>
+              <a:t xml:space="preserve">4  ·  </a:t>
             </a:r>
             <a:r>
               <a:rPr sz="1400" b="0" i="0">
@@ -22937,7 +23043,7 @@
                 </a:solidFill>
                 <a:latin typeface="Consolas"/>
               </a:rPr>
-              <a:t> ├─ API: IController</a:t>
+              <a:t xml:space="preserve"> ├─ API: IController</a:t>
             </a:r>
           </a:p>
           <a:p>
@@ -22949,7 +23055,7 @@
                 </a:solidFill>
                 <a:latin typeface="Consolas"/>
               </a:rPr>
-              <a:t> ├─ uses → Sensor</a:t>
+              <a:t xml:space="preserve"> ├─ uses → Sensor</a:t>
             </a:r>
           </a:p>
           <a:p>
@@ -22961,7 +23067,7 @@
                 </a:solidFill>
                 <a:latin typeface="Consolas"/>
               </a:rPr>
-              <a:t> ├─ uses → Actuator</a:t>
+              <a:t xml:space="preserve"> ├─ uses → Actuator</a:t>
             </a:r>
           </a:p>
           <a:p>
@@ -22973,7 +23079,7 @@
                 </a:solidFill>
                 <a:latin typeface="Consolas"/>
               </a:rPr>
-              <a:t> ├─ forbidden → CloudSDK</a:t>
+              <a:t xml:space="preserve"> ├─ forbidden → CloudSDK</a:t>
             </a:r>
           </a:p>
           <a:p>
@@ -22985,7 +23091,7 @@
                 </a:solidFill>
                 <a:latin typeface="Consolas"/>
               </a:rPr>
-              <a:t> └─ memory ≤ 64 MB</a:t>
+              <a:t xml:space="preserve"> └─ memory ≤ 64 MB</a:t>
             </a:r>
           </a:p>
           <a:p>
@@ -24158,6 +24264,295 @@
                 </a:solidFill>
               </a:rPr>
               <a:t>Should failure control what happens next?</a:t>
+            </a:r>
+          </a:p>
+        </p:txBody>
+      </p:sp>
+    </p:spTree>
+  </p:cSld>
+  <p:clrMapOvr>
+    <a:masterClrMapping/>
+  </p:clrMapOvr>
+</p:sld>
+</file>
+
+<file path=ppt/slides/slide38.xml><?xml version="1.0" encoding="utf-8"?>
+<p:sld xmlns:a="http://schemas.openxmlformats.org/drawingml/2006/main" xmlns:r="http://schemas.openxmlformats.org/officeDocument/2006/relationships" xmlns:p="http://schemas.openxmlformats.org/presentationml/2006/main">
+  <p:cSld>
+    <p:spTree>
+      <p:nvGrpSpPr>
+        <p:cNvPr id="1" name=""/>
+        <p:cNvGrpSpPr/>
+        <p:nvPr/>
+      </p:nvGrpSpPr>
+      <p:grpSpPr>
+        <a:xfrm>
+          <a:off x="0" y="0"/>
+          <a:ext cx="0" cy="0"/>
+          <a:chOff x="0" y="0"/>
+          <a:chExt cx="0" cy="0"/>
+        </a:xfrm>
+      </p:grpSpPr>
+      <p:sp>
+        <p:nvSpPr>
+          <p:cNvPr id="2" name="Title 1"/>
+          <p:cNvSpPr>
+            <a:spLocks noGrp="1"/>
+          </p:cNvSpPr>
+          <p:nvPr>
+            <p:ph type="title"/>
+          </p:nvPr>
+        </p:nvSpPr>
+        <p:spPr/>
+        <p:txBody>
+          <a:bodyPr wrap="square"/>
+          <a:lstStyle/>
+          <a:p>
+            <a:r>
+              <a:rPr sz="2400" b="0">
+                <a:solidFill>
+                  <a:srgbClr val="000000"/>
+                </a:solidFill>
+              </a:rPr>
+              <a:t>The Master Equation</a:t>
+            </a:r>
+          </a:p>
+        </p:txBody>
+      </p:sp>
+      <p:sp>
+        <p:nvSpPr>
+          <p:cNvPr id="3" name="Slide Number Placeholder 2"/>
+          <p:cNvSpPr>
+            <a:spLocks noGrp="1"/>
+          </p:cNvSpPr>
+          <p:nvPr>
+            <p:ph type="sldNum" sz="quarter" idx="4"/>
+          </p:nvPr>
+        </p:nvSpPr>
+        <p:spPr/>
+        <p:txBody>
+          <a:bodyPr/>
+          <a:lstStyle/>
+          <a:p>
+            <a:fld id="{B7EB45DA-9A0D-DC49-8E02-F30A5DDC21C3}" type="slidenum">
+              <a:rPr lang="en-US" smtClean="0"/>
+              <a:t>2</a:t>
+            </a:fld>
+            <a:endParaRPr lang="en-US"/>
+          </a:p>
+        </p:txBody>
+      </p:sp>
+      <p:sp>
+        <p:nvSpPr>
+          <p:cNvPr id="11" name="EqBox"/>
+          <p:cNvSpPr txBox="1"/>
+          <p:nvPr/>
+        </p:nvSpPr>
+        <p:spPr>
+          <a:xfrm>
+            <a:off x="274320" y="1554480"/>
+            <a:ext cx="8595360" cy="822960"/>
+          </a:xfrm>
+          <a:prstGeom prst="rect">
+            <a:avLst/>
+          </a:prstGeom>
+          <a:noFill/>
+          <a:ln>
+            <a:noFill/>
+          </a:ln>
+        </p:spPr>
+        <p:txBody>
+          <a:bodyPr wrap="square" lIns="0" tIns="0" rIns="0" bIns="0" anchor="ctr"/>
+          <a:lstStyle/>
+          <a:p>
+            <a:pPr algn="ctr">
+              <a:spcAft>
+                <a:spcPts val="0"/>
+              </a:spcAft>
+              <a:buNone/>
+            </a:pPr>
+            <a:r>
+              <a:rPr lang="en-US" sz="5400" b="0" i="1" dirty="0">
+                <a:solidFill>
+                  <a:srgbClr val="5C4826"/>
+                </a:solidFill>
+              </a:rPr>
+              <a:t>p(T,M,R,H)</a:t>
+            </a:r>
+          </a:p>
+        </p:txBody>
+      </p:sp>
+      <p:sp>
+        <p:nvSpPr>
+          <p:cNvPr id="12" name="EqGloss"/>
+          <p:cNvSpPr txBox="1"/>
+          <p:nvPr/>
+        </p:nvSpPr>
+        <p:spPr>
+          <a:xfrm>
+            <a:off x="274320" y="2423160"/>
+            <a:ext cx="8595360" cy="365760"/>
+          </a:xfrm>
+          <a:prstGeom prst="rect">
+            <a:avLst/>
+          </a:prstGeom>
+          <a:noFill/>
+          <a:ln>
+            <a:noFill/>
+          </a:ln>
+        </p:spPr>
+        <p:txBody>
+          <a:bodyPr wrap="square" lIns="0" tIns="0" rIns="0" bIns="0" anchor="t"/>
+          <a:lstStyle/>
+          <a:p>
+            <a:pPr algn="ctr">
+              <a:spcAft>
+                <a:spcPts val="0"/>
+              </a:spcAft>
+              <a:buNone/>
+            </a:pPr>
+            <a:r>
+              <a:rPr lang="en-US" sz="1800" b="0" i="1" dirty="0">
+                <a:solidFill>
+                  <a:srgbClr val="555960"/>
+                </a:solidFill>
+              </a:rPr>
+              <a:t>the probability that delegation produces an acceptable result</a:t>
+            </a:r>
+          </a:p>
+        </p:txBody>
+      </p:sp>
+      <p:sp>
+        <p:nvSpPr>
+          <p:cNvPr id="13" name="DefLine"/>
+          <p:cNvSpPr txBox="1"/>
+          <p:nvPr/>
+        </p:nvSpPr>
+        <p:spPr>
+          <a:xfrm>
+            <a:off x="274320" y="4023360"/>
+            <a:ext cx="8595360" cy="365760"/>
+          </a:xfrm>
+          <a:prstGeom prst="rect">
+            <a:avLst/>
+          </a:prstGeom>
+          <a:noFill/>
+          <a:ln>
+            <a:noFill/>
+          </a:ln>
+        </p:spPr>
+        <p:txBody>
+          <a:bodyPr wrap="square" lIns="0" tIns="0" rIns="0" bIns="0" anchor="ctr"/>
+          <a:lstStyle/>
+          <a:p>
+            <a:pPr algn="ctr">
+              <a:spcAft>
+                <a:spcPts val="0"/>
+              </a:spcAft>
+              <a:buNone/>
+            </a:pPr>
+            <a:r>
+              <a:rPr lang="en-US" sz="1600" b="1" i="1" dirty="0">
+                <a:solidFill>
+                  <a:srgbClr val="8E6F3E"/>
+                </a:solidFill>
+              </a:rPr>
+              <a:t>T</a:t>
+            </a:r>
+            <a:r>
+              <a:rPr lang="en-US" sz="1600" b="0" dirty="0">
+                <a:solidFill>
+                  <a:srgbClr val="555960"/>
+                </a:solidFill>
+              </a:rPr>
+              <a:t xml:space="preserve"> task   ·   </a:t>
+            </a:r>
+            <a:r>
+              <a:rPr lang="en-US" sz="1600" b="1" i="1" dirty="0">
+                <a:solidFill>
+                  <a:srgbClr val="8E6F3E"/>
+                </a:solidFill>
+              </a:rPr>
+              <a:t>M</a:t>
+            </a:r>
+            <a:r>
+              <a:rPr lang="en-US" sz="1600" b="0" dirty="0">
+                <a:solidFill>
+                  <a:srgbClr val="555960"/>
+                </a:solidFill>
+              </a:rPr>
+              <a:t xml:space="preserve"> reasoning model   ·   </a:t>
+            </a:r>
+            <a:r>
+              <a:rPr lang="en-US" sz="1600" b="1" i="1" dirty="0">
+                <a:solidFill>
+                  <a:srgbClr val="8E6F3E"/>
+                </a:solidFill>
+              </a:rPr>
+              <a:t>R</a:t>
+            </a:r>
+            <a:r>
+              <a:rPr lang="en-US" sz="1600" b="0" dirty="0">
+                <a:solidFill>
+                  <a:srgbClr val="555960"/>
+                </a:solidFill>
+              </a:rPr>
+              <a:t xml:space="preserve"> representation   ·   </a:t>
+            </a:r>
+            <a:r>
+              <a:rPr lang="en-US" sz="1600" b="1" i="1" dirty="0">
+                <a:solidFill>
+                  <a:srgbClr val="8E6F3E"/>
+                </a:solidFill>
+              </a:rPr>
+              <a:t>H</a:t>
+            </a:r>
+            <a:r>
+              <a:rPr lang="en-US" sz="1600" b="0" dirty="0">
+                <a:solidFill>
+                  <a:srgbClr val="555960"/>
+                </a:solidFill>
+              </a:rPr>
+              <a:t xml:space="preserve"> harness/process</a:t>
+            </a:r>
+          </a:p>
+        </p:txBody>
+      </p:sp>
+      <p:sp>
+        <p:nvSpPr>
+          <p:cNvPr id="199" name="FooterBand"/>
+          <p:cNvSpPr/>
+          <p:nvPr/>
+        </p:nvSpPr>
+        <p:spPr>
+          <a:xfrm>
+            <a:off x="274320" y="5852160"/>
+            <a:ext cx="8595360" cy="566928"/>
+          </a:xfrm>
+          <a:prstGeom prst="rect">
+            <a:avLst/>
+          </a:prstGeom>
+          <a:solidFill>
+            <a:srgbClr val="8E6F3E"/>
+          </a:solidFill>
+          <a:ln>
+            <a:noFill/>
+          </a:ln>
+        </p:spPr>
+        <p:txBody>
+          <a:bodyPr wrap="square" lIns="27432" tIns="22860" rIns="27432" bIns="22860" anchor="ctr"/>
+          <a:lstStyle/>
+          <a:p>
+            <a:pPr algn="ctr">
+              <a:buNone/>
+            </a:pPr>
+            <a:r>
+              <a:rPr lang="en-US" sz="2000" b="1" i="0" dirty="0">
+                <a:solidFill>
+                  <a:srgbClr val="FFFFFF"/>
+                </a:solidFill>
+              </a:rPr>
+              <a:t>What makes a result acceptable?</a:t>
             </a:r>
           </a:p>
         </p:txBody>

</xml_diff>

<commit_message>
deck 2-3: return to the Master Equation before the stretch break (38 -> 39)
New slide 26 'Production is only part of the system', inserted between
'Right obligation, wrong boundary' and 'Stretch break' (located by title
adjacency, post-shift). p(T,M,R,H) sits at the top with the gold
PRODUCTION label ('probability of an acceptable candidate'); the word
'acceptable' opens into the vertical chain CANDIDATE -> OBLIGATION ->
EVIDENCE -> JUDGMENT -> CONSEQUENCE, chips styled exactly as the
'Alignment gives validation consequences' slide (CONSEQUENCE gold/white).
Gold footer band, verbatim: 'Production asks what delegation can produce.
Alignment governs what produced work may cause.' Author's speaker notes
attached. Prohibitions verified: no p(T,M,R,H,A), no 'Alignment changes
H', final slide untouched and equation-free. 37 pre-existing notes
byte-identical; deck now 39 slides.

Co-Authored-By: Claude Opus 5 <noreply@anthropic.com>
</commit_message>
<xml_diff>
--- a/course/lectures/act-2-delegation-and-control/03-alignment/2-3-Alignment.pptx
+++ b/course/lectures/act-2-delegation-and-control/03-alignment/2-3-Alignment.pptx
@@ -33,6 +33,7 @@
     <p:sldId id="269" r:id="rId20"/>
     <p:sldId id="270" r:id="rId21"/>
     <p:sldId id="272" r:id="rId23"/>
+    <p:sldId id="303" r:id="rId55"/>
     <p:sldId id="273" r:id="rId24"/>
     <p:sldId id="288" r:id="rId53"/>
     <p:sldId id="277" r:id="rId28"/>
@@ -4268,6 +4269,131 @@
           <a:p>
             <a:r>
               <a:t>- Reveal "What makes a result acceptable?" last, and leave it up as you advance.</a:t>
+            </a:r>
+          </a:p>
+        </p:txBody>
+      </p:sp>
+    </p:spTree>
+  </p:cSld>
+</p:notes>
+</file>
+
+<file path=ppt/notesSlides/notesSlide39.xml><?xml version="1.0" encoding="utf-8"?>
+<p:notes xmlns:a="http://schemas.openxmlformats.org/drawingml/2006/main" xmlns:p="http://schemas.openxmlformats.org/presentationml/2006/main" xmlns:r="http://schemas.openxmlformats.org/officeDocument/2006/relationships">
+  <p:cSld>
+    <p:spTree>
+      <p:nvGrpSpPr>
+        <p:cNvPr id="1" name=""/>
+        <p:cNvGrpSpPr/>
+        <p:nvPr/>
+      </p:nvGrpSpPr>
+      <p:grpSpPr>
+        <a:xfrm>
+          <a:off x="0" y="0"/>
+          <a:ext cx="0" cy="0"/>
+          <a:chOff x="0" y="0"/>
+          <a:chExt cx="0" cy="0"/>
+        </a:xfrm>
+      </p:grpSpPr>
+      <p:sp>
+        <p:nvSpPr>
+          <p:cNvPr id="2" name="Slide Image Placeholder 1"/>
+          <p:cNvSpPr>
+            <a:spLocks noGrp="1"/>
+          </p:cNvSpPr>
+          <p:nvPr>
+            <p:ph type="sldImg" idx="2"/>
+          </p:nvPr>
+        </p:nvSpPr>
+        <p:spPr/>
+      </p:sp>
+      <p:sp>
+        <p:nvSpPr>
+          <p:cNvPr id="3" name="Notes Placeholder 2"/>
+          <p:cNvSpPr>
+            <a:spLocks noGrp="1"/>
+          </p:cNvSpPr>
+          <p:nvPr>
+            <p:ph type="body" idx="3" sz="quarter"/>
+          </p:nvPr>
+        </p:nvSpPr>
+        <p:spPr/>
+        <p:txBody>
+          <a:bodyPr/>
+          <a:lstStyle/>
+          <a:p>
+            <a:r>
+              <a:t>TIMING: 3 minutes</a:t>
+            </a:r>
+          </a:p>
+          <a:p>
+            <a:r>
+              <a:t>- Now return to where we started. The Master Equation asks about production: how likely is this delegation system to produce an acceptable candidate?</a:t>
+            </a:r>
+          </a:p>
+          <a:p>
+            <a:r>
+              <a:t>- We absolutely care about this. Better models, better representations, better harnesses, and better work orders can raise this probability.</a:t>
+            </a:r>
+          </a:p>
+          <a:p>
+            <a:r>
+              <a:t>- But reliable engineering cannot mean requiring every production attempt to succeed.</a:t>
+            </a:r>
+          </a:p>
+          <a:p>
+            <a:r>
+              <a:t>- We need an engineered answer for the other cases too. What obligation applies? What evidence bears on it? Where can that evidence be obtained? What judgment follows? And what is that judgment permitted to control?</a:t>
+            </a:r>
+          </a:p>
+          <a:p>
+            <a:r>
+              <a:t>- Connect back to the section just finished: even this control system has to respect information availability. We cannot attach a meaningful consequence to a verdict we cannot yet justify. That is why the boundary follows the property.</a:t>
+            </a:r>
+          </a:p>
+          <a:p>
+            <a:r>
+              <a:t>- The conceptual payoff: production quality and Alignment are related, but they are not the same engineering problem. A better producer raises the probability that we get something acceptable. Alignment governs whether what was produced acquires consequences.</a:t>
+            </a:r>
+          </a:p>
+          <a:p>
+            <a:r>
+              <a:t>- Callback to Agents: capability and authority are independent. Production asks what the delegation can produce. Alignment asks what produced work may cause.</a:t>
+            </a:r>
+          </a:p>
+          <a:p>
+            <a:r>
+              <a:t>- Then stretch break. This is a good Act-II-halfway stopping point.</a:t>
+            </a:r>
+          </a:p>
+          <a:p>
+            <a:r>
+              <a:t/>
+            </a:r>
+          </a:p>
+          <a:p>
+            <a:r>
+              <a:t>ANIMATION</a:t>
+            </a:r>
+          </a:p>
+          <a:p>
+            <a:r>
+              <a:t>- Reveal p(T,M,R,H) and the PRODUCTION label first.</a:t>
+            </a:r>
+          </a:p>
+          <a:p>
+            <a:r>
+              <a:t>- Reveal CANDIDATE.</a:t>
+            </a:r>
+          </a:p>
+          <a:p>
+            <a:r>
+              <a:t>- Reveal OBLIGATION, EVIDENCE, JUDGMENT, CONSEQUENCE one at a time.</a:t>
+            </a:r>
+          </a:p>
+          <a:p>
+            <a:r>
+              <a:t>- Reveal the footer last.</a:t>
             </a:r>
           </a:p>
         </p:txBody>
@@ -24553,6 +24679,536 @@
                 </a:solidFill>
               </a:rPr>
               <a:t>What makes a result acceptable?</a:t>
+            </a:r>
+          </a:p>
+        </p:txBody>
+      </p:sp>
+    </p:spTree>
+  </p:cSld>
+  <p:clrMapOvr>
+    <a:masterClrMapping/>
+  </p:clrMapOvr>
+</p:sld>
+</file>
+
+<file path=ppt/slides/slide39.xml><?xml version="1.0" encoding="utf-8"?>
+<p:sld xmlns:a="http://schemas.openxmlformats.org/drawingml/2006/main" xmlns:r="http://schemas.openxmlformats.org/officeDocument/2006/relationships" xmlns:p="http://schemas.openxmlformats.org/presentationml/2006/main">
+  <p:cSld>
+    <p:spTree>
+      <p:nvGrpSpPr>
+        <p:cNvPr id="1" name=""/>
+        <p:cNvGrpSpPr/>
+        <p:nvPr/>
+      </p:nvGrpSpPr>
+      <p:grpSpPr>
+        <a:xfrm>
+          <a:off x="0" y="0"/>
+          <a:ext cx="0" cy="0"/>
+          <a:chOff x="0" y="0"/>
+          <a:chExt cx="0" cy="0"/>
+        </a:xfrm>
+      </p:grpSpPr>
+      <p:sp>
+        <p:nvSpPr>
+          <p:cNvPr id="2" name="Title 1"/>
+          <p:cNvSpPr>
+            <a:spLocks noGrp="1"/>
+          </p:cNvSpPr>
+          <p:nvPr>
+            <p:ph type="title"/>
+          </p:nvPr>
+        </p:nvSpPr>
+        <p:spPr/>
+        <p:txBody>
+          <a:bodyPr wrap="square"/>
+          <a:lstStyle/>
+          <a:p>
+            <a:r>
+              <a:rPr sz="2400" b="0">
+                <a:solidFill>
+                  <a:srgbClr val="000000"/>
+                </a:solidFill>
+              </a:rPr>
+              <a:t>Production is only part of the system</a:t>
+            </a:r>
+          </a:p>
+        </p:txBody>
+      </p:sp>
+      <p:sp>
+        <p:nvSpPr>
+          <p:cNvPr id="3" name="Slide Number Placeholder 2"/>
+          <p:cNvSpPr>
+            <a:spLocks noGrp="1"/>
+          </p:cNvSpPr>
+          <p:nvPr>
+            <p:ph type="sldNum" sz="quarter" idx="4"/>
+          </p:nvPr>
+        </p:nvSpPr>
+        <p:spPr/>
+        <p:txBody>
+          <a:bodyPr/>
+          <a:lstStyle/>
+          <a:p>
+            <a:fld id="{B7EB45DA-9A0D-DC49-8E02-F30A5DDC21C3}" type="slidenum">
+              <a:rPr lang="en-US" smtClean="0"/>
+              <a:t>25</a:t>
+            </a:fld>
+            <a:endParaRPr lang="en-US"/>
+          </a:p>
+        </p:txBody>
+      </p:sp>
+      <p:sp>
+        <p:nvSpPr>
+          <p:cNvPr id="10" name="ProdLabel"/>
+          <p:cNvSpPr txBox="1"/>
+          <p:nvPr/>
+        </p:nvSpPr>
+        <p:spPr>
+          <a:xfrm>
+            <a:off x="365760" y="1143000"/>
+            <a:ext cx="2925024" cy="822960"/>
+          </a:xfrm>
+          <a:prstGeom prst="rect">
+            <a:avLst/>
+          </a:prstGeom>
+          <a:noFill/>
+          <a:ln>
+            <a:noFill/>
+          </a:ln>
+        </p:spPr>
+        <p:txBody>
+          <a:bodyPr wrap="square" lIns="0" tIns="0" rIns="0" bIns="0" anchor="ctr"/>
+          <a:lstStyle/>
+          <a:p>
+            <a:pPr algn="l">
+              <a:spcAft>
+                <a:spcPts val="0"/>
+              </a:spcAft>
+              <a:buNone/>
+            </a:pPr>
+            <a:r>
+              <a:rPr lang="en-US" sz="1800" b="1" dirty="0">
+                <a:solidFill>
+                  <a:srgbClr val="8E6F3E"/>
+                </a:solidFill>
+              </a:rPr>
+              <a:t>PRODUCTION</a:t>
+            </a:r>
+          </a:p>
+          <a:p>
+            <a:pPr algn="l">
+              <a:spcAft>
+                <a:spcPts val="0"/>
+              </a:spcAft>
+              <a:buNone/>
+            </a:pPr>
+            <a:r>
+              <a:rPr lang="en-US" sz="1400" b="0" i="1" dirty="0">
+                <a:solidFill>
+                  <a:srgbClr val="555960"/>
+                </a:solidFill>
+              </a:rPr>
+              <a:t>probability of an acceptable candidate</a:t>
+            </a:r>
+          </a:p>
+        </p:txBody>
+      </p:sp>
+      <p:sp>
+        <p:nvSpPr>
+          <p:cNvPr id="11" name="EqNode"/>
+          <p:cNvSpPr txBox="1"/>
+          <p:nvPr/>
+        </p:nvSpPr>
+        <p:spPr>
+          <a:xfrm>
+            <a:off x="3200400" y="1143000"/>
+            <a:ext cx="2743200" cy="457200"/>
+          </a:xfrm>
+          <a:prstGeom prst="rect">
+            <a:avLst/>
+          </a:prstGeom>
+          <a:noFill/>
+          <a:ln>
+            <a:noFill/>
+          </a:ln>
+        </p:spPr>
+        <p:txBody>
+          <a:bodyPr wrap="square" lIns="0" tIns="0" rIns="0" bIns="0" anchor="ctr"/>
+          <a:lstStyle/>
+          <a:p>
+            <a:pPr algn="ctr">
+              <a:spcAft>
+                <a:spcPts val="0"/>
+              </a:spcAft>
+              <a:buNone/>
+            </a:pPr>
+            <a:r>
+              <a:rPr lang="en-US" sz="2800" b="0" i="1" dirty="0">
+                <a:solidFill>
+                  <a:srgbClr val="5C4826"/>
+                </a:solidFill>
+              </a:rPr>
+              <a:t>p(T,M,R,H)</a:t>
+            </a:r>
+          </a:p>
+        </p:txBody>
+      </p:sp>
+      <p:cxnSp>
+        <p:nvCxnSpPr>
+          <p:cNvPr id="20" name="A0"/>
+          <p:cNvCxnSpPr/>
+          <p:nvPr/>
+        </p:nvCxnSpPr>
+        <p:spPr>
+          <a:xfrm>
+            <a:off x="4572000" y="1737360"/>
+            <a:ext cx="0" cy="182880"/>
+          </a:xfrm>
+          <a:prstGeom prst="straightConnector1">
+            <a:avLst/>
+          </a:prstGeom>
+          <a:ln w="19050">
+            <a:solidFill>
+              <a:srgbClr val="8E6F3E"/>
+            </a:solidFill>
+            <a:tailEnd type="triangle" w="med" len="med"/>
+          </a:ln>
+        </p:spPr>
+      </p:cxnSp>
+      <p:sp>
+        <p:nvSpPr>
+          <p:cNvPr id="21" name="ChipCandidate"/>
+          <p:cNvSpPr/>
+          <p:nvPr/>
+        </p:nvSpPr>
+        <p:spPr>
+          <a:xfrm>
+            <a:off x="3474720" y="1920240"/>
+            <a:ext cx="2194560" cy="457200"/>
+          </a:xfrm>
+          <a:prstGeom prst="rect">
+            <a:avLst/>
+          </a:prstGeom>
+          <a:solidFill>
+            <a:srgbClr val="FBF8F2"/>
+          </a:solidFill>
+          <a:ln w="12700">
+            <a:solidFill>
+              <a:srgbClr val="C9B991"/>
+            </a:solidFill>
+          </a:ln>
+          <a:effectLst/>
+        </p:spPr>
+        <p:txBody>
+          <a:bodyPr rtlCol="0" anchor="ctr" wrap="square" lIns="27432" rIns="27432" tIns="22860" bIns="22860"/>
+          <a:lstStyle/>
+          <a:p>
+            <a:pPr algn="ctr"/>
+            <a:r>
+              <a:rPr sz="1800" b="1" i="0">
+                <a:solidFill>
+                  <a:srgbClr val="5C4826"/>
+                </a:solidFill>
+              </a:rPr>
+              <a:t>CANDIDATE</a:t>
+            </a:r>
+          </a:p>
+        </p:txBody>
+      </p:sp>
+      <p:cxnSp>
+        <p:nvCxnSpPr>
+          <p:cNvPr id="22" name="A1"/>
+          <p:cNvCxnSpPr/>
+          <p:nvPr/>
+        </p:nvCxnSpPr>
+        <p:spPr>
+          <a:xfrm>
+            <a:off x="4572000" y="2377440"/>
+            <a:ext cx="0" cy="228600"/>
+          </a:xfrm>
+          <a:prstGeom prst="straightConnector1">
+            <a:avLst/>
+          </a:prstGeom>
+          <a:ln w="19050">
+            <a:solidFill>
+              <a:srgbClr val="8E6F3E"/>
+            </a:solidFill>
+            <a:tailEnd type="triangle" w="med" len="med"/>
+          </a:ln>
+        </p:spPr>
+      </p:cxnSp>
+      <p:sp>
+        <p:nvSpPr>
+          <p:cNvPr id="23" name="ChipObligation"/>
+          <p:cNvSpPr/>
+          <p:nvPr/>
+        </p:nvSpPr>
+        <p:spPr>
+          <a:xfrm>
+            <a:off x="3474720" y="2606040"/>
+            <a:ext cx="2194560" cy="457200"/>
+          </a:xfrm>
+          <a:prstGeom prst="rect">
+            <a:avLst/>
+          </a:prstGeom>
+          <a:solidFill>
+            <a:srgbClr val="F5F1E8"/>
+          </a:solidFill>
+          <a:ln w="12700">
+            <a:solidFill>
+              <a:srgbClr val="C9B991"/>
+            </a:solidFill>
+          </a:ln>
+          <a:effectLst/>
+        </p:spPr>
+        <p:txBody>
+          <a:bodyPr rtlCol="0" anchor="ctr" wrap="square" lIns="27432" rIns="27432" tIns="22860" bIns="22860"/>
+          <a:lstStyle/>
+          <a:p>
+            <a:pPr algn="ctr"/>
+            <a:r>
+              <a:rPr sz="1800" b="1" i="0">
+                <a:solidFill>
+                  <a:srgbClr val="5C4826"/>
+                </a:solidFill>
+              </a:rPr>
+              <a:t>OBLIGATION</a:t>
+            </a:r>
+          </a:p>
+        </p:txBody>
+      </p:sp>
+      <p:cxnSp>
+        <p:nvCxnSpPr>
+          <p:cNvPr id="24" name="A2"/>
+          <p:cNvCxnSpPr/>
+          <p:nvPr/>
+        </p:nvCxnSpPr>
+        <p:spPr>
+          <a:xfrm>
+            <a:off x="4572000" y="3063240"/>
+            <a:ext cx="0" cy="228600"/>
+          </a:xfrm>
+          <a:prstGeom prst="straightConnector1">
+            <a:avLst/>
+          </a:prstGeom>
+          <a:ln w="19050">
+            <a:solidFill>
+              <a:srgbClr val="8E6F3E"/>
+            </a:solidFill>
+            <a:tailEnd type="triangle" w="med" len="med"/>
+          </a:ln>
+        </p:spPr>
+      </p:cxnSp>
+      <p:sp>
+        <p:nvSpPr>
+          <p:cNvPr id="25" name="ChipEvidence"/>
+          <p:cNvSpPr/>
+          <p:nvPr/>
+        </p:nvSpPr>
+        <p:spPr>
+          <a:xfrm>
+            <a:off x="3474720" y="3291840"/>
+            <a:ext cx="2194560" cy="457200"/>
+          </a:xfrm>
+          <a:prstGeom prst="rect">
+            <a:avLst/>
+          </a:prstGeom>
+          <a:solidFill>
+            <a:srgbClr val="F5F1E8"/>
+          </a:solidFill>
+          <a:ln w="12700">
+            <a:solidFill>
+              <a:srgbClr val="C9B991"/>
+            </a:solidFill>
+          </a:ln>
+          <a:effectLst/>
+        </p:spPr>
+        <p:txBody>
+          <a:bodyPr rtlCol="0" anchor="ctr" wrap="square" lIns="27432" rIns="27432" tIns="22860" bIns="22860"/>
+          <a:lstStyle/>
+          <a:p>
+            <a:pPr algn="ctr"/>
+            <a:r>
+              <a:rPr sz="1800" b="1" i="0">
+                <a:solidFill>
+                  <a:srgbClr val="5C4826"/>
+                </a:solidFill>
+              </a:rPr>
+              <a:t>EVIDENCE</a:t>
+            </a:r>
+          </a:p>
+        </p:txBody>
+      </p:sp>
+      <p:cxnSp>
+        <p:nvCxnSpPr>
+          <p:cNvPr id="26" name="A3"/>
+          <p:cNvCxnSpPr/>
+          <p:nvPr/>
+        </p:nvCxnSpPr>
+        <p:spPr>
+          <a:xfrm>
+            <a:off x="4572000" y="3749040"/>
+            <a:ext cx="0" cy="228600"/>
+          </a:xfrm>
+          <a:prstGeom prst="straightConnector1">
+            <a:avLst/>
+          </a:prstGeom>
+          <a:ln w="19050">
+            <a:solidFill>
+              <a:srgbClr val="8E6F3E"/>
+            </a:solidFill>
+            <a:tailEnd type="triangle" w="med" len="med"/>
+          </a:ln>
+        </p:spPr>
+      </p:cxnSp>
+      <p:sp>
+        <p:nvSpPr>
+          <p:cNvPr id="27" name="ChipJudgment"/>
+          <p:cNvSpPr/>
+          <p:nvPr/>
+        </p:nvSpPr>
+        <p:spPr>
+          <a:xfrm>
+            <a:off x="3474720" y="3977640"/>
+            <a:ext cx="2194560" cy="457200"/>
+          </a:xfrm>
+          <a:prstGeom prst="rect">
+            <a:avLst/>
+          </a:prstGeom>
+          <a:solidFill>
+            <a:srgbClr val="F5F1E8"/>
+          </a:solidFill>
+          <a:ln w="12700">
+            <a:solidFill>
+              <a:srgbClr val="C9B991"/>
+            </a:solidFill>
+          </a:ln>
+          <a:effectLst/>
+        </p:spPr>
+        <p:txBody>
+          <a:bodyPr rtlCol="0" anchor="ctr" wrap="square" lIns="27432" rIns="27432" tIns="22860" bIns="22860"/>
+          <a:lstStyle/>
+          <a:p>
+            <a:pPr algn="ctr"/>
+            <a:r>
+              <a:rPr sz="1800" b="1" i="0">
+                <a:solidFill>
+                  <a:srgbClr val="5C4826"/>
+                </a:solidFill>
+              </a:rPr>
+              <a:t>JUDGMENT</a:t>
+            </a:r>
+          </a:p>
+        </p:txBody>
+      </p:sp>
+      <p:cxnSp>
+        <p:nvCxnSpPr>
+          <p:cNvPr id="28" name="A4"/>
+          <p:cNvCxnSpPr/>
+          <p:nvPr/>
+        </p:nvCxnSpPr>
+        <p:spPr>
+          <a:xfrm>
+            <a:off x="4572000" y="4434840"/>
+            <a:ext cx="0" cy="228600"/>
+          </a:xfrm>
+          <a:prstGeom prst="straightConnector1">
+            <a:avLst/>
+          </a:prstGeom>
+          <a:ln w="19050">
+            <a:solidFill>
+              <a:srgbClr val="8E6F3E"/>
+            </a:solidFill>
+            <a:tailEnd type="triangle" w="med" len="med"/>
+          </a:ln>
+        </p:spPr>
+      </p:cxnSp>
+      <p:sp>
+        <p:nvSpPr>
+          <p:cNvPr id="29" name="ChipConsequence"/>
+          <p:cNvSpPr/>
+          <p:nvPr/>
+        </p:nvSpPr>
+        <p:spPr>
+          <a:xfrm>
+            <a:off x="3474720" y="4663440"/>
+            <a:ext cx="2194560" cy="457200"/>
+          </a:xfrm>
+          <a:prstGeom prst="rect">
+            <a:avLst/>
+          </a:prstGeom>
+          <a:solidFill>
+            <a:srgbClr val="8E6F3E"/>
+          </a:solidFill>
+          <a:ln>
+            <a:noFill/>
+          </a:ln>
+          <a:effectLst/>
+        </p:spPr>
+        <p:txBody>
+          <a:bodyPr rtlCol="0" anchor="ctr" wrap="square" lIns="27432" rIns="27432" tIns="22860" bIns="22860"/>
+          <a:lstStyle/>
+          <a:p>
+            <a:pPr algn="ctr"/>
+            <a:r>
+              <a:rPr sz="1800" b="1" i="0">
+                <a:solidFill>
+                  <a:srgbClr val="FFFFFF"/>
+                </a:solidFill>
+              </a:rPr>
+              <a:t>CONSEQUENCE</a:t>
+            </a:r>
+          </a:p>
+        </p:txBody>
+      </p:sp>
+      <p:sp>
+        <p:nvSpPr>
+          <p:cNvPr id="199" name="FooterBand"/>
+          <p:cNvSpPr/>
+          <p:nvPr/>
+        </p:nvSpPr>
+        <p:spPr>
+          <a:xfrm>
+            <a:off x="274320" y="5641848"/>
+            <a:ext cx="8595360" cy="777240"/>
+          </a:xfrm>
+          <a:prstGeom prst="rect">
+            <a:avLst/>
+          </a:prstGeom>
+          <a:solidFill>
+            <a:srgbClr val="8E6F3E"/>
+          </a:solidFill>
+          <a:ln>
+            <a:noFill/>
+          </a:ln>
+        </p:spPr>
+        <p:txBody>
+          <a:bodyPr wrap="square" lIns="27432" tIns="0" rIns="27432" bIns="45720" anchor="ctr"/>
+          <a:lstStyle/>
+          <a:p>
+            <a:pPr algn="ctr">
+              <a:buNone/>
+            </a:pPr>
+            <a:r>
+              <a:rPr lang="en-US" sz="2000" b="1" i="0" dirty="0">
+                <a:solidFill>
+                  <a:srgbClr val="FFFFFF"/>
+                </a:solidFill>
+              </a:rPr>
+              <a:t>Production asks what delegation can produce.</a:t>
+            </a:r>
+          </a:p>
+          <a:p>
+            <a:pPr algn="ctr">
+              <a:buNone/>
+            </a:pPr>
+            <a:r>
+              <a:rPr lang="en-US" sz="2000" b="1" i="0" dirty="0">
+                <a:solidFill>
+                  <a:srgbClr val="FFFFFF"/>
+                </a:solidFill>
+              </a:rPr>
+              <a:t>Alignment governs what produced work may cause.</a:t>
             </a:r>
           </a:p>
         </p:txBody>

</xml_diff>

<commit_message>
deck 2-3 S2: four failure siblings collapse into wrong result / wrong process
Divider question becomes the two-class claim; new taxonomy slide 'Either bound
can be violated' (question / example / validation target) lands before the
examples; the four failure slides recast as instances; insufficient-evidence
slide gains the explicit classroom question and closes on the
justified-acceptance line, with the decision-boundary speaker note. 20pt floor
across the section.
</commit_message>
<xml_diff>
--- a/course/lectures/act-2-delegation-and-control/03-alignment/2-3-Alignment.pptx
+++ b/course/lectures/act-2-delegation-and-control/03-alignment/2-3-Alignment.pptx
@@ -20,6 +20,7 @@
     <p:sldId id="294" r:id="rId38"/>
     <p:sldId id="295" r:id="rId39"/>
     <p:sldId id="285" r:id="rId50"/>
+    <p:sldId id="304" r:id="rId40"/>
     <p:sldId id="297" r:id="rId41"/>
     <p:sldId id="298" r:id="rId42"/>
     <p:sldId id="299" r:id="rId14"/>
@@ -3103,7 +3104,12 @@
           </a:p>
           <a:p>
             <a:r>
-              <a:t>- Now we have a process, ask the engineering question: how can it fail?</a:t>
+              <a:t>- We bounded the task and the process. Either bound can be violated.</a:t>
+            </a:r>
+          </a:p>
+          <a:p>
+            <a:r>
+              <a:t>- A violated task bound is a wrong RESULT. A violated process bound is a wrong PROCESS.</a:t>
             </a:r>
           </a:p>
           <a:p>
@@ -4498,6 +4504,96 @@
 </p:notes>
 </file>
 
+<file path=ppt/notesSlides/notesSlide40.xml><?xml version="1.0" encoding="utf-8"?>
+<p:notes xmlns:a="http://schemas.openxmlformats.org/drawingml/2006/main" xmlns:p="http://schemas.openxmlformats.org/presentationml/2006/main" xmlns:r="http://schemas.openxmlformats.org/officeDocument/2006/relationships">
+  <p:cSld>
+    <p:spTree>
+      <p:nvGrpSpPr>
+        <p:cNvPr id="1" name=""/>
+        <p:cNvGrpSpPr/>
+        <p:nvPr/>
+      </p:nvGrpSpPr>
+      <p:grpSpPr>
+        <a:xfrm>
+          <a:off x="0" y="0"/>
+          <a:ext cx="0" cy="0"/>
+          <a:chOff x="0" y="0"/>
+          <a:chExt cx="0" cy="0"/>
+        </a:xfrm>
+      </p:grpSpPr>
+      <p:sp>
+        <p:nvSpPr>
+          <p:cNvPr id="2" name="Slide Image Placeholder 1"/>
+          <p:cNvSpPr>
+            <a:spLocks noGrp="1"/>
+          </p:cNvSpPr>
+          <p:nvPr>
+            <p:ph type="sldImg" idx="2"/>
+          </p:nvPr>
+        </p:nvSpPr>
+        <p:spPr/>
+      </p:sp>
+      <p:sp>
+        <p:nvSpPr>
+          <p:cNvPr id="3" name="Notes Placeholder 2"/>
+          <p:cNvSpPr>
+            <a:spLocks noGrp="1"/>
+          </p:cNvSpPr>
+          <p:nvPr>
+            <p:ph type="body" idx="3" sz="quarter"/>
+          </p:nvPr>
+        </p:nvSpPr>
+        <p:spPr/>
+        <p:txBody>
+          <a:bodyPr/>
+          <a:lstStyle/>
+          <a:p>
+            <a:r>
+              <a:t>TIMING: 2 minutes</a:t>
+            </a:r>
+          </a:p>
+          <a:p>
+            <a:r>
+              <a:t>- Section 1 bounded the task and the process. This slide says: either bound can be violated.</a:t>
+            </a:r>
+          </a:p>
+          <a:p>
+            <a:r>
+              <a:t>- Wrong result: the artifact fails an obligation. Validation targets the artifact or system state.</a:t>
+            </a:r>
+          </a:p>
+          <a:p>
+            <a:r>
+              <a:t>- Wrong process: the work was performed outside the delegated process. Validation targets actions, evidence, and authority.</a:t>
+            </a:r>
+          </a:p>
+          <a:p>
+            <a:r>
+              <a:t>- The four slides that follow are examples of these two classes, not four new categories.</a:t>
+            </a:r>
+          </a:p>
+        </p:txBody>
+      </p:sp>
+      <p:sp>
+        <p:nvSpPr>
+          <p:cNvPr id="4" name="Slide Number Placeholder 3"/>
+          <p:cNvSpPr>
+            <a:spLocks noGrp="1"/>
+          </p:cNvSpPr>
+          <p:nvPr>
+            <p:ph type="sldNum" idx="5" sz="quarter"/>
+          </p:nvPr>
+        </p:nvSpPr>
+        <p:spPr/>
+      </p:sp>
+    </p:spTree>
+  </p:cSld>
+  <p:clrMapOvr>
+    <a:masterClrMapping/>
+  </p:clrMapOvr>
+</p:notes>
+</file>
+
 <file path=ppt/notesSlides/notesSlide5.xml><?xml version="1.0" encoding="utf-8"?>
 <p:notes xmlns:a="http://schemas.openxmlformats.org/drawingml/2006/main" xmlns:p="http://schemas.openxmlformats.org/presentationml/2006/main" xmlns:r="http://schemas.openxmlformats.org/officeDocument/2006/relationships">
   <p:cSld>
@@ -4763,17 +4859,12 @@
           <a:lstStyle/>
           <a:p>
             <a:r>
-              <a:t>TIMING: 2 minutes</a:t>
-            </a:r>
-          </a:p>
-          <a:p>
-            <a:r>
-              <a:t>- Fourth failure: "all tests pass" sounds like evidence, but evidence of what?</a:t>
-            </a:r>
-          </a:p>
-          <a:p>
-            <a:r>
-              <a:t>- Which tests? What obligation does each test bear on? In what environment did they run? What remains untested?</a:t>
+              <a:t>TIMING: 3 minutes</a:t>
+            </a:r>
+          </a:p>
+          <a:p>
+            <a:r>
+              <a:t>- Fourth failure: "all tests pass" sounds like evidence, but evidence of what? Which tests? Against which obligations? In which environment? What wasn't tested?</a:t>
             </a:r>
           </a:p>
           <a:p>
@@ -4783,37 +4874,17 @@
           </a:p>
           <a:p>
             <a:r>
-              <a:t>- Evidence is not useful merely because some measurement or test exists. It must bear on an obligation we care about.</a:t>
-            </a:r>
-          </a:p>
-          <a:p>
-            <a:r>
-              <a:t>- This is why the opening exercise produced different answers to "does it work?" Students silently chose different obligations and collected different evidence.</a:t>
-            </a:r>
-          </a:p>
-          <a:p>
-            <a:r>
-              <a:t>ANIMATION</a:t>
-            </a:r>
-          </a:p>
-          <a:p>
-            <a:r>
-              <a:t>- Reveal the agent's claim first: "All tests pass."</a:t>
-            </a:r>
-          </a:p>
-          <a:p>
-            <a:r>
-              <a:t>- Reveal OBLIGATION definition.</a:t>
-            </a:r>
-          </a:p>
-          <a:p>
-            <a:r>
-              <a:t>- Reveal the diagnostic questions.</a:t>
-            </a:r>
-          </a:p>
-          <a:p>
-            <a:r>
-              <a:t>- Reveal "Evidence bears on an obligation" last.</a:t>
+              <a:t>- Then pose the classroom question explicitly and let them argue: can the result be correct while the process is wrong?</a:t>
+            </a:r>
+          </a:p>
+          <a:p>
+            <a:r>
+              <a:t>- Suppose the implementation really is correct. Do we care that the agent did not produce the required evidence? Yes. Engineering decisions are made under uncertainty. We cannot condition acceptance on facts we happen, in hindsight, to know were true. We condition acceptance on evidence available at the decision boundary.</a:t>
+            </a:r>
+          </a:p>
+          <a:p>
+            <a:r>
+              <a:t>- That separates truth from justified engineering judgment — the sharpest conceptual moment in this section.</a:t>
             </a:r>
           </a:p>
         </p:txBody>
@@ -10151,7 +10222,7 @@
                 <a:ea typeface="+mn-ea"/>
                 <a:cs typeface="+mn-cs"/>
               </a:rPr>
-              <a:t>What can go wrong between the work order and the result?</a:t>
+              <a:t>The result can be wrong. The process can be wrong.</a:t>
             </a:r>
           </a:p>
         </p:txBody>
@@ -10267,7 +10338,7 @@
           <a:p>
             <a:r>
               <a:rPr sz="2400"/>
-              <a:t>The result can be wrong</a:t>
+              <a:t>Wrong result</a:t>
             </a:r>
           </a:p>
         </p:txBody>
@@ -10281,7 +10352,7 @@
         <p:spPr>
           <a:xfrm>
             <a:off x="274320" y="932688"/>
-            <a:ext cx="8595360" cy="640080"/>
+            <a:ext cx="8595360" cy="731520"/>
           </a:xfrm>
           <a:prstGeom prst="rect">
             <a:avLst/>
@@ -10296,7 +10367,7 @@
           <a:p>
             <a:pPr algn="l"/>
             <a:r>
-              <a:rPr sz="1700" b="0" i="1">
+              <a:rPr sz="2000" b="0" i="1">
                 <a:solidFill>
                   <a:srgbClr val="555960"/>
                 </a:solidFill>
@@ -10307,7 +10378,7 @@
           <a:p>
             <a:pPr algn="l"/>
             <a:r>
-              <a:rPr sz="1700" b="0" i="1">
+              <a:rPr sz="2000" b="0" i="1">
                 <a:solidFill>
                   <a:srgbClr val="555960"/>
                 </a:solidFill>
@@ -10361,7 +10432,7 @@
           <a:p>
             <a:pPr algn="ctr"/>
             <a:r>
-              <a:rPr sz="1500" b="1" i="0">
+              <a:rPr sz="2000" b="1" i="0">
                 <a:solidFill>
                   <a:srgbClr val="5C4826"/>
                 </a:solidFill>
@@ -10452,7 +10523,7 @@
           <a:p>
             <a:pPr algn="ctr"/>
             <a:r>
-              <a:rPr sz="1400" b="1" i="0">
+              <a:rPr sz="2000" b="1" i="0">
                 <a:solidFill>
                   <a:srgbClr val="5C4826"/>
                 </a:solidFill>
@@ -10541,7 +10612,7 @@
         <p:spPr>
           <a:xfrm>
             <a:off x="3291840" y="3246120"/>
-            <a:ext cx="2103120" cy="365760"/>
+            <a:ext cx="2103120" cy="548640"/>
           </a:xfrm>
           <a:prstGeom prst="rect">
             <a:avLst/>
@@ -10556,7 +10627,7 @@
           <a:p>
             <a:pPr algn="ctr"/>
             <a:r>
-              <a:rPr sz="1500" b="0" i="0">
+              <a:rPr sz="2000" b="0" i="0">
                 <a:solidFill>
                   <a:srgbClr val="555960"/>
                 </a:solidFill>
@@ -10608,7 +10679,7 @@
           <a:p>
             <a:pPr algn="ctr"/>
             <a:r>
-              <a:rPr sz="1500" b="1" i="0">
+              <a:rPr sz="2000" b="1" i="0">
                 <a:solidFill>
                   <a:srgbClr val="FFFFFF"/>
                 </a:solidFill>
@@ -10661,7 +10732,7 @@
         <p:spPr>
           <a:xfrm>
             <a:off x="274320" y="4983480"/>
-            <a:ext cx="8595360" cy="365760"/>
+            <a:ext cx="8595360" cy="731520"/>
           </a:xfrm>
           <a:prstGeom prst="rect">
             <a:avLst/>
@@ -10676,7 +10747,7 @@
           <a:p>
             <a:pPr algn="ctr"/>
             <a:r>
-              <a:rPr sz="1500" b="0" i="1">
+              <a:rPr sz="2000" b="0" i="1">
                 <a:solidFill>
                   <a:srgbClr val="555960"/>
                 </a:solidFill>
@@ -10738,7 +10809,7 @@
           <a:p>
             <a:r>
               <a:rPr sz="2400"/>
-              <a:t>The agent can do the wrong work</a:t>
+              <a:t>Wrong process: prohibited action</a:t>
             </a:r>
           </a:p>
         </p:txBody>
@@ -10787,7 +10858,7 @@
           <a:p>
             <a:pPr algn="l"/>
             <a:r>
-              <a:rPr sz="1700" b="0" i="0">
+              <a:rPr sz="2000" b="0" i="0">
                 <a:solidFill>
                   <a:srgbClr val="5C4826"/>
                 </a:solidFill>
@@ -10841,7 +10912,7 @@
           <a:p>
             <a:pPr algn="l"/>
             <a:r>
-              <a:rPr sz="1700" b="0" i="0">
+              <a:rPr sz="2000" b="0" i="0">
                 <a:solidFill>
                   <a:srgbClr val="5C4826"/>
                 </a:solidFill>
@@ -10895,7 +10966,7 @@
           <a:p>
             <a:pPr algn="l"/>
             <a:r>
-              <a:rPr sz="1700" b="0" i="0">
+              <a:rPr sz="2000" b="0" i="0">
                 <a:solidFill>
                   <a:srgbClr val="5C4826"/>
                 </a:solidFill>
@@ -10949,7 +11020,7 @@
           <a:p>
             <a:pPr algn="l"/>
             <a:r>
-              <a:rPr sz="1700" b="0" i="0">
+              <a:rPr sz="2000" b="0" i="0">
                 <a:solidFill>
                   <a:srgbClr val="5C4826"/>
                 </a:solidFill>
@@ -11001,7 +11072,7 @@
           <a:p>
             <a:pPr algn="ctr"/>
             <a:r>
-              <a:rPr sz="1500" b="1" i="0">
+              <a:rPr sz="2000" b="1" i="0">
                 <a:solidFill>
                   <a:srgbClr val="FFFFFF"/>
                 </a:solidFill>
@@ -11149,7 +11220,7 @@
           <a:p>
             <a:r>
               <a:rPr sz="2400"/>
-              <a:t>The agent can exceed its authority</a:t>
+              <a:t>Wrong process: excess authority</a:t>
             </a:r>
           </a:p>
         </p:txBody>
@@ -11198,7 +11269,7 @@
           <a:p>
             <a:pPr algn="ctr"/>
             <a:r>
-              <a:rPr sz="1400" b="1" i="0">
+              <a:rPr sz="2000" b="1" i="0">
                 <a:solidFill>
                   <a:srgbClr val="5C4826"/>
                 </a:solidFill>
@@ -11323,7 +11394,7 @@
           <a:p>
             <a:pPr algn="ctr"/>
             <a:r>
-              <a:rPr sz="1400" b="1" i="0">
+              <a:rPr sz="2000" b="1" i="0">
                 <a:solidFill>
                   <a:srgbClr val="5C4826"/>
                 </a:solidFill>
@@ -11448,7 +11519,7 @@
           <a:p>
             <a:pPr algn="ctr"/>
             <a:r>
-              <a:rPr sz="1400" b="1" i="0">
+              <a:rPr sz="2000" b="1" i="0">
                 <a:solidFill>
                   <a:srgbClr val="5C4826"/>
                 </a:solidFill>
@@ -11573,7 +11644,7 @@
           <a:p>
             <a:pPr algn="ctr"/>
             <a:r>
-              <a:rPr sz="1400" b="1" i="0">
+              <a:rPr sz="2000" b="1" i="0">
                 <a:solidFill>
                   <a:srgbClr val="5C4826"/>
                 </a:solidFill>
@@ -11698,7 +11769,7 @@
           <a:p>
             <a:pPr algn="ctr"/>
             <a:r>
-              <a:rPr sz="1400" b="1" i="0">
+              <a:rPr sz="2000" b="1" i="0">
                 <a:solidFill>
                   <a:srgbClr val="5C4826"/>
                 </a:solidFill>
@@ -11823,7 +11894,7 @@
           <a:p>
             <a:pPr algn="ctr"/>
             <a:r>
-              <a:rPr sz="1400" b="1" i="0">
+              <a:rPr sz="2000" b="1" i="0">
                 <a:solidFill>
                   <a:srgbClr val="5C4826"/>
                 </a:solidFill>
@@ -11974,7 +12045,7 @@
                   <a:srgbClr val="000000"/>
                 </a:solidFill>
               </a:rPr>
-              <a:t>The evidence can be insufficient</a:t>
+              <a:t>Wrong process: insufficient evidence</a:t>
             </a:r>
           </a:p>
         </p:txBody>
@@ -12131,7 +12202,7 @@
         <p:spPr>
           <a:xfrm>
             <a:off x="521207" y="1828800"/>
-            <a:ext cx="1874519" cy="640080"/>
+            <a:ext cx="1874519" cy="731520"/>
           </a:xfrm>
           <a:prstGeom prst="rect">
             <a:avLst/>
@@ -12166,7 +12237,7 @@
           <a:p>
             <a:pPr algn="ctr"/>
             <a:r>
-              <a:rPr sz="1600" b="0" i="0">
+              <a:rPr sz="2000" b="0" i="0">
                 <a:solidFill>
                   <a:srgbClr val="5C4826"/>
                 </a:solidFill>
@@ -12185,7 +12256,7 @@
         <p:spPr>
           <a:xfrm>
             <a:off x="2596896" y="1828800"/>
-            <a:ext cx="1874519" cy="640080"/>
+            <a:ext cx="1874519" cy="731520"/>
           </a:xfrm>
           <a:prstGeom prst="rect">
             <a:avLst/>
@@ -12220,7 +12291,7 @@
           <a:p>
             <a:pPr algn="ctr"/>
             <a:r>
-              <a:rPr sz="1600" b="0" i="0">
+              <a:rPr sz="2000" b="0" i="0">
                 <a:solidFill>
                   <a:srgbClr val="5C4826"/>
                 </a:solidFill>
@@ -12239,7 +12310,7 @@
         <p:spPr>
           <a:xfrm>
             <a:off x="4672584" y="1828800"/>
-            <a:ext cx="1874519" cy="640080"/>
+            <a:ext cx="1874519" cy="731520"/>
           </a:xfrm>
           <a:prstGeom prst="rect">
             <a:avLst/>
@@ -12274,7 +12345,7 @@
           <a:p>
             <a:pPr algn="ctr"/>
             <a:r>
-              <a:rPr sz="1600" b="0" i="0">
+              <a:rPr sz="2000" b="0" i="0">
                 <a:solidFill>
                   <a:srgbClr val="5C4826"/>
                 </a:solidFill>
@@ -12293,7 +12364,7 @@
         <p:spPr>
           <a:xfrm>
             <a:off x="6748272" y="1828800"/>
-            <a:ext cx="1874519" cy="640080"/>
+            <a:ext cx="1874519" cy="731520"/>
           </a:xfrm>
           <a:prstGeom prst="rect">
             <a:avLst/>
@@ -12328,7 +12399,7 @@
           <a:p>
             <a:pPr algn="ctr"/>
             <a:r>
-              <a:rPr sz="1600" b="0" i="0">
+              <a:rPr sz="2000" b="0" i="0">
                 <a:solidFill>
                   <a:srgbClr val="5C4826"/>
                 </a:solidFill>
@@ -12378,14 +12449,51 @@
           <a:bodyPr rtlCol="0" anchor="ctr" wrap="square"/>
           <a:lstStyle/>
           <a:p>
-            <a:pPr algn="ctr"/>
             <a:r>
               <a:rPr sz="2000" b="1" i="0">
                 <a:solidFill>
                   <a:srgbClr val="FFFFFF"/>
                 </a:solidFill>
               </a:rPr>
-              <a:t>Evidence bears on an obligation.</a:t>
+              <a:t>A correct result is not enough if we cannot justify accepting it.</a:t>
+            </a:r>
+          </a:p>
+        </p:txBody>
+      </p:sp>
+      <p:sp>
+        <p:nvSpPr>
+          <p:cNvPr id="0" name="ClassQuestion"/>
+          <p:cNvSpPr/>
+          <p:nvPr/>
+        </p:nvSpPr>
+        <p:spPr>
+          <a:xfrm>
+            <a:off x="274320" y="4663440"/>
+            <a:ext cx="8595360" cy="548640"/>
+          </a:xfrm>
+          <a:prstGeom prst="rect">
+            <a:avLst/>
+          </a:prstGeom>
+          <a:noFill/>
+          <a:ln>
+            <a:noFill/>
+          </a:ln>
+          <a:effectLst/>
+        </p:spPr>
+        <p:txBody>
+          <a:bodyPr rtlCol="0" anchor="ctr" wrap="square" lIns="27432" rIns="27432" tIns="22860" bIns="22860"/>
+          <a:lstStyle/>
+          <a:p>
+            <a:pPr algn="ctr">
+              <a:buNone/>
+            </a:pPr>
+            <a:r>
+              <a:rPr lang="en-US" sz="2000" b="0" i="1" dirty="0">
+                <a:solidFill>
+                  <a:srgbClr val="555960"/>
+                </a:solidFill>
+              </a:rPr>
+              <a:t>Can the result be correct while the process is wrong?</a:t>
             </a:r>
           </a:p>
         </p:txBody>
@@ -25508,6 +25616,532 @@
                 </a:solidFill>
               </a:rPr>
               <a:t>adding · editing · deleting · persistence · appearance · console errors · refresh · multiple tabs</a:t>
+            </a:r>
+          </a:p>
+        </p:txBody>
+      </p:sp>
+    </p:spTree>
+  </p:cSld>
+  <p:clrMapOvr>
+    <a:masterClrMapping/>
+  </p:clrMapOvr>
+</p:sld>
+</file>
+
+<file path=ppt/slides/slide40.xml><?xml version="1.0" encoding="utf-8"?>
+<p:sld xmlns:a="http://schemas.openxmlformats.org/drawingml/2006/main" xmlns:p="http://schemas.openxmlformats.org/presentationml/2006/main" xmlns:r="http://schemas.openxmlformats.org/officeDocument/2006/relationships">
+  <p:cSld>
+    <p:spTree>
+      <p:nvGrpSpPr>
+        <p:cNvPr id="1" name=""/>
+        <p:cNvGrpSpPr/>
+        <p:nvPr/>
+      </p:nvGrpSpPr>
+      <p:grpSpPr/>
+      <p:sp>
+        <p:nvSpPr>
+          <p:cNvPr id="3" name="Title 2"/>
+          <p:cNvSpPr>
+            <a:spLocks noGrp="1"/>
+          </p:cNvSpPr>
+          <p:nvPr>
+            <p:ph type="title"/>
+          </p:nvPr>
+        </p:nvSpPr>
+        <p:spPr/>
+        <p:txBody>
+          <a:bodyPr/>
+          <a:lstStyle/>
+          <a:p>
+            <a:r>
+              <a:rPr sz="2400"/>
+              <a:t>Either bound can be violated</a:t>
+            </a:r>
+          </a:p>
+        </p:txBody>
+      </p:sp>
+      <p:sp>
+        <p:nvSpPr>
+          <p:cNvPr id="0" name="TaxHead-result"/>
+          <p:cNvSpPr/>
+          <p:nvPr/>
+        </p:nvSpPr>
+        <p:spPr>
+          <a:xfrm>
+            <a:off x="2286000" y="1005840"/>
+            <a:ext cx="3200400" cy="548640"/>
+          </a:xfrm>
+          <a:prstGeom prst="rect">
+            <a:avLst/>
+          </a:prstGeom>
+          <a:solidFill>
+            <a:srgbClr val="8E6F3E"/>
+          </a:solidFill>
+          <a:ln>
+            <a:noFill/>
+          </a:ln>
+          <a:effectLst/>
+        </p:spPr>
+        <p:txBody>
+          <a:bodyPr rtlCol="0" anchor="ctr" wrap="square" lIns="27432" rIns="27432" tIns="22860" bIns="22860"/>
+          <a:lstStyle/>
+          <a:p>
+            <a:pPr algn="ctr">
+              <a:buNone/>
+            </a:pPr>
+            <a:r>
+              <a:rPr lang="en-US" sz="2000" b="1" i="0" dirty="0">
+                <a:solidFill>
+                  <a:srgbClr val="FFFFFF"/>
+                </a:solidFill>
+              </a:rPr>
+              <a:t>WRONG RESULT</a:t>
+            </a:r>
+          </a:p>
+        </p:txBody>
+      </p:sp>
+      <p:sp>
+        <p:nvSpPr>
+          <p:cNvPr id="0" name="TaxHead-process"/>
+          <p:cNvSpPr/>
+          <p:nvPr/>
+        </p:nvSpPr>
+        <p:spPr>
+          <a:xfrm>
+            <a:off x="5577840" y="1005840"/>
+            <a:ext cx="3291840" cy="548640"/>
+          </a:xfrm>
+          <a:prstGeom prst="rect">
+            <a:avLst/>
+          </a:prstGeom>
+          <a:solidFill>
+            <a:srgbClr val="8E6F3E"/>
+          </a:solidFill>
+          <a:ln>
+            <a:noFill/>
+          </a:ln>
+          <a:effectLst/>
+        </p:spPr>
+        <p:txBody>
+          <a:bodyPr rtlCol="0" anchor="ctr" wrap="square" lIns="27432" rIns="27432" tIns="22860" bIns="22860"/>
+          <a:lstStyle/>
+          <a:p>
+            <a:pPr algn="ctr">
+              <a:buNone/>
+            </a:pPr>
+            <a:r>
+              <a:rPr lang="en-US" sz="2000" b="1" i="0" dirty="0">
+                <a:solidFill>
+                  <a:srgbClr val="FFFFFF"/>
+                </a:solidFill>
+              </a:rPr>
+              <a:t>WRONG PROCESS</a:t>
+            </a:r>
+          </a:p>
+        </p:txBody>
+      </p:sp>
+      <p:sp>
+        <p:nvSpPr>
+          <p:cNvPr id="0" name="TaxLbl-QUESTI"/>
+          <p:cNvSpPr/>
+          <p:nvPr/>
+        </p:nvSpPr>
+        <p:spPr>
+          <a:xfrm>
+            <a:off x="274320" y="1737360"/>
+            <a:ext cx="1920240" cy="1097280"/>
+          </a:xfrm>
+          <a:prstGeom prst="rect">
+            <a:avLst/>
+          </a:prstGeom>
+          <a:noFill/>
+          <a:ln>
+            <a:noFill/>
+          </a:ln>
+          <a:effectLst/>
+        </p:spPr>
+        <p:txBody>
+          <a:bodyPr rtlCol="0" anchor="ctr" wrap="square" lIns="27432" rIns="27432" tIns="22860" bIns="22860"/>
+          <a:lstStyle/>
+          <a:p>
+            <a:pPr algn="ctr">
+              <a:buNone/>
+            </a:pPr>
+            <a:r>
+              <a:rPr lang="en-US" sz="2000" b="1" i="0" dirty="0">
+                <a:solidFill>
+                  <a:srgbClr val="5C4826"/>
+                </a:solidFill>
+              </a:rPr>
+              <a:t>QUESTION</a:t>
+            </a:r>
+          </a:p>
+        </p:txBody>
+      </p:sp>
+      <p:sp>
+        <p:nvSpPr>
+          <p:cNvPr id="0" name="TaxC1-QUESTI"/>
+          <p:cNvSpPr/>
+          <p:nvPr/>
+        </p:nvSpPr>
+        <p:spPr>
+          <a:xfrm>
+            <a:off x="2286000" y="1737360"/>
+            <a:ext cx="3200400" cy="1097280"/>
+          </a:xfrm>
+          <a:prstGeom prst="rect">
+            <a:avLst/>
+          </a:prstGeom>
+          <a:solidFill>
+            <a:srgbClr val="F5F1E8"/>
+          </a:solidFill>
+          <a:ln w="12700">
+            <a:solidFill>
+              <a:srgbClr val="C9B991"/>
+            </a:solidFill>
+          </a:ln>
+          <a:effectLst/>
+        </p:spPr>
+        <p:txBody>
+          <a:bodyPr rtlCol="0" anchor="ctr" wrap="square" lIns="27432" rIns="27432" tIns="22860" bIns="22860"/>
+          <a:lstStyle/>
+          <a:p>
+            <a:pPr algn="ctr">
+              <a:buNone/>
+            </a:pPr>
+            <a:r>
+              <a:rPr lang="en-US" sz="2000" b="0" i="0" dirty="0">
+                <a:solidFill>
+                  <a:srgbClr val="5C4826"/>
+                </a:solidFill>
+              </a:rPr>
+              <a:t>Did the artifact satisfy its obligations?</a:t>
+            </a:r>
+          </a:p>
+        </p:txBody>
+      </p:sp>
+      <p:sp>
+        <p:nvSpPr>
+          <p:cNvPr id="0" name="TaxC2-QUESTI"/>
+          <p:cNvSpPr/>
+          <p:nvPr/>
+        </p:nvSpPr>
+        <p:spPr>
+          <a:xfrm>
+            <a:off x="5577840" y="1737360"/>
+            <a:ext cx="3291840" cy="1097280"/>
+          </a:xfrm>
+          <a:prstGeom prst="rect">
+            <a:avLst/>
+          </a:prstGeom>
+          <a:solidFill>
+            <a:srgbClr val="F5F1E8"/>
+          </a:solidFill>
+          <a:ln w="12700">
+            <a:solidFill>
+              <a:srgbClr val="C9B991"/>
+            </a:solidFill>
+          </a:ln>
+          <a:effectLst/>
+        </p:spPr>
+        <p:txBody>
+          <a:bodyPr rtlCol="0" anchor="ctr" wrap="square" lIns="27432" rIns="27432" tIns="22860" bIns="22860"/>
+          <a:lstStyle/>
+          <a:p>
+            <a:pPr algn="ctr">
+              <a:buNone/>
+            </a:pPr>
+            <a:r>
+              <a:rPr lang="en-US" sz="2000" b="0" i="0" dirty="0">
+                <a:solidFill>
+                  <a:srgbClr val="5C4826"/>
+                </a:solidFill>
+              </a:rPr>
+              <a:t>Was the work performed within the delegated process?</a:t>
+            </a:r>
+          </a:p>
+        </p:txBody>
+      </p:sp>
+      <p:sp>
+        <p:nvSpPr>
+          <p:cNvPr id="0" name="TaxLbl-EXAMPL"/>
+          <p:cNvSpPr/>
+          <p:nvPr/>
+        </p:nvSpPr>
+        <p:spPr>
+          <a:xfrm>
+            <a:off x="274320" y="2926080"/>
+            <a:ext cx="1920240" cy="1097280"/>
+          </a:xfrm>
+          <a:prstGeom prst="rect">
+            <a:avLst/>
+          </a:prstGeom>
+          <a:noFill/>
+          <a:ln>
+            <a:noFill/>
+          </a:ln>
+          <a:effectLst/>
+        </p:spPr>
+        <p:txBody>
+          <a:bodyPr rtlCol="0" anchor="ctr" wrap="square" lIns="27432" rIns="27432" tIns="22860" bIns="22860"/>
+          <a:lstStyle/>
+          <a:p>
+            <a:pPr algn="ctr">
+              <a:buNone/>
+            </a:pPr>
+            <a:r>
+              <a:rPr lang="en-US" sz="2000" b="1" i="0" dirty="0">
+                <a:solidFill>
+                  <a:srgbClr val="5C4826"/>
+                </a:solidFill>
+              </a:rPr>
+              <a:t>EXAMPLE</a:t>
+            </a:r>
+          </a:p>
+        </p:txBody>
+      </p:sp>
+      <p:sp>
+        <p:nvSpPr>
+          <p:cNvPr id="0" name="TaxC1-EXAMPL"/>
+          <p:cNvSpPr/>
+          <p:nvPr/>
+        </p:nvSpPr>
+        <p:spPr>
+          <a:xfrm>
+            <a:off x="2286000" y="2926080"/>
+            <a:ext cx="3200400" cy="1097280"/>
+          </a:xfrm>
+          <a:prstGeom prst="rect">
+            <a:avLst/>
+          </a:prstGeom>
+          <a:solidFill>
+            <a:srgbClr val="F5F1E8"/>
+          </a:solidFill>
+          <a:ln w="12700">
+            <a:solidFill>
+              <a:srgbClr val="C9B991"/>
+            </a:solidFill>
+          </a:ln>
+          <a:effectLst/>
+        </p:spPr>
+        <p:txBody>
+          <a:bodyPr rtlCol="0" anchor="ctr" wrap="square" lIns="27432" rIns="27432" tIns="22860" bIns="22860"/>
+          <a:lstStyle/>
+          <a:p>
+            <a:pPr algn="ctr">
+              <a:buNone/>
+            </a:pPr>
+            <a:r>
+              <a:rPr lang="en-US" sz="2000" b="0" i="1" dirty="0">
+                <a:solidFill>
+                  <a:srgbClr val="555960"/>
+                </a:solidFill>
+              </a:rPr>
+              <a:t>Existing API behavior changes</a:t>
+            </a:r>
+          </a:p>
+        </p:txBody>
+      </p:sp>
+      <p:sp>
+        <p:nvSpPr>
+          <p:cNvPr id="0" name="TaxC2-EXAMPL"/>
+          <p:cNvSpPr/>
+          <p:nvPr/>
+        </p:nvSpPr>
+        <p:spPr>
+          <a:xfrm>
+            <a:off x="5577840" y="2926080"/>
+            <a:ext cx="3291840" cy="1097280"/>
+          </a:xfrm>
+          <a:prstGeom prst="rect">
+            <a:avLst/>
+          </a:prstGeom>
+          <a:solidFill>
+            <a:srgbClr val="F5F1E8"/>
+          </a:solidFill>
+          <a:ln w="12700">
+            <a:solidFill>
+              <a:srgbClr val="C9B991"/>
+            </a:solidFill>
+          </a:ln>
+          <a:effectLst/>
+        </p:spPr>
+        <p:txBody>
+          <a:bodyPr rtlCol="0" anchor="ctr" wrap="square" lIns="27432" rIns="27432" tIns="22860" bIns="22860"/>
+          <a:lstStyle/>
+          <a:p>
+            <a:pPr algn="ctr">
+              <a:buNone/>
+            </a:pPr>
+            <a:r>
+              <a:rPr lang="en-US" sz="2000" b="0" i="1" dirty="0">
+                <a:solidFill>
+                  <a:srgbClr val="555960"/>
+                </a:solidFill>
+              </a:rPr>
+              <a:t>Agent modifies a forbidden dependency</a:t>
+            </a:r>
+          </a:p>
+        </p:txBody>
+      </p:sp>
+      <p:sp>
+        <p:nvSpPr>
+          <p:cNvPr id="0" name="TaxLbl-VALIDA"/>
+          <p:cNvSpPr/>
+          <p:nvPr/>
+        </p:nvSpPr>
+        <p:spPr>
+          <a:xfrm>
+            <a:off x="274320" y="4114800"/>
+            <a:ext cx="1920240" cy="1097280"/>
+          </a:xfrm>
+          <a:prstGeom prst="rect">
+            <a:avLst/>
+          </a:prstGeom>
+          <a:noFill/>
+          <a:ln>
+            <a:noFill/>
+          </a:ln>
+          <a:effectLst/>
+        </p:spPr>
+        <p:txBody>
+          <a:bodyPr rtlCol="0" anchor="ctr" wrap="square" lIns="27432" rIns="27432" tIns="22860" bIns="22860"/>
+          <a:lstStyle/>
+          <a:p>
+            <a:pPr algn="ctr">
+              <a:buNone/>
+            </a:pPr>
+            <a:r>
+              <a:rPr lang="en-US" sz="2000" b="1" i="0" dirty="0">
+                <a:solidFill>
+                  <a:srgbClr val="5C4826"/>
+                </a:solidFill>
+              </a:rPr>
+              <a:t>VALIDATION TARGET</a:t>
+            </a:r>
+          </a:p>
+        </p:txBody>
+      </p:sp>
+      <p:sp>
+        <p:nvSpPr>
+          <p:cNvPr id="0" name="TaxC1-VALIDA"/>
+          <p:cNvSpPr/>
+          <p:nvPr/>
+        </p:nvSpPr>
+        <p:spPr>
+          <a:xfrm>
+            <a:off x="2286000" y="4114800"/>
+            <a:ext cx="3200400" cy="1097280"/>
+          </a:xfrm>
+          <a:prstGeom prst="rect">
+            <a:avLst/>
+          </a:prstGeom>
+          <a:solidFill>
+            <a:srgbClr val="F5F1E8"/>
+          </a:solidFill>
+          <a:ln w="12700">
+            <a:solidFill>
+              <a:srgbClr val="C9B991"/>
+            </a:solidFill>
+          </a:ln>
+          <a:effectLst/>
+        </p:spPr>
+        <p:txBody>
+          <a:bodyPr rtlCol="0" anchor="ctr" wrap="square" lIns="27432" rIns="27432" tIns="22860" bIns="22860"/>
+          <a:lstStyle/>
+          <a:p>
+            <a:pPr algn="ctr">
+              <a:buNone/>
+            </a:pPr>
+            <a:r>
+              <a:rPr lang="en-US" sz="2000" b="0" i="0" dirty="0">
+                <a:solidFill>
+                  <a:srgbClr val="5C4826"/>
+                </a:solidFill>
+              </a:rPr>
+              <a:t>Artifact / system state</a:t>
+            </a:r>
+          </a:p>
+        </p:txBody>
+      </p:sp>
+      <p:sp>
+        <p:nvSpPr>
+          <p:cNvPr id="0" name="TaxC2-VALIDA"/>
+          <p:cNvSpPr/>
+          <p:nvPr/>
+        </p:nvSpPr>
+        <p:spPr>
+          <a:xfrm>
+            <a:off x="5577840" y="4114800"/>
+            <a:ext cx="3291840" cy="1097280"/>
+          </a:xfrm>
+          <a:prstGeom prst="rect">
+            <a:avLst/>
+          </a:prstGeom>
+          <a:solidFill>
+            <a:srgbClr val="F5F1E8"/>
+          </a:solidFill>
+          <a:ln w="12700">
+            <a:solidFill>
+              <a:srgbClr val="C9B991"/>
+            </a:solidFill>
+          </a:ln>
+          <a:effectLst/>
+        </p:spPr>
+        <p:txBody>
+          <a:bodyPr rtlCol="0" anchor="ctr" wrap="square" lIns="27432" rIns="27432" tIns="22860" bIns="22860"/>
+          <a:lstStyle/>
+          <a:p>
+            <a:pPr algn="ctr">
+              <a:buNone/>
+            </a:pPr>
+            <a:r>
+              <a:rPr lang="en-US" sz="2000" b="0" i="0" dirty="0">
+                <a:solidFill>
+                  <a:srgbClr val="5C4826"/>
+                </a:solidFill>
+              </a:rPr>
+              <a:t>Actions / evidence / authority</a:t>
+            </a:r>
+          </a:p>
+        </p:txBody>
+      </p:sp>
+      <p:sp>
+        <p:nvSpPr>
+          <p:cNvPr id="0" name="FooterBand"/>
+          <p:cNvSpPr/>
+          <p:nvPr/>
+        </p:nvSpPr>
+        <p:spPr>
+          <a:xfrm>
+            <a:off x="274320" y="5852160"/>
+            <a:ext cx="8595360" cy="566928"/>
+          </a:xfrm>
+          <a:prstGeom prst="rect">
+            <a:avLst/>
+          </a:prstGeom>
+          <a:solidFill>
+            <a:srgbClr val="8E6F3E"/>
+          </a:solidFill>
+          <a:ln>
+            <a:noFill/>
+          </a:ln>
+          <a:effectLst/>
+        </p:spPr>
+        <p:txBody>
+          <a:bodyPr rtlCol="0" anchor="ctr" wrap="square" lIns="27432" rIns="27432" tIns="22860" bIns="22860"/>
+          <a:lstStyle/>
+          <a:p>
+            <a:pPr algn="ctr">
+              <a:buNone/>
+            </a:pPr>
+            <a:r>
+              <a:rPr lang="en-US" sz="2000" b="1" i="0" dirty="0">
+                <a:solidFill>
+                  <a:srgbClr val="FFFFFF"/>
+                </a:solidFill>
+              </a:rPr>
+              <a:t>A correct result does not imply an acceptable process.</a:t>
             </a:r>
           </a:p>
         </p:txBody>

</xml_diff>

<commit_message>
deck 2-3 S5: Modeling becomes 'Models as validation surfaces' on the lab's two models
Divider retitled (SECTION 5); thesis lands on the knowledge slide. Four new
slides reuse the Modeling lab's sensor node instead of the invented
document-processing example (deleted): 'You already have two models'
(memory view / admission-control view, each with its declared omissions),
static validation (budget query, admits route, illegal transition), runtime
observation (lifecycle machines, trace vs model), and the static/dynamic
comparison closing on where each verdict acquires authority. 'Agreement is
not correctness' rebuilt as three large cards at the 20pt floor.
</commit_message>
<xml_diff>
--- a/course/lectures/act-2-delegation-and-control/03-alignment/2-3-Alignment.pptx
+++ b/course/lectures/act-2-delegation-and-control/03-alignment/2-3-Alignment.pptx
@@ -42,7 +42,10 @@
     <p:sldId id="277" r:id="rId28"/>
     <p:sldId id="278" r:id="rId29"/>
     <p:sldId id="279" r:id="rId30"/>
-    <p:sldId id="301" r:id="rId11"/>
+    <p:sldId id="307" r:id="rId10"/>
+    <p:sldId id="308" r:id="rId8"/>
+    <p:sldId id="309" r:id="rId6"/>
+    <p:sldId id="310" r:id="rId5"/>
     <p:sldId id="280" r:id="rId31"/>
     <p:sldId id="281" r:id="rId32"/>
     <p:sldId id="287" r:id="rId52"/>
@@ -2571,7 +2574,7 @@
           </a:p>
           <a:p>
             <a:r>
-              <a:t>- Once we have models, we need one more distinction.</a:t>
+              <a:t>- Once we have models, we need one more distinction — three different kinds of claim.</a:t>
             </a:r>
           </a:p>
           <a:p>
@@ -2591,52 +2594,7 @@
           </a:p>
           <a:p>
             <a:r>
-              <a:t>- These are different claims.</a:t>
-            </a:r>
-          </a:p>
-          <a:p>
-            <a:r>
-              <a:t>- A model and implementation can correspond perfectly and both be wrong relative to the requirement.</a:t>
-            </a:r>
-          </a:p>
-          <a:p>
-            <a:r>
-              <a:t>- An artifact can satisfy its requirement but still be rejected by an incompatible receiving environment.</a:t>
-            </a:r>
-          </a:p>
-          <a:p>
-            <a:r>
-              <a:t>- Evidence for one relation does not establish the others.</a:t>
-            </a:r>
-          </a:p>
-          <a:p>
-            <a:r>
-              <a:t>- This is why "the implementation matches the model" is not by itself a correctness argument.</a:t>
-            </a:r>
-          </a:p>
-          <a:p>
-            <a:r>
-              <a:t>ANIMATION</a:t>
-            </a:r>
-          </a:p>
-          <a:p>
-            <a:r>
-              <a:t>- Reveal CORRESPONDENCE row.</a:t>
-            </a:r>
-          </a:p>
-          <a:p>
-            <a:r>
-              <a:t>- Reveal CONFORMANCE row.</a:t>
-            </a:r>
-          </a:p>
-          <a:p>
-            <a:r>
-              <a:t>- Reveal ACCEPTANCE row.</a:t>
-            </a:r>
-          </a:p>
-          <a:p>
-            <a:r>
-              <a:t>- Reveal "Evidence for one does not establish the others" last.</a:t>
+              <a:t>- A model and implementation can agree and both be wrong against the obligation. Evidence for one claim does not establish the others.</a:t>
             </a:r>
           </a:p>
         </p:txBody>
@@ -3331,7 +3289,12 @@
           </a:p>
           <a:p>
             <a:r>
-              <a:t>- So the obvious challenge is: why did we spend the previous lecture on Modeling?</a:t>
+              <a:t>- This section asks what an explicit model contributes: models give validation mechanisms an explicit object to inspect.</a:t>
+            </a:r>
+          </a:p>
+          <a:p>
+            <a:r>
+              <a:t>- We will use the two models the class built in the Modeling lab — not a new example.</a:t>
             </a:r>
           </a:p>
         </p:txBody>
@@ -4021,156 +3984,6 @@
 </p:notes>
 </file>
 
-<file path=ppt/notesSlides/notesSlide37.xml><?xml version="1.0" encoding="utf-8"?>
-<p:notes xmlns:a="http://schemas.openxmlformats.org/drawingml/2006/main" xmlns:p="http://schemas.openxmlformats.org/presentationml/2006/main" xmlns:r="http://schemas.openxmlformats.org/officeDocument/2006/relationships">
-  <p:cSld>
-    <p:spTree>
-      <p:nvGrpSpPr>
-        <p:cNvPr id="1" name=""/>
-        <p:cNvGrpSpPr/>
-        <p:nvPr/>
-      </p:nvGrpSpPr>
-      <p:grpSpPr>
-        <a:xfrm>
-          <a:off x="0" y="0"/>
-          <a:ext cx="0" cy="0"/>
-          <a:chOff x="0" y="0"/>
-          <a:chExt cx="0" cy="0"/>
-        </a:xfrm>
-      </p:grpSpPr>
-      <p:sp>
-        <p:nvSpPr>
-          <p:cNvPr id="2" name="Slide Image Placeholder 1"/>
-          <p:cNvSpPr>
-            <a:spLocks noGrp="1"/>
-          </p:cNvSpPr>
-          <p:nvPr>
-            <p:ph type="sldImg" idx="2"/>
-          </p:nvPr>
-        </p:nvSpPr>
-        <p:spPr/>
-      </p:sp>
-      <p:sp>
-        <p:nvSpPr>
-          <p:cNvPr id="3" name="Notes Placeholder 2"/>
-          <p:cNvSpPr>
-            <a:spLocks noGrp="1"/>
-          </p:cNvSpPr>
-          <p:nvPr>
-            <p:ph type="body" idx="3" sz="quarter"/>
-          </p:nvPr>
-        </p:nvSpPr>
-        <p:spPr/>
-        <p:txBody>
-          <a:bodyPr/>
-          <a:lstStyle/>
-          <a:p>
-            <a:r>
-              <a:t>TIMING: 3 minutes</a:t>
-            </a:r>
-          </a:p>
-          <a:p>
-            <a:r>
-              <a:t>- Make this concrete with one document-processing-service model.</a:t>
-            </a:r>
-          </a:p>
-          <a:p>
-            <a:r>
-              <a:t>- Suppose the model includes a lifecycle machine and resource graph.</a:t>
-            </a:r>
-          </a:p>
-          <a:p>
-            <a:r>
-              <a:t>- From the lifecycle model, ask whether a Completed document can re-enter processing.</a:t>
-            </a:r>
-          </a:p>
-          <a:p>
-            <a:r>
-              <a:t>- From retry structure, establish whether the retry loop is bounded.</a:t>
-            </a:r>
-          </a:p>
-          <a:p>
-            <a:r>
-              <a:t>- From the resource graph, calculate peak memory demand.</a:t>
-            </a:r>
-          </a:p>
-          <a:p>
-            <a:r>
-              <a:t>- These are different validators over shared engineering knowledge.</a:t>
-            </a:r>
-          </a:p>
-          <a:p>
-            <a:r>
-              <a:t>- Their verdicts may simply be reported, or some may feed a gate.</a:t>
-            </a:r>
-          </a:p>
-          <a:p>
-            <a:r>
-              <a:t>- The gate is optional because not every judgment should automatically block an action.</a:t>
-            </a:r>
-          </a:p>
-          <a:p>
-            <a:r>
-              <a:t>- This is what models buy Alignment: explicit engineering knowledge can be consumed by multiple controls without reconstructing the relevant structure separately each time.</a:t>
-            </a:r>
-          </a:p>
-          <a:p>
-            <a:r>
-              <a:t>ANIMATION</a:t>
-            </a:r>
-          </a:p>
-          <a:p>
-            <a:r>
-              <a:t>- Reveal the explicit model first.</a:t>
-            </a:r>
-          </a:p>
-          <a:p>
-            <a:r>
-              <a:t>- Reveal LIFECYCLE CHECK and verdict.</a:t>
-            </a:r>
-          </a:p>
-          <a:p>
-            <a:r>
-              <a:t>- Reveal RETRY BOUND and verdict.</a:t>
-            </a:r>
-          </a:p>
-          <a:p>
-            <a:r>
-              <a:t>- Reveal MEMORY ANALYSIS and verdict.</a:t>
-            </a:r>
-          </a:p>
-          <a:p>
-            <a:r>
-              <a:t>- Reveal VERDICTS.</a:t>
-            </a:r>
-          </a:p>
-          <a:p>
-            <a:r>
-              <a:t>- Reveal optional GATE last.</a:t>
-            </a:r>
-          </a:p>
-        </p:txBody>
-      </p:sp>
-      <p:sp>
-        <p:nvSpPr>
-          <p:cNvPr id="4" name="Slide Number Placeholder 3"/>
-          <p:cNvSpPr>
-            <a:spLocks noGrp="1"/>
-          </p:cNvSpPr>
-          <p:nvPr>
-            <p:ph type="sldNum" idx="5" sz="quarter"/>
-          </p:nvPr>
-        </p:nvSpPr>
-        <p:spPr/>
-      </p:sp>
-    </p:spTree>
-  </p:cSld>
-  <p:clrMapOvr>
-    <a:masterClrMapping/>
-  </p:clrMapOvr>
-</p:notes>
-</file>
-
 <file path=ppt/notesSlides/notesSlide38.xml><?xml version="1.0" encoding="utf-8"?>
 <p:notes xmlns:a="http://schemas.openxmlformats.org/drawingml/2006/main" xmlns:p="http://schemas.openxmlformats.org/presentationml/2006/main" xmlns:r="http://schemas.openxmlformats.org/officeDocument/2006/relationships">
   <p:cSld>
@@ -4723,6 +4536,346 @@
           <a:p>
             <a:r>
               <a:t>- Ask the class where a type checker sits in this picture. (It plays several roles — which is the point of the previous slide.)</a:t>
+            </a:r>
+          </a:p>
+        </p:txBody>
+      </p:sp>
+      <p:sp>
+        <p:nvSpPr>
+          <p:cNvPr id="4" name="Slide Number Placeholder 3"/>
+          <p:cNvSpPr>
+            <a:spLocks noGrp="1"/>
+          </p:cNvSpPr>
+          <p:nvPr>
+            <p:ph type="sldNum" idx="5" sz="quarter"/>
+          </p:nvPr>
+        </p:nvSpPr>
+        <p:spPr/>
+      </p:sp>
+    </p:spTree>
+  </p:cSld>
+  <p:clrMapOvr>
+    <a:masterClrMapping/>
+  </p:clrMapOvr>
+</p:notes>
+</file>
+
+<file path=ppt/notesSlides/notesSlide43.xml><?xml version="1.0" encoding="utf-8"?>
+<p:notes xmlns:a="http://schemas.openxmlformats.org/drawingml/2006/main" xmlns:p="http://schemas.openxmlformats.org/presentationml/2006/main" xmlns:r="http://schemas.openxmlformats.org/officeDocument/2006/relationships">
+  <p:cSld>
+    <p:spTree>
+      <p:nvGrpSpPr>
+        <p:cNvPr id="1" name=""/>
+        <p:cNvGrpSpPr/>
+        <p:nvPr/>
+      </p:nvGrpSpPr>
+      <p:grpSpPr>
+        <a:xfrm>
+          <a:off x="0" y="0"/>
+          <a:ext cx="0" cy="0"/>
+          <a:chOff x="0" y="0"/>
+          <a:chExt cx="0" cy="0"/>
+        </a:xfrm>
+      </p:grpSpPr>
+      <p:sp>
+        <p:nvSpPr>
+          <p:cNvPr id="2" name="Slide Image Placeholder 1"/>
+          <p:cNvSpPr>
+            <a:spLocks noGrp="1"/>
+          </p:cNvSpPr>
+          <p:nvPr>
+            <p:ph type="sldImg" idx="2"/>
+          </p:nvPr>
+        </p:nvSpPr>
+        <p:spPr/>
+      </p:sp>
+      <p:sp>
+        <p:nvSpPr>
+          <p:cNvPr id="3" name="Notes Placeholder 2"/>
+          <p:cNvSpPr>
+            <a:spLocks noGrp="1"/>
+          </p:cNvSpPr>
+          <p:nvPr>
+            <p:ph type="body" idx="3" sz="quarter"/>
+          </p:nvPr>
+        </p:nvSpPr>
+        <p:spPr/>
+        <p:txBody>
+          <a:bodyPr/>
+          <a:lstStyle/>
+          <a:p>
+            <a:r>
+              <a:t>TIMING: 3 minutes</a:t>
+            </a:r>
+          </a:p>
+          <a:p>
+            <a:r>
+              <a:t>- These are the two models the class built in the Modeling lab: the sensor node with Sense, Analyze, and Transmit threads and a Scheduler.</a:t>
+            </a:r>
+          </a:p>
+          <a:p>
+            <a:r>
+              <a:t>- Two purposeful reductions over ONE set of entities. The memory view knows what each thread costs and the 48 KB ceiling, and omits who decides that a thread may run. The control view knows who may be awake and who says so, and omits what running costs.</a:t>
+            </a:r>
+          </a:p>
+          <a:p>
+            <a:r>
+              <a:t>- Neither model answers the budget question alone; the join is entity identity — Sense in one view IS Sense in the other.</a:t>
+            </a:r>
+          </a:p>
+          <a:p>
+            <a:r>
+              <a:t>- Pose the footer question and DO NOT answer it immediately. Let them discuss.</a:t>
+            </a:r>
+          </a:p>
+        </p:txBody>
+      </p:sp>
+      <p:sp>
+        <p:nvSpPr>
+          <p:cNvPr id="4" name="Slide Number Placeholder 3"/>
+          <p:cNvSpPr>
+            <a:spLocks noGrp="1"/>
+          </p:cNvSpPr>
+          <p:nvPr>
+            <p:ph type="sldNum" idx="5" sz="quarter"/>
+          </p:nvPr>
+        </p:nvSpPr>
+        <p:spPr/>
+      </p:sp>
+    </p:spTree>
+  </p:cSld>
+  <p:clrMapOvr>
+    <a:masterClrMapping/>
+  </p:clrMapOvr>
+</p:notes>
+</file>
+
+<file path=ppt/notesSlides/notesSlide44.xml><?xml version="1.0" encoding="utf-8"?>
+<p:notes xmlns:a="http://schemas.openxmlformats.org/drawingml/2006/main" xmlns:p="http://schemas.openxmlformats.org/presentationml/2006/main" xmlns:r="http://schemas.openxmlformats.org/officeDocument/2006/relationships">
+  <p:cSld>
+    <p:spTree>
+      <p:nvGrpSpPr>
+        <p:cNvPr id="1" name=""/>
+        <p:cNvGrpSpPr/>
+        <p:nvPr/>
+      </p:nvGrpSpPr>
+      <p:grpSpPr>
+        <a:xfrm>
+          <a:off x="0" y="0"/>
+          <a:ext cx="0" cy="0"/>
+          <a:chOff x="0" y="0"/>
+          <a:chExt cx="0" cy="0"/>
+        </a:xfrm>
+      </p:grpSpPr>
+      <p:sp>
+        <p:nvSpPr>
+          <p:cNvPr id="2" name="Slide Image Placeholder 1"/>
+          <p:cNvSpPr>
+            <a:spLocks noGrp="1"/>
+          </p:cNvSpPr>
+          <p:nvPr>
+            <p:ph type="sldImg" idx="2"/>
+          </p:nvPr>
+        </p:nvSpPr>
+        <p:spPr/>
+      </p:sp>
+      <p:sp>
+        <p:nvSpPr>
+          <p:cNvPr id="3" name="Notes Placeholder 2"/>
+          <p:cNvSpPr>
+            <a:spLocks noGrp="1"/>
+          </p:cNvSpPr>
+          <p:nvPr>
+            <p:ph type="body" idx="3" sz="quarter"/>
+          </p:nvPr>
+        </p:nvSpPr>
+        <p:spPr/>
+        <p:txBody>
+          <a:bodyPr/>
+          <a:lstStyle/>
+          <a:p>
+            <a:r>
+              <a:t>TIMING: 3 minutes</a:t>
+            </a:r>
+          </a:p>
+          <a:p>
+            <a:r>
+              <a:t>- Static validation: a verdict decided over the model itself, before any execution.</a:t>
+            </a:r>
+          </a:p>
+          <a:p>
+            <a:r>
+              <a:t>- Ground each question in the lab. 'Can the memory bound be exceeded' is exactly the lab's budget query: peak working memory against the declared 48 KB ceiling — the query that reported 80 KB in Stage 1. 'Does every permitted route cross the required boundary' is the graph query that the Scheduler admits every thread. An illegal transition is one the lifecycle machines do not declare.</a:t>
+            </a:r>
+          </a:p>
+          <a:p>
+            <a:r>
+              <a:t>- The payoff: once the structure is explicit, these stop being archaeology over code and become decidable queries.</a:t>
+            </a:r>
+          </a:p>
+        </p:txBody>
+      </p:sp>
+      <p:sp>
+        <p:nvSpPr>
+          <p:cNvPr id="4" name="Slide Number Placeholder 3"/>
+          <p:cNvSpPr>
+            <a:spLocks noGrp="1"/>
+          </p:cNvSpPr>
+          <p:nvPr>
+            <p:ph type="sldNum" idx="5" sz="quarter"/>
+          </p:nvPr>
+        </p:nvSpPr>
+        <p:spPr/>
+      </p:sp>
+    </p:spTree>
+  </p:cSld>
+  <p:clrMapOvr>
+    <a:masterClrMapping/>
+  </p:clrMapOvr>
+</p:notes>
+</file>
+
+<file path=ppt/notesSlides/notesSlide45.xml><?xml version="1.0" encoding="utf-8"?>
+<p:notes xmlns:a="http://schemas.openxmlformats.org/drawingml/2006/main" xmlns:p="http://schemas.openxmlformats.org/presentationml/2006/main" xmlns:r="http://schemas.openxmlformats.org/officeDocument/2006/relationships">
+  <p:cSld>
+    <p:spTree>
+      <p:nvGrpSpPr>
+        <p:cNvPr id="1" name=""/>
+        <p:cNvGrpSpPr/>
+        <p:nvPr/>
+      </p:nvGrpSpPr>
+      <p:grpSpPr>
+        <a:xfrm>
+          <a:off x="0" y="0"/>
+          <a:ext cx="0" cy="0"/>
+          <a:chOff x="0" y="0"/>
+          <a:chExt cx="0" cy="0"/>
+        </a:xfrm>
+      </p:grpSpPr>
+      <p:sp>
+        <p:nvSpPr>
+          <p:cNvPr id="2" name="Slide Image Placeholder 1"/>
+          <p:cNvSpPr>
+            <a:spLocks noGrp="1"/>
+          </p:cNvSpPr>
+          <p:nvPr>
+            <p:ph type="sldImg" idx="2"/>
+          </p:nvPr>
+        </p:nvSpPr>
+        <p:spPr/>
+      </p:sp>
+      <p:sp>
+        <p:nvSpPr>
+          <p:cNvPr id="3" name="Notes Placeholder 2"/>
+          <p:cNvSpPr>
+            <a:spLocks noGrp="1"/>
+          </p:cNvSpPr>
+          <p:nvPr>
+            <p:ph type="body" idx="3" sz="quarter"/>
+          </p:nvPr>
+        </p:nvSpPr>
+        <p:spPr/>
+        <p:txBody>
+          <a:bodyPr/>
+          <a:lstStyle/>
+          <a:p>
+            <a:r>
+              <a:t>TIMING: 3 minutes</a:t>
+            </a:r>
+          </a:p>
+          <a:p>
+            <a:r>
+              <a:t>- The same model can define what a SENSOR must observe at runtime: the model states expected behavior; the trace is checked against it.</a:t>
+            </a:r>
+          </a:p>
+          <a:p>
+            <a:r>
+              <a:t>- Ground it in the lab's lifecycle machines: every thread is Asleep or Awake, moved by admit and release events. Did an observed wake correspond to a declared transition? Did the awake count ever exceed two? Did working memory stay within its modeled 48 KB bound?</a:t>
+            </a:r>
+          </a:p>
+          <a:p>
+            <a:r>
+              <a:t>- This prevents students from hearing 'model-based validation' as synonymous with static analysis.</a:t>
+            </a:r>
+          </a:p>
+        </p:txBody>
+      </p:sp>
+      <p:sp>
+        <p:nvSpPr>
+          <p:cNvPr id="4" name="Slide Number Placeholder 3"/>
+          <p:cNvSpPr>
+            <a:spLocks noGrp="1"/>
+          </p:cNvSpPr>
+          <p:nvPr>
+            <p:ph type="sldNum" idx="5" sz="quarter"/>
+          </p:nvPr>
+        </p:nvSpPr>
+        <p:spPr/>
+      </p:sp>
+    </p:spTree>
+  </p:cSld>
+  <p:clrMapOvr>
+    <a:masterClrMapping/>
+  </p:clrMapOvr>
+</p:notes>
+</file>
+
+<file path=ppt/notesSlides/notesSlide46.xml><?xml version="1.0" encoding="utf-8"?>
+<p:notes xmlns:a="http://schemas.openxmlformats.org/drawingml/2006/main" xmlns:p="http://schemas.openxmlformats.org/presentationml/2006/main" xmlns:r="http://schemas.openxmlformats.org/officeDocument/2006/relationships">
+  <p:cSld>
+    <p:spTree>
+      <p:nvGrpSpPr>
+        <p:cNvPr id="1" name=""/>
+        <p:cNvGrpSpPr/>
+        <p:nvPr/>
+      </p:nvGrpSpPr>
+      <p:grpSpPr>
+        <a:xfrm>
+          <a:off x="0" y="0"/>
+          <a:ext cx="0" cy="0"/>
+          <a:chOff x="0" y="0"/>
+          <a:chExt cx="0" cy="0"/>
+        </a:xfrm>
+      </p:grpSpPr>
+      <p:sp>
+        <p:nvSpPr>
+          <p:cNvPr id="2" name="Slide Image Placeholder 1"/>
+          <p:cNvSpPr>
+            <a:spLocks noGrp="1"/>
+          </p:cNvSpPr>
+          <p:nvPr>
+            <p:ph type="sldImg" idx="2"/>
+          </p:nvPr>
+        </p:nvSpPr>
+        <p:spPr/>
+      </p:sp>
+      <p:sp>
+        <p:nvSpPr>
+          <p:cNvPr id="3" name="Notes Placeholder 2"/>
+          <p:cNvSpPr>
+            <a:spLocks noGrp="1"/>
+          </p:cNvSpPr>
+          <p:nvPr>
+            <p:ph type="body" idx="3" sz="quarter"/>
+          </p:nvPr>
+        </p:nvSpPr>
+        <p:spPr/>
+        <p:txBody>
+          <a:bodyPr/>
+          <a:lstStyle/>
+          <a:p>
+            <a:r>
+              <a:t>TIMING: 2 minutes</a:t>
+            </a:r>
+          </a:p>
+          <a:p>
+            <a:r>
+              <a:t>- One model, two validation strategies. Static verdicts are exhaustive over the modeled space and available before execution; dynamic verdicts are evidence about the runs you actually observed.</a:t>
+            </a:r>
+          </a:p>
+          <a:p>
+            <a:r>
+              <a:t>- Close with the footer question — and notice it lands back in Alignment: a static verdict might gate merge; a runtime verdict might gate deployment or trigger rollback. Where a verdict acquires authority is an Alignment decision, not a modeling one.</a:t>
             </a:r>
           </a:p>
         </p:txBody>
@@ -21028,7 +21181,7 @@
                 <a:ea typeface="+mn-ea"/>
                 <a:cs typeface="+mn-cs"/>
               </a:rPr>
-              <a:t>SECTION 4</a:t>
+              <a:t>SECTION 5</a:t>
             </a:r>
           </a:p>
         </p:txBody>
@@ -21065,7 +21218,7 @@
                   <a:srgbClr val="000000"/>
                 </a:solidFill>
               </a:rPr>
-              <a:t>What do models buy us?</a:t>
+              <a:t>Models as validation surfaces</a:t>
             </a:r>
           </a:p>
         </p:txBody>
@@ -21212,7 +21365,7 @@
                 <a:ea typeface="+mn-ea"/>
                 <a:cs typeface="+mn-cs"/>
               </a:rPr>
-              <a:t>What does an explicit model add?</a:t>
+              <a:t>How can explicit models help us establish obligations?</a:t>
             </a:r>
           </a:p>
         </p:txBody>
@@ -21718,7 +21871,7 @@
           <a:p>
             <a:pPr algn="ctr"/>
             <a:r>
-              <a:rPr sz="1800" b="1" i="0">
+              <a:rPr sz="2000" b="1" i="0">
                 <a:solidFill>
                   <a:srgbClr val="5C4826"/>
                 </a:solidFill>
@@ -21806,7 +21959,7 @@
           <a:p>
             <a:pPr algn="ctr"/>
             <a:r>
-              <a:rPr sz="1800" b="1" i="0">
+              <a:rPr sz="2000" b="1" i="0">
                 <a:solidFill>
                   <a:srgbClr val="5C4826"/>
                 </a:solidFill>
@@ -21894,7 +22047,7 @@
           <a:p>
             <a:pPr algn="ctr"/>
             <a:r>
-              <a:rPr sz="1800" b="1" i="0">
+              <a:rPr sz="2000" b="1" i="0">
                 <a:solidFill>
                   <a:srgbClr val="5C4826"/>
                 </a:solidFill>
@@ -21982,7 +22135,7 @@
           <a:p>
             <a:pPr algn="ctr"/>
             <a:r>
-              <a:rPr sz="1800" b="1" i="0">
+              <a:rPr sz="2000" b="1" i="0">
                 <a:solidFill>
                   <a:srgbClr val="5C4826"/>
                 </a:solidFill>
@@ -22048,766 +22201,17 @@
           </a:bodyPr>
           <a:lstStyle/>
           <a:p>
-            <a:pPr algn="ctr"/>
-            <a:r>
-              <a:rPr sz="2000" b="0" i="1">
+            <a:r>
+              <a:rPr sz="2000" b="1" i="1">
                 <a:solidFill>
                   <a:srgbClr val="555960"/>
                 </a:solidFill>
               </a:rPr>
-              <a:t>Different analyses can then operate over the same engineering knowledge.</a:t>
-            </a:r>
-          </a:p>
-        </p:txBody>
-      </p:sp>
-    </p:spTree>
-  </p:cSld>
-  <p:clrMapOvr>
-    <a:masterClrMapping/>
-  </p:clrMapOvr>
-</p:sld>
-</file>
-
-<file path=ppt/slides/slide35.xml><?xml version="1.0" encoding="utf-8"?>
-<p:sld xmlns:a="http://schemas.openxmlformats.org/drawingml/2006/main" xmlns:p="http://schemas.openxmlformats.org/presentationml/2006/main" xmlns:r="http://schemas.openxmlformats.org/officeDocument/2006/relationships">
-  <p:cSld>
-    <p:spTree>
-      <p:nvGrpSpPr>
-        <p:cNvPr id="1" name=""/>
-        <p:cNvGrpSpPr/>
-        <p:nvPr/>
-      </p:nvGrpSpPr>
-      <p:grpSpPr/>
-      <p:sp>
-        <p:nvSpPr>
-          <p:cNvPr id="2" name="Content Placeholder 1"/>
-          <p:cNvSpPr>
-            <a:spLocks noGrp="1"/>
-          </p:cNvSpPr>
-          <p:nvPr>
-            <p:ph idx="1"/>
-          </p:nvPr>
-        </p:nvSpPr>
-        <p:spPr/>
-        <p:txBody>
-          <a:bodyPr/>
-          <a:lstStyle/>
-          <a:p/>
-        </p:txBody>
-      </p:sp>
-      <p:sp>
-        <p:nvSpPr>
-          <p:cNvPr id="3" name="Title 2"/>
-          <p:cNvSpPr>
-            <a:spLocks noGrp="1"/>
-          </p:cNvSpPr>
-          <p:nvPr>
-            <p:ph type="title"/>
-          </p:nvPr>
-        </p:nvSpPr>
-        <p:spPr/>
-        <p:txBody>
-          <a:bodyPr/>
-          <a:lstStyle/>
-          <a:p>
-            <a:r>
-              <a:rPr sz="2400"/>
-              <a:t>Models can drive controls</a:t>
-            </a:r>
-          </a:p>
-        </p:txBody>
-      </p:sp>
-      <p:sp>
-        <p:nvSpPr>
-          <p:cNvPr id="15" name="MCGate"/>
-          <p:cNvSpPr/>
-          <p:nvPr/>
-        </p:nvSpPr>
-        <p:spPr>
-          <a:xfrm>
-            <a:off x="3749039" y="3767328"/>
-            <a:ext cx="1645920" cy="566928"/>
-          </a:xfrm>
-          <a:prstGeom prst="rect">
-            <a:avLst/>
-          </a:prstGeom>
-          <a:solidFill>
-            <a:srgbClr val="8E6F3E"/>
-          </a:solidFill>
-          <a:ln>
-            <a:noFill/>
-          </a:ln>
-          <a:effectLst/>
-        </p:spPr>
-        <p:style>
-          <a:lnRef idx="1">
-            <a:schemeClr val="accent1"/>
-          </a:lnRef>
-          <a:fillRef idx="3">
-            <a:schemeClr val="accent1"/>
-          </a:fillRef>
-          <a:effectRef idx="2">
-            <a:schemeClr val="accent1"/>
-          </a:effectRef>
-          <a:fontRef idx="minor">
-            <a:schemeClr val="lt1"/>
-          </a:fontRef>
-        </p:style>
-        <p:txBody>
-          <a:bodyPr rtlCol="0" anchor="ctr" wrap="square" lIns="27432" rIns="27432" tIns="22860" bIns="22860"/>
-          <a:lstStyle/>
-          <a:p>
-            <a:pPr algn="ctr"/>
-            <a:r>
-              <a:rPr sz="1600" b="1" i="0">
-                <a:solidFill>
-                  <a:srgbClr val="FFFFFF"/>
-                </a:solidFill>
-              </a:rPr>
-              <a:t>VERDICTS</a:t>
-            </a:r>
-          </a:p>
-        </p:txBody>
-      </p:sp>
-      <p:sp>
-        <p:nvSpPr>
-          <p:cNvPr id="16" name="MCPoint"/>
-          <p:cNvSpPr txBox="1"/>
-          <p:nvPr/>
-        </p:nvSpPr>
-        <p:spPr>
-          <a:xfrm>
-            <a:off x="502920" y="4572000"/>
-            <a:ext cx="8138160" cy="548640"/>
-          </a:xfrm>
-          <a:prstGeom prst="rect">
-            <a:avLst/>
-          </a:prstGeom>
-          <a:noFill/>
-        </p:spPr>
-        <p:txBody>
-          <a:bodyPr wrap="square" anchor="t">
-            <a:spAutoFit/>
-          </a:bodyPr>
-          <a:lstStyle/>
-          <a:p>
-            <a:pPr algn="ctr"/>
-            <a:r>
-              <a:rPr sz="2000" b="0" i="0">
-                <a:solidFill>
-                  <a:srgbClr val="5C4826"/>
-                </a:solidFill>
-              </a:rPr>
-              <a:t>The same explicit engineering knowledge can support multiple validators and constraints.</a:t>
-            </a:r>
-          </a:p>
-        </p:txBody>
-      </p:sp>
-      <p:sp>
-        <p:nvSpPr>
-          <p:cNvPr id="18" name="RealModel"/>
-          <p:cNvSpPr/>
-          <p:nvPr/>
-        </p:nvSpPr>
-        <p:spPr>
-          <a:xfrm>
-            <a:off x="2103120" y="914400"/>
-            <a:ext cx="4937760" cy="804672"/>
-          </a:xfrm>
-          <a:prstGeom prst="rect">
-            <a:avLst/>
-          </a:prstGeom>
-          <a:solidFill>
-            <a:srgbClr val="8E6F3E"/>
-          </a:solidFill>
-          <a:ln>
-            <a:noFill/>
-          </a:ln>
-          <a:effectLst/>
-        </p:spPr>
-        <p:style>
-          <a:lnRef idx="1">
-            <a:schemeClr val="accent1"/>
-          </a:lnRef>
-          <a:fillRef idx="3">
-            <a:schemeClr val="accent1"/>
-          </a:fillRef>
-          <a:effectRef idx="2">
-            <a:schemeClr val="accent1"/>
-          </a:effectRef>
-          <a:fontRef idx="minor">
-            <a:schemeClr val="lt1"/>
-          </a:fontRef>
-        </p:style>
-        <p:txBody>
-          <a:bodyPr rtlCol="0" anchor="ctr" wrap="square" lIns="27432" rIns="27432" tIns="22860" bIns="22860"/>
-          <a:lstStyle/>
-          <a:p>
-            <a:pPr algn="ctr"/>
-            <a:r>
-              <a:rPr sz="1400" b="1" i="0">
-                <a:solidFill>
-                  <a:srgbClr val="FFFFFF"/>
-                </a:solidFill>
-              </a:rPr>
-              <a:t>DOCUMENT PROCESSING SERVICE</a:t>
-            </a:r>
-          </a:p>
-          <a:p>
-            <a:pPr algn="ctr"/>
-            <a:r>
-              <a:rPr sz="1050" b="1" i="0">
-                <a:solidFill>
-                  <a:srgbClr val="FBF8F2"/>
-                </a:solidFill>
-              </a:rPr>
-              <a:t xml:space="preserve">ONE EXPLICIT MODEL  </a:t>
-            </a:r>
-            <a:r>
-              <a:rPr sz="1050" b="0" i="1">
-                <a:solidFill>
-                  <a:srgbClr val="FBF8F2"/>
-                </a:solidFill>
-              </a:rPr>
-              <a:t>lifecycle machine + resource graph</a:t>
-            </a:r>
-          </a:p>
-        </p:txBody>
-      </p:sp>
-      <p:sp>
-        <p:nvSpPr>
-          <p:cNvPr id="19" name="MC-lifecycle"/>
-          <p:cNvSpPr/>
-          <p:nvPr/>
-        </p:nvSpPr>
-        <p:spPr>
-          <a:xfrm>
-            <a:off x="411480" y="2240280"/>
-            <a:ext cx="2468880" cy="960120"/>
-          </a:xfrm>
-          <a:prstGeom prst="rect">
-            <a:avLst/>
-          </a:prstGeom>
-          <a:solidFill>
-            <a:srgbClr val="F5F1E8"/>
-          </a:solidFill>
-          <a:ln w="12700">
-            <a:solidFill>
-              <a:srgbClr val="C9B991"/>
-            </a:solidFill>
-          </a:ln>
-          <a:effectLst/>
-        </p:spPr>
-        <p:style>
-          <a:lnRef idx="1">
-            <a:schemeClr val="accent1"/>
-          </a:lnRef>
-          <a:fillRef idx="3">
-            <a:schemeClr val="accent1"/>
-          </a:fillRef>
-          <a:effectRef idx="2">
-            <a:schemeClr val="accent1"/>
-          </a:effectRef>
-          <a:fontRef idx="minor">
-            <a:schemeClr val="lt1"/>
-          </a:fontRef>
-        </p:style>
-        <p:txBody>
-          <a:bodyPr rtlCol="0" anchor="ctr" wrap="square" lIns="27432" rIns="27432" tIns="22860" bIns="22860"/>
-          <a:lstStyle/>
-          <a:p>
-            <a:pPr algn="ctr"/>
-            <a:r>
-              <a:rPr sz="1200" b="1" i="0">
-                <a:solidFill>
-                  <a:srgbClr val="5C4826"/>
-                </a:solidFill>
-              </a:rPr>
-              <a:t>LIFECYCLE CHECK</a:t>
-            </a:r>
-          </a:p>
-          <a:p>
-            <a:pPr algn="ctr"/>
-            <a:r>
-              <a:rPr sz="950" b="0" i="0">
-                <a:solidFill>
-                  <a:srgbClr val="555960"/>
-                </a:solidFill>
-              </a:rPr>
-              <a:t>can a Completed document ever be processed again?  no</a:t>
-            </a:r>
-          </a:p>
-        </p:txBody>
-      </p:sp>
-      <p:sp>
-        <p:nvSpPr>
-          <p:cNvPr id="20" name="MC-retry"/>
-          <p:cNvSpPr/>
-          <p:nvPr/>
-        </p:nvSpPr>
-        <p:spPr>
-          <a:xfrm>
-            <a:off x="3337560" y="2240280"/>
-            <a:ext cx="2468880" cy="960120"/>
-          </a:xfrm>
-          <a:prstGeom prst="rect">
-            <a:avLst/>
-          </a:prstGeom>
-          <a:solidFill>
-            <a:srgbClr val="F5F1E8"/>
-          </a:solidFill>
-          <a:ln w="12700">
-            <a:solidFill>
-              <a:srgbClr val="C9B991"/>
-            </a:solidFill>
-          </a:ln>
-          <a:effectLst/>
-        </p:spPr>
-        <p:style>
-          <a:lnRef idx="1">
-            <a:schemeClr val="accent1"/>
-          </a:lnRef>
-          <a:fillRef idx="3">
-            <a:schemeClr val="accent1"/>
-          </a:fillRef>
-          <a:effectRef idx="2">
-            <a:schemeClr val="accent1"/>
-          </a:effectRef>
-          <a:fontRef idx="minor">
-            <a:schemeClr val="lt1"/>
-          </a:fontRef>
-        </p:style>
-        <p:txBody>
-          <a:bodyPr rtlCol="0" anchor="ctr" wrap="square" lIns="27432" rIns="27432" tIns="22860" bIns="22860"/>
-          <a:lstStyle/>
-          <a:p>
-            <a:pPr algn="ctr"/>
-            <a:r>
-              <a:rPr sz="1200" b="1" i="0">
-                <a:solidFill>
-                  <a:srgbClr val="5C4826"/>
-                </a:solidFill>
-              </a:rPr>
-              <a:t>RETRY BOUND</a:t>
-            </a:r>
-          </a:p>
-          <a:p>
-            <a:pPr algn="ctr"/>
-            <a:r>
-              <a:rPr sz="950" b="0" i="0">
-                <a:solidFill>
-                  <a:srgbClr val="555960"/>
-                </a:solidFill>
-              </a:rPr>
-              <a:t>can the retry loop run forever?  no, at most 2 retries</a:t>
-            </a:r>
-          </a:p>
-        </p:txBody>
-      </p:sp>
-      <p:sp>
-        <p:nvSpPr>
-          <p:cNvPr id="21" name="MC-memory"/>
-          <p:cNvSpPr/>
-          <p:nvPr/>
-        </p:nvSpPr>
-        <p:spPr>
-          <a:xfrm>
-            <a:off x="6263640" y="2240280"/>
-            <a:ext cx="2468880" cy="960120"/>
-          </a:xfrm>
-          <a:prstGeom prst="rect">
-            <a:avLst/>
-          </a:prstGeom>
-          <a:solidFill>
-            <a:srgbClr val="F5F1E8"/>
-          </a:solidFill>
-          <a:ln w="12700">
-            <a:solidFill>
-              <a:srgbClr val="C9B991"/>
-            </a:solidFill>
-          </a:ln>
-          <a:effectLst/>
-        </p:spPr>
-        <p:style>
-          <a:lnRef idx="1">
-            <a:schemeClr val="accent1"/>
-          </a:lnRef>
-          <a:fillRef idx="3">
-            <a:schemeClr val="accent1"/>
-          </a:fillRef>
-          <a:effectRef idx="2">
-            <a:schemeClr val="accent1"/>
-          </a:effectRef>
-          <a:fontRef idx="minor">
-            <a:schemeClr val="lt1"/>
-          </a:fontRef>
-        </p:style>
-        <p:txBody>
-          <a:bodyPr rtlCol="0" anchor="ctr" wrap="square" lIns="27432" rIns="27432" tIns="22860" bIns="22860"/>
-          <a:lstStyle/>
-          <a:p>
-            <a:pPr algn="ctr"/>
-            <a:r>
-              <a:rPr sz="1200" b="1" i="0">
-                <a:solidFill>
-                  <a:srgbClr val="5C4826"/>
-                </a:solidFill>
-              </a:rPr>
-              <a:t>MEMORY ANALYSIS</a:t>
-            </a:r>
-          </a:p>
-          <a:p>
-            <a:pPr algn="ctr"/>
-            <a:r>
-              <a:rPr sz="950" b="0" i="0">
-                <a:solidFill>
-                  <a:srgbClr val="555960"/>
-                </a:solidFill>
-              </a:rPr>
-              <a:t>peak demand 2 × 384 MB, within the 1 GB worker ceiling</a:t>
-            </a:r>
-          </a:p>
-        </p:txBody>
-      </p:sp>
-      <p:cxnSp>
-        <p:nvCxnSpPr>
-          <p:cNvPr id="22" name="RM-Conn1"/>
-          <p:cNvCxnSpPr/>
-          <p:nvPr/>
-        </p:nvCxnSpPr>
-        <p:spPr>
-          <a:xfrm flipH="1">
-            <a:off x="1645920" y="1719072"/>
-            <a:ext cx="2926080" cy="521208"/>
-          </a:xfrm>
-          <a:prstGeom prst="line">
-            <a:avLst/>
-          </a:prstGeom>
-          <a:ln w="28575">
-            <a:solidFill>
-              <a:srgbClr val="8E6F3E"/>
-            </a:solidFill>
-            <a:tailEnd type="triangle" w="med" len="med"/>
-          </a:ln>
-        </p:spPr>
-        <p:style>
-          <a:lnRef idx="2">
-            <a:schemeClr val="accent1"/>
-          </a:lnRef>
-          <a:fillRef idx="0">
-            <a:schemeClr val="accent1"/>
-          </a:fillRef>
-          <a:effectRef idx="1">
-            <a:schemeClr val="accent1"/>
-          </a:effectRef>
-          <a:fontRef idx="minor">
-            <a:schemeClr val="tx1"/>
-          </a:fontRef>
-        </p:style>
-      </p:cxnSp>
-      <p:cxnSp>
-        <p:nvCxnSpPr>
-          <p:cNvPr id="23" name="RM-Conn2"/>
-          <p:cNvCxnSpPr/>
-          <p:nvPr/>
-        </p:nvCxnSpPr>
-        <p:spPr>
-          <a:xfrm>
-            <a:off x="4572000" y="1719072"/>
-            <a:ext cx="0" cy="521208"/>
-          </a:xfrm>
-          <a:prstGeom prst="line">
-            <a:avLst/>
-          </a:prstGeom>
-          <a:ln w="28575">
-            <a:solidFill>
-              <a:srgbClr val="8E6F3E"/>
-            </a:solidFill>
-            <a:tailEnd type="triangle" w="med" len="med"/>
-          </a:ln>
-        </p:spPr>
-        <p:style>
-          <a:lnRef idx="2">
-            <a:schemeClr val="accent1"/>
-          </a:lnRef>
-          <a:fillRef idx="0">
-            <a:schemeClr val="accent1"/>
-          </a:fillRef>
-          <a:effectRef idx="1">
-            <a:schemeClr val="accent1"/>
-          </a:effectRef>
-          <a:fontRef idx="minor">
-            <a:schemeClr val="tx1"/>
-          </a:fontRef>
-        </p:style>
-      </p:cxnSp>
-      <p:cxnSp>
-        <p:nvCxnSpPr>
-          <p:cNvPr id="24" name="RM-Conn3"/>
-          <p:cNvCxnSpPr/>
-          <p:nvPr/>
-        </p:nvCxnSpPr>
-        <p:spPr>
-          <a:xfrm>
-            <a:off x="4572000" y="1719072"/>
-            <a:ext cx="2926079" cy="521208"/>
-          </a:xfrm>
-          <a:prstGeom prst="line">
-            <a:avLst/>
-          </a:prstGeom>
-          <a:ln w="28575">
-            <a:solidFill>
-              <a:srgbClr val="8E6F3E"/>
-            </a:solidFill>
-            <a:tailEnd type="triangle" w="med" len="med"/>
-          </a:ln>
-        </p:spPr>
-        <p:style>
-          <a:lnRef idx="2">
-            <a:schemeClr val="accent1"/>
-          </a:lnRef>
-          <a:fillRef idx="0">
-            <a:schemeClr val="accent1"/>
-          </a:fillRef>
-          <a:effectRef idx="1">
-            <a:schemeClr val="accent1"/>
-          </a:effectRef>
-          <a:fontRef idx="minor">
-            <a:schemeClr val="tx1"/>
-          </a:fontRef>
-        </p:style>
-      </p:cxnSp>
-      <p:cxnSp>
-        <p:nvCxnSpPr>
-          <p:cNvPr id="25" name="RM-Conn4"/>
-          <p:cNvCxnSpPr/>
-          <p:nvPr/>
-        </p:nvCxnSpPr>
-        <p:spPr>
-          <a:xfrm>
-            <a:off x="1645920" y="3200400"/>
-            <a:ext cx="2377440" cy="566928"/>
-          </a:xfrm>
-          <a:prstGeom prst="line">
-            <a:avLst/>
-          </a:prstGeom>
-          <a:ln w="28575">
-            <a:solidFill>
-              <a:srgbClr val="8E6F3E"/>
-            </a:solidFill>
-            <a:tailEnd type="triangle" w="med" len="med"/>
-          </a:ln>
-        </p:spPr>
-        <p:style>
-          <a:lnRef idx="2">
-            <a:schemeClr val="accent1"/>
-          </a:lnRef>
-          <a:fillRef idx="0">
-            <a:schemeClr val="accent1"/>
-          </a:fillRef>
-          <a:effectRef idx="1">
-            <a:schemeClr val="accent1"/>
-          </a:effectRef>
-          <a:fontRef idx="minor">
-            <a:schemeClr val="tx1"/>
-          </a:fontRef>
-        </p:style>
-      </p:cxnSp>
-      <p:cxnSp>
-        <p:nvCxnSpPr>
-          <p:cNvPr id="26" name="RM-Conn5"/>
-          <p:cNvCxnSpPr/>
-          <p:nvPr/>
-        </p:nvCxnSpPr>
-        <p:spPr>
-          <a:xfrm>
-            <a:off x="4572000" y="3200400"/>
-            <a:ext cx="0" cy="566928"/>
-          </a:xfrm>
-          <a:prstGeom prst="line">
-            <a:avLst/>
-          </a:prstGeom>
-          <a:ln w="28575">
-            <a:solidFill>
-              <a:srgbClr val="8E6F3E"/>
-            </a:solidFill>
-            <a:tailEnd type="triangle" w="med" len="med"/>
-          </a:ln>
-        </p:spPr>
-        <p:style>
-          <a:lnRef idx="2">
-            <a:schemeClr val="accent1"/>
-          </a:lnRef>
-          <a:fillRef idx="0">
-            <a:schemeClr val="accent1"/>
-          </a:fillRef>
-          <a:effectRef idx="1">
-            <a:schemeClr val="accent1"/>
-          </a:effectRef>
-          <a:fontRef idx="minor">
-            <a:schemeClr val="tx1"/>
-          </a:fontRef>
-        </p:style>
-      </p:cxnSp>
-      <p:cxnSp>
-        <p:nvCxnSpPr>
-          <p:cNvPr id="27" name="RM-Conn6"/>
-          <p:cNvCxnSpPr/>
-          <p:nvPr/>
-        </p:nvCxnSpPr>
-        <p:spPr>
-          <a:xfrm flipH="1">
-            <a:off x="5120640" y="3200400"/>
-            <a:ext cx="2377439" cy="566928"/>
-          </a:xfrm>
-          <a:prstGeom prst="line">
-            <a:avLst/>
-          </a:prstGeom>
-          <a:ln w="28575">
-            <a:solidFill>
-              <a:srgbClr val="8E6F3E"/>
-            </a:solidFill>
-            <a:tailEnd type="triangle" w="med" len="med"/>
-          </a:ln>
-        </p:spPr>
-        <p:style>
-          <a:lnRef idx="2">
-            <a:schemeClr val="accent1"/>
-          </a:lnRef>
-          <a:fillRef idx="0">
-            <a:schemeClr val="accent1"/>
-          </a:fillRef>
-          <a:effectRef idx="1">
-            <a:schemeClr val="accent1"/>
-          </a:effectRef>
-          <a:fontRef idx="minor">
-            <a:schemeClr val="tx1"/>
-          </a:fontRef>
-        </p:style>
-      </p:cxnSp>
-      <p:sp>
-        <p:nvSpPr>
-          <p:cNvPr id="28" name="MC-Optional"/>
-          <p:cNvSpPr txBox="1"/>
-          <p:nvPr/>
-        </p:nvSpPr>
-        <p:spPr>
-          <a:xfrm>
-            <a:off x="5989320" y="3438144"/>
-            <a:ext cx="1234440" cy="274320"/>
-          </a:xfrm>
-          <a:prstGeom prst="rect">
-            <a:avLst/>
-          </a:prstGeom>
-          <a:noFill/>
-        </p:spPr>
-        <p:txBody>
-          <a:bodyPr wrap="square" anchor="t">
-            <a:spAutoFit/>
-          </a:bodyPr>
-          <a:lstStyle/>
-          <a:p>
-            <a:pPr algn="ctr"/>
-            <a:r>
-              <a:rPr sz="1200" b="0" i="1">
-                <a:solidFill>
-                  <a:srgbClr val="555960"/>
-                </a:solidFill>
-              </a:rPr>
-              <a:t>optional</a:t>
-            </a:r>
-          </a:p>
-        </p:txBody>
-      </p:sp>
-      <p:sp>
-        <p:nvSpPr>
-          <p:cNvPr id="29" name="MC-GateOpt"/>
-          <p:cNvSpPr/>
-          <p:nvPr/>
-        </p:nvSpPr>
-        <p:spPr>
-          <a:xfrm>
-            <a:off x="5989320" y="3767328"/>
-            <a:ext cx="1234440" cy="566928"/>
-          </a:xfrm>
-          <a:prstGeom prst="rect">
-            <a:avLst/>
-          </a:prstGeom>
-          <a:solidFill>
-            <a:srgbClr val="8E6F3E"/>
-          </a:solidFill>
-          <a:ln>
-            <a:noFill/>
-          </a:ln>
-          <a:effectLst/>
-        </p:spPr>
-        <p:style>
-          <a:lnRef idx="1">
-            <a:schemeClr val="accent1"/>
-          </a:lnRef>
-          <a:fillRef idx="3">
-            <a:schemeClr val="accent1"/>
-          </a:fillRef>
-          <a:effectRef idx="2">
-            <a:schemeClr val="accent1"/>
-          </a:effectRef>
-          <a:fontRef idx="minor">
-            <a:schemeClr val="lt1"/>
-          </a:fontRef>
-        </p:style>
-        <p:txBody>
-          <a:bodyPr rtlCol="0" anchor="ctr" wrap="square" lIns="27432" rIns="27432" tIns="22860" bIns="22860"/>
-          <a:lstStyle/>
-          <a:p>
-            <a:pPr algn="ctr"/>
-            <a:r>
-              <a:rPr sz="1600" b="1" i="0">
-                <a:solidFill>
-                  <a:srgbClr val="FFFFFF"/>
-                </a:solidFill>
-              </a:rPr>
-              <a:t>GATE</a:t>
-            </a:r>
-          </a:p>
-        </p:txBody>
-      </p:sp>
-      <p:cxnSp>
-        <p:nvCxnSpPr>
-          <p:cNvPr id="30" name="MC-VGArrow"/>
-          <p:cNvCxnSpPr/>
-          <p:nvPr/>
-        </p:nvCxnSpPr>
-        <p:spPr>
-          <a:xfrm>
-            <a:off x="5468112" y="4050791"/>
-            <a:ext cx="457200" cy="0"/>
-          </a:xfrm>
-          <a:prstGeom prst="line">
-            <a:avLst/>
-          </a:prstGeom>
-          <a:ln w="28575">
-            <a:solidFill>
-              <a:srgbClr val="8E6F3E"/>
-            </a:solidFill>
-            <a:tailEnd type="triangle" w="med" len="med"/>
-          </a:ln>
-          <a:effectLst/>
-        </p:spPr>
-        <p:style>
-          <a:lnRef idx="2">
-            <a:schemeClr val="accent1"/>
-          </a:lnRef>
-          <a:fillRef idx="0">
-            <a:schemeClr val="accent1"/>
-          </a:fillRef>
-          <a:effectRef idx="1">
-            <a:schemeClr val="accent1"/>
-          </a:effectRef>
-          <a:fontRef idx="minor">
-            <a:schemeClr val="tx1"/>
-          </a:fontRef>
-        </p:style>
-      </p:cxnSp>
+              <a:t>Models give validation mechanisms an explicit object to inspect.</a:t>
+            </a:r>
+          </a:p>
+        </p:txBody>
+      </p:sp>
     </p:spTree>
   </p:cSld>
   <p:clrMapOvr>
@@ -22929,31 +22333,37 @@
       </p:sp>
       <p:sp>
         <p:nvSpPr>
-          <p:cNvPr id="15" name="TR-Label1"/>
-          <p:cNvSpPr txBox="1"/>
-          <p:nvPr/>
-        </p:nvSpPr>
-        <p:spPr>
-          <a:xfrm>
-            <a:off x="320040" y="1353312"/>
-            <a:ext cx="2697480" cy="457200"/>
+          <p:cNvPr id="0" name="TR-Head0"/>
+          <p:cNvSpPr/>
+          <p:nvPr/>
+        </p:nvSpPr>
+        <p:spPr>
+          <a:xfrm>
+            <a:off x="274320" y="1188720"/>
+            <a:ext cx="2742293" cy="548640"/>
           </a:xfrm>
           <a:prstGeom prst="rect">
             <a:avLst/>
           </a:prstGeom>
-          <a:noFill/>
-        </p:spPr>
-        <p:txBody>
-          <a:bodyPr wrap="square" anchor="t">
-            <a:spAutoFit/>
-          </a:bodyPr>
-          <a:lstStyle/>
-          <a:p>
-            <a:pPr algn="l"/>
-            <a:r>
-              <a:rPr sz="2200" b="1" i="0">
-                <a:solidFill>
-                  <a:srgbClr val="8E6F3E"/>
+          <a:solidFill>
+            <a:srgbClr val="8E6F3E"/>
+          </a:solidFill>
+          <a:ln>
+            <a:noFill/>
+          </a:ln>
+          <a:effectLst/>
+        </p:spPr>
+        <p:txBody>
+          <a:bodyPr rtlCol="0" anchor="ctr" wrap="square" lIns="27432" rIns="27432" tIns="22860" bIns="22860"/>
+          <a:lstStyle/>
+          <a:p>
+            <a:pPr algn="ctr">
+              <a:buNone/>
+            </a:pPr>
+            <a:r>
+              <a:rPr lang="en-US" sz="2000" b="1" i="0" dirty="0">
+                <a:solidFill>
+                  <a:srgbClr val="FFFFFF"/>
                 </a:solidFill>
               </a:rPr>
               <a:t>CORRESPONDENCE</a:t>
@@ -22963,14 +22373,14 @@
       </p:sp>
       <p:sp>
         <p:nvSpPr>
-          <p:cNvPr id="16" name="TR-Box1a"/>
+          <p:cNvPr id="0" name="TR-Body0"/>
           <p:cNvSpPr/>
           <p:nvPr/>
         </p:nvSpPr>
         <p:spPr>
           <a:xfrm>
-            <a:off x="3108960" y="1280160"/>
-            <a:ext cx="1965960" cy="731520"/>
+            <a:off x="274320" y="1737360"/>
+            <a:ext cx="2742293" cy="3108960"/>
           </a:xfrm>
           <a:prstGeom prst="rect">
             <a:avLst/>
@@ -22985,27 +22395,15 @@
           </a:ln>
           <a:effectLst/>
         </p:spPr>
-        <p:style>
-          <a:lnRef idx="1">
-            <a:schemeClr val="accent1"/>
-          </a:lnRef>
-          <a:fillRef idx="3">
-            <a:schemeClr val="accent1"/>
-          </a:fillRef>
-          <a:effectRef idx="2">
-            <a:schemeClr val="accent1"/>
-          </a:effectRef>
-          <a:fontRef idx="minor">
-            <a:schemeClr val="lt1"/>
-          </a:fontRef>
-        </p:style>
         <p:txBody>
           <a:bodyPr rtlCol="0" anchor="ctr" wrap="square" lIns="27432" rIns="27432" tIns="22860" bIns="22860"/>
           <a:lstStyle/>
           <a:p>
-            <a:pPr algn="ctr"/>
-            <a:r>
-              <a:rPr sz="1500" b="0" i="0">
+            <a:pPr algn="ctr">
+              <a:buNone/>
+            </a:pPr>
+            <a:r>
+              <a:rPr lang="en-US" sz="2000" b="1" i="0" dirty="0">
                 <a:solidFill>
                   <a:srgbClr val="5C4826"/>
                 </a:solidFill>
@@ -23013,18 +22411,97 @@
               <a:t>implementation</a:t>
             </a:r>
           </a:p>
-        </p:txBody>
-      </p:sp>
-      <p:sp>
-        <p:nvSpPr>
-          <p:cNvPr id="17" name="TR-Box1b"/>
+          <a:p>
+            <a:pPr algn="ctr">
+              <a:buNone/>
+            </a:pPr>
+            <a:r>
+              <a:rPr lang="en-US" sz="2400" b="1" i="0" dirty="0">
+                <a:solidFill>
+                  <a:srgbClr val="8E6F3E"/>
+                </a:solidFill>
+              </a:rPr>
+              <a:t>↕</a:t>
+            </a:r>
+          </a:p>
+          <a:p>
+            <a:pPr algn="ctr">
+              <a:buNone/>
+            </a:pPr>
+            <a:r>
+              <a:rPr lang="en-US" sz="2000" b="1" i="0" dirty="0">
+                <a:solidFill>
+                  <a:srgbClr val="5C4826"/>
+                </a:solidFill>
+              </a:rPr>
+              <a:t>representation</a:t>
+            </a:r>
+          </a:p>
+          <a:p>
+            <a:pPr algn="ctr">
+              <a:buNone/>
+            </a:pPr>
+            <a:r>
+              <a:rPr lang="en-US" sz="2000" b="0" i="1" dirty="0">
+                <a:solidFill>
+                  <a:srgbClr val="555960"/>
+                </a:solidFill>
+              </a:rPr>
+              <a:t>do they agree?</a:t>
+            </a:r>
+          </a:p>
+        </p:txBody>
+      </p:sp>
+      <p:sp>
+        <p:nvSpPr>
+          <p:cNvPr id="0" name="TR-Head1"/>
           <p:cNvSpPr/>
           <p:nvPr/>
         </p:nvSpPr>
         <p:spPr>
           <a:xfrm>
-            <a:off x="5989320" y="1280160"/>
-            <a:ext cx="2834640" cy="731520"/>
+            <a:off x="3200844" y="1188720"/>
+            <a:ext cx="2742293" cy="548640"/>
+          </a:xfrm>
+          <a:prstGeom prst="rect">
+            <a:avLst/>
+          </a:prstGeom>
+          <a:solidFill>
+            <a:srgbClr val="8E6F3E"/>
+          </a:solidFill>
+          <a:ln>
+            <a:noFill/>
+          </a:ln>
+          <a:effectLst/>
+        </p:spPr>
+        <p:txBody>
+          <a:bodyPr rtlCol="0" anchor="ctr" wrap="square" lIns="27432" rIns="27432" tIns="22860" bIns="22860"/>
+          <a:lstStyle/>
+          <a:p>
+            <a:pPr algn="ctr">
+              <a:buNone/>
+            </a:pPr>
+            <a:r>
+              <a:rPr lang="en-US" sz="2000" b="1" i="0" dirty="0">
+                <a:solidFill>
+                  <a:srgbClr val="FFFFFF"/>
+                </a:solidFill>
+              </a:rPr>
+              <a:t>CONFORMANCE</a:t>
+            </a:r>
+          </a:p>
+        </p:txBody>
+      </p:sp>
+      <p:sp>
+        <p:nvSpPr>
+          <p:cNvPr id="0" name="TR-Body1"/>
+          <p:cNvSpPr/>
+          <p:nvPr/>
+        </p:nvSpPr>
+        <p:spPr>
+          <a:xfrm>
+            <a:off x="3200844" y="1737360"/>
+            <a:ext cx="2742293" cy="3108960"/>
           </a:xfrm>
           <a:prstGeom prst="rect">
             <a:avLst/>
@@ -23039,152 +22516,113 @@
           </a:ln>
           <a:effectLst/>
         </p:spPr>
-        <p:style>
-          <a:lnRef idx="1">
-            <a:schemeClr val="accent1"/>
-          </a:lnRef>
-          <a:fillRef idx="3">
-            <a:schemeClr val="accent1"/>
-          </a:fillRef>
-          <a:effectRef idx="2">
-            <a:schemeClr val="accent1"/>
-          </a:effectRef>
-          <a:fontRef idx="minor">
-            <a:schemeClr val="lt1"/>
-          </a:fontRef>
-        </p:style>
         <p:txBody>
           <a:bodyPr rtlCol="0" anchor="ctr" wrap="square" lIns="27432" rIns="27432" tIns="22860" bIns="22860"/>
           <a:lstStyle/>
           <a:p>
-            <a:pPr algn="ctr"/>
-            <a:r>
-              <a:rPr sz="1500" b="0" i="0">
+            <a:pPr algn="ctr">
+              <a:buNone/>
+            </a:pPr>
+            <a:r>
+              <a:rPr lang="en-US" sz="2000" b="1" i="0" dirty="0">
                 <a:solidFill>
                   <a:srgbClr val="5C4826"/>
                 </a:solidFill>
               </a:rPr>
-              <a:t>representation</a:t>
-            </a:r>
-          </a:p>
-        </p:txBody>
-      </p:sp>
-      <p:cxnSp>
-        <p:nvCxnSpPr>
-          <p:cNvPr id="18" name="TR-Arrow1"/>
-          <p:cNvCxnSpPr/>
-          <p:nvPr/>
-        </p:nvCxnSpPr>
-        <p:spPr>
-          <a:xfrm>
-            <a:off x="5138928" y="1645920"/>
-            <a:ext cx="786384" cy="0"/>
-          </a:xfrm>
-          <a:prstGeom prst="line">
-            <a:avLst/>
-          </a:prstGeom>
-          <a:ln w="28575">
-            <a:solidFill>
-              <a:srgbClr val="8E6F3E"/>
-            </a:solidFill>
-            <a:headEnd type="triangle" w="med" len="med"/>
-            <a:tailEnd type="triangle" w="med" len="med"/>
+              <a:t>artifact</a:t>
+            </a:r>
+          </a:p>
+          <a:p>
+            <a:pPr algn="ctr">
+              <a:buNone/>
+            </a:pPr>
+            <a:r>
+              <a:rPr lang="en-US" sz="2400" b="1" i="0" dirty="0">
+                <a:solidFill>
+                  <a:srgbClr val="8E6F3E"/>
+                </a:solidFill>
+              </a:rPr>
+              <a:t>↕</a:t>
+            </a:r>
+          </a:p>
+          <a:p>
+            <a:pPr algn="ctr">
+              <a:buNone/>
+            </a:pPr>
+            <a:r>
+              <a:rPr lang="en-US" sz="2000" b="1" i="0" dirty="0">
+                <a:solidFill>
+                  <a:srgbClr val="5C4826"/>
+                </a:solidFill>
+              </a:rPr>
+              <a:t>independent obligation</a:t>
+            </a:r>
+          </a:p>
+          <a:p>
+            <a:pPr algn="ctr">
+              <a:buNone/>
+            </a:pPr>
+            <a:r>
+              <a:rPr lang="en-US" sz="2000" b="0" i="1" dirty="0">
+                <a:solidFill>
+                  <a:srgbClr val="555960"/>
+                </a:solidFill>
+              </a:rPr>
+              <a:t>does it satisfy?</a:t>
+            </a:r>
+          </a:p>
+        </p:txBody>
+      </p:sp>
+      <p:sp>
+        <p:nvSpPr>
+          <p:cNvPr id="0" name="TR-Head2"/>
+          <p:cNvSpPr/>
+          <p:nvPr/>
+        </p:nvSpPr>
+        <p:spPr>
+          <a:xfrm>
+            <a:off x="6127368" y="1188720"/>
+            <a:ext cx="2742293" cy="548640"/>
+          </a:xfrm>
+          <a:prstGeom prst="rect">
+            <a:avLst/>
+          </a:prstGeom>
+          <a:solidFill>
+            <a:srgbClr val="8E6F3E"/>
+          </a:solidFill>
+          <a:ln>
+            <a:noFill/>
           </a:ln>
           <a:effectLst/>
         </p:spPr>
-        <p:style>
-          <a:lnRef idx="2">
-            <a:schemeClr val="accent1"/>
-          </a:lnRef>
-          <a:fillRef idx="0">
-            <a:schemeClr val="accent1"/>
-          </a:fillRef>
-          <a:effectRef idx="1">
-            <a:schemeClr val="accent1"/>
-          </a:effectRef>
-          <a:fontRef idx="minor">
-            <a:schemeClr val="tx1"/>
-          </a:fontRef>
-        </p:style>
-      </p:cxnSp>
-      <p:sp>
-        <p:nvSpPr>
-          <p:cNvPr id="19" name="TR-Q1"/>
-          <p:cNvSpPr txBox="1"/>
-          <p:nvPr/>
-        </p:nvSpPr>
-        <p:spPr>
-          <a:xfrm>
-            <a:off x="4617720" y="1097280"/>
-            <a:ext cx="1828800" cy="292608"/>
-          </a:xfrm>
-          <a:prstGeom prst="rect">
-            <a:avLst/>
-          </a:prstGeom>
-          <a:noFill/>
-        </p:spPr>
-        <p:txBody>
-          <a:bodyPr wrap="square" anchor="t">
-            <a:spAutoFit/>
-          </a:bodyPr>
-          <a:lstStyle/>
-          <a:p>
-            <a:pPr algn="ctr"/>
-            <a:r>
-              <a:rPr sz="1200" b="0" i="1">
-                <a:solidFill>
-                  <a:srgbClr val="555960"/>
-                </a:solidFill>
-              </a:rPr>
-              <a:t>do they agree?</a:t>
-            </a:r>
-          </a:p>
-        </p:txBody>
-      </p:sp>
-      <p:sp>
-        <p:nvSpPr>
-          <p:cNvPr id="20" name="TR-Label2"/>
-          <p:cNvSpPr txBox="1"/>
-          <p:nvPr/>
-        </p:nvSpPr>
-        <p:spPr>
-          <a:xfrm>
-            <a:off x="320040" y="2953512"/>
-            <a:ext cx="2697480" cy="457200"/>
-          </a:xfrm>
-          <a:prstGeom prst="rect">
-            <a:avLst/>
-          </a:prstGeom>
-          <a:noFill/>
-        </p:spPr>
-        <p:txBody>
-          <a:bodyPr wrap="square" anchor="t">
-            <a:spAutoFit/>
-          </a:bodyPr>
-          <a:lstStyle/>
-          <a:p>
-            <a:pPr algn="l"/>
-            <a:r>
-              <a:rPr sz="2200" b="1" i="0">
-                <a:solidFill>
-                  <a:srgbClr val="8E6F3E"/>
-                </a:solidFill>
-              </a:rPr>
-              <a:t>CONFORMANCE</a:t>
-            </a:r>
-          </a:p>
-        </p:txBody>
-      </p:sp>
-      <p:sp>
-        <p:nvSpPr>
-          <p:cNvPr id="21" name="TR-Box2a"/>
+        <p:txBody>
+          <a:bodyPr rtlCol="0" anchor="ctr" wrap="square" lIns="27432" rIns="27432" tIns="22860" bIns="22860"/>
+          <a:lstStyle/>
+          <a:p>
+            <a:pPr algn="ctr">
+              <a:buNone/>
+            </a:pPr>
+            <a:r>
+              <a:rPr lang="en-US" sz="2000" b="1" i="0" dirty="0">
+                <a:solidFill>
+                  <a:srgbClr val="FFFFFF"/>
+                </a:solidFill>
+              </a:rPr>
+              <a:t>ACCEPTANCE</a:t>
+            </a:r>
+          </a:p>
+        </p:txBody>
+      </p:sp>
+      <p:sp>
+        <p:nvSpPr>
+          <p:cNvPr id="0" name="TR-Body2"/>
           <p:cNvSpPr/>
           <p:nvPr/>
         </p:nvSpPr>
         <p:spPr>
           <a:xfrm>
-            <a:off x="3108960" y="2880360"/>
-            <a:ext cx="1965960" cy="731520"/>
+            <a:off x="6127368" y="1737360"/>
+            <a:ext cx="2742293" cy="3108960"/>
           </a:xfrm>
           <a:prstGeom prst="rect">
             <a:avLst/>
@@ -23199,27 +22637,15 @@
           </a:ln>
           <a:effectLst/>
         </p:spPr>
-        <p:style>
-          <a:lnRef idx="1">
-            <a:schemeClr val="accent1"/>
-          </a:lnRef>
-          <a:fillRef idx="3">
-            <a:schemeClr val="accent1"/>
-          </a:fillRef>
-          <a:effectRef idx="2">
-            <a:schemeClr val="accent1"/>
-          </a:effectRef>
-          <a:fontRef idx="minor">
-            <a:schemeClr val="lt1"/>
-          </a:fontRef>
-        </p:style>
         <p:txBody>
           <a:bodyPr rtlCol="0" anchor="ctr" wrap="square" lIns="27432" rIns="27432" tIns="22860" bIns="22860"/>
           <a:lstStyle/>
           <a:p>
-            <a:pPr algn="ctr"/>
-            <a:r>
-              <a:rPr sz="1500" b="0" i="0">
+            <a:pPr algn="ctr">
+              <a:buNone/>
+            </a:pPr>
+            <a:r>
+              <a:rPr lang="en-US" sz="2000" b="1" i="0" dirty="0">
                 <a:solidFill>
                   <a:srgbClr val="5C4826"/>
                 </a:solidFill>
@@ -23227,337 +22653,38 @@
               <a:t>artifact</a:t>
             </a:r>
           </a:p>
-        </p:txBody>
-      </p:sp>
-      <p:sp>
-        <p:nvSpPr>
-          <p:cNvPr id="22" name="TR-Box2b"/>
-          <p:cNvSpPr/>
-          <p:nvPr/>
-        </p:nvSpPr>
-        <p:spPr>
-          <a:xfrm>
-            <a:off x="5989320" y="2880360"/>
-            <a:ext cx="2834640" cy="731520"/>
-          </a:xfrm>
-          <a:prstGeom prst="rect">
-            <a:avLst/>
-          </a:prstGeom>
-          <a:solidFill>
-            <a:srgbClr val="F5F1E8"/>
-          </a:solidFill>
-          <a:ln w="12700">
-            <a:solidFill>
-              <a:srgbClr val="C9B991"/>
-            </a:solidFill>
-          </a:ln>
-          <a:effectLst/>
-        </p:spPr>
-        <p:style>
-          <a:lnRef idx="1">
-            <a:schemeClr val="accent1"/>
-          </a:lnRef>
-          <a:fillRef idx="3">
-            <a:schemeClr val="accent1"/>
-          </a:fillRef>
-          <a:effectRef idx="2">
-            <a:schemeClr val="accent1"/>
-          </a:effectRef>
-          <a:fontRef idx="minor">
-            <a:schemeClr val="lt1"/>
-          </a:fontRef>
-        </p:style>
-        <p:txBody>
-          <a:bodyPr rtlCol="0" anchor="ctr" wrap="square" lIns="27432" rIns="27432" tIns="22860" bIns="22860"/>
-          <a:lstStyle/>
-          <a:p>
-            <a:pPr algn="ctr"/>
-            <a:r>
-              <a:rPr sz="1500" b="0" i="0">
+          <a:p>
+            <a:pPr algn="ctr">
+              <a:buNone/>
+            </a:pPr>
+            <a:r>
+              <a:rPr lang="en-US" sz="2400" b="1" i="0" dirty="0">
+                <a:solidFill>
+                  <a:srgbClr val="8E6F3E"/>
+                </a:solidFill>
+              </a:rPr>
+              <a:t>↕</a:t>
+            </a:r>
+          </a:p>
+          <a:p>
+            <a:pPr algn="ctr">
+              <a:buNone/>
+            </a:pPr>
+            <a:r>
+              <a:rPr lang="en-US" sz="2000" b="1" i="0" dirty="0">
                 <a:solidFill>
                   <a:srgbClr val="5C4826"/>
                 </a:solidFill>
               </a:rPr>
-              <a:t>independent obligation</a:t>
-            </a:r>
-          </a:p>
-        </p:txBody>
-      </p:sp>
-      <p:cxnSp>
-        <p:nvCxnSpPr>
-          <p:cNvPr id="23" name="TR-Arrow2"/>
-          <p:cNvCxnSpPr/>
-          <p:nvPr/>
-        </p:nvCxnSpPr>
-        <p:spPr>
-          <a:xfrm>
-            <a:off x="5138928" y="3246120"/>
-            <a:ext cx="786384" cy="0"/>
-          </a:xfrm>
-          <a:prstGeom prst="line">
-            <a:avLst/>
-          </a:prstGeom>
-          <a:ln w="28575">
-            <a:solidFill>
-              <a:srgbClr val="8E6F3E"/>
-            </a:solidFill>
-            <a:tailEnd type="triangle" w="med" len="med"/>
-          </a:ln>
-          <a:effectLst/>
-        </p:spPr>
-        <p:style>
-          <a:lnRef idx="2">
-            <a:schemeClr val="accent1"/>
-          </a:lnRef>
-          <a:fillRef idx="0">
-            <a:schemeClr val="accent1"/>
-          </a:fillRef>
-          <a:effectRef idx="1">
-            <a:schemeClr val="accent1"/>
-          </a:effectRef>
-          <a:fontRef idx="minor">
-            <a:schemeClr val="tx1"/>
-          </a:fontRef>
-        </p:style>
-      </p:cxnSp>
-      <p:sp>
-        <p:nvSpPr>
-          <p:cNvPr id="24" name="TR-Q2"/>
-          <p:cNvSpPr txBox="1"/>
-          <p:nvPr/>
-        </p:nvSpPr>
-        <p:spPr>
-          <a:xfrm>
-            <a:off x="4617720" y="2697480"/>
-            <a:ext cx="1828800" cy="292608"/>
-          </a:xfrm>
-          <a:prstGeom prst="rect">
-            <a:avLst/>
-          </a:prstGeom>
-          <a:noFill/>
-        </p:spPr>
-        <p:txBody>
-          <a:bodyPr wrap="square" anchor="t">
-            <a:spAutoFit/>
-          </a:bodyPr>
-          <a:lstStyle/>
-          <a:p>
-            <a:pPr algn="ctr"/>
-            <a:r>
-              <a:rPr sz="1200" b="0" i="1">
-                <a:solidFill>
-                  <a:srgbClr val="555960"/>
-                </a:solidFill>
-              </a:rPr>
-              <a:t>does it satisfy?</a:t>
-            </a:r>
-          </a:p>
-        </p:txBody>
-      </p:sp>
-      <p:sp>
-        <p:nvSpPr>
-          <p:cNvPr id="25" name="TR-Label3"/>
-          <p:cNvSpPr txBox="1"/>
-          <p:nvPr/>
-        </p:nvSpPr>
-        <p:spPr>
-          <a:xfrm>
-            <a:off x="320040" y="4553712"/>
-            <a:ext cx="2697480" cy="457200"/>
-          </a:xfrm>
-          <a:prstGeom prst="rect">
-            <a:avLst/>
-          </a:prstGeom>
-          <a:noFill/>
-        </p:spPr>
-        <p:txBody>
-          <a:bodyPr wrap="square" anchor="t">
-            <a:spAutoFit/>
-          </a:bodyPr>
-          <a:lstStyle/>
-          <a:p>
-            <a:pPr algn="l"/>
-            <a:r>
-              <a:rPr sz="2200" b="1" i="0">
-                <a:solidFill>
-                  <a:srgbClr val="8E6F3E"/>
-                </a:solidFill>
-              </a:rPr>
-              <a:t>ACCEPTANCE</a:t>
-            </a:r>
-          </a:p>
-        </p:txBody>
-      </p:sp>
-      <p:sp>
-        <p:nvSpPr>
-          <p:cNvPr id="26" name="TR-Box3a"/>
-          <p:cNvSpPr/>
-          <p:nvPr/>
-        </p:nvSpPr>
-        <p:spPr>
-          <a:xfrm>
-            <a:off x="3108960" y="4480559"/>
-            <a:ext cx="1965960" cy="731520"/>
-          </a:xfrm>
-          <a:prstGeom prst="rect">
-            <a:avLst/>
-          </a:prstGeom>
-          <a:solidFill>
-            <a:srgbClr val="F5F1E8"/>
-          </a:solidFill>
-          <a:ln w="12700">
-            <a:solidFill>
-              <a:srgbClr val="C9B991"/>
-            </a:solidFill>
-          </a:ln>
-          <a:effectLst/>
-        </p:spPr>
-        <p:style>
-          <a:lnRef idx="1">
-            <a:schemeClr val="accent1"/>
-          </a:lnRef>
-          <a:fillRef idx="3">
-            <a:schemeClr val="accent1"/>
-          </a:fillRef>
-          <a:effectRef idx="2">
-            <a:schemeClr val="accent1"/>
-          </a:effectRef>
-          <a:fontRef idx="minor">
-            <a:schemeClr val="lt1"/>
-          </a:fontRef>
-        </p:style>
-        <p:txBody>
-          <a:bodyPr rtlCol="0" anchor="ctr" wrap="square" lIns="27432" rIns="27432" tIns="22860" bIns="22860"/>
-          <a:lstStyle/>
-          <a:p>
-            <a:pPr algn="ctr"/>
-            <a:r>
-              <a:rPr sz="1500" b="0" i="0">
-                <a:solidFill>
-                  <a:srgbClr val="5C4826"/>
-                </a:solidFill>
-              </a:rPr>
-              <a:t>artifact</a:t>
-            </a:r>
-          </a:p>
-        </p:txBody>
-      </p:sp>
-      <p:sp>
-        <p:nvSpPr>
-          <p:cNvPr id="27" name="TR-Box3b"/>
-          <p:cNvSpPr/>
-          <p:nvPr/>
-        </p:nvSpPr>
-        <p:spPr>
-          <a:xfrm>
-            <a:off x="5989320" y="4480559"/>
-            <a:ext cx="2834640" cy="731520"/>
-          </a:xfrm>
-          <a:prstGeom prst="rect">
-            <a:avLst/>
-          </a:prstGeom>
-          <a:solidFill>
-            <a:srgbClr val="F5F1E8"/>
-          </a:solidFill>
-          <a:ln w="12700">
-            <a:solidFill>
-              <a:srgbClr val="C9B991"/>
-            </a:solidFill>
-          </a:ln>
-          <a:effectLst/>
-        </p:spPr>
-        <p:style>
-          <a:lnRef idx="1">
-            <a:schemeClr val="accent1"/>
-          </a:lnRef>
-          <a:fillRef idx="3">
-            <a:schemeClr val="accent1"/>
-          </a:fillRef>
-          <a:effectRef idx="2">
-            <a:schemeClr val="accent1"/>
-          </a:effectRef>
-          <a:fontRef idx="minor">
-            <a:schemeClr val="lt1"/>
-          </a:fontRef>
-        </p:style>
-        <p:txBody>
-          <a:bodyPr rtlCol="0" anchor="ctr" wrap="square" lIns="27432" rIns="27432" tIns="22860" bIns="22860"/>
-          <a:lstStyle/>
-          <a:p>
-            <a:pPr algn="ctr"/>
-            <a:r>
-              <a:rPr sz="1500" b="0" i="0">
-                <a:solidFill>
-                  <a:srgbClr val="5C4826"/>
-                </a:solidFill>
-              </a:rPr>
               <a:t>receiving environment</a:t>
             </a:r>
           </a:p>
-        </p:txBody>
-      </p:sp>
-      <p:cxnSp>
-        <p:nvCxnSpPr>
-          <p:cNvPr id="28" name="TR-Arrow3"/>
-          <p:cNvCxnSpPr/>
-          <p:nvPr/>
-        </p:nvCxnSpPr>
-        <p:spPr>
-          <a:xfrm>
-            <a:off x="5138928" y="4846320"/>
-            <a:ext cx="786384" cy="0"/>
-          </a:xfrm>
-          <a:prstGeom prst="line">
-            <a:avLst/>
-          </a:prstGeom>
-          <a:ln w="28575">
-            <a:solidFill>
-              <a:srgbClr val="8E6F3E"/>
-            </a:solidFill>
-            <a:tailEnd type="triangle" w="med" len="med"/>
-          </a:ln>
-          <a:effectLst/>
-        </p:spPr>
-        <p:style>
-          <a:lnRef idx="2">
-            <a:schemeClr val="accent1"/>
-          </a:lnRef>
-          <a:fillRef idx="0">
-            <a:schemeClr val="accent1"/>
-          </a:fillRef>
-          <a:effectRef idx="1">
-            <a:schemeClr val="accent1"/>
-          </a:effectRef>
-          <a:fontRef idx="minor">
-            <a:schemeClr val="tx1"/>
-          </a:fontRef>
-        </p:style>
-      </p:cxnSp>
-      <p:sp>
-        <p:nvSpPr>
-          <p:cNvPr id="29" name="TR-Q3"/>
-          <p:cNvSpPr txBox="1"/>
-          <p:nvPr/>
-        </p:nvSpPr>
-        <p:spPr>
-          <a:xfrm>
-            <a:off x="4617720" y="4297679"/>
-            <a:ext cx="1828800" cy="292608"/>
-          </a:xfrm>
-          <a:prstGeom prst="rect">
-            <a:avLst/>
-          </a:prstGeom>
-          <a:noFill/>
-        </p:spPr>
-        <p:txBody>
-          <a:bodyPr wrap="square" anchor="t">
-            <a:spAutoFit/>
-          </a:bodyPr>
-          <a:lstStyle/>
-          <a:p>
-            <a:pPr algn="ctr"/>
-            <a:r>
-              <a:rPr sz="1200" b="0" i="1">
+          <a:p>
+            <a:pPr algn="ctr">
+              <a:buNone/>
+            </a:pPr>
+            <a:r>
+              <a:rPr lang="en-US" sz="2000" b="0" i="1" dirty="0">
                 <a:solidFill>
                   <a:srgbClr val="555960"/>
                 </a:solidFill>
@@ -23998,7 +23125,7 @@
           <a:p>
             <a:pPr algn="l"/>
             <a:r>
-              <a:rPr sz="1800" b="0" i="1">
+              <a:rPr sz="2000" b="0" i="1">
                 <a:solidFill>
                   <a:srgbClr val="555960"/>
                 </a:solidFill>
@@ -24009,7 +23136,7 @@
           <a:p>
             <a:pPr algn="l"/>
             <a:r>
-              <a:rPr sz="1800" b="0" i="1">
+              <a:rPr sz="2000" b="0" i="1">
                 <a:solidFill>
                   <a:srgbClr val="555960"/>
                 </a:solidFill>
@@ -24043,7 +23170,7 @@
           <a:p>
             <a:pPr algn="r"/>
             <a:r>
-              <a:rPr sz="1800" b="0" i="1">
+              <a:rPr sz="2000" b="0" i="1">
                 <a:solidFill>
                   <a:srgbClr val="555960"/>
                 </a:solidFill>
@@ -24054,7 +23181,7 @@
           <a:p>
             <a:pPr algn="r"/>
             <a:r>
-              <a:rPr sz="1800" b="0" i="1">
+              <a:rPr sz="2000" b="0" i="1">
                 <a:solidFill>
                   <a:srgbClr val="555960"/>
                 </a:solidFill>
@@ -24088,7 +23215,7 @@
           <a:p>
             <a:pPr algn="ctr"/>
             <a:r>
-              <a:rPr sz="1800" b="0" i="1">
+              <a:rPr sz="2000" b="0" i="1">
                 <a:solidFill>
                   <a:srgbClr val="555960"/>
                 </a:solidFill>
@@ -26463,6 +25590,1610 @@
                 </a:solidFill>
               </a:rPr>
               <a:t>Should failure control what happens next?</a:t>
+            </a:r>
+          </a:p>
+        </p:txBody>
+      </p:sp>
+    </p:spTree>
+  </p:cSld>
+  <p:clrMapOvr>
+    <a:masterClrMapping/>
+  </p:clrMapOvr>
+</p:sld>
+</file>
+
+<file path=ppt/slides/slide43.xml><?xml version="1.0" encoding="utf-8"?>
+<p:sld xmlns:a="http://schemas.openxmlformats.org/drawingml/2006/main" xmlns:p="http://schemas.openxmlformats.org/presentationml/2006/main" xmlns:r="http://schemas.openxmlformats.org/officeDocument/2006/relationships">
+  <p:cSld>
+    <p:spTree>
+      <p:nvGrpSpPr>
+        <p:cNvPr id="1" name=""/>
+        <p:cNvGrpSpPr/>
+        <p:nvPr/>
+      </p:nvGrpSpPr>
+      <p:grpSpPr/>
+      <p:sp>
+        <p:nvSpPr>
+          <p:cNvPr id="3" name="Title 2"/>
+          <p:cNvSpPr>
+            <a:spLocks noGrp="1"/>
+          </p:cNvSpPr>
+          <p:nvPr>
+            <p:ph type="title"/>
+          </p:nvPr>
+        </p:nvSpPr>
+        <p:spPr/>
+        <p:txBody>
+          <a:bodyPr wrap="square"/>
+          <a:lstStyle/>
+          <a:p>
+            <a:r>
+              <a:rPr sz="2400" b="0">
+                <a:solidFill>
+                  <a:srgbClr val="000000"/>
+                </a:solidFill>
+              </a:rPr>
+              <a:t>You already have two models</a:t>
+            </a:r>
+          </a:p>
+        </p:txBody>
+      </p:sp>
+      <p:sp>
+        <p:nvSpPr>
+          <p:cNvPr id="4" name="Slide Number Placeholder 5"/>
+          <p:cNvSpPr>
+            <a:spLocks noGrp="1"/>
+          </p:cNvSpPr>
+          <p:nvPr>
+            <p:ph type="sldNum" sz="quarter" idx="4"/>
+          </p:nvPr>
+        </p:nvSpPr>
+        <p:spPr/>
+        <p:txBody>
+          <a:bodyPr/>
+          <a:lstStyle/>
+          <a:p>
+            <a:fld id="{B7EB45DA-9A0D-DC49-8E02-F30A5DDC21C3}" type="slidenum">
+              <a:rPr lang="en-US" smtClean="0"/>
+              <a:t>1</a:t>
+            </a:fld>
+            <a:endParaRPr lang="en-US"/>
+          </a:p>
+        </p:txBody>
+      </p:sp>
+      <p:sp>
+        <p:nvSpPr>
+          <p:cNvPr id="0" name="LabKicker"/>
+          <p:cNvSpPr/>
+          <p:nvPr/>
+        </p:nvSpPr>
+        <p:spPr>
+          <a:xfrm>
+            <a:off x="5349240" y="205000"/>
+            <a:ext cx="3520440" cy="470000"/>
+          </a:xfrm>
+          <a:prstGeom prst="roundRect">
+            <a:avLst/>
+          </a:prstGeom>
+          <a:solidFill>
+            <a:srgbClr val="FBF8F2"/>
+          </a:solidFill>
+          <a:ln w="15875">
+            <a:solidFill>
+              <a:srgbClr val="8E6F3E"/>
+            </a:solidFill>
+          </a:ln>
+          <a:effectLst/>
+        </p:spPr>
+        <p:txBody>
+          <a:bodyPr rtlCol="0" anchor="ctr" wrap="square" lIns="27432" rIns="27432" tIns="22860" bIns="22860"/>
+          <a:lstStyle/>
+          <a:p>
+            <a:pPr algn="ctr">
+              <a:buNone/>
+            </a:pPr>
+            <a:r>
+              <a:rPr lang="en-US" sz="2000" b="1" i="0" dirty="0">
+                <a:solidFill>
+                  <a:srgbClr val="8E6F3E"/>
+                </a:solidFill>
+              </a:rPr>
+              <a:t>FROM THE MODELING LAB</a:t>
+            </a:r>
+          </a:p>
+        </p:txBody>
+      </p:sp>
+      <p:sp>
+        <p:nvSpPr>
+          <p:cNvPr id="0" name="Card-memory"/>
+          <p:cNvSpPr/>
+          <p:nvPr/>
+        </p:nvSpPr>
+        <p:spPr>
+          <a:xfrm>
+            <a:off x="502920" y="1051560"/>
+            <a:ext cx="3977639" cy="4038600"/>
+          </a:xfrm>
+          <a:prstGeom prst="rect">
+            <a:avLst/>
+          </a:prstGeom>
+          <a:solidFill>
+            <a:srgbClr val="F5F1E8"/>
+          </a:solidFill>
+          <a:ln w="12700">
+            <a:solidFill>
+              <a:srgbClr val="C9B991"/>
+            </a:solidFill>
+          </a:ln>
+          <a:effectLst/>
+        </p:spPr>
+        <p:txBody>
+          <a:bodyPr rtlCol="0" anchor="t" wrap="square" lIns="27432" rIns="27432" tIns="22860" bIns="22860"/>
+          <a:lstStyle/>
+          <a:p>
+            <a:pPr algn="ctr">
+              <a:buNone/>
+            </a:pPr>
+            <a:r>
+              <a:rPr lang="en-US" sz="2000" b="1" i="0" dirty="0">
+                <a:solidFill>
+                  <a:srgbClr val="5C4826"/>
+                </a:solidFill>
+              </a:rPr>
+              <a:t>DEVICE FIRMWARE</a:t>
+            </a:r>
+          </a:p>
+          <a:p>
+            <a:pPr algn="ctr">
+              <a:buNone/>
+              <a:spcBef>
+                <a:spcPts val="900"/>
+              </a:spcBef>
+            </a:pPr>
+            <a:r>
+              <a:rPr lang="en-US" sz="2000" b="0" i="1" dirty="0">
+                <a:solidFill>
+                  <a:srgbClr val="555960"/>
+                </a:solidFill>
+              </a:rPr>
+              <a:t>working memory view</a:t>
+            </a:r>
+          </a:p>
+          <a:p>
+            <a:pPr algn="l">
+              <a:buNone/>
+              <a:spcBef>
+                <a:spcPts val="900"/>
+              </a:spcBef>
+            </a:pPr>
+            <a:r>
+              <a:rPr lang="en-US" sz="2000" b="0" i="0" dirty="0">
+                <a:solidFill>
+                  <a:srgbClr val="5C4826"/>
+                </a:solidFill>
+              </a:rPr>
+              <a:t>Sense · Analyze · Transmit</a:t>
+            </a:r>
+          </a:p>
+          <a:p>
+            <a:pPr algn="l">
+              <a:buNone/>
+              <a:spcBef>
+                <a:spcPts val="900"/>
+              </a:spcBef>
+            </a:pPr>
+            <a:r>
+              <a:rPr lang="en-US" sz="2000" b="0" i="0" dirty="0">
+                <a:solidFill>
+                  <a:srgbClr val="5C4826"/>
+                </a:solidFill>
+              </a:rPr>
+              <a:t>max working memory 24 / 32 / 24 KB</a:t>
+            </a:r>
+          </a:p>
+          <a:p>
+            <a:pPr algn="l">
+              <a:buNone/>
+              <a:spcBef>
+                <a:spcPts val="900"/>
+              </a:spcBef>
+            </a:pPr>
+            <a:r>
+              <a:rPr lang="en-US" sz="2000" b="0" i="0" dirty="0">
+                <a:solidFill>
+                  <a:srgbClr val="5C4826"/>
+                </a:solidFill>
+              </a:rPr>
+              <a:t>device ceiling 48 KB</a:t>
+            </a:r>
+          </a:p>
+          <a:p>
+            <a:pPr algn="l">
+              <a:buNone/>
+              <a:spcBef>
+                <a:spcPts val="900"/>
+              </a:spcBef>
+            </a:pPr>
+            <a:r>
+              <a:rPr lang="en-US" sz="2000" b="0" i="1" dirty="0">
+                <a:solidFill>
+                  <a:srgbClr val="555960"/>
+                </a:solidFill>
+              </a:rPr>
+              <a:t>omits: who decides that a thread may run</a:t>
+            </a:r>
+          </a:p>
+        </p:txBody>
+      </p:sp>
+      <p:sp>
+        <p:nvSpPr>
+          <p:cNvPr id="0" name="Card-control"/>
+          <p:cNvSpPr/>
+          <p:nvPr/>
+        </p:nvSpPr>
+        <p:spPr>
+          <a:xfrm>
+            <a:off x="4663440" y="1051560"/>
+            <a:ext cx="3977639" cy="4038600"/>
+          </a:xfrm>
+          <a:prstGeom prst="rect">
+            <a:avLst/>
+          </a:prstGeom>
+          <a:solidFill>
+            <a:srgbClr val="F5F1E8"/>
+          </a:solidFill>
+          <a:ln w="12700">
+            <a:solidFill>
+              <a:srgbClr val="C9B991"/>
+            </a:solidFill>
+          </a:ln>
+          <a:effectLst/>
+        </p:spPr>
+        <p:txBody>
+          <a:bodyPr rtlCol="0" anchor="t" wrap="square" lIns="27432" rIns="27432" tIns="22860" bIns="22860"/>
+          <a:lstStyle/>
+          <a:p>
+            <a:pPr algn="ctr">
+              <a:buNone/>
+            </a:pPr>
+            <a:r>
+              <a:rPr lang="en-US" sz="2000" b="1" i="0" dirty="0">
+                <a:solidFill>
+                  <a:srgbClr val="5C4826"/>
+                </a:solidFill>
+              </a:rPr>
+              <a:t>THREAD ADMISSION CONTROL</a:t>
+            </a:r>
+          </a:p>
+          <a:p>
+            <a:pPr algn="ctr">
+              <a:buNone/>
+              <a:spcBef>
+                <a:spcPts val="900"/>
+              </a:spcBef>
+            </a:pPr>
+            <a:r>
+              <a:rPr lang="en-US" sz="2000" b="0" i="1" dirty="0">
+                <a:solidFill>
+                  <a:srgbClr val="555960"/>
+                </a:solidFill>
+              </a:rPr>
+              <a:t>lifecycle view</a:t>
+            </a:r>
+          </a:p>
+          <a:p>
+            <a:pPr algn="l">
+              <a:buNone/>
+              <a:spcBef>
+                <a:spcPts val="900"/>
+              </a:spcBef>
+            </a:pPr>
+            <a:r>
+              <a:rPr lang="en-US" sz="2000" b="0" i="0" dirty="0">
+                <a:solidFill>
+                  <a:srgbClr val="5C4826"/>
+                </a:solidFill>
+              </a:rPr>
+              <a:t>each thread: Asleep ⇄ Awake</a:t>
+            </a:r>
+          </a:p>
+          <a:p>
+            <a:pPr algn="l">
+              <a:buNone/>
+              <a:spcBef>
+                <a:spcPts val="900"/>
+              </a:spcBef>
+            </a:pPr>
+            <a:r>
+              <a:rPr lang="en-US" sz="2000" b="0" i="0" dirty="0">
+                <a:solidFill>
+                  <a:srgbClr val="5C4826"/>
+                </a:solidFill>
+              </a:rPr>
+              <a:t>asleep holds no working memory; awake holds up to its maximum</a:t>
+            </a:r>
+          </a:p>
+          <a:p>
+            <a:pPr algn="l">
+              <a:buNone/>
+              <a:spcBef>
+                <a:spcPts val="900"/>
+              </a:spcBef>
+            </a:pPr>
+            <a:r>
+              <a:rPr lang="en-US" sz="2000" b="0" i="0" dirty="0">
+                <a:solidFill>
+                  <a:srgbClr val="5C4826"/>
+                </a:solidFill>
+              </a:rPr>
+              <a:t>the Scheduler admits at most two threads awake</a:t>
+            </a:r>
+          </a:p>
+          <a:p>
+            <a:pPr algn="l">
+              <a:buNone/>
+              <a:spcBef>
+                <a:spcPts val="900"/>
+              </a:spcBef>
+            </a:pPr>
+            <a:r>
+              <a:rPr lang="en-US" sz="2000" b="0" i="1" dirty="0">
+                <a:solidFill>
+                  <a:srgbClr val="555960"/>
+                </a:solidFill>
+              </a:rPr>
+              <a:t>omits: what any thread costs in working memory</a:t>
+            </a:r>
+          </a:p>
+        </p:txBody>
+      </p:sp>
+      <p:sp>
+        <p:nvSpPr>
+          <p:cNvPr id="0" name="FooterBand"/>
+          <p:cNvSpPr/>
+          <p:nvPr/>
+        </p:nvSpPr>
+        <p:spPr>
+          <a:xfrm>
+            <a:off x="274320" y="5760720"/>
+            <a:ext cx="8595360" cy="777240"/>
+          </a:xfrm>
+          <a:prstGeom prst="rect">
+            <a:avLst/>
+          </a:prstGeom>
+          <a:solidFill>
+            <a:srgbClr val="8E6F3E"/>
+          </a:solidFill>
+          <a:ln>
+            <a:noFill/>
+          </a:ln>
+          <a:effectLst/>
+        </p:spPr>
+        <p:txBody>
+          <a:bodyPr rtlCol="0" anchor="ctr" wrap="square" lIns="27432" rIns="27432" tIns="22860" bIns="22860"/>
+          <a:lstStyle/>
+          <a:p>
+            <a:pPr algn="ctr">
+              <a:buNone/>
+            </a:pPr>
+            <a:r>
+              <a:rPr lang="en-US" sz="2000" b="1" i="0" dirty="0">
+                <a:solidFill>
+                  <a:srgbClr val="FFFFFF"/>
+                </a:solidFill>
+              </a:rPr>
+              <a:t>How might we use each model in validation?</a:t>
+            </a:r>
+          </a:p>
+        </p:txBody>
+      </p:sp>
+    </p:spTree>
+  </p:cSld>
+  <p:clrMapOvr>
+    <a:masterClrMapping/>
+  </p:clrMapOvr>
+</p:sld>
+</file>
+
+<file path=ppt/slides/slide44.xml><?xml version="1.0" encoding="utf-8"?>
+<p:sld xmlns:a="http://schemas.openxmlformats.org/drawingml/2006/main" xmlns:p="http://schemas.openxmlformats.org/presentationml/2006/main" xmlns:r="http://schemas.openxmlformats.org/officeDocument/2006/relationships">
+  <p:cSld>
+    <p:spTree>
+      <p:nvGrpSpPr>
+        <p:cNvPr id="1" name=""/>
+        <p:cNvGrpSpPr/>
+        <p:nvPr/>
+      </p:nvGrpSpPr>
+      <p:grpSpPr/>
+      <p:sp>
+        <p:nvSpPr>
+          <p:cNvPr id="3" name="Title 2"/>
+          <p:cNvSpPr>
+            <a:spLocks noGrp="1"/>
+          </p:cNvSpPr>
+          <p:nvPr>
+            <p:ph type="title"/>
+          </p:nvPr>
+        </p:nvSpPr>
+        <p:spPr/>
+        <p:txBody>
+          <a:bodyPr wrap="square"/>
+          <a:lstStyle/>
+          <a:p>
+            <a:r>
+              <a:rPr sz="2400" b="0">
+                <a:solidFill>
+                  <a:srgbClr val="000000"/>
+                </a:solidFill>
+              </a:rPr>
+              <a:t>A model can support static validation</a:t>
+            </a:r>
+          </a:p>
+        </p:txBody>
+      </p:sp>
+      <p:sp>
+        <p:nvSpPr>
+          <p:cNvPr id="4" name="Slide Number Placeholder 5"/>
+          <p:cNvSpPr>
+            <a:spLocks noGrp="1"/>
+          </p:cNvSpPr>
+          <p:nvPr>
+            <p:ph type="sldNum" sz="quarter" idx="4"/>
+          </p:nvPr>
+        </p:nvSpPr>
+        <p:spPr/>
+        <p:txBody>
+          <a:bodyPr/>
+          <a:lstStyle/>
+          <a:p>
+            <a:fld id="{B7EB45DA-9A0D-DC49-8E02-F30A5DDC21C3}" type="slidenum">
+              <a:rPr lang="en-US" smtClean="0"/>
+              <a:t>1</a:t>
+            </a:fld>
+            <a:endParaRPr lang="en-US"/>
+          </a:p>
+        </p:txBody>
+      </p:sp>
+      <p:sp>
+        <p:nvSpPr>
+          <p:cNvPr id="0" name="St-MODEL"/>
+          <p:cNvSpPr/>
+          <p:nvPr/>
+        </p:nvSpPr>
+        <p:spPr>
+          <a:xfrm>
+            <a:off x="502920" y="1005840"/>
+            <a:ext cx="1828800" cy="640080"/>
+          </a:xfrm>
+          <a:prstGeom prst="rect">
+            <a:avLst/>
+          </a:prstGeom>
+          <a:solidFill>
+            <a:srgbClr val="8E6F3E"/>
+          </a:solidFill>
+          <a:ln>
+            <a:noFill/>
+          </a:ln>
+          <a:effectLst/>
+        </p:spPr>
+        <p:txBody>
+          <a:bodyPr rtlCol="0" anchor="ctr" wrap="square" lIns="27432" rIns="27432" tIns="22860" bIns="22860"/>
+          <a:lstStyle/>
+          <a:p>
+            <a:pPr algn="ctr">
+              <a:buNone/>
+            </a:pPr>
+            <a:r>
+              <a:rPr lang="en-US" sz="2000" b="1" i="0" dirty="0">
+                <a:solidFill>
+                  <a:srgbClr val="FFFFFF"/>
+                </a:solidFill>
+              </a:rPr>
+              <a:t>MODEL</a:t>
+            </a:r>
+          </a:p>
+        </p:txBody>
+      </p:sp>
+      <p:sp>
+        <p:nvSpPr>
+          <p:cNvPr id="0" name="St-ANALYSIS"/>
+          <p:cNvSpPr/>
+          <p:nvPr/>
+        </p:nvSpPr>
+        <p:spPr>
+          <a:xfrm>
+            <a:off x="3291840" y="1005840"/>
+            <a:ext cx="2560320" cy="640080"/>
+          </a:xfrm>
+          <a:prstGeom prst="rect">
+            <a:avLst/>
+          </a:prstGeom>
+          <a:solidFill>
+            <a:srgbClr val="F5F1E8"/>
+          </a:solidFill>
+          <a:ln w="12700">
+            <a:solidFill>
+              <a:srgbClr val="C9B991"/>
+            </a:solidFill>
+          </a:ln>
+          <a:effectLst/>
+        </p:spPr>
+        <p:txBody>
+          <a:bodyPr rtlCol="0" anchor="ctr" wrap="square" lIns="27432" rIns="27432" tIns="22860" bIns="22860"/>
+          <a:lstStyle/>
+          <a:p>
+            <a:pPr algn="ctr">
+              <a:buNone/>
+            </a:pPr>
+            <a:r>
+              <a:rPr lang="en-US" sz="2000" b="1" i="0" dirty="0">
+                <a:solidFill>
+                  <a:srgbClr val="5C4826"/>
+                </a:solidFill>
+              </a:rPr>
+              <a:t>STATIC ANALYSIS</a:t>
+            </a:r>
+          </a:p>
+        </p:txBody>
+      </p:sp>
+      <p:sp>
+        <p:nvSpPr>
+          <p:cNvPr id="0" name="St-VERDICT"/>
+          <p:cNvSpPr/>
+          <p:nvPr/>
+        </p:nvSpPr>
+        <p:spPr>
+          <a:xfrm>
+            <a:off x="6812280" y="1005840"/>
+            <a:ext cx="1828800" cy="640080"/>
+          </a:xfrm>
+          <a:prstGeom prst="rect">
+            <a:avLst/>
+          </a:prstGeom>
+          <a:solidFill>
+            <a:srgbClr val="8E6F3E"/>
+          </a:solidFill>
+          <a:ln>
+            <a:noFill/>
+          </a:ln>
+          <a:effectLst/>
+        </p:spPr>
+        <p:txBody>
+          <a:bodyPr rtlCol="0" anchor="ctr" wrap="square" lIns="27432" rIns="27432" tIns="22860" bIns="22860"/>
+          <a:lstStyle/>
+          <a:p>
+            <a:pPr algn="ctr">
+              <a:buNone/>
+            </a:pPr>
+            <a:r>
+              <a:rPr lang="en-US" sz="2000" b="1" i="0" dirty="0">
+                <a:solidFill>
+                  <a:srgbClr val="FFFFFF"/>
+                </a:solidFill>
+              </a:rPr>
+              <a:t>VERDICT</a:t>
+            </a:r>
+          </a:p>
+        </p:txBody>
+      </p:sp>
+      <p:cxnSp>
+        <p:nvCxnSpPr>
+          <p:cNvPr id="0" name="St-A1"/>
+          <p:cNvCxnSpPr/>
+          <p:nvPr/>
+        </p:nvCxnSpPr>
+        <p:spPr>
+          <a:xfrm>
+            <a:off x="2331720" y="1325880"/>
+            <a:ext cx="960120" cy="0"/>
+          </a:xfrm>
+          <a:prstGeom prst="straightConnector1">
+            <a:avLst/>
+          </a:prstGeom>
+          <a:ln w="19050">
+            <a:solidFill>
+              <a:srgbClr val="8E6F3E"/>
+            </a:solidFill>
+            <a:tailEnd type="triangle"/>
+          </a:ln>
+        </p:spPr>
+      </p:cxnSp>
+      <p:cxnSp>
+        <p:nvCxnSpPr>
+          <p:cNvPr id="0" name="St-A2"/>
+          <p:cNvCxnSpPr/>
+          <p:nvPr/>
+        </p:nvCxnSpPr>
+        <p:spPr>
+          <a:xfrm>
+            <a:off x="5852160" y="1325880"/>
+            <a:ext cx="960120" cy="0"/>
+          </a:xfrm>
+          <a:prstGeom prst="straightConnector1">
+            <a:avLst/>
+          </a:prstGeom>
+          <a:ln w="19050">
+            <a:solidFill>
+              <a:srgbClr val="8E6F3E"/>
+            </a:solidFill>
+            <a:tailEnd type="triangle"/>
+          </a:ln>
+        </p:spPr>
+      </p:cxnSp>
+      <p:sp>
+        <p:nvSpPr>
+          <p:cNvPr id="0" name="St-Questions"/>
+          <p:cNvSpPr/>
+          <p:nvPr/>
+        </p:nvSpPr>
+        <p:spPr>
+          <a:xfrm>
+            <a:off x="502920" y="2103120"/>
+            <a:ext cx="8138160" cy="3291840"/>
+          </a:xfrm>
+          <a:prstGeom prst="rect">
+            <a:avLst/>
+          </a:prstGeom>
+          <a:solidFill>
+            <a:srgbClr val="F5F1E8"/>
+          </a:solidFill>
+          <a:ln w="12700">
+            <a:solidFill>
+              <a:srgbClr val="C9B991"/>
+            </a:solidFill>
+          </a:ln>
+          <a:effectLst/>
+        </p:spPr>
+        <p:txBody>
+          <a:bodyPr rtlCol="0" anchor="t" wrap="square" lIns="27432" rIns="27432" tIns="22860" bIns="22860"/>
+          <a:lstStyle/>
+          <a:p>
+            <a:pPr algn="l">
+              <a:buNone/>
+            </a:pPr>
+            <a:r>
+              <a:rPr lang="en-US" sz="2000" b="1" i="0" dirty="0">
+                <a:solidFill>
+                  <a:srgbClr val="5C4826"/>
+                </a:solidFill>
+              </a:rPr>
+              <a:t>Questions the lab model can already decide:</a:t>
+            </a:r>
+          </a:p>
+          <a:p>
+            <a:pPr algn="l">
+              <a:buNone/>
+              <a:spcBef>
+                <a:spcPts val="900"/>
+              </a:spcBef>
+            </a:pPr>
+            <a:r>
+              <a:rPr lang="en-US" sz="2000" b="0" i="0" dirty="0">
+                <a:solidFill>
+                  <a:srgbClr val="5C4826"/>
+                </a:solidFill>
+              </a:rPr>
+              <a:t>Is a forbidden dependency reachable?</a:t>
+            </a:r>
+          </a:p>
+          <a:p>
+            <a:pPr algn="l">
+              <a:buNone/>
+              <a:spcBef>
+                <a:spcPts val="900"/>
+              </a:spcBef>
+            </a:pPr>
+            <a:r>
+              <a:rPr lang="en-US" sz="2000" b="0" i="0" dirty="0">
+                <a:solidFill>
+                  <a:srgbClr val="5C4826"/>
+                </a:solidFill>
+              </a:rPr>
+              <a:t>Does every permitted route cross the required boundary?</a:t>
+            </a:r>
+          </a:p>
+          <a:p>
+            <a:pPr algn="l">
+              <a:buNone/>
+              <a:spcBef>
+                <a:spcPts val="900"/>
+              </a:spcBef>
+            </a:pPr>
+            <a:r>
+              <a:rPr lang="en-US" sz="2000" b="0" i="0" dirty="0">
+                <a:solidFill>
+                  <a:srgbClr val="5C4826"/>
+                </a:solidFill>
+              </a:rPr>
+              <a:t>Can the memory bound be exceeded?</a:t>
+            </a:r>
+          </a:p>
+          <a:p>
+            <a:pPr algn="l">
+              <a:buNone/>
+              <a:spcBef>
+                <a:spcPts val="900"/>
+              </a:spcBef>
+            </a:pPr>
+            <a:r>
+              <a:rPr lang="en-US" sz="2000" b="0" i="0" dirty="0">
+                <a:solidFill>
+                  <a:srgbClr val="5C4826"/>
+                </a:solidFill>
+              </a:rPr>
+              <a:t>Is an illegal transition present?</a:t>
+            </a:r>
+          </a:p>
+        </p:txBody>
+      </p:sp>
+      <p:sp>
+        <p:nvSpPr>
+          <p:cNvPr id="0" name="FooterBand"/>
+          <p:cNvSpPr/>
+          <p:nvPr/>
+        </p:nvSpPr>
+        <p:spPr>
+          <a:xfrm>
+            <a:off x="274320" y="5760720"/>
+            <a:ext cx="8595360" cy="777240"/>
+          </a:xfrm>
+          <a:prstGeom prst="rect">
+            <a:avLst/>
+          </a:prstGeom>
+          <a:solidFill>
+            <a:srgbClr val="8E6F3E"/>
+          </a:solidFill>
+          <a:ln>
+            <a:noFill/>
+          </a:ln>
+          <a:effectLst/>
+        </p:spPr>
+        <p:txBody>
+          <a:bodyPr rtlCol="0" anchor="ctr" wrap="square" lIns="27432" rIns="27432" tIns="22860" bIns="22860"/>
+          <a:lstStyle/>
+          <a:p>
+            <a:pPr algn="ctr">
+              <a:buNone/>
+            </a:pPr>
+            <a:r>
+              <a:rPr lang="en-US" sz="2000" b="1" i="0" dirty="0">
+                <a:solidFill>
+                  <a:srgbClr val="FFFFFF"/>
+                </a:solidFill>
+              </a:rPr>
+              <a:t>Explicit structure can turn repeated reconstruction into a decidable query.</a:t>
+            </a:r>
+          </a:p>
+        </p:txBody>
+      </p:sp>
+    </p:spTree>
+  </p:cSld>
+  <p:clrMapOvr>
+    <a:masterClrMapping/>
+  </p:clrMapOvr>
+</p:sld>
+</file>
+
+<file path=ppt/slides/slide45.xml><?xml version="1.0" encoding="utf-8"?>
+<p:sld xmlns:a="http://schemas.openxmlformats.org/drawingml/2006/main" xmlns:p="http://schemas.openxmlformats.org/presentationml/2006/main" xmlns:r="http://schemas.openxmlformats.org/officeDocument/2006/relationships">
+  <p:cSld>
+    <p:spTree>
+      <p:nvGrpSpPr>
+        <p:cNvPr id="1" name=""/>
+        <p:cNvGrpSpPr/>
+        <p:nvPr/>
+      </p:nvGrpSpPr>
+      <p:grpSpPr/>
+      <p:sp>
+        <p:nvSpPr>
+          <p:cNvPr id="3" name="Title 2"/>
+          <p:cNvSpPr>
+            <a:spLocks noGrp="1"/>
+          </p:cNvSpPr>
+          <p:nvPr>
+            <p:ph type="title"/>
+          </p:nvPr>
+        </p:nvSpPr>
+        <p:spPr/>
+        <p:txBody>
+          <a:bodyPr wrap="square"/>
+          <a:lstStyle/>
+          <a:p>
+            <a:r>
+              <a:rPr sz="2400" b="0">
+                <a:solidFill>
+                  <a:srgbClr val="000000"/>
+                </a:solidFill>
+              </a:rPr>
+              <a:t>A model can also define what to observe at runtime</a:t>
+            </a:r>
+          </a:p>
+        </p:txBody>
+      </p:sp>
+      <p:sp>
+        <p:nvSpPr>
+          <p:cNvPr id="4" name="Slide Number Placeholder 5"/>
+          <p:cNvSpPr>
+            <a:spLocks noGrp="1"/>
+          </p:cNvSpPr>
+          <p:nvPr>
+            <p:ph type="sldNum" sz="quarter" idx="4"/>
+          </p:nvPr>
+        </p:nvSpPr>
+        <p:spPr/>
+        <p:txBody>
+          <a:bodyPr/>
+          <a:lstStyle/>
+          <a:p>
+            <a:fld id="{B7EB45DA-9A0D-DC49-8E02-F30A5DDC21C3}" type="slidenum">
+              <a:rPr lang="en-US" smtClean="0"/>
+              <a:t>1</a:t>
+            </a:fld>
+            <a:endParaRPr lang="en-US"/>
+          </a:p>
+        </p:txBody>
+      </p:sp>
+      <p:sp>
+        <p:nvSpPr>
+          <p:cNvPr id="0" name="Dy-MODEL"/>
+          <p:cNvSpPr/>
+          <p:nvPr/>
+        </p:nvSpPr>
+        <p:spPr>
+          <a:xfrm>
+            <a:off x="5245840" y="1097280"/>
+            <a:ext cx="2200000" cy="640080"/>
+          </a:xfrm>
+          <a:prstGeom prst="rect">
+            <a:avLst/>
+          </a:prstGeom>
+          <a:solidFill>
+            <a:srgbClr val="8E6F3E"/>
+          </a:solidFill>
+          <a:ln>
+            <a:noFill/>
+          </a:ln>
+          <a:effectLst/>
+        </p:spPr>
+        <p:txBody>
+          <a:bodyPr rtlCol="0" anchor="ctr" wrap="square" lIns="27432" rIns="27432" tIns="22860" bIns="22860"/>
+          <a:lstStyle/>
+          <a:p>
+            <a:pPr algn="ctr">
+              <a:buNone/>
+            </a:pPr>
+            <a:r>
+              <a:rPr lang="en-US" sz="2000" b="1" i="0" dirty="0">
+                <a:solidFill>
+                  <a:srgbClr val="FFFFFF"/>
+                </a:solidFill>
+              </a:rPr>
+              <a:t>MODEL — expected behavior</a:t>
+            </a:r>
+          </a:p>
+        </p:txBody>
+      </p:sp>
+      <p:cxnSp>
+        <p:nvCxnSpPr>
+          <p:cNvPr id="0" name="Dy-AM"/>
+          <p:cNvCxnSpPr/>
+          <p:nvPr/>
+        </p:nvCxnSpPr>
+        <p:spPr>
+          <a:xfrm>
+            <a:off x="6345840" y="1737360"/>
+            <a:ext cx="0" cy="777240"/>
+          </a:xfrm>
+          <a:prstGeom prst="straightConnector1">
+            <a:avLst/>
+          </a:prstGeom>
+          <a:ln w="19050">
+            <a:solidFill>
+              <a:srgbClr val="8E6F3E"/>
+            </a:solidFill>
+            <a:tailEnd type="triangle"/>
+          </a:ln>
+        </p:spPr>
+      </p:cxnSp>
+      <p:sp>
+        <p:nvSpPr>
+          <p:cNvPr id="0" name="Dy-EXECUTION"/>
+          <p:cNvSpPr/>
+          <p:nvPr/>
+        </p:nvSpPr>
+        <p:spPr>
+          <a:xfrm>
+            <a:off x="274320" y="2514600"/>
+            <a:ext cx="1500000" cy="640080"/>
+          </a:xfrm>
+          <a:prstGeom prst="rect">
+            <a:avLst/>
+          </a:prstGeom>
+          <a:solidFill>
+            <a:srgbClr val="F5F1E8"/>
+          </a:solidFill>
+          <a:ln w="12700">
+            <a:solidFill>
+              <a:srgbClr val="C9B991"/>
+            </a:solidFill>
+          </a:ln>
+          <a:effectLst/>
+        </p:spPr>
+        <p:txBody>
+          <a:bodyPr rtlCol="0" anchor="ctr" wrap="square" lIns="27432" rIns="27432" tIns="22860" bIns="22860"/>
+          <a:lstStyle/>
+          <a:p>
+            <a:pPr algn="ctr">
+              <a:buNone/>
+            </a:pPr>
+            <a:r>
+              <a:rPr lang="en-US" sz="2000" b="1" i="0" dirty="0">
+                <a:solidFill>
+                  <a:srgbClr val="5C4826"/>
+                </a:solidFill>
+              </a:rPr>
+              <a:t>EXECUTION</a:t>
+            </a:r>
+          </a:p>
+        </p:txBody>
+      </p:sp>
+      <p:sp>
+        <p:nvSpPr>
+          <p:cNvPr id="0" name="Dy-SENSOR"/>
+          <p:cNvSpPr/>
+          <p:nvPr/>
+        </p:nvSpPr>
+        <p:spPr>
+          <a:xfrm>
+            <a:off x="2048160" y="2514600"/>
+            <a:ext cx="1500000" cy="640080"/>
+          </a:xfrm>
+          <a:prstGeom prst="rect">
+            <a:avLst/>
+          </a:prstGeom>
+          <a:solidFill>
+            <a:srgbClr val="8E6F3E"/>
+          </a:solidFill>
+          <a:ln>
+            <a:noFill/>
+          </a:ln>
+          <a:effectLst/>
+        </p:spPr>
+        <p:txBody>
+          <a:bodyPr rtlCol="0" anchor="ctr" wrap="square" lIns="27432" rIns="27432" tIns="22860" bIns="22860"/>
+          <a:lstStyle/>
+          <a:p>
+            <a:pPr algn="ctr">
+              <a:buNone/>
+            </a:pPr>
+            <a:r>
+              <a:rPr lang="en-US" sz="2000" b="1" i="0" dirty="0">
+                <a:solidFill>
+                  <a:srgbClr val="FFFFFF"/>
+                </a:solidFill>
+              </a:rPr>
+              <a:t>SENSOR</a:t>
+            </a:r>
+          </a:p>
+        </p:txBody>
+      </p:sp>
+      <p:sp>
+        <p:nvSpPr>
+          <p:cNvPr id="0" name="Dy-TRACE"/>
+          <p:cNvSpPr/>
+          <p:nvPr/>
+        </p:nvSpPr>
+        <p:spPr>
+          <a:xfrm>
+            <a:off x="3822000" y="2514600"/>
+            <a:ext cx="1500000" cy="640080"/>
+          </a:xfrm>
+          <a:prstGeom prst="rect">
+            <a:avLst/>
+          </a:prstGeom>
+          <a:solidFill>
+            <a:srgbClr val="F5F1E8"/>
+          </a:solidFill>
+          <a:ln w="12700">
+            <a:solidFill>
+              <a:srgbClr val="C9B991"/>
+            </a:solidFill>
+          </a:ln>
+          <a:effectLst/>
+        </p:spPr>
+        <p:txBody>
+          <a:bodyPr rtlCol="0" anchor="ctr" wrap="square" lIns="27432" rIns="27432" tIns="22860" bIns="22860"/>
+          <a:lstStyle/>
+          <a:p>
+            <a:pPr algn="ctr">
+              <a:buNone/>
+            </a:pPr>
+            <a:r>
+              <a:rPr lang="en-US" sz="2000" b="1" i="0" dirty="0">
+                <a:solidFill>
+                  <a:srgbClr val="5C4826"/>
+                </a:solidFill>
+              </a:rPr>
+              <a:t>TRACE</a:t>
+            </a:r>
+          </a:p>
+        </p:txBody>
+      </p:sp>
+      <p:sp>
+        <p:nvSpPr>
+          <p:cNvPr id="0" name="Dy-VALIDATOR"/>
+          <p:cNvSpPr/>
+          <p:nvPr/>
+        </p:nvSpPr>
+        <p:spPr>
+          <a:xfrm>
+            <a:off x="5595840" y="2514600"/>
+            <a:ext cx="1500000" cy="640080"/>
+          </a:xfrm>
+          <a:prstGeom prst="rect">
+            <a:avLst/>
+          </a:prstGeom>
+          <a:solidFill>
+            <a:srgbClr val="8E6F3E"/>
+          </a:solidFill>
+          <a:ln>
+            <a:noFill/>
+          </a:ln>
+          <a:effectLst/>
+        </p:spPr>
+        <p:txBody>
+          <a:bodyPr rtlCol="0" anchor="ctr" wrap="square" lIns="27432" rIns="27432" tIns="22860" bIns="22860"/>
+          <a:lstStyle/>
+          <a:p>
+            <a:pPr algn="ctr">
+              <a:buNone/>
+            </a:pPr>
+            <a:r>
+              <a:rPr lang="en-US" sz="2000" b="1" i="0" dirty="0">
+                <a:solidFill>
+                  <a:srgbClr val="FFFFFF"/>
+                </a:solidFill>
+              </a:rPr>
+              <a:t>VALIDATOR</a:t>
+            </a:r>
+          </a:p>
+        </p:txBody>
+      </p:sp>
+      <p:sp>
+        <p:nvSpPr>
+          <p:cNvPr id="0" name="Dy-VERDICT"/>
+          <p:cNvSpPr/>
+          <p:nvPr/>
+        </p:nvSpPr>
+        <p:spPr>
+          <a:xfrm>
+            <a:off x="7369680" y="2514600"/>
+            <a:ext cx="1500000" cy="640080"/>
+          </a:xfrm>
+          <a:prstGeom prst="rect">
+            <a:avLst/>
+          </a:prstGeom>
+          <a:solidFill>
+            <a:srgbClr val="F5F1E8"/>
+          </a:solidFill>
+          <a:ln w="12700">
+            <a:solidFill>
+              <a:srgbClr val="C9B991"/>
+            </a:solidFill>
+          </a:ln>
+          <a:effectLst/>
+        </p:spPr>
+        <p:txBody>
+          <a:bodyPr rtlCol="0" anchor="ctr" wrap="square" lIns="27432" rIns="27432" tIns="22860" bIns="22860"/>
+          <a:lstStyle/>
+          <a:p>
+            <a:pPr algn="ctr">
+              <a:buNone/>
+            </a:pPr>
+            <a:r>
+              <a:rPr lang="en-US" sz="2000" b="1" i="0" dirty="0">
+                <a:solidFill>
+                  <a:srgbClr val="5C4826"/>
+                </a:solidFill>
+              </a:rPr>
+              <a:t>VERDICT</a:t>
+            </a:r>
+          </a:p>
+        </p:txBody>
+      </p:sp>
+      <p:cxnSp>
+        <p:nvCxnSpPr>
+          <p:cNvPr id="0" name="Dy-A0"/>
+          <p:cNvCxnSpPr/>
+          <p:nvPr/>
+        </p:nvCxnSpPr>
+        <p:spPr>
+          <a:xfrm>
+            <a:off x="1774320" y="2834640"/>
+            <a:ext cx="273840" cy="0"/>
+          </a:xfrm>
+          <a:prstGeom prst="straightConnector1">
+            <a:avLst/>
+          </a:prstGeom>
+          <a:ln w="19050">
+            <a:solidFill>
+              <a:srgbClr val="8E6F3E"/>
+            </a:solidFill>
+            <a:tailEnd type="triangle"/>
+          </a:ln>
+        </p:spPr>
+      </p:cxnSp>
+      <p:cxnSp>
+        <p:nvCxnSpPr>
+          <p:cNvPr id="0" name="Dy-A1"/>
+          <p:cNvCxnSpPr/>
+          <p:nvPr/>
+        </p:nvCxnSpPr>
+        <p:spPr>
+          <a:xfrm>
+            <a:off x="3548160" y="2834640"/>
+            <a:ext cx="273840" cy="0"/>
+          </a:xfrm>
+          <a:prstGeom prst="straightConnector1">
+            <a:avLst/>
+          </a:prstGeom>
+          <a:ln w="19050">
+            <a:solidFill>
+              <a:srgbClr val="8E6F3E"/>
+            </a:solidFill>
+            <a:tailEnd type="triangle"/>
+          </a:ln>
+        </p:spPr>
+      </p:cxnSp>
+      <p:cxnSp>
+        <p:nvCxnSpPr>
+          <p:cNvPr id="0" name="Dy-A2"/>
+          <p:cNvCxnSpPr/>
+          <p:nvPr/>
+        </p:nvCxnSpPr>
+        <p:spPr>
+          <a:xfrm>
+            <a:off x="5322000" y="2834640"/>
+            <a:ext cx="273840" cy="0"/>
+          </a:xfrm>
+          <a:prstGeom prst="straightConnector1">
+            <a:avLst/>
+          </a:prstGeom>
+          <a:ln w="19050">
+            <a:solidFill>
+              <a:srgbClr val="8E6F3E"/>
+            </a:solidFill>
+            <a:tailEnd type="triangle"/>
+          </a:ln>
+        </p:spPr>
+      </p:cxnSp>
+      <p:cxnSp>
+        <p:nvCxnSpPr>
+          <p:cNvPr id="0" name="Dy-A3"/>
+          <p:cNvCxnSpPr/>
+          <p:nvPr/>
+        </p:nvCxnSpPr>
+        <p:spPr>
+          <a:xfrm>
+            <a:off x="7095840" y="2834640"/>
+            <a:ext cx="273840" cy="0"/>
+          </a:xfrm>
+          <a:prstGeom prst="straightConnector1">
+            <a:avLst/>
+          </a:prstGeom>
+          <a:ln w="19050">
+            <a:solidFill>
+              <a:srgbClr val="8E6F3E"/>
+            </a:solidFill>
+            <a:tailEnd type="triangle"/>
+          </a:ln>
+        </p:spPr>
+      </p:cxnSp>
+      <p:sp>
+        <p:nvSpPr>
+          <p:cNvPr id="0" name="Dy-Questions"/>
+          <p:cNvSpPr/>
+          <p:nvPr/>
+        </p:nvSpPr>
+        <p:spPr>
+          <a:xfrm>
+            <a:off x="502920" y="3566160"/>
+            <a:ext cx="8138160" cy="2057400"/>
+          </a:xfrm>
+          <a:prstGeom prst="rect">
+            <a:avLst/>
+          </a:prstGeom>
+          <a:solidFill>
+            <a:srgbClr val="F5F1E8"/>
+          </a:solidFill>
+          <a:ln w="12700">
+            <a:solidFill>
+              <a:srgbClr val="C9B991"/>
+            </a:solidFill>
+          </a:ln>
+          <a:effectLst/>
+        </p:spPr>
+        <p:txBody>
+          <a:bodyPr rtlCol="0" anchor="t" wrap="square" lIns="27432" rIns="27432" tIns="22860" bIns="22860"/>
+          <a:lstStyle/>
+          <a:p>
+            <a:pPr algn="l">
+              <a:buNone/>
+            </a:pPr>
+            <a:r>
+              <a:rPr lang="en-US" sz="2000" b="0" i="0" dirty="0">
+                <a:solidFill>
+                  <a:srgbClr val="5C4826"/>
+                </a:solidFill>
+              </a:rPr>
+              <a:t>Did the observed transition exist in the model?</a:t>
+            </a:r>
+          </a:p>
+          <a:p>
+            <a:pPr algn="l">
+              <a:buNone/>
+              <a:spcBef>
+                <a:spcPts val="900"/>
+              </a:spcBef>
+            </a:pPr>
+            <a:r>
+              <a:rPr lang="en-US" sz="2000" b="0" i="0" dirty="0">
+                <a:solidFill>
+                  <a:srgbClr val="5C4826"/>
+                </a:solidFill>
+              </a:rPr>
+              <a:t>Did events occur in the required order?</a:t>
+            </a:r>
+          </a:p>
+          <a:p>
+            <a:pPr algn="l">
+              <a:buNone/>
+              <a:spcBef>
+                <a:spcPts val="900"/>
+              </a:spcBef>
+            </a:pPr>
+            <a:r>
+              <a:rPr lang="en-US" sz="2000" b="0" i="0" dirty="0">
+                <a:solidFill>
+                  <a:srgbClr val="5C4826"/>
+                </a:solidFill>
+              </a:rPr>
+              <a:t>Did execution enter a forbidden state?</a:t>
+            </a:r>
+          </a:p>
+          <a:p>
+            <a:pPr algn="l">
+              <a:buNone/>
+              <a:spcBef>
+                <a:spcPts val="900"/>
+              </a:spcBef>
+            </a:pPr>
+            <a:r>
+              <a:rPr lang="en-US" sz="2000" b="0" i="0" dirty="0">
+                <a:solidFill>
+                  <a:srgbClr val="5C4826"/>
+                </a:solidFill>
+              </a:rPr>
+              <a:t>Did a measured quantity stay within its modeled bound?</a:t>
+            </a:r>
+          </a:p>
+        </p:txBody>
+      </p:sp>
+    </p:spTree>
+  </p:cSld>
+  <p:clrMapOvr>
+    <a:masterClrMapping/>
+  </p:clrMapOvr>
+</p:sld>
+</file>
+
+<file path=ppt/slides/slide46.xml><?xml version="1.0" encoding="utf-8"?>
+<p:sld xmlns:a="http://schemas.openxmlformats.org/drawingml/2006/main" xmlns:p="http://schemas.openxmlformats.org/presentationml/2006/main" xmlns:r="http://schemas.openxmlformats.org/officeDocument/2006/relationships">
+  <p:cSld>
+    <p:spTree>
+      <p:nvGrpSpPr>
+        <p:cNvPr id="1" name=""/>
+        <p:cNvGrpSpPr/>
+        <p:nvPr/>
+      </p:nvGrpSpPr>
+      <p:grpSpPr/>
+      <p:sp>
+        <p:nvSpPr>
+          <p:cNvPr id="3" name="Title 2"/>
+          <p:cNvSpPr>
+            <a:spLocks noGrp="1"/>
+          </p:cNvSpPr>
+          <p:nvPr>
+            <p:ph type="title"/>
+          </p:nvPr>
+        </p:nvSpPr>
+        <p:spPr/>
+        <p:txBody>
+          <a:bodyPr wrap="square"/>
+          <a:lstStyle/>
+          <a:p>
+            <a:r>
+              <a:rPr sz="2400" b="0">
+                <a:solidFill>
+                  <a:srgbClr val="000000"/>
+                </a:solidFill>
+              </a:rPr>
+              <a:t>The same model can support different validation strategies</a:t>
+            </a:r>
+          </a:p>
+        </p:txBody>
+      </p:sp>
+      <p:sp>
+        <p:nvSpPr>
+          <p:cNvPr id="4" name="Slide Number Placeholder 5"/>
+          <p:cNvSpPr>
+            <a:spLocks noGrp="1"/>
+          </p:cNvSpPr>
+          <p:nvPr>
+            <p:ph type="sldNum" sz="quarter" idx="4"/>
+          </p:nvPr>
+        </p:nvSpPr>
+        <p:spPr/>
+        <p:txBody>
+          <a:bodyPr/>
+          <a:lstStyle/>
+          <a:p>
+            <a:fld id="{B7EB45DA-9A0D-DC49-8E02-F30A5DDC21C3}" type="slidenum">
+              <a:rPr lang="en-US" smtClean="0"/>
+              <a:t>1</a:t>
+            </a:fld>
+            <a:endParaRPr lang="en-US"/>
+          </a:p>
+        </p:txBody>
+      </p:sp>
+      <p:sp>
+        <p:nvSpPr>
+          <p:cNvPr id="0" name="Cmp-static"/>
+          <p:cNvSpPr/>
+          <p:nvPr/>
+        </p:nvSpPr>
+        <p:spPr>
+          <a:xfrm>
+            <a:off x="502920" y="1051560"/>
+            <a:ext cx="3977639" cy="4038600"/>
+          </a:xfrm>
+          <a:prstGeom prst="rect">
+            <a:avLst/>
+          </a:prstGeom>
+          <a:solidFill>
+            <a:srgbClr val="F5F1E8"/>
+          </a:solidFill>
+          <a:ln w="12700">
+            <a:solidFill>
+              <a:srgbClr val="C9B991"/>
+            </a:solidFill>
+          </a:ln>
+          <a:effectLst/>
+        </p:spPr>
+        <p:txBody>
+          <a:bodyPr rtlCol="0" anchor="t" wrap="square" lIns="27432" rIns="27432" tIns="22860" bIns="22860"/>
+          <a:lstStyle/>
+          <a:p>
+            <a:pPr algn="ctr">
+              <a:buNone/>
+            </a:pPr>
+            <a:r>
+              <a:rPr lang="en-US" sz="2000" b="1" i="0" dirty="0">
+                <a:solidFill>
+                  <a:srgbClr val="5C4826"/>
+                </a:solidFill>
+              </a:rPr>
+              <a:t>STATIC</a:t>
+            </a:r>
+          </a:p>
+          <a:p>
+            <a:pPr algn="l">
+              <a:buNone/>
+              <a:spcBef>
+                <a:spcPts val="900"/>
+              </a:spcBef>
+            </a:pPr>
+            <a:r>
+              <a:rPr lang="en-US" sz="2000" b="0" i="0" dirty="0">
+                <a:solidFill>
+                  <a:srgbClr val="5C4826"/>
+                </a:solidFill>
+              </a:rPr>
+              <a:t>decided over the model itself</a:t>
+            </a:r>
+          </a:p>
+          <a:p>
+            <a:pPr algn="l">
+              <a:buNone/>
+              <a:spcBef>
+                <a:spcPts val="900"/>
+              </a:spcBef>
+            </a:pPr>
+            <a:r>
+              <a:rPr lang="en-US" sz="2000" b="0" i="0" dirty="0">
+                <a:solidFill>
+                  <a:srgbClr val="5C4826"/>
+                </a:solidFill>
+              </a:rPr>
+              <a:t>runs before any execution</a:t>
+            </a:r>
+          </a:p>
+          <a:p>
+            <a:pPr algn="l">
+              <a:buNone/>
+              <a:spcBef>
+                <a:spcPts val="900"/>
+              </a:spcBef>
+            </a:pPr>
+            <a:r>
+              <a:rPr lang="en-US" sz="2000" b="0" i="0" dirty="0">
+                <a:solidFill>
+                  <a:srgbClr val="5C4826"/>
+                </a:solidFill>
+              </a:rPr>
+              <a:t>exhaustive over the modeled space</a:t>
+            </a:r>
+          </a:p>
+          <a:p>
+            <a:pPr algn="l">
+              <a:buNone/>
+              <a:spcBef>
+                <a:spcPts val="900"/>
+              </a:spcBef>
+            </a:pPr>
+            <a:r>
+              <a:rPr lang="en-US" sz="2000" b="0" i="1" dirty="0">
+                <a:solidFill>
+                  <a:srgbClr val="555960"/>
+                </a:solidFill>
+              </a:rPr>
+              <a:t>can the memory bound be exceeded?</a:t>
+            </a:r>
+          </a:p>
+        </p:txBody>
+      </p:sp>
+      <p:sp>
+        <p:nvSpPr>
+          <p:cNvPr id="0" name="Cmp-dynamic"/>
+          <p:cNvSpPr/>
+          <p:nvPr/>
+        </p:nvSpPr>
+        <p:spPr>
+          <a:xfrm>
+            <a:off x="4663440" y="1051560"/>
+            <a:ext cx="3977639" cy="4038600"/>
+          </a:xfrm>
+          <a:prstGeom prst="rect">
+            <a:avLst/>
+          </a:prstGeom>
+          <a:solidFill>
+            <a:srgbClr val="F5F1E8"/>
+          </a:solidFill>
+          <a:ln w="12700">
+            <a:solidFill>
+              <a:srgbClr val="C9B991"/>
+            </a:solidFill>
+          </a:ln>
+          <a:effectLst/>
+        </p:spPr>
+        <p:txBody>
+          <a:bodyPr rtlCol="0" anchor="t" wrap="square" lIns="27432" rIns="27432" tIns="22860" bIns="22860"/>
+          <a:lstStyle/>
+          <a:p>
+            <a:pPr algn="ctr">
+              <a:buNone/>
+            </a:pPr>
+            <a:r>
+              <a:rPr lang="en-US" sz="2000" b="1" i="0" dirty="0">
+                <a:solidFill>
+                  <a:srgbClr val="5C4826"/>
+                </a:solidFill>
+              </a:rPr>
+              <a:t>DYNAMIC</a:t>
+            </a:r>
+          </a:p>
+          <a:p>
+            <a:pPr algn="l">
+              <a:buNone/>
+              <a:spcBef>
+                <a:spcPts val="900"/>
+              </a:spcBef>
+            </a:pPr>
+            <a:r>
+              <a:rPr lang="en-US" sz="2000" b="0" i="0" dirty="0">
+                <a:solidFill>
+                  <a:srgbClr val="5C4826"/>
+                </a:solidFill>
+              </a:rPr>
+              <a:t>decided over a trace of execution</a:t>
+            </a:r>
+          </a:p>
+          <a:p>
+            <a:pPr algn="l">
+              <a:buNone/>
+              <a:spcBef>
+                <a:spcPts val="900"/>
+              </a:spcBef>
+            </a:pPr>
+            <a:r>
+              <a:rPr lang="en-US" sz="2000" b="0" i="0" dirty="0">
+                <a:solidFill>
+                  <a:srgbClr val="5C4826"/>
+                </a:solidFill>
+              </a:rPr>
+              <a:t>runs while or after the system runs</a:t>
+            </a:r>
+          </a:p>
+          <a:p>
+            <a:pPr algn="l">
+              <a:buNone/>
+              <a:spcBef>
+                <a:spcPts val="900"/>
+              </a:spcBef>
+            </a:pPr>
+            <a:r>
+              <a:rPr lang="en-US" sz="2000" b="0" i="0" dirty="0">
+                <a:solidFill>
+                  <a:srgbClr val="5C4826"/>
+                </a:solidFill>
+              </a:rPr>
+              <a:t>evidence about the runs you observed</a:t>
+            </a:r>
+          </a:p>
+          <a:p>
+            <a:pPr algn="l">
+              <a:buNone/>
+              <a:spcBef>
+                <a:spcPts val="900"/>
+              </a:spcBef>
+            </a:pPr>
+            <a:r>
+              <a:rPr lang="en-US" sz="2000" b="0" i="1" dirty="0">
+                <a:solidFill>
+                  <a:srgbClr val="555960"/>
+                </a:solidFill>
+              </a:rPr>
+              <a:t>did the awake set ever exceed two?</a:t>
+            </a:r>
+          </a:p>
+        </p:txBody>
+      </p:sp>
+      <p:sp>
+        <p:nvSpPr>
+          <p:cNvPr id="0" name="FooterBand"/>
+          <p:cNvSpPr/>
+          <p:nvPr/>
+        </p:nvSpPr>
+        <p:spPr>
+          <a:xfrm>
+            <a:off x="274320" y="5760720"/>
+            <a:ext cx="8595360" cy="777240"/>
+          </a:xfrm>
+          <a:prstGeom prst="rect">
+            <a:avLst/>
+          </a:prstGeom>
+          <a:solidFill>
+            <a:srgbClr val="8E6F3E"/>
+          </a:solidFill>
+          <a:ln>
+            <a:noFill/>
+          </a:ln>
+          <a:effectLst/>
+        </p:spPr>
+        <p:txBody>
+          <a:bodyPr rtlCol="0" anchor="ctr" wrap="square" lIns="27432" rIns="27432" tIns="22860" bIns="22860"/>
+          <a:lstStyle/>
+          <a:p>
+            <a:pPr algn="ctr">
+              <a:buNone/>
+            </a:pPr>
+            <a:r>
+              <a:rPr lang="en-US" sz="2000" b="1" i="0" dirty="0">
+                <a:solidFill>
+                  <a:srgbClr val="FFFFFF"/>
+                </a:solidFill>
+              </a:rPr>
+              <a:t>Where should each verdict acquire authority?</a:t>
             </a:r>
           </a:p>
         </p:txBody>

</xml_diff>

<commit_message>
deck 2-3: fold the author's manual edits into the restructured deck
Author edits found by diffing baseline 8fddbe825 (39 slides) against the
author's re-saved copy:
1. Slide 3 (Vibe code a todo list): 'Do not help the agent.' + 'If it
   makes a choice you did not specify, let it choose.' replaced by
   'Examine the result and refine it as needed.'; 'You have 5 minutes.'
   -> 'You have 5-10 minutes. Give it a whirl'. Applied at slide 3 of
   the 46-slide deck, plus two speaker-note lines updated for coherence
   (the reveal cue quoting the deleted text, and the five-minute timer).
2. Slide 10 title 'Orders reduce degrees of freedom' -> 'More
   instructions means fewer degrees of freedom': CONFLICT — the
   restructure already retitled that slide 'Bound consequential degrees
   of freedom'; left the restructured title, flagged for the author.

Verified: 46 slides, 0 runs under 20pt, 46/46 speaker notes.

Co-Authored-By: Claude Opus 5 <noreply@anthropic.com>
</commit_message>
<xml_diff>
--- a/course/lectures/act-2-delegation-and-control/03-alignment/2-3-Alignment.pptx
+++ b/course/lectures/act-2-delegation-and-control/03-alignment/2-3-Alignment.pptx
@@ -5431,12 +5431,12 @@
           </a:p>
           <a:p>
             <a:r>
-              <a:t>- Reveal "Do not help the agent" and "If it makes a choice…" only after students have started reading.</a:t>
-            </a:r>
-          </a:p>
-          <a:p>
-            <a:r>
-              <a:t>- Start the five-minute timer after instructions are clear.</a:t>
+              <a:t>- Reveal "Examine the result and refine it as needed" only after students have started reading.</a:t>
+            </a:r>
+          </a:p>
+          <a:p>
+            <a:r>
+              <a:t>- Start the timer after instructions are clear.</a:t>
             </a:r>
           </a:p>
         </p:txBody>
@@ -20917,18 +20917,7 @@
                   <a:srgbClr val="555960"/>
                 </a:solidFill>
               </a:rPr>
-              <a:t>Do not help the agent.</a:t>
-            </a:r>
-          </a:p>
-          <a:p>
-            <a:pPr algn="l"/>
-            <a:r>
-              <a:rPr sz="2000" b="0" i="0">
-                <a:solidFill>
-                  <a:srgbClr val="555960"/>
-                </a:solidFill>
-              </a:rPr>
-              <a:t>If it makes a choice you did not specify, let it choose.</a:t>
+              <a:t>Examine the result and refine it as needed.</a:t>
             </a:r>
           </a:p>
         </p:txBody>
@@ -20980,7 +20969,7 @@
                   <a:srgbClr val="FFFFFF"/>
                 </a:solidFill>
               </a:rPr>
-              <a:t>You have 5 minutes.</a:t>
+              <a:t>You have 5-10 minutes. Give it a whirl</a:t>
             </a:r>
           </a:p>
         </p:txBody>

</xml_diff>

<commit_message>
deck 2-3: author's slide-10 title + repair pPr child order (49 schema findings)
Two changes to the restructured deck:

- Slide 10 keeps the author's own title, 'More instructions means fewer degrees of
  freedom', over the restructure's 'Bound consequential degrees of freedom'.
- Repairs 49 OOXML schema violations the restructure introduced: a:spcBef had been
  appended AFTER a:buNone, but CT_TextParagraphProperties requires the sequence
  lnSpc, spcBef, spcAft, bu*, tabLst, defRPr. PowerPoint would have reported the deck
  as needing repair. Every a:pPr is now sorted into canonical order; validator goes
  49 findings -> 0.

Note: the merge commit that brought these in did NOT run tools/pptx_validate.py --
merge commits bypass the staged-pptx gate that blocks ordinary commits.
</commit_message>
<xml_diff>
--- a/course/lectures/act-2-delegation-and-control/03-alignment/2-3-Alignment.pptx
+++ b/course/lectures/act-2-delegation-and-control/03-alignment/2-3-Alignment.pptx
@@ -9183,7 +9183,7 @@
           <a:p>
             <a:r>
               <a:rPr sz="2400"/>
-              <a:t>Bound consequential degrees of freedom</a:t>
+              <a:t>More instructions means fewer degrees of freedom</a:t>
             </a:r>
           </a:p>
         </p:txBody>
@@ -22353,10 +22353,10 @@
           </a:p>
           <a:p>
             <a:pPr algn="ctr">
-              <a:buNone/>
               <a:spcBef>
                 <a:spcPts val="900"/>
               </a:spcBef>
+              <a:buNone/>
             </a:pPr>
             <a:r>
               <a:rPr lang="en-US" sz="2000" b="0" i="1" dirty="0">
@@ -22369,10 +22369,10 @@
           </a:p>
           <a:p>
             <a:pPr algn="l">
-              <a:buNone/>
               <a:spcBef>
                 <a:spcPts val="900"/>
               </a:spcBef>
+              <a:buNone/>
             </a:pPr>
             <a:r>
               <a:rPr lang="en-US" sz="2000" b="0" i="0" dirty="0">
@@ -22385,10 +22385,10 @@
           </a:p>
           <a:p>
             <a:pPr algn="l">
-              <a:buNone/>
               <a:spcBef>
                 <a:spcPts val="900"/>
               </a:spcBef>
+              <a:buNone/>
             </a:pPr>
             <a:r>
               <a:rPr lang="en-US" sz="2000" b="0" i="0" dirty="0">
@@ -22401,10 +22401,10 @@
           </a:p>
           <a:p>
             <a:pPr algn="l">
-              <a:buNone/>
               <a:spcBef>
                 <a:spcPts val="900"/>
               </a:spcBef>
+              <a:buNone/>
             </a:pPr>
             <a:r>
               <a:rPr lang="en-US" sz="2000" b="0" i="0" dirty="0">
@@ -22417,10 +22417,10 @@
           </a:p>
           <a:p>
             <a:pPr algn="l">
-              <a:buNone/>
               <a:spcBef>
                 <a:spcPts val="900"/>
               </a:spcBef>
+              <a:buNone/>
             </a:pPr>
             <a:r>
               <a:rPr lang="en-US" sz="2000" b="0" i="1" dirty="0">
@@ -22475,10 +22475,10 @@
           </a:p>
           <a:p>
             <a:pPr algn="ctr">
-              <a:buNone/>
               <a:spcBef>
                 <a:spcPts val="900"/>
               </a:spcBef>
+              <a:buNone/>
             </a:pPr>
             <a:r>
               <a:rPr lang="en-US" sz="2000" b="0" i="1" dirty="0">
@@ -22491,10 +22491,10 @@
           </a:p>
           <a:p>
             <a:pPr algn="l">
-              <a:buNone/>
               <a:spcBef>
                 <a:spcPts val="900"/>
               </a:spcBef>
+              <a:buNone/>
             </a:pPr>
             <a:r>
               <a:rPr lang="en-US" sz="2000" b="0" i="0" dirty="0">
@@ -22507,10 +22507,10 @@
           </a:p>
           <a:p>
             <a:pPr algn="l">
-              <a:buNone/>
               <a:spcBef>
                 <a:spcPts val="900"/>
               </a:spcBef>
+              <a:buNone/>
             </a:pPr>
             <a:r>
               <a:rPr lang="en-US" sz="2000" b="0" i="0" dirty="0">
@@ -22523,10 +22523,10 @@
           </a:p>
           <a:p>
             <a:pPr algn="l">
-              <a:buNone/>
               <a:spcBef>
                 <a:spcPts val="900"/>
               </a:spcBef>
+              <a:buNone/>
             </a:pPr>
             <a:r>
               <a:rPr lang="en-US" sz="2000" b="0" i="0" dirty="0">
@@ -22539,10 +22539,10 @@
           </a:p>
           <a:p>
             <a:pPr algn="l">
-              <a:buNone/>
               <a:spcBef>
                 <a:spcPts val="900"/>
               </a:spcBef>
+              <a:buNone/>
             </a:pPr>
             <a:r>
               <a:rPr lang="en-US" sz="2000" b="0" i="1" dirty="0">
@@ -22870,10 +22870,10 @@
           </a:p>
           <a:p>
             <a:pPr algn="l">
-              <a:buNone/>
               <a:spcBef>
                 <a:spcPts val="900"/>
               </a:spcBef>
+              <a:buNone/>
             </a:pPr>
             <a:r>
               <a:rPr lang="en-US" sz="2000" b="0" i="0" dirty="0">
@@ -22886,10 +22886,10 @@
           </a:p>
           <a:p>
             <a:pPr algn="l">
-              <a:buNone/>
               <a:spcBef>
                 <a:spcPts val="900"/>
               </a:spcBef>
+              <a:buNone/>
             </a:pPr>
             <a:r>
               <a:rPr lang="en-US" sz="2000" b="0" i="0" dirty="0">
@@ -22902,10 +22902,10 @@
           </a:p>
           <a:p>
             <a:pPr algn="l">
-              <a:buNone/>
               <a:spcBef>
                 <a:spcPts val="900"/>
               </a:spcBef>
+              <a:buNone/>
             </a:pPr>
             <a:r>
               <a:rPr lang="en-US" sz="2000" b="0" i="0" dirty="0">
@@ -22918,10 +22918,10 @@
           </a:p>
           <a:p>
             <a:pPr algn="l">
-              <a:buNone/>
               <a:spcBef>
                 <a:spcPts val="900"/>
               </a:spcBef>
+              <a:buNone/>
             </a:pPr>
             <a:r>
               <a:rPr lang="en-US" sz="2000" b="0" i="0" dirty="0">
@@ -23439,10 +23439,10 @@
           </a:p>
           <a:p>
             <a:pPr algn="l">
-              <a:buNone/>
               <a:spcBef>
                 <a:spcPts val="900"/>
               </a:spcBef>
+              <a:buNone/>
             </a:pPr>
             <a:r>
               <a:rPr lang="en-US" sz="2000" b="0" i="0" dirty="0">
@@ -23455,10 +23455,10 @@
           </a:p>
           <a:p>
             <a:pPr algn="l">
-              <a:buNone/>
               <a:spcBef>
                 <a:spcPts val="900"/>
               </a:spcBef>
+              <a:buNone/>
             </a:pPr>
             <a:r>
               <a:rPr lang="en-US" sz="2000" b="0" i="0" dirty="0">
@@ -23471,10 +23471,10 @@
           </a:p>
           <a:p>
             <a:pPr algn="l">
-              <a:buNone/>
               <a:spcBef>
                 <a:spcPts val="900"/>
               </a:spcBef>
+              <a:buNone/>
             </a:pPr>
             <a:r>
               <a:rPr lang="en-US" sz="2000" b="0" i="0" dirty="0">
@@ -23596,10 +23596,10 @@
           </a:p>
           <a:p>
             <a:pPr algn="l">
-              <a:buNone/>
               <a:spcBef>
                 <a:spcPts val="900"/>
               </a:spcBef>
+              <a:buNone/>
             </a:pPr>
             <a:r>
               <a:rPr lang="en-US" sz="2000" b="0" i="0" dirty="0">
@@ -23612,10 +23612,10 @@
           </a:p>
           <a:p>
             <a:pPr algn="l">
-              <a:buNone/>
               <a:spcBef>
                 <a:spcPts val="900"/>
               </a:spcBef>
+              <a:buNone/>
             </a:pPr>
             <a:r>
               <a:rPr lang="en-US" sz="2000" b="0" i="0" dirty="0">
@@ -23628,10 +23628,10 @@
           </a:p>
           <a:p>
             <a:pPr algn="l">
-              <a:buNone/>
               <a:spcBef>
                 <a:spcPts val="900"/>
               </a:spcBef>
+              <a:buNone/>
             </a:pPr>
             <a:r>
               <a:rPr lang="en-US" sz="2000" b="0" i="0" dirty="0">
@@ -23644,10 +23644,10 @@
           </a:p>
           <a:p>
             <a:pPr algn="l">
-              <a:buNone/>
               <a:spcBef>
                 <a:spcPts val="900"/>
               </a:spcBef>
+              <a:buNone/>
             </a:pPr>
             <a:r>
               <a:rPr lang="en-US" sz="2000" b="0" i="1" dirty="0">
@@ -23702,10 +23702,10 @@
           </a:p>
           <a:p>
             <a:pPr algn="l">
-              <a:buNone/>
               <a:spcBef>
                 <a:spcPts val="900"/>
               </a:spcBef>
+              <a:buNone/>
             </a:pPr>
             <a:r>
               <a:rPr lang="en-US" sz="2000" b="0" i="0" dirty="0">
@@ -23718,10 +23718,10 @@
           </a:p>
           <a:p>
             <a:pPr algn="l">
-              <a:buNone/>
               <a:spcBef>
                 <a:spcPts val="900"/>
               </a:spcBef>
+              <a:buNone/>
             </a:pPr>
             <a:r>
               <a:rPr lang="en-US" sz="2000" b="0" i="0" dirty="0">
@@ -23734,10 +23734,10 @@
           </a:p>
           <a:p>
             <a:pPr algn="l">
-              <a:buNone/>
               <a:spcBef>
                 <a:spcPts val="900"/>
               </a:spcBef>
+              <a:buNone/>
             </a:pPr>
             <a:r>
               <a:rPr lang="en-US" sz="2000" b="0" i="0" dirty="0">
@@ -23750,10 +23750,10 @@
           </a:p>
           <a:p>
             <a:pPr algn="l">
-              <a:buNone/>
               <a:spcBef>
                 <a:spcPts val="900"/>
               </a:spcBef>
+              <a:buNone/>
             </a:pPr>
             <a:r>
               <a:rPr lang="en-US" sz="2000" b="0" i="1" dirty="0">
@@ -26041,10 +26041,10 @@
           </a:p>
           <a:p>
             <a:pPr algn="l">
-              <a:buNone/>
               <a:spcBef>
                 <a:spcPts val="900"/>
               </a:spcBef>
+              <a:buNone/>
             </a:pPr>
             <a:r>
               <a:rPr lang="en-US" sz="2000" b="0" i="0" dirty="0">
@@ -26057,10 +26057,10 @@
           </a:p>
           <a:p>
             <a:pPr algn="l">
-              <a:buNone/>
               <a:spcBef>
                 <a:spcPts val="900"/>
               </a:spcBef>
+              <a:buNone/>
             </a:pPr>
             <a:r>
               <a:rPr lang="en-US" sz="2000" b="0" i="0" dirty="0">
@@ -26073,10 +26073,10 @@
           </a:p>
           <a:p>
             <a:pPr algn="l">
-              <a:buNone/>
               <a:spcBef>
                 <a:spcPts val="900"/>
               </a:spcBef>
+              <a:buNone/>
             </a:pPr>
             <a:r>
               <a:rPr lang="en-US" sz="2000" b="0" i="0" dirty="0">
@@ -26089,10 +26089,10 @@
           </a:p>
           <a:p>
             <a:pPr algn="l">
-              <a:buNone/>
               <a:spcBef>
                 <a:spcPts val="900"/>
               </a:spcBef>
+              <a:buNone/>
             </a:pPr>
             <a:r>
               <a:rPr lang="en-US" sz="2000" b="0" i="0" dirty="0">
@@ -26105,10 +26105,10 @@
           </a:p>
           <a:p>
             <a:pPr algn="l">
-              <a:buNone/>
               <a:spcBef>
                 <a:spcPts val="900"/>
               </a:spcBef>
+              <a:buNone/>
             </a:pPr>
             <a:r>
               <a:rPr lang="en-US" sz="2000" b="0" i="0" dirty="0">
@@ -26163,10 +26163,10 @@
           </a:p>
           <a:p>
             <a:pPr algn="l">
-              <a:buNone/>
               <a:spcBef>
                 <a:spcPts val="900"/>
               </a:spcBef>
+              <a:buNone/>
             </a:pPr>
             <a:r>
               <a:rPr lang="en-US" sz="2000" b="0" i="0" dirty="0">
@@ -26179,10 +26179,10 @@
           </a:p>
           <a:p>
             <a:pPr algn="l">
-              <a:buNone/>
               <a:spcBef>
                 <a:spcPts val="900"/>
               </a:spcBef>
+              <a:buNone/>
             </a:pPr>
             <a:r>
               <a:rPr lang="en-US" sz="2000" b="1" i="0" dirty="0">
@@ -26195,10 +26195,10 @@
           </a:p>
           <a:p>
             <a:pPr algn="l">
-              <a:buNone/>
               <a:spcBef>
                 <a:spcPts val="900"/>
               </a:spcBef>
+              <a:buNone/>
             </a:pPr>
             <a:r>
               <a:rPr lang="en-US" sz="2000" b="1" i="0" dirty="0">
@@ -26211,10 +26211,10 @@
           </a:p>
           <a:p>
             <a:pPr algn="l">
-              <a:buNone/>
               <a:spcBef>
                 <a:spcPts val="900"/>
               </a:spcBef>
+              <a:buNone/>
             </a:pPr>
             <a:r>
               <a:rPr lang="en-US" sz="2000" b="1" i="0" dirty="0">
@@ -26227,10 +26227,10 @@
           </a:p>
           <a:p>
             <a:pPr algn="l">
-              <a:buNone/>
               <a:spcBef>
                 <a:spcPts val="900"/>
               </a:spcBef>
+              <a:buNone/>
             </a:pPr>
             <a:r>
               <a:rPr lang="en-US" sz="2000" b="0" i="1" dirty="0">
@@ -26492,10 +26492,10 @@
           </a:p>
           <a:p>
             <a:pPr algn="l">
-              <a:buNone/>
               <a:spcBef>
                 <a:spcPts val="600"/>
               </a:spcBef>
+              <a:buNone/>
             </a:pPr>
             <a:r>
               <a:rPr lang="en-US" sz="2000" b="1" i="0" dirty="0">
@@ -26516,10 +26516,10 @@
           </a:p>
           <a:p>
             <a:pPr algn="l">
-              <a:buNone/>
               <a:spcBef>
                 <a:spcPts val="600"/>
               </a:spcBef>
+              <a:buNone/>
             </a:pPr>
             <a:r>
               <a:rPr lang="en-US" sz="2000" b="1" i="0" dirty="0">
@@ -26630,10 +26630,10 @@
           </a:p>
           <a:p>
             <a:pPr algn="l">
-              <a:buNone/>
               <a:spcBef>
                 <a:spcPts val="600"/>
               </a:spcBef>
+              <a:buNone/>
             </a:pPr>
             <a:r>
               <a:rPr lang="en-US" sz="2000" b="1" i="0" dirty="0">
@@ -26654,10 +26654,10 @@
           </a:p>
           <a:p>
             <a:pPr algn="l">
-              <a:buNone/>
               <a:spcBef>
                 <a:spcPts val="600"/>
               </a:spcBef>
+              <a:buNone/>
             </a:pPr>
             <a:r>
               <a:rPr lang="en-US" sz="2000" b="1" i="0" dirty="0">
@@ -26768,10 +26768,10 @@
           </a:p>
           <a:p>
             <a:pPr algn="l">
-              <a:buNone/>
               <a:spcBef>
                 <a:spcPts val="600"/>
               </a:spcBef>
+              <a:buNone/>
             </a:pPr>
             <a:r>
               <a:rPr lang="en-US" sz="2000" b="1" i="0" dirty="0">
@@ -28366,10 +28366,10 @@
           </a:p>
           <a:p>
             <a:pPr algn="l">
-              <a:buNone/>
               <a:spcBef>
                 <a:spcPts val="900"/>
               </a:spcBef>
+              <a:buNone/>
             </a:pPr>
             <a:r>
               <a:rPr lang="en-US" sz="2000" b="0" i="0" dirty="0">
@@ -28382,10 +28382,10 @@
           </a:p>
           <a:p>
             <a:pPr algn="l">
-              <a:buNone/>
               <a:spcBef>
                 <a:spcPts val="900"/>
               </a:spcBef>
+              <a:buNone/>
             </a:pPr>
             <a:r>
               <a:rPr lang="en-US" sz="2000" b="0" i="0" dirty="0">
@@ -28398,10 +28398,10 @@
           </a:p>
           <a:p>
             <a:pPr algn="l">
-              <a:buNone/>
               <a:spcBef>
                 <a:spcPts val="900"/>
               </a:spcBef>
+              <a:buNone/>
             </a:pPr>
             <a:r>
               <a:rPr lang="en-US" sz="2000" b="0" i="0" dirty="0">
@@ -28414,10 +28414,10 @@
           </a:p>
           <a:p>
             <a:pPr algn="l">
-              <a:buNone/>
               <a:spcBef>
                 <a:spcPts val="900"/>
               </a:spcBef>
+              <a:buNone/>
             </a:pPr>
             <a:r>
               <a:rPr lang="en-US" sz="2000" b="0" i="0" dirty="0">
@@ -28472,10 +28472,10 @@
           </a:p>
           <a:p>
             <a:pPr algn="l">
-              <a:buNone/>
               <a:spcBef>
                 <a:spcPts val="900"/>
               </a:spcBef>
+              <a:buNone/>
             </a:pPr>
             <a:r>
               <a:rPr lang="en-US" sz="2000" b="0" i="0" dirty="0">
@@ -28488,10 +28488,10 @@
           </a:p>
           <a:p>
             <a:pPr algn="l">
-              <a:buNone/>
               <a:spcBef>
                 <a:spcPts val="900"/>
               </a:spcBef>
+              <a:buNone/>
             </a:pPr>
             <a:r>
               <a:rPr lang="en-US" sz="2000" b="0" i="0" dirty="0">
@@ -28504,10 +28504,10 @@
           </a:p>
           <a:p>
             <a:pPr algn="l">
-              <a:buNone/>
               <a:spcBef>
                 <a:spcPts val="900"/>
               </a:spcBef>
+              <a:buNone/>
             </a:pPr>
             <a:r>
               <a:rPr lang="en-US" sz="2000" b="0" i="0" dirty="0">
@@ -28520,10 +28520,10 @@
           </a:p>
           <a:p>
             <a:pPr algn="l">
-              <a:buNone/>
               <a:spcBef>
                 <a:spcPts val="900"/>
               </a:spcBef>
+              <a:buNone/>
             </a:pPr>
             <a:r>
               <a:rPr lang="en-US" sz="2000" b="0" i="0" dirty="0">
@@ -28536,10 +28536,10 @@
           </a:p>
           <a:p>
             <a:pPr algn="l">
-              <a:buNone/>
               <a:spcBef>
                 <a:spcPts val="900"/>
               </a:spcBef>
+              <a:buNone/>
             </a:pPr>
             <a:r>
               <a:rPr lang="en-US" sz="2000" b="0" i="0" dirty="0">

</xml_diff>

<commit_message>
deck 2-3: cut 6 — drop SECTION 6 divider, merge activity setup + given model into 'Design the Alignment' (46->44)
</commit_message>
<xml_diff>
--- a/course/lectures/act-2-delegation-and-control/03-alignment/2-3-Alignment.pptx
+++ b/course/lectures/act-2-delegation-and-control/03-alignment/2-3-Alignment.pptx
@@ -48,9 +48,7 @@
     <p:sldId id="310" r:id="rId5"/>
     <p:sldId id="280" r:id="rId31"/>
     <p:sldId id="281" r:id="rId32"/>
-    <p:sldId id="287" r:id="rId52"/>
     <p:sldId id="274" r:id="rId25"/>
-    <p:sldId id="311" r:id="rId11"/>
     <p:sldId id="275" r:id="rId26"/>
     <p:sldId id="276" r:id="rId27"/>
     <p:sldId id="282" r:id="rId33"/>
@@ -1405,91 +1403,6 @@
 </p:notes>
 </file>
 
-<file path=ppt/notesSlides/notesSlide16.xml><?xml version="1.0" encoding="utf-8"?>
-<p:notes xmlns:a="http://schemas.openxmlformats.org/drawingml/2006/main" xmlns:p="http://schemas.openxmlformats.org/presentationml/2006/main" xmlns:r="http://schemas.openxmlformats.org/officeDocument/2006/relationships">
-  <p:cSld>
-    <p:spTree>
-      <p:nvGrpSpPr>
-        <p:cNvPr id="1" name=""/>
-        <p:cNvGrpSpPr/>
-        <p:nvPr/>
-      </p:nvGrpSpPr>
-      <p:grpSpPr>
-        <a:xfrm>
-          <a:off x="0" y="0"/>
-          <a:ext cx="0" cy="0"/>
-          <a:chOff x="0" y="0"/>
-          <a:chExt cx="0" cy="0"/>
-        </a:xfrm>
-      </p:grpSpPr>
-      <p:sp>
-        <p:nvSpPr>
-          <p:cNvPr id="2" name="Slide Image Placeholder 1"/>
-          <p:cNvSpPr>
-            <a:spLocks noGrp="1"/>
-          </p:cNvSpPr>
-          <p:nvPr>
-            <p:ph type="sldImg" idx="2"/>
-          </p:nvPr>
-        </p:nvSpPr>
-        <p:spPr/>
-      </p:sp>
-      <p:sp>
-        <p:nvSpPr>
-          <p:cNvPr id="3" name="Notes Placeholder 2"/>
-          <p:cNvSpPr>
-            <a:spLocks noGrp="1"/>
-          </p:cNvSpPr>
-          <p:nvPr>
-            <p:ph type="body" idx="3" sz="quarter"/>
-          </p:nvPr>
-        </p:nvSpPr>
-        <p:spPr/>
-        <p:txBody>
-          <a:bodyPr/>
-          <a:lstStyle/>
-          <a:p>
-            <a:r>
-              <a:t>TIMING: 30 seconds</a:t>
-            </a:r>
-          </a:p>
-          <a:p>
-            <a:r>
-              <a:t>- Enough vocabulary.</a:t>
-            </a:r>
-          </a:p>
-          <a:p>
-            <a:r>
-              <a:t>- Now use it.</a:t>
-            </a:r>
-          </a:p>
-          <a:p>
-            <a:r>
-              <a:t>- You are going to receive explicit obligations and a model, and design the delegated process around them.</a:t>
-            </a:r>
-          </a:p>
-        </p:txBody>
-      </p:sp>
-      <p:sp>
-        <p:nvSpPr>
-          <p:cNvPr id="4" name="Slide Number Placeholder 3"/>
-          <p:cNvSpPr>
-            <a:spLocks noGrp="1"/>
-          </p:cNvSpPr>
-          <p:nvPr>
-            <p:ph type="sldNum" idx="5" sz="quarter"/>
-          </p:nvPr>
-        </p:nvSpPr>
-        <p:spPr/>
-      </p:sp>
-    </p:spTree>
-  </p:cSld>
-  <p:clrMapOvr>
-    <a:masterClrMapping/>
-  </p:clrMapOvr>
-</p:notes>
-</file>
-
 <file path=ppt/notesSlides/notesSlide17.xml><?xml version="1.0" encoding="utf-8"?>
 <p:notes xmlns:a="http://schemas.openxmlformats.org/drawingml/2006/main" xmlns:p="http://schemas.openxmlformats.org/presentationml/2006/main" xmlns:r="http://schemas.openxmlformats.org/officeDocument/2006/relationships">
   <p:cSld>
@@ -1750,12 +1663,17 @@
           <a:lstStyle/>
           <a:p>
             <a:r>
-              <a:t>TIMING: 2 minutes setup + 8-10 minutes work</a:t>
-            </a:r>
-          </a:p>
-          <a:p>
-            <a:r>
-              <a:t>- Scenario: an agent modifies an embedded controller — the SAME domain as the lab's sensor node, so read this as a continuation, not a new scenario.</a:t>
+              <a:t>TIMING: 30 seconds transition + 2 minutes setup + 8-10 minutes work</a:t>
+            </a:r>
+          </a:p>
+          <a:p>
+            <a:r>
+              <a:t>- This slide is now the section transition (the SECTION 6 divider was cut) — the activity title itself is the transition. Setup line: enough vocabulary; now use it.</a:t>
+            </a:r>
+          </a:p>
+          <a:p>
+            <a:r>
+              <a:t>- Scenario (spoken, no longer on the slide): an agent is modifying an embedded controller — the SAME domain as the lab's sensor node, so read this as a continuation, not a new scenario.</a:t>
             </a:r>
           </a:p>
           <a:p>
@@ -1765,12 +1683,22 @@
           </a:p>
           <a:p>
             <a:r>
-              <a:t>- The model is given on the next slide. Do not spend the activity rediscovering it from implementation.</a:t>
-            </a:r>
-          </a:p>
-          <a:p>
-            <a:r>
-              <a:t>- Your job is to design the delegated process and its controls.</a:t>
+              <a:t>- The model is given on the right — the same two kinds the class built in the lab. Structural facts support static checks: the API, the dependency facts (including the forbidden one), and the memory bound. The behavioral ordering defines what to observe at runtime: the cycle.</a:t>
+            </a:r>
+          </a:p>
+          <a:p>
+            <a:r>
+              <a:t>- Use the model as given — do not spend the activity rediscovering it from the implementation.</a:t>
+            </a:r>
+          </a:p>
+          <a:p>
+            <a:r>
+              <a:t>- Teams should ask, per obligation, which side of the model makes the relevant fact explicit — that feeds the MODEL USE question on the worksheet slide.</a:t>
+            </a:r>
+          </a:p>
+          <a:p>
+            <a:r>
+              <a:t>- Your job: design the delegated process and its controls.</a:t>
             </a:r>
           </a:p>
         </p:txBody>
@@ -3876,91 +3804,6 @@
           <a:p>
             <a:r>
               <a:t>- Each response names a control problem; the next slide names the roles that solve them.</a:t>
-            </a:r>
-          </a:p>
-        </p:txBody>
-      </p:sp>
-      <p:sp>
-        <p:nvSpPr>
-          <p:cNvPr id="4" name="Slide Number Placeholder 3"/>
-          <p:cNvSpPr>
-            <a:spLocks noGrp="1"/>
-          </p:cNvSpPr>
-          <p:nvPr>
-            <p:ph type="sldNum" idx="5" sz="quarter"/>
-          </p:nvPr>
-        </p:nvSpPr>
-        <p:spPr/>
-      </p:sp>
-    </p:spTree>
-  </p:cSld>
-  <p:clrMapOvr>
-    <a:masterClrMapping/>
-  </p:clrMapOvr>
-</p:notes>
-</file>
-
-<file path=ppt/notesSlides/notesSlide37.xml><?xml version="1.0" encoding="utf-8"?>
-<p:notes xmlns:a="http://schemas.openxmlformats.org/drawingml/2006/main" xmlns:p="http://schemas.openxmlformats.org/presentationml/2006/main" xmlns:r="http://schemas.openxmlformats.org/officeDocument/2006/relationships">
-  <p:cSld>
-    <p:spTree>
-      <p:nvGrpSpPr>
-        <p:cNvPr id="1" name=""/>
-        <p:cNvGrpSpPr/>
-        <p:nvPr/>
-      </p:nvGrpSpPr>
-      <p:grpSpPr>
-        <a:xfrm>
-          <a:off x="0" y="0"/>
-          <a:ext cx="0" cy="0"/>
-          <a:chOff x="0" y="0"/>
-          <a:chExt cx="0" cy="0"/>
-        </a:xfrm>
-      </p:grpSpPr>
-      <p:sp>
-        <p:nvSpPr>
-          <p:cNvPr id="2" name="Slide Image Placeholder 1"/>
-          <p:cNvSpPr>
-            <a:spLocks noGrp="1"/>
-          </p:cNvSpPr>
-          <p:nvPr>
-            <p:ph type="sldImg" idx="2"/>
-          </p:nvPr>
-        </p:nvSpPr>
-        <p:spPr/>
-      </p:sp>
-      <p:sp>
-        <p:nvSpPr>
-          <p:cNvPr id="3" name="Notes Placeholder 2"/>
-          <p:cNvSpPr>
-            <a:spLocks noGrp="1"/>
-          </p:cNvSpPr>
-          <p:nvPr>
-            <p:ph type="body" idx="3" sz="quarter"/>
-          </p:nvPr>
-        </p:nvSpPr>
-        <p:spPr/>
-        <p:txBody>
-          <a:bodyPr/>
-          <a:lstStyle/>
-          <a:p>
-            <a:r>
-              <a:t>TIMING: 1 minute</a:t>
-            </a:r>
-          </a:p>
-          <a:p>
-            <a:r>
-              <a:t>- Same two kinds of model the class built in the lab: structural facts that support static checks, and a behavioral ordering that defines what to observe at runtime.</a:t>
-            </a:r>
-          </a:p>
-          <a:p>
-            <a:r>
-              <a:t>- The structural side carries the API, the dependency facts (including the forbidden one), and the memory bound. The behavioral side carries the cycle ordering.</a:t>
-            </a:r>
-          </a:p>
-          <a:p>
-            <a:r>
-              <a:t>- Teams should ask, per obligation, which side of the model makes the relevant fact explicit — that feeds the MODEL USE question on the next slide.</a:t>
             </a:r>
           </a:p>
         </p:txBody>
@@ -25094,334 +24937,6 @@
 </p:sld>
 </file>
 
-<file path=ppt/slides/slide41.xml><?xml version="1.0" encoding="utf-8"?>
-<p:sld xmlns:a="http://schemas.openxmlformats.org/drawingml/2006/main" xmlns:r="http://schemas.openxmlformats.org/officeDocument/2006/relationships" xmlns:p="http://schemas.openxmlformats.org/presentationml/2006/main">
-  <p:cSld>
-    <p:spTree>
-      <p:nvGrpSpPr>
-        <p:cNvPr id="1" name=""/>
-        <p:cNvGrpSpPr/>
-        <p:nvPr/>
-      </p:nvGrpSpPr>
-      <p:grpSpPr>
-        <a:xfrm>
-          <a:off x="0" y="0"/>
-          <a:ext cx="0" cy="0"/>
-          <a:chOff x="0" y="0"/>
-          <a:chExt cx="0" cy="0"/>
-        </a:xfrm>
-      </p:grpSpPr>
-      <p:sp>
-        <p:nvSpPr>
-          <p:cNvPr id="100" name="SectionLabel"/>
-          <p:cNvSpPr txBox="1"/>
-          <p:nvPr/>
-        </p:nvSpPr>
-        <p:spPr>
-          <a:xfrm>
-            <a:off x="685800" y="1243584"/>
-            <a:ext cx="7772400" cy="365760"/>
-          </a:xfrm>
-          <a:prstGeom prst="rect">
-            <a:avLst/>
-          </a:prstGeom>
-          <a:noFill/>
-          <a:ln>
-            <a:noFill/>
-          </a:ln>
-        </p:spPr>
-        <p:txBody>
-          <a:bodyPr wrap="square" lIns="0" tIns="0" rIns="0" bIns="0" anchor="t"/>
-          <a:lstStyle/>
-          <a:p>
-            <a:pPr marL="0" marR="0" lvl="0" indent="0" algn="ctr" defTabSz="457200" rtl="0" eaLnBrk="1" fontAlgn="auto" latinLnBrk="0" hangingPunct="1">
-              <a:lnSpc>
-                <a:spcPct val="100000"/>
-              </a:lnSpc>
-              <a:spcBef>
-                <a:spcPts val="0"/>
-              </a:spcBef>
-              <a:spcAft>
-                <a:spcPts val="0"/>
-              </a:spcAft>
-              <a:buClrTx/>
-              <a:buSzTx/>
-              <a:buFontTx/>
-              <a:buNone/>
-              <a:tabLst/>
-              <a:defRPr/>
-            </a:pPr>
-            <a:r>
-              <a:rPr kumimoji="0" lang="en-US" sz="2000" b="1" i="0" u="none" strike="noStrike" kern="1200" cap="none" spc="0" normalizeH="0" baseline="0" noProof="0" dirty="0">
-                <a:ln>
-                  <a:noFill/>
-                </a:ln>
-                <a:solidFill>
-                  <a:srgbClr val="8E6F3E"/>
-                </a:solidFill>
-                <a:effectLst/>
-                <a:uLnTx/>
-                <a:uFillTx/>
-                <a:latin typeface="Calibri" panose="020F0502020204030204"/>
-                <a:ea typeface="+mn-ea"/>
-                <a:cs typeface="+mn-cs"/>
-              </a:rPr>
-              <a:t>SECTION 6</a:t>
-            </a:r>
-          </a:p>
-        </p:txBody>
-      </p:sp>
-      <p:sp>
-        <p:nvSpPr>
-          <p:cNvPr id="2" name="Title 1"/>
-          <p:cNvSpPr>
-            <a:spLocks noGrp="1"/>
-          </p:cNvSpPr>
-          <p:nvPr>
-            <p:ph type="title"/>
-          </p:nvPr>
-        </p:nvSpPr>
-        <p:spPr>
-          <a:xfrm>
-            <a:off x="685800" y="1700784"/>
-            <a:ext cx="7772400" cy="1005840"/>
-          </a:xfrm>
-        </p:spPr>
-        <p:txBody>
-          <a:bodyPr>
-            <a:normAutofit/>
-          </a:bodyPr>
-          <a:lstStyle/>
-          <a:p>
-            <a:pPr algn="ctr">
-              <a:buNone/>
-              <a:defRPr b="0"/>
-            </a:pPr>
-            <a:r>
-              <a:rPr lang="en-US" sz="4000" b="0" i="0" dirty="0">
-                <a:solidFill>
-                  <a:srgbClr val="000000"/>
-                </a:solidFill>
-              </a:rPr>
-              <a:t>Design the Alignment</a:t>
-            </a:r>
-          </a:p>
-        </p:txBody>
-      </p:sp>
-      <p:sp>
-        <p:nvSpPr>
-          <p:cNvPr id="3" name="Slide Number Placeholder 3"/>
-          <p:cNvSpPr>
-            <a:spLocks noGrp="1"/>
-          </p:cNvSpPr>
-          <p:nvPr>
-            <p:ph type="sldNum" sz="quarter" idx="4"/>
-          </p:nvPr>
-        </p:nvSpPr>
-        <p:spPr/>
-        <p:txBody>
-          <a:bodyPr/>
-          <a:lstStyle/>
-          <a:p>
-            <a:pPr marL="0" marR="0" lvl="0" indent="0" algn="r" defTabSz="457200" rtl="0" eaLnBrk="1" fontAlgn="auto" latinLnBrk="0" hangingPunct="1">
-              <a:lnSpc>
-                <a:spcPct val="100000"/>
-              </a:lnSpc>
-              <a:spcBef>
-                <a:spcPts val="0"/>
-              </a:spcBef>
-              <a:spcAft>
-                <a:spcPts val="0"/>
-              </a:spcAft>
-              <a:buClrTx/>
-              <a:buSzTx/>
-              <a:buFontTx/>
-              <a:buNone/>
-              <a:tabLst/>
-              <a:defRPr/>
-            </a:pPr>
-            <a:fld id="{B7EB45DA-9A0D-DC49-8E02-F30A5DDC21C3}" type="slidenum">
-              <a:rPr kumimoji="0" lang="en-US" sz="1200" b="0" i="0" u="none" strike="noStrike" kern="1200" cap="none" spc="0" normalizeH="0" baseline="0" noProof="0" smtClean="0">
-                <a:ln>
-                  <a:noFill/>
-                </a:ln>
-                <a:solidFill>
-                  <a:srgbClr val="000000">
-                    <a:tint val="75000"/>
-                  </a:srgbClr>
-                </a:solidFill>
-                <a:effectLst/>
-                <a:uLnTx/>
-                <a:uFillTx/>
-                <a:latin typeface="Calibri" panose="020F0502020204030204"/>
-                <a:ea typeface="+mn-ea"/>
-                <a:cs typeface="+mn-cs"/>
-              </a:rPr>
-              <a:pPr marL="0" marR="0" lvl="0" indent="0" algn="r" defTabSz="457200" rtl="0" eaLnBrk="1" fontAlgn="auto" latinLnBrk="0" hangingPunct="1">
-                <a:lnSpc>
-                  <a:spcPct val="100000"/>
-                </a:lnSpc>
-                <a:spcBef>
-                  <a:spcPts val="0"/>
-                </a:spcBef>
-                <a:spcAft>
-                  <a:spcPts val="0"/>
-                </a:spcAft>
-                <a:buClrTx/>
-                <a:buSzTx/>
-                <a:buFontTx/>
-                <a:buNone/>
-                <a:tabLst/>
-                <a:defRPr/>
-              </a:pPr>
-              <a:t>23</a:t>
-            </a:fld>
-            <a:endParaRPr kumimoji="0" lang="en-US" sz="1200" b="0" i="0" u="none" strike="noStrike" kern="1200" cap="none" spc="0" normalizeH="0" baseline="0" noProof="0">
-              <a:ln>
-                <a:noFill/>
-              </a:ln>
-              <a:solidFill>
-                <a:srgbClr val="000000">
-                  <a:tint val="75000"/>
-                </a:srgbClr>
-              </a:solidFill>
-              <a:effectLst/>
-              <a:uLnTx/>
-              <a:uFillTx/>
-              <a:latin typeface="Calibri" panose="020F0502020204030204"/>
-              <a:ea typeface="+mn-ea"/>
-              <a:cs typeface="+mn-cs"/>
-            </a:endParaRPr>
-          </a:p>
-        </p:txBody>
-      </p:sp>
-      <p:sp>
-        <p:nvSpPr>
-          <p:cNvPr id="101" name="Question"/>
-          <p:cNvSpPr txBox="1"/>
-          <p:nvPr/>
-        </p:nvSpPr>
-        <p:spPr>
-          <a:xfrm>
-            <a:off x="685800" y="2798064"/>
-            <a:ext cx="7772400" cy="475488"/>
-          </a:xfrm>
-          <a:prstGeom prst="rect">
-            <a:avLst/>
-          </a:prstGeom>
-          <a:noFill/>
-          <a:ln>
-            <a:noFill/>
-          </a:ln>
-        </p:spPr>
-        <p:txBody>
-          <a:bodyPr wrap="square" lIns="0" tIns="0" rIns="0" bIns="0" anchor="t"/>
-          <a:lstStyle/>
-          <a:p>
-            <a:pPr marL="0" marR="0" lvl="0" indent="0" algn="ctr" defTabSz="457200" rtl="0" eaLnBrk="1" fontAlgn="auto" latinLnBrk="0" hangingPunct="1">
-              <a:lnSpc>
-                <a:spcPct val="100000"/>
-              </a:lnSpc>
-              <a:spcBef>
-                <a:spcPts val="0"/>
-              </a:spcBef>
-              <a:spcAft>
-                <a:spcPts val="0"/>
-              </a:spcAft>
-              <a:buClrTx/>
-              <a:buSzTx/>
-              <a:buFontTx/>
-              <a:buNone/>
-              <a:tabLst/>
-              <a:defRPr/>
-            </a:pPr>
-            <a:r>
-              <a:rPr kumimoji="0" lang="en-US" sz="2000" b="0" i="0" u="none" strike="noStrike" kern="1200" cap="none" spc="0" normalizeH="0" baseline="0" noProof="0" dirty="0">
-                <a:ln>
-                  <a:noFill/>
-                </a:ln>
-                <a:solidFill>
-                  <a:srgbClr val="5C4826"/>
-                </a:solidFill>
-                <a:effectLst/>
-                <a:uLnTx/>
-                <a:uFillTx/>
-                <a:latin typeface="Calibri" panose="020F0502020204030204"/>
-                <a:ea typeface="+mn-ea"/>
-                <a:cs typeface="+mn-cs"/>
-              </a:rPr>
-              <a:t>How should the environment control delegated work?</a:t>
-            </a:r>
-          </a:p>
-        </p:txBody>
-      </p:sp>
-      <p:sp>
-        <p:nvSpPr>
-          <p:cNvPr id="103" name="Rule"/>
-          <p:cNvSpPr/>
-          <p:nvPr/>
-        </p:nvSpPr>
-        <p:spPr>
-          <a:xfrm>
-            <a:off x="3429000" y="3584448"/>
-            <a:ext cx="2286000" cy="51206"/>
-          </a:xfrm>
-          <a:prstGeom prst="rect">
-            <a:avLst/>
-          </a:prstGeom>
-          <a:solidFill>
-            <a:srgbClr val="8E6F3E"/>
-          </a:solidFill>
-          <a:ln>
-            <a:noFill/>
-          </a:ln>
-        </p:spPr>
-        <p:txBody>
-          <a:bodyPr wrap="square" lIns="27432" tIns="22860" rIns="27432" bIns="22860" anchor="ctr"/>
-          <a:lstStyle/>
-          <a:p>
-            <a:pPr marL="0" marR="0" lvl="0" indent="0" algn="l" defTabSz="457200" rtl="0" eaLnBrk="1" fontAlgn="auto" latinLnBrk="0" hangingPunct="1">
-              <a:lnSpc>
-                <a:spcPct val="100000"/>
-              </a:lnSpc>
-              <a:spcBef>
-                <a:spcPts val="0"/>
-              </a:spcBef>
-              <a:spcAft>
-                <a:spcPts val="0"/>
-              </a:spcAft>
-              <a:buClrTx/>
-              <a:buSzTx/>
-              <a:buFontTx/>
-              <a:buNone/>
-              <a:tabLst/>
-              <a:defRPr/>
-            </a:pPr>
-            <a:endParaRPr kumimoji="0" lang="en-US" sz="1800" b="0" i="0" u="none" strike="noStrike" kern="1200" cap="none" spc="0" normalizeH="0" baseline="0" noProof="0">
-              <a:ln>
-                <a:noFill/>
-              </a:ln>
-              <a:solidFill>
-                <a:srgbClr val="000000"/>
-              </a:solidFill>
-              <a:effectLst/>
-              <a:uLnTx/>
-              <a:uFillTx/>
-              <a:latin typeface="Calibri" panose="020F0502020204030204"/>
-              <a:ea typeface="+mn-ea"/>
-              <a:cs typeface="+mn-cs"/>
-            </a:endParaRPr>
-          </a:p>
-        </p:txBody>
-      </p:sp>
-    </p:spTree>
-  </p:cSld>
-  <p:clrMapOvr>
-    <a:masterClrMapping/>
-  </p:clrMapOvr>
-</p:sld>
-</file>
-
 <file path=ppt/slides/slide42.xml><?xml version="1.0" encoding="utf-8"?>
 <p:sld xmlns:a="http://schemas.openxmlformats.org/drawingml/2006/main" xmlns:p="http://schemas.openxmlformats.org/presentationml/2006/main" xmlns:r="http://schemas.openxmlformats.org/officeDocument/2006/relationships">
   <p:cSld>
@@ -25453,7 +24968,7 @@
                   <a:srgbClr val="000000"/>
                 </a:solidFill>
               </a:rPr>
-              <a:t>Activity: govern the agent</a:t>
+              <a:t>Design the Alignment</a:t>
             </a:r>
           </a:p>
         </p:txBody>
@@ -25530,25 +25045,23 @@
       </p:sp>
       <p:sp>
         <p:nvSpPr>
-          <p:cNvPr id="6" name="Rectangle 5"/>
+          <p:cNvPr id="12" name="FooterBand"/>
           <p:cNvSpPr/>
           <p:nvPr/>
         </p:nvSpPr>
         <p:spPr>
           <a:xfrm>
-            <a:off x="274320" y="1005840"/>
-            <a:ext cx="8595360" cy="731520"/>
+            <a:off x="274320" y="5852160"/>
+            <a:ext cx="8595360" cy="566928"/>
           </a:xfrm>
           <a:prstGeom prst="rect">
             <a:avLst/>
           </a:prstGeom>
           <a:solidFill>
-            <a:srgbClr val="FBF8F2"/>
+            <a:srgbClr val="8E6F3E"/>
           </a:solidFill>
-          <a:ln w="12700">
-            <a:solidFill>
-              <a:srgbClr val="C9B991"/>
-            </a:solidFill>
+          <a:ln>
+            <a:noFill/>
           </a:ln>
           <a:effectLst/>
         </p:spPr>
@@ -25567,39 +25080,31 @@
           </a:fontRef>
         </p:style>
         <p:txBody>
-          <a:bodyPr rtlCol="0" anchor="ctr" wrap="square" lIns="137160" rIns="27432" tIns="73152" bIns="22860"/>
-          <a:lstStyle/>
-          <a:p>
-            <a:pPr algn="l"/>
+          <a:bodyPr rtlCol="0" anchor="ctr" wrap="square"/>
+          <a:lstStyle/>
+          <a:p>
+            <a:pPr algn="ctr"/>
             <a:r>
               <a:rPr sz="2000" b="1" i="0">
                 <a:solidFill>
-                  <a:srgbClr val="8E6F3E"/>
-                </a:solidFill>
-              </a:rPr>
-              <a:t xml:space="preserve">SCENARIO — </a:t>
-            </a:r>
-            <a:r>
-              <a:rPr sz="2000" b="1" i="0">
-                <a:solidFill>
-                  <a:srgbClr val="5C4826"/>
-                </a:solidFill>
-              </a:rPr>
-              <a:t>an agent is modifying an embedded controller.</a:t>
-            </a:r>
-          </a:p>
-        </p:txBody>
-      </p:sp>
-      <p:sp>
-        <p:nvSpPr>
-          <p:cNvPr id="7" name="Rectangle 6"/>
+                  <a:srgbClr val="FFFFFF"/>
+                </a:solidFill>
+              </a:rPr>
+              <a:t>Design the delegated process and its controls. Use the model as given.</a:t>
+            </a:r>
+          </a:p>
+        </p:txBody>
+      </p:sp>
+      <p:sp>
+        <p:nvSpPr>
+          <p:cNvPr id="901" name="Card-obligations"/>
           <p:cNvSpPr/>
           <p:nvPr/>
         </p:nvSpPr>
         <p:spPr>
           <a:xfrm>
-            <a:off x="274320" y="1920240"/>
-            <a:ext cx="8595360" cy="749808"/>
+            <a:off x="274320" y="1051560"/>
+            <a:ext cx="4160520" cy="4526280"/>
           </a:xfrm>
           <a:prstGeom prst="rect">
             <a:avLst/>
@@ -25614,27 +25119,31 @@
           </a:ln>
           <a:effectLst/>
         </p:spPr>
-        <p:style>
-          <a:lnRef idx="1">
-            <a:schemeClr val="accent1"/>
-          </a:lnRef>
-          <a:fillRef idx="3">
-            <a:schemeClr val="accent1"/>
-          </a:fillRef>
-          <a:effectRef idx="2">
-            <a:schemeClr val="accent1"/>
-          </a:effectRef>
-          <a:fontRef idx="minor">
-            <a:schemeClr val="lt1"/>
-          </a:fontRef>
-        </p:style>
-        <p:txBody>
-          <a:bodyPr rtlCol="0" anchor="ctr" wrap="square" lIns="137160" rIns="27432" tIns="73152" bIns="22860"/>
-          <a:lstStyle/>
-          <a:p>
-            <a:pPr algn="l"/>
-            <a:r>
-              <a:rPr sz="2000" b="1" i="0">
+        <p:txBody>
+          <a:bodyPr rtlCol="0" anchor="t" wrap="square" lIns="27432" rIns="27432" tIns="22860" bIns="22860"/>
+          <a:lstStyle/>
+          <a:p>
+            <a:pPr algn="ctr">
+              <a:buNone/>
+            </a:pPr>
+            <a:r>
+              <a:rPr lang="en-US" sz="2000" b="1" i="0" dirty="0">
+                <a:solidFill>
+                  <a:srgbClr val="5C4826"/>
+                </a:solidFill>
+              </a:rPr>
+              <a:t>OBLIGATIONS</a:t>
+            </a:r>
+          </a:p>
+          <a:p>
+            <a:pPr algn="l">
+              <a:spcBef>
+                <a:spcPts val="900"/>
+              </a:spcBef>
+              <a:buNone/>
+            </a:pPr>
+            <a:r>
+              <a:rPr lang="en-US" sz="2000" b="1" i="0" dirty="0">
                 <a:solidFill>
                   <a:srgbClr val="8E6F3E"/>
                 </a:solidFill>
@@ -25642,7 +25151,7 @@
               <a:t xml:space="preserve">1  ·  </a:t>
             </a:r>
             <a:r>
-              <a:rPr sz="2000" b="0" i="0">
+              <a:rPr lang="en-US" sz="2000" b="0" i="0" dirty="0">
                 <a:solidFill>
                   <a:srgbClr val="5C4826"/>
                 </a:solidFill>
@@ -25650,18 +25159,90 @@
               <a:t>Preserve the external API.</a:t>
             </a:r>
           </a:p>
-        </p:txBody>
-      </p:sp>
-      <p:sp>
-        <p:nvSpPr>
-          <p:cNvPr id="8" name="Rectangle 7"/>
+          <a:p>
+            <a:pPr algn="l">
+              <a:spcBef>
+                <a:spcPts val="900"/>
+              </a:spcBef>
+              <a:buNone/>
+            </a:pPr>
+            <a:r>
+              <a:rPr lang="en-US" sz="2000" b="1" i="0" dirty="0">
+                <a:solidFill>
+                  <a:srgbClr val="8E6F3E"/>
+                </a:solidFill>
+              </a:rPr>
+              <a:t xml:space="preserve">2  ·  </a:t>
+            </a:r>
+            <a:r>
+              <a:rPr lang="en-US" sz="2000" b="0" i="0" dirty="0">
+                <a:solidFill>
+                  <a:srgbClr val="5C4826"/>
+                </a:solidFill>
+              </a:rPr>
+              <a:t>Worst-case memory below 64 MB.</a:t>
+            </a:r>
+          </a:p>
+          <a:p>
+            <a:pPr algn="l">
+              <a:spcBef>
+                <a:spcPts val="900"/>
+              </a:spcBef>
+              <a:buNone/>
+            </a:pPr>
+            <a:r>
+              <a:rPr lang="en-US" sz="2000" b="1" i="0" dirty="0">
+                <a:solidFill>
+                  <a:srgbClr val="8E6F3E"/>
+                </a:solidFill>
+              </a:rPr>
+              <a:t xml:space="preserve">3  ·  </a:t>
+            </a:r>
+            <a:r>
+              <a:rPr lang="en-US" sz="2000" b="0" i="0" dirty="0">
+                <a:solidFill>
+                  <a:srgbClr val="5C4826"/>
+                </a:solidFill>
+              </a:rPr>
+              <a:t>Avoid the forbidden dependency.</a:t>
+            </a:r>
+          </a:p>
+          <a:p>
+            <a:pPr algn="l">
+              <a:spcBef>
+                <a:spcPts val="900"/>
+              </a:spcBef>
+              <a:buNone/>
+            </a:pPr>
+            <a:r>
+              <a:rPr lang="en-US" sz="2000" b="1" i="0" dirty="0">
+                <a:solidFill>
+                  <a:srgbClr val="8E6F3E"/>
+                </a:solidFill>
+              </a:rPr>
+              <a:t xml:space="preserve">4  ·  </a:t>
+            </a:r>
+            <a:r>
+              <a:rPr lang="en-US" sz="2000" b="0" i="0" dirty="0">
+                <a:solidFill>
+                  <a:srgbClr val="5C4826"/>
+                </a:solidFill>
+              </a:rPr>
+              <a:t>Preserve the cycle ordering: Sensor.read → decide → Actuator.act.</a:t>
+            </a:r>
+          </a:p>
+        </p:txBody>
+      </p:sp>
+      <p:sp>
+        <p:nvSpPr>
+          <p:cNvPr id="902" name="Card-given-model"/>
           <p:cNvSpPr/>
           <p:nvPr/>
         </p:nvSpPr>
         <p:spPr>
           <a:xfrm>
-            <a:off x="274320" y="2743200"/>
-            <a:ext cx="8595360" cy="749808"/>
+            <a:off x="4617720" y="1051560"/>
+            <a:ext cx="4251960" cy="4526280"/>
           </a:xfrm>
           <a:prstGeom prst="rect">
             <a:avLst/>
@@ -25676,313 +25257,8 @@
           </a:ln>
           <a:effectLst/>
         </p:spPr>
-        <p:style>
-          <a:lnRef idx="1">
-            <a:schemeClr val="accent1"/>
-          </a:lnRef>
-          <a:fillRef idx="3">
-            <a:schemeClr val="accent1"/>
-          </a:fillRef>
-          <a:effectRef idx="2">
-            <a:schemeClr val="accent1"/>
-          </a:effectRef>
-          <a:fontRef idx="minor">
-            <a:schemeClr val="lt1"/>
-          </a:fontRef>
-        </p:style>
-        <p:txBody>
-          <a:bodyPr rtlCol="0" anchor="ctr" wrap="square" lIns="137160" rIns="27432" tIns="73152" bIns="22860"/>
-          <a:lstStyle/>
-          <a:p>
-            <a:pPr algn="l"/>
-            <a:r>
-              <a:rPr sz="2000" b="1" i="0">
-                <a:solidFill>
-                  <a:srgbClr val="8E6F3E"/>
-                </a:solidFill>
-              </a:rPr>
-              <a:t xml:space="preserve">2  ·  </a:t>
-            </a:r>
-            <a:r>
-              <a:rPr sz="2000" b="0" i="0">
-                <a:solidFill>
-                  <a:srgbClr val="5C4826"/>
-                </a:solidFill>
-              </a:rPr>
-              <a:t>Worst-case memory below 64 MB.</a:t>
-            </a:r>
-          </a:p>
-        </p:txBody>
-      </p:sp>
-      <p:sp>
-        <p:nvSpPr>
-          <p:cNvPr id="9" name="Rectangle 8"/>
-          <p:cNvSpPr/>
-          <p:nvPr/>
-        </p:nvSpPr>
-        <p:spPr>
-          <a:xfrm>
-            <a:off x="274320" y="3566160"/>
-            <a:ext cx="8595360" cy="749808"/>
-          </a:xfrm>
-          <a:prstGeom prst="rect">
-            <a:avLst/>
-          </a:prstGeom>
-          <a:solidFill>
-            <a:srgbClr val="F5F1E8"/>
-          </a:solidFill>
-          <a:ln w="12700">
-            <a:solidFill>
-              <a:srgbClr val="C9B991"/>
-            </a:solidFill>
-          </a:ln>
-          <a:effectLst/>
-        </p:spPr>
-        <p:style>
-          <a:lnRef idx="1">
-            <a:schemeClr val="accent1"/>
-          </a:lnRef>
-          <a:fillRef idx="3">
-            <a:schemeClr val="accent1"/>
-          </a:fillRef>
-          <a:effectRef idx="2">
-            <a:schemeClr val="accent1"/>
-          </a:effectRef>
-          <a:fontRef idx="minor">
-            <a:schemeClr val="lt1"/>
-          </a:fontRef>
-        </p:style>
-        <p:txBody>
-          <a:bodyPr rtlCol="0" anchor="ctr" wrap="square" lIns="137160" rIns="27432" tIns="73152" bIns="22860"/>
-          <a:lstStyle/>
-          <a:p>
-            <a:pPr algn="l"/>
-            <a:r>
-              <a:rPr sz="2000" b="1" i="0">
-                <a:solidFill>
-                  <a:srgbClr val="8E6F3E"/>
-                </a:solidFill>
-              </a:rPr>
-              <a:t xml:space="preserve">3  ·  </a:t>
-            </a:r>
-            <a:r>
-              <a:rPr sz="2000" b="0" i="0">
-                <a:solidFill>
-                  <a:srgbClr val="5C4826"/>
-                </a:solidFill>
-              </a:rPr>
-              <a:t>Avoid the forbidden dependency.</a:t>
-            </a:r>
-          </a:p>
-        </p:txBody>
-      </p:sp>
-      <p:sp>
-        <p:nvSpPr>
-          <p:cNvPr id="10" name="Rectangle 9"/>
-          <p:cNvSpPr/>
-          <p:nvPr/>
-        </p:nvSpPr>
-        <p:spPr>
-          <a:xfrm>
-            <a:off x="274320" y="4389120"/>
-            <a:ext cx="8595360" cy="749808"/>
-          </a:xfrm>
-          <a:prstGeom prst="rect">
-            <a:avLst/>
-          </a:prstGeom>
-          <a:solidFill>
-            <a:srgbClr val="F5F1E8"/>
-          </a:solidFill>
-          <a:ln w="12700">
-            <a:solidFill>
-              <a:srgbClr val="C9B991"/>
-            </a:solidFill>
-          </a:ln>
-          <a:effectLst/>
-        </p:spPr>
-        <p:style>
-          <a:lnRef idx="1">
-            <a:schemeClr val="accent1"/>
-          </a:lnRef>
-          <a:fillRef idx="3">
-            <a:schemeClr val="accent1"/>
-          </a:fillRef>
-          <a:effectRef idx="2">
-            <a:schemeClr val="accent1"/>
-          </a:effectRef>
-          <a:fontRef idx="minor">
-            <a:schemeClr val="lt1"/>
-          </a:fontRef>
-        </p:style>
-        <p:txBody>
-          <a:bodyPr rtlCol="0" anchor="ctr" wrap="square" lIns="137160" rIns="27432" tIns="73152" bIns="22860"/>
-          <a:lstStyle/>
-          <a:p>
-            <a:pPr algn="l"/>
-            <a:r>
-              <a:rPr sz="2000" b="1" i="0">
-                <a:solidFill>
-                  <a:srgbClr val="8E6F3E"/>
-                </a:solidFill>
-              </a:rPr>
-              <a:t xml:space="preserve">4  ·  </a:t>
-            </a:r>
-            <a:r>
-              <a:rPr sz="2000" b="0" i="0">
-                <a:solidFill>
-                  <a:srgbClr val="5C4826"/>
-                </a:solidFill>
-              </a:rPr>
-              <a:t>Preserve the cycle ordering: Sensor.read → decide → Actuator.act.</a:t>
-            </a:r>
-          </a:p>
-        </p:txBody>
-      </p:sp>
-      <p:sp>
-        <p:nvSpPr>
-          <p:cNvPr id="12" name="FooterBand"/>
-          <p:cNvSpPr/>
-          <p:nvPr/>
-        </p:nvSpPr>
-        <p:spPr>
-          <a:xfrm>
-            <a:off x="274320" y="5852160"/>
-            <a:ext cx="8595360" cy="566928"/>
-          </a:xfrm>
-          <a:prstGeom prst="rect">
-            <a:avLst/>
-          </a:prstGeom>
-          <a:solidFill>
-            <a:srgbClr val="8E6F3E"/>
-          </a:solidFill>
-          <a:ln>
-            <a:noFill/>
-          </a:ln>
-          <a:effectLst/>
-        </p:spPr>
-        <p:style>
-          <a:lnRef idx="1">
-            <a:schemeClr val="accent1"/>
-          </a:lnRef>
-          <a:fillRef idx="3">
-            <a:schemeClr val="accent1"/>
-          </a:fillRef>
-          <a:effectRef idx="2">
-            <a:schemeClr val="accent1"/>
-          </a:effectRef>
-          <a:fontRef idx="minor">
-            <a:schemeClr val="lt1"/>
-          </a:fontRef>
-        </p:style>
-        <p:txBody>
-          <a:bodyPr rtlCol="0" anchor="ctr" wrap="square"/>
-          <a:lstStyle/>
-          <a:p>
-            <a:pPr algn="ctr"/>
-            <a:r>
-              <a:rPr sz="2000" b="1" i="0">
-                <a:solidFill>
-                  <a:srgbClr val="FFFFFF"/>
-                </a:solidFill>
-              </a:rPr>
-              <a:t>Design the delegated process and its controls.</a:t>
-            </a:r>
-          </a:p>
-        </p:txBody>
-      </p:sp>
-    </p:spTree>
-  </p:cSld>
-  <p:clrMapOvr>
-    <a:masterClrMapping/>
-  </p:clrMapOvr>
-</p:sld>
-</file>
-
-<file path=ppt/slides/slide43.xml><?xml version="1.0" encoding="utf-8"?>
-<p:sld xmlns:a="http://schemas.openxmlformats.org/drawingml/2006/main" xmlns:p="http://schemas.openxmlformats.org/presentationml/2006/main" xmlns:r="http://schemas.openxmlformats.org/officeDocument/2006/relationships">
-  <p:cSld>
-    <p:spTree>
-      <p:nvGrpSpPr>
-        <p:cNvPr id="1" name=""/>
-        <p:cNvGrpSpPr/>
-        <p:nvPr/>
-      </p:nvGrpSpPr>
-      <p:grpSpPr/>
-      <p:sp>
-        <p:nvSpPr>
-          <p:cNvPr id="3" name="Title 2"/>
-          <p:cNvSpPr>
-            <a:spLocks noGrp="1"/>
-          </p:cNvSpPr>
-          <p:nvPr>
-            <p:ph type="title"/>
-          </p:nvPr>
-        </p:nvSpPr>
-        <p:spPr/>
-        <p:txBody>
-          <a:bodyPr wrap="square"/>
-          <a:lstStyle/>
-          <a:p>
-            <a:r>
-              <a:rPr sz="2400" b="0">
-                <a:solidFill>
-                  <a:srgbClr val="000000"/>
-                </a:solidFill>
-              </a:rPr>
-              <a:t>The given model</a:t>
-            </a:r>
-          </a:p>
-        </p:txBody>
-      </p:sp>
-      <p:sp>
-        <p:nvSpPr>
-          <p:cNvPr id="4" name="Slide Number Placeholder 5"/>
-          <p:cNvSpPr>
-            <a:spLocks noGrp="1"/>
-          </p:cNvSpPr>
-          <p:nvPr>
-            <p:ph type="sldNum" sz="quarter" idx="4"/>
-          </p:nvPr>
-        </p:nvSpPr>
-        <p:spPr/>
-        <p:txBody>
-          <a:bodyPr/>
-          <a:lstStyle/>
-          <a:p>
-            <a:fld id="{B7EB45DA-9A0D-DC49-8E02-F30A5DDC21C3}" type="slidenum">
-              <a:rPr lang="en-US" smtClean="0"/>
-              <a:t>1</a:t>
-            </a:fld>
-            <a:endParaRPr lang="en-US"/>
-          </a:p>
-        </p:txBody>
-      </p:sp>
-      <p:sp>
-        <p:nvSpPr>
-          <p:cNvPr id="0" name="LabKicker"/>
-          <p:cNvSpPr/>
-          <p:nvPr/>
-        </p:nvSpPr>
-        <p:spPr>
-          <a:xfrm>
-            <a:off x="5349240" y="205000"/>
-            <a:ext cx="3520440" cy="470000"/>
-          </a:xfrm>
-          <a:prstGeom prst="roundRect">
-            <a:avLst/>
-          </a:prstGeom>
-          <a:solidFill>
-            <a:srgbClr val="FBF8F2"/>
-          </a:solidFill>
-          <a:ln w="15875">
-            <a:solidFill>
-              <a:srgbClr val="8E6F3E"/>
-            </a:solidFill>
-          </a:ln>
-          <a:effectLst/>
-        </p:spPr>
-        <p:txBody>
-          <a:bodyPr rtlCol="0" anchor="ctr" wrap="square" lIns="27432" rIns="27432" tIns="22860" bIns="22860"/>
+        <p:txBody>
+          <a:bodyPr rtlCol="0" anchor="t" wrap="square" lIns="27432" rIns="27432" tIns="22860" bIns="22860"/>
           <a:lstStyle/>
           <a:p>
             <a:pPr algn="ctr">
@@ -25991,52 +25267,10 @@
             <a:r>
               <a:rPr lang="en-US" sz="2000" b="1" i="0" dirty="0">
                 <a:solidFill>
-                  <a:srgbClr val="8E6F3E"/>
-                </a:solidFill>
-              </a:rPr>
-              <a:t>THE LAB'S DOMAIN AGAIN</a:t>
-            </a:r>
-          </a:p>
-        </p:txBody>
-      </p:sp>
-      <p:sp>
-        <p:nvSpPr>
-          <p:cNvPr id="0" name="GM-structure"/>
-          <p:cNvSpPr/>
-          <p:nvPr/>
-        </p:nvSpPr>
-        <p:spPr>
-          <a:xfrm>
-            <a:off x="502920" y="1051560"/>
-            <a:ext cx="3977639" cy="4038600"/>
-          </a:xfrm>
-          <a:prstGeom prst="rect">
-            <a:avLst/>
-          </a:prstGeom>
-          <a:solidFill>
-            <a:srgbClr val="F5F1E8"/>
-          </a:solidFill>
-          <a:ln w="12700">
-            <a:solidFill>
-              <a:srgbClr val="C9B991"/>
-            </a:solidFill>
-          </a:ln>
-          <a:effectLst/>
-        </p:spPr>
-        <p:txBody>
-          <a:bodyPr rtlCol="0" anchor="t" wrap="square" lIns="27432" rIns="27432" tIns="22860" bIns="22860"/>
-          <a:lstStyle/>
-          <a:p>
-            <a:pPr algn="ctr">
-              <a:buNone/>
-            </a:pPr>
-            <a:r>
-              <a:rPr lang="en-US" sz="2000" b="1" i="0" dirty="0">
-                <a:solidFill>
                   <a:srgbClr val="5C4826"/>
                 </a:solidFill>
               </a:rPr>
-              <a:t>STRUCTURE</a:t>
+              <a:t>THE GIVEN MODEL</a:t>
             </a:r>
           </a:p>
           <a:p>
@@ -26047,12 +25281,12 @@
               <a:buNone/>
             </a:pPr>
             <a:r>
-              <a:rPr lang="en-US" sz="2000" b="0" i="0" dirty="0">
-                <a:solidFill>
-                  <a:srgbClr val="5C4826"/>
-                </a:solidFill>
-              </a:rPr>
-              <a:t>Controller — API: IController</a:t>
+              <a:rPr lang="en-US" sz="2000" b="1" i="0" dirty="0">
+                <a:solidFill>
+                  <a:srgbClr val="8E6F3E"/>
+                </a:solidFill>
+              </a:rPr>
+              <a:t>STRUCTURE</a:t>
             </a:r>
           </a:p>
           <a:p>
@@ -26068,7 +25302,7 @@
                   <a:srgbClr val="5C4826"/>
                 </a:solidFill>
               </a:rPr>
-              <a:t>uses → Sensor</a:t>
+              <a:t>Controller — API: IController</a:t>
             </a:r>
           </a:p>
           <a:p>
@@ -26084,7 +25318,7 @@
                   <a:srgbClr val="5C4826"/>
                 </a:solidFill>
               </a:rPr>
-              <a:t>uses → Actuator</a:t>
+              <a:t>uses → Sensor · Actuator</a:t>
             </a:r>
           </a:p>
           <a:p>
@@ -26119,48 +25353,6 @@
               <a:t>memory ≤ 64 MB</a:t>
             </a:r>
           </a:p>
-        </p:txBody>
-      </p:sp>
-      <p:sp>
-        <p:nvSpPr>
-          <p:cNvPr id="0" name="GM-behavior"/>
-          <p:cNvSpPr/>
-          <p:nvPr/>
-        </p:nvSpPr>
-        <p:spPr>
-          <a:xfrm>
-            <a:off x="4663440" y="1051560"/>
-            <a:ext cx="3977639" cy="4038600"/>
-          </a:xfrm>
-          <a:prstGeom prst="rect">
-            <a:avLst/>
-          </a:prstGeom>
-          <a:solidFill>
-            <a:srgbClr val="F5F1E8"/>
-          </a:solidFill>
-          <a:ln w="12700">
-            <a:solidFill>
-              <a:srgbClr val="C9B991"/>
-            </a:solidFill>
-          </a:ln>
-          <a:effectLst/>
-        </p:spPr>
-        <p:txBody>
-          <a:bodyPr rtlCol="0" anchor="t" wrap="square" lIns="27432" rIns="27432" tIns="22860" bIns="22860"/>
-          <a:lstStyle/>
-          <a:p>
-            <a:pPr algn="ctr">
-              <a:buNone/>
-            </a:pPr>
-            <a:r>
-              <a:rPr lang="en-US" sz="2000" b="1" i="0" dirty="0">
-                <a:solidFill>
-                  <a:srgbClr val="5C4826"/>
-                </a:solidFill>
-              </a:rPr>
-              <a:t>BEHAVIOR</a:t>
-            </a:r>
-          </a:p>
           <a:p>
             <a:pPr algn="l">
               <a:spcBef>
@@ -26169,12 +25361,12 @@
               <a:buNone/>
             </a:pPr>
             <a:r>
-              <a:rPr lang="en-US" sz="2000" b="0" i="0" dirty="0">
-                <a:solidFill>
-                  <a:srgbClr val="5C4826"/>
-                </a:solidFill>
-              </a:rPr>
-              <a:t>each cycle:</a:t>
+              <a:rPr lang="en-US" sz="2000" b="1" i="0" dirty="0">
+                <a:solidFill>
+                  <a:srgbClr val="8E6F3E"/>
+                </a:solidFill>
+              </a:rPr>
+              <a:t>BEHAVIOR</a:t>
             </a:r>
           </a:p>
           <a:p>
@@ -26185,100 +25377,12 @@
               <a:buNone/>
             </a:pPr>
             <a:r>
-              <a:rPr lang="en-US" sz="2000" b="1" i="0" dirty="0">
+              <a:rPr lang="en-US" sz="2000" b="0" i="0" dirty="0">
                 <a:solidFill>
                   <a:srgbClr val="5C4826"/>
                 </a:solidFill>
               </a:rPr>
-              <a:t>Sensor.read</a:t>
-            </a:r>
-          </a:p>
-          <a:p>
-            <a:pPr algn="l">
-              <a:spcBef>
-                <a:spcPts val="900"/>
-              </a:spcBef>
-              <a:buNone/>
-            </a:pPr>
-            <a:r>
-              <a:rPr lang="en-US" sz="2000" b="1" i="0" dirty="0">
-                <a:solidFill>
-                  <a:srgbClr val="5C4826"/>
-                </a:solidFill>
-              </a:rPr>
-              <a:t>→ decide</a:t>
-            </a:r>
-          </a:p>
-          <a:p>
-            <a:pPr algn="l">
-              <a:spcBef>
-                <a:spcPts val="900"/>
-              </a:spcBef>
-              <a:buNone/>
-            </a:pPr>
-            <a:r>
-              <a:rPr lang="en-US" sz="2000" b="1" i="0" dirty="0">
-                <a:solidFill>
-                  <a:srgbClr val="5C4826"/>
-                </a:solidFill>
-              </a:rPr>
-              <a:t>→ Actuator.act</a:t>
-            </a:r>
-          </a:p>
-          <a:p>
-            <a:pPr algn="l">
-              <a:spcBef>
-                <a:spcPts val="900"/>
-              </a:spcBef>
-              <a:buNone/>
-            </a:pPr>
-            <a:r>
-              <a:rPr lang="en-US" sz="2000" b="0" i="1" dirty="0">
-                <a:solidFill>
-                  <a:srgbClr val="555960"/>
-                </a:solidFill>
-              </a:rPr>
-              <a:t>an ordering obligation over execution</a:t>
-            </a:r>
-          </a:p>
-        </p:txBody>
-      </p:sp>
-      <p:sp>
-        <p:nvSpPr>
-          <p:cNvPr id="0" name="FooterBand"/>
-          <p:cNvSpPr/>
-          <p:nvPr/>
-        </p:nvSpPr>
-        <p:spPr>
-          <a:xfrm>
-            <a:off x="274320" y="5760720"/>
-            <a:ext cx="8595360" cy="777240"/>
-          </a:xfrm>
-          <a:prstGeom prst="rect">
-            <a:avLst/>
-          </a:prstGeom>
-          <a:solidFill>
-            <a:srgbClr val="8E6F3E"/>
-          </a:solidFill>
-          <a:ln>
-            <a:noFill/>
-          </a:ln>
-          <a:effectLst/>
-        </p:spPr>
-        <p:txBody>
-          <a:bodyPr rtlCol="0" anchor="ctr" wrap="square" lIns="27432" rIns="27432" tIns="22860" bIns="22860"/>
-          <a:lstStyle/>
-          <a:p>
-            <a:pPr algn="ctr">
-              <a:buNone/>
-            </a:pPr>
-            <a:r>
-              <a:rPr lang="en-US" sz="2000" b="1" i="0" dirty="0">
-                <a:solidFill>
-                  <a:srgbClr val="FFFFFF"/>
-                </a:solidFill>
-              </a:rPr>
-              <a:t>Use the model as given — do not rediscover it from the implementation.</a:t>
+              <a:t>each cycle: Sensor.read → decide → Actuator.act</a:t>
             </a:r>
           </a:p>
         </p:txBody>

</xml_diff>

<commit_message>
deck 2-3: cut 5 — drop the two pre-section beats; lab-models slide opens Section 5 as the discussion, 'knowledge explicit' becomes the answer (44->42)
</commit_message>
<xml_diff>
--- a/course/lectures/act-2-delegation-and-control/03-alignment/2-3-Alignment.pptx
+++ b/course/lectures/act-2-delegation-and-control/03-alignment/2-3-Alignment.pptx
@@ -39,10 +39,8 @@
     <p:sldId id="303" r:id="rId55"/>
     <p:sldId id="273" r:id="rId24"/>
     <p:sldId id="288" r:id="rId53"/>
-    <p:sldId id="277" r:id="rId28"/>
-    <p:sldId id="278" r:id="rId29"/>
+    <p:sldId id="307" r:id="rId10"/>
     <p:sldId id="279" r:id="rId30"/>
-    <p:sldId id="307" r:id="rId10"/>
     <p:sldId id="308" r:id="rId8"/>
     <p:sldId id="309" r:id="rId6"/>
     <p:sldId id="310" r:id="rId5"/>
@@ -2048,191 +2046,6 @@
 </p:notes>
 </file>
 
-<file path=ppt/notesSlides/notesSlide22.xml><?xml version="1.0" encoding="utf-8"?>
-<p:notes xmlns:a="http://schemas.openxmlformats.org/drawingml/2006/main" xmlns:p="http://schemas.openxmlformats.org/presentationml/2006/main" xmlns:r="http://schemas.openxmlformats.org/officeDocument/2006/relationships">
-  <p:cSld>
-    <p:spTree>
-      <p:nvGrpSpPr>
-        <p:cNvPr id="1" name=""/>
-        <p:cNvGrpSpPr/>
-        <p:nvPr/>
-      </p:nvGrpSpPr>
-      <p:grpSpPr>
-        <a:xfrm>
-          <a:off x="0" y="0"/>
-          <a:ext cx="0" cy="0"/>
-          <a:chOff x="0" y="0"/>
-          <a:chExt cx="0" cy="0"/>
-        </a:xfrm>
-      </p:grpSpPr>
-      <p:sp>
-        <p:nvSpPr>
-          <p:cNvPr id="2" name="Slide Image Placeholder 1"/>
-          <p:cNvSpPr>
-            <a:spLocks noGrp="1"/>
-          </p:cNvSpPr>
-          <p:nvPr>
-            <p:ph type="sldImg" idx="2"/>
-          </p:nvPr>
-        </p:nvSpPr>
-        <p:spPr/>
-      </p:sp>
-      <p:sp>
-        <p:nvSpPr>
-          <p:cNvPr id="3" name="Notes Placeholder 2"/>
-          <p:cNvSpPr>
-            <a:spLocks noGrp="1"/>
-          </p:cNvSpPr>
-          <p:nvPr>
-            <p:ph type="body" idx="3" sz="quarter"/>
-          </p:nvPr>
-        </p:nvSpPr>
-        <p:spPr/>
-        <p:txBody>
-          <a:bodyPr/>
-          <a:lstStyle/>
-          <a:p>
-            <a:r>
-              <a:t>TIMING: 1 minute</a:t>
-            </a:r>
-          </a:p>
-          <a:p>
-            <a:r>
-              <a:t>- Everything so far could be done with tests, permissions, CI, repository state, and ordinary process controls.</a:t>
-            </a:r>
-          </a:p>
-          <a:p>
-            <a:r>
-              <a:t>- We reasoned about obligations, evidence, validators, constraints, gates, and authority.</a:t>
-            </a:r>
-          </a:p>
-          <a:p>
-            <a:r>
-              <a:t>- No explicit model was logically required.</a:t>
-            </a:r>
-          </a:p>
-          <a:p>
-            <a:r>
-              <a:t>- So explicit modeling has to earn its cost.</a:t>
-            </a:r>
-          </a:p>
-          <a:p>
-            <a:r>
-              <a:t>- What does it let us do better?</a:t>
-            </a:r>
-          </a:p>
-        </p:txBody>
-      </p:sp>
-      <p:sp>
-        <p:nvSpPr>
-          <p:cNvPr id="4" name="Slide Number Placeholder 3"/>
-          <p:cNvSpPr>
-            <a:spLocks noGrp="1"/>
-          </p:cNvSpPr>
-          <p:nvPr>
-            <p:ph type="sldNum" idx="5" sz="quarter"/>
-          </p:nvPr>
-        </p:nvSpPr>
-        <p:spPr/>
-      </p:sp>
-    </p:spTree>
-  </p:cSld>
-  <p:clrMapOvr>
-    <a:masterClrMapping/>
-  </p:clrMapOvr>
-</p:notes>
-</file>
-
-<file path=ppt/notesSlides/notesSlide23.xml><?xml version="1.0" encoding="utf-8"?>
-<p:notes xmlns:a="http://schemas.openxmlformats.org/drawingml/2006/main" xmlns:p="http://schemas.openxmlformats.org/presentationml/2006/main" xmlns:r="http://schemas.openxmlformats.org/officeDocument/2006/relationships">
-  <p:cSld>
-    <p:spTree>
-      <p:nvGrpSpPr>
-        <p:cNvPr id="1" name=""/>
-        <p:cNvGrpSpPr/>
-        <p:nvPr/>
-      </p:nvGrpSpPr>
-      <p:grpSpPr>
-        <a:xfrm>
-          <a:off x="0" y="0"/>
-          <a:ext cx="0" cy="0"/>
-          <a:chOff x="0" y="0"/>
-          <a:chExt cx="0" cy="0"/>
-        </a:xfrm>
-      </p:grpSpPr>
-      <p:sp>
-        <p:nvSpPr>
-          <p:cNvPr id="2" name="Slide Image Placeholder 1"/>
-          <p:cNvSpPr>
-            <a:spLocks noGrp="1"/>
-          </p:cNvSpPr>
-          <p:nvPr>
-            <p:ph type="sldImg" idx="2"/>
-          </p:nvPr>
-        </p:nvSpPr>
-        <p:spPr/>
-      </p:sp>
-      <p:sp>
-        <p:nvSpPr>
-          <p:cNvPr id="3" name="Notes Placeholder 2"/>
-          <p:cNvSpPr>
-            <a:spLocks noGrp="1"/>
-          </p:cNvSpPr>
-          <p:nvPr>
-            <p:ph type="body" idx="3" sz="quarter"/>
-          </p:nvPr>
-        </p:nvSpPr>
-        <p:spPr/>
-        <p:txBody>
-          <a:bodyPr/>
-          <a:lstStyle/>
-          <a:p>
-            <a:r>
-              <a:t>TIMING: 2 minutes</a:t>
-            </a:r>
-          </a:p>
-          <a:p>
-            <a:r>
-              <a:t>- Ask the room before answering.</a:t>
-            </a:r>
-          </a:p>
-          <a:p>
-            <a:r>
-              <a:t>- Look for answers about preserving knowledge, making relationships inspectable, enabling analysis, reducing repeated reconstruction, and separating what matters from what does not.</a:t>
-            </a:r>
-          </a:p>
-          <a:p>
-            <a:r>
-              <a:t>- Push beyond "documentation." If the model is only documentation, it is not yet clear why Alignment cares.</a:t>
-            </a:r>
-          </a:p>
-          <a:p>
-            <a:r>
-              <a:t>- Ask: what could a control do with a model that is difficult to do with prose or by repeatedly inspecting implementation?</a:t>
-            </a:r>
-          </a:p>
-        </p:txBody>
-      </p:sp>
-      <p:sp>
-        <p:nvSpPr>
-          <p:cNvPr id="4" name="Slide Number Placeholder 3"/>
-          <p:cNvSpPr>
-            <a:spLocks noGrp="1"/>
-          </p:cNvSpPr>
-          <p:nvPr>
-            <p:ph type="sldNum" idx="5" sz="quarter"/>
-          </p:nvPr>
-        </p:nvSpPr>
-        <p:spPr/>
-      </p:sp>
-    </p:spTree>
-  </p:cSld>
-  <p:clrMapOvr>
-    <a:masterClrMapping/>
-  </p:clrMapOvr>
-</p:notes>
-</file>
-
 <file path=ppt/notesSlides/notesSlide24.xml><?xml version="1.0" encoding="utf-8"?>
 <p:notes xmlns:a="http://schemas.openxmlformats.org/drawingml/2006/main" xmlns:p="http://schemas.openxmlformats.org/presentationml/2006/main" xmlns:r="http://schemas.openxmlformats.org/officeDocument/2006/relationships">
   <p:cSld>
@@ -2279,6 +2092,11 @@
           <a:p>
             <a:r>
               <a:t>TIMING: 2 minutes</a:t>
+            </a:r>
+          </a:p>
+          <a:p>
+            <a:r>
+              <a:t>- This slide is the ANSWER to the discussion on the previous slide — show it only after the students talk.</a:t>
             </a:r>
           </a:p>
           <a:p>
@@ -4469,7 +4287,22 @@
           </a:p>
           <a:p>
             <a:r>
+              <a:t>- This is now the section's opening DISCUSSION (it absorbs the deleted "We just did Alignment without models" and "What do models buy us?" beats). Frame it: everything in Sections 1-4 used tests, permissions, CI, and ordinary process controls — no explicit model was logically required, so explicit modeling has to earn its cost.</a:t>
+            </a:r>
+          </a:p>
+          <a:p>
+            <a:r>
               <a:t>- Pose the footer question and DO NOT answer it immediately. Let them discuss.</a:t>
+            </a:r>
+          </a:p>
+          <a:p>
+            <a:r>
+              <a:t>- Look for answers about preserving knowledge, making relationships inspectable, enabling analysis, and reducing repeated reconstruction. Push beyond "documentation": what could a control do with a model that is difficult to do with prose or by repeatedly inspecting the implementation?</a:t>
+            </a:r>
+          </a:p>
+          <a:p>
+            <a:r>
+              <a:t>- The next slide is the answer — show it after they talk.</a:t>
             </a:r>
           </a:p>
         </p:txBody>
@@ -21270,303 +21103,6 @@
 </p:sld>
 </file>
 
-<file path=ppt/slides/slide32.xml><?xml version="1.0" encoding="utf-8"?>
-<p:sld xmlns:a="http://schemas.openxmlformats.org/drawingml/2006/main" xmlns:p="http://schemas.openxmlformats.org/presentationml/2006/main" xmlns:r="http://schemas.openxmlformats.org/officeDocument/2006/relationships">
-  <p:cSld>
-    <p:spTree>
-      <p:nvGrpSpPr>
-        <p:cNvPr id="1" name=""/>
-        <p:cNvGrpSpPr/>
-        <p:nvPr/>
-      </p:nvGrpSpPr>
-      <p:grpSpPr/>
-      <p:sp>
-        <p:nvSpPr>
-          <p:cNvPr id="3" name="Title 2"/>
-          <p:cNvSpPr>
-            <a:spLocks noGrp="1"/>
-          </p:cNvSpPr>
-          <p:nvPr>
-            <p:ph type="title"/>
-          </p:nvPr>
-        </p:nvSpPr>
-        <p:spPr/>
-        <p:txBody>
-          <a:bodyPr wrap="square"/>
-          <a:lstStyle/>
-          <a:p>
-            <a:r>
-              <a:rPr sz="2400" b="0">
-                <a:solidFill>
-                  <a:srgbClr val="000000"/>
-                </a:solidFill>
-              </a:rPr>
-              <a:t>We just did Alignment without models</a:t>
-            </a:r>
-          </a:p>
-        </p:txBody>
-      </p:sp>
-      <p:sp>
-        <p:nvSpPr>
-          <p:cNvPr id="4" name="Slide Number Placeholder 5"/>
-          <p:cNvSpPr>
-            <a:spLocks noGrp="1"/>
-          </p:cNvSpPr>
-          <p:nvPr>
-            <p:ph type="sldNum" sz="quarter" idx="4"/>
-          </p:nvPr>
-        </p:nvSpPr>
-        <p:spPr/>
-        <p:txBody>
-          <a:bodyPr/>
-          <a:lstStyle/>
-          <a:p>
-            <a:fld id="{B7EB45DA-9A0D-DC49-8E02-F30A5DDC21C3}" type="slidenum">
-              <a:rPr lang="en-US" smtClean="0"/>
-              <a:t>1</a:t>
-            </a:fld>
-            <a:endParaRPr lang="en-US"/>
-          </a:p>
-        </p:txBody>
-      </p:sp>
-      <p:sp>
-        <p:nvSpPr>
-          <p:cNvPr id="5" name="TextBox 4"/>
-          <p:cNvSpPr txBox="1"/>
-          <p:nvPr/>
-        </p:nvSpPr>
-        <p:spPr>
-          <a:xfrm>
-            <a:off x="548640" y="1645920"/>
-            <a:ext cx="8046720" cy="1463040"/>
-          </a:xfrm>
-          <a:prstGeom prst="rect">
-            <a:avLst/>
-          </a:prstGeom>
-          <a:noFill/>
-        </p:spPr>
-        <p:txBody>
-          <a:bodyPr wrap="square" anchor="ctr">
-            <a:spAutoFit/>
-          </a:bodyPr>
-          <a:lstStyle/>
-          <a:p>
-            <a:pPr algn="ctr"/>
-            <a:r>
-              <a:rPr sz="2400" b="1" i="0">
-                <a:solidFill>
-                  <a:srgbClr val="000000"/>
-                </a:solidFill>
-              </a:rPr>
-              <a:t>We just reasoned about constraints, evidence, evaluation, and authority.</a:t>
-            </a:r>
-          </a:p>
-          <a:p>
-            <a:pPr algn="ctr"/>
-            <a:r>
-              <a:rPr sz="2400" b="1" i="0">
-                <a:solidFill>
-                  <a:srgbClr val="000000"/>
-                </a:solidFill>
-              </a:rPr>
-              <a:t>No explicit model was required.</a:t>
-            </a:r>
-          </a:p>
-        </p:txBody>
-      </p:sp>
-      <p:sp>
-        <p:nvSpPr>
-          <p:cNvPr id="6" name="TextBox 5"/>
-          <p:cNvSpPr txBox="1"/>
-          <p:nvPr/>
-        </p:nvSpPr>
-        <p:spPr>
-          <a:xfrm>
-            <a:off x="548640" y="3840480"/>
-            <a:ext cx="8046720" cy="548640"/>
-          </a:xfrm>
-          <a:prstGeom prst="rect">
-            <a:avLst/>
-          </a:prstGeom>
-          <a:noFill/>
-        </p:spPr>
-        <p:txBody>
-          <a:bodyPr wrap="square" anchor="t">
-            <a:spAutoFit/>
-          </a:bodyPr>
-          <a:lstStyle/>
-          <a:p>
-            <a:pPr algn="ctr"/>
-            <a:r>
-              <a:rPr sz="2300" b="0" i="1">
-                <a:solidFill>
-                  <a:srgbClr val="8E6F3E"/>
-                </a:solidFill>
-              </a:rPr>
-              <a:t>So why did we spend the previous lecture on Modeling?</a:t>
-            </a:r>
-          </a:p>
-        </p:txBody>
-      </p:sp>
-    </p:spTree>
-  </p:cSld>
-  <p:clrMapOvr>
-    <a:masterClrMapping/>
-  </p:clrMapOvr>
-</p:sld>
-</file>
-
-<file path=ppt/slides/slide33.xml><?xml version="1.0" encoding="utf-8"?>
-<p:sld xmlns:a="http://schemas.openxmlformats.org/drawingml/2006/main" xmlns:p="http://schemas.openxmlformats.org/presentationml/2006/main" xmlns:r="http://schemas.openxmlformats.org/officeDocument/2006/relationships">
-  <p:cSld>
-    <p:spTree>
-      <p:nvGrpSpPr>
-        <p:cNvPr id="1" name=""/>
-        <p:cNvGrpSpPr/>
-        <p:nvPr/>
-      </p:nvGrpSpPr>
-      <p:grpSpPr/>
-      <p:sp>
-        <p:nvSpPr>
-          <p:cNvPr id="2" name="Title 1"/>
-          <p:cNvSpPr>
-            <a:spLocks noGrp="1"/>
-          </p:cNvSpPr>
-          <p:nvPr>
-            <p:ph type="title"/>
-          </p:nvPr>
-        </p:nvSpPr>
-        <p:spPr>
-          <a:xfrm>
-            <a:off x="685800" y="1700784"/>
-            <a:ext cx="7772400" cy="1005840"/>
-          </a:xfrm>
-        </p:spPr>
-        <p:txBody>
-          <a:bodyPr wrap="square"/>
-          <a:lstStyle/>
-          <a:p>
-            <a:pPr algn="ctr"/>
-            <a:r>
-              <a:rPr sz="4000">
-                <a:solidFill>
-                  <a:srgbClr val="000000"/>
-                </a:solidFill>
-              </a:rPr>
-              <a:t>What do models buy us?</a:t>
-            </a:r>
-          </a:p>
-        </p:txBody>
-      </p:sp>
-      <p:sp>
-        <p:nvSpPr>
-          <p:cNvPr id="3" name="Slide Number Placeholder 5"/>
-          <p:cNvSpPr>
-            <a:spLocks noGrp="1"/>
-          </p:cNvSpPr>
-          <p:nvPr>
-            <p:ph type="sldNum" sz="quarter" idx="4"/>
-          </p:nvPr>
-        </p:nvSpPr>
-        <p:spPr/>
-        <p:txBody>
-          <a:bodyPr/>
-          <a:lstStyle/>
-          <a:p>
-            <a:fld id="{B7EB45DA-9A0D-DC49-8E02-F30A5DDC21C3}" type="slidenum">
-              <a:rPr lang="en-US" smtClean="0"/>
-              <a:t>1</a:t>
-            </a:fld>
-            <a:endParaRPr lang="en-US"/>
-          </a:p>
-        </p:txBody>
-      </p:sp>
-      <p:sp>
-        <p:nvSpPr>
-          <p:cNvPr id="4" name="TextBox 3"/>
-          <p:cNvSpPr txBox="1"/>
-          <p:nvPr/>
-        </p:nvSpPr>
-        <p:spPr>
-          <a:xfrm>
-            <a:off x="685800" y="1243584"/>
-            <a:ext cx="7772400" cy="365760"/>
-          </a:xfrm>
-          <a:prstGeom prst="rect">
-            <a:avLst/>
-          </a:prstGeom>
-          <a:noFill/>
-        </p:spPr>
-        <p:txBody>
-          <a:bodyPr wrap="square" anchor="t">
-            <a:spAutoFit/>
-          </a:bodyPr>
-          <a:lstStyle/>
-          <a:p>
-            <a:pPr algn="ctr"/>
-            <a:r>
-              <a:rPr sz="2000" b="1" i="0">
-                <a:solidFill>
-                  <a:srgbClr val="8E6F3E"/>
-                </a:solidFill>
-              </a:rPr>
-              <a:t>DISCUSSION</a:t>
-            </a:r>
-          </a:p>
-        </p:txBody>
-      </p:sp>
-      <p:sp>
-        <p:nvSpPr>
-          <p:cNvPr id="5" name="Rectangle 4"/>
-          <p:cNvSpPr/>
-          <p:nvPr/>
-        </p:nvSpPr>
-        <p:spPr>
-          <a:xfrm>
-            <a:off x="3429000" y="3017520"/>
-            <a:ext cx="2286000" cy="54864"/>
-          </a:xfrm>
-          <a:prstGeom prst="rect">
-            <a:avLst/>
-          </a:prstGeom>
-          <a:solidFill>
-            <a:srgbClr val="8E6F3E"/>
-          </a:solidFill>
-          <a:ln>
-            <a:noFill/>
-          </a:ln>
-          <a:effectLst/>
-        </p:spPr>
-        <p:style>
-          <a:lnRef idx="1">
-            <a:schemeClr val="accent1"/>
-          </a:lnRef>
-          <a:fillRef idx="3">
-            <a:schemeClr val="accent1"/>
-          </a:fillRef>
-          <a:effectRef idx="2">
-            <a:schemeClr val="accent1"/>
-          </a:effectRef>
-          <a:fontRef idx="minor">
-            <a:schemeClr val="lt1"/>
-          </a:fontRef>
-        </p:style>
-        <p:txBody>
-          <a:bodyPr rtlCol="0" anchor="ctr"/>
-          <a:lstStyle/>
-          <a:p>
-            <a:pPr algn="ctr"/>
-          </a:p>
-        </p:txBody>
-      </p:sp>
-    </p:spTree>
-  </p:cSld>
-  <p:clrMapOvr>
-    <a:masterClrMapping/>
-  </p:clrMapOvr>
-</p:sld>
-</file>
-
 <file path=ppt/slides/slide34.xml><?xml version="1.0" encoding="utf-8"?>
 <p:sld xmlns:a="http://schemas.openxmlformats.org/drawingml/2006/main" xmlns:p="http://schemas.openxmlformats.org/presentationml/2006/main" xmlns:r="http://schemas.openxmlformats.org/officeDocument/2006/relationships">
   <p:cSld>
@@ -22120,8 +21656,8 @@
         </p:nvSpPr>
         <p:spPr>
           <a:xfrm>
-            <a:off x="5349240" y="205000"/>
-            <a:ext cx="3520440" cy="470000"/>
+            <a:off x="4069080" y="205000"/>
+            <a:ext cx="4800600" cy="470000"/>
           </a:xfrm>
           <a:prstGeom prst="roundRect">
             <a:avLst/>
@@ -22149,7 +21685,7 @@
                   <a:srgbClr val="8E6F3E"/>
                 </a:solidFill>
               </a:rPr>
-              <a:t>FROM THE MODELING LAB</a:t>
+              <a:t>DISCUSSION · FROM THE MODELING LAB</a:t>
             </a:r>
           </a:p>
         </p:txBody>
@@ -22433,7 +21969,7 @@
                   <a:srgbClr val="FFFFFF"/>
                 </a:solidFill>
               </a:rPr>
-              <a:t>How might we use each model in validation?</a:t>
+              <a:t>How might we use these in validation?</a:t>
             </a:r>
           </a:p>
         </p:txBody>
@@ -24937,6 +24473,464 @@
 </p:sld>
 </file>
 
+<file path=ppt/slides/slide41.xml><?xml version="1.0" encoding="utf-8"?>
+<p:sld xmlns:a="http://schemas.openxmlformats.org/drawingml/2006/main" xmlns:p="http://schemas.openxmlformats.org/presentationml/2006/main" xmlns:r="http://schemas.openxmlformats.org/officeDocument/2006/relationships">
+  <p:cSld>
+    <p:spTree>
+      <p:nvGrpSpPr>
+        <p:cNvPr id="1" name=""/>
+        <p:cNvGrpSpPr/>
+        <p:nvPr/>
+      </p:nvGrpSpPr>
+      <p:grpSpPr/>
+      <p:sp>
+        <p:nvSpPr>
+          <p:cNvPr id="3" name="Title 2"/>
+          <p:cNvSpPr>
+            <a:spLocks noGrp="1"/>
+          </p:cNvSpPr>
+          <p:nvPr>
+            <p:ph type="title"/>
+          </p:nvPr>
+        </p:nvSpPr>
+        <p:spPr/>
+        <p:txBody>
+          <a:bodyPr wrap="square"/>
+          <a:lstStyle/>
+          <a:p>
+            <a:r>
+              <a:rPr sz="2400" b="0">
+                <a:solidFill>
+                  <a:srgbClr val="000000"/>
+                </a:solidFill>
+              </a:rPr>
+              <a:t>Design the Alignment</a:t>
+            </a:r>
+          </a:p>
+        </p:txBody>
+      </p:sp>
+      <p:sp>
+        <p:nvSpPr>
+          <p:cNvPr id="4" name="Slide Number Placeholder 5"/>
+          <p:cNvSpPr>
+            <a:spLocks noGrp="1"/>
+          </p:cNvSpPr>
+          <p:nvPr>
+            <p:ph type="sldNum" sz="quarter" idx="4"/>
+          </p:nvPr>
+        </p:nvSpPr>
+        <p:spPr/>
+        <p:txBody>
+          <a:bodyPr/>
+          <a:lstStyle/>
+          <a:p>
+            <a:fld id="{B7EB45DA-9A0D-DC49-8E02-F30A5DDC21C3}" type="slidenum">
+              <a:rPr lang="en-US" smtClean="0"/>
+              <a:t>1</a:t>
+            </a:fld>
+            <a:endParaRPr lang="en-US"/>
+          </a:p>
+        </p:txBody>
+      </p:sp>
+      <p:sp>
+        <p:nvSpPr>
+          <p:cNvPr id="5" name="KickerBadge">
+            <a:extLst>
+              <a:ext uri="{FF2B5EF4-FFF2-40B4-BE49-F238E27FC236}">
+                <a16:creationId xmlns:a16="http://schemas.microsoft.com/office/drawing/2014/main" id="{55489336-5766-22EA-2ADC-D9F38F769456}"/>
+              </a:ext>
+            </a:extLst>
+          </p:cNvPr>
+          <p:cNvSpPr/>
+          <p:nvPr/>
+        </p:nvSpPr>
+        <p:spPr>
+          <a:xfrm>
+            <a:off x="4480560" y="205000"/>
+            <a:ext cx="4389120" cy="470000"/>
+          </a:xfrm>
+          <a:prstGeom prst="roundRect">
+            <a:avLst/>
+          </a:prstGeom>
+          <a:solidFill>
+            <a:srgbClr val="FBF8F2"/>
+          </a:solidFill>
+          <a:ln w="15875">
+            <a:solidFill>
+              <a:srgbClr val="8E6F3E"/>
+            </a:solidFill>
+          </a:ln>
+        </p:spPr>
+        <p:txBody>
+          <a:bodyPr wrap="square" lIns="91440" tIns="27432" rIns="91440" bIns="27432" anchor="ctr"/>
+          <a:lstStyle/>
+          <a:p>
+            <a:pPr algn="ctr">
+              <a:buNone/>
+            </a:pPr>
+            <a:r>
+              <a:rPr lang="en-US" b="1" i="0" dirty="0" sz="2000">
+                <a:solidFill>
+                  <a:srgbClr val="8E6F3E"/>
+                </a:solidFill>
+              </a:rPr>
+              <a:t>TEAM ACTIVITY  ·  10–12 MINUTES</a:t>
+            </a:r>
+          </a:p>
+        </p:txBody>
+      </p:sp>
+      <p:sp>
+        <p:nvSpPr>
+          <p:cNvPr id="12" name="FooterBand"/>
+          <p:cNvSpPr/>
+          <p:nvPr/>
+        </p:nvSpPr>
+        <p:spPr>
+          <a:xfrm>
+            <a:off x="274320" y="5852160"/>
+            <a:ext cx="8595360" cy="566928"/>
+          </a:xfrm>
+          <a:prstGeom prst="rect">
+            <a:avLst/>
+          </a:prstGeom>
+          <a:solidFill>
+            <a:srgbClr val="8E6F3E"/>
+          </a:solidFill>
+          <a:ln>
+            <a:noFill/>
+          </a:ln>
+          <a:effectLst/>
+        </p:spPr>
+        <p:style>
+          <a:lnRef idx="1">
+            <a:schemeClr val="accent1"/>
+          </a:lnRef>
+          <a:fillRef idx="3">
+            <a:schemeClr val="accent1"/>
+          </a:fillRef>
+          <a:effectRef idx="2">
+            <a:schemeClr val="accent1"/>
+          </a:effectRef>
+          <a:fontRef idx="minor">
+            <a:schemeClr val="lt1"/>
+          </a:fontRef>
+        </p:style>
+        <p:txBody>
+          <a:bodyPr rtlCol="0" anchor="ctr" wrap="square"/>
+          <a:lstStyle/>
+          <a:p>
+            <a:pPr algn="ctr"/>
+            <a:r>
+              <a:rPr sz="2000" b="1" i="0">
+                <a:solidFill>
+                  <a:srgbClr val="FFFFFF"/>
+                </a:solidFill>
+              </a:rPr>
+              <a:t>Design the delegated process and its controls. Use the model as given.</a:t>
+            </a:r>
+          </a:p>
+        </p:txBody>
+      </p:sp>
+      <p:sp>
+        <p:nvSpPr>
+          <p:cNvPr id="901" name="Card-obligations"/>
+          <p:cNvSpPr/>
+          <p:nvPr/>
+        </p:nvSpPr>
+        <p:spPr>
+          <a:xfrm>
+            <a:off x="274320" y="1051560"/>
+            <a:ext cx="4160520" cy="4526280"/>
+          </a:xfrm>
+          <a:prstGeom prst="rect">
+            <a:avLst/>
+          </a:prstGeom>
+          <a:solidFill>
+            <a:srgbClr val="F5F1E8"/>
+          </a:solidFill>
+          <a:ln w="12700">
+            <a:solidFill>
+              <a:srgbClr val="C9B991"/>
+            </a:solidFill>
+          </a:ln>
+          <a:effectLst/>
+        </p:spPr>
+        <p:txBody>
+          <a:bodyPr rtlCol="0" anchor="t" wrap="square" lIns="27432" rIns="27432" tIns="22860" bIns="22860"/>
+          <a:lstStyle/>
+          <a:p>
+            <a:pPr algn="ctr">
+              <a:buNone/>
+            </a:pPr>
+            <a:r>
+              <a:rPr lang="en-US" sz="2000" b="1" i="0" dirty="0">
+                <a:solidFill>
+                  <a:srgbClr val="5C4826"/>
+                </a:solidFill>
+              </a:rPr>
+              <a:t>OBLIGATIONS</a:t>
+            </a:r>
+          </a:p>
+          <a:p>
+            <a:pPr algn="l">
+              <a:spcBef>
+                <a:spcPts val="900"/>
+              </a:spcBef>
+              <a:buNone/>
+            </a:pPr>
+            <a:r>
+              <a:rPr lang="en-US" sz="2000" b="1" i="0" dirty="0">
+                <a:solidFill>
+                  <a:srgbClr val="8E6F3E"/>
+                </a:solidFill>
+              </a:rPr>
+              <a:t xml:space="preserve">1  ·  </a:t>
+            </a:r>
+            <a:r>
+              <a:rPr lang="en-US" sz="2000" b="0" i="0" dirty="0">
+                <a:solidFill>
+                  <a:srgbClr val="5C4826"/>
+                </a:solidFill>
+              </a:rPr>
+              <a:t>Preserve the external API.</a:t>
+            </a:r>
+          </a:p>
+          <a:p>
+            <a:pPr algn="l">
+              <a:spcBef>
+                <a:spcPts val="900"/>
+              </a:spcBef>
+              <a:buNone/>
+            </a:pPr>
+            <a:r>
+              <a:rPr lang="en-US" sz="2000" b="1" i="0" dirty="0">
+                <a:solidFill>
+                  <a:srgbClr val="8E6F3E"/>
+                </a:solidFill>
+              </a:rPr>
+              <a:t xml:space="preserve">2  ·  </a:t>
+            </a:r>
+            <a:r>
+              <a:rPr lang="en-US" sz="2000" b="0" i="0" dirty="0">
+                <a:solidFill>
+                  <a:srgbClr val="5C4826"/>
+                </a:solidFill>
+              </a:rPr>
+              <a:t>Worst-case memory below 64 MB.</a:t>
+            </a:r>
+          </a:p>
+          <a:p>
+            <a:pPr algn="l">
+              <a:spcBef>
+                <a:spcPts val="900"/>
+              </a:spcBef>
+              <a:buNone/>
+            </a:pPr>
+            <a:r>
+              <a:rPr lang="en-US" sz="2000" b="1" i="0" dirty="0">
+                <a:solidFill>
+                  <a:srgbClr val="8E6F3E"/>
+                </a:solidFill>
+              </a:rPr>
+              <a:t xml:space="preserve">3  ·  </a:t>
+            </a:r>
+            <a:r>
+              <a:rPr lang="en-US" sz="2000" b="0" i="0" dirty="0">
+                <a:solidFill>
+                  <a:srgbClr val="5C4826"/>
+                </a:solidFill>
+              </a:rPr>
+              <a:t>Avoid the forbidden dependency.</a:t>
+            </a:r>
+          </a:p>
+          <a:p>
+            <a:pPr algn="l">
+              <a:spcBef>
+                <a:spcPts val="900"/>
+              </a:spcBef>
+              <a:buNone/>
+            </a:pPr>
+            <a:r>
+              <a:rPr lang="en-US" sz="2000" b="1" i="0" dirty="0">
+                <a:solidFill>
+                  <a:srgbClr val="8E6F3E"/>
+                </a:solidFill>
+              </a:rPr>
+              <a:t xml:space="preserve">4  ·  </a:t>
+            </a:r>
+            <a:r>
+              <a:rPr lang="en-US" sz="2000" b="0" i="0" dirty="0">
+                <a:solidFill>
+                  <a:srgbClr val="5C4826"/>
+                </a:solidFill>
+              </a:rPr>
+              <a:t>Preserve the cycle ordering: Sensor.read → decide → Actuator.act.</a:t>
+            </a:r>
+          </a:p>
+        </p:txBody>
+      </p:sp>
+      <p:sp>
+        <p:nvSpPr>
+          <p:cNvPr id="902" name="Card-given-model"/>
+          <p:cNvSpPr/>
+          <p:nvPr/>
+        </p:nvSpPr>
+        <p:spPr>
+          <a:xfrm>
+            <a:off x="4617720" y="1051560"/>
+            <a:ext cx="4251960" cy="4526280"/>
+          </a:xfrm>
+          <a:prstGeom prst="rect">
+            <a:avLst/>
+          </a:prstGeom>
+          <a:solidFill>
+            <a:srgbClr val="F5F1E8"/>
+          </a:solidFill>
+          <a:ln w="12700">
+            <a:solidFill>
+              <a:srgbClr val="C9B991"/>
+            </a:solidFill>
+          </a:ln>
+          <a:effectLst/>
+        </p:spPr>
+        <p:txBody>
+          <a:bodyPr rtlCol="0" anchor="t" wrap="square" lIns="27432" rIns="27432" tIns="22860" bIns="22860"/>
+          <a:lstStyle/>
+          <a:p>
+            <a:pPr algn="ctr">
+              <a:buNone/>
+            </a:pPr>
+            <a:r>
+              <a:rPr lang="en-US" sz="2000" b="1" i="0" dirty="0">
+                <a:solidFill>
+                  <a:srgbClr val="5C4826"/>
+                </a:solidFill>
+              </a:rPr>
+              <a:t>THE GIVEN MODEL</a:t>
+            </a:r>
+          </a:p>
+          <a:p>
+            <a:pPr algn="l">
+              <a:spcBef>
+                <a:spcPts val="900"/>
+              </a:spcBef>
+              <a:buNone/>
+            </a:pPr>
+            <a:r>
+              <a:rPr lang="en-US" sz="2000" b="1" i="0" dirty="0">
+                <a:solidFill>
+                  <a:srgbClr val="8E6F3E"/>
+                </a:solidFill>
+              </a:rPr>
+              <a:t>STRUCTURE</a:t>
+            </a:r>
+          </a:p>
+          <a:p>
+            <a:pPr algn="l">
+              <a:spcBef>
+                <a:spcPts val="900"/>
+              </a:spcBef>
+              <a:buNone/>
+            </a:pPr>
+            <a:r>
+              <a:rPr lang="en-US" sz="2000" b="0" i="0" dirty="0">
+                <a:solidFill>
+                  <a:srgbClr val="5C4826"/>
+                </a:solidFill>
+              </a:rPr>
+              <a:t>Controller — API: IController</a:t>
+            </a:r>
+          </a:p>
+          <a:p>
+            <a:pPr algn="l">
+              <a:spcBef>
+                <a:spcPts val="900"/>
+              </a:spcBef>
+              <a:buNone/>
+            </a:pPr>
+            <a:r>
+              <a:rPr lang="en-US" sz="2000" b="0" i="0" dirty="0">
+                <a:solidFill>
+                  <a:srgbClr val="5C4826"/>
+                </a:solidFill>
+              </a:rPr>
+              <a:t>uses → Sensor · Actuator</a:t>
+            </a:r>
+          </a:p>
+          <a:p>
+            <a:pPr algn="l">
+              <a:spcBef>
+                <a:spcPts val="900"/>
+              </a:spcBef>
+              <a:buNone/>
+            </a:pPr>
+            <a:r>
+              <a:rPr lang="en-US" sz="2000" b="0" i="0" dirty="0">
+                <a:solidFill>
+                  <a:srgbClr val="5C4826"/>
+                </a:solidFill>
+              </a:rPr>
+              <a:t>forbidden → CloudSDK</a:t>
+            </a:r>
+          </a:p>
+          <a:p>
+            <a:pPr algn="l">
+              <a:spcBef>
+                <a:spcPts val="900"/>
+              </a:spcBef>
+              <a:buNone/>
+            </a:pPr>
+            <a:r>
+              <a:rPr lang="en-US" sz="2000" b="0" i="0" dirty="0">
+                <a:solidFill>
+                  <a:srgbClr val="5C4826"/>
+                </a:solidFill>
+              </a:rPr>
+              <a:t>memory ≤ 64 MB</a:t>
+            </a:r>
+          </a:p>
+          <a:p>
+            <a:pPr algn="l">
+              <a:spcBef>
+                <a:spcPts val="900"/>
+              </a:spcBef>
+              <a:buNone/>
+            </a:pPr>
+            <a:r>
+              <a:rPr lang="en-US" sz="2000" b="1" i="0" dirty="0">
+                <a:solidFill>
+                  <a:srgbClr val="8E6F3E"/>
+                </a:solidFill>
+              </a:rPr>
+              <a:t>BEHAVIOR</a:t>
+            </a:r>
+          </a:p>
+          <a:p>
+            <a:pPr algn="l">
+              <a:spcBef>
+                <a:spcPts val="900"/>
+              </a:spcBef>
+              <a:buNone/>
+            </a:pPr>
+            <a:r>
+              <a:rPr lang="en-US" sz="2000" b="0" i="0" dirty="0">
+                <a:solidFill>
+                  <a:srgbClr val="5C4826"/>
+                </a:solidFill>
+              </a:rPr>
+              <a:t>each cycle: Sensor.read → decide → Actuator.act</a:t>
+            </a:r>
+          </a:p>
+        </p:txBody>
+      </p:sp>
+    </p:spTree>
+  </p:cSld>
+  <p:clrMapOvr>
+    <a:masterClrMapping/>
+  </p:clrMapOvr>
+</p:sld>
+</file>
+
 <file path=ppt/slides/slide42.xml><?xml version="1.0" encoding="utf-8"?>
 <p:sld xmlns:a="http://schemas.openxmlformats.org/drawingml/2006/main" xmlns:p="http://schemas.openxmlformats.org/presentationml/2006/main" xmlns:r="http://schemas.openxmlformats.org/officeDocument/2006/relationships">
   <p:cSld>
@@ -24968,7 +24962,7 @@
                   <a:srgbClr val="000000"/>
                 </a:solidFill>
               </a:rPr>
-              <a:t>Design the Alignment</a:t>
+              <a:t>For each obligation</a:t>
             </a:r>
           </a:p>
         </p:txBody>
@@ -24998,54 +24992,7 @@
       </p:sp>
       <p:sp>
         <p:nvSpPr>
-          <p:cNvPr id="5" name="KickerBadge">
-            <a:extLst>
-              <a:ext uri="{FF2B5EF4-FFF2-40B4-BE49-F238E27FC236}">
-                <a16:creationId xmlns:a16="http://schemas.microsoft.com/office/drawing/2014/main" id="{55489336-5766-22EA-2ADC-D9F38F769456}"/>
-              </a:ext>
-            </a:extLst>
-          </p:cNvPr>
-          <p:cNvSpPr/>
-          <p:nvPr/>
-        </p:nvSpPr>
-        <p:spPr>
-          <a:xfrm>
-            <a:off x="4480560" y="205000"/>
-            <a:ext cx="4389120" cy="470000"/>
-          </a:xfrm>
-          <a:prstGeom prst="roundRect">
-            <a:avLst/>
-          </a:prstGeom>
-          <a:solidFill>
-            <a:srgbClr val="FBF8F2"/>
-          </a:solidFill>
-          <a:ln w="15875">
-            <a:solidFill>
-              <a:srgbClr val="8E6F3E"/>
-            </a:solidFill>
-          </a:ln>
-        </p:spPr>
-        <p:txBody>
-          <a:bodyPr wrap="square" lIns="91440" tIns="27432" rIns="91440" bIns="27432" anchor="ctr"/>
-          <a:lstStyle/>
-          <a:p>
-            <a:pPr algn="ctr">
-              <a:buNone/>
-            </a:pPr>
-            <a:r>
-              <a:rPr lang="en-US" b="1" i="0" dirty="0" sz="2000">
-                <a:solidFill>
-                  <a:srgbClr val="8E6F3E"/>
-                </a:solidFill>
-              </a:rPr>
-              <a:t>TEAM ACTIVITY  ·  10–12 MINUTES</a:t>
-            </a:r>
-          </a:p>
-        </p:txBody>
-      </p:sp>
-      <p:sp>
-        <p:nvSpPr>
-          <p:cNvPr id="12" name="FooterBand"/>
+          <p:cNvPr id="15" name="FooterBand"/>
           <p:cNvSpPr/>
           <p:nvPr/>
         </p:nvSpPr>
@@ -25090,21 +25037,61 @@
                   <a:srgbClr val="FFFFFF"/>
                 </a:solidFill>
               </a:rPr>
-              <a:t>Design the delegated process and its controls. Use the model as given.</a:t>
-            </a:r>
-          </a:p>
-        </p:txBody>
-      </p:sp>
-      <p:sp>
-        <p:nvSpPr>
-          <p:cNvPr id="901" name="Card-obligations"/>
+              <a:t>Be ready to defend your boundary and authority choices.</a:t>
+            </a:r>
+          </a:p>
+        </p:txBody>
+      </p:sp>
+      <p:sp>
+        <p:nvSpPr>
+          <p:cNvPr id="0" name="Grp-WHAT MUS"/>
           <p:cNvSpPr/>
           <p:nvPr/>
         </p:nvSpPr>
         <p:spPr>
           <a:xfrm>
-            <a:off x="274320" y="1051560"/>
-            <a:ext cx="4160520" cy="4526280"/>
+            <a:off x="274320" y="1005840"/>
+            <a:ext cx="2103120" cy="1737360"/>
+          </a:xfrm>
+          <a:prstGeom prst="rect">
+            <a:avLst/>
+          </a:prstGeom>
+          <a:solidFill>
+            <a:srgbClr val="8E6F3E"/>
+          </a:solidFill>
+          <a:ln>
+            <a:noFill/>
+          </a:ln>
+          <a:effectLst/>
+        </p:spPr>
+        <p:txBody>
+          <a:bodyPr rtlCol="0" anchor="ctr" wrap="square" lIns="27432" rIns="27432" tIns="22860" bIns="22860"/>
+          <a:lstStyle/>
+          <a:p>
+            <a:pPr algn="ctr">
+              <a:buNone/>
+            </a:pPr>
+            <a:r>
+              <a:rPr lang="en-US" sz="2000" b="1" i="0" dirty="0">
+                <a:solidFill>
+                  <a:srgbClr val="FFFFFF"/>
+                </a:solidFill>
+              </a:rPr>
+              <a:t>WHAT MUST HOLD?</a:t>
+            </a:r>
+          </a:p>
+        </p:txBody>
+      </p:sp>
+      <p:sp>
+        <p:nvSpPr>
+          <p:cNvPr id="0" name="GrpItems-WHAT MUS"/>
+          <p:cNvSpPr/>
+          <p:nvPr/>
+        </p:nvSpPr>
+        <p:spPr>
+          <a:xfrm>
+            <a:off x="2514600" y="1005840"/>
+            <a:ext cx="6355080" cy="1737360"/>
           </a:xfrm>
           <a:prstGeom prst="rect">
             <a:avLst/>
@@ -25120,7 +25107,103 @@
           <a:effectLst/>
         </p:spPr>
         <p:txBody>
-          <a:bodyPr rtlCol="0" anchor="t" wrap="square" lIns="27432" rIns="27432" tIns="22860" bIns="22860"/>
+          <a:bodyPr rtlCol="0" anchor="ctr" wrap="square" lIns="27432" rIns="27432" tIns="22860" bIns="22860"/>
+          <a:lstStyle/>
+          <a:p>
+            <a:pPr algn="l">
+              <a:buNone/>
+            </a:pPr>
+            <a:r>
+              <a:rPr lang="en-US" sz="2000" b="1" i="0" dirty="0">
+                <a:solidFill>
+                  <a:srgbClr val="5C4826"/>
+                </a:solidFill>
+              </a:rPr>
+              <a:t>FAILURE — </a:t>
+            </a:r>
+            <a:r>
+              <a:rPr lang="en-US" sz="2000" b="0" i="0" dirty="0">
+                <a:solidFill>
+                  <a:srgbClr val="5C4826"/>
+                </a:solidFill>
+              </a:rPr>
+              <a:t>what can go wrong?</a:t>
+            </a:r>
+          </a:p>
+          <a:p>
+            <a:pPr algn="l">
+              <a:spcBef>
+                <a:spcPts val="600"/>
+              </a:spcBef>
+              <a:buNone/>
+            </a:pPr>
+            <a:r>
+              <a:rPr lang="en-US" sz="2000" b="1" i="0" dirty="0">
+                <a:solidFill>
+                  <a:srgbClr val="5C4826"/>
+                </a:solidFill>
+              </a:rPr>
+              <a:t>OBLIGATION — </a:t>
+            </a:r>
+            <a:r>
+              <a:rPr lang="en-US" sz="2000" b="0" i="0" dirty="0">
+                <a:solidFill>
+                  <a:srgbClr val="5C4826"/>
+                </a:solidFill>
+              </a:rPr>
+              <a:t>what must be true?</a:t>
+            </a:r>
+          </a:p>
+          <a:p>
+            <a:pPr algn="l">
+              <a:spcBef>
+                <a:spcPts val="600"/>
+              </a:spcBef>
+              <a:buNone/>
+            </a:pPr>
+            <a:r>
+              <a:rPr lang="en-US" sz="2000" b="1" i="0" dirty="0">
+                <a:solidFill>
+                  <a:srgbClr val="5C4826"/>
+                </a:solidFill>
+              </a:rPr>
+              <a:t>MODEL USE — </a:t>
+            </a:r>
+            <a:r>
+              <a:rPr lang="en-US" sz="2000" b="0" i="0" dirty="0">
+                <a:solidFill>
+                  <a:srgbClr val="5C4826"/>
+                </a:solidFill>
+              </a:rPr>
+              <a:t>what fact does the model make explicit, and can you validate it statically or dynamically?</a:t>
+            </a:r>
+          </a:p>
+        </p:txBody>
+      </p:sp>
+      <p:sp>
+        <p:nvSpPr>
+          <p:cNvPr id="0" name="Grp-HOW WILL"/>
+          <p:cNvSpPr/>
+          <p:nvPr/>
+        </p:nvSpPr>
+        <p:spPr>
+          <a:xfrm>
+            <a:off x="274320" y="2880360"/>
+            <a:ext cx="2103120" cy="1371600"/>
+          </a:xfrm>
+          <a:prstGeom prst="rect">
+            <a:avLst/>
+          </a:prstGeom>
+          <a:solidFill>
+            <a:srgbClr val="8E6F3E"/>
+          </a:solidFill>
+          <a:ln>
+            <a:noFill/>
+          </a:ln>
+          <a:effectLst/>
+        </p:spPr>
+        <p:txBody>
+          <a:bodyPr rtlCol="0" anchor="ctr" wrap="square" lIns="27432" rIns="27432" tIns="22860" bIns="22860"/>
           <a:lstStyle/>
           <a:p>
             <a:pPr algn="ctr">
@@ -25129,120 +25212,24 @@
             <a:r>
               <a:rPr lang="en-US" sz="2000" b="1" i="0" dirty="0">
                 <a:solidFill>
-                  <a:srgbClr val="5C4826"/>
-                </a:solidFill>
-              </a:rPr>
-              <a:t>OBLIGATIONS</a:t>
-            </a:r>
-          </a:p>
-          <a:p>
-            <a:pPr algn="l">
-              <a:spcBef>
-                <a:spcPts val="900"/>
-              </a:spcBef>
-              <a:buNone/>
-            </a:pPr>
-            <a:r>
-              <a:rPr lang="en-US" sz="2000" b="1" i="0" dirty="0">
-                <a:solidFill>
-                  <a:srgbClr val="8E6F3E"/>
-                </a:solidFill>
-              </a:rPr>
-              <a:t xml:space="preserve">1  ·  </a:t>
-            </a:r>
-            <a:r>
-              <a:rPr lang="en-US" sz="2000" b="0" i="0" dirty="0">
-                <a:solidFill>
-                  <a:srgbClr val="5C4826"/>
-                </a:solidFill>
-              </a:rPr>
-              <a:t>Preserve the external API.</a:t>
-            </a:r>
-          </a:p>
-          <a:p>
-            <a:pPr algn="l">
-              <a:spcBef>
-                <a:spcPts val="900"/>
-              </a:spcBef>
-              <a:buNone/>
-            </a:pPr>
-            <a:r>
-              <a:rPr lang="en-US" sz="2000" b="1" i="0" dirty="0">
-                <a:solidFill>
-                  <a:srgbClr val="8E6F3E"/>
-                </a:solidFill>
-              </a:rPr>
-              <a:t xml:space="preserve">2  ·  </a:t>
-            </a:r>
-            <a:r>
-              <a:rPr lang="en-US" sz="2000" b="0" i="0" dirty="0">
-                <a:solidFill>
-                  <a:srgbClr val="5C4826"/>
-                </a:solidFill>
-              </a:rPr>
-              <a:t>Worst-case memory below 64 MB.</a:t>
-            </a:r>
-          </a:p>
-          <a:p>
-            <a:pPr algn="l">
-              <a:spcBef>
-                <a:spcPts val="900"/>
-              </a:spcBef>
-              <a:buNone/>
-            </a:pPr>
-            <a:r>
-              <a:rPr lang="en-US" sz="2000" b="1" i="0" dirty="0">
-                <a:solidFill>
-                  <a:srgbClr val="8E6F3E"/>
-                </a:solidFill>
-              </a:rPr>
-              <a:t xml:space="preserve">3  ·  </a:t>
-            </a:r>
-            <a:r>
-              <a:rPr lang="en-US" sz="2000" b="0" i="0" dirty="0">
-                <a:solidFill>
-                  <a:srgbClr val="5C4826"/>
-                </a:solidFill>
-              </a:rPr>
-              <a:t>Avoid the forbidden dependency.</a:t>
-            </a:r>
-          </a:p>
-          <a:p>
-            <a:pPr algn="l">
-              <a:spcBef>
-                <a:spcPts val="900"/>
-              </a:spcBef>
-              <a:buNone/>
-            </a:pPr>
-            <a:r>
-              <a:rPr lang="en-US" sz="2000" b="1" i="0" dirty="0">
-                <a:solidFill>
-                  <a:srgbClr val="8E6F3E"/>
-                </a:solidFill>
-              </a:rPr>
-              <a:t xml:space="preserve">4  ·  </a:t>
-            </a:r>
-            <a:r>
-              <a:rPr lang="en-US" sz="2000" b="0" i="0" dirty="0">
-                <a:solidFill>
-                  <a:srgbClr val="5C4826"/>
-                </a:solidFill>
-              </a:rPr>
-              <a:t>Preserve the cycle ordering: Sensor.read → decide → Actuator.act.</a:t>
-            </a:r>
-          </a:p>
-        </p:txBody>
-      </p:sp>
-      <p:sp>
-        <p:nvSpPr>
-          <p:cNvPr id="902" name="Card-given-model"/>
+                  <a:srgbClr val="FFFFFF"/>
+                </a:solidFill>
+              </a:rPr>
+              <a:t>HOW WILL WE KNOW?</a:t>
+            </a:r>
+          </a:p>
+        </p:txBody>
+      </p:sp>
+      <p:sp>
+        <p:nvSpPr>
+          <p:cNvPr id="0" name="GrpItems-HOW WILL"/>
           <p:cNvSpPr/>
           <p:nvPr/>
         </p:nvSpPr>
         <p:spPr>
           <a:xfrm>
-            <a:off x="4617720" y="1051560"/>
-            <a:ext cx="4251960" cy="4526280"/>
+            <a:off x="2514600" y="2880360"/>
+            <a:ext cx="6355080" cy="1371600"/>
           </a:xfrm>
           <a:prstGeom prst="rect">
             <a:avLst/>
@@ -25258,7 +25245,103 @@
           <a:effectLst/>
         </p:spPr>
         <p:txBody>
-          <a:bodyPr rtlCol="0" anchor="t" wrap="square" lIns="27432" rIns="27432" tIns="22860" bIns="22860"/>
+          <a:bodyPr rtlCol="0" anchor="ctr" wrap="square" lIns="27432" rIns="27432" tIns="22860" bIns="22860"/>
+          <a:lstStyle/>
+          <a:p>
+            <a:pPr algn="l">
+              <a:buNone/>
+            </a:pPr>
+            <a:r>
+              <a:rPr lang="en-US" sz="2000" b="1" i="0" dirty="0">
+                <a:solidFill>
+                  <a:srgbClr val="5C4826"/>
+                </a:solidFill>
+              </a:rPr>
+              <a:t>CONTROL — </a:t>
+            </a:r>
+            <a:r>
+              <a:rPr lang="en-US" sz="2000" b="0" i="0" dirty="0">
+                <a:solidFill>
+                  <a:srgbClr val="5C4826"/>
+                </a:solidFill>
+              </a:rPr>
+              <a:t>can we prevent it, or must we detect it?</a:t>
+            </a:r>
+          </a:p>
+          <a:p>
+            <a:pPr algn="l">
+              <a:spcBef>
+                <a:spcPts val="600"/>
+              </a:spcBef>
+              <a:buNone/>
+            </a:pPr>
+            <a:r>
+              <a:rPr lang="en-US" sz="2000" b="1" i="0" dirty="0">
+                <a:solidFill>
+                  <a:srgbClr val="5C4826"/>
+                </a:solidFill>
+              </a:rPr>
+              <a:t>EVIDENCE — </a:t>
+            </a:r>
+            <a:r>
+              <a:rPr lang="en-US" sz="2000" b="0" i="0" dirty="0">
+                <a:solidFill>
+                  <a:srgbClr val="5C4826"/>
+                </a:solidFill>
+              </a:rPr>
+              <a:t>what observation could establish it?</a:t>
+            </a:r>
+          </a:p>
+          <a:p>
+            <a:pPr algn="l">
+              <a:spcBef>
+                <a:spcPts val="600"/>
+              </a:spcBef>
+              <a:buNone/>
+            </a:pPr>
+            <a:r>
+              <a:rPr lang="en-US" sz="2000" b="1" i="0" dirty="0">
+                <a:solidFill>
+                  <a:srgbClr val="5C4826"/>
+                </a:solidFill>
+              </a:rPr>
+              <a:t>BOUNDARY — </a:t>
+            </a:r>
+            <a:r>
+              <a:rPr lang="en-US" sz="2000" b="0" i="0" dirty="0">
+                <a:solidFill>
+                  <a:srgbClr val="5C4826"/>
+                </a:solidFill>
+              </a:rPr>
+              <a:t>where does enough information exist?</a:t>
+            </a:r>
+          </a:p>
+        </p:txBody>
+      </p:sp>
+      <p:sp>
+        <p:nvSpPr>
+          <p:cNvPr id="0" name="Grp-WHAT WIL"/>
+          <p:cNvSpPr/>
+          <p:nvPr/>
+        </p:nvSpPr>
+        <p:spPr>
+          <a:xfrm>
+            <a:off x="274320" y="4389120"/>
+            <a:ext cx="2103120" cy="1005840"/>
+          </a:xfrm>
+          <a:prstGeom prst="rect">
+            <a:avLst/>
+          </a:prstGeom>
+          <a:solidFill>
+            <a:srgbClr val="8E6F3E"/>
+          </a:solidFill>
+          <a:ln>
+            <a:noFill/>
+          </a:ln>
+          <a:effectLst/>
+        </p:spPr>
+        <p:txBody>
+          <a:bodyPr rtlCol="0" anchor="ctr" wrap="square" lIns="27432" rIns="27432" tIns="22860" bIns="22860"/>
           <a:lstStyle/>
           <a:p>
             <a:pPr algn="ctr">
@@ -25267,122 +25350,411 @@
             <a:r>
               <a:rPr lang="en-US" sz="2000" b="1" i="0" dirty="0">
                 <a:solidFill>
+                  <a:srgbClr val="FFFFFF"/>
+                </a:solidFill>
+              </a:rPr>
+              <a:t>WHAT WILL IT CONTROL?</a:t>
+            </a:r>
+          </a:p>
+        </p:txBody>
+      </p:sp>
+      <p:sp>
+        <p:nvSpPr>
+          <p:cNvPr id="0" name="GrpItems-WHAT WIL"/>
+          <p:cNvSpPr/>
+          <p:nvPr/>
+        </p:nvSpPr>
+        <p:spPr>
+          <a:xfrm>
+            <a:off x="2514600" y="4389120"/>
+            <a:ext cx="6355080" cy="1005840"/>
+          </a:xfrm>
+          <a:prstGeom prst="rect">
+            <a:avLst/>
+          </a:prstGeom>
+          <a:solidFill>
+            <a:srgbClr val="F5F1E8"/>
+          </a:solidFill>
+          <a:ln w="12700">
+            <a:solidFill>
+              <a:srgbClr val="C9B991"/>
+            </a:solidFill>
+          </a:ln>
+          <a:effectLst/>
+        </p:spPr>
+        <p:txBody>
+          <a:bodyPr rtlCol="0" anchor="ctr" wrap="square" lIns="27432" rIns="27432" tIns="22860" bIns="22860"/>
+          <a:lstStyle/>
+          <a:p>
+            <a:pPr algn="l">
+              <a:buNone/>
+            </a:pPr>
+            <a:r>
+              <a:rPr lang="en-US" sz="2000" b="1" i="0" dirty="0">
+                <a:solidFill>
                   <a:srgbClr val="5C4826"/>
                 </a:solidFill>
               </a:rPr>
-              <a:t>THE GIVEN MODEL</a:t>
+              <a:t>MECHANISM — </a:t>
+            </a:r>
+            <a:r>
+              <a:rPr lang="en-US" sz="2000" b="0" i="0" dirty="0">
+                <a:solidFill>
+                  <a:srgbClr val="5C4826"/>
+                </a:solidFill>
+              </a:rPr>
+              <a:t>constraint · sensor · validator · gate</a:t>
             </a:r>
           </a:p>
           <a:p>
             <a:pPr algn="l">
               <a:spcBef>
-                <a:spcPts val="900"/>
+                <a:spcPts val="600"/>
               </a:spcBef>
               <a:buNone/>
             </a:pPr>
             <a:r>
               <a:rPr lang="en-US" sz="2000" b="1" i="0" dirty="0">
                 <a:solidFill>
-                  <a:srgbClr val="8E6F3E"/>
-                </a:solidFill>
-              </a:rPr>
-              <a:t>STRUCTURE</a:t>
-            </a:r>
-          </a:p>
-          <a:p>
-            <a:pPr algn="l">
-              <a:spcBef>
-                <a:spcPts val="900"/>
-              </a:spcBef>
-              <a:buNone/>
-            </a:pPr>
+                  <a:srgbClr val="5C4826"/>
+                </a:solidFill>
+              </a:rPr>
+              <a:t>AUTHORITY — </a:t>
+            </a:r>
             <a:r>
               <a:rPr lang="en-US" sz="2000" b="0" i="0" dirty="0">
                 <a:solidFill>
                   <a:srgbClr val="5C4826"/>
                 </a:solidFill>
               </a:rPr>
-              <a:t>Controller — API: IController</a:t>
-            </a:r>
-          </a:p>
-          <a:p>
-            <a:pPr algn="l">
-              <a:spcBef>
-                <a:spcPts val="900"/>
-              </a:spcBef>
-              <a:buNone/>
-            </a:pPr>
-            <a:r>
-              <a:rPr lang="en-US" sz="2000" b="0" i="0" dirty="0">
+              <a:t>what happens if it fails?</a:t>
+            </a:r>
+          </a:p>
+        </p:txBody>
+      </p:sp>
+    </p:spTree>
+  </p:cSld>
+  <p:clrMapOvr>
+    <a:masterClrMapping/>
+  </p:clrMapOvr>
+</p:sld>
+</file>
+
+<file path=ppt/slides/slide43.xml><?xml version="1.0" encoding="utf-8"?>
+<p:sld xmlns:a="http://schemas.openxmlformats.org/drawingml/2006/main" xmlns:p="http://schemas.openxmlformats.org/presentationml/2006/main" xmlns:r="http://schemas.openxmlformats.org/officeDocument/2006/relationships">
+  <p:cSld>
+    <p:spTree>
+      <p:nvGrpSpPr>
+        <p:cNvPr id="1" name=""/>
+        <p:cNvGrpSpPr/>
+        <p:nvPr/>
+      </p:nvGrpSpPr>
+      <p:grpSpPr/>
+      <p:sp>
+        <p:nvSpPr>
+          <p:cNvPr id="3" name="Title 2"/>
+          <p:cNvSpPr>
+            <a:spLocks noGrp="1"/>
+          </p:cNvSpPr>
+          <p:nvPr>
+            <p:ph type="title"/>
+          </p:nvPr>
+        </p:nvSpPr>
+        <p:spPr/>
+        <p:txBody>
+          <a:bodyPr wrap="square"/>
+          <a:lstStyle/>
+          <a:p>
+            <a:r>
+              <a:rPr sz="2400" b="0">
+                <a:solidFill>
+                  <a:srgbClr val="000000"/>
+                </a:solidFill>
+              </a:rPr>
+              <a:t>Compare your designs</a:t>
+            </a:r>
+          </a:p>
+        </p:txBody>
+      </p:sp>
+      <p:sp>
+        <p:nvSpPr>
+          <p:cNvPr id="4" name="Slide Number Placeholder 5"/>
+          <p:cNvSpPr>
+            <a:spLocks noGrp="1"/>
+          </p:cNvSpPr>
+          <p:nvPr>
+            <p:ph type="sldNum" sz="quarter" idx="4"/>
+          </p:nvPr>
+        </p:nvSpPr>
+        <p:spPr/>
+        <p:txBody>
+          <a:bodyPr/>
+          <a:lstStyle/>
+          <a:p>
+            <a:fld id="{B7EB45DA-9A0D-DC49-8E02-F30A5DDC21C3}" type="slidenum">
+              <a:rPr lang="en-US" smtClean="0"/>
+              <a:t>1</a:t>
+            </a:fld>
+            <a:endParaRPr lang="en-US"/>
+          </a:p>
+        </p:txBody>
+      </p:sp>
+      <p:sp>
+        <p:nvSpPr>
+          <p:cNvPr id="10" name="Compare1"/>
+          <p:cNvSpPr/>
+          <p:nvPr/>
+        </p:nvSpPr>
+        <p:spPr>
+          <a:xfrm>
+            <a:off x="502920" y="1051560"/>
+            <a:ext cx="8138160" cy="749808"/>
+          </a:xfrm>
+          <a:prstGeom prst="rect">
+            <a:avLst/>
+          </a:prstGeom>
+          <a:solidFill>
+            <a:srgbClr val="F5F1E8"/>
+          </a:solidFill>
+          <a:ln w="12700">
+            <a:solidFill>
+              <a:srgbClr val="C9B991"/>
+            </a:solidFill>
+          </a:ln>
+          <a:effectLst/>
+        </p:spPr>
+        <p:style>
+          <a:lnRef idx="1">
+            <a:schemeClr val="accent1"/>
+          </a:lnRef>
+          <a:fillRef idx="3">
+            <a:schemeClr val="accent1"/>
+          </a:fillRef>
+          <a:effectRef idx="2">
+            <a:schemeClr val="accent1"/>
+          </a:effectRef>
+          <a:fontRef idx="minor">
+            <a:schemeClr val="lt1"/>
+          </a:fontRef>
+        </p:style>
+        <p:txBody>
+          <a:bodyPr rtlCol="0" anchor="ctr" wrap="square" lIns="27432" rIns="27432" tIns="22860" bIns="22860"/>
+          <a:lstStyle/>
+          <a:p>
+            <a:pPr algn="l"/>
+            <a:r>
+              <a:rPr sz="2000" b="1" i="0">
                 <a:solidFill>
                   <a:srgbClr val="5C4826"/>
                 </a:solidFill>
               </a:rPr>
-              <a:t>uses → Sensor · Actuator</a:t>
-            </a:r>
-          </a:p>
-          <a:p>
-            <a:pPr algn="l">
-              <a:spcBef>
-                <a:spcPts val="900"/>
-              </a:spcBef>
-              <a:buNone/>
-            </a:pPr>
-            <a:r>
-              <a:rPr lang="en-US" sz="2000" b="0" i="0" dirty="0">
+              <a:t>Same obligation, different boundary</a:t>
+            </a:r>
+          </a:p>
+          <a:p>
+            <a:pPr algn="l"/>
+            <a:r>
+              <a:rPr sz="2000" b="0" i="0">
                 <a:solidFill>
                   <a:srgbClr val="5C4826"/>
                 </a:solidFill>
               </a:rPr>
-              <a:t>forbidden → CloudSDK</a:t>
-            </a:r>
-          </a:p>
-          <a:p>
-            <a:pPr algn="l">
-              <a:spcBef>
-                <a:spcPts val="900"/>
-              </a:spcBef>
-              <a:buNone/>
-            </a:pPr>
-            <a:r>
-              <a:rPr lang="en-US" sz="2000" b="0" i="0" dirty="0">
+              <a:t>Which boundary actually has enough information?</a:t>
+            </a:r>
+          </a:p>
+        </p:txBody>
+      </p:sp>
+      <p:sp>
+        <p:nvSpPr>
+          <p:cNvPr id="11" name="Compare2"/>
+          <p:cNvSpPr/>
+          <p:nvPr/>
+        </p:nvSpPr>
+        <p:spPr>
+          <a:xfrm>
+            <a:off x="502920" y="1965960"/>
+            <a:ext cx="8138160" cy="749808"/>
+          </a:xfrm>
+          <a:prstGeom prst="rect">
+            <a:avLst/>
+          </a:prstGeom>
+          <a:solidFill>
+            <a:srgbClr val="F5F1E8"/>
+          </a:solidFill>
+          <a:ln w="12700">
+            <a:solidFill>
+              <a:srgbClr val="C9B991"/>
+            </a:solidFill>
+          </a:ln>
+          <a:effectLst/>
+        </p:spPr>
+        <p:style>
+          <a:lnRef idx="1">
+            <a:schemeClr val="accent1"/>
+          </a:lnRef>
+          <a:fillRef idx="3">
+            <a:schemeClr val="accent1"/>
+          </a:fillRef>
+          <a:effectRef idx="2">
+            <a:schemeClr val="accent1"/>
+          </a:effectRef>
+          <a:fontRef idx="minor">
+            <a:schemeClr val="lt1"/>
+          </a:fontRef>
+        </p:style>
+        <p:txBody>
+          <a:bodyPr rtlCol="0" anchor="ctr" wrap="square" lIns="27432" rIns="27432" tIns="22860" bIns="22860"/>
+          <a:lstStyle/>
+          <a:p>
+            <a:pPr algn="l"/>
+            <a:r>
+              <a:rPr sz="2000" b="1" i="0">
                 <a:solidFill>
                   <a:srgbClr val="5C4826"/>
                 </a:solidFill>
               </a:rPr>
-              <a:t>memory ≤ 64 MB</a:t>
-            </a:r>
-          </a:p>
-          <a:p>
-            <a:pPr algn="l">
-              <a:spcBef>
-                <a:spcPts val="900"/>
-              </a:spcBef>
-              <a:buNone/>
-            </a:pPr>
-            <a:r>
-              <a:rPr lang="en-US" sz="2000" b="1" i="0" dirty="0">
-                <a:solidFill>
-                  <a:srgbClr val="8E6F3E"/>
-                </a:solidFill>
-              </a:rPr>
-              <a:t>BEHAVIOR</a:t>
-            </a:r>
-          </a:p>
-          <a:p>
-            <a:pPr algn="l">
-              <a:spcBef>
-                <a:spcPts val="900"/>
-              </a:spcBef>
-              <a:buNone/>
-            </a:pPr>
-            <a:r>
-              <a:rPr lang="en-US" sz="2000" b="0" i="0" dirty="0">
+              <a:t>Constraint vs. evidence</a:t>
+            </a:r>
+          </a:p>
+          <a:p>
+            <a:pPr algn="l"/>
+            <a:r>
+              <a:rPr sz="2000" b="0" i="0">
                 <a:solidFill>
                   <a:srgbClr val="5C4826"/>
                 </a:solidFill>
               </a:rPr>
-              <a:t>each cycle: Sensor.read → decide → Actuator.act</a:t>
+              <a:t>Can the failure be prevented, or must it be observed and evaluated?</a:t>
+            </a:r>
+          </a:p>
+        </p:txBody>
+      </p:sp>
+      <p:sp>
+        <p:nvSpPr>
+          <p:cNvPr id="12" name="Compare3"/>
+          <p:cNvSpPr/>
+          <p:nvPr/>
+        </p:nvSpPr>
+        <p:spPr>
+          <a:xfrm>
+            <a:off x="502920" y="2880360"/>
+            <a:ext cx="8138160" cy="1097280"/>
+          </a:xfrm>
+          <a:prstGeom prst="rect">
+            <a:avLst/>
+          </a:prstGeom>
+          <a:solidFill>
+            <a:srgbClr val="F5F1E8"/>
+          </a:solidFill>
+          <a:ln w="12700">
+            <a:solidFill>
+              <a:srgbClr val="C9B991"/>
+            </a:solidFill>
+          </a:ln>
+          <a:effectLst/>
+        </p:spPr>
+        <p:style>
+          <a:lnRef idx="1">
+            <a:schemeClr val="accent1"/>
+          </a:lnRef>
+          <a:fillRef idx="3">
+            <a:schemeClr val="accent1"/>
+          </a:fillRef>
+          <a:effectRef idx="2">
+            <a:schemeClr val="accent1"/>
+          </a:effectRef>
+          <a:fontRef idx="minor">
+            <a:schemeClr val="lt1"/>
+          </a:fontRef>
+        </p:style>
+        <p:txBody>
+          <a:bodyPr rtlCol="0" anchor="ctr" wrap="square" lIns="27432" rIns="27432" tIns="22860" bIns="22860"/>
+          <a:lstStyle/>
+          <a:p>
+            <a:pPr algn="l"/>
+            <a:r>
+              <a:rPr sz="2000" b="1" i="0">
+                <a:solidFill>
+                  <a:srgbClr val="5C4826"/>
+                </a:solidFill>
+              </a:rPr>
+              <a:t>Different authority</a:t>
+            </a:r>
+          </a:p>
+          <a:p>
+            <a:pPr algn="l"/>
+            <a:r>
+              <a:rPr sz="2000" b="0" i="0">
+                <a:solidFill>
+                  <a:srgbClr val="5C4826"/>
+                </a:solidFill>
+              </a:rPr>
+              <a:t>Should this failure block the commit, the PR, the merge, the deployment — or merely produce evidence?</a:t>
+            </a:r>
+          </a:p>
+        </p:txBody>
+      </p:sp>
+      <p:sp>
+        <p:nvSpPr>
+          <p:cNvPr id="13" name="Compare4"/>
+          <p:cNvSpPr/>
+          <p:nvPr/>
+        </p:nvSpPr>
+        <p:spPr>
+          <a:xfrm>
+            <a:off x="502920" y="3977639"/>
+            <a:ext cx="8138160" cy="749808"/>
+          </a:xfrm>
+          <a:prstGeom prst="rect">
+            <a:avLst/>
+          </a:prstGeom>
+          <a:solidFill>
+            <a:srgbClr val="F5F1E8"/>
+          </a:solidFill>
+          <a:ln w="12700">
+            <a:solidFill>
+              <a:srgbClr val="C9B991"/>
+            </a:solidFill>
+          </a:ln>
+          <a:effectLst/>
+        </p:spPr>
+        <p:style>
+          <a:lnRef idx="1">
+            <a:schemeClr val="accent1"/>
+          </a:lnRef>
+          <a:fillRef idx="3">
+            <a:schemeClr val="accent1"/>
+          </a:fillRef>
+          <a:effectRef idx="2">
+            <a:schemeClr val="accent1"/>
+          </a:effectRef>
+          <a:fontRef idx="minor">
+            <a:schemeClr val="lt1"/>
+          </a:fontRef>
+        </p:style>
+        <p:txBody>
+          <a:bodyPr rtlCol="0" anchor="ctr" wrap="square" lIns="27432" rIns="27432" tIns="22860" bIns="22860"/>
+          <a:lstStyle/>
+          <a:p>
+            <a:pPr algn="l"/>
+            <a:r>
+              <a:rPr sz="2000" b="1" i="0">
+                <a:solidFill>
+                  <a:srgbClr val="5C4826"/>
+                </a:solidFill>
+              </a:rPr>
+              <a:t>Model vs. reconstruction</a:t>
+            </a:r>
+          </a:p>
+          <a:p>
+            <a:pPr algn="l"/>
+            <a:r>
+              <a:rPr sz="2000" b="0" i="0">
+                <a:solidFill>
+                  <a:srgbClr val="5C4826"/>
+                </a:solidFill>
+              </a:rPr>
+              <a:t>What becomes easier if the relevant knowledge is explicit?</a:t>
             </a:r>
           </a:p>
         </p:txBody>
@@ -25396,842 +25768,6 @@
 </file>
 
 <file path=ppt/slides/slide44.xml><?xml version="1.0" encoding="utf-8"?>
-<p:sld xmlns:a="http://schemas.openxmlformats.org/drawingml/2006/main" xmlns:p="http://schemas.openxmlformats.org/presentationml/2006/main" xmlns:r="http://schemas.openxmlformats.org/officeDocument/2006/relationships">
-  <p:cSld>
-    <p:spTree>
-      <p:nvGrpSpPr>
-        <p:cNvPr id="1" name=""/>
-        <p:cNvGrpSpPr/>
-        <p:nvPr/>
-      </p:nvGrpSpPr>
-      <p:grpSpPr/>
-      <p:sp>
-        <p:nvSpPr>
-          <p:cNvPr id="3" name="Title 2"/>
-          <p:cNvSpPr>
-            <a:spLocks noGrp="1"/>
-          </p:cNvSpPr>
-          <p:nvPr>
-            <p:ph type="title"/>
-          </p:nvPr>
-        </p:nvSpPr>
-        <p:spPr/>
-        <p:txBody>
-          <a:bodyPr wrap="square"/>
-          <a:lstStyle/>
-          <a:p>
-            <a:r>
-              <a:rPr sz="2400" b="0">
-                <a:solidFill>
-                  <a:srgbClr val="000000"/>
-                </a:solidFill>
-              </a:rPr>
-              <a:t>For each obligation</a:t>
-            </a:r>
-          </a:p>
-        </p:txBody>
-      </p:sp>
-      <p:sp>
-        <p:nvSpPr>
-          <p:cNvPr id="4" name="Slide Number Placeholder 5"/>
-          <p:cNvSpPr>
-            <a:spLocks noGrp="1"/>
-          </p:cNvSpPr>
-          <p:nvPr>
-            <p:ph type="sldNum" sz="quarter" idx="4"/>
-          </p:nvPr>
-        </p:nvSpPr>
-        <p:spPr/>
-        <p:txBody>
-          <a:bodyPr/>
-          <a:lstStyle/>
-          <a:p>
-            <a:fld id="{B7EB45DA-9A0D-DC49-8E02-F30A5DDC21C3}" type="slidenum">
-              <a:rPr lang="en-US" smtClean="0"/>
-              <a:t>1</a:t>
-            </a:fld>
-            <a:endParaRPr lang="en-US"/>
-          </a:p>
-        </p:txBody>
-      </p:sp>
-      <p:sp>
-        <p:nvSpPr>
-          <p:cNvPr id="15" name="FooterBand"/>
-          <p:cNvSpPr/>
-          <p:nvPr/>
-        </p:nvSpPr>
-        <p:spPr>
-          <a:xfrm>
-            <a:off x="274320" y="5852160"/>
-            <a:ext cx="8595360" cy="566928"/>
-          </a:xfrm>
-          <a:prstGeom prst="rect">
-            <a:avLst/>
-          </a:prstGeom>
-          <a:solidFill>
-            <a:srgbClr val="8E6F3E"/>
-          </a:solidFill>
-          <a:ln>
-            <a:noFill/>
-          </a:ln>
-          <a:effectLst/>
-        </p:spPr>
-        <p:style>
-          <a:lnRef idx="1">
-            <a:schemeClr val="accent1"/>
-          </a:lnRef>
-          <a:fillRef idx="3">
-            <a:schemeClr val="accent1"/>
-          </a:fillRef>
-          <a:effectRef idx="2">
-            <a:schemeClr val="accent1"/>
-          </a:effectRef>
-          <a:fontRef idx="minor">
-            <a:schemeClr val="lt1"/>
-          </a:fontRef>
-        </p:style>
-        <p:txBody>
-          <a:bodyPr rtlCol="0" anchor="ctr" wrap="square"/>
-          <a:lstStyle/>
-          <a:p>
-            <a:pPr algn="ctr"/>
-            <a:r>
-              <a:rPr sz="2000" b="1" i="0">
-                <a:solidFill>
-                  <a:srgbClr val="FFFFFF"/>
-                </a:solidFill>
-              </a:rPr>
-              <a:t>Be ready to defend your boundary and authority choices.</a:t>
-            </a:r>
-          </a:p>
-        </p:txBody>
-      </p:sp>
-      <p:sp>
-        <p:nvSpPr>
-          <p:cNvPr id="0" name="Grp-WHAT MUS"/>
-          <p:cNvSpPr/>
-          <p:nvPr/>
-        </p:nvSpPr>
-        <p:spPr>
-          <a:xfrm>
-            <a:off x="274320" y="1005840"/>
-            <a:ext cx="2103120" cy="1737360"/>
-          </a:xfrm>
-          <a:prstGeom prst="rect">
-            <a:avLst/>
-          </a:prstGeom>
-          <a:solidFill>
-            <a:srgbClr val="8E6F3E"/>
-          </a:solidFill>
-          <a:ln>
-            <a:noFill/>
-          </a:ln>
-          <a:effectLst/>
-        </p:spPr>
-        <p:txBody>
-          <a:bodyPr rtlCol="0" anchor="ctr" wrap="square" lIns="27432" rIns="27432" tIns="22860" bIns="22860"/>
-          <a:lstStyle/>
-          <a:p>
-            <a:pPr algn="ctr">
-              <a:buNone/>
-            </a:pPr>
-            <a:r>
-              <a:rPr lang="en-US" sz="2000" b="1" i="0" dirty="0">
-                <a:solidFill>
-                  <a:srgbClr val="FFFFFF"/>
-                </a:solidFill>
-              </a:rPr>
-              <a:t>WHAT MUST HOLD?</a:t>
-            </a:r>
-          </a:p>
-        </p:txBody>
-      </p:sp>
-      <p:sp>
-        <p:nvSpPr>
-          <p:cNvPr id="0" name="GrpItems-WHAT MUS"/>
-          <p:cNvSpPr/>
-          <p:nvPr/>
-        </p:nvSpPr>
-        <p:spPr>
-          <a:xfrm>
-            <a:off x="2514600" y="1005840"/>
-            <a:ext cx="6355080" cy="1737360"/>
-          </a:xfrm>
-          <a:prstGeom prst="rect">
-            <a:avLst/>
-          </a:prstGeom>
-          <a:solidFill>
-            <a:srgbClr val="F5F1E8"/>
-          </a:solidFill>
-          <a:ln w="12700">
-            <a:solidFill>
-              <a:srgbClr val="C9B991"/>
-            </a:solidFill>
-          </a:ln>
-          <a:effectLst/>
-        </p:spPr>
-        <p:txBody>
-          <a:bodyPr rtlCol="0" anchor="ctr" wrap="square" lIns="27432" rIns="27432" tIns="22860" bIns="22860"/>
-          <a:lstStyle/>
-          <a:p>
-            <a:pPr algn="l">
-              <a:buNone/>
-            </a:pPr>
-            <a:r>
-              <a:rPr lang="en-US" sz="2000" b="1" i="0" dirty="0">
-                <a:solidFill>
-                  <a:srgbClr val="5C4826"/>
-                </a:solidFill>
-              </a:rPr>
-              <a:t>FAILURE — </a:t>
-            </a:r>
-            <a:r>
-              <a:rPr lang="en-US" sz="2000" b="0" i="0" dirty="0">
-                <a:solidFill>
-                  <a:srgbClr val="5C4826"/>
-                </a:solidFill>
-              </a:rPr>
-              <a:t>what can go wrong?</a:t>
-            </a:r>
-          </a:p>
-          <a:p>
-            <a:pPr algn="l">
-              <a:spcBef>
-                <a:spcPts val="600"/>
-              </a:spcBef>
-              <a:buNone/>
-            </a:pPr>
-            <a:r>
-              <a:rPr lang="en-US" sz="2000" b="1" i="0" dirty="0">
-                <a:solidFill>
-                  <a:srgbClr val="5C4826"/>
-                </a:solidFill>
-              </a:rPr>
-              <a:t>OBLIGATION — </a:t>
-            </a:r>
-            <a:r>
-              <a:rPr lang="en-US" sz="2000" b="0" i="0" dirty="0">
-                <a:solidFill>
-                  <a:srgbClr val="5C4826"/>
-                </a:solidFill>
-              </a:rPr>
-              <a:t>what must be true?</a:t>
-            </a:r>
-          </a:p>
-          <a:p>
-            <a:pPr algn="l">
-              <a:spcBef>
-                <a:spcPts val="600"/>
-              </a:spcBef>
-              <a:buNone/>
-            </a:pPr>
-            <a:r>
-              <a:rPr lang="en-US" sz="2000" b="1" i="0" dirty="0">
-                <a:solidFill>
-                  <a:srgbClr val="5C4826"/>
-                </a:solidFill>
-              </a:rPr>
-              <a:t>MODEL USE — </a:t>
-            </a:r>
-            <a:r>
-              <a:rPr lang="en-US" sz="2000" b="0" i="0" dirty="0">
-                <a:solidFill>
-                  <a:srgbClr val="5C4826"/>
-                </a:solidFill>
-              </a:rPr>
-              <a:t>what fact does the model make explicit, and can you validate it statically or dynamically?</a:t>
-            </a:r>
-          </a:p>
-        </p:txBody>
-      </p:sp>
-      <p:sp>
-        <p:nvSpPr>
-          <p:cNvPr id="0" name="Grp-HOW WILL"/>
-          <p:cNvSpPr/>
-          <p:nvPr/>
-        </p:nvSpPr>
-        <p:spPr>
-          <a:xfrm>
-            <a:off x="274320" y="2880360"/>
-            <a:ext cx="2103120" cy="1371600"/>
-          </a:xfrm>
-          <a:prstGeom prst="rect">
-            <a:avLst/>
-          </a:prstGeom>
-          <a:solidFill>
-            <a:srgbClr val="8E6F3E"/>
-          </a:solidFill>
-          <a:ln>
-            <a:noFill/>
-          </a:ln>
-          <a:effectLst/>
-        </p:spPr>
-        <p:txBody>
-          <a:bodyPr rtlCol="0" anchor="ctr" wrap="square" lIns="27432" rIns="27432" tIns="22860" bIns="22860"/>
-          <a:lstStyle/>
-          <a:p>
-            <a:pPr algn="ctr">
-              <a:buNone/>
-            </a:pPr>
-            <a:r>
-              <a:rPr lang="en-US" sz="2000" b="1" i="0" dirty="0">
-                <a:solidFill>
-                  <a:srgbClr val="FFFFFF"/>
-                </a:solidFill>
-              </a:rPr>
-              <a:t>HOW WILL WE KNOW?</a:t>
-            </a:r>
-          </a:p>
-        </p:txBody>
-      </p:sp>
-      <p:sp>
-        <p:nvSpPr>
-          <p:cNvPr id="0" name="GrpItems-HOW WILL"/>
-          <p:cNvSpPr/>
-          <p:nvPr/>
-        </p:nvSpPr>
-        <p:spPr>
-          <a:xfrm>
-            <a:off x="2514600" y="2880360"/>
-            <a:ext cx="6355080" cy="1371600"/>
-          </a:xfrm>
-          <a:prstGeom prst="rect">
-            <a:avLst/>
-          </a:prstGeom>
-          <a:solidFill>
-            <a:srgbClr val="F5F1E8"/>
-          </a:solidFill>
-          <a:ln w="12700">
-            <a:solidFill>
-              <a:srgbClr val="C9B991"/>
-            </a:solidFill>
-          </a:ln>
-          <a:effectLst/>
-        </p:spPr>
-        <p:txBody>
-          <a:bodyPr rtlCol="0" anchor="ctr" wrap="square" lIns="27432" rIns="27432" tIns="22860" bIns="22860"/>
-          <a:lstStyle/>
-          <a:p>
-            <a:pPr algn="l">
-              <a:buNone/>
-            </a:pPr>
-            <a:r>
-              <a:rPr lang="en-US" sz="2000" b="1" i="0" dirty="0">
-                <a:solidFill>
-                  <a:srgbClr val="5C4826"/>
-                </a:solidFill>
-              </a:rPr>
-              <a:t>CONTROL — </a:t>
-            </a:r>
-            <a:r>
-              <a:rPr lang="en-US" sz="2000" b="0" i="0" dirty="0">
-                <a:solidFill>
-                  <a:srgbClr val="5C4826"/>
-                </a:solidFill>
-              </a:rPr>
-              <a:t>can we prevent it, or must we detect it?</a:t>
-            </a:r>
-          </a:p>
-          <a:p>
-            <a:pPr algn="l">
-              <a:spcBef>
-                <a:spcPts val="600"/>
-              </a:spcBef>
-              <a:buNone/>
-            </a:pPr>
-            <a:r>
-              <a:rPr lang="en-US" sz="2000" b="1" i="0" dirty="0">
-                <a:solidFill>
-                  <a:srgbClr val="5C4826"/>
-                </a:solidFill>
-              </a:rPr>
-              <a:t>EVIDENCE — </a:t>
-            </a:r>
-            <a:r>
-              <a:rPr lang="en-US" sz="2000" b="0" i="0" dirty="0">
-                <a:solidFill>
-                  <a:srgbClr val="5C4826"/>
-                </a:solidFill>
-              </a:rPr>
-              <a:t>what observation could establish it?</a:t>
-            </a:r>
-          </a:p>
-          <a:p>
-            <a:pPr algn="l">
-              <a:spcBef>
-                <a:spcPts val="600"/>
-              </a:spcBef>
-              <a:buNone/>
-            </a:pPr>
-            <a:r>
-              <a:rPr lang="en-US" sz="2000" b="1" i="0" dirty="0">
-                <a:solidFill>
-                  <a:srgbClr val="5C4826"/>
-                </a:solidFill>
-              </a:rPr>
-              <a:t>BOUNDARY — </a:t>
-            </a:r>
-            <a:r>
-              <a:rPr lang="en-US" sz="2000" b="0" i="0" dirty="0">
-                <a:solidFill>
-                  <a:srgbClr val="5C4826"/>
-                </a:solidFill>
-              </a:rPr>
-              <a:t>where does enough information exist?</a:t>
-            </a:r>
-          </a:p>
-        </p:txBody>
-      </p:sp>
-      <p:sp>
-        <p:nvSpPr>
-          <p:cNvPr id="0" name="Grp-WHAT WIL"/>
-          <p:cNvSpPr/>
-          <p:nvPr/>
-        </p:nvSpPr>
-        <p:spPr>
-          <a:xfrm>
-            <a:off x="274320" y="4389120"/>
-            <a:ext cx="2103120" cy="1005840"/>
-          </a:xfrm>
-          <a:prstGeom prst="rect">
-            <a:avLst/>
-          </a:prstGeom>
-          <a:solidFill>
-            <a:srgbClr val="8E6F3E"/>
-          </a:solidFill>
-          <a:ln>
-            <a:noFill/>
-          </a:ln>
-          <a:effectLst/>
-        </p:spPr>
-        <p:txBody>
-          <a:bodyPr rtlCol="0" anchor="ctr" wrap="square" lIns="27432" rIns="27432" tIns="22860" bIns="22860"/>
-          <a:lstStyle/>
-          <a:p>
-            <a:pPr algn="ctr">
-              <a:buNone/>
-            </a:pPr>
-            <a:r>
-              <a:rPr lang="en-US" sz="2000" b="1" i="0" dirty="0">
-                <a:solidFill>
-                  <a:srgbClr val="FFFFFF"/>
-                </a:solidFill>
-              </a:rPr>
-              <a:t>WHAT WILL IT CONTROL?</a:t>
-            </a:r>
-          </a:p>
-        </p:txBody>
-      </p:sp>
-      <p:sp>
-        <p:nvSpPr>
-          <p:cNvPr id="0" name="GrpItems-WHAT WIL"/>
-          <p:cNvSpPr/>
-          <p:nvPr/>
-        </p:nvSpPr>
-        <p:spPr>
-          <a:xfrm>
-            <a:off x="2514600" y="4389120"/>
-            <a:ext cx="6355080" cy="1005840"/>
-          </a:xfrm>
-          <a:prstGeom prst="rect">
-            <a:avLst/>
-          </a:prstGeom>
-          <a:solidFill>
-            <a:srgbClr val="F5F1E8"/>
-          </a:solidFill>
-          <a:ln w="12700">
-            <a:solidFill>
-              <a:srgbClr val="C9B991"/>
-            </a:solidFill>
-          </a:ln>
-          <a:effectLst/>
-        </p:spPr>
-        <p:txBody>
-          <a:bodyPr rtlCol="0" anchor="ctr" wrap="square" lIns="27432" rIns="27432" tIns="22860" bIns="22860"/>
-          <a:lstStyle/>
-          <a:p>
-            <a:pPr algn="l">
-              <a:buNone/>
-            </a:pPr>
-            <a:r>
-              <a:rPr lang="en-US" sz="2000" b="1" i="0" dirty="0">
-                <a:solidFill>
-                  <a:srgbClr val="5C4826"/>
-                </a:solidFill>
-              </a:rPr>
-              <a:t>MECHANISM — </a:t>
-            </a:r>
-            <a:r>
-              <a:rPr lang="en-US" sz="2000" b="0" i="0" dirty="0">
-                <a:solidFill>
-                  <a:srgbClr val="5C4826"/>
-                </a:solidFill>
-              </a:rPr>
-              <a:t>constraint · sensor · validator · gate</a:t>
-            </a:r>
-          </a:p>
-          <a:p>
-            <a:pPr algn="l">
-              <a:spcBef>
-                <a:spcPts val="600"/>
-              </a:spcBef>
-              <a:buNone/>
-            </a:pPr>
-            <a:r>
-              <a:rPr lang="en-US" sz="2000" b="1" i="0" dirty="0">
-                <a:solidFill>
-                  <a:srgbClr val="5C4826"/>
-                </a:solidFill>
-              </a:rPr>
-              <a:t>AUTHORITY — </a:t>
-            </a:r>
-            <a:r>
-              <a:rPr lang="en-US" sz="2000" b="0" i="0" dirty="0">
-                <a:solidFill>
-                  <a:srgbClr val="5C4826"/>
-                </a:solidFill>
-              </a:rPr>
-              <a:t>what happens if it fails?</a:t>
-            </a:r>
-          </a:p>
-        </p:txBody>
-      </p:sp>
-    </p:spTree>
-  </p:cSld>
-  <p:clrMapOvr>
-    <a:masterClrMapping/>
-  </p:clrMapOvr>
-</p:sld>
-</file>
-
-<file path=ppt/slides/slide45.xml><?xml version="1.0" encoding="utf-8"?>
-<p:sld xmlns:a="http://schemas.openxmlformats.org/drawingml/2006/main" xmlns:p="http://schemas.openxmlformats.org/presentationml/2006/main" xmlns:r="http://schemas.openxmlformats.org/officeDocument/2006/relationships">
-  <p:cSld>
-    <p:spTree>
-      <p:nvGrpSpPr>
-        <p:cNvPr id="1" name=""/>
-        <p:cNvGrpSpPr/>
-        <p:nvPr/>
-      </p:nvGrpSpPr>
-      <p:grpSpPr/>
-      <p:sp>
-        <p:nvSpPr>
-          <p:cNvPr id="3" name="Title 2"/>
-          <p:cNvSpPr>
-            <a:spLocks noGrp="1"/>
-          </p:cNvSpPr>
-          <p:nvPr>
-            <p:ph type="title"/>
-          </p:nvPr>
-        </p:nvSpPr>
-        <p:spPr/>
-        <p:txBody>
-          <a:bodyPr wrap="square"/>
-          <a:lstStyle/>
-          <a:p>
-            <a:r>
-              <a:rPr sz="2400" b="0">
-                <a:solidFill>
-                  <a:srgbClr val="000000"/>
-                </a:solidFill>
-              </a:rPr>
-              <a:t>Compare your designs</a:t>
-            </a:r>
-          </a:p>
-        </p:txBody>
-      </p:sp>
-      <p:sp>
-        <p:nvSpPr>
-          <p:cNvPr id="4" name="Slide Number Placeholder 5"/>
-          <p:cNvSpPr>
-            <a:spLocks noGrp="1"/>
-          </p:cNvSpPr>
-          <p:nvPr>
-            <p:ph type="sldNum" sz="quarter" idx="4"/>
-          </p:nvPr>
-        </p:nvSpPr>
-        <p:spPr/>
-        <p:txBody>
-          <a:bodyPr/>
-          <a:lstStyle/>
-          <a:p>
-            <a:fld id="{B7EB45DA-9A0D-DC49-8E02-F30A5DDC21C3}" type="slidenum">
-              <a:rPr lang="en-US" smtClean="0"/>
-              <a:t>1</a:t>
-            </a:fld>
-            <a:endParaRPr lang="en-US"/>
-          </a:p>
-        </p:txBody>
-      </p:sp>
-      <p:sp>
-        <p:nvSpPr>
-          <p:cNvPr id="10" name="Compare1"/>
-          <p:cNvSpPr/>
-          <p:nvPr/>
-        </p:nvSpPr>
-        <p:spPr>
-          <a:xfrm>
-            <a:off x="502920" y="1051560"/>
-            <a:ext cx="8138160" cy="749808"/>
-          </a:xfrm>
-          <a:prstGeom prst="rect">
-            <a:avLst/>
-          </a:prstGeom>
-          <a:solidFill>
-            <a:srgbClr val="F5F1E8"/>
-          </a:solidFill>
-          <a:ln w="12700">
-            <a:solidFill>
-              <a:srgbClr val="C9B991"/>
-            </a:solidFill>
-          </a:ln>
-          <a:effectLst/>
-        </p:spPr>
-        <p:style>
-          <a:lnRef idx="1">
-            <a:schemeClr val="accent1"/>
-          </a:lnRef>
-          <a:fillRef idx="3">
-            <a:schemeClr val="accent1"/>
-          </a:fillRef>
-          <a:effectRef idx="2">
-            <a:schemeClr val="accent1"/>
-          </a:effectRef>
-          <a:fontRef idx="minor">
-            <a:schemeClr val="lt1"/>
-          </a:fontRef>
-        </p:style>
-        <p:txBody>
-          <a:bodyPr rtlCol="0" anchor="ctr" wrap="square" lIns="27432" rIns="27432" tIns="22860" bIns="22860"/>
-          <a:lstStyle/>
-          <a:p>
-            <a:pPr algn="l"/>
-            <a:r>
-              <a:rPr sz="2000" b="1" i="0">
-                <a:solidFill>
-                  <a:srgbClr val="5C4826"/>
-                </a:solidFill>
-              </a:rPr>
-              <a:t>Same obligation, different boundary</a:t>
-            </a:r>
-          </a:p>
-          <a:p>
-            <a:pPr algn="l"/>
-            <a:r>
-              <a:rPr sz="2000" b="0" i="0">
-                <a:solidFill>
-                  <a:srgbClr val="5C4826"/>
-                </a:solidFill>
-              </a:rPr>
-              <a:t>Which boundary actually has enough information?</a:t>
-            </a:r>
-          </a:p>
-        </p:txBody>
-      </p:sp>
-      <p:sp>
-        <p:nvSpPr>
-          <p:cNvPr id="11" name="Compare2"/>
-          <p:cNvSpPr/>
-          <p:nvPr/>
-        </p:nvSpPr>
-        <p:spPr>
-          <a:xfrm>
-            <a:off x="502920" y="1965960"/>
-            <a:ext cx="8138160" cy="749808"/>
-          </a:xfrm>
-          <a:prstGeom prst="rect">
-            <a:avLst/>
-          </a:prstGeom>
-          <a:solidFill>
-            <a:srgbClr val="F5F1E8"/>
-          </a:solidFill>
-          <a:ln w="12700">
-            <a:solidFill>
-              <a:srgbClr val="C9B991"/>
-            </a:solidFill>
-          </a:ln>
-          <a:effectLst/>
-        </p:spPr>
-        <p:style>
-          <a:lnRef idx="1">
-            <a:schemeClr val="accent1"/>
-          </a:lnRef>
-          <a:fillRef idx="3">
-            <a:schemeClr val="accent1"/>
-          </a:fillRef>
-          <a:effectRef idx="2">
-            <a:schemeClr val="accent1"/>
-          </a:effectRef>
-          <a:fontRef idx="minor">
-            <a:schemeClr val="lt1"/>
-          </a:fontRef>
-        </p:style>
-        <p:txBody>
-          <a:bodyPr rtlCol="0" anchor="ctr" wrap="square" lIns="27432" rIns="27432" tIns="22860" bIns="22860"/>
-          <a:lstStyle/>
-          <a:p>
-            <a:pPr algn="l"/>
-            <a:r>
-              <a:rPr sz="2000" b="1" i="0">
-                <a:solidFill>
-                  <a:srgbClr val="5C4826"/>
-                </a:solidFill>
-              </a:rPr>
-              <a:t>Constraint vs. evidence</a:t>
-            </a:r>
-          </a:p>
-          <a:p>
-            <a:pPr algn="l"/>
-            <a:r>
-              <a:rPr sz="2000" b="0" i="0">
-                <a:solidFill>
-                  <a:srgbClr val="5C4826"/>
-                </a:solidFill>
-              </a:rPr>
-              <a:t>Can the failure be prevented, or must it be observed and evaluated?</a:t>
-            </a:r>
-          </a:p>
-        </p:txBody>
-      </p:sp>
-      <p:sp>
-        <p:nvSpPr>
-          <p:cNvPr id="12" name="Compare3"/>
-          <p:cNvSpPr/>
-          <p:nvPr/>
-        </p:nvSpPr>
-        <p:spPr>
-          <a:xfrm>
-            <a:off x="502920" y="2880360"/>
-            <a:ext cx="8138160" cy="1097280"/>
-          </a:xfrm>
-          <a:prstGeom prst="rect">
-            <a:avLst/>
-          </a:prstGeom>
-          <a:solidFill>
-            <a:srgbClr val="F5F1E8"/>
-          </a:solidFill>
-          <a:ln w="12700">
-            <a:solidFill>
-              <a:srgbClr val="C9B991"/>
-            </a:solidFill>
-          </a:ln>
-          <a:effectLst/>
-        </p:spPr>
-        <p:style>
-          <a:lnRef idx="1">
-            <a:schemeClr val="accent1"/>
-          </a:lnRef>
-          <a:fillRef idx="3">
-            <a:schemeClr val="accent1"/>
-          </a:fillRef>
-          <a:effectRef idx="2">
-            <a:schemeClr val="accent1"/>
-          </a:effectRef>
-          <a:fontRef idx="minor">
-            <a:schemeClr val="lt1"/>
-          </a:fontRef>
-        </p:style>
-        <p:txBody>
-          <a:bodyPr rtlCol="0" anchor="ctr" wrap="square" lIns="27432" rIns="27432" tIns="22860" bIns="22860"/>
-          <a:lstStyle/>
-          <a:p>
-            <a:pPr algn="l"/>
-            <a:r>
-              <a:rPr sz="2000" b="1" i="0">
-                <a:solidFill>
-                  <a:srgbClr val="5C4826"/>
-                </a:solidFill>
-              </a:rPr>
-              <a:t>Different authority</a:t>
-            </a:r>
-          </a:p>
-          <a:p>
-            <a:pPr algn="l"/>
-            <a:r>
-              <a:rPr sz="2000" b="0" i="0">
-                <a:solidFill>
-                  <a:srgbClr val="5C4826"/>
-                </a:solidFill>
-              </a:rPr>
-              <a:t>Should this failure block the commit, the PR, the merge, the deployment — or merely produce evidence?</a:t>
-            </a:r>
-          </a:p>
-        </p:txBody>
-      </p:sp>
-      <p:sp>
-        <p:nvSpPr>
-          <p:cNvPr id="13" name="Compare4"/>
-          <p:cNvSpPr/>
-          <p:nvPr/>
-        </p:nvSpPr>
-        <p:spPr>
-          <a:xfrm>
-            <a:off x="502920" y="3977639"/>
-            <a:ext cx="8138160" cy="749808"/>
-          </a:xfrm>
-          <a:prstGeom prst="rect">
-            <a:avLst/>
-          </a:prstGeom>
-          <a:solidFill>
-            <a:srgbClr val="F5F1E8"/>
-          </a:solidFill>
-          <a:ln w="12700">
-            <a:solidFill>
-              <a:srgbClr val="C9B991"/>
-            </a:solidFill>
-          </a:ln>
-          <a:effectLst/>
-        </p:spPr>
-        <p:style>
-          <a:lnRef idx="1">
-            <a:schemeClr val="accent1"/>
-          </a:lnRef>
-          <a:fillRef idx="3">
-            <a:schemeClr val="accent1"/>
-          </a:fillRef>
-          <a:effectRef idx="2">
-            <a:schemeClr val="accent1"/>
-          </a:effectRef>
-          <a:fontRef idx="minor">
-            <a:schemeClr val="lt1"/>
-          </a:fontRef>
-        </p:style>
-        <p:txBody>
-          <a:bodyPr rtlCol="0" anchor="ctr" wrap="square" lIns="27432" rIns="27432" tIns="22860" bIns="22860"/>
-          <a:lstStyle/>
-          <a:p>
-            <a:pPr algn="l"/>
-            <a:r>
-              <a:rPr sz="2000" b="1" i="0">
-                <a:solidFill>
-                  <a:srgbClr val="5C4826"/>
-                </a:solidFill>
-              </a:rPr>
-              <a:t>Model vs. reconstruction</a:t>
-            </a:r>
-          </a:p>
-          <a:p>
-            <a:pPr algn="l"/>
-            <a:r>
-              <a:rPr sz="2000" b="0" i="0">
-                <a:solidFill>
-                  <a:srgbClr val="5C4826"/>
-                </a:solidFill>
-              </a:rPr>
-              <a:t>What becomes easier if the relevant knowledge is explicit?</a:t>
-            </a:r>
-          </a:p>
-        </p:txBody>
-      </p:sp>
-    </p:spTree>
-  </p:cSld>
-  <p:clrMapOvr>
-    <a:masterClrMapping/>
-  </p:clrMapOvr>
-</p:sld>
-</file>
-
-<file path=ppt/slides/slide46.xml><?xml version="1.0" encoding="utf-8"?>
 <p:sld xmlns:a="http://schemas.openxmlformats.org/drawingml/2006/main" xmlns:p="http://schemas.openxmlformats.org/presentationml/2006/main" xmlns:r="http://schemas.openxmlformats.org/officeDocument/2006/relationships">
   <p:cSld>
     <p:spTree>

</xml_diff>

<commit_message>
deck 2-3: visual QA fix — DISCUSSION marker moves into the footer band; lab kicker back to original geometry (overlapped the title)
</commit_message>
<xml_diff>
--- a/course/lectures/act-2-delegation-and-control/03-alignment/2-3-Alignment.pptx
+++ b/course/lectures/act-2-delegation-and-control/03-alignment/2-3-Alignment.pptx
@@ -17321,8 +17321,8 @@
         </p:nvSpPr>
         <p:spPr>
           <a:xfrm>
-            <a:off x="4069080" y="205000"/>
-            <a:ext cx="4800600" cy="470000"/>
+            <a:off x="5349240" y="205000"/>
+            <a:ext cx="3520440" cy="470000"/>
           </a:xfrm>
           <a:prstGeom prst="roundRect">
             <a:avLst/>
@@ -17350,7 +17350,7 @@
                   <a:srgbClr val="8E6F3E"/>
                 </a:solidFill>
               </a:rPr>
-              <a:t>DISCUSSION · FROM THE MODELING LAB</a:t>
+              <a:t>FROM THE MODELING LAB</a:t>
             </a:r>
           </a:p>
         </p:txBody>
@@ -17634,7 +17634,7 @@
                   <a:srgbClr val="FFFFFF"/>
                 </a:solidFill>
               </a:rPr>
-              <a:t>How might we use these in validation?</a:t>
+              <a:t>DISCUSSION  ·  How might we use these in validation?</a:t>
             </a:r>
           </a:p>
         </p:txBody>

</xml_diff>

<commit_message>
deck 2-3: activity worksheet slide folded into Design-the-Alignment speaker notes (37->36)
</commit_message>
<xml_diff>
--- a/course/lectures/act-2-delegation-and-control/03-alignment/2-3-Alignment.pptx
+++ b/course/lectures/act-2-delegation-and-control/03-alignment/2-3-Alignment.pptx
@@ -42,7 +42,6 @@
     <p:sldId id="280" r:id="rId31"/>
     <p:sldId id="281" r:id="rId32"/>
     <p:sldId id="274" r:id="rId25"/>
-    <p:sldId id="275" r:id="rId26"/>
     <p:sldId id="276" r:id="rId27"/>
     <p:sldId id="282" r:id="rId33"/>
   </p:sldIdLst>
@@ -1581,12 +1580,42 @@
           </a:p>
           <a:p>
             <a:r>
-              <a:t>- Teams should ask, per obligation, which side of the model makes the relevant fact explicit — that feeds the MODEL USE question on the worksheet slide.</a:t>
+              <a:t>- Teams should ask, per obligation, which side of the model makes the relevant fact explicit — that feeds the MODEL USE question in the worksheet sequence below.</a:t>
             </a:r>
           </a:p>
           <a:p>
             <a:r>
               <a:t>- Your job: design the delegated process and its controls.</a:t>
+            </a:r>
+          </a:p>
+          <a:p>
+            <a:r>
+              <a:t>WORKSHEET (was its own slide; keep this slide up while teams work and walk it aloud):</a:t>
+            </a:r>
+          </a:p>
+          <a:p>
+            <a:r>
+              <a:t>- For each obligation, identify what can fail, what evidence establishes it, where it becomes decidable, and what failure should control.</a:t>
+            </a:r>
+          </a:p>
+          <a:p>
+            <a:r>
+              <a:t>- Grouped as three questions. WHAT MUST HOLD: name the failure, state the obligation, and — new since the lab — ask what fact the model makes explicit, and whether you would validate it statically or dynamically.</a:t>
+            </a:r>
+          </a:p>
+          <a:p>
+            <a:r>
+              <a:t>- HOW WILL WE KNOW: prevent or detect, what observation establishes it, and at which boundary enough information exists.</a:t>
+            </a:r>
+          </a:p>
+          <a:p>
+            <a:r>
+              <a:t>- WHAT WILL IT CONTROL: which mechanism plays the role (constraint · sensor · validator · gate), and what authority the verdict carries.</a:t>
+            </a:r>
+          </a:p>
+          <a:p>
+            <a:r>
+              <a:t>- Teams should be ready to defend their boundary and authority choices.</a:t>
             </a:r>
           </a:p>
         </p:txBody>
@@ -1707,96 +1736,6 @@
           <a:p>
             <a:r>
               <a:t>- Reveal the concluding sentence last.</a:t>
-            </a:r>
-          </a:p>
-        </p:txBody>
-      </p:sp>
-      <p:sp>
-        <p:nvSpPr>
-          <p:cNvPr id="4" name="Slide Number Placeholder 3"/>
-          <p:cNvSpPr>
-            <a:spLocks noGrp="1"/>
-          </p:cNvSpPr>
-          <p:nvPr>
-            <p:ph type="sldNum" idx="5" sz="quarter"/>
-          </p:nvPr>
-        </p:nvSpPr>
-        <p:spPr/>
-      </p:sp>
-    </p:spTree>
-  </p:cSld>
-  <p:clrMapOvr>
-    <a:masterClrMapping/>
-  </p:clrMapOvr>
-</p:notes>
-</file>
-
-<file path=ppt/notesSlides/notesSlide20.xml><?xml version="1.0" encoding="utf-8"?>
-<p:notes xmlns:a="http://schemas.openxmlformats.org/drawingml/2006/main" xmlns:p="http://schemas.openxmlformats.org/presentationml/2006/main" xmlns:r="http://schemas.openxmlformats.org/officeDocument/2006/relationships">
-  <p:cSld>
-    <p:spTree>
-      <p:nvGrpSpPr>
-        <p:cNvPr id="1" name=""/>
-        <p:cNvGrpSpPr/>
-        <p:nvPr/>
-      </p:nvGrpSpPr>
-      <p:grpSpPr>
-        <a:xfrm>
-          <a:off x="0" y="0"/>
-          <a:ext cx="0" cy="0"/>
-          <a:chOff x="0" y="0"/>
-          <a:chExt cx="0" cy="0"/>
-        </a:xfrm>
-      </p:grpSpPr>
-      <p:sp>
-        <p:nvSpPr>
-          <p:cNvPr id="2" name="Slide Image Placeholder 1"/>
-          <p:cNvSpPr>
-            <a:spLocks noGrp="1"/>
-          </p:cNvSpPr>
-          <p:nvPr>
-            <p:ph type="sldImg" idx="2"/>
-          </p:nvPr>
-        </p:nvSpPr>
-        <p:spPr/>
-      </p:sp>
-      <p:sp>
-        <p:nvSpPr>
-          <p:cNvPr id="3" name="Notes Placeholder 2"/>
-          <p:cNvSpPr>
-            <a:spLocks noGrp="1"/>
-          </p:cNvSpPr>
-          <p:nvPr>
-            <p:ph type="body" idx="3" sz="quarter"/>
-          </p:nvPr>
-        </p:nvSpPr>
-        <p:spPr/>
-        <p:txBody>
-          <a:bodyPr/>
-          <a:lstStyle/>
-          <a:p>
-            <a:r>
-              <a:t>TIMING: activity continues</a:t>
-            </a:r>
-          </a:p>
-          <a:p>
-            <a:r>
-              <a:t>- Leave this slide up while teams work. For each obligation, walk the same sequence, now grouped into three questions.</a:t>
-            </a:r>
-          </a:p>
-          <a:p>
-            <a:r>
-              <a:t>- WHAT MUST HOLD: name the failure, state the obligation, and — new since the lab — ask what fact the model makes explicit, and whether you would validate it statically or dynamically.</a:t>
-            </a:r>
-          </a:p>
-          <a:p>
-            <a:r>
-              <a:t>- HOW WILL WE KNOW: prevent or detect, what observation establishes it, and at which boundary enough information exists.</a:t>
-            </a:r>
-          </a:p>
-          <a:p>
-            <a:r>
-              <a:t>- WHAT WILL IT CONTROL: which mechanism plays the role, and what authority the verdict carries.</a:t>
             </a:r>
           </a:p>
         </p:txBody>
@@ -21121,515 +21060,6 @@
                 </a:solidFill>
               </a:rPr>
               <a:t>each cycle: Sensor.read → decide → Actuator.act</a:t>
-            </a:r>
-          </a:p>
-        </p:txBody>
-      </p:sp>
-    </p:spTree>
-  </p:cSld>
-  <p:clrMapOvr>
-    <a:masterClrMapping/>
-  </p:clrMapOvr>
-</p:sld>
-</file>
-
-<file path=ppt/slides/slide35.xml><?xml version="1.0" encoding="utf-8"?>
-<p:sld xmlns:a="http://schemas.openxmlformats.org/drawingml/2006/main" xmlns:p="http://schemas.openxmlformats.org/presentationml/2006/main" xmlns:r="http://schemas.openxmlformats.org/officeDocument/2006/relationships">
-  <p:cSld>
-    <p:spTree>
-      <p:nvGrpSpPr>
-        <p:cNvPr id="1" name=""/>
-        <p:cNvGrpSpPr/>
-        <p:nvPr/>
-      </p:nvGrpSpPr>
-      <p:grpSpPr/>
-      <p:sp>
-        <p:nvSpPr>
-          <p:cNvPr id="3" name="Title 2"/>
-          <p:cNvSpPr>
-            <a:spLocks noGrp="1"/>
-          </p:cNvSpPr>
-          <p:nvPr>
-            <p:ph type="title"/>
-          </p:nvPr>
-        </p:nvSpPr>
-        <p:spPr/>
-        <p:txBody>
-          <a:bodyPr wrap="square"/>
-          <a:lstStyle/>
-          <a:p>
-            <a:r>
-              <a:rPr sz="2400" b="0">
-                <a:solidFill>
-                  <a:srgbClr val="000000"/>
-                </a:solidFill>
-              </a:rPr>
-              <a:t>For each obligation</a:t>
-            </a:r>
-          </a:p>
-        </p:txBody>
-      </p:sp>
-      <p:sp>
-        <p:nvSpPr>
-          <p:cNvPr id="4" name="Slide Number Placeholder 5"/>
-          <p:cNvSpPr>
-            <a:spLocks noGrp="1"/>
-          </p:cNvSpPr>
-          <p:nvPr>
-            <p:ph type="sldNum" sz="quarter" idx="4"/>
-          </p:nvPr>
-        </p:nvSpPr>
-        <p:spPr/>
-        <p:txBody>
-          <a:bodyPr/>
-          <a:lstStyle/>
-          <a:p>
-            <a:fld id="{B7EB45DA-9A0D-DC49-8E02-F30A5DDC21C3}" type="slidenum">
-              <a:rPr lang="en-US" smtClean="0"/>
-              <a:t>35</a:t>
-            </a:fld>
-            <a:endParaRPr lang="en-US"/>
-          </a:p>
-        </p:txBody>
-      </p:sp>
-      <p:sp>
-        <p:nvSpPr>
-          <p:cNvPr id="15" name="FooterBand"/>
-          <p:cNvSpPr/>
-          <p:nvPr/>
-        </p:nvSpPr>
-        <p:spPr>
-          <a:xfrm>
-            <a:off x="274320" y="5852160"/>
-            <a:ext cx="8595360" cy="566928"/>
-          </a:xfrm>
-          <a:prstGeom prst="rect">
-            <a:avLst/>
-          </a:prstGeom>
-          <a:solidFill>
-            <a:srgbClr val="8E6F3E"/>
-          </a:solidFill>
-          <a:ln>
-            <a:noFill/>
-          </a:ln>
-          <a:effectLst/>
-        </p:spPr>
-        <p:style>
-          <a:lnRef idx="1">
-            <a:schemeClr val="accent1"/>
-          </a:lnRef>
-          <a:fillRef idx="3">
-            <a:schemeClr val="accent1"/>
-          </a:fillRef>
-          <a:effectRef idx="2">
-            <a:schemeClr val="accent1"/>
-          </a:effectRef>
-          <a:fontRef idx="minor">
-            <a:schemeClr val="lt1"/>
-          </a:fontRef>
-        </p:style>
-        <p:txBody>
-          <a:bodyPr rtlCol="0" anchor="ctr" wrap="square"/>
-          <a:lstStyle/>
-          <a:p>
-            <a:pPr algn="ctr"/>
-            <a:r>
-              <a:rPr sz="2000" b="1" i="0">
-                <a:solidFill>
-                  <a:srgbClr val="FFFFFF"/>
-                </a:solidFill>
-              </a:rPr>
-              <a:t>Be ready to defend your boundary and authority choices.</a:t>
-            </a:r>
-          </a:p>
-        </p:txBody>
-      </p:sp>
-      <p:sp>
-        <p:nvSpPr>
-          <p:cNvPr id="0" name="Grp-WHAT MUS"/>
-          <p:cNvSpPr/>
-          <p:nvPr/>
-        </p:nvSpPr>
-        <p:spPr>
-          <a:xfrm>
-            <a:off x="274320" y="1005840"/>
-            <a:ext cx="2103120" cy="1737360"/>
-          </a:xfrm>
-          <a:prstGeom prst="rect">
-            <a:avLst/>
-          </a:prstGeom>
-          <a:solidFill>
-            <a:srgbClr val="8E6F3E"/>
-          </a:solidFill>
-          <a:ln>
-            <a:noFill/>
-          </a:ln>
-          <a:effectLst/>
-        </p:spPr>
-        <p:txBody>
-          <a:bodyPr rtlCol="0" anchor="ctr" wrap="square" lIns="27432" rIns="27432" tIns="22860" bIns="22860"/>
-          <a:lstStyle/>
-          <a:p>
-            <a:pPr algn="ctr">
-              <a:buNone/>
-            </a:pPr>
-            <a:r>
-              <a:rPr lang="en-US" sz="2000" b="1" i="0" dirty="0">
-                <a:solidFill>
-                  <a:srgbClr val="FFFFFF"/>
-                </a:solidFill>
-              </a:rPr>
-              <a:t>WHAT MUST HOLD?</a:t>
-            </a:r>
-          </a:p>
-        </p:txBody>
-      </p:sp>
-      <p:sp>
-        <p:nvSpPr>
-          <p:cNvPr id="0" name="GrpItems-WHAT MUS"/>
-          <p:cNvSpPr/>
-          <p:nvPr/>
-        </p:nvSpPr>
-        <p:spPr>
-          <a:xfrm>
-            <a:off x="2514600" y="1005840"/>
-            <a:ext cx="6355080" cy="1737360"/>
-          </a:xfrm>
-          <a:prstGeom prst="rect">
-            <a:avLst/>
-          </a:prstGeom>
-          <a:solidFill>
-            <a:srgbClr val="F5F1E8"/>
-          </a:solidFill>
-          <a:ln w="12700">
-            <a:solidFill>
-              <a:srgbClr val="C9B991"/>
-            </a:solidFill>
-          </a:ln>
-          <a:effectLst/>
-        </p:spPr>
-        <p:txBody>
-          <a:bodyPr rtlCol="0" anchor="ctr" wrap="square" lIns="27432" rIns="27432" tIns="22860" bIns="22860"/>
-          <a:lstStyle/>
-          <a:p>
-            <a:pPr algn="l">
-              <a:buNone/>
-            </a:pPr>
-            <a:r>
-              <a:rPr lang="en-US" sz="2000" b="1" i="0" dirty="0">
-                <a:solidFill>
-                  <a:srgbClr val="5C4826"/>
-                </a:solidFill>
-              </a:rPr>
-              <a:t>FAILURE — </a:t>
-            </a:r>
-            <a:r>
-              <a:rPr lang="en-US" sz="2000" b="0" i="0" dirty="0">
-                <a:solidFill>
-                  <a:srgbClr val="5C4826"/>
-                </a:solidFill>
-              </a:rPr>
-              <a:t>what can go wrong?</a:t>
-            </a:r>
-          </a:p>
-          <a:p>
-            <a:pPr algn="l">
-              <a:spcBef>
-                <a:spcPts val="600"/>
-              </a:spcBef>
-              <a:buNone/>
-            </a:pPr>
-            <a:r>
-              <a:rPr lang="en-US" sz="2000" b="1" i="0" dirty="0">
-                <a:solidFill>
-                  <a:srgbClr val="5C4826"/>
-                </a:solidFill>
-              </a:rPr>
-              <a:t>OBLIGATION — </a:t>
-            </a:r>
-            <a:r>
-              <a:rPr lang="en-US" sz="2000" b="0" i="0" dirty="0">
-                <a:solidFill>
-                  <a:srgbClr val="5C4826"/>
-                </a:solidFill>
-              </a:rPr>
-              <a:t>what must be true?</a:t>
-            </a:r>
-          </a:p>
-          <a:p>
-            <a:pPr algn="l">
-              <a:spcBef>
-                <a:spcPts val="600"/>
-              </a:spcBef>
-              <a:buNone/>
-            </a:pPr>
-            <a:r>
-              <a:rPr lang="en-US" sz="2000" b="1" i="0" dirty="0">
-                <a:solidFill>
-                  <a:srgbClr val="5C4826"/>
-                </a:solidFill>
-              </a:rPr>
-              <a:t>MODEL USE — </a:t>
-            </a:r>
-            <a:r>
-              <a:rPr lang="en-US" sz="2000" b="0" i="0" dirty="0">
-                <a:solidFill>
-                  <a:srgbClr val="5C4826"/>
-                </a:solidFill>
-              </a:rPr>
-              <a:t>what fact does the model make explicit, and can you validate it statically or dynamically?</a:t>
-            </a:r>
-          </a:p>
-        </p:txBody>
-      </p:sp>
-      <p:sp>
-        <p:nvSpPr>
-          <p:cNvPr id="0" name="Grp-HOW WILL"/>
-          <p:cNvSpPr/>
-          <p:nvPr/>
-        </p:nvSpPr>
-        <p:spPr>
-          <a:xfrm>
-            <a:off x="274320" y="2880360"/>
-            <a:ext cx="2103120" cy="1371600"/>
-          </a:xfrm>
-          <a:prstGeom prst="rect">
-            <a:avLst/>
-          </a:prstGeom>
-          <a:solidFill>
-            <a:srgbClr val="8E6F3E"/>
-          </a:solidFill>
-          <a:ln>
-            <a:noFill/>
-          </a:ln>
-          <a:effectLst/>
-        </p:spPr>
-        <p:txBody>
-          <a:bodyPr rtlCol="0" anchor="ctr" wrap="square" lIns="27432" rIns="27432" tIns="22860" bIns="22860"/>
-          <a:lstStyle/>
-          <a:p>
-            <a:pPr algn="ctr">
-              <a:buNone/>
-            </a:pPr>
-            <a:r>
-              <a:rPr lang="en-US" sz="2000" b="1" i="0" dirty="0">
-                <a:solidFill>
-                  <a:srgbClr val="FFFFFF"/>
-                </a:solidFill>
-              </a:rPr>
-              <a:t>HOW WILL WE KNOW?</a:t>
-            </a:r>
-          </a:p>
-        </p:txBody>
-      </p:sp>
-      <p:sp>
-        <p:nvSpPr>
-          <p:cNvPr id="0" name="GrpItems-HOW WILL"/>
-          <p:cNvSpPr/>
-          <p:nvPr/>
-        </p:nvSpPr>
-        <p:spPr>
-          <a:xfrm>
-            <a:off x="2514600" y="2880360"/>
-            <a:ext cx="6355080" cy="1371600"/>
-          </a:xfrm>
-          <a:prstGeom prst="rect">
-            <a:avLst/>
-          </a:prstGeom>
-          <a:solidFill>
-            <a:srgbClr val="F5F1E8"/>
-          </a:solidFill>
-          <a:ln w="12700">
-            <a:solidFill>
-              <a:srgbClr val="C9B991"/>
-            </a:solidFill>
-          </a:ln>
-          <a:effectLst/>
-        </p:spPr>
-        <p:txBody>
-          <a:bodyPr rtlCol="0" anchor="ctr" wrap="square" lIns="27432" rIns="27432" tIns="22860" bIns="22860"/>
-          <a:lstStyle/>
-          <a:p>
-            <a:pPr algn="l">
-              <a:buNone/>
-            </a:pPr>
-            <a:r>
-              <a:rPr lang="en-US" sz="2000" b="1" i="0" dirty="0">
-                <a:solidFill>
-                  <a:srgbClr val="5C4826"/>
-                </a:solidFill>
-              </a:rPr>
-              <a:t>CONTROL — </a:t>
-            </a:r>
-            <a:r>
-              <a:rPr lang="en-US" sz="2000" b="0" i="0" dirty="0">
-                <a:solidFill>
-                  <a:srgbClr val="5C4826"/>
-                </a:solidFill>
-              </a:rPr>
-              <a:t>can we prevent it, or must we detect it?</a:t>
-            </a:r>
-          </a:p>
-          <a:p>
-            <a:pPr algn="l">
-              <a:spcBef>
-                <a:spcPts val="600"/>
-              </a:spcBef>
-              <a:buNone/>
-            </a:pPr>
-            <a:r>
-              <a:rPr lang="en-US" sz="2000" b="1" i="0" dirty="0">
-                <a:solidFill>
-                  <a:srgbClr val="5C4826"/>
-                </a:solidFill>
-              </a:rPr>
-              <a:t>EVIDENCE — </a:t>
-            </a:r>
-            <a:r>
-              <a:rPr lang="en-US" sz="2000" b="0" i="0" dirty="0">
-                <a:solidFill>
-                  <a:srgbClr val="5C4826"/>
-                </a:solidFill>
-              </a:rPr>
-              <a:t>what observation could establish it?</a:t>
-            </a:r>
-          </a:p>
-          <a:p>
-            <a:pPr algn="l">
-              <a:spcBef>
-                <a:spcPts val="600"/>
-              </a:spcBef>
-              <a:buNone/>
-            </a:pPr>
-            <a:r>
-              <a:rPr lang="en-US" sz="2000" b="1" i="0" dirty="0">
-                <a:solidFill>
-                  <a:srgbClr val="5C4826"/>
-                </a:solidFill>
-              </a:rPr>
-              <a:t>BOUNDARY — </a:t>
-            </a:r>
-            <a:r>
-              <a:rPr lang="en-US" sz="2000" b="0" i="0" dirty="0">
-                <a:solidFill>
-                  <a:srgbClr val="5C4826"/>
-                </a:solidFill>
-              </a:rPr>
-              <a:t>where does enough information exist?</a:t>
-            </a:r>
-          </a:p>
-        </p:txBody>
-      </p:sp>
-      <p:sp>
-        <p:nvSpPr>
-          <p:cNvPr id="0" name="Grp-WHAT WIL"/>
-          <p:cNvSpPr/>
-          <p:nvPr/>
-        </p:nvSpPr>
-        <p:spPr>
-          <a:xfrm>
-            <a:off x="274320" y="4389120"/>
-            <a:ext cx="2103120" cy="1005840"/>
-          </a:xfrm>
-          <a:prstGeom prst="rect">
-            <a:avLst/>
-          </a:prstGeom>
-          <a:solidFill>
-            <a:srgbClr val="8E6F3E"/>
-          </a:solidFill>
-          <a:ln>
-            <a:noFill/>
-          </a:ln>
-          <a:effectLst/>
-        </p:spPr>
-        <p:txBody>
-          <a:bodyPr rtlCol="0" anchor="ctr" wrap="square" lIns="27432" rIns="27432" tIns="22860" bIns="22860"/>
-          <a:lstStyle/>
-          <a:p>
-            <a:pPr algn="ctr">
-              <a:buNone/>
-            </a:pPr>
-            <a:r>
-              <a:rPr lang="en-US" sz="2000" b="1" i="0" dirty="0">
-                <a:solidFill>
-                  <a:srgbClr val="FFFFFF"/>
-                </a:solidFill>
-              </a:rPr>
-              <a:t>WHAT WILL IT CONTROL?</a:t>
-            </a:r>
-          </a:p>
-        </p:txBody>
-      </p:sp>
-      <p:sp>
-        <p:nvSpPr>
-          <p:cNvPr id="0" name="GrpItems-WHAT WIL"/>
-          <p:cNvSpPr/>
-          <p:nvPr/>
-        </p:nvSpPr>
-        <p:spPr>
-          <a:xfrm>
-            <a:off x="2514600" y="4389120"/>
-            <a:ext cx="6355080" cy="1005840"/>
-          </a:xfrm>
-          <a:prstGeom prst="rect">
-            <a:avLst/>
-          </a:prstGeom>
-          <a:solidFill>
-            <a:srgbClr val="F5F1E8"/>
-          </a:solidFill>
-          <a:ln w="12700">
-            <a:solidFill>
-              <a:srgbClr val="C9B991"/>
-            </a:solidFill>
-          </a:ln>
-          <a:effectLst/>
-        </p:spPr>
-        <p:txBody>
-          <a:bodyPr rtlCol="0" anchor="ctr" wrap="square" lIns="27432" rIns="27432" tIns="22860" bIns="22860"/>
-          <a:lstStyle/>
-          <a:p>
-            <a:pPr algn="l">
-              <a:buNone/>
-            </a:pPr>
-            <a:r>
-              <a:rPr lang="en-US" sz="2000" b="1" i="0" dirty="0">
-                <a:solidFill>
-                  <a:srgbClr val="5C4826"/>
-                </a:solidFill>
-              </a:rPr>
-              <a:t>MECHANISM — </a:t>
-            </a:r>
-            <a:r>
-              <a:rPr lang="en-US" sz="2000" b="0" i="0" dirty="0">
-                <a:solidFill>
-                  <a:srgbClr val="5C4826"/>
-                </a:solidFill>
-              </a:rPr>
-              <a:t>constraint · sensor · validator · gate</a:t>
-            </a:r>
-          </a:p>
-          <a:p>
-            <a:pPr algn="l">
-              <a:spcBef>
-                <a:spcPts val="600"/>
-              </a:spcBef>
-              <a:buNone/>
-            </a:pPr>
-            <a:r>
-              <a:rPr lang="en-US" sz="2000" b="1" i="0" dirty="0">
-                <a:solidFill>
-                  <a:srgbClr val="5C4826"/>
-                </a:solidFill>
-              </a:rPr>
-              <a:t>AUTHORITY — </a:t>
-            </a:r>
-            <a:r>
-              <a:rPr lang="en-US" sz="2000" b="0" i="0" dirty="0">
-                <a:solidFill>
-                  <a:srgbClr val="5C4826"/>
-                </a:solidFill>
-              </a:rPr>
-              <a:t>what happens if it fails?</a:t>
             </a:r>
           </a:p>
         </p:txBody>

</xml_diff>

<commit_message>
deck 2-3: section 5 merges — models buy-us into lab-models slide, static/dynamic to two slides with corrected lab questions, agreement triangle absorbs three-kinds-of-claim (36->33)
</commit_message>
<xml_diff>
--- a/course/lectures/act-2-delegation-and-control/03-alignment/2-3-Alignment.pptx
+++ b/course/lectures/act-2-delegation-and-control/03-alignment/2-3-Alignment.pptx
@@ -35,11 +35,8 @@
     <p:sldId id="273" r:id="rId24"/>
     <p:sldId id="288" r:id="rId53"/>
     <p:sldId id="307" r:id="rId10"/>
-    <p:sldId id="279" r:id="rId30"/>
     <p:sldId id="308" r:id="rId8"/>
     <p:sldId id="309" r:id="rId6"/>
-    <p:sldId id="310" r:id="rId5"/>
-    <p:sldId id="280" r:id="rId31"/>
     <p:sldId id="281" r:id="rId32"/>
     <p:sldId id="274" r:id="rId25"/>
     <p:sldId id="276" r:id="rId27"/>
@@ -1875,241 +1872,6 @@
 </p:notes>
 </file>
 
-<file path=ppt/notesSlides/notesSlide24.xml><?xml version="1.0" encoding="utf-8"?>
-<p:notes xmlns:a="http://schemas.openxmlformats.org/drawingml/2006/main" xmlns:p="http://schemas.openxmlformats.org/presentationml/2006/main" xmlns:r="http://schemas.openxmlformats.org/officeDocument/2006/relationships">
-  <p:cSld>
-    <p:spTree>
-      <p:nvGrpSpPr>
-        <p:cNvPr id="1" name=""/>
-        <p:cNvGrpSpPr/>
-        <p:nvPr/>
-      </p:nvGrpSpPr>
-      <p:grpSpPr>
-        <a:xfrm>
-          <a:off x="0" y="0"/>
-          <a:ext cx="0" cy="0"/>
-          <a:chOff x="0" y="0"/>
-          <a:chExt cx="0" cy="0"/>
-        </a:xfrm>
-      </p:grpSpPr>
-      <p:sp>
-        <p:nvSpPr>
-          <p:cNvPr id="2" name="Slide Image Placeholder 1"/>
-          <p:cNvSpPr>
-            <a:spLocks noGrp="1"/>
-          </p:cNvSpPr>
-          <p:nvPr>
-            <p:ph type="sldImg" idx="2"/>
-          </p:nvPr>
-        </p:nvSpPr>
-        <p:spPr/>
-      </p:sp>
-      <p:sp>
-        <p:nvSpPr>
-          <p:cNvPr id="3" name="Notes Placeholder 2"/>
-          <p:cNvSpPr>
-            <a:spLocks noGrp="1"/>
-          </p:cNvSpPr>
-          <p:nvPr>
-            <p:ph type="body" idx="3" sz="quarter"/>
-          </p:nvPr>
-        </p:nvSpPr>
-        <p:spPr/>
-        <p:txBody>
-          <a:bodyPr/>
-          <a:lstStyle/>
-          <a:p>
-            <a:r>
-              <a:t>TIMING: 2 minutes</a:t>
-            </a:r>
-          </a:p>
-          <a:p>
-            <a:r>
-              <a:t>- This slide is the ANSWER to the discussion on the previous slide — show it only after the students talk.</a:t>
-            </a:r>
-          </a:p>
-          <a:p>
-            <a:r>
-              <a:t>- A model preserves distinctions we have decided matter.</a:t>
-            </a:r>
-          </a:p>
-          <a:p>
-            <a:r>
-              <a:t>- It exposes relationships that would otherwise need to be inferred.</a:t>
-            </a:r>
-          </a:p>
-          <a:p>
-            <a:r>
-              <a:t>- It can deliberately leave realization choices open.</a:t>
-            </a:r>
-          </a:p>
-          <a:p>
-            <a:r>
-              <a:t>- And because the information is explicit and structured, analyses can operate over it directly.</a:t>
-            </a:r>
-          </a:p>
-          <a:p>
-            <a:r>
-              <a:t>- The key point is not that models contain more information than implementation.</a:t>
-            </a:r>
-          </a:p>
-          <a:p>
-            <a:r>
-              <a:t>- The point is that they can contain the right engineering information in a form suited to the question.</a:t>
-            </a:r>
-          </a:p>
-          <a:p>
-            <a:r>
-              <a:t>- Multiple analyses can then operate over the same explicit knowledge.</a:t>
-            </a:r>
-          </a:p>
-          <a:p>
-            <a:r>
-              <a:t>ANIMATION</a:t>
-            </a:r>
-          </a:p>
-          <a:p>
-            <a:r>
-              <a:t>- Reveal PRESERVE.</a:t>
-            </a:r>
-          </a:p>
-          <a:p>
-            <a:r>
-              <a:t>- Reveal EXPOSE.</a:t>
-            </a:r>
-          </a:p>
-          <a:p>
-            <a:r>
-              <a:t>- Reveal LEAVE OPEN.</a:t>
-            </a:r>
-          </a:p>
-          <a:p>
-            <a:r>
-              <a:t>- Reveal ENABLE.</a:t>
-            </a:r>
-          </a:p>
-          <a:p>
-            <a:r>
-              <a:t>- Reveal the concluding sentence last.</a:t>
-            </a:r>
-          </a:p>
-        </p:txBody>
-      </p:sp>
-      <p:sp>
-        <p:nvSpPr>
-          <p:cNvPr id="4" name="Slide Number Placeholder 3"/>
-          <p:cNvSpPr>
-            <a:spLocks noGrp="1"/>
-          </p:cNvSpPr>
-          <p:nvPr>
-            <p:ph type="sldNum" idx="5" sz="quarter"/>
-          </p:nvPr>
-        </p:nvSpPr>
-        <p:spPr/>
-      </p:sp>
-    </p:spTree>
-  </p:cSld>
-  <p:clrMapOvr>
-    <a:masterClrMapping/>
-  </p:clrMapOvr>
-</p:notes>
-</file>
-
-<file path=ppt/notesSlides/notesSlide25.xml><?xml version="1.0" encoding="utf-8"?>
-<p:notes xmlns:a="http://schemas.openxmlformats.org/drawingml/2006/main" xmlns:p="http://schemas.openxmlformats.org/presentationml/2006/main" xmlns:r="http://schemas.openxmlformats.org/officeDocument/2006/relationships">
-  <p:cSld>
-    <p:spTree>
-      <p:nvGrpSpPr>
-        <p:cNvPr id="1" name=""/>
-        <p:cNvGrpSpPr/>
-        <p:nvPr/>
-      </p:nvGrpSpPr>
-      <p:grpSpPr>
-        <a:xfrm>
-          <a:off x="0" y="0"/>
-          <a:ext cx="0" cy="0"/>
-          <a:chOff x="0" y="0"/>
-          <a:chExt cx="0" cy="0"/>
-        </a:xfrm>
-      </p:grpSpPr>
-      <p:sp>
-        <p:nvSpPr>
-          <p:cNvPr id="2" name="Slide Image Placeholder 1"/>
-          <p:cNvSpPr>
-            <a:spLocks noGrp="1"/>
-          </p:cNvSpPr>
-          <p:nvPr>
-            <p:ph type="sldImg" idx="2"/>
-          </p:nvPr>
-        </p:nvSpPr>
-        <p:spPr/>
-      </p:sp>
-      <p:sp>
-        <p:nvSpPr>
-          <p:cNvPr id="3" name="Notes Placeholder 2"/>
-          <p:cNvSpPr>
-            <a:spLocks noGrp="1"/>
-          </p:cNvSpPr>
-          <p:nvPr>
-            <p:ph type="body" idx="3" sz="quarter"/>
-          </p:nvPr>
-        </p:nvSpPr>
-        <p:spPr/>
-        <p:txBody>
-          <a:bodyPr/>
-          <a:lstStyle/>
-          <a:p>
-            <a:r>
-              <a:t>TIMING: 2 minutes</a:t>
-            </a:r>
-          </a:p>
-          <a:p>
-            <a:r>
-              <a:t>- Once we have models, we need one more distinction — three different kinds of claim.</a:t>
-            </a:r>
-          </a:p>
-          <a:p>
-            <a:r>
-              <a:t>- Correspondence: do two representations agree?</a:t>
-            </a:r>
-          </a:p>
-          <a:p>
-            <a:r>
-              <a:t>- Conformance: does an artifact satisfy an independent obligation?</a:t>
-            </a:r>
-          </a:p>
-          <a:p>
-            <a:r>
-              <a:t>- Acceptance: will the receiving environment accept the artifact?</a:t>
-            </a:r>
-          </a:p>
-          <a:p>
-            <a:r>
-              <a:t>- A model and implementation can agree and both be wrong against the obligation. Evidence for one claim does not establish the others.</a:t>
-            </a:r>
-          </a:p>
-        </p:txBody>
-      </p:sp>
-      <p:sp>
-        <p:nvSpPr>
-          <p:cNvPr id="4" name="Slide Number Placeholder 3"/>
-          <p:cNvSpPr>
-            <a:spLocks noGrp="1"/>
-          </p:cNvSpPr>
-          <p:nvPr>
-            <p:ph type="sldNum" idx="5" sz="quarter"/>
-          </p:nvPr>
-        </p:nvSpPr>
-        <p:spPr/>
-      </p:sp>
-    </p:spTree>
-  </p:cSld>
-  <p:clrMapOvr>
-    <a:masterClrMapping/>
-  </p:clrMapOvr>
-</p:notes>
-</file>
-
 <file path=ppt/notesSlides/notesSlide26.xml><?xml version="1.0" encoding="utf-8"?>
 <p:notes xmlns:a="http://schemas.openxmlformats.org/drawingml/2006/main" xmlns:p="http://schemas.openxmlformats.org/presentationml/2006/main" xmlns:r="http://schemas.openxmlformats.org/officeDocument/2006/relationships">
   <p:cSld>
@@ -2155,47 +1917,42 @@
           <a:lstStyle/>
           <a:p>
             <a:r>
-              <a:t>TIMING: 2-3 minutes</a:t>
-            </a:r>
-          </a:p>
-          <a:p>
-            <a:r>
-              <a:t>- Specialize that distinction to model-based engineering.</a:t>
-            </a:r>
-          </a:p>
-          <a:p>
-            <a:r>
-              <a:t>- Transition explicitly: those were three different kinds of engineering claim. Now specialize this to model-based engineering. We have three things that can disagree.</a:t>
-            </a:r>
-          </a:p>
-          <a:p>
-            <a:r>
-              <a:t>- We now have an obligation, a model, and a realization.</a:t>
-            </a:r>
-          </a:p>
-          <a:p>
-            <a:r>
-              <a:t>- Ask what claim each edge makes.</a:t>
-            </a:r>
-          </a:p>
-          <a:p>
-            <a:r>
-              <a:t>- Does the model actually capture the obligation?</a:t>
-            </a:r>
-          </a:p>
-          <a:p>
-            <a:r>
-              <a:t>- Does the realization satisfy the obligation?</a:t>
-            </a:r>
-          </a:p>
-          <a:p>
-            <a:r>
-              <a:t>- Do model and realization correspond?</a:t>
-            </a:r>
-          </a:p>
-          <a:p>
-            <a:r>
-              <a:t>- None of those edges establishes the other two.</a:t>
+              <a:t>TIMING: 3 minutes</a:t>
+            </a:r>
+          </a:p>
+          <a:p>
+            <a:r>
+              <a:t>- One distinction left: three kinds of judgment. The triangle carries them.</a:t>
+            </a:r>
+          </a:p>
+          <a:p>
+            <a:r>
+              <a:t>- We have an obligation, a model, and a realization. Ask what claim each edge makes.</a:t>
+            </a:r>
+          </a:p>
+          <a:p>
+            <a:r>
+              <a:t>- captures? — does the model actually capture the obligation?</a:t>
+            </a:r>
+          </a:p>
+          <a:p>
+            <a:r>
+              <a:t>- satisfies? — does the realization satisfy the obligation? That judgment is CONFORMANCE: an artifact against an independent obligation.</a:t>
+            </a:r>
+          </a:p>
+          <a:p>
+            <a:r>
+              <a:t>- corresponds? — do model and realization agree? That judgment is CORRESPONDENCE: two representations against each other.</a:t>
+            </a:r>
+          </a:p>
+          <a:p>
+            <a:r>
+              <a:t>- ACCEPTANCE brings in a fourth object, the receiving environment: will it accept the artifact? On the slide it is the third legend line, not a fourth node — name the fourth object aloud.</a:t>
+            </a:r>
+          </a:p>
+          <a:p>
+            <a:r>
+              <a:t>- None of these edges establishes the other two. A model and implementation can agree and both be wrong against the obligation. Evidence for one claim does not establish the others.</a:t>
             </a:r>
           </a:p>
           <a:p>
@@ -2210,6 +1967,11 @@
           </a:p>
           <a:p>
             <a:r>
+              <a:t>- (Demoted from the slide; ask aloud:) What claim does each edge make? What evidence would establish it?</a:t>
+            </a:r>
+          </a:p>
+          <a:p>
+            <a:r>
               <a:t>ANIMATION</a:t>
             </a:r>
           </a:p>
@@ -2220,22 +1982,7 @@
           </a:p>
           <a:p>
             <a:r>
-              <a:t>- Reveal obligation-model question.</a:t>
-            </a:r>
-          </a:p>
-          <a:p>
-            <a:r>
-              <a:t>- Reveal obligation-realization question.</a:t>
-            </a:r>
-          </a:p>
-          <a:p>
-            <a:r>
-              <a:t>- Reveal model-realization question.</a:t>
-            </a:r>
-          </a:p>
-          <a:p>
-            <a:r>
-              <a:t>- Ask "What evidence would establish each?" before revealing the closing sentence.</a:t>
+              <a:t>- Reveal the three edge questions, then the legend naming the three judgments.</a:t>
             </a:r>
           </a:p>
         </p:txBody>
@@ -3805,7 +3552,27 @@
           </a:p>
           <a:p>
             <a:r>
-              <a:t>- The next slide is the answer — show it after they talk.</a:t>
+              <a:t>- The VALIDATION SURFACE strip at the bottom is the answer — reveal it after they talk.</a:t>
+            </a:r>
+          </a:p>
+          <a:p>
+            <a:r>
+              <a:t>THE REVEAL (absorbs the deleted answer slide; it is the strip under the cards):</a:t>
+            </a:r>
+          </a:p>
+          <a:p>
+            <a:r>
+              <a:t>- A model preserves consequential distinctions; exposes relationships that would otherwise be inferred; deliberately leaves irrelevant realization choices open; enables evaluation without reconstruction.</a:t>
+            </a:r>
+          </a:p>
+          <a:p>
+            <a:r>
+              <a:t>- The key point is not that models contain MORE information than the implementation — they contain the right engineering information in a form suited to the question. Multiple analyses can then operate over the same explicit knowledge.</a:t>
+            </a:r>
+          </a:p>
+          <a:p>
+            <a:r>
+              <a:t>- Spoken gloss for the strip label: models give validation mechanisms an explicit object to inspect — that is why the strip is labeled VALIDATION SURFACE.</a:t>
             </a:r>
           </a:p>
         </p:txBody>
@@ -3885,7 +3652,7 @@
           </a:p>
           <a:p>
             <a:r>
-              <a:t>- Ground each question in the lab. 'Can the memory bound be exceeded' is exactly the lab's budget query: peak working memory against the declared 48 KB ceiling — the query that reported 80 KB in Stage 1. 'Does every permitted route cross the required boundary' is the graph query that the Scheduler admits every thread. An illegal transition is one the lifecycle machines do not declare.</a:t>
+              <a:t>- Ground each question in the lab. 'Can admitted threads exceed the memory ceiling?' is the budget query: peak working memory of admitted threads against the declared 48 KB ceiling — the query that reported 80 KB in Stage 1. 'Can three threads be Awake simultaneously?' is decided against the Scheduler's admission rule: at most two awake. 'Is an illegal lifecycle transition reachable?' asks for a transition the lifecycle machines do not declare.</a:t>
             </a:r>
           </a:p>
           <a:p>
@@ -3965,12 +3732,12 @@
           </a:p>
           <a:p>
             <a:r>
-              <a:t>- The same model can define what a SENSOR must observe at runtime: the model states expected behavior; the trace is checked against it.</a:t>
-            </a:r>
-          </a:p>
-          <a:p>
-            <a:r>
-              <a:t>- Ground it in the lab's lifecycle machines: every thread is Asleep or Awake, moved by admit and release events. Did an observed wake correspond to a declared transition? Did the awake count ever exceed two? Did working memory stay within its modeled 48 KB bound?</a:t>
+              <a:t>- Dynamic validation: the same model defines what a SENSOR must observe at runtime — the model states expected behavior; the trace is checked against it.</a:t>
+            </a:r>
+          </a:p>
+          <a:p>
+            <a:r>
+              <a:t>- Ground it in the lab's lifecycle machines: every thread is Asleep or Awake, moved by admit and release events. The observation questions (now spoken, no longer projected): Did the observed transition exist in the model? Did events occur in the required order? Did execution enter a forbidden state? Did a measured quantity stay within its modeled bound — did the awake count ever exceed two, and did working memory stay within 48 KB?</a:t>
             </a:r>
           </a:p>
           <a:p>
@@ -3978,79 +3745,9 @@
               <a:t>- This prevents students from hearing 'model-based validation' as synonymous with static analysis.</a:t>
             </a:r>
           </a:p>
-        </p:txBody>
-      </p:sp>
-      <p:sp>
-        <p:nvSpPr>
-          <p:cNvPr id="4" name="Slide Number Placeholder 3"/>
-          <p:cNvSpPr>
-            <a:spLocks noGrp="1"/>
-          </p:cNvSpPr>
-          <p:nvPr>
-            <p:ph type="sldNum" idx="5" sz="quarter"/>
-          </p:nvPr>
-        </p:nvSpPr>
-        <p:spPr/>
-      </p:sp>
-    </p:spTree>
-  </p:cSld>
-  <p:clrMapOvr>
-    <a:masterClrMapping/>
-  </p:clrMapOvr>
-</p:notes>
-</file>
-
-<file path=ppt/notesSlides/notesSlide46.xml><?xml version="1.0" encoding="utf-8"?>
-<p:notes xmlns:a="http://schemas.openxmlformats.org/drawingml/2006/main" xmlns:p="http://schemas.openxmlformats.org/presentationml/2006/main" xmlns:r="http://schemas.openxmlformats.org/officeDocument/2006/relationships">
-  <p:cSld>
-    <p:spTree>
-      <p:nvGrpSpPr>
-        <p:cNvPr id="1" name=""/>
-        <p:cNvGrpSpPr/>
-        <p:nvPr/>
-      </p:nvGrpSpPr>
-      <p:grpSpPr>
-        <a:xfrm>
-          <a:off x="0" y="0"/>
-          <a:ext cx="0" cy="0"/>
-          <a:chOff x="0" y="0"/>
-          <a:chExt cx="0" cy="0"/>
-        </a:xfrm>
-      </p:grpSpPr>
-      <p:sp>
-        <p:nvSpPr>
-          <p:cNvPr id="2" name="Slide Image Placeholder 1"/>
-          <p:cNvSpPr>
-            <a:spLocks noGrp="1"/>
-          </p:cNvSpPr>
-          <p:nvPr>
-            <p:ph type="sldImg" idx="2"/>
-          </p:nvPr>
-        </p:nvSpPr>
-        <p:spPr/>
-      </p:sp>
-      <p:sp>
-        <p:nvSpPr>
-          <p:cNvPr id="3" name="Notes Placeholder 2"/>
-          <p:cNvSpPr>
-            <a:spLocks noGrp="1"/>
-          </p:cNvSpPr>
-          <p:nvPr>
-            <p:ph type="body" idx="3" sz="quarter"/>
-          </p:nvPr>
-        </p:nvSpPr>
-        <p:spPr/>
-        <p:txBody>
-          <a:bodyPr/>
-          <a:lstStyle/>
-          <a:p>
-            <a:r>
-              <a:t>TIMING: 2 minutes</a:t>
-            </a:r>
-          </a:p>
-          <a:p>
-            <a:r>
-              <a:t>- One model, two validation strategies. Static verdicts are exhaustive over the modeled space and available before execution; dynamic verdicts are evidence about the runs you actually observed.</a:t>
+          <a:p>
+            <a:r>
+              <a:t>- The STATIC / DYNAMIC panel (absorbed from the deleted strategies slide): static — verdict over the modeled space, exhaustive, available before execution; dynamic — verdict over observed execution, evidence about the runs you actually observed.</a:t>
             </a:r>
           </a:p>
           <a:p>
@@ -17303,7 +17000,7 @@
         <p:spPr>
           <a:xfrm>
             <a:off x="502920" y="1051560"/>
-            <a:ext cx="3977639" cy="4038600"/>
+            <a:ext cx="3977639" cy="3429000"/>
           </a:xfrm>
           <a:prstGeom prst="rect">
             <a:avLst/>
@@ -17425,7 +17122,7 @@
         <p:spPr>
           <a:xfrm>
             <a:off x="4663440" y="1051560"/>
-            <a:ext cx="3977639" cy="4038600"/>
+            <a:ext cx="3977639" cy="3429000"/>
           </a:xfrm>
           <a:prstGeom prst="rect">
             <a:avLst/>
@@ -17573,88 +17270,21 @@
                   <a:srgbClr val="FFFFFF"/>
                 </a:solidFill>
               </a:rPr>
-              <a:t>DISCUSSION  ·  How might we use these in validation?</a:t>
-            </a:r>
-          </a:p>
-        </p:txBody>
-      </p:sp>
-    </p:spTree>
-  </p:cSld>
-  <p:clrMapOvr>
-    <a:masterClrMapping/>
-  </p:clrMapOvr>
-</p:sld>
-</file>
-
-<file path=ppt/slides/slide28.xml><?xml version="1.0" encoding="utf-8"?>
-<p:sld xmlns:a="http://schemas.openxmlformats.org/drawingml/2006/main" xmlns:p="http://schemas.openxmlformats.org/presentationml/2006/main" xmlns:r="http://schemas.openxmlformats.org/officeDocument/2006/relationships">
-  <p:cSld>
-    <p:spTree>
-      <p:nvGrpSpPr>
-        <p:cNvPr id="1" name=""/>
-        <p:cNvGrpSpPr/>
-        <p:nvPr/>
-      </p:nvGrpSpPr>
-      <p:grpSpPr/>
-      <p:sp>
-        <p:nvSpPr>
-          <p:cNvPr id="3" name="Title 2"/>
-          <p:cNvSpPr>
-            <a:spLocks noGrp="1"/>
-          </p:cNvSpPr>
-          <p:nvPr>
-            <p:ph type="title"/>
-          </p:nvPr>
-        </p:nvSpPr>
-        <p:spPr/>
-        <p:txBody>
-          <a:bodyPr wrap="square"/>
-          <a:lstStyle/>
-          <a:p>
-            <a:r>
-              <a:rPr sz="2400" b="0">
-                <a:solidFill>
-                  <a:srgbClr val="000000"/>
-                </a:solidFill>
-              </a:rPr>
-              <a:t>Models make engineering knowledge explicit</a:t>
-            </a:r>
-          </a:p>
-        </p:txBody>
-      </p:sp>
-      <p:sp>
-        <p:nvSpPr>
-          <p:cNvPr id="4" name="Slide Number Placeholder 5"/>
-          <p:cNvSpPr>
-            <a:spLocks noGrp="1"/>
-          </p:cNvSpPr>
-          <p:nvPr>
-            <p:ph type="sldNum" sz="quarter" idx="4"/>
-          </p:nvPr>
-        </p:nvSpPr>
-        <p:spPr/>
-        <p:txBody>
-          <a:bodyPr/>
-          <a:lstStyle/>
-          <a:p>
-            <a:fld id="{B7EB45DA-9A0D-DC49-8E02-F30A5DDC21C3}" type="slidenum">
-              <a:rPr lang="en-US" smtClean="0"/>
-              <a:t>28</a:t>
-            </a:fld>
-            <a:endParaRPr lang="en-US"/>
-          </a:p>
-        </p:txBody>
-      </p:sp>
-      <p:sp>
-        <p:nvSpPr>
-          <p:cNvPr id="5" name="TextBox 4"/>
+              <a:t>DISCUSSION  ·  What do these models buy us in validation?</a:t>
+            </a:r>
+          </a:p>
+        </p:txBody>
+      </p:sp>
+      <p:sp>
+        <p:nvSpPr>
+          <p:cNvPr id="101" name="TextBox 13"/>
           <p:cNvSpPr txBox="1"/>
           <p:nvPr/>
         </p:nvSpPr>
         <p:spPr>
           <a:xfrm>
-            <a:off x="640080" y="914400"/>
-            <a:ext cx="8595360" cy="365760"/>
+            <a:off x="274320" y="4526280"/>
+            <a:ext cx="8595360" cy="320040"/>
           </a:xfrm>
           <a:prstGeom prst="rect">
             <a:avLst/>
@@ -17667,82 +17297,28 @@
           </a:bodyPr>
           <a:lstStyle/>
           <a:p>
-            <a:pPr algn="l"/>
-            <a:r>
-              <a:rPr sz="2000" b="1" i="0">
+            <a:pPr algn="ctr"/>
+            <a:r>
+              <a:rPr sz="2000" b="1">
                 <a:solidFill>
                   <a:srgbClr val="8E6F3E"/>
                 </a:solidFill>
               </a:rPr>
-              <a:t>A MODEL CAN …</a:t>
-            </a:r>
-          </a:p>
-        </p:txBody>
-      </p:sp>
-      <p:sp>
-        <p:nvSpPr>
-          <p:cNvPr id="6" name="Rectangle 5"/>
-          <p:cNvSpPr/>
-          <p:nvPr/>
-        </p:nvSpPr>
-        <p:spPr>
-          <a:xfrm>
-            <a:off x="640080" y="1371600"/>
-            <a:ext cx="2560320" cy="731520"/>
-          </a:xfrm>
-          <a:prstGeom prst="rect">
-            <a:avLst/>
-          </a:prstGeom>
-          <a:solidFill>
-            <a:srgbClr val="F5F1E8"/>
-          </a:solidFill>
-          <a:ln w="12700">
-            <a:solidFill>
-              <a:srgbClr val="C9B991"/>
-            </a:solidFill>
-          </a:ln>
-          <a:effectLst/>
-        </p:spPr>
-        <p:style>
-          <a:lnRef idx="1">
-            <a:schemeClr val="accent1"/>
-          </a:lnRef>
-          <a:fillRef idx="3">
-            <a:schemeClr val="accent1"/>
-          </a:fillRef>
-          <a:effectRef idx="2">
-            <a:schemeClr val="accent1"/>
-          </a:effectRef>
-          <a:fontRef idx="minor">
-            <a:schemeClr val="lt1"/>
-          </a:fontRef>
-        </p:style>
-        <p:txBody>
-          <a:bodyPr rtlCol="0" anchor="ctr" wrap="square" lIns="27432" rIns="27432" tIns="22860" bIns="22860"/>
-          <a:lstStyle/>
-          <a:p>
-            <a:pPr algn="ctr"/>
-            <a:r>
-              <a:rPr sz="2000" b="1" i="0">
-                <a:solidFill>
-                  <a:srgbClr val="5C4826"/>
-                </a:solidFill>
-              </a:rPr>
-              <a:t>PRESERVE</a:t>
-            </a:r>
-          </a:p>
-        </p:txBody>
-      </p:sp>
-      <p:sp>
-        <p:nvSpPr>
-          <p:cNvPr id="7" name="TextBox 6"/>
+              <a:t>VALIDATION SURFACE</a:t>
+            </a:r>
+          </a:p>
+        </p:txBody>
+      </p:sp>
+      <p:sp>
+        <p:nvSpPr>
+          <p:cNvPr id="102" name="TextBox 13"/>
           <p:cNvSpPr txBox="1"/>
           <p:nvPr/>
         </p:nvSpPr>
         <p:spPr>
           <a:xfrm>
-            <a:off x="3383280" y="1499616"/>
-            <a:ext cx="5440680" cy="731520"/>
+            <a:off x="274320" y="4864608"/>
+            <a:ext cx="8595360" cy="777240"/>
           </a:xfrm>
           <a:prstGeom prst="rect">
             <a:avLst/>
@@ -17755,311 +17331,25 @@
           </a:bodyPr>
           <a:lstStyle/>
           <a:p>
-            <a:pPr algn="l"/>
-            <a:r>
-              <a:rPr sz="2000" b="0" i="0">
+            <a:pPr algn="ctr"/>
+            <a:r>
+              <a:rPr sz="2000" b="0">
                 <a:solidFill>
                   <a:srgbClr val="5C4826"/>
                 </a:solidFill>
               </a:rPr>
-              <a:t>distinctions that matter</a:t>
-            </a:r>
-          </a:p>
-        </p:txBody>
-      </p:sp>
-      <p:sp>
-        <p:nvSpPr>
-          <p:cNvPr id="8" name="Rectangle 7"/>
-          <p:cNvSpPr/>
-          <p:nvPr/>
-        </p:nvSpPr>
-        <p:spPr>
-          <a:xfrm>
-            <a:off x="640080" y="2304288"/>
-            <a:ext cx="2560320" cy="731520"/>
-          </a:xfrm>
-          <a:prstGeom prst="rect">
-            <a:avLst/>
-          </a:prstGeom>
-          <a:solidFill>
-            <a:srgbClr val="F5F1E8"/>
-          </a:solidFill>
-          <a:ln w="12700">
-            <a:solidFill>
-              <a:srgbClr val="C9B991"/>
-            </a:solidFill>
-          </a:ln>
-          <a:effectLst/>
-        </p:spPr>
-        <p:style>
-          <a:lnRef idx="1">
-            <a:schemeClr val="accent1"/>
-          </a:lnRef>
-          <a:fillRef idx="3">
-            <a:schemeClr val="accent1"/>
-          </a:fillRef>
-          <a:effectRef idx="2">
-            <a:schemeClr val="accent1"/>
-          </a:effectRef>
-          <a:fontRef idx="minor">
-            <a:schemeClr val="lt1"/>
-          </a:fontRef>
-        </p:style>
-        <p:txBody>
-          <a:bodyPr rtlCol="0" anchor="ctr" wrap="square" lIns="27432" rIns="27432" tIns="22860" bIns="22860"/>
-          <a:lstStyle/>
+              <a:t>preserve consequential distinctions   ·   expose relationships</a:t>
+            </a:r>
+          </a:p>
           <a:p>
             <a:pPr algn="ctr"/>
             <a:r>
-              <a:rPr sz="2000" b="1" i="0">
+              <a:rPr sz="2000" b="0">
                 <a:solidFill>
                   <a:srgbClr val="5C4826"/>
                 </a:solidFill>
               </a:rPr>
-              <a:t>EXPOSE</a:t>
-            </a:r>
-          </a:p>
-        </p:txBody>
-      </p:sp>
-      <p:sp>
-        <p:nvSpPr>
-          <p:cNvPr id="9" name="TextBox 8"/>
-          <p:cNvSpPr txBox="1"/>
-          <p:nvPr/>
-        </p:nvSpPr>
-        <p:spPr>
-          <a:xfrm>
-            <a:off x="3383280" y="2432304"/>
-            <a:ext cx="5440680" cy="731520"/>
-          </a:xfrm>
-          <a:prstGeom prst="rect">
-            <a:avLst/>
-          </a:prstGeom>
-          <a:noFill/>
-        </p:spPr>
-        <p:txBody>
-          <a:bodyPr wrap="square" anchor="t">
-            <a:spAutoFit/>
-          </a:bodyPr>
-          <a:lstStyle/>
-          <a:p>
-            <a:pPr algn="l"/>
-            <a:r>
-              <a:rPr sz="2000" b="0" i="0">
-                <a:solidFill>
-                  <a:srgbClr val="5C4826"/>
-                </a:solidFill>
-              </a:rPr>
-              <a:t>relationships that would otherwise have to be inferred</a:t>
-            </a:r>
-          </a:p>
-        </p:txBody>
-      </p:sp>
-      <p:sp>
-        <p:nvSpPr>
-          <p:cNvPr id="10" name="Rectangle 9"/>
-          <p:cNvSpPr/>
-          <p:nvPr/>
-        </p:nvSpPr>
-        <p:spPr>
-          <a:xfrm>
-            <a:off x="640080" y="3236976"/>
-            <a:ext cx="2560320" cy="731520"/>
-          </a:xfrm>
-          <a:prstGeom prst="rect">
-            <a:avLst/>
-          </a:prstGeom>
-          <a:solidFill>
-            <a:srgbClr val="F5F1E8"/>
-          </a:solidFill>
-          <a:ln w="12700">
-            <a:solidFill>
-              <a:srgbClr val="C9B991"/>
-            </a:solidFill>
-          </a:ln>
-          <a:effectLst/>
-        </p:spPr>
-        <p:style>
-          <a:lnRef idx="1">
-            <a:schemeClr val="accent1"/>
-          </a:lnRef>
-          <a:fillRef idx="3">
-            <a:schemeClr val="accent1"/>
-          </a:fillRef>
-          <a:effectRef idx="2">
-            <a:schemeClr val="accent1"/>
-          </a:effectRef>
-          <a:fontRef idx="minor">
-            <a:schemeClr val="lt1"/>
-          </a:fontRef>
-        </p:style>
-        <p:txBody>
-          <a:bodyPr rtlCol="0" anchor="ctr" wrap="square" lIns="27432" rIns="27432" tIns="22860" bIns="22860"/>
-          <a:lstStyle/>
-          <a:p>
-            <a:pPr algn="ctr"/>
-            <a:r>
-              <a:rPr sz="2000" b="1" i="0">
-                <a:solidFill>
-                  <a:srgbClr val="5C4826"/>
-                </a:solidFill>
-              </a:rPr>
-              <a:t>LEAVE OPEN</a:t>
-            </a:r>
-          </a:p>
-        </p:txBody>
-      </p:sp>
-      <p:sp>
-        <p:nvSpPr>
-          <p:cNvPr id="11" name="TextBox 10"/>
-          <p:cNvSpPr txBox="1"/>
-          <p:nvPr/>
-        </p:nvSpPr>
-        <p:spPr>
-          <a:xfrm>
-            <a:off x="3383280" y="3364992"/>
-            <a:ext cx="5440680" cy="731520"/>
-          </a:xfrm>
-          <a:prstGeom prst="rect">
-            <a:avLst/>
-          </a:prstGeom>
-          <a:noFill/>
-        </p:spPr>
-        <p:txBody>
-          <a:bodyPr wrap="square" anchor="t">
-            <a:spAutoFit/>
-          </a:bodyPr>
-          <a:lstStyle/>
-          <a:p>
-            <a:pPr algn="l"/>
-            <a:r>
-              <a:rPr sz="2000" b="0" i="0">
-                <a:solidFill>
-                  <a:srgbClr val="5C4826"/>
-                </a:solidFill>
-              </a:rPr>
-              <a:t>realization choices that do not matter</a:t>
-            </a:r>
-          </a:p>
-        </p:txBody>
-      </p:sp>
-      <p:sp>
-        <p:nvSpPr>
-          <p:cNvPr id="12" name="Rectangle 11"/>
-          <p:cNvSpPr/>
-          <p:nvPr/>
-        </p:nvSpPr>
-        <p:spPr>
-          <a:xfrm>
-            <a:off x="640080" y="4169664"/>
-            <a:ext cx="2560320" cy="731520"/>
-          </a:xfrm>
-          <a:prstGeom prst="rect">
-            <a:avLst/>
-          </a:prstGeom>
-          <a:solidFill>
-            <a:srgbClr val="F5F1E8"/>
-          </a:solidFill>
-          <a:ln w="12700">
-            <a:solidFill>
-              <a:srgbClr val="C9B991"/>
-            </a:solidFill>
-          </a:ln>
-          <a:effectLst/>
-        </p:spPr>
-        <p:style>
-          <a:lnRef idx="1">
-            <a:schemeClr val="accent1"/>
-          </a:lnRef>
-          <a:fillRef idx="3">
-            <a:schemeClr val="accent1"/>
-          </a:fillRef>
-          <a:effectRef idx="2">
-            <a:schemeClr val="accent1"/>
-          </a:effectRef>
-          <a:fontRef idx="minor">
-            <a:schemeClr val="lt1"/>
-          </a:fontRef>
-        </p:style>
-        <p:txBody>
-          <a:bodyPr rtlCol="0" anchor="ctr" wrap="square" lIns="27432" rIns="27432" tIns="22860" bIns="22860"/>
-          <a:lstStyle/>
-          <a:p>
-            <a:pPr algn="ctr"/>
-            <a:r>
-              <a:rPr sz="2000" b="1" i="0">
-                <a:solidFill>
-                  <a:srgbClr val="5C4826"/>
-                </a:solidFill>
-              </a:rPr>
-              <a:t>ENABLE</a:t>
-            </a:r>
-          </a:p>
-        </p:txBody>
-      </p:sp>
-      <p:sp>
-        <p:nvSpPr>
-          <p:cNvPr id="13" name="TextBox 12"/>
-          <p:cNvSpPr txBox="1"/>
-          <p:nvPr/>
-        </p:nvSpPr>
-        <p:spPr>
-          <a:xfrm>
-            <a:off x="3383280" y="4297680"/>
-            <a:ext cx="5440680" cy="731520"/>
-          </a:xfrm>
-          <a:prstGeom prst="rect">
-            <a:avLst/>
-          </a:prstGeom>
-          <a:noFill/>
-        </p:spPr>
-        <p:txBody>
-          <a:bodyPr wrap="square" anchor="t">
-            <a:spAutoFit/>
-          </a:bodyPr>
-          <a:lstStyle/>
-          <a:p>
-            <a:pPr algn="l"/>
-            <a:r>
-              <a:rPr sz="2000" b="0" i="0">
-                <a:solidFill>
-                  <a:srgbClr val="5C4826"/>
-                </a:solidFill>
-              </a:rPr>
-              <a:t>evaluations that otherwise require reconstruction</a:t>
-            </a:r>
-          </a:p>
-        </p:txBody>
-      </p:sp>
-      <p:sp>
-        <p:nvSpPr>
-          <p:cNvPr id="14" name="TextBox 13"/>
-          <p:cNvSpPr txBox="1"/>
-          <p:nvPr/>
-        </p:nvSpPr>
-        <p:spPr>
-          <a:xfrm>
-            <a:off x="274320" y="5010912"/>
-            <a:ext cx="8595360" cy="411480"/>
-          </a:xfrm>
-          <a:prstGeom prst="rect">
-            <a:avLst/>
-          </a:prstGeom>
-          <a:noFill/>
-        </p:spPr>
-        <p:txBody>
-          <a:bodyPr wrap="square" anchor="t">
-            <a:spAutoFit/>
-          </a:bodyPr>
-          <a:lstStyle/>
-          <a:p>
-            <a:r>
-              <a:rPr sz="2000" b="1" i="1">
-                <a:solidFill>
-                  <a:srgbClr val="555960"/>
-                </a:solidFill>
-              </a:rPr>
-              <a:t>Models give validation mechanisms an explicit object to inspect.</a:t>
+              <a:t>leave irrelevant choices open   ·   enable evaluation without reconstruction</a:t>
             </a:r>
           </a:p>
         </p:txBody>
@@ -18103,7 +17393,7 @@
                   <a:srgbClr val="000000"/>
                 </a:solidFill>
               </a:rPr>
-              <a:t>A model can support static validation</a:t>
+              <a:t>Models support static validation</a:t>
             </a:r>
           </a:p>
         </p:txBody>
@@ -18350,7 +17640,7 @@
                   <a:srgbClr val="5C4826"/>
                 </a:solidFill>
               </a:rPr>
-              <a:t>Is a forbidden dependency reachable?</a:t>
+              <a:t>Can admitted threads exceed the memory ceiling?</a:t>
             </a:r>
           </a:p>
           <a:p>
@@ -18366,7 +17656,7 @@
                   <a:srgbClr val="5C4826"/>
                 </a:solidFill>
               </a:rPr>
-              <a:t>Does every permitted route cross the required boundary?</a:t>
+              <a:t>Can three threads be Awake simultaneously?</a:t>
             </a:r>
           </a:p>
           <a:p>
@@ -18382,23 +17672,7 @@
                   <a:srgbClr val="5C4826"/>
                 </a:solidFill>
               </a:rPr>
-              <a:t>Can the memory bound be exceeded?</a:t>
-            </a:r>
-          </a:p>
-          <a:p>
-            <a:pPr algn="l">
-              <a:spcBef>
-                <a:spcPts val="900"/>
-              </a:spcBef>
-              <a:buNone/>
-            </a:pPr>
-            <a:r>
-              <a:rPr lang="en-US" sz="2000" b="0" i="0" dirty="0">
-                <a:solidFill>
-                  <a:srgbClr val="5C4826"/>
-                </a:solidFill>
-              </a:rPr>
-              <a:t>Is an illegal transition present?</a:t>
+              <a:t>Is an illegal lifecycle transition reachable?</a:t>
             </a:r>
           </a:p>
         </p:txBody>
@@ -18714,7 +17988,7 @@
                   <a:srgbClr val="000000"/>
                 </a:solidFill>
               </a:rPr>
-              <a:t>A model can also define what to observe at runtime</a:t>
+              <a:t>Models support dynamic validation</a:t>
             </a:r>
           </a:p>
         </p:txBody>
@@ -18750,8 +18024,8 @@
         </p:nvSpPr>
         <p:spPr>
           <a:xfrm>
-            <a:off x="5245840" y="1097280"/>
-            <a:ext cx="2200000" cy="640080"/>
+            <a:off x="2697480" y="3831336"/>
+            <a:ext cx="2203704" cy="731520"/>
           </a:xfrm>
           <a:prstGeom prst="rect">
             <a:avLst/>
@@ -18789,9 +18063,9 @@
           <p:nvPr/>
         </p:nvCxnSpPr>
         <p:spPr>
-          <a:xfrm>
-            <a:off x="6345840" y="1737360"/>
-            <a:ext cx="0" cy="777240"/>
+          <a:xfrm flipH="1">
+            <a:off x="2240280" y="4197096"/>
+            <a:ext cx="402336" cy="0"/>
           </a:xfrm>
           <a:prstGeom prst="straightConnector1">
             <a:avLst/>
@@ -18812,7 +18086,7 @@
         </p:nvSpPr>
         <p:spPr>
           <a:xfrm>
-            <a:off x="274320" y="2514600"/>
+            <a:off x="685800" y="1051560"/>
             <a:ext cx="1500000" cy="640080"/>
           </a:xfrm>
           <a:prstGeom prst="rect">
@@ -18854,7 +18128,7 @@
         </p:nvSpPr>
         <p:spPr>
           <a:xfrm>
-            <a:off x="2048160" y="2514600"/>
+            <a:off x="685800" y="1993392"/>
             <a:ext cx="1500000" cy="640080"/>
           </a:xfrm>
           <a:prstGeom prst="rect">
@@ -18894,7 +18168,7 @@
         </p:nvSpPr>
         <p:spPr>
           <a:xfrm>
-            <a:off x="3822000" y="2514600"/>
+            <a:off x="685800" y="2935224"/>
             <a:ext cx="1500000" cy="640080"/>
           </a:xfrm>
           <a:prstGeom prst="rect">
@@ -18936,7 +18210,7 @@
         </p:nvSpPr>
         <p:spPr>
           <a:xfrm>
-            <a:off x="5595840" y="2514600"/>
+            <a:off x="685800" y="3877056"/>
             <a:ext cx="1500000" cy="640080"/>
           </a:xfrm>
           <a:prstGeom prst="rect">
@@ -18976,7 +18250,7 @@
         </p:nvSpPr>
         <p:spPr>
           <a:xfrm>
-            <a:off x="7369680" y="2514600"/>
+            <a:off x="685800" y="4818888"/>
             <a:ext cx="1500000" cy="640080"/>
           </a:xfrm>
           <a:prstGeom prst="rect">
@@ -19018,8 +18292,8 @@
         </p:nvCxnSpPr>
         <p:spPr>
           <a:xfrm>
-            <a:off x="1774320" y="2834640"/>
-            <a:ext cx="273840" cy="0"/>
+            <a:off x="1435608" y="1691639"/>
+            <a:ext cx="0" cy="301752"/>
           </a:xfrm>
           <a:prstGeom prst="straightConnector1">
             <a:avLst/>
@@ -19040,8 +18314,8 @@
         </p:nvCxnSpPr>
         <p:spPr>
           <a:xfrm>
-            <a:off x="3548160" y="2834640"/>
-            <a:ext cx="273840" cy="0"/>
+            <a:off x="1435608" y="2633472"/>
+            <a:ext cx="0" cy="301752"/>
           </a:xfrm>
           <a:prstGeom prst="straightConnector1">
             <a:avLst/>
@@ -19062,8 +18336,8 @@
         </p:nvCxnSpPr>
         <p:spPr>
           <a:xfrm>
-            <a:off x="5322000" y="2834640"/>
-            <a:ext cx="273840" cy="0"/>
+            <a:off x="1435608" y="3575304"/>
+            <a:ext cx="0" cy="301752"/>
           </a:xfrm>
           <a:prstGeom prst="straightConnector1">
             <a:avLst/>
@@ -19084,8 +18358,8 @@
         </p:nvCxnSpPr>
         <p:spPr>
           <a:xfrm>
-            <a:off x="7095840" y="2834640"/>
-            <a:ext cx="273840" cy="0"/>
+            <a:off x="1435608" y="4517136"/>
+            <a:ext cx="0" cy="301752"/>
           </a:xfrm>
           <a:prstGeom prst="straightConnector1">
             <a:avLst/>
@@ -19100,14 +18374,14 @@
       </p:cxnSp>
       <p:sp>
         <p:nvSpPr>
-          <p:cNvPr id="0" name="Dy-Questions"/>
+          <p:cNvPr id="101" name="Cmp-static"/>
           <p:cNvSpPr/>
           <p:nvPr/>
         </p:nvSpPr>
         <p:spPr>
           <a:xfrm>
-            <a:off x="502920" y="3566160"/>
-            <a:ext cx="8138160" cy="2057400"/>
+            <a:off x="5120640" y="1965960"/>
+            <a:ext cx="3657600" cy="2560320"/>
           </a:xfrm>
           <a:prstGeom prst="rect">
             <a:avLst/>
@@ -19126,350 +18400,65 @@
           <a:bodyPr rtlCol="0" anchor="t" wrap="square" lIns="27432" rIns="27432" tIns="22860" bIns="22860"/>
           <a:lstStyle/>
           <a:p>
-            <a:pPr algn="l">
-              <a:buNone/>
-            </a:pPr>
-            <a:r>
-              <a:rPr lang="en-US" sz="2000" b="0" i="0" dirty="0">
+            <a:pPr algn="ctr"/>
+            <a:r>
+              <a:rPr sz="2000" b="1">
                 <a:solidFill>
                   <a:srgbClr val="5C4826"/>
                 </a:solidFill>
               </a:rPr>
-              <a:t>Did the observed transition exist in the model?</a:t>
-            </a:r>
-          </a:p>
-          <a:p>
-            <a:pPr algn="l">
-              <a:spcBef>
-                <a:spcPts val="900"/>
-              </a:spcBef>
-              <a:buNone/>
-            </a:pPr>
-            <a:r>
-              <a:rPr lang="en-US" sz="2000" b="0" i="0" dirty="0">
+              <a:t>STATIC</a:t>
+            </a:r>
+          </a:p>
+          <a:p>
+            <a:pPr algn="ctr"/>
+            <a:r>
+              <a:rPr sz="2000" b="0">
                 <a:solidFill>
                   <a:srgbClr val="5C4826"/>
                 </a:solidFill>
               </a:rPr>
-              <a:t>Did events occur in the required order?</a:t>
-            </a:r>
-          </a:p>
-          <a:p>
-            <a:pPr algn="l">
-              <a:spcBef>
-                <a:spcPts val="900"/>
-              </a:spcBef>
-              <a:buNone/>
-            </a:pPr>
-            <a:r>
-              <a:rPr lang="en-US" sz="2000" b="0" i="0" dirty="0">
+              <a:t>verdict over the modeled space</a:t>
+            </a:r>
+          </a:p>
+          <a:p>
+            <a:pPr algn="ctr"/>
+            <a:r>
+              <a:rPr sz="2000" b="0">
                 <a:solidFill>
                   <a:srgbClr val="5C4826"/>
                 </a:solidFill>
               </a:rPr>
-              <a:t>Did execution enter a forbidden state?</a:t>
-            </a:r>
-          </a:p>
-          <a:p>
-            <a:pPr algn="l">
-              <a:spcBef>
-                <a:spcPts val="900"/>
-              </a:spcBef>
-              <a:buNone/>
-            </a:pPr>
-            <a:r>
-              <a:rPr lang="en-US" sz="2000" b="0" i="0" dirty="0">
+              <a:t/>
+            </a:r>
+          </a:p>
+          <a:p>
+            <a:pPr algn="ctr"/>
+            <a:r>
+              <a:rPr sz="2000" b="1">
                 <a:solidFill>
                   <a:srgbClr val="5C4826"/>
                 </a:solidFill>
               </a:rPr>
-              <a:t>Did a measured quantity stay within its modeled bound?</a:t>
-            </a:r>
-          </a:p>
-        </p:txBody>
-      </p:sp>
-    </p:spTree>
-  </p:cSld>
-  <p:clrMapOvr>
-    <a:masterClrMapping/>
-  </p:clrMapOvr>
-</p:sld>
-</file>
-
-<file path=ppt/slides/slide31.xml><?xml version="1.0" encoding="utf-8"?>
-<p:sld xmlns:a="http://schemas.openxmlformats.org/drawingml/2006/main" xmlns:p="http://schemas.openxmlformats.org/presentationml/2006/main" xmlns:r="http://schemas.openxmlformats.org/officeDocument/2006/relationships">
-  <p:cSld>
-    <p:spTree>
-      <p:nvGrpSpPr>
-        <p:cNvPr id="1" name=""/>
-        <p:cNvGrpSpPr/>
-        <p:nvPr/>
-      </p:nvGrpSpPr>
-      <p:grpSpPr/>
-      <p:sp>
-        <p:nvSpPr>
-          <p:cNvPr id="3" name="Title 2"/>
-          <p:cNvSpPr>
-            <a:spLocks noGrp="1"/>
-          </p:cNvSpPr>
-          <p:nvPr>
-            <p:ph type="title"/>
-          </p:nvPr>
-        </p:nvSpPr>
-        <p:spPr/>
-        <p:txBody>
-          <a:bodyPr wrap="square"/>
-          <a:lstStyle/>
-          <a:p>
-            <a:r>
-              <a:rPr sz="2400" b="0">
-                <a:solidFill>
-                  <a:srgbClr val="000000"/>
-                </a:solidFill>
-              </a:rPr>
-              <a:t>The same model can support different validation strategies</a:t>
-            </a:r>
-          </a:p>
-        </p:txBody>
-      </p:sp>
-      <p:sp>
-        <p:nvSpPr>
-          <p:cNvPr id="4" name="Slide Number Placeholder 5"/>
-          <p:cNvSpPr>
-            <a:spLocks noGrp="1"/>
-          </p:cNvSpPr>
-          <p:nvPr>
-            <p:ph type="sldNum" sz="quarter" idx="4"/>
-          </p:nvPr>
-        </p:nvSpPr>
-        <p:spPr/>
-        <p:txBody>
-          <a:bodyPr/>
-          <a:lstStyle/>
-          <a:p>
-            <a:fld id="{B7EB45DA-9A0D-DC49-8E02-F30A5DDC21C3}" type="slidenum">
-              <a:rPr lang="en-US" smtClean="0"/>
-              <a:t>31</a:t>
-            </a:fld>
-            <a:endParaRPr lang="en-US"/>
-          </a:p>
-        </p:txBody>
-      </p:sp>
-      <p:sp>
-        <p:nvSpPr>
-          <p:cNvPr id="0" name="Cmp-static"/>
-          <p:cNvSpPr/>
-          <p:nvPr/>
-        </p:nvSpPr>
-        <p:spPr>
-          <a:xfrm>
-            <a:off x="502920" y="1051560"/>
-            <a:ext cx="3977639" cy="4038600"/>
-          </a:xfrm>
-          <a:prstGeom prst="rect">
-            <a:avLst/>
-          </a:prstGeom>
-          <a:solidFill>
-            <a:srgbClr val="F5F1E8"/>
-          </a:solidFill>
-          <a:ln w="12700">
-            <a:solidFill>
-              <a:srgbClr val="C9B991"/>
-            </a:solidFill>
-          </a:ln>
-          <a:effectLst/>
-        </p:spPr>
-        <p:txBody>
-          <a:bodyPr rtlCol="0" anchor="t" wrap="square" lIns="27432" rIns="27432" tIns="22860" bIns="22860"/>
-          <a:lstStyle/>
-          <a:p>
-            <a:pPr algn="ctr">
-              <a:buNone/>
-            </a:pPr>
-            <a:r>
-              <a:rPr lang="en-US" sz="2000" b="1" i="0" dirty="0">
+              <a:t>DYNAMIC</a:t>
+            </a:r>
+          </a:p>
+          <a:p>
+            <a:pPr algn="ctr"/>
+            <a:r>
+              <a:rPr sz="2000" b="0">
                 <a:solidFill>
                   <a:srgbClr val="5C4826"/>
                 </a:solidFill>
               </a:rPr>
-              <a:t>STATIC</a:t>
-            </a:r>
-          </a:p>
-          <a:p>
-            <a:pPr algn="l">
-              <a:spcBef>
-                <a:spcPts val="900"/>
-              </a:spcBef>
-              <a:buNone/>
-            </a:pPr>
-            <a:r>
-              <a:rPr lang="en-US" sz="2000" b="0" i="0" dirty="0">
-                <a:solidFill>
-                  <a:srgbClr val="5C4826"/>
-                </a:solidFill>
-              </a:rPr>
-              <a:t>decided over the model itself</a:t>
-            </a:r>
-          </a:p>
-          <a:p>
-            <a:pPr algn="l">
-              <a:spcBef>
-                <a:spcPts val="900"/>
-              </a:spcBef>
-              <a:buNone/>
-            </a:pPr>
-            <a:r>
-              <a:rPr lang="en-US" sz="2000" b="0" i="0" dirty="0">
-                <a:solidFill>
-                  <a:srgbClr val="5C4826"/>
-                </a:solidFill>
-              </a:rPr>
-              <a:t>runs before any execution</a:t>
-            </a:r>
-          </a:p>
-          <a:p>
-            <a:pPr algn="l">
-              <a:spcBef>
-                <a:spcPts val="900"/>
-              </a:spcBef>
-              <a:buNone/>
-            </a:pPr>
-            <a:r>
-              <a:rPr lang="en-US" sz="2000" b="0" i="0" dirty="0">
-                <a:solidFill>
-                  <a:srgbClr val="5C4826"/>
-                </a:solidFill>
-              </a:rPr>
-              <a:t>exhaustive over the modeled space</a:t>
-            </a:r>
-          </a:p>
-          <a:p>
-            <a:pPr algn="l">
-              <a:spcBef>
-                <a:spcPts val="900"/>
-              </a:spcBef>
-              <a:buNone/>
-            </a:pPr>
-            <a:r>
-              <a:rPr lang="en-US" sz="2000" b="0" i="1" dirty="0">
-                <a:solidFill>
-                  <a:srgbClr val="555960"/>
-                </a:solidFill>
-              </a:rPr>
-              <a:t>can the memory bound be exceeded?</a:t>
-            </a:r>
-          </a:p>
-        </p:txBody>
-      </p:sp>
-      <p:sp>
-        <p:nvSpPr>
-          <p:cNvPr id="0" name="Cmp-dynamic"/>
-          <p:cNvSpPr/>
-          <p:nvPr/>
-        </p:nvSpPr>
-        <p:spPr>
-          <a:xfrm>
-            <a:off x="4663440" y="1051560"/>
-            <a:ext cx="3977639" cy="4038600"/>
-          </a:xfrm>
-          <a:prstGeom prst="rect">
-            <a:avLst/>
-          </a:prstGeom>
-          <a:solidFill>
-            <a:srgbClr val="F5F1E8"/>
-          </a:solidFill>
-          <a:ln w="12700">
-            <a:solidFill>
-              <a:srgbClr val="C9B991"/>
-            </a:solidFill>
-          </a:ln>
-          <a:effectLst/>
-        </p:spPr>
-        <p:txBody>
-          <a:bodyPr rtlCol="0" anchor="t" wrap="square" lIns="27432" rIns="27432" tIns="22860" bIns="22860"/>
-          <a:lstStyle/>
-          <a:p>
-            <a:pPr algn="ctr">
-              <a:buNone/>
-            </a:pPr>
-            <a:r>
-              <a:rPr lang="en-US" sz="2000" b="1" i="0" dirty="0">
-                <a:solidFill>
-                  <a:srgbClr val="5C4826"/>
-                </a:solidFill>
-              </a:rPr>
-              <a:t>DYNAMIC</a:t>
-            </a:r>
-          </a:p>
-          <a:p>
-            <a:pPr algn="l">
-              <a:spcBef>
-                <a:spcPts val="900"/>
-              </a:spcBef>
-              <a:buNone/>
-            </a:pPr>
-            <a:r>
-              <a:rPr lang="en-US" sz="2000" b="0" i="0" dirty="0">
-                <a:solidFill>
-                  <a:srgbClr val="5C4826"/>
-                </a:solidFill>
-              </a:rPr>
-              <a:t>decided over a trace of execution</a:t>
-            </a:r>
-          </a:p>
-          <a:p>
-            <a:pPr algn="l">
-              <a:spcBef>
-                <a:spcPts val="900"/>
-              </a:spcBef>
-              <a:buNone/>
-            </a:pPr>
-            <a:r>
-              <a:rPr lang="en-US" sz="2000" b="0" i="0" dirty="0">
-                <a:solidFill>
-                  <a:srgbClr val="5C4826"/>
-                </a:solidFill>
-              </a:rPr>
-              <a:t>runs while or after the system runs</a:t>
-            </a:r>
-          </a:p>
-          <a:p>
-            <a:pPr algn="l">
-              <a:spcBef>
-                <a:spcPts val="900"/>
-              </a:spcBef>
-              <a:buNone/>
-            </a:pPr>
-            <a:r>
-              <a:rPr lang="en-US" sz="2000" b="0" i="0" dirty="0">
-                <a:solidFill>
-                  <a:srgbClr val="5C4826"/>
-                </a:solidFill>
-              </a:rPr>
-              <a:t>evidence about the runs you observed</a:t>
-            </a:r>
-          </a:p>
-          <a:p>
-            <a:pPr algn="l">
-              <a:spcBef>
-                <a:spcPts val="900"/>
-              </a:spcBef>
-              <a:buNone/>
-            </a:pPr>
-            <a:r>
-              <a:rPr lang="en-US" sz="2000" b="0" i="1" dirty="0">
-                <a:solidFill>
-                  <a:srgbClr val="555960"/>
-                </a:solidFill>
-              </a:rPr>
-              <a:t>did the awake set ever exceed two?</a:t>
-            </a:r>
-          </a:p>
-        </p:txBody>
-      </p:sp>
-      <p:sp>
-        <p:nvSpPr>
-          <p:cNvPr id="0" name="FooterBand"/>
+              <a:t>verdict over observed execution</a:t>
+            </a:r>
+          </a:p>
+        </p:txBody>
+      </p:sp>
+      <p:sp>
+        <p:nvSpPr>
+          <p:cNvPr id="102" name="FooterBand"/>
           <p:cNvSpPr/>
           <p:nvPr/>
         </p:nvSpPr>
@@ -19503,488 +18492,6 @@
                 </a:solidFill>
               </a:rPr>
               <a:t>Where should each verdict acquire authority?</a:t>
-            </a:r>
-          </a:p>
-        </p:txBody>
-      </p:sp>
-    </p:spTree>
-  </p:cSld>
-  <p:clrMapOvr>
-    <a:masterClrMapping/>
-  </p:clrMapOvr>
-</p:sld>
-</file>
-
-<file path=ppt/slides/slide32.xml><?xml version="1.0" encoding="utf-8"?>
-<p:sld xmlns:a="http://schemas.openxmlformats.org/drawingml/2006/main" xmlns:p="http://schemas.openxmlformats.org/presentationml/2006/main" xmlns:r="http://schemas.openxmlformats.org/officeDocument/2006/relationships">
-  <p:cSld>
-    <p:spTree>
-      <p:nvGrpSpPr>
-        <p:cNvPr id="1" name=""/>
-        <p:cNvGrpSpPr/>
-        <p:nvPr/>
-      </p:nvGrpSpPr>
-      <p:grpSpPr/>
-      <p:sp>
-        <p:nvSpPr>
-          <p:cNvPr id="3" name="Title 2"/>
-          <p:cNvSpPr>
-            <a:spLocks noGrp="1"/>
-          </p:cNvSpPr>
-          <p:nvPr>
-            <p:ph type="title"/>
-          </p:nvPr>
-        </p:nvSpPr>
-        <p:spPr/>
-        <p:txBody>
-          <a:bodyPr wrap="square"/>
-          <a:lstStyle/>
-          <a:p>
-            <a:r>
-              <a:rPr sz="2400" b="0">
-                <a:solidFill>
-                  <a:srgbClr val="000000"/>
-                </a:solidFill>
-              </a:rPr>
-              <a:t>Agreement is not correctness</a:t>
-            </a:r>
-          </a:p>
-        </p:txBody>
-      </p:sp>
-      <p:sp>
-        <p:nvSpPr>
-          <p:cNvPr id="4" name="Slide Number Placeholder 5"/>
-          <p:cNvSpPr>
-            <a:spLocks noGrp="1"/>
-          </p:cNvSpPr>
-          <p:nvPr>
-            <p:ph type="sldNum" sz="quarter" idx="4"/>
-          </p:nvPr>
-        </p:nvSpPr>
-        <p:spPr/>
-        <p:txBody>
-          <a:bodyPr/>
-          <a:lstStyle/>
-          <a:p>
-            <a:fld id="{B7EB45DA-9A0D-DC49-8E02-F30A5DDC21C3}" type="slidenum">
-              <a:rPr lang="en-US" smtClean="0"/>
-              <a:t>32</a:t>
-            </a:fld>
-            <a:endParaRPr lang="en-US"/>
-          </a:p>
-        </p:txBody>
-      </p:sp>
-      <p:sp>
-        <p:nvSpPr>
-          <p:cNvPr id="9" name="FooterBand"/>
-          <p:cNvSpPr/>
-          <p:nvPr/>
-        </p:nvSpPr>
-        <p:spPr>
-          <a:xfrm>
-            <a:off x="274320" y="5852160"/>
-            <a:ext cx="8595360" cy="566928"/>
-          </a:xfrm>
-          <a:prstGeom prst="rect">
-            <a:avLst/>
-          </a:prstGeom>
-          <a:solidFill>
-            <a:srgbClr val="8E6F3E"/>
-          </a:solidFill>
-          <a:ln>
-            <a:noFill/>
-          </a:ln>
-          <a:effectLst/>
-        </p:spPr>
-        <p:style>
-          <a:lnRef idx="1">
-            <a:schemeClr val="accent1"/>
-          </a:lnRef>
-          <a:fillRef idx="3">
-            <a:schemeClr val="accent1"/>
-          </a:fillRef>
-          <a:effectRef idx="2">
-            <a:schemeClr val="accent1"/>
-          </a:effectRef>
-          <a:fontRef idx="minor">
-            <a:schemeClr val="lt1"/>
-          </a:fontRef>
-        </p:style>
-        <p:txBody>
-          <a:bodyPr rtlCol="0" anchor="ctr" wrap="square"/>
-          <a:lstStyle/>
-          <a:p>
-            <a:pPr algn="ctr"/>
-            <a:r>
-              <a:rPr sz="2000" b="1" i="0">
-                <a:solidFill>
-                  <a:srgbClr val="FFFFFF"/>
-                </a:solidFill>
-              </a:rPr>
-              <a:t>Evidence for one does not establish the others.</a:t>
-            </a:r>
-          </a:p>
-        </p:txBody>
-      </p:sp>
-      <p:sp>
-        <p:nvSpPr>
-          <p:cNvPr id="0" name="TR-Head0"/>
-          <p:cNvSpPr/>
-          <p:nvPr/>
-        </p:nvSpPr>
-        <p:spPr>
-          <a:xfrm>
-            <a:off x="274320" y="1188720"/>
-            <a:ext cx="2742293" cy="548640"/>
-          </a:xfrm>
-          <a:prstGeom prst="rect">
-            <a:avLst/>
-          </a:prstGeom>
-          <a:solidFill>
-            <a:srgbClr val="8E6F3E"/>
-          </a:solidFill>
-          <a:ln>
-            <a:noFill/>
-          </a:ln>
-          <a:effectLst/>
-        </p:spPr>
-        <p:txBody>
-          <a:bodyPr rtlCol="0" anchor="ctr" wrap="square" lIns="27432" rIns="27432" tIns="22860" bIns="22860"/>
-          <a:lstStyle/>
-          <a:p>
-            <a:pPr algn="ctr">
-              <a:buNone/>
-            </a:pPr>
-            <a:r>
-              <a:rPr lang="en-US" sz="2000" b="1" i="0" dirty="0">
-                <a:solidFill>
-                  <a:srgbClr val="FFFFFF"/>
-                </a:solidFill>
-              </a:rPr>
-              <a:t>CORRESPONDENCE</a:t>
-            </a:r>
-          </a:p>
-        </p:txBody>
-      </p:sp>
-      <p:sp>
-        <p:nvSpPr>
-          <p:cNvPr id="0" name="TR-Body0"/>
-          <p:cNvSpPr/>
-          <p:nvPr/>
-        </p:nvSpPr>
-        <p:spPr>
-          <a:xfrm>
-            <a:off x="274320" y="1737360"/>
-            <a:ext cx="2742293" cy="3108960"/>
-          </a:xfrm>
-          <a:prstGeom prst="rect">
-            <a:avLst/>
-          </a:prstGeom>
-          <a:solidFill>
-            <a:srgbClr val="F5F1E8"/>
-          </a:solidFill>
-          <a:ln w="12700">
-            <a:solidFill>
-              <a:srgbClr val="C9B991"/>
-            </a:solidFill>
-          </a:ln>
-          <a:effectLst/>
-        </p:spPr>
-        <p:txBody>
-          <a:bodyPr rtlCol="0" anchor="ctr" wrap="square" lIns="27432" rIns="27432" tIns="22860" bIns="22860"/>
-          <a:lstStyle/>
-          <a:p>
-            <a:pPr algn="ctr">
-              <a:buNone/>
-            </a:pPr>
-            <a:r>
-              <a:rPr lang="en-US" sz="2000" b="1" i="0" dirty="0">
-                <a:solidFill>
-                  <a:srgbClr val="5C4826"/>
-                </a:solidFill>
-              </a:rPr>
-              <a:t>implementation</a:t>
-            </a:r>
-          </a:p>
-          <a:p>
-            <a:pPr algn="ctr">
-              <a:buNone/>
-            </a:pPr>
-            <a:r>
-              <a:rPr lang="en-US" sz="2400" b="1" i="0" dirty="0">
-                <a:solidFill>
-                  <a:srgbClr val="8E6F3E"/>
-                </a:solidFill>
-              </a:rPr>
-              <a:t>↕</a:t>
-            </a:r>
-          </a:p>
-          <a:p>
-            <a:pPr algn="ctr">
-              <a:buNone/>
-            </a:pPr>
-            <a:r>
-              <a:rPr lang="en-US" sz="2000" b="1" i="0" dirty="0">
-                <a:solidFill>
-                  <a:srgbClr val="5C4826"/>
-                </a:solidFill>
-              </a:rPr>
-              <a:t>representation</a:t>
-            </a:r>
-          </a:p>
-          <a:p>
-            <a:pPr algn="ctr">
-              <a:buNone/>
-            </a:pPr>
-            <a:r>
-              <a:rPr lang="en-US" sz="2000" b="0" i="1" dirty="0">
-                <a:solidFill>
-                  <a:srgbClr val="555960"/>
-                </a:solidFill>
-              </a:rPr>
-              <a:t>do they agree?</a:t>
-            </a:r>
-          </a:p>
-        </p:txBody>
-      </p:sp>
-      <p:sp>
-        <p:nvSpPr>
-          <p:cNvPr id="0" name="TR-Head1"/>
-          <p:cNvSpPr/>
-          <p:nvPr/>
-        </p:nvSpPr>
-        <p:spPr>
-          <a:xfrm>
-            <a:off x="3200844" y="1188720"/>
-            <a:ext cx="2742293" cy="548640"/>
-          </a:xfrm>
-          <a:prstGeom prst="rect">
-            <a:avLst/>
-          </a:prstGeom>
-          <a:solidFill>
-            <a:srgbClr val="8E6F3E"/>
-          </a:solidFill>
-          <a:ln>
-            <a:noFill/>
-          </a:ln>
-          <a:effectLst/>
-        </p:spPr>
-        <p:txBody>
-          <a:bodyPr rtlCol="0" anchor="ctr" wrap="square" lIns="27432" rIns="27432" tIns="22860" bIns="22860"/>
-          <a:lstStyle/>
-          <a:p>
-            <a:pPr algn="ctr">
-              <a:buNone/>
-            </a:pPr>
-            <a:r>
-              <a:rPr lang="en-US" sz="2000" b="1" i="0" dirty="0">
-                <a:solidFill>
-                  <a:srgbClr val="FFFFFF"/>
-                </a:solidFill>
-              </a:rPr>
-              <a:t>CONFORMANCE</a:t>
-            </a:r>
-          </a:p>
-        </p:txBody>
-      </p:sp>
-      <p:sp>
-        <p:nvSpPr>
-          <p:cNvPr id="0" name="TR-Body1"/>
-          <p:cNvSpPr/>
-          <p:nvPr/>
-        </p:nvSpPr>
-        <p:spPr>
-          <a:xfrm>
-            <a:off x="3200844" y="1737360"/>
-            <a:ext cx="2742293" cy="3108960"/>
-          </a:xfrm>
-          <a:prstGeom prst="rect">
-            <a:avLst/>
-          </a:prstGeom>
-          <a:solidFill>
-            <a:srgbClr val="F5F1E8"/>
-          </a:solidFill>
-          <a:ln w="12700">
-            <a:solidFill>
-              <a:srgbClr val="C9B991"/>
-            </a:solidFill>
-          </a:ln>
-          <a:effectLst/>
-        </p:spPr>
-        <p:txBody>
-          <a:bodyPr rtlCol="0" anchor="ctr" wrap="square" lIns="27432" rIns="27432" tIns="22860" bIns="22860"/>
-          <a:lstStyle/>
-          <a:p>
-            <a:pPr algn="ctr">
-              <a:buNone/>
-            </a:pPr>
-            <a:r>
-              <a:rPr lang="en-US" sz="2000" b="1" i="0" dirty="0">
-                <a:solidFill>
-                  <a:srgbClr val="5C4826"/>
-                </a:solidFill>
-              </a:rPr>
-              <a:t>artifact</a:t>
-            </a:r>
-          </a:p>
-          <a:p>
-            <a:pPr algn="ctr">
-              <a:buNone/>
-            </a:pPr>
-            <a:r>
-              <a:rPr lang="en-US" sz="2400" b="1" i="0" dirty="0">
-                <a:solidFill>
-                  <a:srgbClr val="8E6F3E"/>
-                </a:solidFill>
-              </a:rPr>
-              <a:t>↕</a:t>
-            </a:r>
-          </a:p>
-          <a:p>
-            <a:pPr algn="ctr">
-              <a:buNone/>
-            </a:pPr>
-            <a:r>
-              <a:rPr lang="en-US" sz="2000" b="1" i="0" dirty="0">
-                <a:solidFill>
-                  <a:srgbClr val="5C4826"/>
-                </a:solidFill>
-              </a:rPr>
-              <a:t>independent obligation</a:t>
-            </a:r>
-          </a:p>
-          <a:p>
-            <a:pPr algn="ctr">
-              <a:buNone/>
-            </a:pPr>
-            <a:r>
-              <a:rPr lang="en-US" sz="2000" b="0" i="1" dirty="0">
-                <a:solidFill>
-                  <a:srgbClr val="555960"/>
-                </a:solidFill>
-              </a:rPr>
-              <a:t>does it satisfy?</a:t>
-            </a:r>
-          </a:p>
-        </p:txBody>
-      </p:sp>
-      <p:sp>
-        <p:nvSpPr>
-          <p:cNvPr id="0" name="TR-Head2"/>
-          <p:cNvSpPr/>
-          <p:nvPr/>
-        </p:nvSpPr>
-        <p:spPr>
-          <a:xfrm>
-            <a:off x="6127368" y="1188720"/>
-            <a:ext cx="2742293" cy="548640"/>
-          </a:xfrm>
-          <a:prstGeom prst="rect">
-            <a:avLst/>
-          </a:prstGeom>
-          <a:solidFill>
-            <a:srgbClr val="8E6F3E"/>
-          </a:solidFill>
-          <a:ln>
-            <a:noFill/>
-          </a:ln>
-          <a:effectLst/>
-        </p:spPr>
-        <p:txBody>
-          <a:bodyPr rtlCol="0" anchor="ctr" wrap="square" lIns="27432" rIns="27432" tIns="22860" bIns="22860"/>
-          <a:lstStyle/>
-          <a:p>
-            <a:pPr algn="ctr">
-              <a:buNone/>
-            </a:pPr>
-            <a:r>
-              <a:rPr lang="en-US" sz="2000" b="1" i="0" dirty="0">
-                <a:solidFill>
-                  <a:srgbClr val="FFFFFF"/>
-                </a:solidFill>
-              </a:rPr>
-              <a:t>ACCEPTANCE</a:t>
-            </a:r>
-          </a:p>
-        </p:txBody>
-      </p:sp>
-      <p:sp>
-        <p:nvSpPr>
-          <p:cNvPr id="0" name="TR-Body2"/>
-          <p:cNvSpPr/>
-          <p:nvPr/>
-        </p:nvSpPr>
-        <p:spPr>
-          <a:xfrm>
-            <a:off x="6127368" y="1737360"/>
-            <a:ext cx="2742293" cy="3108960"/>
-          </a:xfrm>
-          <a:prstGeom prst="rect">
-            <a:avLst/>
-          </a:prstGeom>
-          <a:solidFill>
-            <a:srgbClr val="F5F1E8"/>
-          </a:solidFill>
-          <a:ln w="12700">
-            <a:solidFill>
-              <a:srgbClr val="C9B991"/>
-            </a:solidFill>
-          </a:ln>
-          <a:effectLst/>
-        </p:spPr>
-        <p:txBody>
-          <a:bodyPr rtlCol="0" anchor="ctr" wrap="square" lIns="27432" rIns="27432" tIns="22860" bIns="22860"/>
-          <a:lstStyle/>
-          <a:p>
-            <a:pPr algn="ctr">
-              <a:buNone/>
-            </a:pPr>
-            <a:r>
-              <a:rPr lang="en-US" sz="2000" b="1" i="0" dirty="0">
-                <a:solidFill>
-                  <a:srgbClr val="5C4826"/>
-                </a:solidFill>
-              </a:rPr>
-              <a:t>artifact</a:t>
-            </a:r>
-          </a:p>
-          <a:p>
-            <a:pPr algn="ctr">
-              <a:buNone/>
-            </a:pPr>
-            <a:r>
-              <a:rPr lang="en-US" sz="2400" b="1" i="0" dirty="0">
-                <a:solidFill>
-                  <a:srgbClr val="8E6F3E"/>
-                </a:solidFill>
-              </a:rPr>
-              <a:t>↕</a:t>
-            </a:r>
-          </a:p>
-          <a:p>
-            <a:pPr algn="ctr">
-              <a:buNone/>
-            </a:pPr>
-            <a:r>
-              <a:rPr lang="en-US" sz="2000" b="1" i="0" dirty="0">
-                <a:solidFill>
-                  <a:srgbClr val="5C4826"/>
-                </a:solidFill>
-              </a:rPr>
-              <a:t>receiving environment</a:t>
-            </a:r>
-          </a:p>
-          <a:p>
-            <a:pPr algn="ctr">
-              <a:buNone/>
-            </a:pPr>
-            <a:r>
-              <a:rPr lang="en-US" sz="2000" b="0" i="1" dirty="0">
-                <a:solidFill>
-                  <a:srgbClr val="555960"/>
-                </a:solidFill>
-              </a:rPr>
-              <a:t>will it accept?</a:t>
             </a:r>
           </a:p>
         </p:txBody>
@@ -20028,7 +18535,7 @@
                   <a:srgbClr val="000000"/>
                 </a:solidFill>
               </a:rPr>
-              <a:t>Three things can disagree</a:t>
+              <a:t>Agreement is not correctness</a:t>
             </a:r>
           </a:p>
         </p:txBody>
@@ -20420,23 +18927,12 @@
           <a:p>
             <a:pPr algn="l"/>
             <a:r>
-              <a:rPr sz="2000" b="0" i="1">
+              <a:rPr sz="2000" b="0">
                 <a:solidFill>
                   <a:srgbClr val="555960"/>
                 </a:solidFill>
               </a:rPr>
-              <a:t>does the model capture</a:t>
-            </a:r>
-          </a:p>
-          <a:p>
-            <a:pPr algn="l"/>
-            <a:r>
-              <a:rPr sz="2000" b="0" i="1">
-                <a:solidFill>
-                  <a:srgbClr val="555960"/>
-                </a:solidFill>
-              </a:rPr>
-              <a:t>the obligation?</a:t>
+              <a:t>captures?</a:t>
             </a:r>
           </a:p>
         </p:txBody>
@@ -20465,23 +18961,12 @@
           <a:p>
             <a:pPr algn="r"/>
             <a:r>
-              <a:rPr sz="2000" b="0" i="1">
+              <a:rPr sz="2000" b="0">
                 <a:solidFill>
                   <a:srgbClr val="555960"/>
                 </a:solidFill>
               </a:rPr>
-              <a:t>does the realization</a:t>
-            </a:r>
-          </a:p>
-          <a:p>
-            <a:pPr algn="r"/>
-            <a:r>
-              <a:rPr sz="2000" b="0" i="1">
-                <a:solidFill>
-                  <a:srgbClr val="555960"/>
-                </a:solidFill>
-              </a:rPr>
-              <a:t>satisfy it?</a:t>
+              <a:t>satisfies?</a:t>
             </a:r>
           </a:p>
         </p:txBody>
@@ -20510,12 +18995,12 @@
           <a:p>
             <a:pPr algn="ctr"/>
             <a:r>
-              <a:rPr sz="2000" b="0" i="1">
+              <a:rPr sz="2000" b="0">
                 <a:solidFill>
                   <a:srgbClr val="555960"/>
                 </a:solidFill>
               </a:rPr>
-              <a:t>do they correspond?</a:t>
+              <a:t>corresponds?</a:t>
             </a:r>
           </a:p>
         </p:txBody>
@@ -20528,8 +19013,8 @@
         </p:nvSpPr>
         <p:spPr>
           <a:xfrm>
-            <a:off x="274320" y="4800600"/>
-            <a:ext cx="8595360" cy="457200"/>
+            <a:off x="274320" y="4572000"/>
+            <a:ext cx="8595360" cy="1143000"/>
           </a:xfrm>
           <a:prstGeom prst="rect">
             <a:avLst/>
@@ -20544,12 +19029,58 @@
           <a:p>
             <a:pPr algn="ctr"/>
             <a:r>
-              <a:rPr sz="2000" b="1" i="0">
+              <a:rPr sz="2000" b="0">
                 <a:solidFill>
                   <a:srgbClr val="5C4826"/>
                 </a:solidFill>
               </a:rPr>
-              <a:t>What claim does each edge make? What evidence would establish it?</a:t>
+              <a:t>model ↔ realization — </a:t>
+            </a:r>
+            <a:r>
+              <a:rPr sz="2000" b="1">
+                <a:solidFill>
+                  <a:srgbClr val="8E6F3E"/>
+                </a:solidFill>
+              </a:rPr>
+              <a:t>correspondence</a:t>
+            </a:r>
+          </a:p>
+          <a:p>
+            <a:pPr algn="ctr"/>
+            <a:r>
+              <a:rPr sz="2000" b="0">
+                <a:solidFill>
+                  <a:srgbClr val="5C4826"/>
+                </a:solidFill>
+              </a:rPr>
+              <a:t>realization ↔ obligation — </a:t>
+            </a:r>
+            <a:r>
+              <a:rPr sz="2000" b="1">
+                <a:solidFill>
+                  <a:srgbClr val="8E6F3E"/>
+                </a:solidFill>
+              </a:rPr>
+              <a:t>conformance</a:t>
+            </a:r>
+          </a:p>
+          <a:p>
+            <a:pPr algn="ctr"/>
+            <a:r>
+              <a:rPr sz="2000" b="0">
+                <a:solidFill>
+                  <a:srgbClr val="5C4826"/>
+                </a:solidFill>
+              </a:rPr>
+              <a:t>realization ↔ receiving environment — </a:t>
+            </a:r>
+            <a:r>
+              <a:rPr sz="2000" b="1">
+                <a:solidFill>
+                  <a:srgbClr val="8E6F3E"/>
+                </a:solidFill>
+              </a:rPr>
+              <a:t>acceptance</a:t>
             </a:r>
           </a:p>
         </p:txBody>
@@ -21072,7 +19603,7 @@
 </p:sld>
 </file>
 
-<file path=ppt/slides/slide36.xml><?xml version="1.0" encoding="utf-8"?>
+<file path=ppt/slides/slide35.xml><?xml version="1.0" encoding="utf-8"?>
 <p:sld xmlns:a="http://schemas.openxmlformats.org/drawingml/2006/main" xmlns:p="http://schemas.openxmlformats.org/presentationml/2006/main" xmlns:r="http://schemas.openxmlformats.org/officeDocument/2006/relationships">
   <p:cSld>
     <p:spTree>
@@ -21399,7 +19930,7 @@
 </p:sld>
 </file>
 
-<file path=ppt/slides/slide37.xml><?xml version="1.0" encoding="utf-8"?>
+<file path=ppt/slides/slide36.xml><?xml version="1.0" encoding="utf-8"?>
 <p:sld xmlns:a="http://schemas.openxmlformats.org/drawingml/2006/main" xmlns:p="http://schemas.openxmlformats.org/presentationml/2006/main" xmlns:r="http://schemas.openxmlformats.org/officeDocument/2006/relationships">
   <p:cSld>
     <p:spTree>

</xml_diff>

<commit_message>
deck 2-3: section 4 merge — concrete architectural-model example folded into Earlier-is-not-always-possible (33->32)
</commit_message>
<xml_diff>
--- a/course/lectures/act-2-delegation-and-control/03-alignment/2-3-Alignment.pptx
+++ b/course/lectures/act-2-delegation-and-control/03-alignment/2-3-Alignment.pptx
@@ -31,7 +31,6 @@
     <p:sldId id="286" r:id="rId51"/>
     <p:sldId id="269" r:id="rId20"/>
     <p:sldId id="270" r:id="rId21"/>
-    <p:sldId id="272" r:id="rId23"/>
     <p:sldId id="273" r:id="rId24"/>
     <p:sldId id="288" r:id="rId53"/>
     <p:sldId id="307" r:id="rId10"/>
@@ -1240,79 +1239,9 @@
               <a:t>- Reveal the upward movement of the check last.</a:t>
             </a:r>
           </a:p>
-        </p:txBody>
-      </p:sp>
-      <p:sp>
-        <p:nvSpPr>
-          <p:cNvPr id="4" name="Slide Number Placeholder 3"/>
-          <p:cNvSpPr>
-            <a:spLocks noGrp="1"/>
-          </p:cNvSpPr>
-          <p:nvPr>
-            <p:ph type="sldNum" idx="5" sz="quarter"/>
-          </p:nvPr>
-        </p:nvSpPr>
-        <p:spPr/>
-      </p:sp>
-    </p:spTree>
-  </p:cSld>
-  <p:clrMapOvr>
-    <a:masterClrMapping/>
-  </p:clrMapOvr>
-</p:notes>
-</file>
-
-<file path=ppt/notesSlides/notesSlide17.xml><?xml version="1.0" encoding="utf-8"?>
-<p:notes xmlns:a="http://schemas.openxmlformats.org/drawingml/2006/main" xmlns:p="http://schemas.openxmlformats.org/presentationml/2006/main" xmlns:r="http://schemas.openxmlformats.org/officeDocument/2006/relationships">
-  <p:cSld>
-    <p:spTree>
-      <p:nvGrpSpPr>
-        <p:cNvPr id="1" name=""/>
-        <p:cNvGrpSpPr/>
-        <p:nvPr/>
-      </p:nvGrpSpPr>
-      <p:grpSpPr>
-        <a:xfrm>
-          <a:off x="0" y="0"/>
-          <a:ext cx="0" cy="0"/>
-          <a:chOff x="0" y="0"/>
-          <a:chExt cx="0" cy="0"/>
-        </a:xfrm>
-      </p:grpSpPr>
-      <p:sp>
-        <p:nvSpPr>
-          <p:cNvPr id="2" name="Slide Image Placeholder 1"/>
-          <p:cNvSpPr>
-            <a:spLocks noGrp="1"/>
-          </p:cNvSpPr>
-          <p:nvPr>
-            <p:ph type="sldImg" idx="2"/>
-          </p:nvPr>
-        </p:nvSpPr>
-        <p:spPr/>
-      </p:sp>
-      <p:sp>
-        <p:nvSpPr>
-          <p:cNvPr id="3" name="Notes Placeholder 2"/>
-          <p:cNvSpPr>
-            <a:spLocks noGrp="1"/>
-          </p:cNvSpPr>
-          <p:nvPr>
-            <p:ph type="body" idx="3" sz="quarter"/>
-          </p:nvPr>
-        </p:nvSpPr>
-        <p:spPr/>
-        <p:txBody>
-          <a:bodyPr/>
-          <a:lstStyle/>
-          <a:p>
-            <a:r>
-              <a:t>TIMING: 2 minutes</a:t>
-            </a:r>
-          </a:p>
-          <a:p>
-            <a:r>
-              <a:t>- Here is the concrete failure mode.</a:t>
+          <a:p>
+            <a:r>
+              <a:t>THE CONCRETE EXAMPLE (absorbed from the deleted boundary-example slide; the obligation bar carries it):</a:t>
             </a:r>
           </a:p>
           <a:p>
@@ -1322,27 +1251,17 @@
           </a:p>
           <a:p>
             <a:r>
-              <a:t>- Enforcing that obligation after every intermediate edit or commit rejects legitimate transitional states.</a:t>
-            </a:r>
-          </a:p>
-          <a:p>
-            <a:r>
-              <a:t>- At merge, the task's work is assembled and the obligation can be evaluated.</a:t>
-            </a:r>
-          </a:p>
-          <a:p>
-            <a:r>
-              <a:t>- Notice the distinction: the obligation was not wrong; its placement was wrong.</a:t>
-            </a:r>
-          </a:p>
-          <a:p>
-            <a:r>
-              <a:t>- This is an Alignment design error, not a reason to abandon the property.</a:t>
-            </a:r>
-          </a:p>
-          <a:p>
-            <a:r>
-              <a:t>- CLOSING BEAT for the section (folds in the deleted "Production is only part of the system" slide):</a:t>
+              <a:t>- Enforcing it after every intermediate edit or commit rejects legitimate transitional states; at merge, the task’s work is assembled and the obligation can be evaluated.</a:t>
+            </a:r>
+          </a:p>
+          <a:p>
+            <a:r>
+              <a:t>- Notice the distinction: the obligation was not wrong; its placement was wrong. This is an Alignment design error, not a reason to abandon the property.</a:t>
+            </a:r>
+          </a:p>
+          <a:p>
+            <a:r>
+              <a:t>CLOSING BEAT for the section (folds in the deleted "Production is only part of the system" slide):</a:t>
             </a:r>
           </a:p>
           <a:p>
@@ -1363,36 +1282,6 @@
           <a:p>
             <a:r>
               <a:t>- Then stretch break. This is a good Act-II-halfway stopping point.</a:t>
-            </a:r>
-          </a:p>
-          <a:p>
-            <a:r>
-              <a:t>ANIMATION</a:t>
-            </a:r>
-          </a:p>
-          <a:p>
-            <a:r>
-              <a:t>- Reveal the obligation.</a:t>
-            </a:r>
-          </a:p>
-          <a:p>
-            <a:r>
-              <a:t>- Reveal per-commit enforcement and the red X.</a:t>
-            </a:r>
-          </a:p>
-          <a:p>
-            <a:r>
-              <a:t>- Reveal the consequence: legitimate intermediate states rejected.</a:t>
-            </a:r>
-          </a:p>
-          <a:p>
-            <a:r>
-              <a:t>- Reveal merge and green check.</a:t>
-            </a:r>
-          </a:p>
-          <a:p>
-            <a:r>
-              <a:t>- Reveal the final sentence last.</a:t>
             </a:r>
           </a:p>
         </p:txBody>
@@ -15052,8 +14941,8 @@
         </p:nvSpPr>
         <p:spPr>
           <a:xfrm>
-            <a:off x="274320" y="4709160"/>
-            <a:ext cx="8595360" cy="822960"/>
+            <a:off x="274320" y="5029200"/>
+            <a:ext cx="8595360" cy="640080"/>
           </a:xfrm>
           <a:prstGeom prst="rect">
             <a:avLst/>
@@ -15073,7 +14962,7 @@
                   <a:srgbClr val="5C4826"/>
                 </a:solidFill>
               </a:rPr>
-              <a:t>Lift the check to the first boundary where the obligation becomes decidable.</a:t>
+              <a:t>The obligation is right. The earlier boundary cannot decide it yet.</a:t>
             </a:r>
           </a:p>
         </p:txBody>
@@ -15086,7 +14975,7 @@
         </p:nvSpPr>
         <p:spPr>
           <a:xfrm>
-            <a:off x="2103120" y="1051560"/>
+            <a:off x="2103120" y="1783080"/>
             <a:ext cx="4937760" cy="900000"/>
           </a:xfrm>
           <a:prstGeom prst="rect">
@@ -15136,7 +15025,7 @@
                   <a:srgbClr val="FBF8F2"/>
                 </a:solidFill>
               </a:rPr>
-              <a:t>obligation decidable here</a:t>
+              <a:t>✓  obligation decidable here</a:t>
             </a:r>
           </a:p>
         </p:txBody>
@@ -15149,8 +15038,8 @@
         </p:nvCxnSpPr>
         <p:spPr>
           <a:xfrm flipV="1">
-            <a:off x="4572000" y="2011680"/>
-            <a:ext cx="0" cy="1024128"/>
+            <a:off x="4572000" y="2788920"/>
+            <a:ext cx="0" cy="868680"/>
           </a:xfrm>
           <a:prstGeom prst="line">
             <a:avLst/>
@@ -15186,7 +15075,7 @@
         </p:nvSpPr>
         <p:spPr>
           <a:xfrm>
-            <a:off x="274320" y="3218688"/>
+            <a:off x="274320" y="3657600"/>
             <a:ext cx="8595360" cy="457200"/>
           </a:xfrm>
           <a:prstGeom prst="rect">
@@ -15207,7 +15096,7 @@
                   <a:srgbClr val="8E6F3E"/>
                 </a:solidFill>
               </a:rPr>
-              <a:t>obligation not decidable at any individual commit</a:t>
+              <a:t>✗  not decidable at any individual commit</a:t>
             </a:r>
           </a:p>
         </p:txBody>
@@ -15220,7 +15109,7 @@
         </p:nvSpPr>
         <p:spPr>
           <a:xfrm>
-            <a:off x="1828800" y="3703320"/>
+            <a:off x="1828800" y="4206240"/>
             <a:ext cx="1188720" cy="566928"/>
           </a:xfrm>
           <a:prstGeom prst="rect">
@@ -15274,7 +15163,7 @@
         </p:nvSpPr>
         <p:spPr>
           <a:xfrm>
-            <a:off x="3264408" y="3703320"/>
+            <a:off x="3264408" y="4206240"/>
             <a:ext cx="1188720" cy="566928"/>
           </a:xfrm>
           <a:prstGeom prst="rect">
@@ -15328,7 +15217,7 @@
         </p:nvSpPr>
         <p:spPr>
           <a:xfrm>
-            <a:off x="4700016" y="3703320"/>
+            <a:off x="4700016" y="4206240"/>
             <a:ext cx="1188720" cy="566928"/>
           </a:xfrm>
           <a:prstGeom prst="rect">
@@ -15382,7 +15271,7 @@
         </p:nvSpPr>
         <p:spPr>
           <a:xfrm>
-            <a:off x="6135624" y="3703320"/>
+            <a:off x="6135624" y="4206240"/>
             <a:ext cx="1188720" cy="566928"/>
           </a:xfrm>
           <a:prstGeom prst="rect">
@@ -15436,7 +15325,7 @@
         </p:nvCxnSpPr>
         <p:spPr>
           <a:xfrm>
-            <a:off x="3026664" y="3986784"/>
+            <a:off x="3026664" y="4489704"/>
             <a:ext cx="237744" cy="0"/>
           </a:xfrm>
           <a:prstGeom prst="line">
@@ -15473,7 +15362,7 @@
         </p:nvCxnSpPr>
         <p:spPr>
           <a:xfrm>
-            <a:off x="4462272" y="3986784"/>
+            <a:off x="4462272" y="4489704"/>
             <a:ext cx="237744" cy="0"/>
           </a:xfrm>
           <a:prstGeom prst="line">
@@ -15510,7 +15399,7 @@
         </p:nvCxnSpPr>
         <p:spPr>
           <a:xfrm>
-            <a:off x="5897880" y="3986784"/>
+            <a:off x="5897880" y="4489704"/>
             <a:ext cx="237744" cy="0"/>
           </a:xfrm>
           <a:prstGeom prst="line">
@@ -15539,82 +15428,15 @@
           </a:fontRef>
         </p:style>
       </p:cxnSp>
-    </p:spTree>
-  </p:cSld>
-  <p:clrMapOvr>
-    <a:masterClrMapping/>
-  </p:clrMapOvr>
-</p:sld>
-</file>
-
-<file path=ppt/slides/slide24.xml><?xml version="1.0" encoding="utf-8"?>
-<p:sld xmlns:a="http://schemas.openxmlformats.org/drawingml/2006/main" xmlns:p="http://schemas.openxmlformats.org/presentationml/2006/main" xmlns:r="http://schemas.openxmlformats.org/officeDocument/2006/relationships">
-  <p:cSld>
-    <p:spTree>
-      <p:nvGrpSpPr>
-        <p:cNvPr id="1" name=""/>
-        <p:cNvGrpSpPr/>
-        <p:nvPr/>
-      </p:nvGrpSpPr>
-      <p:grpSpPr/>
-      <p:sp>
-        <p:nvSpPr>
-          <p:cNvPr id="3" name="Title 2"/>
-          <p:cNvSpPr>
-            <a:spLocks noGrp="1"/>
-          </p:cNvSpPr>
-          <p:nvPr>
-            <p:ph type="title"/>
-          </p:nvPr>
-        </p:nvSpPr>
-        <p:spPr/>
-        <p:txBody>
-          <a:bodyPr wrap="square"/>
-          <a:lstStyle/>
-          <a:p>
-            <a:r>
-              <a:rPr sz="2400" b="0">
-                <a:solidFill>
-                  <a:srgbClr val="000000"/>
-                </a:solidFill>
-              </a:rPr>
-              <a:t>Right obligation, wrong boundary</a:t>
-            </a:r>
-          </a:p>
-        </p:txBody>
-      </p:sp>
-      <p:sp>
-        <p:nvSpPr>
-          <p:cNvPr id="4" name="Slide Number Placeholder 5"/>
-          <p:cNvSpPr>
-            <a:spLocks noGrp="1"/>
-          </p:cNvSpPr>
-          <p:nvPr>
-            <p:ph type="sldNum" sz="quarter" idx="4"/>
-          </p:nvPr>
-        </p:nvSpPr>
-        <p:spPr/>
-        <p:txBody>
-          <a:bodyPr/>
-          <a:lstStyle/>
-          <a:p>
-            <a:fld id="{B7EB45DA-9A0D-DC49-8E02-F30A5DDC21C3}" type="slidenum">
-              <a:rPr lang="en-US" smtClean="0"/>
-              <a:t>24</a:t>
-            </a:fld>
-            <a:endParaRPr lang="en-US"/>
-          </a:p>
-        </p:txBody>
-      </p:sp>
-      <p:sp>
-        <p:nvSpPr>
-          <p:cNvPr id="5" name="Rectangle 4"/>
+      <p:sp>
+        <p:nvSpPr>
+          <p:cNvPr id="101" name="Rectangle 4"/>
           <p:cNvSpPr/>
           <p:nvPr/>
         </p:nvSpPr>
         <p:spPr>
           <a:xfrm>
-            <a:off x="274320" y="1005840"/>
+            <a:off x="274320" y="896112"/>
             <a:ext cx="8595360" cy="731520"/>
           </a:xfrm>
           <a:prstGeom prst="rect">
@@ -15663,776 +15485,7 @@
                   <a:srgbClr val="5C4826"/>
                 </a:solidFill>
               </a:rPr>
-              <a:t>The code and its architectural model must agree when the task completes.</a:t>
-            </a:r>
-          </a:p>
-        </p:txBody>
-      </p:sp>
-      <p:sp>
-        <p:nvSpPr>
-          <p:cNvPr id="6" name="Rectangle 5"/>
-          <p:cNvSpPr/>
-          <p:nvPr/>
-        </p:nvSpPr>
-        <p:spPr>
-          <a:xfrm>
-            <a:off x="292608" y="1920240"/>
-            <a:ext cx="1188720" cy="566928"/>
-          </a:xfrm>
-          <a:prstGeom prst="rect">
-            <a:avLst/>
-          </a:prstGeom>
-          <a:solidFill>
-            <a:srgbClr val="F5F1E8"/>
-          </a:solidFill>
-          <a:ln w="12700">
-            <a:solidFill>
-              <a:srgbClr val="C9B991"/>
-            </a:solidFill>
-          </a:ln>
-          <a:effectLst/>
-        </p:spPr>
-        <p:style>
-          <a:lnRef idx="1">
-            <a:schemeClr val="accent1"/>
-          </a:lnRef>
-          <a:fillRef idx="3">
-            <a:schemeClr val="accent1"/>
-          </a:fillRef>
-          <a:effectRef idx="2">
-            <a:schemeClr val="accent1"/>
-          </a:effectRef>
-          <a:fontRef idx="minor">
-            <a:schemeClr val="lt1"/>
-          </a:fontRef>
-        </p:style>
-        <p:txBody>
-          <a:bodyPr rtlCol="0" anchor="ctr" wrap="square" lIns="27432" rIns="27432" tIns="22860" bIns="22860"/>
-          <a:lstStyle/>
-          <a:p>
-            <a:pPr algn="ctr"/>
-            <a:r>
-              <a:rPr sz="2000" b="1" i="0">
-                <a:solidFill>
-                  <a:srgbClr val="5C4826"/>
-                </a:solidFill>
-              </a:rPr>
-              <a:t>EDIT</a:t>
-            </a:r>
-          </a:p>
-        </p:txBody>
-      </p:sp>
-      <p:cxnSp>
-        <p:nvCxnSpPr>
-          <p:cNvPr id="7" name="Connector 6"/>
-          <p:cNvCxnSpPr/>
-          <p:nvPr/>
-        </p:nvCxnSpPr>
-        <p:spPr>
-          <a:xfrm>
-            <a:off x="1490472" y="2203704"/>
-            <a:ext cx="237744" cy="0"/>
-          </a:xfrm>
-          <a:prstGeom prst="line">
-            <a:avLst/>
-          </a:prstGeom>
-          <a:ln w="28575">
-            <a:solidFill>
-              <a:srgbClr val="8E6F3E"/>
-            </a:solidFill>
-            <a:tailEnd type="triangle" w="med" len="med"/>
-          </a:ln>
-          <a:effectLst/>
-        </p:spPr>
-        <p:style>
-          <a:lnRef idx="2">
-            <a:schemeClr val="accent1"/>
-          </a:lnRef>
-          <a:fillRef idx="0">
-            <a:schemeClr val="accent1"/>
-          </a:fillRef>
-          <a:effectRef idx="1">
-            <a:schemeClr val="accent1"/>
-          </a:effectRef>
-          <a:fontRef idx="minor">
-            <a:schemeClr val="tx1"/>
-          </a:fontRef>
-        </p:style>
-      </p:cxnSp>
-      <p:sp>
-        <p:nvSpPr>
-          <p:cNvPr id="8" name="Rectangle 7"/>
-          <p:cNvSpPr/>
-          <p:nvPr/>
-        </p:nvSpPr>
-        <p:spPr>
-          <a:xfrm>
-            <a:off x="1737360" y="1920240"/>
-            <a:ext cx="1188720" cy="566928"/>
-          </a:xfrm>
-          <a:prstGeom prst="rect">
-            <a:avLst/>
-          </a:prstGeom>
-          <a:solidFill>
-            <a:srgbClr val="F5F1E8"/>
-          </a:solidFill>
-          <a:ln w="12700">
-            <a:solidFill>
-              <a:srgbClr val="C9B991"/>
-            </a:solidFill>
-          </a:ln>
-          <a:effectLst/>
-        </p:spPr>
-        <p:style>
-          <a:lnRef idx="1">
-            <a:schemeClr val="accent1"/>
-          </a:lnRef>
-          <a:fillRef idx="3">
-            <a:schemeClr val="accent1"/>
-          </a:fillRef>
-          <a:effectRef idx="2">
-            <a:schemeClr val="accent1"/>
-          </a:effectRef>
-          <a:fontRef idx="minor">
-            <a:schemeClr val="lt1"/>
-          </a:fontRef>
-        </p:style>
-        <p:txBody>
-          <a:bodyPr rtlCol="0" anchor="ctr" wrap="square" lIns="27432" rIns="27432" tIns="22860" bIns="22860"/>
-          <a:lstStyle/>
-          <a:p>
-            <a:pPr algn="ctr"/>
-            <a:r>
-              <a:rPr sz="2000" b="1" i="0">
-                <a:solidFill>
-                  <a:srgbClr val="5C4826"/>
-                </a:solidFill>
-              </a:rPr>
-              <a:t>COMMIT</a:t>
-            </a:r>
-          </a:p>
-        </p:txBody>
-      </p:sp>
-      <p:cxnSp>
-        <p:nvCxnSpPr>
-          <p:cNvPr id="9" name="Connector 8"/>
-          <p:cNvCxnSpPr/>
-          <p:nvPr/>
-        </p:nvCxnSpPr>
-        <p:spPr>
-          <a:xfrm>
-            <a:off x="2935224" y="2203704"/>
-            <a:ext cx="237744" cy="0"/>
-          </a:xfrm>
-          <a:prstGeom prst="line">
-            <a:avLst/>
-          </a:prstGeom>
-          <a:ln w="28575">
-            <a:solidFill>
-              <a:srgbClr val="8E6F3E"/>
-            </a:solidFill>
-            <a:tailEnd type="triangle" w="med" len="med"/>
-          </a:ln>
-          <a:effectLst/>
-        </p:spPr>
-        <p:style>
-          <a:lnRef idx="2">
-            <a:schemeClr val="accent1"/>
-          </a:lnRef>
-          <a:fillRef idx="0">
-            <a:schemeClr val="accent1"/>
-          </a:fillRef>
-          <a:effectRef idx="1">
-            <a:schemeClr val="accent1"/>
-          </a:effectRef>
-          <a:fontRef idx="minor">
-            <a:schemeClr val="tx1"/>
-          </a:fontRef>
-        </p:style>
-      </p:cxnSp>
-      <p:sp>
-        <p:nvSpPr>
-          <p:cNvPr id="10" name="Rectangle 9"/>
-          <p:cNvSpPr/>
-          <p:nvPr/>
-        </p:nvSpPr>
-        <p:spPr>
-          <a:xfrm>
-            <a:off x="3182112" y="1920240"/>
-            <a:ext cx="1188720" cy="566928"/>
-          </a:xfrm>
-          <a:prstGeom prst="rect">
-            <a:avLst/>
-          </a:prstGeom>
-          <a:solidFill>
-            <a:srgbClr val="F5F1E8"/>
-          </a:solidFill>
-          <a:ln w="12700">
-            <a:solidFill>
-              <a:srgbClr val="C9B991"/>
-            </a:solidFill>
-          </a:ln>
-          <a:effectLst/>
-        </p:spPr>
-        <p:style>
-          <a:lnRef idx="1">
-            <a:schemeClr val="accent1"/>
-          </a:lnRef>
-          <a:fillRef idx="3">
-            <a:schemeClr val="accent1"/>
-          </a:fillRef>
-          <a:effectRef idx="2">
-            <a:schemeClr val="accent1"/>
-          </a:effectRef>
-          <a:fontRef idx="minor">
-            <a:schemeClr val="lt1"/>
-          </a:fontRef>
-        </p:style>
-        <p:txBody>
-          <a:bodyPr rtlCol="0" anchor="ctr" wrap="square" lIns="27432" rIns="27432" tIns="22860" bIns="22860"/>
-          <a:lstStyle/>
-          <a:p>
-            <a:pPr algn="ctr"/>
-            <a:r>
-              <a:rPr sz="2000" b="1" i="0">
-                <a:solidFill>
-                  <a:srgbClr val="5C4826"/>
-                </a:solidFill>
-              </a:rPr>
-              <a:t>PUSH</a:t>
-            </a:r>
-          </a:p>
-        </p:txBody>
-      </p:sp>
-      <p:cxnSp>
-        <p:nvCxnSpPr>
-          <p:cNvPr id="11" name="Connector 10"/>
-          <p:cNvCxnSpPr/>
-          <p:nvPr/>
-        </p:nvCxnSpPr>
-        <p:spPr>
-          <a:xfrm>
-            <a:off x="4379976" y="2203704"/>
-            <a:ext cx="237744" cy="0"/>
-          </a:xfrm>
-          <a:prstGeom prst="line">
-            <a:avLst/>
-          </a:prstGeom>
-          <a:ln w="28575">
-            <a:solidFill>
-              <a:srgbClr val="8E6F3E"/>
-            </a:solidFill>
-            <a:tailEnd type="triangle" w="med" len="med"/>
-          </a:ln>
-          <a:effectLst/>
-        </p:spPr>
-        <p:style>
-          <a:lnRef idx="2">
-            <a:schemeClr val="accent1"/>
-          </a:lnRef>
-          <a:fillRef idx="0">
-            <a:schemeClr val="accent1"/>
-          </a:fillRef>
-          <a:effectRef idx="1">
-            <a:schemeClr val="accent1"/>
-          </a:effectRef>
-          <a:fontRef idx="minor">
-            <a:schemeClr val="tx1"/>
-          </a:fontRef>
-        </p:style>
-      </p:cxnSp>
-      <p:sp>
-        <p:nvSpPr>
-          <p:cNvPr id="12" name="Rectangle 11"/>
-          <p:cNvSpPr/>
-          <p:nvPr/>
-        </p:nvSpPr>
-        <p:spPr>
-          <a:xfrm>
-            <a:off x="4626864" y="1920240"/>
-            <a:ext cx="1188720" cy="566928"/>
-          </a:xfrm>
-          <a:prstGeom prst="rect">
-            <a:avLst/>
-          </a:prstGeom>
-          <a:solidFill>
-            <a:srgbClr val="F5F1E8"/>
-          </a:solidFill>
-          <a:ln w="12700">
-            <a:solidFill>
-              <a:srgbClr val="C9B991"/>
-            </a:solidFill>
-          </a:ln>
-          <a:effectLst/>
-        </p:spPr>
-        <p:style>
-          <a:lnRef idx="1">
-            <a:schemeClr val="accent1"/>
-          </a:lnRef>
-          <a:fillRef idx="3">
-            <a:schemeClr val="accent1"/>
-          </a:fillRef>
-          <a:effectRef idx="2">
-            <a:schemeClr val="accent1"/>
-          </a:effectRef>
-          <a:fontRef idx="minor">
-            <a:schemeClr val="lt1"/>
-          </a:fontRef>
-        </p:style>
-        <p:txBody>
-          <a:bodyPr rtlCol="0" anchor="ctr" wrap="square" lIns="27432" rIns="27432" tIns="22860" bIns="22860"/>
-          <a:lstStyle/>
-          <a:p>
-            <a:pPr algn="ctr"/>
-            <a:r>
-              <a:rPr sz="2000" b="1" i="0">
-                <a:solidFill>
-                  <a:srgbClr val="5C4826"/>
-                </a:solidFill>
-              </a:rPr>
-              <a:t>MERGE</a:t>
-            </a:r>
-          </a:p>
-        </p:txBody>
-      </p:sp>
-      <p:cxnSp>
-        <p:nvCxnSpPr>
-          <p:cNvPr id="13" name="Connector 12"/>
-          <p:cNvCxnSpPr/>
-          <p:nvPr/>
-        </p:nvCxnSpPr>
-        <p:spPr>
-          <a:xfrm>
-            <a:off x="5824728" y="2203704"/>
-            <a:ext cx="237744" cy="0"/>
-          </a:xfrm>
-          <a:prstGeom prst="line">
-            <a:avLst/>
-          </a:prstGeom>
-          <a:ln w="28575">
-            <a:solidFill>
-              <a:srgbClr val="8E6F3E"/>
-            </a:solidFill>
-            <a:tailEnd type="triangle" w="med" len="med"/>
-          </a:ln>
-          <a:effectLst/>
-        </p:spPr>
-        <p:style>
-          <a:lnRef idx="2">
-            <a:schemeClr val="accent1"/>
-          </a:lnRef>
-          <a:fillRef idx="0">
-            <a:schemeClr val="accent1"/>
-          </a:fillRef>
-          <a:effectRef idx="1">
-            <a:schemeClr val="accent1"/>
-          </a:effectRef>
-          <a:fontRef idx="minor">
-            <a:schemeClr val="tx1"/>
-          </a:fontRef>
-        </p:style>
-      </p:cxnSp>
-      <p:sp>
-        <p:nvSpPr>
-          <p:cNvPr id="14" name="Rectangle 13"/>
-          <p:cNvSpPr/>
-          <p:nvPr/>
-        </p:nvSpPr>
-        <p:spPr>
-          <a:xfrm>
-            <a:off x="6071616" y="1920240"/>
-            <a:ext cx="1188720" cy="566928"/>
-          </a:xfrm>
-          <a:prstGeom prst="rect">
-            <a:avLst/>
-          </a:prstGeom>
-          <a:solidFill>
-            <a:srgbClr val="F5F1E8"/>
-          </a:solidFill>
-          <a:ln w="12700">
-            <a:solidFill>
-              <a:srgbClr val="C9B991"/>
-            </a:solidFill>
-          </a:ln>
-          <a:effectLst/>
-        </p:spPr>
-        <p:style>
-          <a:lnRef idx="1">
-            <a:schemeClr val="accent1"/>
-          </a:lnRef>
-          <a:fillRef idx="3">
-            <a:schemeClr val="accent1"/>
-          </a:fillRef>
-          <a:effectRef idx="2">
-            <a:schemeClr val="accent1"/>
-          </a:effectRef>
-          <a:fontRef idx="minor">
-            <a:schemeClr val="lt1"/>
-          </a:fontRef>
-        </p:style>
-        <p:txBody>
-          <a:bodyPr rtlCol="0" anchor="ctr" wrap="square" lIns="27432" rIns="27432" tIns="22860" bIns="22860"/>
-          <a:lstStyle/>
-          <a:p>
-            <a:pPr algn="ctr"/>
-            <a:r>
-              <a:rPr sz="2000" b="1" i="0">
-                <a:solidFill>
-                  <a:srgbClr val="5C4826"/>
-                </a:solidFill>
-              </a:rPr>
-              <a:t>DEPLOY</a:t>
-            </a:r>
-          </a:p>
-        </p:txBody>
-      </p:sp>
-      <p:cxnSp>
-        <p:nvCxnSpPr>
-          <p:cNvPr id="15" name="Connector 14"/>
-          <p:cNvCxnSpPr/>
-          <p:nvPr/>
-        </p:nvCxnSpPr>
-        <p:spPr>
-          <a:xfrm>
-            <a:off x="7269480" y="2203704"/>
-            <a:ext cx="237744" cy="0"/>
-          </a:xfrm>
-          <a:prstGeom prst="line">
-            <a:avLst/>
-          </a:prstGeom>
-          <a:ln w="28575">
-            <a:solidFill>
-              <a:srgbClr val="8E6F3E"/>
-            </a:solidFill>
-            <a:tailEnd type="triangle" w="med" len="med"/>
-          </a:ln>
-          <a:effectLst/>
-        </p:spPr>
-        <p:style>
-          <a:lnRef idx="2">
-            <a:schemeClr val="accent1"/>
-          </a:lnRef>
-          <a:fillRef idx="0">
-            <a:schemeClr val="accent1"/>
-          </a:fillRef>
-          <a:effectRef idx="1">
-            <a:schemeClr val="accent1"/>
-          </a:effectRef>
-          <a:fontRef idx="minor">
-            <a:schemeClr val="tx1"/>
-          </a:fontRef>
-        </p:style>
-      </p:cxnSp>
-      <p:sp>
-        <p:nvSpPr>
-          <p:cNvPr id="16" name="Rectangle 15"/>
-          <p:cNvSpPr/>
-          <p:nvPr/>
-        </p:nvSpPr>
-        <p:spPr>
-          <a:xfrm>
-            <a:off x="7516368" y="1920240"/>
-            <a:ext cx="1188720" cy="566928"/>
-          </a:xfrm>
-          <a:prstGeom prst="rect">
-            <a:avLst/>
-          </a:prstGeom>
-          <a:solidFill>
-            <a:srgbClr val="F5F1E8"/>
-          </a:solidFill>
-          <a:ln w="12700">
-            <a:solidFill>
-              <a:srgbClr val="C9B991"/>
-            </a:solidFill>
-          </a:ln>
-          <a:effectLst/>
-        </p:spPr>
-        <p:style>
-          <a:lnRef idx="1">
-            <a:schemeClr val="accent1"/>
-          </a:lnRef>
-          <a:fillRef idx="3">
-            <a:schemeClr val="accent1"/>
-          </a:fillRef>
-          <a:effectRef idx="2">
-            <a:schemeClr val="accent1"/>
-          </a:effectRef>
-          <a:fontRef idx="minor">
-            <a:schemeClr val="lt1"/>
-          </a:fontRef>
-        </p:style>
-        <p:txBody>
-          <a:bodyPr rtlCol="0" anchor="ctr" wrap="square" lIns="27432" rIns="27432" tIns="22860" bIns="22860"/>
-          <a:lstStyle/>
-          <a:p>
-            <a:pPr algn="ctr"/>
-            <a:r>
-              <a:rPr sz="2000" b="1" i="0">
-                <a:solidFill>
-                  <a:srgbClr val="5C4826"/>
-                </a:solidFill>
-              </a:rPr>
-              <a:t>RUNTIME</a:t>
-            </a:r>
-          </a:p>
-        </p:txBody>
-      </p:sp>
-      <p:cxnSp>
-        <p:nvCxnSpPr>
-          <p:cNvPr id="17" name="Connector 16"/>
-          <p:cNvCxnSpPr/>
-          <p:nvPr/>
-        </p:nvCxnSpPr>
-        <p:spPr>
-          <a:xfrm flipV="1">
-            <a:off x="2331720" y="2606040"/>
-            <a:ext cx="0" cy="640080"/>
-          </a:xfrm>
-          <a:prstGeom prst="line">
-            <a:avLst/>
-          </a:prstGeom>
-          <a:ln w="28575">
-            <a:solidFill>
-              <a:srgbClr val="8E6F3E"/>
-            </a:solidFill>
-            <a:tailEnd type="triangle" w="med" len="med"/>
-          </a:ln>
-          <a:effectLst/>
-        </p:spPr>
-        <p:style>
-          <a:lnRef idx="2">
-            <a:schemeClr val="accent1"/>
-          </a:lnRef>
-          <a:fillRef idx="0">
-            <a:schemeClr val="accent1"/>
-          </a:fillRef>
-          <a:effectRef idx="1">
-            <a:schemeClr val="accent1"/>
-          </a:effectRef>
-          <a:fontRef idx="minor">
-            <a:schemeClr val="tx1"/>
-          </a:fontRef>
-        </p:style>
-      </p:cxnSp>
-      <p:sp>
-        <p:nvSpPr>
-          <p:cNvPr id="18" name="Rectangle 17"/>
-          <p:cNvSpPr/>
-          <p:nvPr/>
-        </p:nvSpPr>
-        <p:spPr>
-          <a:xfrm>
-            <a:off x="1051560" y="3291840"/>
-            <a:ext cx="2560320" cy="1051560"/>
-          </a:xfrm>
-          <a:prstGeom prst="rect">
-            <a:avLst/>
-          </a:prstGeom>
-          <a:solidFill>
-            <a:srgbClr val="FBF8F2"/>
-          </a:solidFill>
-          <a:ln w="12700">
-            <a:solidFill>
-              <a:srgbClr val="C9B991"/>
-            </a:solidFill>
-          </a:ln>
-          <a:effectLst/>
-        </p:spPr>
-        <p:style>
-          <a:lnRef idx="1">
-            <a:schemeClr val="accent1"/>
-          </a:lnRef>
-          <a:fillRef idx="3">
-            <a:schemeClr val="accent1"/>
-          </a:fillRef>
-          <a:effectRef idx="2">
-            <a:schemeClr val="accent1"/>
-          </a:effectRef>
-          <a:fontRef idx="minor">
-            <a:schemeClr val="lt1"/>
-          </a:fontRef>
-        </p:style>
-        <p:txBody>
-          <a:bodyPr rtlCol="0" anchor="ctr" wrap="square" lIns="27432" rIns="27432" tIns="22860" bIns="22860"/>
-          <a:lstStyle/>
-          <a:p>
-            <a:pPr algn="ctr"/>
-            <a:r>
-              <a:rPr sz="2000" b="1" i="0">
-                <a:solidFill>
-                  <a:srgbClr val="5C4826"/>
-                </a:solidFill>
-              </a:rPr>
-              <a:t>✗  enforced per-commit</a:t>
-            </a:r>
-          </a:p>
-          <a:p>
-            <a:pPr algn="ctr"/>
-            <a:r>
-              <a:rPr sz="2000" b="0" i="1">
-                <a:solidFill>
-                  <a:srgbClr val="555960"/>
-                </a:solidFill>
-              </a:rPr>
-              <a:t>rejects legitimate</a:t>
-            </a:r>
-          </a:p>
-          <a:p>
-            <a:pPr algn="ctr"/>
-            <a:r>
-              <a:rPr sz="2000" b="0" i="1">
-                <a:solidFill>
-                  <a:srgbClr val="555960"/>
-                </a:solidFill>
-              </a:rPr>
-              <a:t>intermediate states</a:t>
-            </a:r>
-          </a:p>
-        </p:txBody>
-      </p:sp>
-      <p:cxnSp>
-        <p:nvCxnSpPr>
-          <p:cNvPr id="19" name="Connector 18"/>
-          <p:cNvCxnSpPr/>
-          <p:nvPr/>
-        </p:nvCxnSpPr>
-        <p:spPr>
-          <a:xfrm flipV="1">
-            <a:off x="5221224" y="2606040"/>
-            <a:ext cx="0" cy="640080"/>
-          </a:xfrm>
-          <a:prstGeom prst="line">
-            <a:avLst/>
-          </a:prstGeom>
-          <a:ln w="28575">
-            <a:solidFill>
-              <a:srgbClr val="8E6F3E"/>
-            </a:solidFill>
-            <a:tailEnd type="triangle" w="med" len="med"/>
-          </a:ln>
-          <a:effectLst/>
-        </p:spPr>
-        <p:style>
-          <a:lnRef idx="2">
-            <a:schemeClr val="accent1"/>
-          </a:lnRef>
-          <a:fillRef idx="0">
-            <a:schemeClr val="accent1"/>
-          </a:fillRef>
-          <a:effectRef idx="1">
-            <a:schemeClr val="accent1"/>
-          </a:effectRef>
-          <a:fontRef idx="minor">
-            <a:schemeClr val="tx1"/>
-          </a:fontRef>
-        </p:style>
-      </p:cxnSp>
-      <p:sp>
-        <p:nvSpPr>
-          <p:cNvPr id="20" name="Rectangle 19"/>
-          <p:cNvSpPr/>
-          <p:nvPr/>
-        </p:nvSpPr>
-        <p:spPr>
-          <a:xfrm>
-            <a:off x="3941064" y="3291840"/>
-            <a:ext cx="2560320" cy="1051560"/>
-          </a:xfrm>
-          <a:prstGeom prst="rect">
-            <a:avLst/>
-          </a:prstGeom>
-          <a:solidFill>
-            <a:srgbClr val="F5F1E8"/>
-          </a:solidFill>
-          <a:ln w="12700">
-            <a:solidFill>
-              <a:srgbClr val="C9B991"/>
-            </a:solidFill>
-          </a:ln>
-          <a:effectLst/>
-        </p:spPr>
-        <p:style>
-          <a:lnRef idx="1">
-            <a:schemeClr val="accent1"/>
-          </a:lnRef>
-          <a:fillRef idx="3">
-            <a:schemeClr val="accent1"/>
-          </a:fillRef>
-          <a:effectRef idx="2">
-            <a:schemeClr val="accent1"/>
-          </a:effectRef>
-          <a:fontRef idx="minor">
-            <a:schemeClr val="lt1"/>
-          </a:fontRef>
-        </p:style>
-        <p:txBody>
-          <a:bodyPr rtlCol="0" anchor="ctr" wrap="square" lIns="27432" rIns="27432" tIns="22860" bIns="22860"/>
-          <a:lstStyle/>
-          <a:p>
-            <a:pPr algn="ctr"/>
-            <a:r>
-              <a:rPr sz="2000" b="1" i="0">
-                <a:solidFill>
-                  <a:srgbClr val="5C4826"/>
-                </a:solidFill>
-              </a:rPr>
-              <a:t>✓  decided at merge</a:t>
-            </a:r>
-          </a:p>
-          <a:p>
-            <a:pPr algn="ctr"/>
-            <a:r>
-              <a:rPr sz="2000" b="0" i="1">
-                <a:solidFill>
-                  <a:srgbClr val="555960"/>
-                </a:solidFill>
-              </a:rPr>
-              <a:t>when the task’s work</a:t>
-            </a:r>
-          </a:p>
-          <a:p>
-            <a:pPr algn="ctr"/>
-            <a:r>
-              <a:rPr sz="2000" b="0" i="1">
-                <a:solidFill>
-                  <a:srgbClr val="555960"/>
-                </a:solidFill>
-              </a:rPr>
-              <a:t>is assembled</a:t>
-            </a:r>
-          </a:p>
-        </p:txBody>
-      </p:sp>
-      <p:sp>
-        <p:nvSpPr>
-          <p:cNvPr id="21" name="TextBox 20"/>
-          <p:cNvSpPr txBox="1"/>
-          <p:nvPr/>
-        </p:nvSpPr>
-        <p:spPr>
-          <a:xfrm>
-            <a:off x="274320" y="4572000"/>
-            <a:ext cx="8595360" cy="502920"/>
-          </a:xfrm>
-          <a:prstGeom prst="rect">
-            <a:avLst/>
-          </a:prstGeom>
-          <a:noFill/>
-        </p:spPr>
-        <p:txBody>
-          <a:bodyPr wrap="square" anchor="t">
-            <a:spAutoFit/>
-          </a:bodyPr>
-          <a:lstStyle/>
-          <a:p>
-            <a:pPr algn="ctr"/>
-            <a:r>
-              <a:rPr sz="2000" b="0" i="1">
-                <a:solidFill>
-                  <a:srgbClr val="555960"/>
-                </a:solidFill>
-              </a:rPr>
-              <a:t>The obligation is right. The early boundary simply cannot decide it yet.</a:t>
+              <a:t>Code and architectural model must agree when the task completes.</a:t>
             </a:r>
           </a:p>
         </p:txBody>
@@ -17362,6 +16415,369 @@
 </p:sld>
 </file>
 
+<file path=ppt/slides/slide28.xml><?xml version="1.0" encoding="utf-8"?>
+<p:sld xmlns:a="http://schemas.openxmlformats.org/drawingml/2006/main" xmlns:p="http://schemas.openxmlformats.org/presentationml/2006/main" xmlns:r="http://schemas.openxmlformats.org/officeDocument/2006/relationships">
+  <p:cSld>
+    <p:spTree>
+      <p:nvGrpSpPr>
+        <p:cNvPr id="1" name=""/>
+        <p:cNvGrpSpPr/>
+        <p:nvPr/>
+      </p:nvGrpSpPr>
+      <p:grpSpPr/>
+      <p:sp>
+        <p:nvSpPr>
+          <p:cNvPr id="3" name="Title 2"/>
+          <p:cNvSpPr>
+            <a:spLocks noGrp="1"/>
+          </p:cNvSpPr>
+          <p:nvPr>
+            <p:ph type="title"/>
+          </p:nvPr>
+        </p:nvSpPr>
+        <p:spPr/>
+        <p:txBody>
+          <a:bodyPr wrap="square"/>
+          <a:lstStyle/>
+          <a:p>
+            <a:r>
+              <a:rPr sz="2400" b="0">
+                <a:solidFill>
+                  <a:srgbClr val="000000"/>
+                </a:solidFill>
+              </a:rPr>
+              <a:t>Models support static validation</a:t>
+            </a:r>
+          </a:p>
+        </p:txBody>
+      </p:sp>
+      <p:sp>
+        <p:nvSpPr>
+          <p:cNvPr id="4" name="Slide Number Placeholder 5"/>
+          <p:cNvSpPr>
+            <a:spLocks noGrp="1"/>
+          </p:cNvSpPr>
+          <p:nvPr>
+            <p:ph type="sldNum" sz="quarter" idx="4"/>
+          </p:nvPr>
+        </p:nvSpPr>
+        <p:spPr/>
+        <p:txBody>
+          <a:bodyPr/>
+          <a:lstStyle/>
+          <a:p>
+            <a:fld id="{B7EB45DA-9A0D-DC49-8E02-F30A5DDC21C3}" type="slidenum">
+              <a:rPr lang="en-US" smtClean="0"/>
+              <a:t>29</a:t>
+            </a:fld>
+            <a:endParaRPr lang="en-US"/>
+          </a:p>
+        </p:txBody>
+      </p:sp>
+      <p:sp>
+        <p:nvSpPr>
+          <p:cNvPr id="0" name="St-MODEL"/>
+          <p:cNvSpPr/>
+          <p:nvPr/>
+        </p:nvSpPr>
+        <p:spPr>
+          <a:xfrm>
+            <a:off x="502920" y="1005840"/>
+            <a:ext cx="1828800" cy="640080"/>
+          </a:xfrm>
+          <a:prstGeom prst="rect">
+            <a:avLst/>
+          </a:prstGeom>
+          <a:solidFill>
+            <a:srgbClr val="8E6F3E"/>
+          </a:solidFill>
+          <a:ln>
+            <a:noFill/>
+          </a:ln>
+          <a:effectLst/>
+        </p:spPr>
+        <p:txBody>
+          <a:bodyPr rtlCol="0" anchor="ctr" wrap="square" lIns="27432" rIns="27432" tIns="22860" bIns="22860"/>
+          <a:lstStyle/>
+          <a:p>
+            <a:pPr algn="ctr">
+              <a:buNone/>
+            </a:pPr>
+            <a:r>
+              <a:rPr lang="en-US" sz="2000" b="1" i="0" dirty="0">
+                <a:solidFill>
+                  <a:srgbClr val="FFFFFF"/>
+                </a:solidFill>
+              </a:rPr>
+              <a:t>MODEL</a:t>
+            </a:r>
+          </a:p>
+        </p:txBody>
+      </p:sp>
+      <p:sp>
+        <p:nvSpPr>
+          <p:cNvPr id="0" name="St-ANALYSIS"/>
+          <p:cNvSpPr/>
+          <p:nvPr/>
+        </p:nvSpPr>
+        <p:spPr>
+          <a:xfrm>
+            <a:off x="3291840" y="1005840"/>
+            <a:ext cx="2560320" cy="640080"/>
+          </a:xfrm>
+          <a:prstGeom prst="rect">
+            <a:avLst/>
+          </a:prstGeom>
+          <a:solidFill>
+            <a:srgbClr val="F5F1E8"/>
+          </a:solidFill>
+          <a:ln w="12700">
+            <a:solidFill>
+              <a:srgbClr val="C9B991"/>
+            </a:solidFill>
+          </a:ln>
+          <a:effectLst/>
+        </p:spPr>
+        <p:txBody>
+          <a:bodyPr rtlCol="0" anchor="ctr" wrap="square" lIns="27432" rIns="27432" tIns="22860" bIns="22860"/>
+          <a:lstStyle/>
+          <a:p>
+            <a:pPr algn="ctr">
+              <a:buNone/>
+            </a:pPr>
+            <a:r>
+              <a:rPr lang="en-US" sz="2000" b="1" i="0" dirty="0">
+                <a:solidFill>
+                  <a:srgbClr val="5C4826"/>
+                </a:solidFill>
+              </a:rPr>
+              <a:t>STATIC ANALYSIS</a:t>
+            </a:r>
+          </a:p>
+        </p:txBody>
+      </p:sp>
+      <p:sp>
+        <p:nvSpPr>
+          <p:cNvPr id="0" name="St-VERDICT"/>
+          <p:cNvSpPr/>
+          <p:nvPr/>
+        </p:nvSpPr>
+        <p:spPr>
+          <a:xfrm>
+            <a:off x="6812280" y="1005840"/>
+            <a:ext cx="1828800" cy="640080"/>
+          </a:xfrm>
+          <a:prstGeom prst="rect">
+            <a:avLst/>
+          </a:prstGeom>
+          <a:solidFill>
+            <a:srgbClr val="8E6F3E"/>
+          </a:solidFill>
+          <a:ln>
+            <a:noFill/>
+          </a:ln>
+          <a:effectLst/>
+        </p:spPr>
+        <p:txBody>
+          <a:bodyPr rtlCol="0" anchor="ctr" wrap="square" lIns="27432" rIns="27432" tIns="22860" bIns="22860"/>
+          <a:lstStyle/>
+          <a:p>
+            <a:pPr algn="ctr">
+              <a:buNone/>
+            </a:pPr>
+            <a:r>
+              <a:rPr lang="en-US" sz="2000" b="1" i="0" dirty="0">
+                <a:solidFill>
+                  <a:srgbClr val="FFFFFF"/>
+                </a:solidFill>
+              </a:rPr>
+              <a:t>VERDICT</a:t>
+            </a:r>
+          </a:p>
+        </p:txBody>
+      </p:sp>
+      <p:cxnSp>
+        <p:nvCxnSpPr>
+          <p:cNvPr id="0" name="St-A1"/>
+          <p:cNvCxnSpPr/>
+          <p:nvPr/>
+        </p:nvCxnSpPr>
+        <p:spPr>
+          <a:xfrm>
+            <a:off x="2331720" y="1325880"/>
+            <a:ext cx="960120" cy="0"/>
+          </a:xfrm>
+          <a:prstGeom prst="straightConnector1">
+            <a:avLst/>
+          </a:prstGeom>
+          <a:ln w="19050">
+            <a:solidFill>
+              <a:srgbClr val="8E6F3E"/>
+            </a:solidFill>
+            <a:tailEnd type="triangle"/>
+          </a:ln>
+        </p:spPr>
+      </p:cxnSp>
+      <p:cxnSp>
+        <p:nvCxnSpPr>
+          <p:cNvPr id="0" name="St-A2"/>
+          <p:cNvCxnSpPr/>
+          <p:nvPr/>
+        </p:nvCxnSpPr>
+        <p:spPr>
+          <a:xfrm>
+            <a:off x="5852160" y="1325880"/>
+            <a:ext cx="960120" cy="0"/>
+          </a:xfrm>
+          <a:prstGeom prst="straightConnector1">
+            <a:avLst/>
+          </a:prstGeom>
+          <a:ln w="19050">
+            <a:solidFill>
+              <a:srgbClr val="8E6F3E"/>
+            </a:solidFill>
+            <a:tailEnd type="triangle"/>
+          </a:ln>
+        </p:spPr>
+      </p:cxnSp>
+      <p:sp>
+        <p:nvSpPr>
+          <p:cNvPr id="0" name="St-Questions"/>
+          <p:cNvSpPr/>
+          <p:nvPr/>
+        </p:nvSpPr>
+        <p:spPr>
+          <a:xfrm>
+            <a:off x="502920" y="2103120"/>
+            <a:ext cx="8138160" cy="3291840"/>
+          </a:xfrm>
+          <a:prstGeom prst="rect">
+            <a:avLst/>
+          </a:prstGeom>
+          <a:solidFill>
+            <a:srgbClr val="F5F1E8"/>
+          </a:solidFill>
+          <a:ln w="12700">
+            <a:solidFill>
+              <a:srgbClr val="C9B991"/>
+            </a:solidFill>
+          </a:ln>
+          <a:effectLst/>
+        </p:spPr>
+        <p:txBody>
+          <a:bodyPr rtlCol="0" anchor="t" wrap="square" lIns="27432" rIns="27432" tIns="22860" bIns="22860"/>
+          <a:lstStyle/>
+          <a:p>
+            <a:pPr algn="l">
+              <a:buNone/>
+            </a:pPr>
+            <a:r>
+              <a:rPr lang="en-US" sz="2000" b="1" i="0" dirty="0">
+                <a:solidFill>
+                  <a:srgbClr val="5C4826"/>
+                </a:solidFill>
+              </a:rPr>
+              <a:t>Questions the lab model can already decide:</a:t>
+            </a:r>
+          </a:p>
+          <a:p>
+            <a:pPr algn="l">
+              <a:spcBef>
+                <a:spcPts val="900"/>
+              </a:spcBef>
+              <a:buNone/>
+            </a:pPr>
+            <a:r>
+              <a:rPr lang="en-US" sz="2000" b="0" i="0" dirty="0">
+                <a:solidFill>
+                  <a:srgbClr val="5C4826"/>
+                </a:solidFill>
+              </a:rPr>
+              <a:t>Can admitted threads exceed the memory ceiling?</a:t>
+            </a:r>
+          </a:p>
+          <a:p>
+            <a:pPr algn="l">
+              <a:spcBef>
+                <a:spcPts val="900"/>
+              </a:spcBef>
+              <a:buNone/>
+            </a:pPr>
+            <a:r>
+              <a:rPr lang="en-US" sz="2000" b="0" i="0" dirty="0">
+                <a:solidFill>
+                  <a:srgbClr val="5C4826"/>
+                </a:solidFill>
+              </a:rPr>
+              <a:t>Can three threads be Awake simultaneously?</a:t>
+            </a:r>
+          </a:p>
+          <a:p>
+            <a:pPr algn="l">
+              <a:spcBef>
+                <a:spcPts val="900"/>
+              </a:spcBef>
+              <a:buNone/>
+            </a:pPr>
+            <a:r>
+              <a:rPr lang="en-US" sz="2000" b="0" i="0" dirty="0">
+                <a:solidFill>
+                  <a:srgbClr val="5C4826"/>
+                </a:solidFill>
+              </a:rPr>
+              <a:t>Is an illegal lifecycle transition reachable?</a:t>
+            </a:r>
+          </a:p>
+        </p:txBody>
+      </p:sp>
+      <p:sp>
+        <p:nvSpPr>
+          <p:cNvPr id="0" name="FooterBand"/>
+          <p:cNvSpPr/>
+          <p:nvPr/>
+        </p:nvSpPr>
+        <p:spPr>
+          <a:xfrm>
+            <a:off x="274320" y="5760720"/>
+            <a:ext cx="8595360" cy="777240"/>
+          </a:xfrm>
+          <a:prstGeom prst="rect">
+            <a:avLst/>
+          </a:prstGeom>
+          <a:solidFill>
+            <a:srgbClr val="8E6F3E"/>
+          </a:solidFill>
+          <a:ln>
+            <a:noFill/>
+          </a:ln>
+          <a:effectLst/>
+        </p:spPr>
+        <p:txBody>
+          <a:bodyPr rtlCol="0" anchor="ctr" wrap="square" lIns="27432" rIns="27432" tIns="22860" bIns="22860"/>
+          <a:lstStyle/>
+          <a:p>
+            <a:pPr algn="ctr">
+              <a:buNone/>
+            </a:pPr>
+            <a:r>
+              <a:rPr lang="en-US" sz="2000" b="1" i="0" dirty="0">
+                <a:solidFill>
+                  <a:srgbClr val="FFFFFF"/>
+                </a:solidFill>
+              </a:rPr>
+              <a:t>Explicit structure can turn repeated reconstruction into a decidable query.</a:t>
+            </a:r>
+          </a:p>
+        </p:txBody>
+      </p:sp>
+    </p:spTree>
+  </p:cSld>
+  <p:clrMapOvr>
+    <a:masterClrMapping/>
+  </p:clrMapOvr>
+</p:sld>
+</file>
+
 <file path=ppt/slides/slide29.xml><?xml version="1.0" encoding="utf-8"?>
 <p:sld xmlns:a="http://schemas.openxmlformats.org/drawingml/2006/main" xmlns:p="http://schemas.openxmlformats.org/presentationml/2006/main" xmlns:r="http://schemas.openxmlformats.org/officeDocument/2006/relationships">
   <p:cSld>
@@ -17393,7 +16809,7 @@
                   <a:srgbClr val="000000"/>
                 </a:solidFill>
               </a:rPr>
-              <a:t>Models support static validation</a:t>
+              <a:t>Models support dynamic validation</a:t>
             </a:r>
           </a:p>
         </p:txBody>
@@ -17415,7 +16831,7 @@
           <a:p>
             <a:fld id="{B7EB45DA-9A0D-DC49-8E02-F30A5DDC21C3}" type="slidenum">
               <a:rPr lang="en-US" smtClean="0"/>
-              <a:t>29</a:t>
+              <a:t>30</a:t>
             </a:fld>
             <a:endParaRPr lang="en-US"/>
           </a:p>
@@ -17423,14 +16839,14 @@
       </p:sp>
       <p:sp>
         <p:nvSpPr>
-          <p:cNvPr id="0" name="St-MODEL"/>
+          <p:cNvPr id="0" name="Dy-MODEL"/>
           <p:cNvSpPr/>
           <p:nvPr/>
         </p:nvSpPr>
         <p:spPr>
           <a:xfrm>
-            <a:off x="502920" y="1005840"/>
-            <a:ext cx="1828800" cy="640080"/>
+            <a:off x="2697480" y="3831336"/>
+            <a:ext cx="2203704" cy="731520"/>
           </a:xfrm>
           <a:prstGeom prst="rect">
             <a:avLst/>
@@ -17456,21 +16872,43 @@
                   <a:srgbClr val="FFFFFF"/>
                 </a:solidFill>
               </a:rPr>
-              <a:t>MODEL</a:t>
-            </a:r>
-          </a:p>
-        </p:txBody>
-      </p:sp>
-      <p:sp>
-        <p:nvSpPr>
-          <p:cNvPr id="0" name="St-ANALYSIS"/>
+              <a:t>MODEL — expected behavior</a:t>
+            </a:r>
+          </a:p>
+        </p:txBody>
+      </p:sp>
+      <p:cxnSp>
+        <p:nvCxnSpPr>
+          <p:cNvPr id="0" name="Dy-AM"/>
+          <p:cNvCxnSpPr/>
+          <p:nvPr/>
+        </p:nvCxnSpPr>
+        <p:spPr>
+          <a:xfrm flipH="1">
+            <a:off x="2240280" y="4197096"/>
+            <a:ext cx="402336" cy="0"/>
+          </a:xfrm>
+          <a:prstGeom prst="straightConnector1">
+            <a:avLst/>
+          </a:prstGeom>
+          <a:ln w="19050">
+            <a:solidFill>
+              <a:srgbClr val="8E6F3E"/>
+            </a:solidFill>
+            <a:tailEnd type="triangle"/>
+          </a:ln>
+        </p:spPr>
+      </p:cxnSp>
+      <p:sp>
+        <p:nvSpPr>
+          <p:cNvPr id="0" name="Dy-EXECUTION"/>
           <p:cNvSpPr/>
           <p:nvPr/>
         </p:nvSpPr>
         <p:spPr>
           <a:xfrm>
-            <a:off x="3291840" y="1005840"/>
-            <a:ext cx="2560320" cy="640080"/>
+            <a:off x="685800" y="1051560"/>
+            <a:ext cx="1500000" cy="640080"/>
           </a:xfrm>
           <a:prstGeom prst="rect">
             <a:avLst/>
@@ -17498,21 +16936,21 @@
                   <a:srgbClr val="5C4826"/>
                 </a:solidFill>
               </a:rPr>
-              <a:t>STATIC ANALYSIS</a:t>
-            </a:r>
-          </a:p>
-        </p:txBody>
-      </p:sp>
-      <p:sp>
-        <p:nvSpPr>
-          <p:cNvPr id="0" name="St-VERDICT"/>
+              <a:t>EXECUTION</a:t>
+            </a:r>
+          </a:p>
+        </p:txBody>
+      </p:sp>
+      <p:sp>
+        <p:nvSpPr>
+          <p:cNvPr id="0" name="Dy-SENSOR"/>
           <p:cNvSpPr/>
           <p:nvPr/>
         </p:nvSpPr>
         <p:spPr>
           <a:xfrm>
-            <a:off x="6812280" y="1005840"/>
-            <a:ext cx="1828800" cy="640080"/>
+            <a:off x="685800" y="1993392"/>
+            <a:ext cx="1500000" cy="640080"/>
           </a:xfrm>
           <a:prstGeom prst="rect">
             <a:avLst/>
@@ -17538,65 +16976,21 @@
                   <a:srgbClr val="FFFFFF"/>
                 </a:solidFill>
               </a:rPr>
-              <a:t>VERDICT</a:t>
-            </a:r>
-          </a:p>
-        </p:txBody>
-      </p:sp>
-      <p:cxnSp>
-        <p:nvCxnSpPr>
-          <p:cNvPr id="0" name="St-A1"/>
-          <p:cNvCxnSpPr/>
-          <p:nvPr/>
-        </p:nvCxnSpPr>
-        <p:spPr>
-          <a:xfrm>
-            <a:off x="2331720" y="1325880"/>
-            <a:ext cx="960120" cy="0"/>
-          </a:xfrm>
-          <a:prstGeom prst="straightConnector1">
-            <a:avLst/>
-          </a:prstGeom>
-          <a:ln w="19050">
-            <a:solidFill>
-              <a:srgbClr val="8E6F3E"/>
-            </a:solidFill>
-            <a:tailEnd type="triangle"/>
-          </a:ln>
-        </p:spPr>
-      </p:cxnSp>
-      <p:cxnSp>
-        <p:nvCxnSpPr>
-          <p:cNvPr id="0" name="St-A2"/>
-          <p:cNvCxnSpPr/>
-          <p:nvPr/>
-        </p:nvCxnSpPr>
-        <p:spPr>
-          <a:xfrm>
-            <a:off x="5852160" y="1325880"/>
-            <a:ext cx="960120" cy="0"/>
-          </a:xfrm>
-          <a:prstGeom prst="straightConnector1">
-            <a:avLst/>
-          </a:prstGeom>
-          <a:ln w="19050">
-            <a:solidFill>
-              <a:srgbClr val="8E6F3E"/>
-            </a:solidFill>
-            <a:tailEnd type="triangle"/>
-          </a:ln>
-        </p:spPr>
-      </p:cxnSp>
-      <p:sp>
-        <p:nvSpPr>
-          <p:cNvPr id="0" name="St-Questions"/>
+              <a:t>SENSOR</a:t>
+            </a:r>
+          </a:p>
+        </p:txBody>
+      </p:sp>
+      <p:sp>
+        <p:nvSpPr>
+          <p:cNvPr id="0" name="Dy-TRACE"/>
           <p:cNvSpPr/>
           <p:nvPr/>
         </p:nvSpPr>
         <p:spPr>
           <a:xfrm>
-            <a:off x="502920" y="2103120"/>
-            <a:ext cx="8138160" cy="3291840"/>
+            <a:off x="685800" y="2935224"/>
+            <a:ext cx="1500000" cy="640080"/>
           </a:xfrm>
           <a:prstGeom prst="rect">
             <a:avLst/>
@@ -17612,10 +17006,10 @@
           <a:effectLst/>
         </p:spPr>
         <p:txBody>
-          <a:bodyPr rtlCol="0" anchor="t" wrap="square" lIns="27432" rIns="27432" tIns="22860" bIns="22860"/>
-          <a:lstStyle/>
-          <a:p>
-            <a:pPr algn="l">
+          <a:bodyPr rtlCol="0" anchor="ctr" wrap="square" lIns="27432" rIns="27432" tIns="22860" bIns="22860"/>
+          <a:lstStyle/>
+          <a:p>
+            <a:pPr algn="ctr">
               <a:buNone/>
             </a:pPr>
             <a:r>
@@ -17624,69 +17018,21 @@
                   <a:srgbClr val="5C4826"/>
                 </a:solidFill>
               </a:rPr>
-              <a:t>Questions the lab model can already decide:</a:t>
-            </a:r>
-          </a:p>
-          <a:p>
-            <a:pPr algn="l">
-              <a:spcBef>
-                <a:spcPts val="900"/>
-              </a:spcBef>
-              <a:buNone/>
-            </a:pPr>
-            <a:r>
-              <a:rPr lang="en-US" sz="2000" b="0" i="0" dirty="0">
-                <a:solidFill>
-                  <a:srgbClr val="5C4826"/>
-                </a:solidFill>
-              </a:rPr>
-              <a:t>Can admitted threads exceed the memory ceiling?</a:t>
-            </a:r>
-          </a:p>
-          <a:p>
-            <a:pPr algn="l">
-              <a:spcBef>
-                <a:spcPts val="900"/>
-              </a:spcBef>
-              <a:buNone/>
-            </a:pPr>
-            <a:r>
-              <a:rPr lang="en-US" sz="2000" b="0" i="0" dirty="0">
-                <a:solidFill>
-                  <a:srgbClr val="5C4826"/>
-                </a:solidFill>
-              </a:rPr>
-              <a:t>Can three threads be Awake simultaneously?</a:t>
-            </a:r>
-          </a:p>
-          <a:p>
-            <a:pPr algn="l">
-              <a:spcBef>
-                <a:spcPts val="900"/>
-              </a:spcBef>
-              <a:buNone/>
-            </a:pPr>
-            <a:r>
-              <a:rPr lang="en-US" sz="2000" b="0" i="0" dirty="0">
-                <a:solidFill>
-                  <a:srgbClr val="5C4826"/>
-                </a:solidFill>
-              </a:rPr>
-              <a:t>Is an illegal lifecycle transition reachable?</a:t>
-            </a:r>
-          </a:p>
-        </p:txBody>
-      </p:sp>
-      <p:sp>
-        <p:nvSpPr>
-          <p:cNvPr id="0" name="FooterBand"/>
+              <a:t>TRACE</a:t>
+            </a:r>
+          </a:p>
+        </p:txBody>
+      </p:sp>
+      <p:sp>
+        <p:nvSpPr>
+          <p:cNvPr id="0" name="Dy-VALIDATOR"/>
           <p:cNvSpPr/>
           <p:nvPr/>
         </p:nvSpPr>
         <p:spPr>
           <a:xfrm>
-            <a:off x="274320" y="5760720"/>
-            <a:ext cx="8595360" cy="777240"/>
+            <a:off x="685800" y="3877056"/>
+            <a:ext cx="1500000" cy="640080"/>
           </a:xfrm>
           <a:prstGeom prst="rect">
             <a:avLst/>
@@ -17712,7 +17058,261 @@
                   <a:srgbClr val="FFFFFF"/>
                 </a:solidFill>
               </a:rPr>
-              <a:t>Explicit structure can turn repeated reconstruction into a decidable query.</a:t>
+              <a:t>VALIDATOR</a:t>
+            </a:r>
+          </a:p>
+        </p:txBody>
+      </p:sp>
+      <p:sp>
+        <p:nvSpPr>
+          <p:cNvPr id="0" name="Dy-VERDICT"/>
+          <p:cNvSpPr/>
+          <p:nvPr/>
+        </p:nvSpPr>
+        <p:spPr>
+          <a:xfrm>
+            <a:off x="685800" y="4818888"/>
+            <a:ext cx="1500000" cy="640080"/>
+          </a:xfrm>
+          <a:prstGeom prst="rect">
+            <a:avLst/>
+          </a:prstGeom>
+          <a:solidFill>
+            <a:srgbClr val="F5F1E8"/>
+          </a:solidFill>
+          <a:ln w="12700">
+            <a:solidFill>
+              <a:srgbClr val="C9B991"/>
+            </a:solidFill>
+          </a:ln>
+          <a:effectLst/>
+        </p:spPr>
+        <p:txBody>
+          <a:bodyPr rtlCol="0" anchor="ctr" wrap="square" lIns="27432" rIns="27432" tIns="22860" bIns="22860"/>
+          <a:lstStyle/>
+          <a:p>
+            <a:pPr algn="ctr">
+              <a:buNone/>
+            </a:pPr>
+            <a:r>
+              <a:rPr lang="en-US" sz="2000" b="1" i="0" dirty="0">
+                <a:solidFill>
+                  <a:srgbClr val="5C4826"/>
+                </a:solidFill>
+              </a:rPr>
+              <a:t>VERDICT</a:t>
+            </a:r>
+          </a:p>
+        </p:txBody>
+      </p:sp>
+      <p:cxnSp>
+        <p:nvCxnSpPr>
+          <p:cNvPr id="0" name="Dy-A0"/>
+          <p:cNvCxnSpPr/>
+          <p:nvPr/>
+        </p:nvCxnSpPr>
+        <p:spPr>
+          <a:xfrm>
+            <a:off x="1435608" y="1691639"/>
+            <a:ext cx="0" cy="301752"/>
+          </a:xfrm>
+          <a:prstGeom prst="straightConnector1">
+            <a:avLst/>
+          </a:prstGeom>
+          <a:ln w="19050">
+            <a:solidFill>
+              <a:srgbClr val="8E6F3E"/>
+            </a:solidFill>
+            <a:tailEnd type="triangle"/>
+          </a:ln>
+        </p:spPr>
+      </p:cxnSp>
+      <p:cxnSp>
+        <p:nvCxnSpPr>
+          <p:cNvPr id="0" name="Dy-A1"/>
+          <p:cNvCxnSpPr/>
+          <p:nvPr/>
+        </p:nvCxnSpPr>
+        <p:spPr>
+          <a:xfrm>
+            <a:off x="1435608" y="2633472"/>
+            <a:ext cx="0" cy="301752"/>
+          </a:xfrm>
+          <a:prstGeom prst="straightConnector1">
+            <a:avLst/>
+          </a:prstGeom>
+          <a:ln w="19050">
+            <a:solidFill>
+              <a:srgbClr val="8E6F3E"/>
+            </a:solidFill>
+            <a:tailEnd type="triangle"/>
+          </a:ln>
+        </p:spPr>
+      </p:cxnSp>
+      <p:cxnSp>
+        <p:nvCxnSpPr>
+          <p:cNvPr id="0" name="Dy-A2"/>
+          <p:cNvCxnSpPr/>
+          <p:nvPr/>
+        </p:nvCxnSpPr>
+        <p:spPr>
+          <a:xfrm>
+            <a:off x="1435608" y="3575304"/>
+            <a:ext cx="0" cy="301752"/>
+          </a:xfrm>
+          <a:prstGeom prst="straightConnector1">
+            <a:avLst/>
+          </a:prstGeom>
+          <a:ln w="19050">
+            <a:solidFill>
+              <a:srgbClr val="8E6F3E"/>
+            </a:solidFill>
+            <a:tailEnd type="triangle"/>
+          </a:ln>
+        </p:spPr>
+      </p:cxnSp>
+      <p:cxnSp>
+        <p:nvCxnSpPr>
+          <p:cNvPr id="0" name="Dy-A3"/>
+          <p:cNvCxnSpPr/>
+          <p:nvPr/>
+        </p:nvCxnSpPr>
+        <p:spPr>
+          <a:xfrm>
+            <a:off x="1435608" y="4517136"/>
+            <a:ext cx="0" cy="301752"/>
+          </a:xfrm>
+          <a:prstGeom prst="straightConnector1">
+            <a:avLst/>
+          </a:prstGeom>
+          <a:ln w="19050">
+            <a:solidFill>
+              <a:srgbClr val="8E6F3E"/>
+            </a:solidFill>
+            <a:tailEnd type="triangle"/>
+          </a:ln>
+        </p:spPr>
+      </p:cxnSp>
+      <p:sp>
+        <p:nvSpPr>
+          <p:cNvPr id="101" name="Cmp-static"/>
+          <p:cNvSpPr/>
+          <p:nvPr/>
+        </p:nvSpPr>
+        <p:spPr>
+          <a:xfrm>
+            <a:off x="5120640" y="1965960"/>
+            <a:ext cx="3657600" cy="2560320"/>
+          </a:xfrm>
+          <a:prstGeom prst="rect">
+            <a:avLst/>
+          </a:prstGeom>
+          <a:solidFill>
+            <a:srgbClr val="F5F1E8"/>
+          </a:solidFill>
+          <a:ln w="12700">
+            <a:solidFill>
+              <a:srgbClr val="C9B991"/>
+            </a:solidFill>
+          </a:ln>
+          <a:effectLst/>
+        </p:spPr>
+        <p:txBody>
+          <a:bodyPr rtlCol="0" anchor="t" wrap="square" lIns="27432" rIns="27432" tIns="22860" bIns="22860"/>
+          <a:lstStyle/>
+          <a:p>
+            <a:pPr algn="ctr"/>
+            <a:r>
+              <a:rPr sz="2000" b="1">
+                <a:solidFill>
+                  <a:srgbClr val="5C4826"/>
+                </a:solidFill>
+              </a:rPr>
+              <a:t>STATIC</a:t>
+            </a:r>
+          </a:p>
+          <a:p>
+            <a:pPr algn="ctr"/>
+            <a:r>
+              <a:rPr sz="2000" b="0">
+                <a:solidFill>
+                  <a:srgbClr val="5C4826"/>
+                </a:solidFill>
+              </a:rPr>
+              <a:t>verdict over the modeled space</a:t>
+            </a:r>
+          </a:p>
+          <a:p>
+            <a:pPr algn="ctr"/>
+            <a:r>
+              <a:rPr sz="2000" b="0">
+                <a:solidFill>
+                  <a:srgbClr val="5C4826"/>
+                </a:solidFill>
+              </a:rPr>
+              <a:t/>
+            </a:r>
+          </a:p>
+          <a:p>
+            <a:pPr algn="ctr"/>
+            <a:r>
+              <a:rPr sz="2000" b="1">
+                <a:solidFill>
+                  <a:srgbClr val="5C4826"/>
+                </a:solidFill>
+              </a:rPr>
+              <a:t>DYNAMIC</a:t>
+            </a:r>
+          </a:p>
+          <a:p>
+            <a:pPr algn="ctr"/>
+            <a:r>
+              <a:rPr sz="2000" b="0">
+                <a:solidFill>
+                  <a:srgbClr val="5C4826"/>
+                </a:solidFill>
+              </a:rPr>
+              <a:t>verdict over observed execution</a:t>
+            </a:r>
+          </a:p>
+        </p:txBody>
+      </p:sp>
+      <p:sp>
+        <p:nvSpPr>
+          <p:cNvPr id="102" name="FooterBand"/>
+          <p:cNvSpPr/>
+          <p:nvPr/>
+        </p:nvSpPr>
+        <p:spPr>
+          <a:xfrm>
+            <a:off x="274320" y="5760720"/>
+            <a:ext cx="8595360" cy="777240"/>
+          </a:xfrm>
+          <a:prstGeom prst="rect">
+            <a:avLst/>
+          </a:prstGeom>
+          <a:solidFill>
+            <a:srgbClr val="8E6F3E"/>
+          </a:solidFill>
+          <a:ln>
+            <a:noFill/>
+          </a:ln>
+          <a:effectLst/>
+        </p:spPr>
+        <p:txBody>
+          <a:bodyPr rtlCol="0" anchor="ctr" wrap="square" lIns="27432" rIns="27432" tIns="22860" bIns="22860"/>
+          <a:lstStyle/>
+          <a:p>
+            <a:pPr algn="ctr">
+              <a:buNone/>
+            </a:pPr>
+            <a:r>
+              <a:rPr lang="en-US" sz="2000" b="1" i="0" dirty="0">
+                <a:solidFill>
+                  <a:srgbClr val="FFFFFF"/>
+                </a:solidFill>
+              </a:rPr>
+              <a:t>Where should each verdict acquire authority?</a:t>
             </a:r>
           </a:p>
         </p:txBody>
@@ -17988,553 +17588,6 @@
                   <a:srgbClr val="000000"/>
                 </a:solidFill>
               </a:rPr>
-              <a:t>Models support dynamic validation</a:t>
-            </a:r>
-          </a:p>
-        </p:txBody>
-      </p:sp>
-      <p:sp>
-        <p:nvSpPr>
-          <p:cNvPr id="4" name="Slide Number Placeholder 5"/>
-          <p:cNvSpPr>
-            <a:spLocks noGrp="1"/>
-          </p:cNvSpPr>
-          <p:nvPr>
-            <p:ph type="sldNum" sz="quarter" idx="4"/>
-          </p:nvPr>
-        </p:nvSpPr>
-        <p:spPr/>
-        <p:txBody>
-          <a:bodyPr/>
-          <a:lstStyle/>
-          <a:p>
-            <a:fld id="{B7EB45DA-9A0D-DC49-8E02-F30A5DDC21C3}" type="slidenum">
-              <a:rPr lang="en-US" smtClean="0"/>
-              <a:t>30</a:t>
-            </a:fld>
-            <a:endParaRPr lang="en-US"/>
-          </a:p>
-        </p:txBody>
-      </p:sp>
-      <p:sp>
-        <p:nvSpPr>
-          <p:cNvPr id="0" name="Dy-MODEL"/>
-          <p:cNvSpPr/>
-          <p:nvPr/>
-        </p:nvSpPr>
-        <p:spPr>
-          <a:xfrm>
-            <a:off x="2697480" y="3831336"/>
-            <a:ext cx="2203704" cy="731520"/>
-          </a:xfrm>
-          <a:prstGeom prst="rect">
-            <a:avLst/>
-          </a:prstGeom>
-          <a:solidFill>
-            <a:srgbClr val="8E6F3E"/>
-          </a:solidFill>
-          <a:ln>
-            <a:noFill/>
-          </a:ln>
-          <a:effectLst/>
-        </p:spPr>
-        <p:txBody>
-          <a:bodyPr rtlCol="0" anchor="ctr" wrap="square" lIns="27432" rIns="27432" tIns="22860" bIns="22860"/>
-          <a:lstStyle/>
-          <a:p>
-            <a:pPr algn="ctr">
-              <a:buNone/>
-            </a:pPr>
-            <a:r>
-              <a:rPr lang="en-US" sz="2000" b="1" i="0" dirty="0">
-                <a:solidFill>
-                  <a:srgbClr val="FFFFFF"/>
-                </a:solidFill>
-              </a:rPr>
-              <a:t>MODEL — expected behavior</a:t>
-            </a:r>
-          </a:p>
-        </p:txBody>
-      </p:sp>
-      <p:cxnSp>
-        <p:nvCxnSpPr>
-          <p:cNvPr id="0" name="Dy-AM"/>
-          <p:cNvCxnSpPr/>
-          <p:nvPr/>
-        </p:nvCxnSpPr>
-        <p:spPr>
-          <a:xfrm flipH="1">
-            <a:off x="2240280" y="4197096"/>
-            <a:ext cx="402336" cy="0"/>
-          </a:xfrm>
-          <a:prstGeom prst="straightConnector1">
-            <a:avLst/>
-          </a:prstGeom>
-          <a:ln w="19050">
-            <a:solidFill>
-              <a:srgbClr val="8E6F3E"/>
-            </a:solidFill>
-            <a:tailEnd type="triangle"/>
-          </a:ln>
-        </p:spPr>
-      </p:cxnSp>
-      <p:sp>
-        <p:nvSpPr>
-          <p:cNvPr id="0" name="Dy-EXECUTION"/>
-          <p:cNvSpPr/>
-          <p:nvPr/>
-        </p:nvSpPr>
-        <p:spPr>
-          <a:xfrm>
-            <a:off x="685800" y="1051560"/>
-            <a:ext cx="1500000" cy="640080"/>
-          </a:xfrm>
-          <a:prstGeom prst="rect">
-            <a:avLst/>
-          </a:prstGeom>
-          <a:solidFill>
-            <a:srgbClr val="F5F1E8"/>
-          </a:solidFill>
-          <a:ln w="12700">
-            <a:solidFill>
-              <a:srgbClr val="C9B991"/>
-            </a:solidFill>
-          </a:ln>
-          <a:effectLst/>
-        </p:spPr>
-        <p:txBody>
-          <a:bodyPr rtlCol="0" anchor="ctr" wrap="square" lIns="27432" rIns="27432" tIns="22860" bIns="22860"/>
-          <a:lstStyle/>
-          <a:p>
-            <a:pPr algn="ctr">
-              <a:buNone/>
-            </a:pPr>
-            <a:r>
-              <a:rPr lang="en-US" sz="2000" b="1" i="0" dirty="0">
-                <a:solidFill>
-                  <a:srgbClr val="5C4826"/>
-                </a:solidFill>
-              </a:rPr>
-              <a:t>EXECUTION</a:t>
-            </a:r>
-          </a:p>
-        </p:txBody>
-      </p:sp>
-      <p:sp>
-        <p:nvSpPr>
-          <p:cNvPr id="0" name="Dy-SENSOR"/>
-          <p:cNvSpPr/>
-          <p:nvPr/>
-        </p:nvSpPr>
-        <p:spPr>
-          <a:xfrm>
-            <a:off x="685800" y="1993392"/>
-            <a:ext cx="1500000" cy="640080"/>
-          </a:xfrm>
-          <a:prstGeom prst="rect">
-            <a:avLst/>
-          </a:prstGeom>
-          <a:solidFill>
-            <a:srgbClr val="8E6F3E"/>
-          </a:solidFill>
-          <a:ln>
-            <a:noFill/>
-          </a:ln>
-          <a:effectLst/>
-        </p:spPr>
-        <p:txBody>
-          <a:bodyPr rtlCol="0" anchor="ctr" wrap="square" lIns="27432" rIns="27432" tIns="22860" bIns="22860"/>
-          <a:lstStyle/>
-          <a:p>
-            <a:pPr algn="ctr">
-              <a:buNone/>
-            </a:pPr>
-            <a:r>
-              <a:rPr lang="en-US" sz="2000" b="1" i="0" dirty="0">
-                <a:solidFill>
-                  <a:srgbClr val="FFFFFF"/>
-                </a:solidFill>
-              </a:rPr>
-              <a:t>SENSOR</a:t>
-            </a:r>
-          </a:p>
-        </p:txBody>
-      </p:sp>
-      <p:sp>
-        <p:nvSpPr>
-          <p:cNvPr id="0" name="Dy-TRACE"/>
-          <p:cNvSpPr/>
-          <p:nvPr/>
-        </p:nvSpPr>
-        <p:spPr>
-          <a:xfrm>
-            <a:off x="685800" y="2935224"/>
-            <a:ext cx="1500000" cy="640080"/>
-          </a:xfrm>
-          <a:prstGeom prst="rect">
-            <a:avLst/>
-          </a:prstGeom>
-          <a:solidFill>
-            <a:srgbClr val="F5F1E8"/>
-          </a:solidFill>
-          <a:ln w="12700">
-            <a:solidFill>
-              <a:srgbClr val="C9B991"/>
-            </a:solidFill>
-          </a:ln>
-          <a:effectLst/>
-        </p:spPr>
-        <p:txBody>
-          <a:bodyPr rtlCol="0" anchor="ctr" wrap="square" lIns="27432" rIns="27432" tIns="22860" bIns="22860"/>
-          <a:lstStyle/>
-          <a:p>
-            <a:pPr algn="ctr">
-              <a:buNone/>
-            </a:pPr>
-            <a:r>
-              <a:rPr lang="en-US" sz="2000" b="1" i="0" dirty="0">
-                <a:solidFill>
-                  <a:srgbClr val="5C4826"/>
-                </a:solidFill>
-              </a:rPr>
-              <a:t>TRACE</a:t>
-            </a:r>
-          </a:p>
-        </p:txBody>
-      </p:sp>
-      <p:sp>
-        <p:nvSpPr>
-          <p:cNvPr id="0" name="Dy-VALIDATOR"/>
-          <p:cNvSpPr/>
-          <p:nvPr/>
-        </p:nvSpPr>
-        <p:spPr>
-          <a:xfrm>
-            <a:off x="685800" y="3877056"/>
-            <a:ext cx="1500000" cy="640080"/>
-          </a:xfrm>
-          <a:prstGeom prst="rect">
-            <a:avLst/>
-          </a:prstGeom>
-          <a:solidFill>
-            <a:srgbClr val="8E6F3E"/>
-          </a:solidFill>
-          <a:ln>
-            <a:noFill/>
-          </a:ln>
-          <a:effectLst/>
-        </p:spPr>
-        <p:txBody>
-          <a:bodyPr rtlCol="0" anchor="ctr" wrap="square" lIns="27432" rIns="27432" tIns="22860" bIns="22860"/>
-          <a:lstStyle/>
-          <a:p>
-            <a:pPr algn="ctr">
-              <a:buNone/>
-            </a:pPr>
-            <a:r>
-              <a:rPr lang="en-US" sz="2000" b="1" i="0" dirty="0">
-                <a:solidFill>
-                  <a:srgbClr val="FFFFFF"/>
-                </a:solidFill>
-              </a:rPr>
-              <a:t>VALIDATOR</a:t>
-            </a:r>
-          </a:p>
-        </p:txBody>
-      </p:sp>
-      <p:sp>
-        <p:nvSpPr>
-          <p:cNvPr id="0" name="Dy-VERDICT"/>
-          <p:cNvSpPr/>
-          <p:nvPr/>
-        </p:nvSpPr>
-        <p:spPr>
-          <a:xfrm>
-            <a:off x="685800" y="4818888"/>
-            <a:ext cx="1500000" cy="640080"/>
-          </a:xfrm>
-          <a:prstGeom prst="rect">
-            <a:avLst/>
-          </a:prstGeom>
-          <a:solidFill>
-            <a:srgbClr val="F5F1E8"/>
-          </a:solidFill>
-          <a:ln w="12700">
-            <a:solidFill>
-              <a:srgbClr val="C9B991"/>
-            </a:solidFill>
-          </a:ln>
-          <a:effectLst/>
-        </p:spPr>
-        <p:txBody>
-          <a:bodyPr rtlCol="0" anchor="ctr" wrap="square" lIns="27432" rIns="27432" tIns="22860" bIns="22860"/>
-          <a:lstStyle/>
-          <a:p>
-            <a:pPr algn="ctr">
-              <a:buNone/>
-            </a:pPr>
-            <a:r>
-              <a:rPr lang="en-US" sz="2000" b="1" i="0" dirty="0">
-                <a:solidFill>
-                  <a:srgbClr val="5C4826"/>
-                </a:solidFill>
-              </a:rPr>
-              <a:t>VERDICT</a:t>
-            </a:r>
-          </a:p>
-        </p:txBody>
-      </p:sp>
-      <p:cxnSp>
-        <p:nvCxnSpPr>
-          <p:cNvPr id="0" name="Dy-A0"/>
-          <p:cNvCxnSpPr/>
-          <p:nvPr/>
-        </p:nvCxnSpPr>
-        <p:spPr>
-          <a:xfrm>
-            <a:off x="1435608" y="1691639"/>
-            <a:ext cx="0" cy="301752"/>
-          </a:xfrm>
-          <a:prstGeom prst="straightConnector1">
-            <a:avLst/>
-          </a:prstGeom>
-          <a:ln w="19050">
-            <a:solidFill>
-              <a:srgbClr val="8E6F3E"/>
-            </a:solidFill>
-            <a:tailEnd type="triangle"/>
-          </a:ln>
-        </p:spPr>
-      </p:cxnSp>
-      <p:cxnSp>
-        <p:nvCxnSpPr>
-          <p:cNvPr id="0" name="Dy-A1"/>
-          <p:cNvCxnSpPr/>
-          <p:nvPr/>
-        </p:nvCxnSpPr>
-        <p:spPr>
-          <a:xfrm>
-            <a:off x="1435608" y="2633472"/>
-            <a:ext cx="0" cy="301752"/>
-          </a:xfrm>
-          <a:prstGeom prst="straightConnector1">
-            <a:avLst/>
-          </a:prstGeom>
-          <a:ln w="19050">
-            <a:solidFill>
-              <a:srgbClr val="8E6F3E"/>
-            </a:solidFill>
-            <a:tailEnd type="triangle"/>
-          </a:ln>
-        </p:spPr>
-      </p:cxnSp>
-      <p:cxnSp>
-        <p:nvCxnSpPr>
-          <p:cNvPr id="0" name="Dy-A2"/>
-          <p:cNvCxnSpPr/>
-          <p:nvPr/>
-        </p:nvCxnSpPr>
-        <p:spPr>
-          <a:xfrm>
-            <a:off x="1435608" y="3575304"/>
-            <a:ext cx="0" cy="301752"/>
-          </a:xfrm>
-          <a:prstGeom prst="straightConnector1">
-            <a:avLst/>
-          </a:prstGeom>
-          <a:ln w="19050">
-            <a:solidFill>
-              <a:srgbClr val="8E6F3E"/>
-            </a:solidFill>
-            <a:tailEnd type="triangle"/>
-          </a:ln>
-        </p:spPr>
-      </p:cxnSp>
-      <p:cxnSp>
-        <p:nvCxnSpPr>
-          <p:cNvPr id="0" name="Dy-A3"/>
-          <p:cNvCxnSpPr/>
-          <p:nvPr/>
-        </p:nvCxnSpPr>
-        <p:spPr>
-          <a:xfrm>
-            <a:off x="1435608" y="4517136"/>
-            <a:ext cx="0" cy="301752"/>
-          </a:xfrm>
-          <a:prstGeom prst="straightConnector1">
-            <a:avLst/>
-          </a:prstGeom>
-          <a:ln w="19050">
-            <a:solidFill>
-              <a:srgbClr val="8E6F3E"/>
-            </a:solidFill>
-            <a:tailEnd type="triangle"/>
-          </a:ln>
-        </p:spPr>
-      </p:cxnSp>
-      <p:sp>
-        <p:nvSpPr>
-          <p:cNvPr id="101" name="Cmp-static"/>
-          <p:cNvSpPr/>
-          <p:nvPr/>
-        </p:nvSpPr>
-        <p:spPr>
-          <a:xfrm>
-            <a:off x="5120640" y="1965960"/>
-            <a:ext cx="3657600" cy="2560320"/>
-          </a:xfrm>
-          <a:prstGeom prst="rect">
-            <a:avLst/>
-          </a:prstGeom>
-          <a:solidFill>
-            <a:srgbClr val="F5F1E8"/>
-          </a:solidFill>
-          <a:ln w="12700">
-            <a:solidFill>
-              <a:srgbClr val="C9B991"/>
-            </a:solidFill>
-          </a:ln>
-          <a:effectLst/>
-        </p:spPr>
-        <p:txBody>
-          <a:bodyPr rtlCol="0" anchor="t" wrap="square" lIns="27432" rIns="27432" tIns="22860" bIns="22860"/>
-          <a:lstStyle/>
-          <a:p>
-            <a:pPr algn="ctr"/>
-            <a:r>
-              <a:rPr sz="2000" b="1">
-                <a:solidFill>
-                  <a:srgbClr val="5C4826"/>
-                </a:solidFill>
-              </a:rPr>
-              <a:t>STATIC</a:t>
-            </a:r>
-          </a:p>
-          <a:p>
-            <a:pPr algn="ctr"/>
-            <a:r>
-              <a:rPr sz="2000" b="0">
-                <a:solidFill>
-                  <a:srgbClr val="5C4826"/>
-                </a:solidFill>
-              </a:rPr>
-              <a:t>verdict over the modeled space</a:t>
-            </a:r>
-          </a:p>
-          <a:p>
-            <a:pPr algn="ctr"/>
-            <a:r>
-              <a:rPr sz="2000" b="0">
-                <a:solidFill>
-                  <a:srgbClr val="5C4826"/>
-                </a:solidFill>
-              </a:rPr>
-              <a:t/>
-            </a:r>
-          </a:p>
-          <a:p>
-            <a:pPr algn="ctr"/>
-            <a:r>
-              <a:rPr sz="2000" b="1">
-                <a:solidFill>
-                  <a:srgbClr val="5C4826"/>
-                </a:solidFill>
-              </a:rPr>
-              <a:t>DYNAMIC</a:t>
-            </a:r>
-          </a:p>
-          <a:p>
-            <a:pPr algn="ctr"/>
-            <a:r>
-              <a:rPr sz="2000" b="0">
-                <a:solidFill>
-                  <a:srgbClr val="5C4826"/>
-                </a:solidFill>
-              </a:rPr>
-              <a:t>verdict over observed execution</a:t>
-            </a:r>
-          </a:p>
-        </p:txBody>
-      </p:sp>
-      <p:sp>
-        <p:nvSpPr>
-          <p:cNvPr id="102" name="FooterBand"/>
-          <p:cNvSpPr/>
-          <p:nvPr/>
-        </p:nvSpPr>
-        <p:spPr>
-          <a:xfrm>
-            <a:off x="274320" y="5760720"/>
-            <a:ext cx="8595360" cy="777240"/>
-          </a:xfrm>
-          <a:prstGeom prst="rect">
-            <a:avLst/>
-          </a:prstGeom>
-          <a:solidFill>
-            <a:srgbClr val="8E6F3E"/>
-          </a:solidFill>
-          <a:ln>
-            <a:noFill/>
-          </a:ln>
-          <a:effectLst/>
-        </p:spPr>
-        <p:txBody>
-          <a:bodyPr rtlCol="0" anchor="ctr" wrap="square" lIns="27432" rIns="27432" tIns="22860" bIns="22860"/>
-          <a:lstStyle/>
-          <a:p>
-            <a:pPr algn="ctr">
-              <a:buNone/>
-            </a:pPr>
-            <a:r>
-              <a:rPr lang="en-US" sz="2000" b="1" i="0" dirty="0">
-                <a:solidFill>
-                  <a:srgbClr val="FFFFFF"/>
-                </a:solidFill>
-              </a:rPr>
-              <a:t>Where should each verdict acquire authority?</a:t>
-            </a:r>
-          </a:p>
-        </p:txBody>
-      </p:sp>
-    </p:spTree>
-  </p:cSld>
-  <p:clrMapOvr>
-    <a:masterClrMapping/>
-  </p:clrMapOvr>
-</p:sld>
-</file>
-
-<file path=ppt/slides/slide33.xml><?xml version="1.0" encoding="utf-8"?>
-<p:sld xmlns:a="http://schemas.openxmlformats.org/drawingml/2006/main" xmlns:p="http://schemas.openxmlformats.org/presentationml/2006/main" xmlns:r="http://schemas.openxmlformats.org/officeDocument/2006/relationships">
-  <p:cSld>
-    <p:spTree>
-      <p:nvGrpSpPr>
-        <p:cNvPr id="1" name=""/>
-        <p:cNvGrpSpPr/>
-        <p:nvPr/>
-      </p:nvGrpSpPr>
-      <p:grpSpPr/>
-      <p:sp>
-        <p:nvSpPr>
-          <p:cNvPr id="3" name="Title 2"/>
-          <p:cNvSpPr>
-            <a:spLocks noGrp="1"/>
-          </p:cNvSpPr>
-          <p:nvPr>
-            <p:ph type="title"/>
-          </p:nvPr>
-        </p:nvSpPr>
-        <p:spPr/>
-        <p:txBody>
-          <a:bodyPr wrap="square"/>
-          <a:lstStyle/>
-          <a:p>
-            <a:r>
-              <a:rPr sz="2400" b="0">
-                <a:solidFill>
-                  <a:srgbClr val="000000"/>
-                </a:solidFill>
-              </a:rPr>
               <a:t>Agreement is not correctness</a:t>
             </a:r>
           </a:p>
@@ -19145,7 +18198,7 @@
 </p:sld>
 </file>
 
-<file path=ppt/slides/slide34.xml><?xml version="1.0" encoding="utf-8"?>
+<file path=ppt/slides/slide31.xml><?xml version="1.0" encoding="utf-8"?>
 <p:sld xmlns:a="http://schemas.openxmlformats.org/drawingml/2006/main" xmlns:p="http://schemas.openxmlformats.org/presentationml/2006/main" xmlns:r="http://schemas.openxmlformats.org/officeDocument/2006/relationships">
   <p:cSld>
     <p:spTree>
@@ -19603,7 +18656,7 @@
 </p:sld>
 </file>
 
-<file path=ppt/slides/slide35.xml><?xml version="1.0" encoding="utf-8"?>
+<file path=ppt/slides/slide32.xml><?xml version="1.0" encoding="utf-8"?>
 <p:sld xmlns:a="http://schemas.openxmlformats.org/drawingml/2006/main" xmlns:p="http://schemas.openxmlformats.org/presentationml/2006/main" xmlns:r="http://schemas.openxmlformats.org/officeDocument/2006/relationships">
   <p:cSld>
     <p:spTree>
@@ -19930,7 +18983,7 @@
 </p:sld>
 </file>
 
-<file path=ppt/slides/slide36.xml><?xml version="1.0" encoding="utf-8"?>
+<file path=ppt/slides/slide33.xml><?xml version="1.0" encoding="utf-8"?>
 <p:sld xmlns:a="http://schemas.openxmlformats.org/drawingml/2006/main" xmlns:p="http://schemas.openxmlformats.org/presentationml/2006/main" xmlns:r="http://schemas.openxmlformats.org/officeDocument/2006/relationships">
   <p:cSld>
     <p:spTree>

</xml_diff>

<commit_message>
deck 2-3: section 1 — work-environment recap deleted; DoF columns + process strip merge into Bound-consequential-degrees-of-freedom (31->29)
</commit_message>
<xml_diff>
--- a/course/lectures/act-2-delegation-and-control/03-alignment/2-3-Alignment.pptx
+++ b/course/lectures/act-2-delegation-and-control/03-alignment/2-3-Alignment.pptx
@@ -15,10 +15,8 @@
     <p:sldId id="258" r:id="rId9"/>
     <p:sldId id="284" r:id="rId49"/>
     <p:sldId id="291" r:id="rId35"/>
-    <p:sldId id="292" r:id="rId36"/>
     <p:sldId id="293" r:id="rId37"/>
     <p:sldId id="294" r:id="rId38"/>
-    <p:sldId id="295" r:id="rId39"/>
     <p:sldId id="285" r:id="rId50"/>
     <p:sldId id="304" r:id="rId40"/>
     <p:sldId id="297" r:id="rId41"/>
@@ -1430,37 +1428,47 @@
           <a:lstStyle/>
           <a:p>
             <a:r>
-              <a:t>TIMING: 2 minutes</a:t>
-            </a:r>
-          </a:p>
-          <a:p>
-            <a:r>
-              <a:t>- Recall degrees of freedom from Architecture and Design.</a:t>
-            </a:r>
-          </a:p>
-          <a:p>
-            <a:r>
-              <a:t>- Engineering is not about specifying everything.</a:t>
-            </a:r>
-          </a:p>
-          <a:p>
-            <a:r>
-              <a:t>- We bind choices whose consequences matter: worktree, scope, forbidden actions, evidence, delivery boundary.</a:t>
-            </a:r>
-          </a:p>
-          <a:p>
-            <a:r>
-              <a:t>- We deliberately leave other choices free: local decomposition, naming, implementation details, algorithms where no obligation constrains them.</a:t>
-            </a:r>
-          </a:p>
-          <a:p>
-            <a:r>
-              <a:t>- If we specify all of those too, we have defeated much of the purpose of delegation.</a:t>
-            </a:r>
-          </a:p>
-          <a:p>
-            <a:r>
-              <a:t>- Good delegation is therefore selective reduction of degrees of freedom.</a:t>
+              <a:t>TIMING: 3 minutes</a:t>
+            </a:r>
+          </a:p>
+          <a:p>
+            <a:r>
+              <a:t>- Recall degrees of freedom from Architecture and Design. Engineering is not about specifying everything.</a:t>
+            </a:r>
+          </a:p>
+          <a:p>
+            <a:r>
+              <a:t>- We bind choices whose consequences matter: worktree, scope, forbidden actions, required checks, delivery boundary.</a:t>
+            </a:r>
+          </a:p>
+          <a:p>
+            <a:r>
+              <a:t>- We deliberately leave other choices free: implementation, decomposition, naming, algorithms where no obligation constrains them, the order of intermediate edits.</a:t>
+            </a:r>
+          </a:p>
+          <a:p>
+            <a:r>
+              <a:t>- If we specify all of those too, we have defeated much of the purpose of delegation. Good delegation is therefore selective reduction of degrees of freedom — it constrains consequential choices without prescribing every move (that line was the slide footer; now spoken).</a:t>
+            </a:r>
+          </a:p>
+          <a:p>
+            <a:r>
+              <a:t>THE PROCESS STRIP (absorbed from the deleted "The process is a model" slide):</a:t>
+            </a:r>
+          </a:p>
+          <a:p>
+            <a:r>
+              <a:t>- We can recognize the same move we made in the Modeling lecture: the work order and environment define a model of the delegated process — permitted actions, transitions, stopping conditions, expected evidence.</a:t>
+            </a:r>
+          </a:p>
+          <a:p>
+            <a:r>
+              <a:t>- Importantly, this is not a model of the agent’s internal chain of thought. We do not need to prescribe how the agent reasons internally; we need enough external structure to reason about consequential behavior. That gives us something against which failure can be defined.</a:t>
+            </a:r>
+          </a:p>
+          <a:p>
+            <a:r>
+              <a:t>- This is the first Modeling callback of the lecture: the work order and environment DEFINE a model of the delegated process. We will lean on this in the models section.</a:t>
             </a:r>
           </a:p>
           <a:p>
@@ -1470,17 +1478,12 @@
           </a:p>
           <a:p>
             <a:r>
-              <a:t>- Reveal BOUND first.</a:t>
-            </a:r>
-          </a:p>
-          <a:p>
-            <a:r>
-              <a:t>- Reveal LEAVE FREE second.</a:t>
-            </a:r>
-          </a:p>
-          <a:p>
-            <a:r>
-              <a:t>- Reveal the concluding sentence last.</a:t>
+              <a:t>- Reveal BOUND first, LEAVE FREE second.</a:t>
+            </a:r>
+          </a:p>
+          <a:p>
+            <a:r>
+              <a:t>- Reveal the process strip, then the concluding sentence last.</a:t>
             </a:r>
           </a:p>
         </p:txBody>
@@ -2305,136 +2308,6 @@
 </p:notes>
 </file>
 
-<file path=ppt/notesSlides/notesSlide31.xml><?xml version="1.0" encoding="utf-8"?>
-<p:notes xmlns:a="http://schemas.openxmlformats.org/drawingml/2006/main" xmlns:p="http://schemas.openxmlformats.org/presentationml/2006/main" xmlns:r="http://schemas.openxmlformats.org/officeDocument/2006/relationships">
-  <p:cSld>
-    <p:spTree>
-      <p:nvGrpSpPr>
-        <p:cNvPr id="1" name=""/>
-        <p:cNvGrpSpPr/>
-        <p:nvPr/>
-      </p:nvGrpSpPr>
-      <p:grpSpPr>
-        <a:xfrm>
-          <a:off x="0" y="0"/>
-          <a:ext cx="0" cy="0"/>
-          <a:chOff x="0" y="0"/>
-          <a:chExt cx="0" cy="0"/>
-        </a:xfrm>
-      </p:grpSpPr>
-      <p:sp>
-        <p:nvSpPr>
-          <p:cNvPr id="2" name="Slide Image Placeholder 1"/>
-          <p:cNvSpPr>
-            <a:spLocks noGrp="1"/>
-          </p:cNvSpPr>
-          <p:nvPr>
-            <p:ph type="sldImg" idx="2"/>
-          </p:nvPr>
-        </p:nvSpPr>
-        <p:spPr/>
-      </p:sp>
-      <p:sp>
-        <p:nvSpPr>
-          <p:cNvPr id="3" name="Notes Placeholder 2"/>
-          <p:cNvSpPr>
-            <a:spLocks noGrp="1"/>
-          </p:cNvSpPr>
-          <p:nvPr>
-            <p:ph type="body" idx="3" sz="quarter"/>
-          </p:nvPr>
-        </p:nvSpPr>
-        <p:spPr/>
-        <p:txBody>
-          <a:bodyPr/>
-          <a:lstStyle/>
-          <a:p>
-            <a:r>
-              <a:t>TIMING: 2 minutes</a:t>
-            </a:r>
-          </a:p>
-          <a:p>
-            <a:r>
-              <a:t>- We can now recognize the same move we made in the Modeling lecture.</a:t>
-            </a:r>
-          </a:p>
-          <a:p>
-            <a:r>
-              <a:t>- The work order and environment define a model of the delegated process.</a:t>
-            </a:r>
-          </a:p>
-          <a:p>
-            <a:r>
-              <a:t>- It has permitted actions, transitions, stopping conditions, and expected evidence.</a:t>
-            </a:r>
-          </a:p>
-          <a:p>
-            <a:r>
-              <a:t>- Importantly, this is not a model of the agent's internal chain of thought.</a:t>
-            </a:r>
-          </a:p>
-          <a:p>
-            <a:r>
-              <a:t>- We generally do not need to prescribe how the agent reasons internally.</a:t>
-            </a:r>
-          </a:p>
-          <a:p>
-            <a:r>
-              <a:t>- We need enough external structure to reason about consequential behavior.</a:t>
-            </a:r>
-          </a:p>
-          <a:p>
-            <a:r>
-              <a:t>- That gives us something against which failure can be defined.</a:t>
-            </a:r>
-          </a:p>
-          <a:p>
-            <a:r>
-              <a:t>ANIMATION</a:t>
-            </a:r>
-          </a:p>
-          <a:p>
-            <a:r>
-              <a:t>- Reveal the process sequence.</a:t>
-            </a:r>
-          </a:p>
-          <a:p>
-            <a:r>
-              <a:t>- Reveal the four kinds of modeled information.</a:t>
-            </a:r>
-          </a:p>
-          <a:p>
-            <a:r>
-              <a:t>- Reveal the final sentence about internal reasoning last.</a:t>
-            </a:r>
-          </a:p>
-          <a:p>
-            <a:r>
-              <a:t>- This is the first Modeling callback of the lecture: the work order and environment DEFINE a model of the delegated process. We will lean on this in the models section.</a:t>
-            </a:r>
-          </a:p>
-        </p:txBody>
-      </p:sp>
-      <p:sp>
-        <p:nvSpPr>
-          <p:cNvPr id="4" name="Slide Number Placeholder 3"/>
-          <p:cNvSpPr>
-            <a:spLocks noGrp="1"/>
-          </p:cNvSpPr>
-          <p:nvPr>
-            <p:ph type="sldNum" idx="5" sz="quarter"/>
-          </p:nvPr>
-        </p:nvSpPr>
-        <p:spPr/>
-      </p:sp>
-    </p:spTree>
-  </p:cSld>
-  <p:clrMapOvr>
-    <a:masterClrMapping/>
-  </p:clrMapOvr>
-</p:notes>
-</file>
-
 <file path=ppt/notesSlides/notesSlide32.xml><?xml version="1.0" encoding="utf-8"?>
 <p:notes xmlns:a="http://schemas.openxmlformats.org/drawingml/2006/main" xmlns:p="http://schemas.openxmlformats.org/presentationml/2006/main" xmlns:r="http://schemas.openxmlformats.org/officeDocument/2006/relationships">
   <p:cSld>
@@ -3526,136 +3399,6 @@
           <a:p>
             <a:r>
               <a:t>- Close with the footer question — and notice it lands back in Alignment: a static verdict might gate merge; a runtime verdict might gate deployment or trigger rollback. Where a verdict acquires authority is an Alignment decision, not a modeling one.</a:t>
-            </a:r>
-          </a:p>
-        </p:txBody>
-      </p:sp>
-      <p:sp>
-        <p:nvSpPr>
-          <p:cNvPr id="4" name="Slide Number Placeholder 3"/>
-          <p:cNvSpPr>
-            <a:spLocks noGrp="1"/>
-          </p:cNvSpPr>
-          <p:nvPr>
-            <p:ph type="sldNum" idx="5" sz="quarter"/>
-          </p:nvPr>
-        </p:nvSpPr>
-        <p:spPr/>
-      </p:sp>
-    </p:spTree>
-  </p:cSld>
-  <p:clrMapOvr>
-    <a:masterClrMapping/>
-  </p:clrMapOvr>
-</p:notes>
-</file>
-
-<file path=ppt/notesSlides/notesSlide5.xml><?xml version="1.0" encoding="utf-8"?>
-<p:notes xmlns:a="http://schemas.openxmlformats.org/drawingml/2006/main" xmlns:p="http://schemas.openxmlformats.org/presentationml/2006/main" xmlns:r="http://schemas.openxmlformats.org/officeDocument/2006/relationships">
-  <p:cSld>
-    <p:spTree>
-      <p:nvGrpSpPr>
-        <p:cNvPr id="1" name=""/>
-        <p:cNvGrpSpPr/>
-        <p:nvPr/>
-      </p:nvGrpSpPr>
-      <p:grpSpPr>
-        <a:xfrm>
-          <a:off x="0" y="0"/>
-          <a:ext cx="0" cy="0"/>
-          <a:chOff x="0" y="0"/>
-          <a:chExt cx="0" cy="0"/>
-        </a:xfrm>
-      </p:grpSpPr>
-      <p:sp>
-        <p:nvSpPr>
-          <p:cNvPr id="2" name="Slide Image Placeholder 1"/>
-          <p:cNvSpPr>
-            <a:spLocks noGrp="1"/>
-          </p:cNvSpPr>
-          <p:nvPr>
-            <p:ph type="sldImg" idx="2"/>
-          </p:nvPr>
-        </p:nvSpPr>
-        <p:spPr/>
-      </p:sp>
-      <p:sp>
-        <p:nvSpPr>
-          <p:cNvPr id="3" name="Notes Placeholder 2"/>
-          <p:cNvSpPr>
-            <a:spLocks noGrp="1"/>
-          </p:cNvSpPr>
-          <p:nvPr>
-            <p:ph type="body" idx="3" sz="quarter"/>
-          </p:nvPr>
-        </p:nvSpPr>
-        <p:spPr/>
-        <p:txBody>
-          <a:bodyPr/>
-          <a:lstStyle/>
-          <a:p>
-            <a:r>
-              <a:t>TIMING: 2 minutes</a:t>
-            </a:r>
-          </a:p>
-          <a:p>
-            <a:r>
-              <a:t>- In practice, the agent does not receive only natural-language instructions.</a:t>
-            </a:r>
-          </a:p>
-          <a:p>
-            <a:r>
-              <a:t>- It receives a repository, worktree, branch, tools, tests, CI configuration, issue context, and repository instructions.</a:t>
-            </a:r>
-          </a:p>
-          <a:p>
-            <a:r>
-              <a:t>- Those things collectively define part of the delegated environment.</a:t>
-            </a:r>
-          </a:p>
-          <a:p>
-            <a:r>
-              <a:t>- Some are information. Some are capabilities. Some are constraints.</a:t>
-            </a:r>
-          </a:p>
-          <a:p>
-            <a:r>
-              <a:t>- The output is also structured: not "some code somewhere," but typically a proposed change, commit, or PR.</a:t>
-            </a:r>
-          </a:p>
-          <a:p>
-            <a:r>
-              <a:t>- This environment is already doing engineering work before we add any sophisticated agent-specific machinery.</a:t>
-            </a:r>
-          </a:p>
-          <a:p>
-            <a:r>
-              <a:t>ANIMATION</a:t>
-            </a:r>
-          </a:p>
-          <a:p>
-            <a:r>
-              <a:t>- Reveal WORK ORDER and WORKTREE.</a:t>
-            </a:r>
-          </a:p>
-          <a:p>
-            <a:r>
-              <a:t>- Reveal AGENT.</a:t>
-            </a:r>
-          </a:p>
-          <a:p>
-            <a:r>
-              <a:t>- Reveal proposed change / commit / PR.</a:t>
-            </a:r>
-          </a:p>
-          <a:p>
-            <a:r>
-              <a:t>- Reveal the concrete environment elements last.</a:t>
-            </a:r>
-          </a:p>
-          <a:p>
-            <a:r>
-              <a:t>- Frame this as an EXAMPLE of the taxonomy: the work environment is how we bound the process — where the agent may work, what it may touch, what tools it has.</a:t>
             </a:r>
           </a:p>
         </p:txBody>
@@ -7737,7 +7480,7 @@
           <a:p>
             <a:r>
               <a:rPr sz="2400"/>
-              <a:t>More instructions means fewer degrees of freedom</a:t>
+              <a:t>Bound consequential degrees of freedom</a:t>
             </a:r>
           </a:p>
         </p:txBody>
@@ -7751,7 +7494,7 @@
         <p:spPr>
           <a:xfrm>
             <a:off x="502920" y="1051560"/>
-            <a:ext cx="3977639" cy="3291840"/>
+            <a:ext cx="3977639" cy="3154680"/>
           </a:xfrm>
           <a:prstGeom prst="rect">
             <a:avLst/>
@@ -7824,7 +7567,7 @@
                   <a:srgbClr val="5C4826"/>
                 </a:solidFill>
               </a:rPr>
-              <a:t>files in scope</a:t>
+              <a:t>scope</a:t>
             </a:r>
           </a:p>
           <a:p>
@@ -7871,7 +7614,7 @@
         <p:spPr>
           <a:xfrm>
             <a:off x="4663440" y="1051560"/>
-            <a:ext cx="3977639" cy="3291840"/>
+            <a:ext cx="3977639" cy="3154680"/>
           </a:xfrm>
           <a:prstGeom prst="rect">
             <a:avLst/>
@@ -7933,7 +7676,7 @@
                   <a:srgbClr val="5C4826"/>
                 </a:solidFill>
               </a:rPr>
-              <a:t>local implementation</a:t>
+              <a:t>implementation</a:t>
             </a:r>
           </a:p>
           <a:p>
@@ -7955,7 +7698,7 @@
                   <a:srgbClr val="5C4826"/>
                 </a:solidFill>
               </a:rPr>
-              <a:t>naming choices</a:t>
+              <a:t>naming</a:t>
             </a:r>
           </a:p>
           <a:p>
@@ -7966,7 +7709,7 @@
                   <a:srgbClr val="5C4826"/>
                 </a:solidFill>
               </a:rPr>
-              <a:t>algorithm, where unconstrained</a:t>
+              <a:t>unconstrained algorithms</a:t>
             </a:r>
           </a:p>
           <a:p>
@@ -7977,229 +7720,20 @@
                   <a:srgbClr val="5C4826"/>
                 </a:solidFill>
               </a:rPr>
-              <a:t>order of intermediate edits</a:t>
-            </a:r>
-          </a:p>
-        </p:txBody>
-      </p:sp>
-      <p:sp>
-        <p:nvSpPr>
-          <p:cNvPr id="6" name="FooterBand"/>
+              <a:t>intermediate edits</a:t>
+            </a:r>
+          </a:p>
+        </p:txBody>
+      </p:sp>
+      <p:sp>
+        <p:nvSpPr>
+          <p:cNvPr id="101" name="PCINSPECT"/>
           <p:cNvSpPr/>
           <p:nvPr/>
         </p:nvSpPr>
         <p:spPr>
           <a:xfrm>
-            <a:off x="274320" y="5760720"/>
-            <a:ext cx="8595360" cy="777240"/>
-          </a:xfrm>
-          <a:prstGeom prst="rect">
-            <a:avLst/>
-          </a:prstGeom>
-          <a:solidFill>
-            <a:srgbClr val="8E6F3E"/>
-          </a:solidFill>
-          <a:ln>
-            <a:noFill/>
-          </a:ln>
-          <a:effectLst/>
-        </p:spPr>
-        <p:style>
-          <a:lnRef idx="1">
-            <a:schemeClr val="accent1"/>
-          </a:lnRef>
-          <a:fillRef idx="3">
-            <a:schemeClr val="accent1"/>
-          </a:fillRef>
-          <a:effectRef idx="2">
-            <a:schemeClr val="accent1"/>
-          </a:effectRef>
-          <a:fontRef idx="minor">
-            <a:schemeClr val="lt1"/>
-          </a:fontRef>
-        </p:style>
-        <p:txBody>
-          <a:bodyPr rtlCol="0" anchor="ctr" wrap="square" lIns="27432" rIns="27432" tIns="22860" bIns="22860"/>
-          <a:lstStyle/>
-          <a:p>
-            <a:pPr algn="ctr"/>
-            <a:r>
-              <a:rPr sz="2000" b="1" i="0">
-                <a:solidFill>
-                  <a:srgbClr val="FFFFFF"/>
-                </a:solidFill>
-              </a:rPr>
-              <a:t>Good delegation constrains consequential choices</a:t>
-            </a:r>
-          </a:p>
-          <a:p>
-            <a:pPr algn="ctr"/>
-            <a:r>
-              <a:rPr sz="2000" b="1" i="0">
-                <a:solidFill>
-                  <a:srgbClr val="FFFFFF"/>
-                </a:solidFill>
-              </a:rPr>
-              <a:t>without prescribing every move.</a:t>
-            </a:r>
-          </a:p>
-        </p:txBody>
-      </p:sp>
-    </p:spTree>
-  </p:cSld>
-  <p:clrMapOvr>
-    <a:masterClrMapping/>
-  </p:clrMapOvr>
-</p:sld>
-</file>
-
-<file path=ppt/slides/slide11.xml><?xml version="1.0" encoding="utf-8"?>
-<p:sld xmlns:a="http://schemas.openxmlformats.org/drawingml/2006/main" xmlns:p="http://schemas.openxmlformats.org/presentationml/2006/main" xmlns:r="http://schemas.openxmlformats.org/officeDocument/2006/relationships">
-  <p:cSld>
-    <p:spTree>
-      <p:nvGrpSpPr>
-        <p:cNvPr id="1" name=""/>
-        <p:cNvGrpSpPr/>
-        <p:nvPr/>
-      </p:nvGrpSpPr>
-      <p:grpSpPr/>
-      <p:sp>
-        <p:nvSpPr>
-          <p:cNvPr id="2" name="Content Placeholder 1"/>
-          <p:cNvSpPr>
-            <a:spLocks noGrp="1"/>
-          </p:cNvSpPr>
-          <p:nvPr>
-            <p:ph idx="1"/>
-          </p:nvPr>
-        </p:nvSpPr>
-        <p:spPr/>
-        <p:txBody>
-          <a:bodyPr/>
-          <a:lstStyle/>
-          <a:p/>
-        </p:txBody>
-      </p:sp>
-      <p:sp>
-        <p:nvSpPr>
-          <p:cNvPr id="3" name="Title 2"/>
-          <p:cNvSpPr>
-            <a:spLocks noGrp="1"/>
-          </p:cNvSpPr>
-          <p:nvPr>
-            <p:ph type="title"/>
-          </p:nvPr>
-        </p:nvSpPr>
-        <p:spPr/>
-        <p:txBody>
-          <a:bodyPr/>
-          <a:lstStyle/>
-          <a:p>
-            <a:r>
-              <a:rPr sz="2400"/>
-              <a:t>The process is a model</a:t>
-            </a:r>
-          </a:p>
-        </p:txBody>
-      </p:sp>
-      <p:sp>
-        <p:nvSpPr>
-          <p:cNvPr id="4" name="PCWorkOrder"/>
-          <p:cNvSpPr/>
-          <p:nvPr/>
-        </p:nvSpPr>
-        <p:spPr>
-          <a:xfrm>
-            <a:off x="502920" y="1005840"/>
-            <a:ext cx="1737360" cy="548640"/>
-          </a:xfrm>
-          <a:prstGeom prst="rect">
-            <a:avLst/>
-          </a:prstGeom>
-          <a:solidFill>
-            <a:srgbClr val="8E6F3E"/>
-          </a:solidFill>
-          <a:ln>
-            <a:noFill/>
-          </a:ln>
-          <a:effectLst/>
-        </p:spPr>
-        <p:style>
-          <a:lnRef idx="1">
-            <a:schemeClr val="accent1"/>
-          </a:lnRef>
-          <a:fillRef idx="3">
-            <a:schemeClr val="accent1"/>
-          </a:fillRef>
-          <a:effectRef idx="2">
-            <a:schemeClr val="accent1"/>
-          </a:effectRef>
-          <a:fontRef idx="minor">
-            <a:schemeClr val="lt1"/>
-          </a:fontRef>
-        </p:style>
-        <p:txBody>
-          <a:bodyPr rtlCol="0" anchor="ctr" wrap="square" lIns="27432" rIns="27432" tIns="22860" bIns="22860"/>
-          <a:lstStyle/>
-          <a:p>
-            <a:pPr algn="ctr"/>
-            <a:r>
-              <a:rPr sz="2000" b="1" i="0">
-                <a:solidFill>
-                  <a:srgbClr val="FFFFFF"/>
-                </a:solidFill>
-              </a:rPr>
-              <a:t>WORK ORDER</a:t>
-            </a:r>
-          </a:p>
-        </p:txBody>
-      </p:sp>
-      <p:cxnSp>
-        <p:nvCxnSpPr>
-          <p:cNvPr id="5" name="Connector 4"/>
-          <p:cNvCxnSpPr/>
-          <p:nvPr/>
-        </p:nvCxnSpPr>
-        <p:spPr>
-          <a:xfrm>
-            <a:off x="1371600" y="1554480"/>
-            <a:ext cx="0" cy="365760"/>
-          </a:xfrm>
-          <a:prstGeom prst="line">
-            <a:avLst/>
-          </a:prstGeom>
-          <a:ln w="28575">
-            <a:solidFill>
-              <a:srgbClr val="8E6F3E"/>
-            </a:solidFill>
-            <a:tailEnd type="triangle" w="med" len="med"/>
-          </a:ln>
-          <a:effectLst/>
-        </p:spPr>
-        <p:style>
-          <a:lnRef idx="2">
-            <a:schemeClr val="accent1"/>
-          </a:lnRef>
-          <a:fillRef idx="0">
-            <a:schemeClr val="accent1"/>
-          </a:fillRef>
-          <a:effectRef idx="1">
-            <a:schemeClr val="accent1"/>
-          </a:effectRef>
-          <a:fontRef idx="minor">
-            <a:schemeClr val="tx1"/>
-          </a:fontRef>
-        </p:style>
-      </p:cxnSp>
-      <p:sp>
-        <p:nvSpPr>
-          <p:cNvPr id="6" name="PCINSPECT"/>
-          <p:cNvSpPr/>
-          <p:nvPr/>
-        </p:nvSpPr>
-        <p:spPr>
-          <a:xfrm>
-            <a:off x="502920" y="1920240"/>
+            <a:off x="502920" y="4407408"/>
             <a:ext cx="1417320" cy="594360"/>
           </a:xfrm>
           <a:prstGeom prst="rect">
@@ -8247,13 +7781,13 @@
       </p:sp>
       <p:cxnSp>
         <p:nvCxnSpPr>
-          <p:cNvPr id="7" name="Connector 6"/>
+          <p:cNvPr id="102" name="Connector 6"/>
           <p:cNvCxnSpPr/>
           <p:nvPr/>
         </p:nvCxnSpPr>
         <p:spPr>
           <a:xfrm>
-            <a:off x="1920240" y="2217420"/>
+            <a:off x="1920240" y="4704588"/>
             <a:ext cx="182880" cy="0"/>
           </a:xfrm>
           <a:prstGeom prst="line">
@@ -8284,13 +7818,13 @@
       </p:cxnSp>
       <p:sp>
         <p:nvSpPr>
-          <p:cNvPr id="8" name="PCMODIFY"/>
+          <p:cNvPr id="103" name="PCMODIFY"/>
           <p:cNvSpPr/>
           <p:nvPr/>
         </p:nvSpPr>
         <p:spPr>
           <a:xfrm>
-            <a:off x="2103120" y="1920240"/>
+            <a:off x="2103120" y="4407408"/>
             <a:ext cx="1417320" cy="594360"/>
           </a:xfrm>
           <a:prstGeom prst="rect">
@@ -8338,13 +7872,13 @@
       </p:sp>
       <p:cxnSp>
         <p:nvCxnSpPr>
-          <p:cNvPr id="9" name="Connector 8"/>
+          <p:cNvPr id="104" name="Connector 8"/>
           <p:cNvCxnSpPr/>
           <p:nvPr/>
         </p:nvCxnSpPr>
         <p:spPr>
           <a:xfrm>
-            <a:off x="3520439" y="2217420"/>
+            <a:off x="3520439" y="4704588"/>
             <a:ext cx="182881" cy="0"/>
           </a:xfrm>
           <a:prstGeom prst="line">
@@ -8375,13 +7909,13 @@
       </p:cxnSp>
       <p:sp>
         <p:nvSpPr>
-          <p:cNvPr id="10" name="PCCHECK"/>
+          <p:cNvPr id="105" name="PCCHECK"/>
           <p:cNvSpPr/>
           <p:nvPr/>
         </p:nvSpPr>
         <p:spPr>
           <a:xfrm>
-            <a:off x="3703320" y="1920240"/>
+            <a:off x="3703320" y="4407408"/>
             <a:ext cx="1417320" cy="594360"/>
           </a:xfrm>
           <a:prstGeom prst="rect">
@@ -8429,13 +7963,13 @@
       </p:sp>
       <p:cxnSp>
         <p:nvCxnSpPr>
-          <p:cNvPr id="11" name="Connector 10"/>
+          <p:cNvPr id="106" name="Connector 10"/>
           <p:cNvCxnSpPr/>
           <p:nvPr/>
         </p:nvCxnSpPr>
         <p:spPr>
           <a:xfrm>
-            <a:off x="5120640" y="2217420"/>
+            <a:off x="5120640" y="4704588"/>
             <a:ext cx="182880" cy="0"/>
           </a:xfrm>
           <a:prstGeom prst="line">
@@ -8466,13 +8000,13 @@
       </p:cxnSp>
       <p:sp>
         <p:nvSpPr>
-          <p:cNvPr id="12" name="PCCOMMIT"/>
+          <p:cNvPr id="107" name="PCCOMMIT"/>
           <p:cNvSpPr/>
           <p:nvPr/>
         </p:nvSpPr>
         <p:spPr>
           <a:xfrm>
-            <a:off x="5303520" y="1920240"/>
+            <a:off x="5303520" y="4407408"/>
             <a:ext cx="1417320" cy="594360"/>
           </a:xfrm>
           <a:prstGeom prst="rect">
@@ -8520,13 +8054,13 @@
       </p:sp>
       <p:cxnSp>
         <p:nvCxnSpPr>
-          <p:cNvPr id="13" name="Connector 12"/>
+          <p:cNvPr id="108" name="Connector 12"/>
           <p:cNvCxnSpPr/>
           <p:nvPr/>
         </p:nvCxnSpPr>
         <p:spPr>
           <a:xfrm>
-            <a:off x="6720840" y="2217420"/>
+            <a:off x="6720840" y="4704588"/>
             <a:ext cx="182880" cy="0"/>
           </a:xfrm>
           <a:prstGeom prst="line">
@@ -8557,13 +8091,13 @@
       </p:cxnSp>
       <p:sp>
         <p:nvSpPr>
-          <p:cNvPr id="14" name="PCPROPOSE"/>
+          <p:cNvPr id="109" name="PCPROPOSE"/>
           <p:cNvSpPr/>
           <p:nvPr/>
         </p:nvSpPr>
         <p:spPr>
           <a:xfrm>
-            <a:off x="6903720" y="1920240"/>
+            <a:off x="6903720" y="4407408"/>
             <a:ext cx="1417320" cy="594360"/>
           </a:xfrm>
           <a:prstGeom prst="rect">
@@ -8609,125 +8143,16 @@
           </a:p>
         </p:txBody>
       </p:sp>
-      <p:cxnSp>
-        <p:nvCxnSpPr>
-          <p:cNvPr id="15" name="Connector 14"/>
-          <p:cNvCxnSpPr/>
-          <p:nvPr/>
-        </p:nvCxnSpPr>
-        <p:spPr>
-          <a:xfrm>
-            <a:off x="4411980" y="2514600"/>
-            <a:ext cx="0" cy="274320"/>
-          </a:xfrm>
-          <a:prstGeom prst="line">
-            <a:avLst/>
-          </a:prstGeom>
-          <a:ln w="19050">
-            <a:solidFill>
-              <a:srgbClr val="C9B991"/>
-            </a:solidFill>
-          </a:ln>
-          <a:effectLst/>
-        </p:spPr>
-        <p:style>
-          <a:lnRef idx="2">
-            <a:schemeClr val="accent1"/>
-          </a:lnRef>
-          <a:fillRef idx="0">
-            <a:schemeClr val="accent1"/>
-          </a:fillRef>
-          <a:effectRef idx="1">
-            <a:schemeClr val="accent1"/>
-          </a:effectRef>
-          <a:fontRef idx="minor">
-            <a:schemeClr val="tx1"/>
-          </a:fontRef>
-        </p:style>
-      </p:cxnSp>
-      <p:cxnSp>
-        <p:nvCxnSpPr>
-          <p:cNvPr id="16" name="Connector 15"/>
-          <p:cNvCxnSpPr/>
-          <p:nvPr/>
-        </p:nvCxnSpPr>
-        <p:spPr>
-          <a:xfrm flipH="1">
-            <a:off x="2811779" y="2788920"/>
-            <a:ext cx="1600201" cy="0"/>
-          </a:xfrm>
-          <a:prstGeom prst="line">
-            <a:avLst/>
-          </a:prstGeom>
-          <a:ln w="19050">
-            <a:solidFill>
-              <a:srgbClr val="C9B991"/>
-            </a:solidFill>
-          </a:ln>
-          <a:effectLst/>
-        </p:spPr>
-        <p:style>
-          <a:lnRef idx="2">
-            <a:schemeClr val="accent1"/>
-          </a:lnRef>
-          <a:fillRef idx="0">
-            <a:schemeClr val="accent1"/>
-          </a:fillRef>
-          <a:effectRef idx="1">
-            <a:schemeClr val="accent1"/>
-          </a:effectRef>
-          <a:fontRef idx="minor">
-            <a:schemeClr val="tx1"/>
-          </a:fontRef>
-        </p:style>
-      </p:cxnSp>
-      <p:cxnSp>
-        <p:nvCxnSpPr>
-          <p:cNvPr id="17" name="Connector 16"/>
-          <p:cNvCxnSpPr/>
-          <p:nvPr/>
-        </p:nvCxnSpPr>
-        <p:spPr>
-          <a:xfrm flipV="1">
-            <a:off x="2811779" y="2551176"/>
-            <a:ext cx="0" cy="237744"/>
-          </a:xfrm>
-          <a:prstGeom prst="line">
-            <a:avLst/>
-          </a:prstGeom>
-          <a:ln w="19050">
-            <a:solidFill>
-              <a:srgbClr val="C9B991"/>
-            </a:solidFill>
-            <a:tailEnd type="triangle" w="med" len="med"/>
-          </a:ln>
-          <a:effectLst/>
-        </p:spPr>
-        <p:style>
-          <a:lnRef idx="2">
-            <a:schemeClr val="accent1"/>
-          </a:lnRef>
-          <a:fillRef idx="0">
-            <a:schemeClr val="accent1"/>
-          </a:fillRef>
-          <a:effectRef idx="1">
-            <a:schemeClr val="accent1"/>
-          </a:effectRef>
-          <a:fontRef idx="minor">
-            <a:schemeClr val="tx1"/>
-          </a:fontRef>
-        </p:style>
-      </p:cxnSp>
-      <p:sp>
-        <p:nvSpPr>
-          <p:cNvPr id="18" name="PCAspects"/>
+      <p:sp>
+        <p:nvSpPr>
+          <p:cNvPr id="110" name="PCMain"/>
           <p:cNvSpPr txBox="1"/>
           <p:nvPr/>
         </p:nvSpPr>
         <p:spPr>
           <a:xfrm>
-            <a:off x="274320" y="3246120"/>
-            <a:ext cx="8595360" cy="700000"/>
+            <a:off x="274320" y="5212080"/>
+            <a:ext cx="8595360" cy="914400"/>
           </a:xfrm>
           <a:prstGeom prst="rect">
             <a:avLst/>
@@ -8742,79 +8167,12 @@
           <a:p>
             <a:pPr algn="ctr"/>
             <a:r>
-              <a:rPr sz="2000" b="0" i="1">
-                <a:solidFill>
-                  <a:srgbClr val="555960"/>
-                </a:solidFill>
-              </a:rPr>
-              <a:t>permitted actions · required transitions · stopping criteria · required evidence</a:t>
-            </a:r>
-          </a:p>
-        </p:txBody>
-      </p:sp>
-      <p:sp>
-        <p:nvSpPr>
-          <p:cNvPr id="19" name="PCMain"/>
-          <p:cNvSpPr txBox="1"/>
-          <p:nvPr/>
-        </p:nvSpPr>
-        <p:spPr>
-          <a:xfrm>
-            <a:off x="502920" y="3977639"/>
-            <a:ext cx="8138160" cy="868680"/>
-          </a:xfrm>
-          <a:prstGeom prst="rect">
-            <a:avLst/>
-          </a:prstGeom>
-          <a:noFill/>
-        </p:spPr>
-        <p:txBody>
-          <a:bodyPr wrap="square" anchor="t">
-            <a:spAutoFit/>
-          </a:bodyPr>
-          <a:lstStyle/>
-          <a:p>
-            <a:r>
-              <a:rPr sz="2000" b="0" i="0">
+              <a:rPr sz="2000" b="0">
                 <a:solidFill>
                   <a:srgbClr val="5C4826"/>
                 </a:solidFill>
               </a:rPr>
-              <a:t>A process model makes consequential actions, transitions, evidence, and stopping conditions explicit.</a:t>
-            </a:r>
-          </a:p>
-        </p:txBody>
-      </p:sp>
-      <p:sp>
-        <p:nvSpPr>
-          <p:cNvPr id="20" name="PCCaveat"/>
-          <p:cNvSpPr txBox="1"/>
-          <p:nvPr/>
-        </p:nvSpPr>
-        <p:spPr>
-          <a:xfrm>
-            <a:off x="502920" y="4983480"/>
-            <a:ext cx="8138160" cy="457200"/>
-          </a:xfrm>
-          <a:prstGeom prst="rect">
-            <a:avLst/>
-          </a:prstGeom>
-          <a:noFill/>
-        </p:spPr>
-        <p:txBody>
-          <a:bodyPr wrap="square" anchor="t">
-            <a:spAutoFit/>
-          </a:bodyPr>
-          <a:lstStyle/>
-          <a:p>
-            <a:pPr algn="ctr"/>
-            <a:r>
-              <a:rPr sz="2000" b="1" i="0">
-                <a:solidFill>
-                  <a:srgbClr val="8E6F3E"/>
-                </a:solidFill>
-              </a:rPr>
-              <a:t>It need not prescribe the agent’s internal reasoning.</a:t>
+              <a:t>A process model makes consequential actions, transitions, evidence, and stopping conditions explicit without prescribing internal reasoning.</a:t>
             </a:r>
           </a:p>
         </p:txBody>
@@ -20125,821 +19483,6 @@
                 </a:solidFill>
               </a:rPr>
               <a:t>What actions require separate authority?</a:t>
-            </a:r>
-          </a:p>
-        </p:txBody>
-      </p:sp>
-    </p:spTree>
-  </p:cSld>
-  <p:clrMapOvr>
-    <a:masterClrMapping/>
-  </p:clrMapOvr>
-</p:sld>
-</file>
-
-<file path=ppt/slides/slide8.xml><?xml version="1.0" encoding="utf-8"?>
-<p:sld xmlns:a="http://schemas.openxmlformats.org/drawingml/2006/main" xmlns:p="http://schemas.openxmlformats.org/presentationml/2006/main" xmlns:r="http://schemas.openxmlformats.org/officeDocument/2006/relationships">
-  <p:cSld>
-    <p:spTree>
-      <p:nvGrpSpPr>
-        <p:cNvPr id="1" name=""/>
-        <p:cNvGrpSpPr/>
-        <p:nvPr/>
-      </p:nvGrpSpPr>
-      <p:grpSpPr/>
-      <p:sp>
-        <p:nvSpPr>
-          <p:cNvPr id="2" name="Content Placeholder 1"/>
-          <p:cNvSpPr>
-            <a:spLocks noGrp="1"/>
-          </p:cNvSpPr>
-          <p:nvPr>
-            <p:ph idx="1"/>
-          </p:nvPr>
-        </p:nvSpPr>
-        <p:spPr/>
-        <p:txBody>
-          <a:bodyPr/>
-          <a:lstStyle/>
-          <a:p/>
-        </p:txBody>
-      </p:sp>
-      <p:sp>
-        <p:nvSpPr>
-          <p:cNvPr id="3" name="Title 2"/>
-          <p:cNvSpPr>
-            <a:spLocks noGrp="1"/>
-          </p:cNvSpPr>
-          <p:nvPr>
-            <p:ph type="title"/>
-          </p:nvPr>
-        </p:nvSpPr>
-        <p:spPr/>
-        <p:txBody>
-          <a:bodyPr/>
-          <a:lstStyle/>
-          <a:p>
-            <a:r>
-              <a:rPr sz="2400"/>
-              <a:t>A real agent gets a work environment</a:t>
-            </a:r>
-          </a:p>
-        </p:txBody>
-      </p:sp>
-      <p:sp>
-        <p:nvSpPr>
-          <p:cNvPr id="4" name="WorkOrder"/>
-          <p:cNvSpPr/>
-          <p:nvPr/>
-        </p:nvSpPr>
-        <p:spPr>
-          <a:xfrm>
-            <a:off x="3566160" y="914400"/>
-            <a:ext cx="2011680" cy="502920"/>
-          </a:xfrm>
-          <a:prstGeom prst="rect">
-            <a:avLst/>
-          </a:prstGeom>
-          <a:solidFill>
-            <a:srgbClr val="8E6F3E"/>
-          </a:solidFill>
-          <a:ln>
-            <a:noFill/>
-          </a:ln>
-          <a:effectLst/>
-        </p:spPr>
-        <p:style>
-          <a:lnRef idx="1">
-            <a:schemeClr val="accent1"/>
-          </a:lnRef>
-          <a:fillRef idx="3">
-            <a:schemeClr val="accent1"/>
-          </a:fillRef>
-          <a:effectRef idx="2">
-            <a:schemeClr val="accent1"/>
-          </a:effectRef>
-          <a:fontRef idx="minor">
-            <a:schemeClr val="lt1"/>
-          </a:fontRef>
-        </p:style>
-        <p:txBody>
-          <a:bodyPr rtlCol="0" anchor="ctr" wrap="square" lIns="27432" rIns="27432" tIns="22860" bIns="22860"/>
-          <a:lstStyle/>
-          <a:p>
-            <a:pPr algn="ctr"/>
-            <a:r>
-              <a:rPr sz="2000" b="1" i="0">
-                <a:solidFill>
-                  <a:srgbClr val="FFFFFF"/>
-                </a:solidFill>
-              </a:rPr>
-              <a:t>WORK ORDER</a:t>
-            </a:r>
-          </a:p>
-        </p:txBody>
-      </p:sp>
-      <p:cxnSp>
-        <p:nvCxnSpPr>
-          <p:cNvPr id="5" name="Connector 4"/>
-          <p:cNvCxnSpPr/>
-          <p:nvPr/>
-        </p:nvCxnSpPr>
-        <p:spPr>
-          <a:xfrm>
-            <a:off x="4572000" y="1417320"/>
-            <a:ext cx="0" cy="301752"/>
-          </a:xfrm>
-          <a:prstGeom prst="line">
-            <a:avLst/>
-          </a:prstGeom>
-          <a:ln w="28575">
-            <a:solidFill>
-              <a:srgbClr val="8E6F3E"/>
-            </a:solidFill>
-            <a:tailEnd type="triangle" w="med" len="med"/>
-          </a:ln>
-          <a:effectLst/>
-        </p:spPr>
-        <p:style>
-          <a:lnRef idx="2">
-            <a:schemeClr val="accent1"/>
-          </a:lnRef>
-          <a:fillRef idx="0">
-            <a:schemeClr val="accent1"/>
-          </a:fillRef>
-          <a:effectRef idx="1">
-            <a:schemeClr val="accent1"/>
-          </a:effectRef>
-          <a:fontRef idx="minor">
-            <a:schemeClr val="tx1"/>
-          </a:fontRef>
-        </p:style>
-      </p:cxnSp>
-      <p:sp>
-        <p:nvSpPr>
-          <p:cNvPr id="6" name="Worktree"/>
-          <p:cNvSpPr/>
-          <p:nvPr/>
-        </p:nvSpPr>
-        <p:spPr>
-          <a:xfrm>
-            <a:off x="1097280" y="1737360"/>
-            <a:ext cx="6949440" cy="2240280"/>
-          </a:xfrm>
-          <a:prstGeom prst="rect">
-            <a:avLst/>
-          </a:prstGeom>
-          <a:noFill/>
-          <a:ln w="19050">
-            <a:solidFill>
-              <a:srgbClr val="C9B991"/>
-            </a:solidFill>
-          </a:ln>
-          <a:effectLst/>
-        </p:spPr>
-        <p:style>
-          <a:lnRef idx="1">
-            <a:schemeClr val="accent1"/>
-          </a:lnRef>
-          <a:fillRef idx="3">
-            <a:schemeClr val="accent1"/>
-          </a:fillRef>
-          <a:effectRef idx="2">
-            <a:schemeClr val="accent1"/>
-          </a:effectRef>
-          <a:fontRef idx="minor">
-            <a:schemeClr val="lt1"/>
-          </a:fontRef>
-        </p:style>
-        <p:txBody>
-          <a:bodyPr rtlCol="0" anchor="ctr" wrap="square" lIns="27432" rIns="27432" tIns="22860" bIns="22860"/>
-          <a:lstStyle/>
-          <a:p>
-            <a:pPr algn="ctr"/>
-            <a:r>
-              <a:rPr sz="1200" b="0" i="0">
-                <a:solidFill>
-                  <a:srgbClr val="5C4826"/>
-                </a:solidFill>
-              </a:rPr>
-              <a:t/>
-            </a:r>
-          </a:p>
-        </p:txBody>
-      </p:sp>
-      <p:sp>
-        <p:nvSpPr>
-          <p:cNvPr id="7" name="WorktreeLabel"/>
-          <p:cNvSpPr txBox="1"/>
-          <p:nvPr/>
-        </p:nvSpPr>
-        <p:spPr>
-          <a:xfrm>
-            <a:off x="1234440" y="1810512"/>
-            <a:ext cx="1828800" cy="365760"/>
-          </a:xfrm>
-          <a:prstGeom prst="rect">
-            <a:avLst/>
-          </a:prstGeom>
-          <a:noFill/>
-        </p:spPr>
-        <p:txBody>
-          <a:bodyPr wrap="square" anchor="t">
-            <a:spAutoFit/>
-          </a:bodyPr>
-          <a:lstStyle/>
-          <a:p>
-            <a:pPr algn="l"/>
-            <a:r>
-              <a:rPr sz="2000" b="1" i="0">
-                <a:solidFill>
-                  <a:srgbClr val="8E6F3E"/>
-                </a:solidFill>
-              </a:rPr>
-              <a:t>WORKTREE</a:t>
-            </a:r>
-          </a:p>
-        </p:txBody>
-      </p:sp>
-      <p:sp>
-        <p:nvSpPr>
-          <p:cNvPr id="8" name="EnvRepo"/>
-          <p:cNvSpPr/>
-          <p:nvPr/>
-        </p:nvSpPr>
-        <p:spPr>
-          <a:xfrm>
-            <a:off x="1463040" y="2212848"/>
-            <a:ext cx="1737360" cy="530352"/>
-          </a:xfrm>
-          <a:prstGeom prst="rect">
-            <a:avLst/>
-          </a:prstGeom>
-          <a:solidFill>
-            <a:srgbClr val="F5F1E8"/>
-          </a:solidFill>
-          <a:ln w="12700">
-            <a:solidFill>
-              <a:srgbClr val="C9B991"/>
-            </a:solidFill>
-          </a:ln>
-          <a:effectLst/>
-        </p:spPr>
-        <p:style>
-          <a:lnRef idx="1">
-            <a:schemeClr val="accent1"/>
-          </a:lnRef>
-          <a:fillRef idx="3">
-            <a:schemeClr val="accent1"/>
-          </a:fillRef>
-          <a:effectRef idx="2">
-            <a:schemeClr val="accent1"/>
-          </a:effectRef>
-          <a:fontRef idx="minor">
-            <a:schemeClr val="lt1"/>
-          </a:fontRef>
-        </p:style>
-        <p:txBody>
-          <a:bodyPr rtlCol="0" anchor="ctr" wrap="square" lIns="27432" rIns="27432" tIns="22860" bIns="22860"/>
-          <a:lstStyle/>
-          <a:p>
-            <a:pPr algn="ctr"/>
-            <a:r>
-              <a:rPr sz="2000" b="0" i="0">
-                <a:solidFill>
-                  <a:srgbClr val="5C4826"/>
-                </a:solidFill>
-              </a:rPr>
-              <a:t>repository</a:t>
-            </a:r>
-          </a:p>
-        </p:txBody>
-      </p:sp>
-      <p:sp>
-        <p:nvSpPr>
-          <p:cNvPr id="9" name="EnvTools"/>
-          <p:cNvSpPr/>
-          <p:nvPr/>
-        </p:nvSpPr>
-        <p:spPr>
-          <a:xfrm>
-            <a:off x="3703320" y="2212848"/>
-            <a:ext cx="1737360" cy="530352"/>
-          </a:xfrm>
-          <a:prstGeom prst="rect">
-            <a:avLst/>
-          </a:prstGeom>
-          <a:solidFill>
-            <a:srgbClr val="F5F1E8"/>
-          </a:solidFill>
-          <a:ln w="12700">
-            <a:solidFill>
-              <a:srgbClr val="C9B991"/>
-            </a:solidFill>
-          </a:ln>
-          <a:effectLst/>
-        </p:spPr>
-        <p:style>
-          <a:lnRef idx="1">
-            <a:schemeClr val="accent1"/>
-          </a:lnRef>
-          <a:fillRef idx="3">
-            <a:schemeClr val="accent1"/>
-          </a:fillRef>
-          <a:effectRef idx="2">
-            <a:schemeClr val="accent1"/>
-          </a:effectRef>
-          <a:fontRef idx="minor">
-            <a:schemeClr val="lt1"/>
-          </a:fontRef>
-        </p:style>
-        <p:txBody>
-          <a:bodyPr rtlCol="0" anchor="ctr" wrap="square" lIns="27432" rIns="27432" tIns="22860" bIns="22860"/>
-          <a:lstStyle/>
-          <a:p>
-            <a:pPr algn="ctr"/>
-            <a:r>
-              <a:rPr sz="2000" b="0" i="0">
-                <a:solidFill>
-                  <a:srgbClr val="5C4826"/>
-                </a:solidFill>
-              </a:rPr>
-              <a:t>tools</a:t>
-            </a:r>
-          </a:p>
-        </p:txBody>
-      </p:sp>
-      <p:sp>
-        <p:nvSpPr>
-          <p:cNvPr id="10" name="EnvContext"/>
-          <p:cNvSpPr/>
-          <p:nvPr/>
-        </p:nvSpPr>
-        <p:spPr>
-          <a:xfrm>
-            <a:off x="5943600" y="2212848"/>
-            <a:ext cx="1737360" cy="530352"/>
-          </a:xfrm>
-          <a:prstGeom prst="rect">
-            <a:avLst/>
-          </a:prstGeom>
-          <a:solidFill>
-            <a:srgbClr val="F5F1E8"/>
-          </a:solidFill>
-          <a:ln w="12700">
-            <a:solidFill>
-              <a:srgbClr val="C9B991"/>
-            </a:solidFill>
-          </a:ln>
-          <a:effectLst/>
-        </p:spPr>
-        <p:style>
-          <a:lnRef idx="1">
-            <a:schemeClr val="accent1"/>
-          </a:lnRef>
-          <a:fillRef idx="3">
-            <a:schemeClr val="accent1"/>
-          </a:fillRef>
-          <a:effectRef idx="2">
-            <a:schemeClr val="accent1"/>
-          </a:effectRef>
-          <a:fontRef idx="minor">
-            <a:schemeClr val="lt1"/>
-          </a:fontRef>
-        </p:style>
-        <p:txBody>
-          <a:bodyPr rtlCol="0" anchor="ctr" wrap="square" lIns="27432" rIns="27432" tIns="22860" bIns="22860"/>
-          <a:lstStyle/>
-          <a:p>
-            <a:pPr algn="ctr"/>
-            <a:r>
-              <a:rPr sz="2000" b="0" i="0">
-                <a:solidFill>
-                  <a:srgbClr val="5C4826"/>
-                </a:solidFill>
-              </a:rPr>
-              <a:t>context</a:t>
-            </a:r>
-          </a:p>
-        </p:txBody>
-      </p:sp>
-      <p:sp>
-        <p:nvSpPr>
-          <p:cNvPr id="11" name="EnvAgent"/>
-          <p:cNvSpPr/>
-          <p:nvPr/>
-        </p:nvSpPr>
-        <p:spPr>
-          <a:xfrm>
-            <a:off x="3703320" y="3218688"/>
-            <a:ext cx="1737360" cy="566928"/>
-          </a:xfrm>
-          <a:prstGeom prst="rect">
-            <a:avLst/>
-          </a:prstGeom>
-          <a:solidFill>
-            <a:srgbClr val="8E6F3E"/>
-          </a:solidFill>
-          <a:ln>
-            <a:noFill/>
-          </a:ln>
-          <a:effectLst/>
-        </p:spPr>
-        <p:style>
-          <a:lnRef idx="1">
-            <a:schemeClr val="accent1"/>
-          </a:lnRef>
-          <a:fillRef idx="3">
-            <a:schemeClr val="accent1"/>
-          </a:fillRef>
-          <a:effectRef idx="2">
-            <a:schemeClr val="accent1"/>
-          </a:effectRef>
-          <a:fontRef idx="minor">
-            <a:schemeClr val="lt1"/>
-          </a:fontRef>
-        </p:style>
-        <p:txBody>
-          <a:bodyPr rtlCol="0" anchor="ctr" wrap="square" lIns="27432" rIns="27432" tIns="22860" bIns="22860"/>
-          <a:lstStyle/>
-          <a:p>
-            <a:pPr algn="ctr"/>
-            <a:r>
-              <a:rPr sz="2000" b="1" i="0">
-                <a:solidFill>
-                  <a:srgbClr val="FFFFFF"/>
-                </a:solidFill>
-              </a:rPr>
-              <a:t>AGENT</a:t>
-            </a:r>
-          </a:p>
-        </p:txBody>
-      </p:sp>
-      <p:cxnSp>
-        <p:nvCxnSpPr>
-          <p:cNvPr id="12" name="Connector 11"/>
-          <p:cNvCxnSpPr/>
-          <p:nvPr/>
-        </p:nvCxnSpPr>
-        <p:spPr>
-          <a:xfrm>
-            <a:off x="2331720" y="2743200"/>
-            <a:ext cx="1554480" cy="512064"/>
-          </a:xfrm>
-          <a:prstGeom prst="line">
-            <a:avLst/>
-          </a:prstGeom>
-          <a:ln w="28575">
-            <a:solidFill>
-              <a:srgbClr val="8E6F3E"/>
-            </a:solidFill>
-            <a:tailEnd type="triangle" w="med" len="med"/>
-          </a:ln>
-          <a:effectLst/>
-        </p:spPr>
-        <p:style>
-          <a:lnRef idx="2">
-            <a:schemeClr val="accent1"/>
-          </a:lnRef>
-          <a:fillRef idx="0">
-            <a:schemeClr val="accent1"/>
-          </a:fillRef>
-          <a:effectRef idx="1">
-            <a:schemeClr val="accent1"/>
-          </a:effectRef>
-          <a:fontRef idx="minor">
-            <a:schemeClr val="tx1"/>
-          </a:fontRef>
-        </p:style>
-      </p:cxnSp>
-      <p:cxnSp>
-        <p:nvCxnSpPr>
-          <p:cNvPr id="13" name="Connector 12"/>
-          <p:cNvCxnSpPr/>
-          <p:nvPr/>
-        </p:nvCxnSpPr>
-        <p:spPr>
-          <a:xfrm>
-            <a:off x="4572000" y="2743200"/>
-            <a:ext cx="0" cy="475488"/>
-          </a:xfrm>
-          <a:prstGeom prst="line">
-            <a:avLst/>
-          </a:prstGeom>
-          <a:ln w="28575">
-            <a:solidFill>
-              <a:srgbClr val="8E6F3E"/>
-            </a:solidFill>
-            <a:tailEnd type="triangle" w="med" len="med"/>
-          </a:ln>
-          <a:effectLst/>
-        </p:spPr>
-        <p:style>
-          <a:lnRef idx="2">
-            <a:schemeClr val="accent1"/>
-          </a:lnRef>
-          <a:fillRef idx="0">
-            <a:schemeClr val="accent1"/>
-          </a:fillRef>
-          <a:effectRef idx="1">
-            <a:schemeClr val="accent1"/>
-          </a:effectRef>
-          <a:fontRef idx="minor">
-            <a:schemeClr val="tx1"/>
-          </a:fontRef>
-        </p:style>
-      </p:cxnSp>
-      <p:cxnSp>
-        <p:nvCxnSpPr>
-          <p:cNvPr id="14" name="Connector 13"/>
-          <p:cNvCxnSpPr/>
-          <p:nvPr/>
-        </p:nvCxnSpPr>
-        <p:spPr>
-          <a:xfrm flipH="1">
-            <a:off x="5257800" y="2743200"/>
-            <a:ext cx="1554480" cy="512064"/>
-          </a:xfrm>
-          <a:prstGeom prst="line">
-            <a:avLst/>
-          </a:prstGeom>
-          <a:ln w="28575">
-            <a:solidFill>
-              <a:srgbClr val="8E6F3E"/>
-            </a:solidFill>
-            <a:tailEnd type="triangle" w="med" len="med"/>
-          </a:ln>
-          <a:effectLst/>
-        </p:spPr>
-        <p:style>
-          <a:lnRef idx="2">
-            <a:schemeClr val="accent1"/>
-          </a:lnRef>
-          <a:fillRef idx="0">
-            <a:schemeClr val="accent1"/>
-          </a:fillRef>
-          <a:effectRef idx="1">
-            <a:schemeClr val="accent1"/>
-          </a:effectRef>
-          <a:fontRef idx="minor">
-            <a:schemeClr val="tx1"/>
-          </a:fontRef>
-        </p:style>
-      </p:cxnSp>
-      <p:cxnSp>
-        <p:nvCxnSpPr>
-          <p:cNvPr id="15" name="Connector 14"/>
-          <p:cNvCxnSpPr/>
-          <p:nvPr/>
-        </p:nvCxnSpPr>
-        <p:spPr>
-          <a:xfrm>
-            <a:off x="4572000" y="3785615"/>
-            <a:ext cx="0" cy="420625"/>
-          </a:xfrm>
-          <a:prstGeom prst="line">
-            <a:avLst/>
-          </a:prstGeom>
-          <a:ln w="28575">
-            <a:solidFill>
-              <a:srgbClr val="8E6F3E"/>
-            </a:solidFill>
-            <a:tailEnd type="triangle" w="med" len="med"/>
-          </a:ln>
-          <a:effectLst/>
-        </p:spPr>
-        <p:style>
-          <a:lnRef idx="2">
-            <a:schemeClr val="accent1"/>
-          </a:lnRef>
-          <a:fillRef idx="0">
-            <a:schemeClr val="accent1"/>
-          </a:fillRef>
-          <a:effectRef idx="1">
-            <a:schemeClr val="accent1"/>
-          </a:effectRef>
-          <a:fontRef idx="minor">
-            <a:schemeClr val="tx1"/>
-          </a:fontRef>
-        </p:style>
-      </p:cxnSp>
-      <p:sp>
-        <p:nvSpPr>
-          <p:cNvPr id="16" name="Proposed"/>
-          <p:cNvSpPr/>
-          <p:nvPr/>
-        </p:nvSpPr>
-        <p:spPr>
-          <a:xfrm>
-            <a:off x="3566160" y="4224528"/>
-            <a:ext cx="2011680" cy="475488"/>
-          </a:xfrm>
-          <a:prstGeom prst="rect">
-            <a:avLst/>
-          </a:prstGeom>
-          <a:solidFill>
-            <a:srgbClr val="F5F1E8"/>
-          </a:solidFill>
-          <a:ln w="12700">
-            <a:solidFill>
-              <a:srgbClr val="C9B991"/>
-            </a:solidFill>
-          </a:ln>
-          <a:effectLst/>
-        </p:spPr>
-        <p:style>
-          <a:lnRef idx="1">
-            <a:schemeClr val="accent1"/>
-          </a:lnRef>
-          <a:fillRef idx="3">
-            <a:schemeClr val="accent1"/>
-          </a:fillRef>
-          <a:effectRef idx="2">
-            <a:schemeClr val="accent1"/>
-          </a:effectRef>
-          <a:fontRef idx="minor">
-            <a:schemeClr val="lt1"/>
-          </a:fontRef>
-        </p:style>
-        <p:txBody>
-          <a:bodyPr rtlCol="0" anchor="ctr" wrap="square" lIns="27432" rIns="27432" tIns="22860" bIns="22860"/>
-          <a:lstStyle/>
-          <a:p>
-            <a:pPr algn="ctr"/>
-            <a:r>
-              <a:rPr sz="2000" b="0" i="0">
-                <a:solidFill>
-                  <a:srgbClr val="5C4826"/>
-                </a:solidFill>
-              </a:rPr>
-              <a:t>proposed change</a:t>
-            </a:r>
-          </a:p>
-        </p:txBody>
-      </p:sp>
-      <p:cxnSp>
-        <p:nvCxnSpPr>
-          <p:cNvPr id="17" name="Connector 16"/>
-          <p:cNvCxnSpPr/>
-          <p:nvPr/>
-        </p:nvCxnSpPr>
-        <p:spPr>
-          <a:xfrm>
-            <a:off x="4572000" y="4700016"/>
-            <a:ext cx="0" cy="292608"/>
-          </a:xfrm>
-          <a:prstGeom prst="line">
-            <a:avLst/>
-          </a:prstGeom>
-          <a:ln w="28575">
-            <a:solidFill>
-              <a:srgbClr val="8E6F3E"/>
-            </a:solidFill>
-            <a:tailEnd type="triangle" w="med" len="med"/>
-          </a:ln>
-          <a:effectLst/>
-        </p:spPr>
-        <p:style>
-          <a:lnRef idx="2">
-            <a:schemeClr val="accent1"/>
-          </a:lnRef>
-          <a:fillRef idx="0">
-            <a:schemeClr val="accent1"/>
-          </a:fillRef>
-          <a:effectRef idx="1">
-            <a:schemeClr val="accent1"/>
-          </a:effectRef>
-          <a:fontRef idx="minor">
-            <a:schemeClr val="tx1"/>
-          </a:fontRef>
-        </p:style>
-      </p:cxnSp>
-      <p:sp>
-        <p:nvSpPr>
-          <p:cNvPr id="18" name="CommitPR"/>
-          <p:cNvSpPr/>
-          <p:nvPr/>
-        </p:nvSpPr>
-        <p:spPr>
-          <a:xfrm>
-            <a:off x="3566160" y="5010912"/>
-            <a:ext cx="2011680" cy="475488"/>
-          </a:xfrm>
-          <a:prstGeom prst="rect">
-            <a:avLst/>
-          </a:prstGeom>
-          <a:solidFill>
-            <a:srgbClr val="F5F1E8"/>
-          </a:solidFill>
-          <a:ln w="12700">
-            <a:solidFill>
-              <a:srgbClr val="C9B991"/>
-            </a:solidFill>
-          </a:ln>
-          <a:effectLst/>
-        </p:spPr>
-        <p:style>
-          <a:lnRef idx="1">
-            <a:schemeClr val="accent1"/>
-          </a:lnRef>
-          <a:fillRef idx="3">
-            <a:schemeClr val="accent1"/>
-          </a:fillRef>
-          <a:effectRef idx="2">
-            <a:schemeClr val="accent1"/>
-          </a:effectRef>
-          <a:fontRef idx="minor">
-            <a:schemeClr val="lt1"/>
-          </a:fontRef>
-        </p:style>
-        <p:txBody>
-          <a:bodyPr rtlCol="0" anchor="ctr" wrap="square" lIns="27432" rIns="27432" tIns="22860" bIns="22860"/>
-          <a:lstStyle/>
-          <a:p>
-            <a:pPr algn="ctr"/>
-            <a:r>
-              <a:rPr sz="2000" b="0" i="0">
-                <a:solidFill>
-                  <a:srgbClr val="5C4826"/>
-                </a:solidFill>
-              </a:rPr>
-              <a:t>commit / PR</a:t>
-            </a:r>
-          </a:p>
-        </p:txBody>
-      </p:sp>
-      <p:sp>
-        <p:nvSpPr>
-          <p:cNvPr id="19" name="EnvCaption"/>
-          <p:cNvSpPr txBox="1"/>
-          <p:nvPr/>
-        </p:nvSpPr>
-        <p:spPr>
-          <a:xfrm>
-            <a:off x="274320" y="5559552"/>
-            <a:ext cx="8595360" cy="365760"/>
-          </a:xfrm>
-          <a:prstGeom prst="rect">
-            <a:avLst/>
-          </a:prstGeom>
-          <a:noFill/>
-        </p:spPr>
-        <p:txBody>
-          <a:bodyPr wrap="square" anchor="t">
-            <a:spAutoFit/>
-          </a:bodyPr>
-          <a:lstStyle/>
-          <a:p>
-            <a:pPr algn="ctr"/>
-            <a:r>
-              <a:rPr sz="2000" b="0" i="1">
-                <a:solidFill>
-                  <a:srgbClr val="555960"/>
-                </a:solidFill>
-              </a:rPr>
-              <a:t>Git worktree · branch · issue · repository instructions · tools · tests · CI · PR</a:t>
-            </a:r>
-          </a:p>
-        </p:txBody>
-      </p:sp>
-      <p:sp>
-        <p:nvSpPr>
-          <p:cNvPr id="0" name="ExampleKicker"/>
-          <p:cNvSpPr/>
-          <p:nvPr/>
-        </p:nvSpPr>
-        <p:spPr>
-          <a:xfrm>
-            <a:off x="5349240" y="205000"/>
-            <a:ext cx="3520440" cy="470000"/>
-          </a:xfrm>
-          <a:prstGeom prst="roundRect">
-            <a:avLst/>
-          </a:prstGeom>
-          <a:solidFill>
-            <a:srgbClr val="FBF8F2"/>
-          </a:solidFill>
-          <a:ln w="15875">
-            <a:solidFill>
-              <a:srgbClr val="8E6F3E"/>
-            </a:solidFill>
-          </a:ln>
-          <a:effectLst/>
-        </p:spPr>
-        <p:txBody>
-          <a:bodyPr rtlCol="0" anchor="ctr" wrap="square" lIns="27432" rIns="27432" tIns="22860" bIns="22860"/>
-          <a:lstStyle/>
-          <a:p>
-            <a:pPr algn="ctr">
-              <a:buNone/>
-            </a:pPr>
-            <a:r>
-              <a:rPr lang="en-US" sz="2000" b="1" i="0" dirty="0">
-                <a:solidFill>
-                  <a:srgbClr val="8E6F3E"/>
-                </a:solidFill>
-              </a:rPr>
-              <a:t>EXAMPLE · PROCESS BOUNDS</a:t>
             </a:r>
           </a:p>
         </p:txBody>

</xml_diff>

<commit_message>
deck 2-3: slide 17 — unwrap VALIDATION/ALIGNMENT row labels and CONSEQUENCE card (widen boxes, trim insets; no text or size changes)
</commit_message>
<xml_diff>
--- a/course/lectures/act-2-delegation-and-control/03-alignment/2-3-Alignment.pptx
+++ b/course/lectures/act-2-delegation-and-control/03-alignment/2-3-Alignment.pptx
@@ -10356,7 +10356,7 @@
         <p:spPr>
           <a:xfrm>
             <a:off x="137160" y="1572768"/>
-            <a:ext cx="1371600" cy="640080"/>
+            <a:ext cx="1417320" cy="640080"/>
           </a:xfrm>
           <a:prstGeom prst="rect">
             <a:avLst/>
@@ -10364,7 +10364,7 @@
           <a:noFill/>
         </p:spPr>
         <p:txBody>
-          <a:bodyPr wrap="square" anchor="ctr">
+          <a:bodyPr wrap="square" anchor="ctr" rIns="0">
             <a:spAutoFit/>
           </a:bodyPr>
           <a:lstStyle/>
@@ -10663,7 +10663,7 @@
         <p:spPr>
           <a:xfrm>
             <a:off x="7150608" y="1591056"/>
-            <a:ext cx="1627632" cy="603504"/>
+            <a:ext cx="1719072" cy="603504"/>
           </a:xfrm>
           <a:prstGeom prst="rect">
             <a:avLst/>
@@ -10865,7 +10865,7 @@
         <p:spPr>
           <a:xfrm>
             <a:off x="137160" y="2907792"/>
-            <a:ext cx="1371600" cy="640080"/>
+            <a:ext cx="1417320" cy="640080"/>
           </a:xfrm>
           <a:prstGeom prst="rect">
             <a:avLst/>
@@ -10873,7 +10873,7 @@
           <a:noFill/>
         </p:spPr>
         <p:txBody>
-          <a:bodyPr wrap="square" anchor="ctr">
+          <a:bodyPr wrap="square" anchor="ctr" rIns="0">
             <a:spAutoFit/>
           </a:bodyPr>
           <a:lstStyle/>
@@ -11172,7 +11172,7 @@
         <p:spPr>
           <a:xfrm>
             <a:off x="7150608" y="2926080"/>
-            <a:ext cx="1627632" cy="603504"/>
+            <a:ext cx="1719072" cy="603504"/>
           </a:xfrm>
           <a:prstGeom prst="rect">
             <a:avLst/>
@@ -11200,7 +11200,7 @@
           </a:fontRef>
         </p:style>
         <p:txBody>
-          <a:bodyPr rtlCol="0" anchor="ctr" wrap="square" lIns="27432" rIns="27432" tIns="22860" bIns="22860"/>
+          <a:bodyPr rtlCol="0" anchor="ctr" wrap="square" lIns="0" rIns="0" tIns="22860" bIns="22860"/>
           <a:lstStyle/>
           <a:p>
             <a:pPr algn="ctr"/>

</xml_diff>

<commit_message>
deck 2-3: slides 23-25 — footer band clears the slide-number region (band 61.2pt -> 46.8pt tall, bottom 514.8 -> 500.4pt)
</commit_message>
<xml_diff>
--- a/course/lectures/act-2-delegation-and-control/03-alignment/2-3-Alignment.pptx
+++ b/course/lectures/act-2-delegation-and-control/03-alignment/2-3-Alignment.pptx
@@ -14446,7 +14446,7 @@
         <p:spPr>
           <a:xfrm>
             <a:off x="274320" y="5760720"/>
-            <a:ext cx="8595360" cy="777240"/>
+            <a:ext cx="8595360" cy="594360"/>
           </a:xfrm>
           <a:prstGeom prst="rect">
             <a:avLst/>
@@ -14888,7 +14888,7 @@
         <p:spPr>
           <a:xfrm>
             <a:off x="274320" y="5760720"/>
-            <a:ext cx="8595360" cy="777240"/>
+            <a:ext cx="8595360" cy="594360"/>
           </a:xfrm>
           <a:prstGeom prst="rect">
             <a:avLst/>
@@ -15435,7 +15435,7 @@
         <p:spPr>
           <a:xfrm>
             <a:off x="274320" y="5760720"/>
-            <a:ext cx="8595360" cy="777240"/>
+            <a:ext cx="8595360" cy="594360"/>
           </a:xfrm>
           <a:prstGeom prst="rect">
             <a:avLst/>

</xml_diff>

<commit_message>
deck 2-3: slide 3 — 'Vibe-code' (verb modifier), drop 'Give it a whirl' from the footer
Co-Authored-By: Claude Opus 5 <noreply@anthropic.com>
</commit_message>
<xml_diff>
--- a/course/lectures/act-2-delegation-and-control/03-alignment/2-3-Alignment.pptx
+++ b/course/lectures/act-2-delegation-and-control/03-alignment/2-3-Alignment.pptx
@@ -17311,7 +17311,7 @@
           <a:p>
             <a:r>
               <a:rPr sz="2400"/>
-              <a:t>Vibe code a todo list</a:t>
+              <a:t>Vibe-code a todo list</a:t>
             </a:r>
           </a:p>
         </p:txBody>
@@ -17486,7 +17486,7 @@
                   <a:srgbClr val="FFFFFF"/>
                 </a:solidFill>
               </a:rPr>
-              <a:t>You have 5-10 minutes. Give it a whirl</a:t>
+              <a:t>You have 5–10 minutes.</a:t>
             </a:r>
           </a:p>
         </p:txBody>

</xml_diff>

<commit_message>
deck 2-3: slide 5 — ALIGNMENT asks 'How do we enforce what must be true?'; footer connects obligations to controls; notes gain the two enforcement modes
Co-Authored-By: Claude Opus 5 <noreply@anthropic.com>
</commit_message>
<xml_diff>
--- a/course/lectures/act-2-delegation-and-control/03-alignment/2-3-Alignment.pptx
+++ b/course/lectures/act-2-delegation-and-control/03-alignment/2-3-Alignment.pptx
@@ -2169,6 +2169,11 @@
           <a:p>
             <a:r>
               <a:t>- Alignment connects the engineering judgment to what the engineered environment permits.</a:t>
+            </a:r>
+          </a:p>
+          <a:p>
+            <a:r>
+              <a:t>- Sometimes by preventing invalid states; sometimes by producing evidence, evaluating it, and making subsequent action conditional on the verdict.</a:t>
             </a:r>
           </a:p>
           <a:p>
@@ -17996,7 +18001,7 @@
                   <a:srgbClr val="8E6F3E"/>
                 </a:solidFill>
               </a:rPr>
-              <a:t>When should an engineering judgment control what the agent — or the environment — is permitted to do?</a:t>
+              <a:t>How do we enforce what must be true?</a:t>
             </a:r>
           </a:p>
         </p:txBody>
@@ -18048,7 +18053,7 @@
                   <a:srgbClr val="FFFFFF"/>
                 </a:solidFill>
               </a:rPr>
-              <a:t>Alignment connects a validation judgment</a:t>
+              <a:t>Alignment connects engineering obligations</a:t>
             </a:r>
           </a:p>
           <a:p>
@@ -18059,7 +18064,7 @@
                   <a:srgbClr val="FFFFFF"/>
                 </a:solidFill>
               </a:rPr>
-              <a:t>to what the environment permits.</a:t>
+              <a:t>to controls in the environment.</a:t>
             </a:r>
           </a:p>
         </p:txBody>

</xml_diff>

<commit_message>
deck 2-3: slide 9 — title gains the article; LEAVE FREE: 'algorithm choice, where unconstrained'
Co-Authored-By: Claude Opus 5 <noreply@anthropic.com>
</commit_message>
<xml_diff>
--- a/course/lectures/act-2-delegation-and-control/03-alignment/2-3-Alignment.pptx
+++ b/course/lectures/act-2-delegation-and-control/03-alignment/2-3-Alignment.pptx
@@ -19338,7 +19338,7 @@
           <a:p>
             <a:r>
               <a:rPr sz="2400"/>
-              <a:t>Bound consequential degrees of freedom</a:t>
+              <a:t>Bound the consequential degrees of freedom</a:t>
             </a:r>
           </a:p>
         </p:txBody>
@@ -19567,7 +19567,7 @@
                   <a:srgbClr val="5C4826"/>
                 </a:solidFill>
               </a:rPr>
-              <a:t>unconstrained algorithms</a:t>
+              <a:t>algorithm choice, where unconstrained</a:t>
             </a:r>
           </a:p>
           <a:p>

</xml_diff>

<commit_message>
deck 2-3: slide 13 — parallel grammar across SCOPE / AUTHORITY / EVIDENCE cards
Co-Authored-By: Claude Opus 5 <noreply@anthropic.com>
</commit_message>
<xml_diff>
--- a/course/lectures/act-2-delegation-and-control/03-alignment/2-3-Alignment.pptx
+++ b/course/lectures/act-2-delegation-and-control/03-alignment/2-3-Alignment.pptx
@@ -8884,7 +8884,7 @@
                   <a:srgbClr val="555960"/>
                 </a:solidFill>
               </a:rPr>
-              <a:t>modifies forbidden file / changes test</a:t>
+              <a:t>forbidden file · altered test</a:t>
             </a:r>
           </a:p>
         </p:txBody>
@@ -8942,7 +8942,7 @@
                   <a:srgbClr val="5C4826"/>
                 </a:solidFill>
               </a:rPr>
-              <a:t>Agent takes an unauthorized consequential action</a:t>
+              <a:t>Work exceeds delegated authority</a:t>
             </a:r>
           </a:p>
           <a:p>
@@ -8958,7 +8958,7 @@
                   <a:srgbClr val="555960"/>
                 </a:solidFill>
               </a:rPr>
-              <a:t>merge / deploy</a:t>
+              <a:t>merge · deploy</a:t>
             </a:r>
           </a:p>
         </p:txBody>
@@ -9016,7 +9016,7 @@
                   <a:srgbClr val="5C4826"/>
                 </a:solidFill>
               </a:rPr>
-              <a:t>Required evidence is absent or inadequate</a:t>
+              <a:t>Evidence does not establish the obligation</a:t>
             </a:r>
           </a:p>
           <a:p>
@@ -9032,7 +9032,7 @@
                   <a:srgbClr val="555960"/>
                 </a:solidFill>
               </a:rPr>
-              <a:t>“all tests pass” without establishing what was tested</a:t>
+              <a:t>“all tests pass” without saying what was tested</a:t>
             </a:r>
           </a:p>
         </p:txBody>

</xml_diff>

<commit_message>
deck 2-3: slide 26 — drop the acceptance legend line (receiving environment is not in the triangle)
Co-Authored-By: Claude Opus 5 <noreply@anthropic.com>
</commit_message>
<xml_diff>
--- a/course/lectures/act-2-delegation-and-control/03-alignment/2-3-Alignment.pptx
+++ b/course/lectures/act-2-delegation-and-control/03-alignment/2-3-Alignment.pptx
@@ -16037,25 +16037,6 @@
                 </a:solidFill>
               </a:rPr>
               <a:t>conformance</a:t>
-            </a:r>
-          </a:p>
-          <a:p>
-            <a:pPr algn="ctr"/>
-            <a:r>
-              <a:rPr sz="2000" b="0">
-                <a:solidFill>
-                  <a:srgbClr val="5C4826"/>
-                </a:solidFill>
-              </a:rPr>
-              <a:t>realization ↔ receiving environment — </a:t>
-            </a:r>
-            <a:r>
-              <a:rPr sz="2000" b="1">
-                <a:solidFill>
-                  <a:srgbClr val="8E6F3E"/>
-                </a:solidFill>
-              </a:rPr>
-              <a:t>acceptance</a:t>
             </a:r>
           </a:p>
         </p:txBody>

</xml_diff>

<commit_message>
deck 2-3 slide 2: Master Equation becomes a reprise of Modeling's production band, extended by the Alignment check
Reuse Modeling-1 slide 4's visual grammar: the long-form chain equation at
22pt (a reprise, not the headline) over the production-band figure, extended
below by the new Alignment structure — Encoded property drops to MODEL,
Realization drops to CHECK, the check consults the model, PASS / DO NOT PASS,
and the quantity Alignment improves: P(L | C). Nothing in the band changed:
Alignment does not improve the fabricator; it adds selection on its output.
Deck-local figure variant production-band-with-check-deck.{svg,png} (Modeling's
figure untouched). Build-animation sequence goes in the speaker notes —
python-pptx has no animation API, so the slide ships as one static composite.
</commit_message>
<xml_diff>
--- a/course/lectures/act-2-delegation-and-control/03-alignment/2-3-Alignment.pptx
+++ b/course/lectures/act-2-delegation-and-control/03-alignment/2-3-Alignment.pptx
@@ -2673,57 +2673,63 @@
           <a:lstStyle/>
           <a:p>
             <a:r>
-              <a:t>TIMING: 1 minute</a:t>
-            </a:r>
-          </a:p>
-          <a:p>
-            <a:r>
-              <a:t>- You saw this equation in Modeling. It describes the production problem: given the task, reasoner, representation, and harness, how likely is delegation to produce an acceptable result?</a:t>
-            </a:r>
-          </a:p>
-          <a:p>
-            <a:r>
-              <a:t>- Last time we opened R. Modeling changes the representation available to the reasoner.</a:t>
-            </a:r>
-          </a:p>
-          <a:p>
-            <a:r>
-              <a:t>- Today, notice one word we have mostly taken for granted: acceptable. What does that mean?</a:t>
-            </a:r>
-          </a:p>
-          <a:p>
-            <a:r>
-              <a:t>- Then immediately: let's run the production system.</a:t>
-            </a:r>
-          </a:p>
-          <a:p>
-            <a:r>
-              <a:t>- Advance to the vibe-coding exercise. Do not explain Alignment first; the students are about to experience the ambiguity in "acceptable" for themselves.</a:t>
-            </a:r>
-          </a:p>
-          <a:p>
-            <a:r>
-              <a:t/>
-            </a:r>
-          </a:p>
-          <a:p>
-            <a:r>
-              <a:t>ANIMATION</a:t>
-            </a:r>
-          </a:p>
-          <a:p>
-            <a:r>
-              <a:t>- Reveal the equation exactly as remembered from Modeling.</a:t>
-            </a:r>
-          </a:p>
-          <a:p>
-            <a:r>
-              <a:t>- Reveal the four definitions.</a:t>
-            </a:r>
-          </a:p>
-          <a:p>
-            <a:r>
-              <a:t>- Reveal "What makes a result acceptable?" last, and leave it up as you advance.</a:t>
+              <a:t>TIMING: 2 minutes</a:t>
+            </a:r>
+          </a:p>
+          <a:p>
+            <a:r>
+              <a:t>- Same equation, same picture as Modeling-1 — say so: you have seen this; nothing in the production band has changed.</a:t>
+            </a:r>
+          </a:p>
+          <a:p>
+            <a:r>
+              <a:t>- What is new is below the band. The encoded obligation drops down as the MODEL; the realization drops down to the CHECK; the check consults the model; the verdict is PASS or DO NOT PASS.</a:t>
+            </a:r>
+          </a:p>
+          <a:p>
+            <a:r>
+              <a:t>- The point you must not blur: Alignment does NOT make the fabricator better. P(E | R), P(I | E, R), and P(L | I, E, R) are untouched. Alignment changes the production system by adding SELECTION on the fabricator's output. Modeling works inside production; Alignment acts on its output.</a:t>
+            </a:r>
+          </a:p>
+          <a:p>
+            <a:r>
+              <a:t>- The quantity that improves is P(L | C). Before Alignment: how likely is the agent to realize the obligation correctly? After Alignment: given that this realization was admitted, how likely is it to be correct?</a:t>
+            </a:r>
+          </a:p>
+          <a:p>
+            <a:r>
+              <a:t>- Then immediately: let's run the production system. Advance to the vibe-coding exercise; do not belabor the structure — the students are about to experience what happens without the check.</a:t>
+            </a:r>
+          </a:p>
+          <a:p/>
+          <a:p>
+            <a:r>
+              <a:t>ANIMATION (apply by hand in PowerPoint — python-pptx has no animation API, so this ships as one static composite; the check structure is baked into the figure, so building steps 2-5 as clicks means overlaying native shapes or splitting the picture):</a:t>
+            </a:r>
+          </a:p>
+          <a:p>
+            <a:r>
+              <a:t>1. equation + production pipeline</a:t>
+            </a:r>
+          </a:p>
+          <a:p>
+            <a:r>
+              <a:t>2. fade in Realization → CHECK</a:t>
+            </a:r>
+          </a:p>
+          <a:p>
+            <a:r>
+              <a:t>3. draw the arrow back from CHECK to MODEL</a:t>
+            </a:r>
+          </a:p>
+          <a:p>
+            <a:r>
+              <a:t>4. reveal PASS / DO NOT PASS</a:t>
+            </a:r>
+          </a:p>
+          <a:p>
+            <a:r>
+              <a:t>5. reveal P(L | C)</a:t>
             </a:r>
           </a:p>
         </p:txBody>
@@ -12777,7 +12783,7 @@
                   <a:srgbClr val="000000"/>
                 </a:solidFill>
               </a:rPr>
-              <a:t>The Master Equation</a:t>
+              <a:t>The Master Equation: Alignment adds a check</a:t>
             </a:r>
           </a:p>
         </p:txBody>
@@ -12807,14 +12813,14 @@
       </p:sp>
       <p:sp>
         <p:nvSpPr>
-          <p:cNvPr id="11" name="EqBox"/>
+          <p:cNvPr id="4" name="EqBox"/>
           <p:cNvSpPr txBox="1"/>
           <p:nvPr/>
         </p:nvSpPr>
         <p:spPr>
           <a:xfrm>
-            <a:off x="274320" y="1554480"/>
-            <a:ext cx="8595360" cy="822960"/>
+            <a:off x="274320" y="804672"/>
+            <a:ext cx="8595360" cy="411480"/>
           </a:xfrm>
           <a:prstGeom prst="rect">
             <a:avLst/>
@@ -12835,187 +12841,198 @@
               <a:buNone/>
             </a:pPr>
             <a:r>
-              <a:rPr lang="en-US" sz="5400" b="0" i="1" dirty="0">
+              <a:rPr lang="en-US" sz="2200" b="0" i="1" dirty="0">
                 <a:solidFill>
                   <a:srgbClr val="5C4826"/>
                 </a:solidFill>
               </a:rPr>
-              <a:t>p(T,M,R,H)</a:t>
-            </a:r>
-          </a:p>
-        </p:txBody>
-      </p:sp>
-      <p:sp>
-        <p:nvSpPr>
-          <p:cNvPr id="12" name="EqGloss"/>
+              <a:t>p</a:t>
+            </a:r>
+            <a:r>
+              <a:rPr lang="en-US" sz="2200" b="0" i="1" baseline="-25000" dirty="0">
+                <a:solidFill>
+                  <a:srgbClr val="5C4826"/>
+                </a:solidFill>
+              </a:rPr>
+              <a:t>R</a:t>
+            </a:r>
+            <a:r>
+              <a:rPr lang="en-US" sz="2200" b="0" i="1" dirty="0">
+                <a:solidFill>
+                  <a:srgbClr val="5C4826"/>
+                </a:solidFill>
+              </a:rPr>
+              <a:t> = P(E | R) · P(I | E, R) · P(L | I, E, R)</a:t>
+            </a:r>
+          </a:p>
+        </p:txBody>
+      </p:sp>
+      <p:pic>
+        <p:nvPicPr>
+          <p:cNvPr id="5" name="BandCheckFigure" descr="production-band-with-check-deck.png"/>
+          <p:cNvPicPr>
+            <a:picLocks noChangeAspect="1"/>
+          </p:cNvPicPr>
+          <p:nvPr/>
+        </p:nvPicPr>
+        <p:blipFill>
+          <a:blip r:embed="rId3"/>
+          <a:stretch>
+            <a:fillRect/>
+          </a:stretch>
+        </p:blipFill>
+        <p:spPr>
+          <a:xfrm>
+            <a:off x="685800" y="1280160"/>
+            <a:ext cx="7315200" cy="4216400"/>
+          </a:xfrm>
+          <a:prstGeom prst="rect">
+            <a:avLst/>
+          </a:prstGeom>
+        </p:spPr>
+      </p:pic>
+      <p:sp>
+        <p:nvSpPr>
+          <p:cNvPr id="6" name="ContrastBlock"/>
           <p:cNvSpPr txBox="1"/>
           <p:nvPr/>
         </p:nvSpPr>
         <p:spPr>
           <a:xfrm>
-            <a:off x="274320" y="2423160"/>
-            <a:ext cx="8595360" cy="365760"/>
+            <a:off x="960120" y="4114800"/>
+            <a:ext cx="4983480" cy="1280160"/>
           </a:xfrm>
           <a:prstGeom prst="rect">
             <a:avLst/>
           </a:prstGeom>
           <a:noFill/>
-          <a:ln>
-            <a:noFill/>
-          </a:ln>
-        </p:spPr>
-        <p:txBody>
-          <a:bodyPr wrap="square" lIns="0" tIns="0" rIns="0" bIns="0" anchor="t"/>
-          <a:lstStyle/>
-          <a:p>
-            <a:pPr algn="ctr">
-              <a:spcAft>
-                <a:spcPts val="0"/>
-              </a:spcAft>
-              <a:buNone/>
+        </p:spPr>
+        <p:txBody>
+          <a:bodyPr wrap="square" lIns="0" rIns="0" tIns="0" bIns="0">
+            <a:spAutoFit/>
+          </a:bodyPr>
+          <a:lstStyle/>
+          <a:p>
+            <a:r>
+              <a:rPr sz="2000" b="1" i="0">
+                <a:solidFill>
+                  <a:srgbClr val="5C4826"/>
+                </a:solidFill>
+              </a:rPr>
+              <a:t>Before Alignment: </a:t>
+            </a:r>
+            <a:r>
+              <a:rPr sz="2000" b="0" i="0">
+                <a:solidFill>
+                  <a:srgbClr val="555960"/>
+                </a:solidFill>
+              </a:rPr>
+              <a:t>How likely is the agent to realize the obligation correctly?</a:t>
+            </a:r>
+          </a:p>
+          <a:p>
+            <a:pPr>
+              <a:spcBef>
+                <a:spcPts val="800"/>
+              </a:spcBef>
             </a:pPr>
             <a:r>
-              <a:rPr lang="en-US" sz="2000" b="0" i="1" dirty="0">
+              <a:rPr sz="2000" b="1" i="0">
+                <a:solidFill>
+                  <a:srgbClr val="5C4826"/>
+                </a:solidFill>
+              </a:rPr>
+              <a:t>After Alignment: </a:t>
+            </a:r>
+            <a:r>
+              <a:rPr sz="2000" b="0" i="0">
                 <a:solidFill>
                   <a:srgbClr val="555960"/>
                 </a:solidFill>
               </a:rPr>
-              <a:t>the probability that delegation produces an acceptable result</a:t>
-            </a:r>
-          </a:p>
-        </p:txBody>
-      </p:sp>
-      <p:sp>
-        <p:nvSpPr>
-          <p:cNvPr id="13" name="DefLine"/>
+              <a:t>Given that this realization was admitted, how likely is it to be correct?</a:t>
+            </a:r>
+          </a:p>
+        </p:txBody>
+      </p:sp>
+      <p:sp>
+        <p:nvSpPr>
+          <p:cNvPr id="7" name="Annotation-modeling"/>
           <p:cNvSpPr txBox="1"/>
           <p:nvPr/>
         </p:nvSpPr>
         <p:spPr>
           <a:xfrm>
-            <a:off x="274320" y="4023360"/>
-            <a:ext cx="8595360" cy="365760"/>
+            <a:off x="274320" y="5559552"/>
+            <a:ext cx="7818120" cy="585216"/>
           </a:xfrm>
           <a:prstGeom prst="rect">
             <a:avLst/>
           </a:prstGeom>
           <a:noFill/>
-          <a:ln>
-            <a:noFill/>
-          </a:ln>
-        </p:spPr>
-        <p:txBody>
-          <a:bodyPr wrap="square" lIns="0" tIns="0" rIns="0" bIns="0" anchor="ctr"/>
-          <a:lstStyle/>
-          <a:p>
-            <a:pPr algn="ctr">
-              <a:spcAft>
-                <a:spcPts val="0"/>
-              </a:spcAft>
-              <a:buNone/>
-            </a:pPr>
-            <a:r>
-              <a:rPr lang="en-US" sz="2000" b="1" i="1" dirty="0">
-                <a:solidFill>
-                  <a:srgbClr val="8E6F3E"/>
-                </a:solidFill>
-              </a:rPr>
-              <a:t>T</a:t>
-            </a:r>
-            <a:r>
-              <a:rPr lang="en-US" sz="2000" b="0" dirty="0">
-                <a:solidFill>
-                  <a:srgbClr val="555960"/>
-                </a:solidFill>
-              </a:rPr>
-              <a:t xml:space="preserve"> task   ·   </a:t>
-            </a:r>
-            <a:r>
-              <a:rPr lang="en-US" sz="2000" b="1" i="1" dirty="0">
-                <a:solidFill>
-                  <a:srgbClr val="8E6F3E"/>
-                </a:solidFill>
-              </a:rPr>
-              <a:t>M</a:t>
-            </a:r>
-            <a:r>
-              <a:rPr lang="en-US" sz="2000" b="0" dirty="0">
-                <a:solidFill>
-                  <a:srgbClr val="555960"/>
-                </a:solidFill>
-              </a:rPr>
-              <a:t xml:space="preserve"> reasoning model   ·   </a:t>
-            </a:r>
-            <a:r>
-              <a:rPr lang="en-US" sz="2000" b="1" i="1" dirty="0">
-                <a:solidFill>
-                  <a:srgbClr val="8E6F3E"/>
-                </a:solidFill>
-              </a:rPr>
-              <a:t>R</a:t>
-            </a:r>
-            <a:r>
-              <a:rPr lang="en-US" sz="2000" b="0" dirty="0">
-                <a:solidFill>
-                  <a:srgbClr val="555960"/>
-                </a:solidFill>
-              </a:rPr>
-              <a:t xml:space="preserve"> representation   ·   </a:t>
-            </a:r>
-            <a:r>
-              <a:rPr lang="en-US" sz="2000" b="1" i="1" dirty="0">
-                <a:solidFill>
-                  <a:srgbClr val="8E6F3E"/>
-                </a:solidFill>
-              </a:rPr>
-              <a:t>H</a:t>
-            </a:r>
-            <a:r>
-              <a:rPr lang="en-US" sz="2000" b="0" dirty="0">
-                <a:solidFill>
-                  <a:srgbClr val="555960"/>
-                </a:solidFill>
-              </a:rPr>
-              <a:t xml:space="preserve"> harness/process</a:t>
-            </a:r>
-          </a:p>
-        </p:txBody>
-      </p:sp>
-      <p:sp>
-        <p:nvSpPr>
-          <p:cNvPr id="199" name="FooterBand"/>
-          <p:cNvSpPr/>
-          <p:nvPr/>
-        </p:nvSpPr>
-        <p:spPr>
-          <a:xfrm>
-            <a:off x="274320" y="5852160"/>
-            <a:ext cx="8595360" cy="566928"/>
+        </p:spPr>
+        <p:txBody>
+          <a:bodyPr wrap="square" lIns="0" rIns="0" tIns="0" bIns="0">
+            <a:spAutoFit/>
+          </a:bodyPr>
+          <a:lstStyle/>
+          <a:p>
+            <a:r>
+              <a:rPr sz="2000" b="1" i="0">
+                <a:solidFill>
+                  <a:srgbClr val="5C4826"/>
+                </a:solidFill>
+              </a:rPr>
+              <a:t>Modeling</a:t>
+            </a:r>
+            <a:r>
+              <a:rPr sz="2000" b="0" i="0">
+                <a:solidFill>
+                  <a:srgbClr val="5C4826"/>
+                </a:solidFill>
+              </a:rPr>
+              <a:t> raises the probability of a correct realization by improving what is represented and interpreted.</a:t>
+            </a:r>
+          </a:p>
+        </p:txBody>
+      </p:sp>
+      <p:sp>
+        <p:nvSpPr>
+          <p:cNvPr id="8" name="Annotation-alignment"/>
+          <p:cNvSpPr txBox="1"/>
+          <p:nvPr/>
+        </p:nvSpPr>
+        <p:spPr>
+          <a:xfrm>
+            <a:off x="274320" y="6181344"/>
+            <a:ext cx="7818120" cy="585216"/>
           </a:xfrm>
           <a:prstGeom prst="rect">
             <a:avLst/>
           </a:prstGeom>
-          <a:solidFill>
-            <a:srgbClr val="8E6F3E"/>
-          </a:solidFill>
-          <a:ln>
-            <a:noFill/>
-          </a:ln>
-        </p:spPr>
-        <p:txBody>
-          <a:bodyPr wrap="square" lIns="27432" tIns="22860" rIns="27432" bIns="22860" anchor="ctr"/>
-          <a:lstStyle/>
-          <a:p>
-            <a:pPr algn="ctr">
-              <a:buNone/>
-            </a:pPr>
-            <a:r>
-              <a:rPr lang="en-US" sz="2000" b="1" i="0" dirty="0">
-                <a:solidFill>
-                  <a:srgbClr val="FFFFFF"/>
-                </a:solidFill>
-              </a:rPr>
-              <a:t>What makes a result acceptable?</a:t>
+          <a:noFill/>
+        </p:spPr>
+        <p:txBody>
+          <a:bodyPr wrap="square" lIns="0" rIns="0" tIns="0" bIns="0">
+            <a:spAutoFit/>
+          </a:bodyPr>
+          <a:lstStyle/>
+          <a:p>
+            <a:r>
+              <a:rPr sz="2000" b="1" i="0">
+                <a:solidFill>
+                  <a:srgbClr val="9A3F12"/>
+                </a:solidFill>
+              </a:rPr>
+              <a:t>Alignment</a:t>
+            </a:r>
+            <a:r>
+              <a:rPr sz="2000" b="0" i="0">
+                <a:solidFill>
+                  <a:srgbClr val="5C4826"/>
+                </a:solidFill>
+              </a:rPr>
+              <a:t> raises the probability of an accepted implementation being correct by checking the realization against the obligation.</a:t>
             </a:r>
           </a:p>
         </p:txBody>

</xml_diff>

<commit_message>
deck 2-3 slide 27: the activity becomes a return to the lab
Replace the Controller/IController toy scenario (obligations card + given-model
card) with the two models the class built in the Modeling lab — DEVICE FIRMWARE
(working memory view) and THREAD ADMISSION CONTROL (lifecycle view) — reprising
slide 23's own card treatment, compacted to the left half. Right: choose one
obligation from the lab + five design questions (violate / prevent-or-detect /
evidence / earliest decidable boundary / consequence). Footer takeaway:
MODEL -> CHECK -> DECIDE -> CONTROL. TEAM ACTIVITY marker kept; worksheet
guidance retained in the notes. In Modeling they built the model; now they use
it as an independent validation surface.
</commit_message>
<xml_diff>
--- a/course/lectures/act-2-delegation-and-control/03-alignment/2-3-Alignment.pptx
+++ b/course/lectures/act-2-delegation-and-control/03-alignment/2-3-Alignment.pptx
@@ -1298,42 +1298,27 @@
           </a:p>
           <a:p>
             <a:r>
-              <a:t>- This slide is now the section transition (the SECTION 6 divider was cut) — the activity title itself is the transition. Setup line: enough vocabulary; now use it.</a:t>
-            </a:r>
-          </a:p>
-          <a:p>
-            <a:r>
-              <a:t>- Scenario (spoken, no longer on the slide): an agent is modifying an embedded controller — the SAME domain as the lab's sensor node, so read this as a continuation, not a new scenario.</a:t>
-            </a:r>
-          </a:p>
-          <a:p>
-            <a:r>
-              <a:t>- Four obligations: API preservation, a memory bound, a forbidden dependency, and cycle ordering.</a:t>
-            </a:r>
-          </a:p>
-          <a:p>
-            <a:r>
-              <a:t>- The model is given on the right — the same two kinds the class built in the lab. Structural facts support static checks: the API, the dependency facts (including the forbidden one), and the memory bound. The behavioral ordering defines what to observe at runtime: the cycle.</a:t>
-            </a:r>
-          </a:p>
-          <a:p>
-            <a:r>
-              <a:t>- Use the model as given — do not spend the activity rediscovering it from the implementation.</a:t>
-            </a:r>
-          </a:p>
-          <a:p>
-            <a:r>
-              <a:t>- Teams should ask, per obligation, which side of the model makes the relevant fact explicit — that feeds the MODEL USE question in the worksheet sequence below.</a:t>
-            </a:r>
-          </a:p>
-          <a:p>
-            <a:r>
-              <a:t>- Your job: design the delegated process and its controls.</a:t>
-            </a:r>
-          </a:p>
-          <a:p>
-            <a:r>
-              <a:t>WORKSHEET (was its own slide; keep this slide up while teams work and walk it aloud):</a:t>
+              <a:t>- This slide is the section transition — the activity title itself is the transition. Setup line: enough vocabulary; now use it.</a:t>
+            </a:r>
+          </a:p>
+          <a:p>
+            <a:r>
+              <a:t>- This is unmistakably a RETURN TO THE LAB, not a new scenario: the two model cards on the left are the two models the class built in the Modeling lab and saw four slides ago (the working-memory view and the lifecycle view of the sensor node). In Modeling, they built and used the model; now they use that same model as an independent validation surface.</a:t>
+            </a:r>
+          </a:p>
+          <a:p>
+            <a:r>
+              <a:t>- This lands the Modeling deck's own message that models constrain implementation without determining it: we left realization choices free; now we check that the chosen realization still satisfies what the model preserved.</a:t>
+            </a:r>
+          </a:p>
+          <a:p>
+            <a:r>
+              <a:t>- Teams choose ONE obligation from the lab — the 48 KB device ceiling, the at-most-two-awake admission rule, a per-thread working-memory maximum — and walk the five questions on the right.</a:t>
+            </a:r>
+          </a:p>
+          <a:p>
+            <a:r>
+              <a:t>WORKSHEET (keep this slide up while teams work and walk it aloud):</a:t>
             </a:r>
           </a:p>
           <a:p>
@@ -1343,22 +1328,17 @@
           </a:p>
           <a:p>
             <a:r>
-              <a:t>- Grouped as three questions. WHAT MUST HOLD: name the failure, state the obligation, and — new since the lab — ask what fact the model makes explicit, and whether you would validate it statically or dynamically.</a:t>
-            </a:r>
-          </a:p>
-          <a:p>
-            <a:r>
-              <a:t>- HOW WILL WE KNOW: prevent or detect, what observation establishes it, and at which boundary enough information exists.</a:t>
-            </a:r>
-          </a:p>
-          <a:p>
-            <a:r>
-              <a:t>- WHAT WILL IT CONTROL: which mechanism plays the role (constraint · sensor · validator · gate), and what authority the verdict carries.</a:t>
-            </a:r>
-          </a:p>
-          <a:p>
-            <a:r>
-              <a:t>- Teams should be ready to defend their boundary and authority choices.</a:t>
+              <a:t>- The five numbered questions walk that sequence: failure mode; prevent or detect; evidence; earliest decidable boundary; consequence of a failed check. Teams should also ask which of the two views makes the relevant fact explicit, and whether they would validate it statically or dynamically.</a:t>
+            </a:r>
+          </a:p>
+          <a:p>
+            <a:r>
+              <a:t>- Teams should be ready to defend their boundary choices and what authority the verdict carries.</a:t>
+            </a:r>
+          </a:p>
+          <a:p>
+            <a:r>
+              <a:t>- Takeaway strip: MODEL → CHECK → DECIDE → CONTROL.</a:t>
             </a:r>
           </a:p>
         </p:txBody>
@@ -16138,7 +16118,12 @@
             <p:ph type="title"/>
           </p:nvPr>
         </p:nvSpPr>
-        <p:spPr/>
+        <p:spPr>
+          <a:xfrm>
+            <a:off x="274320" y="18288"/>
+            <a:ext cx="8046720" cy="731520"/>
+          </a:xfrm>
+        </p:spPr>
         <p:txBody>
           <a:bodyPr wrap="square"/>
           <a:lstStyle/>
@@ -16149,7 +16134,17 @@
                   <a:srgbClr val="000000"/>
                 </a:solidFill>
               </a:rPr>
-              <a:t>Design the Alignment</a:t>
+              <a:t>Back to the lab:</a:t>
+            </a:r>
+          </a:p>
+          <a:p>
+            <a:r>
+              <a:rPr sz="2400" b="0">
+                <a:solidFill>
+                  <a:srgbClr val="000000"/>
+                </a:solidFill>
+              </a:rPr>
+              <a:t>design the Alignment</a:t>
             </a:r>
           </a:p>
         </p:txBody>
@@ -16271,21 +16266,21 @@
                   <a:srgbClr val="FFFFFF"/>
                 </a:solidFill>
               </a:rPr>
-              <a:t>Design the delegated process and its controls. Use the model as given.</a:t>
-            </a:r>
-          </a:p>
-        </p:txBody>
-      </p:sp>
-      <p:sp>
-        <p:nvSpPr>
-          <p:cNvPr id="901" name="Card-obligations"/>
+              <a:t>MODEL  →  CHECK  →  DECIDE  →  CONTROL</a:t>
+            </a:r>
+          </a:p>
+        </p:txBody>
+      </p:sp>
+      <p:sp>
+        <p:nvSpPr>
+          <p:cNvPr id="13" name="Card-memory"/>
           <p:cNvSpPr/>
           <p:nvPr/>
         </p:nvSpPr>
         <p:spPr>
           <a:xfrm>
             <a:off x="274320" y="1051560"/>
-            <a:ext cx="4160520" cy="4526280"/>
+            <a:ext cx="4069080" cy="2103120"/>
           </a:xfrm>
           <a:prstGeom prst="rect">
             <a:avLst/>
@@ -16313,7 +16308,23 @@
                   <a:srgbClr val="5C4826"/>
                 </a:solidFill>
               </a:rPr>
-              <a:t>OBLIGATIONS</a:t>
+              <a:t>DEVICE FIRMWARE</a:t>
+            </a:r>
+          </a:p>
+          <a:p>
+            <a:pPr algn="ctr">
+              <a:spcBef>
+                <a:spcPts val="900"/>
+              </a:spcBef>
+              <a:buNone/>
+            </a:pPr>
+            <a:r>
+              <a:rPr lang="en-US" sz="2000" b="0" i="1" dirty="0">
+                <a:solidFill>
+                  <a:srgbClr val="555960"/>
+                </a:solidFill>
+              </a:rPr>
+              <a:t>working memory view</a:t>
             </a:r>
           </a:p>
           <a:p>
@@ -16324,20 +16335,12 @@
               <a:buNone/>
             </a:pPr>
             <a:r>
-              <a:rPr lang="en-US" sz="2000" b="1" i="0" dirty="0">
-                <a:solidFill>
-                  <a:srgbClr val="8E6F3E"/>
-                </a:solidFill>
-              </a:rPr>
-              <a:t xml:space="preserve">1  ·  </a:t>
-            </a:r>
-            <a:r>
               <a:rPr lang="en-US" sz="2000" b="0" i="0" dirty="0">
                 <a:solidFill>
                   <a:srgbClr val="5C4826"/>
                 </a:solidFill>
               </a:rPr>
-              <a:t>Preserve the external API.</a:t>
+              <a:t>Sense · Analyze · Transmit</a:t>
             </a:r>
           </a:p>
           <a:p>
@@ -16348,20 +16351,12 @@
               <a:buNone/>
             </a:pPr>
             <a:r>
-              <a:rPr lang="en-US" sz="2000" b="1" i="0" dirty="0">
-                <a:solidFill>
-                  <a:srgbClr val="8E6F3E"/>
-                </a:solidFill>
-              </a:rPr>
-              <a:t xml:space="preserve">2  ·  </a:t>
-            </a:r>
-            <a:r>
               <a:rPr lang="en-US" sz="2000" b="0" i="0" dirty="0">
                 <a:solidFill>
                   <a:srgbClr val="5C4826"/>
                 </a:solidFill>
               </a:rPr>
-              <a:t>Worst-case memory below 64 MB.</a:t>
+              <a:t>max working memory 24 / 32 / 24 KB</a:t>
             </a:r>
           </a:p>
           <a:p>
@@ -16372,58 +16367,26 @@
               <a:buNone/>
             </a:pPr>
             <a:r>
-              <a:rPr lang="en-US" sz="2000" b="1" i="0" dirty="0">
-                <a:solidFill>
-                  <a:srgbClr val="8E6F3E"/>
-                </a:solidFill>
-              </a:rPr>
-              <a:t xml:space="preserve">3  ·  </a:t>
-            </a:r>
-            <a:r>
               <a:rPr lang="en-US" sz="2000" b="0" i="0" dirty="0">
                 <a:solidFill>
                   <a:srgbClr val="5C4826"/>
                 </a:solidFill>
               </a:rPr>
-              <a:t>Avoid the forbidden dependency.</a:t>
-            </a:r>
-          </a:p>
-          <a:p>
-            <a:pPr algn="l">
-              <a:spcBef>
-                <a:spcPts val="900"/>
-              </a:spcBef>
-              <a:buNone/>
-            </a:pPr>
-            <a:r>
-              <a:rPr lang="en-US" sz="2000" b="1" i="0" dirty="0">
-                <a:solidFill>
-                  <a:srgbClr val="8E6F3E"/>
-                </a:solidFill>
-              </a:rPr>
-              <a:t xml:space="preserve">4  ·  </a:t>
-            </a:r>
-            <a:r>
-              <a:rPr lang="en-US" sz="2000" b="0" i="0" dirty="0">
-                <a:solidFill>
-                  <a:srgbClr val="5C4826"/>
-                </a:solidFill>
-              </a:rPr>
-              <a:t>Preserve the cycle ordering: Sensor.read → decide → Actuator.act.</a:t>
-            </a:r>
-          </a:p>
-        </p:txBody>
-      </p:sp>
-      <p:sp>
-        <p:nvSpPr>
-          <p:cNvPr id="902" name="Card-given-model"/>
+              <a:t>device ceiling 48 KB</a:t>
+            </a:r>
+          </a:p>
+        </p:txBody>
+      </p:sp>
+      <p:sp>
+        <p:nvSpPr>
+          <p:cNvPr id="14" name="Card-control"/>
           <p:cNvSpPr/>
           <p:nvPr/>
         </p:nvSpPr>
         <p:spPr>
           <a:xfrm>
-            <a:off x="4617720" y="1051560"/>
-            <a:ext cx="4251960" cy="4526280"/>
+            <a:off x="274320" y="3291840"/>
+            <a:ext cx="4069080" cy="2103120"/>
           </a:xfrm>
           <a:prstGeom prst="rect">
             <a:avLst/>
@@ -16451,7 +16414,23 @@
                   <a:srgbClr val="5C4826"/>
                 </a:solidFill>
               </a:rPr>
-              <a:t>THE GIVEN MODEL</a:t>
+              <a:t>THREAD ADMISSION CONTROL</a:t>
+            </a:r>
+          </a:p>
+          <a:p>
+            <a:pPr algn="ctr">
+              <a:spcBef>
+                <a:spcPts val="900"/>
+              </a:spcBef>
+              <a:buNone/>
+            </a:pPr>
+            <a:r>
+              <a:rPr lang="en-US" sz="2000" b="0" i="1" dirty="0">
+                <a:solidFill>
+                  <a:srgbClr val="555960"/>
+                </a:solidFill>
+              </a:rPr>
+              <a:t>lifecycle view</a:t>
             </a:r>
           </a:p>
           <a:p>
@@ -16462,12 +16441,12 @@
               <a:buNone/>
             </a:pPr>
             <a:r>
-              <a:rPr lang="en-US" sz="2000" b="1" i="0" dirty="0">
-                <a:solidFill>
-                  <a:srgbClr val="8E6F3E"/>
-                </a:solidFill>
-              </a:rPr>
-              <a:t>STRUCTURE</a:t>
+              <a:rPr lang="en-US" sz="2000" b="0" i="0" dirty="0">
+                <a:solidFill>
+                  <a:srgbClr val="5C4826"/>
+                </a:solidFill>
+              </a:rPr>
+              <a:t>each thread: Asleep ⇄ Awake</a:t>
             </a:r>
           </a:p>
           <a:p>
@@ -16483,7 +16462,49 @@
                   <a:srgbClr val="5C4826"/>
                 </a:solidFill>
               </a:rPr>
-              <a:t>Controller — API: IController</a:t>
+              <a:t>the Scheduler admits at most two threads awake</a:t>
+            </a:r>
+          </a:p>
+        </p:txBody>
+      </p:sp>
+      <p:sp>
+        <p:nvSpPr>
+          <p:cNvPr id="15" name="Card-prompt"/>
+          <p:cNvSpPr/>
+          <p:nvPr/>
+        </p:nvSpPr>
+        <p:spPr>
+          <a:xfrm>
+            <a:off x="4526280" y="1051560"/>
+            <a:ext cx="4343400" cy="4343400"/>
+          </a:xfrm>
+          <a:prstGeom prst="rect">
+            <a:avLst/>
+          </a:prstGeom>
+          <a:solidFill>
+            <a:srgbClr val="F5F1E8"/>
+          </a:solidFill>
+          <a:ln w="12700">
+            <a:solidFill>
+              <a:srgbClr val="C9B991"/>
+            </a:solidFill>
+          </a:ln>
+          <a:effectLst/>
+        </p:spPr>
+        <p:txBody>
+          <a:bodyPr rtlCol="0" anchor="t" wrap="square" lIns="27432" rIns="27432" tIns="22860" bIns="22860"/>
+          <a:lstStyle/>
+          <a:p>
+            <a:pPr algn="l">
+              <a:buNone/>
+            </a:pPr>
+            <a:r>
+              <a:rPr lang="en-US" sz="2000" b="1" i="0" dirty="0">
+                <a:solidFill>
+                  <a:srgbClr val="5C4826"/>
+                </a:solidFill>
+              </a:rPr>
+              <a:t>Choose one obligation from the lab.</a:t>
             </a:r>
           </a:p>
           <a:p>
@@ -16499,7 +16520,7 @@
                   <a:srgbClr val="5C4826"/>
                 </a:solidFill>
               </a:rPr>
-              <a:t>uses → Sensor · Actuator</a:t>
+              <a:t>1  ·  How could the realization violate it?</a:t>
             </a:r>
           </a:p>
           <a:p>
@@ -16515,7 +16536,7 @@
                   <a:srgbClr val="5C4826"/>
                 </a:solidFill>
               </a:rPr>
-              <a:t>forbidden → CloudSDK</a:t>
+              <a:t>2  ·  Can you prevent that failure, or must you detect it?</a:t>
             </a:r>
           </a:p>
           <a:p>
@@ -16531,7 +16552,7 @@
                   <a:srgbClr val="5C4826"/>
                 </a:solidFill>
               </a:rPr>
-              <a:t>memory ≤ 64 MB</a:t>
+              <a:t>3  ·  What evidence would let you decide?</a:t>
             </a:r>
           </a:p>
           <a:p>
@@ -16542,12 +16563,12 @@
               <a:buNone/>
             </a:pPr>
             <a:r>
-              <a:rPr lang="en-US" sz="2000" b="1" i="0" dirty="0">
-                <a:solidFill>
-                  <a:srgbClr val="8E6F3E"/>
-                </a:solidFill>
-              </a:rPr>
-              <a:t>BEHAVIOR</a:t>
+              <a:rPr lang="en-US" sz="2000" b="0" i="0" dirty="0">
+                <a:solidFill>
+                  <a:srgbClr val="5C4826"/>
+                </a:solidFill>
+              </a:rPr>
+              <a:t>4  ·  Where is the earliest boundary at which it is decidable?</a:t>
             </a:r>
           </a:p>
           <a:p>
@@ -16563,7 +16584,7 @@
                   <a:srgbClr val="5C4826"/>
                 </a:solidFill>
               </a:rPr>
-              <a:t>each cycle: Sensor.read → decide → Actuator.act</a:t>
+              <a:t>5  ·  What should happen if the check fails?</a:t>
             </a:r>
           </a:p>
         </p:txBody>

</xml_diff>

<commit_message>
deck 2-3 slide 22: notes set Section 5 intent — use the model, not analyze it
Co-Authored-By: Claude Opus 5 <noreply@anthropic.com>
</commit_message>
<xml_diff>
--- a/course/lectures/act-2-delegation-and-control/03-alignment/2-3-Alignment.pptx
+++ b/course/lectures/act-2-delegation-and-control/03-alignment/2-3-Alignment.pptx
@@ -2131,6 +2131,16 @@
           <a:p>
             <a:r>
               <a:t>- We will use the two models the class built in the Modeling lab — not a new example.</a:t>
+            </a:r>
+          </a:p>
+          <a:p>
+            <a:r>
+              <a:t>- We are no longer asking how to build or analyze a model. We already did that in Modeling. We are asking how an existing model can participate in Alignment.</a:t>
+            </a:r>
+          </a:p>
+          <a:p>
+            <a:r>
+              <a:t>- That distinction governs the next several slides.</a:t>
             </a:r>
           </a:p>
         </p:txBody>

</xml_diff>

<commit_message>
deck 2-3 slide 23: payoff strip — a model becomes a validation surface; transition notes
Co-Authored-By: Claude Opus 5 <noreply@anthropic.com>
</commit_message>
<xml_diff>
--- a/course/lectures/act-2-delegation-and-control/03-alignment/2-3-Alignment.pptx
+++ b/course/lectures/act-2-delegation-and-control/03-alignment/2-3-Alignment.pptx
@@ -2215,6 +2215,11 @@
           </a:p>
           <a:p>
             <a:r>
+              <a:t>- Last time, we asked what questions these models let us answer. Today the model is already here. The question is: how can we use it to decide whether something the agent built or did is acceptable?</a:t>
+            </a:r>
+          </a:p>
+          <a:p>
+            <a:r>
               <a:t>- These are the two models the class built in the Modeling lab: the sensor node with Sense, Analyze, and Transmit threads and a Scheduler.</a:t>
             </a:r>
           </a:p>
@@ -2245,7 +2250,7 @@
           </a:p>
           <a:p>
             <a:r>
-              <a:t>- The VALIDATION SURFACE strip at the bottom is the answer — reveal it after they talk.</a:t>
+              <a:t>- The payoff strip under the cards is the answer — reveal it after they talk.</a:t>
             </a:r>
           </a:p>
           <a:p>
@@ -2265,7 +2270,7 @@
           </a:p>
           <a:p>
             <a:r>
-              <a:t>- Spoken gloss for the strip label: models give validation mechanisms an explicit object to inspect — that is why the strip is labeled VALIDATION SURFACE.</a:t>
+              <a:t>- Spoken gloss for the strip: models give validation mechanisms an explicit object to inspect — that is what makes a model a validation surface.</a:t>
             </a:r>
           </a:p>
         </p:txBody>
@@ -14477,7 +14482,7 @@
         <p:spPr>
           <a:xfrm>
             <a:off x="274320" y="1051560"/>
-            <a:ext cx="4206239" cy="3429000"/>
+            <a:ext cx="4206239" cy="3063240"/>
           </a:xfrm>
           <a:prstGeom prst="rect">
             <a:avLst/>
@@ -14599,7 +14604,7 @@
         <p:spPr>
           <a:xfrm>
             <a:off x="4663440" y="1051560"/>
-            <a:ext cx="4206239" cy="3429000"/>
+            <a:ext cx="4206239" cy="3063240"/>
           </a:xfrm>
           <a:prstGeom prst="rect">
             <a:avLst/>
@@ -14708,6 +14713,48 @@
                 </a:solidFill>
               </a:rPr>
               <a:t>omits: what any thread costs in working memory</a:t>
+            </a:r>
+          </a:p>
+        </p:txBody>
+      </p:sp>
+      <p:sp>
+        <p:nvSpPr>
+          <p:cNvPr id="9" name="PayoffBand"/>
+          <p:cNvSpPr/>
+          <p:nvPr/>
+        </p:nvSpPr>
+        <p:spPr>
+          <a:xfrm>
+            <a:off x="274320" y="4206240"/>
+            <a:ext cx="8595360" cy="655320"/>
+          </a:xfrm>
+          <a:prstGeom prst="rect">
+            <a:avLst/>
+          </a:prstGeom>
+          <a:solidFill>
+            <a:srgbClr val="F5F1E8"/>
+          </a:solidFill>
+          <a:ln w="12700">
+            <a:solidFill>
+              <a:srgbClr val="C9B991"/>
+            </a:solidFill>
+          </a:ln>
+          <a:effectLst/>
+        </p:spPr>
+        <p:txBody>
+          <a:bodyPr wrap="square" lIns="27432" tIns="22860" rIns="27432" bIns="22860" rtlCol="0" anchor="ctr"/>
+          <a:lstStyle/>
+          <a:p>
+            <a:pPr algn="ctr">
+              <a:buNone/>
+            </a:pPr>
+            <a:r>
+              <a:rPr lang="en-US" sz="2000" b="1" i="0" dirty="0">
+                <a:solidFill>
+                  <a:srgbClr val="5C4826"/>
+                </a:solidFill>
+              </a:rPr>
+              <a:t>A model becomes a validation surface when a realization can be checked against what the model makes explicit.</a:t>
             </a:r>
           </a:p>
         </p:txBody>

</xml_diff>

<commit_message>
deck 2-3 slide 24: REPLACE model-analysis slide with model-vs-realization CHECK diagram
Old slide asked questions answered by analyzing the model (Modeling, not
Alignment). New slide introduces REALIZATION and the correspondence check;
OBLIGATION deliberately withheld until the triangle.

Co-Authored-By: Claude Opus 5 <noreply@anthropic.com>
</commit_message>
<xml_diff>
--- a/course/lectures/act-2-delegation-and-control/03-alignment/2-3-Alignment.pptx
+++ b/course/lectures/act-2-delegation-and-control/03-alignment/2-3-Alignment.pptx
@@ -2345,17 +2345,27 @@
           </a:p>
           <a:p>
             <a:r>
-              <a:t>- Static validation: a verdict decided over the model itself, before any execution.</a:t>
-            </a:r>
-          </a:p>
-          <a:p>
-            <a:r>
-              <a:t>- Ground each question in the lab. 'Can admitted threads exceed the memory ceiling?' is the budget query: peak working memory of admitted threads against the declared 48 KB ceiling — the query that reported 80 KB in Stage 1. 'Can three threads be Awake simultaneously?' is decided against the Scheduler's admission rule: at most two awake. 'Is an illegal lifecycle transition reachable?' asks for a transition the lifecycle machines do not declare.</a:t>
-            </a:r>
-          </a:p>
-          <a:p>
-            <a:r>
-              <a:t>- The payoff: once the structure is explicit, these stop being archaeology over code and become decidable queries.</a:t>
+              <a:t>- In Modeling, we could analyze this model and ask whether its own states permit three threads to be Awake. That's useful, but it's not Alignment yet.</a:t>
+            </a:r>
+          </a:p>
+          <a:p>
+            <a:r>
+              <a:t>- Here we have an implementation or execution produced by delegated work. Now the model gives us an explicit surface against which that realization can be checked.</a:t>
+            </a:r>
+          </a:p>
+          <a:p>
+            <a:r>
+              <a:t>- Walk the picture. The model says what should be true: the lifecycle, the memory bounds, the admission rule. The realization is what was actually built: source code, configuration, execution. The check asks whether the realization corresponds where the model matters.</a:t>
+            </a:r>
+          </a:p>
+          <a:p>
+            <a:r>
+              <a:t>- There are at least two broad ways to do that. We can inspect the realization without running it, or we can observe it executing.</a:t>
+            </a:r>
+          </a:p>
+          <a:p>
+            <a:r>
+              <a:t>- Do not introduce OBLIGATION yet; the triangle two slides ahead complicates this picture deliberately.</a:t>
             </a:r>
           </a:p>
         </p:txBody>
@@ -15007,7 +15017,7 @@
                   <a:srgbClr val="000000"/>
                 </a:solidFill>
               </a:rPr>
-              <a:t>Models support static validation</a:t>
+              <a:t>Models give us something to check against</a:t>
             </a:r>
           </a:p>
         </p:txBody>
@@ -15037,14 +15047,14 @@
       </p:sp>
       <p:sp>
         <p:nvSpPr>
-          <p:cNvPr id="2" name="St-MODEL"/>
+          <p:cNvPr id="2" name="Mr-MODEL"/>
           <p:cNvSpPr/>
           <p:nvPr/>
         </p:nvSpPr>
         <p:spPr>
           <a:xfrm>
             <a:off x="502920" y="1005840"/>
-            <a:ext cx="1828800" cy="640080"/>
+            <a:ext cx="3200400" cy="640080"/>
           </a:xfrm>
           <a:prstGeom prst="rect">
             <a:avLst/>
@@ -15077,14 +15087,54 @@
       </p:sp>
       <p:sp>
         <p:nvSpPr>
-          <p:cNvPr id="5" name="St-ANALYSIS"/>
+          <p:cNvPr id="5" name="Mr-REALIZATION"/>
           <p:cNvSpPr/>
           <p:nvPr/>
         </p:nvSpPr>
         <p:spPr>
           <a:xfrm>
-            <a:off x="3291840" y="1005840"/>
-            <a:ext cx="2560320" cy="640080"/>
+            <a:off x="5440680" y="1005840"/>
+            <a:ext cx="3200400" cy="640080"/>
+          </a:xfrm>
+          <a:prstGeom prst="rect">
+            <a:avLst/>
+          </a:prstGeom>
+          <a:solidFill>
+            <a:srgbClr val="8E6F3E"/>
+          </a:solidFill>
+          <a:ln>
+            <a:noFill/>
+          </a:ln>
+          <a:effectLst/>
+        </p:spPr>
+        <p:txBody>
+          <a:bodyPr wrap="square" lIns="27432" tIns="22860" rIns="27432" bIns="22860" rtlCol="0" anchor="ctr"/>
+          <a:lstStyle/>
+          <a:p>
+            <a:pPr algn="ctr">
+              <a:buNone/>
+            </a:pPr>
+            <a:r>
+              <a:rPr lang="en-US" sz="2000" b="1" i="0" dirty="0">
+                <a:solidFill>
+                  <a:srgbClr val="FFFFFF"/>
+                </a:solidFill>
+              </a:rPr>
+              <a:t>REALIZATION</a:t>
+            </a:r>
+          </a:p>
+        </p:txBody>
+      </p:sp>
+      <p:sp>
+        <p:nvSpPr>
+          <p:cNvPr id="6" name="Mr-ModelCap"/>
+          <p:cNvSpPr/>
+          <p:nvPr/>
+        </p:nvSpPr>
+        <p:spPr>
+          <a:xfrm>
+            <a:off x="502920" y="1737360"/>
+            <a:ext cx="3200400" cy="1051560"/>
           </a:xfrm>
           <a:prstGeom prst="rect">
             <a:avLst/>
@@ -15107,110 +15157,42 @@
               <a:buNone/>
             </a:pPr>
             <a:r>
-              <a:rPr lang="en-US" sz="2000" b="1" i="0" dirty="0">
+              <a:rPr lang="en-US" sz="2000" b="0" i="1" dirty="0">
                 <a:solidFill>
                   <a:srgbClr val="5C4826"/>
                 </a:solidFill>
               </a:rPr>
-              <a:t>STATIC ANALYSIS</a:t>
-            </a:r>
-          </a:p>
-        </p:txBody>
-      </p:sp>
-      <p:sp>
-        <p:nvSpPr>
-          <p:cNvPr id="6" name="St-VERDICT"/>
+              <a:t>what should be true</a:t>
+            </a:r>
+          </a:p>
+          <a:p>
+            <a:pPr algn="ctr">
+              <a:spcBef>
+                <a:spcPts val="600"/>
+              </a:spcBef>
+              <a:buNone/>
+            </a:pPr>
+            <a:r>
+              <a:rPr lang="en-US" sz="2000" b="0" i="0" dirty="0">
+                <a:solidFill>
+                  <a:srgbClr val="5C4826"/>
+                </a:solidFill>
+              </a:rPr>
+              <a:t>lifecycle · memory bounds · admission rule</a:t>
+            </a:r>
+          </a:p>
+        </p:txBody>
+      </p:sp>
+      <p:sp>
+        <p:nvSpPr>
+          <p:cNvPr id="7" name="Mr-RealCap"/>
           <p:cNvSpPr/>
           <p:nvPr/>
         </p:nvSpPr>
         <p:spPr>
           <a:xfrm>
-            <a:off x="6812280" y="1005840"/>
-            <a:ext cx="1828800" cy="640080"/>
-          </a:xfrm>
-          <a:prstGeom prst="rect">
-            <a:avLst/>
-          </a:prstGeom>
-          <a:solidFill>
-            <a:srgbClr val="8E6F3E"/>
-          </a:solidFill>
-          <a:ln>
-            <a:noFill/>
-          </a:ln>
-          <a:effectLst/>
-        </p:spPr>
-        <p:txBody>
-          <a:bodyPr wrap="square" lIns="27432" tIns="22860" rIns="27432" bIns="22860" rtlCol="0" anchor="ctr"/>
-          <a:lstStyle/>
-          <a:p>
-            <a:pPr algn="ctr">
-              <a:buNone/>
-            </a:pPr>
-            <a:r>
-              <a:rPr lang="en-US" sz="2000" b="1" i="0" dirty="0">
-                <a:solidFill>
-                  <a:srgbClr val="FFFFFF"/>
-                </a:solidFill>
-              </a:rPr>
-              <a:t>VERDICT</a:t>
-            </a:r>
-          </a:p>
-        </p:txBody>
-      </p:sp>
-      <p:cxnSp>
-        <p:nvCxnSpPr>
-          <p:cNvPr id="7" name="St-A1"/>
-          <p:cNvCxnSpPr/>
-          <p:nvPr/>
-        </p:nvCxnSpPr>
-        <p:spPr>
-          <a:xfrm>
-            <a:off x="2331720" y="1325880"/>
-            <a:ext cx="960120" cy="0"/>
-          </a:xfrm>
-          <a:prstGeom prst="straightConnector1">
-            <a:avLst/>
-          </a:prstGeom>
-          <a:ln w="19050">
-            <a:solidFill>
-              <a:srgbClr val="8E6F3E"/>
-            </a:solidFill>
-            <a:tailEnd type="triangle"/>
-          </a:ln>
-        </p:spPr>
-      </p:cxnSp>
-      <p:cxnSp>
-        <p:nvCxnSpPr>
-          <p:cNvPr id="8" name="St-A2"/>
-          <p:cNvCxnSpPr/>
-          <p:nvPr/>
-        </p:nvCxnSpPr>
-        <p:spPr>
-          <a:xfrm>
-            <a:off x="5852160" y="1325880"/>
-            <a:ext cx="960120" cy="0"/>
-          </a:xfrm>
-          <a:prstGeom prst="straightConnector1">
-            <a:avLst/>
-          </a:prstGeom>
-          <a:ln w="19050">
-            <a:solidFill>
-              <a:srgbClr val="8E6F3E"/>
-            </a:solidFill>
-            <a:tailEnd type="triangle"/>
-          </a:ln>
-        </p:spPr>
-      </p:cxnSp>
-      <p:sp>
-        <p:nvSpPr>
-          <p:cNvPr id="9" name="St-Questions"/>
-          <p:cNvSpPr/>
-          <p:nvPr/>
-        </p:nvSpPr>
-        <p:spPr>
-          <a:xfrm>
-            <a:off x="502920" y="2103120"/>
-            <a:ext cx="8138160" cy="2377440"/>
+            <a:off x="5440680" y="1737360"/>
+            <a:ext cx="3200400" cy="1051560"/>
           </a:xfrm>
           <a:prstGeom prst="rect">
             <a:avLst/>
@@ -15226,25 +15208,25 @@
           <a:effectLst/>
         </p:spPr>
         <p:txBody>
-          <a:bodyPr wrap="square" lIns="27432" tIns="22860" rIns="27432" bIns="22860" rtlCol="0" anchor="t"/>
-          <a:lstStyle/>
-          <a:p>
-            <a:pPr algn="l">
+          <a:bodyPr wrap="square" lIns="27432" tIns="22860" rIns="27432" bIns="22860" rtlCol="0" anchor="ctr"/>
+          <a:lstStyle/>
+          <a:p>
+            <a:pPr algn="ctr">
               <a:buNone/>
             </a:pPr>
             <a:r>
-              <a:rPr lang="en-US" sz="2000" b="1" i="0" dirty="0">
+              <a:rPr lang="en-US" sz="2000" b="0" i="1" dirty="0">
                 <a:solidFill>
                   <a:srgbClr val="5C4826"/>
                 </a:solidFill>
               </a:rPr>
-              <a:t>Questions the lab model can already decide:</a:t>
-            </a:r>
-          </a:p>
-          <a:p>
-            <a:pPr algn="l">
+              <a:t>what was actually built</a:t>
+            </a:r>
+          </a:p>
+          <a:p>
+            <a:pPr algn="ctr">
               <a:spcBef>
-                <a:spcPts val="900"/>
+                <a:spcPts val="600"/>
               </a:spcBef>
               <a:buNone/>
             </a:pPr>
@@ -15254,13 +15236,99 @@
                   <a:srgbClr val="5C4826"/>
                 </a:solidFill>
               </a:rPr>
-              <a:t>Can admitted threads exceed the memory ceiling?</a:t>
-            </a:r>
-          </a:p>
-          <a:p>
-            <a:pPr algn="l">
+              <a:t>source code · configuration · execution</a:t>
+            </a:r>
+          </a:p>
+        </p:txBody>
+      </p:sp>
+      <p:cxnSp>
+        <p:nvCxnSpPr>
+          <p:cNvPr id="8" name="Mr-A1"/>
+          <p:cNvCxnSpPr/>
+          <p:nvPr/>
+        </p:nvCxnSpPr>
+        <p:spPr>
+          <a:xfrm>
+            <a:off x="2103120" y="2788920"/>
+            <a:ext cx="0" cy="301752"/>
+          </a:xfrm>
+          <a:prstGeom prst="straightConnector1">
+            <a:avLst/>
+          </a:prstGeom>
+          <a:ln w="19050">
+            <a:solidFill>
+              <a:srgbClr val="8E6F3E"/>
+            </a:solidFill>
+            <a:tailEnd type="triangle"/>
+          </a:ln>
+        </p:spPr>
+      </p:cxnSp>
+      <p:cxnSp>
+        <p:nvCxnSpPr>
+          <p:cNvPr id="9" name="Mr-A2"/>
+          <p:cNvCxnSpPr/>
+          <p:nvPr/>
+        </p:nvCxnSpPr>
+        <p:spPr>
+          <a:xfrm>
+            <a:off x="7040880" y="2788920"/>
+            <a:ext cx="0" cy="301752"/>
+          </a:xfrm>
+          <a:prstGeom prst="straightConnector1">
+            <a:avLst/>
+          </a:prstGeom>
+          <a:ln w="19050">
+            <a:solidFill>
+              <a:srgbClr val="8E6F3E"/>
+            </a:solidFill>
+            <a:tailEnd type="triangle"/>
+          </a:ln>
+        </p:spPr>
+      </p:cxnSp>
+      <p:sp>
+        <p:nvSpPr>
+          <p:cNvPr id="10" name="Mr-CHECK"/>
+          <p:cNvSpPr/>
+          <p:nvPr/>
+        </p:nvSpPr>
+        <p:spPr>
+          <a:xfrm>
+            <a:off x="1371600" y="3090672"/>
+            <a:ext cx="6400800" cy="868680"/>
+          </a:xfrm>
+          <a:prstGeom prst="rect">
+            <a:avLst/>
+          </a:prstGeom>
+          <a:solidFill>
+            <a:srgbClr val="F5F1E8"/>
+          </a:solidFill>
+          <a:ln w="12700">
+            <a:solidFill>
+              <a:srgbClr val="C9B991"/>
+            </a:solidFill>
+          </a:ln>
+          <a:effectLst/>
+        </p:spPr>
+        <p:txBody>
+          <a:bodyPr wrap="square" lIns="27432" tIns="22860" rIns="27432" bIns="22860" rtlCol="0" anchor="ctr"/>
+          <a:lstStyle/>
+          <a:p>
+            <a:pPr algn="ctr">
+              <a:buNone/>
+            </a:pPr>
+            <a:r>
+              <a:rPr lang="en-US" sz="2000" b="1" i="0" dirty="0">
+                <a:solidFill>
+                  <a:srgbClr val="5C4826"/>
+                </a:solidFill>
+              </a:rPr>
+              <a:t>CHECK</a:t>
+            </a:r>
+          </a:p>
+          <a:p>
+            <a:pPr algn="ctr">
               <a:spcBef>
-                <a:spcPts val="900"/>
+                <a:spcPts val="600"/>
               </a:spcBef>
               <a:buNone/>
             </a:pPr>
@@ -15270,37 +15338,43 @@
                   <a:srgbClr val="5C4826"/>
                 </a:solidFill>
               </a:rPr>
-              <a:t>Can three threads be Awake simultaneously?</a:t>
-            </a:r>
-          </a:p>
-          <a:p>
-            <a:pPr algn="l">
-              <a:spcBef>
-                <a:spcPts val="900"/>
-              </a:spcBef>
-              <a:buNone/>
-            </a:pPr>
-            <a:r>
-              <a:rPr lang="en-US" sz="2000" b="0" i="0" dirty="0">
-                <a:solidFill>
-                  <a:srgbClr val="5C4826"/>
-                </a:solidFill>
-              </a:rPr>
-              <a:t>Is an illegal lifecycle transition reachable?</a:t>
-            </a:r>
-          </a:p>
-        </p:txBody>
-      </p:sp>
-      <p:sp>
-        <p:nvSpPr>
-          <p:cNvPr id="10" name="FooterBand"/>
+              <a:t>Does the realization correspond where the model matters?</a:t>
+            </a:r>
+          </a:p>
+        </p:txBody>
+      </p:sp>
+      <p:cxnSp>
+        <p:nvCxnSpPr>
+          <p:cNvPr id="11" name="Mr-A3"/>
+          <p:cNvCxnSpPr/>
+          <p:nvPr/>
+        </p:nvCxnSpPr>
+        <p:spPr>
+          <a:xfrm>
+            <a:off x="4572000" y="3959352"/>
+            <a:ext cx="0" cy="301752"/>
+          </a:xfrm>
+          <a:prstGeom prst="straightConnector1">
+            <a:avLst/>
+          </a:prstGeom>
+          <a:ln w="19050">
+            <a:solidFill>
+              <a:srgbClr val="8E6F3E"/>
+            </a:solidFill>
+            <a:tailEnd type="triangle"/>
+          </a:ln>
+        </p:spPr>
+      </p:cxnSp>
+      <p:sp>
+        <p:nvSpPr>
+          <p:cNvPr id="12" name="Mr-VERDICT"/>
           <p:cNvSpPr/>
           <p:nvPr/>
         </p:nvSpPr>
         <p:spPr>
           <a:xfrm>
-            <a:off x="274320" y="5760720"/>
-            <a:ext cx="8595360" cy="594360"/>
+            <a:off x="3657600" y="4261104"/>
+            <a:ext cx="1828800" cy="640080"/>
           </a:xfrm>
           <a:prstGeom prst="rect">
             <a:avLst/>
@@ -15326,7 +15400,47 @@
                   <a:srgbClr val="FFFFFF"/>
                 </a:solidFill>
               </a:rPr>
-              <a:t>Explicit structure can turn repeated reconstruction into a decidable query.</a:t>
+              <a:t>VERDICT</a:t>
+            </a:r>
+          </a:p>
+        </p:txBody>
+      </p:sp>
+      <p:sp>
+        <p:nvSpPr>
+          <p:cNvPr id="13" name="FooterBand"/>
+          <p:cNvSpPr/>
+          <p:nvPr/>
+        </p:nvSpPr>
+        <p:spPr>
+          <a:xfrm>
+            <a:off x="274320" y="5577840"/>
+            <a:ext cx="8595360" cy="777240"/>
+          </a:xfrm>
+          <a:prstGeom prst="rect">
+            <a:avLst/>
+          </a:prstGeom>
+          <a:solidFill>
+            <a:srgbClr val="8E6F3E"/>
+          </a:solidFill>
+          <a:ln>
+            <a:noFill/>
+          </a:ln>
+          <a:effectLst/>
+        </p:spPr>
+        <p:txBody>
+          <a:bodyPr wrap="square" lIns="27432" tIns="22860" rIns="27432" bIns="22860" rtlCol="0" anchor="ctr"/>
+          <a:lstStyle/>
+          <a:p>
+            <a:pPr algn="ctr">
+              <a:buNone/>
+            </a:pPr>
+            <a:r>
+              <a:rPr lang="en-US" sz="2000" b="1" i="0" dirty="0">
+                <a:solidFill>
+                  <a:srgbClr val="FFFFFF"/>
+                </a:solidFill>
+              </a:rPr>
+              <a:t>The model makes expected structure or behavior explicit so the realization can be checked against it.</a:t>
             </a:r>
           </a:p>
         </p:txBody>

</xml_diff>

<commit_message>
deck 2-3: NEW slide 25 — Check correspondence statically (deck 30 -> 31 slides)
Static-check sibling of the dynamic slide: MODEL + REALIZATION converge into
a STATIC CHECK band; three lab-grounded questions; takeaway pins that static
evidence establishes correspondence without execution.

Co-Authored-By: Claude Opus 5 <noreply@anthropic.com>
</commit_message>
<xml_diff>
--- a/course/lectures/act-2-delegation-and-control/03-alignment/2-3-Alignment.pptx
+++ b/course/lectures/act-2-delegation-and-control/03-alignment/2-3-Alignment.pptx
@@ -32,6 +32,7 @@
     <p:sldId id="288" r:id="rId23"/>
     <p:sldId id="307" r:id="rId24"/>
     <p:sldId id="308" r:id="rId25"/>
+    <p:sldId id="311" r:id="rId37"/>
     <p:sldId id="309" r:id="rId26"/>
     <p:sldId id="281" r:id="rId27"/>
     <p:sldId id="310" r:id="rId28"/>
@@ -3215,6 +3216,101 @@
           <a:p>
             <a:r>
               <a:t>- Leave the final question, "Should failure control what happens next?", as the last reveal and final image of the lecture.</a:t>
+            </a:r>
+          </a:p>
+        </p:txBody>
+      </p:sp>
+      <p:sp>
+        <p:nvSpPr>
+          <p:cNvPr id="4" name="Slide Number Placeholder 3"/>
+          <p:cNvSpPr>
+            <a:spLocks noGrp="1"/>
+          </p:cNvSpPr>
+          <p:nvPr>
+            <p:ph type="sldNum" sz="quarter" idx="5"/>
+          </p:nvPr>
+        </p:nvSpPr>
+        <p:spPr/>
+      </p:sp>
+    </p:spTree>
+  </p:cSld>
+  <p:clrMapOvr>
+    <a:masterClrMapping/>
+  </p:clrMapOvr>
+</p:notes>
+</file>
+
+<file path=ppt/notesSlides/notesSlide31.xml><?xml version="1.0" encoding="utf-8"?>
+<p:notes xmlns:a="http://schemas.openxmlformats.org/drawingml/2006/main" xmlns:r="http://schemas.openxmlformats.org/officeDocument/2006/relationships" xmlns:p="http://schemas.openxmlformats.org/presentationml/2006/main">
+  <p:cSld>
+    <p:spTree>
+      <p:nvGrpSpPr>
+        <p:cNvPr id="1" name=""/>
+        <p:cNvGrpSpPr/>
+        <p:nvPr/>
+      </p:nvGrpSpPr>
+      <p:grpSpPr>
+        <a:xfrm>
+          <a:off x="0" y="0"/>
+          <a:ext cx="0" cy="0"/>
+          <a:chOff x="0" y="0"/>
+          <a:chExt cx="0" cy="0"/>
+        </a:xfrm>
+      </p:grpSpPr>
+      <p:sp>
+        <p:nvSpPr>
+          <p:cNvPr id="2" name="Slide Image Placeholder 1"/>
+          <p:cNvSpPr>
+            <a:spLocks noGrp="1" noRot="1" noChangeAspect="1"/>
+          </p:cNvSpPr>
+          <p:nvPr>
+            <p:ph type="sldImg" idx="2"/>
+          </p:nvPr>
+        </p:nvSpPr>
+        <p:spPr/>
+      </p:sp>
+      <p:sp>
+        <p:nvSpPr>
+          <p:cNvPr id="3" name="Notes Placeholder 2"/>
+          <p:cNvSpPr>
+            <a:spLocks noGrp="1"/>
+          </p:cNvSpPr>
+          <p:nvPr>
+            <p:ph type="body" sz="quarter" idx="3"/>
+          </p:nvPr>
+        </p:nvSpPr>
+        <p:spPr/>
+        <p:txBody>
+          <a:bodyPr/>
+          <a:lstStyle/>
+          <a:p>
+            <a:r>
+              <a:t>TIMING: 3 minutes</a:t>
+            </a:r>
+          </a:p>
+          <a:p>
+            <a:r>
+              <a:t>- The first broad way: inspect the realization without executing it.</a:t>
+            </a:r>
+          </a:p>
+          <a:p>
+            <a:r>
+              <a:t>- Say 'static check', not 'static analysis'. 'Static check' is broader and more accurate: correspondence could be established by AST queries, architectural conformance, type checking, dependency checking, conventional static analysis, and more.</a:t>
+            </a:r>
+          </a:p>
+          <a:p>
+            <a:r>
+              <a:t>- Ground each question in the lab. 'Can any code path admit a third Awake thread?' checks the code against the admission rule the class modeled — at most two awake. 'Does the implementation permit a lifecycle transition absent from the model?' checks the code's transitions against the modeled lifecycle. 'Do implementation resource bounds agree with the modeled bounds?' checks declared limits against the per-thread working-memory maxima and the 48 KB ceiling.</a:t>
+            </a:r>
+          </a:p>
+          <a:p>
+            <a:r>
+              <a:t>- Note what each question interrogates: the REALIZATION, against what the model makes explicit. We are not analyzing the model; we are using it.</a:t>
+            </a:r>
+          </a:p>
+          <a:p>
+            <a:r>
+              <a:t>- Careful claim: a green verdict proves neither the model nor the implementation correct. It establishes the selected correspondence property we checked — nothing more. 'Agreement is not correctness', two slides from now, exposes that limitation deliberately.</a:t>
             </a:r>
           </a:p>
         </p:txBody>
@@ -18475,6 +18571,540 @@
                 </a:solidFill>
               </a:rPr>
               <a:t>Should failure control what happens next?</a:t>
+            </a:r>
+          </a:p>
+        </p:txBody>
+      </p:sp>
+    </p:spTree>
+  </p:cSld>
+  <p:clrMapOvr>
+    <a:masterClrMapping/>
+  </p:clrMapOvr>
+</p:sld>
+</file>
+
+<file path=ppt/slides/slide31.xml><?xml version="1.0" encoding="utf-8"?>
+<p:sld xmlns:a="http://schemas.openxmlformats.org/drawingml/2006/main" xmlns:r="http://schemas.openxmlformats.org/officeDocument/2006/relationships" xmlns:p="http://schemas.openxmlformats.org/presentationml/2006/main">
+  <p:cSld>
+    <p:spTree>
+      <p:nvGrpSpPr>
+        <p:cNvPr id="1" name=""/>
+        <p:cNvGrpSpPr/>
+        <p:nvPr/>
+      </p:nvGrpSpPr>
+      <p:grpSpPr>
+        <a:xfrm>
+          <a:off x="0" y="0"/>
+          <a:ext cx="0" cy="0"/>
+          <a:chOff x="0" y="0"/>
+          <a:chExt cx="0" cy="0"/>
+        </a:xfrm>
+      </p:grpSpPr>
+      <p:sp>
+        <p:nvSpPr>
+          <p:cNvPr id="3" name="Title 2"/>
+          <p:cNvSpPr>
+            <a:spLocks noGrp="1"/>
+          </p:cNvSpPr>
+          <p:nvPr>
+            <p:ph type="title"/>
+          </p:nvPr>
+        </p:nvSpPr>
+        <p:spPr/>
+        <p:txBody>
+          <a:bodyPr wrap="square">
+            <a:normAutofit fontScale="90000"/>
+          </a:bodyPr>
+          <a:lstStyle/>
+          <a:p>
+            <a:r>
+              <a:rPr sz="2400" b="0" dirty="0">
+                <a:solidFill>
+                  <a:srgbClr val="000000"/>
+                </a:solidFill>
+              </a:rPr>
+              <a:t>Check correspondence statically</a:t>
+            </a:r>
+          </a:p>
+        </p:txBody>
+      </p:sp>
+      <p:sp>
+        <p:nvSpPr>
+          <p:cNvPr id="4" name="Slide Number Placeholder 5"/>
+          <p:cNvSpPr>
+            <a:spLocks noGrp="1"/>
+          </p:cNvSpPr>
+          <p:nvPr>
+            <p:ph type="sldNum" sz="quarter" idx="4"/>
+          </p:nvPr>
+        </p:nvSpPr>
+        <p:spPr/>
+        <p:txBody>
+          <a:bodyPr/>
+          <a:lstStyle/>
+          <a:p>
+            <a:fld id="{B7EB45DA-9A0D-DC49-8E02-F30A5DDC21C3}" type="slidenum">
+              <a:rPr lang="en-US" smtClean="0"/>
+              <a:t>25</a:t>
+            </a:fld>
+            <a:endParaRPr lang="en-US"/>
+          </a:p>
+        </p:txBody>
+      </p:sp>
+      <p:sp>
+        <p:nvSpPr>
+          <p:cNvPr id="2" name="Sc-MODEL"/>
+          <p:cNvSpPr/>
+          <p:nvPr/>
+        </p:nvSpPr>
+        <p:spPr>
+          <a:xfrm>
+            <a:off x="502920" y="1005840"/>
+            <a:ext cx="3200400" cy="548640"/>
+          </a:xfrm>
+          <a:prstGeom prst="rect">
+            <a:avLst/>
+          </a:prstGeom>
+          <a:solidFill>
+            <a:srgbClr val="8E6F3E"/>
+          </a:solidFill>
+          <a:ln>
+            <a:noFill/>
+          </a:ln>
+          <a:effectLst/>
+        </p:spPr>
+        <p:txBody>
+          <a:bodyPr wrap="square" lIns="27432" tIns="22860" rIns="27432" bIns="22860" rtlCol="0" anchor="ctr"/>
+          <a:lstStyle/>
+          <a:p>
+            <a:pPr algn="ctr">
+              <a:buNone/>
+            </a:pPr>
+            <a:r>
+              <a:rPr lang="en-US" sz="2000" b="1" i="0" dirty="0">
+                <a:solidFill>
+                  <a:srgbClr val="FFFFFF"/>
+                </a:solidFill>
+              </a:rPr>
+              <a:t>MODEL</a:t>
+            </a:r>
+          </a:p>
+        </p:txBody>
+      </p:sp>
+      <p:sp>
+        <p:nvSpPr>
+          <p:cNvPr id="5" name="Sc-REALIZATION"/>
+          <p:cNvSpPr/>
+          <p:nvPr/>
+        </p:nvSpPr>
+        <p:spPr>
+          <a:xfrm>
+            <a:off x="5440680" y="1005840"/>
+            <a:ext cx="3200400" cy="548640"/>
+          </a:xfrm>
+          <a:prstGeom prst="rect">
+            <a:avLst/>
+          </a:prstGeom>
+          <a:solidFill>
+            <a:srgbClr val="8E6F3E"/>
+          </a:solidFill>
+          <a:ln>
+            <a:noFill/>
+          </a:ln>
+          <a:effectLst/>
+        </p:spPr>
+        <p:txBody>
+          <a:bodyPr wrap="square" lIns="27432" tIns="22860" rIns="27432" bIns="22860" rtlCol="0" anchor="ctr"/>
+          <a:lstStyle/>
+          <a:p>
+            <a:pPr algn="ctr">
+              <a:buNone/>
+            </a:pPr>
+            <a:r>
+              <a:rPr lang="en-US" sz="2000" b="1" i="0" dirty="0">
+                <a:solidFill>
+                  <a:srgbClr val="FFFFFF"/>
+                </a:solidFill>
+              </a:rPr>
+              <a:t>REALIZATION</a:t>
+            </a:r>
+          </a:p>
+        </p:txBody>
+      </p:sp>
+      <p:sp>
+        <p:nvSpPr>
+          <p:cNvPr id="6" name="Sc-ModelItems"/>
+          <p:cNvSpPr/>
+          <p:nvPr/>
+        </p:nvSpPr>
+        <p:spPr>
+          <a:xfrm>
+            <a:off x="502920" y="1645920"/>
+            <a:ext cx="3200400" cy="731520"/>
+          </a:xfrm>
+          <a:prstGeom prst="rect">
+            <a:avLst/>
+          </a:prstGeom>
+          <a:solidFill>
+            <a:srgbClr val="F5F1E8"/>
+          </a:solidFill>
+          <a:ln w="12700">
+            <a:solidFill>
+              <a:srgbClr val="C9B991"/>
+            </a:solidFill>
+          </a:ln>
+          <a:effectLst/>
+        </p:spPr>
+        <p:txBody>
+          <a:bodyPr wrap="square" lIns="27432" tIns="22860" rIns="27432" bIns="22860" rtlCol="0" anchor="ctr"/>
+          <a:lstStyle/>
+          <a:p>
+            <a:pPr algn="ctr">
+              <a:buNone/>
+            </a:pPr>
+            <a:r>
+              <a:rPr lang="en-US" sz="2000" b="0" i="0" dirty="0">
+                <a:solidFill>
+                  <a:srgbClr val="5C4826"/>
+                </a:solidFill>
+              </a:rPr>
+              <a:t>lifecycle / bounds</a:t>
+            </a:r>
+          </a:p>
+          <a:p>
+            <a:pPr algn="ctr">
+              <a:spcBef>
+                <a:spcPts val="300"/>
+              </a:spcBef>
+              <a:buNone/>
+            </a:pPr>
+            <a:r>
+              <a:rPr lang="en-US" sz="2000" b="0" i="0" dirty="0">
+                <a:solidFill>
+                  <a:srgbClr val="5C4826"/>
+                </a:solidFill>
+              </a:rPr>
+              <a:t>architectural rules</a:t>
+            </a:r>
+          </a:p>
+        </p:txBody>
+      </p:sp>
+      <p:sp>
+        <p:nvSpPr>
+          <p:cNvPr id="7" name="Sc-RealItems"/>
+          <p:cNvSpPr/>
+          <p:nvPr/>
+        </p:nvSpPr>
+        <p:spPr>
+          <a:xfrm>
+            <a:off x="5440680" y="1645920"/>
+            <a:ext cx="3200400" cy="731520"/>
+          </a:xfrm>
+          <a:prstGeom prst="rect">
+            <a:avLst/>
+          </a:prstGeom>
+          <a:solidFill>
+            <a:srgbClr val="F5F1E8"/>
+          </a:solidFill>
+          <a:ln w="12700">
+            <a:solidFill>
+              <a:srgbClr val="C9B991"/>
+            </a:solidFill>
+          </a:ln>
+          <a:effectLst/>
+        </p:spPr>
+        <p:txBody>
+          <a:bodyPr wrap="square" lIns="27432" tIns="22860" rIns="27432" bIns="22860" rtlCol="0" anchor="ctr"/>
+          <a:lstStyle/>
+          <a:p>
+            <a:pPr algn="ctr">
+              <a:buNone/>
+            </a:pPr>
+            <a:r>
+              <a:rPr lang="en-US" sz="2000" b="0" i="0" dirty="0">
+                <a:solidFill>
+                  <a:srgbClr val="5C4826"/>
+                </a:solidFill>
+              </a:rPr>
+              <a:t>source code</a:t>
+            </a:r>
+          </a:p>
+          <a:p>
+            <a:pPr algn="ctr">
+              <a:spcBef>
+                <a:spcPts val="300"/>
+              </a:spcBef>
+              <a:buNone/>
+            </a:pPr>
+            <a:r>
+              <a:rPr lang="en-US" sz="2000" b="0" i="0" dirty="0">
+                <a:solidFill>
+                  <a:srgbClr val="5C4826"/>
+                </a:solidFill>
+              </a:rPr>
+              <a:t>configuration</a:t>
+            </a:r>
+          </a:p>
+        </p:txBody>
+      </p:sp>
+      <p:cxnSp>
+        <p:nvCxnSpPr>
+          <p:cNvPr id="8" name="Sc-A1"/>
+          <p:cNvCxnSpPr/>
+          <p:nvPr/>
+        </p:nvCxnSpPr>
+        <p:spPr>
+          <a:xfrm>
+            <a:off x="2103120" y="2377440"/>
+            <a:ext cx="0" cy="274320"/>
+          </a:xfrm>
+          <a:prstGeom prst="straightConnector1">
+            <a:avLst/>
+          </a:prstGeom>
+          <a:ln w="19050">
+            <a:solidFill>
+              <a:srgbClr val="8E6F3E"/>
+            </a:solidFill>
+            <a:tailEnd type="triangle"/>
+          </a:ln>
+        </p:spPr>
+      </p:cxnSp>
+      <p:cxnSp>
+        <p:nvCxnSpPr>
+          <p:cNvPr id="9" name="Sc-A2"/>
+          <p:cNvCxnSpPr/>
+          <p:nvPr/>
+        </p:nvCxnSpPr>
+        <p:spPr>
+          <a:xfrm>
+            <a:off x="7040880" y="2377440"/>
+            <a:ext cx="0" cy="274320"/>
+          </a:xfrm>
+          <a:prstGeom prst="straightConnector1">
+            <a:avLst/>
+          </a:prstGeom>
+          <a:ln w="19050">
+            <a:solidFill>
+              <a:srgbClr val="8E6F3E"/>
+            </a:solidFill>
+            <a:tailEnd type="triangle"/>
+          </a:ln>
+        </p:spPr>
+      </p:cxnSp>
+      <p:sp>
+        <p:nvSpPr>
+          <p:cNvPr id="10" name="Sc-CHECK"/>
+          <p:cNvSpPr/>
+          <p:nvPr/>
+        </p:nvSpPr>
+        <p:spPr>
+          <a:xfrm>
+            <a:off x="1828800" y="2651760"/>
+            <a:ext cx="5486400" cy="548640"/>
+          </a:xfrm>
+          <a:prstGeom prst="rect">
+            <a:avLst/>
+          </a:prstGeom>
+          <a:solidFill>
+            <a:srgbClr val="F5F1E8"/>
+          </a:solidFill>
+          <a:ln w="12700">
+            <a:solidFill>
+              <a:srgbClr val="C9B991"/>
+            </a:solidFill>
+          </a:ln>
+          <a:effectLst/>
+        </p:spPr>
+        <p:txBody>
+          <a:bodyPr wrap="square" lIns="27432" tIns="22860" rIns="27432" bIns="22860" rtlCol="0" anchor="ctr"/>
+          <a:lstStyle/>
+          <a:p>
+            <a:pPr algn="ctr">
+              <a:buNone/>
+            </a:pPr>
+            <a:r>
+              <a:rPr lang="en-US" sz="2000" b="1" i="0" dirty="0">
+                <a:solidFill>
+                  <a:srgbClr val="5C4826"/>
+                </a:solidFill>
+              </a:rPr>
+              <a:t>STATIC CHECK</a:t>
+            </a:r>
+          </a:p>
+        </p:txBody>
+      </p:sp>
+      <p:cxnSp>
+        <p:nvCxnSpPr>
+          <p:cNvPr id="11" name="Sc-A3"/>
+          <p:cNvCxnSpPr/>
+          <p:nvPr/>
+        </p:nvCxnSpPr>
+        <p:spPr>
+          <a:xfrm>
+            <a:off x="4572000" y="3200400"/>
+            <a:ext cx="0" cy="274320"/>
+          </a:xfrm>
+          <a:prstGeom prst="straightConnector1">
+            <a:avLst/>
+          </a:prstGeom>
+          <a:ln w="19050">
+            <a:solidFill>
+              <a:srgbClr val="8E6F3E"/>
+            </a:solidFill>
+            <a:tailEnd type="triangle"/>
+          </a:ln>
+        </p:spPr>
+      </p:cxnSp>
+      <p:sp>
+        <p:nvSpPr>
+          <p:cNvPr id="12" name="Sc-VERDICT"/>
+          <p:cNvSpPr/>
+          <p:nvPr/>
+        </p:nvSpPr>
+        <p:spPr>
+          <a:xfrm>
+            <a:off x="3657600" y="3474720"/>
+            <a:ext cx="1828800" cy="548640"/>
+          </a:xfrm>
+          <a:prstGeom prst="rect">
+            <a:avLst/>
+          </a:prstGeom>
+          <a:solidFill>
+            <a:srgbClr val="8E6F3E"/>
+          </a:solidFill>
+          <a:ln>
+            <a:noFill/>
+          </a:ln>
+          <a:effectLst/>
+        </p:spPr>
+        <p:txBody>
+          <a:bodyPr wrap="square" lIns="27432" tIns="22860" rIns="27432" bIns="22860" rtlCol="0" anchor="ctr"/>
+          <a:lstStyle/>
+          <a:p>
+            <a:pPr algn="ctr">
+              <a:buNone/>
+            </a:pPr>
+            <a:r>
+              <a:rPr lang="en-US" sz="2000" b="1" i="0" dirty="0">
+                <a:solidFill>
+                  <a:srgbClr val="FFFFFF"/>
+                </a:solidFill>
+              </a:rPr>
+              <a:t>VERDICT</a:t>
+            </a:r>
+          </a:p>
+        </p:txBody>
+      </p:sp>
+      <p:sp>
+        <p:nvSpPr>
+          <p:cNvPr id="13" name="Sc-Questions"/>
+          <p:cNvSpPr/>
+          <p:nvPr/>
+        </p:nvSpPr>
+        <p:spPr>
+          <a:xfrm>
+            <a:off x="502920" y="4114800"/>
+            <a:ext cx="8138160" cy="1371600"/>
+          </a:xfrm>
+          <a:prstGeom prst="rect">
+            <a:avLst/>
+          </a:prstGeom>
+          <a:solidFill>
+            <a:srgbClr val="F5F1E8"/>
+          </a:solidFill>
+          <a:ln w="12700">
+            <a:solidFill>
+              <a:srgbClr val="C9B991"/>
+            </a:solidFill>
+          </a:ln>
+          <a:effectLst/>
+        </p:spPr>
+        <p:txBody>
+          <a:bodyPr wrap="square" lIns="27432" tIns="22860" rIns="27432" bIns="22860" rtlCol="0" anchor="ctr"/>
+          <a:lstStyle/>
+          <a:p>
+            <a:pPr algn="l">
+              <a:buNone/>
+            </a:pPr>
+            <a:r>
+              <a:rPr lang="en-US" sz="2000" b="0" i="0" dirty="0">
+                <a:solidFill>
+                  <a:srgbClr val="5C4826"/>
+                </a:solidFill>
+              </a:rPr>
+              <a:t>Can any code path admit a third Awake thread?</a:t>
+            </a:r>
+          </a:p>
+          <a:p>
+            <a:pPr algn="l">
+              <a:spcBef>
+                <a:spcPts val="300"/>
+              </a:spcBef>
+              <a:buNone/>
+            </a:pPr>
+            <a:r>
+              <a:rPr lang="en-US" sz="2000" b="0" i="0" dirty="0">
+                <a:solidFill>
+                  <a:srgbClr val="5C4826"/>
+                </a:solidFill>
+              </a:rPr>
+              <a:t>Does the implementation permit a lifecycle transition absent from the model?</a:t>
+            </a:r>
+          </a:p>
+          <a:p>
+            <a:pPr algn="l">
+              <a:spcBef>
+                <a:spcPts val="300"/>
+              </a:spcBef>
+              <a:buNone/>
+            </a:pPr>
+            <a:r>
+              <a:rPr lang="en-US" sz="2000" b="0" i="0" dirty="0">
+                <a:solidFill>
+                  <a:srgbClr val="5C4826"/>
+                </a:solidFill>
+              </a:rPr>
+              <a:t>Do implementation resource bounds agree with the modeled bounds?</a:t>
+            </a:r>
+          </a:p>
+        </p:txBody>
+      </p:sp>
+      <p:sp>
+        <p:nvSpPr>
+          <p:cNvPr id="14" name="FooterBand"/>
+          <p:cNvSpPr/>
+          <p:nvPr/>
+        </p:nvSpPr>
+        <p:spPr>
+          <a:xfrm>
+            <a:off x="274320" y="5577840"/>
+            <a:ext cx="8595360" cy="777240"/>
+          </a:xfrm>
+          <a:prstGeom prst="rect">
+            <a:avLst/>
+          </a:prstGeom>
+          <a:solidFill>
+            <a:srgbClr val="8E6F3E"/>
+          </a:solidFill>
+          <a:ln>
+            <a:noFill/>
+          </a:ln>
+          <a:effectLst/>
+        </p:spPr>
+        <p:txBody>
+          <a:bodyPr wrap="square" lIns="27432" tIns="22860" rIns="27432" bIns="22860" rtlCol="0" anchor="ctr"/>
+          <a:lstStyle/>
+          <a:p>
+            <a:pPr algn="ctr">
+              <a:buNone/>
+            </a:pPr>
+            <a:r>
+              <a:rPr lang="en-US" sz="2000" b="1" i="0" dirty="0">
+                <a:solidFill>
+                  <a:srgbClr val="FFFFFF"/>
+                </a:solidFill>
+              </a:rPr>
+              <a:t>Static evidence can establish correspondence without executing the realization.</a:t>
             </a:r>
           </a:p>
         </p:txBody>

</xml_diff>

<commit_message>
deck 2-3 slide 26: dynamic slide becomes 'Check correspondence dynamically', parallel to 25
STATIC/DYNAMIC label pair DELETED ('static = verdict over the modeled space'
is the conflation being fixed); two lab questions projected; narrower
takeaway — correspondence over observed execution only.

Co-Authored-By: Claude Opus 5 <noreply@anthropic.com>
</commit_message>
<xml_diff>
--- a/course/lectures/act-2-delegation-and-control/03-alignment/2-3-Alignment.pptx
+++ b/course/lectures/act-2-delegation-and-control/03-alignment/2-3-Alignment.pptx
@@ -2441,12 +2441,12 @@
           </a:p>
           <a:p>
             <a:r>
-              <a:t>- Dynamic validation: the same model defines what a SENSOR must observe at runtime — the model states expected behavior; the trace is checked against it.</a:t>
-            </a:r>
-          </a:p>
-          <a:p>
-            <a:r>
-              <a:t>- Ground it in the lab's lifecycle machines: every thread is Asleep or Awake, moved by admit and release events. The observation questions (now spoken, no longer projected): Did the observed transition exist in the model? Did events occur in the required order? Did execution enter a forbidden state? Did a measured quantity stay within its modeled bound — did the awake count ever exceed two, and did working memory stay within 48 KB?</a:t>
+              <a:t>- The second broad way: observe the realization executing. The same model defines what a SENSOR must observe at runtime — the model states expected behavior; the trace is checked against it.</a:t>
+            </a:r>
+          </a:p>
+          <a:p>
+            <a:r>
+              <a:t>- Ground it in the lab's lifecycle machines: every thread is Asleep or Awake, moved by admit and release events. The observation questions (two projected on the slide, the rest spoken): Did the observed transition exist in the model? Did events occur in the required order? Did execution enter a forbidden state? Did a measured quantity stay within its modeled bound — did the awake count ever exceed two, and did working memory stay within 48 KB?</a:t>
             </a:r>
           </a:p>
           <a:p>
@@ -2456,12 +2456,12 @@
           </a:p>
           <a:p>
             <a:r>
-              <a:t>- The STATIC / DYNAMIC panel (absorbed from the deleted strategies slide): static — verdict over the modeled space, exhaustive, available before execution; dynamic — verdict over observed execution, evidence about the runs you actually observed.</a:t>
-            </a:r>
-          </a:p>
-          <a:p>
-            <a:r>
-              <a:t>- Close with the footer question — and notice it lands back in Alignment: a static verdict might gate merge; a runtime verdict might gate deployment or trigger rollback. Where a verdict acquires authority is an Alignment decision, not a modeling one.</a:t>
+              <a:t>- The takeaway is deliberately narrower than 'the implementation corresponds to the model': a trace cannot establish universal correspondence. Dynamic evidence establishes correspondence over the execution you actually observed — nothing beyond it.</a:t>
+            </a:r>
+          </a:p>
+          <a:p>
+            <a:r>
+              <a:t>- Close by asking aloud: where should each verdict acquire authority? Notice it lands back in Alignment: a static verdict might gate merge; a runtime verdict might gate deployment or trigger rollback. Where a verdict acquires authority is an Alignment decision, not a modeling one.</a:t>
             </a:r>
           </a:p>
         </p:txBody>
@@ -15584,12 +15584,12 @@
           <a:lstStyle/>
           <a:p>
             <a:r>
-              <a:rPr sz="2400" b="0">
+              <a:rPr sz="2400" b="0" dirty="0">
                 <a:solidFill>
                   <a:srgbClr val="000000"/>
                 </a:solidFill>
               </a:rPr>
-              <a:t>Models support dynamic validation</a:t>
+              <a:t>Check correspondence dynamically</a:t>
             </a:r>
           </a:p>
         </p:txBody>
@@ -15611,7 +15611,7 @@
           <a:p>
             <a:fld id="{B7EB45DA-9A0D-DC49-8E02-F30A5DDC21C3}" type="slidenum">
               <a:rPr lang="en-US" smtClean="0"/>
-              <a:t>25</a:t>
+              <a:t>26</a:t>
             </a:fld>
             <a:endParaRPr lang="en-US"/>
           </a:p>
@@ -15625,8 +15625,8 @@
         </p:nvSpPr>
         <p:spPr>
           <a:xfrm>
-            <a:off x="2697480" y="3831336"/>
-            <a:ext cx="2203704" cy="731520"/>
+            <a:off x="502920" y="1005840"/>
+            <a:ext cx="3200400" cy="548640"/>
           </a:xfrm>
           <a:prstGeom prst="rect">
             <a:avLst/>
@@ -15652,43 +15652,21 @@
                   <a:srgbClr val="FFFFFF"/>
                 </a:solidFill>
               </a:rPr>
-              <a:t>MODEL — expected behavior</a:t>
-            </a:r>
-          </a:p>
-        </p:txBody>
-      </p:sp>
-      <p:cxnSp>
-        <p:nvCxnSpPr>
-          <p:cNvPr id="5" name="Dy-AM"/>
-          <p:cNvCxnSpPr/>
-          <p:nvPr/>
-        </p:nvCxnSpPr>
-        <p:spPr>
-          <a:xfrm flipH="1">
-            <a:off x="2240280" y="4197096"/>
-            <a:ext cx="402336" cy="0"/>
-          </a:xfrm>
-          <a:prstGeom prst="straightConnector1">
-            <a:avLst/>
-          </a:prstGeom>
-          <a:ln w="19050">
-            <a:solidFill>
-              <a:srgbClr val="8E6F3E"/>
-            </a:solidFill>
-            <a:tailEnd type="triangle"/>
-          </a:ln>
-        </p:spPr>
-      </p:cxnSp>
-      <p:sp>
-        <p:nvSpPr>
-          <p:cNvPr id="6" name="Dy-EXECUTION"/>
+              <a:t>MODEL</a:t>
+            </a:r>
+          </a:p>
+        </p:txBody>
+      </p:sp>
+      <p:sp>
+        <p:nvSpPr>
+          <p:cNvPr id="5" name="Dy-ModelCap"/>
           <p:cNvSpPr/>
           <p:nvPr/>
         </p:nvSpPr>
         <p:spPr>
           <a:xfrm>
-            <a:off x="685800" y="1051560"/>
-            <a:ext cx="1500000" cy="640080"/>
+            <a:off x="502920" y="1645920"/>
+            <a:ext cx="3200400" cy="457200"/>
           </a:xfrm>
           <a:prstGeom prst="rect">
             <a:avLst/>
@@ -15711,26 +15689,26 @@
               <a:buNone/>
             </a:pPr>
             <a:r>
-              <a:rPr lang="en-US" sz="2000" b="1" i="0" dirty="0">
+              <a:rPr lang="en-US" sz="2000" b="0" i="1" dirty="0">
                 <a:solidFill>
                   <a:srgbClr val="5C4826"/>
                 </a:solidFill>
               </a:rPr>
-              <a:t>EXECUTION</a:t>
-            </a:r>
-          </a:p>
-        </p:txBody>
-      </p:sp>
-      <p:sp>
-        <p:nvSpPr>
-          <p:cNvPr id="7" name="Dy-SENSOR"/>
+              <a:t>expected behavior</a:t>
+            </a:r>
+          </a:p>
+        </p:txBody>
+      </p:sp>
+      <p:sp>
+        <p:nvSpPr>
+          <p:cNvPr id="6" name="Dy-EXECUTION"/>
           <p:cNvSpPr/>
           <p:nvPr/>
         </p:nvSpPr>
         <p:spPr>
           <a:xfrm>
-            <a:off x="685800" y="1993392"/>
-            <a:ext cx="1500000" cy="640080"/>
+            <a:off x="5440680" y="1005840"/>
+            <a:ext cx="3200400" cy="548640"/>
           </a:xfrm>
           <a:prstGeom prst="rect">
             <a:avLst/>
@@ -15756,21 +15734,43 @@
                   <a:srgbClr val="FFFFFF"/>
                 </a:solidFill>
               </a:rPr>
-              <a:t>SENSOR</a:t>
-            </a:r>
-          </a:p>
-        </p:txBody>
-      </p:sp>
-      <p:sp>
-        <p:nvSpPr>
-          <p:cNvPr id="8" name="Dy-TRACE"/>
+              <a:t>EXECUTION</a:t>
+            </a:r>
+          </a:p>
+        </p:txBody>
+      </p:sp>
+      <p:cxnSp>
+        <p:nvCxnSpPr>
+          <p:cNvPr id="7" name="Dy-A0"/>
+          <p:cNvCxnSpPr/>
+          <p:nvPr/>
+        </p:nvCxnSpPr>
+        <p:spPr>
+          <a:xfrm>
+            <a:off x="7040880" y="1554480"/>
+            <a:ext cx="0" cy="228600"/>
+          </a:xfrm>
+          <a:prstGeom prst="straightConnector1">
+            <a:avLst/>
+          </a:prstGeom>
+          <a:ln w="19050">
+            <a:solidFill>
+              <a:srgbClr val="8E6F3E"/>
+            </a:solidFill>
+            <a:tailEnd type="triangle"/>
+          </a:ln>
+        </p:spPr>
+      </p:cxnSp>
+      <p:sp>
+        <p:nvSpPr>
+          <p:cNvPr id="8" name="Dy-SENSOR"/>
           <p:cNvSpPr/>
           <p:nvPr/>
         </p:nvSpPr>
         <p:spPr>
           <a:xfrm>
-            <a:off x="685800" y="2935224"/>
-            <a:ext cx="1500000" cy="640080"/>
+            <a:off x="5440680" y="1783080"/>
+            <a:ext cx="3200400" cy="457200"/>
           </a:xfrm>
           <a:prstGeom prst="rect">
             <a:avLst/>
@@ -15798,61 +15798,43 @@
                   <a:srgbClr val="5C4826"/>
                 </a:solidFill>
               </a:rPr>
-              <a:t>TRACE</a:t>
-            </a:r>
-          </a:p>
-        </p:txBody>
-      </p:sp>
-      <p:sp>
-        <p:nvSpPr>
-          <p:cNvPr id="9" name="Dy-VALIDATOR"/>
+              <a:t>SENSOR</a:t>
+            </a:r>
+          </a:p>
+        </p:txBody>
+      </p:sp>
+      <p:cxnSp>
+        <p:nvCxnSpPr>
+          <p:cNvPr id="9" name="Dy-A1"/>
+          <p:cNvCxnSpPr/>
+          <p:nvPr/>
+        </p:nvCxnSpPr>
+        <p:spPr>
+          <a:xfrm>
+            <a:off x="7040880" y="2240280"/>
+            <a:ext cx="0" cy="228600"/>
+          </a:xfrm>
+          <a:prstGeom prst="straightConnector1">
+            <a:avLst/>
+          </a:prstGeom>
+          <a:ln w="19050">
+            <a:solidFill>
+              <a:srgbClr val="8E6F3E"/>
+            </a:solidFill>
+            <a:tailEnd type="triangle"/>
+          </a:ln>
+        </p:spPr>
+      </p:cxnSp>
+      <p:sp>
+        <p:nvSpPr>
+          <p:cNvPr id="10" name="Dy-TRACE"/>
           <p:cNvSpPr/>
           <p:nvPr/>
         </p:nvSpPr>
         <p:spPr>
           <a:xfrm>
-            <a:off x="685800" y="3877056"/>
-            <a:ext cx="1500000" cy="640080"/>
-          </a:xfrm>
-          <a:prstGeom prst="rect">
-            <a:avLst/>
-          </a:prstGeom>
-          <a:solidFill>
-            <a:srgbClr val="8E6F3E"/>
-          </a:solidFill>
-          <a:ln>
-            <a:noFill/>
-          </a:ln>
-          <a:effectLst/>
-        </p:spPr>
-        <p:txBody>
-          <a:bodyPr wrap="square" lIns="27432" tIns="22860" rIns="27432" bIns="22860" rtlCol="0" anchor="ctr"/>
-          <a:lstStyle/>
-          <a:p>
-            <a:pPr algn="ctr">
-              <a:buNone/>
-            </a:pPr>
-            <a:r>
-              <a:rPr lang="en-US" sz="2000" b="1" i="0" dirty="0">
-                <a:solidFill>
-                  <a:srgbClr val="FFFFFF"/>
-                </a:solidFill>
-              </a:rPr>
-              <a:t>VALIDATOR</a:t>
-            </a:r>
-          </a:p>
-        </p:txBody>
-      </p:sp>
-      <p:sp>
-        <p:nvSpPr>
-          <p:cNvPr id="10" name="Dy-VERDICT"/>
-          <p:cNvSpPr/>
-          <p:nvPr/>
-        </p:nvSpPr>
-        <p:spPr>
-          <a:xfrm>
-            <a:off x="685800" y="4818888"/>
-            <a:ext cx="1500000" cy="640080"/>
+            <a:off x="5440680" y="2468880"/>
+            <a:ext cx="3200400" cy="457200"/>
           </a:xfrm>
           <a:prstGeom prst="rect">
             <a:avLst/>
@@ -15880,21 +15862,21 @@
                   <a:srgbClr val="5C4826"/>
                 </a:solidFill>
               </a:rPr>
-              <a:t>VERDICT</a:t>
+              <a:t>TRACE</a:t>
             </a:r>
           </a:p>
         </p:txBody>
       </p:sp>
       <p:cxnSp>
         <p:nvCxnSpPr>
-          <p:cNvPr id="11" name="Dy-A0"/>
+          <p:cNvPr id="11" name="Dy-A2"/>
           <p:cNvCxnSpPr/>
           <p:nvPr/>
         </p:nvCxnSpPr>
         <p:spPr>
           <a:xfrm>
-            <a:off x="1435608" y="1691639"/>
-            <a:ext cx="0" cy="301752"/>
+            <a:off x="7040880" y="2926080"/>
+            <a:ext cx="0" cy="365760"/>
           </a:xfrm>
           <a:prstGeom prst="straightConnector1">
             <a:avLst/>
@@ -15909,14 +15891,14 @@
       </p:cxnSp>
       <p:cxnSp>
         <p:nvCxnSpPr>
-          <p:cNvPr id="12" name="Dy-A1"/>
+          <p:cNvPr id="12" name="Dy-A3"/>
           <p:cNvCxnSpPr/>
           <p:nvPr/>
         </p:nvCxnSpPr>
         <p:spPr>
           <a:xfrm>
-            <a:off x="1435608" y="2633472"/>
-            <a:ext cx="0" cy="301752"/>
+            <a:off x="2103120" y="2103120"/>
+            <a:ext cx="0" cy="1188720"/>
           </a:xfrm>
           <a:prstGeom prst="straightConnector1">
             <a:avLst/>
@@ -15929,60 +15911,16 @@
           </a:ln>
         </p:spPr>
       </p:cxnSp>
-      <p:cxnSp>
-        <p:nvCxnSpPr>
-          <p:cNvPr id="13" name="Dy-A2"/>
-          <p:cNvCxnSpPr/>
-          <p:nvPr/>
-        </p:nvCxnSpPr>
-        <p:spPr>
-          <a:xfrm>
-            <a:off x="1435608" y="3575304"/>
-            <a:ext cx="0" cy="301752"/>
-          </a:xfrm>
-          <a:prstGeom prst="straightConnector1">
-            <a:avLst/>
-          </a:prstGeom>
-          <a:ln w="19050">
-            <a:solidFill>
-              <a:srgbClr val="8E6F3E"/>
-            </a:solidFill>
-            <a:tailEnd type="triangle"/>
-          </a:ln>
-        </p:spPr>
-      </p:cxnSp>
-      <p:cxnSp>
-        <p:nvCxnSpPr>
-          <p:cNvPr id="14" name="Dy-A3"/>
-          <p:cNvCxnSpPr/>
-          <p:nvPr/>
-        </p:nvCxnSpPr>
-        <p:spPr>
-          <a:xfrm>
-            <a:off x="1435608" y="4517136"/>
-            <a:ext cx="0" cy="301752"/>
-          </a:xfrm>
-          <a:prstGeom prst="straightConnector1">
-            <a:avLst/>
-          </a:prstGeom>
-          <a:ln w="19050">
-            <a:solidFill>
-              <a:srgbClr val="8E6F3E"/>
-            </a:solidFill>
-            <a:tailEnd type="triangle"/>
-          </a:ln>
-        </p:spPr>
-      </p:cxnSp>
-      <p:sp>
-        <p:nvSpPr>
-          <p:cNvPr id="101" name="Cmp-static"/>
+      <p:sp>
+        <p:nvSpPr>
+          <p:cNvPr id="13" name="Dy-VALIDATOR"/>
           <p:cNvSpPr/>
           <p:nvPr/>
         </p:nvSpPr>
         <p:spPr>
           <a:xfrm>
-            <a:off x="5120640" y="1965960"/>
-            <a:ext cx="3657600" cy="2560320"/>
+            <a:off x="1828800" y="3291840"/>
+            <a:ext cx="5486400" cy="548640"/>
           </a:xfrm>
           <a:prstGeom prst="rect">
             <a:avLst/>
@@ -15998,72 +15936,55 @@
           <a:effectLst/>
         </p:spPr>
         <p:txBody>
-          <a:bodyPr wrap="square" lIns="27432" tIns="22860" rIns="27432" bIns="22860" rtlCol="0" anchor="t"/>
-          <a:lstStyle/>
-          <a:p>
-            <a:pPr algn="ctr"/>
-            <a:r>
-              <a:rPr sz="2000" b="1">
+          <a:bodyPr wrap="square" lIns="27432" tIns="22860" rIns="27432" bIns="22860" rtlCol="0" anchor="ctr"/>
+          <a:lstStyle/>
+          <a:p>
+            <a:pPr algn="ctr">
+              <a:buNone/>
+            </a:pPr>
+            <a:r>
+              <a:rPr lang="en-US" sz="2000" b="1" i="0" dirty="0">
                 <a:solidFill>
                   <a:srgbClr val="5C4826"/>
                 </a:solidFill>
               </a:rPr>
-              <a:t>STATIC</a:t>
-            </a:r>
-          </a:p>
-          <a:p>
-            <a:pPr algn="ctr"/>
-            <a:r>
-              <a:rPr sz="2000" b="0">
-                <a:solidFill>
-                  <a:srgbClr val="5C4826"/>
-                </a:solidFill>
-              </a:rPr>
-              <a:t>verdict over the modeled space</a:t>
-            </a:r>
-          </a:p>
-          <a:p>
-            <a:pPr algn="ctr"/>
-            <a:endParaRPr sz="2000" b="0">
-              <a:solidFill>
-                <a:srgbClr val="5C4826"/>
-              </a:solidFill>
-            </a:endParaRPr>
-          </a:p>
-          <a:p>
-            <a:pPr algn="ctr"/>
-            <a:r>
-              <a:rPr sz="2000" b="1">
-                <a:solidFill>
-                  <a:srgbClr val="5C4826"/>
-                </a:solidFill>
-              </a:rPr>
-              <a:t>DYNAMIC</a:t>
-            </a:r>
-          </a:p>
-          <a:p>
-            <a:pPr algn="ctr"/>
-            <a:r>
-              <a:rPr sz="2000" b="0">
-                <a:solidFill>
-                  <a:srgbClr val="5C4826"/>
-                </a:solidFill>
-              </a:rPr>
-              <a:t>verdict over observed execution</a:t>
-            </a:r>
-          </a:p>
-        </p:txBody>
-      </p:sp>
-      <p:sp>
-        <p:nvSpPr>
-          <p:cNvPr id="102" name="FooterBand"/>
+              <a:t>VALIDATOR</a:t>
+            </a:r>
+          </a:p>
+        </p:txBody>
+      </p:sp>
+      <p:cxnSp>
+        <p:nvCxnSpPr>
+          <p:cNvPr id="14" name="Dy-A4"/>
+          <p:cNvCxnSpPr/>
+          <p:nvPr/>
+        </p:nvCxnSpPr>
+        <p:spPr>
+          <a:xfrm>
+            <a:off x="4572000" y="3840480"/>
+            <a:ext cx="0" cy="274320"/>
+          </a:xfrm>
+          <a:prstGeom prst="straightConnector1">
+            <a:avLst/>
+          </a:prstGeom>
+          <a:ln w="19050">
+            <a:solidFill>
+              <a:srgbClr val="8E6F3E"/>
+            </a:solidFill>
+            <a:tailEnd type="triangle"/>
+          </a:ln>
+        </p:spPr>
+      </p:cxnSp>
+      <p:sp>
+        <p:nvSpPr>
+          <p:cNvPr id="15" name="Dy-VERDICT"/>
           <p:cNvSpPr/>
           <p:nvPr/>
         </p:nvSpPr>
         <p:spPr>
           <a:xfrm>
-            <a:off x="274320" y="5760720"/>
-            <a:ext cx="8595360" cy="594360"/>
+            <a:off x="3657600" y="4114800"/>
+            <a:ext cx="1828800" cy="548640"/>
           </a:xfrm>
           <a:prstGeom prst="rect">
             <a:avLst/>
@@ -16089,7 +16010,105 @@
                   <a:srgbClr val="FFFFFF"/>
                 </a:solidFill>
               </a:rPr>
-              <a:t>Where should each verdict acquire authority?</a:t>
+              <a:t>VERDICT</a:t>
+            </a:r>
+          </a:p>
+        </p:txBody>
+      </p:sp>
+      <p:sp>
+        <p:nvSpPr>
+          <p:cNvPr id="16" name="Dy-Questions"/>
+          <p:cNvSpPr/>
+          <p:nvPr/>
+        </p:nvSpPr>
+        <p:spPr>
+          <a:xfrm>
+            <a:off x="502920" y="4785360"/>
+            <a:ext cx="8138160" cy="655320"/>
+          </a:xfrm>
+          <a:prstGeom prst="rect">
+            <a:avLst/>
+          </a:prstGeom>
+          <a:solidFill>
+            <a:srgbClr val="F5F1E8"/>
+          </a:solidFill>
+          <a:ln w="12700">
+            <a:solidFill>
+              <a:srgbClr val="C9B991"/>
+            </a:solidFill>
+          </a:ln>
+          <a:effectLst/>
+        </p:spPr>
+        <p:txBody>
+          <a:bodyPr wrap="square" lIns="27432" tIns="22860" rIns="27432" bIns="22860" rtlCol="0" anchor="ctr"/>
+          <a:lstStyle/>
+          <a:p>
+            <a:pPr algn="l">
+              <a:buNone/>
+            </a:pPr>
+            <a:r>
+              <a:rPr lang="en-US" sz="2000" b="0" i="0" dirty="0">
+                <a:solidFill>
+                  <a:srgbClr val="5C4826"/>
+                </a:solidFill>
+              </a:rPr>
+              <a:t>Did the Scheduler ever admit three Awake threads?</a:t>
+            </a:r>
+          </a:p>
+          <a:p>
+            <a:pPr algn="l">
+              <a:spcBef>
+                <a:spcPts val="300"/>
+              </a:spcBef>
+              <a:buNone/>
+            </a:pPr>
+            <a:r>
+              <a:rPr lang="en-US" sz="2000" b="0" i="0" dirty="0">
+                <a:solidFill>
+                  <a:srgbClr val="5C4826"/>
+                </a:solidFill>
+              </a:rPr>
+              <a:t>Did an observed lifecycle transition violate the modeled lifecycle?</a:t>
+            </a:r>
+          </a:p>
+        </p:txBody>
+      </p:sp>
+      <p:sp>
+        <p:nvSpPr>
+          <p:cNvPr id="17" name="FooterBand"/>
+          <p:cNvSpPr/>
+          <p:nvPr/>
+        </p:nvSpPr>
+        <p:spPr>
+          <a:xfrm>
+            <a:off x="274320" y="5760720"/>
+            <a:ext cx="8595360" cy="594360"/>
+          </a:xfrm>
+          <a:prstGeom prst="rect">
+            <a:avLst/>
+          </a:prstGeom>
+          <a:solidFill>
+            <a:srgbClr val="8E6F3E"/>
+          </a:solidFill>
+          <a:ln>
+            <a:noFill/>
+          </a:ln>
+          <a:effectLst/>
+        </p:spPr>
+        <p:txBody>
+          <a:bodyPr wrap="square" lIns="27432" tIns="22860" rIns="27432" bIns="22860" rtlCol="0" anchor="ctr"/>
+          <a:lstStyle/>
+          <a:p>
+            <a:pPr algn="ctr">
+              <a:buNone/>
+            </a:pPr>
+            <a:r>
+              <a:rPr lang="en-US" sz="2000" b="1" i="0" dirty="0">
+                <a:solidFill>
+                  <a:srgbClr val="FFFFFF"/>
+                </a:solidFill>
+              </a:rPr>
+              <a:t>Dynamic evidence establishes correspondence over observed execution.</a:t>
             </a:r>
           </a:p>
         </p:txBody>

</xml_diff>

<commit_message>
deck 2-3 slide 27: triangle notes refer back to the two correspondence slides
On-slide content unchanged. Notes add the backward reference, the three-edge
walk, and 'a perfectly implemented bad model is still wrong' (notes only).

Co-Authored-By: Claude Opus 5 <noreply@anthropic.com>
</commit_message>
<xml_diff>
--- a/course/lectures/act-2-delegation-and-control/03-alignment/2-3-Alignment.pptx
+++ b/course/lectures/act-2-delegation-and-control/03-alignment/2-3-Alignment.pptx
@@ -2537,6 +2537,21 @@
           <a:p>
             <a:r>
               <a:t>- One distinction left: three kinds of judgment. The triangle carries them.</a:t>
+            </a:r>
+          </a:p>
+          <a:p>
+            <a:r>
+              <a:t>- The previous two slides gave us ways to establish this bottom edge: correspondence between model and realization. But don't confuse agreement with correctness.</a:t>
+            </a:r>
+          </a:p>
+          <a:p>
+            <a:r>
+              <a:t>- Walk the triangle: 1. Model and realization: does the realization correspond to the model? 2. Model and obligation: did the model capture the thing we actually care about? 3. Realization and obligation: does the resulting system actually satisfy the obligation?</a:t>
+            </a:r>
+          </a:p>
+          <a:p>
+            <a:r>
+              <a:t>- A perfectly implemented bad model is still wrong.</a:t>
             </a:r>
           </a:p>
           <a:p>

</xml_diff>

<commit_message>
deck 2-3 slide 29: activity admits static+dynamic checks; pipeline led by OBLIGATION
Q3 becomes 'What would you check, and what evidence would let you decide?';
footer pipeline becomes OBLIGATION -> MODEL -> CHECK -> DECIDE -> CONTROL.

Co-Authored-By: Claude Opus 5 <noreply@anthropic.com>
</commit_message>
<xml_diff>
--- a/course/lectures/act-2-delegation-and-control/03-alignment/2-3-Alignment.pptx
+++ b/course/lectures/act-2-delegation-and-control/03-alignment/2-3-Alignment.pptx
@@ -2840,7 +2840,7 @@
           </a:p>
           <a:p>
             <a:r>
-              <a:t>- Takeaway strip: MODEL → CHECK → DECIDE → CONTROL.</a:t>
+              <a:t>- Takeaway strip: OBLIGATION → MODEL → CHECK → DECIDE → CONTROL — the triangle has just made the point that the model is not the source of truth; the engineering obligation is.</a:t>
             </a:r>
           </a:p>
         </p:txBody>
@@ -17321,7 +17321,7 @@
                   <a:srgbClr val="FFFFFF"/>
                 </a:solidFill>
               </a:rPr>
-              <a:t>MODEL  →  CHECK  →  DECIDE  →  CONTROL</a:t>
+              <a:t>OBLIGATION  →  MODEL  →  CHECK  →  DECIDE  →  CONTROL</a:t>
             </a:r>
           </a:p>
         </p:txBody>
@@ -17607,7 +17607,7 @@
                   <a:srgbClr val="5C4826"/>
                 </a:solidFill>
               </a:rPr>
-              <a:t>3  ·  What evidence would let you decide?</a:t>
+              <a:t>3  ·  What would you check, and what evidence would let you decide?</a:t>
             </a:r>
           </a:p>
           <a:p>

</xml_diff>

<commit_message>
deck 2-3 slide 30: report-out — 'Static vs. dynamic evidence' replaces 'Model vs. reconstruction'; authority goes last
Co-Authored-By: Claude Opus 5 <noreply@anthropic.com>
</commit_message>
<xml_diff>
--- a/course/lectures/act-2-delegation-and-control/03-alignment/2-3-Alignment.pptx
+++ b/course/lectures/act-2-delegation-and-control/03-alignment/2-3-Alignment.pptx
@@ -2935,12 +2935,12 @@
           </a:p>
           <a:p>
             <a:r>
-              <a:t>- If teams attach different consequences, ask whether this failure warrants blocking commit, PR, merge, deployment, or merely producing evidence.</a:t>
-            </a:r>
-          </a:p>
-          <a:p>
-            <a:r>
-              <a:t>- Finally ask what work the explicit model saved. What would have had to be reconstructed from implementation otherwise?</a:t>
+              <a:t>- If teams relied on different evidence, ask whether the obligation can be decided from the realization itself — statically — or only from observed execution.</a:t>
+            </a:r>
+          </a:p>
+          <a:p>
+            <a:r>
+              <a:t>- Finally, if teams attach different consequences, ask whether this failure warrants blocking commit, PR, merge, deployment, or merely producing evidence. This dimension goes last because it returns to the central Alignment question: where does the verdict acquire authority?</a:t>
             </a:r>
           </a:p>
           <a:p>
@@ -17928,7 +17928,7 @@
                   <a:srgbClr val="5C4826"/>
                 </a:solidFill>
               </a:rPr>
-              <a:t>Different authority</a:t>
+              <a:t>Static vs. dynamic evidence</a:t>
             </a:r>
           </a:p>
           <a:p>
@@ -17939,7 +17939,7 @@
                   <a:srgbClr val="5C4826"/>
                 </a:solidFill>
               </a:rPr>
-              <a:t>Should this failure block the commit, the PR, the merge, the deployment — or merely produce evidence?</a:t>
+              <a:t>Can the obligation be decided from the realization itself, or only from observed execution?</a:t>
             </a:r>
           </a:p>
         </p:txBody>
@@ -17953,7 +17953,7 @@
         <p:spPr>
           <a:xfrm>
             <a:off x="502920" y="4142739"/>
-            <a:ext cx="8138160" cy="749808"/>
+            <a:ext cx="8138160" cy="1097280"/>
           </a:xfrm>
           <a:prstGeom prst="rect">
             <a:avLst/>
@@ -17993,7 +17993,7 @@
                   <a:srgbClr val="5C4826"/>
                 </a:solidFill>
               </a:rPr>
-              <a:t>Model vs. reconstruction</a:t>
+              <a:t>Different authority</a:t>
             </a:r>
           </a:p>
           <a:p>
@@ -18004,7 +18004,7 @@
                   <a:srgbClr val="5C4826"/>
                 </a:solidFill>
               </a:rPr>
-              <a:t>What becomes easier if the relevant knowledge is explicit?</a:t>
+              <a:t>Should this failure block the commit, the PR, the merge, the deployment — or merely produce evidence?</a:t>
             </a:r>
           </a:p>
         </p:txBody>

</xml_diff>

<commit_message>
deck 2-3: slide-number caches follow the +1 insertion (positions 27-31)
Co-Authored-By: Claude Opus 5 <noreply@anthropic.com>
</commit_message>
<xml_diff>
--- a/course/lectures/act-2-delegation-and-control/03-alignment/2-3-Alignment.pptx
+++ b/course/lectures/act-2-delegation-and-control/03-alignment/2-3-Alignment.pptx
@@ -16198,7 +16198,7 @@
           <a:p>
             <a:fld id="{B7EB45DA-9A0D-DC49-8E02-F30A5DDC21C3}" type="slidenum">
               <a:rPr lang="en-US" smtClean="0"/>
-              <a:t>26</a:t>
+              <a:t>27</a:t>
             </a:fld>
             <a:endParaRPr lang="en-US"/>
           </a:p>
@@ -16971,7 +16971,7 @@
                 <a:tabLst/>
                 <a:defRPr/>
               </a:pPr>
-              <a:t>27</a:t>
+              <a:t>28</a:t>
             </a:fld>
             <a:endParaRPr kumimoji="0" lang="en-US" sz="1200" b="0" i="0" u="none" strike="noStrike" kern="1200" cap="none" spc="0" normalizeH="0" baseline="0" noProof="0">
               <a:ln>
@@ -17221,7 +17221,7 @@
           <a:p>
             <a:fld id="{B7EB45DA-9A0D-DC49-8E02-F30A5DDC21C3}" type="slidenum">
               <a:rPr lang="en-US" smtClean="0"/>
-              <a:t>28</a:t>
+              <a:t>29</a:t>
             </a:fld>
             <a:endParaRPr lang="en-US"/>
           </a:p>
@@ -17743,7 +17743,7 @@
           <a:p>
             <a:fld id="{B7EB45DA-9A0D-DC49-8E02-F30A5DDC21C3}" type="slidenum">
               <a:rPr lang="en-US" smtClean="0"/>
-              <a:t>29</a:t>
+              <a:t>30</a:t>
             </a:fld>
             <a:endParaRPr lang="en-US"/>
           </a:p>
@@ -18303,7 +18303,7 @@
           <a:p>
             <a:fld id="{B7EB45DA-9A0D-DC49-8E02-F30A5DDC21C3}" type="slidenum">
               <a:rPr lang="en-US" smtClean="0"/>
-              <a:t>30</a:t>
+              <a:t>31</a:t>
             </a:fld>
             <a:endParaRPr lang="en-US"/>
           </a:p>

</xml_diff>

<commit_message>
deck 2-3 slide 23: render fix — restore card heights, TPS pill to top-right kicker spot
Shrunken cards clipped the control card's omits line; full-height cards plus
the freed bottom zone seat the payoff band without overlap.

Co-Authored-By: Claude Opus 5 <noreply@anthropic.com>
</commit_message>
<xml_diff>
--- a/course/lectures/act-2-delegation-and-control/03-alignment/2-3-Alignment.pptx
+++ b/course/lectures/act-2-delegation-and-control/03-alignment/2-3-Alignment.pptx
@@ -14603,7 +14603,7 @@
         <p:spPr>
           <a:xfrm>
             <a:off x="274320" y="1051560"/>
-            <a:ext cx="4206239" cy="3063240"/>
+            <a:ext cx="4206239" cy="3429000"/>
           </a:xfrm>
           <a:prstGeom prst="rect">
             <a:avLst/>
@@ -14725,7 +14725,7 @@
         <p:spPr>
           <a:xfrm>
             <a:off x="4663440" y="1051560"/>
-            <a:ext cx="4206239" cy="3063240"/>
+            <a:ext cx="4206239" cy="3429000"/>
           </a:xfrm>
           <a:prstGeom prst="rect">
             <a:avLst/>
@@ -14846,7 +14846,7 @@
         </p:nvSpPr>
         <p:spPr>
           <a:xfrm>
-            <a:off x="274320" y="4206240"/>
+            <a:off x="274320" y="4792980"/>
             <a:ext cx="8595360" cy="655320"/>
           </a:xfrm>
           <a:prstGeom prst="rect">
@@ -14934,8 +14934,8 @@
         </p:nvSpPr>
         <p:spPr>
           <a:xfrm>
-            <a:off x="3063240" y="5013058"/>
-            <a:ext cx="3017520" cy="548640"/>
+            <a:off x="5852160" y="205000"/>
+            <a:ext cx="3017520" cy="470000"/>
           </a:xfrm>
           <a:prstGeom prst="roundRect">
             <a:avLst/>

</xml_diff>

<commit_message>
deck 2-3: author's edits — retitles on 27 and 31; slide 25 gains a declared-correspondence question
Authored by hand in PowerPoint, four slides:
- 23: 'DISCUSS' becomes 'Quick Chat'; the validation-surface payoff line is dropped.
- 25: adds 'Is there any declared correspondence between the model and its realization?';
  drops the resource-bounds question; the takeaway tightens to 'Static evidence can show
  correspondence w/o executing the implementation.'
- 27: 'Agreement is not correctness' becomes 'Alignment helps us answer just one of three
  questions', and the legend gains a 'Vocabulary' label with the relations recast as
  'Model <-> realization' and 'Model/Realization <-> obligation'.
- 31: 'How do you know?' becomes 'In closing: How do you supervise your delegation?'

Verified: 31 slides, 0 runs under 20pt, 31/31 notes, pptx_validate 0 OPC / 0 schema.
</commit_message>
<xml_diff>
--- a/course/lectures/act-2-delegation-and-control/03-alignment/2-3-Alignment.pptx
+++ b/course/lectures/act-2-delegation-and-control/03-alignment/2-3-Alignment.pptx
@@ -5,7 +5,7 @@
     <p:sldMasterId id="2147483708" r:id="rId1"/>
   </p:sldMasterIdLst>
   <p:notesMasterIdLst>
-    <p:notesMasterId r:id="rId32"/>
+    <p:notesMasterId r:id="rId33"/>
   </p:notesMasterIdLst>
   <p:sldIdLst>
     <p:sldId id="256" r:id="rId2"/>
@@ -32,13 +32,13 @@
     <p:sldId id="288" r:id="rId23"/>
     <p:sldId id="307" r:id="rId24"/>
     <p:sldId id="308" r:id="rId25"/>
-    <p:sldId id="311" r:id="rId37"/>
-    <p:sldId id="309" r:id="rId26"/>
-    <p:sldId id="281" r:id="rId27"/>
-    <p:sldId id="310" r:id="rId28"/>
-    <p:sldId id="274" r:id="rId29"/>
-    <p:sldId id="276" r:id="rId30"/>
-    <p:sldId id="282" r:id="rId31"/>
+    <p:sldId id="311" r:id="rId26"/>
+    <p:sldId id="309" r:id="rId27"/>
+    <p:sldId id="281" r:id="rId28"/>
+    <p:sldId id="310" r:id="rId29"/>
+    <p:sldId id="274" r:id="rId30"/>
+    <p:sldId id="276" r:id="rId31"/>
+    <p:sldId id="282" r:id="rId32"/>
   </p:sldIdLst>
   <p:sldSz cx="9144000" cy="6858000" type="screen4x3"/>
   <p:notesSz cx="6858000" cy="9144000"/>
@@ -2441,27 +2441,27 @@
           </a:p>
           <a:p>
             <a:r>
-              <a:t>- The second broad way: observe the realization executing. The same model defines what a SENSOR must observe at runtime — the model states expected behavior; the trace is checked against it.</a:t>
-            </a:r>
-          </a:p>
-          <a:p>
-            <a:r>
-              <a:t>- Ground it in the lab's lifecycle machines: every thread is Asleep or Awake, moved by admit and release events. The observation questions (two projected on the slide, the rest spoken): Did the observed transition exist in the model? Did events occur in the required order? Did execution enter a forbidden state? Did a measured quantity stay within its modeled bound — did the awake count ever exceed two, and did working memory stay within 48 KB?</a:t>
-            </a:r>
-          </a:p>
-          <a:p>
-            <a:r>
-              <a:t>- This prevents students from hearing 'model-based validation' as synonymous with static analysis.</a:t>
-            </a:r>
-          </a:p>
-          <a:p>
-            <a:r>
-              <a:t>- The takeaway is deliberately narrower than 'the implementation corresponds to the model': a trace cannot establish universal correspondence. Dynamic evidence establishes correspondence over the execution you actually observed — nothing beyond it.</a:t>
-            </a:r>
-          </a:p>
-          <a:p>
-            <a:r>
-              <a:t>- Close by asking aloud: where should each verdict acquire authority? Notice it lands back in Alignment: a static verdict might gate merge; a runtime verdict might gate deployment or trigger rollback. Where a verdict acquires authority is an Alignment decision, not a modeling one.</a:t>
+              <a:t>- The first broad way: inspect the realization without executing it.</a:t>
+            </a:r>
+          </a:p>
+          <a:p>
+            <a:r>
+              <a:t>- Say 'static check', not 'static analysis'. 'Static check' is broader and more accurate: correspondence could be established by AST queries, architectural conformance, type checking, dependency checking, conventional static analysis, and more.</a:t>
+            </a:r>
+          </a:p>
+          <a:p>
+            <a:r>
+              <a:t>- Ground each question in the lab. 'Can any code path admit a third Awake thread?' checks the code against the admission rule the class modeled — at most two awake. 'Does the implementation permit a lifecycle transition absent from the model?' checks the code's transitions against the modeled lifecycle. 'Do implementation resource bounds agree with the modeled bounds?' checks declared limits against the per-thread working-memory maxima and the 48 KB ceiling.</a:t>
+            </a:r>
+          </a:p>
+          <a:p>
+            <a:r>
+              <a:t>- Note what each question interrogates: the REALIZATION, against what the model makes explicit. We are not analyzing the model; we are using it.</a:t>
+            </a:r>
+          </a:p>
+          <a:p>
+            <a:r>
+              <a:t>- Careful claim: a green verdict proves neither the model nor the implementation correct. It establishes the selected correspondence property we checked — nothing more. 'Agreement is not correctness', two slides from now, exposes that limitation deliberately.</a:t>
             </a:r>
           </a:p>
         </p:txBody>
@@ -2536,82 +2536,27 @@
           </a:p>
           <a:p>
             <a:r>
-              <a:t>- One distinction left: three kinds of judgment. The triangle carries them.</a:t>
-            </a:r>
-          </a:p>
-          <a:p>
-            <a:r>
-              <a:t>- The previous two slides gave us ways to establish this bottom edge: correspondence between model and realization. But don't confuse agreement with correctness.</a:t>
-            </a:r>
-          </a:p>
-          <a:p>
-            <a:r>
-              <a:t>- Walk the triangle: 1. Model and realization: does the realization correspond to the model? 2. Model and obligation: did the model capture the thing we actually care about? 3. Realization and obligation: does the resulting system actually satisfy the obligation?</a:t>
-            </a:r>
-          </a:p>
-          <a:p>
-            <a:r>
-              <a:t>- A perfectly implemented bad model is still wrong.</a:t>
-            </a:r>
-          </a:p>
-          <a:p>
-            <a:r>
-              <a:t>- We have an obligation, a model, and a realization. Ask what claim each edge makes.</a:t>
-            </a:r>
-          </a:p>
-          <a:p>
-            <a:r>
-              <a:t>- captures? — does the model actually capture the obligation?</a:t>
-            </a:r>
-          </a:p>
-          <a:p>
-            <a:r>
-              <a:t>- satisfies? — does the realization satisfy the obligation? That judgment is CONFORMANCE: an artifact against an independent obligation.</a:t>
-            </a:r>
-          </a:p>
-          <a:p>
-            <a:r>
-              <a:t>- corresponds? — do model and realization agree? That judgment is CORRESPONDENCE: two representations against each other.</a:t>
-            </a:r>
-          </a:p>
-          <a:p>
-            <a:r>
-              <a:t>- ACCEPTANCE brings in a fourth object, the receiving environment: will it accept the artifact? On the slide it is the third legend line, not a fourth node — name the fourth object aloud.</a:t>
-            </a:r>
-          </a:p>
-          <a:p>
-            <a:r>
-              <a:t>- None of these edges establishes the other two. A model and implementation can agree and both be wrong against the obligation. Evidence for one claim does not establish the others.</a:t>
-            </a:r>
-          </a:p>
-          <a:p>
-            <a:r>
-              <a:t>- This matters because model-driven development can otherwise create a false sense of assurance: we can become very good at keeping implementation synchronized with a bad model.</a:t>
-            </a:r>
-          </a:p>
-          <a:p>
-            <a:r>
-              <a:t>- Correspondence is useful, but it is only one edge of the engineering argument.</a:t>
-            </a:r>
-          </a:p>
-          <a:p>
-            <a:r>
-              <a:t>- (Demoted from the slide; ask aloud:) What claim does each edge make? What evidence would establish it?</a:t>
-            </a:r>
-          </a:p>
-          <a:p>
-            <a:r>
-              <a:t>ANIMATION</a:t>
-            </a:r>
-          </a:p>
-          <a:p>
-            <a:r>
-              <a:t>- Reveal OBLIGATION, MODEL, REALIZATION without edges if possible.</a:t>
-            </a:r>
-          </a:p>
-          <a:p>
-            <a:r>
-              <a:t>- Reveal the three edge questions, then the legend naming the three judgments.</a:t>
+              <a:t>- The second broad way: observe the realization executing. The same model defines what a SENSOR must observe at runtime — the model states expected behavior; the trace is checked against it.</a:t>
+            </a:r>
+          </a:p>
+          <a:p>
+            <a:r>
+              <a:t>- Ground it in the lab's lifecycle machines: every thread is Asleep or Awake, moved by admit and release events. The observation questions (two projected on the slide, the rest spoken): Did the observed transition exist in the model? Did events occur in the required order? Did execution enter a forbidden state? Did a measured quantity stay within its modeled bound — did the awake count ever exceed two, and did working memory stay within 48 KB?</a:t>
+            </a:r>
+          </a:p>
+          <a:p>
+            <a:r>
+              <a:t>- This prevents students from hearing 'model-based validation' as synonymous with static analysis.</a:t>
+            </a:r>
+          </a:p>
+          <a:p>
+            <a:r>
+              <a:t>- The takeaway is deliberately narrower than 'the implementation corresponds to the model': a trace cannot establish universal correspondence. Dynamic evidence establishes correspondence over the execution you actually observed — nothing beyond it.</a:t>
+            </a:r>
+          </a:p>
+          <a:p>
+            <a:r>
+              <a:t>- Close by asking aloud: where should each verdict acquire authority? Notice it lands back in Alignment: a static verdict might gate merge; a runtime verdict might gate deployment or trigger rollback. Where a verdict acquires authority is an Alignment decision, not a modeling one.</a:t>
             </a:r>
           </a:p>
         </p:txBody>
@@ -2637,6 +2582,156 @@
 </file>
 
 <file path=ppt/notesSlides/notesSlide27.xml><?xml version="1.0" encoding="utf-8"?>
+<p:notes xmlns:a="http://schemas.openxmlformats.org/drawingml/2006/main" xmlns:r="http://schemas.openxmlformats.org/officeDocument/2006/relationships" xmlns:p="http://schemas.openxmlformats.org/presentationml/2006/main">
+  <p:cSld>
+    <p:spTree>
+      <p:nvGrpSpPr>
+        <p:cNvPr id="1" name=""/>
+        <p:cNvGrpSpPr/>
+        <p:nvPr/>
+      </p:nvGrpSpPr>
+      <p:grpSpPr>
+        <a:xfrm>
+          <a:off x="0" y="0"/>
+          <a:ext cx="0" cy="0"/>
+          <a:chOff x="0" y="0"/>
+          <a:chExt cx="0" cy="0"/>
+        </a:xfrm>
+      </p:grpSpPr>
+      <p:sp>
+        <p:nvSpPr>
+          <p:cNvPr id="2" name="Slide Image Placeholder 1"/>
+          <p:cNvSpPr>
+            <a:spLocks noGrp="1" noRot="1" noChangeAspect="1"/>
+          </p:cNvSpPr>
+          <p:nvPr>
+            <p:ph type="sldImg" idx="2"/>
+          </p:nvPr>
+        </p:nvSpPr>
+        <p:spPr/>
+      </p:sp>
+      <p:sp>
+        <p:nvSpPr>
+          <p:cNvPr id="3" name="Notes Placeholder 2"/>
+          <p:cNvSpPr>
+            <a:spLocks noGrp="1"/>
+          </p:cNvSpPr>
+          <p:nvPr>
+            <p:ph type="body" sz="quarter" idx="3"/>
+          </p:nvPr>
+        </p:nvSpPr>
+        <p:spPr/>
+        <p:txBody>
+          <a:bodyPr/>
+          <a:lstStyle/>
+          <a:p>
+            <a:r>
+              <a:t>TIMING: 3 minutes</a:t>
+            </a:r>
+          </a:p>
+          <a:p>
+            <a:r>
+              <a:t>- One distinction left: three kinds of judgment. The triangle carries them.</a:t>
+            </a:r>
+          </a:p>
+          <a:p>
+            <a:r>
+              <a:t>- The previous two slides gave us ways to establish this bottom edge: correspondence between model and realization. But don't confuse agreement with correctness.</a:t>
+            </a:r>
+          </a:p>
+          <a:p>
+            <a:r>
+              <a:t>- Walk the triangle: 1. Model and realization: does the realization correspond to the model? 2. Model and obligation: did the model capture the thing we actually care about? 3. Realization and obligation: does the resulting system actually satisfy the obligation?</a:t>
+            </a:r>
+          </a:p>
+          <a:p>
+            <a:r>
+              <a:t>- A perfectly implemented bad model is still wrong.</a:t>
+            </a:r>
+          </a:p>
+          <a:p>
+            <a:r>
+              <a:t>- We have an obligation, a model, and a realization. Ask what claim each edge makes.</a:t>
+            </a:r>
+          </a:p>
+          <a:p>
+            <a:r>
+              <a:t>- captures? — does the model actually capture the obligation?</a:t>
+            </a:r>
+          </a:p>
+          <a:p>
+            <a:r>
+              <a:t>- satisfies? — does the realization satisfy the obligation? That judgment is CONFORMANCE: an artifact against an independent obligation.</a:t>
+            </a:r>
+          </a:p>
+          <a:p>
+            <a:r>
+              <a:t>- corresponds? — do model and realization agree? That judgment is CORRESPONDENCE: two representations against each other.</a:t>
+            </a:r>
+          </a:p>
+          <a:p>
+            <a:r>
+              <a:t>- ACCEPTANCE brings in a fourth object, the receiving environment: will it accept the artifact? On the slide it is the third legend line, not a fourth node — name the fourth object aloud.</a:t>
+            </a:r>
+          </a:p>
+          <a:p>
+            <a:r>
+              <a:t>- None of these edges establishes the other two. A model and implementation can agree and both be wrong against the obligation. Evidence for one claim does not establish the others.</a:t>
+            </a:r>
+          </a:p>
+          <a:p>
+            <a:r>
+              <a:t>- This matters because model-driven development can otherwise create a false sense of assurance: we can become very good at keeping implementation synchronized with a bad model.</a:t>
+            </a:r>
+          </a:p>
+          <a:p>
+            <a:r>
+              <a:t>- Correspondence is useful, but it is only one edge of the engineering argument.</a:t>
+            </a:r>
+          </a:p>
+          <a:p>
+            <a:r>
+              <a:t>- (Demoted from the slide; ask aloud:) What claim does each edge make? What evidence would establish it?</a:t>
+            </a:r>
+          </a:p>
+          <a:p>
+            <a:r>
+              <a:t>ANIMATION</a:t>
+            </a:r>
+          </a:p>
+          <a:p>
+            <a:r>
+              <a:t>- Reveal OBLIGATION, MODEL, REALIZATION without edges if possible.</a:t>
+            </a:r>
+          </a:p>
+          <a:p>
+            <a:r>
+              <a:t>- Reveal the three edge questions, then the legend naming the three judgments.</a:t>
+            </a:r>
+          </a:p>
+        </p:txBody>
+      </p:sp>
+      <p:sp>
+        <p:nvSpPr>
+          <p:cNvPr id="4" name="Slide Number Placeholder 3"/>
+          <p:cNvSpPr>
+            <a:spLocks noGrp="1"/>
+          </p:cNvSpPr>
+          <p:nvPr>
+            <p:ph type="sldNum" sz="quarter" idx="5"/>
+          </p:nvPr>
+        </p:nvSpPr>
+        <p:spPr/>
+      </p:sp>
+    </p:spTree>
+  </p:cSld>
+  <p:clrMapOvr>
+    <a:masterClrMapping/>
+  </p:clrMapOvr>
+</p:notes>
+</file>
+
+<file path=ppt/notesSlides/notesSlide28.xml><?xml version="1.0" encoding="utf-8"?>
 <p:notes xmlns:a="http://schemas.openxmlformats.org/drawingml/2006/main" xmlns:r="http://schemas.openxmlformats.org/officeDocument/2006/relationships" xmlns:p="http://schemas.openxmlformats.org/presentationml/2006/main">
   <p:cSld>
     <p:spTree>
@@ -2743,121 +2838,6 @@
         <p14:creationId xmlns:p14="http://schemas.microsoft.com/office/powerpoint/2010/main" val="150573818"/>
       </p:ext>
     </p:extLst>
-  </p:cSld>
-  <p:clrMapOvr>
-    <a:masterClrMapping/>
-  </p:clrMapOvr>
-</p:notes>
-</file>
-
-<file path=ppt/notesSlides/notesSlide28.xml><?xml version="1.0" encoding="utf-8"?>
-<p:notes xmlns:a="http://schemas.openxmlformats.org/drawingml/2006/main" xmlns:r="http://schemas.openxmlformats.org/officeDocument/2006/relationships" xmlns:p="http://schemas.openxmlformats.org/presentationml/2006/main">
-  <p:cSld>
-    <p:spTree>
-      <p:nvGrpSpPr>
-        <p:cNvPr id="1" name=""/>
-        <p:cNvGrpSpPr/>
-        <p:nvPr/>
-      </p:nvGrpSpPr>
-      <p:grpSpPr>
-        <a:xfrm>
-          <a:off x="0" y="0"/>
-          <a:ext cx="0" cy="0"/>
-          <a:chOff x="0" y="0"/>
-          <a:chExt cx="0" cy="0"/>
-        </a:xfrm>
-      </p:grpSpPr>
-      <p:sp>
-        <p:nvSpPr>
-          <p:cNvPr id="2" name="Slide Image Placeholder 1"/>
-          <p:cNvSpPr>
-            <a:spLocks noGrp="1" noRot="1" noChangeAspect="1"/>
-          </p:cNvSpPr>
-          <p:nvPr>
-            <p:ph type="sldImg" idx="2"/>
-          </p:nvPr>
-        </p:nvSpPr>
-        <p:spPr/>
-      </p:sp>
-      <p:sp>
-        <p:nvSpPr>
-          <p:cNvPr id="3" name="Notes Placeholder 2"/>
-          <p:cNvSpPr>
-            <a:spLocks noGrp="1"/>
-          </p:cNvSpPr>
-          <p:nvPr>
-            <p:ph type="body" sz="quarter" idx="3"/>
-          </p:nvPr>
-        </p:nvSpPr>
-        <p:spPr/>
-        <p:txBody>
-          <a:bodyPr/>
-          <a:lstStyle/>
-          <a:p>
-            <a:r>
-              <a:t>TIMING: 30 seconds transition + 2 minutes setup + 8-10 minutes work</a:t>
-            </a:r>
-          </a:p>
-          <a:p>
-            <a:r>
-              <a:t>- This slide is the section transition — the activity title itself is the transition. Setup line: enough vocabulary; now use it.</a:t>
-            </a:r>
-          </a:p>
-          <a:p>
-            <a:r>
-              <a:t>- This is unmistakably a RETURN TO THE LAB, not a new scenario: the two model cards on the left are the two models the class built in the Modeling lab and saw four slides ago (the working-memory view and the lifecycle view of the sensor node). In Modeling, they built and used the model; now they use that same model as an independent validation surface.</a:t>
-            </a:r>
-          </a:p>
-          <a:p>
-            <a:r>
-              <a:t>- This lands the Modeling deck's own message that models constrain implementation without determining it: we left realization choices free; now we check that the chosen realization still satisfies what the model preserved.</a:t>
-            </a:r>
-          </a:p>
-          <a:p>
-            <a:r>
-              <a:t>- Teams choose ONE obligation from the lab — the 48 KB device ceiling, the at-most-two-awake admission rule, a per-thread working-memory maximum — and walk the five questions on the right.</a:t>
-            </a:r>
-          </a:p>
-          <a:p>
-            <a:r>
-              <a:t>WORKSHEET (keep this slide up while teams work and walk it aloud):</a:t>
-            </a:r>
-          </a:p>
-          <a:p>
-            <a:r>
-              <a:t>- For each obligation, identify what can fail, what evidence establishes it, where it becomes decidable, and what failure should control.</a:t>
-            </a:r>
-          </a:p>
-          <a:p>
-            <a:r>
-              <a:t>- The five numbered questions walk that sequence: failure mode; prevent or detect; evidence; earliest decidable boundary; consequence of a failed check. Teams should also ask which of the two views makes the relevant fact explicit, and whether they would validate it statically or dynamically.</a:t>
-            </a:r>
-          </a:p>
-          <a:p>
-            <a:r>
-              <a:t>- Teams should be ready to defend their boundary choices and what authority the verdict carries.</a:t>
-            </a:r>
-          </a:p>
-          <a:p>
-            <a:r>
-              <a:t>- Takeaway strip: OBLIGATION → MODEL → CHECK → DECIDE → CONTROL — the triangle has just made the point that the model is not the source of truth; the engineering obligation is.</a:t>
-            </a:r>
-          </a:p>
-        </p:txBody>
-      </p:sp>
-      <p:sp>
-        <p:nvSpPr>
-          <p:cNvPr id="4" name="Slide Number Placeholder 3"/>
-          <p:cNvSpPr>
-            <a:spLocks noGrp="1"/>
-          </p:cNvSpPr>
-          <p:nvPr>
-            <p:ph type="sldNum" sz="quarter" idx="5"/>
-          </p:nvPr>
-        </p:nvSpPr>
-        <p:spPr/>
-      </p:sp>
-    </p:spTree>
   </p:cSld>
   <p:clrMapOvr>
     <a:masterClrMapping/>
@@ -2910,52 +2890,52 @@
           <a:lstStyle/>
           <a:p>
             <a:r>
-              <a:t>TIMING: 4-5 minutes</a:t>
-            </a:r>
-          </a:p>
-          <a:p>
-            <a:r>
-              <a:t>- Have two or three teams report a control they designed differently.</a:t>
-            </a:r>
-          </a:p>
-          <a:p>
-            <a:r>
-              <a:t>- Do not search immediately for the one correct design. Compare the engineering tradeoffs.</a:t>
-            </a:r>
-          </a:p>
-          <a:p>
-            <a:r>
-              <a:t>- If teams chose different boundaries for the same obligation, ask which boundary actually contains enough information.</a:t>
-            </a:r>
-          </a:p>
-          <a:p>
-            <a:r>
-              <a:t>- If one team chose a constraint and another chose detection, ask whether the invalid state can cleanly be excluded.</a:t>
-            </a:r>
-          </a:p>
-          <a:p>
-            <a:r>
-              <a:t>- If teams relied on different evidence, ask whether the obligation can be decided from the realization itself — statically — or only from observed execution.</a:t>
-            </a:r>
-          </a:p>
-          <a:p>
-            <a:r>
-              <a:t>- Finally, if teams attach different consequences, ask whether this failure warrants blocking commit, PR, merge, deployment, or merely producing evidence. This dimension goes last because it returns to the central Alignment question: where does the verdict acquire authority?</a:t>
-            </a:r>
-          </a:p>
-          <a:p>
-            <a:r>
-              <a:t>- The important thing is that the design is defensible against the failure model and obligation, not that everyone chose identical machinery.</a:t>
-            </a:r>
-          </a:p>
-          <a:p>
-            <a:r>
-              <a:t>ANIMATION</a:t>
-            </a:r>
-          </a:p>
-          <a:p>
-            <a:r>
-              <a:t>- Reveal comparison questions one at a time as they become relevant to student answers.</a:t>
+              <a:t>TIMING: 30 seconds transition + 2 minutes setup + 8-10 minutes work</a:t>
+            </a:r>
+          </a:p>
+          <a:p>
+            <a:r>
+              <a:t>- This slide is the section transition — the activity title itself is the transition. Setup line: enough vocabulary; now use it.</a:t>
+            </a:r>
+          </a:p>
+          <a:p>
+            <a:r>
+              <a:t>- This is unmistakably a RETURN TO THE LAB, not a new scenario: the two model cards on the left are the two models the class built in the Modeling lab and saw four slides ago (the working-memory view and the lifecycle view of the sensor node). In Modeling, they built and used the model; now they use that same model as an independent validation surface.</a:t>
+            </a:r>
+          </a:p>
+          <a:p>
+            <a:r>
+              <a:t>- This lands the Modeling deck's own message that models constrain implementation without determining it: we left realization choices free; now we check that the chosen realization still satisfies what the model preserved.</a:t>
+            </a:r>
+          </a:p>
+          <a:p>
+            <a:r>
+              <a:t>- Teams choose ONE obligation from the lab — the 48 KB device ceiling, the at-most-two-awake admission rule, a per-thread working-memory maximum — and walk the five questions on the right.</a:t>
+            </a:r>
+          </a:p>
+          <a:p>
+            <a:r>
+              <a:t>WORKSHEET (keep this slide up while teams work and walk it aloud):</a:t>
+            </a:r>
+          </a:p>
+          <a:p>
+            <a:r>
+              <a:t>- For each obligation, identify what can fail, what evidence establishes it, where it becomes decidable, and what failure should control.</a:t>
+            </a:r>
+          </a:p>
+          <a:p>
+            <a:r>
+              <a:t>- The five numbered questions walk that sequence: failure mode; prevent or detect; evidence; earliest decidable boundary; consequence of a failed check. Teams should also ask which of the two views makes the relevant fact explicit, and whether they would validate it statically or dynamically.</a:t>
+            </a:r>
+          </a:p>
+          <a:p>
+            <a:r>
+              <a:t>- Teams should be ready to defend their boundary choices and what authority the verdict carries.</a:t>
+            </a:r>
+          </a:p>
+          <a:p>
+            <a:r>
+              <a:t>- Takeaway strip: OBLIGATION → MODEL → CHECK → DECIDE → CONTROL — the triangle has just made the point that the model is not the source of truth; the engineering obligation is.</a:t>
             </a:r>
           </a:p>
         </p:txBody>
@@ -3140,72 +3120,42 @@
           <a:lstStyle/>
           <a:p>
             <a:r>
-              <a:t>TIMING: 3 minutes</a:t>
-            </a:r>
-          </a:p>
-          <a:p>
-            <a:r>
-              <a:t>- Return to the question from slide 1.</a:t>
-            </a:r>
-          </a:p>
-          <a:p>
-            <a:r>
-              <a:t>- Modeling and Alignment solve different parts of the problem.</a:t>
-            </a:r>
-          </a:p>
-          <a:p>
-            <a:r>
-              <a:t>- Modeling makes consequential engineering knowledge explicit while leaving irrelevant choices free.</a:t>
-            </a:r>
-          </a:p>
-          <a:p>
-            <a:r>
-              <a:t>- Alignment decides which obligations have consequences in the engineered environment.</a:t>
-            </a:r>
-          </a:p>
-          <a:p>
-            <a:r>
-              <a:t>- Then walk the reusable questions in order.</a:t>
-            </a:r>
-          </a:p>
-          <a:p>
-            <a:r>
-              <a:t>- How can delegated work fail? Start with the failure model.</a:t>
-            </a:r>
-          </a:p>
-          <a:p>
-            <a:r>
-              <a:t>- What must be true? State the obligation.</a:t>
-            </a:r>
-          </a:p>
-          <a:p>
-            <a:r>
-              <a:t>- What evidence bears on it? Do not confuse activity with evidence.</a:t>
-            </a:r>
-          </a:p>
-          <a:p>
-            <a:r>
-              <a:t>- Where can it be decided? Put the mechanism at a boundary with sufficient information.</a:t>
-            </a:r>
-          </a:p>
-          <a:p>
-            <a:r>
-              <a:t>- How will it be evaluated? Identify the validator or equivalent judgment.</a:t>
-            </a:r>
-          </a:p>
-          <a:p>
-            <a:r>
-              <a:t>- Should failure control what happens next? Decide the authority of the verdict.</a:t>
-            </a:r>
-          </a:p>
-          <a:p>
-            <a:r>
-              <a:t>- That last question is what turns Validation into Alignment.</a:t>
-            </a:r>
-          </a:p>
-          <a:p>
-            <a:r>
-              <a:t>- End there. Do not add another summary or slogan.</a:t>
+              <a:t>TIMING: 4-5 minutes</a:t>
+            </a:r>
+          </a:p>
+          <a:p>
+            <a:r>
+              <a:t>- Have two or three teams report a control they designed differently.</a:t>
+            </a:r>
+          </a:p>
+          <a:p>
+            <a:r>
+              <a:t>- Do not search immediately for the one correct design. Compare the engineering tradeoffs.</a:t>
+            </a:r>
+          </a:p>
+          <a:p>
+            <a:r>
+              <a:t>- If teams chose different boundaries for the same obligation, ask which boundary actually contains enough information.</a:t>
+            </a:r>
+          </a:p>
+          <a:p>
+            <a:r>
+              <a:t>- If one team chose a constraint and another chose detection, ask whether the invalid state can cleanly be excluded.</a:t>
+            </a:r>
+          </a:p>
+          <a:p>
+            <a:r>
+              <a:t>- If teams relied on different evidence, ask whether the obligation can be decided from the realization itself — statically — or only from observed execution.</a:t>
+            </a:r>
+          </a:p>
+          <a:p>
+            <a:r>
+              <a:t>- Finally, if teams attach different consequences, ask whether this failure warrants blocking commit, PR, merge, deployment, or merely producing evidence. This dimension goes last because it returns to the central Alignment question: where does the verdict acquire authority?</a:t>
+            </a:r>
+          </a:p>
+          <a:p>
+            <a:r>
+              <a:t>- The important thing is that the design is defensible against the failure model and obligation, not that everyone chose identical machinery.</a:t>
             </a:r>
           </a:p>
           <a:p>
@@ -3215,22 +3165,7 @@
           </a:p>
           <a:p>
             <a:r>
-              <a:t>- Reveal MODELING.</a:t>
-            </a:r>
-          </a:p>
-          <a:p>
-            <a:r>
-              <a:t>- Reveal ALIGNMENT.</a:t>
-            </a:r>
-          </a:p>
-          <a:p>
-            <a:r>
-              <a:t>- Reveal the reusable questions one at a time.</a:t>
-            </a:r>
-          </a:p>
-          <a:p>
-            <a:r>
-              <a:t>- Leave the final question, "Should failure control what happens next?", as the last reveal and final image of the lecture.</a:t>
+              <a:t>- Reveal comparison questions one at a time as they become relevant to student answers.</a:t>
             </a:r>
           </a:p>
         </p:txBody>
@@ -3305,27 +3240,92 @@
           </a:p>
           <a:p>
             <a:r>
-              <a:t>- The first broad way: inspect the realization without executing it.</a:t>
-            </a:r>
-          </a:p>
-          <a:p>
-            <a:r>
-              <a:t>- Say 'static check', not 'static analysis'. 'Static check' is broader and more accurate: correspondence could be established by AST queries, architectural conformance, type checking, dependency checking, conventional static analysis, and more.</a:t>
-            </a:r>
-          </a:p>
-          <a:p>
-            <a:r>
-              <a:t>- Ground each question in the lab. 'Can any code path admit a third Awake thread?' checks the code against the admission rule the class modeled — at most two awake. 'Does the implementation permit a lifecycle transition absent from the model?' checks the code's transitions against the modeled lifecycle. 'Do implementation resource bounds agree with the modeled bounds?' checks declared limits against the per-thread working-memory maxima and the 48 KB ceiling.</a:t>
-            </a:r>
-          </a:p>
-          <a:p>
-            <a:r>
-              <a:t>- Note what each question interrogates: the REALIZATION, against what the model makes explicit. We are not analyzing the model; we are using it.</a:t>
-            </a:r>
-          </a:p>
-          <a:p>
-            <a:r>
-              <a:t>- Careful claim: a green verdict proves neither the model nor the implementation correct. It establishes the selected correspondence property we checked — nothing more. 'Agreement is not correctness', two slides from now, exposes that limitation deliberately.</a:t>
+              <a:t>- Return to the question from slide 1.</a:t>
+            </a:r>
+          </a:p>
+          <a:p>
+            <a:r>
+              <a:t>- Modeling and Alignment solve different parts of the problem.</a:t>
+            </a:r>
+          </a:p>
+          <a:p>
+            <a:r>
+              <a:t>- Modeling makes consequential engineering knowledge explicit while leaving irrelevant choices free.</a:t>
+            </a:r>
+          </a:p>
+          <a:p>
+            <a:r>
+              <a:t>- Alignment decides which obligations have consequences in the engineered environment.</a:t>
+            </a:r>
+          </a:p>
+          <a:p>
+            <a:r>
+              <a:t>- Then walk the reusable questions in order.</a:t>
+            </a:r>
+          </a:p>
+          <a:p>
+            <a:r>
+              <a:t>- How can delegated work fail? Start with the failure model.</a:t>
+            </a:r>
+          </a:p>
+          <a:p>
+            <a:r>
+              <a:t>- What must be true? State the obligation.</a:t>
+            </a:r>
+          </a:p>
+          <a:p>
+            <a:r>
+              <a:t>- What evidence bears on it? Do not confuse activity with evidence.</a:t>
+            </a:r>
+          </a:p>
+          <a:p>
+            <a:r>
+              <a:t>- Where can it be decided? Put the mechanism at a boundary with sufficient information.</a:t>
+            </a:r>
+          </a:p>
+          <a:p>
+            <a:r>
+              <a:t>- How will it be evaluated? Identify the validator or equivalent judgment.</a:t>
+            </a:r>
+          </a:p>
+          <a:p>
+            <a:r>
+              <a:t>- Should failure control what happens next? Decide the authority of the verdict.</a:t>
+            </a:r>
+          </a:p>
+          <a:p>
+            <a:r>
+              <a:t>- That last question is what turns Validation into Alignment.</a:t>
+            </a:r>
+          </a:p>
+          <a:p>
+            <a:r>
+              <a:t>- End there. Do not add another summary or slogan.</a:t>
+            </a:r>
+          </a:p>
+          <a:p>
+            <a:r>
+              <a:t>ANIMATION</a:t>
+            </a:r>
+          </a:p>
+          <a:p>
+            <a:r>
+              <a:t>- Reveal MODELING.</a:t>
+            </a:r>
+          </a:p>
+          <a:p>
+            <a:r>
+              <a:t>- Reveal ALIGNMENT.</a:t>
+            </a:r>
+          </a:p>
+          <a:p>
+            <a:r>
+              <a:t>- Reveal the reusable questions one at a time.</a:t>
+            </a:r>
+          </a:p>
+          <a:p>
+            <a:r>
+              <a:t>- Leave the final question, "Should failure control what happens next?", as the last reveal and final image of the lecture.</a:t>
             </a:r>
           </a:p>
         </p:txBody>
@@ -14840,55 +14840,13 @@
       </p:sp>
       <p:sp>
         <p:nvSpPr>
-          <p:cNvPr id="9" name="PayoffBand"/>
-          <p:cNvSpPr/>
-          <p:nvPr/>
-        </p:nvSpPr>
-        <p:spPr>
-          <a:xfrm>
-            <a:off x="274320" y="4792980"/>
-            <a:ext cx="8595360" cy="655320"/>
-          </a:xfrm>
-          <a:prstGeom prst="rect">
-            <a:avLst/>
-          </a:prstGeom>
-          <a:solidFill>
-            <a:srgbClr val="F5F1E8"/>
-          </a:solidFill>
-          <a:ln w="12700">
-            <a:solidFill>
-              <a:srgbClr val="C9B991"/>
-            </a:solidFill>
-          </a:ln>
-          <a:effectLst/>
-        </p:spPr>
-        <p:txBody>
-          <a:bodyPr wrap="square" lIns="27432" tIns="22860" rIns="27432" bIns="22860" rtlCol="0" anchor="ctr"/>
-          <a:lstStyle/>
-          <a:p>
-            <a:pPr algn="ctr">
-              <a:buNone/>
-            </a:pPr>
-            <a:r>
-              <a:rPr lang="en-US" sz="2000" b="1" i="0" dirty="0">
-                <a:solidFill>
-                  <a:srgbClr val="5C4826"/>
-                </a:solidFill>
-              </a:rPr>
-              <a:t>A model becomes a validation surface when a realization can be checked against what the model makes explicit.</a:t>
-            </a:r>
-          </a:p>
-        </p:txBody>
-      </p:sp>
-      <p:sp>
-        <p:nvSpPr>
           <p:cNvPr id="7" name="FooterBand"/>
           <p:cNvSpPr/>
           <p:nvPr/>
         </p:nvSpPr>
         <p:spPr>
           <a:xfrm>
-            <a:off x="274320" y="5760720"/>
+            <a:off x="274319" y="5509260"/>
             <a:ext cx="8595360" cy="594360"/>
           </a:xfrm>
           <a:prstGeom prst="rect">
@@ -14915,7 +14873,7 @@
                   <a:srgbClr val="FFFFFF"/>
                 </a:solidFill>
               </a:rPr>
-              <a:t>DISCUSS  ·  How can we use these models in validation?</a:t>
+              <a:t>Quick Chat ·  How can we use these models in validation?</a:t>
             </a:r>
           </a:p>
         </p:txBody>
@@ -14934,7 +14892,7 @@
         </p:nvSpPr>
         <p:spPr>
           <a:xfrm>
-            <a:off x="5852160" y="205000"/>
+            <a:off x="3154680" y="4775517"/>
             <a:ext cx="3017520" cy="470000"/>
           </a:xfrm>
           <a:prstGeom prst="roundRect">
@@ -15604,7 +15562,7 @@
                   <a:srgbClr val="000000"/>
                 </a:solidFill>
               </a:rPr>
-              <a:t>Check correspondence dynamically</a:t>
+              <a:t>Check correspondence statically</a:t>
             </a:r>
           </a:p>
         </p:txBody>
@@ -15626,7 +15584,7 @@
           <a:p>
             <a:fld id="{B7EB45DA-9A0D-DC49-8E02-F30A5DDC21C3}" type="slidenum">
               <a:rPr lang="en-US" smtClean="0"/>
-              <a:t>26</a:t>
+              <a:t>25</a:t>
             </a:fld>
             <a:endParaRPr lang="en-US"/>
           </a:p>
@@ -15634,7 +15592,7 @@
       </p:sp>
       <p:sp>
         <p:nvSpPr>
-          <p:cNvPr id="2" name="Dy-MODEL"/>
+          <p:cNvPr id="2" name="Sc-MODEL"/>
           <p:cNvSpPr/>
           <p:nvPr/>
         </p:nvSpPr>
@@ -15674,14 +15632,54 @@
       </p:sp>
       <p:sp>
         <p:nvSpPr>
-          <p:cNvPr id="5" name="Dy-ModelCap"/>
+          <p:cNvPr id="5" name="Sc-REALIZATION"/>
           <p:cNvSpPr/>
           <p:nvPr/>
         </p:nvSpPr>
         <p:spPr>
           <a:xfrm>
+            <a:off x="5440680" y="1005840"/>
+            <a:ext cx="3200400" cy="548640"/>
+          </a:xfrm>
+          <a:prstGeom prst="rect">
+            <a:avLst/>
+          </a:prstGeom>
+          <a:solidFill>
+            <a:srgbClr val="8E6F3E"/>
+          </a:solidFill>
+          <a:ln>
+            <a:noFill/>
+          </a:ln>
+          <a:effectLst/>
+        </p:spPr>
+        <p:txBody>
+          <a:bodyPr wrap="square" lIns="27432" tIns="22860" rIns="27432" bIns="22860" rtlCol="0" anchor="ctr"/>
+          <a:lstStyle/>
+          <a:p>
+            <a:pPr algn="ctr">
+              <a:buNone/>
+            </a:pPr>
+            <a:r>
+              <a:rPr lang="en-US" sz="2000" b="1" i="0" dirty="0">
+                <a:solidFill>
+                  <a:srgbClr val="FFFFFF"/>
+                </a:solidFill>
+              </a:rPr>
+              <a:t>REALIZATION</a:t>
+            </a:r>
+          </a:p>
+        </p:txBody>
+      </p:sp>
+      <p:sp>
+        <p:nvSpPr>
+          <p:cNvPr id="6" name="Sc-ModelItems"/>
+          <p:cNvSpPr/>
+          <p:nvPr/>
+        </p:nvSpPr>
+        <p:spPr>
+          <a:xfrm>
             <a:off x="502920" y="1645920"/>
-            <a:ext cx="3200400" cy="457200"/>
+            <a:ext cx="3200400" cy="731520"/>
           </a:xfrm>
           <a:prstGeom prst="rect">
             <a:avLst/>
@@ -15704,88 +15702,42 @@
               <a:buNone/>
             </a:pPr>
             <a:r>
-              <a:rPr lang="en-US" sz="2000" b="0" i="1" dirty="0">
+              <a:rPr lang="en-US" sz="2000" b="0" i="0" dirty="0">
                 <a:solidFill>
                   <a:srgbClr val="5C4826"/>
                 </a:solidFill>
               </a:rPr>
-              <a:t>expected behavior</a:t>
-            </a:r>
-          </a:p>
-        </p:txBody>
-      </p:sp>
-      <p:sp>
-        <p:nvSpPr>
-          <p:cNvPr id="6" name="Dy-EXECUTION"/>
-          <p:cNvSpPr/>
-          <p:nvPr/>
-        </p:nvSpPr>
-        <p:spPr>
-          <a:xfrm>
-            <a:off x="5440680" y="1005840"/>
-            <a:ext cx="3200400" cy="548640"/>
-          </a:xfrm>
-          <a:prstGeom prst="rect">
-            <a:avLst/>
-          </a:prstGeom>
-          <a:solidFill>
-            <a:srgbClr val="8E6F3E"/>
-          </a:solidFill>
-          <a:ln>
-            <a:noFill/>
-          </a:ln>
-          <a:effectLst/>
-        </p:spPr>
-        <p:txBody>
-          <a:bodyPr wrap="square" lIns="27432" tIns="22860" rIns="27432" bIns="22860" rtlCol="0" anchor="ctr"/>
-          <a:lstStyle/>
+              <a:t>lifecycle / bounds</a:t>
+            </a:r>
+          </a:p>
           <a:p>
             <a:pPr algn="ctr">
+              <a:spcBef>
+                <a:spcPts val="300"/>
+              </a:spcBef>
               <a:buNone/>
             </a:pPr>
             <a:r>
-              <a:rPr lang="en-US" sz="2000" b="1" i="0" dirty="0">
-                <a:solidFill>
-                  <a:srgbClr val="FFFFFF"/>
-                </a:solidFill>
-              </a:rPr>
-              <a:t>EXECUTION</a:t>
-            </a:r>
-          </a:p>
-        </p:txBody>
-      </p:sp>
-      <p:cxnSp>
-        <p:nvCxnSpPr>
-          <p:cNvPr id="7" name="Dy-A0"/>
-          <p:cNvCxnSpPr/>
-          <p:nvPr/>
-        </p:nvCxnSpPr>
-        <p:spPr>
-          <a:xfrm>
-            <a:off x="7040880" y="1554480"/>
-            <a:ext cx="0" cy="228600"/>
-          </a:xfrm>
-          <a:prstGeom prst="straightConnector1">
-            <a:avLst/>
-          </a:prstGeom>
-          <a:ln w="19050">
-            <a:solidFill>
-              <a:srgbClr val="8E6F3E"/>
-            </a:solidFill>
-            <a:tailEnd type="triangle"/>
-          </a:ln>
-        </p:spPr>
-      </p:cxnSp>
-      <p:sp>
-        <p:nvSpPr>
-          <p:cNvPr id="8" name="Dy-SENSOR"/>
+              <a:rPr lang="en-US" sz="2000" b="0" i="0" dirty="0">
+                <a:solidFill>
+                  <a:srgbClr val="5C4826"/>
+                </a:solidFill>
+              </a:rPr>
+              <a:t>architectural rules</a:t>
+            </a:r>
+          </a:p>
+        </p:txBody>
+      </p:sp>
+      <p:sp>
+        <p:nvSpPr>
+          <p:cNvPr id="7" name="Sc-RealItems"/>
           <p:cNvSpPr/>
           <p:nvPr/>
         </p:nvSpPr>
         <p:spPr>
           <a:xfrm>
-            <a:off x="5440680" y="1783080"/>
-            <a:ext cx="3200400" cy="457200"/>
+            <a:off x="5440680" y="1645920"/>
+            <a:ext cx="3200400" cy="731520"/>
           </a:xfrm>
           <a:prstGeom prst="rect">
             <a:avLst/>
@@ -15808,26 +15760,42 @@
               <a:buNone/>
             </a:pPr>
             <a:r>
-              <a:rPr lang="en-US" sz="2000" b="1" i="0" dirty="0">
+              <a:rPr lang="en-US" sz="2000" b="0" i="0" dirty="0">
                 <a:solidFill>
                   <a:srgbClr val="5C4826"/>
                 </a:solidFill>
               </a:rPr>
-              <a:t>SENSOR</a:t>
+              <a:t>source code</a:t>
+            </a:r>
+          </a:p>
+          <a:p>
+            <a:pPr algn="ctr">
+              <a:spcBef>
+                <a:spcPts val="300"/>
+              </a:spcBef>
+              <a:buNone/>
+            </a:pPr>
+            <a:r>
+              <a:rPr lang="en-US" sz="2000" b="0" i="0" dirty="0">
+                <a:solidFill>
+                  <a:srgbClr val="5C4826"/>
+                </a:solidFill>
+              </a:rPr>
+              <a:t>configuration</a:t>
             </a:r>
           </a:p>
         </p:txBody>
       </p:sp>
       <p:cxnSp>
         <p:nvCxnSpPr>
-          <p:cNvPr id="9" name="Dy-A1"/>
+          <p:cNvPr id="8" name="Sc-A1"/>
           <p:cNvCxnSpPr/>
           <p:nvPr/>
         </p:nvCxnSpPr>
         <p:spPr>
           <a:xfrm>
-            <a:off x="7040880" y="2240280"/>
-            <a:ext cx="0" cy="228600"/>
+            <a:off x="2103120" y="2377440"/>
+            <a:ext cx="0" cy="274320"/>
           </a:xfrm>
           <a:prstGeom prst="straightConnector1">
             <a:avLst/>
@@ -15840,16 +15808,38 @@
           </a:ln>
         </p:spPr>
       </p:cxnSp>
-      <p:sp>
-        <p:nvSpPr>
-          <p:cNvPr id="10" name="Dy-TRACE"/>
+      <p:cxnSp>
+        <p:nvCxnSpPr>
+          <p:cNvPr id="9" name="Sc-A2"/>
+          <p:cNvCxnSpPr/>
+          <p:nvPr/>
+        </p:nvCxnSpPr>
+        <p:spPr>
+          <a:xfrm>
+            <a:off x="7040880" y="2377440"/>
+            <a:ext cx="0" cy="274320"/>
+          </a:xfrm>
+          <a:prstGeom prst="straightConnector1">
+            <a:avLst/>
+          </a:prstGeom>
+          <a:ln w="19050">
+            <a:solidFill>
+              <a:srgbClr val="8E6F3E"/>
+            </a:solidFill>
+            <a:tailEnd type="triangle"/>
+          </a:ln>
+        </p:spPr>
+      </p:cxnSp>
+      <p:sp>
+        <p:nvSpPr>
+          <p:cNvPr id="10" name="Sc-CHECK"/>
           <p:cNvSpPr/>
           <p:nvPr/>
         </p:nvSpPr>
         <p:spPr>
           <a:xfrm>
-            <a:off x="5440680" y="2468880"/>
-            <a:ext cx="3200400" cy="457200"/>
+            <a:off x="1828800" y="2651760"/>
+            <a:ext cx="5486400" cy="548640"/>
           </a:xfrm>
           <a:prstGeom prst="rect">
             <a:avLst/>
@@ -15877,21 +15867,21 @@
                   <a:srgbClr val="5C4826"/>
                 </a:solidFill>
               </a:rPr>
-              <a:t>TRACE</a:t>
+              <a:t>STATIC CHECK</a:t>
             </a:r>
           </a:p>
         </p:txBody>
       </p:sp>
       <p:cxnSp>
         <p:nvCxnSpPr>
-          <p:cNvPr id="11" name="Dy-A2"/>
+          <p:cNvPr id="11" name="Sc-A3"/>
           <p:cNvCxnSpPr/>
           <p:nvPr/>
         </p:nvCxnSpPr>
         <p:spPr>
           <a:xfrm>
-            <a:off x="7040880" y="2926080"/>
-            <a:ext cx="0" cy="365760"/>
+            <a:off x="4572000" y="3200400"/>
+            <a:ext cx="0" cy="274320"/>
           </a:xfrm>
           <a:prstGeom prst="straightConnector1">
             <a:avLst/>
@@ -15904,38 +15894,56 @@
           </a:ln>
         </p:spPr>
       </p:cxnSp>
-      <p:cxnSp>
-        <p:nvCxnSpPr>
-          <p:cNvPr id="12" name="Dy-A3"/>
-          <p:cNvCxnSpPr/>
-          <p:nvPr/>
-        </p:nvCxnSpPr>
-        <p:spPr>
-          <a:xfrm>
-            <a:off x="2103120" y="2103120"/>
-            <a:ext cx="0" cy="1188720"/>
-          </a:xfrm>
-          <a:prstGeom prst="straightConnector1">
-            <a:avLst/>
-          </a:prstGeom>
-          <a:ln w="19050">
-            <a:solidFill>
-              <a:srgbClr val="8E6F3E"/>
-            </a:solidFill>
-            <a:tailEnd type="triangle"/>
+      <p:sp>
+        <p:nvSpPr>
+          <p:cNvPr id="12" name="Sc-VERDICT"/>
+          <p:cNvSpPr/>
+          <p:nvPr/>
+        </p:nvSpPr>
+        <p:spPr>
+          <a:xfrm>
+            <a:off x="3657600" y="3474720"/>
+            <a:ext cx="1828800" cy="548640"/>
+          </a:xfrm>
+          <a:prstGeom prst="rect">
+            <a:avLst/>
+          </a:prstGeom>
+          <a:solidFill>
+            <a:srgbClr val="8E6F3E"/>
+          </a:solidFill>
+          <a:ln>
+            <a:noFill/>
           </a:ln>
-        </p:spPr>
-      </p:cxnSp>
-      <p:sp>
-        <p:nvSpPr>
-          <p:cNvPr id="13" name="Dy-VALIDATOR"/>
+          <a:effectLst/>
+        </p:spPr>
+        <p:txBody>
+          <a:bodyPr wrap="square" lIns="27432" tIns="22860" rIns="27432" bIns="22860" rtlCol="0" anchor="ctr"/>
+          <a:lstStyle/>
+          <a:p>
+            <a:pPr algn="ctr">
+              <a:buNone/>
+            </a:pPr>
+            <a:r>
+              <a:rPr lang="en-US" sz="2000" b="1" i="0" dirty="0">
+                <a:solidFill>
+                  <a:srgbClr val="FFFFFF"/>
+                </a:solidFill>
+              </a:rPr>
+              <a:t>VERDICT</a:t>
+            </a:r>
+          </a:p>
+        </p:txBody>
+      </p:sp>
+      <p:sp>
+        <p:nvSpPr>
+          <p:cNvPr id="13" name="Sc-Questions"/>
           <p:cNvSpPr/>
           <p:nvPr/>
         </p:nvSpPr>
         <p:spPr>
           <a:xfrm>
-            <a:off x="1828800" y="3291840"/>
-            <a:ext cx="5486400" cy="548640"/>
+            <a:off x="502920" y="4114800"/>
+            <a:ext cx="8138160" cy="1371600"/>
           </a:xfrm>
           <a:prstGeom prst="rect">
             <a:avLst/>
@@ -15954,52 +15962,59 @@
           <a:bodyPr wrap="square" lIns="27432" tIns="22860" rIns="27432" bIns="22860" rtlCol="0" anchor="ctr"/>
           <a:lstStyle/>
           <a:p>
-            <a:pPr algn="ctr">
+            <a:pPr algn="l">
               <a:buNone/>
             </a:pPr>
             <a:r>
-              <a:rPr lang="en-US" sz="2000" b="1" i="0" dirty="0">
+              <a:rPr lang="en-US" sz="2000" b="0" i="0" dirty="0">
                 <a:solidFill>
                   <a:srgbClr val="5C4826"/>
                 </a:solidFill>
               </a:rPr>
-              <a:t>VALIDATOR</a:t>
-            </a:r>
-          </a:p>
-        </p:txBody>
-      </p:sp>
-      <p:cxnSp>
-        <p:nvCxnSpPr>
-          <p:cNvPr id="14" name="Dy-A4"/>
-          <p:cNvCxnSpPr/>
-          <p:nvPr/>
-        </p:nvCxnSpPr>
-        <p:spPr>
-          <a:xfrm>
-            <a:off x="4572000" y="3840480"/>
-            <a:ext cx="0" cy="274320"/>
-          </a:xfrm>
-          <a:prstGeom prst="straightConnector1">
-            <a:avLst/>
-          </a:prstGeom>
-          <a:ln w="19050">
-            <a:solidFill>
-              <a:srgbClr val="8E6F3E"/>
-            </a:solidFill>
-            <a:tailEnd type="triangle"/>
-          </a:ln>
-        </p:spPr>
-      </p:cxnSp>
-      <p:sp>
-        <p:nvSpPr>
-          <p:cNvPr id="15" name="Dy-VERDICT"/>
+              <a:t>Is there any declared correspondence between the model and its realization?</a:t>
+            </a:r>
+          </a:p>
+          <a:p>
+            <a:pPr algn="l">
+              <a:buNone/>
+            </a:pPr>
+            <a:r>
+              <a:rPr lang="en-US" sz="2000" b="0" i="0" dirty="0">
+                <a:solidFill>
+                  <a:srgbClr val="5C4826"/>
+                </a:solidFill>
+              </a:rPr>
+              <a:t>Can any code path admit a third Awake thread?</a:t>
+            </a:r>
+          </a:p>
+          <a:p>
+            <a:pPr algn="l">
+              <a:spcBef>
+                <a:spcPts val="300"/>
+              </a:spcBef>
+              <a:buNone/>
+            </a:pPr>
+            <a:r>
+              <a:rPr lang="en-US" sz="2000" b="0" i="0" dirty="0">
+                <a:solidFill>
+                  <a:srgbClr val="5C4826"/>
+                </a:solidFill>
+              </a:rPr>
+              <a:t>Does the implementation permit a lifecycle transition absent from the model?</a:t>
+            </a:r>
+          </a:p>
+        </p:txBody>
+      </p:sp>
+      <p:sp>
+        <p:nvSpPr>
+          <p:cNvPr id="14" name="FooterBand"/>
           <p:cNvSpPr/>
           <p:nvPr/>
         </p:nvSpPr>
         <p:spPr>
           <a:xfrm>
-            <a:off x="3657600" y="4114800"/>
-            <a:ext cx="1828800" cy="548640"/>
+            <a:off x="274320" y="5623560"/>
+            <a:ext cx="8595360" cy="777240"/>
           </a:xfrm>
           <a:prstGeom prst="rect">
             <a:avLst/>
@@ -16025,105 +16040,7 @@
                   <a:srgbClr val="FFFFFF"/>
                 </a:solidFill>
               </a:rPr>
-              <a:t>VERDICT</a:t>
-            </a:r>
-          </a:p>
-        </p:txBody>
-      </p:sp>
-      <p:sp>
-        <p:nvSpPr>
-          <p:cNvPr id="16" name="Dy-Questions"/>
-          <p:cNvSpPr/>
-          <p:nvPr/>
-        </p:nvSpPr>
-        <p:spPr>
-          <a:xfrm>
-            <a:off x="502920" y="4785360"/>
-            <a:ext cx="8138160" cy="655320"/>
-          </a:xfrm>
-          <a:prstGeom prst="rect">
-            <a:avLst/>
-          </a:prstGeom>
-          <a:solidFill>
-            <a:srgbClr val="F5F1E8"/>
-          </a:solidFill>
-          <a:ln w="12700">
-            <a:solidFill>
-              <a:srgbClr val="C9B991"/>
-            </a:solidFill>
-          </a:ln>
-          <a:effectLst/>
-        </p:spPr>
-        <p:txBody>
-          <a:bodyPr wrap="square" lIns="27432" tIns="22860" rIns="27432" bIns="22860" rtlCol="0" anchor="ctr"/>
-          <a:lstStyle/>
-          <a:p>
-            <a:pPr algn="l">
-              <a:buNone/>
-            </a:pPr>
-            <a:r>
-              <a:rPr lang="en-US" sz="2000" b="0" i="0" dirty="0">
-                <a:solidFill>
-                  <a:srgbClr val="5C4826"/>
-                </a:solidFill>
-              </a:rPr>
-              <a:t>Did the Scheduler ever admit three Awake threads?</a:t>
-            </a:r>
-          </a:p>
-          <a:p>
-            <a:pPr algn="l">
-              <a:spcBef>
-                <a:spcPts val="300"/>
-              </a:spcBef>
-              <a:buNone/>
-            </a:pPr>
-            <a:r>
-              <a:rPr lang="en-US" sz="2000" b="0" i="0" dirty="0">
-                <a:solidFill>
-                  <a:srgbClr val="5C4826"/>
-                </a:solidFill>
-              </a:rPr>
-              <a:t>Did an observed lifecycle transition violate the modeled lifecycle?</a:t>
-            </a:r>
-          </a:p>
-        </p:txBody>
-      </p:sp>
-      <p:sp>
-        <p:nvSpPr>
-          <p:cNvPr id="17" name="FooterBand"/>
-          <p:cNvSpPr/>
-          <p:nvPr/>
-        </p:nvSpPr>
-        <p:spPr>
-          <a:xfrm>
-            <a:off x="274320" y="5760720"/>
-            <a:ext cx="8595360" cy="594360"/>
-          </a:xfrm>
-          <a:prstGeom prst="rect">
-            <a:avLst/>
-          </a:prstGeom>
-          <a:solidFill>
-            <a:srgbClr val="8E6F3E"/>
-          </a:solidFill>
-          <a:ln>
-            <a:noFill/>
-          </a:ln>
-          <a:effectLst/>
-        </p:spPr>
-        <p:txBody>
-          <a:bodyPr wrap="square" lIns="27432" tIns="22860" rIns="27432" bIns="22860" rtlCol="0" anchor="ctr"/>
-          <a:lstStyle/>
-          <a:p>
-            <a:pPr algn="ctr">
-              <a:buNone/>
-            </a:pPr>
-            <a:r>
-              <a:rPr lang="en-US" sz="2000" b="1" i="0" dirty="0">
-                <a:solidFill>
-                  <a:srgbClr val="FFFFFF"/>
-                </a:solidFill>
-              </a:rPr>
-              <a:t>Dynamic evidence establishes correspondence over observed execution.</a:t>
+              <a:t>Static evidence can show correspondence w/o executing the implementation.</a:t>
             </a:r>
           </a:p>
         </p:txBody>
@@ -16171,12 +16088,12 @@
           <a:lstStyle/>
           <a:p>
             <a:r>
-              <a:rPr sz="2400" b="0">
+              <a:rPr sz="2400" b="0" dirty="0">
                 <a:solidFill>
                   <a:srgbClr val="000000"/>
                 </a:solidFill>
               </a:rPr>
-              <a:t>Agreement is not correctness</a:t>
+              <a:t>Check correspondence dynamically</a:t>
             </a:r>
           </a:p>
         </p:txBody>
@@ -16198,7 +16115,7 @@
           <a:p>
             <a:fld id="{B7EB45DA-9A0D-DC49-8E02-F30A5DDC21C3}" type="slidenum">
               <a:rPr lang="en-US" smtClean="0"/>
-              <a:t>27</a:t>
+              <a:t>26</a:t>
             </a:fld>
             <a:endParaRPr lang="en-US"/>
           </a:p>
@@ -16206,14 +16123,14 @@
       </p:sp>
       <p:sp>
         <p:nvSpPr>
-          <p:cNvPr id="5" name="Rectangle 4"/>
+          <p:cNvPr id="2" name="Dy-MODEL"/>
           <p:cNvSpPr/>
           <p:nvPr/>
         </p:nvSpPr>
         <p:spPr>
           <a:xfrm>
-            <a:off x="3474720" y="1097280"/>
-            <a:ext cx="2194560" cy="685800"/>
+            <a:off x="502920" y="1005840"/>
+            <a:ext cx="3200400" cy="548640"/>
           </a:xfrm>
           <a:prstGeom prst="rect">
             <a:avLst/>
@@ -16226,46 +16143,34 @@
           </a:ln>
           <a:effectLst/>
         </p:spPr>
-        <p:style>
-          <a:lnRef idx="1">
-            <a:schemeClr val="accent1"/>
-          </a:lnRef>
-          <a:fillRef idx="3">
-            <a:schemeClr val="accent1"/>
-          </a:fillRef>
-          <a:effectRef idx="2">
-            <a:schemeClr val="accent1"/>
-          </a:effectRef>
-          <a:fontRef idx="minor">
-            <a:schemeClr val="lt1"/>
-          </a:fontRef>
-        </p:style>
         <p:txBody>
           <a:bodyPr wrap="square" lIns="27432" tIns="22860" rIns="27432" bIns="22860" rtlCol="0" anchor="ctr"/>
           <a:lstStyle/>
           <a:p>
-            <a:pPr algn="ctr"/>
-            <a:r>
-              <a:rPr sz="2000" b="1" i="0">
+            <a:pPr algn="ctr">
+              <a:buNone/>
+            </a:pPr>
+            <a:r>
+              <a:rPr lang="en-US" sz="2000" b="1" i="0" dirty="0">
                 <a:solidFill>
                   <a:srgbClr val="FFFFFF"/>
                 </a:solidFill>
               </a:rPr>
-              <a:t>OBLIGATION</a:t>
-            </a:r>
-          </a:p>
-        </p:txBody>
-      </p:sp>
-      <p:sp>
-        <p:nvSpPr>
-          <p:cNvPr id="6" name="Rectangle 5"/>
+              <a:t>MODEL</a:t>
+            </a:r>
+          </a:p>
+        </p:txBody>
+      </p:sp>
+      <p:sp>
+        <p:nvSpPr>
+          <p:cNvPr id="5" name="Dy-ModelCap"/>
           <p:cNvSpPr/>
           <p:nvPr/>
         </p:nvSpPr>
         <p:spPr>
           <a:xfrm>
-            <a:off x="914400" y="3566160"/>
-            <a:ext cx="2194560" cy="685800"/>
+            <a:off x="502920" y="1645920"/>
+            <a:ext cx="3200400" cy="457200"/>
           </a:xfrm>
           <a:prstGeom prst="rect">
             <a:avLst/>
@@ -16280,46 +16185,96 @@
           </a:ln>
           <a:effectLst/>
         </p:spPr>
-        <p:style>
-          <a:lnRef idx="1">
-            <a:schemeClr val="accent1"/>
-          </a:lnRef>
-          <a:fillRef idx="3">
-            <a:schemeClr val="accent1"/>
-          </a:fillRef>
-          <a:effectRef idx="2">
-            <a:schemeClr val="accent1"/>
-          </a:effectRef>
-          <a:fontRef idx="minor">
-            <a:schemeClr val="lt1"/>
-          </a:fontRef>
-        </p:style>
         <p:txBody>
           <a:bodyPr wrap="square" lIns="27432" tIns="22860" rIns="27432" bIns="22860" rtlCol="0" anchor="ctr"/>
           <a:lstStyle/>
           <a:p>
-            <a:pPr algn="ctr"/>
-            <a:r>
-              <a:rPr sz="2000" b="1" i="0">
+            <a:pPr algn="ctr">
+              <a:buNone/>
+            </a:pPr>
+            <a:r>
+              <a:rPr lang="en-US" sz="2000" b="0" i="1" dirty="0">
                 <a:solidFill>
                   <a:srgbClr val="5C4826"/>
                 </a:solidFill>
               </a:rPr>
-              <a:t>MODEL</a:t>
-            </a:r>
-          </a:p>
-        </p:txBody>
-      </p:sp>
-      <p:sp>
-        <p:nvSpPr>
-          <p:cNvPr id="7" name="Rectangle 6"/>
+              <a:t>expected behavior</a:t>
+            </a:r>
+          </a:p>
+        </p:txBody>
+      </p:sp>
+      <p:sp>
+        <p:nvSpPr>
+          <p:cNvPr id="6" name="Dy-EXECUTION"/>
           <p:cNvSpPr/>
           <p:nvPr/>
         </p:nvSpPr>
         <p:spPr>
           <a:xfrm>
-            <a:off x="6035040" y="3566160"/>
-            <a:ext cx="2194560" cy="685800"/>
+            <a:off x="5440680" y="1005840"/>
+            <a:ext cx="3200400" cy="548640"/>
+          </a:xfrm>
+          <a:prstGeom prst="rect">
+            <a:avLst/>
+          </a:prstGeom>
+          <a:solidFill>
+            <a:srgbClr val="8E6F3E"/>
+          </a:solidFill>
+          <a:ln>
+            <a:noFill/>
+          </a:ln>
+          <a:effectLst/>
+        </p:spPr>
+        <p:txBody>
+          <a:bodyPr wrap="square" lIns="27432" tIns="22860" rIns="27432" bIns="22860" rtlCol="0" anchor="ctr"/>
+          <a:lstStyle/>
+          <a:p>
+            <a:pPr algn="ctr">
+              <a:buNone/>
+            </a:pPr>
+            <a:r>
+              <a:rPr lang="en-US" sz="2000" b="1" i="0" dirty="0">
+                <a:solidFill>
+                  <a:srgbClr val="FFFFFF"/>
+                </a:solidFill>
+              </a:rPr>
+              <a:t>EXECUTION</a:t>
+            </a:r>
+          </a:p>
+        </p:txBody>
+      </p:sp>
+      <p:cxnSp>
+        <p:nvCxnSpPr>
+          <p:cNvPr id="7" name="Dy-A0"/>
+          <p:cNvCxnSpPr/>
+          <p:nvPr/>
+        </p:nvCxnSpPr>
+        <p:spPr>
+          <a:xfrm>
+            <a:off x="7040880" y="1554480"/>
+            <a:ext cx="0" cy="228600"/>
+          </a:xfrm>
+          <a:prstGeom prst="straightConnector1">
+            <a:avLst/>
+          </a:prstGeom>
+          <a:ln w="19050">
+            <a:solidFill>
+              <a:srgbClr val="8E6F3E"/>
+            </a:solidFill>
+            <a:tailEnd type="triangle"/>
+          </a:ln>
+        </p:spPr>
+      </p:cxnSp>
+      <p:sp>
+        <p:nvSpPr>
+          <p:cNvPr id="8" name="Dy-SENSOR"/>
+          <p:cNvSpPr/>
+          <p:nvPr/>
+        </p:nvSpPr>
+        <p:spPr>
+          <a:xfrm>
+            <a:off x="5440680" y="1783080"/>
+            <a:ext cx="3200400" cy="457200"/>
           </a:xfrm>
           <a:prstGeom prst="rect">
             <a:avLst/>
@@ -16334,6 +16289,437 @@
           </a:ln>
           <a:effectLst/>
         </p:spPr>
+        <p:txBody>
+          <a:bodyPr wrap="square" lIns="27432" tIns="22860" rIns="27432" bIns="22860" rtlCol="0" anchor="ctr"/>
+          <a:lstStyle/>
+          <a:p>
+            <a:pPr algn="ctr">
+              <a:buNone/>
+            </a:pPr>
+            <a:r>
+              <a:rPr lang="en-US" sz="2000" b="1" i="0" dirty="0">
+                <a:solidFill>
+                  <a:srgbClr val="5C4826"/>
+                </a:solidFill>
+              </a:rPr>
+              <a:t>SENSOR</a:t>
+            </a:r>
+          </a:p>
+        </p:txBody>
+      </p:sp>
+      <p:cxnSp>
+        <p:nvCxnSpPr>
+          <p:cNvPr id="9" name="Dy-A1"/>
+          <p:cNvCxnSpPr/>
+          <p:nvPr/>
+        </p:nvCxnSpPr>
+        <p:spPr>
+          <a:xfrm>
+            <a:off x="7040880" y="2240280"/>
+            <a:ext cx="0" cy="228600"/>
+          </a:xfrm>
+          <a:prstGeom prst="straightConnector1">
+            <a:avLst/>
+          </a:prstGeom>
+          <a:ln w="19050">
+            <a:solidFill>
+              <a:srgbClr val="8E6F3E"/>
+            </a:solidFill>
+            <a:tailEnd type="triangle"/>
+          </a:ln>
+        </p:spPr>
+      </p:cxnSp>
+      <p:sp>
+        <p:nvSpPr>
+          <p:cNvPr id="10" name="Dy-TRACE"/>
+          <p:cNvSpPr/>
+          <p:nvPr/>
+        </p:nvSpPr>
+        <p:spPr>
+          <a:xfrm>
+            <a:off x="5440680" y="2468880"/>
+            <a:ext cx="3200400" cy="457200"/>
+          </a:xfrm>
+          <a:prstGeom prst="rect">
+            <a:avLst/>
+          </a:prstGeom>
+          <a:solidFill>
+            <a:srgbClr val="F5F1E8"/>
+          </a:solidFill>
+          <a:ln w="12700">
+            <a:solidFill>
+              <a:srgbClr val="C9B991"/>
+            </a:solidFill>
+          </a:ln>
+          <a:effectLst/>
+        </p:spPr>
+        <p:txBody>
+          <a:bodyPr wrap="square" lIns="27432" tIns="22860" rIns="27432" bIns="22860" rtlCol="0" anchor="ctr"/>
+          <a:lstStyle/>
+          <a:p>
+            <a:pPr algn="ctr">
+              <a:buNone/>
+            </a:pPr>
+            <a:r>
+              <a:rPr lang="en-US" sz="2000" b="1" i="0" dirty="0">
+                <a:solidFill>
+                  <a:srgbClr val="5C4826"/>
+                </a:solidFill>
+              </a:rPr>
+              <a:t>TRACE</a:t>
+            </a:r>
+          </a:p>
+        </p:txBody>
+      </p:sp>
+      <p:cxnSp>
+        <p:nvCxnSpPr>
+          <p:cNvPr id="11" name="Dy-A2"/>
+          <p:cNvCxnSpPr/>
+          <p:nvPr/>
+        </p:nvCxnSpPr>
+        <p:spPr>
+          <a:xfrm>
+            <a:off x="7040880" y="2926080"/>
+            <a:ext cx="0" cy="365760"/>
+          </a:xfrm>
+          <a:prstGeom prst="straightConnector1">
+            <a:avLst/>
+          </a:prstGeom>
+          <a:ln w="19050">
+            <a:solidFill>
+              <a:srgbClr val="8E6F3E"/>
+            </a:solidFill>
+            <a:tailEnd type="triangle"/>
+          </a:ln>
+        </p:spPr>
+      </p:cxnSp>
+      <p:cxnSp>
+        <p:nvCxnSpPr>
+          <p:cNvPr id="12" name="Dy-A3"/>
+          <p:cNvCxnSpPr/>
+          <p:nvPr/>
+        </p:nvCxnSpPr>
+        <p:spPr>
+          <a:xfrm>
+            <a:off x="2103120" y="2103120"/>
+            <a:ext cx="0" cy="1188720"/>
+          </a:xfrm>
+          <a:prstGeom prst="straightConnector1">
+            <a:avLst/>
+          </a:prstGeom>
+          <a:ln w="19050">
+            <a:solidFill>
+              <a:srgbClr val="8E6F3E"/>
+            </a:solidFill>
+            <a:tailEnd type="triangle"/>
+          </a:ln>
+        </p:spPr>
+      </p:cxnSp>
+      <p:sp>
+        <p:nvSpPr>
+          <p:cNvPr id="13" name="Dy-VALIDATOR"/>
+          <p:cNvSpPr/>
+          <p:nvPr/>
+        </p:nvSpPr>
+        <p:spPr>
+          <a:xfrm>
+            <a:off x="1828800" y="3291840"/>
+            <a:ext cx="5486400" cy="548640"/>
+          </a:xfrm>
+          <a:prstGeom prst="rect">
+            <a:avLst/>
+          </a:prstGeom>
+          <a:solidFill>
+            <a:srgbClr val="F5F1E8"/>
+          </a:solidFill>
+          <a:ln w="12700">
+            <a:solidFill>
+              <a:srgbClr val="C9B991"/>
+            </a:solidFill>
+          </a:ln>
+          <a:effectLst/>
+        </p:spPr>
+        <p:txBody>
+          <a:bodyPr wrap="square" lIns="27432" tIns="22860" rIns="27432" bIns="22860" rtlCol="0" anchor="ctr"/>
+          <a:lstStyle/>
+          <a:p>
+            <a:pPr algn="ctr">
+              <a:buNone/>
+            </a:pPr>
+            <a:r>
+              <a:rPr lang="en-US" sz="2000" b="1" i="0" dirty="0">
+                <a:solidFill>
+                  <a:srgbClr val="5C4826"/>
+                </a:solidFill>
+              </a:rPr>
+              <a:t>VALIDATOR</a:t>
+            </a:r>
+          </a:p>
+        </p:txBody>
+      </p:sp>
+      <p:cxnSp>
+        <p:nvCxnSpPr>
+          <p:cNvPr id="14" name="Dy-A4"/>
+          <p:cNvCxnSpPr/>
+          <p:nvPr/>
+        </p:nvCxnSpPr>
+        <p:spPr>
+          <a:xfrm>
+            <a:off x="4572000" y="3840480"/>
+            <a:ext cx="0" cy="274320"/>
+          </a:xfrm>
+          <a:prstGeom prst="straightConnector1">
+            <a:avLst/>
+          </a:prstGeom>
+          <a:ln w="19050">
+            <a:solidFill>
+              <a:srgbClr val="8E6F3E"/>
+            </a:solidFill>
+            <a:tailEnd type="triangle"/>
+          </a:ln>
+        </p:spPr>
+      </p:cxnSp>
+      <p:sp>
+        <p:nvSpPr>
+          <p:cNvPr id="15" name="Dy-VERDICT"/>
+          <p:cNvSpPr/>
+          <p:nvPr/>
+        </p:nvSpPr>
+        <p:spPr>
+          <a:xfrm>
+            <a:off x="3657600" y="4114800"/>
+            <a:ext cx="1828800" cy="548640"/>
+          </a:xfrm>
+          <a:prstGeom prst="rect">
+            <a:avLst/>
+          </a:prstGeom>
+          <a:solidFill>
+            <a:srgbClr val="8E6F3E"/>
+          </a:solidFill>
+          <a:ln>
+            <a:noFill/>
+          </a:ln>
+          <a:effectLst/>
+        </p:spPr>
+        <p:txBody>
+          <a:bodyPr wrap="square" lIns="27432" tIns="22860" rIns="27432" bIns="22860" rtlCol="0" anchor="ctr"/>
+          <a:lstStyle/>
+          <a:p>
+            <a:pPr algn="ctr">
+              <a:buNone/>
+            </a:pPr>
+            <a:r>
+              <a:rPr lang="en-US" sz="2000" b="1" i="0" dirty="0">
+                <a:solidFill>
+                  <a:srgbClr val="FFFFFF"/>
+                </a:solidFill>
+              </a:rPr>
+              <a:t>VERDICT</a:t>
+            </a:r>
+          </a:p>
+        </p:txBody>
+      </p:sp>
+      <p:sp>
+        <p:nvSpPr>
+          <p:cNvPr id="16" name="Dy-Questions"/>
+          <p:cNvSpPr/>
+          <p:nvPr/>
+        </p:nvSpPr>
+        <p:spPr>
+          <a:xfrm>
+            <a:off x="502920" y="4785360"/>
+            <a:ext cx="8138160" cy="655320"/>
+          </a:xfrm>
+          <a:prstGeom prst="rect">
+            <a:avLst/>
+          </a:prstGeom>
+          <a:solidFill>
+            <a:srgbClr val="F5F1E8"/>
+          </a:solidFill>
+          <a:ln w="12700">
+            <a:solidFill>
+              <a:srgbClr val="C9B991"/>
+            </a:solidFill>
+          </a:ln>
+          <a:effectLst/>
+        </p:spPr>
+        <p:txBody>
+          <a:bodyPr wrap="square" lIns="27432" tIns="22860" rIns="27432" bIns="22860" rtlCol="0" anchor="ctr"/>
+          <a:lstStyle/>
+          <a:p>
+            <a:pPr algn="l">
+              <a:buNone/>
+            </a:pPr>
+            <a:r>
+              <a:rPr lang="en-US" sz="2000" b="0" i="0" dirty="0">
+                <a:solidFill>
+                  <a:srgbClr val="5C4826"/>
+                </a:solidFill>
+              </a:rPr>
+              <a:t>Did the Scheduler ever admit three Awake threads?</a:t>
+            </a:r>
+          </a:p>
+          <a:p>
+            <a:pPr algn="l">
+              <a:spcBef>
+                <a:spcPts val="300"/>
+              </a:spcBef>
+              <a:buNone/>
+            </a:pPr>
+            <a:r>
+              <a:rPr lang="en-US" sz="2000" b="0" i="0" dirty="0">
+                <a:solidFill>
+                  <a:srgbClr val="5C4826"/>
+                </a:solidFill>
+              </a:rPr>
+              <a:t>Did an observed lifecycle transition violate the modeled lifecycle?</a:t>
+            </a:r>
+          </a:p>
+        </p:txBody>
+      </p:sp>
+      <p:sp>
+        <p:nvSpPr>
+          <p:cNvPr id="17" name="FooterBand"/>
+          <p:cNvSpPr/>
+          <p:nvPr/>
+        </p:nvSpPr>
+        <p:spPr>
+          <a:xfrm>
+            <a:off x="274320" y="5760720"/>
+            <a:ext cx="8595360" cy="594360"/>
+          </a:xfrm>
+          <a:prstGeom prst="rect">
+            <a:avLst/>
+          </a:prstGeom>
+          <a:solidFill>
+            <a:srgbClr val="8E6F3E"/>
+          </a:solidFill>
+          <a:ln>
+            <a:noFill/>
+          </a:ln>
+          <a:effectLst/>
+        </p:spPr>
+        <p:txBody>
+          <a:bodyPr wrap="square" lIns="27432" tIns="22860" rIns="27432" bIns="22860" rtlCol="0" anchor="ctr"/>
+          <a:lstStyle/>
+          <a:p>
+            <a:pPr algn="ctr">
+              <a:buNone/>
+            </a:pPr>
+            <a:r>
+              <a:rPr lang="en-US" sz="2000" b="1" i="0" dirty="0">
+                <a:solidFill>
+                  <a:srgbClr val="FFFFFF"/>
+                </a:solidFill>
+              </a:rPr>
+              <a:t>Dynamic evidence establishes correspondence over observed execution.</a:t>
+            </a:r>
+          </a:p>
+        </p:txBody>
+      </p:sp>
+    </p:spTree>
+  </p:cSld>
+  <p:clrMapOvr>
+    <a:masterClrMapping/>
+  </p:clrMapOvr>
+</p:sld>
+</file>
+
+<file path=ppt/slides/slide27.xml><?xml version="1.0" encoding="utf-8"?>
+<p:sld xmlns:a="http://schemas.openxmlformats.org/drawingml/2006/main" xmlns:r="http://schemas.openxmlformats.org/officeDocument/2006/relationships" xmlns:p="http://schemas.openxmlformats.org/presentationml/2006/main">
+  <p:cSld>
+    <p:spTree>
+      <p:nvGrpSpPr>
+        <p:cNvPr id="1" name=""/>
+        <p:cNvGrpSpPr/>
+        <p:nvPr/>
+      </p:nvGrpSpPr>
+      <p:grpSpPr>
+        <a:xfrm>
+          <a:off x="0" y="0"/>
+          <a:ext cx="0" cy="0"/>
+          <a:chOff x="0" y="0"/>
+          <a:chExt cx="0" cy="0"/>
+        </a:xfrm>
+      </p:grpSpPr>
+      <p:sp>
+        <p:nvSpPr>
+          <p:cNvPr id="3" name="Title 2"/>
+          <p:cNvSpPr>
+            <a:spLocks noGrp="1"/>
+          </p:cNvSpPr>
+          <p:nvPr>
+            <p:ph type="title"/>
+          </p:nvPr>
+        </p:nvSpPr>
+        <p:spPr/>
+        <p:txBody>
+          <a:bodyPr wrap="square">
+            <a:normAutofit fontScale="90000"/>
+          </a:bodyPr>
+          <a:lstStyle/>
+          <a:p>
+            <a:r>
+              <a:rPr lang="en-US" sz="2400" dirty="0">
+                <a:solidFill>
+                  <a:srgbClr val="000000"/>
+                </a:solidFill>
+              </a:rPr>
+              <a:t>Alignment helps us answer just one of three questions</a:t>
+            </a:r>
+            <a:endParaRPr sz="2400" b="0" dirty="0">
+              <a:solidFill>
+                <a:srgbClr val="000000"/>
+              </a:solidFill>
+            </a:endParaRPr>
+          </a:p>
+        </p:txBody>
+      </p:sp>
+      <p:sp>
+        <p:nvSpPr>
+          <p:cNvPr id="4" name="Slide Number Placeholder 5"/>
+          <p:cNvSpPr>
+            <a:spLocks noGrp="1"/>
+          </p:cNvSpPr>
+          <p:nvPr>
+            <p:ph type="sldNum" sz="quarter" idx="4"/>
+          </p:nvPr>
+        </p:nvSpPr>
+        <p:spPr/>
+        <p:txBody>
+          <a:bodyPr/>
+          <a:lstStyle/>
+          <a:p>
+            <a:fld id="{B7EB45DA-9A0D-DC49-8E02-F30A5DDC21C3}" type="slidenum">
+              <a:rPr lang="en-US" smtClean="0"/>
+              <a:t>27</a:t>
+            </a:fld>
+            <a:endParaRPr lang="en-US"/>
+          </a:p>
+        </p:txBody>
+      </p:sp>
+      <p:sp>
+        <p:nvSpPr>
+          <p:cNvPr id="5" name="Rectangle 4"/>
+          <p:cNvSpPr/>
+          <p:nvPr/>
+        </p:nvSpPr>
+        <p:spPr>
+          <a:xfrm>
+            <a:off x="3474720" y="1097280"/>
+            <a:ext cx="2194560" cy="685800"/>
+          </a:xfrm>
+          <a:prstGeom prst="rect">
+            <a:avLst/>
+          </a:prstGeom>
+          <a:solidFill>
+            <a:srgbClr val="8E6F3E"/>
+          </a:solidFill>
+          <a:ln>
+            <a:noFill/>
+          </a:ln>
+          <a:effectLst/>
+        </p:spPr>
         <p:style>
           <a:lnRef idx="1">
             <a:schemeClr val="accent1"/>
@@ -16356,6 +16742,114 @@
             <a:r>
               <a:rPr sz="2000" b="1" i="0">
                 <a:solidFill>
+                  <a:srgbClr val="FFFFFF"/>
+                </a:solidFill>
+              </a:rPr>
+              <a:t>OBLIGATION</a:t>
+            </a:r>
+          </a:p>
+        </p:txBody>
+      </p:sp>
+      <p:sp>
+        <p:nvSpPr>
+          <p:cNvPr id="6" name="Rectangle 5"/>
+          <p:cNvSpPr/>
+          <p:nvPr/>
+        </p:nvSpPr>
+        <p:spPr>
+          <a:xfrm>
+            <a:off x="914400" y="3566160"/>
+            <a:ext cx="2194560" cy="685800"/>
+          </a:xfrm>
+          <a:prstGeom prst="rect">
+            <a:avLst/>
+          </a:prstGeom>
+          <a:solidFill>
+            <a:srgbClr val="F5F1E8"/>
+          </a:solidFill>
+          <a:ln w="12700">
+            <a:solidFill>
+              <a:srgbClr val="C9B991"/>
+            </a:solidFill>
+          </a:ln>
+          <a:effectLst/>
+        </p:spPr>
+        <p:style>
+          <a:lnRef idx="1">
+            <a:schemeClr val="accent1"/>
+          </a:lnRef>
+          <a:fillRef idx="3">
+            <a:schemeClr val="accent1"/>
+          </a:fillRef>
+          <a:effectRef idx="2">
+            <a:schemeClr val="accent1"/>
+          </a:effectRef>
+          <a:fontRef idx="minor">
+            <a:schemeClr val="lt1"/>
+          </a:fontRef>
+        </p:style>
+        <p:txBody>
+          <a:bodyPr wrap="square" lIns="27432" tIns="22860" rIns="27432" bIns="22860" rtlCol="0" anchor="ctr"/>
+          <a:lstStyle/>
+          <a:p>
+            <a:pPr algn="ctr"/>
+            <a:r>
+              <a:rPr sz="2000" b="1" i="0">
+                <a:solidFill>
+                  <a:srgbClr val="5C4826"/>
+                </a:solidFill>
+              </a:rPr>
+              <a:t>MODEL</a:t>
+            </a:r>
+          </a:p>
+        </p:txBody>
+      </p:sp>
+      <p:sp>
+        <p:nvSpPr>
+          <p:cNvPr id="7" name="Rectangle 6"/>
+          <p:cNvSpPr/>
+          <p:nvPr/>
+        </p:nvSpPr>
+        <p:spPr>
+          <a:xfrm>
+            <a:off x="6035040" y="3566160"/>
+            <a:ext cx="2194560" cy="685800"/>
+          </a:xfrm>
+          <a:prstGeom prst="rect">
+            <a:avLst/>
+          </a:prstGeom>
+          <a:solidFill>
+            <a:srgbClr val="F5F1E8"/>
+          </a:solidFill>
+          <a:ln w="12700">
+            <a:solidFill>
+              <a:srgbClr val="C9B991"/>
+            </a:solidFill>
+          </a:ln>
+          <a:effectLst/>
+        </p:spPr>
+        <p:style>
+          <a:lnRef idx="1">
+            <a:schemeClr val="accent1"/>
+          </a:lnRef>
+          <a:fillRef idx="3">
+            <a:schemeClr val="accent1"/>
+          </a:fillRef>
+          <a:effectRef idx="2">
+            <a:schemeClr val="accent1"/>
+          </a:effectRef>
+          <a:fontRef idx="minor">
+            <a:schemeClr val="lt1"/>
+          </a:fontRef>
+        </p:style>
+        <p:txBody>
+          <a:bodyPr wrap="square" lIns="27432" tIns="22860" rIns="27432" bIns="22860" rtlCol="0" anchor="ctr"/>
+          <a:lstStyle/>
+          <a:p>
+            <a:pPr algn="ctr"/>
+            <a:r>
+              <a:rPr sz="2000" b="1" i="0">
+                <a:solidFill>
                   <a:srgbClr val="5C4826"/>
                 </a:solidFill>
               </a:rPr>
@@ -16382,6 +16876,9 @@
             <a:solidFill>
               <a:srgbClr val="8E6F3E"/>
             </a:solidFill>
+            <a:prstDash val="sysDot"/>
+            <a:headEnd type="arrow" w="med" len="med"/>
+            <a:tailEnd type="none" w="med" len="med"/>
           </a:ln>
           <a:effectLst/>
         </p:spPr>
@@ -16418,6 +16915,7 @@
             <a:solidFill>
               <a:srgbClr val="8E6F3E"/>
             </a:solidFill>
+            <a:prstDash val="sysDot"/>
           </a:ln>
           <a:effectLst/>
         </p:spPr>
@@ -16454,6 +16952,9 @@
             <a:solidFill>
               <a:srgbClr val="8E6F3E"/>
             </a:solidFill>
+            <a:prstDash val="sysDot"/>
+            <a:headEnd type="arrow" w="med" len="med"/>
+            <a:tailEnd type="none" w="med" len="med"/>
           </a:ln>
           <a:effectLst/>
         </p:spPr>
@@ -16490,6 +16991,7 @@
             <a:solidFill>
               <a:srgbClr val="8E6F3E"/>
             </a:solidFill>
+            <a:prstDash val="sysDot"/>
           </a:ln>
           <a:effectLst/>
         </p:spPr>
@@ -16552,8 +17054,8 @@
         </p:nvSpPr>
         <p:spPr>
           <a:xfrm>
-            <a:off x="2121408" y="2331720"/>
-            <a:ext cx="2395728" cy="640080"/>
+            <a:off x="713232" y="1076643"/>
+            <a:ext cx="2395728" cy="461665"/>
           </a:xfrm>
           <a:prstGeom prst="rect">
             <a:avLst/>
@@ -16568,7 +17070,7 @@
           <a:p>
             <a:pPr algn="l"/>
             <a:r>
-              <a:rPr sz="2000" b="0">
+              <a:rPr sz="2400" b="0" i="1" dirty="0">
                 <a:solidFill>
                   <a:srgbClr val="555960"/>
                 </a:solidFill>
@@ -16586,8 +17088,8 @@
         </p:nvSpPr>
         <p:spPr>
           <a:xfrm>
-            <a:off x="4626864" y="2331720"/>
-            <a:ext cx="2395728" cy="640080"/>
+            <a:off x="6119622" y="1072187"/>
+            <a:ext cx="2395728" cy="461665"/>
           </a:xfrm>
           <a:prstGeom prst="rect">
             <a:avLst/>
@@ -16602,7 +17104,7 @@
           <a:p>
             <a:pPr algn="r"/>
             <a:r>
-              <a:rPr sz="2000" b="0">
+              <a:rPr sz="2400" b="0" i="1" dirty="0">
                 <a:solidFill>
                   <a:srgbClr val="555960"/>
                 </a:solidFill>
@@ -16621,7 +17123,7 @@
         <p:spPr>
           <a:xfrm>
             <a:off x="3108960" y="4069080"/>
-            <a:ext cx="2926080" cy="411480"/>
+            <a:ext cx="2926080" cy="461665"/>
           </a:xfrm>
           <a:prstGeom prst="rect">
             <a:avLst/>
@@ -16636,7 +17138,7 @@
           <a:p>
             <a:pPr algn="ctr"/>
             <a:r>
-              <a:rPr sz="2000" b="0">
+              <a:rPr sz="2400" b="0" dirty="0">
                 <a:solidFill>
                   <a:srgbClr val="555960"/>
                 </a:solidFill>
@@ -16654,8 +17156,8 @@
         </p:nvSpPr>
         <p:spPr>
           <a:xfrm>
-            <a:off x="274320" y="4572000"/>
-            <a:ext cx="8595360" cy="1143000"/>
+            <a:off x="274320" y="4774530"/>
+            <a:ext cx="8595360" cy="1015663"/>
           </a:xfrm>
           <a:prstGeom prst="rect">
             <a:avLst/>
@@ -16670,15 +17172,34 @@
           <a:p>
             <a:pPr algn="ctr"/>
             <a:r>
-              <a:rPr sz="2000" b="0">
+              <a:rPr lang="en-US" sz="2000" b="1" i="1" dirty="0">
                 <a:solidFill>
                   <a:srgbClr val="5C4826"/>
                 </a:solidFill>
               </a:rPr>
-              <a:t>model ↔ realization — </a:t>
-            </a:r>
-            <a:r>
-              <a:rPr sz="2000" b="1">
+              <a:t>Vocabulary</a:t>
+            </a:r>
+          </a:p>
+          <a:p>
+            <a:pPr algn="ctr"/>
+            <a:r>
+              <a:rPr lang="en-US" sz="2000" dirty="0">
+                <a:solidFill>
+                  <a:srgbClr val="5C4826"/>
+                </a:solidFill>
+              </a:rPr>
+              <a:t>M</a:t>
+            </a:r>
+            <a:r>
+              <a:rPr sz="2000" b="0" dirty="0">
+                <a:solidFill>
+                  <a:srgbClr val="5C4826"/>
+                </a:solidFill>
+              </a:rPr>
+              <a:t>odel ↔ realization — </a:t>
+            </a:r>
+            <a:r>
+              <a:rPr sz="2000" b="1" dirty="0">
                 <a:solidFill>
                   <a:srgbClr val="8E6F3E"/>
                 </a:solidFill>
@@ -16689,15 +17210,31 @@
           <a:p>
             <a:pPr algn="ctr"/>
             <a:r>
-              <a:rPr sz="2000" b="0">
+              <a:rPr lang="en-US" sz="2000" b="0" dirty="0">
                 <a:solidFill>
                   <a:srgbClr val="5C4826"/>
                 </a:solidFill>
               </a:rPr>
-              <a:t>realization ↔ obligation — </a:t>
-            </a:r>
-            <a:r>
-              <a:rPr sz="2000" b="1">
+              <a:t>Model/</a:t>
+            </a:r>
+            <a:r>
+              <a:rPr lang="en-US" sz="2000" dirty="0">
+                <a:solidFill>
+                  <a:srgbClr val="5C4826"/>
+                </a:solidFill>
+              </a:rPr>
+              <a:t>R</a:t>
+            </a:r>
+            <a:r>
+              <a:rPr sz="2000" b="0" dirty="0">
+                <a:solidFill>
+                  <a:srgbClr val="5C4826"/>
+                </a:solidFill>
+              </a:rPr>
+              <a:t>ealization ↔ obligation — </a:t>
+            </a:r>
+            <a:r>
+              <a:rPr sz="2000" b="1" dirty="0">
                 <a:solidFill>
                   <a:srgbClr val="8E6F3E"/>
                 </a:solidFill>
@@ -16755,6 +17292,41 @@
                 </a:solidFill>
               </a:rPr>
               <a:t>Correspondence is one edge, not the whole triangle.</a:t>
+            </a:r>
+          </a:p>
+        </p:txBody>
+      </p:sp>
+      <p:sp>
+        <p:nvSpPr>
+          <p:cNvPr id="2" name="TextBox 1">
+            <a:extLst>
+              <a:ext uri="{FF2B5EF4-FFF2-40B4-BE49-F238E27FC236}">
+                <a16:creationId xmlns:a16="http://schemas.microsoft.com/office/drawing/2014/main" id="{E51D8973-EDB4-AC8B-A0CE-64034FAE3609}"/>
+              </a:ext>
+            </a:extLst>
+          </p:cNvPr>
+          <p:cNvSpPr txBox="1"/>
+          <p:nvPr/>
+        </p:nvSpPr>
+        <p:spPr>
+          <a:xfrm>
+            <a:off x="3429564" y="3142457"/>
+            <a:ext cx="2239716" cy="584775"/>
+          </a:xfrm>
+          <a:prstGeom prst="rect">
+            <a:avLst/>
+          </a:prstGeom>
+          <a:noFill/>
+        </p:spPr>
+        <p:txBody>
+          <a:bodyPr wrap="none" rtlCol="0">
+            <a:spAutoFit/>
+          </a:bodyPr>
+          <a:lstStyle/>
+          <a:p>
+            <a:r>
+              <a:rPr lang="en-US" sz="3200" dirty="0"/>
+              <a:t>ALIGNMENT</a:t>
             </a:r>
           </a:p>
         </p:txBody>
@@ -16767,7 +17339,7 @@
 </p:sld>
 </file>
 
-<file path=ppt/slides/slide27.xml><?xml version="1.0" encoding="utf-8"?>
+<file path=ppt/slides/slide28.xml><?xml version="1.0" encoding="utf-8"?>
 <p:sld xmlns:a="http://schemas.openxmlformats.org/drawingml/2006/main" xmlns:r="http://schemas.openxmlformats.org/officeDocument/2006/relationships" xmlns:p="http://schemas.openxmlformats.org/presentationml/2006/main">
   <p:cSld>
     <p:spTree>
@@ -17136,522 +17708,6 @@
 </p:sld>
 </file>
 
-<file path=ppt/slides/slide28.xml><?xml version="1.0" encoding="utf-8"?>
-<p:sld xmlns:a="http://schemas.openxmlformats.org/drawingml/2006/main" xmlns:r="http://schemas.openxmlformats.org/officeDocument/2006/relationships" xmlns:p="http://schemas.openxmlformats.org/presentationml/2006/main">
-  <p:cSld>
-    <p:spTree>
-      <p:nvGrpSpPr>
-        <p:cNvPr id="1" name=""/>
-        <p:cNvGrpSpPr/>
-        <p:nvPr/>
-      </p:nvGrpSpPr>
-      <p:grpSpPr>
-        <a:xfrm>
-          <a:off x="0" y="0"/>
-          <a:ext cx="0" cy="0"/>
-          <a:chOff x="0" y="0"/>
-          <a:chExt cx="0" cy="0"/>
-        </a:xfrm>
-      </p:grpSpPr>
-      <p:sp>
-        <p:nvSpPr>
-          <p:cNvPr id="3" name="Title 2"/>
-          <p:cNvSpPr>
-            <a:spLocks noGrp="1"/>
-          </p:cNvSpPr>
-          <p:nvPr>
-            <p:ph type="title"/>
-          </p:nvPr>
-        </p:nvSpPr>
-        <p:spPr>
-          <a:xfrm>
-            <a:off x="274320" y="18288"/>
-            <a:ext cx="8046720" cy="731520"/>
-          </a:xfrm>
-        </p:spPr>
-        <p:txBody>
-          <a:bodyPr wrap="square">
-            <a:normAutofit fontScale="90000"/>
-          </a:bodyPr>
-          <a:lstStyle/>
-          <a:p>
-            <a:r>
-              <a:rPr sz="2400" b="0" dirty="0">
-                <a:solidFill>
-                  <a:srgbClr val="000000"/>
-                </a:solidFill>
-              </a:rPr>
-              <a:t>Back to the lab:</a:t>
-            </a:r>
-          </a:p>
-          <a:p>
-            <a:r>
-              <a:rPr lang="en-US" sz="2400" dirty="0">
-                <a:solidFill>
-                  <a:srgbClr val="000000"/>
-                </a:solidFill>
-              </a:rPr>
-              <a:t>D</a:t>
-            </a:r>
-            <a:r>
-              <a:rPr sz="2400" b="0" dirty="0">
-                <a:solidFill>
-                  <a:srgbClr val="000000"/>
-                </a:solidFill>
-              </a:rPr>
-              <a:t>esign the Alignment</a:t>
-            </a:r>
-          </a:p>
-        </p:txBody>
-      </p:sp>
-      <p:sp>
-        <p:nvSpPr>
-          <p:cNvPr id="4" name="Slide Number Placeholder 5"/>
-          <p:cNvSpPr>
-            <a:spLocks noGrp="1"/>
-          </p:cNvSpPr>
-          <p:nvPr>
-            <p:ph type="sldNum" sz="quarter" idx="4"/>
-          </p:nvPr>
-        </p:nvSpPr>
-        <p:spPr/>
-        <p:txBody>
-          <a:bodyPr/>
-          <a:lstStyle/>
-          <a:p>
-            <a:fld id="{B7EB45DA-9A0D-DC49-8E02-F30A5DDC21C3}" type="slidenum">
-              <a:rPr lang="en-US" smtClean="0"/>
-              <a:t>29</a:t>
-            </a:fld>
-            <a:endParaRPr lang="en-US"/>
-          </a:p>
-        </p:txBody>
-      </p:sp>
-      <p:sp>
-        <p:nvSpPr>
-          <p:cNvPr id="5" name="KickerBadge">
-            <a:extLst>
-              <a:ext uri="{FF2B5EF4-FFF2-40B4-BE49-F238E27FC236}">
-                <a16:creationId xmlns:a16="http://schemas.microsoft.com/office/drawing/2014/main" id="{55489336-5766-22EA-2ADC-D9F38F769456}"/>
-              </a:ext>
-            </a:extLst>
-          </p:cNvPr>
-          <p:cNvSpPr/>
-          <p:nvPr/>
-        </p:nvSpPr>
-        <p:spPr>
-          <a:xfrm>
-            <a:off x="4480560" y="205000"/>
-            <a:ext cx="4389120" cy="470000"/>
-          </a:xfrm>
-          <a:prstGeom prst="roundRect">
-            <a:avLst/>
-          </a:prstGeom>
-          <a:solidFill>
-            <a:srgbClr val="FBF8F2"/>
-          </a:solidFill>
-          <a:ln w="15875">
-            <a:solidFill>
-              <a:srgbClr val="8E6F3E"/>
-            </a:solidFill>
-          </a:ln>
-        </p:spPr>
-        <p:txBody>
-          <a:bodyPr wrap="square" lIns="91440" tIns="27432" rIns="91440" bIns="27432" anchor="ctr"/>
-          <a:lstStyle/>
-          <a:p>
-            <a:pPr algn="ctr">
-              <a:buNone/>
-            </a:pPr>
-            <a:r>
-              <a:rPr lang="en-US" sz="2000" b="1" i="0" dirty="0">
-                <a:solidFill>
-                  <a:srgbClr val="8E6F3E"/>
-                </a:solidFill>
-              </a:rPr>
-              <a:t>TEAM ACTIVITY  ·  10–12 MINUTES</a:t>
-            </a:r>
-          </a:p>
-        </p:txBody>
-      </p:sp>
-      <p:sp>
-        <p:nvSpPr>
-          <p:cNvPr id="12" name="FooterBand"/>
-          <p:cNvSpPr/>
-          <p:nvPr/>
-        </p:nvSpPr>
-        <p:spPr>
-          <a:xfrm>
-            <a:off x="274320" y="5852160"/>
-            <a:ext cx="8595360" cy="566928"/>
-          </a:xfrm>
-          <a:prstGeom prst="rect">
-            <a:avLst/>
-          </a:prstGeom>
-          <a:solidFill>
-            <a:srgbClr val="8E6F3E"/>
-          </a:solidFill>
-          <a:ln>
-            <a:noFill/>
-          </a:ln>
-          <a:effectLst/>
-        </p:spPr>
-        <p:style>
-          <a:lnRef idx="1">
-            <a:schemeClr val="accent1"/>
-          </a:lnRef>
-          <a:fillRef idx="3">
-            <a:schemeClr val="accent1"/>
-          </a:fillRef>
-          <a:effectRef idx="2">
-            <a:schemeClr val="accent1"/>
-          </a:effectRef>
-          <a:fontRef idx="minor">
-            <a:schemeClr val="lt1"/>
-          </a:fontRef>
-        </p:style>
-        <p:txBody>
-          <a:bodyPr wrap="square" rtlCol="0" anchor="ctr"/>
-          <a:lstStyle/>
-          <a:p>
-            <a:pPr algn="ctr"/>
-            <a:r>
-              <a:rPr sz="2000" b="1" i="0">
-                <a:solidFill>
-                  <a:srgbClr val="FFFFFF"/>
-                </a:solidFill>
-              </a:rPr>
-              <a:t>OBLIGATION  →  MODEL  →  CHECK  →  DECIDE  →  CONTROL</a:t>
-            </a:r>
-          </a:p>
-        </p:txBody>
-      </p:sp>
-      <p:sp>
-        <p:nvSpPr>
-          <p:cNvPr id="13" name="Card-memory"/>
-          <p:cNvSpPr/>
-          <p:nvPr/>
-        </p:nvSpPr>
-        <p:spPr>
-          <a:xfrm>
-            <a:off x="274320" y="1051560"/>
-            <a:ext cx="4069080" cy="2103120"/>
-          </a:xfrm>
-          <a:prstGeom prst="rect">
-            <a:avLst/>
-          </a:prstGeom>
-          <a:solidFill>
-            <a:srgbClr val="F5F1E8"/>
-          </a:solidFill>
-          <a:ln w="12700">
-            <a:solidFill>
-              <a:srgbClr val="C9B991"/>
-            </a:solidFill>
-          </a:ln>
-          <a:effectLst/>
-        </p:spPr>
-        <p:txBody>
-          <a:bodyPr wrap="square" lIns="27432" tIns="22860" rIns="27432" bIns="22860" rtlCol="0" anchor="t"/>
-          <a:lstStyle/>
-          <a:p>
-            <a:pPr algn="ctr">
-              <a:buNone/>
-            </a:pPr>
-            <a:r>
-              <a:rPr lang="en-US" sz="2000" b="1" i="0" dirty="0">
-                <a:solidFill>
-                  <a:srgbClr val="5C4826"/>
-                </a:solidFill>
-              </a:rPr>
-              <a:t>DEVICE FIRMWARE</a:t>
-            </a:r>
-          </a:p>
-          <a:p>
-            <a:pPr algn="ctr">
-              <a:spcBef>
-                <a:spcPts val="900"/>
-              </a:spcBef>
-              <a:buNone/>
-            </a:pPr>
-            <a:r>
-              <a:rPr lang="en-US" sz="2000" b="0" i="1" dirty="0">
-                <a:solidFill>
-                  <a:srgbClr val="555960"/>
-                </a:solidFill>
-              </a:rPr>
-              <a:t>working memory view</a:t>
-            </a:r>
-          </a:p>
-          <a:p>
-            <a:pPr algn="l">
-              <a:spcBef>
-                <a:spcPts val="900"/>
-              </a:spcBef>
-              <a:buNone/>
-            </a:pPr>
-            <a:r>
-              <a:rPr lang="en-US" sz="2000" b="0" i="0" dirty="0">
-                <a:solidFill>
-                  <a:srgbClr val="5C4826"/>
-                </a:solidFill>
-              </a:rPr>
-              <a:t>Sense · Analyze · Transmit</a:t>
-            </a:r>
-          </a:p>
-          <a:p>
-            <a:pPr algn="l">
-              <a:spcBef>
-                <a:spcPts val="900"/>
-              </a:spcBef>
-              <a:buNone/>
-            </a:pPr>
-            <a:r>
-              <a:rPr lang="en-US" sz="2000" b="0" i="0" dirty="0">
-                <a:solidFill>
-                  <a:srgbClr val="5C4826"/>
-                </a:solidFill>
-              </a:rPr>
-              <a:t>max working memory 24 / 32 / 24 KB</a:t>
-            </a:r>
-          </a:p>
-          <a:p>
-            <a:pPr algn="l">
-              <a:spcBef>
-                <a:spcPts val="900"/>
-              </a:spcBef>
-              <a:buNone/>
-            </a:pPr>
-            <a:r>
-              <a:rPr lang="en-US" sz="2000" b="0" i="0" dirty="0">
-                <a:solidFill>
-                  <a:srgbClr val="5C4826"/>
-                </a:solidFill>
-              </a:rPr>
-              <a:t>device ceiling 48 KB</a:t>
-            </a:r>
-          </a:p>
-        </p:txBody>
-      </p:sp>
-      <p:sp>
-        <p:nvSpPr>
-          <p:cNvPr id="14" name="Card-control"/>
-          <p:cNvSpPr/>
-          <p:nvPr/>
-        </p:nvSpPr>
-        <p:spPr>
-          <a:xfrm>
-            <a:off x="274320" y="3291840"/>
-            <a:ext cx="4069080" cy="2103120"/>
-          </a:xfrm>
-          <a:prstGeom prst="rect">
-            <a:avLst/>
-          </a:prstGeom>
-          <a:solidFill>
-            <a:srgbClr val="F5F1E8"/>
-          </a:solidFill>
-          <a:ln w="12700">
-            <a:solidFill>
-              <a:srgbClr val="C9B991"/>
-            </a:solidFill>
-          </a:ln>
-          <a:effectLst/>
-        </p:spPr>
-        <p:txBody>
-          <a:bodyPr wrap="square" lIns="27432" tIns="22860" rIns="27432" bIns="22860" rtlCol="0" anchor="t"/>
-          <a:lstStyle/>
-          <a:p>
-            <a:pPr algn="ctr">
-              <a:buNone/>
-            </a:pPr>
-            <a:r>
-              <a:rPr lang="en-US" sz="2000" b="1" i="0" dirty="0">
-                <a:solidFill>
-                  <a:srgbClr val="5C4826"/>
-                </a:solidFill>
-              </a:rPr>
-              <a:t>THREAD ADMISSION CONTROL</a:t>
-            </a:r>
-          </a:p>
-          <a:p>
-            <a:pPr algn="ctr">
-              <a:spcBef>
-                <a:spcPts val="900"/>
-              </a:spcBef>
-              <a:buNone/>
-            </a:pPr>
-            <a:r>
-              <a:rPr lang="en-US" sz="2000" b="0" i="1" dirty="0">
-                <a:solidFill>
-                  <a:srgbClr val="555960"/>
-                </a:solidFill>
-              </a:rPr>
-              <a:t>lifecycle view</a:t>
-            </a:r>
-          </a:p>
-          <a:p>
-            <a:pPr algn="l">
-              <a:spcBef>
-                <a:spcPts val="900"/>
-              </a:spcBef>
-              <a:buNone/>
-            </a:pPr>
-            <a:r>
-              <a:rPr lang="en-US" sz="2000" b="0" i="0" dirty="0">
-                <a:solidFill>
-                  <a:srgbClr val="5C4826"/>
-                </a:solidFill>
-              </a:rPr>
-              <a:t>each thread: Asleep ⇄ Awake</a:t>
-            </a:r>
-          </a:p>
-          <a:p>
-            <a:pPr algn="l">
-              <a:spcBef>
-                <a:spcPts val="900"/>
-              </a:spcBef>
-              <a:buNone/>
-            </a:pPr>
-            <a:r>
-              <a:rPr lang="en-US" sz="2000" b="0" i="0" dirty="0">
-                <a:solidFill>
-                  <a:srgbClr val="5C4826"/>
-                </a:solidFill>
-              </a:rPr>
-              <a:t>the Scheduler admits at most two threads awake</a:t>
-            </a:r>
-          </a:p>
-        </p:txBody>
-      </p:sp>
-      <p:sp>
-        <p:nvSpPr>
-          <p:cNvPr id="15" name="Card-prompt"/>
-          <p:cNvSpPr/>
-          <p:nvPr/>
-        </p:nvSpPr>
-        <p:spPr>
-          <a:xfrm>
-            <a:off x="4526280" y="1051560"/>
-            <a:ext cx="4343400" cy="4343400"/>
-          </a:xfrm>
-          <a:prstGeom prst="rect">
-            <a:avLst/>
-          </a:prstGeom>
-          <a:solidFill>
-            <a:srgbClr val="F5F1E8"/>
-          </a:solidFill>
-          <a:ln w="12700">
-            <a:solidFill>
-              <a:srgbClr val="C9B991"/>
-            </a:solidFill>
-          </a:ln>
-          <a:effectLst/>
-        </p:spPr>
-        <p:txBody>
-          <a:bodyPr wrap="square" lIns="27432" tIns="22860" rIns="27432" bIns="22860" rtlCol="0" anchor="t"/>
-          <a:lstStyle/>
-          <a:p>
-            <a:pPr algn="l">
-              <a:buNone/>
-            </a:pPr>
-            <a:r>
-              <a:rPr lang="en-US" sz="2000" b="1" i="0" dirty="0">
-                <a:solidFill>
-                  <a:srgbClr val="5C4826"/>
-                </a:solidFill>
-              </a:rPr>
-              <a:t>Choose one obligation from the lab.</a:t>
-            </a:r>
-          </a:p>
-          <a:p>
-            <a:pPr algn="l">
-              <a:spcBef>
-                <a:spcPts val="900"/>
-              </a:spcBef>
-              <a:buNone/>
-            </a:pPr>
-            <a:r>
-              <a:rPr lang="en-US" sz="2000" b="0" i="0" dirty="0">
-                <a:solidFill>
-                  <a:srgbClr val="5C4826"/>
-                </a:solidFill>
-              </a:rPr>
-              <a:t>1  ·  How could the realization violate it?</a:t>
-            </a:r>
-          </a:p>
-          <a:p>
-            <a:pPr algn="l">
-              <a:spcBef>
-                <a:spcPts val="900"/>
-              </a:spcBef>
-              <a:buNone/>
-            </a:pPr>
-            <a:r>
-              <a:rPr lang="en-US" sz="2000" b="0" i="0" dirty="0">
-                <a:solidFill>
-                  <a:srgbClr val="5C4826"/>
-                </a:solidFill>
-              </a:rPr>
-              <a:t>2  ·  Can you prevent that failure, or must you detect it?</a:t>
-            </a:r>
-          </a:p>
-          <a:p>
-            <a:pPr algn="l">
-              <a:spcBef>
-                <a:spcPts val="900"/>
-              </a:spcBef>
-              <a:buNone/>
-            </a:pPr>
-            <a:r>
-              <a:rPr lang="en-US" sz="2000" b="0" i="0" dirty="0">
-                <a:solidFill>
-                  <a:srgbClr val="5C4826"/>
-                </a:solidFill>
-              </a:rPr>
-              <a:t>3  ·  What would you check, and what evidence would let you decide?</a:t>
-            </a:r>
-          </a:p>
-          <a:p>
-            <a:pPr algn="l">
-              <a:spcBef>
-                <a:spcPts val="900"/>
-              </a:spcBef>
-              <a:buNone/>
-            </a:pPr>
-            <a:r>
-              <a:rPr lang="en-US" sz="2000" b="0" i="0" dirty="0">
-                <a:solidFill>
-                  <a:srgbClr val="5C4826"/>
-                </a:solidFill>
-              </a:rPr>
-              <a:t>4  ·  Where is the earliest boundary at which it is decidable?</a:t>
-            </a:r>
-          </a:p>
-          <a:p>
-            <a:pPr algn="l">
-              <a:spcBef>
-                <a:spcPts val="900"/>
-              </a:spcBef>
-              <a:buNone/>
-            </a:pPr>
-            <a:r>
-              <a:rPr lang="en-US" sz="2000" b="0" i="0" dirty="0">
-                <a:solidFill>
-                  <a:srgbClr val="5C4826"/>
-                </a:solidFill>
-              </a:rPr>
-              <a:t>5  ·  What should happen if the check fails?</a:t>
-            </a:r>
-          </a:p>
-        </p:txBody>
-      </p:sp>
-    </p:spTree>
-  </p:cSld>
-  <p:clrMapOvr>
-    <a:masterClrMapping/>
-  </p:clrMapOvr>
-</p:sld>
-</file>
-
 <file path=ppt/slides/slide29.xml><?xml version="1.0" encoding="utf-8"?>
 <p:sld xmlns:a="http://schemas.openxmlformats.org/drawingml/2006/main" xmlns:r="http://schemas.openxmlformats.org/officeDocument/2006/relationships" xmlns:p="http://schemas.openxmlformats.org/presentationml/2006/main">
   <p:cSld>
@@ -17679,7 +17735,12 @@
             <p:ph type="title"/>
           </p:nvPr>
         </p:nvSpPr>
-        <p:spPr/>
+        <p:spPr>
+          <a:xfrm>
+            <a:off x="274320" y="18288"/>
+            <a:ext cx="8046720" cy="731520"/>
+          </a:xfrm>
+        </p:spPr>
         <p:txBody>
           <a:bodyPr wrap="square">
             <a:normAutofit fontScale="90000"/>
@@ -17687,12 +17748,22 @@
           <a:lstStyle/>
           <a:p>
             <a:r>
-              <a:rPr lang="en-US" sz="2400" b="0" dirty="0">
+              <a:rPr sz="2400" b="0" dirty="0">
                 <a:solidFill>
                   <a:srgbClr val="000000"/>
                 </a:solidFill>
               </a:rPr>
-              <a:t>Report-out: </a:t>
+              <a:t>Back to the lab:</a:t>
+            </a:r>
+          </a:p>
+          <a:p>
+            <a:r>
+              <a:rPr lang="en-US" sz="2400" dirty="0">
+                <a:solidFill>
+                  <a:srgbClr val="000000"/>
+                </a:solidFill>
+              </a:rPr>
+              <a:t>D</a:t>
             </a:r>
             <a:r>
               <a:rPr sz="2400" b="0" dirty="0">
@@ -17700,29 +17771,8 @@
                   <a:srgbClr val="000000"/>
                 </a:solidFill>
               </a:rPr>
-              <a:t>Compare your </a:t>
-            </a:r>
-            <a:r>
-              <a:rPr lang="en-US" sz="2400" dirty="0">
-                <a:solidFill>
-                  <a:srgbClr val="000000"/>
-                </a:solidFill>
-              </a:rPr>
-              <a:t>A</a:t>
-            </a:r>
-            <a:r>
-              <a:rPr lang="en-US" sz="2400" b="0" dirty="0">
-                <a:solidFill>
-                  <a:srgbClr val="000000"/>
-                </a:solidFill>
-              </a:rPr>
-              <a:t>lignment approaches</a:t>
-            </a:r>
-            <a:endParaRPr sz="2400" b="0" dirty="0">
-              <a:solidFill>
-                <a:srgbClr val="000000"/>
-              </a:solidFill>
-            </a:endParaRPr>
+              <a:t>esign the Alignment</a:t>
+            </a:r>
           </a:p>
         </p:txBody>
       </p:sp>
@@ -17743,7 +17793,7 @@
           <a:p>
             <a:fld id="{B7EB45DA-9A0D-DC49-8E02-F30A5DDC21C3}" type="slidenum">
               <a:rPr lang="en-US" smtClean="0"/>
-              <a:t>30</a:t>
+              <a:t>29</a:t>
             </a:fld>
             <a:endParaRPr lang="en-US"/>
           </a:p>
@@ -17751,14 +17801,113 @@
       </p:sp>
       <p:sp>
         <p:nvSpPr>
-          <p:cNvPr id="10" name="Compare1"/>
+          <p:cNvPr id="5" name="KickerBadge">
+            <a:extLst>
+              <a:ext uri="{FF2B5EF4-FFF2-40B4-BE49-F238E27FC236}">
+                <a16:creationId xmlns:a16="http://schemas.microsoft.com/office/drawing/2014/main" id="{55489336-5766-22EA-2ADC-D9F38F769456}"/>
+              </a:ext>
+            </a:extLst>
+          </p:cNvPr>
           <p:cNvSpPr/>
           <p:nvPr/>
         </p:nvSpPr>
         <p:spPr>
           <a:xfrm>
-            <a:off x="502920" y="1051560"/>
-            <a:ext cx="8138160" cy="749808"/>
+            <a:off x="4480560" y="205000"/>
+            <a:ext cx="4389120" cy="470000"/>
+          </a:xfrm>
+          <a:prstGeom prst="roundRect">
+            <a:avLst/>
+          </a:prstGeom>
+          <a:solidFill>
+            <a:srgbClr val="FBF8F2"/>
+          </a:solidFill>
+          <a:ln w="15875">
+            <a:solidFill>
+              <a:srgbClr val="8E6F3E"/>
+            </a:solidFill>
+          </a:ln>
+        </p:spPr>
+        <p:txBody>
+          <a:bodyPr wrap="square" lIns="91440" tIns="27432" rIns="91440" bIns="27432" anchor="ctr"/>
+          <a:lstStyle/>
+          <a:p>
+            <a:pPr algn="ctr">
+              <a:buNone/>
+            </a:pPr>
+            <a:r>
+              <a:rPr lang="en-US" sz="2000" b="1" i="0" dirty="0">
+                <a:solidFill>
+                  <a:srgbClr val="8E6F3E"/>
+                </a:solidFill>
+              </a:rPr>
+              <a:t>TEAM ACTIVITY  ·  10–12 MINUTES</a:t>
+            </a:r>
+          </a:p>
+        </p:txBody>
+      </p:sp>
+      <p:sp>
+        <p:nvSpPr>
+          <p:cNvPr id="12" name="FooterBand"/>
+          <p:cNvSpPr/>
+          <p:nvPr/>
+        </p:nvSpPr>
+        <p:spPr>
+          <a:xfrm>
+            <a:off x="274320" y="5852160"/>
+            <a:ext cx="8595360" cy="566928"/>
+          </a:xfrm>
+          <a:prstGeom prst="rect">
+            <a:avLst/>
+          </a:prstGeom>
+          <a:solidFill>
+            <a:srgbClr val="8E6F3E"/>
+          </a:solidFill>
+          <a:ln>
+            <a:noFill/>
+          </a:ln>
+          <a:effectLst/>
+        </p:spPr>
+        <p:style>
+          <a:lnRef idx="1">
+            <a:schemeClr val="accent1"/>
+          </a:lnRef>
+          <a:fillRef idx="3">
+            <a:schemeClr val="accent1"/>
+          </a:fillRef>
+          <a:effectRef idx="2">
+            <a:schemeClr val="accent1"/>
+          </a:effectRef>
+          <a:fontRef idx="minor">
+            <a:schemeClr val="lt1"/>
+          </a:fontRef>
+        </p:style>
+        <p:txBody>
+          <a:bodyPr wrap="square" rtlCol="0" anchor="ctr"/>
+          <a:lstStyle/>
+          <a:p>
+            <a:pPr algn="ctr"/>
+            <a:r>
+              <a:rPr sz="2000" b="1" i="0">
+                <a:solidFill>
+                  <a:srgbClr val="FFFFFF"/>
+                </a:solidFill>
+              </a:rPr>
+              <a:t>OBLIGATION  →  MODEL  →  CHECK  →  DECIDE  →  CONTROL</a:t>
+            </a:r>
+          </a:p>
+        </p:txBody>
+      </p:sp>
+      <p:sp>
+        <p:nvSpPr>
+          <p:cNvPr id="13" name="Card-memory"/>
+          <p:cNvSpPr/>
+          <p:nvPr/>
+        </p:nvSpPr>
+        <p:spPr>
+          <a:xfrm>
+            <a:off x="274320" y="1051560"/>
+            <a:ext cx="4069080" cy="2103120"/>
           </a:xfrm>
           <a:prstGeom prst="rect">
             <a:avLst/>
@@ -17773,57 +17922,98 @@
           </a:ln>
           <a:effectLst/>
         </p:spPr>
-        <p:style>
-          <a:lnRef idx="1">
-            <a:schemeClr val="accent1"/>
-          </a:lnRef>
-          <a:fillRef idx="3">
-            <a:schemeClr val="accent1"/>
-          </a:fillRef>
-          <a:effectRef idx="2">
-            <a:schemeClr val="accent1"/>
-          </a:effectRef>
-          <a:fontRef idx="minor">
-            <a:schemeClr val="lt1"/>
-          </a:fontRef>
-        </p:style>
-        <p:txBody>
-          <a:bodyPr wrap="square" lIns="27432" tIns="22860" rIns="27432" bIns="22860" rtlCol="0" anchor="ctr"/>
-          <a:lstStyle/>
-          <a:p>
-            <a:pPr algn="l"/>
-            <a:r>
-              <a:rPr sz="2000" b="1" i="0">
+        <p:txBody>
+          <a:bodyPr wrap="square" lIns="27432" tIns="22860" rIns="27432" bIns="22860" rtlCol="0" anchor="t"/>
+          <a:lstStyle/>
+          <a:p>
+            <a:pPr algn="ctr">
+              <a:buNone/>
+            </a:pPr>
+            <a:r>
+              <a:rPr lang="en-US" sz="2000" b="1" i="0" dirty="0">
                 <a:solidFill>
                   <a:srgbClr val="5C4826"/>
                 </a:solidFill>
               </a:rPr>
-              <a:t>Same obligation, different boundary</a:t>
-            </a:r>
-          </a:p>
-          <a:p>
-            <a:pPr algn="l"/>
-            <a:r>
-              <a:rPr sz="2000" b="0" i="0">
+              <a:t>DEVICE FIRMWARE</a:t>
+            </a:r>
+          </a:p>
+          <a:p>
+            <a:pPr algn="ctr">
+              <a:spcBef>
+                <a:spcPts val="900"/>
+              </a:spcBef>
+              <a:buNone/>
+            </a:pPr>
+            <a:r>
+              <a:rPr lang="en-US" sz="2000" b="0" i="1" dirty="0">
+                <a:solidFill>
+                  <a:srgbClr val="555960"/>
+                </a:solidFill>
+              </a:rPr>
+              <a:t>working memory view</a:t>
+            </a:r>
+          </a:p>
+          <a:p>
+            <a:pPr algn="l">
+              <a:spcBef>
+                <a:spcPts val="900"/>
+              </a:spcBef>
+              <a:buNone/>
+            </a:pPr>
+            <a:r>
+              <a:rPr lang="en-US" sz="2000" b="0" i="0" dirty="0">
                 <a:solidFill>
                   <a:srgbClr val="5C4826"/>
                 </a:solidFill>
               </a:rPr>
-              <a:t>Which boundary actually has enough information?</a:t>
-            </a:r>
-          </a:p>
-        </p:txBody>
-      </p:sp>
-      <p:sp>
-        <p:nvSpPr>
-          <p:cNvPr id="11" name="Compare2"/>
+              <a:t>Sense · Analyze · Transmit</a:t>
+            </a:r>
+          </a:p>
+          <a:p>
+            <a:pPr algn="l">
+              <a:spcBef>
+                <a:spcPts val="900"/>
+              </a:spcBef>
+              <a:buNone/>
+            </a:pPr>
+            <a:r>
+              <a:rPr lang="en-US" sz="2000" b="0" i="0" dirty="0">
+                <a:solidFill>
+                  <a:srgbClr val="5C4826"/>
+                </a:solidFill>
+              </a:rPr>
+              <a:t>max working memory 24 / 32 / 24 KB</a:t>
+            </a:r>
+          </a:p>
+          <a:p>
+            <a:pPr algn="l">
+              <a:spcBef>
+                <a:spcPts val="900"/>
+              </a:spcBef>
+              <a:buNone/>
+            </a:pPr>
+            <a:r>
+              <a:rPr lang="en-US" sz="2000" b="0" i="0" dirty="0">
+                <a:solidFill>
+                  <a:srgbClr val="5C4826"/>
+                </a:solidFill>
+              </a:rPr>
+              <a:t>device ceiling 48 KB</a:t>
+            </a:r>
+          </a:p>
+        </p:txBody>
+      </p:sp>
+      <p:sp>
+        <p:nvSpPr>
+          <p:cNvPr id="14" name="Card-control"/>
           <p:cNvSpPr/>
           <p:nvPr/>
         </p:nvSpPr>
         <p:spPr>
           <a:xfrm>
-            <a:off x="502920" y="1965960"/>
-            <a:ext cx="8138160" cy="749808"/>
+            <a:off x="274320" y="3291840"/>
+            <a:ext cx="4069080" cy="2103120"/>
           </a:xfrm>
           <a:prstGeom prst="rect">
             <a:avLst/>
@@ -17838,57 +18028,82 @@
           </a:ln>
           <a:effectLst/>
         </p:spPr>
-        <p:style>
-          <a:lnRef idx="1">
-            <a:schemeClr val="accent1"/>
-          </a:lnRef>
-          <a:fillRef idx="3">
-            <a:schemeClr val="accent1"/>
-          </a:fillRef>
-          <a:effectRef idx="2">
-            <a:schemeClr val="accent1"/>
-          </a:effectRef>
-          <a:fontRef idx="minor">
-            <a:schemeClr val="lt1"/>
-          </a:fontRef>
-        </p:style>
-        <p:txBody>
-          <a:bodyPr wrap="square" lIns="27432" tIns="22860" rIns="27432" bIns="22860" rtlCol="0" anchor="ctr"/>
-          <a:lstStyle/>
-          <a:p>
-            <a:pPr algn="l"/>
-            <a:r>
-              <a:rPr sz="2000" b="1" i="0">
+        <p:txBody>
+          <a:bodyPr wrap="square" lIns="27432" tIns="22860" rIns="27432" bIns="22860" rtlCol="0" anchor="t"/>
+          <a:lstStyle/>
+          <a:p>
+            <a:pPr algn="ctr">
+              <a:buNone/>
+            </a:pPr>
+            <a:r>
+              <a:rPr lang="en-US" sz="2000" b="1" i="0" dirty="0">
                 <a:solidFill>
                   <a:srgbClr val="5C4826"/>
                 </a:solidFill>
               </a:rPr>
-              <a:t>Constraint vs. evidence</a:t>
-            </a:r>
-          </a:p>
-          <a:p>
-            <a:pPr algn="l"/>
-            <a:r>
-              <a:rPr sz="2000" b="0" i="0">
+              <a:t>THREAD ADMISSION CONTROL</a:t>
+            </a:r>
+          </a:p>
+          <a:p>
+            <a:pPr algn="ctr">
+              <a:spcBef>
+                <a:spcPts val="900"/>
+              </a:spcBef>
+              <a:buNone/>
+            </a:pPr>
+            <a:r>
+              <a:rPr lang="en-US" sz="2000" b="0" i="1" dirty="0">
+                <a:solidFill>
+                  <a:srgbClr val="555960"/>
+                </a:solidFill>
+              </a:rPr>
+              <a:t>lifecycle view</a:t>
+            </a:r>
+          </a:p>
+          <a:p>
+            <a:pPr algn="l">
+              <a:spcBef>
+                <a:spcPts val="900"/>
+              </a:spcBef>
+              <a:buNone/>
+            </a:pPr>
+            <a:r>
+              <a:rPr lang="en-US" sz="2000" b="0" i="0" dirty="0">
                 <a:solidFill>
                   <a:srgbClr val="5C4826"/>
                 </a:solidFill>
               </a:rPr>
-              <a:t>Can the failure be prevented, or must it be observed and evaluated?</a:t>
-            </a:r>
-          </a:p>
-        </p:txBody>
-      </p:sp>
-      <p:sp>
-        <p:nvSpPr>
-          <p:cNvPr id="12" name="Compare3"/>
+              <a:t>each thread: Asleep ⇄ Awake</a:t>
+            </a:r>
+          </a:p>
+          <a:p>
+            <a:pPr algn="l">
+              <a:spcBef>
+                <a:spcPts val="900"/>
+              </a:spcBef>
+              <a:buNone/>
+            </a:pPr>
+            <a:r>
+              <a:rPr lang="en-US" sz="2000" b="0" i="0" dirty="0">
+                <a:solidFill>
+                  <a:srgbClr val="5C4826"/>
+                </a:solidFill>
+              </a:rPr>
+              <a:t>the Scheduler admits at most two threads awake</a:t>
+            </a:r>
+          </a:p>
+        </p:txBody>
+      </p:sp>
+      <p:sp>
+        <p:nvSpPr>
+          <p:cNvPr id="15" name="Card-prompt"/>
           <p:cNvSpPr/>
           <p:nvPr/>
         </p:nvSpPr>
         <p:spPr>
           <a:xfrm>
-            <a:off x="502920" y="2880360"/>
-            <a:ext cx="8138160" cy="1097280"/>
+            <a:off x="4526280" y="1051560"/>
+            <a:ext cx="4343400" cy="4343400"/>
           </a:xfrm>
           <a:prstGeom prst="rect">
             <a:avLst/>
@@ -17903,108 +18118,100 @@
           </a:ln>
           <a:effectLst/>
         </p:spPr>
-        <p:style>
-          <a:lnRef idx="1">
-            <a:schemeClr val="accent1"/>
-          </a:lnRef>
-          <a:fillRef idx="3">
-            <a:schemeClr val="accent1"/>
-          </a:fillRef>
-          <a:effectRef idx="2">
-            <a:schemeClr val="accent1"/>
-          </a:effectRef>
-          <a:fontRef idx="minor">
-            <a:schemeClr val="lt1"/>
-          </a:fontRef>
-        </p:style>
-        <p:txBody>
-          <a:bodyPr wrap="square" lIns="27432" tIns="22860" rIns="27432" bIns="22860" rtlCol="0" anchor="ctr"/>
-          <a:lstStyle/>
-          <a:p>
-            <a:pPr algn="l"/>
-            <a:r>
-              <a:rPr sz="2000" b="1" i="0">
+        <p:txBody>
+          <a:bodyPr wrap="square" lIns="27432" tIns="22860" rIns="27432" bIns="22860" rtlCol="0" anchor="t"/>
+          <a:lstStyle/>
+          <a:p>
+            <a:pPr algn="l">
+              <a:buNone/>
+            </a:pPr>
+            <a:r>
+              <a:rPr lang="en-US" sz="2000" b="1" i="0" dirty="0">
                 <a:solidFill>
                   <a:srgbClr val="5C4826"/>
                 </a:solidFill>
               </a:rPr>
-              <a:t>Static vs. dynamic evidence</a:t>
-            </a:r>
-          </a:p>
-          <a:p>
-            <a:pPr algn="l"/>
-            <a:r>
-              <a:rPr sz="2000" b="0" i="0">
+              <a:t>Choose one obligation from the lab.</a:t>
+            </a:r>
+          </a:p>
+          <a:p>
+            <a:pPr algn="l">
+              <a:spcBef>
+                <a:spcPts val="900"/>
+              </a:spcBef>
+              <a:buNone/>
+            </a:pPr>
+            <a:r>
+              <a:rPr lang="en-US" sz="2000" b="0" i="0" dirty="0">
                 <a:solidFill>
                   <a:srgbClr val="5C4826"/>
                 </a:solidFill>
               </a:rPr>
-              <a:t>Can the obligation be decided from the realization itself, or only from observed execution?</a:t>
-            </a:r>
-          </a:p>
-        </p:txBody>
-      </p:sp>
-      <p:sp>
-        <p:nvSpPr>
-          <p:cNvPr id="13" name="Compare4"/>
-          <p:cNvSpPr/>
-          <p:nvPr/>
-        </p:nvSpPr>
-        <p:spPr>
-          <a:xfrm>
-            <a:off x="502920" y="4142739"/>
-            <a:ext cx="8138160" cy="1097280"/>
-          </a:xfrm>
-          <a:prstGeom prst="rect">
-            <a:avLst/>
-          </a:prstGeom>
-          <a:solidFill>
-            <a:srgbClr val="F5F1E8"/>
-          </a:solidFill>
-          <a:ln w="12700">
-            <a:solidFill>
-              <a:srgbClr val="C9B991"/>
-            </a:solidFill>
-          </a:ln>
-          <a:effectLst/>
-        </p:spPr>
-        <p:style>
-          <a:lnRef idx="1">
-            <a:schemeClr val="accent1"/>
-          </a:lnRef>
-          <a:fillRef idx="3">
-            <a:schemeClr val="accent1"/>
-          </a:fillRef>
-          <a:effectRef idx="2">
-            <a:schemeClr val="accent1"/>
-          </a:effectRef>
-          <a:fontRef idx="minor">
-            <a:schemeClr val="lt1"/>
-          </a:fontRef>
-        </p:style>
-        <p:txBody>
-          <a:bodyPr wrap="square" lIns="27432" tIns="22860" rIns="27432" bIns="22860" rtlCol="0" anchor="ctr"/>
-          <a:lstStyle/>
-          <a:p>
-            <a:pPr algn="l"/>
-            <a:r>
-              <a:rPr sz="2000" b="1" i="0">
+              <a:t>1  ·  How could the realization violate it?</a:t>
+            </a:r>
+          </a:p>
+          <a:p>
+            <a:pPr algn="l">
+              <a:spcBef>
+                <a:spcPts val="900"/>
+              </a:spcBef>
+              <a:buNone/>
+            </a:pPr>
+            <a:r>
+              <a:rPr lang="en-US" sz="2000" b="0" i="0" dirty="0">
                 <a:solidFill>
                   <a:srgbClr val="5C4826"/>
                 </a:solidFill>
               </a:rPr>
-              <a:t>Different authority</a:t>
-            </a:r>
-          </a:p>
-          <a:p>
-            <a:pPr algn="l"/>
-            <a:r>
-              <a:rPr sz="2000" b="0" i="0">
+              <a:t>2  ·  Can you prevent that failure, or must you detect it?</a:t>
+            </a:r>
+          </a:p>
+          <a:p>
+            <a:pPr algn="l">
+              <a:spcBef>
+                <a:spcPts val="900"/>
+              </a:spcBef>
+              <a:buNone/>
+            </a:pPr>
+            <a:r>
+              <a:rPr lang="en-US" sz="2000" b="0" i="0" dirty="0">
                 <a:solidFill>
                   <a:srgbClr val="5C4826"/>
                 </a:solidFill>
               </a:rPr>
-              <a:t>Should this failure block the commit, the PR, the merge, the deployment — or merely produce evidence?</a:t>
+              <a:t>3  ·  What would you check, and what evidence would let you decide?</a:t>
+            </a:r>
+          </a:p>
+          <a:p>
+            <a:pPr algn="l">
+              <a:spcBef>
+                <a:spcPts val="900"/>
+              </a:spcBef>
+              <a:buNone/>
+            </a:pPr>
+            <a:r>
+              <a:rPr lang="en-US" sz="2000" b="0" i="0" dirty="0">
+                <a:solidFill>
+                  <a:srgbClr val="5C4826"/>
+                </a:solidFill>
+              </a:rPr>
+              <a:t>4  ·  Where is the earliest boundary at which it is decidable?</a:t>
+            </a:r>
+          </a:p>
+          <a:p>
+            <a:pPr algn="l">
+              <a:spcBef>
+                <a:spcPts val="900"/>
+              </a:spcBef>
+              <a:buNone/>
+            </a:pPr>
+            <a:r>
+              <a:rPr lang="en-US" sz="2000" b="0" i="0" dirty="0">
+                <a:solidFill>
+                  <a:srgbClr val="5C4826"/>
+                </a:solidFill>
+              </a:rPr>
+              <a:t>5  ·  What should happen if the check fails?</a:t>
             </a:r>
           </a:p>
         </p:txBody>
@@ -18276,13 +18483,42 @@
           <a:lstStyle/>
           <a:p>
             <a:r>
-              <a:rPr sz="2400" b="0">
+              <a:rPr lang="en-US" sz="2400" b="0" dirty="0">
                 <a:solidFill>
                   <a:srgbClr val="000000"/>
                 </a:solidFill>
               </a:rPr>
-              <a:t>How do you know?</a:t>
-            </a:r>
+              <a:t>Report-out: </a:t>
+            </a:r>
+            <a:r>
+              <a:rPr sz="2400" b="0" dirty="0">
+                <a:solidFill>
+                  <a:srgbClr val="000000"/>
+                </a:solidFill>
+              </a:rPr>
+              <a:t>Compare your </a:t>
+            </a:r>
+            <a:r>
+              <a:rPr lang="en-US" sz="2400" dirty="0">
+                <a:solidFill>
+                  <a:srgbClr val="000000"/>
+                </a:solidFill>
+              </a:rPr>
+              <a:t>A</a:t>
+            </a:r>
+            <a:r>
+              <a:rPr lang="en-US" sz="2400" b="0" dirty="0">
+                <a:solidFill>
+                  <a:srgbClr val="000000"/>
+                </a:solidFill>
+              </a:rPr>
+              <a:t>lignment approaches</a:t>
+            </a:r>
+            <a:endParaRPr sz="2400" b="0" dirty="0">
+              <a:solidFill>
+                <a:srgbClr val="000000"/>
+              </a:solidFill>
+            </a:endParaRPr>
           </a:p>
         </p:txBody>
       </p:sp>
@@ -18303,7 +18539,7 @@
           <a:p>
             <a:fld id="{B7EB45DA-9A0D-DC49-8E02-F30A5DDC21C3}" type="slidenum">
               <a:rPr lang="en-US" smtClean="0"/>
-              <a:t>31</a:t>
+              <a:t>30</a:t>
             </a:fld>
             <a:endParaRPr lang="en-US"/>
           </a:p>
@@ -18311,192 +18547,20 @@
       </p:sp>
       <p:sp>
         <p:nvSpPr>
-          <p:cNvPr id="5" name="Rectangle 4"/>
+          <p:cNvPr id="10" name="Compare1"/>
           <p:cNvSpPr/>
           <p:nvPr/>
         </p:nvSpPr>
         <p:spPr>
           <a:xfrm>
-            <a:off x="640080" y="1005840"/>
-            <a:ext cx="2194560" cy="822960"/>
+            <a:off x="502920" y="1051560"/>
+            <a:ext cx="8138160" cy="749808"/>
           </a:xfrm>
           <a:prstGeom prst="rect">
             <a:avLst/>
           </a:prstGeom>
           <a:solidFill>
-            <a:srgbClr val="8E6F3E"/>
-          </a:solidFill>
-          <a:ln>
-            <a:noFill/>
-          </a:ln>
-          <a:effectLst/>
-        </p:spPr>
-        <p:style>
-          <a:lnRef idx="1">
-            <a:schemeClr val="accent1"/>
-          </a:lnRef>
-          <a:fillRef idx="3">
-            <a:schemeClr val="accent1"/>
-          </a:fillRef>
-          <a:effectRef idx="2">
-            <a:schemeClr val="accent1"/>
-          </a:effectRef>
-          <a:fontRef idx="minor">
-            <a:schemeClr val="lt1"/>
-          </a:fontRef>
-        </p:style>
-        <p:txBody>
-          <a:bodyPr wrap="square" lIns="27432" tIns="22860" rIns="27432" bIns="22860" rtlCol="0" anchor="ctr"/>
-          <a:lstStyle/>
-          <a:p>
-            <a:pPr algn="ctr"/>
-            <a:r>
-              <a:rPr sz="2000" b="1" i="0">
-                <a:solidFill>
-                  <a:srgbClr val="FFFFFF"/>
-                </a:solidFill>
-              </a:rPr>
-              <a:t>MODELING</a:t>
-            </a:r>
-          </a:p>
-        </p:txBody>
-      </p:sp>
-      <p:sp>
-        <p:nvSpPr>
-          <p:cNvPr id="6" name="TextBox 5"/>
-          <p:cNvSpPr txBox="1"/>
-          <p:nvPr/>
-        </p:nvSpPr>
-        <p:spPr>
-          <a:xfrm>
-            <a:off x="3108960" y="1033272"/>
-            <a:ext cx="5715000" cy="1005840"/>
-          </a:xfrm>
-          <a:prstGeom prst="rect">
-            <a:avLst/>
-          </a:prstGeom>
-          <a:noFill/>
-        </p:spPr>
-        <p:txBody>
-          <a:bodyPr wrap="square" anchor="ctr">
-            <a:spAutoFit/>
-          </a:bodyPr>
-          <a:lstStyle/>
-          <a:p>
-            <a:pPr algn="l"/>
-            <a:r>
-              <a:rPr sz="2000" b="0" i="0">
-                <a:solidFill>
-                  <a:srgbClr val="5C4826"/>
-                </a:solidFill>
-              </a:rPr>
-              <a:t>make consequential engineering knowledge explicit while leaving irrelevant choices free</a:t>
-            </a:r>
-          </a:p>
-        </p:txBody>
-      </p:sp>
-      <p:sp>
-        <p:nvSpPr>
-          <p:cNvPr id="7" name="Rectangle 6"/>
-          <p:cNvSpPr/>
-          <p:nvPr/>
-        </p:nvSpPr>
-        <p:spPr>
-          <a:xfrm>
-            <a:off x="640080" y="2103120"/>
-            <a:ext cx="2194560" cy="822960"/>
-          </a:xfrm>
-          <a:prstGeom prst="rect">
-            <a:avLst/>
-          </a:prstGeom>
-          <a:solidFill>
-            <a:srgbClr val="8E6F3E"/>
-          </a:solidFill>
-          <a:ln>
-            <a:noFill/>
-          </a:ln>
-          <a:effectLst/>
-        </p:spPr>
-        <p:style>
-          <a:lnRef idx="1">
-            <a:schemeClr val="accent1"/>
-          </a:lnRef>
-          <a:fillRef idx="3">
-            <a:schemeClr val="accent1"/>
-          </a:fillRef>
-          <a:effectRef idx="2">
-            <a:schemeClr val="accent1"/>
-          </a:effectRef>
-          <a:fontRef idx="minor">
-            <a:schemeClr val="lt1"/>
-          </a:fontRef>
-        </p:style>
-        <p:txBody>
-          <a:bodyPr wrap="square" lIns="27432" tIns="22860" rIns="27432" bIns="22860" rtlCol="0" anchor="ctr"/>
-          <a:lstStyle/>
-          <a:p>
-            <a:pPr algn="ctr"/>
-            <a:r>
-              <a:rPr sz="2000" b="1" i="0">
-                <a:solidFill>
-                  <a:srgbClr val="FFFFFF"/>
-                </a:solidFill>
-              </a:rPr>
-              <a:t>ALIGNMENT</a:t>
-            </a:r>
-          </a:p>
-        </p:txBody>
-      </p:sp>
-      <p:sp>
-        <p:nvSpPr>
-          <p:cNvPr id="8" name="TextBox 7"/>
-          <p:cNvSpPr txBox="1"/>
-          <p:nvPr/>
-        </p:nvSpPr>
-        <p:spPr>
-          <a:xfrm>
-            <a:off x="3108960" y="2130552"/>
-            <a:ext cx="5715000" cy="1005840"/>
-          </a:xfrm>
-          <a:prstGeom prst="rect">
-            <a:avLst/>
-          </a:prstGeom>
-          <a:noFill/>
-        </p:spPr>
-        <p:txBody>
-          <a:bodyPr wrap="square" anchor="ctr">
-            <a:spAutoFit/>
-          </a:bodyPr>
-          <a:lstStyle/>
-          <a:p>
-            <a:pPr algn="l"/>
-            <a:r>
-              <a:rPr sz="2000" b="0" i="0">
-                <a:solidFill>
-                  <a:srgbClr val="5C4826"/>
-                </a:solidFill>
-              </a:rPr>
-              <a:t>connect selected obligations to consequences in the engineered environment</a:t>
-            </a:r>
-          </a:p>
-        </p:txBody>
-      </p:sp>
-      <p:sp>
-        <p:nvSpPr>
-          <p:cNvPr id="9" name="Rectangle 8"/>
-          <p:cNvSpPr/>
-          <p:nvPr/>
-        </p:nvSpPr>
-        <p:spPr>
-          <a:xfrm>
-            <a:off x="640080" y="3291840"/>
-            <a:ext cx="8183879" cy="2514600"/>
-          </a:xfrm>
-          <a:prstGeom prst="rect">
-            <a:avLst/>
-          </a:prstGeom>
-          <a:solidFill>
-            <a:srgbClr val="FBF8F2"/>
+            <a:srgbClr val="F5F1E8"/>
           </a:solidFill>
           <a:ln w="12700">
             <a:solidFill>
@@ -18520,91 +18584,223 @@
           </a:fontRef>
         </p:style>
         <p:txBody>
-          <a:bodyPr wrap="square" lIns="137160" tIns="73152" rIns="27432" bIns="22860" rtlCol="0" anchor="t"/>
+          <a:bodyPr wrap="square" lIns="27432" tIns="22860" rIns="27432" bIns="22860" rtlCol="0" anchor="ctr"/>
           <a:lstStyle/>
           <a:p>
             <a:pPr algn="l"/>
             <a:r>
               <a:rPr sz="2000" b="1" i="0">
                 <a:solidFill>
-                  <a:srgbClr val="8E6F3E"/>
-                </a:solidFill>
-              </a:rPr>
-              <a:t>THE REUSABLE QUESTIONS</a:t>
-            </a:r>
-          </a:p>
-          <a:p>
-            <a:pPr algn="l">
-              <a:spcBef>
-                <a:spcPts val="600"/>
-              </a:spcBef>
-            </a:pPr>
+                  <a:srgbClr val="5C4826"/>
+                </a:solidFill>
+              </a:rPr>
+              <a:t>Same obligation, different boundary</a:t>
+            </a:r>
+          </a:p>
+          <a:p>
+            <a:pPr algn="l"/>
+            <a:r>
+              <a:rPr sz="2000" b="0" i="0">
+                <a:solidFill>
+                  <a:srgbClr val="5C4826"/>
+                </a:solidFill>
+              </a:rPr>
+              <a:t>Which boundary actually has enough information?</a:t>
+            </a:r>
+          </a:p>
+        </p:txBody>
+      </p:sp>
+      <p:sp>
+        <p:nvSpPr>
+          <p:cNvPr id="11" name="Compare2"/>
+          <p:cNvSpPr/>
+          <p:nvPr/>
+        </p:nvSpPr>
+        <p:spPr>
+          <a:xfrm>
+            <a:off x="502920" y="1965960"/>
+            <a:ext cx="8138160" cy="749808"/>
+          </a:xfrm>
+          <a:prstGeom prst="rect">
+            <a:avLst/>
+          </a:prstGeom>
+          <a:solidFill>
+            <a:srgbClr val="F5F1E8"/>
+          </a:solidFill>
+          <a:ln w="12700">
+            <a:solidFill>
+              <a:srgbClr val="C9B991"/>
+            </a:solidFill>
+          </a:ln>
+          <a:effectLst/>
+        </p:spPr>
+        <p:style>
+          <a:lnRef idx="1">
+            <a:schemeClr val="accent1"/>
+          </a:lnRef>
+          <a:fillRef idx="3">
+            <a:schemeClr val="accent1"/>
+          </a:fillRef>
+          <a:effectRef idx="2">
+            <a:schemeClr val="accent1"/>
+          </a:effectRef>
+          <a:fontRef idx="minor">
+            <a:schemeClr val="lt1"/>
+          </a:fontRef>
+        </p:style>
+        <p:txBody>
+          <a:bodyPr wrap="square" lIns="27432" tIns="22860" rIns="27432" bIns="22860" rtlCol="0" anchor="ctr"/>
+          <a:lstStyle/>
+          <a:p>
+            <a:pPr algn="l"/>
             <a:r>
               <a:rPr sz="2000" b="1" i="0">
                 <a:solidFill>
                   <a:srgbClr val="5C4826"/>
                 </a:solidFill>
               </a:rPr>
-              <a:t>How can the delegated work fail?</a:t>
-            </a:r>
-          </a:p>
-          <a:p>
-            <a:pPr algn="l">
-              <a:spcBef>
-                <a:spcPts val="600"/>
-              </a:spcBef>
-            </a:pPr>
+              <a:t>Constraint vs. evidence</a:t>
+            </a:r>
+          </a:p>
+          <a:p>
+            <a:pPr algn="l"/>
             <a:r>
               <a:rPr sz="2000" b="0" i="0">
                 <a:solidFill>
                   <a:srgbClr val="5C4826"/>
                 </a:solidFill>
               </a:rPr>
-              <a:t>What must be true?</a:t>
-            </a:r>
-          </a:p>
+              <a:t>Can the failure be prevented, or must it be observed and evaluated?</a:t>
+            </a:r>
+          </a:p>
+        </p:txBody>
+      </p:sp>
+      <p:sp>
+        <p:nvSpPr>
+          <p:cNvPr id="12" name="Compare3"/>
+          <p:cNvSpPr/>
+          <p:nvPr/>
+        </p:nvSpPr>
+        <p:spPr>
+          <a:xfrm>
+            <a:off x="502920" y="2880360"/>
+            <a:ext cx="8138160" cy="1097280"/>
+          </a:xfrm>
+          <a:prstGeom prst="rect">
+            <a:avLst/>
+          </a:prstGeom>
+          <a:solidFill>
+            <a:srgbClr val="F5F1E8"/>
+          </a:solidFill>
+          <a:ln w="12700">
+            <a:solidFill>
+              <a:srgbClr val="C9B991"/>
+            </a:solidFill>
+          </a:ln>
+          <a:effectLst/>
+        </p:spPr>
+        <p:style>
+          <a:lnRef idx="1">
+            <a:schemeClr val="accent1"/>
+          </a:lnRef>
+          <a:fillRef idx="3">
+            <a:schemeClr val="accent1"/>
+          </a:fillRef>
+          <a:effectRef idx="2">
+            <a:schemeClr val="accent1"/>
+          </a:effectRef>
+          <a:fontRef idx="minor">
+            <a:schemeClr val="lt1"/>
+          </a:fontRef>
+        </p:style>
+        <p:txBody>
+          <a:bodyPr wrap="square" lIns="27432" tIns="22860" rIns="27432" bIns="22860" rtlCol="0" anchor="ctr"/>
+          <a:lstStyle/>
           <a:p>
             <a:pPr algn="l"/>
             <a:r>
+              <a:rPr sz="2000" b="1" i="0">
+                <a:solidFill>
+                  <a:srgbClr val="5C4826"/>
+                </a:solidFill>
+              </a:rPr>
+              <a:t>Static vs. dynamic evidence</a:t>
+            </a:r>
+          </a:p>
+          <a:p>
+            <a:pPr algn="l"/>
+            <a:r>
               <a:rPr sz="2000" b="0" i="0">
                 <a:solidFill>
                   <a:srgbClr val="5C4826"/>
                 </a:solidFill>
               </a:rPr>
-              <a:t>What evidence bears on it?</a:t>
-            </a:r>
-          </a:p>
+              <a:t>Can the obligation be decided from the realization itself, or only from observed execution?</a:t>
+            </a:r>
+          </a:p>
+        </p:txBody>
+      </p:sp>
+      <p:sp>
+        <p:nvSpPr>
+          <p:cNvPr id="13" name="Compare4"/>
+          <p:cNvSpPr/>
+          <p:nvPr/>
+        </p:nvSpPr>
+        <p:spPr>
+          <a:xfrm>
+            <a:off x="502920" y="4142739"/>
+            <a:ext cx="8138160" cy="1097280"/>
+          </a:xfrm>
+          <a:prstGeom prst="rect">
+            <a:avLst/>
+          </a:prstGeom>
+          <a:solidFill>
+            <a:srgbClr val="F5F1E8"/>
+          </a:solidFill>
+          <a:ln w="12700">
+            <a:solidFill>
+              <a:srgbClr val="C9B991"/>
+            </a:solidFill>
+          </a:ln>
+          <a:effectLst/>
+        </p:spPr>
+        <p:style>
+          <a:lnRef idx="1">
+            <a:schemeClr val="accent1"/>
+          </a:lnRef>
+          <a:fillRef idx="3">
+            <a:schemeClr val="accent1"/>
+          </a:fillRef>
+          <a:effectRef idx="2">
+            <a:schemeClr val="accent1"/>
+          </a:effectRef>
+          <a:fontRef idx="minor">
+            <a:schemeClr val="lt1"/>
+          </a:fontRef>
+        </p:style>
+        <p:txBody>
+          <a:bodyPr wrap="square" lIns="27432" tIns="22860" rIns="27432" bIns="22860" rtlCol="0" anchor="ctr"/>
+          <a:lstStyle/>
           <a:p>
             <a:pPr algn="l"/>
             <a:r>
+              <a:rPr sz="2000" b="1" i="0">
+                <a:solidFill>
+                  <a:srgbClr val="5C4826"/>
+                </a:solidFill>
+              </a:rPr>
+              <a:t>Different authority</a:t>
+            </a:r>
+          </a:p>
+          <a:p>
+            <a:pPr algn="l"/>
+            <a:r>
               <a:rPr sz="2000" b="0" i="0">
                 <a:solidFill>
                   <a:srgbClr val="5C4826"/>
                 </a:solidFill>
               </a:rPr>
-              <a:t>Where can it be decided?</a:t>
-            </a:r>
-          </a:p>
-          <a:p>
-            <a:pPr algn="l"/>
-            <a:r>
-              <a:rPr sz="2000" b="0" i="0">
-                <a:solidFill>
-                  <a:srgbClr val="5C4826"/>
-                </a:solidFill>
-              </a:rPr>
-              <a:t>How will it be evaluated?</a:t>
-            </a:r>
-          </a:p>
-          <a:p>
-            <a:pPr algn="l"/>
-            <a:r>
-              <a:rPr sz="2000" b="0" i="0">
-                <a:solidFill>
-                  <a:srgbClr val="5C4826"/>
-                </a:solidFill>
-              </a:rPr>
-              <a:t>Should failure control what happens next?</a:t>
+              <a:t>Should this failure block the commit, the PR, the merge, the deployment — or merely produce evidence?</a:t>
             </a:r>
           </a:p>
         </p:txBody>
@@ -18647,17 +18843,41 @@
         <p:spPr/>
         <p:txBody>
           <a:bodyPr wrap="square">
-            <a:normAutofit fontScale="90000"/>
+            <a:noAutofit/>
           </a:bodyPr>
           <a:lstStyle/>
           <a:p>
             <a:r>
-              <a:rPr sz="2400" b="0" dirty="0">
+              <a:rPr lang="en-US" sz="2400" b="1" dirty="0">
                 <a:solidFill>
                   <a:srgbClr val="000000"/>
                 </a:solidFill>
               </a:rPr>
-              <a:t>Check correspondence statically</a:t>
+              <a:t>In closing: </a:t>
+            </a:r>
+            <a:r>
+              <a:rPr sz="2400" b="1" dirty="0">
+                <a:solidFill>
+                  <a:srgbClr val="000000"/>
+                </a:solidFill>
+              </a:rPr>
+              <a:t>How do you </a:t>
+            </a:r>
+            <a:r>
+              <a:rPr lang="en-US" sz="2400" b="1" dirty="0">
+                <a:solidFill>
+                  <a:srgbClr val="000000"/>
+                </a:solidFill>
+              </a:rPr>
+              <a:t>supervise your delegation</a:t>
+            </a:r>
+            <a:r>
+              <a:rPr sz="2400" b="1" dirty="0">
+                <a:solidFill>
+                  <a:srgbClr val="000000"/>
+                </a:solidFill>
+              </a:rPr>
+              <a:t>?</a:t>
             </a:r>
           </a:p>
         </p:txBody>
@@ -18679,7 +18899,7 @@
           <a:p>
             <a:fld id="{B7EB45DA-9A0D-DC49-8E02-F30A5DDC21C3}" type="slidenum">
               <a:rPr lang="en-US" smtClean="0"/>
-              <a:t>25</a:t>
+              <a:t>31</a:t>
             </a:fld>
             <a:endParaRPr lang="en-US"/>
           </a:p>
@@ -18687,14 +18907,14 @@
       </p:sp>
       <p:sp>
         <p:nvSpPr>
-          <p:cNvPr id="2" name="Sc-MODEL"/>
+          <p:cNvPr id="5" name="Rectangle 4"/>
           <p:cNvSpPr/>
           <p:nvPr/>
         </p:nvSpPr>
         <p:spPr>
           <a:xfrm>
-            <a:off x="502920" y="1005840"/>
-            <a:ext cx="3200400" cy="548640"/>
+            <a:off x="640080" y="1005840"/>
+            <a:ext cx="2194560" cy="822960"/>
           </a:xfrm>
           <a:prstGeom prst="rect">
             <a:avLst/>
@@ -18707,34 +18927,80 @@
           </a:ln>
           <a:effectLst/>
         </p:spPr>
+        <p:style>
+          <a:lnRef idx="1">
+            <a:schemeClr val="accent1"/>
+          </a:lnRef>
+          <a:fillRef idx="3">
+            <a:schemeClr val="accent1"/>
+          </a:fillRef>
+          <a:effectRef idx="2">
+            <a:schemeClr val="accent1"/>
+          </a:effectRef>
+          <a:fontRef idx="minor">
+            <a:schemeClr val="lt1"/>
+          </a:fontRef>
+        </p:style>
         <p:txBody>
           <a:bodyPr wrap="square" lIns="27432" tIns="22860" rIns="27432" bIns="22860" rtlCol="0" anchor="ctr"/>
           <a:lstStyle/>
           <a:p>
-            <a:pPr algn="ctr">
-              <a:buNone/>
-            </a:pPr>
-            <a:r>
-              <a:rPr lang="en-US" sz="2000" b="1" i="0" dirty="0">
+            <a:pPr algn="ctr"/>
+            <a:r>
+              <a:rPr sz="2000" b="1" i="0">
                 <a:solidFill>
                   <a:srgbClr val="FFFFFF"/>
                 </a:solidFill>
               </a:rPr>
-              <a:t>MODEL</a:t>
-            </a:r>
-          </a:p>
-        </p:txBody>
-      </p:sp>
-      <p:sp>
-        <p:nvSpPr>
-          <p:cNvPr id="5" name="Sc-REALIZATION"/>
+              <a:t>MODELING</a:t>
+            </a:r>
+          </a:p>
+        </p:txBody>
+      </p:sp>
+      <p:sp>
+        <p:nvSpPr>
+          <p:cNvPr id="6" name="TextBox 5"/>
+          <p:cNvSpPr txBox="1"/>
+          <p:nvPr/>
+        </p:nvSpPr>
+        <p:spPr>
+          <a:xfrm>
+            <a:off x="3108960" y="1033272"/>
+            <a:ext cx="5715000" cy="1005840"/>
+          </a:xfrm>
+          <a:prstGeom prst="rect">
+            <a:avLst/>
+          </a:prstGeom>
+          <a:noFill/>
+        </p:spPr>
+        <p:txBody>
+          <a:bodyPr wrap="square" anchor="ctr">
+            <a:spAutoFit/>
+          </a:bodyPr>
+          <a:lstStyle/>
+          <a:p>
+            <a:pPr algn="l"/>
+            <a:r>
+              <a:rPr sz="2000" b="0" i="0">
+                <a:solidFill>
+                  <a:srgbClr val="5C4826"/>
+                </a:solidFill>
+              </a:rPr>
+              <a:t>make consequential engineering knowledge explicit while leaving irrelevant choices free</a:t>
+            </a:r>
+          </a:p>
+        </p:txBody>
+      </p:sp>
+      <p:sp>
+        <p:nvSpPr>
+          <p:cNvPr id="7" name="Rectangle 6"/>
           <p:cNvSpPr/>
           <p:nvPr/>
         </p:nvSpPr>
         <p:spPr>
           <a:xfrm>
-            <a:off x="5440680" y="1005840"/>
-            <a:ext cx="3200400" cy="548640"/>
+            <a:off x="640080" y="2103120"/>
+            <a:ext cx="2194560" cy="822960"/>
           </a:xfrm>
           <a:prstGeom prst="rect">
             <a:avLst/>
@@ -18747,40 +19013,86 @@
           </a:ln>
           <a:effectLst/>
         </p:spPr>
+        <p:style>
+          <a:lnRef idx="1">
+            <a:schemeClr val="accent1"/>
+          </a:lnRef>
+          <a:fillRef idx="3">
+            <a:schemeClr val="accent1"/>
+          </a:fillRef>
+          <a:effectRef idx="2">
+            <a:schemeClr val="accent1"/>
+          </a:effectRef>
+          <a:fontRef idx="minor">
+            <a:schemeClr val="lt1"/>
+          </a:fontRef>
+        </p:style>
         <p:txBody>
           <a:bodyPr wrap="square" lIns="27432" tIns="22860" rIns="27432" bIns="22860" rtlCol="0" anchor="ctr"/>
           <a:lstStyle/>
           <a:p>
-            <a:pPr algn="ctr">
-              <a:buNone/>
-            </a:pPr>
-            <a:r>
-              <a:rPr lang="en-US" sz="2000" b="1" i="0" dirty="0">
+            <a:pPr algn="ctr"/>
+            <a:r>
+              <a:rPr sz="2000" b="1" i="0">
                 <a:solidFill>
                   <a:srgbClr val="FFFFFF"/>
                 </a:solidFill>
               </a:rPr>
-              <a:t>REALIZATION</a:t>
-            </a:r>
-          </a:p>
-        </p:txBody>
-      </p:sp>
-      <p:sp>
-        <p:nvSpPr>
-          <p:cNvPr id="6" name="Sc-ModelItems"/>
+              <a:t>ALIGNMENT</a:t>
+            </a:r>
+          </a:p>
+        </p:txBody>
+      </p:sp>
+      <p:sp>
+        <p:nvSpPr>
+          <p:cNvPr id="8" name="TextBox 7"/>
+          <p:cNvSpPr txBox="1"/>
+          <p:nvPr/>
+        </p:nvSpPr>
+        <p:spPr>
+          <a:xfrm>
+            <a:off x="3108960" y="2130552"/>
+            <a:ext cx="5715000" cy="1005840"/>
+          </a:xfrm>
+          <a:prstGeom prst="rect">
+            <a:avLst/>
+          </a:prstGeom>
+          <a:noFill/>
+        </p:spPr>
+        <p:txBody>
+          <a:bodyPr wrap="square" anchor="ctr">
+            <a:spAutoFit/>
+          </a:bodyPr>
+          <a:lstStyle/>
+          <a:p>
+            <a:pPr algn="l"/>
+            <a:r>
+              <a:rPr sz="2000" b="0" i="0">
+                <a:solidFill>
+                  <a:srgbClr val="5C4826"/>
+                </a:solidFill>
+              </a:rPr>
+              <a:t>connect selected obligations to consequences in the engineered environment</a:t>
+            </a:r>
+          </a:p>
+        </p:txBody>
+      </p:sp>
+      <p:sp>
+        <p:nvSpPr>
+          <p:cNvPr id="9" name="Rectangle 8"/>
           <p:cNvSpPr/>
           <p:nvPr/>
         </p:nvSpPr>
         <p:spPr>
           <a:xfrm>
-            <a:off x="502920" y="1645920"/>
-            <a:ext cx="3200400" cy="731520"/>
+            <a:off x="640080" y="3291840"/>
+            <a:ext cx="8183879" cy="2514600"/>
           </a:xfrm>
           <a:prstGeom prst="rect">
             <a:avLst/>
           </a:prstGeom>
           <a:solidFill>
-            <a:srgbClr val="F5F1E8"/>
+            <a:srgbClr val="FBF8F2"/>
           </a:solidFill>
           <a:ln w="12700">
             <a:solidFill>
@@ -18789,356 +19101,106 @@
           </a:ln>
           <a:effectLst/>
         </p:spPr>
-        <p:txBody>
-          <a:bodyPr wrap="square" lIns="27432" tIns="22860" rIns="27432" bIns="22860" rtlCol="0" anchor="ctr"/>
-          <a:lstStyle/>
-          <a:p>
-            <a:pPr algn="ctr">
-              <a:buNone/>
-            </a:pPr>
-            <a:r>
-              <a:rPr lang="en-US" sz="2000" b="0" i="0" dirty="0">
-                <a:solidFill>
-                  <a:srgbClr val="5C4826"/>
-                </a:solidFill>
-              </a:rPr>
-              <a:t>lifecycle / bounds</a:t>
-            </a:r>
-          </a:p>
-          <a:p>
-            <a:pPr algn="ctr">
-              <a:spcBef>
-                <a:spcPts val="300"/>
-              </a:spcBef>
-              <a:buNone/>
-            </a:pPr>
-            <a:r>
-              <a:rPr lang="en-US" sz="2000" b="0" i="0" dirty="0">
-                <a:solidFill>
-                  <a:srgbClr val="5C4826"/>
-                </a:solidFill>
-              </a:rPr>
-              <a:t>architectural rules</a:t>
-            </a:r>
-          </a:p>
-        </p:txBody>
-      </p:sp>
-      <p:sp>
-        <p:nvSpPr>
-          <p:cNvPr id="7" name="Sc-RealItems"/>
-          <p:cNvSpPr/>
-          <p:nvPr/>
-        </p:nvSpPr>
-        <p:spPr>
-          <a:xfrm>
-            <a:off x="5440680" y="1645920"/>
-            <a:ext cx="3200400" cy="731520"/>
-          </a:xfrm>
-          <a:prstGeom prst="rect">
-            <a:avLst/>
-          </a:prstGeom>
-          <a:solidFill>
-            <a:srgbClr val="F5F1E8"/>
-          </a:solidFill>
-          <a:ln w="12700">
-            <a:solidFill>
-              <a:srgbClr val="C9B991"/>
-            </a:solidFill>
-          </a:ln>
-          <a:effectLst/>
-        </p:spPr>
-        <p:txBody>
-          <a:bodyPr wrap="square" lIns="27432" tIns="22860" rIns="27432" bIns="22860" rtlCol="0" anchor="ctr"/>
-          <a:lstStyle/>
-          <a:p>
-            <a:pPr algn="ctr">
-              <a:buNone/>
-            </a:pPr>
-            <a:r>
-              <a:rPr lang="en-US" sz="2000" b="0" i="0" dirty="0">
-                <a:solidFill>
-                  <a:srgbClr val="5C4826"/>
-                </a:solidFill>
-              </a:rPr>
-              <a:t>source code</a:t>
-            </a:r>
-          </a:p>
-          <a:p>
-            <a:pPr algn="ctr">
-              <a:spcBef>
-                <a:spcPts val="300"/>
-              </a:spcBef>
-              <a:buNone/>
-            </a:pPr>
-            <a:r>
-              <a:rPr lang="en-US" sz="2000" b="0" i="0" dirty="0">
-                <a:solidFill>
-                  <a:srgbClr val="5C4826"/>
-                </a:solidFill>
-              </a:rPr>
-              <a:t>configuration</a:t>
-            </a:r>
-          </a:p>
-        </p:txBody>
-      </p:sp>
-      <p:cxnSp>
-        <p:nvCxnSpPr>
-          <p:cNvPr id="8" name="Sc-A1"/>
-          <p:cNvCxnSpPr/>
-          <p:nvPr/>
-        </p:nvCxnSpPr>
-        <p:spPr>
-          <a:xfrm>
-            <a:off x="2103120" y="2377440"/>
-            <a:ext cx="0" cy="274320"/>
-          </a:xfrm>
-          <a:prstGeom prst="straightConnector1">
-            <a:avLst/>
-          </a:prstGeom>
-          <a:ln w="19050">
-            <a:solidFill>
-              <a:srgbClr val="8E6F3E"/>
-            </a:solidFill>
-            <a:tailEnd type="triangle"/>
-          </a:ln>
-        </p:spPr>
-      </p:cxnSp>
-      <p:cxnSp>
-        <p:nvCxnSpPr>
-          <p:cNvPr id="9" name="Sc-A2"/>
-          <p:cNvCxnSpPr/>
-          <p:nvPr/>
-        </p:nvCxnSpPr>
-        <p:spPr>
-          <a:xfrm>
-            <a:off x="7040880" y="2377440"/>
-            <a:ext cx="0" cy="274320"/>
-          </a:xfrm>
-          <a:prstGeom prst="straightConnector1">
-            <a:avLst/>
-          </a:prstGeom>
-          <a:ln w="19050">
-            <a:solidFill>
-              <a:srgbClr val="8E6F3E"/>
-            </a:solidFill>
-            <a:tailEnd type="triangle"/>
-          </a:ln>
-        </p:spPr>
-      </p:cxnSp>
-      <p:sp>
-        <p:nvSpPr>
-          <p:cNvPr id="10" name="Sc-CHECK"/>
-          <p:cNvSpPr/>
-          <p:nvPr/>
-        </p:nvSpPr>
-        <p:spPr>
-          <a:xfrm>
-            <a:off x="1828800" y="2651760"/>
-            <a:ext cx="5486400" cy="548640"/>
-          </a:xfrm>
-          <a:prstGeom prst="rect">
-            <a:avLst/>
-          </a:prstGeom>
-          <a:solidFill>
-            <a:srgbClr val="F5F1E8"/>
-          </a:solidFill>
-          <a:ln w="12700">
-            <a:solidFill>
-              <a:srgbClr val="C9B991"/>
-            </a:solidFill>
-          </a:ln>
-          <a:effectLst/>
-        </p:spPr>
-        <p:txBody>
-          <a:bodyPr wrap="square" lIns="27432" tIns="22860" rIns="27432" bIns="22860" rtlCol="0" anchor="ctr"/>
-          <a:lstStyle/>
-          <a:p>
-            <a:pPr algn="ctr">
-              <a:buNone/>
-            </a:pPr>
-            <a:r>
-              <a:rPr lang="en-US" sz="2000" b="1" i="0" dirty="0">
-                <a:solidFill>
-                  <a:srgbClr val="5C4826"/>
-                </a:solidFill>
-              </a:rPr>
-              <a:t>STATIC CHECK</a:t>
-            </a:r>
-          </a:p>
-        </p:txBody>
-      </p:sp>
-      <p:cxnSp>
-        <p:nvCxnSpPr>
-          <p:cNvPr id="11" name="Sc-A3"/>
-          <p:cNvCxnSpPr/>
-          <p:nvPr/>
-        </p:nvCxnSpPr>
-        <p:spPr>
-          <a:xfrm>
-            <a:off x="4572000" y="3200400"/>
-            <a:ext cx="0" cy="274320"/>
-          </a:xfrm>
-          <a:prstGeom prst="straightConnector1">
-            <a:avLst/>
-          </a:prstGeom>
-          <a:ln w="19050">
-            <a:solidFill>
-              <a:srgbClr val="8E6F3E"/>
-            </a:solidFill>
-            <a:tailEnd type="triangle"/>
-          </a:ln>
-        </p:spPr>
-      </p:cxnSp>
-      <p:sp>
-        <p:nvSpPr>
-          <p:cNvPr id="12" name="Sc-VERDICT"/>
-          <p:cNvSpPr/>
-          <p:nvPr/>
-        </p:nvSpPr>
-        <p:spPr>
-          <a:xfrm>
-            <a:off x="3657600" y="3474720"/>
-            <a:ext cx="1828800" cy="548640"/>
-          </a:xfrm>
-          <a:prstGeom prst="rect">
-            <a:avLst/>
-          </a:prstGeom>
-          <a:solidFill>
-            <a:srgbClr val="8E6F3E"/>
-          </a:solidFill>
-          <a:ln>
-            <a:noFill/>
-          </a:ln>
-          <a:effectLst/>
-        </p:spPr>
-        <p:txBody>
-          <a:bodyPr wrap="square" lIns="27432" tIns="22860" rIns="27432" bIns="22860" rtlCol="0" anchor="ctr"/>
-          <a:lstStyle/>
-          <a:p>
-            <a:pPr algn="ctr">
-              <a:buNone/>
-            </a:pPr>
-            <a:r>
-              <a:rPr lang="en-US" sz="2000" b="1" i="0" dirty="0">
-                <a:solidFill>
-                  <a:srgbClr val="FFFFFF"/>
-                </a:solidFill>
-              </a:rPr>
-              <a:t>VERDICT</a:t>
-            </a:r>
-          </a:p>
-        </p:txBody>
-      </p:sp>
-      <p:sp>
-        <p:nvSpPr>
-          <p:cNvPr id="13" name="Sc-Questions"/>
-          <p:cNvSpPr/>
-          <p:nvPr/>
-        </p:nvSpPr>
-        <p:spPr>
-          <a:xfrm>
-            <a:off x="502920" y="4114800"/>
-            <a:ext cx="8138160" cy="1371600"/>
-          </a:xfrm>
-          <a:prstGeom prst="rect">
-            <a:avLst/>
-          </a:prstGeom>
-          <a:solidFill>
-            <a:srgbClr val="F5F1E8"/>
-          </a:solidFill>
-          <a:ln w="12700">
-            <a:solidFill>
-              <a:srgbClr val="C9B991"/>
-            </a:solidFill>
-          </a:ln>
-          <a:effectLst/>
-        </p:spPr>
-        <p:txBody>
-          <a:bodyPr wrap="square" lIns="27432" tIns="22860" rIns="27432" bIns="22860" rtlCol="0" anchor="ctr"/>
-          <a:lstStyle/>
-          <a:p>
-            <a:pPr algn="l">
-              <a:buNone/>
-            </a:pPr>
-            <a:r>
-              <a:rPr lang="en-US" sz="2000" b="0" i="0" dirty="0">
-                <a:solidFill>
-                  <a:srgbClr val="5C4826"/>
-                </a:solidFill>
-              </a:rPr>
-              <a:t>Can any code path admit a third Awake thread?</a:t>
+        <p:style>
+          <a:lnRef idx="1">
+            <a:schemeClr val="accent1"/>
+          </a:lnRef>
+          <a:fillRef idx="3">
+            <a:schemeClr val="accent1"/>
+          </a:fillRef>
+          <a:effectRef idx="2">
+            <a:schemeClr val="accent1"/>
+          </a:effectRef>
+          <a:fontRef idx="minor">
+            <a:schemeClr val="lt1"/>
+          </a:fontRef>
+        </p:style>
+        <p:txBody>
+          <a:bodyPr wrap="square" lIns="137160" tIns="73152" rIns="27432" bIns="22860" rtlCol="0" anchor="t"/>
+          <a:lstStyle/>
+          <a:p>
+            <a:pPr algn="l"/>
+            <a:r>
+              <a:rPr sz="2000" b="1" i="0">
+                <a:solidFill>
+                  <a:srgbClr val="8E6F3E"/>
+                </a:solidFill>
+              </a:rPr>
+              <a:t>THE REUSABLE QUESTIONS</a:t>
             </a:r>
           </a:p>
           <a:p>
             <a:pPr algn="l">
               <a:spcBef>
-                <a:spcPts val="300"/>
+                <a:spcPts val="600"/>
               </a:spcBef>
-              <a:buNone/>
             </a:pPr>
             <a:r>
-              <a:rPr lang="en-US" sz="2000" b="0" i="0" dirty="0">
+              <a:rPr sz="2000" b="1" i="0">
                 <a:solidFill>
                   <a:srgbClr val="5C4826"/>
                 </a:solidFill>
               </a:rPr>
-              <a:t>Does the implementation permit a lifecycle transition absent from the model?</a:t>
+              <a:t>How can the delegated work fail?</a:t>
             </a:r>
           </a:p>
           <a:p>
             <a:pPr algn="l">
               <a:spcBef>
-                <a:spcPts val="300"/>
+                <a:spcPts val="600"/>
               </a:spcBef>
-              <a:buNone/>
             </a:pPr>
             <a:r>
-              <a:rPr lang="en-US" sz="2000" b="0" i="0" dirty="0">
+              <a:rPr sz="2000" b="0" i="0">
                 <a:solidFill>
                   <a:srgbClr val="5C4826"/>
                 </a:solidFill>
               </a:rPr>
-              <a:t>Do implementation resource bounds agree with the modeled bounds?</a:t>
-            </a:r>
-          </a:p>
-        </p:txBody>
-      </p:sp>
-      <p:sp>
-        <p:nvSpPr>
-          <p:cNvPr id="14" name="FooterBand"/>
-          <p:cNvSpPr/>
-          <p:nvPr/>
-        </p:nvSpPr>
-        <p:spPr>
-          <a:xfrm>
-            <a:off x="274320" y="5577840"/>
-            <a:ext cx="8595360" cy="777240"/>
-          </a:xfrm>
-          <a:prstGeom prst="rect">
-            <a:avLst/>
-          </a:prstGeom>
-          <a:solidFill>
-            <a:srgbClr val="8E6F3E"/>
-          </a:solidFill>
-          <a:ln>
-            <a:noFill/>
-          </a:ln>
-          <a:effectLst/>
-        </p:spPr>
-        <p:txBody>
-          <a:bodyPr wrap="square" lIns="27432" tIns="22860" rIns="27432" bIns="22860" rtlCol="0" anchor="ctr"/>
-          <a:lstStyle/>
-          <a:p>
-            <a:pPr algn="ctr">
-              <a:buNone/>
-            </a:pPr>
-            <a:r>
-              <a:rPr lang="en-US" sz="2000" b="1" i="0" dirty="0">
-                <a:solidFill>
-                  <a:srgbClr val="FFFFFF"/>
-                </a:solidFill>
-              </a:rPr>
-              <a:t>Static evidence can establish correspondence without executing the realization.</a:t>
+              <a:t>What must be true?</a:t>
+            </a:r>
+          </a:p>
+          <a:p>
+            <a:pPr algn="l"/>
+            <a:r>
+              <a:rPr sz="2000" b="0" i="0">
+                <a:solidFill>
+                  <a:srgbClr val="5C4826"/>
+                </a:solidFill>
+              </a:rPr>
+              <a:t>What evidence bears on it?</a:t>
+            </a:r>
+          </a:p>
+          <a:p>
+            <a:pPr algn="l"/>
+            <a:r>
+              <a:rPr sz="2000" b="0" i="0">
+                <a:solidFill>
+                  <a:srgbClr val="5C4826"/>
+                </a:solidFill>
+              </a:rPr>
+              <a:t>Where can it be decided?</a:t>
+            </a:r>
+          </a:p>
+          <a:p>
+            <a:pPr algn="l"/>
+            <a:r>
+              <a:rPr sz="2000" b="0" i="0">
+                <a:solidFill>
+                  <a:srgbClr val="5C4826"/>
+                </a:solidFill>
+              </a:rPr>
+              <a:t>How will it be evaluated?</a:t>
+            </a:r>
+          </a:p>
+          <a:p>
+            <a:pPr algn="l"/>
+            <a:r>
+              <a:rPr sz="2000" b="0" i="0">
+                <a:solidFill>
+                  <a:srgbClr val="5C4826"/>
+                </a:solidFill>
+              </a:rPr>
+              <a:t>Should failure control what happens next?</a:t>
             </a:r>
           </a:p>
         </p:txBody>

</xml_diff>

<commit_message>
deck 2-3: author retitles slide 27 to name active alignment explicitly
'Alignment can change the realization' -> 'Active alignment can be used to change the
realization'. The slide introduces the active/passive distinction, so naming the term in the
title makes the pairing with the passive-alignment material explicit rather than implied.

Verified: 32 slides, 0 runs under 20pt, 32/32 notes, pptx_validate 0 OPC / 0 schema.
</commit_message>
<xml_diff>
--- a/course/lectures/act-2-delegation-and-control/03-alignment/2-3-Alignment.pptx
+++ b/course/lectures/act-2-delegation-and-control/03-alignment/2-3-Alignment.pptx
@@ -5,7 +5,7 @@
     <p:sldMasterId id="2147483708" r:id="rId1"/>
   </p:sldMasterIdLst>
   <p:notesMasterIdLst>
-    <p:notesMasterId r:id="rId33"/>
+    <p:notesMasterId r:id="rId34"/>
   </p:notesMasterIdLst>
   <p:sldIdLst>
     <p:sldId id="256" r:id="rId2"/>
@@ -34,12 +34,12 @@
     <p:sldId id="308" r:id="rId25"/>
     <p:sldId id="311" r:id="rId26"/>
     <p:sldId id="309" r:id="rId27"/>
-    <p:sldId id="312" r:id="rId38"/>
-    <p:sldId id="281" r:id="rId28"/>
-    <p:sldId id="310" r:id="rId29"/>
-    <p:sldId id="274" r:id="rId30"/>
-    <p:sldId id="276" r:id="rId31"/>
-    <p:sldId id="282" r:id="rId32"/>
+    <p:sldId id="312" r:id="rId28"/>
+    <p:sldId id="281" r:id="rId29"/>
+    <p:sldId id="310" r:id="rId30"/>
+    <p:sldId id="274" r:id="rId31"/>
+    <p:sldId id="276" r:id="rId32"/>
+    <p:sldId id="282" r:id="rId33"/>
   </p:sldIdLst>
   <p:sldSz cx="9144000" cy="6858000" type="screen4x3"/>
   <p:notesSz cx="6858000" cy="9144000"/>
@@ -230,7 +230,7 @@
           </a:lstStyle>
           <a:p>
             <a:fld id="{27E8B4C4-0720-F64E-9EEE-9472CF165DC6}" type="datetimeFigureOut">
-              <a:t>10/7/26</a:t>
+              <a:t>10/8/26</a:t>
             </a:fld>
             <a:endParaRPr lang="en-US"/>
           </a:p>
@@ -2627,87 +2627,17 @@
           <a:lstStyle/>
           <a:p>
             <a:r>
-              <a:t>TIMING: 3 minutes</a:t>
-            </a:r>
-          </a:p>
-          <a:p>
-            <a:r>
-              <a:t>- One distinction left: three kinds of judgment. The triangle carries them.</a:t>
-            </a:r>
-          </a:p>
-          <a:p>
-            <a:r>
-              <a:t>- The previous two slides gave us ways to establish this bottom edge: correspondence between model and realization. But don't confuse agreement with correctness.</a:t>
-            </a:r>
-          </a:p>
-          <a:p>
-            <a:r>
-              <a:t>- Walk the triangle: 1. Model and realization: does the realization correspond to the model? 2. Model and obligation: did the model capture the thing we actually care about? 3. Realization and obligation: does the resulting system actually satisfy the obligation?</a:t>
-            </a:r>
-          </a:p>
-          <a:p>
-            <a:r>
-              <a:t>- A perfectly implemented bad model is still wrong.</a:t>
-            </a:r>
-          </a:p>
-          <a:p>
-            <a:r>
-              <a:t>- We have an obligation, a model, and a realization. Ask what claim each edge makes.</a:t>
-            </a:r>
-          </a:p>
-          <a:p>
-            <a:r>
-              <a:t>- captures? — does the model actually capture the obligation?</a:t>
-            </a:r>
-          </a:p>
-          <a:p>
-            <a:r>
-              <a:t>- satisfies? — does the realization satisfy the obligation? That judgment is CONFORMANCE: an artifact against an independent obligation.</a:t>
-            </a:r>
-          </a:p>
-          <a:p>
-            <a:r>
-              <a:t>- corresponds? — do model and realization agree? That judgment is CORRESPONDENCE: two representations against each other.</a:t>
-            </a:r>
-          </a:p>
-          <a:p>
-            <a:r>
-              <a:t>- ACCEPTANCE brings in a fourth object, the receiving environment: will it accept the artifact? On the slide it is the third legend line, not a fourth node — name the fourth object aloud.</a:t>
-            </a:r>
-          </a:p>
-          <a:p>
-            <a:r>
-              <a:t>- None of these edges establishes the other two. A model and implementation can agree and both be wrong against the obligation. Evidence for one claim does not establish the others.</a:t>
-            </a:r>
-          </a:p>
-          <a:p>
-            <a:r>
-              <a:t>- This matters because model-driven development can otherwise create a false sense of assurance: we can become very good at keeping implementation synchronized with a bad model.</a:t>
-            </a:r>
-          </a:p>
-          <a:p>
-            <a:r>
-              <a:t>- Correspondence is useful, but it is only one edge of the engineering argument.</a:t>
-            </a:r>
-          </a:p>
-          <a:p>
-            <a:r>
-              <a:t>- (Demoted from the slide; ask aloud:) What claim does each edge make? What evidence would establish it?</a:t>
-            </a:r>
-          </a:p>
-          <a:p>
-            <a:r>
-              <a:t>ANIMATION</a:t>
-            </a:r>
-          </a:p>
-          <a:p>
-            <a:r>
-              <a:t>- Reveal OBLIGATION, MODEL, REALIZATION without edges if possible.</a:t>
-            </a:r>
-          </a:p>
-          <a:p>
-            <a:r>
-              <a:t>- Reveal the three edge questions, then the legend naming the three judgments.</a:t>
+              <a:t>Name the gap in the lecture explicitly. So far this lecture has mostly discussed passive alignment, because controls are easiest to explain as checks on proposed work. But alignment is not merely rejection. If an existing realization violates a newly explicit obligation, the environment can expose the disagreement and use agents or other engineering work to change the realization until correspondence is established. After that succeeds, the same obligation can be preserved passively.</a:t>
+            </a:r>
+          </a:p>
+          <a:p>
+            <a:r>
+              <a:t>Brownfield engineering: this is how a model acquires authority over a system that predates the model — one of the most practically important consequences of the active/passive distinction. And active alignment is not necessarily behavior preserving: satisfying a new model may require substantial changes to the realization, so do not assume it is just a refactor.</a:t>
+            </a:r>
+          </a:p>
+          <a:p>
+            <a:r>
+              <a:t>Bridge forward to Failure-Aware Engineering, the next unit: a failure reveals something that should become explicit; you model the lesson; active alignment repairs the existing realization to satisfy it; passive alignment prevents later work from silently undoing it. Active alignment produces durable engineering structure — failure analysis tells us what the new evidence justifies changing; active alignment explains how a newly discovered obligation can be imposed on an already-existing realization.</a:t>
             </a:r>
           </a:p>
         </p:txBody>
@@ -2733,6 +2663,156 @@
 </file>
 
 <file path=ppt/notesSlides/notesSlide28.xml><?xml version="1.0" encoding="utf-8"?>
+<p:notes xmlns:a="http://schemas.openxmlformats.org/drawingml/2006/main" xmlns:r="http://schemas.openxmlformats.org/officeDocument/2006/relationships" xmlns:p="http://schemas.openxmlformats.org/presentationml/2006/main">
+  <p:cSld>
+    <p:spTree>
+      <p:nvGrpSpPr>
+        <p:cNvPr id="1" name=""/>
+        <p:cNvGrpSpPr/>
+        <p:nvPr/>
+      </p:nvGrpSpPr>
+      <p:grpSpPr>
+        <a:xfrm>
+          <a:off x="0" y="0"/>
+          <a:ext cx="0" cy="0"/>
+          <a:chOff x="0" y="0"/>
+          <a:chExt cx="0" cy="0"/>
+        </a:xfrm>
+      </p:grpSpPr>
+      <p:sp>
+        <p:nvSpPr>
+          <p:cNvPr id="2" name="Slide Image Placeholder 1"/>
+          <p:cNvSpPr>
+            <a:spLocks noGrp="1" noRot="1" noChangeAspect="1"/>
+          </p:cNvSpPr>
+          <p:nvPr>
+            <p:ph type="sldImg" idx="2"/>
+          </p:nvPr>
+        </p:nvSpPr>
+        <p:spPr/>
+      </p:sp>
+      <p:sp>
+        <p:nvSpPr>
+          <p:cNvPr id="3" name="Notes Placeholder 2"/>
+          <p:cNvSpPr>
+            <a:spLocks noGrp="1"/>
+          </p:cNvSpPr>
+          <p:nvPr>
+            <p:ph type="body" sz="quarter" idx="3"/>
+          </p:nvPr>
+        </p:nvSpPr>
+        <p:spPr/>
+        <p:txBody>
+          <a:bodyPr/>
+          <a:lstStyle/>
+          <a:p>
+            <a:r>
+              <a:t>TIMING: 3 minutes</a:t>
+            </a:r>
+          </a:p>
+          <a:p>
+            <a:r>
+              <a:t>- One distinction left: three kinds of judgment. The triangle carries them.</a:t>
+            </a:r>
+          </a:p>
+          <a:p>
+            <a:r>
+              <a:t>- The previous two slides gave us ways to establish this bottom edge: correspondence between model and realization. But don't confuse agreement with correctness.</a:t>
+            </a:r>
+          </a:p>
+          <a:p>
+            <a:r>
+              <a:t>- Walk the triangle: 1. Model and realization: does the realization correspond to the model? 2. Model and obligation: did the model capture the thing we actually care about? 3. Realization and obligation: does the resulting system actually satisfy the obligation?</a:t>
+            </a:r>
+          </a:p>
+          <a:p>
+            <a:r>
+              <a:t>- A perfectly implemented bad model is still wrong.</a:t>
+            </a:r>
+          </a:p>
+          <a:p>
+            <a:r>
+              <a:t>- We have an obligation, a model, and a realization. Ask what claim each edge makes.</a:t>
+            </a:r>
+          </a:p>
+          <a:p>
+            <a:r>
+              <a:t>- captures? — does the model actually capture the obligation?</a:t>
+            </a:r>
+          </a:p>
+          <a:p>
+            <a:r>
+              <a:t>- satisfies? — does the realization satisfy the obligation? That judgment is CONFORMANCE: an artifact against an independent obligation.</a:t>
+            </a:r>
+          </a:p>
+          <a:p>
+            <a:r>
+              <a:t>- corresponds? — do model and realization agree? That judgment is CORRESPONDENCE: two representations against each other.</a:t>
+            </a:r>
+          </a:p>
+          <a:p>
+            <a:r>
+              <a:t>- ACCEPTANCE brings in a fourth object, the receiving environment: will it accept the artifact? On the slide it is the third legend line, not a fourth node — name the fourth object aloud.</a:t>
+            </a:r>
+          </a:p>
+          <a:p>
+            <a:r>
+              <a:t>- None of these edges establishes the other two. A model and implementation can agree and both be wrong against the obligation. Evidence for one claim does not establish the others.</a:t>
+            </a:r>
+          </a:p>
+          <a:p>
+            <a:r>
+              <a:t>- This matters because model-driven development can otherwise create a false sense of assurance: we can become very good at keeping implementation synchronized with a bad model.</a:t>
+            </a:r>
+          </a:p>
+          <a:p>
+            <a:r>
+              <a:t>- Correspondence is useful, but it is only one edge of the engineering argument.</a:t>
+            </a:r>
+          </a:p>
+          <a:p>
+            <a:r>
+              <a:t>- (Demoted from the slide; ask aloud:) What claim does each edge make? What evidence would establish it?</a:t>
+            </a:r>
+          </a:p>
+          <a:p>
+            <a:r>
+              <a:t>ANIMATION</a:t>
+            </a:r>
+          </a:p>
+          <a:p>
+            <a:r>
+              <a:t>- Reveal OBLIGATION, MODEL, REALIZATION without edges if possible.</a:t>
+            </a:r>
+          </a:p>
+          <a:p>
+            <a:r>
+              <a:t>- Reveal the three edge questions, then the legend naming the three judgments.</a:t>
+            </a:r>
+          </a:p>
+        </p:txBody>
+      </p:sp>
+      <p:sp>
+        <p:nvSpPr>
+          <p:cNvPr id="4" name="Slide Number Placeholder 3"/>
+          <p:cNvSpPr>
+            <a:spLocks noGrp="1"/>
+          </p:cNvSpPr>
+          <p:nvPr>
+            <p:ph type="sldNum" sz="quarter" idx="5"/>
+          </p:nvPr>
+        </p:nvSpPr>
+        <p:spPr/>
+      </p:sp>
+    </p:spTree>
+  </p:cSld>
+  <p:clrMapOvr>
+    <a:masterClrMapping/>
+  </p:clrMapOvr>
+</p:notes>
+</file>
+
+<file path=ppt/notesSlides/notesSlide29.xml><?xml version="1.0" encoding="utf-8"?>
 <p:notes xmlns:a="http://schemas.openxmlformats.org/drawingml/2006/main" xmlns:r="http://schemas.openxmlformats.org/officeDocument/2006/relationships" xmlns:p="http://schemas.openxmlformats.org/presentationml/2006/main">
   <p:cSld>
     <p:spTree>
@@ -2839,121 +2919,6 @@
         <p14:creationId xmlns:p14="http://schemas.microsoft.com/office/powerpoint/2010/main" val="150573818"/>
       </p:ext>
     </p:extLst>
-  </p:cSld>
-  <p:clrMapOvr>
-    <a:masterClrMapping/>
-  </p:clrMapOvr>
-</p:notes>
-</file>
-
-<file path=ppt/notesSlides/notesSlide29.xml><?xml version="1.0" encoding="utf-8"?>
-<p:notes xmlns:a="http://schemas.openxmlformats.org/drawingml/2006/main" xmlns:r="http://schemas.openxmlformats.org/officeDocument/2006/relationships" xmlns:p="http://schemas.openxmlformats.org/presentationml/2006/main">
-  <p:cSld>
-    <p:spTree>
-      <p:nvGrpSpPr>
-        <p:cNvPr id="1" name=""/>
-        <p:cNvGrpSpPr/>
-        <p:nvPr/>
-      </p:nvGrpSpPr>
-      <p:grpSpPr>
-        <a:xfrm>
-          <a:off x="0" y="0"/>
-          <a:ext cx="0" cy="0"/>
-          <a:chOff x="0" y="0"/>
-          <a:chExt cx="0" cy="0"/>
-        </a:xfrm>
-      </p:grpSpPr>
-      <p:sp>
-        <p:nvSpPr>
-          <p:cNvPr id="2" name="Slide Image Placeholder 1"/>
-          <p:cNvSpPr>
-            <a:spLocks noGrp="1" noRot="1" noChangeAspect="1"/>
-          </p:cNvSpPr>
-          <p:nvPr>
-            <p:ph type="sldImg" idx="2"/>
-          </p:nvPr>
-        </p:nvSpPr>
-        <p:spPr/>
-      </p:sp>
-      <p:sp>
-        <p:nvSpPr>
-          <p:cNvPr id="3" name="Notes Placeholder 2"/>
-          <p:cNvSpPr>
-            <a:spLocks noGrp="1"/>
-          </p:cNvSpPr>
-          <p:nvPr>
-            <p:ph type="body" sz="quarter" idx="3"/>
-          </p:nvPr>
-        </p:nvSpPr>
-        <p:spPr/>
-        <p:txBody>
-          <a:bodyPr/>
-          <a:lstStyle/>
-          <a:p>
-            <a:r>
-              <a:t>TIMING: 30 seconds transition + 2 minutes setup + 8-10 minutes work</a:t>
-            </a:r>
-          </a:p>
-          <a:p>
-            <a:r>
-              <a:t>- This slide is the section transition — the activity title itself is the transition. Setup line: enough vocabulary; now use it.</a:t>
-            </a:r>
-          </a:p>
-          <a:p>
-            <a:r>
-              <a:t>- This is unmistakably a RETURN TO THE LAB, not a new scenario: the two model cards on the left are the two models the class built in the Modeling lab and saw four slides ago (the working-memory view and the lifecycle view of the sensor node). In Modeling, they built and used the model; now they use that same model as an independent validation surface.</a:t>
-            </a:r>
-          </a:p>
-          <a:p>
-            <a:r>
-              <a:t>- This lands the Modeling deck's own message that models constrain implementation without determining it: we left realization choices free; now we check that the chosen realization still satisfies what the model preserved.</a:t>
-            </a:r>
-          </a:p>
-          <a:p>
-            <a:r>
-              <a:t>- Teams choose ONE obligation from the lab — the 48 KB device ceiling, the at-most-two-awake admission rule, a per-thread working-memory maximum — and walk the five questions on the right.</a:t>
-            </a:r>
-          </a:p>
-          <a:p>
-            <a:r>
-              <a:t>WORKSHEET (keep this slide up while teams work and walk it aloud):</a:t>
-            </a:r>
-          </a:p>
-          <a:p>
-            <a:r>
-              <a:t>- For each obligation, identify what can fail, what evidence establishes it, where it becomes decidable, and what failure should control.</a:t>
-            </a:r>
-          </a:p>
-          <a:p>
-            <a:r>
-              <a:t>- The five numbered questions walk that sequence: failure mode; prevent or detect; evidence; earliest decidable boundary; consequence of a failed check. Teams should also ask which of the two views makes the relevant fact explicit, and whether they would validate it statically or dynamically.</a:t>
-            </a:r>
-          </a:p>
-          <a:p>
-            <a:r>
-              <a:t>- Teams should be ready to defend their boundary choices and what authority the verdict carries.</a:t>
-            </a:r>
-          </a:p>
-          <a:p>
-            <a:r>
-              <a:t>- Takeaway strip: OBLIGATION → MODEL → CHECK → DECIDE → CONTROL — the triangle has just made the point that the model is not the source of truth; the engineering obligation is.</a:t>
-            </a:r>
-          </a:p>
-        </p:txBody>
-      </p:sp>
-      <p:sp>
-        <p:nvSpPr>
-          <p:cNvPr id="4" name="Slide Number Placeholder 3"/>
-          <p:cNvSpPr>
-            <a:spLocks noGrp="1"/>
-          </p:cNvSpPr>
-          <p:nvPr>
-            <p:ph type="sldNum" sz="quarter" idx="5"/>
-          </p:nvPr>
-        </p:nvSpPr>
-        <p:spPr/>
-      </p:sp>
-    </p:spTree>
   </p:cSld>
   <p:clrMapOvr>
     <a:masterClrMapping/>
@@ -3121,52 +3086,52 @@
           <a:lstStyle/>
           <a:p>
             <a:r>
-              <a:t>TIMING: 4-5 minutes</a:t>
-            </a:r>
-          </a:p>
-          <a:p>
-            <a:r>
-              <a:t>- Have two or three teams report a control they designed differently.</a:t>
-            </a:r>
-          </a:p>
-          <a:p>
-            <a:r>
-              <a:t>- Do not search immediately for the one correct design. Compare the engineering tradeoffs.</a:t>
-            </a:r>
-          </a:p>
-          <a:p>
-            <a:r>
-              <a:t>- If teams chose different boundaries for the same obligation, ask which boundary actually contains enough information.</a:t>
-            </a:r>
-          </a:p>
-          <a:p>
-            <a:r>
-              <a:t>- If one team chose a constraint and another chose detection, ask whether the invalid state can cleanly be excluded.</a:t>
-            </a:r>
-          </a:p>
-          <a:p>
-            <a:r>
-              <a:t>- If teams relied on different evidence, ask whether the obligation can be decided from the realization itself — statically — or only from observed execution.</a:t>
-            </a:r>
-          </a:p>
-          <a:p>
-            <a:r>
-              <a:t>- Finally, if teams attach different consequences, ask whether this failure warrants blocking commit, PR, merge, deployment, or merely producing evidence. This dimension goes last because it returns to the central Alignment question: where does the verdict acquire authority?</a:t>
-            </a:r>
-          </a:p>
-          <a:p>
-            <a:r>
-              <a:t>- The important thing is that the design is defensible against the failure model and obligation, not that everyone chose identical machinery.</a:t>
-            </a:r>
-          </a:p>
-          <a:p>
-            <a:r>
-              <a:t>ANIMATION</a:t>
-            </a:r>
-          </a:p>
-          <a:p>
-            <a:r>
-              <a:t>- Reveal comparison questions one at a time as they become relevant to student answers.</a:t>
+              <a:t>TIMING: 30 seconds transition + 2 minutes setup + 8-10 minutes work</a:t>
+            </a:r>
+          </a:p>
+          <a:p>
+            <a:r>
+              <a:t>- This slide is the section transition — the activity title itself is the transition. Setup line: enough vocabulary; now use it.</a:t>
+            </a:r>
+          </a:p>
+          <a:p>
+            <a:r>
+              <a:t>- This is unmistakably a RETURN TO THE LAB, not a new scenario: the two model cards on the left are the two models the class built in the Modeling lab and saw four slides ago (the working-memory view and the lifecycle view of the sensor node). In Modeling, they built and used the model; now they use that same model as an independent validation surface.</a:t>
+            </a:r>
+          </a:p>
+          <a:p>
+            <a:r>
+              <a:t>- This lands the Modeling deck's own message that models constrain implementation without determining it: we left realization choices free; now we check that the chosen realization still satisfies what the model preserved.</a:t>
+            </a:r>
+          </a:p>
+          <a:p>
+            <a:r>
+              <a:t>- Teams choose ONE obligation from the lab — the 48 KB device ceiling, the at-most-two-awake admission rule, a per-thread working-memory maximum — and walk the five questions on the right.</a:t>
+            </a:r>
+          </a:p>
+          <a:p>
+            <a:r>
+              <a:t>WORKSHEET (keep this slide up while teams work and walk it aloud):</a:t>
+            </a:r>
+          </a:p>
+          <a:p>
+            <a:r>
+              <a:t>- For each obligation, identify what can fail, what evidence establishes it, where it becomes decidable, and what failure should control.</a:t>
+            </a:r>
+          </a:p>
+          <a:p>
+            <a:r>
+              <a:t>- The five numbered questions walk that sequence: failure mode; prevent or detect; evidence; earliest decidable boundary; consequence of a failed check. Teams should also ask which of the two views makes the relevant fact explicit, and whether they would validate it statically or dynamically.</a:t>
+            </a:r>
+          </a:p>
+          <a:p>
+            <a:r>
+              <a:t>- Teams should be ready to defend their boundary choices and what authority the verdict carries.</a:t>
+            </a:r>
+          </a:p>
+          <a:p>
+            <a:r>
+              <a:t>- Takeaway strip: OBLIGATION → MODEL → CHECK → DECIDE → CONTROL — the triangle has just made the point that the model is not the source of truth; the engineering obligation is.</a:t>
             </a:r>
           </a:p>
         </p:txBody>
@@ -3236,72 +3201,42 @@
           <a:lstStyle/>
           <a:p>
             <a:r>
-              <a:t>TIMING: 3 minutes</a:t>
-            </a:r>
-          </a:p>
-          <a:p>
-            <a:r>
-              <a:t>- Return to the question from slide 1.</a:t>
-            </a:r>
-          </a:p>
-          <a:p>
-            <a:r>
-              <a:t>- Modeling and Alignment solve different parts of the problem.</a:t>
-            </a:r>
-          </a:p>
-          <a:p>
-            <a:r>
-              <a:t>- Modeling makes consequential engineering knowledge explicit while leaving irrelevant choices free.</a:t>
-            </a:r>
-          </a:p>
-          <a:p>
-            <a:r>
-              <a:t>- Alignment decides which obligations have consequences in the engineered environment.</a:t>
-            </a:r>
-          </a:p>
-          <a:p>
-            <a:r>
-              <a:t>- Then walk the reusable questions in order.</a:t>
-            </a:r>
-          </a:p>
-          <a:p>
-            <a:r>
-              <a:t>- How can delegated work fail? Start with the failure model.</a:t>
-            </a:r>
-          </a:p>
-          <a:p>
-            <a:r>
-              <a:t>- What must be true? State the obligation.</a:t>
-            </a:r>
-          </a:p>
-          <a:p>
-            <a:r>
-              <a:t>- What evidence bears on it? Do not confuse activity with evidence.</a:t>
-            </a:r>
-          </a:p>
-          <a:p>
-            <a:r>
-              <a:t>- Where can it be decided? Put the mechanism at a boundary with sufficient information.</a:t>
-            </a:r>
-          </a:p>
-          <a:p>
-            <a:r>
-              <a:t>- How will it be evaluated? Identify the validator or equivalent judgment.</a:t>
-            </a:r>
-          </a:p>
-          <a:p>
-            <a:r>
-              <a:t>- Should failure control what happens next? Decide the authority of the verdict.</a:t>
-            </a:r>
-          </a:p>
-          <a:p>
-            <a:r>
-              <a:t>- That last question is what turns Validation into Alignment.</a:t>
-            </a:r>
-          </a:p>
-          <a:p>
-            <a:r>
-              <a:t>- End there. Do not add another summary or slogan.</a:t>
+              <a:t>TIMING: 4-5 minutes</a:t>
+            </a:r>
+          </a:p>
+          <a:p>
+            <a:r>
+              <a:t>- Have two or three teams report a control they designed differently.</a:t>
+            </a:r>
+          </a:p>
+          <a:p>
+            <a:r>
+              <a:t>- Do not search immediately for the one correct design. Compare the engineering tradeoffs.</a:t>
+            </a:r>
+          </a:p>
+          <a:p>
+            <a:r>
+              <a:t>- If teams chose different boundaries for the same obligation, ask which boundary actually contains enough information.</a:t>
+            </a:r>
+          </a:p>
+          <a:p>
+            <a:r>
+              <a:t>- If one team chose a constraint and another chose detection, ask whether the invalid state can cleanly be excluded.</a:t>
+            </a:r>
+          </a:p>
+          <a:p>
+            <a:r>
+              <a:t>- If teams relied on different evidence, ask whether the obligation can be decided from the realization itself — statically — or only from observed execution.</a:t>
+            </a:r>
+          </a:p>
+          <a:p>
+            <a:r>
+              <a:t>- Finally, if teams attach different consequences, ask whether this failure warrants blocking commit, PR, merge, deployment, or merely producing evidence. This dimension goes last because it returns to the central Alignment question: where does the verdict acquire authority?</a:t>
+            </a:r>
+          </a:p>
+          <a:p>
+            <a:r>
+              <a:t>- The important thing is that the design is defensible against the failure model and obligation, not that everyone chose identical machinery.</a:t>
             </a:r>
           </a:p>
           <a:p>
@@ -3311,22 +3246,7 @@
           </a:p>
           <a:p>
             <a:r>
-              <a:t>- Reveal MODELING.</a:t>
-            </a:r>
-          </a:p>
-          <a:p>
-            <a:r>
-              <a:t>- Reveal ALIGNMENT.</a:t>
-            </a:r>
-          </a:p>
-          <a:p>
-            <a:r>
-              <a:t>- Reveal the reusable questions one at a time.</a:t>
-            </a:r>
-          </a:p>
-          <a:p>
-            <a:r>
-              <a:t>- Leave the final question, "Should failure control what happens next?", as the last reveal and final image of the lecture.</a:t>
+              <a:t>- Reveal comparison questions one at a time as they become relevant to student answers.</a:t>
             </a:r>
           </a:p>
         </p:txBody>
@@ -3352,7 +3272,7 @@
 </file>
 
 <file path=ppt/notesSlides/notesSlide32.xml><?xml version="1.0" encoding="utf-8"?>
-<p:notes xmlns:a="http://schemas.openxmlformats.org/drawingml/2006/main" xmlns:p="http://schemas.openxmlformats.org/presentationml/2006/main" xmlns:r="http://schemas.openxmlformats.org/officeDocument/2006/relationships">
+<p:notes xmlns:a="http://schemas.openxmlformats.org/drawingml/2006/main" xmlns:r="http://schemas.openxmlformats.org/officeDocument/2006/relationships" xmlns:p="http://schemas.openxmlformats.org/presentationml/2006/main">
   <p:cSld>
     <p:spTree>
       <p:nvGrpSpPr>
@@ -3372,7 +3292,7 @@
         <p:nvSpPr>
           <p:cNvPr id="2" name="Slide Image Placeholder 1"/>
           <p:cNvSpPr>
-            <a:spLocks noGrp="1"/>
+            <a:spLocks noGrp="1" noRot="1" noChangeAspect="1"/>
           </p:cNvSpPr>
           <p:nvPr>
             <p:ph type="sldImg" idx="2"/>
@@ -3387,7 +3307,7 @@
             <a:spLocks noGrp="1"/>
           </p:cNvSpPr>
           <p:nvPr>
-            <p:ph type="body" idx="3" sz="quarter"/>
+            <p:ph type="body" sz="quarter" idx="3"/>
           </p:nvPr>
         </p:nvSpPr>
         <p:spPr/>
@@ -3396,17 +3316,97 @@
           <a:lstStyle/>
           <a:p>
             <a:r>
-              <a:t>Name the gap in the lecture explicitly. So far this lecture has mostly discussed passive alignment, because controls are easiest to explain as checks on proposed work. But alignment is not merely rejection. If an existing realization violates a newly explicit obligation, the environment can expose the disagreement and use agents or other engineering work to change the realization until correspondence is established. After that succeeds, the same obligation can be preserved passively.</a:t>
-            </a:r>
-          </a:p>
-          <a:p>
-            <a:r>
-              <a:t>Brownfield engineering: this is how a model acquires authority over a system that predates the model — one of the most practically important consequences of the active/passive distinction. And active alignment is not necessarily behavior preserving: satisfying a new model may require substantial changes to the realization, so do not assume it is just a refactor.</a:t>
-            </a:r>
-          </a:p>
-          <a:p>
-            <a:r>
-              <a:t>Bridge forward to Failure-Aware Engineering, the next unit: a failure reveals something that should become explicit; you model the lesson; active alignment repairs the existing realization to satisfy it; passive alignment prevents later work from silently undoing it. Active alignment produces durable engineering structure — failure analysis tells us what the new evidence justifies changing; active alignment explains how a newly discovered obligation can be imposed on an already-existing realization.</a:t>
+              <a:t>TIMING: 3 minutes</a:t>
+            </a:r>
+          </a:p>
+          <a:p>
+            <a:r>
+              <a:t>- Return to the question from slide 1.</a:t>
+            </a:r>
+          </a:p>
+          <a:p>
+            <a:r>
+              <a:t>- Modeling and Alignment solve different parts of the problem.</a:t>
+            </a:r>
+          </a:p>
+          <a:p>
+            <a:r>
+              <a:t>- Modeling makes consequential engineering knowledge explicit while leaving irrelevant choices free.</a:t>
+            </a:r>
+          </a:p>
+          <a:p>
+            <a:r>
+              <a:t>- Alignment decides which obligations have consequences in the engineered environment.</a:t>
+            </a:r>
+          </a:p>
+          <a:p>
+            <a:r>
+              <a:t>- Then walk the reusable questions in order.</a:t>
+            </a:r>
+          </a:p>
+          <a:p>
+            <a:r>
+              <a:t>- How can delegated work fail? Start with the failure model.</a:t>
+            </a:r>
+          </a:p>
+          <a:p>
+            <a:r>
+              <a:t>- What must be true? State the obligation.</a:t>
+            </a:r>
+          </a:p>
+          <a:p>
+            <a:r>
+              <a:t>- What evidence bears on it? Do not confuse activity with evidence.</a:t>
+            </a:r>
+          </a:p>
+          <a:p>
+            <a:r>
+              <a:t>- Where can it be decided? Put the mechanism at a boundary with sufficient information.</a:t>
+            </a:r>
+          </a:p>
+          <a:p>
+            <a:r>
+              <a:t>- How will it be evaluated? Identify the validator or equivalent judgment.</a:t>
+            </a:r>
+          </a:p>
+          <a:p>
+            <a:r>
+              <a:t>- Should failure control what happens next? Decide the authority of the verdict.</a:t>
+            </a:r>
+          </a:p>
+          <a:p>
+            <a:r>
+              <a:t>- That last question is what turns Validation into Alignment.</a:t>
+            </a:r>
+          </a:p>
+          <a:p>
+            <a:r>
+              <a:t>- End there. Do not add another summary or slogan.</a:t>
+            </a:r>
+          </a:p>
+          <a:p>
+            <a:r>
+              <a:t>ANIMATION</a:t>
+            </a:r>
+          </a:p>
+          <a:p>
+            <a:r>
+              <a:t>- Reveal MODELING.</a:t>
+            </a:r>
+          </a:p>
+          <a:p>
+            <a:r>
+              <a:t>- Reveal ALIGNMENT.</a:t>
+            </a:r>
+          </a:p>
+          <a:p>
+            <a:r>
+              <a:t>- Reveal the reusable questions one at a time.</a:t>
+            </a:r>
+          </a:p>
+          <a:p>
+            <a:r>
+              <a:t>- Leave the final question, "Should failure control what happens next?", as the last reveal and final image of the lecture.</a:t>
             </a:r>
           </a:p>
         </p:txBody>
@@ -3418,7 +3418,7 @@
             <a:spLocks noGrp="1"/>
           </p:cNvSpPr>
           <p:nvPr>
-            <p:ph type="sldNum" idx="5" sz="quarter"/>
+            <p:ph type="sldNum" sz="quarter" idx="5"/>
           </p:nvPr>
         </p:nvSpPr>
         <p:spPr/>
@@ -16741,6 +16741,381 @@
           <a:lstStyle/>
           <a:p>
             <a:r>
+              <a:rPr lang="en-US" sz="2400" i="1" dirty="0">
+                <a:solidFill>
+                  <a:srgbClr val="000000"/>
+                </a:solidFill>
+              </a:rPr>
+              <a:t>Active </a:t>
+            </a:r>
+            <a:r>
+              <a:rPr lang="en-US" sz="2400" dirty="0">
+                <a:solidFill>
+                  <a:srgbClr val="000000"/>
+                </a:solidFill>
+              </a:rPr>
+              <a:t>a</a:t>
+            </a:r>
+            <a:r>
+              <a:rPr sz="2400" b="0" dirty="0">
+                <a:solidFill>
+                  <a:srgbClr val="000000"/>
+                </a:solidFill>
+              </a:rPr>
+              <a:t>lignment can </a:t>
+            </a:r>
+            <a:r>
+              <a:rPr lang="en-US" sz="2400" b="0" dirty="0">
+                <a:solidFill>
+                  <a:srgbClr val="000000"/>
+                </a:solidFill>
+              </a:rPr>
+              <a:t>be used to </a:t>
+            </a:r>
+            <a:r>
+              <a:rPr sz="2400" b="0" dirty="0">
+                <a:solidFill>
+                  <a:srgbClr val="000000"/>
+                </a:solidFill>
+              </a:rPr>
+              <a:t>change the realization</a:t>
+            </a:r>
+          </a:p>
+        </p:txBody>
+      </p:sp>
+      <p:sp>
+        <p:nvSpPr>
+          <p:cNvPr id="4" name="Slide Number Placeholder 5"/>
+          <p:cNvSpPr>
+            <a:spLocks noGrp="1"/>
+          </p:cNvSpPr>
+          <p:nvPr>
+            <p:ph type="sldNum" sz="quarter" idx="4"/>
+          </p:nvPr>
+        </p:nvSpPr>
+        <p:spPr/>
+        <p:txBody>
+          <a:bodyPr/>
+          <a:lstStyle/>
+          <a:p>
+            <a:fld id="{B7EB45DA-9A0D-DC49-8E02-F30A5DDC21C3}" type="slidenum">
+              <a:rPr lang="en-US" smtClean="0"/>
+              <a:t>27</a:t>
+            </a:fld>
+            <a:endParaRPr lang="en-US"/>
+          </a:p>
+        </p:txBody>
+      </p:sp>
+      <p:pic>
+        <p:nvPicPr>
+          <p:cNvPr id="5" name="Fig-ActiveAlignment" descr="active-passive-alignment-deck.png"/>
+          <p:cNvPicPr>
+            <a:picLocks noChangeAspect="1"/>
+          </p:cNvPicPr>
+          <p:nvPr/>
+        </p:nvPicPr>
+        <p:blipFill>
+          <a:blip r:embed="rId3"/>
+          <a:stretch>
+            <a:fillRect/>
+          </a:stretch>
+        </p:blipFill>
+        <p:spPr>
+          <a:xfrm>
+            <a:off x="384048" y="914400"/>
+            <a:ext cx="3911600" cy="4526280"/>
+          </a:xfrm>
+          <a:prstGeom prst="rect">
+            <a:avLst/>
+          </a:prstGeom>
+        </p:spPr>
+      </p:pic>
+      <p:graphicFrame>
+        <p:nvGraphicFramePr>
+          <p:cNvPr id="6" name="ActivePassiveCompare"/>
+          <p:cNvGraphicFramePr>
+            <a:graphicFrameLocks noGrp="1"/>
+          </p:cNvGraphicFramePr>
+          <p:nvPr/>
+        </p:nvGraphicFramePr>
+        <p:xfrm>
+          <a:off x="4663440" y="1874519"/>
+          <a:ext cx="4023360" cy="2423160"/>
+        </p:xfrm>
+        <a:graphic>
+          <a:graphicData uri="http://schemas.openxmlformats.org/drawingml/2006/table">
+            <a:tbl>
+              <a:tblPr>
+                <a:tableStyleId>{2D5ABB26-0587-4C30-8999-92F81FD0307C}</a:tableStyleId>
+              </a:tblPr>
+              <a:tblGrid>
+                <a:gridCol w="2011680">
+                  <a:extLst>
+                    <a:ext uri="{9D8B030D-6E8A-4147-A177-3AD203B41FA5}">
+                      <a16:colId xmlns:a16="http://schemas.microsoft.com/office/drawing/2014/main" val="20000"/>
+                    </a:ext>
+                  </a:extLst>
+                </a:gridCol>
+                <a:gridCol w="2011680">
+                  <a:extLst>
+                    <a:ext uri="{9D8B030D-6E8A-4147-A177-3AD203B41FA5}">
+                      <a16:colId xmlns:a16="http://schemas.microsoft.com/office/drawing/2014/main" val="20001"/>
+                    </a:ext>
+                  </a:extLst>
+                </a:gridCol>
+              </a:tblGrid>
+              <a:tr h="502920">
+                <a:tc>
+                  <a:txBody>
+                    <a:bodyPr/>
+                    <a:lstStyle/>
+                    <a:p>
+                      <a:pPr algn="ctr"/>
+                      <a:r>
+                        <a:rPr sz="2000" b="1" i="0" dirty="0">
+                          <a:solidFill>
+                            <a:srgbClr val="FFFFFF"/>
+                          </a:solidFill>
+                        </a:rPr>
+                        <a:t>ACTIVE</a:t>
+                      </a:r>
+                    </a:p>
+                  </a:txBody>
+                  <a:tcPr marL="54864" marR="54864" marT="36576" marB="36576" anchor="ctr">
+                    <a:solidFill>
+                      <a:srgbClr val="8E6F3E"/>
+                    </a:solidFill>
+                  </a:tcPr>
+                </a:tc>
+                <a:tc>
+                  <a:txBody>
+                    <a:bodyPr/>
+                    <a:lstStyle/>
+                    <a:p>
+                      <a:pPr algn="ctr"/>
+                      <a:r>
+                        <a:rPr sz="2000" b="1" i="0">
+                          <a:solidFill>
+                            <a:srgbClr val="FFFFFF"/>
+                          </a:solidFill>
+                        </a:rPr>
+                        <a:t>PASSIVE</a:t>
+                      </a:r>
+                    </a:p>
+                  </a:txBody>
+                  <a:tcPr marL="54864" marR="54864" marT="36576" marB="36576" anchor="ctr">
+                    <a:solidFill>
+                      <a:srgbClr val="8E6F3E"/>
+                    </a:solidFill>
+                  </a:tcPr>
+                </a:tc>
+                <a:extLst>
+                  <a:ext uri="{0D108BD9-81ED-4DB2-BD59-A6C34878D82A}">
+                    <a16:rowId xmlns:a16="http://schemas.microsoft.com/office/drawing/2014/main" val="10000"/>
+                  </a:ext>
+                </a:extLst>
+              </a:tr>
+              <a:tr h="960120">
+                <a:tc>
+                  <a:txBody>
+                    <a:bodyPr/>
+                    <a:lstStyle/>
+                    <a:p>
+                      <a:pPr algn="ctr"/>
+                      <a:r>
+                        <a:rPr sz="2000" b="0" i="1">
+                          <a:solidFill>
+                            <a:srgbClr val="5C4826"/>
+                          </a:solidFill>
+                        </a:rPr>
+                        <a:t>establish correspondence</a:t>
+                      </a:r>
+                    </a:p>
+                  </a:txBody>
+                  <a:tcPr marL="54864" marR="54864" marT="36576" marB="36576" anchor="ctr">
+                    <a:solidFill>
+                      <a:srgbClr val="F5F1E8"/>
+                    </a:solidFill>
+                  </a:tcPr>
+                </a:tc>
+                <a:tc>
+                  <a:txBody>
+                    <a:bodyPr/>
+                    <a:lstStyle/>
+                    <a:p>
+                      <a:pPr algn="ctr"/>
+                      <a:r>
+                        <a:rPr sz="2000" b="0" i="1">
+                          <a:solidFill>
+                            <a:srgbClr val="5C4826"/>
+                          </a:solidFill>
+                        </a:rPr>
+                        <a:t>preserve correspondence</a:t>
+                      </a:r>
+                    </a:p>
+                  </a:txBody>
+                  <a:tcPr marL="54864" marR="54864" marT="36576" marB="36576" anchor="ctr">
+                    <a:solidFill>
+                      <a:srgbClr val="F5F1E8"/>
+                    </a:solidFill>
+                  </a:tcPr>
+                </a:tc>
+                <a:extLst>
+                  <a:ext uri="{0D108BD9-81ED-4DB2-BD59-A6C34878D82A}">
+                    <a16:rowId xmlns:a16="http://schemas.microsoft.com/office/drawing/2014/main" val="10001"/>
+                  </a:ext>
+                </a:extLst>
+              </a:tr>
+              <a:tr h="960120">
+                <a:tc>
+                  <a:txBody>
+                    <a:bodyPr/>
+                    <a:lstStyle/>
+                    <a:p>
+                      <a:pPr algn="ctr"/>
+                      <a:r>
+                        <a:rPr sz="2000" b="0" i="0">
+                          <a:solidFill>
+                            <a:srgbClr val="5C4826"/>
+                          </a:solidFill>
+                        </a:rPr>
+                        <a:t>S → S′ until M agrees</a:t>
+                      </a:r>
+                    </a:p>
+                  </a:txBody>
+                  <a:tcPr marL="54864" marR="54864" marT="36576" marB="36576" anchor="ctr">
+                    <a:solidFill>
+                      <a:srgbClr val="F5F1E8"/>
+                    </a:solidFill>
+                  </a:tcPr>
+                </a:tc>
+                <a:tc>
+                  <a:txBody>
+                    <a:bodyPr/>
+                    <a:lstStyle/>
+                    <a:p>
+                      <a:pPr algn="ctr"/>
+                      <a:r>
+                        <a:rPr sz="2000" b="0" i="0">
+                          <a:solidFill>
+                            <a:srgbClr val="5C4826"/>
+                          </a:solidFill>
+                        </a:rPr>
+                        <a:t>ΔS → check → admit/reject</a:t>
+                      </a:r>
+                    </a:p>
+                  </a:txBody>
+                  <a:tcPr marL="54864" marR="54864" marT="36576" marB="36576" anchor="ctr">
+                    <a:solidFill>
+                      <a:srgbClr val="F5F1E8"/>
+                    </a:solidFill>
+                  </a:tcPr>
+                </a:tc>
+                <a:extLst>
+                  <a:ext uri="{0D108BD9-81ED-4DB2-BD59-A6C34878D82A}">
+                    <a16:rowId xmlns:a16="http://schemas.microsoft.com/office/drawing/2014/main" val="10002"/>
+                  </a:ext>
+                </a:extLst>
+              </a:tr>
+            </a:tbl>
+          </a:graphicData>
+        </a:graphic>
+      </p:graphicFrame>
+      <p:sp>
+        <p:nvSpPr>
+          <p:cNvPr id="7" name="FooterBand"/>
+          <p:cNvSpPr/>
+          <p:nvPr/>
+        </p:nvSpPr>
+        <p:spPr>
+          <a:xfrm>
+            <a:off x="274320" y="5577840"/>
+            <a:ext cx="8595360" cy="777240"/>
+          </a:xfrm>
+          <a:prstGeom prst="rect">
+            <a:avLst/>
+          </a:prstGeom>
+          <a:solidFill>
+            <a:srgbClr val="8E6F3E"/>
+          </a:solidFill>
+          <a:ln>
+            <a:noFill/>
+          </a:ln>
+          <a:effectLst/>
+        </p:spPr>
+        <p:style>
+          <a:lnRef idx="1">
+            <a:schemeClr val="accent1"/>
+          </a:lnRef>
+          <a:fillRef idx="3">
+            <a:schemeClr val="accent1"/>
+          </a:fillRef>
+          <a:effectRef idx="2">
+            <a:schemeClr val="accent1"/>
+          </a:effectRef>
+          <a:fontRef idx="minor">
+            <a:schemeClr val="lt1"/>
+          </a:fontRef>
+        </p:style>
+        <p:txBody>
+          <a:bodyPr wrap="square" lIns="27432" tIns="22860" rIns="27432" bIns="22860" rtlCol="0" anchor="ctr"/>
+          <a:lstStyle/>
+          <a:p>
+            <a:pPr algn="ctr"/>
+            <a:r>
+              <a:rPr sz="2000" b="1">
+                <a:solidFill>
+                  <a:srgbClr val="FFFFFF"/>
+                </a:solidFill>
+              </a:rPr>
+              <a:t>A model can govern an existing system by first becoming a target for change, then a constraint on later change.</a:t>
+            </a:r>
+          </a:p>
+        </p:txBody>
+      </p:sp>
+    </p:spTree>
+  </p:cSld>
+  <p:clrMapOvr>
+    <a:masterClrMapping/>
+  </p:clrMapOvr>
+</p:sld>
+</file>
+
+<file path=ppt/slides/slide28.xml><?xml version="1.0" encoding="utf-8"?>
+<p:sld xmlns:a="http://schemas.openxmlformats.org/drawingml/2006/main" xmlns:r="http://schemas.openxmlformats.org/officeDocument/2006/relationships" xmlns:p="http://schemas.openxmlformats.org/presentationml/2006/main">
+  <p:cSld>
+    <p:spTree>
+      <p:nvGrpSpPr>
+        <p:cNvPr id="1" name=""/>
+        <p:cNvGrpSpPr/>
+        <p:nvPr/>
+      </p:nvGrpSpPr>
+      <p:grpSpPr>
+        <a:xfrm>
+          <a:off x="0" y="0"/>
+          <a:ext cx="0" cy="0"/>
+          <a:chOff x="0" y="0"/>
+          <a:chExt cx="0" cy="0"/>
+        </a:xfrm>
+      </p:grpSpPr>
+      <p:sp>
+        <p:nvSpPr>
+          <p:cNvPr id="3" name="Title 2"/>
+          <p:cNvSpPr>
+            <a:spLocks noGrp="1"/>
+          </p:cNvSpPr>
+          <p:nvPr>
+            <p:ph type="title"/>
+          </p:nvPr>
+        </p:nvSpPr>
+        <p:spPr/>
+        <p:txBody>
+          <a:bodyPr wrap="square">
+            <a:normAutofit fontScale="90000"/>
+          </a:bodyPr>
+          <a:lstStyle/>
+          <a:p>
+            <a:r>
               <a:rPr lang="en-US" sz="2400" dirty="0">
                 <a:solidFill>
                   <a:srgbClr val="000000"/>
@@ -17420,7 +17795,7 @@
 </p:sld>
 </file>
 
-<file path=ppt/slides/slide28.xml><?xml version="1.0" encoding="utf-8"?>
+<file path=ppt/slides/slide29.xml><?xml version="1.0" encoding="utf-8"?>
 <p:sld xmlns:a="http://schemas.openxmlformats.org/drawingml/2006/main" xmlns:r="http://schemas.openxmlformats.org/officeDocument/2006/relationships" xmlns:p="http://schemas.openxmlformats.org/presentationml/2006/main">
   <p:cSld>
     <p:spTree>
@@ -17789,522 +18164,6 @@
 </p:sld>
 </file>
 
-<file path=ppt/slides/slide29.xml><?xml version="1.0" encoding="utf-8"?>
-<p:sld xmlns:a="http://schemas.openxmlformats.org/drawingml/2006/main" xmlns:r="http://schemas.openxmlformats.org/officeDocument/2006/relationships" xmlns:p="http://schemas.openxmlformats.org/presentationml/2006/main">
-  <p:cSld>
-    <p:spTree>
-      <p:nvGrpSpPr>
-        <p:cNvPr id="1" name=""/>
-        <p:cNvGrpSpPr/>
-        <p:nvPr/>
-      </p:nvGrpSpPr>
-      <p:grpSpPr>
-        <a:xfrm>
-          <a:off x="0" y="0"/>
-          <a:ext cx="0" cy="0"/>
-          <a:chOff x="0" y="0"/>
-          <a:chExt cx="0" cy="0"/>
-        </a:xfrm>
-      </p:grpSpPr>
-      <p:sp>
-        <p:nvSpPr>
-          <p:cNvPr id="3" name="Title 2"/>
-          <p:cNvSpPr>
-            <a:spLocks noGrp="1"/>
-          </p:cNvSpPr>
-          <p:nvPr>
-            <p:ph type="title"/>
-          </p:nvPr>
-        </p:nvSpPr>
-        <p:spPr>
-          <a:xfrm>
-            <a:off x="274320" y="18288"/>
-            <a:ext cx="8046720" cy="731520"/>
-          </a:xfrm>
-        </p:spPr>
-        <p:txBody>
-          <a:bodyPr wrap="square">
-            <a:normAutofit fontScale="90000"/>
-          </a:bodyPr>
-          <a:lstStyle/>
-          <a:p>
-            <a:r>
-              <a:rPr sz="2400" b="0" dirty="0">
-                <a:solidFill>
-                  <a:srgbClr val="000000"/>
-                </a:solidFill>
-              </a:rPr>
-              <a:t>Back to the lab:</a:t>
-            </a:r>
-          </a:p>
-          <a:p>
-            <a:r>
-              <a:rPr lang="en-US" sz="2400" dirty="0">
-                <a:solidFill>
-                  <a:srgbClr val="000000"/>
-                </a:solidFill>
-              </a:rPr>
-              <a:t>D</a:t>
-            </a:r>
-            <a:r>
-              <a:rPr sz="2400" b="0" dirty="0">
-                <a:solidFill>
-                  <a:srgbClr val="000000"/>
-                </a:solidFill>
-              </a:rPr>
-              <a:t>esign the Alignment</a:t>
-            </a:r>
-          </a:p>
-        </p:txBody>
-      </p:sp>
-      <p:sp>
-        <p:nvSpPr>
-          <p:cNvPr id="4" name="Slide Number Placeholder 5"/>
-          <p:cNvSpPr>
-            <a:spLocks noGrp="1"/>
-          </p:cNvSpPr>
-          <p:nvPr>
-            <p:ph type="sldNum" sz="quarter" idx="4"/>
-          </p:nvPr>
-        </p:nvSpPr>
-        <p:spPr/>
-        <p:txBody>
-          <a:bodyPr/>
-          <a:lstStyle/>
-          <a:p>
-            <a:fld id="{B7EB45DA-9A0D-DC49-8E02-F30A5DDC21C3}" type="slidenum">
-              <a:rPr lang="en-US" smtClean="0"/>
-              <a:t>30</a:t>
-            </a:fld>
-            <a:endParaRPr lang="en-US"/>
-          </a:p>
-        </p:txBody>
-      </p:sp>
-      <p:sp>
-        <p:nvSpPr>
-          <p:cNvPr id="5" name="KickerBadge">
-            <a:extLst>
-              <a:ext uri="{FF2B5EF4-FFF2-40B4-BE49-F238E27FC236}">
-                <a16:creationId xmlns:a16="http://schemas.microsoft.com/office/drawing/2014/main" id="{55489336-5766-22EA-2ADC-D9F38F769456}"/>
-              </a:ext>
-            </a:extLst>
-          </p:cNvPr>
-          <p:cNvSpPr/>
-          <p:nvPr/>
-        </p:nvSpPr>
-        <p:spPr>
-          <a:xfrm>
-            <a:off x="4480560" y="205000"/>
-            <a:ext cx="4389120" cy="470000"/>
-          </a:xfrm>
-          <a:prstGeom prst="roundRect">
-            <a:avLst/>
-          </a:prstGeom>
-          <a:solidFill>
-            <a:srgbClr val="FBF8F2"/>
-          </a:solidFill>
-          <a:ln w="15875">
-            <a:solidFill>
-              <a:srgbClr val="8E6F3E"/>
-            </a:solidFill>
-          </a:ln>
-        </p:spPr>
-        <p:txBody>
-          <a:bodyPr wrap="square" lIns="91440" tIns="27432" rIns="91440" bIns="27432" anchor="ctr"/>
-          <a:lstStyle/>
-          <a:p>
-            <a:pPr algn="ctr">
-              <a:buNone/>
-            </a:pPr>
-            <a:r>
-              <a:rPr lang="en-US" sz="2000" b="1" i="0" dirty="0">
-                <a:solidFill>
-                  <a:srgbClr val="8E6F3E"/>
-                </a:solidFill>
-              </a:rPr>
-              <a:t>TEAM ACTIVITY  ·  10–12 MINUTES</a:t>
-            </a:r>
-          </a:p>
-        </p:txBody>
-      </p:sp>
-      <p:sp>
-        <p:nvSpPr>
-          <p:cNvPr id="12" name="FooterBand"/>
-          <p:cNvSpPr/>
-          <p:nvPr/>
-        </p:nvSpPr>
-        <p:spPr>
-          <a:xfrm>
-            <a:off x="274320" y="5852160"/>
-            <a:ext cx="8595360" cy="566928"/>
-          </a:xfrm>
-          <a:prstGeom prst="rect">
-            <a:avLst/>
-          </a:prstGeom>
-          <a:solidFill>
-            <a:srgbClr val="8E6F3E"/>
-          </a:solidFill>
-          <a:ln>
-            <a:noFill/>
-          </a:ln>
-          <a:effectLst/>
-        </p:spPr>
-        <p:style>
-          <a:lnRef idx="1">
-            <a:schemeClr val="accent1"/>
-          </a:lnRef>
-          <a:fillRef idx="3">
-            <a:schemeClr val="accent1"/>
-          </a:fillRef>
-          <a:effectRef idx="2">
-            <a:schemeClr val="accent1"/>
-          </a:effectRef>
-          <a:fontRef idx="minor">
-            <a:schemeClr val="lt1"/>
-          </a:fontRef>
-        </p:style>
-        <p:txBody>
-          <a:bodyPr wrap="square" rtlCol="0" anchor="ctr"/>
-          <a:lstStyle/>
-          <a:p>
-            <a:pPr algn="ctr"/>
-            <a:r>
-              <a:rPr sz="2000" b="1" i="0">
-                <a:solidFill>
-                  <a:srgbClr val="FFFFFF"/>
-                </a:solidFill>
-              </a:rPr>
-              <a:t>OBLIGATION  →  MODEL  →  CHECK  →  DECIDE  →  CONTROL</a:t>
-            </a:r>
-          </a:p>
-        </p:txBody>
-      </p:sp>
-      <p:sp>
-        <p:nvSpPr>
-          <p:cNvPr id="13" name="Card-memory"/>
-          <p:cNvSpPr/>
-          <p:nvPr/>
-        </p:nvSpPr>
-        <p:spPr>
-          <a:xfrm>
-            <a:off x="274320" y="1051560"/>
-            <a:ext cx="4069080" cy="2103120"/>
-          </a:xfrm>
-          <a:prstGeom prst="rect">
-            <a:avLst/>
-          </a:prstGeom>
-          <a:solidFill>
-            <a:srgbClr val="F5F1E8"/>
-          </a:solidFill>
-          <a:ln w="12700">
-            <a:solidFill>
-              <a:srgbClr val="C9B991"/>
-            </a:solidFill>
-          </a:ln>
-          <a:effectLst/>
-        </p:spPr>
-        <p:txBody>
-          <a:bodyPr wrap="square" lIns="27432" tIns="22860" rIns="27432" bIns="22860" rtlCol="0" anchor="t"/>
-          <a:lstStyle/>
-          <a:p>
-            <a:pPr algn="ctr">
-              <a:buNone/>
-            </a:pPr>
-            <a:r>
-              <a:rPr lang="en-US" sz="2000" b="1" i="0" dirty="0">
-                <a:solidFill>
-                  <a:srgbClr val="5C4826"/>
-                </a:solidFill>
-              </a:rPr>
-              <a:t>DEVICE FIRMWARE</a:t>
-            </a:r>
-          </a:p>
-          <a:p>
-            <a:pPr algn="ctr">
-              <a:spcBef>
-                <a:spcPts val="900"/>
-              </a:spcBef>
-              <a:buNone/>
-            </a:pPr>
-            <a:r>
-              <a:rPr lang="en-US" sz="2000" b="0" i="1" dirty="0">
-                <a:solidFill>
-                  <a:srgbClr val="555960"/>
-                </a:solidFill>
-              </a:rPr>
-              <a:t>working memory view</a:t>
-            </a:r>
-          </a:p>
-          <a:p>
-            <a:pPr algn="l">
-              <a:spcBef>
-                <a:spcPts val="900"/>
-              </a:spcBef>
-              <a:buNone/>
-            </a:pPr>
-            <a:r>
-              <a:rPr lang="en-US" sz="2000" b="0" i="0" dirty="0">
-                <a:solidFill>
-                  <a:srgbClr val="5C4826"/>
-                </a:solidFill>
-              </a:rPr>
-              <a:t>Sense · Analyze · Transmit</a:t>
-            </a:r>
-          </a:p>
-          <a:p>
-            <a:pPr algn="l">
-              <a:spcBef>
-                <a:spcPts val="900"/>
-              </a:spcBef>
-              <a:buNone/>
-            </a:pPr>
-            <a:r>
-              <a:rPr lang="en-US" sz="2000" b="0" i="0" dirty="0">
-                <a:solidFill>
-                  <a:srgbClr val="5C4826"/>
-                </a:solidFill>
-              </a:rPr>
-              <a:t>max working memory 24 / 32 / 24 KB</a:t>
-            </a:r>
-          </a:p>
-          <a:p>
-            <a:pPr algn="l">
-              <a:spcBef>
-                <a:spcPts val="900"/>
-              </a:spcBef>
-              <a:buNone/>
-            </a:pPr>
-            <a:r>
-              <a:rPr lang="en-US" sz="2000" b="0" i="0" dirty="0">
-                <a:solidFill>
-                  <a:srgbClr val="5C4826"/>
-                </a:solidFill>
-              </a:rPr>
-              <a:t>device ceiling 48 KB</a:t>
-            </a:r>
-          </a:p>
-        </p:txBody>
-      </p:sp>
-      <p:sp>
-        <p:nvSpPr>
-          <p:cNvPr id="14" name="Card-control"/>
-          <p:cNvSpPr/>
-          <p:nvPr/>
-        </p:nvSpPr>
-        <p:spPr>
-          <a:xfrm>
-            <a:off x="274320" y="3291840"/>
-            <a:ext cx="4069080" cy="2103120"/>
-          </a:xfrm>
-          <a:prstGeom prst="rect">
-            <a:avLst/>
-          </a:prstGeom>
-          <a:solidFill>
-            <a:srgbClr val="F5F1E8"/>
-          </a:solidFill>
-          <a:ln w="12700">
-            <a:solidFill>
-              <a:srgbClr val="C9B991"/>
-            </a:solidFill>
-          </a:ln>
-          <a:effectLst/>
-        </p:spPr>
-        <p:txBody>
-          <a:bodyPr wrap="square" lIns="27432" tIns="22860" rIns="27432" bIns="22860" rtlCol="0" anchor="t"/>
-          <a:lstStyle/>
-          <a:p>
-            <a:pPr algn="ctr">
-              <a:buNone/>
-            </a:pPr>
-            <a:r>
-              <a:rPr lang="en-US" sz="2000" b="1" i="0" dirty="0">
-                <a:solidFill>
-                  <a:srgbClr val="5C4826"/>
-                </a:solidFill>
-              </a:rPr>
-              <a:t>THREAD ADMISSION CONTROL</a:t>
-            </a:r>
-          </a:p>
-          <a:p>
-            <a:pPr algn="ctr">
-              <a:spcBef>
-                <a:spcPts val="900"/>
-              </a:spcBef>
-              <a:buNone/>
-            </a:pPr>
-            <a:r>
-              <a:rPr lang="en-US" sz="2000" b="0" i="1" dirty="0">
-                <a:solidFill>
-                  <a:srgbClr val="555960"/>
-                </a:solidFill>
-              </a:rPr>
-              <a:t>lifecycle view</a:t>
-            </a:r>
-          </a:p>
-          <a:p>
-            <a:pPr algn="l">
-              <a:spcBef>
-                <a:spcPts val="900"/>
-              </a:spcBef>
-              <a:buNone/>
-            </a:pPr>
-            <a:r>
-              <a:rPr lang="en-US" sz="2000" b="0" i="0" dirty="0">
-                <a:solidFill>
-                  <a:srgbClr val="5C4826"/>
-                </a:solidFill>
-              </a:rPr>
-              <a:t>each thread: Asleep ⇄ Awake</a:t>
-            </a:r>
-          </a:p>
-          <a:p>
-            <a:pPr algn="l">
-              <a:spcBef>
-                <a:spcPts val="900"/>
-              </a:spcBef>
-              <a:buNone/>
-            </a:pPr>
-            <a:r>
-              <a:rPr lang="en-US" sz="2000" b="0" i="0" dirty="0">
-                <a:solidFill>
-                  <a:srgbClr val="5C4826"/>
-                </a:solidFill>
-              </a:rPr>
-              <a:t>the Scheduler admits at most two threads awake</a:t>
-            </a:r>
-          </a:p>
-        </p:txBody>
-      </p:sp>
-      <p:sp>
-        <p:nvSpPr>
-          <p:cNvPr id="15" name="Card-prompt"/>
-          <p:cNvSpPr/>
-          <p:nvPr/>
-        </p:nvSpPr>
-        <p:spPr>
-          <a:xfrm>
-            <a:off x="4526280" y="1051560"/>
-            <a:ext cx="4343400" cy="4343400"/>
-          </a:xfrm>
-          <a:prstGeom prst="rect">
-            <a:avLst/>
-          </a:prstGeom>
-          <a:solidFill>
-            <a:srgbClr val="F5F1E8"/>
-          </a:solidFill>
-          <a:ln w="12700">
-            <a:solidFill>
-              <a:srgbClr val="C9B991"/>
-            </a:solidFill>
-          </a:ln>
-          <a:effectLst/>
-        </p:spPr>
-        <p:txBody>
-          <a:bodyPr wrap="square" lIns="27432" tIns="22860" rIns="27432" bIns="22860" rtlCol="0" anchor="t"/>
-          <a:lstStyle/>
-          <a:p>
-            <a:pPr algn="l">
-              <a:buNone/>
-            </a:pPr>
-            <a:r>
-              <a:rPr lang="en-US" sz="2000" b="1" i="0" dirty="0">
-                <a:solidFill>
-                  <a:srgbClr val="5C4826"/>
-                </a:solidFill>
-              </a:rPr>
-              <a:t>Choose one obligation from the lab.</a:t>
-            </a:r>
-          </a:p>
-          <a:p>
-            <a:pPr algn="l">
-              <a:spcBef>
-                <a:spcPts val="900"/>
-              </a:spcBef>
-              <a:buNone/>
-            </a:pPr>
-            <a:r>
-              <a:rPr lang="en-US" sz="2000" b="0" i="0" dirty="0">
-                <a:solidFill>
-                  <a:srgbClr val="5C4826"/>
-                </a:solidFill>
-              </a:rPr>
-              <a:t>1  ·  How could the realization violate it?</a:t>
-            </a:r>
-          </a:p>
-          <a:p>
-            <a:pPr algn="l">
-              <a:spcBef>
-                <a:spcPts val="900"/>
-              </a:spcBef>
-              <a:buNone/>
-            </a:pPr>
-            <a:r>
-              <a:rPr lang="en-US" sz="2000" b="0" i="0" dirty="0">
-                <a:solidFill>
-                  <a:srgbClr val="5C4826"/>
-                </a:solidFill>
-              </a:rPr>
-              <a:t>2  ·  Can you prevent that failure, or must you detect it?</a:t>
-            </a:r>
-          </a:p>
-          <a:p>
-            <a:pPr algn="l">
-              <a:spcBef>
-                <a:spcPts val="900"/>
-              </a:spcBef>
-              <a:buNone/>
-            </a:pPr>
-            <a:r>
-              <a:rPr lang="en-US" sz="2000" b="0" i="0" dirty="0">
-                <a:solidFill>
-                  <a:srgbClr val="5C4826"/>
-                </a:solidFill>
-              </a:rPr>
-              <a:t>3  ·  What would you check, and what evidence would let you decide?</a:t>
-            </a:r>
-          </a:p>
-          <a:p>
-            <a:pPr algn="l">
-              <a:spcBef>
-                <a:spcPts val="900"/>
-              </a:spcBef>
-              <a:buNone/>
-            </a:pPr>
-            <a:r>
-              <a:rPr lang="en-US" sz="2000" b="0" i="0" dirty="0">
-                <a:solidFill>
-                  <a:srgbClr val="5C4826"/>
-                </a:solidFill>
-              </a:rPr>
-              <a:t>4  ·  Where is the earliest boundary at which it is decidable?</a:t>
-            </a:r>
-          </a:p>
-          <a:p>
-            <a:pPr algn="l">
-              <a:spcBef>
-                <a:spcPts val="900"/>
-              </a:spcBef>
-              <a:buNone/>
-            </a:pPr>
-            <a:r>
-              <a:rPr lang="en-US" sz="2000" b="0" i="0" dirty="0">
-                <a:solidFill>
-                  <a:srgbClr val="5C4826"/>
-                </a:solidFill>
-              </a:rPr>
-              <a:t>5  ·  What should happen if the check fails?</a:t>
-            </a:r>
-          </a:p>
-        </p:txBody>
-      </p:sp>
-    </p:spTree>
-  </p:cSld>
-  <p:clrMapOvr>
-    <a:masterClrMapping/>
-  </p:clrMapOvr>
-</p:sld>
-</file>
-
 <file path=ppt/slides/slide3.xml><?xml version="1.0" encoding="utf-8"?>
 <p:sld xmlns:a="http://schemas.openxmlformats.org/drawingml/2006/main" xmlns:r="http://schemas.openxmlformats.org/officeDocument/2006/relationships" xmlns:p="http://schemas.openxmlformats.org/presentationml/2006/main">
   <p:cSld>
@@ -18556,7 +18415,12 @@
             <p:ph type="title"/>
           </p:nvPr>
         </p:nvSpPr>
-        <p:spPr/>
+        <p:spPr>
+          <a:xfrm>
+            <a:off x="274320" y="18288"/>
+            <a:ext cx="8046720" cy="731520"/>
+          </a:xfrm>
+        </p:spPr>
         <p:txBody>
           <a:bodyPr wrap="square">
             <a:normAutofit fontScale="90000"/>
@@ -18564,12 +18428,22 @@
           <a:lstStyle/>
           <a:p>
             <a:r>
-              <a:rPr lang="en-US" sz="2400" b="0" dirty="0">
+              <a:rPr sz="2400" b="0" dirty="0">
                 <a:solidFill>
                   <a:srgbClr val="000000"/>
                 </a:solidFill>
               </a:rPr>
-              <a:t>Report-out: </a:t>
+              <a:t>Back to the lab:</a:t>
+            </a:r>
+          </a:p>
+          <a:p>
+            <a:r>
+              <a:rPr lang="en-US" sz="2400" dirty="0">
+                <a:solidFill>
+                  <a:srgbClr val="000000"/>
+                </a:solidFill>
+              </a:rPr>
+              <a:t>D</a:t>
             </a:r>
             <a:r>
               <a:rPr sz="2400" b="0" dirty="0">
@@ -18577,29 +18451,8 @@
                   <a:srgbClr val="000000"/>
                 </a:solidFill>
               </a:rPr>
-              <a:t>Compare your </a:t>
-            </a:r>
-            <a:r>
-              <a:rPr lang="en-US" sz="2400" dirty="0">
-                <a:solidFill>
-                  <a:srgbClr val="000000"/>
-                </a:solidFill>
-              </a:rPr>
-              <a:t>A</a:t>
-            </a:r>
-            <a:r>
-              <a:rPr lang="en-US" sz="2400" b="0" dirty="0">
-                <a:solidFill>
-                  <a:srgbClr val="000000"/>
-                </a:solidFill>
-              </a:rPr>
-              <a:t>lignment approaches</a:t>
-            </a:r>
-            <a:endParaRPr sz="2400" b="0" dirty="0">
-              <a:solidFill>
-                <a:srgbClr val="000000"/>
-              </a:solidFill>
-            </a:endParaRPr>
+              <a:t>esign the Alignment</a:t>
+            </a:r>
           </a:p>
         </p:txBody>
       </p:sp>
@@ -18620,7 +18473,7 @@
           <a:p>
             <a:fld id="{B7EB45DA-9A0D-DC49-8E02-F30A5DDC21C3}" type="slidenum">
               <a:rPr lang="en-US" smtClean="0"/>
-              <a:t>31</a:t>
+              <a:t>30</a:t>
             </a:fld>
             <a:endParaRPr lang="en-US"/>
           </a:p>
@@ -18628,14 +18481,113 @@
       </p:sp>
       <p:sp>
         <p:nvSpPr>
-          <p:cNvPr id="10" name="Compare1"/>
+          <p:cNvPr id="5" name="KickerBadge">
+            <a:extLst>
+              <a:ext uri="{FF2B5EF4-FFF2-40B4-BE49-F238E27FC236}">
+                <a16:creationId xmlns:a16="http://schemas.microsoft.com/office/drawing/2014/main" id="{55489336-5766-22EA-2ADC-D9F38F769456}"/>
+              </a:ext>
+            </a:extLst>
+          </p:cNvPr>
           <p:cNvSpPr/>
           <p:nvPr/>
         </p:nvSpPr>
         <p:spPr>
           <a:xfrm>
-            <a:off x="502920" y="1051560"/>
-            <a:ext cx="8138160" cy="749808"/>
+            <a:off x="4480560" y="205000"/>
+            <a:ext cx="4389120" cy="470000"/>
+          </a:xfrm>
+          <a:prstGeom prst="roundRect">
+            <a:avLst/>
+          </a:prstGeom>
+          <a:solidFill>
+            <a:srgbClr val="FBF8F2"/>
+          </a:solidFill>
+          <a:ln w="15875">
+            <a:solidFill>
+              <a:srgbClr val="8E6F3E"/>
+            </a:solidFill>
+          </a:ln>
+        </p:spPr>
+        <p:txBody>
+          <a:bodyPr wrap="square" lIns="91440" tIns="27432" rIns="91440" bIns="27432" anchor="ctr"/>
+          <a:lstStyle/>
+          <a:p>
+            <a:pPr algn="ctr">
+              <a:buNone/>
+            </a:pPr>
+            <a:r>
+              <a:rPr lang="en-US" sz="2000" b="1" i="0" dirty="0">
+                <a:solidFill>
+                  <a:srgbClr val="8E6F3E"/>
+                </a:solidFill>
+              </a:rPr>
+              <a:t>TEAM ACTIVITY  ·  10–12 MINUTES</a:t>
+            </a:r>
+          </a:p>
+        </p:txBody>
+      </p:sp>
+      <p:sp>
+        <p:nvSpPr>
+          <p:cNvPr id="12" name="FooterBand"/>
+          <p:cNvSpPr/>
+          <p:nvPr/>
+        </p:nvSpPr>
+        <p:spPr>
+          <a:xfrm>
+            <a:off x="274320" y="5852160"/>
+            <a:ext cx="8595360" cy="566928"/>
+          </a:xfrm>
+          <a:prstGeom prst="rect">
+            <a:avLst/>
+          </a:prstGeom>
+          <a:solidFill>
+            <a:srgbClr val="8E6F3E"/>
+          </a:solidFill>
+          <a:ln>
+            <a:noFill/>
+          </a:ln>
+          <a:effectLst/>
+        </p:spPr>
+        <p:style>
+          <a:lnRef idx="1">
+            <a:schemeClr val="accent1"/>
+          </a:lnRef>
+          <a:fillRef idx="3">
+            <a:schemeClr val="accent1"/>
+          </a:fillRef>
+          <a:effectRef idx="2">
+            <a:schemeClr val="accent1"/>
+          </a:effectRef>
+          <a:fontRef idx="minor">
+            <a:schemeClr val="lt1"/>
+          </a:fontRef>
+        </p:style>
+        <p:txBody>
+          <a:bodyPr wrap="square" rtlCol="0" anchor="ctr"/>
+          <a:lstStyle/>
+          <a:p>
+            <a:pPr algn="ctr"/>
+            <a:r>
+              <a:rPr sz="2000" b="1" i="0">
+                <a:solidFill>
+                  <a:srgbClr val="FFFFFF"/>
+                </a:solidFill>
+              </a:rPr>
+              <a:t>OBLIGATION  →  MODEL  →  CHECK  →  DECIDE  →  CONTROL</a:t>
+            </a:r>
+          </a:p>
+        </p:txBody>
+      </p:sp>
+      <p:sp>
+        <p:nvSpPr>
+          <p:cNvPr id="13" name="Card-memory"/>
+          <p:cNvSpPr/>
+          <p:nvPr/>
+        </p:nvSpPr>
+        <p:spPr>
+          <a:xfrm>
+            <a:off x="274320" y="1051560"/>
+            <a:ext cx="4069080" cy="2103120"/>
           </a:xfrm>
           <a:prstGeom prst="rect">
             <a:avLst/>
@@ -18650,57 +18602,98 @@
           </a:ln>
           <a:effectLst/>
         </p:spPr>
-        <p:style>
-          <a:lnRef idx="1">
-            <a:schemeClr val="accent1"/>
-          </a:lnRef>
-          <a:fillRef idx="3">
-            <a:schemeClr val="accent1"/>
-          </a:fillRef>
-          <a:effectRef idx="2">
-            <a:schemeClr val="accent1"/>
-          </a:effectRef>
-          <a:fontRef idx="minor">
-            <a:schemeClr val="lt1"/>
-          </a:fontRef>
-        </p:style>
-        <p:txBody>
-          <a:bodyPr wrap="square" lIns="27432" tIns="22860" rIns="27432" bIns="22860" rtlCol="0" anchor="ctr"/>
-          <a:lstStyle/>
-          <a:p>
-            <a:pPr algn="l"/>
-            <a:r>
-              <a:rPr sz="2000" b="1" i="0">
+        <p:txBody>
+          <a:bodyPr wrap="square" lIns="27432" tIns="22860" rIns="27432" bIns="22860" rtlCol="0" anchor="t"/>
+          <a:lstStyle/>
+          <a:p>
+            <a:pPr algn="ctr">
+              <a:buNone/>
+            </a:pPr>
+            <a:r>
+              <a:rPr lang="en-US" sz="2000" b="1" i="0" dirty="0">
                 <a:solidFill>
                   <a:srgbClr val="5C4826"/>
                 </a:solidFill>
               </a:rPr>
-              <a:t>Same obligation, different boundary</a:t>
-            </a:r>
-          </a:p>
-          <a:p>
-            <a:pPr algn="l"/>
-            <a:r>
-              <a:rPr sz="2000" b="0" i="0">
+              <a:t>DEVICE FIRMWARE</a:t>
+            </a:r>
+          </a:p>
+          <a:p>
+            <a:pPr algn="ctr">
+              <a:spcBef>
+                <a:spcPts val="900"/>
+              </a:spcBef>
+              <a:buNone/>
+            </a:pPr>
+            <a:r>
+              <a:rPr lang="en-US" sz="2000" b="0" i="1" dirty="0">
+                <a:solidFill>
+                  <a:srgbClr val="555960"/>
+                </a:solidFill>
+              </a:rPr>
+              <a:t>working memory view</a:t>
+            </a:r>
+          </a:p>
+          <a:p>
+            <a:pPr algn="l">
+              <a:spcBef>
+                <a:spcPts val="900"/>
+              </a:spcBef>
+              <a:buNone/>
+            </a:pPr>
+            <a:r>
+              <a:rPr lang="en-US" sz="2000" b="0" i="0" dirty="0">
                 <a:solidFill>
                   <a:srgbClr val="5C4826"/>
                 </a:solidFill>
               </a:rPr>
-              <a:t>Which boundary actually has enough information?</a:t>
-            </a:r>
-          </a:p>
-        </p:txBody>
-      </p:sp>
-      <p:sp>
-        <p:nvSpPr>
-          <p:cNvPr id="11" name="Compare2"/>
+              <a:t>Sense · Analyze · Transmit</a:t>
+            </a:r>
+          </a:p>
+          <a:p>
+            <a:pPr algn="l">
+              <a:spcBef>
+                <a:spcPts val="900"/>
+              </a:spcBef>
+              <a:buNone/>
+            </a:pPr>
+            <a:r>
+              <a:rPr lang="en-US" sz="2000" b="0" i="0" dirty="0">
+                <a:solidFill>
+                  <a:srgbClr val="5C4826"/>
+                </a:solidFill>
+              </a:rPr>
+              <a:t>max working memory 24 / 32 / 24 KB</a:t>
+            </a:r>
+          </a:p>
+          <a:p>
+            <a:pPr algn="l">
+              <a:spcBef>
+                <a:spcPts val="900"/>
+              </a:spcBef>
+              <a:buNone/>
+            </a:pPr>
+            <a:r>
+              <a:rPr lang="en-US" sz="2000" b="0" i="0" dirty="0">
+                <a:solidFill>
+                  <a:srgbClr val="5C4826"/>
+                </a:solidFill>
+              </a:rPr>
+              <a:t>device ceiling 48 KB</a:t>
+            </a:r>
+          </a:p>
+        </p:txBody>
+      </p:sp>
+      <p:sp>
+        <p:nvSpPr>
+          <p:cNvPr id="14" name="Card-control"/>
           <p:cNvSpPr/>
           <p:nvPr/>
         </p:nvSpPr>
         <p:spPr>
           <a:xfrm>
-            <a:off x="502920" y="1965960"/>
-            <a:ext cx="8138160" cy="749808"/>
+            <a:off x="274320" y="3291840"/>
+            <a:ext cx="4069080" cy="2103120"/>
           </a:xfrm>
           <a:prstGeom prst="rect">
             <a:avLst/>
@@ -18715,57 +18708,82 @@
           </a:ln>
           <a:effectLst/>
         </p:spPr>
-        <p:style>
-          <a:lnRef idx="1">
-            <a:schemeClr val="accent1"/>
-          </a:lnRef>
-          <a:fillRef idx="3">
-            <a:schemeClr val="accent1"/>
-          </a:fillRef>
-          <a:effectRef idx="2">
-            <a:schemeClr val="accent1"/>
-          </a:effectRef>
-          <a:fontRef idx="minor">
-            <a:schemeClr val="lt1"/>
-          </a:fontRef>
-        </p:style>
-        <p:txBody>
-          <a:bodyPr wrap="square" lIns="27432" tIns="22860" rIns="27432" bIns="22860" rtlCol="0" anchor="ctr"/>
-          <a:lstStyle/>
-          <a:p>
-            <a:pPr algn="l"/>
-            <a:r>
-              <a:rPr sz="2000" b="1" i="0">
+        <p:txBody>
+          <a:bodyPr wrap="square" lIns="27432" tIns="22860" rIns="27432" bIns="22860" rtlCol="0" anchor="t"/>
+          <a:lstStyle/>
+          <a:p>
+            <a:pPr algn="ctr">
+              <a:buNone/>
+            </a:pPr>
+            <a:r>
+              <a:rPr lang="en-US" sz="2000" b="1" i="0" dirty="0">
                 <a:solidFill>
                   <a:srgbClr val="5C4826"/>
                 </a:solidFill>
               </a:rPr>
-              <a:t>Constraint vs. evidence</a:t>
-            </a:r>
-          </a:p>
-          <a:p>
-            <a:pPr algn="l"/>
-            <a:r>
-              <a:rPr sz="2000" b="0" i="0">
+              <a:t>THREAD ADMISSION CONTROL</a:t>
+            </a:r>
+          </a:p>
+          <a:p>
+            <a:pPr algn="ctr">
+              <a:spcBef>
+                <a:spcPts val="900"/>
+              </a:spcBef>
+              <a:buNone/>
+            </a:pPr>
+            <a:r>
+              <a:rPr lang="en-US" sz="2000" b="0" i="1" dirty="0">
+                <a:solidFill>
+                  <a:srgbClr val="555960"/>
+                </a:solidFill>
+              </a:rPr>
+              <a:t>lifecycle view</a:t>
+            </a:r>
+          </a:p>
+          <a:p>
+            <a:pPr algn="l">
+              <a:spcBef>
+                <a:spcPts val="900"/>
+              </a:spcBef>
+              <a:buNone/>
+            </a:pPr>
+            <a:r>
+              <a:rPr lang="en-US" sz="2000" b="0" i="0" dirty="0">
                 <a:solidFill>
                   <a:srgbClr val="5C4826"/>
                 </a:solidFill>
               </a:rPr>
-              <a:t>Can the failure be prevented, or must it be observed and evaluated?</a:t>
-            </a:r>
-          </a:p>
-        </p:txBody>
-      </p:sp>
-      <p:sp>
-        <p:nvSpPr>
-          <p:cNvPr id="12" name="Compare3"/>
+              <a:t>each thread: Asleep ⇄ Awake</a:t>
+            </a:r>
+          </a:p>
+          <a:p>
+            <a:pPr algn="l">
+              <a:spcBef>
+                <a:spcPts val="900"/>
+              </a:spcBef>
+              <a:buNone/>
+            </a:pPr>
+            <a:r>
+              <a:rPr lang="en-US" sz="2000" b="0" i="0" dirty="0">
+                <a:solidFill>
+                  <a:srgbClr val="5C4826"/>
+                </a:solidFill>
+              </a:rPr>
+              <a:t>the Scheduler admits at most two threads awake</a:t>
+            </a:r>
+          </a:p>
+        </p:txBody>
+      </p:sp>
+      <p:sp>
+        <p:nvSpPr>
+          <p:cNvPr id="15" name="Card-prompt"/>
           <p:cNvSpPr/>
           <p:nvPr/>
         </p:nvSpPr>
         <p:spPr>
           <a:xfrm>
-            <a:off x="502920" y="2880360"/>
-            <a:ext cx="8138160" cy="1097280"/>
+            <a:off x="4526280" y="1051560"/>
+            <a:ext cx="4343400" cy="4343400"/>
           </a:xfrm>
           <a:prstGeom prst="rect">
             <a:avLst/>
@@ -18780,108 +18798,100 @@
           </a:ln>
           <a:effectLst/>
         </p:spPr>
-        <p:style>
-          <a:lnRef idx="1">
-            <a:schemeClr val="accent1"/>
-          </a:lnRef>
-          <a:fillRef idx="3">
-            <a:schemeClr val="accent1"/>
-          </a:fillRef>
-          <a:effectRef idx="2">
-            <a:schemeClr val="accent1"/>
-          </a:effectRef>
-          <a:fontRef idx="minor">
-            <a:schemeClr val="lt1"/>
-          </a:fontRef>
-        </p:style>
-        <p:txBody>
-          <a:bodyPr wrap="square" lIns="27432" tIns="22860" rIns="27432" bIns="22860" rtlCol="0" anchor="ctr"/>
-          <a:lstStyle/>
-          <a:p>
-            <a:pPr algn="l"/>
-            <a:r>
-              <a:rPr sz="2000" b="1" i="0">
+        <p:txBody>
+          <a:bodyPr wrap="square" lIns="27432" tIns="22860" rIns="27432" bIns="22860" rtlCol="0" anchor="t"/>
+          <a:lstStyle/>
+          <a:p>
+            <a:pPr algn="l">
+              <a:buNone/>
+            </a:pPr>
+            <a:r>
+              <a:rPr lang="en-US" sz="2000" b="1" i="0" dirty="0">
                 <a:solidFill>
                   <a:srgbClr val="5C4826"/>
                 </a:solidFill>
               </a:rPr>
-              <a:t>Static vs. dynamic evidence</a:t>
-            </a:r>
-          </a:p>
-          <a:p>
-            <a:pPr algn="l"/>
-            <a:r>
-              <a:rPr sz="2000" b="0" i="0">
+              <a:t>Choose one obligation from the lab.</a:t>
+            </a:r>
+          </a:p>
+          <a:p>
+            <a:pPr algn="l">
+              <a:spcBef>
+                <a:spcPts val="900"/>
+              </a:spcBef>
+              <a:buNone/>
+            </a:pPr>
+            <a:r>
+              <a:rPr lang="en-US" sz="2000" b="0" i="0" dirty="0">
                 <a:solidFill>
                   <a:srgbClr val="5C4826"/>
                 </a:solidFill>
               </a:rPr>
-              <a:t>Can the obligation be decided from the realization itself, or only from observed execution?</a:t>
-            </a:r>
-          </a:p>
-        </p:txBody>
-      </p:sp>
-      <p:sp>
-        <p:nvSpPr>
-          <p:cNvPr id="13" name="Compare4"/>
-          <p:cNvSpPr/>
-          <p:nvPr/>
-        </p:nvSpPr>
-        <p:spPr>
-          <a:xfrm>
-            <a:off x="502920" y="4142739"/>
-            <a:ext cx="8138160" cy="1097280"/>
-          </a:xfrm>
-          <a:prstGeom prst="rect">
-            <a:avLst/>
-          </a:prstGeom>
-          <a:solidFill>
-            <a:srgbClr val="F5F1E8"/>
-          </a:solidFill>
-          <a:ln w="12700">
-            <a:solidFill>
-              <a:srgbClr val="C9B991"/>
-            </a:solidFill>
-          </a:ln>
-          <a:effectLst/>
-        </p:spPr>
-        <p:style>
-          <a:lnRef idx="1">
-            <a:schemeClr val="accent1"/>
-          </a:lnRef>
-          <a:fillRef idx="3">
-            <a:schemeClr val="accent1"/>
-          </a:fillRef>
-          <a:effectRef idx="2">
-            <a:schemeClr val="accent1"/>
-          </a:effectRef>
-          <a:fontRef idx="minor">
-            <a:schemeClr val="lt1"/>
-          </a:fontRef>
-        </p:style>
-        <p:txBody>
-          <a:bodyPr wrap="square" lIns="27432" tIns="22860" rIns="27432" bIns="22860" rtlCol="0" anchor="ctr"/>
-          <a:lstStyle/>
-          <a:p>
-            <a:pPr algn="l"/>
-            <a:r>
-              <a:rPr sz="2000" b="1" i="0">
+              <a:t>1  ·  How could the realization violate it?</a:t>
+            </a:r>
+          </a:p>
+          <a:p>
+            <a:pPr algn="l">
+              <a:spcBef>
+                <a:spcPts val="900"/>
+              </a:spcBef>
+              <a:buNone/>
+            </a:pPr>
+            <a:r>
+              <a:rPr lang="en-US" sz="2000" b="0" i="0" dirty="0">
                 <a:solidFill>
                   <a:srgbClr val="5C4826"/>
                 </a:solidFill>
               </a:rPr>
-              <a:t>Different authority</a:t>
-            </a:r>
-          </a:p>
-          <a:p>
-            <a:pPr algn="l"/>
-            <a:r>
-              <a:rPr sz="2000" b="0" i="0">
+              <a:t>2  ·  Can you prevent that failure, or must you detect it?</a:t>
+            </a:r>
+          </a:p>
+          <a:p>
+            <a:pPr algn="l">
+              <a:spcBef>
+                <a:spcPts val="900"/>
+              </a:spcBef>
+              <a:buNone/>
+            </a:pPr>
+            <a:r>
+              <a:rPr lang="en-US" sz="2000" b="0" i="0" dirty="0">
                 <a:solidFill>
                   <a:srgbClr val="5C4826"/>
                 </a:solidFill>
               </a:rPr>
-              <a:t>Should this failure block the commit, the PR, the merge, the deployment — or merely produce evidence?</a:t>
+              <a:t>3  ·  What would you check, and what evidence would let you decide?</a:t>
+            </a:r>
+          </a:p>
+          <a:p>
+            <a:pPr algn="l">
+              <a:spcBef>
+                <a:spcPts val="900"/>
+              </a:spcBef>
+              <a:buNone/>
+            </a:pPr>
+            <a:r>
+              <a:rPr lang="en-US" sz="2000" b="0" i="0" dirty="0">
+                <a:solidFill>
+                  <a:srgbClr val="5C4826"/>
+                </a:solidFill>
+              </a:rPr>
+              <a:t>4  ·  Where is the earliest boundary at which it is decidable?</a:t>
+            </a:r>
+          </a:p>
+          <a:p>
+            <a:pPr algn="l">
+              <a:spcBef>
+                <a:spcPts val="900"/>
+              </a:spcBef>
+              <a:buNone/>
+            </a:pPr>
+            <a:r>
+              <a:rPr lang="en-US" sz="2000" b="0" i="0" dirty="0">
+                <a:solidFill>
+                  <a:srgbClr val="5C4826"/>
+                </a:solidFill>
+              </a:rPr>
+              <a:t>5  ·  What should happen if the check fails?</a:t>
             </a:r>
           </a:p>
         </p:txBody>
@@ -18924,6 +18934,371 @@
         <p:spPr/>
         <p:txBody>
           <a:bodyPr wrap="square">
+            <a:normAutofit fontScale="90000"/>
+          </a:bodyPr>
+          <a:lstStyle/>
+          <a:p>
+            <a:r>
+              <a:rPr lang="en-US" sz="2400" b="0" dirty="0">
+                <a:solidFill>
+                  <a:srgbClr val="000000"/>
+                </a:solidFill>
+              </a:rPr>
+              <a:t>Report-out: </a:t>
+            </a:r>
+            <a:r>
+              <a:rPr sz="2400" b="0" dirty="0">
+                <a:solidFill>
+                  <a:srgbClr val="000000"/>
+                </a:solidFill>
+              </a:rPr>
+              <a:t>Compare your </a:t>
+            </a:r>
+            <a:r>
+              <a:rPr lang="en-US" sz="2400" dirty="0">
+                <a:solidFill>
+                  <a:srgbClr val="000000"/>
+                </a:solidFill>
+              </a:rPr>
+              <a:t>A</a:t>
+            </a:r>
+            <a:r>
+              <a:rPr lang="en-US" sz="2400" b="0" dirty="0">
+                <a:solidFill>
+                  <a:srgbClr val="000000"/>
+                </a:solidFill>
+              </a:rPr>
+              <a:t>lignment approaches</a:t>
+            </a:r>
+            <a:endParaRPr sz="2400" b="0" dirty="0">
+              <a:solidFill>
+                <a:srgbClr val="000000"/>
+              </a:solidFill>
+            </a:endParaRPr>
+          </a:p>
+        </p:txBody>
+      </p:sp>
+      <p:sp>
+        <p:nvSpPr>
+          <p:cNvPr id="4" name="Slide Number Placeholder 5"/>
+          <p:cNvSpPr>
+            <a:spLocks noGrp="1"/>
+          </p:cNvSpPr>
+          <p:nvPr>
+            <p:ph type="sldNum" sz="quarter" idx="4"/>
+          </p:nvPr>
+        </p:nvSpPr>
+        <p:spPr/>
+        <p:txBody>
+          <a:bodyPr/>
+          <a:lstStyle/>
+          <a:p>
+            <a:fld id="{B7EB45DA-9A0D-DC49-8E02-F30A5DDC21C3}" type="slidenum">
+              <a:rPr lang="en-US" smtClean="0"/>
+              <a:t>31</a:t>
+            </a:fld>
+            <a:endParaRPr lang="en-US"/>
+          </a:p>
+        </p:txBody>
+      </p:sp>
+      <p:sp>
+        <p:nvSpPr>
+          <p:cNvPr id="10" name="Compare1"/>
+          <p:cNvSpPr/>
+          <p:nvPr/>
+        </p:nvSpPr>
+        <p:spPr>
+          <a:xfrm>
+            <a:off x="502920" y="1051560"/>
+            <a:ext cx="8138160" cy="749808"/>
+          </a:xfrm>
+          <a:prstGeom prst="rect">
+            <a:avLst/>
+          </a:prstGeom>
+          <a:solidFill>
+            <a:srgbClr val="F5F1E8"/>
+          </a:solidFill>
+          <a:ln w="12700">
+            <a:solidFill>
+              <a:srgbClr val="C9B991"/>
+            </a:solidFill>
+          </a:ln>
+          <a:effectLst/>
+        </p:spPr>
+        <p:style>
+          <a:lnRef idx="1">
+            <a:schemeClr val="accent1"/>
+          </a:lnRef>
+          <a:fillRef idx="3">
+            <a:schemeClr val="accent1"/>
+          </a:fillRef>
+          <a:effectRef idx="2">
+            <a:schemeClr val="accent1"/>
+          </a:effectRef>
+          <a:fontRef idx="minor">
+            <a:schemeClr val="lt1"/>
+          </a:fontRef>
+        </p:style>
+        <p:txBody>
+          <a:bodyPr wrap="square" lIns="27432" tIns="22860" rIns="27432" bIns="22860" rtlCol="0" anchor="ctr"/>
+          <a:lstStyle/>
+          <a:p>
+            <a:pPr algn="l"/>
+            <a:r>
+              <a:rPr sz="2000" b="1" i="0">
+                <a:solidFill>
+                  <a:srgbClr val="5C4826"/>
+                </a:solidFill>
+              </a:rPr>
+              <a:t>Same obligation, different boundary</a:t>
+            </a:r>
+          </a:p>
+          <a:p>
+            <a:pPr algn="l"/>
+            <a:r>
+              <a:rPr sz="2000" b="0" i="0">
+                <a:solidFill>
+                  <a:srgbClr val="5C4826"/>
+                </a:solidFill>
+              </a:rPr>
+              <a:t>Which boundary actually has enough information?</a:t>
+            </a:r>
+          </a:p>
+        </p:txBody>
+      </p:sp>
+      <p:sp>
+        <p:nvSpPr>
+          <p:cNvPr id="11" name="Compare2"/>
+          <p:cNvSpPr/>
+          <p:nvPr/>
+        </p:nvSpPr>
+        <p:spPr>
+          <a:xfrm>
+            <a:off x="502920" y="1965960"/>
+            <a:ext cx="8138160" cy="749808"/>
+          </a:xfrm>
+          <a:prstGeom prst="rect">
+            <a:avLst/>
+          </a:prstGeom>
+          <a:solidFill>
+            <a:srgbClr val="F5F1E8"/>
+          </a:solidFill>
+          <a:ln w="12700">
+            <a:solidFill>
+              <a:srgbClr val="C9B991"/>
+            </a:solidFill>
+          </a:ln>
+          <a:effectLst/>
+        </p:spPr>
+        <p:style>
+          <a:lnRef idx="1">
+            <a:schemeClr val="accent1"/>
+          </a:lnRef>
+          <a:fillRef idx="3">
+            <a:schemeClr val="accent1"/>
+          </a:fillRef>
+          <a:effectRef idx="2">
+            <a:schemeClr val="accent1"/>
+          </a:effectRef>
+          <a:fontRef idx="minor">
+            <a:schemeClr val="lt1"/>
+          </a:fontRef>
+        </p:style>
+        <p:txBody>
+          <a:bodyPr wrap="square" lIns="27432" tIns="22860" rIns="27432" bIns="22860" rtlCol="0" anchor="ctr"/>
+          <a:lstStyle/>
+          <a:p>
+            <a:pPr algn="l"/>
+            <a:r>
+              <a:rPr sz="2000" b="1" i="0">
+                <a:solidFill>
+                  <a:srgbClr val="5C4826"/>
+                </a:solidFill>
+              </a:rPr>
+              <a:t>Constraint vs. evidence</a:t>
+            </a:r>
+          </a:p>
+          <a:p>
+            <a:pPr algn="l"/>
+            <a:r>
+              <a:rPr sz="2000" b="0" i="0">
+                <a:solidFill>
+                  <a:srgbClr val="5C4826"/>
+                </a:solidFill>
+              </a:rPr>
+              <a:t>Can the failure be prevented, or must it be observed and evaluated?</a:t>
+            </a:r>
+          </a:p>
+        </p:txBody>
+      </p:sp>
+      <p:sp>
+        <p:nvSpPr>
+          <p:cNvPr id="12" name="Compare3"/>
+          <p:cNvSpPr/>
+          <p:nvPr/>
+        </p:nvSpPr>
+        <p:spPr>
+          <a:xfrm>
+            <a:off x="502920" y="2880360"/>
+            <a:ext cx="8138160" cy="1097280"/>
+          </a:xfrm>
+          <a:prstGeom prst="rect">
+            <a:avLst/>
+          </a:prstGeom>
+          <a:solidFill>
+            <a:srgbClr val="F5F1E8"/>
+          </a:solidFill>
+          <a:ln w="12700">
+            <a:solidFill>
+              <a:srgbClr val="C9B991"/>
+            </a:solidFill>
+          </a:ln>
+          <a:effectLst/>
+        </p:spPr>
+        <p:style>
+          <a:lnRef idx="1">
+            <a:schemeClr val="accent1"/>
+          </a:lnRef>
+          <a:fillRef idx="3">
+            <a:schemeClr val="accent1"/>
+          </a:fillRef>
+          <a:effectRef idx="2">
+            <a:schemeClr val="accent1"/>
+          </a:effectRef>
+          <a:fontRef idx="minor">
+            <a:schemeClr val="lt1"/>
+          </a:fontRef>
+        </p:style>
+        <p:txBody>
+          <a:bodyPr wrap="square" lIns="27432" tIns="22860" rIns="27432" bIns="22860" rtlCol="0" anchor="ctr"/>
+          <a:lstStyle/>
+          <a:p>
+            <a:pPr algn="l"/>
+            <a:r>
+              <a:rPr sz="2000" b="1" i="0">
+                <a:solidFill>
+                  <a:srgbClr val="5C4826"/>
+                </a:solidFill>
+              </a:rPr>
+              <a:t>Static vs. dynamic evidence</a:t>
+            </a:r>
+          </a:p>
+          <a:p>
+            <a:pPr algn="l"/>
+            <a:r>
+              <a:rPr sz="2000" b="0" i="0">
+                <a:solidFill>
+                  <a:srgbClr val="5C4826"/>
+                </a:solidFill>
+              </a:rPr>
+              <a:t>Can the obligation be decided from the realization itself, or only from observed execution?</a:t>
+            </a:r>
+          </a:p>
+        </p:txBody>
+      </p:sp>
+      <p:sp>
+        <p:nvSpPr>
+          <p:cNvPr id="13" name="Compare4"/>
+          <p:cNvSpPr/>
+          <p:nvPr/>
+        </p:nvSpPr>
+        <p:spPr>
+          <a:xfrm>
+            <a:off x="502920" y="4142739"/>
+            <a:ext cx="8138160" cy="1097280"/>
+          </a:xfrm>
+          <a:prstGeom prst="rect">
+            <a:avLst/>
+          </a:prstGeom>
+          <a:solidFill>
+            <a:srgbClr val="F5F1E8"/>
+          </a:solidFill>
+          <a:ln w="12700">
+            <a:solidFill>
+              <a:srgbClr val="C9B991"/>
+            </a:solidFill>
+          </a:ln>
+          <a:effectLst/>
+        </p:spPr>
+        <p:style>
+          <a:lnRef idx="1">
+            <a:schemeClr val="accent1"/>
+          </a:lnRef>
+          <a:fillRef idx="3">
+            <a:schemeClr val="accent1"/>
+          </a:fillRef>
+          <a:effectRef idx="2">
+            <a:schemeClr val="accent1"/>
+          </a:effectRef>
+          <a:fontRef idx="minor">
+            <a:schemeClr val="lt1"/>
+          </a:fontRef>
+        </p:style>
+        <p:txBody>
+          <a:bodyPr wrap="square" lIns="27432" tIns="22860" rIns="27432" bIns="22860" rtlCol="0" anchor="ctr"/>
+          <a:lstStyle/>
+          <a:p>
+            <a:pPr algn="l"/>
+            <a:r>
+              <a:rPr sz="2000" b="1" i="0">
+                <a:solidFill>
+                  <a:srgbClr val="5C4826"/>
+                </a:solidFill>
+              </a:rPr>
+              <a:t>Different authority</a:t>
+            </a:r>
+          </a:p>
+          <a:p>
+            <a:pPr algn="l"/>
+            <a:r>
+              <a:rPr sz="2000" b="0" i="0">
+                <a:solidFill>
+                  <a:srgbClr val="5C4826"/>
+                </a:solidFill>
+              </a:rPr>
+              <a:t>Should this failure block the commit, the PR, the merge, the deployment — or merely produce evidence?</a:t>
+            </a:r>
+          </a:p>
+        </p:txBody>
+      </p:sp>
+    </p:spTree>
+  </p:cSld>
+  <p:clrMapOvr>
+    <a:masterClrMapping/>
+  </p:clrMapOvr>
+</p:sld>
+</file>
+
+<file path=ppt/slides/slide32.xml><?xml version="1.0" encoding="utf-8"?>
+<p:sld xmlns:a="http://schemas.openxmlformats.org/drawingml/2006/main" xmlns:r="http://schemas.openxmlformats.org/officeDocument/2006/relationships" xmlns:p="http://schemas.openxmlformats.org/presentationml/2006/main">
+  <p:cSld>
+    <p:spTree>
+      <p:nvGrpSpPr>
+        <p:cNvPr id="1" name=""/>
+        <p:cNvGrpSpPr/>
+        <p:nvPr/>
+      </p:nvGrpSpPr>
+      <p:grpSpPr>
+        <a:xfrm>
+          <a:off x="0" y="0"/>
+          <a:ext cx="0" cy="0"/>
+          <a:chOff x="0" y="0"/>
+          <a:chExt cx="0" cy="0"/>
+        </a:xfrm>
+      </p:grpSpPr>
+      <p:sp>
+        <p:nvSpPr>
+          <p:cNvPr id="3" name="Title 2"/>
+          <p:cNvSpPr>
+            <a:spLocks noGrp="1"/>
+          </p:cNvSpPr>
+          <p:nvPr>
+            <p:ph type="title"/>
+          </p:nvPr>
+        </p:nvSpPr>
+        <p:spPr/>
+        <p:txBody>
+          <a:bodyPr wrap="square">
             <a:noAutofit/>
           </a:bodyPr>
           <a:lstStyle/>
@@ -19282,315 +19657,6 @@
                 </a:solidFill>
               </a:rPr>
               <a:t>Should failure control what happens next?</a:t>
-            </a:r>
-          </a:p>
-        </p:txBody>
-      </p:sp>
-    </p:spTree>
-  </p:cSld>
-  <p:clrMapOvr>
-    <a:masterClrMapping/>
-  </p:clrMapOvr>
-</p:sld>
-</file>
-
-<file path=ppt/slides/slide32.xml><?xml version="1.0" encoding="utf-8"?>
-<p:sld xmlns:a="http://schemas.openxmlformats.org/drawingml/2006/main" xmlns:p="http://schemas.openxmlformats.org/presentationml/2006/main" xmlns:r="http://schemas.openxmlformats.org/officeDocument/2006/relationships">
-  <p:cSld>
-    <p:spTree>
-      <p:nvGrpSpPr>
-        <p:cNvPr id="1" name=""/>
-        <p:cNvGrpSpPr/>
-        <p:nvPr/>
-      </p:nvGrpSpPr>
-      <p:grpSpPr/>
-      <p:sp>
-        <p:nvSpPr>
-          <p:cNvPr id="3" name="Title 2"/>
-          <p:cNvSpPr>
-            <a:spLocks noGrp="1"/>
-          </p:cNvSpPr>
-          <p:nvPr>
-            <p:ph type="title"/>
-          </p:nvPr>
-        </p:nvSpPr>
-        <p:spPr/>
-        <p:txBody>
-          <a:bodyPr wrap="square">
-            <a:normAutofit fontScale="90000"/>
-          </a:bodyPr>
-          <a:lstStyle/>
-          <a:p>
-            <a:r>
-              <a:rPr sz="2400" b="0" dirty="0">
-                <a:solidFill>
-                  <a:srgbClr val="000000"/>
-                </a:solidFill>
-              </a:rPr>
-              <a:t>Alignment can change the realization</a:t>
-            </a:r>
-          </a:p>
-        </p:txBody>
-      </p:sp>
-      <p:sp>
-        <p:nvSpPr>
-          <p:cNvPr id="4" name="Slide Number Placeholder 5"/>
-          <p:cNvSpPr>
-            <a:spLocks noGrp="1"/>
-          </p:cNvSpPr>
-          <p:nvPr>
-            <p:ph type="sldNum" sz="quarter" idx="4"/>
-          </p:nvPr>
-        </p:nvSpPr>
-        <p:spPr/>
-        <p:txBody>
-          <a:bodyPr/>
-          <a:lstStyle/>
-          <a:p>
-            <a:fld id="{B7EB45DA-9A0D-DC49-8E02-F30A5DDC21C3}" type="slidenum">
-              <a:rPr lang="en-US" smtClean="0"/>
-              <a:t>27</a:t>
-            </a:fld>
-            <a:endParaRPr lang="en-US"/>
-          </a:p>
-        </p:txBody>
-      </p:sp>
-      <p:pic>
-        <p:nvPicPr>
-          <p:cNvPr id="5" name="Fig-ActiveAlignment" descr="active-passive-alignment-deck.png"/>
-          <p:cNvPicPr>
-            <a:picLocks noChangeAspect="1"/>
-          </p:cNvPicPr>
-          <p:nvPr/>
-        </p:nvPicPr>
-        <p:blipFill>
-          <a:blip r:embed="rId2"/>
-          <a:stretch>
-            <a:fillRect/>
-          </a:stretch>
-        </p:blipFill>
-        <p:spPr>
-          <a:xfrm>
-            <a:off x="384048" y="914400"/>
-            <a:ext cx="3911600" cy="4526280"/>
-          </a:xfrm>
-          <a:prstGeom prst="rect">
-            <a:avLst/>
-          </a:prstGeom>
-        </p:spPr>
-      </p:pic>
-      <p:graphicFrame>
-        <p:nvGraphicFramePr>
-          <p:cNvPr id="6" name="ActivePassiveCompare"/>
-          <p:cNvGraphicFramePr>
-            <a:graphicFrameLocks noGrp="1"/>
-          </p:cNvGraphicFramePr>
-          <p:nvPr/>
-        </p:nvGraphicFramePr>
-        <p:xfrm>
-          <a:off x="4663440" y="1874519"/>
-          <a:ext cx="4023360" cy="2423160"/>
-        </p:xfrm>
-        <a:graphic>
-          <a:graphicData uri="http://schemas.openxmlformats.org/drawingml/2006/table">
-            <a:tbl>
-              <a:tblPr>
-                <a:tableStyleId>{2D5ABB26-0587-4C30-8999-92F81FD0307C}</a:tableStyleId>
-              </a:tblPr>
-              <a:tblGrid>
-                <a:gridCol w="2011680"/>
-                <a:gridCol w="2011680"/>
-              </a:tblGrid>
-              <a:tr h="502920">
-                <a:tc>
-                  <a:txBody>
-                    <a:bodyPr/>
-                    <a:lstStyle/>
-                    <a:p>
-                      <a:pPr algn="ctr"/>
-                      <a:r>
-                        <a:rPr sz="2000" b="1" i="0">
-                          <a:solidFill>
-                            <a:srgbClr val="FFFFFF"/>
-                          </a:solidFill>
-                        </a:rPr>
-                        <a:t>ACTIVE</a:t>
-                      </a:r>
-                    </a:p>
-                  </a:txBody>
-                  <a:tcPr anchor="ctr" marL="54864" marR="54864" marT="36576" marB="36576">
-                    <a:solidFill>
-                      <a:srgbClr val="8E6F3E"/>
-                    </a:solidFill>
-                  </a:tcPr>
-                </a:tc>
-                <a:tc>
-                  <a:txBody>
-                    <a:bodyPr/>
-                    <a:lstStyle/>
-                    <a:p>
-                      <a:pPr algn="ctr"/>
-                      <a:r>
-                        <a:rPr sz="2000" b="1" i="0">
-                          <a:solidFill>
-                            <a:srgbClr val="FFFFFF"/>
-                          </a:solidFill>
-                        </a:rPr>
-                        <a:t>PASSIVE</a:t>
-                      </a:r>
-                    </a:p>
-                  </a:txBody>
-                  <a:tcPr anchor="ctr" marL="54864" marR="54864" marT="36576" marB="36576">
-                    <a:solidFill>
-                      <a:srgbClr val="8E6F3E"/>
-                    </a:solidFill>
-                  </a:tcPr>
-                </a:tc>
-              </a:tr>
-              <a:tr h="960120">
-                <a:tc>
-                  <a:txBody>
-                    <a:bodyPr/>
-                    <a:lstStyle/>
-                    <a:p>
-                      <a:pPr algn="ctr"/>
-                      <a:r>
-                        <a:rPr sz="2000" b="0" i="1">
-                          <a:solidFill>
-                            <a:srgbClr val="5C4826"/>
-                          </a:solidFill>
-                        </a:rPr>
-                        <a:t>establish correspondence</a:t>
-                      </a:r>
-                    </a:p>
-                  </a:txBody>
-                  <a:tcPr anchor="ctr" marL="54864" marR="54864" marT="36576" marB="36576">
-                    <a:solidFill>
-                      <a:srgbClr val="F5F1E8"/>
-                    </a:solidFill>
-                  </a:tcPr>
-                </a:tc>
-                <a:tc>
-                  <a:txBody>
-                    <a:bodyPr/>
-                    <a:lstStyle/>
-                    <a:p>
-                      <a:pPr algn="ctr"/>
-                      <a:r>
-                        <a:rPr sz="2000" b="0" i="1">
-                          <a:solidFill>
-                            <a:srgbClr val="5C4826"/>
-                          </a:solidFill>
-                        </a:rPr>
-                        <a:t>preserve correspondence</a:t>
-                      </a:r>
-                    </a:p>
-                  </a:txBody>
-                  <a:tcPr anchor="ctr" marL="54864" marR="54864" marT="36576" marB="36576">
-                    <a:solidFill>
-                      <a:srgbClr val="F5F1E8"/>
-                    </a:solidFill>
-                  </a:tcPr>
-                </a:tc>
-              </a:tr>
-              <a:tr h="960120">
-                <a:tc>
-                  <a:txBody>
-                    <a:bodyPr/>
-                    <a:lstStyle/>
-                    <a:p>
-                      <a:pPr algn="ctr"/>
-                      <a:r>
-                        <a:rPr sz="2000" b="0" i="0">
-                          <a:solidFill>
-                            <a:srgbClr val="5C4826"/>
-                          </a:solidFill>
-                        </a:rPr>
-                        <a:t>S → S′ until M agrees</a:t>
-                      </a:r>
-                    </a:p>
-                  </a:txBody>
-                  <a:tcPr anchor="ctr" marL="54864" marR="54864" marT="36576" marB="36576">
-                    <a:solidFill>
-                      <a:srgbClr val="F5F1E8"/>
-                    </a:solidFill>
-                  </a:tcPr>
-                </a:tc>
-                <a:tc>
-                  <a:txBody>
-                    <a:bodyPr/>
-                    <a:lstStyle/>
-                    <a:p>
-                      <a:pPr algn="ctr"/>
-                      <a:r>
-                        <a:rPr sz="2000" b="0" i="0">
-                          <a:solidFill>
-                            <a:srgbClr val="5C4826"/>
-                          </a:solidFill>
-                        </a:rPr>
-                        <a:t>ΔS → check → admit/reject</a:t>
-                      </a:r>
-                    </a:p>
-                  </a:txBody>
-                  <a:tcPr anchor="ctr" marL="54864" marR="54864" marT="36576" marB="36576">
-                    <a:solidFill>
-                      <a:srgbClr val="F5F1E8"/>
-                    </a:solidFill>
-                  </a:tcPr>
-                </a:tc>
-              </a:tr>
-            </a:tbl>
-          </a:graphicData>
-        </a:graphic>
-      </p:graphicFrame>
-      <p:sp>
-        <p:nvSpPr>
-          <p:cNvPr id="7" name="FooterBand"/>
-          <p:cNvSpPr/>
-          <p:nvPr/>
-        </p:nvSpPr>
-        <p:spPr>
-          <a:xfrm>
-            <a:off x="274320" y="5577840"/>
-            <a:ext cx="8595360" cy="777240"/>
-          </a:xfrm>
-          <a:prstGeom prst="rect">
-            <a:avLst/>
-          </a:prstGeom>
-          <a:solidFill>
-            <a:srgbClr val="8E6F3E"/>
-          </a:solidFill>
-          <a:ln>
-            <a:noFill/>
-          </a:ln>
-          <a:effectLst/>
-        </p:spPr>
-        <p:style>
-          <a:lnRef idx="1">
-            <a:schemeClr val="accent1"/>
-          </a:lnRef>
-          <a:fillRef idx="3">
-            <a:schemeClr val="accent1"/>
-          </a:fillRef>
-          <a:effectRef idx="2">
-            <a:schemeClr val="accent1"/>
-          </a:effectRef>
-          <a:fontRef idx="minor">
-            <a:schemeClr val="lt1"/>
-          </a:fontRef>
-        </p:style>
-        <p:txBody>
-          <a:bodyPr rtlCol="0" anchor="ctr" wrap="square" lIns="27432" rIns="27432" tIns="22860" bIns="22860"/>
-          <a:lstStyle/>
-          <a:p>
-            <a:pPr algn="ctr"/>
-            <a:r>
-              <a:rPr sz="2000" b="1">
-                <a:solidFill>
-                  <a:srgbClr val="FFFFFF"/>
-                </a:solidFill>
-              </a:rPr>
-              <a:t>A model can govern an existing system by first becoming a target for change, then a constraint on later change.</a:t>
             </a:r>
           </a:p>
         </p:txBody>

</xml_diff>

<commit_message>
deck 2-3 slide 26: an engineer's retrofit line for active alignment
The author's edit. Slide 26 gains the voiced example of noticing an
unconstrained degree of freedom and handing the model back as a retrofit
target, which makes active alignment concrete before slide 27 turns it
into a constraint on later change.
</commit_message>
<xml_diff>
--- a/course/lectures/act-2-delegation-and-control/03-alignment/2-3-Alignment.pptx
+++ b/course/lectures/act-2-delegation-and-control/03-alignment/2-3-Alignment.pptx
@@ -21302,10 +21302,16 @@
           <p:cNvGraphicFramePr>
             <a:graphicFrameLocks noGrp="1"/>
           </p:cNvGraphicFramePr>
-          <p:nvPr/>
+          <p:nvPr>
+            <p:extLst>
+              <p:ext uri="{D42A27DB-BD31-4B8C-83A1-F6EECF244321}">
+                <p14:modId xmlns:p14="http://schemas.microsoft.com/office/powerpoint/2010/main" val="737483233"/>
+              </p:ext>
+            </p:extLst>
+          </p:nvPr>
         </p:nvGraphicFramePr>
         <p:xfrm>
-          <a:off x="4663440" y="1874519"/>
+          <a:off x="4620576" y="2725335"/>
           <a:ext cx="4023360" cy="2423160"/>
         </p:xfrm>
         <a:graphic>
@@ -21535,6 +21541,41 @@
                 </a:solidFill>
               </a:rPr>
               <a:t>A model can govern an existing system by first becoming a target for change, then a constraint on later change.</a:t>
+            </a:r>
+          </a:p>
+        </p:txBody>
+      </p:sp>
+      <p:sp>
+        <p:nvSpPr>
+          <p:cNvPr id="2" name="TextBox 1">
+            <a:extLst>
+              <a:ext uri="{FF2B5EF4-FFF2-40B4-BE49-F238E27FC236}">
+                <a16:creationId xmlns:a16="http://schemas.microsoft.com/office/drawing/2014/main" id="{C01F10B8-AA70-F2D8-5FA7-B524EB4EE045}"/>
+              </a:ext>
+            </a:extLst>
+          </p:cNvPr>
+          <p:cNvSpPr txBox="1"/>
+          <p:nvPr/>
+        </p:nvSpPr>
+        <p:spPr>
+          <a:xfrm>
+            <a:off x="4572000" y="956139"/>
+            <a:ext cx="4442113" cy="1569660"/>
+          </a:xfrm>
+          <a:prstGeom prst="rect">
+            <a:avLst/>
+          </a:prstGeom>
+          <a:noFill/>
+        </p:spPr>
+        <p:txBody>
+          <a:bodyPr wrap="square" rtlCol="0">
+            <a:spAutoFit/>
+          </a:bodyPr>
+          <a:lstStyle/>
+          <a:p>
+            <a:r>
+              <a:rPr lang="en-US" sz="2400" i="1" dirty="0"/>
+              <a:t>“Oops, I forgot to control memory use. That’s a degree of freedom I should not have left open. Here is the model, retrofit the code.”</a:t>
             </a:r>
           </a:p>
         </p:txBody>

</xml_diff>